<commit_message>
14 sun 24 songs
</commit_message>
<xml_diff>
--- a/xerox.pptx
+++ b/xerox.pptx
@@ -224,7 +224,7 @@
           <a:p>
             <a:fld id="{3502DD63-DF8D-4AB8-92A0-0ECCF612C06C}" type="datetimeFigureOut">
               <a:rPr lang="en-IN" smtClean="0"/>
-              <a:t>06-01-2024</a:t>
+              <a:t>13-01-2024</a:t>
             </a:fld>
             <a:endParaRPr lang="en-IN"/>
           </a:p>
@@ -402,7 +402,7 @@
           <a:p>
             <a:fld id="{1AE741EC-1360-4793-999B-941E0396C9FA}" type="datetimeFigureOut">
               <a:rPr lang="en-IN" smtClean="0"/>
-              <a:t>06-01-2024</a:t>
+              <a:t>13-01-2024</a:t>
             </a:fld>
             <a:endParaRPr lang="en-IN"/>
           </a:p>
@@ -802,7 +802,7 @@
           <a:p>
             <a:fld id="{86FBD32F-FCAD-481A-B7D8-4D813FB7DB24}" type="datetimeFigureOut">
               <a:rPr lang="en-IN" smtClean="0"/>
-              <a:t>06-01-2024</a:t>
+              <a:t>13-01-2024</a:t>
             </a:fld>
             <a:endParaRPr lang="en-IN"/>
           </a:p>
@@ -972,7 +972,7 @@
           <a:p>
             <a:fld id="{86FBD32F-FCAD-481A-B7D8-4D813FB7DB24}" type="datetimeFigureOut">
               <a:rPr lang="en-IN" smtClean="0"/>
-              <a:t>06-01-2024</a:t>
+              <a:t>13-01-2024</a:t>
             </a:fld>
             <a:endParaRPr lang="en-IN"/>
           </a:p>
@@ -1152,7 +1152,7 @@
           <a:p>
             <a:fld id="{86FBD32F-FCAD-481A-B7D8-4D813FB7DB24}" type="datetimeFigureOut">
               <a:rPr lang="en-IN" smtClean="0"/>
-              <a:t>06-01-2024</a:t>
+              <a:t>13-01-2024</a:t>
             </a:fld>
             <a:endParaRPr lang="en-IN"/>
           </a:p>
@@ -1322,7 +1322,7 @@
           <a:p>
             <a:fld id="{86FBD32F-FCAD-481A-B7D8-4D813FB7DB24}" type="datetimeFigureOut">
               <a:rPr lang="en-IN" smtClean="0"/>
-              <a:t>06-01-2024</a:t>
+              <a:t>13-01-2024</a:t>
             </a:fld>
             <a:endParaRPr lang="en-IN"/>
           </a:p>
@@ -1566,7 +1566,7 @@
           <a:p>
             <a:fld id="{86FBD32F-FCAD-481A-B7D8-4D813FB7DB24}" type="datetimeFigureOut">
               <a:rPr lang="en-IN" smtClean="0"/>
-              <a:t>06-01-2024</a:t>
+              <a:t>13-01-2024</a:t>
             </a:fld>
             <a:endParaRPr lang="en-IN"/>
           </a:p>
@@ -1798,7 +1798,7 @@
           <a:p>
             <a:fld id="{86FBD32F-FCAD-481A-B7D8-4D813FB7DB24}" type="datetimeFigureOut">
               <a:rPr lang="en-IN" smtClean="0"/>
-              <a:t>06-01-2024</a:t>
+              <a:t>13-01-2024</a:t>
             </a:fld>
             <a:endParaRPr lang="en-IN"/>
           </a:p>
@@ -2165,7 +2165,7 @@
           <a:p>
             <a:fld id="{86FBD32F-FCAD-481A-B7D8-4D813FB7DB24}" type="datetimeFigureOut">
               <a:rPr lang="en-IN" smtClean="0"/>
-              <a:t>06-01-2024</a:t>
+              <a:t>13-01-2024</a:t>
             </a:fld>
             <a:endParaRPr lang="en-IN"/>
           </a:p>
@@ -2283,7 +2283,7 @@
           <a:p>
             <a:fld id="{86FBD32F-FCAD-481A-B7D8-4D813FB7DB24}" type="datetimeFigureOut">
               <a:rPr lang="en-IN" smtClean="0"/>
-              <a:t>06-01-2024</a:t>
+              <a:t>13-01-2024</a:t>
             </a:fld>
             <a:endParaRPr lang="en-IN"/>
           </a:p>
@@ -2378,7 +2378,7 @@
           <a:p>
             <a:fld id="{86FBD32F-FCAD-481A-B7D8-4D813FB7DB24}" type="datetimeFigureOut">
               <a:rPr lang="en-IN" smtClean="0"/>
-              <a:t>06-01-2024</a:t>
+              <a:t>13-01-2024</a:t>
             </a:fld>
             <a:endParaRPr lang="en-IN"/>
           </a:p>
@@ -2655,7 +2655,7 @@
           <a:p>
             <a:fld id="{86FBD32F-FCAD-481A-B7D8-4D813FB7DB24}" type="datetimeFigureOut">
               <a:rPr lang="en-IN" smtClean="0"/>
-              <a:t>06-01-2024</a:t>
+              <a:t>13-01-2024</a:t>
             </a:fld>
             <a:endParaRPr lang="en-IN"/>
           </a:p>
@@ -2912,7 +2912,7 @@
           <a:p>
             <a:fld id="{86FBD32F-FCAD-481A-B7D8-4D813FB7DB24}" type="datetimeFigureOut">
               <a:rPr lang="en-IN" smtClean="0"/>
-              <a:t>06-01-2024</a:t>
+              <a:t>13-01-2024</a:t>
             </a:fld>
             <a:endParaRPr lang="en-IN"/>
           </a:p>
@@ -3125,7 +3125,7 @@
           <a:p>
             <a:fld id="{86FBD32F-FCAD-481A-B7D8-4D813FB7DB24}" type="datetimeFigureOut">
               <a:rPr lang="en-IN" smtClean="0"/>
-              <a:t>06-01-2024</a:t>
+              <a:t>13-01-2024</a:t>
             </a:fld>
             <a:endParaRPr lang="en-IN"/>
           </a:p>
@@ -3596,7 +3596,7 @@
               <a:defRPr/>
             </a:pPr>
             <a:r>
-              <a:rPr kumimoji="0" lang="te-IN" sz="2000" i="0" u="none" strike="noStrike" kern="1200" cap="none" spc="0" normalizeH="0" baseline="0" noProof="0" dirty="0">
+              <a:rPr kumimoji="0" lang="te-IN" sz="1600" i="0" u="none" strike="noStrike" kern="1200" cap="none" spc="0" normalizeH="0" baseline="0" noProof="0" dirty="0">
                 <a:ln>
                   <a:noFill/>
                 </a:ln>
@@ -3609,7 +3609,7 @@
                 <a:latin typeface="Ramabhadra" panose="02000600000000000000" pitchFamily="2" charset="0"/>
                 <a:cs typeface="Ramabhadra" panose="02000600000000000000" pitchFamily="2" charset="0"/>
               </a:rPr>
-              <a:t>ఎవరు నా చేయి విడచిన</a:t>
+              <a:t>పాడెద స్తుతి గానము</a:t>
             </a:r>
           </a:p>
           <a:p>
@@ -3628,7 +3628,7 @@
               <a:defRPr/>
             </a:pPr>
             <a:r>
-              <a:rPr kumimoji="0" lang="te-IN" sz="2000" i="0" u="none" strike="noStrike" kern="1200" cap="none" spc="0" normalizeH="0" baseline="0" noProof="0" dirty="0">
+              <a:rPr kumimoji="0" lang="te-IN" sz="1600" i="0" u="none" strike="noStrike" kern="1200" cap="none" spc="0" normalizeH="0" baseline="0" noProof="0" dirty="0">
                 <a:ln>
                   <a:noFill/>
                 </a:ln>
@@ -3641,7 +3641,7 @@
                 <a:latin typeface="Ramabhadra" panose="02000600000000000000" pitchFamily="2" charset="0"/>
                 <a:cs typeface="Ramabhadra" panose="02000600000000000000" pitchFamily="2" charset="0"/>
               </a:rPr>
-              <a:t>యేసు చేయి విడువడు (2)</a:t>
+              <a:t>కొనియాడెద నీ నామము(2)</a:t>
             </a:r>
           </a:p>
           <a:p>
@@ -3660,7 +3660,7 @@
               <a:defRPr/>
             </a:pPr>
             <a:r>
-              <a:rPr kumimoji="0" lang="te-IN" sz="2000" i="0" u="none" strike="noStrike" kern="1200" cap="none" spc="0" normalizeH="0" baseline="0" noProof="0" dirty="0">
+              <a:rPr kumimoji="0" lang="te-IN" sz="1600" i="0" u="none" strike="noStrike" kern="1200" cap="none" spc="0" normalizeH="0" baseline="0" noProof="0" dirty="0">
                 <a:ln>
                   <a:noFill/>
                 </a:ln>
@@ -3673,7 +3673,7 @@
                 <a:latin typeface="Ramabhadra" panose="02000600000000000000" pitchFamily="2" charset="0"/>
                 <a:cs typeface="Ramabhadra" panose="02000600000000000000" pitchFamily="2" charset="0"/>
               </a:rPr>
-              <a:t>చేయి విడువడు (3)</a:t>
+              <a:t>నీవే నా ప్రేమానురాగం</a:t>
             </a:r>
           </a:p>
           <a:p>
@@ -3692,7 +3692,7 @@
               <a:defRPr/>
             </a:pPr>
             <a:r>
-              <a:rPr kumimoji="0" lang="te-IN" sz="2000" i="0" u="none" strike="noStrike" kern="1200" cap="none" spc="0" normalizeH="0" baseline="0" noProof="0" dirty="0">
+              <a:rPr kumimoji="0" lang="te-IN" sz="1600" i="0" u="none" strike="noStrike" kern="1200" cap="none" spc="0" normalizeH="0" baseline="0" noProof="0" dirty="0">
                 <a:ln>
                   <a:noFill/>
                 </a:ln>
@@ -3705,7 +3705,7 @@
                 <a:latin typeface="Ramabhadra" panose="02000600000000000000" pitchFamily="2" charset="0"/>
                 <a:cs typeface="Ramabhadra" panose="02000600000000000000" pitchFamily="2" charset="0"/>
               </a:rPr>
-              <a:t>యేసు చేయి విడువడు</a:t>
+              <a:t>క్షణమైనా విడువని స్నేహం</a:t>
             </a:r>
           </a:p>
           <a:p>
@@ -3723,7 +3723,39 @@
               <a:tabLst/>
               <a:defRPr/>
             </a:pPr>
-            <a:endParaRPr kumimoji="0" lang="te-IN" sz="2000" i="0" u="none" strike="noStrike" kern="1200" cap="none" spc="0" normalizeH="0" baseline="0" noProof="0" dirty="0">
+            <a:r>
+              <a:rPr kumimoji="0" lang="te-IN" sz="1600" i="0" u="none" strike="noStrike" kern="1200" cap="none" spc="0" normalizeH="0" baseline="0" noProof="0" dirty="0">
+                <a:ln>
+                  <a:noFill/>
+                </a:ln>
+                <a:solidFill>
+                  <a:schemeClr val="tx1"/>
+                </a:solidFill>
+                <a:effectLst/>
+                <a:uLnTx/>
+                <a:uFillTx/>
+                <a:latin typeface="Ramabhadra" panose="02000600000000000000" pitchFamily="2" charset="0"/>
+                <a:cs typeface="Ramabhadra" panose="02000600000000000000" pitchFamily="2" charset="0"/>
+              </a:rPr>
+              <a:t>అతి శ్రేష్టుడా నా యేసయ్య(2)</a:t>
+            </a:r>
+          </a:p>
+          <a:p>
+            <a:pPr marL="0" marR="0" lvl="0" indent="0" algn="ctr" defTabSz="439781" rtl="0" eaLnBrk="1" fontAlgn="auto" latinLnBrk="0" hangingPunct="1">
+              <a:spcBef>
+                <a:spcPts val="0"/>
+              </a:spcBef>
+              <a:spcAft>
+                <a:spcPts val="0"/>
+              </a:spcAft>
+              <a:buClrTx/>
+              <a:buSzTx/>
+              <a:buFontTx/>
+              <a:buNone/>
+              <a:tabLst/>
+              <a:defRPr/>
+            </a:pPr>
+            <a:endParaRPr kumimoji="0" lang="te-IN" sz="1600" i="0" u="none" strike="noStrike" kern="1200" cap="none" spc="0" normalizeH="0" baseline="0" noProof="0" dirty="0">
               <a:ln>
                 <a:noFill/>
               </a:ln>
@@ -3753,7 +3785,7 @@
               <a:defRPr/>
             </a:pPr>
             <a:r>
-              <a:rPr kumimoji="0" lang="te-IN" sz="2000" i="0" u="none" strike="noStrike" kern="1200" cap="none" spc="0" normalizeH="0" baseline="0" noProof="0" dirty="0">
+              <a:rPr kumimoji="0" lang="te-IN" sz="1600" i="0" u="none" strike="noStrike" kern="1200" cap="none" spc="0" normalizeH="0" baseline="0" noProof="0" dirty="0">
                 <a:ln>
                   <a:noFill/>
                 </a:ln>
@@ -3766,7 +3798,7 @@
                 <a:latin typeface="Ramabhadra" panose="02000600000000000000" pitchFamily="2" charset="0"/>
                 <a:cs typeface="Ramabhadra" panose="02000600000000000000" pitchFamily="2" charset="0"/>
               </a:rPr>
-              <a:t>తల్లి ఆయనే తండ్రి ఆయనే (2)</a:t>
+              <a:t>ఇల నాకెవ్వరు లేరనుకొనగా నా దరి చేరితివే </a:t>
             </a:r>
           </a:p>
           <a:p>
@@ -3785,7 +3817,7 @@
               <a:defRPr/>
             </a:pPr>
             <a:r>
-              <a:rPr kumimoji="0" lang="te-IN" sz="2000" i="0" u="none" strike="noStrike" kern="1200" cap="none" spc="0" normalizeH="0" baseline="0" noProof="0" dirty="0">
+              <a:rPr kumimoji="0" lang="te-IN" sz="1600" i="0" u="none" strike="noStrike" kern="1200" cap="none" spc="0" normalizeH="0" baseline="0" noProof="0" dirty="0">
                 <a:ln>
                   <a:noFill/>
                 </a:ln>
@@ -3798,7 +3830,7 @@
                 <a:latin typeface="Ramabhadra" panose="02000600000000000000" pitchFamily="2" charset="0"/>
                 <a:cs typeface="Ramabhadra" panose="02000600000000000000" pitchFamily="2" charset="0"/>
               </a:rPr>
-              <a:t>లాలించును నన్ను పాలించును (2) </a:t>
+              <a:t>నే నమ్మినవారే నను మరచినను</a:t>
             </a:r>
           </a:p>
           <a:p>
@@ -3816,7 +3848,135 @@
               <a:tabLst/>
               <a:defRPr/>
             </a:pPr>
-            <a:endParaRPr kumimoji="0" lang="te-IN" sz="2000" i="0" u="none" strike="noStrike" kern="1200" cap="none" spc="0" normalizeH="0" baseline="0" noProof="0" dirty="0">
+            <a:r>
+              <a:rPr kumimoji="0" lang="te-IN" sz="1600" i="0" u="none" strike="noStrike" kern="1200" cap="none" spc="0" normalizeH="0" baseline="0" noProof="0" dirty="0">
+                <a:ln>
+                  <a:noFill/>
+                </a:ln>
+                <a:solidFill>
+                  <a:schemeClr val="tx1"/>
+                </a:solidFill>
+                <a:effectLst/>
+                <a:uLnTx/>
+                <a:uFillTx/>
+                <a:latin typeface="Ramabhadra" panose="02000600000000000000" pitchFamily="2" charset="0"/>
+                <a:cs typeface="Ramabhadra" panose="02000600000000000000" pitchFamily="2" charset="0"/>
+              </a:rPr>
+              <a:t>మరువని దేవుడవు(2)</a:t>
+            </a:r>
+          </a:p>
+          <a:p>
+            <a:pPr marL="0" marR="0" lvl="0" indent="0" algn="ctr" defTabSz="439781" rtl="0" eaLnBrk="1" fontAlgn="auto" latinLnBrk="0" hangingPunct="1">
+              <a:spcBef>
+                <a:spcPts val="0"/>
+              </a:spcBef>
+              <a:spcAft>
+                <a:spcPts val="0"/>
+              </a:spcAft>
+              <a:buClrTx/>
+              <a:buSzTx/>
+              <a:buFontTx/>
+              <a:buNone/>
+              <a:tabLst/>
+              <a:defRPr/>
+            </a:pPr>
+            <a:r>
+              <a:rPr kumimoji="0" lang="te-IN" sz="1600" i="0" u="none" strike="noStrike" kern="1200" cap="none" spc="0" normalizeH="0" baseline="0" noProof="0" dirty="0">
+                <a:ln>
+                  <a:noFill/>
+                </a:ln>
+                <a:solidFill>
+                  <a:schemeClr val="tx1"/>
+                </a:solidFill>
+                <a:effectLst/>
+                <a:uLnTx/>
+                <a:uFillTx/>
+                <a:latin typeface="Ramabhadra" panose="02000600000000000000" pitchFamily="2" charset="0"/>
+                <a:cs typeface="Ramabhadra" panose="02000600000000000000" pitchFamily="2" charset="0"/>
+              </a:rPr>
+              <a:t>నీ ఆశలే నాలో చిగురించెను</a:t>
+            </a:r>
+          </a:p>
+          <a:p>
+            <a:pPr marL="0" marR="0" lvl="0" indent="0" algn="ctr" defTabSz="439781" rtl="0" eaLnBrk="1" fontAlgn="auto" latinLnBrk="0" hangingPunct="1">
+              <a:spcBef>
+                <a:spcPts val="0"/>
+              </a:spcBef>
+              <a:spcAft>
+                <a:spcPts val="0"/>
+              </a:spcAft>
+              <a:buClrTx/>
+              <a:buSzTx/>
+              <a:buFontTx/>
+              <a:buNone/>
+              <a:tabLst/>
+              <a:defRPr/>
+            </a:pPr>
+            <a:r>
+              <a:rPr kumimoji="0" lang="te-IN" sz="1600" i="0" u="none" strike="noStrike" kern="1200" cap="none" spc="0" normalizeH="0" baseline="0" noProof="0" dirty="0">
+                <a:ln>
+                  <a:noFill/>
+                </a:ln>
+                <a:solidFill>
+                  <a:schemeClr val="tx1"/>
+                </a:solidFill>
+                <a:effectLst/>
+                <a:uLnTx/>
+                <a:uFillTx/>
+                <a:latin typeface="Ramabhadra" panose="02000600000000000000" pitchFamily="2" charset="0"/>
+                <a:cs typeface="Ramabhadra" panose="02000600000000000000" pitchFamily="2" charset="0"/>
+              </a:rPr>
+              <a:t>నీ వాక్యమే నన్ను బ్రతికించెను(2)</a:t>
+            </a:r>
+          </a:p>
+          <a:p>
+            <a:pPr marL="0" marR="0" lvl="0" indent="0" algn="ctr" defTabSz="439781" rtl="0" eaLnBrk="1" fontAlgn="auto" latinLnBrk="0" hangingPunct="1">
+              <a:spcBef>
+                <a:spcPts val="0"/>
+              </a:spcBef>
+              <a:spcAft>
+                <a:spcPts val="0"/>
+              </a:spcAft>
+              <a:buClrTx/>
+              <a:buSzTx/>
+              <a:buFontTx/>
+              <a:buNone/>
+              <a:tabLst/>
+              <a:defRPr/>
+            </a:pPr>
+            <a:r>
+              <a:rPr kumimoji="0" lang="te-IN" sz="1600" i="0" u="none" strike="noStrike" kern="1200" cap="none" spc="0" normalizeH="0" baseline="0" noProof="0" dirty="0">
+                <a:ln>
+                  <a:noFill/>
+                </a:ln>
+                <a:solidFill>
+                  <a:schemeClr val="tx1"/>
+                </a:solidFill>
+                <a:effectLst/>
+                <a:uLnTx/>
+                <a:uFillTx/>
+                <a:latin typeface="Ramabhadra" panose="02000600000000000000" pitchFamily="2" charset="0"/>
+                <a:cs typeface="Ramabhadra" panose="02000600000000000000" pitchFamily="2" charset="0"/>
+              </a:rPr>
+              <a:t>నీ అనుబంధము నాకు ఆనందమే(2)</a:t>
+            </a:r>
+          </a:p>
+          <a:p>
+            <a:pPr marL="0" marR="0" lvl="0" indent="0" algn="ctr" defTabSz="439781" rtl="0" eaLnBrk="1" fontAlgn="auto" latinLnBrk="0" hangingPunct="1">
+              <a:spcBef>
+                <a:spcPts val="0"/>
+              </a:spcBef>
+              <a:spcAft>
+                <a:spcPts val="0"/>
+              </a:spcAft>
+              <a:buClrTx/>
+              <a:buSzTx/>
+              <a:buFontTx/>
+              <a:buNone/>
+              <a:tabLst/>
+              <a:defRPr/>
+            </a:pPr>
+            <a:endParaRPr kumimoji="0" lang="te-IN" sz="1600" i="0" u="none" strike="noStrike" kern="1200" cap="none" spc="0" normalizeH="0" baseline="0" noProof="0" dirty="0">
               <a:ln>
                 <a:noFill/>
               </a:ln>
@@ -3846,7 +4006,7 @@
               <a:defRPr/>
             </a:pPr>
             <a:r>
-              <a:rPr kumimoji="0" lang="te-IN" sz="2000" i="0" u="none" strike="noStrike" kern="1200" cap="none" spc="0" normalizeH="0" baseline="0" noProof="0" dirty="0">
+              <a:rPr kumimoji="0" lang="te-IN" sz="1600" i="0" u="none" strike="noStrike" kern="1200" cap="none" spc="0" normalizeH="0" baseline="0" noProof="0" dirty="0">
                 <a:ln>
                   <a:noFill/>
                 </a:ln>
@@ -3859,7 +4019,7 @@
                 <a:latin typeface="Ramabhadra" panose="02000600000000000000" pitchFamily="2" charset="0"/>
                 <a:cs typeface="Ramabhadra" panose="02000600000000000000" pitchFamily="2" charset="0"/>
               </a:rPr>
-              <a:t>వేదన శ్రమలూ ఉన్నప్పుడల్లా (2)</a:t>
+              <a:t>నా ప్రతి అణువును పరిశుద్ధపరిచెను</a:t>
             </a:r>
           </a:p>
           <a:p>
@@ -3878,7 +4038,7 @@
               <a:defRPr/>
             </a:pPr>
             <a:r>
-              <a:rPr kumimoji="0" lang="te-IN" sz="2000" i="0" u="none" strike="noStrike" kern="1200" cap="none" spc="0" normalizeH="0" baseline="0" noProof="0" dirty="0">
+              <a:rPr kumimoji="0" lang="te-IN" sz="1600" i="0" u="none" strike="noStrike" kern="1200" cap="none" spc="0" normalizeH="0" baseline="0" noProof="0" dirty="0">
                 <a:ln>
                   <a:noFill/>
                 </a:ln>
@@ -3891,7 +4051,7 @@
                 <a:latin typeface="Ramabhadra" panose="02000600000000000000" pitchFamily="2" charset="0"/>
                 <a:cs typeface="Ramabhadra" panose="02000600000000000000" pitchFamily="2" charset="0"/>
               </a:rPr>
-              <a:t>వేడుకొందునే కాపాడును (2) </a:t>
+              <a:t>నీ రుధిర ధారలే</a:t>
             </a:r>
           </a:p>
           <a:p>
@@ -3909,19 +4069,22 @@
               <a:tabLst/>
               <a:defRPr/>
             </a:pPr>
-            <a:endParaRPr kumimoji="0" lang="te-IN" sz="2000" i="0" u="none" strike="noStrike" kern="1200" cap="none" spc="0" normalizeH="0" baseline="0" noProof="0" dirty="0">
-              <a:ln>
-                <a:noFill/>
-              </a:ln>
-              <a:solidFill>
-                <a:schemeClr val="tx1"/>
-              </a:solidFill>
-              <a:effectLst/>
-              <a:uLnTx/>
-              <a:uFillTx/>
-              <a:latin typeface="Ramabhadra" panose="02000600000000000000" pitchFamily="2" charset="0"/>
-              <a:cs typeface="Ramabhadra" panose="02000600000000000000" pitchFamily="2" charset="0"/>
-            </a:endParaRPr>
+            <a:r>
+              <a:rPr kumimoji="0" lang="te-IN" sz="1600" i="0" u="none" strike="noStrike" kern="1200" cap="none" spc="0" normalizeH="0" baseline="0" noProof="0" dirty="0">
+                <a:ln>
+                  <a:noFill/>
+                </a:ln>
+                <a:solidFill>
+                  <a:schemeClr val="tx1"/>
+                </a:solidFill>
+                <a:effectLst/>
+                <a:uLnTx/>
+                <a:uFillTx/>
+                <a:latin typeface="Ramabhadra" panose="02000600000000000000" pitchFamily="2" charset="0"/>
+                <a:cs typeface="Ramabhadra" panose="02000600000000000000" pitchFamily="2" charset="0"/>
+              </a:rPr>
+              <a:t>నీ దర్శనమే నను నిలిపినది ధరణిలో నీ కొరకే(2)</a:t>
+            </a:r>
           </a:p>
           <a:p>
             <a:pPr marL="0" marR="0" lvl="0" indent="0" algn="ctr" defTabSz="439781" rtl="0" eaLnBrk="1" fontAlgn="auto" latinLnBrk="0" hangingPunct="1">
@@ -3939,7 +4102,7 @@
               <a:defRPr/>
             </a:pPr>
             <a:r>
-              <a:rPr kumimoji="0" lang="te-IN" sz="2000" i="0" u="none" strike="noStrike" kern="1200" cap="none" spc="0" normalizeH="0" baseline="0" noProof="0" dirty="0">
+              <a:rPr kumimoji="0" lang="te-IN" sz="1600" i="0" u="none" strike="noStrike" kern="1200" cap="none" spc="0" normalizeH="0" baseline="0" noProof="0" dirty="0">
                 <a:ln>
                   <a:noFill/>
                 </a:ln>
@@ -3952,7 +4115,7 @@
                 <a:latin typeface="Ramabhadra" panose="02000600000000000000" pitchFamily="2" charset="0"/>
                 <a:cs typeface="Ramabhadra" panose="02000600000000000000" pitchFamily="2" charset="0"/>
               </a:rPr>
-              <a:t>రక్తముతో కడిగి వేసాడే (2)</a:t>
+              <a:t>నీ చేతులే నను నిర్మించెను</a:t>
             </a:r>
           </a:p>
           <a:p>
@@ -3971,7 +4134,7 @@
               <a:defRPr/>
             </a:pPr>
             <a:r>
-              <a:rPr kumimoji="0" lang="te-IN" sz="2000" i="0" u="none" strike="noStrike" kern="1200" cap="none" spc="0" normalizeH="0" baseline="0" noProof="0" dirty="0">
+              <a:rPr kumimoji="0" lang="te-IN" sz="1600" i="0" u="none" strike="noStrike" kern="1200" cap="none" spc="0" normalizeH="0" baseline="0" noProof="0" dirty="0">
                 <a:ln>
                   <a:noFill/>
                 </a:ln>
@@ -3984,7 +4147,39 @@
                 <a:latin typeface="Ramabhadra" panose="02000600000000000000" pitchFamily="2" charset="0"/>
                 <a:cs typeface="Ramabhadra" panose="02000600000000000000" pitchFamily="2" charset="0"/>
               </a:rPr>
-              <a:t>రక్షణ సంతోషం నాకు ఇచ్చాడే (2) </a:t>
+              <a:t>నీ రూపమే నాలో కలిగెను(2)</a:t>
+            </a:r>
+          </a:p>
+          <a:p>
+            <a:pPr marL="0" marR="0" lvl="0" indent="0" algn="ctr" defTabSz="439781" rtl="0" eaLnBrk="1" fontAlgn="auto" latinLnBrk="0" hangingPunct="1">
+              <a:spcBef>
+                <a:spcPts val="0"/>
+              </a:spcBef>
+              <a:spcAft>
+                <a:spcPts val="0"/>
+              </a:spcAft>
+              <a:buClrTx/>
+              <a:buSzTx/>
+              <a:buFontTx/>
+              <a:buNone/>
+              <a:tabLst/>
+              <a:defRPr/>
+            </a:pPr>
+            <a:r>
+              <a:rPr kumimoji="0" lang="te-IN" sz="1600" i="0" u="none" strike="noStrike" kern="1200" cap="none" spc="0" normalizeH="0" baseline="0" noProof="0" dirty="0">
+                <a:ln>
+                  <a:noFill/>
+                </a:ln>
+                <a:solidFill>
+                  <a:schemeClr val="tx1"/>
+                </a:solidFill>
+                <a:effectLst/>
+                <a:uLnTx/>
+                <a:uFillTx/>
+                <a:latin typeface="Ramabhadra" panose="02000600000000000000" pitchFamily="2" charset="0"/>
+                <a:cs typeface="Ramabhadra" panose="02000600000000000000" pitchFamily="2" charset="0"/>
+              </a:rPr>
+              <a:t>నీ అభిషేకము పరమానందమే(2)</a:t>
             </a:r>
           </a:p>
         </p:txBody>
@@ -4049,7 +4244,7 @@
               </a:spcAft>
             </a:pPr>
             <a:r>
-              <a:rPr lang="te-IN" b="0" i="0" dirty="0">
+              <a:rPr lang="te-IN" sz="1600" b="0" i="0" dirty="0">
                 <a:solidFill>
                   <a:schemeClr val="tx1"/>
                 </a:solidFill>
@@ -4057,7 +4252,91 @@
                 <a:latin typeface="Ramabhadra" panose="02000600000000000000" pitchFamily="2" charset="0"/>
                 <a:cs typeface="Ramabhadra" panose="02000600000000000000" pitchFamily="2" charset="0"/>
               </a:rPr>
-              <a:t>స్తుతి సింహాసనాసీనుడా</a:t>
+              <a:t>కృప కృప నీ కృప</a:t>
+            </a:r>
+            <a:br>
+              <a:rPr lang="te-IN" sz="1600" b="0" i="0" dirty="0">
+                <a:solidFill>
+                  <a:schemeClr val="tx1"/>
+                </a:solidFill>
+                <a:effectLst/>
+                <a:latin typeface="Ramabhadra" panose="02000600000000000000" pitchFamily="2" charset="0"/>
+                <a:cs typeface="Ramabhadra" panose="02000600000000000000" pitchFamily="2" charset="0"/>
+              </a:rPr>
+            </a:br>
+            <a:r>
+              <a:rPr lang="te-IN" sz="1600" b="0" i="0" dirty="0">
+                <a:solidFill>
+                  <a:schemeClr val="tx1"/>
+                </a:solidFill>
+                <a:effectLst/>
+                <a:latin typeface="Ramabhadra" panose="02000600000000000000" pitchFamily="2" charset="0"/>
+                <a:cs typeface="Ramabhadra" panose="02000600000000000000" pitchFamily="2" charset="0"/>
+              </a:rPr>
+              <a:t>కృప కృప క్రీస్తు కృప (2)</a:t>
+            </a:r>
+            <a:br>
+              <a:rPr lang="te-IN" sz="1600" b="0" i="0" dirty="0">
+                <a:solidFill>
+                  <a:schemeClr val="tx1"/>
+                </a:solidFill>
+                <a:effectLst/>
+                <a:latin typeface="Ramabhadra" panose="02000600000000000000" pitchFamily="2" charset="0"/>
+                <a:cs typeface="Ramabhadra" panose="02000600000000000000" pitchFamily="2" charset="0"/>
+              </a:rPr>
+            </a:br>
+            <a:r>
+              <a:rPr lang="te-IN" sz="1600" b="0" i="0" dirty="0">
+                <a:solidFill>
+                  <a:schemeClr val="tx1"/>
+                </a:solidFill>
+                <a:effectLst/>
+                <a:latin typeface="Ramabhadra" panose="02000600000000000000" pitchFamily="2" charset="0"/>
+                <a:cs typeface="Ramabhadra" panose="02000600000000000000" pitchFamily="2" charset="0"/>
+              </a:rPr>
+              <a:t>నేనైతే నీ కృపయందు</a:t>
+            </a:r>
+            <a:br>
+              <a:rPr lang="te-IN" sz="1600" b="0" i="0" dirty="0">
+                <a:solidFill>
+                  <a:schemeClr val="tx1"/>
+                </a:solidFill>
+                <a:effectLst/>
+                <a:latin typeface="Ramabhadra" panose="02000600000000000000" pitchFamily="2" charset="0"/>
+                <a:cs typeface="Ramabhadra" panose="02000600000000000000" pitchFamily="2" charset="0"/>
+              </a:rPr>
+            </a:br>
+            <a:r>
+              <a:rPr lang="te-IN" sz="1600" b="0" i="0" dirty="0">
+                <a:solidFill>
+                  <a:schemeClr val="tx1"/>
+                </a:solidFill>
+                <a:effectLst/>
+                <a:latin typeface="Ramabhadra" panose="02000600000000000000" pitchFamily="2" charset="0"/>
+                <a:cs typeface="Ramabhadra" panose="02000600000000000000" pitchFamily="2" charset="0"/>
+              </a:rPr>
+              <a:t>నమ్మికయుంచి యున్నాను</a:t>
+            </a:r>
+            <a:br>
+              <a:rPr lang="te-IN" sz="1600" b="0" i="0" dirty="0">
+                <a:solidFill>
+                  <a:schemeClr val="tx1"/>
+                </a:solidFill>
+                <a:effectLst/>
+                <a:latin typeface="Ramabhadra" panose="02000600000000000000" pitchFamily="2" charset="0"/>
+                <a:cs typeface="Ramabhadra" panose="02000600000000000000" pitchFamily="2" charset="0"/>
+              </a:rPr>
+            </a:br>
+            <a:r>
+              <a:rPr lang="te-IN" sz="1600" b="0" i="0" dirty="0">
+                <a:solidFill>
+                  <a:schemeClr val="tx1"/>
+                </a:solidFill>
+                <a:effectLst/>
+                <a:latin typeface="Ramabhadra" panose="02000600000000000000" pitchFamily="2" charset="0"/>
+                <a:cs typeface="Ramabhadra" panose="02000600000000000000" pitchFamily="2" charset="0"/>
+              </a:rPr>
+              <a:t>నా నమ్మికయుంచి యున్నాను (2)      </a:t>
             </a:r>
           </a:p>
           <a:p>
@@ -4070,7 +4349,7 @@
               </a:spcAft>
             </a:pPr>
             <a:r>
-              <a:rPr lang="te-IN" b="0" i="0" dirty="0">
+              <a:rPr lang="te-IN" sz="1600" b="0" i="0" dirty="0">
                 <a:solidFill>
                   <a:schemeClr val="tx1"/>
                 </a:solidFill>
@@ -4078,7 +4357,7 @@
                 <a:latin typeface="Ramabhadra" panose="02000600000000000000" pitchFamily="2" charset="0"/>
                 <a:cs typeface="Ramabhadra" panose="02000600000000000000" pitchFamily="2" charset="0"/>
               </a:rPr>
-              <a:t>యేసు రాజా దివ్య తేజా (2)</a:t>
+              <a:t> </a:t>
             </a:r>
           </a:p>
           <a:p>
@@ -4090,14 +4369,17 @@
                 <a:spcPts val="0"/>
               </a:spcAft>
             </a:pPr>
-            <a:endParaRPr lang="te-IN" b="0" i="0" dirty="0">
-              <a:solidFill>
-                <a:schemeClr val="tx1"/>
-              </a:solidFill>
-              <a:effectLst/>
-              <a:latin typeface="Ramabhadra" panose="02000600000000000000" pitchFamily="2" charset="0"/>
-              <a:cs typeface="Ramabhadra" panose="02000600000000000000" pitchFamily="2" charset="0"/>
-            </a:endParaRPr>
+            <a:r>
+              <a:rPr lang="te-IN" sz="1600" b="0" i="0" dirty="0">
+                <a:solidFill>
+                  <a:schemeClr val="tx1"/>
+                </a:solidFill>
+                <a:effectLst/>
+                <a:latin typeface="Ramabhadra" panose="02000600000000000000" pitchFamily="2" charset="0"/>
+                <a:cs typeface="Ramabhadra" panose="02000600000000000000" pitchFamily="2" charset="0"/>
+              </a:rPr>
+              <a:t>కృపను గూర్చి న్యాయము గూర్చి</a:t>
+            </a:r>
           </a:p>
           <a:p>
             <a:pPr marL="0" marR="0" indent="0" algn="ctr" rtl="0" eaLnBrk="1" fontAlgn="auto" latinLnBrk="0" hangingPunct="1">
@@ -4109,7 +4391,7 @@
               </a:spcAft>
             </a:pPr>
             <a:r>
-              <a:rPr lang="te-IN" b="0" i="0" dirty="0">
+              <a:rPr lang="te-IN" sz="1600" b="0" i="0" dirty="0">
                 <a:solidFill>
                   <a:schemeClr val="tx1"/>
                 </a:solidFill>
@@ -4117,7 +4399,28 @@
                 <a:latin typeface="Ramabhadra" panose="02000600000000000000" pitchFamily="2" charset="0"/>
                 <a:cs typeface="Ramabhadra" panose="02000600000000000000" pitchFamily="2" charset="0"/>
               </a:rPr>
-              <a:t>అద్వితీయుడవు పరిశుద్ధుడవు</a:t>
+              <a:t> నేను పాడెదను</a:t>
+            </a:r>
+            <a:br>
+              <a:rPr lang="te-IN" sz="1600" b="0" i="0" dirty="0">
+                <a:solidFill>
+                  <a:schemeClr val="tx1"/>
+                </a:solidFill>
+                <a:effectLst/>
+                <a:latin typeface="Ramabhadra" panose="02000600000000000000" pitchFamily="2" charset="0"/>
+                <a:cs typeface="Ramabhadra" panose="02000600000000000000" pitchFamily="2" charset="0"/>
+              </a:rPr>
+            </a:br>
+            <a:r>
+              <a:rPr lang="te-IN" sz="1600" b="0" i="0" dirty="0">
+                <a:solidFill>
+                  <a:schemeClr val="tx1"/>
+                </a:solidFill>
+                <a:effectLst/>
+                <a:latin typeface="Ramabhadra" panose="02000600000000000000" pitchFamily="2" charset="0"/>
+                <a:cs typeface="Ramabhadra" panose="02000600000000000000" pitchFamily="2" charset="0"/>
+              </a:rPr>
+              <a:t>నీ సన్నిధిలో నిర్దోషముతో </a:t>
             </a:r>
           </a:p>
           <a:p>
@@ -4130,7 +4433,7 @@
               </a:spcAft>
             </a:pPr>
             <a:r>
-              <a:rPr lang="te-IN" b="0" i="0" dirty="0">
+              <a:rPr lang="te-IN" sz="1600" b="0" i="0" dirty="0">
                 <a:solidFill>
                   <a:schemeClr val="tx1"/>
                 </a:solidFill>
@@ -4138,7 +4441,49 @@
                 <a:latin typeface="Ramabhadra" panose="02000600000000000000" pitchFamily="2" charset="0"/>
                 <a:cs typeface="Ramabhadra" panose="02000600000000000000" pitchFamily="2" charset="0"/>
               </a:rPr>
-              <a:t>అతి సుందరుడవు నీవే ప్రభూ (2)</a:t>
+              <a:t>నేను నడచెదను (2)</a:t>
+            </a:r>
+            <a:br>
+              <a:rPr lang="te-IN" sz="1600" b="0" i="0" dirty="0">
+                <a:solidFill>
+                  <a:schemeClr val="tx1"/>
+                </a:solidFill>
+                <a:effectLst/>
+                <a:latin typeface="Ramabhadra" panose="02000600000000000000" pitchFamily="2" charset="0"/>
+                <a:cs typeface="Ramabhadra" panose="02000600000000000000" pitchFamily="2" charset="0"/>
+              </a:rPr>
+            </a:br>
+            <a:r>
+              <a:rPr lang="te-IN" sz="1600" b="0" i="0" dirty="0">
+                <a:solidFill>
+                  <a:schemeClr val="tx1"/>
+                </a:solidFill>
+                <a:effectLst/>
+                <a:latin typeface="Ramabhadra" panose="02000600000000000000" pitchFamily="2" charset="0"/>
+                <a:cs typeface="Ramabhadra" panose="02000600000000000000" pitchFamily="2" charset="0"/>
+              </a:rPr>
+              <a:t>నీ కృపయే నాకు ఆధారం</a:t>
+            </a:r>
+            <a:br>
+              <a:rPr lang="te-IN" sz="1600" b="0" i="0" dirty="0">
+                <a:solidFill>
+                  <a:schemeClr val="tx1"/>
+                </a:solidFill>
+                <a:effectLst/>
+                <a:latin typeface="Ramabhadra" panose="02000600000000000000" pitchFamily="2" charset="0"/>
+                <a:cs typeface="Ramabhadra" panose="02000600000000000000" pitchFamily="2" charset="0"/>
+              </a:rPr>
+            </a:br>
+            <a:r>
+              <a:rPr lang="te-IN" sz="1600" b="0" i="0" dirty="0">
+                <a:solidFill>
+                  <a:schemeClr val="tx1"/>
+                </a:solidFill>
+                <a:effectLst/>
+                <a:latin typeface="Ramabhadra" panose="02000600000000000000" pitchFamily="2" charset="0"/>
+                <a:cs typeface="Ramabhadra" panose="02000600000000000000" pitchFamily="2" charset="0"/>
+              </a:rPr>
+              <a:t>      ఆ కృపయే నాకు ఆదరణ (2)       </a:t>
             </a:r>
           </a:p>
           <a:p>
@@ -4151,7 +4496,7 @@
               </a:spcAft>
             </a:pPr>
             <a:r>
-              <a:rPr lang="te-IN" b="0" i="0" dirty="0">
+              <a:rPr lang="te-IN" sz="1600" b="0" i="0" dirty="0">
                 <a:solidFill>
                   <a:schemeClr val="tx1"/>
                 </a:solidFill>
@@ -4159,7 +4504,7 @@
                 <a:latin typeface="Ramabhadra" panose="02000600000000000000" pitchFamily="2" charset="0"/>
                 <a:cs typeface="Ramabhadra" panose="02000600000000000000" pitchFamily="2" charset="0"/>
               </a:rPr>
-              <a:t>నీతి న్యాయములు నీ సింహాసనాధారం (2)</a:t>
+              <a:t> </a:t>
             </a:r>
           </a:p>
           <a:p>
@@ -4172,7 +4517,7 @@
               </a:spcAft>
             </a:pPr>
             <a:r>
-              <a:rPr lang="te-IN" b="0" i="0" dirty="0">
+              <a:rPr lang="te-IN" sz="1600" b="0" i="0" dirty="0">
                 <a:solidFill>
                   <a:schemeClr val="tx1"/>
                 </a:solidFill>
@@ -4180,7 +4525,7 @@
                 <a:latin typeface="Ramabhadra" panose="02000600000000000000" pitchFamily="2" charset="0"/>
                 <a:cs typeface="Ramabhadra" panose="02000600000000000000" pitchFamily="2" charset="0"/>
               </a:rPr>
-              <a:t>కృపా సత్యములు నీ సన్నిధానవర్తులు (2)</a:t>
+              <a:t>దీన దశలో నేన్నునప్పుడు </a:t>
             </a:r>
           </a:p>
           <a:p>
@@ -4192,14 +4537,38 @@
                 <a:spcPts val="0"/>
               </a:spcAft>
             </a:pPr>
-            <a:endParaRPr lang="te-IN" b="0" i="0" dirty="0">
-              <a:solidFill>
-                <a:schemeClr val="tx1"/>
-              </a:solidFill>
-              <a:effectLst/>
-              <a:latin typeface="Ramabhadra" panose="02000600000000000000" pitchFamily="2" charset="0"/>
-              <a:cs typeface="Ramabhadra" panose="02000600000000000000" pitchFamily="2" charset="0"/>
-            </a:endParaRPr>
+            <a:r>
+              <a:rPr lang="te-IN" sz="1600" b="0" i="0" dirty="0">
+                <a:solidFill>
+                  <a:schemeClr val="tx1"/>
+                </a:solidFill>
+                <a:effectLst/>
+                <a:latin typeface="Ramabhadra" panose="02000600000000000000" pitchFamily="2" charset="0"/>
+                <a:cs typeface="Ramabhadra" panose="02000600000000000000" pitchFamily="2" charset="0"/>
+              </a:rPr>
+              <a:t>నను మరువనిది నీ కృప</a:t>
+            </a:r>
+            <a:br>
+              <a:rPr lang="te-IN" sz="1600" b="0" i="0" dirty="0">
+                <a:solidFill>
+                  <a:schemeClr val="tx1"/>
+                </a:solidFill>
+                <a:effectLst/>
+                <a:latin typeface="Ramabhadra" panose="02000600000000000000" pitchFamily="2" charset="0"/>
+                <a:cs typeface="Ramabhadra" panose="02000600000000000000" pitchFamily="2" charset="0"/>
+              </a:rPr>
+            </a:br>
+            <a:r>
+              <a:rPr lang="te-IN" sz="1600" b="0" i="0" dirty="0">
+                <a:solidFill>
+                  <a:schemeClr val="tx1"/>
+                </a:solidFill>
+                <a:effectLst/>
+                <a:latin typeface="Ramabhadra" panose="02000600000000000000" pitchFamily="2" charset="0"/>
+                <a:cs typeface="Ramabhadra" panose="02000600000000000000" pitchFamily="2" charset="0"/>
+              </a:rPr>
+              <a:t>నేనీ స్థితిలో ఉన్నానంటే </a:t>
+            </a:r>
           </a:p>
           <a:p>
             <a:pPr marL="0" marR="0" indent="0" algn="ctr" rtl="0" eaLnBrk="1" fontAlgn="auto" latinLnBrk="0" hangingPunct="1">
@@ -4211,7 +4580,7 @@
               </a:spcAft>
             </a:pPr>
             <a:r>
-              <a:rPr lang="te-IN" b="0" i="0" dirty="0">
+              <a:rPr lang="te-IN" sz="1600" b="0" i="0" dirty="0">
                 <a:solidFill>
                   <a:schemeClr val="tx1"/>
                 </a:solidFill>
@@ -4219,20 +4588,10 @@
                 <a:latin typeface="Ramabhadra" panose="02000600000000000000" pitchFamily="2" charset="0"/>
                 <a:cs typeface="Ramabhadra" panose="02000600000000000000" pitchFamily="2" charset="0"/>
               </a:rPr>
-              <a:t>బలియు అర్పణ కోరవు నీవు</a:t>
-            </a:r>
-          </a:p>
-          <a:p>
-            <a:pPr marL="0" marR="0" indent="0" algn="ctr" rtl="0" eaLnBrk="1" fontAlgn="auto" latinLnBrk="0" hangingPunct="1">
-              <a:spcBef>
-                <a:spcPts val="0"/>
-              </a:spcBef>
-              <a:spcAft>
-                <a:spcPts val="0"/>
-              </a:spcAft>
-            </a:pPr>
-            <a:r>
-              <a:rPr lang="te-IN" b="0" i="0" dirty="0">
+              <a:t>కేవలము అది నీ కృప (2)</a:t>
+            </a:r>
+            <a:br>
+              <a:rPr lang="te-IN" sz="1600" b="0" i="0" dirty="0">
                 <a:solidFill>
                   <a:schemeClr val="tx1"/>
                 </a:solidFill>
@@ -4240,20 +4599,9 @@
                 <a:latin typeface="Ramabhadra" panose="02000600000000000000" pitchFamily="2" charset="0"/>
                 <a:cs typeface="Ramabhadra" panose="02000600000000000000" pitchFamily="2" charset="0"/>
               </a:rPr>
-              <a:t>బలియైతివి నా దోషముకై (2)</a:t>
-            </a:r>
-          </a:p>
-          <a:p>
-            <a:pPr marL="0" marR="0" indent="0" algn="ctr" rtl="0" eaLnBrk="1" fontAlgn="auto" latinLnBrk="0" hangingPunct="1">
-              <a:spcBef>
-                <a:spcPts val="0"/>
-              </a:spcBef>
-              <a:spcAft>
-                <a:spcPts val="0"/>
-              </a:spcAft>
-            </a:pPr>
-            <a:r>
-              <a:rPr lang="te-IN" b="0" i="0" dirty="0">
+            </a:br>
+            <a:r>
+              <a:rPr lang="te-IN" sz="1600" b="0" i="0" dirty="0">
                 <a:solidFill>
                   <a:schemeClr val="tx1"/>
                 </a:solidFill>
@@ -4261,20 +4609,10 @@
                 <a:latin typeface="Ramabhadra" panose="02000600000000000000" pitchFamily="2" charset="0"/>
                 <a:cs typeface="Ramabhadra" panose="02000600000000000000" pitchFamily="2" charset="0"/>
               </a:rPr>
-              <a:t>నా హృదయమే నీ ప్రియమగు ఆలయం (2)</a:t>
-            </a:r>
-          </a:p>
-          <a:p>
-            <a:pPr marL="0" marR="0" indent="0" algn="ctr" rtl="0" eaLnBrk="1" fontAlgn="auto" latinLnBrk="0" hangingPunct="1">
-              <a:spcBef>
-                <a:spcPts val="0"/>
-              </a:spcBef>
-              <a:spcAft>
-                <a:spcPts val="0"/>
-              </a:spcAft>
-            </a:pPr>
-            <a:r>
-              <a:rPr lang="te-IN" b="0" i="0" dirty="0">
+              <a:t>నీ కృపయే నాకు ఆధారం</a:t>
+            </a:r>
+            <a:br>
+              <a:rPr lang="te-IN" sz="1600" b="0" i="0" dirty="0">
                 <a:solidFill>
                   <a:schemeClr val="tx1"/>
                 </a:solidFill>
@@ -4282,7 +4620,17 @@
                 <a:latin typeface="Ramabhadra" panose="02000600000000000000" pitchFamily="2" charset="0"/>
                 <a:cs typeface="Ramabhadra" panose="02000600000000000000" pitchFamily="2" charset="0"/>
               </a:rPr>
-              <a:t>స్తుతియాగమునే చేసెద నిరతం (2)</a:t>
+            </a:br>
+            <a:r>
+              <a:rPr lang="te-IN" sz="1600" b="0" i="0" dirty="0">
+                <a:solidFill>
+                  <a:schemeClr val="tx1"/>
+                </a:solidFill>
+                <a:effectLst/>
+                <a:latin typeface="Ramabhadra" panose="02000600000000000000" pitchFamily="2" charset="0"/>
+                <a:cs typeface="Ramabhadra" panose="02000600000000000000" pitchFamily="2" charset="0"/>
+              </a:rPr>
+              <a:t>      ఆ కృపయే నాకు ఆదరణ (2)</a:t>
             </a:r>
           </a:p>
         </p:txBody>
@@ -4348,9 +4696,12 @@
                 <a:latin typeface="Ramabhadra" panose="02000600000000000000" pitchFamily="2" charset="0"/>
                 <a:cs typeface="Ramabhadra" panose="02000600000000000000" pitchFamily="2" charset="0"/>
               </a:rPr>
-              <a:t>జుంటె తేనె ధారల కన్నా</a:t>
-            </a:r>
-            <a:br>
+              <a:t>నీవుంటే నాకు చాలు యేసయ్యా</a:t>
+            </a:r>
+          </a:p>
+          <a:p>
+            <a:pPr algn="ctr"/>
+            <a:r>
               <a:rPr lang="te-IN" sz="1750" b="0" i="0" dirty="0">
                 <a:solidFill>
                   <a:srgbClr val="000000"/>
@@ -4359,7 +4710,11 @@
                 <a:latin typeface="Ramabhadra" panose="02000600000000000000" pitchFamily="2" charset="0"/>
                 <a:cs typeface="Ramabhadra" panose="02000600000000000000" pitchFamily="2" charset="0"/>
               </a:rPr>
-            </a:br>
+              <a:t>నీవెంటే నేను ఉంటానేసయ్యా (2)</a:t>
+            </a:r>
+          </a:p>
+          <a:p>
+            <a:pPr algn="ctr"/>
             <a:r>
               <a:rPr lang="te-IN" sz="1750" b="0" i="0" dirty="0">
                 <a:solidFill>
@@ -4369,9 +4724,12 @@
                 <a:latin typeface="Ramabhadra" panose="02000600000000000000" pitchFamily="2" charset="0"/>
                 <a:cs typeface="Ramabhadra" panose="02000600000000000000" pitchFamily="2" charset="0"/>
               </a:rPr>
-              <a:t>యేసు నామమే మధురం</a:t>
-            </a:r>
-            <a:br>
+              <a:t>నీ మాట చాలయ్యా నీ చూపు చాలయ్యా</a:t>
+            </a:r>
+          </a:p>
+          <a:p>
+            <a:pPr algn="ctr"/>
+            <a:r>
               <a:rPr lang="te-IN" sz="1750" b="0" i="0" dirty="0">
                 <a:solidFill>
                   <a:srgbClr val="000000"/>
@@ -4380,59 +4738,7 @@
                 <a:latin typeface="Ramabhadra" panose="02000600000000000000" pitchFamily="2" charset="0"/>
                 <a:cs typeface="Ramabhadra" panose="02000600000000000000" pitchFamily="2" charset="0"/>
               </a:rPr>
-            </a:br>
-            <a:r>
-              <a:rPr lang="te-IN" sz="1750" b="0" i="0" dirty="0">
-                <a:solidFill>
-                  <a:srgbClr val="000000"/>
-                </a:solidFill>
-                <a:effectLst/>
-                <a:latin typeface="Ramabhadra" panose="02000600000000000000" pitchFamily="2" charset="0"/>
-                <a:cs typeface="Ramabhadra" panose="02000600000000000000" pitchFamily="2" charset="0"/>
-              </a:rPr>
-              <a:t>యేసయ్య సన్నిధినే మరువజాలను (2)</a:t>
-            </a:r>
-            <a:br>
-              <a:rPr lang="te-IN" sz="1750" b="0" i="0" dirty="0">
-                <a:solidFill>
-                  <a:srgbClr val="000000"/>
-                </a:solidFill>
-                <a:effectLst/>
-                <a:latin typeface="Ramabhadra" panose="02000600000000000000" pitchFamily="2" charset="0"/>
-                <a:cs typeface="Ramabhadra" panose="02000600000000000000" pitchFamily="2" charset="0"/>
-              </a:rPr>
-            </a:br>
-            <a:r>
-              <a:rPr lang="te-IN" sz="1750" b="0" i="0" dirty="0">
-                <a:solidFill>
-                  <a:srgbClr val="000000"/>
-                </a:solidFill>
-                <a:effectLst/>
-                <a:latin typeface="Ramabhadra" panose="02000600000000000000" pitchFamily="2" charset="0"/>
-                <a:cs typeface="Ramabhadra" panose="02000600000000000000" pitchFamily="2" charset="0"/>
-              </a:rPr>
-              <a:t>జీవితకాలమంతా ఆనందించెదా</a:t>
-            </a:r>
-            <a:br>
-              <a:rPr lang="te-IN" sz="1750" b="0" i="0" dirty="0">
-                <a:solidFill>
-                  <a:srgbClr val="000000"/>
-                </a:solidFill>
-                <a:effectLst/>
-                <a:latin typeface="Ramabhadra" panose="02000600000000000000" pitchFamily="2" charset="0"/>
-                <a:cs typeface="Ramabhadra" panose="02000600000000000000" pitchFamily="2" charset="0"/>
-              </a:rPr>
-            </a:br>
-            <a:r>
-              <a:rPr lang="te-IN" sz="1750" b="0" i="0" dirty="0">
-                <a:solidFill>
-                  <a:srgbClr val="000000"/>
-                </a:solidFill>
-                <a:effectLst/>
-                <a:latin typeface="Ramabhadra" panose="02000600000000000000" pitchFamily="2" charset="0"/>
-                <a:cs typeface="Ramabhadra" panose="02000600000000000000" pitchFamily="2" charset="0"/>
-              </a:rPr>
-              <a:t>యేసయ్యనే ఆరాధించెదా (2)  </a:t>
+              <a:t>నీ తోడు చాలయ్యా నీ నీడ చాలయ్యా (2)</a:t>
             </a:r>
           </a:p>
           <a:p>
@@ -4457,9 +4763,12 @@
                 <a:latin typeface="Ramabhadra" panose="02000600000000000000" pitchFamily="2" charset="0"/>
                 <a:cs typeface="Ramabhadra" panose="02000600000000000000" pitchFamily="2" charset="0"/>
               </a:rPr>
-              <a:t>యేసయ్య నామమే బహు పూజనీయము</a:t>
-            </a:r>
-            <a:br>
+              <a:t>ఎన్ని బాధలున్ననూ ఇబ్బందులైననూ</a:t>
+            </a:r>
+          </a:p>
+          <a:p>
+            <a:pPr algn="ctr"/>
+            <a:r>
               <a:rPr lang="te-IN" sz="1750" b="0" i="0" dirty="0">
                 <a:solidFill>
                   <a:srgbClr val="000000"/>
@@ -4468,7 +4777,22 @@
                 <a:latin typeface="Ramabhadra" panose="02000600000000000000" pitchFamily="2" charset="0"/>
                 <a:cs typeface="Ramabhadra" panose="02000600000000000000" pitchFamily="2" charset="0"/>
               </a:rPr>
-            </a:br>
+              <a:t>ఎంత కష్టమొచ్చినా నిష్టూరమైననూ (2)</a:t>
+            </a:r>
+          </a:p>
+          <a:p>
+            <a:pPr algn="ctr"/>
+            <a:endParaRPr lang="te-IN" sz="1750" b="0" i="0" dirty="0">
+              <a:solidFill>
+                <a:srgbClr val="000000"/>
+              </a:solidFill>
+              <a:effectLst/>
+              <a:latin typeface="Ramabhadra" panose="02000600000000000000" pitchFamily="2" charset="0"/>
+              <a:cs typeface="Ramabhadra" panose="02000600000000000000" pitchFamily="2" charset="0"/>
+            </a:endParaRPr>
+          </a:p>
+          <a:p>
+            <a:pPr algn="ctr"/>
             <a:r>
               <a:rPr lang="te-IN" sz="1750" b="0" i="0" dirty="0">
                 <a:solidFill>
@@ -4478,9 +4802,12 @@
                 <a:latin typeface="Ramabhadra" panose="02000600000000000000" pitchFamily="2" charset="0"/>
                 <a:cs typeface="Ramabhadra" panose="02000600000000000000" pitchFamily="2" charset="0"/>
               </a:rPr>
-              <a:t>నాపై దృష్టి నిలిపి సంత్రుష్టిగా నను ఉంచి (2)</a:t>
-            </a:r>
-            <a:br>
+              <a:t>బ్రతుకు నావ పగిలినా కడలి పాలైననూ</a:t>
+            </a:r>
+          </a:p>
+          <a:p>
+            <a:pPr algn="ctr"/>
+            <a:r>
               <a:rPr lang="te-IN" sz="1750" b="0" i="0" dirty="0">
                 <a:solidFill>
                   <a:srgbClr val="000000"/>
@@ -4489,7 +4816,21 @@
                 <a:latin typeface="Ramabhadra" panose="02000600000000000000" pitchFamily="2" charset="0"/>
                 <a:cs typeface="Ramabhadra" panose="02000600000000000000" pitchFamily="2" charset="0"/>
               </a:rPr>
-            </a:br>
+              <a:t>అలలు ముంచి వేసినా ఆశలు అనగారినా (2) </a:t>
+            </a:r>
+          </a:p>
+          <a:p>
+            <a:pPr algn="ctr"/>
+            <a:endParaRPr lang="te-IN" sz="1750" dirty="0">
+              <a:solidFill>
+                <a:srgbClr val="000000"/>
+              </a:solidFill>
+              <a:latin typeface="Ramabhadra" panose="02000600000000000000" pitchFamily="2" charset="0"/>
+              <a:cs typeface="Ramabhadra" panose="02000600000000000000" pitchFamily="2" charset="0"/>
+            </a:endParaRPr>
+          </a:p>
+          <a:p>
+            <a:pPr algn="ctr"/>
             <a:r>
               <a:rPr lang="te-IN" sz="1750" b="0" i="0" dirty="0">
                 <a:solidFill>
@@ -4499,9 +4840,12 @@
                 <a:latin typeface="Ramabhadra" panose="02000600000000000000" pitchFamily="2" charset="0"/>
                 <a:cs typeface="Ramabhadra" panose="02000600000000000000" pitchFamily="2" charset="0"/>
               </a:rPr>
-              <a:t>నన్నెంతగానో దీవించి</a:t>
-            </a:r>
-            <a:br>
+              <a:t>ఆస్తులన్నీ పోయినా అనాథగా మిగిలినా</a:t>
+            </a:r>
+          </a:p>
+          <a:p>
+            <a:pPr algn="ctr"/>
+            <a:r>
               <a:rPr lang="te-IN" sz="1750" b="0" i="0" dirty="0">
                 <a:solidFill>
                   <a:srgbClr val="000000"/>
@@ -4510,108 +4854,7 @@
                 <a:latin typeface="Ramabhadra" panose="02000600000000000000" pitchFamily="2" charset="0"/>
                 <a:cs typeface="Ramabhadra" panose="02000600000000000000" pitchFamily="2" charset="0"/>
               </a:rPr>
-            </a:br>
-            <a:r>
-              <a:rPr lang="te-IN" sz="1750" b="0" i="0" dirty="0">
-                <a:solidFill>
-                  <a:srgbClr val="000000"/>
-                </a:solidFill>
-                <a:effectLst/>
-                <a:latin typeface="Ramabhadra" panose="02000600000000000000" pitchFamily="2" charset="0"/>
-                <a:cs typeface="Ramabhadra" panose="02000600000000000000" pitchFamily="2" charset="0"/>
-              </a:rPr>
-              <a:t>జీవజలపు ఊటలతో ఉజ్జీవింపజేసెనే (2) </a:t>
-            </a:r>
-          </a:p>
-          <a:p>
-            <a:pPr algn="ctr"/>
-            <a:r>
-              <a:rPr lang="te-IN" sz="1750" b="0" i="0" dirty="0">
-                <a:solidFill>
-                  <a:srgbClr val="000000"/>
-                </a:solidFill>
-                <a:effectLst/>
-                <a:latin typeface="Ramabhadra" panose="02000600000000000000" pitchFamily="2" charset="0"/>
-                <a:cs typeface="Ramabhadra" panose="02000600000000000000" pitchFamily="2" charset="0"/>
-              </a:rPr>
-              <a:t> </a:t>
-            </a:r>
-          </a:p>
-          <a:p>
-            <a:pPr algn="ctr"/>
-            <a:r>
-              <a:rPr lang="te-IN" sz="1750" b="0" i="0" dirty="0">
-                <a:solidFill>
-                  <a:srgbClr val="000000"/>
-                </a:solidFill>
-                <a:effectLst/>
-                <a:latin typeface="Ramabhadra" panose="02000600000000000000" pitchFamily="2" charset="0"/>
-                <a:cs typeface="Ramabhadra" panose="02000600000000000000" pitchFamily="2" charset="0"/>
-              </a:rPr>
-              <a:t>యేసయ్య నామమే బలమైన దుర్గము</a:t>
-            </a:r>
-            <a:br>
-              <a:rPr lang="te-IN" sz="1750" b="0" i="0" dirty="0">
-                <a:solidFill>
-                  <a:srgbClr val="000000"/>
-                </a:solidFill>
-                <a:effectLst/>
-                <a:latin typeface="Ramabhadra" panose="02000600000000000000" pitchFamily="2" charset="0"/>
-                <a:cs typeface="Ramabhadra" panose="02000600000000000000" pitchFamily="2" charset="0"/>
-              </a:rPr>
-            </a:br>
-            <a:r>
-              <a:rPr lang="te-IN" sz="1750" b="0" i="0" dirty="0">
-                <a:solidFill>
-                  <a:srgbClr val="000000"/>
-                </a:solidFill>
-                <a:effectLst/>
-                <a:latin typeface="Ramabhadra" panose="02000600000000000000" pitchFamily="2" charset="0"/>
-                <a:cs typeface="Ramabhadra" panose="02000600000000000000" pitchFamily="2" charset="0"/>
-              </a:rPr>
-              <a:t>నా తోడై నిలిచి క్షేమముగా నను దాచి (2)</a:t>
-            </a:r>
-            <a:br>
-              <a:rPr lang="te-IN" sz="1750" b="0" i="0" dirty="0">
-                <a:solidFill>
-                  <a:srgbClr val="000000"/>
-                </a:solidFill>
-                <a:effectLst/>
-                <a:latin typeface="Ramabhadra" panose="02000600000000000000" pitchFamily="2" charset="0"/>
-                <a:cs typeface="Ramabhadra" panose="02000600000000000000" pitchFamily="2" charset="0"/>
-              </a:rPr>
-            </a:br>
-            <a:r>
-              <a:rPr lang="te-IN" sz="1750" b="0" i="0" dirty="0">
-                <a:solidFill>
-                  <a:srgbClr val="000000"/>
-                </a:solidFill>
-                <a:effectLst/>
-                <a:latin typeface="Ramabhadra" panose="02000600000000000000" pitchFamily="2" charset="0"/>
-                <a:cs typeface="Ramabhadra" panose="02000600000000000000" pitchFamily="2" charset="0"/>
-              </a:rPr>
-              <a:t>నన్నెంతగానో కరుణించి</a:t>
-            </a:r>
-            <a:br>
-              <a:rPr lang="te-IN" sz="1750" b="0" i="0" dirty="0">
-                <a:solidFill>
-                  <a:srgbClr val="000000"/>
-                </a:solidFill>
-                <a:effectLst/>
-                <a:latin typeface="Ramabhadra" panose="02000600000000000000" pitchFamily="2" charset="0"/>
-                <a:cs typeface="Ramabhadra" panose="02000600000000000000" pitchFamily="2" charset="0"/>
-              </a:rPr>
-            </a:br>
-            <a:r>
-              <a:rPr lang="te-IN" sz="1750" b="0" i="0" dirty="0">
-                <a:solidFill>
-                  <a:srgbClr val="000000"/>
-                </a:solidFill>
-                <a:effectLst/>
-                <a:latin typeface="Ramabhadra" panose="02000600000000000000" pitchFamily="2" charset="0"/>
-                <a:cs typeface="Ramabhadra" panose="02000600000000000000" pitchFamily="2" charset="0"/>
-              </a:rPr>
-              <a:t>పవిత్ర లేఖనాలతో ఉత్తేజింపజేసెనే (2)</a:t>
+              <a:t>ఆప్తులే విడనాడినా ఆరోగ్యం క్షీణించినా (2)</a:t>
             </a:r>
           </a:p>
         </p:txBody>
@@ -4676,7 +4919,7 @@
                 <a:latin typeface="Ramabhadra" panose="02000600000000000000" pitchFamily="2" charset="0"/>
                 <a:cs typeface="Ramabhadra" panose="02000600000000000000" pitchFamily="2" charset="0"/>
               </a:rPr>
-              <a:t>నమ్మకమైన దేవుడవైన</a:t>
+              <a:t>యేసయ్యా నా</a:t>
             </a:r>
           </a:p>
           <a:p>
@@ -4689,7 +4932,7 @@
                 <a:latin typeface="Ramabhadra" panose="02000600000000000000" pitchFamily="2" charset="0"/>
                 <a:cs typeface="Ramabhadra" panose="02000600000000000000" pitchFamily="2" charset="0"/>
               </a:rPr>
-              <a:t>నీవే చాలు యేసయ్యా (2)</a:t>
+              <a:t>హృదయ స్పందన నీవే కదా (2)</a:t>
             </a:r>
           </a:p>
           <a:p>
@@ -4702,7 +4945,7 @@
                 <a:latin typeface="Ramabhadra" panose="02000600000000000000" pitchFamily="2" charset="0"/>
                 <a:cs typeface="Ramabhadra" panose="02000600000000000000" pitchFamily="2" charset="0"/>
               </a:rPr>
-              <a:t>నేనేమైయున్నా ఏ స్థితిలో ఉన్నా (2)</a:t>
+              <a:t>విశ్వమంతా నీ నామము</a:t>
             </a:r>
           </a:p>
           <a:p>
@@ -4715,7 +4958,7 @@
                 <a:latin typeface="Ramabhadra" panose="02000600000000000000" pitchFamily="2" charset="0"/>
                 <a:cs typeface="Ramabhadra" panose="02000600000000000000" pitchFamily="2" charset="0"/>
               </a:rPr>
-              <a:t>ఇంకేమి కోరుకోనయ్యా (2)</a:t>
+              <a:t>ఘణనీయము (2)</a:t>
             </a:r>
           </a:p>
           <a:p>
@@ -4738,7 +4981,7 @@
                 <a:latin typeface="Ramabhadra" panose="02000600000000000000" pitchFamily="2" charset="0"/>
                 <a:cs typeface="Ramabhadra" panose="02000600000000000000" pitchFamily="2" charset="0"/>
               </a:rPr>
-              <a:t>ఆప్తులైన వారే హాని చేయచూసినా</a:t>
+              <a:t>నీవు కనిపించని రోజున</a:t>
             </a:r>
           </a:p>
           <a:p>
@@ -4751,7 +4994,7 @@
                 <a:latin typeface="Ramabhadra" panose="02000600000000000000" pitchFamily="2" charset="0"/>
                 <a:cs typeface="Ramabhadra" panose="02000600000000000000" pitchFamily="2" charset="0"/>
               </a:rPr>
-              <a:t>మిత్రులే నిలువకుండినా (2)</a:t>
+              <a:t>ఒక క్షణమొక యుగముగా మారెనే (2)</a:t>
             </a:r>
           </a:p>
           <a:p>
@@ -4764,7 +5007,7 @@
                 <a:latin typeface="Ramabhadra" panose="02000600000000000000" pitchFamily="2" charset="0"/>
                 <a:cs typeface="Ramabhadra" panose="02000600000000000000" pitchFamily="2" charset="0"/>
               </a:rPr>
-              <a:t>న్యాయము తీర్చే నీవు నాకుంటే (2)</a:t>
+              <a:t>నీవు నడిపించిన రోజున</a:t>
             </a:r>
           </a:p>
           <a:p>
@@ -4777,7 +5020,20 @@
                 <a:latin typeface="Ramabhadra" panose="02000600000000000000" pitchFamily="2" charset="0"/>
                 <a:cs typeface="Ramabhadra" panose="02000600000000000000" pitchFamily="2" charset="0"/>
               </a:rPr>
-              <a:t>చాలు యేసయ్యా (2)</a:t>
+              <a:t>యుగయుగాల తలపు మది నిండెనే (2)</a:t>
+            </a:r>
+          </a:p>
+          <a:p>
+            <a:pPr algn="ctr" defTabSz="439781"/>
+            <a:r>
+              <a:rPr lang="te-IN" sz="1900" dirty="0">
+                <a:solidFill>
+                  <a:schemeClr val="tx1"/>
+                </a:solidFill>
+                <a:latin typeface="Ramabhadra" panose="02000600000000000000" pitchFamily="2" charset="0"/>
+                <a:cs typeface="Ramabhadra" panose="02000600000000000000" pitchFamily="2" charset="0"/>
+              </a:rPr>
+              <a:t>యుగయుగాల తలపు మది నిండెనే</a:t>
             </a:r>
           </a:p>
           <a:p>
@@ -4800,7 +5056,7 @@
                 <a:latin typeface="Ramabhadra" panose="02000600000000000000" pitchFamily="2" charset="0"/>
                 <a:cs typeface="Ramabhadra" panose="02000600000000000000" pitchFamily="2" charset="0"/>
               </a:rPr>
-              <a:t>జ్ఞానమంత చూపి శక్తి ధారపోసినా</a:t>
+              <a:t>నీవు మాట్లాడని రోజున</a:t>
             </a:r>
           </a:p>
           <a:p>
@@ -4813,7 +5069,7 @@
                 <a:latin typeface="Ramabhadra" panose="02000600000000000000" pitchFamily="2" charset="0"/>
                 <a:cs typeface="Ramabhadra" panose="02000600000000000000" pitchFamily="2" charset="0"/>
               </a:rPr>
-              <a:t>నష్టమే మిగులుచుండినా (2)</a:t>
+              <a:t>నా కనులకు నిద్దుర కరువాయెనే (2)</a:t>
             </a:r>
           </a:p>
           <a:p>
@@ -4826,7 +5082,7 @@
                 <a:latin typeface="Ramabhadra" panose="02000600000000000000" pitchFamily="2" charset="0"/>
                 <a:cs typeface="Ramabhadra" panose="02000600000000000000" pitchFamily="2" charset="0"/>
               </a:rPr>
-              <a:t>శాపము బాపే నీవు నాకుంటే (2)</a:t>
+              <a:t>నీవు పెదవిప్పిన రోజున</a:t>
             </a:r>
           </a:p>
           <a:p>
@@ -4839,7 +5095,20 @@
                 <a:latin typeface="Ramabhadra" panose="02000600000000000000" pitchFamily="2" charset="0"/>
                 <a:cs typeface="Ramabhadra" panose="02000600000000000000" pitchFamily="2" charset="0"/>
               </a:rPr>
-              <a:t>చాలు యేసయ్యా (2)</a:t>
+              <a:t>నీ సన్నిధి పచ్చిక బయలాయెనే (2)</a:t>
+            </a:r>
+          </a:p>
+          <a:p>
+            <a:pPr algn="ctr" defTabSz="439781"/>
+            <a:r>
+              <a:rPr lang="te-IN" sz="1900" dirty="0">
+                <a:solidFill>
+                  <a:schemeClr val="tx1"/>
+                </a:solidFill>
+                <a:latin typeface="Ramabhadra" panose="02000600000000000000" pitchFamily="2" charset="0"/>
+                <a:cs typeface="Ramabhadra" panose="02000600000000000000" pitchFamily="2" charset="0"/>
+              </a:rPr>
+              <a:t>నీ సన్నిధి పచ్చిక బయలాయెనే</a:t>
             </a:r>
           </a:p>
         </p:txBody>

</xml_diff>

<commit_message>
21st sunday jan 24
</commit_message>
<xml_diff>
--- a/xerox.pptx
+++ b/xerox.pptx
@@ -224,7 +224,7 @@
           <a:p>
             <a:fld id="{3502DD63-DF8D-4AB8-92A0-0ECCF612C06C}" type="datetimeFigureOut">
               <a:rPr lang="en-IN" smtClean="0"/>
-              <a:t>13-01-2024</a:t>
+              <a:t>20-01-2024</a:t>
             </a:fld>
             <a:endParaRPr lang="en-IN"/>
           </a:p>
@@ -402,7 +402,7 @@
           <a:p>
             <a:fld id="{1AE741EC-1360-4793-999B-941E0396C9FA}" type="datetimeFigureOut">
               <a:rPr lang="en-IN" smtClean="0"/>
-              <a:t>13-01-2024</a:t>
+              <a:t>20-01-2024</a:t>
             </a:fld>
             <a:endParaRPr lang="en-IN"/>
           </a:p>
@@ -802,7 +802,7 @@
           <a:p>
             <a:fld id="{86FBD32F-FCAD-481A-B7D8-4D813FB7DB24}" type="datetimeFigureOut">
               <a:rPr lang="en-IN" smtClean="0"/>
-              <a:t>13-01-2024</a:t>
+              <a:t>20-01-2024</a:t>
             </a:fld>
             <a:endParaRPr lang="en-IN"/>
           </a:p>
@@ -972,7 +972,7 @@
           <a:p>
             <a:fld id="{86FBD32F-FCAD-481A-B7D8-4D813FB7DB24}" type="datetimeFigureOut">
               <a:rPr lang="en-IN" smtClean="0"/>
-              <a:t>13-01-2024</a:t>
+              <a:t>20-01-2024</a:t>
             </a:fld>
             <a:endParaRPr lang="en-IN"/>
           </a:p>
@@ -1152,7 +1152,7 @@
           <a:p>
             <a:fld id="{86FBD32F-FCAD-481A-B7D8-4D813FB7DB24}" type="datetimeFigureOut">
               <a:rPr lang="en-IN" smtClean="0"/>
-              <a:t>13-01-2024</a:t>
+              <a:t>20-01-2024</a:t>
             </a:fld>
             <a:endParaRPr lang="en-IN"/>
           </a:p>
@@ -1322,7 +1322,7 @@
           <a:p>
             <a:fld id="{86FBD32F-FCAD-481A-B7D8-4D813FB7DB24}" type="datetimeFigureOut">
               <a:rPr lang="en-IN" smtClean="0"/>
-              <a:t>13-01-2024</a:t>
+              <a:t>20-01-2024</a:t>
             </a:fld>
             <a:endParaRPr lang="en-IN"/>
           </a:p>
@@ -1566,7 +1566,7 @@
           <a:p>
             <a:fld id="{86FBD32F-FCAD-481A-B7D8-4D813FB7DB24}" type="datetimeFigureOut">
               <a:rPr lang="en-IN" smtClean="0"/>
-              <a:t>13-01-2024</a:t>
+              <a:t>20-01-2024</a:t>
             </a:fld>
             <a:endParaRPr lang="en-IN"/>
           </a:p>
@@ -1798,7 +1798,7 @@
           <a:p>
             <a:fld id="{86FBD32F-FCAD-481A-B7D8-4D813FB7DB24}" type="datetimeFigureOut">
               <a:rPr lang="en-IN" smtClean="0"/>
-              <a:t>13-01-2024</a:t>
+              <a:t>20-01-2024</a:t>
             </a:fld>
             <a:endParaRPr lang="en-IN"/>
           </a:p>
@@ -2165,7 +2165,7 @@
           <a:p>
             <a:fld id="{86FBD32F-FCAD-481A-B7D8-4D813FB7DB24}" type="datetimeFigureOut">
               <a:rPr lang="en-IN" smtClean="0"/>
-              <a:t>13-01-2024</a:t>
+              <a:t>20-01-2024</a:t>
             </a:fld>
             <a:endParaRPr lang="en-IN"/>
           </a:p>
@@ -2283,7 +2283,7 @@
           <a:p>
             <a:fld id="{86FBD32F-FCAD-481A-B7D8-4D813FB7DB24}" type="datetimeFigureOut">
               <a:rPr lang="en-IN" smtClean="0"/>
-              <a:t>13-01-2024</a:t>
+              <a:t>20-01-2024</a:t>
             </a:fld>
             <a:endParaRPr lang="en-IN"/>
           </a:p>
@@ -2378,7 +2378,7 @@
           <a:p>
             <a:fld id="{86FBD32F-FCAD-481A-B7D8-4D813FB7DB24}" type="datetimeFigureOut">
               <a:rPr lang="en-IN" smtClean="0"/>
-              <a:t>13-01-2024</a:t>
+              <a:t>20-01-2024</a:t>
             </a:fld>
             <a:endParaRPr lang="en-IN"/>
           </a:p>
@@ -2655,7 +2655,7 @@
           <a:p>
             <a:fld id="{86FBD32F-FCAD-481A-B7D8-4D813FB7DB24}" type="datetimeFigureOut">
               <a:rPr lang="en-IN" smtClean="0"/>
-              <a:t>13-01-2024</a:t>
+              <a:t>20-01-2024</a:t>
             </a:fld>
             <a:endParaRPr lang="en-IN"/>
           </a:p>
@@ -2912,7 +2912,7 @@
           <a:p>
             <a:fld id="{86FBD32F-FCAD-481A-B7D8-4D813FB7DB24}" type="datetimeFigureOut">
               <a:rPr lang="en-IN" smtClean="0"/>
-              <a:t>13-01-2024</a:t>
+              <a:t>20-01-2024</a:t>
             </a:fld>
             <a:endParaRPr lang="en-IN"/>
           </a:p>
@@ -3125,7 +3125,7 @@
           <a:p>
             <a:fld id="{86FBD32F-FCAD-481A-B7D8-4D813FB7DB24}" type="datetimeFigureOut">
               <a:rPr lang="en-IN" smtClean="0"/>
-              <a:t>13-01-2024</a:t>
+              <a:t>20-01-2024</a:t>
             </a:fld>
             <a:endParaRPr lang="en-IN"/>
           </a:p>
@@ -3553,7 +3553,7 @@
           <a:solidFill>
             <a:schemeClr val="bg1"/>
           </a:solidFill>
-          <a:ln>
+          <a:ln w="28575">
             <a:solidFill>
               <a:schemeClr val="bg1">
                 <a:lumMod val="85000"/>
@@ -3596,10 +3596,7 @@
               <a:defRPr/>
             </a:pPr>
             <a:r>
-              <a:rPr kumimoji="0" lang="te-IN" sz="1600" i="0" u="none" strike="noStrike" kern="1200" cap="none" spc="0" normalizeH="0" baseline="0" noProof="0" dirty="0">
-                <a:ln>
-                  <a:noFill/>
-                </a:ln>
+              <a:rPr kumimoji="0" lang="te-IN" sz="1700" i="0" u="none" strike="noStrike" kern="1200" cap="none" spc="0" normalizeH="0" baseline="0" noProof="0" dirty="0">
                 <a:solidFill>
                   <a:schemeClr val="tx1"/>
                 </a:solidFill>
@@ -3609,7 +3606,7 @@
                 <a:latin typeface="Ramabhadra" panose="02000600000000000000" pitchFamily="2" charset="0"/>
                 <a:cs typeface="Ramabhadra" panose="02000600000000000000" pitchFamily="2" charset="0"/>
               </a:rPr>
-              <a:t>పాడెద స్తుతి గానము</a:t>
+              <a:t>రాజ జగమెరిగిన నా యేసు రాజా</a:t>
             </a:r>
           </a:p>
           <a:p>
@@ -3628,10 +3625,7 @@
               <a:defRPr/>
             </a:pPr>
             <a:r>
-              <a:rPr kumimoji="0" lang="te-IN" sz="1600" i="0" u="none" strike="noStrike" kern="1200" cap="none" spc="0" normalizeH="0" baseline="0" noProof="0" dirty="0">
-                <a:ln>
-                  <a:noFill/>
-                </a:ln>
+              <a:rPr kumimoji="0" lang="te-IN" sz="1700" i="0" u="none" strike="noStrike" kern="1200" cap="none" spc="0" normalizeH="0" baseline="0" noProof="0" dirty="0">
                 <a:solidFill>
                   <a:schemeClr val="tx1"/>
                 </a:solidFill>
@@ -3641,7 +3635,7 @@
                 <a:latin typeface="Ramabhadra" panose="02000600000000000000" pitchFamily="2" charset="0"/>
                 <a:cs typeface="Ramabhadra" panose="02000600000000000000" pitchFamily="2" charset="0"/>
               </a:rPr>
-              <a:t>కొనియాడెద నీ నామము(2)</a:t>
+              <a:t>రాగాలలో అనురాగాలు కురిపించిన</a:t>
             </a:r>
           </a:p>
           <a:p>
@@ -3660,10 +3654,7 @@
               <a:defRPr/>
             </a:pPr>
             <a:r>
-              <a:rPr kumimoji="0" lang="te-IN" sz="1600" i="0" u="none" strike="noStrike" kern="1200" cap="none" spc="0" normalizeH="0" baseline="0" noProof="0" dirty="0">
-                <a:ln>
-                  <a:noFill/>
-                </a:ln>
+              <a:rPr kumimoji="0" lang="te-IN" sz="1700" i="0" u="none" strike="noStrike" kern="1200" cap="none" spc="0" normalizeH="0" baseline="0" noProof="0" dirty="0">
                 <a:solidFill>
                   <a:schemeClr val="tx1"/>
                 </a:solidFill>
@@ -3673,7 +3664,7 @@
                 <a:latin typeface="Ramabhadra" panose="02000600000000000000" pitchFamily="2" charset="0"/>
                 <a:cs typeface="Ramabhadra" panose="02000600000000000000" pitchFamily="2" charset="0"/>
               </a:rPr>
-              <a:t>నీవే నా ప్రేమానురాగం</a:t>
+              <a:t>మనబంధము అనుబంధము (2)</a:t>
             </a:r>
           </a:p>
           <a:p>
@@ -3692,10 +3683,7 @@
               <a:defRPr/>
             </a:pPr>
             <a:r>
-              <a:rPr kumimoji="0" lang="te-IN" sz="1600" i="0" u="none" strike="noStrike" kern="1200" cap="none" spc="0" normalizeH="0" baseline="0" noProof="0" dirty="0">
-                <a:ln>
-                  <a:noFill/>
-                </a:ln>
+              <a:rPr kumimoji="0" lang="te-IN" sz="1700" i="0" u="none" strike="noStrike" kern="1200" cap="none" spc="0" normalizeH="0" baseline="0" noProof="0" dirty="0">
                 <a:solidFill>
                   <a:schemeClr val="tx1"/>
                 </a:solidFill>
@@ -3705,7 +3693,7 @@
                 <a:latin typeface="Ramabhadra" panose="02000600000000000000" pitchFamily="2" charset="0"/>
                 <a:cs typeface="Ramabhadra" panose="02000600000000000000" pitchFamily="2" charset="0"/>
               </a:rPr>
-              <a:t>క్షణమైనా విడువని స్నేహం</a:t>
+              <a:t>విడదీయగలరా ఎవరైనను మరి ఏదైనను? (2)</a:t>
             </a:r>
           </a:p>
           <a:p>
@@ -3723,22 +3711,16 @@
               <a:tabLst/>
               <a:defRPr/>
             </a:pPr>
-            <a:r>
-              <a:rPr kumimoji="0" lang="te-IN" sz="1600" i="0" u="none" strike="noStrike" kern="1200" cap="none" spc="0" normalizeH="0" baseline="0" noProof="0" dirty="0">
-                <a:ln>
-                  <a:noFill/>
-                </a:ln>
-                <a:solidFill>
-                  <a:schemeClr val="tx1"/>
-                </a:solidFill>
-                <a:effectLst/>
-                <a:uLnTx/>
-                <a:uFillTx/>
-                <a:latin typeface="Ramabhadra" panose="02000600000000000000" pitchFamily="2" charset="0"/>
-                <a:cs typeface="Ramabhadra" panose="02000600000000000000" pitchFamily="2" charset="0"/>
-              </a:rPr>
-              <a:t>అతి శ్రేష్టుడా నా యేసయ్య(2)</a:t>
-            </a:r>
+            <a:endParaRPr kumimoji="0" lang="te-IN" sz="1700" i="0" u="none" strike="noStrike" kern="1200" cap="none" spc="0" normalizeH="0" baseline="0" noProof="0" dirty="0">
+              <a:solidFill>
+                <a:schemeClr val="tx1"/>
+              </a:solidFill>
+              <a:effectLst/>
+              <a:uLnTx/>
+              <a:uFillTx/>
+              <a:latin typeface="Ramabhadra" panose="02000600000000000000" pitchFamily="2" charset="0"/>
+              <a:cs typeface="Ramabhadra" panose="02000600000000000000" pitchFamily="2" charset="0"/>
+            </a:endParaRPr>
           </a:p>
           <a:p>
             <a:pPr marL="0" marR="0" lvl="0" indent="0" algn="ctr" defTabSz="439781" rtl="0" eaLnBrk="1" fontAlgn="auto" latinLnBrk="0" hangingPunct="1">
@@ -3755,19 +3737,19 @@
               <a:tabLst/>
               <a:defRPr/>
             </a:pPr>
-            <a:endParaRPr kumimoji="0" lang="te-IN" sz="1600" i="0" u="none" strike="noStrike" kern="1200" cap="none" spc="0" normalizeH="0" baseline="0" noProof="0" dirty="0">
-              <a:ln>
-                <a:noFill/>
-              </a:ln>
-              <a:solidFill>
-                <a:schemeClr val="tx1"/>
-              </a:solidFill>
-              <a:effectLst/>
-              <a:uLnTx/>
-              <a:uFillTx/>
-              <a:latin typeface="Ramabhadra" panose="02000600000000000000" pitchFamily="2" charset="0"/>
-              <a:cs typeface="Ramabhadra" panose="02000600000000000000" pitchFamily="2" charset="0"/>
-            </a:endParaRPr>
+            <a:r>
+              <a:rPr kumimoji="0" lang="te-IN" sz="1700" i="0" u="none" strike="noStrike" kern="1200" cap="none" spc="0" normalizeH="0" baseline="0" noProof="0" dirty="0">
+                <a:solidFill>
+                  <a:schemeClr val="tx1"/>
+                </a:solidFill>
+                <a:effectLst/>
+                <a:uLnTx/>
+                <a:uFillTx/>
+                <a:latin typeface="Ramabhadra" panose="02000600000000000000" pitchFamily="2" charset="0"/>
+                <a:cs typeface="Ramabhadra" panose="02000600000000000000" pitchFamily="2" charset="0"/>
+              </a:rPr>
+              <a:t>దీన స్థితియందున సంపన్న స్థితియందున</a:t>
+            </a:r>
           </a:p>
           <a:p>
             <a:pPr marL="0" marR="0" lvl="0" indent="0" algn="ctr" defTabSz="439781" rtl="0" eaLnBrk="1" fontAlgn="auto" latinLnBrk="0" hangingPunct="1">
@@ -3785,10 +3767,7 @@
               <a:defRPr/>
             </a:pPr>
             <a:r>
-              <a:rPr kumimoji="0" lang="te-IN" sz="1600" i="0" u="none" strike="noStrike" kern="1200" cap="none" spc="0" normalizeH="0" baseline="0" noProof="0" dirty="0">
-                <a:ln>
-                  <a:noFill/>
-                </a:ln>
+              <a:rPr kumimoji="0" lang="te-IN" sz="1700" i="0" u="none" strike="noStrike" kern="1200" cap="none" spc="0" normalizeH="0" baseline="0" noProof="0" dirty="0">
                 <a:solidFill>
                   <a:schemeClr val="tx1"/>
                 </a:solidFill>
@@ -3798,7 +3777,7 @@
                 <a:latin typeface="Ramabhadra" panose="02000600000000000000" pitchFamily="2" charset="0"/>
                 <a:cs typeface="Ramabhadra" panose="02000600000000000000" pitchFamily="2" charset="0"/>
               </a:rPr>
-              <a:t>ఇల నాకెవ్వరు లేరనుకొనగా నా దరి చేరితివే </a:t>
+              <a:t>నడచినను ఎగిరినను</a:t>
             </a:r>
           </a:p>
           <a:p>
@@ -3817,10 +3796,7 @@
               <a:defRPr/>
             </a:pPr>
             <a:r>
-              <a:rPr kumimoji="0" lang="te-IN" sz="1600" i="0" u="none" strike="noStrike" kern="1200" cap="none" spc="0" normalizeH="0" baseline="0" noProof="0" dirty="0">
-                <a:ln>
-                  <a:noFill/>
-                </a:ln>
+              <a:rPr kumimoji="0" lang="te-IN" sz="1700" i="0" u="none" strike="noStrike" kern="1200" cap="none" spc="0" normalizeH="0" baseline="0" noProof="0" dirty="0">
                 <a:solidFill>
                   <a:schemeClr val="tx1"/>
                 </a:solidFill>
@@ -3830,7 +3806,7 @@
                 <a:latin typeface="Ramabhadra" panose="02000600000000000000" pitchFamily="2" charset="0"/>
                 <a:cs typeface="Ramabhadra" panose="02000600000000000000" pitchFamily="2" charset="0"/>
               </a:rPr>
-              <a:t>నే నమ్మినవారే నను మరచినను</a:t>
+              <a:t>సంతృప్తి కలిగి యుందునే (2)</a:t>
             </a:r>
           </a:p>
           <a:p>
@@ -3849,10 +3825,7 @@
               <a:defRPr/>
             </a:pPr>
             <a:r>
-              <a:rPr kumimoji="0" lang="te-IN" sz="1600" i="0" u="none" strike="noStrike" kern="1200" cap="none" spc="0" normalizeH="0" baseline="0" noProof="0" dirty="0">
-                <a:ln>
-                  <a:noFill/>
-                </a:ln>
+              <a:rPr kumimoji="0" lang="te-IN" sz="1700" i="0" u="none" strike="noStrike" kern="1200" cap="none" spc="0" normalizeH="0" baseline="0" noProof="0" dirty="0">
                 <a:solidFill>
                   <a:schemeClr val="tx1"/>
                 </a:solidFill>
@@ -3862,7 +3835,7 @@
                 <a:latin typeface="Ramabhadra" panose="02000600000000000000" pitchFamily="2" charset="0"/>
                 <a:cs typeface="Ramabhadra" panose="02000600000000000000" pitchFamily="2" charset="0"/>
               </a:rPr>
-              <a:t>మరువని దేవుడవు(2)</a:t>
+              <a:t>నిత్యము ఆరాధనకు నా ఆధారమా</a:t>
             </a:r>
           </a:p>
           <a:p>
@@ -3881,10 +3854,7 @@
               <a:defRPr/>
             </a:pPr>
             <a:r>
-              <a:rPr kumimoji="0" lang="te-IN" sz="1600" i="0" u="none" strike="noStrike" kern="1200" cap="none" spc="0" normalizeH="0" baseline="0" noProof="0" dirty="0">
-                <a:ln>
-                  <a:noFill/>
-                </a:ln>
+              <a:rPr kumimoji="0" lang="te-IN" sz="1700" i="0" u="none" strike="noStrike" kern="1200" cap="none" spc="0" normalizeH="0" baseline="0" noProof="0" dirty="0">
                 <a:solidFill>
                   <a:schemeClr val="tx1"/>
                 </a:solidFill>
@@ -3894,7 +3864,7 @@
                 <a:latin typeface="Ramabhadra" panose="02000600000000000000" pitchFamily="2" charset="0"/>
                 <a:cs typeface="Ramabhadra" panose="02000600000000000000" pitchFamily="2" charset="0"/>
               </a:rPr>
-              <a:t>నీ ఆశలే నాలో చిగురించెను</a:t>
+              <a:t>స్తోత్రబలులు నీకే అర్పించెద యేసయ్యా (2)</a:t>
             </a:r>
           </a:p>
           <a:p>
@@ -3912,22 +3882,16 @@
               <a:tabLst/>
               <a:defRPr/>
             </a:pPr>
-            <a:r>
-              <a:rPr kumimoji="0" lang="te-IN" sz="1600" i="0" u="none" strike="noStrike" kern="1200" cap="none" spc="0" normalizeH="0" baseline="0" noProof="0" dirty="0">
-                <a:ln>
-                  <a:noFill/>
-                </a:ln>
-                <a:solidFill>
-                  <a:schemeClr val="tx1"/>
-                </a:solidFill>
-                <a:effectLst/>
-                <a:uLnTx/>
-                <a:uFillTx/>
-                <a:latin typeface="Ramabhadra" panose="02000600000000000000" pitchFamily="2" charset="0"/>
-                <a:cs typeface="Ramabhadra" panose="02000600000000000000" pitchFamily="2" charset="0"/>
-              </a:rPr>
-              <a:t>నీ వాక్యమే నన్ను బ్రతికించెను(2)</a:t>
-            </a:r>
+            <a:endParaRPr kumimoji="0" lang="te-IN" sz="1700" i="0" u="none" strike="noStrike" kern="1200" cap="none" spc="0" normalizeH="0" baseline="0" noProof="0" dirty="0">
+              <a:solidFill>
+                <a:schemeClr val="tx1"/>
+              </a:solidFill>
+              <a:effectLst/>
+              <a:uLnTx/>
+              <a:uFillTx/>
+              <a:latin typeface="Ramabhadra" panose="02000600000000000000" pitchFamily="2" charset="0"/>
+              <a:cs typeface="Ramabhadra" panose="02000600000000000000" pitchFamily="2" charset="0"/>
+            </a:endParaRPr>
           </a:p>
           <a:p>
             <a:pPr marL="0" marR="0" lvl="0" indent="0" algn="ctr" defTabSz="439781" rtl="0" eaLnBrk="1" fontAlgn="auto" latinLnBrk="0" hangingPunct="1">
@@ -3945,10 +3909,7 @@
               <a:defRPr/>
             </a:pPr>
             <a:r>
-              <a:rPr kumimoji="0" lang="te-IN" sz="1600" i="0" u="none" strike="noStrike" kern="1200" cap="none" spc="0" normalizeH="0" baseline="0" noProof="0" dirty="0">
-                <a:ln>
-                  <a:noFill/>
-                </a:ln>
+              <a:rPr kumimoji="0" lang="te-IN" sz="1700" i="0" u="none" strike="noStrike" kern="1200" cap="none" spc="0" normalizeH="0" baseline="0" noProof="0" dirty="0">
                 <a:solidFill>
                   <a:schemeClr val="tx1"/>
                 </a:solidFill>
@@ -3958,7 +3919,7 @@
                 <a:latin typeface="Ramabhadra" panose="02000600000000000000" pitchFamily="2" charset="0"/>
                 <a:cs typeface="Ramabhadra" panose="02000600000000000000" pitchFamily="2" charset="0"/>
               </a:rPr>
-              <a:t>నీ అనుబంధము నాకు ఆనందమే(2)</a:t>
+              <a:t>బలహీనతలయందున అవమానములయందున</a:t>
             </a:r>
           </a:p>
           <a:p>
@@ -3976,19 +3937,19 @@
               <a:tabLst/>
               <a:defRPr/>
             </a:pPr>
-            <a:endParaRPr kumimoji="0" lang="te-IN" sz="1600" i="0" u="none" strike="noStrike" kern="1200" cap="none" spc="0" normalizeH="0" baseline="0" noProof="0" dirty="0">
-              <a:ln>
-                <a:noFill/>
-              </a:ln>
-              <a:solidFill>
-                <a:schemeClr val="tx1"/>
-              </a:solidFill>
-              <a:effectLst/>
-              <a:uLnTx/>
-              <a:uFillTx/>
-              <a:latin typeface="Ramabhadra" panose="02000600000000000000" pitchFamily="2" charset="0"/>
-              <a:cs typeface="Ramabhadra" panose="02000600000000000000" pitchFamily="2" charset="0"/>
-            </a:endParaRPr>
+            <a:r>
+              <a:rPr kumimoji="0" lang="te-IN" sz="1700" i="0" u="none" strike="noStrike" kern="1200" cap="none" spc="0" normalizeH="0" baseline="0" noProof="0" dirty="0">
+                <a:solidFill>
+                  <a:schemeClr val="tx1"/>
+                </a:solidFill>
+                <a:effectLst/>
+                <a:uLnTx/>
+                <a:uFillTx/>
+                <a:latin typeface="Ramabhadra" panose="02000600000000000000" pitchFamily="2" charset="0"/>
+                <a:cs typeface="Ramabhadra" panose="02000600000000000000" pitchFamily="2" charset="0"/>
+              </a:rPr>
+              <a:t>పడినను కృంగినను</a:t>
+            </a:r>
           </a:p>
           <a:p>
             <a:pPr marL="0" marR="0" lvl="0" indent="0" algn="ctr" defTabSz="439781" rtl="0" eaLnBrk="1" fontAlgn="auto" latinLnBrk="0" hangingPunct="1">
@@ -4006,10 +3967,7 @@
               <a:defRPr/>
             </a:pPr>
             <a:r>
-              <a:rPr kumimoji="0" lang="te-IN" sz="1600" i="0" u="none" strike="noStrike" kern="1200" cap="none" spc="0" normalizeH="0" baseline="0" noProof="0" dirty="0">
-                <a:ln>
-                  <a:noFill/>
-                </a:ln>
+              <a:rPr kumimoji="0" lang="te-IN" sz="1700" i="0" u="none" strike="noStrike" kern="1200" cap="none" spc="0" normalizeH="0" baseline="0" noProof="0" dirty="0">
                 <a:solidFill>
                   <a:schemeClr val="tx1"/>
                 </a:solidFill>
@@ -4019,7 +3977,7 @@
                 <a:latin typeface="Ramabhadra" panose="02000600000000000000" pitchFamily="2" charset="0"/>
                 <a:cs typeface="Ramabhadra" panose="02000600000000000000" pitchFamily="2" charset="0"/>
               </a:rPr>
-              <a:t>నా ప్రతి అణువును పరిశుద్ధపరిచెను</a:t>
+              <a:t>నీకృప కలిగియుందునే (2)</a:t>
             </a:r>
           </a:p>
           <a:p>
@@ -4038,10 +3996,7 @@
               <a:defRPr/>
             </a:pPr>
             <a:r>
-              <a:rPr kumimoji="0" lang="te-IN" sz="1600" i="0" u="none" strike="noStrike" kern="1200" cap="none" spc="0" normalizeH="0" baseline="0" noProof="0" dirty="0">
-                <a:ln>
-                  <a:noFill/>
-                </a:ln>
+              <a:rPr kumimoji="0" lang="te-IN" sz="1700" i="0" u="none" strike="noStrike" kern="1200" cap="none" spc="0" normalizeH="0" baseline="0" noProof="0" dirty="0">
                 <a:solidFill>
                   <a:schemeClr val="tx1"/>
                 </a:solidFill>
@@ -4051,7 +4006,7 @@
                 <a:latin typeface="Ramabhadra" panose="02000600000000000000" pitchFamily="2" charset="0"/>
                 <a:cs typeface="Ramabhadra" panose="02000600000000000000" pitchFamily="2" charset="0"/>
               </a:rPr>
-              <a:t>నీ రుధిర ధారలే</a:t>
+              <a:t>నిత్యము ఆరాధనకు నా ఆధారమా</a:t>
             </a:r>
           </a:p>
           <a:p>
@@ -4070,10 +4025,7 @@
               <a:defRPr/>
             </a:pPr>
             <a:r>
-              <a:rPr kumimoji="0" lang="te-IN" sz="1600" i="0" u="none" strike="noStrike" kern="1200" cap="none" spc="0" normalizeH="0" baseline="0" noProof="0" dirty="0">
-                <a:ln>
-                  <a:noFill/>
-                </a:ln>
+              <a:rPr kumimoji="0" lang="te-IN" sz="1700" i="0" u="none" strike="noStrike" kern="1200" cap="none" spc="0" normalizeH="0" baseline="0" noProof="0" dirty="0">
                 <a:solidFill>
                   <a:schemeClr val="tx1"/>
                 </a:solidFill>
@@ -4083,103 +4035,7 @@
                 <a:latin typeface="Ramabhadra" panose="02000600000000000000" pitchFamily="2" charset="0"/>
                 <a:cs typeface="Ramabhadra" panose="02000600000000000000" pitchFamily="2" charset="0"/>
               </a:rPr>
-              <a:t>నీ దర్శనమే నను నిలిపినది ధరణిలో నీ కొరకే(2)</a:t>
-            </a:r>
-          </a:p>
-          <a:p>
-            <a:pPr marL="0" marR="0" lvl="0" indent="0" algn="ctr" defTabSz="439781" rtl="0" eaLnBrk="1" fontAlgn="auto" latinLnBrk="0" hangingPunct="1">
-              <a:spcBef>
-                <a:spcPts val="0"/>
-              </a:spcBef>
-              <a:spcAft>
-                <a:spcPts val="0"/>
-              </a:spcAft>
-              <a:buClrTx/>
-              <a:buSzTx/>
-              <a:buFontTx/>
-              <a:buNone/>
-              <a:tabLst/>
-              <a:defRPr/>
-            </a:pPr>
-            <a:r>
-              <a:rPr kumimoji="0" lang="te-IN" sz="1600" i="0" u="none" strike="noStrike" kern="1200" cap="none" spc="0" normalizeH="0" baseline="0" noProof="0" dirty="0">
-                <a:ln>
-                  <a:noFill/>
-                </a:ln>
-                <a:solidFill>
-                  <a:schemeClr val="tx1"/>
-                </a:solidFill>
-                <a:effectLst/>
-                <a:uLnTx/>
-                <a:uFillTx/>
-                <a:latin typeface="Ramabhadra" panose="02000600000000000000" pitchFamily="2" charset="0"/>
-                <a:cs typeface="Ramabhadra" panose="02000600000000000000" pitchFamily="2" charset="0"/>
-              </a:rPr>
-              <a:t>నీ చేతులే నను నిర్మించెను</a:t>
-            </a:r>
-          </a:p>
-          <a:p>
-            <a:pPr marL="0" marR="0" lvl="0" indent="0" algn="ctr" defTabSz="439781" rtl="0" eaLnBrk="1" fontAlgn="auto" latinLnBrk="0" hangingPunct="1">
-              <a:spcBef>
-                <a:spcPts val="0"/>
-              </a:spcBef>
-              <a:spcAft>
-                <a:spcPts val="0"/>
-              </a:spcAft>
-              <a:buClrTx/>
-              <a:buSzTx/>
-              <a:buFontTx/>
-              <a:buNone/>
-              <a:tabLst/>
-              <a:defRPr/>
-            </a:pPr>
-            <a:r>
-              <a:rPr kumimoji="0" lang="te-IN" sz="1600" i="0" u="none" strike="noStrike" kern="1200" cap="none" spc="0" normalizeH="0" baseline="0" noProof="0" dirty="0">
-                <a:ln>
-                  <a:noFill/>
-                </a:ln>
-                <a:solidFill>
-                  <a:schemeClr val="tx1"/>
-                </a:solidFill>
-                <a:effectLst/>
-                <a:uLnTx/>
-                <a:uFillTx/>
-                <a:latin typeface="Ramabhadra" panose="02000600000000000000" pitchFamily="2" charset="0"/>
-                <a:cs typeface="Ramabhadra" panose="02000600000000000000" pitchFamily="2" charset="0"/>
-              </a:rPr>
-              <a:t>నీ రూపమే నాలో కలిగెను(2)</a:t>
-            </a:r>
-          </a:p>
-          <a:p>
-            <a:pPr marL="0" marR="0" lvl="0" indent="0" algn="ctr" defTabSz="439781" rtl="0" eaLnBrk="1" fontAlgn="auto" latinLnBrk="0" hangingPunct="1">
-              <a:spcBef>
-                <a:spcPts val="0"/>
-              </a:spcBef>
-              <a:spcAft>
-                <a:spcPts val="0"/>
-              </a:spcAft>
-              <a:buClrTx/>
-              <a:buSzTx/>
-              <a:buFontTx/>
-              <a:buNone/>
-              <a:tabLst/>
-              <a:defRPr/>
-            </a:pPr>
-            <a:r>
-              <a:rPr kumimoji="0" lang="te-IN" sz="1600" i="0" u="none" strike="noStrike" kern="1200" cap="none" spc="0" normalizeH="0" baseline="0" noProof="0" dirty="0">
-                <a:ln>
-                  <a:noFill/>
-                </a:ln>
-                <a:solidFill>
-                  <a:schemeClr val="tx1"/>
-                </a:solidFill>
-                <a:effectLst/>
-                <a:uLnTx/>
-                <a:uFillTx/>
-                <a:latin typeface="Ramabhadra" panose="02000600000000000000" pitchFamily="2" charset="0"/>
-                <a:cs typeface="Ramabhadra" panose="02000600000000000000" pitchFamily="2" charset="0"/>
-              </a:rPr>
-              <a:t>నీ అభిషేకము పరమానందమే(2)</a:t>
+              <a:t>స్తోత్రబలులు నీకే అర్పించెద యేసయ్యా (2)</a:t>
             </a:r>
           </a:p>
         </p:txBody>
@@ -4207,7 +4063,7 @@
           <a:solidFill>
             <a:schemeClr val="bg1"/>
           </a:solidFill>
-          <a:ln>
+          <a:ln w="28575">
             <a:solidFill>
               <a:schemeClr val="bg1">
                 <a:lumMod val="85000"/>
@@ -4244,7 +4100,7 @@
               </a:spcAft>
             </a:pPr>
             <a:r>
-              <a:rPr lang="te-IN" sz="1600" b="0" i="0" dirty="0">
+              <a:rPr lang="te-IN" b="0" i="0" dirty="0">
                 <a:solidFill>
                   <a:schemeClr val="tx1"/>
                 </a:solidFill>
@@ -4252,10 +4108,10 @@
                 <a:latin typeface="Ramabhadra" panose="02000600000000000000" pitchFamily="2" charset="0"/>
                 <a:cs typeface="Ramabhadra" panose="02000600000000000000" pitchFamily="2" charset="0"/>
               </a:rPr>
-              <a:t>కృప కృప నీ కృప</a:t>
+              <a:t>దేవా నా దేవా – నీవే నా కాపరి</a:t>
             </a:r>
             <a:br>
-              <a:rPr lang="te-IN" sz="1600" b="0" i="0" dirty="0">
+              <a:rPr lang="te-IN" b="0" i="0" dirty="0">
                 <a:solidFill>
                   <a:schemeClr val="tx1"/>
                 </a:solidFill>
@@ -4265,7 +4121,7 @@
               </a:rPr>
             </a:br>
             <a:r>
-              <a:rPr lang="te-IN" sz="1600" b="0" i="0" dirty="0">
+              <a:rPr lang="te-IN" b="0" i="0" dirty="0">
                 <a:solidFill>
                   <a:schemeClr val="tx1"/>
                 </a:solidFill>
@@ -4273,10 +4129,10 @@
                 <a:latin typeface="Ramabhadra" panose="02000600000000000000" pitchFamily="2" charset="0"/>
                 <a:cs typeface="Ramabhadra" panose="02000600000000000000" pitchFamily="2" charset="0"/>
               </a:rPr>
-              <a:t>కృప కృప క్రీస్తు కృప (2)</a:t>
+              <a:t>నీ ప్రేమ నీ క్షమా – ఎంతో గొప్పది (2)</a:t>
             </a:r>
             <a:br>
-              <a:rPr lang="te-IN" sz="1600" b="0" i="0" dirty="0">
+              <a:rPr lang="te-IN" b="0" i="0" dirty="0">
                 <a:solidFill>
                   <a:schemeClr val="tx1"/>
                 </a:solidFill>
@@ -4286,7 +4142,7 @@
               </a:rPr>
             </a:br>
             <a:r>
-              <a:rPr lang="te-IN" sz="1600" b="0" i="0" dirty="0">
+              <a:rPr lang="te-IN" b="0" i="0" dirty="0">
                 <a:solidFill>
                   <a:schemeClr val="tx1"/>
                 </a:solidFill>
@@ -4294,10 +4150,10 @@
                 <a:latin typeface="Ramabhadra" panose="02000600000000000000" pitchFamily="2" charset="0"/>
                 <a:cs typeface="Ramabhadra" panose="02000600000000000000" pitchFamily="2" charset="0"/>
               </a:rPr>
-              <a:t>నేనైతే నీ కృపయందు</a:t>
+              <a:t>ఆరాధింతును హృదయాంతరంగములో</a:t>
             </a:r>
             <a:br>
-              <a:rPr lang="te-IN" sz="1600" b="0" i="0" dirty="0">
+              <a:rPr lang="te-IN" b="0" i="0" dirty="0">
                 <a:solidFill>
                   <a:schemeClr val="tx1"/>
                 </a:solidFill>
@@ -4307,7 +4163,7 @@
               </a:rPr>
             </a:br>
             <a:r>
-              <a:rPr lang="te-IN" sz="1600" b="0" i="0" dirty="0">
+              <a:rPr lang="te-IN" b="0" i="0" dirty="0">
                 <a:solidFill>
                   <a:schemeClr val="tx1"/>
                 </a:solidFill>
@@ -4315,10 +4171,10 @@
                 <a:latin typeface="Ramabhadra" panose="02000600000000000000" pitchFamily="2" charset="0"/>
                 <a:cs typeface="Ramabhadra" panose="02000600000000000000" pitchFamily="2" charset="0"/>
               </a:rPr>
-              <a:t>నమ్మికయుంచి యున్నాను</a:t>
+              <a:t>స్తుతించెదను నీ పాద సన్నిధిలో (2)</a:t>
             </a:r>
             <a:br>
-              <a:rPr lang="te-IN" sz="1600" b="0" i="0" dirty="0">
+              <a:rPr lang="te-IN" b="0" i="0" dirty="0">
                 <a:solidFill>
                   <a:schemeClr val="tx1"/>
                 </a:solidFill>
@@ -4328,7 +4184,7 @@
               </a:rPr>
             </a:br>
             <a:r>
-              <a:rPr lang="te-IN" sz="1600" b="0" i="0" dirty="0">
+              <a:rPr lang="te-IN" b="0" i="0" dirty="0">
                 <a:solidFill>
                   <a:schemeClr val="tx1"/>
                 </a:solidFill>
@@ -4336,7 +4192,7 @@
                 <a:latin typeface="Ramabhadra" panose="02000600000000000000" pitchFamily="2" charset="0"/>
                 <a:cs typeface="Ramabhadra" panose="02000600000000000000" pitchFamily="2" charset="0"/>
               </a:rPr>
-              <a:t>నా నమ్మికయుంచి యున్నాను (2)      </a:t>
+              <a:t>నీవే కదా దేవుడవు – (2)</a:t>
             </a:r>
           </a:p>
           <a:p>
@@ -4349,7 +4205,7 @@
               </a:spcAft>
             </a:pPr>
             <a:r>
-              <a:rPr lang="te-IN" sz="1600" b="0" i="0" dirty="0">
+              <a:rPr lang="te-IN" b="0" i="0" dirty="0">
                 <a:solidFill>
                   <a:schemeClr val="tx1"/>
                 </a:solidFill>
@@ -4357,7 +4213,7 @@
                 <a:latin typeface="Ramabhadra" panose="02000600000000000000" pitchFamily="2" charset="0"/>
                 <a:cs typeface="Ramabhadra" panose="02000600000000000000" pitchFamily="2" charset="0"/>
               </a:rPr>
-              <a:t> </a:t>
+              <a:t>దేవా యేసు దేవా (4)     </a:t>
             </a:r>
           </a:p>
           <a:p>
@@ -4369,17 +4225,14 @@
                 <a:spcPts val="0"/>
               </a:spcAft>
             </a:pPr>
-            <a:r>
-              <a:rPr lang="te-IN" sz="1600" b="0" i="0" dirty="0">
-                <a:solidFill>
-                  <a:schemeClr val="tx1"/>
-                </a:solidFill>
-                <a:effectLst/>
-                <a:latin typeface="Ramabhadra" panose="02000600000000000000" pitchFamily="2" charset="0"/>
-                <a:cs typeface="Ramabhadra" panose="02000600000000000000" pitchFamily="2" charset="0"/>
-              </a:rPr>
-              <a:t>కృపను గూర్చి న్యాయము గూర్చి</a:t>
-            </a:r>
+            <a:endParaRPr lang="te-IN" b="0" i="0" dirty="0">
+              <a:solidFill>
+                <a:schemeClr val="tx1"/>
+              </a:solidFill>
+              <a:effectLst/>
+              <a:latin typeface="Ramabhadra" panose="02000600000000000000" pitchFamily="2" charset="0"/>
+              <a:cs typeface="Ramabhadra" panose="02000600000000000000" pitchFamily="2" charset="0"/>
+            </a:endParaRPr>
           </a:p>
           <a:p>
             <a:pPr marL="0" marR="0" indent="0" algn="ctr" rtl="0" eaLnBrk="1" fontAlgn="auto" latinLnBrk="0" hangingPunct="1">
@@ -4391,7 +4244,7 @@
               </a:spcAft>
             </a:pPr>
             <a:r>
-              <a:rPr lang="te-IN" sz="1600" b="0" i="0" dirty="0">
+              <a:rPr lang="te-IN" b="0" i="0" dirty="0">
                 <a:solidFill>
                   <a:schemeClr val="tx1"/>
                 </a:solidFill>
@@ -4399,10 +4252,10 @@
                 <a:latin typeface="Ramabhadra" panose="02000600000000000000" pitchFamily="2" charset="0"/>
                 <a:cs typeface="Ramabhadra" panose="02000600000000000000" pitchFamily="2" charset="0"/>
               </a:rPr>
-              <a:t> నేను పాడెదను</a:t>
+              <a:t>పాపము నుండి విడిపించినావు</a:t>
             </a:r>
             <a:br>
-              <a:rPr lang="te-IN" sz="1600" b="0" i="0" dirty="0">
+              <a:rPr lang="te-IN" b="0" i="0" dirty="0">
                 <a:solidFill>
                   <a:schemeClr val="tx1"/>
                 </a:solidFill>
@@ -4412,7 +4265,7 @@
               </a:rPr>
             </a:br>
             <a:r>
-              <a:rPr lang="te-IN" sz="1600" b="0" i="0" dirty="0">
+              <a:rPr lang="te-IN" b="0" i="0" dirty="0">
                 <a:solidFill>
                   <a:schemeClr val="tx1"/>
                 </a:solidFill>
@@ -4420,7 +4273,49 @@
                 <a:latin typeface="Ramabhadra" panose="02000600000000000000" pitchFamily="2" charset="0"/>
                 <a:cs typeface="Ramabhadra" panose="02000600000000000000" pitchFamily="2" charset="0"/>
               </a:rPr>
-              <a:t>నీ సన్నిధిలో నిర్దోషముతో </a:t>
+              <a:t>పరిశుద్ధుని చేసి ప్రేమించినావు (2)</a:t>
+            </a:r>
+            <a:br>
+              <a:rPr lang="te-IN" b="0" i="0" dirty="0">
+                <a:solidFill>
+                  <a:schemeClr val="tx1"/>
+                </a:solidFill>
+                <a:effectLst/>
+                <a:latin typeface="Ramabhadra" panose="02000600000000000000" pitchFamily="2" charset="0"/>
+                <a:cs typeface="Ramabhadra" panose="02000600000000000000" pitchFamily="2" charset="0"/>
+              </a:rPr>
+            </a:br>
+            <a:r>
+              <a:rPr lang="te-IN" b="0" i="0" dirty="0">
+                <a:solidFill>
+                  <a:schemeClr val="tx1"/>
+                </a:solidFill>
+                <a:effectLst/>
+                <a:latin typeface="Ramabhadra" panose="02000600000000000000" pitchFamily="2" charset="0"/>
+                <a:cs typeface="Ramabhadra" panose="02000600000000000000" pitchFamily="2" charset="0"/>
+              </a:rPr>
+              <a:t>నీవే కదా దేవుడవు – (2)</a:t>
+            </a:r>
+            <a:br>
+              <a:rPr lang="te-IN" b="0" i="0" dirty="0">
+                <a:solidFill>
+                  <a:schemeClr val="tx1"/>
+                </a:solidFill>
+                <a:effectLst/>
+                <a:latin typeface="Ramabhadra" panose="02000600000000000000" pitchFamily="2" charset="0"/>
+                <a:cs typeface="Ramabhadra" panose="02000600000000000000" pitchFamily="2" charset="0"/>
+              </a:rPr>
+            </a:br>
+            <a:r>
+              <a:rPr lang="te-IN" b="0" i="0" dirty="0">
+                <a:solidFill>
+                  <a:schemeClr val="tx1"/>
+                </a:solidFill>
+                <a:effectLst/>
+                <a:latin typeface="Ramabhadra" panose="02000600000000000000" pitchFamily="2" charset="0"/>
+                <a:cs typeface="Ramabhadra" panose="02000600000000000000" pitchFamily="2" charset="0"/>
+              </a:rPr>
+              <a:t>దేవా యేసు దేవా (4)       </a:t>
             </a:r>
           </a:p>
           <a:p>
@@ -4432,59 +4327,14 @@
                 <a:spcPts val="0"/>
               </a:spcAft>
             </a:pPr>
-            <a:r>
-              <a:rPr lang="te-IN" sz="1600" b="0" i="0" dirty="0">
-                <a:solidFill>
-                  <a:schemeClr val="tx1"/>
-                </a:solidFill>
-                <a:effectLst/>
-                <a:latin typeface="Ramabhadra" panose="02000600000000000000" pitchFamily="2" charset="0"/>
-                <a:cs typeface="Ramabhadra" panose="02000600000000000000" pitchFamily="2" charset="0"/>
-              </a:rPr>
-              <a:t>నేను నడచెదను (2)</a:t>
-            </a:r>
-            <a:br>
-              <a:rPr lang="te-IN" sz="1600" b="0" i="0" dirty="0">
-                <a:solidFill>
-                  <a:schemeClr val="tx1"/>
-                </a:solidFill>
-                <a:effectLst/>
-                <a:latin typeface="Ramabhadra" panose="02000600000000000000" pitchFamily="2" charset="0"/>
-                <a:cs typeface="Ramabhadra" panose="02000600000000000000" pitchFamily="2" charset="0"/>
-              </a:rPr>
-            </a:br>
-            <a:r>
-              <a:rPr lang="te-IN" sz="1600" b="0" i="0" dirty="0">
-                <a:solidFill>
-                  <a:schemeClr val="tx1"/>
-                </a:solidFill>
-                <a:effectLst/>
-                <a:latin typeface="Ramabhadra" panose="02000600000000000000" pitchFamily="2" charset="0"/>
-                <a:cs typeface="Ramabhadra" panose="02000600000000000000" pitchFamily="2" charset="0"/>
-              </a:rPr>
-              <a:t>నీ కృపయే నాకు ఆధారం</a:t>
-            </a:r>
-            <a:br>
-              <a:rPr lang="te-IN" sz="1600" b="0" i="0" dirty="0">
-                <a:solidFill>
-                  <a:schemeClr val="tx1"/>
-                </a:solidFill>
-                <a:effectLst/>
-                <a:latin typeface="Ramabhadra" panose="02000600000000000000" pitchFamily="2" charset="0"/>
-                <a:cs typeface="Ramabhadra" panose="02000600000000000000" pitchFamily="2" charset="0"/>
-              </a:rPr>
-            </a:br>
-            <a:r>
-              <a:rPr lang="te-IN" sz="1600" b="0" i="0" dirty="0">
-                <a:solidFill>
-                  <a:schemeClr val="tx1"/>
-                </a:solidFill>
-                <a:effectLst/>
-                <a:latin typeface="Ramabhadra" panose="02000600000000000000" pitchFamily="2" charset="0"/>
-                <a:cs typeface="Ramabhadra" panose="02000600000000000000" pitchFamily="2" charset="0"/>
-              </a:rPr>
-              <a:t>      ఆ కృపయే నాకు ఆదరణ (2)       </a:t>
-            </a:r>
+            <a:endParaRPr lang="te-IN" b="0" i="0" dirty="0">
+              <a:solidFill>
+                <a:schemeClr val="tx1"/>
+              </a:solidFill>
+              <a:effectLst/>
+              <a:latin typeface="Ramabhadra" panose="02000600000000000000" pitchFamily="2" charset="0"/>
+              <a:cs typeface="Ramabhadra" panose="02000600000000000000" pitchFamily="2" charset="0"/>
+            </a:endParaRPr>
           </a:p>
           <a:p>
             <a:pPr marL="0" marR="0" indent="0" algn="ctr" rtl="0" eaLnBrk="1" fontAlgn="auto" latinLnBrk="0" hangingPunct="1">
@@ -4496,7 +4346,7 @@
               </a:spcAft>
             </a:pPr>
             <a:r>
-              <a:rPr lang="te-IN" sz="1600" b="0" i="0" dirty="0">
+              <a:rPr lang="te-IN" b="0" i="0" dirty="0">
                 <a:solidFill>
                   <a:schemeClr val="tx1"/>
                 </a:solidFill>
@@ -4504,20 +4354,10 @@
                 <a:latin typeface="Ramabhadra" panose="02000600000000000000" pitchFamily="2" charset="0"/>
                 <a:cs typeface="Ramabhadra" panose="02000600000000000000" pitchFamily="2" charset="0"/>
               </a:rPr>
-              <a:t> </a:t>
-            </a:r>
-          </a:p>
-          <a:p>
-            <a:pPr marL="0" marR="0" indent="0" algn="ctr" rtl="0" eaLnBrk="1" fontAlgn="auto" latinLnBrk="0" hangingPunct="1">
-              <a:spcBef>
-                <a:spcPts val="0"/>
-              </a:spcBef>
-              <a:spcAft>
-                <a:spcPts val="0"/>
-              </a:spcAft>
-            </a:pPr>
-            <a:r>
-              <a:rPr lang="te-IN" sz="1600" b="0" i="0" dirty="0">
+              <a:t>పరిశుద్ధాత్మను నాలో నింపావు</a:t>
+            </a:r>
+            <a:br>
+              <a:rPr lang="te-IN" b="0" i="0" dirty="0">
                 <a:solidFill>
                   <a:schemeClr val="tx1"/>
                 </a:solidFill>
@@ -4525,20 +4365,9 @@
                 <a:latin typeface="Ramabhadra" panose="02000600000000000000" pitchFamily="2" charset="0"/>
                 <a:cs typeface="Ramabhadra" panose="02000600000000000000" pitchFamily="2" charset="0"/>
               </a:rPr>
-              <a:t>దీన దశలో నేన్నునప్పుడు </a:t>
-            </a:r>
-          </a:p>
-          <a:p>
-            <a:pPr marL="0" marR="0" indent="0" algn="ctr" rtl="0" eaLnBrk="1" fontAlgn="auto" latinLnBrk="0" hangingPunct="1">
-              <a:spcBef>
-                <a:spcPts val="0"/>
-              </a:spcBef>
-              <a:spcAft>
-                <a:spcPts val="0"/>
-              </a:spcAft>
-            </a:pPr>
-            <a:r>
-              <a:rPr lang="te-IN" sz="1600" b="0" i="0" dirty="0">
+            </a:br>
+            <a:r>
+              <a:rPr lang="te-IN" b="0" i="0" dirty="0">
                 <a:solidFill>
                   <a:schemeClr val="tx1"/>
                 </a:solidFill>
@@ -4546,10 +4375,10 @@
                 <a:latin typeface="Ramabhadra" panose="02000600000000000000" pitchFamily="2" charset="0"/>
                 <a:cs typeface="Ramabhadra" panose="02000600000000000000" pitchFamily="2" charset="0"/>
               </a:rPr>
-              <a:t>నను మరువనిది నీ కృప</a:t>
+              <a:t>మట్టి దేహమును మహిమతో నింపావు (2)</a:t>
             </a:r>
             <a:br>
-              <a:rPr lang="te-IN" sz="1600" b="0" i="0" dirty="0">
+              <a:rPr lang="te-IN" b="0" i="0" dirty="0">
                 <a:solidFill>
                   <a:schemeClr val="tx1"/>
                 </a:solidFill>
@@ -4559,7 +4388,7 @@
               </a:rPr>
             </a:br>
             <a:r>
-              <a:rPr lang="te-IN" sz="1600" b="0" i="0" dirty="0">
+              <a:rPr lang="te-IN" b="0" i="0" dirty="0">
                 <a:solidFill>
                   <a:schemeClr val="tx1"/>
                 </a:solidFill>
@@ -4567,20 +4396,10 @@
                 <a:latin typeface="Ramabhadra" panose="02000600000000000000" pitchFamily="2" charset="0"/>
                 <a:cs typeface="Ramabhadra" panose="02000600000000000000" pitchFamily="2" charset="0"/>
               </a:rPr>
-              <a:t>నేనీ స్థితిలో ఉన్నానంటే </a:t>
-            </a:r>
-          </a:p>
-          <a:p>
-            <a:pPr marL="0" marR="0" indent="0" algn="ctr" rtl="0" eaLnBrk="1" fontAlgn="auto" latinLnBrk="0" hangingPunct="1">
-              <a:spcBef>
-                <a:spcPts val="0"/>
-              </a:spcBef>
-              <a:spcAft>
-                <a:spcPts val="0"/>
-              </a:spcAft>
-            </a:pPr>
-            <a:r>
-              <a:rPr lang="te-IN" sz="1600" b="0" i="0" dirty="0">
+              <a:t>నీవే కదా దేవుడవు – (2)</a:t>
+            </a:r>
+            <a:br>
+              <a:rPr lang="te-IN" b="0" i="0" dirty="0">
                 <a:solidFill>
                   <a:schemeClr val="tx1"/>
                 </a:solidFill>
@@ -4588,10 +4407,9 @@
                 <a:latin typeface="Ramabhadra" panose="02000600000000000000" pitchFamily="2" charset="0"/>
                 <a:cs typeface="Ramabhadra" panose="02000600000000000000" pitchFamily="2" charset="0"/>
               </a:rPr>
-              <a:t>కేవలము అది నీ కృప (2)</a:t>
-            </a:r>
-            <a:br>
-              <a:rPr lang="te-IN" sz="1600" b="0" i="0" dirty="0">
+            </a:br>
+            <a:r>
+              <a:rPr lang="te-IN" b="0" i="0" dirty="0">
                 <a:solidFill>
                   <a:schemeClr val="tx1"/>
                 </a:solidFill>
@@ -4599,38 +4417,7 @@
                 <a:latin typeface="Ramabhadra" panose="02000600000000000000" pitchFamily="2" charset="0"/>
                 <a:cs typeface="Ramabhadra" panose="02000600000000000000" pitchFamily="2" charset="0"/>
               </a:rPr>
-            </a:br>
-            <a:r>
-              <a:rPr lang="te-IN" sz="1600" b="0" i="0" dirty="0">
-                <a:solidFill>
-                  <a:schemeClr val="tx1"/>
-                </a:solidFill>
-                <a:effectLst/>
-                <a:latin typeface="Ramabhadra" panose="02000600000000000000" pitchFamily="2" charset="0"/>
-                <a:cs typeface="Ramabhadra" panose="02000600000000000000" pitchFamily="2" charset="0"/>
-              </a:rPr>
-              <a:t>నీ కృపయే నాకు ఆధారం</a:t>
-            </a:r>
-            <a:br>
-              <a:rPr lang="te-IN" sz="1600" b="0" i="0" dirty="0">
-                <a:solidFill>
-                  <a:schemeClr val="tx1"/>
-                </a:solidFill>
-                <a:effectLst/>
-                <a:latin typeface="Ramabhadra" panose="02000600000000000000" pitchFamily="2" charset="0"/>
-                <a:cs typeface="Ramabhadra" panose="02000600000000000000" pitchFamily="2" charset="0"/>
-              </a:rPr>
-            </a:br>
-            <a:r>
-              <a:rPr lang="te-IN" sz="1600" b="0" i="0" dirty="0">
-                <a:solidFill>
-                  <a:schemeClr val="tx1"/>
-                </a:solidFill>
-                <a:effectLst/>
-                <a:latin typeface="Ramabhadra" panose="02000600000000000000" pitchFamily="2" charset="0"/>
-                <a:cs typeface="Ramabhadra" panose="02000600000000000000" pitchFamily="2" charset="0"/>
-              </a:rPr>
-              <a:t>      ఆ కృపయే నాకు ఆదరణ (2)</a:t>
+              <a:t>దేవా యేసు దేవా (4)       </a:t>
             </a:r>
           </a:p>
         </p:txBody>
@@ -4658,7 +4445,7 @@
           <a:solidFill>
             <a:schemeClr val="bg1"/>
           </a:solidFill>
-          <a:ln>
+          <a:ln w="28575">
             <a:solidFill>
               <a:schemeClr val="bg1">
                 <a:lumMod val="85000"/>
@@ -4688,7 +4475,7 @@
           <a:p>
             <a:pPr algn="ctr"/>
             <a:r>
-              <a:rPr lang="te-IN" sz="1750" b="0" i="0" dirty="0">
+              <a:rPr lang="te-IN" b="0" i="0" dirty="0">
                 <a:solidFill>
                   <a:srgbClr val="000000"/>
                 </a:solidFill>
@@ -4696,13 +4483,13 @@
                 <a:latin typeface="Ramabhadra" panose="02000600000000000000" pitchFamily="2" charset="0"/>
                 <a:cs typeface="Ramabhadra" panose="02000600000000000000" pitchFamily="2" charset="0"/>
               </a:rPr>
-              <a:t>నీవుంటే నాకు చాలు యేసయ్యా</a:t>
+              <a:t>విన్నపములు వినువాడా</a:t>
             </a:r>
           </a:p>
           <a:p>
             <a:pPr algn="ctr"/>
             <a:r>
-              <a:rPr lang="te-IN" sz="1750" b="0" i="0" dirty="0">
+              <a:rPr lang="te-IN" b="0" i="0" dirty="0">
                 <a:solidFill>
                   <a:srgbClr val="000000"/>
                 </a:solidFill>
@@ -4710,13 +4497,13 @@
                 <a:latin typeface="Ramabhadra" panose="02000600000000000000" pitchFamily="2" charset="0"/>
                 <a:cs typeface="Ramabhadra" panose="02000600000000000000" pitchFamily="2" charset="0"/>
               </a:rPr>
-              <a:t>నీవెంటే నేను ఉంటానేసయ్యా (2)</a:t>
+              <a:t>నా కన్నీరు తుడుచు వాడా </a:t>
             </a:r>
           </a:p>
           <a:p>
             <a:pPr algn="ctr"/>
             <a:r>
-              <a:rPr lang="te-IN" sz="1750" b="0" i="0" dirty="0">
+              <a:rPr lang="te-IN" b="0" i="0" dirty="0">
                 <a:solidFill>
                   <a:srgbClr val="000000"/>
                 </a:solidFill>
@@ -4724,13 +4511,13 @@
                 <a:latin typeface="Ramabhadra" panose="02000600000000000000" pitchFamily="2" charset="0"/>
                 <a:cs typeface="Ramabhadra" panose="02000600000000000000" pitchFamily="2" charset="0"/>
               </a:rPr>
-              <a:t>నీ మాట చాలయ్యా నీ చూపు చాలయ్యా</a:t>
+              <a:t>సుఖములు ఇచ్చువాడా</a:t>
             </a:r>
           </a:p>
           <a:p>
             <a:pPr algn="ctr"/>
             <a:r>
-              <a:rPr lang="te-IN" sz="1750" b="0" i="0" dirty="0">
+              <a:rPr lang="te-IN" b="0" i="0" dirty="0">
                 <a:solidFill>
                   <a:srgbClr val="000000"/>
                 </a:solidFill>
@@ -4738,12 +4525,12 @@
                 <a:latin typeface="Ramabhadra" panose="02000600000000000000" pitchFamily="2" charset="0"/>
                 <a:cs typeface="Ramabhadra" panose="02000600000000000000" pitchFamily="2" charset="0"/>
               </a:rPr>
-              <a:t>నీ తోడు చాలయ్యా నీ నీడ చాలయ్యా (2)</a:t>
+              <a:t>స్తోత్రము యేసయ్యా </a:t>
             </a:r>
           </a:p>
           <a:p>
             <a:pPr algn="ctr"/>
-            <a:endParaRPr lang="te-IN" sz="1750" b="0" i="0" dirty="0">
+            <a:endParaRPr lang="te-IN" b="0" i="0" dirty="0">
               <a:solidFill>
                 <a:srgbClr val="000000"/>
               </a:solidFill>
@@ -4755,7 +4542,7 @@
           <a:p>
             <a:pPr algn="ctr"/>
             <a:r>
-              <a:rPr lang="te-IN" sz="1750" b="0" i="0" dirty="0">
+              <a:rPr lang="te-IN" b="0" i="0" dirty="0">
                 <a:solidFill>
                   <a:srgbClr val="000000"/>
                 </a:solidFill>
@@ -4763,13 +4550,13 @@
                 <a:latin typeface="Ramabhadra" panose="02000600000000000000" pitchFamily="2" charset="0"/>
                 <a:cs typeface="Ramabhadra" panose="02000600000000000000" pitchFamily="2" charset="0"/>
               </a:rPr>
-              <a:t>ఎన్ని బాధలున్ననూ ఇబ్బందులైననూ</a:t>
+              <a:t>నీ నుండియే అన్ని సాధ్యమయ్యా </a:t>
             </a:r>
           </a:p>
           <a:p>
             <a:pPr algn="ctr"/>
             <a:r>
-              <a:rPr lang="te-IN" sz="1750" b="0" i="0" dirty="0">
+              <a:rPr lang="te-IN" b="0" i="0" dirty="0">
                 <a:solidFill>
                   <a:srgbClr val="000000"/>
                 </a:solidFill>
@@ -4777,12 +4564,26 @@
                 <a:latin typeface="Ramabhadra" panose="02000600000000000000" pitchFamily="2" charset="0"/>
                 <a:cs typeface="Ramabhadra" panose="02000600000000000000" pitchFamily="2" charset="0"/>
               </a:rPr>
-              <a:t>ఎంత కష్టమొచ్చినా నిష్టూరమైననూ (2)</a:t>
+              <a:t>మాట ఒకటి చాలునయ్య</a:t>
             </a:r>
           </a:p>
           <a:p>
             <a:pPr algn="ctr"/>
-            <a:endParaRPr lang="te-IN" sz="1750" b="0" i="0" dirty="0">
+            <a:r>
+              <a:rPr lang="te-IN" b="0" i="0" dirty="0">
+                <a:solidFill>
+                  <a:srgbClr val="000000"/>
+                </a:solidFill>
+                <a:effectLst/>
+                <a:latin typeface="Ramabhadra" panose="02000600000000000000" pitchFamily="2" charset="0"/>
+                <a:cs typeface="Ramabhadra" panose="02000600000000000000" pitchFamily="2" charset="0"/>
+              </a:rPr>
+              <a:t>నీ మాట ఒకటి చాలునయ్య </a:t>
+            </a:r>
+          </a:p>
+          <a:p>
+            <a:pPr algn="ctr"/>
+            <a:endParaRPr lang="te-IN" b="0" i="0" dirty="0">
               <a:solidFill>
                 <a:srgbClr val="000000"/>
               </a:solidFill>
@@ -4794,7 +4595,7 @@
           <a:p>
             <a:pPr algn="ctr"/>
             <a:r>
-              <a:rPr lang="te-IN" sz="1750" b="0" i="0" dirty="0">
+              <a:rPr lang="te-IN" b="0" i="0" dirty="0">
                 <a:solidFill>
                   <a:srgbClr val="000000"/>
                 </a:solidFill>
@@ -4802,13 +4603,13 @@
                 <a:latin typeface="Ramabhadra" panose="02000600000000000000" pitchFamily="2" charset="0"/>
                 <a:cs typeface="Ramabhadra" panose="02000600000000000000" pitchFamily="2" charset="0"/>
               </a:rPr>
-              <a:t>బ్రతుకు నావ పగిలినా కడలి పాలైననూ</a:t>
+              <a:t>నా చిత్తమే శుద్ధి పొందు </a:t>
             </a:r>
           </a:p>
           <a:p>
             <a:pPr algn="ctr"/>
             <a:r>
-              <a:rPr lang="te-IN" sz="1750" b="0" i="0" dirty="0">
+              <a:rPr lang="te-IN" b="0" i="0" dirty="0">
                 <a:solidFill>
                   <a:srgbClr val="000000"/>
                 </a:solidFill>
@@ -4816,15 +4617,30 @@
                 <a:latin typeface="Ramabhadra" panose="02000600000000000000" pitchFamily="2" charset="0"/>
                 <a:cs typeface="Ramabhadra" panose="02000600000000000000" pitchFamily="2" charset="0"/>
               </a:rPr>
-              <a:t>అలలు ముంచి వేసినా ఆశలు అనగారినా (2) </a:t>
+              <a:t>అని చెప్పి తాకితివే</a:t>
             </a:r>
           </a:p>
           <a:p>
             <a:pPr algn="ctr"/>
-            <a:endParaRPr lang="te-IN" sz="1750" dirty="0">
+            <a:r>
+              <a:rPr lang="te-IN" b="0" i="0" dirty="0">
+                <a:solidFill>
+                  <a:srgbClr val="000000"/>
+                </a:solidFill>
+                <a:effectLst/>
+                <a:latin typeface="Ramabhadra" panose="02000600000000000000" pitchFamily="2" charset="0"/>
+                <a:cs typeface="Ramabhadra" panose="02000600000000000000" pitchFamily="2" charset="0"/>
+              </a:rPr>
+              <a:t>అయ్యా అని చెప్పి తాకితివే </a:t>
+            </a:r>
+          </a:p>
+          <a:p>
+            <a:pPr algn="ctr"/>
+            <a:endParaRPr lang="te-IN" b="0" i="0" dirty="0">
               <a:solidFill>
                 <a:srgbClr val="000000"/>
               </a:solidFill>
+              <a:effectLst/>
               <a:latin typeface="Ramabhadra" panose="02000600000000000000" pitchFamily="2" charset="0"/>
               <a:cs typeface="Ramabhadra" panose="02000600000000000000" pitchFamily="2" charset="0"/>
             </a:endParaRPr>
@@ -4832,7 +4648,7 @@
           <a:p>
             <a:pPr algn="ctr"/>
             <a:r>
-              <a:rPr lang="te-IN" sz="1750" b="0" i="0" dirty="0">
+              <a:rPr lang="te-IN" b="0" i="0" dirty="0">
                 <a:solidFill>
                   <a:srgbClr val="000000"/>
                 </a:solidFill>
@@ -4840,13 +4656,13 @@
                 <a:latin typeface="Ramabhadra" panose="02000600000000000000" pitchFamily="2" charset="0"/>
                 <a:cs typeface="Ramabhadra" panose="02000600000000000000" pitchFamily="2" charset="0"/>
               </a:rPr>
-              <a:t>ఆస్తులన్నీ పోయినా అనాథగా మిగిలినా</a:t>
+              <a:t>నా వ్యాధిని సిలువ లోనా   </a:t>
             </a:r>
           </a:p>
           <a:p>
             <a:pPr algn="ctr"/>
             <a:r>
-              <a:rPr lang="te-IN" sz="1750" b="0" i="0" dirty="0">
+              <a:rPr lang="te-IN" b="0" i="0" dirty="0">
                 <a:solidFill>
                   <a:srgbClr val="000000"/>
                 </a:solidFill>
@@ -4854,7 +4670,21 @@
                 <a:latin typeface="Ramabhadra" panose="02000600000000000000" pitchFamily="2" charset="0"/>
                 <a:cs typeface="Ramabhadra" panose="02000600000000000000" pitchFamily="2" charset="0"/>
               </a:rPr>
-              <a:t>ఆప్తులే విడనాడినా ఆరోగ్యం క్షీణించినా (2)</a:t>
+              <a:t>నీవుపొంది తీర్చితివే</a:t>
+            </a:r>
+          </a:p>
+          <a:p>
+            <a:pPr algn="ctr"/>
+            <a:r>
+              <a:rPr lang="te-IN" b="0" i="0" dirty="0">
+                <a:solidFill>
+                  <a:srgbClr val="000000"/>
+                </a:solidFill>
+                <a:effectLst/>
+                <a:latin typeface="Ramabhadra" panose="02000600000000000000" pitchFamily="2" charset="0"/>
+                <a:cs typeface="Ramabhadra" panose="02000600000000000000" pitchFamily="2" charset="0"/>
+              </a:rPr>
+              <a:t>అయ్యా నీవుపొంది తీర్చితివే</a:t>
             </a:r>
           </a:p>
         </p:txBody>
@@ -4882,7 +4712,7 @@
           <a:solidFill>
             <a:schemeClr val="bg1"/>
           </a:solidFill>
-          <a:ln>
+          <a:ln w="28575">
             <a:solidFill>
               <a:schemeClr val="bg1">
                 <a:lumMod val="85000"/>
@@ -4912,58 +4742,71 @@
           <a:p>
             <a:pPr algn="ctr" defTabSz="439781"/>
             <a:r>
-              <a:rPr lang="te-IN" sz="1900" dirty="0">
+              <a:rPr lang="te-IN" dirty="0">
                 <a:solidFill>
                   <a:schemeClr val="tx1"/>
                 </a:solidFill>
                 <a:latin typeface="Ramabhadra" panose="02000600000000000000" pitchFamily="2" charset="0"/>
                 <a:cs typeface="Ramabhadra" panose="02000600000000000000" pitchFamily="2" charset="0"/>
               </a:rPr>
-              <a:t>యేసయ్యా నా</a:t>
+              <a:t>స్తుతి పాత్రుడా - స్తోత్రార్హుడా</a:t>
             </a:r>
           </a:p>
           <a:p>
             <a:pPr algn="ctr" defTabSz="439781"/>
             <a:r>
-              <a:rPr lang="te-IN" sz="1900" dirty="0">
+              <a:rPr lang="te-IN" dirty="0">
                 <a:solidFill>
                   <a:schemeClr val="tx1"/>
                 </a:solidFill>
                 <a:latin typeface="Ramabhadra" panose="02000600000000000000" pitchFamily="2" charset="0"/>
                 <a:cs typeface="Ramabhadra" panose="02000600000000000000" pitchFamily="2" charset="0"/>
               </a:rPr>
-              <a:t>హృదయ స్పందన నీవే కదా (2)</a:t>
+              <a:t>స్తుతులందుకో - పూజార్హుడా</a:t>
             </a:r>
           </a:p>
           <a:p>
             <a:pPr algn="ctr" defTabSz="439781"/>
             <a:r>
-              <a:rPr lang="te-IN" sz="1900" dirty="0">
+              <a:rPr lang="te-IN" dirty="0">
                 <a:solidFill>
                   <a:schemeClr val="tx1"/>
                 </a:solidFill>
                 <a:latin typeface="Ramabhadra" panose="02000600000000000000" pitchFamily="2" charset="0"/>
                 <a:cs typeface="Ramabhadra" panose="02000600000000000000" pitchFamily="2" charset="0"/>
               </a:rPr>
-              <a:t>విశ్వమంతా నీ నామము</a:t>
+              <a:t>ఆకాశమందు నీవు తప్ప –</a:t>
             </a:r>
           </a:p>
           <a:p>
             <a:pPr algn="ctr" defTabSz="439781"/>
             <a:r>
-              <a:rPr lang="te-IN" sz="1900" dirty="0">
+              <a:rPr lang="te-IN" dirty="0">
                 <a:solidFill>
                   <a:schemeClr val="tx1"/>
                 </a:solidFill>
                 <a:latin typeface="Ramabhadra" panose="02000600000000000000" pitchFamily="2" charset="0"/>
                 <a:cs typeface="Ramabhadra" panose="02000600000000000000" pitchFamily="2" charset="0"/>
               </a:rPr>
-              <a:t>ఘణనీయము (2)</a:t>
+              <a:t>నాకెవరున్నారు నా ప్రభు</a:t>
             </a:r>
           </a:p>
           <a:p>
             <a:pPr algn="ctr" defTabSz="439781"/>
-            <a:endParaRPr lang="te-IN" sz="1900" dirty="0">
+            <a:r>
+              <a:rPr lang="te-IN" dirty="0">
+                <a:solidFill>
+                  <a:schemeClr val="tx1"/>
+                </a:solidFill>
+                <a:latin typeface="Ramabhadra" panose="02000600000000000000" pitchFamily="2" charset="0"/>
+                <a:cs typeface="Ramabhadra" panose="02000600000000000000" pitchFamily="2" charset="0"/>
+              </a:rPr>
+              <a:t>స్తుతి పాత్రుడా.... ఆఆఅ</a:t>
+            </a:r>
+          </a:p>
+          <a:p>
+            <a:pPr algn="ctr" defTabSz="439781"/>
+            <a:endParaRPr lang="te-IN" dirty="0">
               <a:solidFill>
                 <a:schemeClr val="tx1"/>
               </a:solidFill>
@@ -4974,71 +4817,58 @@
           <a:p>
             <a:pPr algn="ctr" defTabSz="439781"/>
             <a:r>
-              <a:rPr lang="te-IN" sz="1900" dirty="0">
+              <a:rPr lang="te-IN" dirty="0">
                 <a:solidFill>
                   <a:schemeClr val="tx1"/>
                 </a:solidFill>
                 <a:latin typeface="Ramabhadra" panose="02000600000000000000" pitchFamily="2" charset="0"/>
                 <a:cs typeface="Ramabhadra" panose="02000600000000000000" pitchFamily="2" charset="0"/>
               </a:rPr>
-              <a:t>నీవు కనిపించని రోజున</a:t>
+              <a:t>నా శత్రువులు నను తరుముచుండగా –</a:t>
             </a:r>
           </a:p>
           <a:p>
             <a:pPr algn="ctr" defTabSz="439781"/>
             <a:r>
-              <a:rPr lang="te-IN" sz="1900" dirty="0">
+              <a:rPr lang="te-IN" dirty="0">
                 <a:solidFill>
                   <a:schemeClr val="tx1"/>
                 </a:solidFill>
                 <a:latin typeface="Ramabhadra" panose="02000600000000000000" pitchFamily="2" charset="0"/>
                 <a:cs typeface="Ramabhadra" panose="02000600000000000000" pitchFamily="2" charset="0"/>
               </a:rPr>
-              <a:t>ఒక క్షణమొక యుగముగా మారెనే (2)</a:t>
+              <a:t>నా యాత్మ నాలో కృంగెనే ప్రభూ (2)</a:t>
             </a:r>
           </a:p>
           <a:p>
             <a:pPr algn="ctr" defTabSz="439781"/>
             <a:r>
-              <a:rPr lang="te-IN" sz="1900" dirty="0">
+              <a:rPr lang="te-IN" dirty="0">
                 <a:solidFill>
                   <a:schemeClr val="tx1"/>
                 </a:solidFill>
                 <a:latin typeface="Ramabhadra" panose="02000600000000000000" pitchFamily="2" charset="0"/>
                 <a:cs typeface="Ramabhadra" panose="02000600000000000000" pitchFamily="2" charset="0"/>
               </a:rPr>
-              <a:t>నీవు నడిపించిన రోజున</a:t>
+              <a:t>నా మనస్సు నీ వైపు త్రిప్పిన వెంటనే - శత్రుల చేతినుండి</a:t>
             </a:r>
           </a:p>
           <a:p>
             <a:pPr algn="ctr" defTabSz="439781"/>
             <a:r>
-              <a:rPr lang="te-IN" sz="1900" dirty="0">
+              <a:rPr lang="te-IN" dirty="0">
                 <a:solidFill>
                   <a:schemeClr val="tx1"/>
                 </a:solidFill>
                 <a:latin typeface="Ramabhadra" panose="02000600000000000000" pitchFamily="2" charset="0"/>
                 <a:cs typeface="Ramabhadra" panose="02000600000000000000" pitchFamily="2" charset="0"/>
               </a:rPr>
-              <a:t>యుగయుగాల తలపు మది నిండెనే (2)</a:t>
+              <a:t>విడిపించినావు - కాపాడినావు (2)</a:t>
             </a:r>
           </a:p>
           <a:p>
             <a:pPr algn="ctr" defTabSz="439781"/>
-            <a:r>
-              <a:rPr lang="te-IN" sz="1900" dirty="0">
-                <a:solidFill>
-                  <a:schemeClr val="tx1"/>
-                </a:solidFill>
-                <a:latin typeface="Ramabhadra" panose="02000600000000000000" pitchFamily="2" charset="0"/>
-                <a:cs typeface="Ramabhadra" panose="02000600000000000000" pitchFamily="2" charset="0"/>
-              </a:rPr>
-              <a:t>యుగయుగాల తలపు మది నిండెనే</a:t>
-            </a:r>
-          </a:p>
-          <a:p>
-            <a:pPr algn="ctr" defTabSz="439781"/>
-            <a:endParaRPr lang="te-IN" sz="1900" dirty="0">
+            <a:endParaRPr lang="te-IN" dirty="0">
               <a:solidFill>
                 <a:schemeClr val="tx1"/>
               </a:solidFill>
@@ -5049,66 +4879,80 @@
           <a:p>
             <a:pPr algn="ctr" defTabSz="439781"/>
             <a:r>
-              <a:rPr lang="te-IN" sz="1900" dirty="0">
+              <a:rPr lang="te-IN" dirty="0">
                 <a:solidFill>
                   <a:schemeClr val="tx1"/>
                 </a:solidFill>
                 <a:latin typeface="Ramabhadra" panose="02000600000000000000" pitchFamily="2" charset="0"/>
                 <a:cs typeface="Ramabhadra" panose="02000600000000000000" pitchFamily="2" charset="0"/>
               </a:rPr>
-              <a:t>నీవు మాట్లాడని రోజున</a:t>
-            </a:r>
+              <a:t>నా ప్రాణ స్నేహితులు నన్ను చూచి</a:t>
+            </a:r>
+            <a:endParaRPr lang="en-IN" dirty="0">
+              <a:solidFill>
+                <a:schemeClr val="tx1"/>
+              </a:solidFill>
+              <a:latin typeface="Ramabhadra" panose="02000600000000000000" pitchFamily="2" charset="0"/>
+              <a:cs typeface="Ramabhadra" panose="02000600000000000000" pitchFamily="2" charset="0"/>
+            </a:endParaRPr>
           </a:p>
           <a:p>
             <a:pPr algn="ctr" defTabSz="439781"/>
             <a:r>
-              <a:rPr lang="te-IN" sz="1900" dirty="0">
+              <a:rPr lang="te-IN" dirty="0">
                 <a:solidFill>
                   <a:schemeClr val="tx1"/>
                 </a:solidFill>
                 <a:latin typeface="Ramabhadra" panose="02000600000000000000" pitchFamily="2" charset="0"/>
                 <a:cs typeface="Ramabhadra" panose="02000600000000000000" pitchFamily="2" charset="0"/>
               </a:rPr>
-              <a:t>నా కనులకు నిద్దుర కరువాయెనే (2)</a:t>
+              <a:t>దూరాన నిలిచేరు నా ప్రభూ (2)</a:t>
             </a:r>
           </a:p>
           <a:p>
             <a:pPr algn="ctr" defTabSz="439781"/>
             <a:r>
-              <a:rPr lang="te-IN" sz="1900" dirty="0">
+              <a:rPr lang="te-IN" dirty="0">
                 <a:solidFill>
                   <a:schemeClr val="tx1"/>
                 </a:solidFill>
                 <a:latin typeface="Ramabhadra" panose="02000600000000000000" pitchFamily="2" charset="0"/>
                 <a:cs typeface="Ramabhadra" panose="02000600000000000000" pitchFamily="2" charset="0"/>
               </a:rPr>
-              <a:t>నీవు పెదవిప్పిన రోజున</a:t>
-            </a:r>
+              <a:t>నీ వాక్య ధ్యానమే నా త్రోవకు వెలుగై –</a:t>
+            </a:r>
+            <a:endParaRPr lang="en-IN" dirty="0">
+              <a:solidFill>
+                <a:schemeClr val="tx1"/>
+              </a:solidFill>
+              <a:latin typeface="Ramabhadra" panose="02000600000000000000" pitchFamily="2" charset="0"/>
+              <a:cs typeface="Ramabhadra" panose="02000600000000000000" pitchFamily="2" charset="0"/>
+            </a:endParaRPr>
           </a:p>
           <a:p>
             <a:pPr algn="ctr" defTabSz="439781"/>
             <a:r>
-              <a:rPr lang="te-IN" sz="1900" dirty="0">
+              <a:rPr lang="te-IN" dirty="0">
                 <a:solidFill>
                   <a:schemeClr val="tx1"/>
                 </a:solidFill>
                 <a:latin typeface="Ramabhadra" panose="02000600000000000000" pitchFamily="2" charset="0"/>
                 <a:cs typeface="Ramabhadra" panose="02000600000000000000" pitchFamily="2" charset="0"/>
               </a:rPr>
-              <a:t>నీ సన్నిధి పచ్చిక బయలాయెనే (2)</a:t>
+              <a:t>నను నిల్పెను</a:t>
             </a:r>
           </a:p>
           <a:p>
             <a:pPr algn="ctr" defTabSz="439781"/>
             <a:r>
-              <a:rPr lang="te-IN" sz="1900" dirty="0">
+              <a:rPr lang="te-IN" dirty="0">
                 <a:solidFill>
                   <a:schemeClr val="tx1"/>
                 </a:solidFill>
                 <a:latin typeface="Ramabhadra" panose="02000600000000000000" pitchFamily="2" charset="0"/>
                 <a:cs typeface="Ramabhadra" panose="02000600000000000000" pitchFamily="2" charset="0"/>
               </a:rPr>
-              <a:t>నీ సన్నిధి పచ్చిక బయలాయెనే</a:t>
+              <a:t>నీ సన్నీధిలో - నీ సంఘములో (2)</a:t>
             </a:r>
           </a:p>
         </p:txBody>

</xml_diff>

<commit_message>
18 sun 2024 feb
</commit_message>
<xml_diff>
--- a/xerox.pptx
+++ b/xerox.pptx
@@ -224,7 +224,7 @@
           <a:p>
             <a:fld id="{3502DD63-DF8D-4AB8-92A0-0ECCF612C06C}" type="datetimeFigureOut">
               <a:rPr lang="en-IN" smtClean="0"/>
-              <a:t>10-02-2024</a:t>
+              <a:t>18-02-2024</a:t>
             </a:fld>
             <a:endParaRPr lang="en-IN"/>
           </a:p>
@@ -402,7 +402,7 @@
           <a:p>
             <a:fld id="{1AE741EC-1360-4793-999B-941E0396C9FA}" type="datetimeFigureOut">
               <a:rPr lang="en-IN" smtClean="0"/>
-              <a:t>10-02-2024</a:t>
+              <a:t>18-02-2024</a:t>
             </a:fld>
             <a:endParaRPr lang="en-IN"/>
           </a:p>
@@ -802,7 +802,7 @@
           <a:p>
             <a:fld id="{86FBD32F-FCAD-481A-B7D8-4D813FB7DB24}" type="datetimeFigureOut">
               <a:rPr lang="en-IN" smtClean="0"/>
-              <a:t>10-02-2024</a:t>
+              <a:t>18-02-2024</a:t>
             </a:fld>
             <a:endParaRPr lang="en-IN"/>
           </a:p>
@@ -972,7 +972,7 @@
           <a:p>
             <a:fld id="{86FBD32F-FCAD-481A-B7D8-4D813FB7DB24}" type="datetimeFigureOut">
               <a:rPr lang="en-IN" smtClean="0"/>
-              <a:t>10-02-2024</a:t>
+              <a:t>18-02-2024</a:t>
             </a:fld>
             <a:endParaRPr lang="en-IN"/>
           </a:p>
@@ -1152,7 +1152,7 @@
           <a:p>
             <a:fld id="{86FBD32F-FCAD-481A-B7D8-4D813FB7DB24}" type="datetimeFigureOut">
               <a:rPr lang="en-IN" smtClean="0"/>
-              <a:t>10-02-2024</a:t>
+              <a:t>18-02-2024</a:t>
             </a:fld>
             <a:endParaRPr lang="en-IN"/>
           </a:p>
@@ -1322,7 +1322,7 @@
           <a:p>
             <a:fld id="{86FBD32F-FCAD-481A-B7D8-4D813FB7DB24}" type="datetimeFigureOut">
               <a:rPr lang="en-IN" smtClean="0"/>
-              <a:t>10-02-2024</a:t>
+              <a:t>18-02-2024</a:t>
             </a:fld>
             <a:endParaRPr lang="en-IN"/>
           </a:p>
@@ -1566,7 +1566,7 @@
           <a:p>
             <a:fld id="{86FBD32F-FCAD-481A-B7D8-4D813FB7DB24}" type="datetimeFigureOut">
               <a:rPr lang="en-IN" smtClean="0"/>
-              <a:t>10-02-2024</a:t>
+              <a:t>18-02-2024</a:t>
             </a:fld>
             <a:endParaRPr lang="en-IN"/>
           </a:p>
@@ -1798,7 +1798,7 @@
           <a:p>
             <a:fld id="{86FBD32F-FCAD-481A-B7D8-4D813FB7DB24}" type="datetimeFigureOut">
               <a:rPr lang="en-IN" smtClean="0"/>
-              <a:t>10-02-2024</a:t>
+              <a:t>18-02-2024</a:t>
             </a:fld>
             <a:endParaRPr lang="en-IN"/>
           </a:p>
@@ -2165,7 +2165,7 @@
           <a:p>
             <a:fld id="{86FBD32F-FCAD-481A-B7D8-4D813FB7DB24}" type="datetimeFigureOut">
               <a:rPr lang="en-IN" smtClean="0"/>
-              <a:t>10-02-2024</a:t>
+              <a:t>18-02-2024</a:t>
             </a:fld>
             <a:endParaRPr lang="en-IN"/>
           </a:p>
@@ -2283,7 +2283,7 @@
           <a:p>
             <a:fld id="{86FBD32F-FCAD-481A-B7D8-4D813FB7DB24}" type="datetimeFigureOut">
               <a:rPr lang="en-IN" smtClean="0"/>
-              <a:t>10-02-2024</a:t>
+              <a:t>18-02-2024</a:t>
             </a:fld>
             <a:endParaRPr lang="en-IN"/>
           </a:p>
@@ -2378,7 +2378,7 @@
           <a:p>
             <a:fld id="{86FBD32F-FCAD-481A-B7D8-4D813FB7DB24}" type="datetimeFigureOut">
               <a:rPr lang="en-IN" smtClean="0"/>
-              <a:t>10-02-2024</a:t>
+              <a:t>18-02-2024</a:t>
             </a:fld>
             <a:endParaRPr lang="en-IN"/>
           </a:p>
@@ -2655,7 +2655,7 @@
           <a:p>
             <a:fld id="{86FBD32F-FCAD-481A-B7D8-4D813FB7DB24}" type="datetimeFigureOut">
               <a:rPr lang="en-IN" smtClean="0"/>
-              <a:t>10-02-2024</a:t>
+              <a:t>18-02-2024</a:t>
             </a:fld>
             <a:endParaRPr lang="en-IN"/>
           </a:p>
@@ -2912,7 +2912,7 @@
           <a:p>
             <a:fld id="{86FBD32F-FCAD-481A-B7D8-4D813FB7DB24}" type="datetimeFigureOut">
               <a:rPr lang="en-IN" smtClean="0"/>
-              <a:t>10-02-2024</a:t>
+              <a:t>18-02-2024</a:t>
             </a:fld>
             <a:endParaRPr lang="en-IN"/>
           </a:p>
@@ -3125,7 +3125,7 @@
           <a:p>
             <a:fld id="{86FBD32F-FCAD-481A-B7D8-4D813FB7DB24}" type="datetimeFigureOut">
               <a:rPr lang="en-IN" smtClean="0"/>
-              <a:t>10-02-2024</a:t>
+              <a:t>18-02-2024</a:t>
             </a:fld>
             <a:endParaRPr lang="en-IN"/>
           </a:p>
@@ -3606,8 +3606,18 @@
                 <a:latin typeface="Ramabhadra" panose="02000600000000000000" pitchFamily="2" charset="0"/>
                 <a:cs typeface="Ramabhadra" panose="02000600000000000000" pitchFamily="2" charset="0"/>
               </a:rPr>
-              <a:t>ఆరాధన అధిక స్తోత్రము (2)</a:t>
-            </a:r>
+              <a:t>పాడెద నేనొక నూతన గీతం</a:t>
+            </a:r>
+            <a:endParaRPr kumimoji="0" lang="en-IN" sz="2000" i="0" u="none" strike="noStrike" kern="1200" cap="none" spc="0" normalizeH="0" baseline="0" noProof="0" dirty="0">
+              <a:solidFill>
+                <a:schemeClr val="tx1"/>
+              </a:solidFill>
+              <a:effectLst/>
+              <a:uLnTx/>
+              <a:uFillTx/>
+              <a:latin typeface="Ramabhadra" panose="02000600000000000000" pitchFamily="2" charset="0"/>
+              <a:cs typeface="Ramabhadra" panose="02000600000000000000" pitchFamily="2" charset="0"/>
+            </a:endParaRPr>
           </a:p>
           <a:p>
             <a:pPr marL="0" marR="0" lvl="0" indent="0" algn="ctr" defTabSz="439781" rtl="0" eaLnBrk="1" fontAlgn="auto" latinLnBrk="0" hangingPunct="1">
@@ -3635,7 +3645,7 @@
                 <a:latin typeface="Ramabhadra" panose="02000600000000000000" pitchFamily="2" charset="0"/>
                 <a:cs typeface="Ramabhadra" panose="02000600000000000000" pitchFamily="2" charset="0"/>
               </a:rPr>
-              <a:t>నా యేసుకే నేనర్పింతును (2)</a:t>
+              <a:t>పాడెద మనసారా</a:t>
             </a:r>
           </a:p>
           <a:p>
@@ -3664,7 +3674,7 @@
                 <a:latin typeface="Ramabhadra" panose="02000600000000000000" pitchFamily="2" charset="0"/>
                 <a:cs typeface="Ramabhadra" panose="02000600000000000000" pitchFamily="2" charset="0"/>
               </a:rPr>
-              <a:t>నా యేసుకే నా సమస్తము (2)</a:t>
+              <a:t>యేసయ్యా నీ నామమేగాగ వేరొక నామము లేదాయే (2)</a:t>
             </a:r>
           </a:p>
           <a:p>
@@ -3719,8 +3729,18 @@
                 <a:latin typeface="Ramabhadra" panose="02000600000000000000" pitchFamily="2" charset="0"/>
                 <a:cs typeface="Ramabhadra" panose="02000600000000000000" pitchFamily="2" charset="0"/>
               </a:rPr>
-              <a:t>పరమ దూత సైన్యము</a:t>
-            </a:r>
+              <a:t>కలుషితమైన నదియై నేను</a:t>
+            </a:r>
+            <a:endParaRPr kumimoji="0" lang="en-IN" sz="2000" i="0" u="none" strike="noStrike" kern="1200" cap="none" spc="0" normalizeH="0" baseline="0" noProof="0" dirty="0">
+              <a:solidFill>
+                <a:schemeClr val="tx1"/>
+              </a:solidFill>
+              <a:effectLst/>
+              <a:uLnTx/>
+              <a:uFillTx/>
+              <a:latin typeface="Ramabhadra" panose="02000600000000000000" pitchFamily="2" charset="0"/>
+              <a:cs typeface="Ramabhadra" panose="02000600000000000000" pitchFamily="2" charset="0"/>
+            </a:endParaRPr>
           </a:p>
           <a:p>
             <a:pPr marL="0" marR="0" lvl="0" indent="0" algn="ctr" defTabSz="439781" rtl="0" eaLnBrk="1" fontAlgn="auto" latinLnBrk="0" hangingPunct="1">
@@ -3748,7 +3768,7 @@
                 <a:latin typeface="Ramabhadra" panose="02000600000000000000" pitchFamily="2" charset="0"/>
                 <a:cs typeface="Ramabhadra" panose="02000600000000000000" pitchFamily="2" charset="0"/>
               </a:rPr>
-              <a:t>నిన్ను కోరి స్తుతింపగా (2)</a:t>
+              <a:t>కడలియైన నీలో (2)</a:t>
             </a:r>
           </a:p>
           <a:p>
@@ -3777,36 +3797,7 @@
                 <a:latin typeface="Ramabhadra" panose="02000600000000000000" pitchFamily="2" charset="0"/>
                 <a:cs typeface="Ramabhadra" panose="02000600000000000000" pitchFamily="2" charset="0"/>
               </a:rPr>
-              <a:t>వేనోళ్ళతో నే పాడెదన్ (2)</a:t>
-            </a:r>
-          </a:p>
-          <a:p>
-            <a:pPr marL="0" marR="0" lvl="0" indent="0" algn="ctr" defTabSz="439781" rtl="0" eaLnBrk="1" fontAlgn="auto" latinLnBrk="0" hangingPunct="1">
-              <a:spcBef>
-                <a:spcPts val="0"/>
-              </a:spcBef>
-              <a:spcAft>
-                <a:spcPts val="0"/>
-              </a:spcAft>
-              <a:buClrTx/>
-              <a:buSzTx/>
-              <a:buFontTx/>
-              <a:buNone/>
-              <a:tabLst/>
-              <a:defRPr/>
-            </a:pPr>
-            <a:r>
-              <a:rPr kumimoji="0" lang="te-IN" sz="2000" i="0" u="none" strike="noStrike" kern="1200" cap="none" spc="0" normalizeH="0" baseline="0" noProof="0" dirty="0">
-                <a:solidFill>
-                  <a:schemeClr val="tx1"/>
-                </a:solidFill>
-                <a:effectLst/>
-                <a:uLnTx/>
-                <a:uFillTx/>
-                <a:latin typeface="Ramabhadra" panose="02000600000000000000" pitchFamily="2" charset="0"/>
-                <a:cs typeface="Ramabhadra" panose="02000600000000000000" pitchFamily="2" charset="0"/>
-              </a:rPr>
-              <a:t>నే పాపిని నన్ను చేకొనుమా</a:t>
+              <a:t>కలిసిపోతినే కలువరి ధారిలో కనబడదే ఇక పాపాలరాశి (2)</a:t>
             </a:r>
           </a:p>
           <a:p>
@@ -3861,7 +3852,7 @@
                 <a:latin typeface="Ramabhadra" panose="02000600000000000000" pitchFamily="2" charset="0"/>
                 <a:cs typeface="Ramabhadra" panose="02000600000000000000" pitchFamily="2" charset="0"/>
               </a:rPr>
-              <a:t>కరుణ ధార రుధిరము</a:t>
+              <a:t>పోరు తరగని సిగ సెగలన్నియు - అణచి కృపాతిశయము (2)</a:t>
             </a:r>
           </a:p>
           <a:p>
@@ -3890,104 +3881,7 @@
                 <a:latin typeface="Ramabhadra" panose="02000600000000000000" pitchFamily="2" charset="0"/>
                 <a:cs typeface="Ramabhadra" panose="02000600000000000000" pitchFamily="2" charset="0"/>
               </a:rPr>
-              <a:t>నన్ను తాకి ప్రవహింపగా (2)</a:t>
-            </a:r>
-          </a:p>
-          <a:p>
-            <a:pPr marL="0" marR="0" lvl="0" indent="0" algn="ctr" defTabSz="439781" rtl="0" eaLnBrk="1" fontAlgn="auto" latinLnBrk="0" hangingPunct="1">
-              <a:spcBef>
-                <a:spcPts val="0"/>
-              </a:spcBef>
-              <a:spcAft>
-                <a:spcPts val="0"/>
-              </a:spcAft>
-              <a:buClrTx/>
-              <a:buSzTx/>
-              <a:buFontTx/>
-              <a:buNone/>
-              <a:tabLst/>
-              <a:defRPr/>
-            </a:pPr>
-            <a:r>
-              <a:rPr kumimoji="0" lang="te-IN" sz="2000" i="0" u="none" strike="noStrike" kern="1200" cap="none" spc="0" normalizeH="0" baseline="0" noProof="0" dirty="0">
-                <a:solidFill>
-                  <a:schemeClr val="tx1"/>
-                </a:solidFill>
-                <a:effectLst/>
-                <a:uLnTx/>
-                <a:uFillTx/>
-                <a:latin typeface="Ramabhadra" panose="02000600000000000000" pitchFamily="2" charset="0"/>
-                <a:cs typeface="Ramabhadra" panose="02000600000000000000" pitchFamily="2" charset="0"/>
-              </a:rPr>
-              <a:t>నా పాపమంతయు</a:t>
-            </a:r>
-            <a:endParaRPr kumimoji="0" lang="en-US" sz="2000" i="0" u="none" strike="noStrike" kern="1200" cap="none" spc="0" normalizeH="0" baseline="0" noProof="0" dirty="0">
-              <a:solidFill>
-                <a:schemeClr val="tx1"/>
-              </a:solidFill>
-              <a:effectLst/>
-              <a:uLnTx/>
-              <a:uFillTx/>
-              <a:latin typeface="Ramabhadra" panose="02000600000000000000" pitchFamily="2" charset="0"/>
-              <a:cs typeface="Ramabhadra" panose="02000600000000000000" pitchFamily="2" charset="0"/>
-            </a:endParaRPr>
-          </a:p>
-          <a:p>
-            <a:pPr marL="0" marR="0" lvl="0" indent="0" algn="ctr" defTabSz="439781" rtl="0" eaLnBrk="1" fontAlgn="auto" latinLnBrk="0" hangingPunct="1">
-              <a:spcBef>
-                <a:spcPts val="0"/>
-              </a:spcBef>
-              <a:spcAft>
-                <a:spcPts val="0"/>
-              </a:spcAft>
-              <a:buClrTx/>
-              <a:buSzTx/>
-              <a:buFontTx/>
-              <a:buNone/>
-              <a:tabLst/>
-              <a:defRPr/>
-            </a:pPr>
-            <a:r>
-              <a:rPr kumimoji="0" lang="te-IN" sz="2000" i="0" u="none" strike="noStrike" kern="1200" cap="none" spc="0" normalizeH="0" baseline="0" noProof="0" dirty="0">
-                <a:solidFill>
-                  <a:schemeClr val="tx1"/>
-                </a:solidFill>
-                <a:effectLst/>
-                <a:uLnTx/>
-                <a:uFillTx/>
-                <a:latin typeface="Ramabhadra" panose="02000600000000000000" pitchFamily="2" charset="0"/>
-                <a:cs typeface="Ramabhadra" panose="02000600000000000000" pitchFamily="2" charset="0"/>
-              </a:rPr>
-              <a:t>తొలగిపోయెను (2)</a:t>
-            </a:r>
-          </a:p>
-          <a:p>
-            <a:pPr marL="0" marR="0" lvl="0" indent="0" algn="ctr" defTabSz="439781" rtl="0" eaLnBrk="1" fontAlgn="auto" latinLnBrk="0" hangingPunct="1">
-              <a:spcBef>
-                <a:spcPts val="0"/>
-              </a:spcBef>
-              <a:spcAft>
-                <a:spcPts val="0"/>
-              </a:spcAft>
-              <a:buClrTx/>
-              <a:buSzTx/>
-              <a:buFontTx/>
-              <a:buNone/>
-              <a:tabLst/>
-              <a:defRPr/>
-            </a:pPr>
-            <a:r>
-              <a:rPr kumimoji="0" lang="te-IN" sz="2000" i="0" u="none" strike="noStrike" kern="1200" cap="none" spc="0" normalizeH="0" baseline="0" noProof="0" dirty="0">
-                <a:solidFill>
-                  <a:schemeClr val="tx1"/>
-                </a:solidFill>
-                <a:effectLst/>
-                <a:uLnTx/>
-                <a:uFillTx/>
-                <a:latin typeface="Ramabhadra" panose="02000600000000000000" pitchFamily="2" charset="0"/>
-                <a:cs typeface="Ramabhadra" panose="02000600000000000000" pitchFamily="2" charset="0"/>
-              </a:rPr>
-              <a:t>నా జీవితం నీకే అంకితం</a:t>
+              <a:t>కొదువైన నానా హృదయములోన పొంగెనే అభిషేకతైలం (2)</a:t>
             </a:r>
           </a:p>
         </p:txBody>
@@ -4052,7 +3946,7 @@
               </a:spcAft>
             </a:pPr>
             <a:r>
-              <a:rPr lang="te-IN" sz="1250" b="0" i="0" dirty="0">
+              <a:rPr lang="te-IN" sz="1600" b="0" i="0" dirty="0">
                 <a:solidFill>
                   <a:schemeClr val="tx1"/>
                 </a:solidFill>
@@ -4060,7 +3954,7 @@
                 <a:latin typeface="Ramabhadra" panose="02000600000000000000" pitchFamily="2" charset="0"/>
                 <a:cs typeface="Ramabhadra" panose="02000600000000000000" pitchFamily="2" charset="0"/>
               </a:rPr>
-              <a:t>నీవే కృపాదారము… త్రియేక దేవా</a:t>
+              <a:t>స్తుతి సింహాసనాసీనుడా</a:t>
             </a:r>
           </a:p>
           <a:p>
@@ -4073,7 +3967,7 @@
               </a:spcAft>
             </a:pPr>
             <a:r>
-              <a:rPr lang="te-IN" sz="1250" b="0" i="0" dirty="0">
+              <a:rPr lang="te-IN" sz="1600" b="0" i="0" dirty="0">
                 <a:solidFill>
                   <a:schemeClr val="tx1"/>
                 </a:solidFill>
@@ -4081,7 +3975,7 @@
                 <a:latin typeface="Ramabhadra" panose="02000600000000000000" pitchFamily="2" charset="0"/>
                 <a:cs typeface="Ramabhadra" panose="02000600000000000000" pitchFamily="2" charset="0"/>
               </a:rPr>
-              <a:t>నీవే క్షేమాదారము… నా యేసయ్యా</a:t>
+              <a:t>యేసు రాజా దివ్య తేజా (2)</a:t>
             </a:r>
           </a:p>
           <a:p>
@@ -4093,17 +3987,14 @@
                 <a:spcPts val="0"/>
               </a:spcAft>
             </a:pPr>
-            <a:r>
-              <a:rPr lang="te-IN" sz="1250" b="0" i="0" dirty="0">
-                <a:solidFill>
-                  <a:schemeClr val="tx1"/>
-                </a:solidFill>
-                <a:effectLst/>
-                <a:latin typeface="Ramabhadra" panose="02000600000000000000" pitchFamily="2" charset="0"/>
-                <a:cs typeface="Ramabhadra" panose="02000600000000000000" pitchFamily="2" charset="0"/>
-              </a:rPr>
-              <a:t>నూతన బలమును… నవనూతన కృపను</a:t>
-            </a:r>
+            <a:endParaRPr lang="te-IN" sz="1600" b="0" i="0" dirty="0">
+              <a:solidFill>
+                <a:schemeClr val="tx1"/>
+              </a:solidFill>
+              <a:effectLst/>
+              <a:latin typeface="Ramabhadra" panose="02000600000000000000" pitchFamily="2" charset="0"/>
+              <a:cs typeface="Ramabhadra" panose="02000600000000000000" pitchFamily="2" charset="0"/>
+            </a:endParaRPr>
           </a:p>
           <a:p>
             <a:pPr marL="0" marR="0" indent="0" algn="ctr" rtl="0" eaLnBrk="1" fontAlgn="auto" latinLnBrk="0" hangingPunct="1">
@@ -4115,7 +4006,7 @@
               </a:spcAft>
             </a:pPr>
             <a:r>
-              <a:rPr lang="te-IN" sz="1250" b="0" i="0" dirty="0">
+              <a:rPr lang="te-IN" sz="1600" b="0" i="0" dirty="0">
                 <a:solidFill>
                   <a:schemeClr val="tx1"/>
                 </a:solidFill>
@@ -4123,7 +4014,7 @@
                 <a:latin typeface="Ramabhadra" panose="02000600000000000000" pitchFamily="2" charset="0"/>
                 <a:cs typeface="Ramabhadra" panose="02000600000000000000" pitchFamily="2" charset="0"/>
               </a:rPr>
-              <a:t>నూతన బలమును… నవనూతన కృపను</a:t>
+              <a:t>అద్వితీయుడవు పరిశుద్ధుడవు</a:t>
             </a:r>
           </a:p>
           <a:p>
@@ -4136,7 +4027,7 @@
               </a:spcAft>
             </a:pPr>
             <a:r>
-              <a:rPr lang="te-IN" sz="1250" b="0" i="0" dirty="0">
+              <a:rPr lang="te-IN" sz="1600" b="0" i="0" dirty="0">
                 <a:solidFill>
                   <a:schemeClr val="tx1"/>
                 </a:solidFill>
@@ -4144,7 +4035,7 @@
                 <a:latin typeface="Ramabhadra" panose="02000600000000000000" pitchFamily="2" charset="0"/>
                 <a:cs typeface="Ramabhadra" panose="02000600000000000000" pitchFamily="2" charset="0"/>
               </a:rPr>
-              <a:t>నేటి వరకు దయచేయుచున్నావు</a:t>
+              <a:t>అతి సుందరుడవు నీవే ప్రభూ (2)</a:t>
             </a:r>
           </a:p>
           <a:p>
@@ -4157,7 +4048,7 @@
               </a:spcAft>
             </a:pPr>
             <a:r>
-              <a:rPr lang="te-IN" sz="1250" b="0" i="0" dirty="0">
+              <a:rPr lang="te-IN" sz="1600" b="0" i="0" dirty="0">
                 <a:solidFill>
                   <a:schemeClr val="tx1"/>
                 </a:solidFill>
@@ -4165,7 +4056,7 @@
                 <a:latin typeface="Ramabhadra" panose="02000600000000000000" pitchFamily="2" charset="0"/>
                 <a:cs typeface="Ramabhadra" panose="02000600000000000000" pitchFamily="2" charset="0"/>
               </a:rPr>
-              <a:t>నిన్నే ఆరాధింతును పరిశుద్ధుడా</a:t>
+              <a:t>నీతి న్యాయములు నీ సింహాసనాధారం (2)</a:t>
             </a:r>
           </a:p>
           <a:p>
@@ -4178,7 +4069,7 @@
               </a:spcAft>
             </a:pPr>
             <a:r>
-              <a:rPr lang="te-IN" sz="1250" b="0" i="0" dirty="0">
+              <a:rPr lang="te-IN" sz="1600" b="0" i="0" dirty="0">
                 <a:solidFill>
                   <a:schemeClr val="tx1"/>
                 </a:solidFill>
@@ -4186,16 +4077,8 @@
                 <a:latin typeface="Ramabhadra" panose="02000600000000000000" pitchFamily="2" charset="0"/>
                 <a:cs typeface="Ramabhadra" panose="02000600000000000000" pitchFamily="2" charset="0"/>
               </a:rPr>
-              <a:t>ఈ స్తోత్రగీతం నీకేనయ్యా</a:t>
-            </a:r>
-            <a:endParaRPr lang="en-US" sz="1250" b="0" i="0" dirty="0">
-              <a:solidFill>
-                <a:schemeClr val="tx1"/>
-              </a:solidFill>
-              <a:effectLst/>
-              <a:latin typeface="Ramabhadra" panose="02000600000000000000" pitchFamily="2" charset="0"/>
-              <a:cs typeface="Ramabhadra" panose="02000600000000000000" pitchFamily="2" charset="0"/>
-            </a:endParaRPr>
+              <a:t>కృపా సత్యములు నీ సన్నిధానవర్తులు (2)</a:t>
+            </a:r>
           </a:p>
           <a:p>
             <a:pPr marL="0" marR="0" indent="0" algn="ctr" rtl="0" eaLnBrk="1" fontAlgn="auto" latinLnBrk="0" hangingPunct="1">
@@ -4206,10 +4089,11 @@
                 <a:spcPts val="0"/>
               </a:spcAft>
             </a:pPr>
-            <a:endParaRPr lang="en-US" sz="1250" dirty="0">
+            <a:endParaRPr lang="te-IN" sz="1600" b="0" i="0" dirty="0">
               <a:solidFill>
                 <a:schemeClr val="tx1"/>
               </a:solidFill>
+              <a:effectLst/>
               <a:latin typeface="Ramabhadra" panose="02000600000000000000" pitchFamily="2" charset="0"/>
               <a:cs typeface="Ramabhadra" panose="02000600000000000000" pitchFamily="2" charset="0"/>
             </a:endParaRPr>
@@ -4224,7 +4108,7 @@
               </a:spcAft>
             </a:pPr>
             <a:r>
-              <a:rPr lang="te-IN" sz="1250" b="0" i="0" dirty="0">
+              <a:rPr lang="te-IN" sz="1600" b="0" i="0" dirty="0">
                 <a:solidFill>
                   <a:schemeClr val="tx1"/>
                 </a:solidFill>
@@ -4232,7 +4116,7 @@
                 <a:latin typeface="Ramabhadra" panose="02000600000000000000" pitchFamily="2" charset="0"/>
                 <a:cs typeface="Ramabhadra" panose="02000600000000000000" pitchFamily="2" charset="0"/>
               </a:rPr>
-              <a:t>ఆనందించితిని అనురాగబంధాల… ఆశ్రయపురమైన నీలో నేను</a:t>
+              <a:t>బలియు అర్పణ కోరవు నీవు</a:t>
             </a:r>
           </a:p>
           <a:p>
@@ -4245,7 +4129,7 @@
               </a:spcAft>
             </a:pPr>
             <a:r>
-              <a:rPr lang="te-IN" sz="1250" b="0" i="0" dirty="0">
+              <a:rPr lang="te-IN" sz="1600" b="0" i="0" dirty="0">
                 <a:solidFill>
                   <a:schemeClr val="tx1"/>
                 </a:solidFill>
@@ -4253,7 +4137,7 @@
                 <a:latin typeface="Ramabhadra" panose="02000600000000000000" pitchFamily="2" charset="0"/>
                 <a:cs typeface="Ramabhadra" panose="02000600000000000000" pitchFamily="2" charset="0"/>
               </a:rPr>
-              <a:t>ఆకర్షించితిని ఆకాశముకంటే… ఉన్నతమైన నీ ప్రేమను చూపి</a:t>
+              <a:t>బలియైతివి నా దోషముకై (2)</a:t>
             </a:r>
           </a:p>
           <a:p>
@@ -4266,7 +4150,7 @@
               </a:spcAft>
             </a:pPr>
             <a:r>
-              <a:rPr lang="te-IN" sz="1250" b="0" i="0" dirty="0">
+              <a:rPr lang="te-IN" sz="1600" b="0" i="0" dirty="0">
                 <a:solidFill>
                   <a:schemeClr val="tx1"/>
                 </a:solidFill>
@@ -4274,7 +4158,7 @@
                 <a:latin typeface="Ramabhadra" panose="02000600000000000000" pitchFamily="2" charset="0"/>
                 <a:cs typeface="Ramabhadra" panose="02000600000000000000" pitchFamily="2" charset="0"/>
               </a:rPr>
-              <a:t>ఆపదలెన్నో అలుముకున్నను… అభయమునిచ్చితివి</a:t>
+              <a:t>నా హృదయమే నీ ప్రియమగు ఆలయం (2)</a:t>
             </a:r>
           </a:p>
           <a:p>
@@ -4287,7 +4171,7 @@
               </a:spcAft>
             </a:pPr>
             <a:r>
-              <a:rPr lang="te-IN" sz="1250" b="0" i="0" dirty="0">
+              <a:rPr lang="te-IN" sz="1600" b="0" i="0" dirty="0">
                 <a:solidFill>
                   <a:schemeClr val="tx1"/>
                 </a:solidFill>
@@ -4295,7 +4179,7 @@
                 <a:latin typeface="Ramabhadra" panose="02000600000000000000" pitchFamily="2" charset="0"/>
                 <a:cs typeface="Ramabhadra" panose="02000600000000000000" pitchFamily="2" charset="0"/>
               </a:rPr>
-              <a:t>ఆవేదనల అగ్నిజ్వాలలో… అండగా నిలచితివి</a:t>
+              <a:t>స్తుతియాగమునే చేసెద నిరతం (2)</a:t>
             </a:r>
           </a:p>
           <a:p>
@@ -4307,17 +4191,14 @@
                 <a:spcPts val="0"/>
               </a:spcAft>
             </a:pPr>
-            <a:r>
-              <a:rPr lang="te-IN" sz="1250" b="0" i="0" dirty="0">
-                <a:solidFill>
-                  <a:schemeClr val="tx1"/>
-                </a:solidFill>
-                <a:effectLst/>
-                <a:latin typeface="Ramabhadra" panose="02000600000000000000" pitchFamily="2" charset="0"/>
-                <a:cs typeface="Ramabhadra" panose="02000600000000000000" pitchFamily="2" charset="0"/>
-              </a:rPr>
-              <a:t>ఆలోచనవై ఆశ్రయమిచ్చి… కాపాడుచున్నావు</a:t>
-            </a:r>
+            <a:endParaRPr lang="te-IN" sz="1600" b="0" i="0" dirty="0">
+              <a:solidFill>
+                <a:schemeClr val="tx1"/>
+              </a:solidFill>
+              <a:effectLst/>
+              <a:latin typeface="Ramabhadra" panose="02000600000000000000" pitchFamily="2" charset="0"/>
+              <a:cs typeface="Ramabhadra" panose="02000600000000000000" pitchFamily="2" charset="0"/>
+            </a:endParaRPr>
           </a:p>
           <a:p>
             <a:pPr marL="0" marR="0" indent="0" algn="ctr" rtl="0" eaLnBrk="1" fontAlgn="auto" latinLnBrk="0" hangingPunct="1">
@@ -4329,7 +4210,7 @@
               </a:spcAft>
             </a:pPr>
             <a:r>
-              <a:rPr lang="te-IN" sz="1250" b="0" i="0" dirty="0">
+              <a:rPr lang="te-IN" sz="1600" b="0" i="0" dirty="0">
                 <a:solidFill>
                   <a:schemeClr val="tx1"/>
                 </a:solidFill>
@@ -4337,16 +4218,8 @@
                 <a:latin typeface="Ramabhadra" panose="02000600000000000000" pitchFamily="2" charset="0"/>
                 <a:cs typeface="Ramabhadra" panose="02000600000000000000" pitchFamily="2" charset="0"/>
               </a:rPr>
-              <a:t>నీకే ఈ ప్రేమ గీతం అంకితమయ్యా… ఈ స్తోత్ర గీతం నీకేనయ్యా</a:t>
-            </a:r>
-            <a:endParaRPr lang="en-US" sz="1250" b="0" i="0" dirty="0">
-              <a:solidFill>
-                <a:schemeClr val="tx1"/>
-              </a:solidFill>
-              <a:effectLst/>
-              <a:latin typeface="Ramabhadra" panose="02000600000000000000" pitchFamily="2" charset="0"/>
-              <a:cs typeface="Ramabhadra" panose="02000600000000000000" pitchFamily="2" charset="0"/>
-            </a:endParaRPr>
+              <a:t>బూరధ్వనులే నింగిలో మ్రోగగా</a:t>
+            </a:r>
           </a:p>
           <a:p>
             <a:pPr marL="0" marR="0" indent="0" algn="ctr" rtl="0" eaLnBrk="1" fontAlgn="auto" latinLnBrk="0" hangingPunct="1">
@@ -4357,13 +4230,17 @@
                 <a:spcPts val="0"/>
               </a:spcAft>
             </a:pPr>
-            <a:endParaRPr lang="en-US" sz="1250" dirty="0">
-              <a:solidFill>
-                <a:schemeClr val="tx1"/>
-              </a:solidFill>
-              <a:latin typeface="Ramabhadra" panose="02000600000000000000" pitchFamily="2" charset="0"/>
-              <a:cs typeface="Ramabhadra" panose="02000600000000000000" pitchFamily="2" charset="0"/>
-            </a:endParaRPr>
+            <a:r>
+              <a:rPr lang="te-IN" sz="1600" b="0" i="0" dirty="0">
+                <a:solidFill>
+                  <a:schemeClr val="tx1"/>
+                </a:solidFill>
+                <a:effectLst/>
+                <a:latin typeface="Ramabhadra" panose="02000600000000000000" pitchFamily="2" charset="0"/>
+                <a:cs typeface="Ramabhadra" panose="02000600000000000000" pitchFamily="2" charset="0"/>
+              </a:rPr>
+              <a:t>రాజధిరాజ నీవే వచ్చువేళ (2)</a:t>
+            </a:r>
           </a:p>
           <a:p>
             <a:pPr marL="0" marR="0" indent="0" algn="ctr" rtl="0" eaLnBrk="1" fontAlgn="auto" latinLnBrk="0" hangingPunct="1">
@@ -4375,7 +4252,7 @@
               </a:spcAft>
             </a:pPr>
             <a:r>
-              <a:rPr lang="te-IN" sz="1250" b="0" i="0" dirty="0">
+              <a:rPr lang="te-IN" sz="1600" b="0" i="0" dirty="0">
                 <a:solidFill>
                   <a:schemeClr val="tx1"/>
                 </a:solidFill>
@@ -4383,7 +4260,7 @@
                 <a:latin typeface="Ramabhadra" panose="02000600000000000000" pitchFamily="2" charset="0"/>
                 <a:cs typeface="Ramabhadra" panose="02000600000000000000" pitchFamily="2" charset="0"/>
               </a:rPr>
-              <a:t>సర్వకృపానిధి సీయోను పురవాసి</a:t>
+              <a:t>సంసిద్ధతతో వెలిగే సిద్దెతో (2)</a:t>
             </a:r>
           </a:p>
           <a:p>
@@ -4396,7 +4273,7 @@
               </a:spcAft>
             </a:pPr>
             <a:r>
-              <a:rPr lang="te-IN" sz="1250" b="0" i="0" dirty="0">
+              <a:rPr lang="te-IN" sz="1600" b="0" i="0" dirty="0">
                 <a:solidFill>
                   <a:schemeClr val="tx1"/>
                 </a:solidFill>
@@ -4404,163 +4281,7 @@
                 <a:latin typeface="Ramabhadra" panose="02000600000000000000" pitchFamily="2" charset="0"/>
                 <a:cs typeface="Ramabhadra" panose="02000600000000000000" pitchFamily="2" charset="0"/>
               </a:rPr>
-              <a:t>నీ స్వాస్థ్యముకై నన్ను పిలచితివి </a:t>
-            </a:r>
-            <a:r>
-              <a:rPr lang="en-US" sz="1250" b="0" i="0" dirty="0">
-                <a:solidFill>
-                  <a:schemeClr val="tx1"/>
-                </a:solidFill>
-                <a:effectLst/>
-                <a:latin typeface="Ramabhadra" panose="02000600000000000000" pitchFamily="2" charset="0"/>
-                <a:cs typeface="Ramabhadra" panose="02000600000000000000" pitchFamily="2" charset="0"/>
-              </a:rPr>
-              <a:t>(2)</a:t>
-            </a:r>
-          </a:p>
-          <a:p>
-            <a:pPr marL="0" marR="0" indent="0" algn="ctr" rtl="0" eaLnBrk="1" fontAlgn="auto" latinLnBrk="0" hangingPunct="1">
-              <a:spcBef>
-                <a:spcPts val="0"/>
-              </a:spcBef>
-              <a:spcAft>
-                <a:spcPts val="0"/>
-              </a:spcAft>
-            </a:pPr>
-            <a:r>
-              <a:rPr lang="te-IN" sz="1250" b="0" i="0" dirty="0">
-                <a:solidFill>
-                  <a:schemeClr val="tx1"/>
-                </a:solidFill>
-                <a:effectLst/>
-                <a:latin typeface="Ramabhadra" panose="02000600000000000000" pitchFamily="2" charset="0"/>
-                <a:cs typeface="Ramabhadra" panose="02000600000000000000" pitchFamily="2" charset="0"/>
-              </a:rPr>
-              <a:t>సిలువను మోయుచు నీ చిత్తమును</a:t>
-            </a:r>
-          </a:p>
-          <a:p>
-            <a:pPr marL="0" marR="0" indent="0" algn="ctr" rtl="0" eaLnBrk="1" fontAlgn="auto" latinLnBrk="0" hangingPunct="1">
-              <a:spcBef>
-                <a:spcPts val="0"/>
-              </a:spcBef>
-              <a:spcAft>
-                <a:spcPts val="0"/>
-              </a:spcAft>
-            </a:pPr>
-            <a:r>
-              <a:rPr lang="te-IN" sz="1250" b="0" i="0" dirty="0">
-                <a:solidFill>
-                  <a:schemeClr val="tx1"/>
-                </a:solidFill>
-                <a:effectLst/>
-                <a:latin typeface="Ramabhadra" panose="02000600000000000000" pitchFamily="2" charset="0"/>
-                <a:cs typeface="Ramabhadra" panose="02000600000000000000" pitchFamily="2" charset="0"/>
-              </a:rPr>
-              <a:t>నెరవేర్చెదను సహనముకలిగి </a:t>
-            </a:r>
-            <a:r>
-              <a:rPr lang="en-US" sz="1250" b="0" i="0" dirty="0">
-                <a:solidFill>
-                  <a:schemeClr val="tx1"/>
-                </a:solidFill>
-                <a:effectLst/>
-                <a:latin typeface="Ramabhadra" panose="02000600000000000000" pitchFamily="2" charset="0"/>
-                <a:cs typeface="Ramabhadra" panose="02000600000000000000" pitchFamily="2" charset="0"/>
-              </a:rPr>
-              <a:t>(2)</a:t>
-            </a:r>
-            <a:endParaRPr lang="te-IN" sz="1250" b="0" i="0" dirty="0">
-              <a:solidFill>
-                <a:schemeClr val="tx1"/>
-              </a:solidFill>
-              <a:effectLst/>
-              <a:latin typeface="Ramabhadra" panose="02000600000000000000" pitchFamily="2" charset="0"/>
-              <a:cs typeface="Ramabhadra" panose="02000600000000000000" pitchFamily="2" charset="0"/>
-            </a:endParaRPr>
-          </a:p>
-          <a:p>
-            <a:pPr marL="0" marR="0" indent="0" algn="ctr" rtl="0" eaLnBrk="1" fontAlgn="auto" latinLnBrk="0" hangingPunct="1">
-              <a:spcBef>
-                <a:spcPts val="0"/>
-              </a:spcBef>
-              <a:spcAft>
-                <a:spcPts val="0"/>
-              </a:spcAft>
-            </a:pPr>
-            <a:r>
-              <a:rPr lang="te-IN" sz="1250" b="0" i="0" dirty="0">
-                <a:solidFill>
-                  <a:schemeClr val="tx1"/>
-                </a:solidFill>
-                <a:effectLst/>
-                <a:latin typeface="Ramabhadra" panose="02000600000000000000" pitchFamily="2" charset="0"/>
-                <a:cs typeface="Ramabhadra" panose="02000600000000000000" pitchFamily="2" charset="0"/>
-              </a:rPr>
-              <a:t>శిధిలముకానీ సంపదలెన్నో… నాకై దాచితివీ</a:t>
-            </a:r>
-          </a:p>
-          <a:p>
-            <a:pPr marL="0" marR="0" indent="0" algn="ctr" rtl="0" eaLnBrk="1" fontAlgn="auto" latinLnBrk="0" hangingPunct="1">
-              <a:spcBef>
-                <a:spcPts val="0"/>
-              </a:spcBef>
-              <a:spcAft>
-                <a:spcPts val="0"/>
-              </a:spcAft>
-            </a:pPr>
-            <a:r>
-              <a:rPr lang="te-IN" sz="1250" b="0" i="0" dirty="0">
-                <a:solidFill>
-                  <a:schemeClr val="tx1"/>
-                </a:solidFill>
-                <a:effectLst/>
-                <a:latin typeface="Ramabhadra" panose="02000600000000000000" pitchFamily="2" charset="0"/>
-                <a:cs typeface="Ramabhadra" panose="02000600000000000000" pitchFamily="2" charset="0"/>
-              </a:rPr>
-              <a:t>సాహసమైన గొప్ప కార్యములు… నాకై చేసితివీ</a:t>
-            </a:r>
-          </a:p>
-          <a:p>
-            <a:pPr marL="0" marR="0" indent="0" algn="ctr" rtl="0" eaLnBrk="1" fontAlgn="auto" latinLnBrk="0" hangingPunct="1">
-              <a:spcBef>
-                <a:spcPts val="0"/>
-              </a:spcBef>
-              <a:spcAft>
-                <a:spcPts val="0"/>
-              </a:spcAft>
-            </a:pPr>
-            <a:r>
-              <a:rPr lang="te-IN" sz="1250" b="0" i="0" dirty="0">
-                <a:solidFill>
-                  <a:schemeClr val="tx1"/>
-                </a:solidFill>
-                <a:effectLst/>
-                <a:latin typeface="Ramabhadra" panose="02000600000000000000" pitchFamily="2" charset="0"/>
-                <a:cs typeface="Ramabhadra" panose="02000600000000000000" pitchFamily="2" charset="0"/>
-              </a:rPr>
-              <a:t>సర్వశక్తిగల దేవుడవై… నడిపించుచున్నావు</a:t>
-            </a:r>
-          </a:p>
-          <a:p>
-            <a:pPr marL="0" marR="0" indent="0" algn="ctr" rtl="0" eaLnBrk="1" fontAlgn="auto" latinLnBrk="0" hangingPunct="1">
-              <a:spcBef>
-                <a:spcPts val="0"/>
-              </a:spcBef>
-              <a:spcAft>
-                <a:spcPts val="0"/>
-              </a:spcAft>
-            </a:pPr>
-            <a:r>
-              <a:rPr lang="te-IN" sz="1250" b="0" i="0" dirty="0">
-                <a:solidFill>
-                  <a:schemeClr val="tx1"/>
-                </a:solidFill>
-                <a:effectLst/>
-                <a:latin typeface="Ramabhadra" panose="02000600000000000000" pitchFamily="2" charset="0"/>
-                <a:cs typeface="Ramabhadra" panose="02000600000000000000" pitchFamily="2" charset="0"/>
-              </a:rPr>
-              <a:t>నిన్నే ఆరాధింతును పరిశుద్ధుడా… ఈ స్తోత్రగీతం నీకేనయ్యా</a:t>
+              <a:t>పెండ్లి కుమరుడా నిన్నెదుర్కొందును (2)</a:t>
             </a:r>
           </a:p>
         </p:txBody>
@@ -4626,16 +4347,8 @@
                 <a:latin typeface="Ramabhadra" panose="02000600000000000000" pitchFamily="2" charset="0"/>
                 <a:cs typeface="Ramabhadra" panose="02000600000000000000" pitchFamily="2" charset="0"/>
               </a:rPr>
-              <a:t>సుమధుర స్వరముల గానాలతో</a:t>
-            </a:r>
-            <a:endParaRPr lang="en-US" sz="1500" b="0" i="0" dirty="0">
-              <a:solidFill>
-                <a:srgbClr val="000000"/>
-              </a:solidFill>
-              <a:effectLst/>
-              <a:latin typeface="Ramabhadra" panose="02000600000000000000" pitchFamily="2" charset="0"/>
-              <a:cs typeface="Ramabhadra" panose="02000600000000000000" pitchFamily="2" charset="0"/>
-            </a:endParaRPr>
+              <a:t>ఎడబాయని నీ కృప</a:t>
+            </a:r>
           </a:p>
           <a:p>
             <a:pPr algn="ctr"/>
@@ -4648,7 +4361,7 @@
                 <a:latin typeface="Ramabhadra" panose="02000600000000000000" pitchFamily="2" charset="0"/>
                 <a:cs typeface="Ramabhadra" panose="02000600000000000000" pitchFamily="2" charset="0"/>
               </a:rPr>
-              <a:t>వేలాది దూతల గళములతో</a:t>
+              <a:t>నను విడువదు ఎన్నటికీ (2)</a:t>
             </a:r>
           </a:p>
           <a:p>
@@ -4662,16 +4375,8 @@
                 <a:latin typeface="Ramabhadra" panose="02000600000000000000" pitchFamily="2" charset="0"/>
                 <a:cs typeface="Ramabhadra" panose="02000600000000000000" pitchFamily="2" charset="0"/>
               </a:rPr>
-              <a:t>కొనియాడబడుచున్న నా యేసయ్యా</a:t>
-            </a:r>
-            <a:endParaRPr lang="en-US" sz="1500" b="0" i="0" dirty="0">
-              <a:solidFill>
-                <a:srgbClr val="000000"/>
-              </a:solidFill>
-              <a:effectLst/>
-              <a:latin typeface="Ramabhadra" panose="02000600000000000000" pitchFamily="2" charset="0"/>
-              <a:cs typeface="Ramabhadra" panose="02000600000000000000" pitchFamily="2" charset="0"/>
-            </a:endParaRPr>
+              <a:t>యేసయ్యా నీ ప్రేమానురాగం</a:t>
+            </a:r>
           </a:p>
           <a:p>
             <a:pPr algn="ctr"/>
@@ -4684,38 +4389,10 @@
                 <a:latin typeface="Ramabhadra" panose="02000600000000000000" pitchFamily="2" charset="0"/>
                 <a:cs typeface="Ramabhadra" panose="02000600000000000000" pitchFamily="2" charset="0"/>
               </a:rPr>
-              <a:t>నీకే నా ఆరాధన (2)</a:t>
-            </a:r>
-          </a:p>
-          <a:p>
-            <a:pPr algn="ctr"/>
-            <a:r>
-              <a:rPr lang="te-IN" sz="1500" b="0" i="0" dirty="0">
-                <a:solidFill>
-                  <a:srgbClr val="000000"/>
-                </a:solidFill>
-                <a:effectLst/>
-                <a:latin typeface="Ramabhadra" panose="02000600000000000000" pitchFamily="2" charset="0"/>
-                <a:cs typeface="Ramabhadra" panose="02000600000000000000" pitchFamily="2" charset="0"/>
-              </a:rPr>
-              <a:t>మహదానందమే నాలో పరవశమే</a:t>
-            </a:r>
-          </a:p>
-          <a:p>
-            <a:pPr algn="ctr"/>
-            <a:r>
-              <a:rPr lang="te-IN" sz="1500" b="0" i="0" dirty="0">
-                <a:solidFill>
-                  <a:srgbClr val="000000"/>
-                </a:solidFill>
-                <a:effectLst/>
-                <a:latin typeface="Ramabhadra" panose="02000600000000000000" pitchFamily="2" charset="0"/>
-                <a:cs typeface="Ramabhadra" panose="02000600000000000000" pitchFamily="2" charset="0"/>
-              </a:rPr>
-              <a:t>నిన్ను స్తుతించిన ప్రతీక్షణం (2</a:t>
-            </a:r>
-            <a:r>
-              <a:rPr lang="en-US" sz="1500" b="0" i="0" dirty="0">
+              <a:t>నను కాయును అనుక్షణం (2</a:t>
+            </a:r>
+            <a:r>
+              <a:rPr lang="en-IN" sz="1500" b="0" i="0" dirty="0">
                 <a:solidFill>
                   <a:srgbClr val="000000"/>
                 </a:solidFill>
@@ -4756,9 +4433,79 @@
                 <a:latin typeface="Ramabhadra" panose="02000600000000000000" pitchFamily="2" charset="0"/>
                 <a:cs typeface="Ramabhadra" panose="02000600000000000000" pitchFamily="2" charset="0"/>
               </a:rPr>
-              <a:t>ఎడారి త్రోవలో నే నడిచినా</a:t>
-            </a:r>
-            <a:endParaRPr lang="en-US" sz="1500" b="0" i="0" dirty="0">
+              <a:t>శోకపు లోయలలో – కష్టాల కడగండ్లలో</a:t>
+            </a:r>
+          </a:p>
+          <a:p>
+            <a:pPr algn="ctr"/>
+            <a:r>
+              <a:rPr lang="te-IN" sz="1500" b="0" i="0" dirty="0">
+                <a:solidFill>
+                  <a:srgbClr val="000000"/>
+                </a:solidFill>
+                <a:effectLst/>
+                <a:latin typeface="Ramabhadra" panose="02000600000000000000" pitchFamily="2" charset="0"/>
+                <a:cs typeface="Ramabhadra" panose="02000600000000000000" pitchFamily="2" charset="0"/>
+              </a:rPr>
+              <a:t>కడలేని కడలిలో – నిరాశ నిసృహలో (2)</a:t>
+            </a:r>
+          </a:p>
+          <a:p>
+            <a:pPr algn="ctr"/>
+            <a:r>
+              <a:rPr lang="te-IN" sz="1500" b="0" i="0" dirty="0">
+                <a:solidFill>
+                  <a:srgbClr val="000000"/>
+                </a:solidFill>
+                <a:effectLst/>
+                <a:latin typeface="Ramabhadra" panose="02000600000000000000" pitchFamily="2" charset="0"/>
+                <a:cs typeface="Ramabhadra" panose="02000600000000000000" pitchFamily="2" charset="0"/>
+              </a:rPr>
+              <a:t>అర్ధమేకాని ఈ జీవితం</a:t>
+            </a:r>
+          </a:p>
+          <a:p>
+            <a:pPr algn="ctr"/>
+            <a:r>
+              <a:rPr lang="te-IN" sz="1500" b="0" i="0" dirty="0">
+                <a:solidFill>
+                  <a:srgbClr val="000000"/>
+                </a:solidFill>
+                <a:effectLst/>
+                <a:latin typeface="Ramabhadra" panose="02000600000000000000" pitchFamily="2" charset="0"/>
+                <a:cs typeface="Ramabhadra" panose="02000600000000000000" pitchFamily="2" charset="0"/>
+              </a:rPr>
+              <a:t>ఇక వ్యర్థమని నేననుకొనగ (2)</a:t>
+            </a:r>
+          </a:p>
+          <a:p>
+            <a:pPr algn="ctr"/>
+            <a:r>
+              <a:rPr lang="te-IN" sz="1500" b="0" i="0" dirty="0">
+                <a:solidFill>
+                  <a:srgbClr val="000000"/>
+                </a:solidFill>
+                <a:effectLst/>
+                <a:latin typeface="Ramabhadra" panose="02000600000000000000" pitchFamily="2" charset="0"/>
+                <a:cs typeface="Ramabhadra" panose="02000600000000000000" pitchFamily="2" charset="0"/>
+              </a:rPr>
+              <a:t>కృపా కనికరముగల దేవా</a:t>
+            </a:r>
+          </a:p>
+          <a:p>
+            <a:pPr algn="ctr"/>
+            <a:r>
+              <a:rPr lang="te-IN" sz="1500" b="0" i="0" dirty="0">
+                <a:solidFill>
+                  <a:srgbClr val="000000"/>
+                </a:solidFill>
+                <a:effectLst/>
+                <a:latin typeface="Ramabhadra" panose="02000600000000000000" pitchFamily="2" charset="0"/>
+                <a:cs typeface="Ramabhadra" panose="02000600000000000000" pitchFamily="2" charset="0"/>
+              </a:rPr>
+              <a:t>నా కష్టాల కడలిని దాటించితివి (2)</a:t>
+            </a:r>
+            <a:endParaRPr lang="en-IN" sz="1500" b="0" i="0" dirty="0">
               <a:solidFill>
                 <a:srgbClr val="000000"/>
               </a:solidFill>
@@ -4766,84 +4513,6 @@
               <a:latin typeface="Ramabhadra" panose="02000600000000000000" pitchFamily="2" charset="0"/>
               <a:cs typeface="Ramabhadra" panose="02000600000000000000" pitchFamily="2" charset="0"/>
             </a:endParaRPr>
-          </a:p>
-          <a:p>
-            <a:pPr algn="ctr"/>
-            <a:r>
-              <a:rPr lang="te-IN" sz="1500" b="0" i="0" dirty="0">
-                <a:solidFill>
-                  <a:srgbClr val="000000"/>
-                </a:solidFill>
-                <a:effectLst/>
-                <a:latin typeface="Ramabhadra" panose="02000600000000000000" pitchFamily="2" charset="0"/>
-                <a:cs typeface="Ramabhadra" panose="02000600000000000000" pitchFamily="2" charset="0"/>
-              </a:rPr>
-              <a:t>ఎరుగని మార్గములో నను నడిపినా</a:t>
-            </a:r>
-          </a:p>
-          <a:p>
-            <a:pPr algn="ctr"/>
-            <a:r>
-              <a:rPr lang="te-IN" sz="1500" b="0" i="0" dirty="0">
-                <a:solidFill>
-                  <a:srgbClr val="000000"/>
-                </a:solidFill>
-                <a:effectLst/>
-                <a:latin typeface="Ramabhadra" panose="02000600000000000000" pitchFamily="2" charset="0"/>
-                <a:cs typeface="Ramabhadra" panose="02000600000000000000" pitchFamily="2" charset="0"/>
-              </a:rPr>
-              <a:t>నా ముందు నడచిన జయవీరుడా</a:t>
-            </a:r>
-            <a:endParaRPr lang="en-US" sz="1500" b="0" i="0" dirty="0">
-              <a:solidFill>
-                <a:srgbClr val="000000"/>
-              </a:solidFill>
-              <a:effectLst/>
-              <a:latin typeface="Ramabhadra" panose="02000600000000000000" pitchFamily="2" charset="0"/>
-              <a:cs typeface="Ramabhadra" panose="02000600000000000000" pitchFamily="2" charset="0"/>
-            </a:endParaRPr>
-          </a:p>
-          <a:p>
-            <a:pPr algn="ctr"/>
-            <a:r>
-              <a:rPr lang="te-IN" sz="1500" b="0" i="0" dirty="0">
-                <a:solidFill>
-                  <a:srgbClr val="000000"/>
-                </a:solidFill>
-                <a:effectLst/>
-                <a:latin typeface="Ramabhadra" panose="02000600000000000000" pitchFamily="2" charset="0"/>
-                <a:cs typeface="Ramabhadra" panose="02000600000000000000" pitchFamily="2" charset="0"/>
-              </a:rPr>
-              <a:t>నా విజయ సంకేతమా (2)</a:t>
-            </a:r>
-          </a:p>
-          <a:p>
-            <a:pPr algn="ctr"/>
-            <a:r>
-              <a:rPr lang="te-IN" sz="1500" b="0" i="0" dirty="0">
-                <a:solidFill>
-                  <a:srgbClr val="000000"/>
-                </a:solidFill>
-                <a:effectLst/>
-                <a:latin typeface="Ramabhadra" panose="02000600000000000000" pitchFamily="2" charset="0"/>
-                <a:cs typeface="Ramabhadra" panose="02000600000000000000" pitchFamily="2" charset="0"/>
-              </a:rPr>
-              <a:t>నీవే నీవే – నా ఆనందము</a:t>
-            </a:r>
-          </a:p>
-          <a:p>
-            <a:pPr algn="ctr"/>
-            <a:r>
-              <a:rPr lang="te-IN" sz="1500" b="0" i="0" dirty="0">
-                <a:solidFill>
-                  <a:srgbClr val="000000"/>
-                </a:solidFill>
-                <a:effectLst/>
-                <a:latin typeface="Ramabhadra" panose="02000600000000000000" pitchFamily="2" charset="0"/>
-                <a:cs typeface="Ramabhadra" panose="02000600000000000000" pitchFamily="2" charset="0"/>
-              </a:rPr>
-              <a:t>నీవే నీవే – నా ఆధారము (2)</a:t>
-            </a:r>
           </a:p>
           <a:p>
             <a:pPr algn="ctr"/>
@@ -4867,16 +4536,8 @@
                 <a:latin typeface="Ramabhadra" panose="02000600000000000000" pitchFamily="2" charset="0"/>
                 <a:cs typeface="Ramabhadra" panose="02000600000000000000" pitchFamily="2" charset="0"/>
               </a:rPr>
-              <a:t>సంపూర్ణమైన నీ చిత్తమే</a:t>
-            </a:r>
-            <a:endParaRPr lang="en-US" sz="1500" b="0" i="0" dirty="0">
-              <a:solidFill>
-                <a:srgbClr val="000000"/>
-              </a:solidFill>
-              <a:effectLst/>
-              <a:latin typeface="Ramabhadra" panose="02000600000000000000" pitchFamily="2" charset="0"/>
-              <a:cs typeface="Ramabhadra" panose="02000600000000000000" pitchFamily="2" charset="0"/>
-            </a:endParaRPr>
+              <a:t>విశ్వాస పోరాటంలో – ఎదురాయె శోధనలు</a:t>
+            </a:r>
           </a:p>
           <a:p>
             <a:pPr algn="ctr"/>
@@ -4889,7 +4550,7 @@
                 <a:latin typeface="Ramabhadra" panose="02000600000000000000" pitchFamily="2" charset="0"/>
                 <a:cs typeface="Ramabhadra" panose="02000600000000000000" pitchFamily="2" charset="0"/>
               </a:rPr>
-              <a:t>అనుకూలమైన సంకల్పమే</a:t>
+              <a:t>లోకాశల అలజడిలో – సడలితి విశ్వాసములో (2)</a:t>
             </a:r>
           </a:p>
           <a:p>
@@ -4903,16 +4564,8 @@
                 <a:latin typeface="Ramabhadra" panose="02000600000000000000" pitchFamily="2" charset="0"/>
                 <a:cs typeface="Ramabhadra" panose="02000600000000000000" pitchFamily="2" charset="0"/>
               </a:rPr>
-              <a:t>జరిగించుచున్నావు నను విడువక</a:t>
-            </a:r>
-            <a:endParaRPr lang="en-US" sz="1500" b="0" i="0" dirty="0">
-              <a:solidFill>
-                <a:srgbClr val="000000"/>
-              </a:solidFill>
-              <a:effectLst/>
-              <a:latin typeface="Ramabhadra" panose="02000600000000000000" pitchFamily="2" charset="0"/>
-              <a:cs typeface="Ramabhadra" panose="02000600000000000000" pitchFamily="2" charset="0"/>
-            </a:endParaRPr>
+              <a:t>దుష్టుల క్షేమమునే చూచి</a:t>
+            </a:r>
           </a:p>
           <a:p>
             <a:pPr algn="ctr"/>
@@ -4925,7 +4578,7 @@
                 <a:latin typeface="Ramabhadra" panose="02000600000000000000" pitchFamily="2" charset="0"/>
                 <a:cs typeface="Ramabhadra" panose="02000600000000000000" pitchFamily="2" charset="0"/>
               </a:rPr>
-              <a:t>నా ధైర్యము నీవేగా (2)</a:t>
+              <a:t>ఇక నీతి వ్యర్థమని అనుకొనగ (2)</a:t>
             </a:r>
           </a:p>
           <a:p>
@@ -4939,7 +4592,7 @@
                 <a:latin typeface="Ramabhadra" panose="02000600000000000000" pitchFamily="2" charset="0"/>
                 <a:cs typeface="Ramabhadra" panose="02000600000000000000" pitchFamily="2" charset="0"/>
               </a:rPr>
-              <a:t>నీవే నీవే – నా జయగీతము</a:t>
+              <a:t>దీర్ఘశాంతముగల దేవా</a:t>
             </a:r>
           </a:p>
           <a:p>
@@ -4953,7 +4606,7 @@
                 <a:latin typeface="Ramabhadra" panose="02000600000000000000" pitchFamily="2" charset="0"/>
                 <a:cs typeface="Ramabhadra" panose="02000600000000000000" pitchFamily="2" charset="0"/>
               </a:rPr>
-              <a:t>నీవే నీవే – నా స్తుతిగీతము (2)</a:t>
+              <a:t>నా చేయి విడువక నడిపించితివి (2) </a:t>
             </a:r>
           </a:p>
         </p:txBody>
@@ -5018,9 +4671,12 @@
                 <a:latin typeface="Ramabhadra" panose="02000600000000000000" pitchFamily="2" charset="0"/>
                 <a:cs typeface="Ramabhadra" panose="02000600000000000000" pitchFamily="2" charset="0"/>
               </a:rPr>
-              <a:t>శుభవేళ – స్తోత్రబలి</a:t>
-            </a:r>
-            <a:br>
+              <a:t>పరమున ఆలయం నిరతం నీవేగా</a:t>
+            </a:r>
+          </a:p>
+          <a:p>
+            <a:pPr algn="ctr" defTabSz="439781"/>
+            <a:r>
               <a:rPr lang="te-IN" dirty="0">
                 <a:solidFill>
                   <a:schemeClr val="tx1"/>
@@ -5028,7 +4684,11 @@
                 <a:latin typeface="Ramabhadra" panose="02000600000000000000" pitchFamily="2" charset="0"/>
                 <a:cs typeface="Ramabhadra" panose="02000600000000000000" pitchFamily="2" charset="0"/>
               </a:rPr>
-            </a:br>
+              <a:t>సరి సాటి రారు ప్రభువా</a:t>
+            </a:r>
+          </a:p>
+          <a:p>
+            <a:pPr algn="ctr" defTabSz="439781"/>
             <a:r>
               <a:rPr lang="te-IN" dirty="0">
                 <a:solidFill>
@@ -5037,9 +4697,12 @@
                 <a:latin typeface="Ramabhadra" panose="02000600000000000000" pitchFamily="2" charset="0"/>
                 <a:cs typeface="Ramabhadra" panose="02000600000000000000" pitchFamily="2" charset="0"/>
               </a:rPr>
-              <a:t>తండ్రీ దేవా – నీకేనయ్యా</a:t>
-            </a:r>
-            <a:br>
+              <a:t>నీ సన్నిధి కాంతికి</a:t>
+            </a:r>
+          </a:p>
+          <a:p>
+            <a:pPr algn="ctr" defTabSz="439781"/>
+            <a:r>
               <a:rPr lang="te-IN" dirty="0">
                 <a:solidFill>
                   <a:schemeClr val="tx1"/>
@@ -5047,54 +4710,7 @@
                 <a:latin typeface="Ramabhadra" panose="02000600000000000000" pitchFamily="2" charset="0"/>
                 <a:cs typeface="Ramabhadra" panose="02000600000000000000" pitchFamily="2" charset="0"/>
               </a:rPr>
-            </a:br>
-            <a:r>
-              <a:rPr lang="te-IN" dirty="0">
-                <a:solidFill>
-                  <a:schemeClr val="tx1"/>
-                </a:solidFill>
-                <a:latin typeface="Ramabhadra" panose="02000600000000000000" pitchFamily="2" charset="0"/>
-                <a:cs typeface="Ramabhadra" panose="02000600000000000000" pitchFamily="2" charset="0"/>
-              </a:rPr>
-              <a:t>ఆరాధన – స్తోత్రబలి</a:t>
-            </a:r>
-            <a:br>
-              <a:rPr lang="te-IN" dirty="0">
-                <a:solidFill>
-                  <a:schemeClr val="tx1"/>
-                </a:solidFill>
-                <a:latin typeface="Ramabhadra" panose="02000600000000000000" pitchFamily="2" charset="0"/>
-                <a:cs typeface="Ramabhadra" panose="02000600000000000000" pitchFamily="2" charset="0"/>
-              </a:rPr>
-            </a:br>
-            <a:r>
-              <a:rPr lang="te-IN" dirty="0">
-                <a:solidFill>
-                  <a:schemeClr val="tx1"/>
-                </a:solidFill>
-                <a:latin typeface="Ramabhadra" panose="02000600000000000000" pitchFamily="2" charset="0"/>
-                <a:cs typeface="Ramabhadra" panose="02000600000000000000" pitchFamily="2" charset="0"/>
-              </a:rPr>
-              <a:t>తండ్రీ దేవా – నీకేనయ్యా</a:t>
-            </a:r>
-            <a:br>
-              <a:rPr lang="te-IN" dirty="0">
-                <a:solidFill>
-                  <a:schemeClr val="tx1"/>
-                </a:solidFill>
-                <a:latin typeface="Ramabhadra" panose="02000600000000000000" pitchFamily="2" charset="0"/>
-                <a:cs typeface="Ramabhadra" panose="02000600000000000000" pitchFamily="2" charset="0"/>
-              </a:rPr>
-            </a:br>
-            <a:r>
-              <a:rPr lang="te-IN" dirty="0">
-                <a:solidFill>
-                  <a:schemeClr val="tx1"/>
-                </a:solidFill>
-                <a:latin typeface="Ramabhadra" panose="02000600000000000000" pitchFamily="2" charset="0"/>
-                <a:cs typeface="Ramabhadra" panose="02000600000000000000" pitchFamily="2" charset="0"/>
-              </a:rPr>
-              <a:t>తండ్రీ దేవా – నీకేనయ్యా (2) </a:t>
+              <a:t>గొరెపిల్ల మహిమకు (2) </a:t>
             </a:r>
           </a:p>
           <a:p>
@@ -5117,7 +4733,7 @@
                 <a:latin typeface="Ramabhadra" panose="02000600000000000000" pitchFamily="2" charset="0"/>
                 <a:cs typeface="Ramabhadra" panose="02000600000000000000" pitchFamily="2" charset="0"/>
               </a:rPr>
-              <a:t>ఎల్ షడ్డాయ్ – ఎల్ షడ్డాయ్ </a:t>
+              <a:t>ఉండదు దుఃఖమచట</a:t>
             </a:r>
           </a:p>
           <a:p>
@@ -5130,9 +4746,12 @@
                 <a:latin typeface="Ramabhadra" panose="02000600000000000000" pitchFamily="2" charset="0"/>
                 <a:cs typeface="Ramabhadra" panose="02000600000000000000" pitchFamily="2" charset="0"/>
               </a:rPr>
-              <a:t> సర్వ శక్తిమంతుడా (2)</a:t>
-            </a:r>
-            <a:br>
+              <a:t>ఉండును దేవుడు </a:t>
+            </a:r>
+          </a:p>
+          <a:p>
+            <a:pPr algn="ctr" defTabSz="439781"/>
+            <a:r>
               <a:rPr lang="te-IN" dirty="0">
                 <a:solidFill>
                   <a:schemeClr val="tx1"/>
@@ -5140,7 +4759,11 @@
                 <a:latin typeface="Ramabhadra" panose="02000600000000000000" pitchFamily="2" charset="0"/>
                 <a:cs typeface="Ramabhadra" panose="02000600000000000000" pitchFamily="2" charset="0"/>
               </a:rPr>
-            </a:br>
+              <a:t>తుడిచి వేయును కన్నీటి బాధలు (2)</a:t>
+            </a:r>
+          </a:p>
+          <a:p>
+            <a:pPr algn="ctr" defTabSz="439781"/>
             <a:r>
               <a:rPr lang="te-IN" dirty="0">
                 <a:solidFill>
@@ -5149,7 +4772,7 @@
                 <a:latin typeface="Ramabhadra" panose="02000600000000000000" pitchFamily="2" charset="0"/>
                 <a:cs typeface="Ramabhadra" panose="02000600000000000000" pitchFamily="2" charset="0"/>
               </a:rPr>
-              <a:t>సర్వ శక్తిమంతుడా </a:t>
+              <a:t>అది అంతము ఆయనే</a:t>
             </a:r>
           </a:p>
           <a:p>
@@ -5162,18 +4785,8 @@
                 <a:latin typeface="Ramabhadra" panose="02000600000000000000" pitchFamily="2" charset="0"/>
                 <a:cs typeface="Ramabhadra" panose="02000600000000000000" pitchFamily="2" charset="0"/>
               </a:rPr>
-              <a:t>ఎల్ షడ్డాయ్ ఎల్ షడ్డాయ్ (2) </a:t>
-            </a:r>
-          </a:p>
-          <a:p>
-            <a:pPr algn="ctr" defTabSz="439781"/>
-            <a:endParaRPr lang="te-IN" dirty="0">
-              <a:solidFill>
-                <a:schemeClr val="tx1"/>
-              </a:solidFill>
-              <a:latin typeface="Ramabhadra" panose="02000600000000000000" pitchFamily="2" charset="0"/>
-              <a:cs typeface="Ramabhadra" panose="02000600000000000000" pitchFamily="2" charset="0"/>
-            </a:endParaRPr>
+              <a:t>జీవ జలముల ఊటయు</a:t>
+            </a:r>
           </a:p>
           <a:p>
             <a:pPr algn="ctr" defTabSz="439781"/>
@@ -5185,7 +4798,7 @@
                 <a:latin typeface="Ramabhadra" panose="02000600000000000000" pitchFamily="2" charset="0"/>
                 <a:cs typeface="Ramabhadra" panose="02000600000000000000" pitchFamily="2" charset="0"/>
               </a:rPr>
-              <a:t>ఎల్ రోయి – ఎల్ రోయి </a:t>
+              <a:t> </a:t>
             </a:r>
           </a:p>
           <a:p>
@@ -5198,9 +4811,12 @@
                 <a:latin typeface="Ramabhadra" panose="02000600000000000000" pitchFamily="2" charset="0"/>
                 <a:cs typeface="Ramabhadra" panose="02000600000000000000" pitchFamily="2" charset="0"/>
               </a:rPr>
-              <a:t>నన్నిల చూచువాడా (2)</a:t>
-            </a:r>
-            <a:br>
+              <a:t>తండ్రి భూమి మీద</a:t>
+            </a:r>
+          </a:p>
+          <a:p>
+            <a:pPr algn="ctr" defTabSz="439781"/>
+            <a:r>
               <a:rPr lang="te-IN" dirty="0">
                 <a:solidFill>
                   <a:schemeClr val="tx1"/>
@@ -5208,7 +4824,11 @@
                 <a:latin typeface="Ramabhadra" panose="02000600000000000000" pitchFamily="2" charset="0"/>
                 <a:cs typeface="Ramabhadra" panose="02000600000000000000" pitchFamily="2" charset="0"/>
               </a:rPr>
-            </a:br>
+              <a:t>తన చిత్తము జరిపెను</a:t>
+            </a:r>
+          </a:p>
+          <a:p>
+            <a:pPr algn="ctr" defTabSz="439781"/>
             <a:r>
               <a:rPr lang="te-IN" dirty="0">
                 <a:solidFill>
@@ -5217,7 +4837,7 @@
                 <a:latin typeface="Ramabhadra" panose="02000600000000000000" pitchFamily="2" charset="0"/>
                 <a:cs typeface="Ramabhadra" panose="02000600000000000000" pitchFamily="2" charset="0"/>
               </a:rPr>
-              <a:t>నన్నిల చూచువాడా </a:t>
+              <a:t>వ్యాధి లేమీయు</a:t>
             </a:r>
           </a:p>
           <a:p>
@@ -5230,7 +4850,33 @@
                 <a:latin typeface="Ramabhadra" panose="02000600000000000000" pitchFamily="2" charset="0"/>
                 <a:cs typeface="Ramabhadra" panose="02000600000000000000" pitchFamily="2" charset="0"/>
               </a:rPr>
-              <a:t>ఎల్ రోయి ఎల్ రోయి (2)</a:t>
+              <a:t>మన పదముల్ తాకెను (2)</a:t>
+            </a:r>
+          </a:p>
+          <a:p>
+            <a:pPr algn="ctr" defTabSz="439781"/>
+            <a:r>
+              <a:rPr lang="te-IN" dirty="0">
+                <a:solidFill>
+                  <a:schemeClr val="tx1"/>
+                </a:solidFill>
+                <a:latin typeface="Ramabhadra" panose="02000600000000000000" pitchFamily="2" charset="0"/>
+                <a:cs typeface="Ramabhadra" panose="02000600000000000000" pitchFamily="2" charset="0"/>
+              </a:rPr>
+              <a:t>జయించి మరణమున్</a:t>
+            </a:r>
+          </a:p>
+          <a:p>
+            <a:pPr algn="ctr" defTabSz="439781"/>
+            <a:r>
+              <a:rPr lang="te-IN" dirty="0">
+                <a:solidFill>
+                  <a:schemeClr val="tx1"/>
+                </a:solidFill>
+                <a:latin typeface="Ramabhadra" panose="02000600000000000000" pitchFamily="2" charset="0"/>
+                <a:cs typeface="Ramabhadra" panose="02000600000000000000" pitchFamily="2" charset="0"/>
+              </a:rPr>
+              <a:t>నిత్య జీవము నిచ్చెను</a:t>
             </a:r>
           </a:p>
         </p:txBody>

</xml_diff>

<commit_message>
03 march sunday sogns
</commit_message>
<xml_diff>
--- a/xerox.pptx
+++ b/xerox.pptx
@@ -224,7 +224,7 @@
           <a:p>
             <a:fld id="{3502DD63-DF8D-4AB8-92A0-0ECCF612C06C}" type="datetimeFigureOut">
               <a:rPr lang="en-IN" smtClean="0"/>
-              <a:t>21-02-2024</a:t>
+              <a:t>02-03-2024</a:t>
             </a:fld>
             <a:endParaRPr lang="en-IN"/>
           </a:p>
@@ -402,7 +402,7 @@
           <a:p>
             <a:fld id="{1AE741EC-1360-4793-999B-941E0396C9FA}" type="datetimeFigureOut">
               <a:rPr lang="en-IN" smtClean="0"/>
-              <a:t>21-02-2024</a:t>
+              <a:t>02-03-2024</a:t>
             </a:fld>
             <a:endParaRPr lang="en-IN"/>
           </a:p>
@@ -802,7 +802,7 @@
           <a:p>
             <a:fld id="{86FBD32F-FCAD-481A-B7D8-4D813FB7DB24}" type="datetimeFigureOut">
               <a:rPr lang="en-IN" smtClean="0"/>
-              <a:t>21-02-2024</a:t>
+              <a:t>02-03-2024</a:t>
             </a:fld>
             <a:endParaRPr lang="en-IN"/>
           </a:p>
@@ -972,7 +972,7 @@
           <a:p>
             <a:fld id="{86FBD32F-FCAD-481A-B7D8-4D813FB7DB24}" type="datetimeFigureOut">
               <a:rPr lang="en-IN" smtClean="0"/>
-              <a:t>21-02-2024</a:t>
+              <a:t>02-03-2024</a:t>
             </a:fld>
             <a:endParaRPr lang="en-IN"/>
           </a:p>
@@ -1152,7 +1152,7 @@
           <a:p>
             <a:fld id="{86FBD32F-FCAD-481A-B7D8-4D813FB7DB24}" type="datetimeFigureOut">
               <a:rPr lang="en-IN" smtClean="0"/>
-              <a:t>21-02-2024</a:t>
+              <a:t>02-03-2024</a:t>
             </a:fld>
             <a:endParaRPr lang="en-IN"/>
           </a:p>
@@ -1322,7 +1322,7 @@
           <a:p>
             <a:fld id="{86FBD32F-FCAD-481A-B7D8-4D813FB7DB24}" type="datetimeFigureOut">
               <a:rPr lang="en-IN" smtClean="0"/>
-              <a:t>21-02-2024</a:t>
+              <a:t>02-03-2024</a:t>
             </a:fld>
             <a:endParaRPr lang="en-IN"/>
           </a:p>
@@ -1566,7 +1566,7 @@
           <a:p>
             <a:fld id="{86FBD32F-FCAD-481A-B7D8-4D813FB7DB24}" type="datetimeFigureOut">
               <a:rPr lang="en-IN" smtClean="0"/>
-              <a:t>21-02-2024</a:t>
+              <a:t>02-03-2024</a:t>
             </a:fld>
             <a:endParaRPr lang="en-IN"/>
           </a:p>
@@ -1798,7 +1798,7 @@
           <a:p>
             <a:fld id="{86FBD32F-FCAD-481A-B7D8-4D813FB7DB24}" type="datetimeFigureOut">
               <a:rPr lang="en-IN" smtClean="0"/>
-              <a:t>21-02-2024</a:t>
+              <a:t>02-03-2024</a:t>
             </a:fld>
             <a:endParaRPr lang="en-IN"/>
           </a:p>
@@ -2165,7 +2165,7 @@
           <a:p>
             <a:fld id="{86FBD32F-FCAD-481A-B7D8-4D813FB7DB24}" type="datetimeFigureOut">
               <a:rPr lang="en-IN" smtClean="0"/>
-              <a:t>21-02-2024</a:t>
+              <a:t>02-03-2024</a:t>
             </a:fld>
             <a:endParaRPr lang="en-IN"/>
           </a:p>
@@ -2283,7 +2283,7 @@
           <a:p>
             <a:fld id="{86FBD32F-FCAD-481A-B7D8-4D813FB7DB24}" type="datetimeFigureOut">
               <a:rPr lang="en-IN" smtClean="0"/>
-              <a:t>21-02-2024</a:t>
+              <a:t>02-03-2024</a:t>
             </a:fld>
             <a:endParaRPr lang="en-IN"/>
           </a:p>
@@ -2378,7 +2378,7 @@
           <a:p>
             <a:fld id="{86FBD32F-FCAD-481A-B7D8-4D813FB7DB24}" type="datetimeFigureOut">
               <a:rPr lang="en-IN" smtClean="0"/>
-              <a:t>21-02-2024</a:t>
+              <a:t>02-03-2024</a:t>
             </a:fld>
             <a:endParaRPr lang="en-IN"/>
           </a:p>
@@ -2655,7 +2655,7 @@
           <a:p>
             <a:fld id="{86FBD32F-FCAD-481A-B7D8-4D813FB7DB24}" type="datetimeFigureOut">
               <a:rPr lang="en-IN" smtClean="0"/>
-              <a:t>21-02-2024</a:t>
+              <a:t>02-03-2024</a:t>
             </a:fld>
             <a:endParaRPr lang="en-IN"/>
           </a:p>
@@ -2912,7 +2912,7 @@
           <a:p>
             <a:fld id="{86FBD32F-FCAD-481A-B7D8-4D813FB7DB24}" type="datetimeFigureOut">
               <a:rPr lang="en-IN" smtClean="0"/>
-              <a:t>21-02-2024</a:t>
+              <a:t>02-03-2024</a:t>
             </a:fld>
             <a:endParaRPr lang="en-IN"/>
           </a:p>
@@ -3125,7 +3125,7 @@
           <a:p>
             <a:fld id="{86FBD32F-FCAD-481A-B7D8-4D813FB7DB24}" type="datetimeFigureOut">
               <a:rPr lang="en-IN" smtClean="0"/>
-              <a:t>21-02-2024</a:t>
+              <a:t>02-03-2024</a:t>
             </a:fld>
             <a:endParaRPr lang="en-IN"/>
           </a:p>
@@ -3596,7 +3596,7 @@
               <a:defRPr/>
             </a:pPr>
             <a:r>
-              <a:rPr kumimoji="0" lang="te-IN" i="0" u="none" strike="noStrike" kern="1200" cap="none" spc="0" normalizeH="0" baseline="0" noProof="0" dirty="0">
+              <a:rPr kumimoji="0" lang="te-IN" sz="1700" i="0" u="none" strike="noStrike" kern="1200" cap="none" spc="0" normalizeH="0" baseline="0" noProof="0" dirty="0">
                 <a:solidFill>
                   <a:schemeClr val="tx1"/>
                 </a:solidFill>
@@ -3606,7 +3606,7 @@
                 <a:latin typeface="Ramabhadra" panose="02000600000000000000" pitchFamily="2" charset="0"/>
                 <a:cs typeface="Ramabhadra" panose="02000600000000000000" pitchFamily="2" charset="0"/>
               </a:rPr>
-              <a:t>నా ప్రాణమా నా అంతరంగమా </a:t>
+              <a:t>ప్రాణేశ్వర – ప్రభు దైవకుమార</a:t>
             </a:r>
           </a:p>
           <a:p>
@@ -3625,7 +3625,7 @@
               <a:defRPr/>
             </a:pPr>
             <a:r>
-              <a:rPr kumimoji="0" lang="te-IN" i="0" u="none" strike="noStrike" kern="1200" cap="none" spc="0" normalizeH="0" baseline="0" noProof="0" dirty="0">
+              <a:rPr kumimoji="0" lang="te-IN" sz="1700" i="0" u="none" strike="noStrike" kern="1200" cap="none" spc="0" normalizeH="0" baseline="0" noProof="0" dirty="0">
                 <a:solidFill>
                   <a:schemeClr val="tx1"/>
                 </a:solidFill>
@@ -3635,7 +3635,7 @@
                 <a:latin typeface="Ramabhadra" panose="02000600000000000000" pitchFamily="2" charset="0"/>
                 <a:cs typeface="Ramabhadra" panose="02000600000000000000" pitchFamily="2" charset="0"/>
               </a:rPr>
-              <a:t>నాలో వున్న నా సమస్తమా (2)</a:t>
+              <a:t>ప్రణుతింతును నిన్నే- ఆశతీర</a:t>
             </a:r>
           </a:p>
           <a:p>
@@ -3654,7 +3654,7 @@
               <a:defRPr/>
             </a:pPr>
             <a:r>
-              <a:rPr kumimoji="0" lang="te-IN" i="0" u="none" strike="noStrike" kern="1200" cap="none" spc="0" normalizeH="0" baseline="0" noProof="0" dirty="0">
+              <a:rPr kumimoji="0" lang="te-IN" sz="1700" i="0" u="none" strike="noStrike" kern="1200" cap="none" spc="0" normalizeH="0" baseline="0" noProof="0" dirty="0">
                 <a:solidFill>
                   <a:schemeClr val="tx1"/>
                 </a:solidFill>
@@ -3664,7 +3664,7 @@
                 <a:latin typeface="Ramabhadra" panose="02000600000000000000" pitchFamily="2" charset="0"/>
                 <a:cs typeface="Ramabhadra" panose="02000600000000000000" pitchFamily="2" charset="0"/>
               </a:rPr>
-              <a:t>యెహోవ చేసిన ఉపకారములలో</a:t>
+              <a:t>ప్రాణేశ్వర – ప్రభు దైవకుమార</a:t>
             </a:r>
           </a:p>
           <a:p>
@@ -3683,7 +3683,7 @@
               <a:defRPr/>
             </a:pPr>
             <a:r>
-              <a:rPr kumimoji="0" lang="te-IN" i="0" u="none" strike="noStrike" kern="1200" cap="none" spc="0" normalizeH="0" baseline="0" noProof="0" dirty="0">
+              <a:rPr kumimoji="0" lang="te-IN" sz="1700" i="0" u="none" strike="noStrike" kern="1200" cap="none" spc="0" normalizeH="0" baseline="0" noProof="0" dirty="0">
                 <a:solidFill>
                   <a:schemeClr val="tx1"/>
                 </a:solidFill>
@@ -3693,7 +3693,7 @@
                 <a:latin typeface="Ramabhadra" panose="02000600000000000000" pitchFamily="2" charset="0"/>
                 <a:cs typeface="Ramabhadra" panose="02000600000000000000" pitchFamily="2" charset="0"/>
               </a:rPr>
-              <a:t>దేనిని మరువక కొనియాడుమా (2)</a:t>
+              <a:t>నా ఆత్మతో పాటలు పాడ –</a:t>
             </a:r>
           </a:p>
           <a:p>
@@ -3712,7 +3712,7 @@
               <a:defRPr/>
             </a:pPr>
             <a:r>
-              <a:rPr kumimoji="0" lang="te-IN" i="0" u="none" strike="noStrike" kern="1200" cap="none" spc="0" normalizeH="0" baseline="0" noProof="0" dirty="0">
+              <a:rPr kumimoji="0" lang="te-IN" sz="1700" i="0" u="none" strike="noStrike" kern="1200" cap="none" spc="0" normalizeH="0" baseline="0" noProof="0" dirty="0">
                 <a:solidFill>
                   <a:schemeClr val="tx1"/>
                 </a:solidFill>
@@ -3722,7 +3722,7 @@
                 <a:latin typeface="Ramabhadra" panose="02000600000000000000" pitchFamily="2" charset="0"/>
                 <a:cs typeface="Ramabhadra" panose="02000600000000000000" pitchFamily="2" charset="0"/>
               </a:rPr>
-              <a:t>ఆ.. ఆ… ఆ.. ఆ… ఆ.. ఆ…</a:t>
+              <a:t>నీ కృపలే నాకు హేతువులాయె -2</a:t>
             </a:r>
           </a:p>
           <a:p>
@@ -3740,7 +3740,65 @@
               <a:tabLst/>
               <a:defRPr/>
             </a:pPr>
-            <a:endParaRPr kumimoji="0" lang="te-IN" i="0" u="none" strike="noStrike" kern="1200" cap="none" spc="0" normalizeH="0" baseline="0" noProof="0" dirty="0">
+            <a:r>
+              <a:rPr kumimoji="0" lang="te-IN" sz="1700" i="0" u="none" strike="noStrike" kern="1200" cap="none" spc="0" normalizeH="0" baseline="0" noProof="0" dirty="0">
+                <a:solidFill>
+                  <a:schemeClr val="tx1"/>
+                </a:solidFill>
+                <a:effectLst/>
+                <a:uLnTx/>
+                <a:uFillTx/>
+                <a:latin typeface="Ramabhadra" panose="02000600000000000000" pitchFamily="2" charset="0"/>
+                <a:cs typeface="Ramabhadra" panose="02000600000000000000" pitchFamily="2" charset="0"/>
+              </a:rPr>
+              <a:t>నిత్య నిబంధన నీతో చేసి –</a:t>
+            </a:r>
+          </a:p>
+          <a:p>
+            <a:pPr marL="0" marR="0" lvl="0" indent="0" algn="ctr" defTabSz="439781" rtl="0" eaLnBrk="1" fontAlgn="auto" latinLnBrk="0" hangingPunct="1">
+              <a:spcBef>
+                <a:spcPts val="0"/>
+              </a:spcBef>
+              <a:spcAft>
+                <a:spcPts val="0"/>
+              </a:spcAft>
+              <a:buClrTx/>
+              <a:buSzTx/>
+              <a:buFontTx/>
+              <a:buNone/>
+              <a:tabLst/>
+              <a:defRPr/>
+            </a:pPr>
+            <a:r>
+              <a:rPr kumimoji="0" lang="te-IN" sz="1700" i="0" u="none" strike="noStrike" kern="1200" cap="none" spc="0" normalizeH="0" baseline="0" noProof="0" dirty="0">
+                <a:solidFill>
+                  <a:schemeClr val="tx1"/>
+                </a:solidFill>
+                <a:effectLst/>
+                <a:uLnTx/>
+                <a:uFillTx/>
+                <a:latin typeface="Ramabhadra" panose="02000600000000000000" pitchFamily="2" charset="0"/>
+                <a:cs typeface="Ramabhadra" panose="02000600000000000000" pitchFamily="2" charset="0"/>
+              </a:rPr>
+              <a:t>నీ పాద సన్నిధి చేరియున్నానే -2      </a:t>
+            </a:r>
+          </a:p>
+          <a:p>
+            <a:pPr marL="0" marR="0" lvl="0" indent="0" algn="ctr" defTabSz="439781" rtl="0" eaLnBrk="1" fontAlgn="auto" latinLnBrk="0" hangingPunct="1">
+              <a:spcBef>
+                <a:spcPts val="0"/>
+              </a:spcBef>
+              <a:spcAft>
+                <a:spcPts val="0"/>
+              </a:spcAft>
+              <a:buClrTx/>
+              <a:buSzTx/>
+              <a:buFontTx/>
+              <a:buNone/>
+              <a:tabLst/>
+              <a:defRPr/>
+            </a:pPr>
+            <a:endParaRPr kumimoji="0" lang="te-IN" sz="1700" i="0" u="none" strike="noStrike" kern="1200" cap="none" spc="0" normalizeH="0" baseline="0" noProof="0" dirty="0">
               <a:solidFill>
                 <a:schemeClr val="tx1"/>
               </a:solidFill>
@@ -3767,7 +3825,7 @@
               <a:defRPr/>
             </a:pPr>
             <a:r>
-              <a:rPr kumimoji="0" lang="te-IN" i="0" u="none" strike="noStrike" kern="1200" cap="none" spc="0" normalizeH="0" baseline="0" noProof="0" dirty="0">
+              <a:rPr kumimoji="0" lang="te-IN" sz="1700" i="0" u="none" strike="noStrike" kern="1200" cap="none" spc="0" normalizeH="0" baseline="0" noProof="0" dirty="0">
                 <a:solidFill>
                   <a:schemeClr val="tx1"/>
                 </a:solidFill>
@@ -3777,7 +3835,7 @@
                 <a:latin typeface="Ramabhadra" panose="02000600000000000000" pitchFamily="2" charset="0"/>
                 <a:cs typeface="Ramabhadra" panose="02000600000000000000" pitchFamily="2" charset="0"/>
               </a:rPr>
-              <a:t>నీ దోషములన్ని క్షమియించువాడు </a:t>
+              <a:t>నా ఊటలన్నియు నీ యందేనని –</a:t>
             </a:r>
           </a:p>
           <a:p>
@@ -3796,7 +3854,7 @@
               <a:defRPr/>
             </a:pPr>
             <a:r>
-              <a:rPr kumimoji="0" lang="te-IN" i="0" u="none" strike="noStrike" kern="1200" cap="none" spc="0" normalizeH="0" baseline="0" noProof="0" dirty="0">
+              <a:rPr kumimoji="0" lang="te-IN" sz="1700" i="0" u="none" strike="noStrike" kern="1200" cap="none" spc="0" normalizeH="0" baseline="0" noProof="0" dirty="0">
                 <a:solidFill>
                   <a:schemeClr val="tx1"/>
                 </a:solidFill>
@@ -3806,7 +3864,7 @@
                 <a:latin typeface="Ramabhadra" panose="02000600000000000000" pitchFamily="2" charset="0"/>
                 <a:cs typeface="Ramabhadra" panose="02000600000000000000" pitchFamily="2" charset="0"/>
               </a:rPr>
-              <a:t>నీ పాపములన్ని పార ద్రోలువాడు (2)</a:t>
+              <a:t>వాద్యము వాయించి పాడెదను -2</a:t>
             </a:r>
           </a:p>
           <a:p>
@@ -3825,7 +3883,7 @@
               <a:defRPr/>
             </a:pPr>
             <a:r>
-              <a:rPr kumimoji="0" lang="te-IN" i="0" u="none" strike="noStrike" kern="1200" cap="none" spc="0" normalizeH="0" baseline="0" noProof="0" dirty="0">
+              <a:rPr kumimoji="0" lang="te-IN" sz="1700" i="0" u="none" strike="noStrike" kern="1200" cap="none" spc="0" normalizeH="0" baseline="0" noProof="0" dirty="0">
                 <a:solidFill>
                   <a:schemeClr val="tx1"/>
                 </a:solidFill>
@@ -3835,7 +3893,7 @@
                 <a:latin typeface="Ramabhadra" panose="02000600000000000000" pitchFamily="2" charset="0"/>
                 <a:cs typeface="Ramabhadra" panose="02000600000000000000" pitchFamily="2" charset="0"/>
               </a:rPr>
-              <a:t>పరమ వైద్యుడు ప్రభు యేసుడు </a:t>
+              <a:t>జీవిత కాలమంతా నిన్నే స్తుతించి –</a:t>
             </a:r>
           </a:p>
           <a:p>
@@ -3854,7 +3912,7 @@
               <a:defRPr/>
             </a:pPr>
             <a:r>
-              <a:rPr kumimoji="0" lang="te-IN" i="0" u="none" strike="noStrike" kern="1200" cap="none" spc="0" normalizeH="0" baseline="0" noProof="0" dirty="0">
+              <a:rPr kumimoji="0" lang="te-IN" sz="1700" i="0" u="none" strike="noStrike" kern="1200" cap="none" spc="0" normalizeH="0" baseline="0" noProof="0" dirty="0">
                 <a:solidFill>
                   <a:schemeClr val="tx1"/>
                 </a:solidFill>
@@ -3864,7 +3922,7 @@
                 <a:latin typeface="Ramabhadra" panose="02000600000000000000" pitchFamily="2" charset="0"/>
                 <a:cs typeface="Ramabhadra" panose="02000600000000000000" pitchFamily="2" charset="0"/>
               </a:rPr>
-              <a:t>పరిశుద్ధ నామమును సన్నుతించుమా (2)</a:t>
+              <a:t>సాగెద నూతన యెరూషలేము  -2</a:t>
             </a:r>
           </a:p>
           <a:p>
@@ -3882,7 +3940,7 @@
               <a:tabLst/>
               <a:defRPr/>
             </a:pPr>
-            <a:endParaRPr kumimoji="0" lang="te-IN" i="0" u="none" strike="noStrike" kern="1200" cap="none" spc="0" normalizeH="0" baseline="0" noProof="0" dirty="0">
+            <a:endParaRPr kumimoji="0" lang="te-IN" sz="1700" i="0" u="none" strike="noStrike" kern="1200" cap="none" spc="0" normalizeH="0" baseline="0" noProof="0" dirty="0">
               <a:solidFill>
                 <a:schemeClr val="tx1"/>
               </a:solidFill>
@@ -3909,7 +3967,7 @@
               <a:defRPr/>
             </a:pPr>
             <a:r>
-              <a:rPr kumimoji="0" lang="te-IN" i="0" u="none" strike="noStrike" kern="1200" cap="none" spc="0" normalizeH="0" baseline="0" noProof="0" dirty="0">
+              <a:rPr kumimoji="0" lang="te-IN" sz="1700" i="0" u="none" strike="noStrike" kern="1200" cap="none" spc="0" normalizeH="0" baseline="0" noProof="0" dirty="0">
                 <a:solidFill>
                   <a:schemeClr val="tx1"/>
                 </a:solidFill>
@@ -3919,7 +3977,7 @@
                 <a:latin typeface="Ramabhadra" panose="02000600000000000000" pitchFamily="2" charset="0"/>
                 <a:cs typeface="Ramabhadra" panose="02000600000000000000" pitchFamily="2" charset="0"/>
               </a:rPr>
-              <a:t>సమాధిలోనుండి నీ ప్రాణమును </a:t>
+              <a:t>కమనీయమైన నీ దర్శనము –</a:t>
             </a:r>
           </a:p>
           <a:p>
@@ -3938,7 +3996,7 @@
               <a:defRPr/>
             </a:pPr>
             <a:r>
-              <a:rPr kumimoji="0" lang="te-IN" i="0" u="none" strike="noStrike" kern="1200" cap="none" spc="0" normalizeH="0" baseline="0" noProof="0" dirty="0">
+              <a:rPr kumimoji="0" lang="te-IN" sz="1700" i="0" u="none" strike="noStrike" kern="1200" cap="none" spc="0" normalizeH="0" baseline="0" noProof="0" dirty="0">
                 <a:solidFill>
                   <a:schemeClr val="tx1"/>
                 </a:solidFill>
@@ -3948,7 +4006,7 @@
                 <a:latin typeface="Ramabhadra" panose="02000600000000000000" pitchFamily="2" charset="0"/>
                 <a:cs typeface="Ramabhadra" panose="02000600000000000000" pitchFamily="2" charset="0"/>
               </a:rPr>
-              <a:t>విమోచించుచున్నాడు శ్రీయేసుడు (2)</a:t>
+              <a:t>కలనైనను మెలకువనైన  -2</a:t>
             </a:r>
           </a:p>
           <a:p>
@@ -3967,7 +4025,7 @@
               <a:defRPr/>
             </a:pPr>
             <a:r>
-              <a:rPr kumimoji="0" lang="te-IN" i="0" u="none" strike="noStrike" kern="1200" cap="none" spc="0" normalizeH="0" baseline="0" noProof="0" dirty="0">
+              <a:rPr kumimoji="0" lang="te-IN" sz="1700" i="0" u="none" strike="noStrike" kern="1200" cap="none" spc="0" normalizeH="0" baseline="0" noProof="0" dirty="0">
                 <a:solidFill>
                   <a:schemeClr val="tx1"/>
                 </a:solidFill>
@@ -3977,7 +4035,7 @@
                 <a:latin typeface="Ramabhadra" panose="02000600000000000000" pitchFamily="2" charset="0"/>
                 <a:cs typeface="Ramabhadra" panose="02000600000000000000" pitchFamily="2" charset="0"/>
               </a:rPr>
-              <a:t>కరుణా కటాక్షములను నీకు కిరీటముగా </a:t>
+              <a:t>కనబడినా నా ఆశలు తీరవే –</a:t>
             </a:r>
           </a:p>
           <a:p>
@@ -3996,7 +4054,7 @@
               <a:defRPr/>
             </a:pPr>
             <a:r>
-              <a:rPr kumimoji="0" lang="te-IN" i="0" u="none" strike="noStrike" kern="1200" cap="none" spc="0" normalizeH="0" baseline="0" noProof="0" dirty="0">
+              <a:rPr kumimoji="0" lang="te-IN" sz="1700" i="0" u="none" strike="noStrike" kern="1200" cap="none" spc="0" normalizeH="0" baseline="0" noProof="0" dirty="0">
                 <a:solidFill>
                   <a:schemeClr val="tx1"/>
                 </a:solidFill>
@@ -4006,7 +4064,7 @@
                 <a:latin typeface="Ramabhadra" panose="02000600000000000000" pitchFamily="2" charset="0"/>
                 <a:cs typeface="Ramabhadra" panose="02000600000000000000" pitchFamily="2" charset="0"/>
               </a:rPr>
-              <a:t>ధరియింపజేయును ప్రభు యేసుడు (2)</a:t>
+              <a:t>కనిపెట్టుచుంటిని కడబూరధ్వనికి -2</a:t>
             </a:r>
           </a:p>
         </p:txBody>
@@ -4071,7 +4129,7 @@
               </a:spcAft>
             </a:pPr>
             <a:r>
-              <a:rPr lang="te-IN" sz="2000" b="0" i="0" dirty="0">
+              <a:rPr lang="te-IN" sz="1600" b="0" i="0" dirty="0">
                 <a:solidFill>
                   <a:schemeClr val="tx1"/>
                 </a:solidFill>
@@ -4079,7 +4137,7 @@
                 <a:latin typeface="Ramabhadra" panose="02000600000000000000" pitchFamily="2" charset="0"/>
                 <a:cs typeface="Ramabhadra" panose="02000600000000000000" pitchFamily="2" charset="0"/>
               </a:rPr>
-              <a:t>స్తుతులన్ గైకొనుమా</a:t>
+              <a:t>స్తుతి పాత్రుడా – స్తోత్రార్హుడా</a:t>
             </a:r>
           </a:p>
           <a:p>
@@ -4092,7 +4150,7 @@
               </a:spcAft>
             </a:pPr>
             <a:r>
-              <a:rPr lang="te-IN" sz="2000" b="0" i="0" dirty="0">
+              <a:rPr lang="te-IN" sz="1600" b="0" i="0" dirty="0">
                 <a:solidFill>
                   <a:schemeClr val="tx1"/>
                 </a:solidFill>
@@ -4100,7 +4158,7 @@
                 <a:latin typeface="Ramabhadra" panose="02000600000000000000" pitchFamily="2" charset="0"/>
                 <a:cs typeface="Ramabhadra" panose="02000600000000000000" pitchFamily="2" charset="0"/>
               </a:rPr>
-              <a:t>సుత యేసు క్రీస్తువా</a:t>
+              <a:t>స్తుతులందుకో - పూజార్హుడా</a:t>
             </a:r>
           </a:p>
           <a:p>
@@ -4113,7 +4171,7 @@
               </a:spcAft>
             </a:pPr>
             <a:r>
-              <a:rPr lang="te-IN" sz="2000" b="0" i="0" dirty="0">
+              <a:rPr lang="te-IN" sz="1600" b="0" i="0" dirty="0">
                 <a:solidFill>
                   <a:schemeClr val="tx1"/>
                 </a:solidFill>
@@ -4121,7 +4179,7 @@
                 <a:latin typeface="Ramabhadra" panose="02000600000000000000" pitchFamily="2" charset="0"/>
                 <a:cs typeface="Ramabhadra" panose="02000600000000000000" pitchFamily="2" charset="0"/>
               </a:rPr>
-              <a:t>సతతము మమ్ములను </a:t>
+              <a:t>ఆకాశమందు నీవు తప్ప –</a:t>
             </a:r>
           </a:p>
           <a:p>
@@ -4134,7 +4192,7 @@
               </a:spcAft>
             </a:pPr>
             <a:r>
-              <a:rPr lang="te-IN" sz="2000" b="0" i="0" dirty="0">
+              <a:rPr lang="te-IN" sz="1600" b="0" i="0" dirty="0">
                 <a:solidFill>
                   <a:schemeClr val="tx1"/>
                 </a:solidFill>
@@ -4142,7 +4200,7 @@
                 <a:latin typeface="Ramabhadra" panose="02000600000000000000" pitchFamily="2" charset="0"/>
                 <a:cs typeface="Ramabhadra" panose="02000600000000000000" pitchFamily="2" charset="0"/>
               </a:rPr>
-              <a:t>కృపనిడి కావుమా</a:t>
+              <a:t>నాకెవరున్నారు నా ప్రభు</a:t>
             </a:r>
           </a:p>
           <a:p>
@@ -4154,7 +4212,28 @@
                 <a:spcPts val="0"/>
               </a:spcAft>
             </a:pPr>
-            <a:endParaRPr lang="te-IN" sz="2000" b="0" i="0" dirty="0">
+            <a:r>
+              <a:rPr lang="te-IN" sz="1600" b="0" i="0" dirty="0">
+                <a:solidFill>
+                  <a:schemeClr val="tx1"/>
+                </a:solidFill>
+                <a:effectLst/>
+                <a:latin typeface="Ramabhadra" panose="02000600000000000000" pitchFamily="2" charset="0"/>
+                <a:cs typeface="Ramabhadra" panose="02000600000000000000" pitchFamily="2" charset="0"/>
+              </a:rPr>
+              <a:t>స్తుతి పాత్రుడా.... ఆఆఅ</a:t>
+            </a:r>
+          </a:p>
+          <a:p>
+            <a:pPr marL="0" marR="0" indent="0" algn="ctr" rtl="0" eaLnBrk="1" fontAlgn="auto" latinLnBrk="0" hangingPunct="1">
+              <a:spcBef>
+                <a:spcPts val="0"/>
+              </a:spcBef>
+              <a:spcAft>
+                <a:spcPts val="0"/>
+              </a:spcAft>
+            </a:pPr>
+            <a:endParaRPr lang="te-IN" sz="1600" b="0" i="0" dirty="0">
               <a:solidFill>
                 <a:schemeClr val="tx1"/>
               </a:solidFill>
@@ -4173,7 +4252,7 @@
               </a:spcAft>
             </a:pPr>
             <a:r>
-              <a:rPr lang="te-IN" sz="2000" b="0" i="0" dirty="0">
+              <a:rPr lang="te-IN" sz="1600" b="0" i="0" dirty="0">
                 <a:solidFill>
                   <a:schemeClr val="tx1"/>
                 </a:solidFill>
@@ -4181,7 +4260,7 @@
                 <a:latin typeface="Ramabhadra" panose="02000600000000000000" pitchFamily="2" charset="0"/>
                 <a:cs typeface="Ramabhadra" panose="02000600000000000000" pitchFamily="2" charset="0"/>
               </a:rPr>
-              <a:t>మా పెదవులతో ఎప్పుడు నీ</a:t>
+              <a:t>నా శత్రువులు నను తరుముచుండగా - నా యాత్మ నాలో కృంగెనే ప్రభూ -2</a:t>
             </a:r>
           </a:p>
           <a:p>
@@ -4194,7 +4273,7 @@
               </a:spcAft>
             </a:pPr>
             <a:r>
-              <a:rPr lang="te-IN" sz="2000" b="0" i="0" dirty="0">
+              <a:rPr lang="te-IN" sz="1600" b="0" i="0" dirty="0">
                 <a:solidFill>
                   <a:schemeClr val="tx1"/>
                 </a:solidFill>
@@ -4202,7 +4281,7 @@
                 <a:latin typeface="Ramabhadra" panose="02000600000000000000" pitchFamily="2" charset="0"/>
                 <a:cs typeface="Ramabhadra" panose="02000600000000000000" pitchFamily="2" charset="0"/>
               </a:rPr>
-              <a:t>  వాక్యమును పఠింప నిమ్ము</a:t>
+              <a:t>నా మనస్సు నీ వైపు త్రిప్పిన వెంటనే –</a:t>
             </a:r>
           </a:p>
           <a:p>
@@ -4215,7 +4294,7 @@
               </a:spcAft>
             </a:pPr>
             <a:r>
-              <a:rPr lang="te-IN" sz="2000" b="0" i="0" dirty="0">
+              <a:rPr lang="te-IN" sz="1600" b="0" i="0" dirty="0">
                 <a:solidFill>
                   <a:schemeClr val="tx1"/>
                 </a:solidFill>
@@ -4223,7 +4302,7 @@
                 <a:latin typeface="Ramabhadra" panose="02000600000000000000" pitchFamily="2" charset="0"/>
                 <a:cs typeface="Ramabhadra" panose="02000600000000000000" pitchFamily="2" charset="0"/>
               </a:rPr>
-              <a:t>మా కాలు చేతులు ఎప్పుడు నీ </a:t>
+              <a:t>శత్రుల చేతినుండి</a:t>
             </a:r>
           </a:p>
           <a:p>
@@ -4236,7 +4315,7 @@
               </a:spcAft>
             </a:pPr>
             <a:r>
-              <a:rPr lang="te-IN" sz="2000" b="0" i="0" dirty="0">
+              <a:rPr lang="te-IN" sz="1600" b="0" i="0" dirty="0">
                 <a:solidFill>
                   <a:schemeClr val="tx1"/>
                 </a:solidFill>
@@ -4244,7 +4323,7 @@
                 <a:latin typeface="Ramabhadra" panose="02000600000000000000" pitchFamily="2" charset="0"/>
                 <a:cs typeface="Ramabhadra" panose="02000600000000000000" pitchFamily="2" charset="0"/>
               </a:rPr>
-              <a:t>సేవను చేయను వాడనిమ్ము </a:t>
+              <a:t>విడిపించినావు - కాపాడినావు -2</a:t>
             </a:r>
           </a:p>
           <a:p>
@@ -4256,7 +4335,7 @@
                 <a:spcPts val="0"/>
               </a:spcAft>
             </a:pPr>
-            <a:endParaRPr lang="te-IN" sz="2000" b="0" i="0" dirty="0">
+            <a:endParaRPr lang="te-IN" sz="1600" b="0" i="0" dirty="0">
               <a:solidFill>
                 <a:schemeClr val="tx1"/>
               </a:solidFill>
@@ -4275,7 +4354,7 @@
               </a:spcAft>
             </a:pPr>
             <a:r>
-              <a:rPr lang="te-IN" sz="2000" b="0" i="0" dirty="0">
+              <a:rPr lang="te-IN" sz="1600" b="0" i="0" dirty="0">
                 <a:solidFill>
                   <a:schemeClr val="tx1"/>
                 </a:solidFill>
@@ -4283,7 +4362,7 @@
                 <a:latin typeface="Ramabhadra" panose="02000600000000000000" pitchFamily="2" charset="0"/>
                 <a:cs typeface="Ramabhadra" panose="02000600000000000000" pitchFamily="2" charset="0"/>
               </a:rPr>
-              <a:t>మా కలిమియు పదవుల నెల్ల </a:t>
+              <a:t>నా ప్రాణ స్నేహితులు నన్ను చూచి దూరాన నిలిచేరు నా ప్రభూ -2</a:t>
             </a:r>
           </a:p>
           <a:p>
@@ -4296,7 +4375,7 @@
               </a:spcAft>
             </a:pPr>
             <a:r>
-              <a:rPr lang="te-IN" sz="2000" b="0" i="0" dirty="0">
+              <a:rPr lang="te-IN" sz="1600" b="0" i="0" dirty="0">
                 <a:solidFill>
                   <a:schemeClr val="tx1"/>
                 </a:solidFill>
@@ -4304,7 +4383,7 @@
                 <a:latin typeface="Ramabhadra" panose="02000600000000000000" pitchFamily="2" charset="0"/>
                 <a:cs typeface="Ramabhadra" panose="02000600000000000000" pitchFamily="2" charset="0"/>
               </a:rPr>
-              <a:t>నీ శుద్ధ కృపచే పొందితిమి </a:t>
+              <a:t>నీ వాక్య ధ్యానమే నా త్రోవకు వెలుగై –</a:t>
             </a:r>
           </a:p>
           <a:p>
@@ -4317,7 +4396,7 @@
               </a:spcAft>
             </a:pPr>
             <a:r>
-              <a:rPr lang="te-IN" sz="2000" b="0" i="0" dirty="0">
+              <a:rPr lang="te-IN" sz="1600" b="0" i="0" dirty="0">
                 <a:solidFill>
                   <a:schemeClr val="tx1"/>
                 </a:solidFill>
@@ -4325,7 +4404,7 @@
                 <a:latin typeface="Ramabhadra" panose="02000600000000000000" pitchFamily="2" charset="0"/>
                 <a:cs typeface="Ramabhadra" panose="02000600000000000000" pitchFamily="2" charset="0"/>
               </a:rPr>
-              <a:t>మా కాలమంతయు జీవింప </a:t>
+              <a:t>నను నిల్పెను</a:t>
             </a:r>
           </a:p>
           <a:p>
@@ -4338,7 +4417,7 @@
               </a:spcAft>
             </a:pPr>
             <a:r>
-              <a:rPr lang="te-IN" sz="2000" b="0" i="0" dirty="0">
+              <a:rPr lang="te-IN" sz="1600" b="0" i="0" dirty="0">
                 <a:solidFill>
                   <a:schemeClr val="tx1"/>
                 </a:solidFill>
@@ -4346,7 +4425,7 @@
                 <a:latin typeface="Ramabhadra" panose="02000600000000000000" pitchFamily="2" charset="0"/>
                 <a:cs typeface="Ramabhadra" panose="02000600000000000000" pitchFamily="2" charset="0"/>
               </a:rPr>
-              <a:t>నిలకడగ నుండ దీవించుము</a:t>
+              <a:t>నీ సన్నీధిలో - నీ సంఘములో -2</a:t>
             </a:r>
           </a:p>
         </p:txBody>
@@ -4404,7 +4483,7 @@
           <a:p>
             <a:pPr algn="ctr"/>
             <a:r>
-              <a:rPr lang="te-IN" sz="2000" b="0" i="0" dirty="0">
+              <a:rPr lang="te-IN" sz="1600" b="0" i="0" dirty="0">
                 <a:solidFill>
                   <a:srgbClr val="000000"/>
                 </a:solidFill>
@@ -4412,13 +4491,13 @@
                 <a:latin typeface="Ramabhadra" panose="02000600000000000000" pitchFamily="2" charset="0"/>
                 <a:cs typeface="Ramabhadra" panose="02000600000000000000" pitchFamily="2" charset="0"/>
               </a:rPr>
-              <a:t>ఆత్మతో అభిషేకం</a:t>
+              <a:t>నేనెల్లప్పుడు యెహోవను సన్నుతించెదన్</a:t>
             </a:r>
           </a:p>
           <a:p>
             <a:pPr algn="ctr"/>
             <a:r>
-              <a:rPr lang="te-IN" sz="2000" b="0" i="0" dirty="0">
+              <a:rPr lang="te-IN" sz="1600" b="0" i="0" dirty="0">
                 <a:solidFill>
                   <a:srgbClr val="000000"/>
                 </a:solidFill>
@@ -4426,26 +4505,24 @@
                 <a:latin typeface="Ramabhadra" panose="02000600000000000000" pitchFamily="2" charset="0"/>
                 <a:cs typeface="Ramabhadra" panose="02000600000000000000" pitchFamily="2" charset="0"/>
               </a:rPr>
-              <a:t>మాపై కుమ్మరించు దేవా</a:t>
+              <a:t>నిత్యము ఆయన కీర్తి నా నోట నుండున్ (2)</a:t>
             </a:r>
           </a:p>
           <a:p>
             <a:pPr algn="ctr"/>
-            <a:r>
-              <a:rPr lang="te-IN" sz="2000" dirty="0">
-                <a:solidFill>
-                  <a:srgbClr val="000000"/>
-                </a:solidFill>
-                <a:latin typeface="Ramabhadra" panose="02000600000000000000" pitchFamily="2" charset="0"/>
-                <a:cs typeface="Ramabhadra" panose="02000600000000000000" pitchFamily="2" charset="0"/>
-              </a:rPr>
-              <a:t>దైవత్మచే ఆవరించుము</a:t>
-            </a:r>
+            <a:endParaRPr lang="te-IN" sz="1600" b="0" i="0" dirty="0">
+              <a:solidFill>
+                <a:srgbClr val="000000"/>
+              </a:solidFill>
+              <a:effectLst/>
+              <a:latin typeface="Ramabhadra" panose="02000600000000000000" pitchFamily="2" charset="0"/>
+              <a:cs typeface="Ramabhadra" panose="02000600000000000000" pitchFamily="2" charset="0"/>
+            </a:endParaRPr>
           </a:p>
           <a:p>
             <a:pPr algn="ctr"/>
             <a:r>
-              <a:rPr lang="te-IN" sz="2000" b="0" i="0" dirty="0">
+              <a:rPr lang="te-IN" sz="1600" b="0" i="0" dirty="0">
                 <a:solidFill>
                   <a:srgbClr val="000000"/>
                 </a:solidFill>
@@ -4453,23 +4530,13 @@
                 <a:latin typeface="Ramabhadra" panose="02000600000000000000" pitchFamily="2" charset="0"/>
                 <a:cs typeface="Ramabhadra" panose="02000600000000000000" pitchFamily="2" charset="0"/>
               </a:rPr>
-              <a:t>ఆత్మ దాహం నిండి ఆనందింతుము</a:t>
+              <a:t>అంతా నా మేలుకే – ఆరాధన యేసుకే</a:t>
             </a:r>
           </a:p>
           <a:p>
             <a:pPr algn="ctr"/>
-            <a:endParaRPr lang="te-IN" sz="2000" dirty="0">
-              <a:solidFill>
-                <a:srgbClr val="000000"/>
-              </a:solidFill>
-              <a:latin typeface="Ramabhadra" panose="02000600000000000000" pitchFamily="2" charset="0"/>
-              <a:cs typeface="Ramabhadra" panose="02000600000000000000" pitchFamily="2" charset="0"/>
-            </a:endParaRPr>
-          </a:p>
-          <a:p>
-            <a:pPr algn="ctr"/>
-            <a:r>
-              <a:rPr lang="te-IN" sz="2000" b="0" i="0" dirty="0">
+            <a:r>
+              <a:rPr lang="te-IN" sz="1600" b="0" i="0" dirty="0">
                 <a:solidFill>
                   <a:srgbClr val="000000"/>
                 </a:solidFill>
@@ -4477,13 +4544,13 @@
                 <a:latin typeface="Ramabhadra" panose="02000600000000000000" pitchFamily="2" charset="0"/>
                 <a:cs typeface="Ramabhadra" panose="02000600000000000000" pitchFamily="2" charset="0"/>
               </a:rPr>
-              <a:t>నూతన ఆభిషేకం</a:t>
+              <a:t>అంతా నా మంచికే –</a:t>
             </a:r>
           </a:p>
           <a:p>
             <a:pPr algn="ctr"/>
             <a:r>
-              <a:rPr lang="te-IN" sz="2000" b="0" i="0" dirty="0">
+              <a:rPr lang="te-IN" sz="1600" b="0" i="0" dirty="0">
                 <a:solidFill>
                   <a:srgbClr val="000000"/>
                 </a:solidFill>
@@ -4491,13 +4558,13 @@
                 <a:latin typeface="Ramabhadra" panose="02000600000000000000" pitchFamily="2" charset="0"/>
                 <a:cs typeface="Ramabhadra" panose="02000600000000000000" pitchFamily="2" charset="0"/>
               </a:rPr>
-              <a:t>నూతన తలంపులతో</a:t>
+              <a:t>తన చిత్తమునకు తల వంచితే</a:t>
             </a:r>
           </a:p>
           <a:p>
             <a:pPr algn="ctr"/>
             <a:r>
-              <a:rPr lang="te-IN" sz="2000" b="0" i="0" dirty="0">
+              <a:rPr lang="te-IN" sz="1600" b="0" i="0" dirty="0">
                 <a:solidFill>
                   <a:srgbClr val="000000"/>
                 </a:solidFill>
@@ -4505,20 +4572,13 @@
                 <a:latin typeface="Ramabhadra" panose="02000600000000000000" pitchFamily="2" charset="0"/>
                 <a:cs typeface="Ramabhadra" panose="02000600000000000000" pitchFamily="2" charset="0"/>
               </a:rPr>
-              <a:t>నిండెదము ఆత్మతో</a:t>
-            </a:r>
-            <a:endParaRPr lang="te-IN" sz="2000" dirty="0">
-              <a:solidFill>
-                <a:srgbClr val="000000"/>
-              </a:solidFill>
-              <a:latin typeface="Ramabhadra" panose="02000600000000000000" pitchFamily="2" charset="0"/>
-              <a:cs typeface="Ramabhadra" panose="02000600000000000000" pitchFamily="2" charset="0"/>
-            </a:endParaRPr>
+              <a:t>తన చిత్తమునకు తల వంచితే</a:t>
+            </a:r>
           </a:p>
           <a:p>
             <a:pPr algn="ctr"/>
             <a:r>
-              <a:rPr lang="te-IN" sz="2000" b="0" i="0" dirty="0">
+              <a:rPr lang="te-IN" sz="1600" b="0" i="0" dirty="0">
                 <a:solidFill>
                   <a:srgbClr val="000000"/>
                 </a:solidFill>
@@ -4526,23 +4586,13 @@
                 <a:latin typeface="Ramabhadra" panose="02000600000000000000" pitchFamily="2" charset="0"/>
                 <a:cs typeface="Ramabhadra" panose="02000600000000000000" pitchFamily="2" charset="0"/>
               </a:rPr>
-              <a:t>ఆనంద భరితులమై</a:t>
+              <a:t>ఆరాధన ఆపను – స్తుతియించుట మానను (2)</a:t>
             </a:r>
           </a:p>
           <a:p>
             <a:pPr algn="ctr"/>
-            <a:endParaRPr lang="te-IN" sz="2000" dirty="0">
-              <a:solidFill>
-                <a:srgbClr val="000000"/>
-              </a:solidFill>
-              <a:latin typeface="Ramabhadra" panose="02000600000000000000" pitchFamily="2" charset="0"/>
-              <a:cs typeface="Ramabhadra" panose="02000600000000000000" pitchFamily="2" charset="0"/>
-            </a:endParaRPr>
-          </a:p>
-          <a:p>
-            <a:pPr algn="ctr"/>
-            <a:r>
-              <a:rPr lang="te-IN" sz="2000" b="0" i="0" dirty="0">
+            <a:r>
+              <a:rPr lang="te-IN" sz="1600" b="0" i="0" dirty="0">
                 <a:solidFill>
                   <a:srgbClr val="000000"/>
                 </a:solidFill>
@@ -4550,12 +4600,16 @@
                 <a:latin typeface="Ramabhadra" panose="02000600000000000000" pitchFamily="2" charset="0"/>
                 <a:cs typeface="Ramabhadra" panose="02000600000000000000" pitchFamily="2" charset="0"/>
               </a:rPr>
-              <a:t>ఆగ్నితో ఆభిషేకం</a:t>
-            </a:r>
-            <a:endParaRPr lang="te-IN" sz="2000" dirty="0">
+              <a:t>స్తుతియించుట మానను</a:t>
+            </a:r>
+          </a:p>
+          <a:p>
+            <a:pPr algn="ctr"/>
+            <a:endParaRPr lang="te-IN" sz="1600" b="0" i="0" dirty="0">
               <a:solidFill>
                 <a:srgbClr val="000000"/>
               </a:solidFill>
+              <a:effectLst/>
               <a:latin typeface="Ramabhadra" panose="02000600000000000000" pitchFamily="2" charset="0"/>
               <a:cs typeface="Ramabhadra" panose="02000600000000000000" pitchFamily="2" charset="0"/>
             </a:endParaRPr>
@@ -4563,7 +4617,7 @@
           <a:p>
             <a:pPr algn="ctr"/>
             <a:r>
-              <a:rPr lang="te-IN" sz="2000" b="0" i="0" dirty="0">
+              <a:rPr lang="te-IN" sz="1600" b="0" i="0" dirty="0">
                 <a:solidFill>
                   <a:srgbClr val="000000"/>
                 </a:solidFill>
@@ -4571,33 +4625,116 @@
                 <a:latin typeface="Ramabhadra" panose="02000600000000000000" pitchFamily="2" charset="0"/>
                 <a:cs typeface="Ramabhadra" panose="02000600000000000000" pitchFamily="2" charset="0"/>
               </a:rPr>
-              <a:t>ముఖముతో కనిపించును</a:t>
+              <a:t>కన్నీళ్లే పానములైనా – కఠిన దుఃఖ బాధలైనా</a:t>
             </a:r>
           </a:p>
           <a:p>
             <a:pPr algn="ctr"/>
             <a:r>
-              <a:rPr lang="te-IN" sz="2000" dirty="0">
+              <a:rPr lang="te-IN" sz="1600" b="0" i="0" dirty="0">
                 <a:solidFill>
                   <a:srgbClr val="000000"/>
                 </a:solidFill>
+                <a:effectLst/>
                 <a:latin typeface="Ramabhadra" panose="02000600000000000000" pitchFamily="2" charset="0"/>
                 <a:cs typeface="Ramabhadra" panose="02000600000000000000" pitchFamily="2" charset="0"/>
               </a:rPr>
-              <a:t>శత్రువును జయించుటకు</a:t>
+              <a:t>స్థితి గతులే మారినా – అవకాశం చేజారినా (2)</a:t>
             </a:r>
           </a:p>
           <a:p>
             <a:pPr algn="ctr"/>
             <a:r>
-              <a:rPr lang="te-IN" sz="2000" dirty="0">
+              <a:rPr lang="te-IN" sz="1600" b="0" i="0" dirty="0">
                 <a:solidFill>
                   <a:srgbClr val="000000"/>
                 </a:solidFill>
+                <a:effectLst/>
                 <a:latin typeface="Ramabhadra" panose="02000600000000000000" pitchFamily="2" charset="0"/>
                 <a:cs typeface="Ramabhadra" panose="02000600000000000000" pitchFamily="2" charset="0"/>
               </a:rPr>
-              <a:t>శక్తితో నడిచెదము</a:t>
+              <a:t>మారదు యేసు ప్రేమ – నిత్యుడైన తండ్రి ప్రేమ (2)</a:t>
+            </a:r>
+          </a:p>
+          <a:p>
+            <a:pPr algn="ctr"/>
+            <a:r>
+              <a:rPr lang="te-IN" sz="1600" b="0" i="0" dirty="0">
+                <a:solidFill>
+                  <a:srgbClr val="000000"/>
+                </a:solidFill>
+                <a:effectLst/>
+                <a:latin typeface="Ramabhadra" panose="02000600000000000000" pitchFamily="2" charset="0"/>
+                <a:cs typeface="Ramabhadra" panose="02000600000000000000" pitchFamily="2" charset="0"/>
+              </a:rPr>
+              <a:t>మారదు యేసు ప్రేమ – నిత్యుడైన తండ్రి ప్రేమ (2)</a:t>
+            </a:r>
+          </a:p>
+          <a:p>
+            <a:pPr algn="ctr"/>
+            <a:endParaRPr lang="te-IN" sz="1600" b="0" i="0" dirty="0">
+              <a:solidFill>
+                <a:srgbClr val="000000"/>
+              </a:solidFill>
+              <a:effectLst/>
+              <a:latin typeface="Ramabhadra" panose="02000600000000000000" pitchFamily="2" charset="0"/>
+              <a:cs typeface="Ramabhadra" panose="02000600000000000000" pitchFamily="2" charset="0"/>
+            </a:endParaRPr>
+          </a:p>
+          <a:p>
+            <a:pPr algn="ctr"/>
+            <a:r>
+              <a:rPr lang="te-IN" sz="1600" b="0" i="0" dirty="0">
+                <a:solidFill>
+                  <a:srgbClr val="000000"/>
+                </a:solidFill>
+                <a:effectLst/>
+                <a:latin typeface="Ramabhadra" panose="02000600000000000000" pitchFamily="2" charset="0"/>
+                <a:cs typeface="Ramabhadra" panose="02000600000000000000" pitchFamily="2" charset="0"/>
+              </a:rPr>
+              <a:t>ఆస్తులన్ని కోల్పోయినా – కన్నవారే కనుమరుగైనా</a:t>
+            </a:r>
+          </a:p>
+          <a:p>
+            <a:pPr algn="ctr"/>
+            <a:r>
+              <a:rPr lang="te-IN" sz="1600" b="0" i="0" dirty="0">
+                <a:solidFill>
+                  <a:srgbClr val="000000"/>
+                </a:solidFill>
+                <a:effectLst/>
+                <a:latin typeface="Ramabhadra" panose="02000600000000000000" pitchFamily="2" charset="0"/>
+                <a:cs typeface="Ramabhadra" panose="02000600000000000000" pitchFamily="2" charset="0"/>
+              </a:rPr>
+              <a:t>ఊపిరి భరువైనా – గుండెలే పగిలినా (2)</a:t>
+            </a:r>
+          </a:p>
+          <a:p>
+            <a:pPr algn="ctr"/>
+            <a:r>
+              <a:rPr lang="te-IN" sz="1600" b="0" i="0" dirty="0">
+                <a:solidFill>
+                  <a:srgbClr val="000000"/>
+                </a:solidFill>
+                <a:effectLst/>
+                <a:latin typeface="Ramabhadra" panose="02000600000000000000" pitchFamily="2" charset="0"/>
+                <a:cs typeface="Ramabhadra" panose="02000600000000000000" pitchFamily="2" charset="0"/>
+              </a:rPr>
+              <a:t>యెహోవా ఇచ్చెను – యెహోవా తీసుకొనెను (2)</a:t>
+            </a:r>
+          </a:p>
+          <a:p>
+            <a:pPr algn="ctr"/>
+            <a:r>
+              <a:rPr lang="te-IN" sz="1600" b="0" i="0" dirty="0">
+                <a:solidFill>
+                  <a:srgbClr val="000000"/>
+                </a:solidFill>
+                <a:effectLst/>
+                <a:latin typeface="Ramabhadra" panose="02000600000000000000" pitchFamily="2" charset="0"/>
+                <a:cs typeface="Ramabhadra" panose="02000600000000000000" pitchFamily="2" charset="0"/>
+              </a:rPr>
+              <a:t>ఆయన నామమునకే – స్తుతి కలుగు గాక (2)</a:t>
             </a:r>
           </a:p>
         </p:txBody>
@@ -4662,7 +4799,7 @@
                 <a:latin typeface="Ramabhadra" panose="02000600000000000000" pitchFamily="2" charset="0"/>
                 <a:cs typeface="Ramabhadra" panose="02000600000000000000" pitchFamily="2" charset="0"/>
               </a:rPr>
-              <a:t>పరమున ఆలయం నిరతం నీవేగా</a:t>
+              <a:t>ఆనంద సంద్రమ్మున – నా జీవిత నావను </a:t>
             </a:r>
           </a:p>
           <a:p>
@@ -4675,33 +4812,7 @@
                 <a:latin typeface="Ramabhadra" panose="02000600000000000000" pitchFamily="2" charset="0"/>
                 <a:cs typeface="Ramabhadra" panose="02000600000000000000" pitchFamily="2" charset="0"/>
               </a:rPr>
-              <a:t>సరి సాటి రారు ప్రభువా</a:t>
-            </a:r>
-          </a:p>
-          <a:p>
-            <a:pPr algn="ctr" defTabSz="439781"/>
-            <a:r>
-              <a:rPr lang="te-IN" dirty="0">
-                <a:solidFill>
-                  <a:schemeClr val="tx1"/>
-                </a:solidFill>
-                <a:latin typeface="Ramabhadra" panose="02000600000000000000" pitchFamily="2" charset="0"/>
-                <a:cs typeface="Ramabhadra" panose="02000600000000000000" pitchFamily="2" charset="0"/>
-              </a:rPr>
-              <a:t>నీ సన్నిధి కాంతికి</a:t>
-            </a:r>
-          </a:p>
-          <a:p>
-            <a:pPr algn="ctr" defTabSz="439781"/>
-            <a:r>
-              <a:rPr lang="te-IN" dirty="0">
-                <a:solidFill>
-                  <a:schemeClr val="tx1"/>
-                </a:solidFill>
-                <a:latin typeface="Ramabhadra" panose="02000600000000000000" pitchFamily="2" charset="0"/>
-                <a:cs typeface="Ramabhadra" panose="02000600000000000000" pitchFamily="2" charset="0"/>
-              </a:rPr>
-              <a:t>గొరెపిల్ల మహిమకు (2) </a:t>
+              <a:t>నడిపేది ఆ యేసుడే – దరిచేర్చు ఆ దేవుడే</a:t>
             </a:r>
           </a:p>
           <a:p>
@@ -4724,7 +4835,7 @@
                 <a:latin typeface="Ramabhadra" panose="02000600000000000000" pitchFamily="2" charset="0"/>
                 <a:cs typeface="Ramabhadra" panose="02000600000000000000" pitchFamily="2" charset="0"/>
               </a:rPr>
-              <a:t>ఉండదు దుఃఖమచట</a:t>
+              <a:t>పెనుగాలులే వీచినా – తుఫానులే తరిమినా</a:t>
             </a:r>
           </a:p>
           <a:p>
@@ -4737,7 +4848,7 @@
                 <a:latin typeface="Ramabhadra" panose="02000600000000000000" pitchFamily="2" charset="0"/>
                 <a:cs typeface="Ramabhadra" panose="02000600000000000000" pitchFamily="2" charset="0"/>
               </a:rPr>
-              <a:t>ఉండును దేవుడు </a:t>
+              <a:t>గద్దించి కాపాడు – ప్రభువండ నీకుండ</a:t>
             </a:r>
           </a:p>
           <a:p>
@@ -4750,8 +4861,18 @@
                 <a:latin typeface="Ramabhadra" panose="02000600000000000000" pitchFamily="2" charset="0"/>
                 <a:cs typeface="Ramabhadra" panose="02000600000000000000" pitchFamily="2" charset="0"/>
               </a:rPr>
-              <a:t>తుడిచి వేయును కన్నీటి బాధలు (2)</a:t>
-            </a:r>
+              <a:t>దిగులేల ఓ సోదరా! – నిశ్చింతగా సాగుమా</a:t>
+            </a:r>
+          </a:p>
+          <a:p>
+            <a:pPr algn="ctr" defTabSz="439781"/>
+            <a:endParaRPr lang="te-IN" dirty="0">
+              <a:solidFill>
+                <a:schemeClr val="tx1"/>
+              </a:solidFill>
+              <a:latin typeface="Ramabhadra" panose="02000600000000000000" pitchFamily="2" charset="0"/>
+              <a:cs typeface="Ramabhadra" panose="02000600000000000000" pitchFamily="2" charset="0"/>
+            </a:endParaRPr>
           </a:p>
           <a:p>
             <a:pPr algn="ctr" defTabSz="439781"/>
@@ -4763,7 +4884,7 @@
                 <a:latin typeface="Ramabhadra" panose="02000600000000000000" pitchFamily="2" charset="0"/>
                 <a:cs typeface="Ramabhadra" panose="02000600000000000000" pitchFamily="2" charset="0"/>
               </a:rPr>
-              <a:t>అది అంతము ఆయనే</a:t>
+              <a:t>ఆపత్కాలములందునా –</a:t>
             </a:r>
           </a:p>
           <a:p>
@@ -4776,7 +4897,7 @@
                 <a:latin typeface="Ramabhadra" panose="02000600000000000000" pitchFamily="2" charset="0"/>
                 <a:cs typeface="Ramabhadra" panose="02000600000000000000" pitchFamily="2" charset="0"/>
               </a:rPr>
-              <a:t>జీవ జలముల ఊటయు</a:t>
+              <a:t>రోధించి ప్రార్ధించినా</a:t>
             </a:r>
           </a:p>
           <a:p>
@@ -4789,7 +4910,7 @@
                 <a:latin typeface="Ramabhadra" panose="02000600000000000000" pitchFamily="2" charset="0"/>
                 <a:cs typeface="Ramabhadra" panose="02000600000000000000" pitchFamily="2" charset="0"/>
               </a:rPr>
-              <a:t> </a:t>
+              <a:t>జవాబేమి లేదని – దూషింప బోకుమా</a:t>
             </a:r>
           </a:p>
           <a:p>
@@ -4802,7 +4923,7 @@
                 <a:latin typeface="Ramabhadra" panose="02000600000000000000" pitchFamily="2" charset="0"/>
                 <a:cs typeface="Ramabhadra" panose="02000600000000000000" pitchFamily="2" charset="0"/>
               </a:rPr>
-              <a:t>తండ్రి భూమి మీద</a:t>
+              <a:t>ప్రభుచిత్తమనె గిన్నెనే –</a:t>
             </a:r>
           </a:p>
           <a:p>
@@ -4815,59 +4936,7 @@
                 <a:latin typeface="Ramabhadra" panose="02000600000000000000" pitchFamily="2" charset="0"/>
                 <a:cs typeface="Ramabhadra" panose="02000600000000000000" pitchFamily="2" charset="0"/>
               </a:rPr>
-              <a:t>తన చిత్తము జరిపెను</a:t>
-            </a:r>
-          </a:p>
-          <a:p>
-            <a:pPr algn="ctr" defTabSz="439781"/>
-            <a:r>
-              <a:rPr lang="te-IN" dirty="0">
-                <a:solidFill>
-                  <a:schemeClr val="tx1"/>
-                </a:solidFill>
-                <a:latin typeface="Ramabhadra" panose="02000600000000000000" pitchFamily="2" charset="0"/>
-                <a:cs typeface="Ramabhadra" panose="02000600000000000000" pitchFamily="2" charset="0"/>
-              </a:rPr>
-              <a:t>వ్యాధి లేమీయు</a:t>
-            </a:r>
-          </a:p>
-          <a:p>
-            <a:pPr algn="ctr" defTabSz="439781"/>
-            <a:r>
-              <a:rPr lang="te-IN" dirty="0">
-                <a:solidFill>
-                  <a:schemeClr val="tx1"/>
-                </a:solidFill>
-                <a:latin typeface="Ramabhadra" panose="02000600000000000000" pitchFamily="2" charset="0"/>
-                <a:cs typeface="Ramabhadra" panose="02000600000000000000" pitchFamily="2" charset="0"/>
-              </a:rPr>
-              <a:t>మన పదముల్ తాకెను (2)</a:t>
-            </a:r>
-          </a:p>
-          <a:p>
-            <a:pPr algn="ctr" defTabSz="439781"/>
-            <a:r>
-              <a:rPr lang="te-IN" dirty="0">
-                <a:solidFill>
-                  <a:schemeClr val="tx1"/>
-                </a:solidFill>
-                <a:latin typeface="Ramabhadra" panose="02000600000000000000" pitchFamily="2" charset="0"/>
-                <a:cs typeface="Ramabhadra" panose="02000600000000000000" pitchFamily="2" charset="0"/>
-              </a:rPr>
-              <a:t>జయించి మరణమున్</a:t>
-            </a:r>
-          </a:p>
-          <a:p>
-            <a:pPr algn="ctr" defTabSz="439781"/>
-            <a:r>
-              <a:rPr lang="te-IN" dirty="0">
-                <a:solidFill>
-                  <a:schemeClr val="tx1"/>
-                </a:solidFill>
-                <a:latin typeface="Ramabhadra" panose="02000600000000000000" pitchFamily="2" charset="0"/>
-                <a:cs typeface="Ramabhadra" panose="02000600000000000000" pitchFamily="2" charset="0"/>
-              </a:rPr>
-              <a:t>నిత్య జీవము నిచ్చెను</a:t>
+              <a:t>సంతోషముగ త్రాగుమా </a:t>
             </a:r>
           </a:p>
         </p:txBody>

</xml_diff>

<commit_message>
11 sunday march songs
</commit_message>
<xml_diff>
--- a/xerox.pptx
+++ b/xerox.pptx
@@ -224,7 +224,7 @@
           <a:p>
             <a:fld id="{3502DD63-DF8D-4AB8-92A0-0ECCF612C06C}" type="datetimeFigureOut">
               <a:rPr lang="en-IN" smtClean="0"/>
-              <a:t>02-03-2024</a:t>
+              <a:t>06-03-2024</a:t>
             </a:fld>
             <a:endParaRPr lang="en-IN"/>
           </a:p>
@@ -402,7 +402,7 @@
           <a:p>
             <a:fld id="{1AE741EC-1360-4793-999B-941E0396C9FA}" type="datetimeFigureOut">
               <a:rPr lang="en-IN" smtClean="0"/>
-              <a:t>02-03-2024</a:t>
+              <a:t>06-03-2024</a:t>
             </a:fld>
             <a:endParaRPr lang="en-IN"/>
           </a:p>
@@ -802,7 +802,7 @@
           <a:p>
             <a:fld id="{86FBD32F-FCAD-481A-B7D8-4D813FB7DB24}" type="datetimeFigureOut">
               <a:rPr lang="en-IN" smtClean="0"/>
-              <a:t>02-03-2024</a:t>
+              <a:t>06-03-2024</a:t>
             </a:fld>
             <a:endParaRPr lang="en-IN"/>
           </a:p>
@@ -972,7 +972,7 @@
           <a:p>
             <a:fld id="{86FBD32F-FCAD-481A-B7D8-4D813FB7DB24}" type="datetimeFigureOut">
               <a:rPr lang="en-IN" smtClean="0"/>
-              <a:t>02-03-2024</a:t>
+              <a:t>06-03-2024</a:t>
             </a:fld>
             <a:endParaRPr lang="en-IN"/>
           </a:p>
@@ -1152,7 +1152,7 @@
           <a:p>
             <a:fld id="{86FBD32F-FCAD-481A-B7D8-4D813FB7DB24}" type="datetimeFigureOut">
               <a:rPr lang="en-IN" smtClean="0"/>
-              <a:t>02-03-2024</a:t>
+              <a:t>06-03-2024</a:t>
             </a:fld>
             <a:endParaRPr lang="en-IN"/>
           </a:p>
@@ -1322,7 +1322,7 @@
           <a:p>
             <a:fld id="{86FBD32F-FCAD-481A-B7D8-4D813FB7DB24}" type="datetimeFigureOut">
               <a:rPr lang="en-IN" smtClean="0"/>
-              <a:t>02-03-2024</a:t>
+              <a:t>06-03-2024</a:t>
             </a:fld>
             <a:endParaRPr lang="en-IN"/>
           </a:p>
@@ -1566,7 +1566,7 @@
           <a:p>
             <a:fld id="{86FBD32F-FCAD-481A-B7D8-4D813FB7DB24}" type="datetimeFigureOut">
               <a:rPr lang="en-IN" smtClean="0"/>
-              <a:t>02-03-2024</a:t>
+              <a:t>06-03-2024</a:t>
             </a:fld>
             <a:endParaRPr lang="en-IN"/>
           </a:p>
@@ -1798,7 +1798,7 @@
           <a:p>
             <a:fld id="{86FBD32F-FCAD-481A-B7D8-4D813FB7DB24}" type="datetimeFigureOut">
               <a:rPr lang="en-IN" smtClean="0"/>
-              <a:t>02-03-2024</a:t>
+              <a:t>06-03-2024</a:t>
             </a:fld>
             <a:endParaRPr lang="en-IN"/>
           </a:p>
@@ -2165,7 +2165,7 @@
           <a:p>
             <a:fld id="{86FBD32F-FCAD-481A-B7D8-4D813FB7DB24}" type="datetimeFigureOut">
               <a:rPr lang="en-IN" smtClean="0"/>
-              <a:t>02-03-2024</a:t>
+              <a:t>06-03-2024</a:t>
             </a:fld>
             <a:endParaRPr lang="en-IN"/>
           </a:p>
@@ -2283,7 +2283,7 @@
           <a:p>
             <a:fld id="{86FBD32F-FCAD-481A-B7D8-4D813FB7DB24}" type="datetimeFigureOut">
               <a:rPr lang="en-IN" smtClean="0"/>
-              <a:t>02-03-2024</a:t>
+              <a:t>06-03-2024</a:t>
             </a:fld>
             <a:endParaRPr lang="en-IN"/>
           </a:p>
@@ -2378,7 +2378,7 @@
           <a:p>
             <a:fld id="{86FBD32F-FCAD-481A-B7D8-4D813FB7DB24}" type="datetimeFigureOut">
               <a:rPr lang="en-IN" smtClean="0"/>
-              <a:t>02-03-2024</a:t>
+              <a:t>06-03-2024</a:t>
             </a:fld>
             <a:endParaRPr lang="en-IN"/>
           </a:p>
@@ -2655,7 +2655,7 @@
           <a:p>
             <a:fld id="{86FBD32F-FCAD-481A-B7D8-4D813FB7DB24}" type="datetimeFigureOut">
               <a:rPr lang="en-IN" smtClean="0"/>
-              <a:t>02-03-2024</a:t>
+              <a:t>06-03-2024</a:t>
             </a:fld>
             <a:endParaRPr lang="en-IN"/>
           </a:p>
@@ -2912,7 +2912,7 @@
           <a:p>
             <a:fld id="{86FBD32F-FCAD-481A-B7D8-4D813FB7DB24}" type="datetimeFigureOut">
               <a:rPr lang="en-IN" smtClean="0"/>
-              <a:t>02-03-2024</a:t>
+              <a:t>06-03-2024</a:t>
             </a:fld>
             <a:endParaRPr lang="en-IN"/>
           </a:p>
@@ -3125,7 +3125,7 @@
           <a:p>
             <a:fld id="{86FBD32F-FCAD-481A-B7D8-4D813FB7DB24}" type="datetimeFigureOut">
               <a:rPr lang="en-IN" smtClean="0"/>
-              <a:t>02-03-2024</a:t>
+              <a:t>06-03-2024</a:t>
             </a:fld>
             <a:endParaRPr lang="en-IN"/>
           </a:p>
@@ -3596,7 +3596,7 @@
               <a:defRPr/>
             </a:pPr>
             <a:r>
-              <a:rPr kumimoji="0" lang="te-IN" sz="1700" i="0" u="none" strike="noStrike" kern="1200" cap="none" spc="0" normalizeH="0" baseline="0" noProof="0" dirty="0">
+              <a:rPr kumimoji="0" lang="te-IN" sz="2000" i="0" u="none" strike="noStrike" kern="1200" cap="none" spc="0" normalizeH="0" baseline="0" noProof="0" dirty="0">
                 <a:solidFill>
                   <a:schemeClr val="tx1"/>
                 </a:solidFill>
@@ -3606,8 +3606,44 @@
                 <a:latin typeface="Ramabhadra" panose="02000600000000000000" pitchFamily="2" charset="0"/>
                 <a:cs typeface="Ramabhadra" panose="02000600000000000000" pitchFamily="2" charset="0"/>
               </a:rPr>
-              <a:t>ప్రాణేశ్వర – ప్రభు దైవకుమార</a:t>
-            </a:r>
+              <a:t>యెహోవా ఆలకించుము</a:t>
+            </a:r>
+            <a:r>
+              <a:rPr kumimoji="0" lang="en-IN" sz="2000" i="0" u="none" strike="noStrike" kern="1200" cap="none" spc="0" normalizeH="0" baseline="0" noProof="0" dirty="0">
+                <a:solidFill>
+                  <a:schemeClr val="tx1"/>
+                </a:solidFill>
+                <a:effectLst/>
+                <a:uLnTx/>
+                <a:uFillTx/>
+                <a:latin typeface="Ramabhadra" panose="02000600000000000000" pitchFamily="2" charset="0"/>
+                <a:cs typeface="Ramabhadra" panose="02000600000000000000" pitchFamily="2" charset="0"/>
+              </a:rPr>
+              <a:t> </a:t>
+            </a:r>
+            <a:r>
+              <a:rPr kumimoji="0" lang="te-IN" sz="2000" i="0" u="none" strike="noStrike" kern="1200" cap="none" spc="0" normalizeH="0" baseline="0" noProof="0" dirty="0">
+                <a:solidFill>
+                  <a:schemeClr val="tx1"/>
+                </a:solidFill>
+                <a:effectLst/>
+                <a:uLnTx/>
+                <a:uFillTx/>
+                <a:latin typeface="Ramabhadra" panose="02000600000000000000" pitchFamily="2" charset="0"/>
+                <a:cs typeface="Ramabhadra" panose="02000600000000000000" pitchFamily="2" charset="0"/>
+              </a:rPr>
+              <a:t>దేవా</a:t>
+            </a:r>
+            <a:endParaRPr kumimoji="0" lang="en-IN" sz="2000" i="0" u="none" strike="noStrike" kern="1200" cap="none" spc="0" normalizeH="0" baseline="0" noProof="0" dirty="0">
+              <a:solidFill>
+                <a:schemeClr val="tx1"/>
+              </a:solidFill>
+              <a:effectLst/>
+              <a:uLnTx/>
+              <a:uFillTx/>
+              <a:latin typeface="Ramabhadra" panose="02000600000000000000" pitchFamily="2" charset="0"/>
+              <a:cs typeface="Ramabhadra" panose="02000600000000000000" pitchFamily="2" charset="0"/>
+            </a:endParaRPr>
           </a:p>
           <a:p>
             <a:pPr marL="0" marR="0" lvl="0" indent="0" algn="ctr" defTabSz="439781" rtl="0" eaLnBrk="1" fontAlgn="auto" latinLnBrk="0" hangingPunct="1">
@@ -3625,7 +3661,7 @@
               <a:defRPr/>
             </a:pPr>
             <a:r>
-              <a:rPr kumimoji="0" lang="te-IN" sz="1700" i="0" u="none" strike="noStrike" kern="1200" cap="none" spc="0" normalizeH="0" baseline="0" noProof="0" dirty="0">
+              <a:rPr kumimoji="0" lang="te-IN" sz="2000" i="0" u="none" strike="noStrike" kern="1200" cap="none" spc="0" normalizeH="0" baseline="0" noProof="0" dirty="0">
                 <a:solidFill>
                   <a:schemeClr val="tx1"/>
                 </a:solidFill>
@@ -3635,7 +3671,7 @@
                 <a:latin typeface="Ramabhadra" panose="02000600000000000000" pitchFamily="2" charset="0"/>
                 <a:cs typeface="Ramabhadra" panose="02000600000000000000" pitchFamily="2" charset="0"/>
               </a:rPr>
-              <a:t>ప్రణుతింతును నిన్నే- ఆశతీర</a:t>
+              <a:t>ఆశ్రయ దుర్గము నీవే  </a:t>
             </a:r>
           </a:p>
           <a:p>
@@ -3654,7 +3690,7 @@
               <a:defRPr/>
             </a:pPr>
             <a:r>
-              <a:rPr kumimoji="0" lang="te-IN" sz="1700" i="0" u="none" strike="noStrike" kern="1200" cap="none" spc="0" normalizeH="0" baseline="0" noProof="0" dirty="0">
+              <a:rPr kumimoji="0" lang="te-IN" sz="2000" i="0" u="none" strike="noStrike" kern="1200" cap="none" spc="0" normalizeH="0" baseline="0" noProof="0" dirty="0">
                 <a:solidFill>
                   <a:schemeClr val="tx1"/>
                 </a:solidFill>
@@ -3664,7 +3700,7 @@
                 <a:latin typeface="Ramabhadra" panose="02000600000000000000" pitchFamily="2" charset="0"/>
                 <a:cs typeface="Ramabhadra" panose="02000600000000000000" pitchFamily="2" charset="0"/>
               </a:rPr>
-              <a:t>ప్రాణేశ్వర – ప్రభు దైవకుమార</a:t>
+              <a:t>మా రక్షణ శృంగము మా ఎతైన కోట </a:t>
             </a:r>
           </a:p>
           <a:p>
@@ -3683,7 +3719,7 @@
               <a:defRPr/>
             </a:pPr>
             <a:r>
-              <a:rPr kumimoji="0" lang="te-IN" sz="1700" i="0" u="none" strike="noStrike" kern="1200" cap="none" spc="0" normalizeH="0" baseline="0" noProof="0" dirty="0">
+              <a:rPr kumimoji="0" lang="te-IN" sz="2000" i="0" u="none" strike="noStrike" kern="1200" cap="none" spc="0" normalizeH="0" baseline="0" noProof="0" dirty="0">
                 <a:solidFill>
                   <a:schemeClr val="tx1"/>
                 </a:solidFill>
@@ -3693,7 +3729,7 @@
                 <a:latin typeface="Ramabhadra" panose="02000600000000000000" pitchFamily="2" charset="0"/>
                 <a:cs typeface="Ramabhadra" panose="02000600000000000000" pitchFamily="2" charset="0"/>
               </a:rPr>
-              <a:t>నా ఆత్మతో పాటలు పాడ –</a:t>
+              <a:t>నేను ఎవరికి ఎన్నడు భయపడను</a:t>
             </a:r>
           </a:p>
           <a:p>
@@ -3712,7 +3748,7 @@
               <a:defRPr/>
             </a:pPr>
             <a:r>
-              <a:rPr kumimoji="0" lang="te-IN" sz="1700" i="0" u="none" strike="noStrike" kern="1200" cap="none" spc="0" normalizeH="0" baseline="0" noProof="0" dirty="0">
+              <a:rPr kumimoji="0" lang="te-IN" sz="2000" i="0" u="none" strike="noStrike" kern="1200" cap="none" spc="0" normalizeH="0" baseline="0" noProof="0" dirty="0">
                 <a:solidFill>
                   <a:schemeClr val="tx1"/>
                 </a:solidFill>
@@ -3722,7 +3758,7 @@
                 <a:latin typeface="Ramabhadra" panose="02000600000000000000" pitchFamily="2" charset="0"/>
                 <a:cs typeface="Ramabhadra" panose="02000600000000000000" pitchFamily="2" charset="0"/>
               </a:rPr>
-              <a:t>నీ కృపలే నాకు హేతువులాయె -2</a:t>
+              <a:t>నేను ఎవరికి ఎన్నడు భయపడను</a:t>
             </a:r>
           </a:p>
           <a:p>
@@ -3740,19 +3776,16 @@
               <a:tabLst/>
               <a:defRPr/>
             </a:pPr>
-            <a:r>
-              <a:rPr kumimoji="0" lang="te-IN" sz="1700" i="0" u="none" strike="noStrike" kern="1200" cap="none" spc="0" normalizeH="0" baseline="0" noProof="0" dirty="0">
-                <a:solidFill>
-                  <a:schemeClr val="tx1"/>
-                </a:solidFill>
-                <a:effectLst/>
-                <a:uLnTx/>
-                <a:uFillTx/>
-                <a:latin typeface="Ramabhadra" panose="02000600000000000000" pitchFamily="2" charset="0"/>
-                <a:cs typeface="Ramabhadra" panose="02000600000000000000" pitchFamily="2" charset="0"/>
-              </a:rPr>
-              <a:t>నిత్య నిబంధన నీతో చేసి –</a:t>
-            </a:r>
+            <a:endParaRPr kumimoji="0" lang="te-IN" sz="2000" i="0" u="none" strike="noStrike" kern="1200" cap="none" spc="0" normalizeH="0" baseline="0" noProof="0" dirty="0">
+              <a:solidFill>
+                <a:schemeClr val="tx1"/>
+              </a:solidFill>
+              <a:effectLst/>
+              <a:uLnTx/>
+              <a:uFillTx/>
+              <a:latin typeface="Ramabhadra" panose="02000600000000000000" pitchFamily="2" charset="0"/>
+              <a:cs typeface="Ramabhadra" panose="02000600000000000000" pitchFamily="2" charset="0"/>
+            </a:endParaRPr>
           </a:p>
           <a:p>
             <a:pPr marL="0" marR="0" lvl="0" indent="0" algn="ctr" defTabSz="439781" rtl="0" eaLnBrk="1" fontAlgn="auto" latinLnBrk="0" hangingPunct="1">
@@ -3770,7 +3803,7 @@
               <a:defRPr/>
             </a:pPr>
             <a:r>
-              <a:rPr kumimoji="0" lang="te-IN" sz="1700" i="0" u="none" strike="noStrike" kern="1200" cap="none" spc="0" normalizeH="0" baseline="0" noProof="0" dirty="0">
+              <a:rPr kumimoji="0" lang="te-IN" sz="2000" i="0" u="none" strike="noStrike" kern="1200" cap="none" spc="0" normalizeH="0" baseline="0" noProof="0" dirty="0">
                 <a:solidFill>
                   <a:schemeClr val="tx1"/>
                 </a:solidFill>
@@ -3780,7 +3813,7 @@
                 <a:latin typeface="Ramabhadra" panose="02000600000000000000" pitchFamily="2" charset="0"/>
                 <a:cs typeface="Ramabhadra" panose="02000600000000000000" pitchFamily="2" charset="0"/>
               </a:rPr>
-              <a:t>నీ పాద సన్నిధి చేరియున్నానే -2      </a:t>
+              <a:t>విరిగి నలిగిన హృదయము నీకు </a:t>
             </a:r>
           </a:p>
           <a:p>
@@ -3798,16 +3831,19 @@
               <a:tabLst/>
               <a:defRPr/>
             </a:pPr>
-            <a:endParaRPr kumimoji="0" lang="te-IN" sz="1700" i="0" u="none" strike="noStrike" kern="1200" cap="none" spc="0" normalizeH="0" baseline="0" noProof="0" dirty="0">
-              <a:solidFill>
-                <a:schemeClr val="tx1"/>
-              </a:solidFill>
-              <a:effectLst/>
-              <a:uLnTx/>
-              <a:uFillTx/>
-              <a:latin typeface="Ramabhadra" panose="02000600000000000000" pitchFamily="2" charset="0"/>
-              <a:cs typeface="Ramabhadra" panose="02000600000000000000" pitchFamily="2" charset="0"/>
-            </a:endParaRPr>
+            <a:r>
+              <a:rPr kumimoji="0" lang="te-IN" sz="2000" i="0" u="none" strike="noStrike" kern="1200" cap="none" spc="0" normalizeH="0" baseline="0" noProof="0" dirty="0">
+                <a:solidFill>
+                  <a:schemeClr val="tx1"/>
+                </a:solidFill>
+                <a:effectLst/>
+                <a:uLnTx/>
+                <a:uFillTx/>
+                <a:latin typeface="Ramabhadra" panose="02000600000000000000" pitchFamily="2" charset="0"/>
+                <a:cs typeface="Ramabhadra" panose="02000600000000000000" pitchFamily="2" charset="0"/>
+              </a:rPr>
+              <a:t>ఇష్టమైన బలి కదా దేవా </a:t>
+            </a:r>
           </a:p>
           <a:p>
             <a:pPr marL="0" marR="0" lvl="0" indent="0" algn="ctr" defTabSz="439781" rtl="0" eaLnBrk="1" fontAlgn="auto" latinLnBrk="0" hangingPunct="1">
@@ -3825,7 +3861,7 @@
               <a:defRPr/>
             </a:pPr>
             <a:r>
-              <a:rPr kumimoji="0" lang="te-IN" sz="1700" i="0" u="none" strike="noStrike" kern="1200" cap="none" spc="0" normalizeH="0" baseline="0" noProof="0" dirty="0">
+              <a:rPr kumimoji="0" lang="te-IN" sz="2000" i="0" u="none" strike="noStrike" kern="1200" cap="none" spc="0" normalizeH="0" baseline="0" noProof="0" dirty="0">
                 <a:solidFill>
                   <a:schemeClr val="tx1"/>
                 </a:solidFill>
@@ -3835,7 +3871,7 @@
                 <a:latin typeface="Ramabhadra" panose="02000600000000000000" pitchFamily="2" charset="0"/>
                 <a:cs typeface="Ramabhadra" panose="02000600000000000000" pitchFamily="2" charset="0"/>
               </a:rPr>
-              <a:t>నా ఊటలన్నియు నీ యందేనని –</a:t>
+              <a:t>నాదు హృదయము నర్పించెదను </a:t>
             </a:r>
           </a:p>
           <a:p>
@@ -3854,7 +3890,7 @@
               <a:defRPr/>
             </a:pPr>
             <a:r>
-              <a:rPr kumimoji="0" lang="te-IN" sz="1700" i="0" u="none" strike="noStrike" kern="1200" cap="none" spc="0" normalizeH="0" baseline="0" noProof="0" dirty="0">
+              <a:rPr kumimoji="0" lang="te-IN" sz="2000" i="0" u="none" strike="noStrike" kern="1200" cap="none" spc="0" normalizeH="0" baseline="0" noProof="0" dirty="0">
                 <a:solidFill>
                   <a:schemeClr val="tx1"/>
                 </a:solidFill>
@@ -3864,7 +3900,7 @@
                 <a:latin typeface="Ramabhadra" panose="02000600000000000000" pitchFamily="2" charset="0"/>
                 <a:cs typeface="Ramabhadra" panose="02000600000000000000" pitchFamily="2" charset="0"/>
               </a:rPr>
-              <a:t>వాద్యము వాయించి పాడెదను -2</a:t>
+              <a:t> నా సమస్తము నీదే దేవా </a:t>
             </a:r>
           </a:p>
           <a:p>
@@ -3882,19 +3918,16 @@
               <a:tabLst/>
               <a:defRPr/>
             </a:pPr>
-            <a:r>
-              <a:rPr kumimoji="0" lang="te-IN" sz="1700" i="0" u="none" strike="noStrike" kern="1200" cap="none" spc="0" normalizeH="0" baseline="0" noProof="0" dirty="0">
-                <a:solidFill>
-                  <a:schemeClr val="tx1"/>
-                </a:solidFill>
-                <a:effectLst/>
-                <a:uLnTx/>
-                <a:uFillTx/>
-                <a:latin typeface="Ramabhadra" panose="02000600000000000000" pitchFamily="2" charset="0"/>
-                <a:cs typeface="Ramabhadra" panose="02000600000000000000" pitchFamily="2" charset="0"/>
-              </a:rPr>
-              <a:t>జీవిత కాలమంతా నిన్నే స్తుతించి –</a:t>
-            </a:r>
+            <a:endParaRPr kumimoji="0" lang="te-IN" sz="2000" i="0" u="none" strike="noStrike" kern="1200" cap="none" spc="0" normalizeH="0" baseline="0" noProof="0" dirty="0">
+              <a:solidFill>
+                <a:schemeClr val="tx1"/>
+              </a:solidFill>
+              <a:effectLst/>
+              <a:uLnTx/>
+              <a:uFillTx/>
+              <a:latin typeface="Ramabhadra" panose="02000600000000000000" pitchFamily="2" charset="0"/>
+              <a:cs typeface="Ramabhadra" panose="02000600000000000000" pitchFamily="2" charset="0"/>
+            </a:endParaRPr>
           </a:p>
           <a:p>
             <a:pPr marL="0" marR="0" lvl="0" indent="0" algn="ctr" defTabSz="439781" rtl="0" eaLnBrk="1" fontAlgn="auto" latinLnBrk="0" hangingPunct="1">
@@ -3912,7 +3945,7 @@
               <a:defRPr/>
             </a:pPr>
             <a:r>
-              <a:rPr kumimoji="0" lang="te-IN" sz="1700" i="0" u="none" strike="noStrike" kern="1200" cap="none" spc="0" normalizeH="0" baseline="0" noProof="0" dirty="0">
+              <a:rPr kumimoji="0" lang="te-IN" sz="2000" i="0" u="none" strike="noStrike" kern="1200" cap="none" spc="0" normalizeH="0" baseline="0" noProof="0" dirty="0">
                 <a:solidFill>
                   <a:schemeClr val="tx1"/>
                 </a:solidFill>
@@ -3922,7 +3955,7 @@
                 <a:latin typeface="Ramabhadra" panose="02000600000000000000" pitchFamily="2" charset="0"/>
                 <a:cs typeface="Ramabhadra" panose="02000600000000000000" pitchFamily="2" charset="0"/>
               </a:rPr>
-              <a:t>సాగెద నూతన యెరూషలేము  -2</a:t>
+              <a:t>కారు చీకటిలో కాంతివలే </a:t>
             </a:r>
           </a:p>
           <a:p>
@@ -3940,16 +3973,19 @@
               <a:tabLst/>
               <a:defRPr/>
             </a:pPr>
-            <a:endParaRPr kumimoji="0" lang="te-IN" sz="1700" i="0" u="none" strike="noStrike" kern="1200" cap="none" spc="0" normalizeH="0" baseline="0" noProof="0" dirty="0">
-              <a:solidFill>
-                <a:schemeClr val="tx1"/>
-              </a:solidFill>
-              <a:effectLst/>
-              <a:uLnTx/>
-              <a:uFillTx/>
-              <a:latin typeface="Ramabhadra" panose="02000600000000000000" pitchFamily="2" charset="0"/>
-              <a:cs typeface="Ramabhadra" panose="02000600000000000000" pitchFamily="2" charset="0"/>
-            </a:endParaRPr>
+            <a:r>
+              <a:rPr kumimoji="0" lang="te-IN" sz="2000" i="0" u="none" strike="noStrike" kern="1200" cap="none" spc="0" normalizeH="0" baseline="0" noProof="0" dirty="0">
+                <a:solidFill>
+                  <a:schemeClr val="tx1"/>
+                </a:solidFill>
+                <a:effectLst/>
+                <a:uLnTx/>
+                <a:uFillTx/>
+                <a:latin typeface="Ramabhadra" panose="02000600000000000000" pitchFamily="2" charset="0"/>
+                <a:cs typeface="Ramabhadra" panose="02000600000000000000" pitchFamily="2" charset="0"/>
+              </a:rPr>
+              <a:t>అడుగిడితివి మా బ్రతుకులలో </a:t>
+            </a:r>
           </a:p>
           <a:p>
             <a:pPr marL="0" marR="0" lvl="0" indent="0" algn="ctr" defTabSz="439781" rtl="0" eaLnBrk="1" fontAlgn="auto" latinLnBrk="0" hangingPunct="1">
@@ -3967,7 +4003,7 @@
               <a:defRPr/>
             </a:pPr>
             <a:r>
-              <a:rPr kumimoji="0" lang="te-IN" sz="1700" i="0" u="none" strike="noStrike" kern="1200" cap="none" spc="0" normalizeH="0" baseline="0" noProof="0" dirty="0">
+              <a:rPr kumimoji="0" lang="te-IN" sz="2000" i="0" u="none" strike="noStrike" kern="1200" cap="none" spc="0" normalizeH="0" baseline="0" noProof="0" dirty="0">
                 <a:solidFill>
                   <a:schemeClr val="tx1"/>
                 </a:solidFill>
@@ -3977,7 +4013,7 @@
                 <a:latin typeface="Ramabhadra" panose="02000600000000000000" pitchFamily="2" charset="0"/>
                 <a:cs typeface="Ramabhadra" panose="02000600000000000000" pitchFamily="2" charset="0"/>
               </a:rPr>
-              <a:t>కమనీయమైన నీ దర్శనము –</a:t>
+              <a:t>ఆత్మ దాహము తీర్చు ప్రభువా  </a:t>
             </a:r>
           </a:p>
           <a:p>
@@ -3996,7 +4032,7 @@
               <a:defRPr/>
             </a:pPr>
             <a:r>
-              <a:rPr kumimoji="0" lang="te-IN" sz="1700" i="0" u="none" strike="noStrike" kern="1200" cap="none" spc="0" normalizeH="0" baseline="0" noProof="0" dirty="0">
+              <a:rPr kumimoji="0" lang="te-IN" sz="2000" i="0" u="none" strike="noStrike" kern="1200" cap="none" spc="0" normalizeH="0" baseline="0" noProof="0" dirty="0">
                 <a:solidFill>
                   <a:schemeClr val="tx1"/>
                 </a:solidFill>
@@ -4006,65 +4042,7 @@
                 <a:latin typeface="Ramabhadra" panose="02000600000000000000" pitchFamily="2" charset="0"/>
                 <a:cs typeface="Ramabhadra" panose="02000600000000000000" pitchFamily="2" charset="0"/>
               </a:rPr>
-              <a:t>కలనైనను మెలకువనైన  -2</a:t>
-            </a:r>
-          </a:p>
-          <a:p>
-            <a:pPr marL="0" marR="0" lvl="0" indent="0" algn="ctr" defTabSz="439781" rtl="0" eaLnBrk="1" fontAlgn="auto" latinLnBrk="0" hangingPunct="1">
-              <a:spcBef>
-                <a:spcPts val="0"/>
-              </a:spcBef>
-              <a:spcAft>
-                <a:spcPts val="0"/>
-              </a:spcAft>
-              <a:buClrTx/>
-              <a:buSzTx/>
-              <a:buFontTx/>
-              <a:buNone/>
-              <a:tabLst/>
-              <a:defRPr/>
-            </a:pPr>
-            <a:r>
-              <a:rPr kumimoji="0" lang="te-IN" sz="1700" i="0" u="none" strike="noStrike" kern="1200" cap="none" spc="0" normalizeH="0" baseline="0" noProof="0" dirty="0">
-                <a:solidFill>
-                  <a:schemeClr val="tx1"/>
-                </a:solidFill>
-                <a:effectLst/>
-                <a:uLnTx/>
-                <a:uFillTx/>
-                <a:latin typeface="Ramabhadra" panose="02000600000000000000" pitchFamily="2" charset="0"/>
-                <a:cs typeface="Ramabhadra" panose="02000600000000000000" pitchFamily="2" charset="0"/>
-              </a:rPr>
-              <a:t>కనబడినా నా ఆశలు తీరవే –</a:t>
-            </a:r>
-          </a:p>
-          <a:p>
-            <a:pPr marL="0" marR="0" lvl="0" indent="0" algn="ctr" defTabSz="439781" rtl="0" eaLnBrk="1" fontAlgn="auto" latinLnBrk="0" hangingPunct="1">
-              <a:spcBef>
-                <a:spcPts val="0"/>
-              </a:spcBef>
-              <a:spcAft>
-                <a:spcPts val="0"/>
-              </a:spcAft>
-              <a:buClrTx/>
-              <a:buSzTx/>
-              <a:buFontTx/>
-              <a:buNone/>
-              <a:tabLst/>
-              <a:defRPr/>
-            </a:pPr>
-            <a:r>
-              <a:rPr kumimoji="0" lang="te-IN" sz="1700" i="0" u="none" strike="noStrike" kern="1200" cap="none" spc="0" normalizeH="0" baseline="0" noProof="0" dirty="0">
-                <a:solidFill>
-                  <a:schemeClr val="tx1"/>
-                </a:solidFill>
-                <a:effectLst/>
-                <a:uLnTx/>
-                <a:uFillTx/>
-                <a:latin typeface="Ramabhadra" panose="02000600000000000000" pitchFamily="2" charset="0"/>
-                <a:cs typeface="Ramabhadra" panose="02000600000000000000" pitchFamily="2" charset="0"/>
-              </a:rPr>
-              <a:t>కనిపెట్టుచుంటిని కడబూరధ్వనికి -2</a:t>
+              <a:t>పరమ బాటలో నడిపించితివి</a:t>
             </a:r>
           </a:p>
         </p:txBody>
@@ -4137,7 +4115,7 @@
                 <a:latin typeface="Ramabhadra" panose="02000600000000000000" pitchFamily="2" charset="0"/>
                 <a:cs typeface="Ramabhadra" panose="02000600000000000000" pitchFamily="2" charset="0"/>
               </a:rPr>
-              <a:t>స్తుతి పాత్రుడా – స్తోత్రార్హుడా</a:t>
+              <a:t>నిను స్తుతించినా చాలు నా బ్రతుకు దినములో</a:t>
             </a:r>
           </a:p>
           <a:p>
@@ -4158,7 +4136,7 @@
                 <a:latin typeface="Ramabhadra" panose="02000600000000000000" pitchFamily="2" charset="0"/>
                 <a:cs typeface="Ramabhadra" panose="02000600000000000000" pitchFamily="2" charset="0"/>
               </a:rPr>
-              <a:t>స్తుతులందుకో - పూజార్హుడా</a:t>
+              <a:t>నిను పొగిడినా చాలు నా గుండె గుడిలో (2)</a:t>
             </a:r>
           </a:p>
           <a:p>
@@ -4179,7 +4157,7 @@
                 <a:latin typeface="Ramabhadra" panose="02000600000000000000" pitchFamily="2" charset="0"/>
                 <a:cs typeface="Ramabhadra" panose="02000600000000000000" pitchFamily="2" charset="0"/>
               </a:rPr>
-              <a:t>ఆకాశమందు నీవు తప్ప –</a:t>
+              <a:t>ఉన్నా లేకున్నా నా స్థితి గతులే మారినా</a:t>
             </a:r>
           </a:p>
           <a:p>
@@ -4200,7 +4178,7 @@
                 <a:latin typeface="Ramabhadra" panose="02000600000000000000" pitchFamily="2" charset="0"/>
                 <a:cs typeface="Ramabhadra" panose="02000600000000000000" pitchFamily="2" charset="0"/>
               </a:rPr>
-              <a:t>నాకెవరున్నారు నా ప్రభు</a:t>
+              <a:t>నీ సన్నిధిలో…</a:t>
             </a:r>
           </a:p>
           <a:p>
@@ -4221,8 +4199,16 @@
                 <a:latin typeface="Ramabhadra" panose="02000600000000000000" pitchFamily="2" charset="0"/>
                 <a:cs typeface="Ramabhadra" panose="02000600000000000000" pitchFamily="2" charset="0"/>
               </a:rPr>
-              <a:t>స్తుతి పాత్రుడా.... ఆఆఅ</a:t>
-            </a:r>
+              <a:t>నీ సన్నిధిలో ఆనందించే భాగ్యమున్నా చాలు</a:t>
+            </a:r>
+            <a:endParaRPr lang="en-IN" sz="1600" b="0" i="0" dirty="0">
+              <a:solidFill>
+                <a:schemeClr val="tx1"/>
+              </a:solidFill>
+              <a:effectLst/>
+              <a:latin typeface="Ramabhadra" panose="02000600000000000000" pitchFamily="2" charset="0"/>
+              <a:cs typeface="Ramabhadra" panose="02000600000000000000" pitchFamily="2" charset="0"/>
+            </a:endParaRPr>
           </a:p>
           <a:p>
             <a:pPr marL="0" marR="0" indent="0" algn="ctr" rtl="0" eaLnBrk="1" fontAlgn="auto" latinLnBrk="0" hangingPunct="1">
@@ -4260,7 +4246,7 @@
                 <a:latin typeface="Ramabhadra" panose="02000600000000000000" pitchFamily="2" charset="0"/>
                 <a:cs typeface="Ramabhadra" panose="02000600000000000000" pitchFamily="2" charset="0"/>
               </a:rPr>
-              <a:t>నా శత్రువులు నను తరుముచుండగా - నా యాత్మ నాలో కృంగెనే ప్రభూ -2</a:t>
+              <a:t>స్తుతులకు పాత్రుడవు నీవేనయ్యా</a:t>
             </a:r>
           </a:p>
           <a:p>
@@ -4281,7 +4267,7 @@
                 <a:latin typeface="Ramabhadra" panose="02000600000000000000" pitchFamily="2" charset="0"/>
                 <a:cs typeface="Ramabhadra" panose="02000600000000000000" pitchFamily="2" charset="0"/>
               </a:rPr>
-              <a:t>నా మనస్సు నీ వైపు త్రిప్పిన వెంటనే –</a:t>
+              <a:t>స్తోత్రార్హుడవు నీవేనయ్యా (2)</a:t>
             </a:r>
           </a:p>
           <a:p>
@@ -4302,28 +4288,7 @@
                 <a:latin typeface="Ramabhadra" panose="02000600000000000000" pitchFamily="2" charset="0"/>
                 <a:cs typeface="Ramabhadra" panose="02000600000000000000" pitchFamily="2" charset="0"/>
               </a:rPr>
-              <a:t>శత్రుల చేతినుండి</a:t>
-            </a:r>
-          </a:p>
-          <a:p>
-            <a:pPr marL="0" marR="0" indent="0" algn="ctr" rtl="0" eaLnBrk="1" fontAlgn="auto" latinLnBrk="0" hangingPunct="1">
-              <a:spcBef>
-                <a:spcPts val="0"/>
-              </a:spcBef>
-              <a:spcAft>
-                <a:spcPts val="0"/>
-              </a:spcAft>
-            </a:pPr>
-            <a:r>
-              <a:rPr lang="te-IN" sz="1600" b="0" i="0" dirty="0">
-                <a:solidFill>
-                  <a:schemeClr val="tx1"/>
-                </a:solidFill>
-                <a:effectLst/>
-                <a:latin typeface="Ramabhadra" panose="02000600000000000000" pitchFamily="2" charset="0"/>
-                <a:cs typeface="Ramabhadra" panose="02000600000000000000" pitchFamily="2" charset="0"/>
-              </a:rPr>
-              <a:t>విడిపించినావు - కాపాడినావు -2</a:t>
+              <a:t>నీవేనయ్యా నాకు నీవేనయ్యా (2)</a:t>
             </a:r>
           </a:p>
           <a:p>
@@ -4362,7 +4327,7 @@
                 <a:latin typeface="Ramabhadra" panose="02000600000000000000" pitchFamily="2" charset="0"/>
                 <a:cs typeface="Ramabhadra" panose="02000600000000000000" pitchFamily="2" charset="0"/>
               </a:rPr>
-              <a:t>నా ప్రాణ స్నేహితులు నన్ను చూచి దూరాన నిలిచేరు నా ప్రభూ -2</a:t>
+              <a:t>ప్రేమా స్వరూపుడవు నీవేనయ్యా</a:t>
             </a:r>
           </a:p>
           <a:p>
@@ -4383,7 +4348,7 @@
                 <a:latin typeface="Ramabhadra" panose="02000600000000000000" pitchFamily="2" charset="0"/>
                 <a:cs typeface="Ramabhadra" panose="02000600000000000000" pitchFamily="2" charset="0"/>
               </a:rPr>
-              <a:t>నీ వాక్య ధ్యానమే నా త్రోవకు వెలుగై –</a:t>
+              <a:t>స్తోత్రార్హుడవు నీవేనయ్యా (2)</a:t>
             </a:r>
           </a:p>
           <a:p>
@@ -4404,28 +4369,7 @@
                 <a:latin typeface="Ramabhadra" panose="02000600000000000000" pitchFamily="2" charset="0"/>
                 <a:cs typeface="Ramabhadra" panose="02000600000000000000" pitchFamily="2" charset="0"/>
               </a:rPr>
-              <a:t>నను నిల్పెను</a:t>
-            </a:r>
-          </a:p>
-          <a:p>
-            <a:pPr marL="0" marR="0" indent="0" algn="ctr" rtl="0" eaLnBrk="1" fontAlgn="auto" latinLnBrk="0" hangingPunct="1">
-              <a:spcBef>
-                <a:spcPts val="0"/>
-              </a:spcBef>
-              <a:spcAft>
-                <a:spcPts val="0"/>
-              </a:spcAft>
-            </a:pPr>
-            <a:r>
-              <a:rPr lang="te-IN" sz="1600" b="0" i="0" dirty="0">
-                <a:solidFill>
-                  <a:schemeClr val="tx1"/>
-                </a:solidFill>
-                <a:effectLst/>
-                <a:latin typeface="Ramabhadra" panose="02000600000000000000" pitchFamily="2" charset="0"/>
-                <a:cs typeface="Ramabhadra" panose="02000600000000000000" pitchFamily="2" charset="0"/>
-              </a:rPr>
-              <a:t>నీ సన్నీధిలో - నీ సంఘములో -2</a:t>
+              <a:t>నీవేనయ్యా నాకు నీవేనయ్యా (2) </a:t>
             </a:r>
           </a:p>
         </p:txBody>
@@ -4491,7 +4435,7 @@
                 <a:latin typeface="Ramabhadra" panose="02000600000000000000" pitchFamily="2" charset="0"/>
                 <a:cs typeface="Ramabhadra" panose="02000600000000000000" pitchFamily="2" charset="0"/>
               </a:rPr>
-              <a:t>నేనెల్లప్పుడు యెహోవను సన్నుతించెదన్</a:t>
+              <a:t>అపారమైనది నీ కృప  </a:t>
             </a:r>
           </a:p>
           <a:p>
@@ -4505,7 +4449,49 @@
                 <a:latin typeface="Ramabhadra" panose="02000600000000000000" pitchFamily="2" charset="0"/>
                 <a:cs typeface="Ramabhadra" panose="02000600000000000000" pitchFamily="2" charset="0"/>
               </a:rPr>
-              <a:t>నిత్యము ఆయన కీర్తి నా నోట నుండున్ (2)</a:t>
+              <a:t>అమూల్యమైనది నీ కృప</a:t>
+            </a:r>
+          </a:p>
+          <a:p>
+            <a:pPr algn="ctr"/>
+            <a:r>
+              <a:rPr lang="te-IN" sz="1600" b="0" i="0" dirty="0">
+                <a:solidFill>
+                  <a:srgbClr val="000000"/>
+                </a:solidFill>
+                <a:effectLst/>
+                <a:latin typeface="Ramabhadra" panose="02000600000000000000" pitchFamily="2" charset="0"/>
+                <a:cs typeface="Ramabhadra" panose="02000600000000000000" pitchFamily="2" charset="0"/>
+              </a:rPr>
+              <a:t>జీవము కంటె ఉత్తమమైనది  </a:t>
+            </a:r>
+          </a:p>
+          <a:p>
+            <a:pPr algn="ctr"/>
+            <a:r>
+              <a:rPr lang="te-IN" sz="1600" b="0" i="0" dirty="0">
+                <a:solidFill>
+                  <a:srgbClr val="000000"/>
+                </a:solidFill>
+                <a:effectLst/>
+                <a:latin typeface="Ramabhadra" panose="02000600000000000000" pitchFamily="2" charset="0"/>
+                <a:cs typeface="Ramabhadra" panose="02000600000000000000" pitchFamily="2" charset="0"/>
+              </a:rPr>
+              <a:t>పర్వత శిఖరము కన్న ఎతైనది</a:t>
+            </a:r>
+          </a:p>
+          <a:p>
+            <a:pPr algn="ctr"/>
+            <a:r>
+              <a:rPr lang="te-IN" sz="1600" b="0" i="0" dirty="0">
+                <a:solidFill>
+                  <a:srgbClr val="000000"/>
+                </a:solidFill>
+                <a:effectLst/>
+                <a:latin typeface="Ramabhadra" panose="02000600000000000000" pitchFamily="2" charset="0"/>
+                <a:cs typeface="Ramabhadra" panose="02000600000000000000" pitchFamily="2" charset="0"/>
+              </a:rPr>
+              <a:t>కృప కృప కృప కృప నీకృప   ॥2॥</a:t>
             </a:r>
           </a:p>
           <a:p>
@@ -4530,7 +4516,7 @@
                 <a:latin typeface="Ramabhadra" panose="02000600000000000000" pitchFamily="2" charset="0"/>
                 <a:cs typeface="Ramabhadra" panose="02000600000000000000" pitchFamily="2" charset="0"/>
               </a:rPr>
-              <a:t>అంతా నా మేలుకే – ఆరాధన యేసుకే</a:t>
+              <a:t>పాప దాస్యములో చిక్కబడి యుండగా </a:t>
             </a:r>
           </a:p>
           <a:p>
@@ -4544,7 +4530,7 @@
                 <a:latin typeface="Ramabhadra" panose="02000600000000000000" pitchFamily="2" charset="0"/>
                 <a:cs typeface="Ramabhadra" panose="02000600000000000000" pitchFamily="2" charset="0"/>
               </a:rPr>
-              <a:t>అంతా నా మంచికే –</a:t>
+              <a:t>నను రక్షించెను నీకృప</a:t>
             </a:r>
           </a:p>
           <a:p>
@@ -4558,7 +4544,7 @@
                 <a:latin typeface="Ramabhadra" panose="02000600000000000000" pitchFamily="2" charset="0"/>
                 <a:cs typeface="Ramabhadra" panose="02000600000000000000" pitchFamily="2" charset="0"/>
               </a:rPr>
-              <a:t>తన చిత్తమునకు తల వంచితే</a:t>
+              <a:t>రోగబలహీనతందునే కృంగి యుండగా</a:t>
             </a:r>
           </a:p>
           <a:p>
@@ -4572,7 +4558,7 @@
                 <a:latin typeface="Ramabhadra" panose="02000600000000000000" pitchFamily="2" charset="0"/>
                 <a:cs typeface="Ramabhadra" panose="02000600000000000000" pitchFamily="2" charset="0"/>
               </a:rPr>
-              <a:t>తన చిత్తమునకు తల వంచితే</a:t>
+              <a:t> నను స్వస్థపరచును నీకృప</a:t>
             </a:r>
           </a:p>
           <a:p>
@@ -4586,7 +4572,7 @@
                 <a:latin typeface="Ramabhadra" panose="02000600000000000000" pitchFamily="2" charset="0"/>
                 <a:cs typeface="Ramabhadra" panose="02000600000000000000" pitchFamily="2" charset="0"/>
               </a:rPr>
-              <a:t>ఆరాధన ఆపను – స్తుతియించుట మానను (2)</a:t>
+              <a:t>మారా వంటి జీవితం </a:t>
             </a:r>
           </a:p>
           <a:p>
@@ -4600,7 +4586,7 @@
                 <a:latin typeface="Ramabhadra" panose="02000600000000000000" pitchFamily="2" charset="0"/>
                 <a:cs typeface="Ramabhadra" panose="02000600000000000000" pitchFamily="2" charset="0"/>
               </a:rPr>
-              <a:t>స్తుతియించుట మానను</a:t>
+              <a:t>మధురముగా మార్చెను నీ కృప</a:t>
             </a:r>
           </a:p>
           <a:p>
@@ -4625,7 +4611,7 @@
                 <a:latin typeface="Ramabhadra" panose="02000600000000000000" pitchFamily="2" charset="0"/>
                 <a:cs typeface="Ramabhadra" panose="02000600000000000000" pitchFamily="2" charset="0"/>
               </a:rPr>
-              <a:t>కన్నీళ్లే పానములైనా – కఠిన దుఃఖ బాధలైనా</a:t>
+              <a:t>నా హీన స్థితిలో పడిపోయి ఉండగా</a:t>
             </a:r>
           </a:p>
           <a:p>
@@ -4639,7 +4625,7 @@
                 <a:latin typeface="Ramabhadra" panose="02000600000000000000" pitchFamily="2" charset="0"/>
                 <a:cs typeface="Ramabhadra" panose="02000600000000000000" pitchFamily="2" charset="0"/>
               </a:rPr>
-              <a:t>స్థితి గతులే మారినా – అవకాశం చేజారినా (2)</a:t>
+              <a:t> నను లేవనెత్తేను నీ కృప</a:t>
             </a:r>
           </a:p>
           <a:p>
@@ -4653,7 +4639,7 @@
                 <a:latin typeface="Ramabhadra" panose="02000600000000000000" pitchFamily="2" charset="0"/>
                 <a:cs typeface="Ramabhadra" panose="02000600000000000000" pitchFamily="2" charset="0"/>
               </a:rPr>
-              <a:t>మారదు యేసు ప్రేమ – నిత్యుడైన తండ్రి ప్రేమ (2)</a:t>
+              <a:t>ఆదరించు వారు లేక అలసియున్న నన్ను </a:t>
             </a:r>
           </a:p>
           <a:p>
@@ -4667,19 +4653,22 @@
                 <a:latin typeface="Ramabhadra" panose="02000600000000000000" pitchFamily="2" charset="0"/>
                 <a:cs typeface="Ramabhadra" panose="02000600000000000000" pitchFamily="2" charset="0"/>
               </a:rPr>
-              <a:t>మారదు యేసు ప్రేమ – నిత్యుడైన తండ్రి ప్రేమ (2)</a:t>
+              <a:t>ఆదరించెను నీ కృప</a:t>
             </a:r>
           </a:p>
           <a:p>
             <a:pPr algn="ctr"/>
-            <a:endParaRPr lang="te-IN" sz="1600" b="0" i="0" dirty="0">
-              <a:solidFill>
-                <a:srgbClr val="000000"/>
-              </a:solidFill>
-              <a:effectLst/>
-              <a:latin typeface="Ramabhadra" panose="02000600000000000000" pitchFamily="2" charset="0"/>
-              <a:cs typeface="Ramabhadra" panose="02000600000000000000" pitchFamily="2" charset="0"/>
-            </a:endParaRPr>
+            <a:r>
+              <a:rPr lang="te-IN" sz="1600" b="0" i="0" dirty="0">
+                <a:solidFill>
+                  <a:srgbClr val="000000"/>
+                </a:solidFill>
+                <a:effectLst/>
+                <a:latin typeface="Ramabhadra" panose="02000600000000000000" pitchFamily="2" charset="0"/>
+                <a:cs typeface="Ramabhadra" panose="02000600000000000000" pitchFamily="2" charset="0"/>
+              </a:rPr>
+              <a:t>మోడైన నా జీవితం </a:t>
+            </a:r>
           </a:p>
           <a:p>
             <a:pPr algn="ctr"/>
@@ -4692,49 +4681,7 @@
                 <a:latin typeface="Ramabhadra" panose="02000600000000000000" pitchFamily="2" charset="0"/>
                 <a:cs typeface="Ramabhadra" panose="02000600000000000000" pitchFamily="2" charset="0"/>
               </a:rPr>
-              <a:t>ఆస్తులన్ని కోల్పోయినా – కన్నవారే కనుమరుగైనా</a:t>
-            </a:r>
-          </a:p>
-          <a:p>
-            <a:pPr algn="ctr"/>
-            <a:r>
-              <a:rPr lang="te-IN" sz="1600" b="0" i="0" dirty="0">
-                <a:solidFill>
-                  <a:srgbClr val="000000"/>
-                </a:solidFill>
-                <a:effectLst/>
-                <a:latin typeface="Ramabhadra" panose="02000600000000000000" pitchFamily="2" charset="0"/>
-                <a:cs typeface="Ramabhadra" panose="02000600000000000000" pitchFamily="2" charset="0"/>
-              </a:rPr>
-              <a:t>ఊపిరి భరువైనా – గుండెలే పగిలినా (2)</a:t>
-            </a:r>
-          </a:p>
-          <a:p>
-            <a:pPr algn="ctr"/>
-            <a:r>
-              <a:rPr lang="te-IN" sz="1600" b="0" i="0" dirty="0">
-                <a:solidFill>
-                  <a:srgbClr val="000000"/>
-                </a:solidFill>
-                <a:effectLst/>
-                <a:latin typeface="Ramabhadra" panose="02000600000000000000" pitchFamily="2" charset="0"/>
-                <a:cs typeface="Ramabhadra" panose="02000600000000000000" pitchFamily="2" charset="0"/>
-              </a:rPr>
-              <a:t>యెహోవా ఇచ్చెను – యెహోవా తీసుకొనెను (2)</a:t>
-            </a:r>
-          </a:p>
-          <a:p>
-            <a:pPr algn="ctr"/>
-            <a:r>
-              <a:rPr lang="te-IN" sz="1600" b="0" i="0" dirty="0">
-                <a:solidFill>
-                  <a:srgbClr val="000000"/>
-                </a:solidFill>
-                <a:effectLst/>
-                <a:latin typeface="Ramabhadra" panose="02000600000000000000" pitchFamily="2" charset="0"/>
-                <a:cs typeface="Ramabhadra" panose="02000600000000000000" pitchFamily="2" charset="0"/>
-              </a:rPr>
-              <a:t>ఆయన నామమునకే – స్తుతి కలుగు గాక (2)</a:t>
+              <a:t>చిగురింపజేసెను నీ కృప </a:t>
             </a:r>
           </a:p>
         </p:txBody>
@@ -4792,32 +4739,16 @@
           <a:p>
             <a:pPr algn="ctr" defTabSz="439781"/>
             <a:r>
-              <a:rPr lang="te-IN" dirty="0">
+              <a:rPr lang="te-IN" sz="1500" dirty="0">
                 <a:solidFill>
                   <a:schemeClr val="tx1"/>
                 </a:solidFill>
                 <a:latin typeface="Ramabhadra" panose="02000600000000000000" pitchFamily="2" charset="0"/>
                 <a:cs typeface="Ramabhadra" panose="02000600000000000000" pitchFamily="2" charset="0"/>
               </a:rPr>
-              <a:t>ఆనంద సంద్రమ్మున – నా జీవిత నావను </a:t>
-            </a:r>
-          </a:p>
-          <a:p>
-            <a:pPr algn="ctr" defTabSz="439781"/>
-            <a:r>
-              <a:rPr lang="te-IN" dirty="0">
-                <a:solidFill>
-                  <a:schemeClr val="tx1"/>
-                </a:solidFill>
-                <a:latin typeface="Ramabhadra" panose="02000600000000000000" pitchFamily="2" charset="0"/>
-                <a:cs typeface="Ramabhadra" panose="02000600000000000000" pitchFamily="2" charset="0"/>
-              </a:rPr>
-              <a:t>నడిపేది ఆ యేసుడే – దరిచేర్చు ఆ దేవుడే</a:t>
-            </a:r>
-          </a:p>
-          <a:p>
-            <a:pPr algn="ctr" defTabSz="439781"/>
-            <a:endParaRPr lang="te-IN" dirty="0">
+              <a:t>స్తుతి పాడుటకే బ్రతికించిన –</a:t>
+            </a:r>
+            <a:endParaRPr lang="en-IN" sz="1500" dirty="0">
               <a:solidFill>
                 <a:schemeClr val="tx1"/>
               </a:solidFill>
@@ -4828,45 +4759,71 @@
           <a:p>
             <a:pPr algn="ctr" defTabSz="439781"/>
             <a:r>
-              <a:rPr lang="te-IN" dirty="0">
+              <a:rPr lang="te-IN" sz="1500" dirty="0">
                 <a:solidFill>
                   <a:schemeClr val="tx1"/>
                 </a:solidFill>
                 <a:latin typeface="Ramabhadra" panose="02000600000000000000" pitchFamily="2" charset="0"/>
                 <a:cs typeface="Ramabhadra" panose="02000600000000000000" pitchFamily="2" charset="0"/>
               </a:rPr>
-              <a:t>పెనుగాలులే వీచినా – తుఫానులే తరిమినా</a:t>
+              <a:t>జీవనదాతవు నీవేనయ్యా</a:t>
             </a:r>
           </a:p>
           <a:p>
             <a:pPr algn="ctr" defTabSz="439781"/>
             <a:r>
-              <a:rPr lang="te-IN" dirty="0">
+              <a:rPr lang="te-IN" sz="1500" dirty="0">
                 <a:solidFill>
                   <a:schemeClr val="tx1"/>
                 </a:solidFill>
                 <a:latin typeface="Ramabhadra" panose="02000600000000000000" pitchFamily="2" charset="0"/>
                 <a:cs typeface="Ramabhadra" panose="02000600000000000000" pitchFamily="2" charset="0"/>
               </a:rPr>
-              <a:t>గద్దించి కాపాడు – ప్రభువండ నీకుండ</a:t>
+              <a:t>ఇన్నాళ్లుగా నను పోషించిన – తల్లివలె నను ఓదార్చిన</a:t>
             </a:r>
           </a:p>
           <a:p>
             <a:pPr algn="ctr" defTabSz="439781"/>
             <a:r>
-              <a:rPr lang="te-IN" dirty="0">
+              <a:rPr lang="te-IN" sz="1500" dirty="0">
                 <a:solidFill>
                   <a:schemeClr val="tx1"/>
                 </a:solidFill>
                 <a:latin typeface="Ramabhadra" panose="02000600000000000000" pitchFamily="2" charset="0"/>
                 <a:cs typeface="Ramabhadra" panose="02000600000000000000" pitchFamily="2" charset="0"/>
               </a:rPr>
-              <a:t>దిగులేల ఓ సోదరా! – నిశ్చింతగా సాగుమా</a:t>
+              <a:t>నీ ప్రేమ నాపై ఎన్నడు మారదు యేసయ్యా (2)</a:t>
             </a:r>
           </a:p>
           <a:p>
             <a:pPr algn="ctr" defTabSz="439781"/>
-            <a:endParaRPr lang="te-IN" dirty="0">
+            <a:r>
+              <a:rPr lang="te-IN" sz="1500" dirty="0">
+                <a:solidFill>
+                  <a:schemeClr val="tx1"/>
+                </a:solidFill>
+                <a:latin typeface="Ramabhadra" panose="02000600000000000000" pitchFamily="2" charset="0"/>
+                <a:cs typeface="Ramabhadra" panose="02000600000000000000" pitchFamily="2" charset="0"/>
+              </a:rPr>
+              <a:t>జీవితకాలమంతా ఆధారం నీవేనయ్యా</a:t>
+            </a:r>
+          </a:p>
+          <a:p>
+            <a:pPr algn="ctr" defTabSz="439781"/>
+            <a:r>
+              <a:rPr lang="te-IN" sz="1500" dirty="0">
+                <a:solidFill>
+                  <a:schemeClr val="tx1"/>
+                </a:solidFill>
+                <a:latin typeface="Ramabhadra" panose="02000600000000000000" pitchFamily="2" charset="0"/>
+                <a:cs typeface="Ramabhadra" panose="02000600000000000000" pitchFamily="2" charset="0"/>
+              </a:rPr>
+              <a:t>నా జీవితకాలమంతా ఆరాధించి ఘనపరతును</a:t>
+            </a:r>
+          </a:p>
+          <a:p>
+            <a:pPr algn="ctr" defTabSz="439781"/>
+            <a:endParaRPr lang="te-IN" sz="1500" dirty="0">
               <a:solidFill>
                 <a:schemeClr val="tx1"/>
               </a:solidFill>
@@ -4877,66 +4834,175 @@
           <a:p>
             <a:pPr algn="ctr" defTabSz="439781"/>
             <a:r>
-              <a:rPr lang="te-IN" dirty="0">
+              <a:rPr lang="te-IN" sz="1500" dirty="0">
                 <a:solidFill>
                   <a:schemeClr val="tx1"/>
                 </a:solidFill>
                 <a:latin typeface="Ramabhadra" panose="02000600000000000000" pitchFamily="2" charset="0"/>
                 <a:cs typeface="Ramabhadra" panose="02000600000000000000" pitchFamily="2" charset="0"/>
               </a:rPr>
-              <a:t>ఆపత్కాలములందునా –</a:t>
-            </a:r>
+              <a:t>ప్రాణభయమును తొలగించినావు –</a:t>
+            </a:r>
+            <a:endParaRPr lang="en-IN" sz="1500" dirty="0">
+              <a:solidFill>
+                <a:schemeClr val="tx1"/>
+              </a:solidFill>
+              <a:latin typeface="Ramabhadra" panose="02000600000000000000" pitchFamily="2" charset="0"/>
+              <a:cs typeface="Ramabhadra" panose="02000600000000000000" pitchFamily="2" charset="0"/>
+            </a:endParaRPr>
           </a:p>
           <a:p>
             <a:pPr algn="ctr" defTabSz="439781"/>
             <a:r>
-              <a:rPr lang="te-IN" dirty="0">
+              <a:rPr lang="te-IN" sz="1500" dirty="0">
                 <a:solidFill>
                   <a:schemeClr val="tx1"/>
                 </a:solidFill>
                 <a:latin typeface="Ramabhadra" panose="02000600000000000000" pitchFamily="2" charset="0"/>
                 <a:cs typeface="Ramabhadra" panose="02000600000000000000" pitchFamily="2" charset="0"/>
               </a:rPr>
-              <a:t>రోధించి ప్రార్ధించినా</a:t>
+              <a:t>ప్రాకారములను స్థాపించినావు</a:t>
             </a:r>
           </a:p>
           <a:p>
             <a:pPr algn="ctr" defTabSz="439781"/>
             <a:r>
-              <a:rPr lang="te-IN" dirty="0">
+              <a:rPr lang="te-IN" sz="1500" dirty="0">
                 <a:solidFill>
                   <a:schemeClr val="tx1"/>
                 </a:solidFill>
                 <a:latin typeface="Ramabhadra" panose="02000600000000000000" pitchFamily="2" charset="0"/>
                 <a:cs typeface="Ramabhadra" panose="02000600000000000000" pitchFamily="2" charset="0"/>
               </a:rPr>
-              <a:t>జవాబేమి లేదని – దూషింప బోకుమా</a:t>
-            </a:r>
+              <a:t>సర్వజనులలో నీ మహిమ వివరింప</a:t>
+            </a:r>
+            <a:endParaRPr lang="en-IN" sz="1500" dirty="0">
+              <a:solidFill>
+                <a:schemeClr val="tx1"/>
+              </a:solidFill>
+              <a:latin typeface="Ramabhadra" panose="02000600000000000000" pitchFamily="2" charset="0"/>
+              <a:cs typeface="Ramabhadra" panose="02000600000000000000" pitchFamily="2" charset="0"/>
+            </a:endParaRPr>
           </a:p>
           <a:p>
             <a:pPr algn="ctr" defTabSz="439781"/>
             <a:r>
-              <a:rPr lang="te-IN" dirty="0">
+              <a:rPr lang="te-IN" sz="1500" dirty="0">
                 <a:solidFill>
                   <a:schemeClr val="tx1"/>
                 </a:solidFill>
                 <a:latin typeface="Ramabhadra" panose="02000600000000000000" pitchFamily="2" charset="0"/>
                 <a:cs typeface="Ramabhadra" panose="02000600000000000000" pitchFamily="2" charset="0"/>
               </a:rPr>
-              <a:t>ప్రభుచిత్తమనె గిన్నెనే –</a:t>
+              <a:t>దీర్ఘాయువుతో నను నింపినావు (2)</a:t>
             </a:r>
           </a:p>
           <a:p>
             <a:pPr algn="ctr" defTabSz="439781"/>
             <a:r>
-              <a:rPr lang="te-IN" dirty="0">
+              <a:rPr lang="te-IN" sz="1500" dirty="0">
                 <a:solidFill>
                   <a:schemeClr val="tx1"/>
                 </a:solidFill>
                 <a:latin typeface="Ramabhadra" panose="02000600000000000000" pitchFamily="2" charset="0"/>
                 <a:cs typeface="Ramabhadra" panose="02000600000000000000" pitchFamily="2" charset="0"/>
               </a:rPr>
-              <a:t>సంతోషముగ త్రాగుమా </a:t>
+              <a:t>నీ కృపా బాహుళ్యమే వీడని అనుబంధమై</a:t>
+            </a:r>
+          </a:p>
+          <a:p>
+            <a:pPr algn="ctr" defTabSz="439781"/>
+            <a:r>
+              <a:rPr lang="te-IN" sz="1500" dirty="0">
+                <a:solidFill>
+                  <a:schemeClr val="tx1"/>
+                </a:solidFill>
+                <a:latin typeface="Ramabhadra" panose="02000600000000000000" pitchFamily="2" charset="0"/>
+                <a:cs typeface="Ramabhadra" panose="02000600000000000000" pitchFamily="2" charset="0"/>
+              </a:rPr>
+              <a:t>తలచిన ప్రతిక్షణమున నూతన బలమిచ్చెను</a:t>
+            </a:r>
+          </a:p>
+          <a:p>
+            <a:pPr algn="ctr" defTabSz="439781"/>
+            <a:endParaRPr lang="te-IN" sz="1500" dirty="0">
+              <a:solidFill>
+                <a:schemeClr val="tx1"/>
+              </a:solidFill>
+              <a:latin typeface="Ramabhadra" panose="02000600000000000000" pitchFamily="2" charset="0"/>
+              <a:cs typeface="Ramabhadra" panose="02000600000000000000" pitchFamily="2" charset="0"/>
+            </a:endParaRPr>
+          </a:p>
+          <a:p>
+            <a:pPr algn="ctr" defTabSz="439781"/>
+            <a:r>
+              <a:rPr lang="te-IN" sz="1500" dirty="0">
+                <a:solidFill>
+                  <a:schemeClr val="tx1"/>
+                </a:solidFill>
+                <a:latin typeface="Ramabhadra" panose="02000600000000000000" pitchFamily="2" charset="0"/>
+                <a:cs typeface="Ramabhadra" panose="02000600000000000000" pitchFamily="2" charset="0"/>
+              </a:rPr>
+              <a:t>నాపై ఉదయించె నీ మహిమ కిరణాలు – కనుమరుగాయెను నా దుఖ:దినములు</a:t>
+            </a:r>
+          </a:p>
+          <a:p>
+            <a:pPr algn="ctr" defTabSz="439781"/>
+            <a:r>
+              <a:rPr lang="te-IN" sz="1500" dirty="0">
+                <a:solidFill>
+                  <a:schemeClr val="tx1"/>
+                </a:solidFill>
+                <a:latin typeface="Ramabhadra" panose="02000600000000000000" pitchFamily="2" charset="0"/>
+                <a:cs typeface="Ramabhadra" panose="02000600000000000000" pitchFamily="2" charset="0"/>
+              </a:rPr>
+              <a:t>కృపలనుపొంది నీ కాడి మోయుటకు</a:t>
+            </a:r>
+            <a:endParaRPr lang="en-IN" sz="1500" dirty="0">
+              <a:solidFill>
+                <a:schemeClr val="tx1"/>
+              </a:solidFill>
+              <a:latin typeface="Ramabhadra" panose="02000600000000000000" pitchFamily="2" charset="0"/>
+              <a:cs typeface="Ramabhadra" panose="02000600000000000000" pitchFamily="2" charset="0"/>
+            </a:endParaRPr>
+          </a:p>
+          <a:p>
+            <a:pPr algn="ctr" defTabSz="439781"/>
+            <a:r>
+              <a:rPr lang="te-IN" sz="1500" dirty="0">
+                <a:solidFill>
+                  <a:schemeClr val="tx1"/>
+                </a:solidFill>
+                <a:latin typeface="Ramabhadra" panose="02000600000000000000" pitchFamily="2" charset="0"/>
+                <a:cs typeface="Ramabhadra" panose="02000600000000000000" pitchFamily="2" charset="0"/>
+              </a:rPr>
+              <a:t>లోకములోనుండి ఏర్పరచినావు (2)</a:t>
+            </a:r>
+          </a:p>
+          <a:p>
+            <a:pPr algn="ctr" defTabSz="439781"/>
+            <a:r>
+              <a:rPr lang="te-IN" sz="1500" dirty="0">
+                <a:solidFill>
+                  <a:schemeClr val="tx1"/>
+                </a:solidFill>
+                <a:latin typeface="Ramabhadra" panose="02000600000000000000" pitchFamily="2" charset="0"/>
+                <a:cs typeface="Ramabhadra" panose="02000600000000000000" pitchFamily="2" charset="0"/>
+              </a:rPr>
+              <a:t>నీ దివ్య సంకల్పమే- అవనిలో శుభప్రదమై</a:t>
+            </a:r>
+          </a:p>
+          <a:p>
+            <a:pPr algn="ctr" defTabSz="439781"/>
+            <a:r>
+              <a:rPr lang="te-IN" sz="1500" dirty="0">
+                <a:solidFill>
+                  <a:schemeClr val="tx1"/>
+                </a:solidFill>
+                <a:latin typeface="Ramabhadra" panose="02000600000000000000" pitchFamily="2" charset="0"/>
+                <a:cs typeface="Ramabhadra" panose="02000600000000000000" pitchFamily="2" charset="0"/>
+              </a:rPr>
+              <a:t>నీ నిత్య రాజ్యమునకై నిరీక్షణ కలిగించెను</a:t>
             </a:r>
           </a:p>
         </p:txBody>

</xml_diff>

<commit_message>
05 sunday songs may
</commit_message>
<xml_diff>
--- a/xerox.pptx
+++ b/xerox.pptx
@@ -224,7 +224,7 @@
           <a:p>
             <a:fld id="{3502DD63-DF8D-4AB8-92A0-0ECCF612C06C}" type="datetimeFigureOut">
               <a:rPr lang="en-IN" smtClean="0"/>
-              <a:t>25-04-2024</a:t>
+              <a:t>04-05-2024</a:t>
             </a:fld>
             <a:endParaRPr lang="en-IN"/>
           </a:p>
@@ -402,7 +402,7 @@
           <a:p>
             <a:fld id="{1AE741EC-1360-4793-999B-941E0396C9FA}" type="datetimeFigureOut">
               <a:rPr lang="en-IN" smtClean="0"/>
-              <a:t>25-04-2024</a:t>
+              <a:t>04-05-2024</a:t>
             </a:fld>
             <a:endParaRPr lang="en-IN"/>
           </a:p>
@@ -802,7 +802,7 @@
           <a:p>
             <a:fld id="{86FBD32F-FCAD-481A-B7D8-4D813FB7DB24}" type="datetimeFigureOut">
               <a:rPr lang="en-IN" smtClean="0"/>
-              <a:t>25-04-2024</a:t>
+              <a:t>04-05-2024</a:t>
             </a:fld>
             <a:endParaRPr lang="en-IN"/>
           </a:p>
@@ -972,7 +972,7 @@
           <a:p>
             <a:fld id="{86FBD32F-FCAD-481A-B7D8-4D813FB7DB24}" type="datetimeFigureOut">
               <a:rPr lang="en-IN" smtClean="0"/>
-              <a:t>25-04-2024</a:t>
+              <a:t>04-05-2024</a:t>
             </a:fld>
             <a:endParaRPr lang="en-IN"/>
           </a:p>
@@ -1152,7 +1152,7 @@
           <a:p>
             <a:fld id="{86FBD32F-FCAD-481A-B7D8-4D813FB7DB24}" type="datetimeFigureOut">
               <a:rPr lang="en-IN" smtClean="0"/>
-              <a:t>25-04-2024</a:t>
+              <a:t>04-05-2024</a:t>
             </a:fld>
             <a:endParaRPr lang="en-IN"/>
           </a:p>
@@ -1322,7 +1322,7 @@
           <a:p>
             <a:fld id="{86FBD32F-FCAD-481A-B7D8-4D813FB7DB24}" type="datetimeFigureOut">
               <a:rPr lang="en-IN" smtClean="0"/>
-              <a:t>25-04-2024</a:t>
+              <a:t>04-05-2024</a:t>
             </a:fld>
             <a:endParaRPr lang="en-IN"/>
           </a:p>
@@ -1566,7 +1566,7 @@
           <a:p>
             <a:fld id="{86FBD32F-FCAD-481A-B7D8-4D813FB7DB24}" type="datetimeFigureOut">
               <a:rPr lang="en-IN" smtClean="0"/>
-              <a:t>25-04-2024</a:t>
+              <a:t>04-05-2024</a:t>
             </a:fld>
             <a:endParaRPr lang="en-IN"/>
           </a:p>
@@ -1798,7 +1798,7 @@
           <a:p>
             <a:fld id="{86FBD32F-FCAD-481A-B7D8-4D813FB7DB24}" type="datetimeFigureOut">
               <a:rPr lang="en-IN" smtClean="0"/>
-              <a:t>25-04-2024</a:t>
+              <a:t>04-05-2024</a:t>
             </a:fld>
             <a:endParaRPr lang="en-IN"/>
           </a:p>
@@ -2165,7 +2165,7 @@
           <a:p>
             <a:fld id="{86FBD32F-FCAD-481A-B7D8-4D813FB7DB24}" type="datetimeFigureOut">
               <a:rPr lang="en-IN" smtClean="0"/>
-              <a:t>25-04-2024</a:t>
+              <a:t>04-05-2024</a:t>
             </a:fld>
             <a:endParaRPr lang="en-IN"/>
           </a:p>
@@ -2283,7 +2283,7 @@
           <a:p>
             <a:fld id="{86FBD32F-FCAD-481A-B7D8-4D813FB7DB24}" type="datetimeFigureOut">
               <a:rPr lang="en-IN" smtClean="0"/>
-              <a:t>25-04-2024</a:t>
+              <a:t>04-05-2024</a:t>
             </a:fld>
             <a:endParaRPr lang="en-IN"/>
           </a:p>
@@ -2378,7 +2378,7 @@
           <a:p>
             <a:fld id="{86FBD32F-FCAD-481A-B7D8-4D813FB7DB24}" type="datetimeFigureOut">
               <a:rPr lang="en-IN" smtClean="0"/>
-              <a:t>25-04-2024</a:t>
+              <a:t>04-05-2024</a:t>
             </a:fld>
             <a:endParaRPr lang="en-IN"/>
           </a:p>
@@ -2655,7 +2655,7 @@
           <a:p>
             <a:fld id="{86FBD32F-FCAD-481A-B7D8-4D813FB7DB24}" type="datetimeFigureOut">
               <a:rPr lang="en-IN" smtClean="0"/>
-              <a:t>25-04-2024</a:t>
+              <a:t>04-05-2024</a:t>
             </a:fld>
             <a:endParaRPr lang="en-IN"/>
           </a:p>
@@ -2912,7 +2912,7 @@
           <a:p>
             <a:fld id="{86FBD32F-FCAD-481A-B7D8-4D813FB7DB24}" type="datetimeFigureOut">
               <a:rPr lang="en-IN" smtClean="0"/>
-              <a:t>25-04-2024</a:t>
+              <a:t>04-05-2024</a:t>
             </a:fld>
             <a:endParaRPr lang="en-IN"/>
           </a:p>
@@ -3125,7 +3125,7 @@
           <a:p>
             <a:fld id="{86FBD32F-FCAD-481A-B7D8-4D813FB7DB24}" type="datetimeFigureOut">
               <a:rPr lang="en-IN" smtClean="0"/>
-              <a:t>25-04-2024</a:t>
+              <a:t>04-05-2024</a:t>
             </a:fld>
             <a:endParaRPr lang="en-IN"/>
           </a:p>
@@ -3596,7 +3596,7 @@
               <a:defRPr/>
             </a:pPr>
             <a:r>
-              <a:rPr kumimoji="0" lang="te-IN" sz="1700" i="0" u="none" strike="noStrike" kern="1200" cap="none" spc="0" normalizeH="0" baseline="0" noProof="0" dirty="0">
+              <a:rPr kumimoji="0" lang="te-IN" sz="1900" i="0" u="none" strike="noStrike" kern="1200" cap="none" spc="0" normalizeH="0" baseline="0" noProof="0" dirty="0">
                 <a:solidFill>
                   <a:schemeClr val="tx1"/>
                 </a:solidFill>
@@ -3606,9 +3606,112 @@
                 <a:latin typeface="Ramabhadra" panose="02000600000000000000" pitchFamily="2" charset="0"/>
                 <a:cs typeface="Ramabhadra" panose="02000600000000000000" pitchFamily="2" charset="0"/>
               </a:rPr>
-              <a:t>స్తోత్రింతున్ మనసారా యేసు ప్రభో</a:t>
-            </a:r>
-            <a:endParaRPr kumimoji="0" lang="en-IN" sz="1700" i="0" u="none" strike="noStrike" kern="1200" cap="none" spc="0" normalizeH="0" baseline="0" noProof="0" dirty="0">
+              <a:t>స్తోత్రము స్తుతి స్తోత్రము  </a:t>
+            </a:r>
+          </a:p>
+          <a:p>
+            <a:pPr marL="0" marR="0" lvl="0" indent="0" algn="ctr" defTabSz="439781" rtl="0" eaLnBrk="1" fontAlgn="auto" latinLnBrk="0" hangingPunct="1">
+              <a:spcBef>
+                <a:spcPts val="0"/>
+              </a:spcBef>
+              <a:spcAft>
+                <a:spcPts val="0"/>
+              </a:spcAft>
+              <a:buClrTx/>
+              <a:buSzTx/>
+              <a:buFontTx/>
+              <a:buNone/>
+              <a:tabLst/>
+              <a:defRPr/>
+            </a:pPr>
+            <a:r>
+              <a:rPr kumimoji="0" lang="te-IN" sz="1900" i="0" u="none" strike="noStrike" kern="1200" cap="none" spc="0" normalizeH="0" baseline="0" noProof="0" dirty="0">
+                <a:solidFill>
+                  <a:schemeClr val="tx1"/>
+                </a:solidFill>
+                <a:effectLst/>
+                <a:uLnTx/>
+                <a:uFillTx/>
+                <a:latin typeface="Ramabhadra" panose="02000600000000000000" pitchFamily="2" charset="0"/>
+                <a:cs typeface="Ramabhadra" panose="02000600000000000000" pitchFamily="2" charset="0"/>
+              </a:rPr>
+              <a:t>చెల్లించుడి యేసుకే (2)</a:t>
+            </a:r>
+          </a:p>
+          <a:p>
+            <a:pPr marL="0" marR="0" lvl="0" indent="0" algn="ctr" defTabSz="439781" rtl="0" eaLnBrk="1" fontAlgn="auto" latinLnBrk="0" hangingPunct="1">
+              <a:spcBef>
+                <a:spcPts val="0"/>
+              </a:spcBef>
+              <a:spcAft>
+                <a:spcPts val="0"/>
+              </a:spcAft>
+              <a:buClrTx/>
+              <a:buSzTx/>
+              <a:buFontTx/>
+              <a:buNone/>
+              <a:tabLst/>
+              <a:defRPr/>
+            </a:pPr>
+            <a:r>
+              <a:rPr kumimoji="0" lang="te-IN" sz="1900" i="0" u="none" strike="noStrike" kern="1200" cap="none" spc="0" normalizeH="0" baseline="0" noProof="0" dirty="0">
+                <a:solidFill>
+                  <a:schemeClr val="tx1"/>
+                </a:solidFill>
+                <a:effectLst/>
+                <a:uLnTx/>
+                <a:uFillTx/>
+                <a:latin typeface="Ramabhadra" panose="02000600000000000000" pitchFamily="2" charset="0"/>
+                <a:cs typeface="Ramabhadra" panose="02000600000000000000" pitchFamily="2" charset="0"/>
+              </a:rPr>
+              <a:t>రాజాధిరాజు దేవాధిదేవుడు </a:t>
+            </a:r>
+          </a:p>
+          <a:p>
+            <a:pPr marL="0" marR="0" lvl="0" indent="0" algn="ctr" defTabSz="439781" rtl="0" eaLnBrk="1" fontAlgn="auto" latinLnBrk="0" hangingPunct="1">
+              <a:spcBef>
+                <a:spcPts val="0"/>
+              </a:spcBef>
+              <a:spcAft>
+                <a:spcPts val="0"/>
+              </a:spcAft>
+              <a:buClrTx/>
+              <a:buSzTx/>
+              <a:buFontTx/>
+              <a:buNone/>
+              <a:tabLst/>
+              <a:defRPr/>
+            </a:pPr>
+            <a:r>
+              <a:rPr kumimoji="0" lang="te-IN" sz="1900" i="0" u="none" strike="noStrike" kern="1200" cap="none" spc="0" normalizeH="0" baseline="0" noProof="0" dirty="0">
+                <a:solidFill>
+                  <a:schemeClr val="tx1"/>
+                </a:solidFill>
+                <a:effectLst/>
+                <a:uLnTx/>
+                <a:uFillTx/>
+                <a:latin typeface="Ramabhadra" panose="02000600000000000000" pitchFamily="2" charset="0"/>
+                <a:cs typeface="Ramabhadra" panose="02000600000000000000" pitchFamily="2" charset="0"/>
+              </a:rPr>
+              <a:t> స్తుతులకు పాత్రుడు</a:t>
+            </a:r>
+          </a:p>
+          <a:p>
+            <a:pPr marL="0" marR="0" lvl="0" indent="0" algn="ctr" defTabSz="439781" rtl="0" eaLnBrk="1" fontAlgn="auto" latinLnBrk="0" hangingPunct="1">
+              <a:spcBef>
+                <a:spcPts val="0"/>
+              </a:spcBef>
+              <a:spcAft>
+                <a:spcPts val="0"/>
+              </a:spcAft>
+              <a:buClrTx/>
+              <a:buSzTx/>
+              <a:buFontTx/>
+              <a:buNone/>
+              <a:tabLst/>
+              <a:defRPr/>
+            </a:pPr>
+            <a:endParaRPr kumimoji="0" lang="te-IN" sz="1900" i="0" u="none" strike="noStrike" kern="1200" cap="none" spc="0" normalizeH="0" baseline="0" noProof="0" dirty="0">
               <a:solidFill>
                 <a:schemeClr val="tx1"/>
               </a:solidFill>
@@ -3635,7 +3738,7 @@
               <a:defRPr/>
             </a:pPr>
             <a:r>
-              <a:rPr kumimoji="0" lang="te-IN" sz="1700" i="0" u="none" strike="noStrike" kern="1200" cap="none" spc="0" normalizeH="0" baseline="0" noProof="0" dirty="0">
+              <a:rPr kumimoji="0" lang="te-IN" sz="1900" i="0" u="none" strike="noStrike" kern="1200" cap="none" spc="0" normalizeH="0" baseline="0" noProof="0" dirty="0">
                 <a:solidFill>
                   <a:schemeClr val="tx1"/>
                 </a:solidFill>
@@ -3645,7 +3748,7 @@
                 <a:latin typeface="Ramabhadra" panose="02000600000000000000" pitchFamily="2" charset="0"/>
                 <a:cs typeface="Ramabhadra" panose="02000600000000000000" pitchFamily="2" charset="0"/>
               </a:rPr>
-              <a:t>స్తుతి గీతములతో ఎల్లప్పుడు   </a:t>
+              <a:t> మనుష్య కుమారుడై మనుజుల పాపముకై</a:t>
             </a:r>
           </a:p>
           <a:p>
@@ -3664,7 +3767,7 @@
               <a:defRPr/>
             </a:pPr>
             <a:r>
-              <a:rPr kumimoji="0" lang="te-IN" sz="1700" i="0" u="none" strike="noStrike" kern="1200" cap="none" spc="0" normalizeH="0" baseline="0" noProof="0" dirty="0">
+              <a:rPr kumimoji="0" lang="te-IN" sz="1900" i="0" u="none" strike="noStrike" kern="1200" cap="none" spc="0" normalizeH="0" baseline="0" noProof="0" dirty="0">
                 <a:solidFill>
                   <a:schemeClr val="tx1"/>
                 </a:solidFill>
@@ -3674,9 +3777,112 @@
                 <a:latin typeface="Ramabhadra" panose="02000600000000000000" pitchFamily="2" charset="0"/>
                 <a:cs typeface="Ramabhadra" panose="02000600000000000000" pitchFamily="2" charset="0"/>
               </a:rPr>
-              <a:t>సర్వేశ్వరా నన్ను కరుణతో</a:t>
-            </a:r>
-            <a:endParaRPr kumimoji="0" lang="en-IN" sz="1700" i="0" u="none" strike="noStrike" kern="1200" cap="none" spc="0" normalizeH="0" baseline="0" noProof="0" dirty="0">
+              <a:t>మహిలోన వెలసెను</a:t>
+            </a:r>
+          </a:p>
+          <a:p>
+            <a:pPr marL="0" marR="0" lvl="0" indent="0" algn="ctr" defTabSz="439781" rtl="0" eaLnBrk="1" fontAlgn="auto" latinLnBrk="0" hangingPunct="1">
+              <a:spcBef>
+                <a:spcPts val="0"/>
+              </a:spcBef>
+              <a:spcAft>
+                <a:spcPts val="0"/>
+              </a:spcAft>
+              <a:buClrTx/>
+              <a:buSzTx/>
+              <a:buFontTx/>
+              <a:buNone/>
+              <a:tabLst/>
+              <a:defRPr/>
+            </a:pPr>
+            <a:r>
+              <a:rPr kumimoji="0" lang="te-IN" sz="1900" i="0" u="none" strike="noStrike" kern="1200" cap="none" spc="0" normalizeH="0" baseline="0" noProof="0" dirty="0">
+                <a:solidFill>
+                  <a:schemeClr val="tx1"/>
+                </a:solidFill>
+                <a:effectLst/>
+                <a:uLnTx/>
+                <a:uFillTx/>
+                <a:latin typeface="Ramabhadra" panose="02000600000000000000" pitchFamily="2" charset="0"/>
+                <a:cs typeface="Ramabhadra" panose="02000600000000000000" pitchFamily="2" charset="0"/>
+              </a:rPr>
+              <a:t>మరణించి లెచేను (2)</a:t>
+            </a:r>
+          </a:p>
+          <a:p>
+            <a:pPr marL="0" marR="0" lvl="0" indent="0" algn="ctr" defTabSz="439781" rtl="0" eaLnBrk="1" fontAlgn="auto" latinLnBrk="0" hangingPunct="1">
+              <a:spcBef>
+                <a:spcPts val="0"/>
+              </a:spcBef>
+              <a:spcAft>
+                <a:spcPts val="0"/>
+              </a:spcAft>
+              <a:buClrTx/>
+              <a:buSzTx/>
+              <a:buFontTx/>
+              <a:buNone/>
+              <a:tabLst/>
+              <a:defRPr/>
+            </a:pPr>
+            <a:r>
+              <a:rPr kumimoji="0" lang="te-IN" sz="1900" i="0" u="none" strike="noStrike" kern="1200" cap="none" spc="0" normalizeH="0" baseline="0" noProof="0" dirty="0">
+                <a:solidFill>
+                  <a:schemeClr val="tx1"/>
+                </a:solidFill>
+                <a:effectLst/>
+                <a:uLnTx/>
+                <a:uFillTx/>
+                <a:latin typeface="Ramabhadra" panose="02000600000000000000" pitchFamily="2" charset="0"/>
+                <a:cs typeface="Ramabhadra" panose="02000600000000000000" pitchFamily="2" charset="0"/>
+              </a:rPr>
+              <a:t>మహిమ స్వరూపుడు </a:t>
+            </a:r>
+          </a:p>
+          <a:p>
+            <a:pPr marL="0" marR="0" lvl="0" indent="0" algn="ctr" defTabSz="439781" rtl="0" eaLnBrk="1" fontAlgn="auto" latinLnBrk="0" hangingPunct="1">
+              <a:spcBef>
+                <a:spcPts val="0"/>
+              </a:spcBef>
+              <a:spcAft>
+                <a:spcPts val="0"/>
+              </a:spcAft>
+              <a:buClrTx/>
+              <a:buSzTx/>
+              <a:buFontTx/>
+              <a:buNone/>
+              <a:tabLst/>
+              <a:defRPr/>
+            </a:pPr>
+            <a:r>
+              <a:rPr kumimoji="0" lang="te-IN" sz="1900" i="0" u="none" strike="noStrike" kern="1200" cap="none" spc="0" normalizeH="0" baseline="0" noProof="0" dirty="0">
+                <a:solidFill>
+                  <a:schemeClr val="tx1"/>
+                </a:solidFill>
+                <a:effectLst/>
+                <a:uLnTx/>
+                <a:uFillTx/>
+                <a:latin typeface="Ramabhadra" panose="02000600000000000000" pitchFamily="2" charset="0"/>
+                <a:cs typeface="Ramabhadra" panose="02000600000000000000" pitchFamily="2" charset="0"/>
+              </a:rPr>
+              <a:t>మహిమ స్వరూపుడు</a:t>
+            </a:r>
+          </a:p>
+          <a:p>
+            <a:pPr marL="0" marR="0" lvl="0" indent="0" algn="ctr" defTabSz="439781" rtl="0" eaLnBrk="1" fontAlgn="auto" latinLnBrk="0" hangingPunct="1">
+              <a:spcBef>
+                <a:spcPts val="0"/>
+              </a:spcBef>
+              <a:spcAft>
+                <a:spcPts val="0"/>
+              </a:spcAft>
+              <a:buClrTx/>
+              <a:buSzTx/>
+              <a:buFontTx/>
+              <a:buNone/>
+              <a:tabLst/>
+              <a:defRPr/>
+            </a:pPr>
+            <a:endParaRPr kumimoji="0" lang="te-IN" sz="1900" i="0" u="none" strike="noStrike" kern="1200" cap="none" spc="0" normalizeH="0" baseline="0" noProof="0" dirty="0">
               <a:solidFill>
                 <a:schemeClr val="tx1"/>
               </a:solidFill>
@@ -3703,7 +3909,7 @@
               <a:defRPr/>
             </a:pPr>
             <a:r>
-              <a:rPr kumimoji="0" lang="te-IN" sz="1700" i="0" u="none" strike="noStrike" kern="1200" cap="none" spc="0" normalizeH="0" baseline="0" noProof="0" dirty="0">
+              <a:rPr kumimoji="0" lang="te-IN" sz="1900" i="0" u="none" strike="noStrike" kern="1200" cap="none" spc="0" normalizeH="0" baseline="0" noProof="0" dirty="0">
                 <a:solidFill>
                   <a:schemeClr val="tx1"/>
                 </a:solidFill>
@@ -3713,7 +3919,7 @@
                 <a:latin typeface="Ramabhadra" panose="02000600000000000000" pitchFamily="2" charset="0"/>
                 <a:cs typeface="Ramabhadra" panose="02000600000000000000" pitchFamily="2" charset="0"/>
               </a:rPr>
-              <a:t>నీ సన్నిధి చేర్చుమా   </a:t>
+              <a:t>పాపపు వస్త్రము మార్చి నీతిమంతులుగ తీర్చి</a:t>
             </a:r>
           </a:p>
           <a:p>
@@ -3731,16 +3937,19 @@
               <a:tabLst/>
               <a:defRPr/>
             </a:pPr>
-            <a:endParaRPr kumimoji="0" lang="te-IN" sz="1700" i="0" u="none" strike="noStrike" kern="1200" cap="none" spc="0" normalizeH="0" baseline="0" noProof="0" dirty="0">
-              <a:solidFill>
-                <a:schemeClr val="tx1"/>
-              </a:solidFill>
-              <a:effectLst/>
-              <a:uLnTx/>
-              <a:uFillTx/>
-              <a:latin typeface="Ramabhadra" panose="02000600000000000000" pitchFamily="2" charset="0"/>
-              <a:cs typeface="Ramabhadra" panose="02000600000000000000" pitchFamily="2" charset="0"/>
-            </a:endParaRPr>
+            <a:r>
+              <a:rPr kumimoji="0" lang="te-IN" sz="1900" i="0" u="none" strike="noStrike" kern="1200" cap="none" spc="0" normalizeH="0" baseline="0" noProof="0" dirty="0">
+                <a:solidFill>
+                  <a:schemeClr val="tx1"/>
+                </a:solidFill>
+                <a:effectLst/>
+                <a:uLnTx/>
+                <a:uFillTx/>
+                <a:latin typeface="Ramabhadra" panose="02000600000000000000" pitchFamily="2" charset="0"/>
+                <a:cs typeface="Ramabhadra" panose="02000600000000000000" pitchFamily="2" charset="0"/>
+              </a:rPr>
+              <a:t>పరిశుద్దులతో చేర్చి  </a:t>
+            </a:r>
           </a:p>
           <a:p>
             <a:pPr marL="0" marR="0" lvl="0" indent="0" algn="ctr" defTabSz="439781" rtl="0" eaLnBrk="1" fontAlgn="auto" latinLnBrk="0" hangingPunct="1">
@@ -3758,7 +3967,7 @@
               <a:defRPr/>
             </a:pPr>
             <a:r>
-              <a:rPr kumimoji="0" lang="te-IN" sz="1700" i="0" u="none" strike="noStrike" kern="1200" cap="none" spc="0" normalizeH="0" baseline="0" noProof="0" dirty="0">
+              <a:rPr kumimoji="0" lang="te-IN" sz="1900" i="0" u="none" strike="noStrike" kern="1200" cap="none" spc="0" normalizeH="0" baseline="0" noProof="0" dirty="0">
                 <a:solidFill>
                   <a:schemeClr val="tx1"/>
                 </a:solidFill>
@@ -3768,18 +3977,8 @@
                 <a:latin typeface="Ramabhadra" panose="02000600000000000000" pitchFamily="2" charset="0"/>
                 <a:cs typeface="Ramabhadra" panose="02000600000000000000" pitchFamily="2" charset="0"/>
               </a:rPr>
-              <a:t>అనుదినము నీ వాక్యము</a:t>
-            </a:r>
-            <a:endParaRPr kumimoji="0" lang="en-IN" sz="1700" i="0" u="none" strike="noStrike" kern="1200" cap="none" spc="0" normalizeH="0" baseline="0" noProof="0" dirty="0">
-              <a:solidFill>
-                <a:schemeClr val="tx1"/>
-              </a:solidFill>
-              <a:effectLst/>
-              <a:uLnTx/>
-              <a:uFillTx/>
-              <a:latin typeface="Ramabhadra" panose="02000600000000000000" pitchFamily="2" charset="0"/>
-              <a:cs typeface="Ramabhadra" panose="02000600000000000000" pitchFamily="2" charset="0"/>
-            </a:endParaRPr>
+              <a:t>   పరమ సౌభాగ్యము నిచ్చి (2)</a:t>
+            </a:r>
           </a:p>
           <a:p>
             <a:pPr marL="0" marR="0" lvl="0" indent="0" algn="ctr" defTabSz="439781" rtl="0" eaLnBrk="1" fontAlgn="auto" latinLnBrk="0" hangingPunct="1">
@@ -3797,7 +3996,7 @@
               <a:defRPr/>
             </a:pPr>
             <a:r>
-              <a:rPr kumimoji="0" lang="te-IN" sz="1700" i="0" u="none" strike="noStrike" kern="1200" cap="none" spc="0" normalizeH="0" baseline="0" noProof="0" dirty="0">
+              <a:rPr kumimoji="0" lang="te-IN" sz="1900" i="0" u="none" strike="noStrike" kern="1200" cap="none" spc="0" normalizeH="0" baseline="0" noProof="0" dirty="0">
                 <a:solidFill>
                   <a:schemeClr val="tx1"/>
                 </a:solidFill>
@@ -3807,7 +4006,7 @@
                 <a:latin typeface="Ramabhadra" panose="02000600000000000000" pitchFamily="2" charset="0"/>
                 <a:cs typeface="Ramabhadra" panose="02000600000000000000" pitchFamily="2" charset="0"/>
               </a:rPr>
-              <a:t>అందించి బలపరుచు రక్షకా</a:t>
+              <a:t>మహిమ స్వరూపుడు </a:t>
             </a:r>
           </a:p>
           <a:p>
@@ -3826,7 +4025,7 @@
               <a:defRPr/>
             </a:pPr>
             <a:r>
-              <a:rPr kumimoji="0" lang="te-IN" sz="1700" i="0" u="none" strike="noStrike" kern="1200" cap="none" spc="0" normalizeH="0" baseline="0" noProof="0" dirty="0">
+              <a:rPr kumimoji="0" lang="te-IN" sz="1900" i="0" u="none" strike="noStrike" kern="1200" cap="none" spc="0" normalizeH="0" baseline="0" noProof="0" dirty="0">
                 <a:solidFill>
                   <a:schemeClr val="tx1"/>
                 </a:solidFill>
@@ -3836,354 +4035,7 @@
                 <a:latin typeface="Ramabhadra" panose="02000600000000000000" pitchFamily="2" charset="0"/>
                 <a:cs typeface="Ramabhadra" panose="02000600000000000000" pitchFamily="2" charset="0"/>
               </a:rPr>
-              <a:t>ఆనందముతో</a:t>
-            </a:r>
-            <a:r>
-              <a:rPr kumimoji="0" lang="en-IN" sz="1700" i="0" u="none" strike="noStrike" kern="1200" cap="none" spc="0" normalizeH="0" baseline="0" noProof="0" dirty="0">
-                <a:solidFill>
-                  <a:schemeClr val="tx1"/>
-                </a:solidFill>
-                <a:effectLst/>
-                <a:uLnTx/>
-                <a:uFillTx/>
-                <a:latin typeface="Ramabhadra" panose="02000600000000000000" pitchFamily="2" charset="0"/>
-                <a:cs typeface="Ramabhadra" panose="02000600000000000000" pitchFamily="2" charset="0"/>
-              </a:rPr>
-              <a:t> </a:t>
-            </a:r>
-            <a:r>
-              <a:rPr kumimoji="0" lang="te-IN" sz="1700" i="0" u="none" strike="noStrike" kern="1200" cap="none" spc="0" normalizeH="0" baseline="0" noProof="0" dirty="0">
-                <a:solidFill>
-                  <a:schemeClr val="tx1"/>
-                </a:solidFill>
-                <a:effectLst/>
-                <a:uLnTx/>
-                <a:uFillTx/>
-                <a:latin typeface="Ramabhadra" panose="02000600000000000000" pitchFamily="2" charset="0"/>
-                <a:cs typeface="Ramabhadra" panose="02000600000000000000" pitchFamily="2" charset="0"/>
-              </a:rPr>
-              <a:t>నా సర్వమున్</a:t>
-            </a:r>
-            <a:endParaRPr kumimoji="0" lang="en-IN" sz="1700" i="0" u="none" strike="noStrike" kern="1200" cap="none" spc="0" normalizeH="0" baseline="0" noProof="0" dirty="0">
-              <a:solidFill>
-                <a:schemeClr val="tx1"/>
-              </a:solidFill>
-              <a:effectLst/>
-              <a:uLnTx/>
-              <a:uFillTx/>
-              <a:latin typeface="Ramabhadra" panose="02000600000000000000" pitchFamily="2" charset="0"/>
-              <a:cs typeface="Ramabhadra" panose="02000600000000000000" pitchFamily="2" charset="0"/>
-            </a:endParaRPr>
-          </a:p>
-          <a:p>
-            <a:pPr marL="0" marR="0" lvl="0" indent="0" algn="ctr" defTabSz="439781" rtl="0" eaLnBrk="1" fontAlgn="auto" latinLnBrk="0" hangingPunct="1">
-              <a:spcBef>
-                <a:spcPts val="0"/>
-              </a:spcBef>
-              <a:spcAft>
-                <a:spcPts val="0"/>
-              </a:spcAft>
-              <a:buClrTx/>
-              <a:buSzTx/>
-              <a:buFontTx/>
-              <a:buNone/>
-              <a:tabLst/>
-              <a:defRPr/>
-            </a:pPr>
-            <a:r>
-              <a:rPr kumimoji="0" lang="te-IN" sz="1700" i="0" u="none" strike="noStrike" kern="1200" cap="none" spc="0" normalizeH="0" baseline="0" noProof="0" dirty="0">
-                <a:solidFill>
-                  <a:schemeClr val="tx1"/>
-                </a:solidFill>
-                <a:effectLst/>
-                <a:uLnTx/>
-                <a:uFillTx/>
-                <a:latin typeface="Ramabhadra" panose="02000600000000000000" pitchFamily="2" charset="0"/>
-                <a:cs typeface="Ramabhadra" panose="02000600000000000000" pitchFamily="2" charset="0"/>
-              </a:rPr>
-              <a:t>అర్పింతు నీకే ప్రభువా  </a:t>
-            </a:r>
-          </a:p>
-          <a:p>
-            <a:pPr marL="0" marR="0" lvl="0" indent="0" algn="ctr" defTabSz="439781" rtl="0" eaLnBrk="1" fontAlgn="auto" latinLnBrk="0" hangingPunct="1">
-              <a:spcBef>
-                <a:spcPts val="0"/>
-              </a:spcBef>
-              <a:spcAft>
-                <a:spcPts val="0"/>
-              </a:spcAft>
-              <a:buClrTx/>
-              <a:buSzTx/>
-              <a:buFontTx/>
-              <a:buNone/>
-              <a:tabLst/>
-              <a:defRPr/>
-            </a:pPr>
-            <a:endParaRPr kumimoji="0" lang="te-IN" sz="1700" i="0" u="none" strike="noStrike" kern="1200" cap="none" spc="0" normalizeH="0" baseline="0" noProof="0" dirty="0">
-              <a:solidFill>
-                <a:schemeClr val="tx1"/>
-              </a:solidFill>
-              <a:effectLst/>
-              <a:uLnTx/>
-              <a:uFillTx/>
-              <a:latin typeface="Ramabhadra" panose="02000600000000000000" pitchFamily="2" charset="0"/>
-              <a:cs typeface="Ramabhadra" panose="02000600000000000000" pitchFamily="2" charset="0"/>
-            </a:endParaRPr>
-          </a:p>
-          <a:p>
-            <a:pPr marL="0" marR="0" lvl="0" indent="0" algn="ctr" defTabSz="439781" rtl="0" eaLnBrk="1" fontAlgn="auto" latinLnBrk="0" hangingPunct="1">
-              <a:spcBef>
-                <a:spcPts val="0"/>
-              </a:spcBef>
-              <a:spcAft>
-                <a:spcPts val="0"/>
-              </a:spcAft>
-              <a:buClrTx/>
-              <a:buSzTx/>
-              <a:buFontTx/>
-              <a:buNone/>
-              <a:tabLst/>
-              <a:defRPr/>
-            </a:pPr>
-            <a:r>
-              <a:rPr kumimoji="0" lang="te-IN" sz="1700" i="0" u="none" strike="noStrike" kern="1200" cap="none" spc="0" normalizeH="0" baseline="0" noProof="0" dirty="0">
-                <a:solidFill>
-                  <a:schemeClr val="tx1"/>
-                </a:solidFill>
-                <a:effectLst/>
-                <a:uLnTx/>
-                <a:uFillTx/>
-                <a:latin typeface="Ramabhadra" panose="02000600000000000000" pitchFamily="2" charset="0"/>
-                <a:cs typeface="Ramabhadra" panose="02000600000000000000" pitchFamily="2" charset="0"/>
-              </a:rPr>
-              <a:t>నింపుము  నీ ఆత్మతో నా దేవా</a:t>
-            </a:r>
-            <a:endParaRPr kumimoji="0" lang="en-IN" sz="1700" i="0" u="none" strike="noStrike" kern="1200" cap="none" spc="0" normalizeH="0" baseline="0" noProof="0" dirty="0">
-              <a:solidFill>
-                <a:schemeClr val="tx1"/>
-              </a:solidFill>
-              <a:effectLst/>
-              <a:uLnTx/>
-              <a:uFillTx/>
-              <a:latin typeface="Ramabhadra" panose="02000600000000000000" pitchFamily="2" charset="0"/>
-              <a:cs typeface="Ramabhadra" panose="02000600000000000000" pitchFamily="2" charset="0"/>
-            </a:endParaRPr>
-          </a:p>
-          <a:p>
-            <a:pPr marL="0" marR="0" lvl="0" indent="0" algn="ctr" defTabSz="439781" rtl="0" eaLnBrk="1" fontAlgn="auto" latinLnBrk="0" hangingPunct="1">
-              <a:spcBef>
-                <a:spcPts val="0"/>
-              </a:spcBef>
-              <a:spcAft>
-                <a:spcPts val="0"/>
-              </a:spcAft>
-              <a:buClrTx/>
-              <a:buSzTx/>
-              <a:buFontTx/>
-              <a:buNone/>
-              <a:tabLst/>
-              <a:defRPr/>
-            </a:pPr>
-            <a:r>
-              <a:rPr kumimoji="0" lang="te-IN" sz="1700" i="0" u="none" strike="noStrike" kern="1200" cap="none" spc="0" normalizeH="0" baseline="0" noProof="0" dirty="0">
-                <a:solidFill>
-                  <a:schemeClr val="tx1"/>
-                </a:solidFill>
-                <a:effectLst/>
-                <a:uLnTx/>
-                <a:uFillTx/>
-                <a:latin typeface="Ramabhadra" panose="02000600000000000000" pitchFamily="2" charset="0"/>
-                <a:cs typeface="Ramabhadra" panose="02000600000000000000" pitchFamily="2" charset="0"/>
-              </a:rPr>
-              <a:t>నడుపుము నీ హస్త బలముతో </a:t>
-            </a:r>
-          </a:p>
-          <a:p>
-            <a:pPr marL="0" marR="0" lvl="0" indent="0" algn="ctr" defTabSz="439781" rtl="0" eaLnBrk="1" fontAlgn="auto" latinLnBrk="0" hangingPunct="1">
-              <a:spcBef>
-                <a:spcPts val="0"/>
-              </a:spcBef>
-              <a:spcAft>
-                <a:spcPts val="0"/>
-              </a:spcAft>
-              <a:buClrTx/>
-              <a:buSzTx/>
-              <a:buFontTx/>
-              <a:buNone/>
-              <a:tabLst/>
-              <a:defRPr/>
-            </a:pPr>
-            <a:r>
-              <a:rPr kumimoji="0" lang="te-IN" sz="1700" i="0" u="none" strike="noStrike" kern="1200" cap="none" spc="0" normalizeH="0" baseline="0" noProof="0" dirty="0">
-                <a:solidFill>
-                  <a:schemeClr val="tx1"/>
-                </a:solidFill>
-                <a:effectLst/>
-                <a:uLnTx/>
-                <a:uFillTx/>
-                <a:latin typeface="Ramabhadra" panose="02000600000000000000" pitchFamily="2" charset="0"/>
-                <a:cs typeface="Ramabhadra" panose="02000600000000000000" pitchFamily="2" charset="0"/>
-              </a:rPr>
-              <a:t>నీ చితమైన నా ప్రభు</a:t>
-            </a:r>
-            <a:endParaRPr kumimoji="0" lang="en-IN" sz="1700" i="0" u="none" strike="noStrike" kern="1200" cap="none" spc="0" normalizeH="0" baseline="0" noProof="0" dirty="0">
-              <a:solidFill>
-                <a:schemeClr val="tx1"/>
-              </a:solidFill>
-              <a:effectLst/>
-              <a:uLnTx/>
-              <a:uFillTx/>
-              <a:latin typeface="Ramabhadra" panose="02000600000000000000" pitchFamily="2" charset="0"/>
-              <a:cs typeface="Ramabhadra" panose="02000600000000000000" pitchFamily="2" charset="0"/>
-            </a:endParaRPr>
-          </a:p>
-          <a:p>
-            <a:pPr marL="0" marR="0" lvl="0" indent="0" algn="ctr" defTabSz="439781" rtl="0" eaLnBrk="1" fontAlgn="auto" latinLnBrk="0" hangingPunct="1">
-              <a:spcBef>
-                <a:spcPts val="0"/>
-              </a:spcBef>
-              <a:spcAft>
-                <a:spcPts val="0"/>
-              </a:spcAft>
-              <a:buClrTx/>
-              <a:buSzTx/>
-              <a:buFontTx/>
-              <a:buNone/>
-              <a:tabLst/>
-              <a:defRPr/>
-            </a:pPr>
-            <a:r>
-              <a:rPr kumimoji="0" lang="te-IN" sz="1700" i="0" u="none" strike="noStrike" kern="1200" cap="none" spc="0" normalizeH="0" baseline="0" noProof="0" dirty="0">
-                <a:solidFill>
-                  <a:schemeClr val="tx1"/>
-                </a:solidFill>
-                <a:effectLst/>
-                <a:uLnTx/>
-                <a:uFillTx/>
-                <a:latin typeface="Ramabhadra" panose="02000600000000000000" pitchFamily="2" charset="0"/>
-                <a:cs typeface="Ramabhadra" panose="02000600000000000000" pitchFamily="2" charset="0"/>
-              </a:rPr>
-              <a:t>నీ యందె నను నిలుపుమా </a:t>
-            </a:r>
-            <a:endParaRPr kumimoji="0" lang="en-IN" sz="1700" i="0" u="none" strike="noStrike" kern="1200" cap="none" spc="0" normalizeH="0" baseline="0" noProof="0" dirty="0">
-              <a:solidFill>
-                <a:schemeClr val="tx1"/>
-              </a:solidFill>
-              <a:effectLst/>
-              <a:uLnTx/>
-              <a:uFillTx/>
-              <a:latin typeface="Ramabhadra" panose="02000600000000000000" pitchFamily="2" charset="0"/>
-              <a:cs typeface="Ramabhadra" panose="02000600000000000000" pitchFamily="2" charset="0"/>
-            </a:endParaRPr>
-          </a:p>
-          <a:p>
-            <a:pPr marL="0" marR="0" lvl="0" indent="0" algn="ctr" defTabSz="439781" rtl="0" eaLnBrk="1" fontAlgn="auto" latinLnBrk="0" hangingPunct="1">
-              <a:spcBef>
-                <a:spcPts val="0"/>
-              </a:spcBef>
-              <a:spcAft>
-                <a:spcPts val="0"/>
-              </a:spcAft>
-              <a:buClrTx/>
-              <a:buSzTx/>
-              <a:buFontTx/>
-              <a:buNone/>
-              <a:tabLst/>
-              <a:defRPr/>
-            </a:pPr>
-            <a:endParaRPr lang="en-IN" sz="1700" dirty="0">
-              <a:solidFill>
-                <a:schemeClr val="tx1"/>
-              </a:solidFill>
-              <a:latin typeface="Ramabhadra" panose="02000600000000000000" pitchFamily="2" charset="0"/>
-              <a:cs typeface="Ramabhadra" panose="02000600000000000000" pitchFamily="2" charset="0"/>
-            </a:endParaRPr>
-          </a:p>
-          <a:p>
-            <a:pPr marL="0" marR="0" lvl="0" indent="0" algn="ctr" defTabSz="439781" rtl="0" eaLnBrk="1" fontAlgn="auto" latinLnBrk="0" hangingPunct="1">
-              <a:spcBef>
-                <a:spcPts val="0"/>
-              </a:spcBef>
-              <a:spcAft>
-                <a:spcPts val="0"/>
-              </a:spcAft>
-              <a:buClrTx/>
-              <a:buSzTx/>
-              <a:buFontTx/>
-              <a:buNone/>
-              <a:tabLst/>
-              <a:defRPr/>
-            </a:pPr>
-            <a:r>
-              <a:rPr kumimoji="0" lang="te-IN" sz="1700" i="0" u="none" strike="noStrike" kern="1200" cap="none" spc="0" normalizeH="0" baseline="0" noProof="0" dirty="0">
-                <a:solidFill>
-                  <a:schemeClr val="tx1"/>
-                </a:solidFill>
-                <a:effectLst/>
-                <a:uLnTx/>
-                <a:uFillTx/>
-                <a:latin typeface="Ramabhadra" panose="02000600000000000000" pitchFamily="2" charset="0"/>
-                <a:cs typeface="Ramabhadra" panose="02000600000000000000" pitchFamily="2" charset="0"/>
-              </a:rPr>
-              <a:t>మానవుల పాపములు బాపితివయ్యా </a:t>
-            </a:r>
-          </a:p>
-          <a:p>
-            <a:pPr marL="0" marR="0" lvl="0" indent="0" algn="ctr" defTabSz="439781" rtl="0" eaLnBrk="1" fontAlgn="auto" latinLnBrk="0" hangingPunct="1">
-              <a:spcBef>
-                <a:spcPts val="0"/>
-              </a:spcBef>
-              <a:spcAft>
-                <a:spcPts val="0"/>
-              </a:spcAft>
-              <a:buClrTx/>
-              <a:buSzTx/>
-              <a:buFontTx/>
-              <a:buNone/>
-              <a:tabLst/>
-              <a:defRPr/>
-            </a:pPr>
-            <a:r>
-              <a:rPr kumimoji="0" lang="te-IN" sz="1700" i="0" u="none" strike="noStrike" kern="1200" cap="none" spc="0" normalizeH="0" baseline="0" noProof="0" dirty="0">
-                <a:solidFill>
-                  <a:schemeClr val="tx1"/>
-                </a:solidFill>
-                <a:effectLst/>
-                <a:uLnTx/>
-                <a:uFillTx/>
-                <a:latin typeface="Ramabhadra" panose="02000600000000000000" pitchFamily="2" charset="0"/>
-                <a:cs typeface="Ramabhadra" panose="02000600000000000000" pitchFamily="2" charset="0"/>
-              </a:rPr>
-              <a:t>మృత్యువును జయించి లేచితివయ్యా </a:t>
-            </a:r>
-          </a:p>
-          <a:p>
-            <a:pPr marL="0" marR="0" lvl="0" indent="0" algn="ctr" defTabSz="439781" rtl="0" eaLnBrk="1" fontAlgn="auto" latinLnBrk="0" hangingPunct="1">
-              <a:spcBef>
-                <a:spcPts val="0"/>
-              </a:spcBef>
-              <a:spcAft>
-                <a:spcPts val="0"/>
-              </a:spcAft>
-              <a:buClrTx/>
-              <a:buSzTx/>
-              <a:buFontTx/>
-              <a:buNone/>
-              <a:tabLst/>
-              <a:defRPr/>
-            </a:pPr>
-            <a:r>
-              <a:rPr kumimoji="0" lang="te-IN" sz="1700" i="0" u="none" strike="noStrike" kern="1200" cap="none" spc="0" normalizeH="0" baseline="0" noProof="0" dirty="0">
-                <a:solidFill>
-                  <a:schemeClr val="tx1"/>
-                </a:solidFill>
-                <a:effectLst/>
-                <a:uLnTx/>
-                <a:uFillTx/>
-                <a:latin typeface="Ramabhadra" panose="02000600000000000000" pitchFamily="2" charset="0"/>
-                <a:cs typeface="Ramabhadra" panose="02000600000000000000" pitchFamily="2" charset="0"/>
-              </a:rPr>
-              <a:t>జయధీరుడైన యేసునకు స్తోత్రములర్పింతుమా</a:t>
+              <a:t>మహిమ స్వరూపుడు</a:t>
             </a:r>
           </a:p>
         </p:txBody>
@@ -4256,7 +4108,7 @@
                 <a:latin typeface="Ramabhadra" panose="02000600000000000000" pitchFamily="2" charset="0"/>
                 <a:cs typeface="Ramabhadra" panose="02000600000000000000" pitchFamily="2" charset="0"/>
               </a:rPr>
-              <a:t>యెహోవా నీ నామము ఎంతో బలమైనది</a:t>
+              <a:t>హల్లెలూయ పాట యేసయ్య పాట</a:t>
             </a:r>
           </a:p>
           <a:p>
@@ -4277,7 +4129,7 @@
                 <a:latin typeface="Ramabhadra" panose="02000600000000000000" pitchFamily="2" charset="0"/>
                 <a:cs typeface="Ramabhadra" panose="02000600000000000000" pitchFamily="2" charset="0"/>
               </a:rPr>
-              <a:t>ఆ…ఆ…ఆ… ఎంతో బలమైనది</a:t>
+              <a:t>పాడాలి ప్రతి చోట పాడాలి ప్రతి నోట</a:t>
             </a:r>
           </a:p>
           <a:p>
@@ -4298,57 +4150,7 @@
                 <a:latin typeface="Ramabhadra" panose="02000600000000000000" pitchFamily="2" charset="0"/>
                 <a:cs typeface="Ramabhadra" panose="02000600000000000000" pitchFamily="2" charset="0"/>
               </a:rPr>
-              <a:t>యేసయ్య నీ నామము</a:t>
-            </a:r>
-            <a:endParaRPr lang="en-IN" sz="1900" b="0" i="0" dirty="0">
-              <a:solidFill>
-                <a:schemeClr val="tx1"/>
-              </a:solidFill>
-              <a:effectLst/>
-              <a:latin typeface="Ramabhadra" panose="02000600000000000000" pitchFamily="2" charset="0"/>
-              <a:cs typeface="Ramabhadra" panose="02000600000000000000" pitchFamily="2" charset="0"/>
-            </a:endParaRPr>
-          </a:p>
-          <a:p>
-            <a:pPr marL="0" marR="0" indent="0" algn="ctr" rtl="0" eaLnBrk="1" fontAlgn="auto" latinLnBrk="0" hangingPunct="1">
-              <a:spcBef>
-                <a:spcPts val="0"/>
-              </a:spcBef>
-              <a:spcAft>
-                <a:spcPts val="0"/>
-              </a:spcAft>
-            </a:pPr>
-            <a:r>
-              <a:rPr lang="te-IN" sz="1900" b="0" i="0" dirty="0">
-                <a:solidFill>
-                  <a:schemeClr val="tx1"/>
-                </a:solidFill>
-                <a:effectLst/>
-                <a:latin typeface="Ramabhadra" panose="02000600000000000000" pitchFamily="2" charset="0"/>
-                <a:cs typeface="Ramabhadra" panose="02000600000000000000" pitchFamily="2" charset="0"/>
-              </a:rPr>
-              <a:t>ఎంతో ఘనమైనది</a:t>
-            </a:r>
-          </a:p>
-          <a:p>
-            <a:pPr marL="0" marR="0" indent="0" algn="ctr" rtl="0" eaLnBrk="1" fontAlgn="auto" latinLnBrk="0" hangingPunct="1">
-              <a:spcBef>
-                <a:spcPts val="0"/>
-              </a:spcBef>
-              <a:spcAft>
-                <a:spcPts val="0"/>
-              </a:spcAft>
-            </a:pPr>
-            <a:r>
-              <a:rPr lang="te-IN" sz="1900" b="0" i="0" dirty="0">
-                <a:solidFill>
-                  <a:schemeClr val="tx1"/>
-                </a:solidFill>
-                <a:effectLst/>
-                <a:latin typeface="Ramabhadra" panose="02000600000000000000" pitchFamily="2" charset="0"/>
-                <a:cs typeface="Ramabhadra" panose="02000600000000000000" pitchFamily="2" charset="0"/>
-              </a:rPr>
-              <a:t>ఆ…ఆ…ఆ…  ఎంతో ఘనమైనది</a:t>
+              <a:t>హల్లెలూయా హల్లెలూయా హల్లెలూయా (4)</a:t>
             </a:r>
           </a:p>
           <a:p>
@@ -4387,16 +4189,8 @@
                 <a:latin typeface="Ramabhadra" panose="02000600000000000000" pitchFamily="2" charset="0"/>
                 <a:cs typeface="Ramabhadra" panose="02000600000000000000" pitchFamily="2" charset="0"/>
               </a:rPr>
-              <a:t>మోషే ప్రార్ధించగా</a:t>
-            </a:r>
-            <a:endParaRPr lang="en-IN" sz="1900" b="0" i="0" dirty="0">
-              <a:solidFill>
-                <a:schemeClr val="tx1"/>
-              </a:solidFill>
-              <a:effectLst/>
-              <a:latin typeface="Ramabhadra" panose="02000600000000000000" pitchFamily="2" charset="0"/>
-              <a:cs typeface="Ramabhadra" panose="02000600000000000000" pitchFamily="2" charset="0"/>
-            </a:endParaRPr>
+              <a:t>స్తుతిపాటలే పాడుమా –</a:t>
+            </a:r>
           </a:p>
           <a:p>
             <a:pPr marL="0" marR="0" indent="0" algn="ctr" rtl="0" eaLnBrk="1" fontAlgn="auto" latinLnBrk="0" hangingPunct="1">
@@ -4416,57 +4210,7 @@
                 <a:latin typeface="Ramabhadra" panose="02000600000000000000" pitchFamily="2" charset="0"/>
                 <a:cs typeface="Ramabhadra" panose="02000600000000000000" pitchFamily="2" charset="0"/>
               </a:rPr>
-              <a:t>మన్నాను కురిపించితివి (2)</a:t>
-            </a:r>
-          </a:p>
-          <a:p>
-            <a:pPr marL="0" marR="0" indent="0" algn="ctr" rtl="0" eaLnBrk="1" fontAlgn="auto" latinLnBrk="0" hangingPunct="1">
-              <a:spcBef>
-                <a:spcPts val="0"/>
-              </a:spcBef>
-              <a:spcAft>
-                <a:spcPts val="0"/>
-              </a:spcAft>
-            </a:pPr>
-            <a:r>
-              <a:rPr lang="te-IN" sz="1900" b="0" i="0" dirty="0">
-                <a:solidFill>
-                  <a:schemeClr val="tx1"/>
-                </a:solidFill>
-                <a:effectLst/>
-                <a:latin typeface="Ramabhadra" panose="02000600000000000000" pitchFamily="2" charset="0"/>
-                <a:cs typeface="Ramabhadra" panose="02000600000000000000" pitchFamily="2" charset="0"/>
-              </a:rPr>
-              <a:t>యెహోషువా ప్రార్ధించగా</a:t>
-            </a:r>
-            <a:endParaRPr lang="en-IN" sz="1900" b="0" i="0" dirty="0">
-              <a:solidFill>
-                <a:schemeClr val="tx1"/>
-              </a:solidFill>
-              <a:effectLst/>
-              <a:latin typeface="Ramabhadra" panose="02000600000000000000" pitchFamily="2" charset="0"/>
-              <a:cs typeface="Ramabhadra" panose="02000600000000000000" pitchFamily="2" charset="0"/>
-            </a:endParaRPr>
-          </a:p>
-          <a:p>
-            <a:pPr marL="0" marR="0" indent="0" algn="ctr" rtl="0" eaLnBrk="1" fontAlgn="auto" latinLnBrk="0" hangingPunct="1">
-              <a:spcBef>
-                <a:spcPts val="0"/>
-              </a:spcBef>
-              <a:spcAft>
-                <a:spcPts val="0"/>
-              </a:spcAft>
-            </a:pPr>
-            <a:r>
-              <a:rPr lang="te-IN" sz="1900" b="0" i="0" dirty="0">
-                <a:solidFill>
-                  <a:schemeClr val="tx1"/>
-                </a:solidFill>
-                <a:effectLst/>
-                <a:latin typeface="Ramabhadra" panose="02000600000000000000" pitchFamily="2" charset="0"/>
-                <a:cs typeface="Ramabhadra" panose="02000600000000000000" pitchFamily="2" charset="0"/>
-              </a:rPr>
-              <a:t>సూర్యచంద్రుల నాపితివి (2)</a:t>
+              <a:t>ప్రభు యేసునే వేడుమా (2)</a:t>
             </a:r>
           </a:p>
           <a:p>
@@ -4505,9 +4249,40 @@
                 <a:latin typeface="Ramabhadra" panose="02000600000000000000" pitchFamily="2" charset="0"/>
                 <a:cs typeface="Ramabhadra" panose="02000600000000000000" pitchFamily="2" charset="0"/>
               </a:rPr>
-              <a:t>నీ ప్రజల పక్షముగా</a:t>
-            </a:r>
-            <a:endParaRPr lang="en-IN" sz="1900" b="0" i="0" dirty="0">
+              <a:t>కష్టములే కలిగిన –</a:t>
+            </a:r>
+          </a:p>
+          <a:p>
+            <a:pPr marL="0" marR="0" indent="0" algn="ctr" rtl="0" eaLnBrk="1" fontAlgn="auto" latinLnBrk="0" hangingPunct="1">
+              <a:spcBef>
+                <a:spcPts val="0"/>
+              </a:spcBef>
+              <a:spcAft>
+                <a:spcPts val="0"/>
+              </a:spcAft>
+            </a:pPr>
+            <a:r>
+              <a:rPr lang="te-IN" sz="1900" b="0" i="0" dirty="0">
+                <a:solidFill>
+                  <a:schemeClr val="tx1"/>
+                </a:solidFill>
+                <a:effectLst/>
+                <a:latin typeface="Ramabhadra" panose="02000600000000000000" pitchFamily="2" charset="0"/>
+                <a:cs typeface="Ramabhadra" panose="02000600000000000000" pitchFamily="2" charset="0"/>
+              </a:rPr>
+              <a:t>కన్నీరులే మిగిలినా “స్తుతి”</a:t>
+            </a:r>
+          </a:p>
+          <a:p>
+            <a:pPr marL="0" marR="0" indent="0" algn="ctr" rtl="0" eaLnBrk="1" fontAlgn="auto" latinLnBrk="0" hangingPunct="1">
+              <a:spcBef>
+                <a:spcPts val="0"/>
+              </a:spcBef>
+              <a:spcAft>
+                <a:spcPts val="0"/>
+              </a:spcAft>
+            </a:pPr>
+            <a:endParaRPr lang="te-IN" sz="1900" b="0" i="0" dirty="0">
               <a:solidFill>
                 <a:schemeClr val="tx1"/>
               </a:solidFill>
@@ -4534,7 +4309,7 @@
                 <a:latin typeface="Ramabhadra" panose="02000600000000000000" pitchFamily="2" charset="0"/>
                 <a:cs typeface="Ramabhadra" panose="02000600000000000000" pitchFamily="2" charset="0"/>
               </a:rPr>
-              <a:t>యుద్దములు చేసిన దేవా (2)</a:t>
+              <a:t>బంధాలు బిగియించినా –</a:t>
             </a:r>
           </a:p>
           <a:p>
@@ -4555,9 +4330,19 @@
                 <a:latin typeface="Ramabhadra" panose="02000600000000000000" pitchFamily="2" charset="0"/>
                 <a:cs typeface="Ramabhadra" panose="02000600000000000000" pitchFamily="2" charset="0"/>
               </a:rPr>
-              <a:t>అగ్నిలో పడవేసినా</a:t>
-            </a:r>
-            <a:endParaRPr lang="en-IN" sz="1900" b="0" i="0" dirty="0">
+              <a:t>చేరసాలలో వేసినా “స్తుతి”</a:t>
+            </a:r>
+          </a:p>
+          <a:p>
+            <a:pPr marL="0" marR="0" indent="0" algn="ctr" rtl="0" eaLnBrk="1" fontAlgn="auto" latinLnBrk="0" hangingPunct="1">
+              <a:spcBef>
+                <a:spcPts val="0"/>
+              </a:spcBef>
+              <a:spcAft>
+                <a:spcPts val="0"/>
+              </a:spcAft>
+            </a:pPr>
+            <a:endParaRPr lang="te-IN" sz="1900" b="0" i="0" dirty="0">
               <a:solidFill>
                 <a:schemeClr val="tx1"/>
               </a:solidFill>
@@ -4584,7 +4369,28 @@
                 <a:latin typeface="Ramabhadra" panose="02000600000000000000" pitchFamily="2" charset="0"/>
                 <a:cs typeface="Ramabhadra" panose="02000600000000000000" pitchFamily="2" charset="0"/>
               </a:rPr>
-              <a:t>భయమేమి లేకుండిరి (2) </a:t>
+              <a:t>నీ తల్లి నిను మరిచినా – </a:t>
+            </a:r>
+          </a:p>
+          <a:p>
+            <a:pPr marL="0" marR="0" indent="0" algn="ctr" rtl="0" eaLnBrk="1" fontAlgn="auto" latinLnBrk="0" hangingPunct="1">
+              <a:spcBef>
+                <a:spcPts val="0"/>
+              </a:spcBef>
+              <a:spcAft>
+                <a:spcPts val="0"/>
+              </a:spcAft>
+            </a:pPr>
+            <a:r>
+              <a:rPr lang="te-IN" sz="1900" b="0" i="0" dirty="0">
+                <a:solidFill>
+                  <a:schemeClr val="tx1"/>
+                </a:solidFill>
+                <a:effectLst/>
+                <a:latin typeface="Ramabhadra" panose="02000600000000000000" pitchFamily="2" charset="0"/>
+                <a:cs typeface="Ramabhadra" panose="02000600000000000000" pitchFamily="2" charset="0"/>
+              </a:rPr>
+              <a:t>మరువని నీ దేవుడు “స్తుతి”</a:t>
             </a:r>
           </a:p>
         </p:txBody>
@@ -4650,7 +4456,7 @@
                 <a:latin typeface="Ramabhadra" panose="02000600000000000000" pitchFamily="2" charset="0"/>
                 <a:cs typeface="Ramabhadra" panose="02000600000000000000" pitchFamily="2" charset="0"/>
               </a:rPr>
-              <a:t>నీవు చేసిన మేళ్లకు</a:t>
+              <a:t>విన్నపములు వినువాడా</a:t>
             </a:r>
           </a:p>
           <a:p>
@@ -4664,7 +4470,7 @@
                 <a:latin typeface="Ramabhadra" panose="02000600000000000000" pitchFamily="2" charset="0"/>
                 <a:cs typeface="Ramabhadra" panose="02000600000000000000" pitchFamily="2" charset="0"/>
               </a:rPr>
-              <a:t>నీవు చూపిన కృపలకు (2)</a:t>
+              <a:t>నా కన్నీరు తుడుచు వాడా </a:t>
             </a:r>
           </a:p>
           <a:p>
@@ -4678,7 +4484,7 @@
                 <a:latin typeface="Ramabhadra" panose="02000600000000000000" pitchFamily="2" charset="0"/>
                 <a:cs typeface="Ramabhadra" panose="02000600000000000000" pitchFamily="2" charset="0"/>
               </a:rPr>
-              <a:t>వందనం యేసయ్యా (4)</a:t>
+              <a:t>సుఖములు ఇచ్చువాడా స్తోత్రము యేసయ్యా </a:t>
             </a:r>
           </a:p>
           <a:p>
@@ -4703,7 +4509,7 @@
                 <a:latin typeface="Ramabhadra" panose="02000600000000000000" pitchFamily="2" charset="0"/>
                 <a:cs typeface="Ramabhadra" panose="02000600000000000000" pitchFamily="2" charset="0"/>
               </a:rPr>
-              <a:t>ఏపాటివాడనని నేను</a:t>
+              <a:t>నీ నుండియే అన్ని సాధ్యమయ్యా </a:t>
             </a:r>
           </a:p>
           <a:p>
@@ -4717,7 +4523,7 @@
                 <a:latin typeface="Ramabhadra" panose="02000600000000000000" pitchFamily="2" charset="0"/>
                 <a:cs typeface="Ramabhadra" panose="02000600000000000000" pitchFamily="2" charset="0"/>
               </a:rPr>
-              <a:t>నన్నెంతగానో ప్రేమించావు</a:t>
+              <a:t>మాట ఒకటి చాలునయ్య</a:t>
             </a:r>
           </a:p>
           <a:p>
@@ -4731,21 +4537,7 @@
                 <a:latin typeface="Ramabhadra" panose="02000600000000000000" pitchFamily="2" charset="0"/>
                 <a:cs typeface="Ramabhadra" panose="02000600000000000000" pitchFamily="2" charset="0"/>
               </a:rPr>
-              <a:t>అంచెలంచెలుగా హెచ్చించి</a:t>
-            </a:r>
-          </a:p>
-          <a:p>
-            <a:pPr algn="ctr"/>
-            <a:r>
-              <a:rPr lang="te-IN" sz="2300" b="0" i="0" dirty="0">
-                <a:solidFill>
-                  <a:srgbClr val="000000"/>
-                </a:solidFill>
-                <a:effectLst/>
-                <a:latin typeface="Ramabhadra" panose="02000600000000000000" pitchFamily="2" charset="0"/>
-                <a:cs typeface="Ramabhadra" panose="02000600000000000000" pitchFamily="2" charset="0"/>
-              </a:rPr>
-              <a:t>నన్నెంతగానో దీవించావు (2)</a:t>
+              <a:t>నీ మాట ఒకటి చాలునయ్య </a:t>
             </a:r>
           </a:p>
           <a:p>
@@ -4770,7 +4562,7 @@
                 <a:latin typeface="Ramabhadra" panose="02000600000000000000" pitchFamily="2" charset="0"/>
                 <a:cs typeface="Ramabhadra" panose="02000600000000000000" pitchFamily="2" charset="0"/>
               </a:rPr>
-              <a:t>బలహీనుడనైన నన్ను</a:t>
+              <a:t>నా చిత్తమే శుద్ధి పొందు </a:t>
             </a:r>
           </a:p>
           <a:p>
@@ -4784,7 +4576,7 @@
                 <a:latin typeface="Ramabhadra" panose="02000600000000000000" pitchFamily="2" charset="0"/>
                 <a:cs typeface="Ramabhadra" panose="02000600000000000000" pitchFamily="2" charset="0"/>
               </a:rPr>
-              <a:t>నీవెంతగానో బలపరచావు</a:t>
+              <a:t>అని చెప్పి తాకితివే</a:t>
             </a:r>
           </a:p>
           <a:p>
@@ -4798,21 +4590,7 @@
                 <a:latin typeface="Ramabhadra" panose="02000600000000000000" pitchFamily="2" charset="0"/>
                 <a:cs typeface="Ramabhadra" panose="02000600000000000000" pitchFamily="2" charset="0"/>
               </a:rPr>
-              <a:t>క్రీస్తేసు మహిమైశ్వర్యములో</a:t>
-            </a:r>
-          </a:p>
-          <a:p>
-            <a:pPr algn="ctr"/>
-            <a:r>
-              <a:rPr lang="te-IN" sz="2300" b="0" i="0" dirty="0">
-                <a:solidFill>
-                  <a:srgbClr val="000000"/>
-                </a:solidFill>
-                <a:effectLst/>
-                <a:latin typeface="Ramabhadra" panose="02000600000000000000" pitchFamily="2" charset="0"/>
-                <a:cs typeface="Ramabhadra" panose="02000600000000000000" pitchFamily="2" charset="0"/>
-              </a:rPr>
-              <a:t>ప్రతి అవసరమును తీర్చావు (2)</a:t>
+              <a:t>అయ్యా అని చెప్పి తాకితివే </a:t>
             </a:r>
           </a:p>
         </p:txBody>
@@ -4870,42 +4648,95 @@
           <a:p>
             <a:pPr algn="ctr" defTabSz="439781"/>
             <a:r>
-              <a:rPr lang="te-IN" dirty="0">
+              <a:rPr lang="te-IN" sz="1700" dirty="0">
                 <a:solidFill>
                   <a:schemeClr val="tx1"/>
                 </a:solidFill>
                 <a:latin typeface="Ramabhadra" panose="02000600000000000000" pitchFamily="2" charset="0"/>
                 <a:cs typeface="Ramabhadra" panose="02000600000000000000" pitchFamily="2" charset="0"/>
               </a:rPr>
-              <a:t>నీ కృప నిత్యముండును</a:t>
+              <a:t>ఆశ్చర్యకరుడు ఆలోచనకర్త</a:t>
+            </a:r>
+            <a:br>
+              <a:rPr lang="te-IN" sz="1700" dirty="0">
+                <a:solidFill>
+                  <a:schemeClr val="tx1"/>
+                </a:solidFill>
+                <a:latin typeface="Ramabhadra" panose="02000600000000000000" pitchFamily="2" charset="0"/>
+                <a:cs typeface="Ramabhadra" panose="02000600000000000000" pitchFamily="2" charset="0"/>
+              </a:rPr>
+            </a:br>
+            <a:r>
+              <a:rPr lang="te-IN" sz="1700" dirty="0">
+                <a:solidFill>
+                  <a:schemeClr val="tx1"/>
+                </a:solidFill>
+                <a:latin typeface="Ramabhadra" panose="02000600000000000000" pitchFamily="2" charset="0"/>
+                <a:cs typeface="Ramabhadra" panose="02000600000000000000" pitchFamily="2" charset="0"/>
+              </a:rPr>
+              <a:t>నిత్యుడగు తండ్రి సమాధానకర్త (2)</a:t>
+            </a:r>
+            <a:br>
+              <a:rPr lang="te-IN" sz="1700" dirty="0">
+                <a:solidFill>
+                  <a:schemeClr val="tx1"/>
+                </a:solidFill>
+                <a:latin typeface="Ramabhadra" panose="02000600000000000000" pitchFamily="2" charset="0"/>
+                <a:cs typeface="Ramabhadra" panose="02000600000000000000" pitchFamily="2" charset="0"/>
+              </a:rPr>
+            </a:br>
+            <a:r>
+              <a:rPr lang="te-IN" sz="1700" dirty="0">
+                <a:solidFill>
+                  <a:schemeClr val="tx1"/>
+                </a:solidFill>
+                <a:latin typeface="Ramabhadra" panose="02000600000000000000" pitchFamily="2" charset="0"/>
+                <a:cs typeface="Ramabhadra" panose="02000600000000000000" pitchFamily="2" charset="0"/>
+              </a:rPr>
+              <a:t>తనవంటి గొప్ప దేవుడు ఎవరున్నారిలలో</a:t>
+            </a:r>
+            <a:br>
+              <a:rPr lang="te-IN" sz="1700" dirty="0">
+                <a:solidFill>
+                  <a:schemeClr val="tx1"/>
+                </a:solidFill>
+                <a:latin typeface="Ramabhadra" panose="02000600000000000000" pitchFamily="2" charset="0"/>
+                <a:cs typeface="Ramabhadra" panose="02000600000000000000" pitchFamily="2" charset="0"/>
+              </a:rPr>
+            </a:br>
+            <a:r>
+              <a:rPr lang="te-IN" sz="1700" dirty="0">
+                <a:solidFill>
+                  <a:schemeClr val="tx1"/>
+                </a:solidFill>
+                <a:latin typeface="Ramabhadra" panose="02000600000000000000" pitchFamily="2" charset="0"/>
+                <a:cs typeface="Ramabhadra" panose="02000600000000000000" pitchFamily="2" charset="0"/>
+              </a:rPr>
+              <a:t>తన సాటైనా దీటైనా </a:t>
             </a:r>
           </a:p>
           <a:p>
             <a:pPr algn="ctr" defTabSz="439781"/>
             <a:r>
-              <a:rPr lang="te-IN" dirty="0">
+              <a:rPr lang="te-IN" sz="1700" dirty="0">
                 <a:solidFill>
                   <a:schemeClr val="tx1"/>
                 </a:solidFill>
                 <a:latin typeface="Ramabhadra" panose="02000600000000000000" pitchFamily="2" charset="0"/>
                 <a:cs typeface="Ramabhadra" panose="02000600000000000000" pitchFamily="2" charset="0"/>
               </a:rPr>
-              <a:t>నీ కృప నిత్య జీవము</a:t>
-            </a:r>
-          </a:p>
-          <a:p>
-            <a:pPr algn="ctr" defTabSz="439781"/>
-            <a:r>
-              <a:rPr lang="te-IN" dirty="0">
+              <a:t>    దేవుడు లేడిలలో (2)    </a:t>
+            </a:r>
+            <a:br>
+              <a:rPr lang="te-IN" sz="1700" dirty="0">
                 <a:solidFill>
                   <a:schemeClr val="tx1"/>
                 </a:solidFill>
                 <a:latin typeface="Ramabhadra" panose="02000600000000000000" pitchFamily="2" charset="0"/>
                 <a:cs typeface="Ramabhadra" panose="02000600000000000000" pitchFamily="2" charset="0"/>
               </a:rPr>
-              <a:t>నీ కృప వివరింప</a:t>
-            </a:r>
-            <a:endParaRPr lang="en-IN" dirty="0">
+            </a:br>
+            <a:endParaRPr lang="te-IN" sz="1700" dirty="0">
               <a:solidFill>
                 <a:schemeClr val="tx1"/>
               </a:solidFill>
@@ -4916,52 +4747,82 @@
           <a:p>
             <a:pPr algn="ctr" defTabSz="439781"/>
             <a:r>
-              <a:rPr lang="te-IN" dirty="0">
+              <a:rPr lang="te-IN" sz="1700" dirty="0">
                 <a:solidFill>
                   <a:schemeClr val="tx1"/>
                 </a:solidFill>
                 <a:latin typeface="Ramabhadra" panose="02000600000000000000" pitchFamily="2" charset="0"/>
                 <a:cs typeface="Ramabhadra" panose="02000600000000000000" pitchFamily="2" charset="0"/>
               </a:rPr>
-              <a:t>నా తరమా యేసయ్యా (2)</a:t>
-            </a:r>
-          </a:p>
-          <a:p>
-            <a:pPr algn="ctr" defTabSz="439781"/>
-            <a:r>
-              <a:rPr lang="te-IN" dirty="0">
+              <a:t>తన చేతిలో రోగాలు లయమైపోయెను</a:t>
+            </a:r>
+            <a:br>
+              <a:rPr lang="te-IN" sz="1700" dirty="0">
                 <a:solidFill>
                   <a:schemeClr val="tx1"/>
                 </a:solidFill>
                 <a:latin typeface="Ramabhadra" panose="02000600000000000000" pitchFamily="2" charset="0"/>
                 <a:cs typeface="Ramabhadra" panose="02000600000000000000" pitchFamily="2" charset="0"/>
               </a:rPr>
-              <a:t>నీతిమంతుల గుడారాలలో వినబడుచున్నది</a:t>
-            </a:r>
-          </a:p>
-          <a:p>
-            <a:pPr algn="ctr" defTabSz="439781"/>
-            <a:r>
-              <a:rPr lang="te-IN" dirty="0">
+            </a:br>
+            <a:r>
+              <a:rPr lang="te-IN" sz="1700" dirty="0">
                 <a:solidFill>
                   <a:schemeClr val="tx1"/>
                 </a:solidFill>
                 <a:latin typeface="Ramabhadra" panose="02000600000000000000" pitchFamily="2" charset="0"/>
                 <a:cs typeface="Ramabhadra" panose="02000600000000000000" pitchFamily="2" charset="0"/>
               </a:rPr>
-              <a:t>రక్షణ సంగీత సునాదము (2</a:t>
-            </a:r>
-            <a:r>
-              <a:rPr lang="en-IN" dirty="0">
+              <a:t>తన చూపుతో దయ్యాలు విలవిలలాడెను (2)</a:t>
+            </a:r>
+            <a:br>
+              <a:rPr lang="te-IN" sz="1700" dirty="0">
                 <a:solidFill>
                   <a:schemeClr val="tx1"/>
                 </a:solidFill>
                 <a:latin typeface="Ramabhadra" panose="02000600000000000000" pitchFamily="2" charset="0"/>
                 <a:cs typeface="Ramabhadra" panose="02000600000000000000" pitchFamily="2" charset="0"/>
               </a:rPr>
-              <a:t>)</a:t>
-            </a:r>
-            <a:endParaRPr lang="te-IN" dirty="0">
+            </a:br>
+            <a:r>
+              <a:rPr lang="te-IN" sz="1700" dirty="0">
+                <a:solidFill>
+                  <a:schemeClr val="tx1"/>
+                </a:solidFill>
+                <a:latin typeface="Ramabhadra" panose="02000600000000000000" pitchFamily="2" charset="0"/>
+                <a:cs typeface="Ramabhadra" panose="02000600000000000000" pitchFamily="2" charset="0"/>
+              </a:rPr>
+              <a:t>తన మాటతో ప్రకృతినే శాసించినవాడు (2)</a:t>
+            </a:r>
+            <a:br>
+              <a:rPr lang="te-IN" sz="1700" dirty="0">
+                <a:solidFill>
+                  <a:schemeClr val="tx1"/>
+                </a:solidFill>
+                <a:latin typeface="Ramabhadra" panose="02000600000000000000" pitchFamily="2" charset="0"/>
+                <a:cs typeface="Ramabhadra" panose="02000600000000000000" pitchFamily="2" charset="0"/>
+              </a:rPr>
+            </a:br>
+            <a:r>
+              <a:rPr lang="te-IN" sz="1700" dirty="0">
+                <a:solidFill>
+                  <a:schemeClr val="tx1"/>
+                </a:solidFill>
+                <a:latin typeface="Ramabhadra" panose="02000600000000000000" pitchFamily="2" charset="0"/>
+                <a:cs typeface="Ramabhadra" panose="02000600000000000000" pitchFamily="2" charset="0"/>
+              </a:rPr>
+              <a:t>నీటిపై ఠీవిగా నడచినవాడతడు (2)      </a:t>
+            </a:r>
+            <a:br>
+              <a:rPr lang="te-IN" sz="1700" dirty="0">
+                <a:solidFill>
+                  <a:schemeClr val="tx1"/>
+                </a:solidFill>
+                <a:latin typeface="Ramabhadra" panose="02000600000000000000" pitchFamily="2" charset="0"/>
+                <a:cs typeface="Ramabhadra" panose="02000600000000000000" pitchFamily="2" charset="0"/>
+              </a:rPr>
+            </a:br>
+            <a:endParaRPr lang="te-IN" sz="1700" dirty="0">
               <a:solidFill>
                 <a:schemeClr val="tx1"/>
               </a:solidFill>
@@ -4971,127 +4832,98 @@
           </a:p>
           <a:p>
             <a:pPr algn="ctr" defTabSz="439781"/>
-            <a:endParaRPr lang="te-IN" dirty="0">
-              <a:solidFill>
-                <a:schemeClr val="tx1"/>
-              </a:solidFill>
-              <a:latin typeface="Ramabhadra" panose="02000600000000000000" pitchFamily="2" charset="0"/>
-              <a:cs typeface="Ramabhadra" panose="02000600000000000000" pitchFamily="2" charset="0"/>
-            </a:endParaRPr>
+            <a:r>
+              <a:rPr lang="te-IN" sz="1700" dirty="0">
+                <a:solidFill>
+                  <a:schemeClr val="tx1"/>
+                </a:solidFill>
+                <a:latin typeface="Ramabhadra" panose="02000600000000000000" pitchFamily="2" charset="0"/>
+                <a:cs typeface="Ramabhadra" panose="02000600000000000000" pitchFamily="2" charset="0"/>
+              </a:rPr>
+              <a:t>మనకోసం తన ప్రాణాన్నే బలి ఇచ్చినవాడతడు</a:t>
+            </a:r>
+            <a:br>
+              <a:rPr lang="te-IN" sz="1700" dirty="0">
+                <a:solidFill>
+                  <a:schemeClr val="tx1"/>
+                </a:solidFill>
+                <a:latin typeface="Ramabhadra" panose="02000600000000000000" pitchFamily="2" charset="0"/>
+                <a:cs typeface="Ramabhadra" panose="02000600000000000000" pitchFamily="2" charset="0"/>
+              </a:rPr>
+            </a:br>
+            <a:r>
+              <a:rPr lang="te-IN" sz="1700" dirty="0">
+                <a:solidFill>
+                  <a:schemeClr val="tx1"/>
+                </a:solidFill>
+                <a:latin typeface="Ramabhadra" panose="02000600000000000000" pitchFamily="2" charset="0"/>
+                <a:cs typeface="Ramabhadra" panose="02000600000000000000" pitchFamily="2" charset="0"/>
+              </a:rPr>
+              <a:t>మనకోసం సజీవుడై లేచినవాడతడు (2)</a:t>
+            </a:r>
+            <a:br>
+              <a:rPr lang="te-IN" sz="1700" dirty="0">
+                <a:solidFill>
+                  <a:schemeClr val="tx1"/>
+                </a:solidFill>
+                <a:latin typeface="Ramabhadra" panose="02000600000000000000" pitchFamily="2" charset="0"/>
+                <a:cs typeface="Ramabhadra" panose="02000600000000000000" pitchFamily="2" charset="0"/>
+              </a:rPr>
+            </a:br>
+            <a:r>
+              <a:rPr lang="te-IN" sz="1700" dirty="0">
+                <a:solidFill>
+                  <a:schemeClr val="tx1"/>
+                </a:solidFill>
+                <a:latin typeface="Ramabhadra" panose="02000600000000000000" pitchFamily="2" charset="0"/>
+                <a:cs typeface="Ramabhadra" panose="02000600000000000000" pitchFamily="2" charset="0"/>
+              </a:rPr>
+              <a:t>తన శాంతినే పంచిపెట్టిన</a:t>
+            </a:r>
           </a:p>
           <a:p>
             <a:pPr algn="ctr" defTabSz="439781"/>
             <a:r>
-              <a:rPr lang="te-IN" dirty="0">
+              <a:rPr lang="te-IN" sz="1700" dirty="0">
                 <a:solidFill>
                   <a:schemeClr val="tx1"/>
                 </a:solidFill>
                 <a:latin typeface="Ramabhadra" panose="02000600000000000000" pitchFamily="2" charset="0"/>
                 <a:cs typeface="Ramabhadra" panose="02000600000000000000" pitchFamily="2" charset="0"/>
               </a:rPr>
-              <a:t>శృతి ఉన్న పాటలకు విలువలు ఉన్నట్లె</a:t>
+              <a:t>శాంతమూర్తి యేసు (2)</a:t>
+            </a:r>
+            <a:br>
+              <a:rPr lang="te-IN" sz="1700" dirty="0">
+                <a:solidFill>
+                  <a:schemeClr val="tx1"/>
+                </a:solidFill>
+                <a:latin typeface="Ramabhadra" panose="02000600000000000000" pitchFamily="2" charset="0"/>
+                <a:cs typeface="Ramabhadra" panose="02000600000000000000" pitchFamily="2" charset="0"/>
+              </a:rPr>
+            </a:br>
+            <a:r>
+              <a:rPr lang="te-IN" sz="1700" dirty="0">
+                <a:solidFill>
+                  <a:schemeClr val="tx1"/>
+                </a:solidFill>
+                <a:latin typeface="Ramabhadra" panose="02000600000000000000" pitchFamily="2" charset="0"/>
+                <a:cs typeface="Ramabhadra" panose="02000600000000000000" pitchFamily="2" charset="0"/>
+              </a:rPr>
+              <a:t>తన సర్వాన్నే ధారబోసిన</a:t>
             </a:r>
           </a:p>
           <a:p>
             <a:pPr algn="ctr" defTabSz="439781"/>
             <a:r>
-              <a:rPr lang="te-IN" dirty="0">
+              <a:rPr lang="te-IN" sz="1700" dirty="0">
                 <a:solidFill>
                   <a:schemeClr val="tx1"/>
                 </a:solidFill>
                 <a:latin typeface="Ramabhadra" panose="02000600000000000000" pitchFamily="2" charset="0"/>
                 <a:cs typeface="Ramabhadra" panose="02000600000000000000" pitchFamily="2" charset="0"/>
               </a:rPr>
-              <a:t>కృతజ్ఞతనిచ్చావు కృపలో నిలిపావు (2)</a:t>
-            </a:r>
-          </a:p>
-          <a:p>
-            <a:pPr algn="ctr" defTabSz="439781"/>
-            <a:r>
-              <a:rPr lang="te-IN" dirty="0">
-                <a:solidFill>
-                  <a:schemeClr val="tx1"/>
-                </a:solidFill>
-                <a:latin typeface="Ramabhadra" panose="02000600000000000000" pitchFamily="2" charset="0"/>
-                <a:cs typeface="Ramabhadra" panose="02000600000000000000" pitchFamily="2" charset="0"/>
-              </a:rPr>
-              <a:t>కృంగిన వేళలో నను లేవనెత్తిన</a:t>
-            </a:r>
-            <a:endParaRPr lang="en-IN" dirty="0">
-              <a:solidFill>
-                <a:schemeClr val="tx1"/>
-              </a:solidFill>
-              <a:latin typeface="Ramabhadra" panose="02000600000000000000" pitchFamily="2" charset="0"/>
-              <a:cs typeface="Ramabhadra" panose="02000600000000000000" pitchFamily="2" charset="0"/>
-            </a:endParaRPr>
-          </a:p>
-          <a:p>
-            <a:pPr algn="ctr" defTabSz="439781"/>
-            <a:r>
-              <a:rPr lang="te-IN" dirty="0">
-                <a:solidFill>
-                  <a:schemeClr val="tx1"/>
-                </a:solidFill>
-                <a:latin typeface="Ramabhadra" panose="02000600000000000000" pitchFamily="2" charset="0"/>
-                <a:cs typeface="Ramabhadra" panose="02000600000000000000" pitchFamily="2" charset="0"/>
-              </a:rPr>
-              <a:t>చిరునామా నీవేగా (2)</a:t>
-            </a:r>
-            <a:endParaRPr lang="en-IN" dirty="0">
-              <a:solidFill>
-                <a:schemeClr val="tx1"/>
-              </a:solidFill>
-              <a:latin typeface="Ramabhadra" panose="02000600000000000000" pitchFamily="2" charset="0"/>
-              <a:cs typeface="Ramabhadra" panose="02000600000000000000" pitchFamily="2" charset="0"/>
-            </a:endParaRPr>
-          </a:p>
-          <a:p>
-            <a:pPr algn="ctr" defTabSz="439781"/>
-            <a:endParaRPr lang="te-IN" dirty="0">
-              <a:solidFill>
-                <a:schemeClr val="tx1"/>
-              </a:solidFill>
-              <a:latin typeface="Ramabhadra" panose="02000600000000000000" pitchFamily="2" charset="0"/>
-              <a:cs typeface="Ramabhadra" panose="02000600000000000000" pitchFamily="2" charset="0"/>
-            </a:endParaRPr>
-          </a:p>
-          <a:p>
-            <a:pPr algn="ctr" defTabSz="439781"/>
-            <a:r>
-              <a:rPr lang="te-IN" dirty="0">
-                <a:solidFill>
-                  <a:schemeClr val="tx1"/>
-                </a:solidFill>
-                <a:latin typeface="Ramabhadra" panose="02000600000000000000" pitchFamily="2" charset="0"/>
-                <a:cs typeface="Ramabhadra" panose="02000600000000000000" pitchFamily="2" charset="0"/>
-              </a:rPr>
-              <a:t>ప్రతి చరణము వెంట పల్లవి ఉన్నట్లె</a:t>
-            </a:r>
-          </a:p>
-          <a:p>
-            <a:pPr algn="ctr" defTabSz="439781"/>
-            <a:r>
-              <a:rPr lang="te-IN" dirty="0">
-                <a:solidFill>
-                  <a:schemeClr val="tx1"/>
-                </a:solidFill>
-                <a:latin typeface="Ramabhadra" panose="02000600000000000000" pitchFamily="2" charset="0"/>
-                <a:cs typeface="Ramabhadra" panose="02000600000000000000" pitchFamily="2" charset="0"/>
-              </a:rPr>
-              <a:t>ప్రతి క్షణమున నీవు పలుకరించావు (2)</a:t>
-            </a:r>
-          </a:p>
-          <a:p>
-            <a:pPr algn="ctr" defTabSz="439781"/>
-            <a:r>
-              <a:rPr lang="te-IN" dirty="0">
-                <a:solidFill>
-                  <a:schemeClr val="tx1"/>
-                </a:solidFill>
-                <a:latin typeface="Ramabhadra" panose="02000600000000000000" pitchFamily="2" charset="0"/>
-                <a:cs typeface="Ramabhadra" panose="02000600000000000000" pitchFamily="2" charset="0"/>
-              </a:rPr>
-              <a:t>ప్రతికూలమైన పరిస్థితిలన్నియు కనుమరుగైపోయెనే (2) </a:t>
+              <a:t>త్యాగశీలి క్రీస్తు (2)   </a:t>
             </a:r>
           </a:p>
         </p:txBody>

</xml_diff>

<commit_message>
12 sunday songs may
</commit_message>
<xml_diff>
--- a/xerox.pptx
+++ b/xerox.pptx
@@ -224,7 +224,7 @@
           <a:p>
             <a:fld id="{3502DD63-DF8D-4AB8-92A0-0ECCF612C06C}" type="datetimeFigureOut">
               <a:rPr lang="en-IN" smtClean="0"/>
-              <a:t>04-05-2024</a:t>
+              <a:t>11-05-2024</a:t>
             </a:fld>
             <a:endParaRPr lang="en-IN"/>
           </a:p>
@@ -402,7 +402,7 @@
           <a:p>
             <a:fld id="{1AE741EC-1360-4793-999B-941E0396C9FA}" type="datetimeFigureOut">
               <a:rPr lang="en-IN" smtClean="0"/>
-              <a:t>04-05-2024</a:t>
+              <a:t>11-05-2024</a:t>
             </a:fld>
             <a:endParaRPr lang="en-IN"/>
           </a:p>
@@ -802,7 +802,7 @@
           <a:p>
             <a:fld id="{86FBD32F-FCAD-481A-B7D8-4D813FB7DB24}" type="datetimeFigureOut">
               <a:rPr lang="en-IN" smtClean="0"/>
-              <a:t>04-05-2024</a:t>
+              <a:t>11-05-2024</a:t>
             </a:fld>
             <a:endParaRPr lang="en-IN"/>
           </a:p>
@@ -972,7 +972,7 @@
           <a:p>
             <a:fld id="{86FBD32F-FCAD-481A-B7D8-4D813FB7DB24}" type="datetimeFigureOut">
               <a:rPr lang="en-IN" smtClean="0"/>
-              <a:t>04-05-2024</a:t>
+              <a:t>11-05-2024</a:t>
             </a:fld>
             <a:endParaRPr lang="en-IN"/>
           </a:p>
@@ -1152,7 +1152,7 @@
           <a:p>
             <a:fld id="{86FBD32F-FCAD-481A-B7D8-4D813FB7DB24}" type="datetimeFigureOut">
               <a:rPr lang="en-IN" smtClean="0"/>
-              <a:t>04-05-2024</a:t>
+              <a:t>11-05-2024</a:t>
             </a:fld>
             <a:endParaRPr lang="en-IN"/>
           </a:p>
@@ -1322,7 +1322,7 @@
           <a:p>
             <a:fld id="{86FBD32F-FCAD-481A-B7D8-4D813FB7DB24}" type="datetimeFigureOut">
               <a:rPr lang="en-IN" smtClean="0"/>
-              <a:t>04-05-2024</a:t>
+              <a:t>11-05-2024</a:t>
             </a:fld>
             <a:endParaRPr lang="en-IN"/>
           </a:p>
@@ -1566,7 +1566,7 @@
           <a:p>
             <a:fld id="{86FBD32F-FCAD-481A-B7D8-4D813FB7DB24}" type="datetimeFigureOut">
               <a:rPr lang="en-IN" smtClean="0"/>
-              <a:t>04-05-2024</a:t>
+              <a:t>11-05-2024</a:t>
             </a:fld>
             <a:endParaRPr lang="en-IN"/>
           </a:p>
@@ -1798,7 +1798,7 @@
           <a:p>
             <a:fld id="{86FBD32F-FCAD-481A-B7D8-4D813FB7DB24}" type="datetimeFigureOut">
               <a:rPr lang="en-IN" smtClean="0"/>
-              <a:t>04-05-2024</a:t>
+              <a:t>11-05-2024</a:t>
             </a:fld>
             <a:endParaRPr lang="en-IN"/>
           </a:p>
@@ -2165,7 +2165,7 @@
           <a:p>
             <a:fld id="{86FBD32F-FCAD-481A-B7D8-4D813FB7DB24}" type="datetimeFigureOut">
               <a:rPr lang="en-IN" smtClean="0"/>
-              <a:t>04-05-2024</a:t>
+              <a:t>11-05-2024</a:t>
             </a:fld>
             <a:endParaRPr lang="en-IN"/>
           </a:p>
@@ -2283,7 +2283,7 @@
           <a:p>
             <a:fld id="{86FBD32F-FCAD-481A-B7D8-4D813FB7DB24}" type="datetimeFigureOut">
               <a:rPr lang="en-IN" smtClean="0"/>
-              <a:t>04-05-2024</a:t>
+              <a:t>11-05-2024</a:t>
             </a:fld>
             <a:endParaRPr lang="en-IN"/>
           </a:p>
@@ -2378,7 +2378,7 @@
           <a:p>
             <a:fld id="{86FBD32F-FCAD-481A-B7D8-4D813FB7DB24}" type="datetimeFigureOut">
               <a:rPr lang="en-IN" smtClean="0"/>
-              <a:t>04-05-2024</a:t>
+              <a:t>11-05-2024</a:t>
             </a:fld>
             <a:endParaRPr lang="en-IN"/>
           </a:p>
@@ -2655,7 +2655,7 @@
           <a:p>
             <a:fld id="{86FBD32F-FCAD-481A-B7D8-4D813FB7DB24}" type="datetimeFigureOut">
               <a:rPr lang="en-IN" smtClean="0"/>
-              <a:t>04-05-2024</a:t>
+              <a:t>11-05-2024</a:t>
             </a:fld>
             <a:endParaRPr lang="en-IN"/>
           </a:p>
@@ -2912,7 +2912,7 @@
           <a:p>
             <a:fld id="{86FBD32F-FCAD-481A-B7D8-4D813FB7DB24}" type="datetimeFigureOut">
               <a:rPr lang="en-IN" smtClean="0"/>
-              <a:t>04-05-2024</a:t>
+              <a:t>11-05-2024</a:t>
             </a:fld>
             <a:endParaRPr lang="en-IN"/>
           </a:p>
@@ -3125,7 +3125,7 @@
           <a:p>
             <a:fld id="{86FBD32F-FCAD-481A-B7D8-4D813FB7DB24}" type="datetimeFigureOut">
               <a:rPr lang="en-IN" smtClean="0"/>
-              <a:t>04-05-2024</a:t>
+              <a:t>11-05-2024</a:t>
             </a:fld>
             <a:endParaRPr lang="en-IN"/>
           </a:p>
@@ -3596,7 +3596,7 @@
               <a:defRPr/>
             </a:pPr>
             <a:r>
-              <a:rPr kumimoji="0" lang="te-IN" sz="1900" i="0" u="none" strike="noStrike" kern="1200" cap="none" spc="0" normalizeH="0" baseline="0" noProof="0" dirty="0">
+              <a:rPr kumimoji="0" lang="te-IN" sz="1350" i="0" u="none" strike="noStrike" kern="1200" cap="none" spc="0" normalizeH="0" baseline="0" noProof="0" dirty="0">
                 <a:solidFill>
                   <a:schemeClr val="tx1"/>
                 </a:solidFill>
@@ -3606,7 +3606,7 @@
                 <a:latin typeface="Ramabhadra" panose="02000600000000000000" pitchFamily="2" charset="0"/>
                 <a:cs typeface="Ramabhadra" panose="02000600000000000000" pitchFamily="2" charset="0"/>
               </a:rPr>
-              <a:t>స్తోత్రము స్తుతి స్తోత్రము  </a:t>
+              <a:t>కృపా క్షేమము నీ శాశ్వత జీవము</a:t>
             </a:r>
           </a:p>
           <a:p>
@@ -3625,7 +3625,7 @@
               <a:defRPr/>
             </a:pPr>
             <a:r>
-              <a:rPr kumimoji="0" lang="te-IN" sz="1900" i="0" u="none" strike="noStrike" kern="1200" cap="none" spc="0" normalizeH="0" baseline="0" noProof="0" dirty="0">
+              <a:rPr kumimoji="0" lang="te-IN" sz="1350" i="0" u="none" strike="noStrike" kern="1200" cap="none" spc="0" normalizeH="0" baseline="0" noProof="0" dirty="0">
                 <a:solidFill>
                   <a:schemeClr val="tx1"/>
                 </a:solidFill>
@@ -3635,7 +3635,7 @@
                 <a:latin typeface="Ramabhadra" panose="02000600000000000000" pitchFamily="2" charset="0"/>
                 <a:cs typeface="Ramabhadra" panose="02000600000000000000" pitchFamily="2" charset="0"/>
               </a:rPr>
-              <a:t>చెల్లించుడి యేసుకే (2)</a:t>
+              <a:t>నా జీవిత కాలమంతయు నీవు దయచేయువాడవు (2)</a:t>
             </a:r>
           </a:p>
           <a:p>
@@ -3654,7 +3654,7 @@
               <a:defRPr/>
             </a:pPr>
             <a:r>
-              <a:rPr kumimoji="0" lang="te-IN" sz="1900" i="0" u="none" strike="noStrike" kern="1200" cap="none" spc="0" normalizeH="0" baseline="0" noProof="0" dirty="0">
+              <a:rPr kumimoji="0" lang="te-IN" sz="1350" i="0" u="none" strike="noStrike" kern="1200" cap="none" spc="0" normalizeH="0" baseline="0" noProof="0" dirty="0">
                 <a:solidFill>
                   <a:schemeClr val="tx1"/>
                 </a:solidFill>
@@ -3664,7 +3664,7 @@
                 <a:latin typeface="Ramabhadra" panose="02000600000000000000" pitchFamily="2" charset="0"/>
                 <a:cs typeface="Ramabhadra" panose="02000600000000000000" pitchFamily="2" charset="0"/>
               </a:rPr>
-              <a:t>రాజాధిరాజు దేవాధిదేవుడు </a:t>
+              <a:t>మహోన్నతమైన నీ ఉపకారములు</a:t>
             </a:r>
           </a:p>
           <a:p>
@@ -3683,7 +3683,7 @@
               <a:defRPr/>
             </a:pPr>
             <a:r>
-              <a:rPr kumimoji="0" lang="te-IN" sz="1900" i="0" u="none" strike="noStrike" kern="1200" cap="none" spc="0" normalizeH="0" baseline="0" noProof="0" dirty="0">
+              <a:rPr kumimoji="0" lang="te-IN" sz="1350" i="0" u="none" strike="noStrike" kern="1200" cap="none" spc="0" normalizeH="0" baseline="0" noProof="0" dirty="0">
                 <a:solidFill>
                   <a:schemeClr val="tx1"/>
                 </a:solidFill>
@@ -3693,7 +3693,7 @@
                 <a:latin typeface="Ramabhadra" panose="02000600000000000000" pitchFamily="2" charset="0"/>
                 <a:cs typeface="Ramabhadra" panose="02000600000000000000" pitchFamily="2" charset="0"/>
               </a:rPr>
-              <a:t> స్తుతులకు పాత్రుడు</a:t>
+              <a:t>తలంచుచు అనుక్షణము పరవశించనా</a:t>
             </a:r>
           </a:p>
           <a:p>
@@ -3711,16 +3711,19 @@
               <a:tabLst/>
               <a:defRPr/>
             </a:pPr>
-            <a:endParaRPr kumimoji="0" lang="te-IN" sz="1900" i="0" u="none" strike="noStrike" kern="1200" cap="none" spc="0" normalizeH="0" baseline="0" noProof="0" dirty="0">
-              <a:solidFill>
-                <a:schemeClr val="tx1"/>
-              </a:solidFill>
-              <a:effectLst/>
-              <a:uLnTx/>
-              <a:uFillTx/>
-              <a:latin typeface="Ramabhadra" panose="02000600000000000000" pitchFamily="2" charset="0"/>
-              <a:cs typeface="Ramabhadra" panose="02000600000000000000" pitchFamily="2" charset="0"/>
-            </a:endParaRPr>
+            <a:r>
+              <a:rPr kumimoji="0" lang="te-IN" sz="1350" i="0" u="none" strike="noStrike" kern="1200" cap="none" spc="0" normalizeH="0" baseline="0" noProof="0" dirty="0">
+                <a:solidFill>
+                  <a:schemeClr val="tx1"/>
+                </a:solidFill>
+                <a:effectLst/>
+                <a:uLnTx/>
+                <a:uFillTx/>
+                <a:latin typeface="Ramabhadra" panose="02000600000000000000" pitchFamily="2" charset="0"/>
+                <a:cs typeface="Ramabhadra" panose="02000600000000000000" pitchFamily="2" charset="0"/>
+              </a:rPr>
+              <a:t>నీ కృపలోనే పరవశించనా</a:t>
+            </a:r>
           </a:p>
           <a:p>
             <a:pPr marL="0" marR="0" lvl="0" indent="0" algn="ctr" defTabSz="439781" rtl="0" eaLnBrk="1" fontAlgn="auto" latinLnBrk="0" hangingPunct="1">
@@ -3737,19 +3740,16 @@
               <a:tabLst/>
               <a:defRPr/>
             </a:pPr>
-            <a:r>
-              <a:rPr kumimoji="0" lang="te-IN" sz="1900" i="0" u="none" strike="noStrike" kern="1200" cap="none" spc="0" normalizeH="0" baseline="0" noProof="0" dirty="0">
-                <a:solidFill>
-                  <a:schemeClr val="tx1"/>
-                </a:solidFill>
-                <a:effectLst/>
-                <a:uLnTx/>
-                <a:uFillTx/>
-                <a:latin typeface="Ramabhadra" panose="02000600000000000000" pitchFamily="2" charset="0"/>
-                <a:cs typeface="Ramabhadra" panose="02000600000000000000" pitchFamily="2" charset="0"/>
-              </a:rPr>
-              <a:t> మనుష్య కుమారుడై మనుజుల పాపముకై</a:t>
-            </a:r>
+            <a:endParaRPr kumimoji="0" lang="te-IN" sz="1350" i="0" u="none" strike="noStrike" kern="1200" cap="none" spc="0" normalizeH="0" baseline="0" noProof="0" dirty="0">
+              <a:solidFill>
+                <a:schemeClr val="tx1"/>
+              </a:solidFill>
+              <a:effectLst/>
+              <a:uLnTx/>
+              <a:uFillTx/>
+              <a:latin typeface="Ramabhadra" panose="02000600000000000000" pitchFamily="2" charset="0"/>
+              <a:cs typeface="Ramabhadra" panose="02000600000000000000" pitchFamily="2" charset="0"/>
+            </a:endParaRPr>
           </a:p>
           <a:p>
             <a:pPr marL="0" marR="0" lvl="0" indent="0" algn="ctr" defTabSz="439781" rtl="0" eaLnBrk="1" fontAlgn="auto" latinLnBrk="0" hangingPunct="1">
@@ -3767,7 +3767,7 @@
               <a:defRPr/>
             </a:pPr>
             <a:r>
-              <a:rPr kumimoji="0" lang="te-IN" sz="1900" i="0" u="none" strike="noStrike" kern="1200" cap="none" spc="0" normalizeH="0" baseline="0" noProof="0" dirty="0">
+              <a:rPr kumimoji="0" lang="te-IN" sz="1350" i="0" u="none" strike="noStrike" kern="1200" cap="none" spc="0" normalizeH="0" baseline="0" noProof="0" dirty="0">
                 <a:solidFill>
                   <a:schemeClr val="tx1"/>
                 </a:solidFill>
@@ -3777,7 +3777,7 @@
                 <a:latin typeface="Ramabhadra" panose="02000600000000000000" pitchFamily="2" charset="0"/>
                 <a:cs typeface="Ramabhadra" panose="02000600000000000000" pitchFamily="2" charset="0"/>
               </a:rPr>
-              <a:t>మహిలోన వెలసెను</a:t>
+              <a:t>నా ప్రతి ప్రార్ధనకు నీవిచ్చిన ఈవులే</a:t>
             </a:r>
           </a:p>
           <a:p>
@@ -3796,7 +3796,7 @@
               <a:defRPr/>
             </a:pPr>
             <a:r>
-              <a:rPr kumimoji="0" lang="te-IN" sz="1900" i="0" u="none" strike="noStrike" kern="1200" cap="none" spc="0" normalizeH="0" baseline="0" noProof="0" dirty="0">
+              <a:rPr kumimoji="0" lang="te-IN" sz="1350" i="0" u="none" strike="noStrike" kern="1200" cap="none" spc="0" normalizeH="0" baseline="0" noProof="0" dirty="0">
                 <a:solidFill>
                   <a:schemeClr val="tx1"/>
                 </a:solidFill>
@@ -3806,7 +3806,7 @@
                 <a:latin typeface="Ramabhadra" panose="02000600000000000000" pitchFamily="2" charset="0"/>
                 <a:cs typeface="Ramabhadra" panose="02000600000000000000" pitchFamily="2" charset="0"/>
               </a:rPr>
-              <a:t>మరణించి లెచేను (2)</a:t>
+              <a:t>లెక్కకు మించిన దీవెనలైనాయి (2)</a:t>
             </a:r>
           </a:p>
           <a:p>
@@ -3825,7 +3825,7 @@
               <a:defRPr/>
             </a:pPr>
             <a:r>
-              <a:rPr kumimoji="0" lang="te-IN" sz="1900" i="0" u="none" strike="noStrike" kern="1200" cap="none" spc="0" normalizeH="0" baseline="0" noProof="0" dirty="0">
+              <a:rPr kumimoji="0" lang="te-IN" sz="1350" i="0" u="none" strike="noStrike" kern="1200" cap="none" spc="0" normalizeH="0" baseline="0" noProof="0" dirty="0">
                 <a:solidFill>
                   <a:schemeClr val="tx1"/>
                 </a:solidFill>
@@ -3835,7 +3835,7 @@
                 <a:latin typeface="Ramabhadra" panose="02000600000000000000" pitchFamily="2" charset="0"/>
                 <a:cs typeface="Ramabhadra" panose="02000600000000000000" pitchFamily="2" charset="0"/>
               </a:rPr>
-              <a:t>మహిమ స్వరూపుడు </a:t>
+              <a:t>అడుగులు తడబడక నడిపినది నీ దివ్య వాక్యమే</a:t>
             </a:r>
           </a:p>
           <a:p>
@@ -3854,7 +3854,7 @@
               <a:defRPr/>
             </a:pPr>
             <a:r>
-              <a:rPr kumimoji="0" lang="te-IN" sz="1900" i="0" u="none" strike="noStrike" kern="1200" cap="none" spc="0" normalizeH="0" baseline="0" noProof="0" dirty="0">
+              <a:rPr kumimoji="0" lang="te-IN" sz="1350" i="0" u="none" strike="noStrike" kern="1200" cap="none" spc="0" normalizeH="0" baseline="0" noProof="0" dirty="0">
                 <a:solidFill>
                   <a:schemeClr val="tx1"/>
                 </a:solidFill>
@@ -3864,7 +3864,7 @@
                 <a:latin typeface="Ramabhadra" panose="02000600000000000000" pitchFamily="2" charset="0"/>
                 <a:cs typeface="Ramabhadra" panose="02000600000000000000" pitchFamily="2" charset="0"/>
               </a:rPr>
-              <a:t>మహిమ స్వరూపుడు</a:t>
+              <a:t>కడలిని మించిన విశ్వాసమునిచ్చి విజయము చేకూర్చెను (2)</a:t>
             </a:r>
           </a:p>
           <a:p>
@@ -3882,16 +3882,19 @@
               <a:tabLst/>
               <a:defRPr/>
             </a:pPr>
-            <a:endParaRPr kumimoji="0" lang="te-IN" sz="1900" i="0" u="none" strike="noStrike" kern="1200" cap="none" spc="0" normalizeH="0" baseline="0" noProof="0" dirty="0">
-              <a:solidFill>
-                <a:schemeClr val="tx1"/>
-              </a:solidFill>
-              <a:effectLst/>
-              <a:uLnTx/>
-              <a:uFillTx/>
-              <a:latin typeface="Ramabhadra" panose="02000600000000000000" pitchFamily="2" charset="0"/>
-              <a:cs typeface="Ramabhadra" panose="02000600000000000000" pitchFamily="2" charset="0"/>
-            </a:endParaRPr>
+            <a:r>
+              <a:rPr kumimoji="0" lang="te-IN" sz="1350" i="0" u="none" strike="noStrike" kern="1200" cap="none" spc="0" normalizeH="0" baseline="0" noProof="0" dirty="0">
+                <a:solidFill>
+                  <a:schemeClr val="tx1"/>
+                </a:solidFill>
+                <a:effectLst/>
+                <a:uLnTx/>
+                <a:uFillTx/>
+                <a:latin typeface="Ramabhadra" panose="02000600000000000000" pitchFamily="2" charset="0"/>
+                <a:cs typeface="Ramabhadra" panose="02000600000000000000" pitchFamily="2" charset="0"/>
+              </a:rPr>
+              <a:t>నీ వాక్యమే మకరంధమై బలపరిచెను నన్ను</a:t>
+            </a:r>
           </a:p>
           <a:p>
             <a:pPr marL="0" marR="0" lvl="0" indent="0" algn="ctr" defTabSz="439781" rtl="0" eaLnBrk="1" fontAlgn="auto" latinLnBrk="0" hangingPunct="1">
@@ -3909,7 +3912,7 @@
               <a:defRPr/>
             </a:pPr>
             <a:r>
-              <a:rPr kumimoji="0" lang="te-IN" sz="1900" i="0" u="none" strike="noStrike" kern="1200" cap="none" spc="0" normalizeH="0" baseline="0" noProof="0" dirty="0">
+              <a:rPr kumimoji="0" lang="te-IN" sz="1350" i="0" u="none" strike="noStrike" kern="1200" cap="none" spc="0" normalizeH="0" baseline="0" noProof="0" dirty="0">
                 <a:solidFill>
                   <a:schemeClr val="tx1"/>
                 </a:solidFill>
@@ -3919,7 +3922,7 @@
                 <a:latin typeface="Ramabhadra" panose="02000600000000000000" pitchFamily="2" charset="0"/>
                 <a:cs typeface="Ramabhadra" panose="02000600000000000000" pitchFamily="2" charset="0"/>
               </a:rPr>
-              <a:t>పాపపు వస్త్రము మార్చి నీతిమంతులుగ తీర్చి</a:t>
+              <a:t>నా యేసయ్య స్తుతిపాత్రుడ ఆరాధన నీకే (2)</a:t>
             </a:r>
           </a:p>
           <a:p>
@@ -3938,7 +3941,7 @@
               <a:defRPr/>
             </a:pPr>
             <a:r>
-              <a:rPr kumimoji="0" lang="te-IN" sz="1900" i="0" u="none" strike="noStrike" kern="1200" cap="none" spc="0" normalizeH="0" baseline="0" noProof="0" dirty="0">
+              <a:rPr kumimoji="0" lang="te-IN" sz="1350" i="0" u="none" strike="noStrike" kern="1200" cap="none" spc="0" normalizeH="0" baseline="0" noProof="0" dirty="0">
                 <a:solidFill>
                   <a:schemeClr val="tx1"/>
                 </a:solidFill>
@@ -3948,7 +3951,7 @@
                 <a:latin typeface="Ramabhadra" panose="02000600000000000000" pitchFamily="2" charset="0"/>
                 <a:cs typeface="Ramabhadra" panose="02000600000000000000" pitchFamily="2" charset="0"/>
               </a:rPr>
-              <a:t>పరిశుద్దులతో చేర్చి  </a:t>
+              <a:t>ఆరాధన నీకే</a:t>
             </a:r>
           </a:p>
           <a:p>
@@ -3966,19 +3969,16 @@
               <a:tabLst/>
               <a:defRPr/>
             </a:pPr>
-            <a:r>
-              <a:rPr kumimoji="0" lang="te-IN" sz="1900" i="0" u="none" strike="noStrike" kern="1200" cap="none" spc="0" normalizeH="0" baseline="0" noProof="0" dirty="0">
-                <a:solidFill>
-                  <a:schemeClr val="tx1"/>
-                </a:solidFill>
-                <a:effectLst/>
-                <a:uLnTx/>
-                <a:uFillTx/>
-                <a:latin typeface="Ramabhadra" panose="02000600000000000000" pitchFamily="2" charset="0"/>
-                <a:cs typeface="Ramabhadra" panose="02000600000000000000" pitchFamily="2" charset="0"/>
-              </a:rPr>
-              <a:t>   పరమ సౌభాగ్యము నిచ్చి (2)</a:t>
-            </a:r>
+            <a:endParaRPr kumimoji="0" lang="te-IN" sz="1350" i="0" u="none" strike="noStrike" kern="1200" cap="none" spc="0" normalizeH="0" baseline="0" noProof="0" dirty="0">
+              <a:solidFill>
+                <a:schemeClr val="tx1"/>
+              </a:solidFill>
+              <a:effectLst/>
+              <a:uLnTx/>
+              <a:uFillTx/>
+              <a:latin typeface="Ramabhadra" panose="02000600000000000000" pitchFamily="2" charset="0"/>
+              <a:cs typeface="Ramabhadra" panose="02000600000000000000" pitchFamily="2" charset="0"/>
+            </a:endParaRPr>
           </a:p>
           <a:p>
             <a:pPr marL="0" marR="0" lvl="0" indent="0" algn="ctr" defTabSz="439781" rtl="0" eaLnBrk="1" fontAlgn="auto" latinLnBrk="0" hangingPunct="1">
@@ -3996,7 +3996,7 @@
               <a:defRPr/>
             </a:pPr>
             <a:r>
-              <a:rPr kumimoji="0" lang="te-IN" sz="1900" i="0" u="none" strike="noStrike" kern="1200" cap="none" spc="0" normalizeH="0" baseline="0" noProof="0" dirty="0">
+              <a:rPr kumimoji="0" lang="te-IN" sz="1350" i="0" u="none" strike="noStrike" kern="1200" cap="none" spc="0" normalizeH="0" baseline="0" noProof="0" dirty="0">
                 <a:solidFill>
                   <a:schemeClr val="tx1"/>
                 </a:solidFill>
@@ -4006,7 +4006,7 @@
                 <a:latin typeface="Ramabhadra" panose="02000600000000000000" pitchFamily="2" charset="0"/>
                 <a:cs typeface="Ramabhadra" panose="02000600000000000000" pitchFamily="2" charset="0"/>
               </a:rPr>
-              <a:t>మహిమ స్వరూపుడు </a:t>
+              <a:t>నీ సత్య మార్గములో ఫలించిన అనుభవమే</a:t>
             </a:r>
           </a:p>
           <a:p>
@@ -4025,7 +4025,7 @@
               <a:defRPr/>
             </a:pPr>
             <a:r>
-              <a:rPr kumimoji="0" lang="te-IN" sz="1900" i="0" u="none" strike="noStrike" kern="1200" cap="none" spc="0" normalizeH="0" baseline="0" noProof="0" dirty="0">
+              <a:rPr kumimoji="0" lang="te-IN" sz="1350" i="0" u="none" strike="noStrike" kern="1200" cap="none" spc="0" normalizeH="0" baseline="0" noProof="0" dirty="0">
                 <a:solidFill>
                   <a:schemeClr val="tx1"/>
                 </a:solidFill>
@@ -4035,7 +4035,152 @@
                 <a:latin typeface="Ramabhadra" panose="02000600000000000000" pitchFamily="2" charset="0"/>
                 <a:cs typeface="Ramabhadra" panose="02000600000000000000" pitchFamily="2" charset="0"/>
               </a:rPr>
-              <a:t>మహిమ స్వరూపుడు</a:t>
+              <a:t>పరిమళింపచేసి సాక్షిగ నిలిపాయి (2)</a:t>
+            </a:r>
+          </a:p>
+          <a:p>
+            <a:pPr marL="0" marR="0" lvl="0" indent="0" algn="ctr" defTabSz="439781" rtl="0" eaLnBrk="1" fontAlgn="auto" latinLnBrk="0" hangingPunct="1">
+              <a:spcBef>
+                <a:spcPts val="0"/>
+              </a:spcBef>
+              <a:spcAft>
+                <a:spcPts val="0"/>
+              </a:spcAft>
+              <a:buClrTx/>
+              <a:buSzTx/>
+              <a:buFontTx/>
+              <a:buNone/>
+              <a:tabLst/>
+              <a:defRPr/>
+            </a:pPr>
+            <a:r>
+              <a:rPr kumimoji="0" lang="te-IN" sz="1350" i="0" u="none" strike="noStrike" kern="1200" cap="none" spc="0" normalizeH="0" baseline="0" noProof="0" dirty="0">
+                <a:solidFill>
+                  <a:schemeClr val="tx1"/>
+                </a:solidFill>
+                <a:effectLst/>
+                <a:uLnTx/>
+                <a:uFillTx/>
+                <a:latin typeface="Ramabhadra" panose="02000600000000000000" pitchFamily="2" charset="0"/>
+                <a:cs typeface="Ramabhadra" panose="02000600000000000000" pitchFamily="2" charset="0"/>
+              </a:rPr>
+              <a:t>కలతచెందక నిలిపినది నీ దివ్య దర్శనమే</a:t>
+            </a:r>
+          </a:p>
+          <a:p>
+            <a:pPr marL="0" marR="0" lvl="0" indent="0" algn="ctr" defTabSz="439781" rtl="0" eaLnBrk="1" fontAlgn="auto" latinLnBrk="0" hangingPunct="1">
+              <a:spcBef>
+                <a:spcPts val="0"/>
+              </a:spcBef>
+              <a:spcAft>
+                <a:spcPts val="0"/>
+              </a:spcAft>
+              <a:buClrTx/>
+              <a:buSzTx/>
+              <a:buFontTx/>
+              <a:buNone/>
+              <a:tabLst/>
+              <a:defRPr/>
+            </a:pPr>
+            <a:r>
+              <a:rPr kumimoji="0" lang="te-IN" sz="1350" i="0" u="none" strike="noStrike" kern="1200" cap="none" spc="0" normalizeH="0" baseline="0" noProof="0" dirty="0">
+                <a:solidFill>
+                  <a:schemeClr val="tx1"/>
+                </a:solidFill>
+                <a:effectLst/>
+                <a:uLnTx/>
+                <a:uFillTx/>
+                <a:latin typeface="Ramabhadra" panose="02000600000000000000" pitchFamily="2" charset="0"/>
+                <a:cs typeface="Ramabhadra" panose="02000600000000000000" pitchFamily="2" charset="0"/>
+              </a:rPr>
+              <a:t>గమ్యము చేరే శక్తితో నను నింపి నూతన కృపనిచ్చెను (2)</a:t>
+            </a:r>
+          </a:p>
+          <a:p>
+            <a:pPr marL="0" marR="0" lvl="0" indent="0" algn="ctr" defTabSz="439781" rtl="0" eaLnBrk="1" fontAlgn="auto" latinLnBrk="0" hangingPunct="1">
+              <a:spcBef>
+                <a:spcPts val="0"/>
+              </a:spcBef>
+              <a:spcAft>
+                <a:spcPts val="0"/>
+              </a:spcAft>
+              <a:buClrTx/>
+              <a:buSzTx/>
+              <a:buFontTx/>
+              <a:buNone/>
+              <a:tabLst/>
+              <a:defRPr/>
+            </a:pPr>
+            <a:r>
+              <a:rPr kumimoji="0" lang="te-IN" sz="1350" i="0" u="none" strike="noStrike" kern="1200" cap="none" spc="0" normalizeH="0" baseline="0" noProof="0" dirty="0">
+                <a:solidFill>
+                  <a:schemeClr val="tx1"/>
+                </a:solidFill>
+                <a:effectLst/>
+                <a:uLnTx/>
+                <a:uFillTx/>
+                <a:latin typeface="Ramabhadra" panose="02000600000000000000" pitchFamily="2" charset="0"/>
+                <a:cs typeface="Ramabhadra" panose="02000600000000000000" pitchFamily="2" charset="0"/>
+              </a:rPr>
+              <a:t>ఆరాధ్యుడా అభిషిక్తుడా ఆరాధన నీకే</a:t>
+            </a:r>
+          </a:p>
+          <a:p>
+            <a:pPr marL="0" marR="0" lvl="0" indent="0" algn="ctr" defTabSz="439781" rtl="0" eaLnBrk="1" fontAlgn="auto" latinLnBrk="0" hangingPunct="1">
+              <a:spcBef>
+                <a:spcPts val="0"/>
+              </a:spcBef>
+              <a:spcAft>
+                <a:spcPts val="0"/>
+              </a:spcAft>
+              <a:buClrTx/>
+              <a:buSzTx/>
+              <a:buFontTx/>
+              <a:buNone/>
+              <a:tabLst/>
+              <a:defRPr/>
+            </a:pPr>
+            <a:r>
+              <a:rPr kumimoji="0" lang="te-IN" sz="1350" i="0" u="none" strike="noStrike" kern="1200" cap="none" spc="0" normalizeH="0" baseline="0" noProof="0" dirty="0">
+                <a:solidFill>
+                  <a:schemeClr val="tx1"/>
+                </a:solidFill>
+                <a:effectLst/>
+                <a:uLnTx/>
+                <a:uFillTx/>
+                <a:latin typeface="Ramabhadra" panose="02000600000000000000" pitchFamily="2" charset="0"/>
+                <a:cs typeface="Ramabhadra" panose="02000600000000000000" pitchFamily="2" charset="0"/>
+              </a:rPr>
+              <a:t>నా యేసయ్య స్తుతిపాత్రుడ ఆరాధన నీకే (2)</a:t>
+            </a:r>
+          </a:p>
+          <a:p>
+            <a:pPr marL="0" marR="0" lvl="0" indent="0" algn="ctr" defTabSz="439781" rtl="0" eaLnBrk="1" fontAlgn="auto" latinLnBrk="0" hangingPunct="1">
+              <a:spcBef>
+                <a:spcPts val="0"/>
+              </a:spcBef>
+              <a:spcAft>
+                <a:spcPts val="0"/>
+              </a:spcAft>
+              <a:buClrTx/>
+              <a:buSzTx/>
+              <a:buFontTx/>
+              <a:buNone/>
+              <a:tabLst/>
+              <a:defRPr/>
+            </a:pPr>
+            <a:r>
+              <a:rPr kumimoji="0" lang="te-IN" sz="1350" i="0" u="none" strike="noStrike" kern="1200" cap="none" spc="0" normalizeH="0" baseline="0" noProof="0" dirty="0">
+                <a:solidFill>
+                  <a:schemeClr val="tx1"/>
+                </a:solidFill>
+                <a:effectLst/>
+                <a:uLnTx/>
+                <a:uFillTx/>
+                <a:latin typeface="Ramabhadra" panose="02000600000000000000" pitchFamily="2" charset="0"/>
+                <a:cs typeface="Ramabhadra" panose="02000600000000000000" pitchFamily="2" charset="0"/>
+              </a:rPr>
+              <a:t>ఆరాధన నీకే</a:t>
             </a:r>
           </a:p>
         </p:txBody>
@@ -4091,16 +4236,9 @@
           <a:bodyPr rtlCol="0" anchor="ctr"/>
           <a:lstStyle/>
           <a:p>
-            <a:pPr marL="0" marR="0" indent="0" algn="ctr" rtl="0" eaLnBrk="1" fontAlgn="auto" latinLnBrk="0" hangingPunct="1">
-              <a:spcBef>
-                <a:spcPts val="0"/>
-              </a:spcBef>
-              <a:spcAft>
-                <a:spcPts val="0"/>
-              </a:spcAft>
-            </a:pPr>
-            <a:r>
-              <a:rPr lang="te-IN" sz="1900" b="0" i="0" dirty="0">
+            <a:pPr lvl="1" algn="ctr"/>
+            <a:r>
+              <a:rPr lang="te-IN" sz="2000" b="0" i="0" dirty="0">
                 <a:solidFill>
                   <a:schemeClr val="tx1"/>
                 </a:solidFill>
@@ -4108,61 +4246,9 @@
                 <a:latin typeface="Ramabhadra" panose="02000600000000000000" pitchFamily="2" charset="0"/>
                 <a:cs typeface="Ramabhadra" panose="02000600000000000000" pitchFamily="2" charset="0"/>
               </a:rPr>
-              <a:t>హల్లెలూయ పాట యేసయ్య పాట</a:t>
-            </a:r>
-          </a:p>
-          <a:p>
-            <a:pPr marL="0" marR="0" indent="0" algn="ctr" rtl="0" eaLnBrk="1" fontAlgn="auto" latinLnBrk="0" hangingPunct="1">
-              <a:spcBef>
-                <a:spcPts val="0"/>
-              </a:spcBef>
-              <a:spcAft>
-                <a:spcPts val="0"/>
-              </a:spcAft>
-            </a:pPr>
-            <a:r>
-              <a:rPr lang="te-IN" sz="1900" b="0" i="0" dirty="0">
-                <a:solidFill>
-                  <a:schemeClr val="tx1"/>
-                </a:solidFill>
-                <a:effectLst/>
-                <a:latin typeface="Ramabhadra" panose="02000600000000000000" pitchFamily="2" charset="0"/>
-                <a:cs typeface="Ramabhadra" panose="02000600000000000000" pitchFamily="2" charset="0"/>
-              </a:rPr>
-              <a:t>పాడాలి ప్రతి చోట పాడాలి ప్రతి నోట</a:t>
-            </a:r>
-          </a:p>
-          <a:p>
-            <a:pPr marL="0" marR="0" indent="0" algn="ctr" rtl="0" eaLnBrk="1" fontAlgn="auto" latinLnBrk="0" hangingPunct="1">
-              <a:spcBef>
-                <a:spcPts val="0"/>
-              </a:spcBef>
-              <a:spcAft>
-                <a:spcPts val="0"/>
-              </a:spcAft>
-            </a:pPr>
-            <a:r>
-              <a:rPr lang="te-IN" sz="1900" b="0" i="0" dirty="0">
-                <a:solidFill>
-                  <a:schemeClr val="tx1"/>
-                </a:solidFill>
-                <a:effectLst/>
-                <a:latin typeface="Ramabhadra" panose="02000600000000000000" pitchFamily="2" charset="0"/>
-                <a:cs typeface="Ramabhadra" panose="02000600000000000000" pitchFamily="2" charset="0"/>
-              </a:rPr>
-              <a:t>హల్లెలూయా హల్లెలూయా హల్లెలూయా (4)</a:t>
-            </a:r>
-          </a:p>
-          <a:p>
-            <a:pPr marL="0" marR="0" indent="0" algn="ctr" rtl="0" eaLnBrk="1" fontAlgn="auto" latinLnBrk="0" hangingPunct="1">
-              <a:spcBef>
-                <a:spcPts val="0"/>
-              </a:spcBef>
-              <a:spcAft>
-                <a:spcPts val="0"/>
-              </a:spcAft>
-            </a:pPr>
-            <a:endParaRPr lang="te-IN" sz="1900" b="0" i="0" dirty="0">
+              <a:t>యేసే నా పరిహారి</a:t>
+            </a:r>
+            <a:endParaRPr lang="en-IN" sz="2000" b="0" i="0" dirty="0">
               <a:solidFill>
                 <a:schemeClr val="tx1"/>
               </a:solidFill>
@@ -4172,16 +4258,9 @@
             </a:endParaRPr>
           </a:p>
           <a:p>
-            <a:pPr marL="0" marR="0" indent="0" algn="ctr" rtl="0" eaLnBrk="1" fontAlgn="auto" latinLnBrk="0" hangingPunct="1">
-              <a:spcBef>
-                <a:spcPts val="0"/>
-              </a:spcBef>
-              <a:spcAft>
-                <a:spcPts val="0"/>
-              </a:spcAft>
-            </a:pPr>
-            <a:r>
-              <a:rPr lang="te-IN" sz="1900" b="0" i="0" dirty="0">
+            <a:pPr lvl="1" algn="ctr"/>
+            <a:r>
+              <a:rPr lang="te-IN" sz="2000" b="0" i="0" dirty="0">
                 <a:solidFill>
                   <a:schemeClr val="tx1"/>
                 </a:solidFill>
@@ -4189,20 +4268,10 @@
                 <a:latin typeface="Ramabhadra" panose="02000600000000000000" pitchFamily="2" charset="0"/>
                 <a:cs typeface="Ramabhadra" panose="02000600000000000000" pitchFamily="2" charset="0"/>
               </a:rPr>
-              <a:t>స్తుతిపాటలే పాడుమా –</a:t>
-            </a:r>
-          </a:p>
-          <a:p>
-            <a:pPr marL="0" marR="0" indent="0" algn="ctr" rtl="0" eaLnBrk="1" fontAlgn="auto" latinLnBrk="0" hangingPunct="1">
-              <a:spcBef>
-                <a:spcPts val="0"/>
-              </a:spcBef>
-              <a:spcAft>
-                <a:spcPts val="0"/>
-              </a:spcAft>
-            </a:pPr>
-            <a:r>
-              <a:rPr lang="te-IN" sz="1900" b="0" i="0" dirty="0">
+              <a:t>ప్రియ యేసే నా పరిహారి</a:t>
+            </a:r>
+            <a:br>
+              <a:rPr lang="te-IN" sz="2000" b="0" i="0" dirty="0">
                 <a:solidFill>
                   <a:schemeClr val="tx1"/>
                 </a:solidFill>
@@ -4210,19 +4279,19 @@
                 <a:latin typeface="Ramabhadra" panose="02000600000000000000" pitchFamily="2" charset="0"/>
                 <a:cs typeface="Ramabhadra" panose="02000600000000000000" pitchFamily="2" charset="0"/>
               </a:rPr>
-              <a:t>ప్రభు యేసునే వేడుమా (2)</a:t>
-            </a:r>
-          </a:p>
-          <a:p>
-            <a:pPr marL="0" marR="0" indent="0" algn="ctr" rtl="0" eaLnBrk="1" fontAlgn="auto" latinLnBrk="0" hangingPunct="1">
-              <a:spcBef>
-                <a:spcPts val="0"/>
-              </a:spcBef>
-              <a:spcAft>
-                <a:spcPts val="0"/>
-              </a:spcAft>
-            </a:pPr>
-            <a:endParaRPr lang="te-IN" sz="1900" b="0" i="0" dirty="0">
+            </a:br>
+            <a:r>
+              <a:rPr lang="te-IN" sz="2000" b="0" i="0" dirty="0">
+                <a:solidFill>
+                  <a:schemeClr val="tx1"/>
+                </a:solidFill>
+                <a:effectLst/>
+                <a:latin typeface="Ramabhadra" panose="02000600000000000000" pitchFamily="2" charset="0"/>
+                <a:cs typeface="Ramabhadra" panose="02000600000000000000" pitchFamily="2" charset="0"/>
+              </a:rPr>
+              <a:t>   నా జీవిత కాలమెల్ల</a:t>
+            </a:r>
+            <a:endParaRPr lang="en-IN" sz="2000" b="0" i="0" dirty="0">
               <a:solidFill>
                 <a:schemeClr val="tx1"/>
               </a:solidFill>
@@ -4232,16 +4301,9 @@
             </a:endParaRPr>
           </a:p>
           <a:p>
-            <a:pPr marL="0" marR="0" indent="0" algn="ctr" rtl="0" eaLnBrk="1" fontAlgn="auto" latinLnBrk="0" hangingPunct="1">
-              <a:spcBef>
-                <a:spcPts val="0"/>
-              </a:spcBef>
-              <a:spcAft>
-                <a:spcPts val="0"/>
-              </a:spcAft>
-            </a:pPr>
-            <a:r>
-              <a:rPr lang="te-IN" sz="1900" b="0" i="0" dirty="0">
+            <a:pPr lvl="1" algn="ctr"/>
+            <a:r>
+              <a:rPr lang="te-IN" sz="2000" b="0" i="0" dirty="0">
                 <a:solidFill>
                   <a:schemeClr val="tx1"/>
                 </a:solidFill>
@@ -4249,40 +4311,12 @@
                 <a:latin typeface="Ramabhadra" panose="02000600000000000000" pitchFamily="2" charset="0"/>
                 <a:cs typeface="Ramabhadra" panose="02000600000000000000" pitchFamily="2" charset="0"/>
               </a:rPr>
-              <a:t>కష్టములే కలిగిన –</a:t>
-            </a:r>
-          </a:p>
-          <a:p>
-            <a:pPr marL="0" marR="0" indent="0" algn="ctr" rtl="0" eaLnBrk="1" fontAlgn="auto" latinLnBrk="0" hangingPunct="1">
-              <a:spcBef>
-                <a:spcPts val="0"/>
-              </a:spcBef>
-              <a:spcAft>
-                <a:spcPts val="0"/>
-              </a:spcAft>
-            </a:pPr>
-            <a:r>
-              <a:rPr lang="te-IN" sz="1900" b="0" i="0" dirty="0">
-                <a:solidFill>
-                  <a:schemeClr val="tx1"/>
-                </a:solidFill>
-                <a:effectLst/>
-                <a:latin typeface="Ramabhadra" panose="02000600000000000000" pitchFamily="2" charset="0"/>
-                <a:cs typeface="Ramabhadra" panose="02000600000000000000" pitchFamily="2" charset="0"/>
-              </a:rPr>
-              <a:t>కన్నీరులే మిగిలినా “స్తుతి”</a:t>
-            </a:r>
-          </a:p>
-          <a:p>
-            <a:pPr marL="0" marR="0" indent="0" algn="ctr" rtl="0" eaLnBrk="1" fontAlgn="auto" latinLnBrk="0" hangingPunct="1">
-              <a:spcBef>
-                <a:spcPts val="0"/>
-              </a:spcBef>
-              <a:spcAft>
-                <a:spcPts val="0"/>
-              </a:spcAft>
-            </a:pPr>
-            <a:endParaRPr lang="te-IN" sz="1900" b="0" i="0" dirty="0">
+              <a:t>ప్రియ ప్రభువే నా పరిహారి (2)</a:t>
+            </a:r>
+          </a:p>
+          <a:p>
+            <a:pPr lvl="1" algn="ctr"/>
+            <a:endParaRPr lang="te-IN" sz="2000" b="0" i="0" dirty="0">
               <a:solidFill>
                 <a:schemeClr val="tx1"/>
               </a:solidFill>
@@ -4292,16 +4326,9 @@
             </a:endParaRPr>
           </a:p>
           <a:p>
-            <a:pPr marL="0" marR="0" indent="0" algn="ctr" rtl="0" eaLnBrk="1" fontAlgn="auto" latinLnBrk="0" hangingPunct="1">
-              <a:spcBef>
-                <a:spcPts val="0"/>
-              </a:spcBef>
-              <a:spcAft>
-                <a:spcPts val="0"/>
-              </a:spcAft>
-            </a:pPr>
-            <a:r>
-              <a:rPr lang="te-IN" sz="1900" b="0" i="0" dirty="0">
+            <a:pPr lvl="1" algn="ctr"/>
+            <a:r>
+              <a:rPr lang="te-IN" sz="2000" b="0" i="0" dirty="0">
                 <a:solidFill>
                   <a:schemeClr val="tx1"/>
                 </a:solidFill>
@@ -4309,40 +4336,9 @@
                 <a:latin typeface="Ramabhadra" panose="02000600000000000000" pitchFamily="2" charset="0"/>
                 <a:cs typeface="Ramabhadra" panose="02000600000000000000" pitchFamily="2" charset="0"/>
               </a:rPr>
-              <a:t>బంధాలు బిగియించినా –</a:t>
-            </a:r>
-          </a:p>
-          <a:p>
-            <a:pPr marL="0" marR="0" indent="0" algn="ctr" rtl="0" eaLnBrk="1" fontAlgn="auto" latinLnBrk="0" hangingPunct="1">
-              <a:spcBef>
-                <a:spcPts val="0"/>
-              </a:spcBef>
-              <a:spcAft>
-                <a:spcPts val="0"/>
-              </a:spcAft>
-            </a:pPr>
-            <a:r>
-              <a:rPr lang="te-IN" sz="1900" b="0" i="0" dirty="0">
-                <a:solidFill>
-                  <a:schemeClr val="tx1"/>
-                </a:solidFill>
-                <a:effectLst/>
-                <a:latin typeface="Ramabhadra" panose="02000600000000000000" pitchFamily="2" charset="0"/>
-                <a:cs typeface="Ramabhadra" panose="02000600000000000000" pitchFamily="2" charset="0"/>
-              </a:rPr>
-              <a:t>చేరసాలలో వేసినా “స్తుతి”</a:t>
-            </a:r>
-          </a:p>
-          <a:p>
-            <a:pPr marL="0" marR="0" indent="0" algn="ctr" rtl="0" eaLnBrk="1" fontAlgn="auto" latinLnBrk="0" hangingPunct="1">
-              <a:spcBef>
-                <a:spcPts val="0"/>
-              </a:spcBef>
-              <a:spcAft>
-                <a:spcPts val="0"/>
-              </a:spcAft>
-            </a:pPr>
-            <a:endParaRPr lang="te-IN" sz="1900" b="0" i="0" dirty="0">
+              <a:t>ఎన్ని కష్టాలు కలిగిననూ</a:t>
+            </a:r>
+            <a:endParaRPr lang="en-IN" sz="2000" b="0" i="0" dirty="0">
               <a:solidFill>
                 <a:schemeClr val="tx1"/>
               </a:solidFill>
@@ -4352,16 +4348,9 @@
             </a:endParaRPr>
           </a:p>
           <a:p>
-            <a:pPr marL="0" marR="0" indent="0" algn="ctr" rtl="0" eaLnBrk="1" fontAlgn="auto" latinLnBrk="0" hangingPunct="1">
-              <a:spcBef>
-                <a:spcPts val="0"/>
-              </a:spcBef>
-              <a:spcAft>
-                <a:spcPts val="0"/>
-              </a:spcAft>
-            </a:pPr>
-            <a:r>
-              <a:rPr lang="te-IN" sz="1900" b="0" i="0" dirty="0">
+            <a:pPr lvl="1" algn="ctr"/>
+            <a:r>
+              <a:rPr lang="te-IN" sz="2000" b="0" i="0" dirty="0">
                 <a:solidFill>
                   <a:schemeClr val="tx1"/>
                 </a:solidFill>
@@ -4369,20 +4358,13 @@
                 <a:latin typeface="Ramabhadra" panose="02000600000000000000" pitchFamily="2" charset="0"/>
                 <a:cs typeface="Ramabhadra" panose="02000600000000000000" pitchFamily="2" charset="0"/>
               </a:rPr>
-              <a:t>నీ తల్లి నిను మరిచినా – </a:t>
-            </a:r>
-          </a:p>
-          <a:p>
-            <a:pPr marL="0" marR="0" indent="0" algn="ctr" rtl="0" eaLnBrk="1" fontAlgn="auto" latinLnBrk="0" hangingPunct="1">
-              <a:spcBef>
-                <a:spcPts val="0"/>
-              </a:spcBef>
-              <a:spcAft>
-                <a:spcPts val="0"/>
-              </a:spcAft>
-            </a:pPr>
-            <a:r>
-              <a:rPr lang="te-IN" sz="1900" b="0" i="0" dirty="0">
+              <a:t>నన్ను కృంగించె భాదలెన్నో</a:t>
+            </a:r>
+          </a:p>
+          <a:p>
+            <a:pPr lvl="1" algn="ctr"/>
+            <a:r>
+              <a:rPr lang="te-IN" sz="2000" b="0" i="0" dirty="0">
                 <a:solidFill>
                   <a:schemeClr val="tx1"/>
                 </a:solidFill>
@@ -4390,7 +4372,103 @@
                 <a:latin typeface="Ramabhadra" panose="02000600000000000000" pitchFamily="2" charset="0"/>
                 <a:cs typeface="Ramabhadra" panose="02000600000000000000" pitchFamily="2" charset="0"/>
               </a:rPr>
-              <a:t>మరువని నీ దేవుడు “స్తుతి”</a:t>
+              <a:t>ఎన్ని నష్టాలు వాటిల్లినా </a:t>
+            </a:r>
+          </a:p>
+          <a:p>
+            <a:pPr lvl="1" algn="ctr"/>
+            <a:r>
+              <a:rPr lang="te-IN" sz="2000" b="0" i="0" dirty="0">
+                <a:solidFill>
+                  <a:schemeClr val="tx1"/>
+                </a:solidFill>
+                <a:effectLst/>
+                <a:latin typeface="Ramabhadra" panose="02000600000000000000" pitchFamily="2" charset="0"/>
+                <a:cs typeface="Ramabhadra" panose="02000600000000000000" pitchFamily="2" charset="0"/>
+              </a:rPr>
+              <a:t>ప్రియ ప్రభువే నా పరిహారి (2)</a:t>
+            </a:r>
+          </a:p>
+          <a:p>
+            <a:pPr lvl="1" algn="ctr"/>
+            <a:endParaRPr lang="te-IN" sz="2000" b="0" i="0" dirty="0">
+              <a:solidFill>
+                <a:schemeClr val="tx1"/>
+              </a:solidFill>
+              <a:effectLst/>
+              <a:latin typeface="Ramabhadra" panose="02000600000000000000" pitchFamily="2" charset="0"/>
+              <a:cs typeface="Ramabhadra" panose="02000600000000000000" pitchFamily="2" charset="0"/>
+            </a:endParaRPr>
+          </a:p>
+          <a:p>
+            <a:pPr lvl="1" algn="ctr"/>
+            <a:r>
+              <a:rPr lang="te-IN" sz="2000" b="0" i="0" dirty="0">
+                <a:solidFill>
+                  <a:schemeClr val="tx1"/>
+                </a:solidFill>
+                <a:effectLst/>
+                <a:latin typeface="Ramabhadra" panose="02000600000000000000" pitchFamily="2" charset="0"/>
+                <a:cs typeface="Ramabhadra" panose="02000600000000000000" pitchFamily="2" charset="0"/>
+              </a:rPr>
+              <a:t>నన్ను సాతాను వెంబడించినా</a:t>
+            </a:r>
+            <a:endParaRPr lang="en-IN" sz="2000" b="0" i="0" dirty="0">
+              <a:solidFill>
+                <a:schemeClr val="tx1"/>
+              </a:solidFill>
+              <a:effectLst/>
+              <a:latin typeface="Ramabhadra" panose="02000600000000000000" pitchFamily="2" charset="0"/>
+              <a:cs typeface="Ramabhadra" panose="02000600000000000000" pitchFamily="2" charset="0"/>
+            </a:endParaRPr>
+          </a:p>
+          <a:p>
+            <a:pPr lvl="1" algn="ctr"/>
+            <a:r>
+              <a:rPr lang="te-IN" sz="2000" b="0" i="0" dirty="0">
+                <a:solidFill>
+                  <a:schemeClr val="tx1"/>
+                </a:solidFill>
+                <a:effectLst/>
+                <a:latin typeface="Ramabhadra" panose="02000600000000000000" pitchFamily="2" charset="0"/>
+                <a:cs typeface="Ramabhadra" panose="02000600000000000000" pitchFamily="2" charset="0"/>
+              </a:rPr>
+              <a:t>నన్ను శత్రువు ఎదిరించినా (2)</a:t>
+            </a:r>
+            <a:br>
+              <a:rPr lang="te-IN" sz="2000" b="0" i="0" dirty="0">
+                <a:solidFill>
+                  <a:schemeClr val="tx1"/>
+                </a:solidFill>
+                <a:effectLst/>
+                <a:latin typeface="Ramabhadra" panose="02000600000000000000" pitchFamily="2" charset="0"/>
+                <a:cs typeface="Ramabhadra" panose="02000600000000000000" pitchFamily="2" charset="0"/>
+              </a:rPr>
+            </a:br>
+            <a:r>
+              <a:rPr lang="te-IN" sz="2000" b="0" i="0" dirty="0">
+                <a:solidFill>
+                  <a:schemeClr val="tx1"/>
+                </a:solidFill>
+                <a:effectLst/>
+                <a:latin typeface="Ramabhadra" panose="02000600000000000000" pitchFamily="2" charset="0"/>
+                <a:cs typeface="Ramabhadra" panose="02000600000000000000" pitchFamily="2" charset="0"/>
+              </a:rPr>
+              <a:t>పలు నిందలు నను చుట్టినా</a:t>
+            </a:r>
+          </a:p>
+          <a:p>
+            <a:pPr lvl="1" algn="ctr"/>
+            <a:r>
+              <a:rPr lang="te-IN" sz="2000" b="0" i="0" dirty="0">
+                <a:solidFill>
+                  <a:schemeClr val="tx1"/>
+                </a:solidFill>
+                <a:effectLst/>
+                <a:latin typeface="Ramabhadra" panose="02000600000000000000" pitchFamily="2" charset="0"/>
+                <a:cs typeface="Ramabhadra" panose="02000600000000000000" pitchFamily="2" charset="0"/>
+              </a:rPr>
+              <a:t>ప్రియ ప్రభువే నా పరిహారి (2)</a:t>
             </a:r>
           </a:p>
         </p:txBody>
@@ -4448,7 +4526,7 @@
           <a:p>
             <a:pPr algn="ctr"/>
             <a:r>
-              <a:rPr lang="te-IN" sz="2300" b="0" i="0" dirty="0">
+              <a:rPr lang="te-IN" sz="1900" b="0" i="0" dirty="0">
                 <a:solidFill>
                   <a:srgbClr val="000000"/>
                 </a:solidFill>
@@ -4456,13 +4534,13 @@
                 <a:latin typeface="Ramabhadra" panose="02000600000000000000" pitchFamily="2" charset="0"/>
                 <a:cs typeface="Ramabhadra" panose="02000600000000000000" pitchFamily="2" charset="0"/>
               </a:rPr>
-              <a:t>విన్నపములు వినువాడా</a:t>
+              <a:t>స్తోత్రము చెల్లించెదము మన యేసుకే స్తోత్రము చెల్లించెదము</a:t>
             </a:r>
           </a:p>
           <a:p>
             <a:pPr algn="ctr"/>
             <a:r>
-              <a:rPr lang="te-IN" sz="2300" b="0" i="0" dirty="0">
+              <a:rPr lang="te-IN" sz="1900" b="0" i="0" dirty="0">
                 <a:solidFill>
                   <a:srgbClr val="000000"/>
                 </a:solidFill>
@@ -4470,13 +4548,13 @@
                 <a:latin typeface="Ramabhadra" panose="02000600000000000000" pitchFamily="2" charset="0"/>
                 <a:cs typeface="Ramabhadra" panose="02000600000000000000" pitchFamily="2" charset="0"/>
               </a:rPr>
-              <a:t>నా కన్నీరు తుడుచు వాడా </a:t>
+              <a:t>మంచివాడు గొప్పవాడు మన దేవుడు</a:t>
             </a:r>
           </a:p>
           <a:p>
             <a:pPr algn="ctr"/>
             <a:r>
-              <a:rPr lang="te-IN" sz="2300" b="0" i="0" dirty="0">
+              <a:rPr lang="te-IN" sz="1900" b="0" i="0" dirty="0">
                 <a:solidFill>
                   <a:srgbClr val="000000"/>
                 </a:solidFill>
@@ -4484,12 +4562,12 @@
                 <a:latin typeface="Ramabhadra" panose="02000600000000000000" pitchFamily="2" charset="0"/>
                 <a:cs typeface="Ramabhadra" panose="02000600000000000000" pitchFamily="2" charset="0"/>
               </a:rPr>
-              <a:t>సుఖములు ఇచ్చువాడా స్తోత్రము యేసయ్యా </a:t>
+              <a:t>వాక్యమునిచ్చు దేవుడు (2)</a:t>
             </a:r>
           </a:p>
           <a:p>
             <a:pPr algn="ctr"/>
-            <a:endParaRPr lang="te-IN" sz="2300" b="0" i="0" dirty="0">
+            <a:endParaRPr lang="te-IN" sz="1900" b="0" i="0" dirty="0">
               <a:solidFill>
                 <a:srgbClr val="000000"/>
               </a:solidFill>
@@ -4501,7 +4579,7 @@
           <a:p>
             <a:pPr algn="ctr"/>
             <a:r>
-              <a:rPr lang="te-IN" sz="2300" b="0" i="0" dirty="0">
+              <a:rPr lang="te-IN" sz="1900" b="0" i="0" dirty="0">
                 <a:solidFill>
                   <a:srgbClr val="000000"/>
                 </a:solidFill>
@@ -4509,13 +4587,13 @@
                 <a:latin typeface="Ramabhadra" panose="02000600000000000000" pitchFamily="2" charset="0"/>
                 <a:cs typeface="Ramabhadra" panose="02000600000000000000" pitchFamily="2" charset="0"/>
               </a:rPr>
-              <a:t>నీ నుండియే అన్ని సాధ్యమయ్యా </a:t>
+              <a:t>యెరికో మనకు ముందు వచ్చినా –</a:t>
             </a:r>
           </a:p>
           <a:p>
             <a:pPr algn="ctr"/>
             <a:r>
-              <a:rPr lang="te-IN" sz="2300" b="0" i="0" dirty="0">
+              <a:rPr lang="te-IN" sz="1900" b="0" i="0" dirty="0">
                 <a:solidFill>
                   <a:srgbClr val="000000"/>
                 </a:solidFill>
@@ -4523,13 +4601,13 @@
                 <a:latin typeface="Ramabhadra" panose="02000600000000000000" pitchFamily="2" charset="0"/>
                 <a:cs typeface="Ramabhadra" panose="02000600000000000000" pitchFamily="2" charset="0"/>
               </a:rPr>
-              <a:t>మాట ఒకటి చాలునయ్య</a:t>
+              <a:t>క్రీస్తు యేసు ముందే నిలుచును</a:t>
             </a:r>
           </a:p>
           <a:p>
             <a:pPr algn="ctr"/>
             <a:r>
-              <a:rPr lang="te-IN" sz="2300" b="0" i="0" dirty="0">
+              <a:rPr lang="te-IN" sz="1900" b="0" i="0" dirty="0">
                 <a:solidFill>
                   <a:srgbClr val="000000"/>
                 </a:solidFill>
@@ -4537,12 +4615,9 @@
                 <a:latin typeface="Ramabhadra" panose="02000600000000000000" pitchFamily="2" charset="0"/>
                 <a:cs typeface="Ramabhadra" panose="02000600000000000000" pitchFamily="2" charset="0"/>
               </a:rPr>
-              <a:t>నీ మాట ఒకటి చాలునయ్య </a:t>
-            </a:r>
-          </a:p>
-          <a:p>
-            <a:pPr algn="ctr"/>
-            <a:endParaRPr lang="te-IN" sz="2300" b="0" i="0" dirty="0">
+              <a:t>భయపడకు దిగులు పడకు,</a:t>
+            </a:r>
+            <a:endParaRPr lang="en-IN" sz="1900" b="0" i="0" dirty="0">
               <a:solidFill>
                 <a:srgbClr val="000000"/>
               </a:solidFill>
@@ -4554,7 +4629,7 @@
           <a:p>
             <a:pPr algn="ctr"/>
             <a:r>
-              <a:rPr lang="te-IN" sz="2300" b="0" i="0" dirty="0">
+              <a:rPr lang="te-IN" sz="1900" b="0" i="0" dirty="0">
                 <a:solidFill>
                   <a:srgbClr val="000000"/>
                 </a:solidFill>
@@ -4562,13 +4637,24 @@
                 <a:latin typeface="Ramabhadra" panose="02000600000000000000" pitchFamily="2" charset="0"/>
                 <a:cs typeface="Ramabhadra" panose="02000600000000000000" pitchFamily="2" charset="0"/>
               </a:rPr>
-              <a:t>నా చిత్తమే శుద్ధి పొందు </a:t>
+              <a:t>ప్రార్ధించి స్తుతియించుము</a:t>
             </a:r>
           </a:p>
           <a:p>
             <a:pPr algn="ctr"/>
-            <a:r>
-              <a:rPr lang="te-IN" sz="2300" b="0" i="0" dirty="0">
+            <a:endParaRPr lang="te-IN" sz="1900" b="0" i="0" dirty="0">
+              <a:solidFill>
+                <a:srgbClr val="000000"/>
+              </a:solidFill>
+              <a:effectLst/>
+              <a:latin typeface="Ramabhadra" panose="02000600000000000000" pitchFamily="2" charset="0"/>
+              <a:cs typeface="Ramabhadra" panose="02000600000000000000" pitchFamily="2" charset="0"/>
+            </a:endParaRPr>
+          </a:p>
+          <a:p>
+            <a:pPr algn="ctr"/>
+            <a:r>
+              <a:rPr lang="te-IN" sz="1900" b="0" i="0" dirty="0">
                 <a:solidFill>
                   <a:srgbClr val="000000"/>
                 </a:solidFill>
@@ -4576,13 +4662,13 @@
                 <a:latin typeface="Ramabhadra" panose="02000600000000000000" pitchFamily="2" charset="0"/>
                 <a:cs typeface="Ramabhadra" panose="02000600000000000000" pitchFamily="2" charset="0"/>
               </a:rPr>
-              <a:t>అని చెప్పి తాకితివే</a:t>
+              <a:t>గొల్యాత్ మనకు ఎదురు వచ్చినా - క్రీస్తుయేసు ముందే నిలుచును</a:t>
             </a:r>
           </a:p>
           <a:p>
             <a:pPr algn="ctr"/>
             <a:r>
-              <a:rPr lang="te-IN" sz="2300" b="0" i="0" dirty="0">
+              <a:rPr lang="te-IN" sz="1900" b="0" i="0" dirty="0">
                 <a:solidFill>
                   <a:srgbClr val="000000"/>
                 </a:solidFill>
@@ -4590,7 +4676,29 @@
                 <a:latin typeface="Ramabhadra" panose="02000600000000000000" pitchFamily="2" charset="0"/>
                 <a:cs typeface="Ramabhadra" panose="02000600000000000000" pitchFamily="2" charset="0"/>
               </a:rPr>
-              <a:t>అయ్యా అని చెప్పి తాకితివే </a:t>
+              <a:t>హల్లేలూయా – హల్లేలూయా</a:t>
+            </a:r>
+            <a:endParaRPr lang="en-IN" sz="1900" b="0" i="0" dirty="0">
+              <a:solidFill>
+                <a:srgbClr val="000000"/>
+              </a:solidFill>
+              <a:effectLst/>
+              <a:latin typeface="Ramabhadra" panose="02000600000000000000" pitchFamily="2" charset="0"/>
+              <a:cs typeface="Ramabhadra" panose="02000600000000000000" pitchFamily="2" charset="0"/>
+            </a:endParaRPr>
+          </a:p>
+          <a:p>
+            <a:pPr algn="ctr"/>
+            <a:r>
+              <a:rPr lang="te-IN" sz="1900" b="0" i="0" dirty="0">
+                <a:solidFill>
+                  <a:srgbClr val="000000"/>
+                </a:solidFill>
+                <a:effectLst/>
+                <a:latin typeface="Ramabhadra" panose="02000600000000000000" pitchFamily="2" charset="0"/>
+                <a:cs typeface="Ramabhadra" panose="02000600000000000000" pitchFamily="2" charset="0"/>
+              </a:rPr>
+              <a:t>జయమని పాడెదమూ</a:t>
             </a:r>
           </a:p>
         </p:txBody>
@@ -4648,95 +4756,45 @@
           <a:p>
             <a:pPr algn="ctr" defTabSz="439781"/>
             <a:r>
-              <a:rPr lang="te-IN" sz="1700" dirty="0">
+              <a:rPr lang="te-IN" dirty="0">
                 <a:solidFill>
                   <a:schemeClr val="tx1"/>
                 </a:solidFill>
                 <a:latin typeface="Ramabhadra" panose="02000600000000000000" pitchFamily="2" charset="0"/>
                 <a:cs typeface="Ramabhadra" panose="02000600000000000000" pitchFamily="2" charset="0"/>
               </a:rPr>
-              <a:t>ఆశ్చర్యకరుడు ఆలోచనకర్త</a:t>
-            </a:r>
-            <a:br>
-              <a:rPr lang="te-IN" sz="1700" dirty="0">
+              <a:t>శాశ్వతమైనది నా యేసుని ప్రేమ </a:t>
+            </a:r>
+          </a:p>
+          <a:p>
+            <a:pPr algn="ctr" defTabSz="439781"/>
+            <a:r>
+              <a:rPr lang="te-IN" dirty="0">
                 <a:solidFill>
                   <a:schemeClr val="tx1"/>
                 </a:solidFill>
                 <a:latin typeface="Ramabhadra" panose="02000600000000000000" pitchFamily="2" charset="0"/>
                 <a:cs typeface="Ramabhadra" panose="02000600000000000000" pitchFamily="2" charset="0"/>
               </a:rPr>
-            </a:br>
-            <a:r>
-              <a:rPr lang="te-IN" sz="1700" dirty="0">
+              <a:t>నిరంతరం ఉండునది నిజ దేవుని ప్రేమ </a:t>
+            </a:r>
+          </a:p>
+          <a:p>
+            <a:pPr algn="ctr" defTabSz="439781"/>
+            <a:r>
+              <a:rPr lang="te-IN" dirty="0">
                 <a:solidFill>
                   <a:schemeClr val="tx1"/>
                 </a:solidFill>
                 <a:latin typeface="Ramabhadra" panose="02000600000000000000" pitchFamily="2" charset="0"/>
                 <a:cs typeface="Ramabhadra" panose="02000600000000000000" pitchFamily="2" charset="0"/>
               </a:rPr>
-              <a:t>నిత్యుడగు తండ్రి సమాధానకర్త (2)</a:t>
-            </a:r>
-            <a:br>
-              <a:rPr lang="te-IN" sz="1700" dirty="0">
-                <a:solidFill>
-                  <a:schemeClr val="tx1"/>
-                </a:solidFill>
-                <a:latin typeface="Ramabhadra" panose="02000600000000000000" pitchFamily="2" charset="0"/>
-                <a:cs typeface="Ramabhadra" panose="02000600000000000000" pitchFamily="2" charset="0"/>
-              </a:rPr>
-            </a:br>
-            <a:r>
-              <a:rPr lang="te-IN" sz="1700" dirty="0">
-                <a:solidFill>
-                  <a:schemeClr val="tx1"/>
-                </a:solidFill>
-                <a:latin typeface="Ramabhadra" panose="02000600000000000000" pitchFamily="2" charset="0"/>
-                <a:cs typeface="Ramabhadra" panose="02000600000000000000" pitchFamily="2" charset="0"/>
-              </a:rPr>
-              <a:t>తనవంటి గొప్ప దేవుడు ఎవరున్నారిలలో</a:t>
-            </a:r>
-            <a:br>
-              <a:rPr lang="te-IN" sz="1700" dirty="0">
-                <a:solidFill>
-                  <a:schemeClr val="tx1"/>
-                </a:solidFill>
-                <a:latin typeface="Ramabhadra" panose="02000600000000000000" pitchFamily="2" charset="0"/>
-                <a:cs typeface="Ramabhadra" panose="02000600000000000000" pitchFamily="2" charset="0"/>
-              </a:rPr>
-            </a:br>
-            <a:r>
-              <a:rPr lang="te-IN" sz="1700" dirty="0">
-                <a:solidFill>
-                  <a:schemeClr val="tx1"/>
-                </a:solidFill>
-                <a:latin typeface="Ramabhadra" panose="02000600000000000000" pitchFamily="2" charset="0"/>
-                <a:cs typeface="Ramabhadra" panose="02000600000000000000" pitchFamily="2" charset="0"/>
-              </a:rPr>
-              <a:t>తన సాటైనా దీటైనా </a:t>
+              <a:t>యేసుని ప్రేమ  నా యేసుని ప్రేమ</a:t>
             </a:r>
           </a:p>
           <a:p>
             <a:pPr algn="ctr" defTabSz="439781"/>
-            <a:r>
-              <a:rPr lang="te-IN" sz="1700" dirty="0">
-                <a:solidFill>
-                  <a:schemeClr val="tx1"/>
-                </a:solidFill>
-                <a:latin typeface="Ramabhadra" panose="02000600000000000000" pitchFamily="2" charset="0"/>
-                <a:cs typeface="Ramabhadra" panose="02000600000000000000" pitchFamily="2" charset="0"/>
-              </a:rPr>
-              <a:t>    దేవుడు లేడిలలో (2)    </a:t>
-            </a:r>
-            <a:br>
-              <a:rPr lang="te-IN" sz="1700" dirty="0">
-                <a:solidFill>
-                  <a:schemeClr val="tx1"/>
-                </a:solidFill>
-                <a:latin typeface="Ramabhadra" panose="02000600000000000000" pitchFamily="2" charset="0"/>
-                <a:cs typeface="Ramabhadra" panose="02000600000000000000" pitchFamily="2" charset="0"/>
-              </a:rPr>
-            </a:br>
-            <a:endParaRPr lang="te-IN" sz="1700" dirty="0">
+            <a:endParaRPr lang="te-IN" dirty="0">
               <a:solidFill>
                 <a:schemeClr val="tx1"/>
               </a:solidFill>
@@ -4747,82 +4805,71 @@
           <a:p>
             <a:pPr algn="ctr" defTabSz="439781"/>
             <a:r>
-              <a:rPr lang="te-IN" sz="1700" dirty="0">
+              <a:rPr lang="te-IN" dirty="0">
                 <a:solidFill>
                   <a:schemeClr val="tx1"/>
                 </a:solidFill>
                 <a:latin typeface="Ramabhadra" panose="02000600000000000000" pitchFamily="2" charset="0"/>
                 <a:cs typeface="Ramabhadra" panose="02000600000000000000" pitchFamily="2" charset="0"/>
               </a:rPr>
-              <a:t>తన చేతిలో రోగాలు లయమైపోయెను</a:t>
-            </a:r>
-            <a:br>
-              <a:rPr lang="te-IN" sz="1700" dirty="0">
+              <a:t>నా పాపములను భరియించినది  </a:t>
+            </a:r>
+          </a:p>
+          <a:p>
+            <a:pPr algn="ctr" defTabSz="439781"/>
+            <a:r>
+              <a:rPr lang="te-IN" dirty="0">
                 <a:solidFill>
                   <a:schemeClr val="tx1"/>
                 </a:solidFill>
                 <a:latin typeface="Ramabhadra" panose="02000600000000000000" pitchFamily="2" charset="0"/>
                 <a:cs typeface="Ramabhadra" panose="02000600000000000000" pitchFamily="2" charset="0"/>
               </a:rPr>
-            </a:br>
-            <a:r>
-              <a:rPr lang="te-IN" sz="1700" dirty="0">
+              <a:t>నాకై శ్రమలను సహియించినది </a:t>
+            </a:r>
+          </a:p>
+          <a:p>
+            <a:pPr algn="ctr" defTabSz="439781"/>
+            <a:r>
+              <a:rPr lang="te-IN" dirty="0">
                 <a:solidFill>
                   <a:schemeClr val="tx1"/>
                 </a:solidFill>
                 <a:latin typeface="Ramabhadra" panose="02000600000000000000" pitchFamily="2" charset="0"/>
                 <a:cs typeface="Ramabhadra" panose="02000600000000000000" pitchFamily="2" charset="0"/>
               </a:rPr>
-              <a:t>తన చూపుతో దయ్యాలు విలవిలలాడెను (2)</a:t>
-            </a:r>
-            <a:br>
-              <a:rPr lang="te-IN" sz="1700" dirty="0">
+              <a:t>నాకు మారుగా మరణించినది </a:t>
+            </a:r>
+          </a:p>
+          <a:p>
+            <a:pPr algn="ctr" defTabSz="439781"/>
+            <a:r>
+              <a:rPr lang="te-IN" dirty="0">
                 <a:solidFill>
                   <a:schemeClr val="tx1"/>
                 </a:solidFill>
                 <a:latin typeface="Ramabhadra" panose="02000600000000000000" pitchFamily="2" charset="0"/>
                 <a:cs typeface="Ramabhadra" panose="02000600000000000000" pitchFamily="2" charset="0"/>
               </a:rPr>
-            </a:br>
-            <a:r>
-              <a:rPr lang="te-IN" sz="1700" dirty="0">
+              <a:t>నను జీవముతో బ్రతికించునది  </a:t>
+            </a:r>
+          </a:p>
+          <a:p>
+            <a:pPr algn="ctr" defTabSz="439781"/>
+            <a:r>
+              <a:rPr lang="te-IN" dirty="0">
                 <a:solidFill>
                   <a:schemeClr val="tx1"/>
                 </a:solidFill>
                 <a:latin typeface="Ramabhadra" panose="02000600000000000000" pitchFamily="2" charset="0"/>
                 <a:cs typeface="Ramabhadra" panose="02000600000000000000" pitchFamily="2" charset="0"/>
               </a:rPr>
-              <a:t>తన మాటతో ప్రకృతినే శాసించినవాడు (2)</a:t>
-            </a:r>
-            <a:br>
-              <a:rPr lang="te-IN" sz="1700" dirty="0">
-                <a:solidFill>
-                  <a:schemeClr val="tx1"/>
-                </a:solidFill>
-                <a:latin typeface="Ramabhadra" panose="02000600000000000000" pitchFamily="2" charset="0"/>
-                <a:cs typeface="Ramabhadra" panose="02000600000000000000" pitchFamily="2" charset="0"/>
-              </a:rPr>
-            </a:br>
-            <a:r>
-              <a:rPr lang="te-IN" sz="1700" dirty="0">
-                <a:solidFill>
-                  <a:schemeClr val="tx1"/>
-                </a:solidFill>
-                <a:latin typeface="Ramabhadra" panose="02000600000000000000" pitchFamily="2" charset="0"/>
-                <a:cs typeface="Ramabhadra" panose="02000600000000000000" pitchFamily="2" charset="0"/>
-              </a:rPr>
-              <a:t>నీటిపై ఠీవిగా నడచినవాడతడు (2)      </a:t>
-            </a:r>
-            <a:br>
-              <a:rPr lang="te-IN" sz="1700" dirty="0">
-                <a:solidFill>
-                  <a:schemeClr val="tx1"/>
-                </a:solidFill>
-                <a:latin typeface="Ramabhadra" panose="02000600000000000000" pitchFamily="2" charset="0"/>
-                <a:cs typeface="Ramabhadra" panose="02000600000000000000" pitchFamily="2" charset="0"/>
-              </a:rPr>
-            </a:br>
-            <a:endParaRPr lang="te-IN" sz="1700" dirty="0">
+              <a:t>యేసుని ప్రేమ  నా యేసుని ప్రేమ</a:t>
+            </a:r>
+          </a:p>
+          <a:p>
+            <a:pPr algn="ctr" defTabSz="439781"/>
+            <a:endParaRPr lang="te-IN" dirty="0">
               <a:solidFill>
                 <a:schemeClr val="tx1"/>
               </a:solidFill>
@@ -4833,97 +4880,66 @@
           <a:p>
             <a:pPr algn="ctr" defTabSz="439781"/>
             <a:r>
-              <a:rPr lang="te-IN" sz="1700" dirty="0">
+              <a:rPr lang="te-IN" dirty="0">
                 <a:solidFill>
                   <a:schemeClr val="tx1"/>
                 </a:solidFill>
                 <a:latin typeface="Ramabhadra" panose="02000600000000000000" pitchFamily="2" charset="0"/>
                 <a:cs typeface="Ramabhadra" panose="02000600000000000000" pitchFamily="2" charset="0"/>
               </a:rPr>
-              <a:t>మనకోసం తన ప్రాణాన్నే బలి ఇచ్చినవాడతడు</a:t>
-            </a:r>
-            <a:br>
-              <a:rPr lang="te-IN" sz="1700" dirty="0">
+              <a:t> మరణపులోయలో నను కాచినది </a:t>
+            </a:r>
+          </a:p>
+          <a:p>
+            <a:pPr algn="ctr" defTabSz="439781"/>
+            <a:r>
+              <a:rPr lang="te-IN" dirty="0">
                 <a:solidFill>
                   <a:schemeClr val="tx1"/>
                 </a:solidFill>
                 <a:latin typeface="Ramabhadra" panose="02000600000000000000" pitchFamily="2" charset="0"/>
                 <a:cs typeface="Ramabhadra" panose="02000600000000000000" pitchFamily="2" charset="0"/>
               </a:rPr>
-            </a:br>
-            <a:r>
-              <a:rPr lang="te-IN" sz="1700" dirty="0">
+              <a:t>నా శ్రమలో నను ఓదార్చినది </a:t>
+            </a:r>
+          </a:p>
+          <a:p>
+            <a:pPr algn="ctr" defTabSz="439781"/>
+            <a:r>
+              <a:rPr lang="te-IN" dirty="0">
                 <a:solidFill>
                   <a:schemeClr val="tx1"/>
                 </a:solidFill>
                 <a:latin typeface="Ramabhadra" panose="02000600000000000000" pitchFamily="2" charset="0"/>
                 <a:cs typeface="Ramabhadra" panose="02000600000000000000" pitchFamily="2" charset="0"/>
               </a:rPr>
-              <a:t>మనకోసం సజీవుడై లేచినవాడతడు (2)</a:t>
-            </a:r>
-            <a:br>
-              <a:rPr lang="te-IN" sz="1700" dirty="0">
+              <a:t>నను వీడనిది ఎడబాయనిది</a:t>
+            </a:r>
+          </a:p>
+          <a:p>
+            <a:pPr algn="ctr" defTabSz="439781"/>
+            <a:r>
+              <a:rPr lang="te-IN" dirty="0">
                 <a:solidFill>
                   <a:schemeClr val="tx1"/>
                 </a:solidFill>
                 <a:latin typeface="Ramabhadra" panose="02000600000000000000" pitchFamily="2" charset="0"/>
                 <a:cs typeface="Ramabhadra" panose="02000600000000000000" pitchFamily="2" charset="0"/>
               </a:rPr>
-            </a:br>
-            <a:r>
-              <a:rPr lang="te-IN" sz="1700" dirty="0">
+              <a:t>మారనిది మధురమైనది </a:t>
+            </a:r>
+          </a:p>
+          <a:p>
+            <a:pPr algn="ctr" defTabSz="439781"/>
+            <a:r>
+              <a:rPr lang="te-IN" dirty="0">
                 <a:solidFill>
                   <a:schemeClr val="tx1"/>
                 </a:solidFill>
                 <a:latin typeface="Ramabhadra" panose="02000600000000000000" pitchFamily="2" charset="0"/>
                 <a:cs typeface="Ramabhadra" panose="02000600000000000000" pitchFamily="2" charset="0"/>
               </a:rPr>
-              <a:t>తన శాంతినే పంచిపెట్టిన</a:t>
-            </a:r>
-          </a:p>
-          <a:p>
-            <a:pPr algn="ctr" defTabSz="439781"/>
-            <a:r>
-              <a:rPr lang="te-IN" sz="1700" dirty="0">
-                <a:solidFill>
-                  <a:schemeClr val="tx1"/>
-                </a:solidFill>
-                <a:latin typeface="Ramabhadra" panose="02000600000000000000" pitchFamily="2" charset="0"/>
-                <a:cs typeface="Ramabhadra" panose="02000600000000000000" pitchFamily="2" charset="0"/>
-              </a:rPr>
-              <a:t>శాంతమూర్తి యేసు (2)</a:t>
-            </a:r>
-            <a:br>
-              <a:rPr lang="te-IN" sz="1700" dirty="0">
-                <a:solidFill>
-                  <a:schemeClr val="tx1"/>
-                </a:solidFill>
-                <a:latin typeface="Ramabhadra" panose="02000600000000000000" pitchFamily="2" charset="0"/>
-                <a:cs typeface="Ramabhadra" panose="02000600000000000000" pitchFamily="2" charset="0"/>
-              </a:rPr>
-            </a:br>
-            <a:r>
-              <a:rPr lang="te-IN" sz="1700" dirty="0">
-                <a:solidFill>
-                  <a:schemeClr val="tx1"/>
-                </a:solidFill>
-                <a:latin typeface="Ramabhadra" panose="02000600000000000000" pitchFamily="2" charset="0"/>
-                <a:cs typeface="Ramabhadra" panose="02000600000000000000" pitchFamily="2" charset="0"/>
-              </a:rPr>
-              <a:t>తన సర్వాన్నే ధారబోసిన</a:t>
-            </a:r>
-          </a:p>
-          <a:p>
-            <a:pPr algn="ctr" defTabSz="439781"/>
-            <a:r>
-              <a:rPr lang="te-IN" sz="1700" dirty="0">
-                <a:solidFill>
-                  <a:schemeClr val="tx1"/>
-                </a:solidFill>
-                <a:latin typeface="Ramabhadra" panose="02000600000000000000" pitchFamily="2" charset="0"/>
-                <a:cs typeface="Ramabhadra" panose="02000600000000000000" pitchFamily="2" charset="0"/>
-              </a:rPr>
-              <a:t>త్యాగశీలి క్రీస్తు (2)   </a:t>
+              <a:t>యేసుని ప్రేమ నా యేసుని ప్రేమ</a:t>
             </a:r>
           </a:p>
         </p:txBody>

</xml_diff>

<commit_message>
02 june songs sunday
</commit_message>
<xml_diff>
--- a/xerox.pptx
+++ b/xerox.pptx
@@ -11,7 +11,7 @@
     <p:handoutMasterId r:id="rId4"/>
   </p:handoutMasterIdLst>
   <p:sldIdLst>
-    <p:sldId id="284" r:id="rId2"/>
+    <p:sldId id="282" r:id="rId2"/>
   </p:sldIdLst>
   <p:sldSz cx="6858000" cy="9906000" type="A4"/>
   <p:notesSz cx="6858000" cy="9945688"/>
@@ -115,7 +115,7 @@
       <p14:sectionLst xmlns:p14="http://schemas.microsoft.com/office/powerpoint/2010/main">
         <p14:section name="Untitled Section" id="{A9D60E13-7795-4B21-B9EC-5BF21E65AAC1}">
           <p14:sldIdLst>
-            <p14:sldId id="284"/>
+            <p14:sldId id="282"/>
           </p14:sldIdLst>
         </p14:section>
         <p14:section name="Untitled Section" id="{A6F8D81D-7D40-4647-AE92-8344CF040961}">
@@ -224,7 +224,7 @@
           <a:p>
             <a:fld id="{3502DD63-DF8D-4AB8-92A0-0ECCF612C06C}" type="datetimeFigureOut">
               <a:rPr lang="en-IN" smtClean="0"/>
-              <a:t>18-05-2024</a:t>
+              <a:t>01-06-2024</a:t>
             </a:fld>
             <a:endParaRPr lang="en-IN"/>
           </a:p>
@@ -402,7 +402,7 @@
           <a:p>
             <a:fld id="{1AE741EC-1360-4793-999B-941E0396C9FA}" type="datetimeFigureOut">
               <a:rPr lang="en-IN" smtClean="0"/>
-              <a:t>18-05-2024</a:t>
+              <a:t>01-06-2024</a:t>
             </a:fld>
             <a:endParaRPr lang="en-IN"/>
           </a:p>
@@ -802,7 +802,7 @@
           <a:p>
             <a:fld id="{86FBD32F-FCAD-481A-B7D8-4D813FB7DB24}" type="datetimeFigureOut">
               <a:rPr lang="en-IN" smtClean="0"/>
-              <a:t>18-05-2024</a:t>
+              <a:t>01-06-2024</a:t>
             </a:fld>
             <a:endParaRPr lang="en-IN"/>
           </a:p>
@@ -972,7 +972,7 @@
           <a:p>
             <a:fld id="{86FBD32F-FCAD-481A-B7D8-4D813FB7DB24}" type="datetimeFigureOut">
               <a:rPr lang="en-IN" smtClean="0"/>
-              <a:t>18-05-2024</a:t>
+              <a:t>01-06-2024</a:t>
             </a:fld>
             <a:endParaRPr lang="en-IN"/>
           </a:p>
@@ -1152,7 +1152,7 @@
           <a:p>
             <a:fld id="{86FBD32F-FCAD-481A-B7D8-4D813FB7DB24}" type="datetimeFigureOut">
               <a:rPr lang="en-IN" smtClean="0"/>
-              <a:t>18-05-2024</a:t>
+              <a:t>01-06-2024</a:t>
             </a:fld>
             <a:endParaRPr lang="en-IN"/>
           </a:p>
@@ -1322,7 +1322,7 @@
           <a:p>
             <a:fld id="{86FBD32F-FCAD-481A-B7D8-4D813FB7DB24}" type="datetimeFigureOut">
               <a:rPr lang="en-IN" smtClean="0"/>
-              <a:t>18-05-2024</a:t>
+              <a:t>01-06-2024</a:t>
             </a:fld>
             <a:endParaRPr lang="en-IN"/>
           </a:p>
@@ -1566,7 +1566,7 @@
           <a:p>
             <a:fld id="{86FBD32F-FCAD-481A-B7D8-4D813FB7DB24}" type="datetimeFigureOut">
               <a:rPr lang="en-IN" smtClean="0"/>
-              <a:t>18-05-2024</a:t>
+              <a:t>01-06-2024</a:t>
             </a:fld>
             <a:endParaRPr lang="en-IN"/>
           </a:p>
@@ -1798,7 +1798,7 @@
           <a:p>
             <a:fld id="{86FBD32F-FCAD-481A-B7D8-4D813FB7DB24}" type="datetimeFigureOut">
               <a:rPr lang="en-IN" smtClean="0"/>
-              <a:t>18-05-2024</a:t>
+              <a:t>01-06-2024</a:t>
             </a:fld>
             <a:endParaRPr lang="en-IN"/>
           </a:p>
@@ -2165,7 +2165,7 @@
           <a:p>
             <a:fld id="{86FBD32F-FCAD-481A-B7D8-4D813FB7DB24}" type="datetimeFigureOut">
               <a:rPr lang="en-IN" smtClean="0"/>
-              <a:t>18-05-2024</a:t>
+              <a:t>01-06-2024</a:t>
             </a:fld>
             <a:endParaRPr lang="en-IN"/>
           </a:p>
@@ -2283,7 +2283,7 @@
           <a:p>
             <a:fld id="{86FBD32F-FCAD-481A-B7D8-4D813FB7DB24}" type="datetimeFigureOut">
               <a:rPr lang="en-IN" smtClean="0"/>
-              <a:t>18-05-2024</a:t>
+              <a:t>01-06-2024</a:t>
             </a:fld>
             <a:endParaRPr lang="en-IN"/>
           </a:p>
@@ -2378,7 +2378,7 @@
           <a:p>
             <a:fld id="{86FBD32F-FCAD-481A-B7D8-4D813FB7DB24}" type="datetimeFigureOut">
               <a:rPr lang="en-IN" smtClean="0"/>
-              <a:t>18-05-2024</a:t>
+              <a:t>01-06-2024</a:t>
             </a:fld>
             <a:endParaRPr lang="en-IN"/>
           </a:p>
@@ -2655,7 +2655,7 @@
           <a:p>
             <a:fld id="{86FBD32F-FCAD-481A-B7D8-4D813FB7DB24}" type="datetimeFigureOut">
               <a:rPr lang="en-IN" smtClean="0"/>
-              <a:t>18-05-2024</a:t>
+              <a:t>01-06-2024</a:t>
             </a:fld>
             <a:endParaRPr lang="en-IN"/>
           </a:p>
@@ -2912,7 +2912,7 @@
           <a:p>
             <a:fld id="{86FBD32F-FCAD-481A-B7D8-4D813FB7DB24}" type="datetimeFigureOut">
               <a:rPr lang="en-IN" smtClean="0"/>
-              <a:t>18-05-2024</a:t>
+              <a:t>01-06-2024</a:t>
             </a:fld>
             <a:endParaRPr lang="en-IN"/>
           </a:p>
@@ -3125,7 +3125,7 @@
           <a:p>
             <a:fld id="{86FBD32F-FCAD-481A-B7D8-4D813FB7DB24}" type="datetimeFigureOut">
               <a:rPr lang="en-IN" smtClean="0"/>
-              <a:t>18-05-2024</a:t>
+              <a:t>01-06-2024</a:t>
             </a:fld>
             <a:endParaRPr lang="en-IN"/>
           </a:p>
@@ -3532,10 +3532,10 @@
       </p:grpSpPr>
       <p:sp>
         <p:nvSpPr>
-          <p:cNvPr id="5" name="Rectangle 4">
+          <p:cNvPr id="2" name="Rectangle 1">
             <a:extLst>
               <a:ext uri="{FF2B5EF4-FFF2-40B4-BE49-F238E27FC236}">
-                <a16:creationId xmlns:a16="http://schemas.microsoft.com/office/drawing/2014/main" id="{954B1B4E-F899-4AA1-B554-B078DFCD42B8}"/>
+                <a16:creationId xmlns:a16="http://schemas.microsoft.com/office/drawing/2014/main" id="{C2114CF1-1236-46D5-9846-2222D8891EB8}"/>
               </a:ext>
             </a:extLst>
           </p:cNvPr>
@@ -3544,8 +3544,8 @@
         </p:nvSpPr>
         <p:spPr>
           <a:xfrm>
-            <a:off x="80159" y="4876800"/>
-            <a:ext cx="3377869" cy="4752474"/>
+            <a:off x="51132" y="125663"/>
+            <a:ext cx="3377868" cy="4752474"/>
           </a:xfrm>
           <a:prstGeom prst="rect">
             <a:avLst/>
@@ -3553,7 +3553,7 @@
           <a:solidFill>
             <a:schemeClr val="bg1"/>
           </a:solidFill>
-          <a:ln w="28575">
+          <a:ln>
             <a:solidFill>
               <a:schemeClr val="bg1">
                 <a:lumMod val="85000"/>
@@ -3581,442 +3581,469 @@
           <a:bodyPr rtlCol="0" anchor="ctr"/>
           <a:lstStyle/>
           <a:p>
-            <a:pPr marL="0" marR="0" lvl="0" indent="0" algn="ctr" defTabSz="439781" rtl="0" eaLnBrk="1" fontAlgn="auto" latinLnBrk="0" hangingPunct="1">
+            <a:pPr marL="0" marR="0" indent="0" algn="ctr" rtl="0" eaLnBrk="1" fontAlgn="auto" latinLnBrk="0" hangingPunct="1">
               <a:spcBef>
                 <a:spcPts val="0"/>
               </a:spcBef>
               <a:spcAft>
                 <a:spcPts val="0"/>
               </a:spcAft>
-              <a:buClrTx/>
-              <a:buSzTx/>
-              <a:buFontTx/>
-              <a:buNone/>
-              <a:tabLst/>
-              <a:defRPr/>
             </a:pPr>
             <a:r>
-              <a:rPr kumimoji="0" lang="te-IN" i="0" u="none" strike="noStrike" kern="1200" cap="none" spc="0" normalizeH="0" baseline="0" noProof="0" dirty="0">
+              <a:rPr lang="te-IN" sz="1380" b="0" i="0" dirty="0">
                 <a:solidFill>
                   <a:schemeClr val="tx1"/>
                 </a:solidFill>
                 <a:effectLst/>
-                <a:uLnTx/>
-                <a:uFillTx/>
-                <a:latin typeface="Ramabhadra" panose="02000600000000000000" pitchFamily="2" charset="0"/>
-                <a:cs typeface="Ramabhadra" panose="02000600000000000000" pitchFamily="2" charset="0"/>
-              </a:rPr>
-              <a:t>నా ప్రాణమా నా అంతరంగమా </a:t>
-            </a:r>
-          </a:p>
-          <a:p>
-            <a:pPr marL="0" marR="0" lvl="0" indent="0" algn="ctr" defTabSz="439781" rtl="0" eaLnBrk="1" fontAlgn="auto" latinLnBrk="0" hangingPunct="1">
+                <a:latin typeface="Ramabhadra" panose="02000600000000000000" pitchFamily="2" charset="0"/>
+                <a:cs typeface="Ramabhadra" panose="02000600000000000000" pitchFamily="2" charset="0"/>
+              </a:rPr>
+              <a:t>కృపా క్షేమము నీ శాశ్వత జీవము</a:t>
+            </a:r>
+          </a:p>
+          <a:p>
+            <a:pPr marL="0" marR="0" indent="0" algn="ctr" rtl="0" eaLnBrk="1" fontAlgn="auto" latinLnBrk="0" hangingPunct="1">
               <a:spcBef>
                 <a:spcPts val="0"/>
               </a:spcBef>
               <a:spcAft>
                 <a:spcPts val="0"/>
               </a:spcAft>
-              <a:buClrTx/>
-              <a:buSzTx/>
-              <a:buFontTx/>
-              <a:buNone/>
-              <a:tabLst/>
-              <a:defRPr/>
             </a:pPr>
             <a:r>
-              <a:rPr kumimoji="0" lang="te-IN" i="0" u="none" strike="noStrike" kern="1200" cap="none" spc="0" normalizeH="0" baseline="0" noProof="0" dirty="0">
+              <a:rPr lang="te-IN" sz="1380" b="0" i="0" dirty="0">
                 <a:solidFill>
                   <a:schemeClr val="tx1"/>
                 </a:solidFill>
                 <a:effectLst/>
-                <a:uLnTx/>
-                <a:uFillTx/>
-                <a:latin typeface="Ramabhadra" panose="02000600000000000000" pitchFamily="2" charset="0"/>
-                <a:cs typeface="Ramabhadra" panose="02000600000000000000" pitchFamily="2" charset="0"/>
-              </a:rPr>
-              <a:t>నాలో వున్న నా సమస్తమా (2)</a:t>
-            </a:r>
-          </a:p>
-          <a:p>
-            <a:pPr marL="0" marR="0" lvl="0" indent="0" algn="ctr" defTabSz="439781" rtl="0" eaLnBrk="1" fontAlgn="auto" latinLnBrk="0" hangingPunct="1">
+                <a:latin typeface="Ramabhadra" panose="02000600000000000000" pitchFamily="2" charset="0"/>
+                <a:cs typeface="Ramabhadra" panose="02000600000000000000" pitchFamily="2" charset="0"/>
+              </a:rPr>
+              <a:t>నా జీవిత కాలమంతయు నీవు దయచేయువాడవు (2)</a:t>
+            </a:r>
+          </a:p>
+          <a:p>
+            <a:pPr marL="0" marR="0" indent="0" algn="ctr" rtl="0" eaLnBrk="1" fontAlgn="auto" latinLnBrk="0" hangingPunct="1">
               <a:spcBef>
                 <a:spcPts val="0"/>
               </a:spcBef>
               <a:spcAft>
                 <a:spcPts val="0"/>
               </a:spcAft>
-              <a:buClrTx/>
-              <a:buSzTx/>
-              <a:buFontTx/>
-              <a:buNone/>
-              <a:tabLst/>
-              <a:defRPr/>
             </a:pPr>
             <a:r>
-              <a:rPr kumimoji="0" lang="te-IN" i="0" u="none" strike="noStrike" kern="1200" cap="none" spc="0" normalizeH="0" baseline="0" noProof="0" dirty="0">
+              <a:rPr lang="te-IN" sz="1380" b="0" i="0" dirty="0">
                 <a:solidFill>
                   <a:schemeClr val="tx1"/>
                 </a:solidFill>
                 <a:effectLst/>
-                <a:uLnTx/>
-                <a:uFillTx/>
-                <a:latin typeface="Ramabhadra" panose="02000600000000000000" pitchFamily="2" charset="0"/>
-                <a:cs typeface="Ramabhadra" panose="02000600000000000000" pitchFamily="2" charset="0"/>
-              </a:rPr>
-              <a:t>యెహోవ చేసిన ఉపకారములలో</a:t>
-            </a:r>
-          </a:p>
-          <a:p>
-            <a:pPr marL="0" marR="0" lvl="0" indent="0" algn="ctr" defTabSz="439781" rtl="0" eaLnBrk="1" fontAlgn="auto" latinLnBrk="0" hangingPunct="1">
+                <a:latin typeface="Ramabhadra" panose="02000600000000000000" pitchFamily="2" charset="0"/>
+                <a:cs typeface="Ramabhadra" panose="02000600000000000000" pitchFamily="2" charset="0"/>
+              </a:rPr>
+              <a:t>మహోన్నతమైన నీ ఉపకారములు</a:t>
+            </a:r>
+          </a:p>
+          <a:p>
+            <a:pPr marL="0" marR="0" indent="0" algn="ctr" rtl="0" eaLnBrk="1" fontAlgn="auto" latinLnBrk="0" hangingPunct="1">
               <a:spcBef>
                 <a:spcPts val="0"/>
               </a:spcBef>
               <a:spcAft>
                 <a:spcPts val="0"/>
               </a:spcAft>
-              <a:buClrTx/>
-              <a:buSzTx/>
-              <a:buFontTx/>
-              <a:buNone/>
-              <a:tabLst/>
-              <a:defRPr/>
             </a:pPr>
             <a:r>
-              <a:rPr kumimoji="0" lang="te-IN" i="0" u="none" strike="noStrike" kern="1200" cap="none" spc="0" normalizeH="0" baseline="0" noProof="0" dirty="0">
+              <a:rPr lang="te-IN" sz="1380" b="0" i="0" dirty="0">
                 <a:solidFill>
                   <a:schemeClr val="tx1"/>
                 </a:solidFill>
                 <a:effectLst/>
-                <a:uLnTx/>
-                <a:uFillTx/>
-                <a:latin typeface="Ramabhadra" panose="02000600000000000000" pitchFamily="2" charset="0"/>
-                <a:cs typeface="Ramabhadra" panose="02000600000000000000" pitchFamily="2" charset="0"/>
-              </a:rPr>
-              <a:t>దేనిని మరువక కొనియాడుమా (2)</a:t>
-            </a:r>
-          </a:p>
-          <a:p>
-            <a:pPr marL="0" marR="0" lvl="0" indent="0" algn="ctr" defTabSz="439781" rtl="0" eaLnBrk="1" fontAlgn="auto" latinLnBrk="0" hangingPunct="1">
+                <a:latin typeface="Ramabhadra" panose="02000600000000000000" pitchFamily="2" charset="0"/>
+                <a:cs typeface="Ramabhadra" panose="02000600000000000000" pitchFamily="2" charset="0"/>
+              </a:rPr>
+              <a:t>తలంచుచు అనుక్షణము పరవశించనా</a:t>
+            </a:r>
+          </a:p>
+          <a:p>
+            <a:pPr marL="0" marR="0" indent="0" algn="ctr" rtl="0" eaLnBrk="1" fontAlgn="auto" latinLnBrk="0" hangingPunct="1">
               <a:spcBef>
                 <a:spcPts val="0"/>
               </a:spcBef>
               <a:spcAft>
                 <a:spcPts val="0"/>
               </a:spcAft>
-              <a:buClrTx/>
-              <a:buSzTx/>
-              <a:buFontTx/>
-              <a:buNone/>
-              <a:tabLst/>
-              <a:defRPr/>
             </a:pPr>
             <a:r>
-              <a:rPr kumimoji="0" lang="te-IN" i="0" u="none" strike="noStrike" kern="1200" cap="none" spc="0" normalizeH="0" baseline="0" noProof="0" dirty="0">
+              <a:rPr lang="te-IN" sz="1380" b="0" i="0" dirty="0">
                 <a:solidFill>
                   <a:schemeClr val="tx1"/>
                 </a:solidFill>
                 <a:effectLst/>
-                <a:uLnTx/>
-                <a:uFillTx/>
-                <a:latin typeface="Ramabhadra" panose="02000600000000000000" pitchFamily="2" charset="0"/>
-                <a:cs typeface="Ramabhadra" panose="02000600000000000000" pitchFamily="2" charset="0"/>
-              </a:rPr>
-              <a:t>ఆ.. ఆ… ఆ.. ఆ… ఆ.. ఆ…</a:t>
-            </a:r>
-          </a:p>
-          <a:p>
-            <a:pPr marL="0" marR="0" lvl="0" indent="0" algn="ctr" defTabSz="439781" rtl="0" eaLnBrk="1" fontAlgn="auto" latinLnBrk="0" hangingPunct="1">
+                <a:latin typeface="Ramabhadra" panose="02000600000000000000" pitchFamily="2" charset="0"/>
+                <a:cs typeface="Ramabhadra" panose="02000600000000000000" pitchFamily="2" charset="0"/>
+              </a:rPr>
+              <a:t>నీ కృపలోనే పరవశించనా</a:t>
+            </a:r>
+          </a:p>
+          <a:p>
+            <a:pPr marL="0" marR="0" indent="0" algn="ctr" rtl="0" eaLnBrk="1" fontAlgn="auto" latinLnBrk="0" hangingPunct="1">
               <a:spcBef>
                 <a:spcPts val="0"/>
               </a:spcBef>
               <a:spcAft>
                 <a:spcPts val="0"/>
               </a:spcAft>
-              <a:buClrTx/>
-              <a:buSzTx/>
-              <a:buFontTx/>
-              <a:buNone/>
-              <a:tabLst/>
-              <a:defRPr/>
             </a:pPr>
-            <a:endParaRPr kumimoji="0" lang="te-IN" i="0" u="none" strike="noStrike" kern="1200" cap="none" spc="0" normalizeH="0" baseline="0" noProof="0" dirty="0">
+            <a:endParaRPr lang="te-IN" sz="1380" b="0" i="0" dirty="0">
               <a:solidFill>
                 <a:schemeClr val="tx1"/>
               </a:solidFill>
               <a:effectLst/>
-              <a:uLnTx/>
-              <a:uFillTx/>
               <a:latin typeface="Ramabhadra" panose="02000600000000000000" pitchFamily="2" charset="0"/>
               <a:cs typeface="Ramabhadra" panose="02000600000000000000" pitchFamily="2" charset="0"/>
             </a:endParaRPr>
           </a:p>
           <a:p>
-            <a:pPr marL="0" marR="0" lvl="0" indent="0" algn="ctr" defTabSz="439781" rtl="0" eaLnBrk="1" fontAlgn="auto" latinLnBrk="0" hangingPunct="1">
+            <a:pPr marL="0" marR="0" indent="0" algn="ctr" rtl="0" eaLnBrk="1" fontAlgn="auto" latinLnBrk="0" hangingPunct="1">
               <a:spcBef>
                 <a:spcPts val="0"/>
               </a:spcBef>
               <a:spcAft>
                 <a:spcPts val="0"/>
               </a:spcAft>
-              <a:buClrTx/>
-              <a:buSzTx/>
-              <a:buFontTx/>
-              <a:buNone/>
-              <a:tabLst/>
-              <a:defRPr/>
             </a:pPr>
             <a:r>
-              <a:rPr kumimoji="0" lang="te-IN" i="0" u="none" strike="noStrike" kern="1200" cap="none" spc="0" normalizeH="0" baseline="0" noProof="0" dirty="0">
+              <a:rPr lang="te-IN" sz="1380" b="0" i="0" dirty="0">
                 <a:solidFill>
                   <a:schemeClr val="tx1"/>
                 </a:solidFill>
                 <a:effectLst/>
-                <a:uLnTx/>
-                <a:uFillTx/>
-                <a:latin typeface="Ramabhadra" panose="02000600000000000000" pitchFamily="2" charset="0"/>
-                <a:cs typeface="Ramabhadra" panose="02000600000000000000" pitchFamily="2" charset="0"/>
-              </a:rPr>
-              <a:t>నీ దోషములన్నిటిని క్షమియించువాడు </a:t>
-            </a:r>
-          </a:p>
-          <a:p>
-            <a:pPr marL="0" marR="0" lvl="0" indent="0" algn="ctr" defTabSz="439781" rtl="0" eaLnBrk="1" fontAlgn="auto" latinLnBrk="0" hangingPunct="1">
+                <a:latin typeface="Ramabhadra" panose="02000600000000000000" pitchFamily="2" charset="0"/>
+                <a:cs typeface="Ramabhadra" panose="02000600000000000000" pitchFamily="2" charset="0"/>
+              </a:rPr>
+              <a:t>నా ప్రతి ప్రార్ధనకు నీవిచ్చిన ఈవులే</a:t>
+            </a:r>
+          </a:p>
+          <a:p>
+            <a:pPr marL="0" marR="0" indent="0" algn="ctr" rtl="0" eaLnBrk="1" fontAlgn="auto" latinLnBrk="0" hangingPunct="1">
               <a:spcBef>
                 <a:spcPts val="0"/>
               </a:spcBef>
               <a:spcAft>
                 <a:spcPts val="0"/>
               </a:spcAft>
-              <a:buClrTx/>
-              <a:buSzTx/>
-              <a:buFontTx/>
-              <a:buNone/>
-              <a:tabLst/>
-              <a:defRPr/>
             </a:pPr>
             <a:r>
-              <a:rPr kumimoji="0" lang="te-IN" i="0" u="none" strike="noStrike" kern="1200" cap="none" spc="0" normalizeH="0" baseline="0" noProof="0" dirty="0">
+              <a:rPr lang="te-IN" sz="1380" b="0" i="0" dirty="0">
                 <a:solidFill>
                   <a:schemeClr val="tx1"/>
                 </a:solidFill>
                 <a:effectLst/>
-                <a:uLnTx/>
-                <a:uFillTx/>
-                <a:latin typeface="Ramabhadra" panose="02000600000000000000" pitchFamily="2" charset="0"/>
-                <a:cs typeface="Ramabhadra" panose="02000600000000000000" pitchFamily="2" charset="0"/>
-              </a:rPr>
-              <a:t>నీ పాపములన్ని పార ద్రోలువాడు (2)</a:t>
-            </a:r>
-          </a:p>
-          <a:p>
-            <a:pPr marL="0" marR="0" lvl="0" indent="0" algn="ctr" defTabSz="439781" rtl="0" eaLnBrk="1" fontAlgn="auto" latinLnBrk="0" hangingPunct="1">
+                <a:latin typeface="Ramabhadra" panose="02000600000000000000" pitchFamily="2" charset="0"/>
+                <a:cs typeface="Ramabhadra" panose="02000600000000000000" pitchFamily="2" charset="0"/>
+              </a:rPr>
+              <a:t>లెక్కకు మించిన దీవెనలైనాయి (2)</a:t>
+            </a:r>
+          </a:p>
+          <a:p>
+            <a:pPr marL="0" marR="0" indent="0" algn="ctr" rtl="0" eaLnBrk="1" fontAlgn="auto" latinLnBrk="0" hangingPunct="1">
               <a:spcBef>
                 <a:spcPts val="0"/>
               </a:spcBef>
               <a:spcAft>
                 <a:spcPts val="0"/>
               </a:spcAft>
-              <a:buClrTx/>
-              <a:buSzTx/>
-              <a:buFontTx/>
-              <a:buNone/>
-              <a:tabLst/>
-              <a:defRPr/>
             </a:pPr>
             <a:r>
-              <a:rPr kumimoji="0" lang="te-IN" i="0" u="none" strike="noStrike" kern="1200" cap="none" spc="0" normalizeH="0" baseline="0" noProof="0" dirty="0">
+              <a:rPr lang="te-IN" sz="1380" b="0" i="0" dirty="0">
                 <a:solidFill>
                   <a:schemeClr val="tx1"/>
                 </a:solidFill>
                 <a:effectLst/>
-                <a:uLnTx/>
-                <a:uFillTx/>
-                <a:latin typeface="Ramabhadra" panose="02000600000000000000" pitchFamily="2" charset="0"/>
-                <a:cs typeface="Ramabhadra" panose="02000600000000000000" pitchFamily="2" charset="0"/>
-              </a:rPr>
-              <a:t>పరమ వైద్యుడు ప్రభు యేసుడు </a:t>
-            </a:r>
-          </a:p>
-          <a:p>
-            <a:pPr marL="0" marR="0" lvl="0" indent="0" algn="ctr" defTabSz="439781" rtl="0" eaLnBrk="1" fontAlgn="auto" latinLnBrk="0" hangingPunct="1">
+                <a:latin typeface="Ramabhadra" panose="02000600000000000000" pitchFamily="2" charset="0"/>
+                <a:cs typeface="Ramabhadra" panose="02000600000000000000" pitchFamily="2" charset="0"/>
+              </a:rPr>
+              <a:t>అడుగులు తడబడక నడిపినది నీ దివ్య వాక్యమే</a:t>
+            </a:r>
+          </a:p>
+          <a:p>
+            <a:pPr marL="0" marR="0" indent="0" algn="ctr" rtl="0" eaLnBrk="1" fontAlgn="auto" latinLnBrk="0" hangingPunct="1">
               <a:spcBef>
                 <a:spcPts val="0"/>
               </a:spcBef>
               <a:spcAft>
                 <a:spcPts val="0"/>
               </a:spcAft>
-              <a:buClrTx/>
-              <a:buSzTx/>
-              <a:buFontTx/>
-              <a:buNone/>
-              <a:tabLst/>
-              <a:defRPr/>
             </a:pPr>
             <a:r>
-              <a:rPr kumimoji="0" lang="te-IN" i="0" u="none" strike="noStrike" kern="1200" cap="none" spc="0" normalizeH="0" baseline="0" noProof="0" dirty="0">
+              <a:rPr lang="te-IN" sz="1380" b="0" i="0" dirty="0">
                 <a:solidFill>
                   <a:schemeClr val="tx1"/>
                 </a:solidFill>
                 <a:effectLst/>
-                <a:uLnTx/>
-                <a:uFillTx/>
-                <a:latin typeface="Ramabhadra" panose="02000600000000000000" pitchFamily="2" charset="0"/>
-                <a:cs typeface="Ramabhadra" panose="02000600000000000000" pitchFamily="2" charset="0"/>
-              </a:rPr>
-              <a:t>పరిశుద్ధ నామమును సన్నుతించుమా (2)</a:t>
-            </a:r>
-          </a:p>
-          <a:p>
-            <a:pPr marL="0" marR="0" lvl="0" indent="0" algn="ctr" defTabSz="439781" rtl="0" eaLnBrk="1" fontAlgn="auto" latinLnBrk="0" hangingPunct="1">
+                <a:latin typeface="Ramabhadra" panose="02000600000000000000" pitchFamily="2" charset="0"/>
+                <a:cs typeface="Ramabhadra" panose="02000600000000000000" pitchFamily="2" charset="0"/>
+              </a:rPr>
+              <a:t>కడలిని మించిన విశ్వాసమునిచ్చి</a:t>
+            </a:r>
+          </a:p>
+          <a:p>
+            <a:pPr marL="0" marR="0" indent="0" algn="ctr" rtl="0" eaLnBrk="1" fontAlgn="auto" latinLnBrk="0" hangingPunct="1">
               <a:spcBef>
                 <a:spcPts val="0"/>
               </a:spcBef>
               <a:spcAft>
                 <a:spcPts val="0"/>
               </a:spcAft>
-              <a:buClrTx/>
-              <a:buSzTx/>
-              <a:buFontTx/>
-              <a:buNone/>
-              <a:tabLst/>
-              <a:defRPr/>
             </a:pPr>
-            <a:endParaRPr kumimoji="0" lang="te-IN" i="0" u="none" strike="noStrike" kern="1200" cap="none" spc="0" normalizeH="0" baseline="0" noProof="0" dirty="0">
+            <a:r>
+              <a:rPr lang="te-IN" sz="1380" b="0" i="0" dirty="0">
+                <a:solidFill>
+                  <a:schemeClr val="tx1"/>
+                </a:solidFill>
+                <a:effectLst/>
+                <a:latin typeface="Ramabhadra" panose="02000600000000000000" pitchFamily="2" charset="0"/>
+                <a:cs typeface="Ramabhadra" panose="02000600000000000000" pitchFamily="2" charset="0"/>
+              </a:rPr>
+              <a:t>విజయము చేకూర్చెను (2)</a:t>
+            </a:r>
+          </a:p>
+          <a:p>
+            <a:pPr marL="0" marR="0" indent="0" algn="ctr" rtl="0" eaLnBrk="1" fontAlgn="auto" latinLnBrk="0" hangingPunct="1">
+              <a:spcBef>
+                <a:spcPts val="0"/>
+              </a:spcBef>
+              <a:spcAft>
+                <a:spcPts val="0"/>
+              </a:spcAft>
+            </a:pPr>
+            <a:r>
+              <a:rPr lang="te-IN" sz="1380" b="0" i="0" dirty="0">
+                <a:solidFill>
+                  <a:schemeClr val="tx1"/>
+                </a:solidFill>
+                <a:effectLst/>
+                <a:latin typeface="Ramabhadra" panose="02000600000000000000" pitchFamily="2" charset="0"/>
+                <a:cs typeface="Ramabhadra" panose="02000600000000000000" pitchFamily="2" charset="0"/>
+              </a:rPr>
+              <a:t>నీ వాక్యమే మకరంధమై బలపరిచెను నన్ను</a:t>
+            </a:r>
+          </a:p>
+          <a:p>
+            <a:pPr marL="0" marR="0" indent="0" algn="ctr" rtl="0" eaLnBrk="1" fontAlgn="auto" latinLnBrk="0" hangingPunct="1">
+              <a:spcBef>
+                <a:spcPts val="0"/>
+              </a:spcBef>
+              <a:spcAft>
+                <a:spcPts val="0"/>
+              </a:spcAft>
+            </a:pPr>
+            <a:r>
+              <a:rPr lang="te-IN" sz="1380" b="0" i="0" dirty="0">
+                <a:solidFill>
+                  <a:schemeClr val="tx1"/>
+                </a:solidFill>
+                <a:effectLst/>
+                <a:latin typeface="Ramabhadra" panose="02000600000000000000" pitchFamily="2" charset="0"/>
+                <a:cs typeface="Ramabhadra" panose="02000600000000000000" pitchFamily="2" charset="0"/>
+              </a:rPr>
+              <a:t>నా యేసయ్య స్తుతిపాత్రుడ ఆరాధన నీకే (2)</a:t>
+            </a:r>
+          </a:p>
+          <a:p>
+            <a:pPr marL="0" marR="0" indent="0" algn="ctr" rtl="0" eaLnBrk="1" fontAlgn="auto" latinLnBrk="0" hangingPunct="1">
+              <a:spcBef>
+                <a:spcPts val="0"/>
+              </a:spcBef>
+              <a:spcAft>
+                <a:spcPts val="0"/>
+              </a:spcAft>
+            </a:pPr>
+            <a:r>
+              <a:rPr lang="te-IN" sz="1380" b="0" i="0" dirty="0">
+                <a:solidFill>
+                  <a:schemeClr val="tx1"/>
+                </a:solidFill>
+                <a:effectLst/>
+                <a:latin typeface="Ramabhadra" panose="02000600000000000000" pitchFamily="2" charset="0"/>
+                <a:cs typeface="Ramabhadra" panose="02000600000000000000" pitchFamily="2" charset="0"/>
+              </a:rPr>
+              <a:t>ఆరాధన నీకే</a:t>
+            </a:r>
+          </a:p>
+          <a:p>
+            <a:pPr marL="0" marR="0" indent="0" algn="ctr" rtl="0" eaLnBrk="1" fontAlgn="auto" latinLnBrk="0" hangingPunct="1">
+              <a:spcBef>
+                <a:spcPts val="0"/>
+              </a:spcBef>
+              <a:spcAft>
+                <a:spcPts val="0"/>
+              </a:spcAft>
+            </a:pPr>
+            <a:endParaRPr lang="te-IN" sz="1380" b="0" i="0" dirty="0">
               <a:solidFill>
                 <a:schemeClr val="tx1"/>
               </a:solidFill>
               <a:effectLst/>
-              <a:uLnTx/>
-              <a:uFillTx/>
               <a:latin typeface="Ramabhadra" panose="02000600000000000000" pitchFamily="2" charset="0"/>
               <a:cs typeface="Ramabhadra" panose="02000600000000000000" pitchFamily="2" charset="0"/>
             </a:endParaRPr>
           </a:p>
           <a:p>
-            <a:pPr marL="0" marR="0" lvl="0" indent="0" algn="ctr" defTabSz="439781" rtl="0" eaLnBrk="1" fontAlgn="auto" latinLnBrk="0" hangingPunct="1">
+            <a:pPr marL="0" marR="0" indent="0" algn="ctr" rtl="0" eaLnBrk="1" fontAlgn="auto" latinLnBrk="0" hangingPunct="1">
               <a:spcBef>
                 <a:spcPts val="0"/>
               </a:spcBef>
               <a:spcAft>
                 <a:spcPts val="0"/>
               </a:spcAft>
-              <a:buClrTx/>
-              <a:buSzTx/>
-              <a:buFontTx/>
-              <a:buNone/>
-              <a:tabLst/>
-              <a:defRPr/>
             </a:pPr>
             <a:r>
-              <a:rPr kumimoji="0" lang="te-IN" i="0" u="none" strike="noStrike" kern="1200" cap="none" spc="0" normalizeH="0" baseline="0" noProof="0" dirty="0">
+              <a:rPr lang="te-IN" sz="1380" b="0" i="0" dirty="0">
                 <a:solidFill>
                   <a:schemeClr val="tx1"/>
                 </a:solidFill>
                 <a:effectLst/>
-                <a:uLnTx/>
-                <a:uFillTx/>
-                <a:latin typeface="Ramabhadra" panose="02000600000000000000" pitchFamily="2" charset="0"/>
-                <a:cs typeface="Ramabhadra" panose="02000600000000000000" pitchFamily="2" charset="0"/>
-              </a:rPr>
-              <a:t>సమాధిలోనుండి నీ ప్రాణమును </a:t>
-            </a:r>
-          </a:p>
-          <a:p>
-            <a:pPr marL="0" marR="0" lvl="0" indent="0" algn="ctr" defTabSz="439781" rtl="0" eaLnBrk="1" fontAlgn="auto" latinLnBrk="0" hangingPunct="1">
+                <a:latin typeface="Ramabhadra" panose="02000600000000000000" pitchFamily="2" charset="0"/>
+                <a:cs typeface="Ramabhadra" panose="02000600000000000000" pitchFamily="2" charset="0"/>
+              </a:rPr>
+              <a:t>నీ సత్య మార్గములో ఫలించిన అనుభవమే</a:t>
+            </a:r>
+          </a:p>
+          <a:p>
+            <a:pPr marL="0" marR="0" indent="0" algn="ctr" rtl="0" eaLnBrk="1" fontAlgn="auto" latinLnBrk="0" hangingPunct="1">
               <a:spcBef>
                 <a:spcPts val="0"/>
               </a:spcBef>
               <a:spcAft>
                 <a:spcPts val="0"/>
               </a:spcAft>
-              <a:buClrTx/>
-              <a:buSzTx/>
-              <a:buFontTx/>
-              <a:buNone/>
-              <a:tabLst/>
-              <a:defRPr/>
             </a:pPr>
             <a:r>
-              <a:rPr kumimoji="0" lang="te-IN" i="0" u="none" strike="noStrike" kern="1200" cap="none" spc="0" normalizeH="0" baseline="0" noProof="0" dirty="0">
+              <a:rPr lang="te-IN" sz="1380" b="0" i="0" dirty="0">
                 <a:solidFill>
                   <a:schemeClr val="tx1"/>
                 </a:solidFill>
                 <a:effectLst/>
-                <a:uLnTx/>
-                <a:uFillTx/>
-                <a:latin typeface="Ramabhadra" panose="02000600000000000000" pitchFamily="2" charset="0"/>
-                <a:cs typeface="Ramabhadra" panose="02000600000000000000" pitchFamily="2" charset="0"/>
-              </a:rPr>
-              <a:t>విమోచించుచున్నాడు శ్రీయేసుడు (2)</a:t>
-            </a:r>
-          </a:p>
-          <a:p>
-            <a:pPr marL="0" marR="0" lvl="0" indent="0" algn="ctr" defTabSz="439781" rtl="0" eaLnBrk="1" fontAlgn="auto" latinLnBrk="0" hangingPunct="1">
+                <a:latin typeface="Ramabhadra" panose="02000600000000000000" pitchFamily="2" charset="0"/>
+                <a:cs typeface="Ramabhadra" panose="02000600000000000000" pitchFamily="2" charset="0"/>
+              </a:rPr>
+              <a:t>పరిమళింపచేసి సాక్షిగ నిలిపాయి (2)</a:t>
+            </a:r>
+          </a:p>
+          <a:p>
+            <a:pPr marL="0" marR="0" indent="0" algn="ctr" rtl="0" eaLnBrk="1" fontAlgn="auto" latinLnBrk="0" hangingPunct="1">
               <a:spcBef>
                 <a:spcPts val="0"/>
               </a:spcBef>
               <a:spcAft>
                 <a:spcPts val="0"/>
               </a:spcAft>
-              <a:buClrTx/>
-              <a:buSzTx/>
-              <a:buFontTx/>
-              <a:buNone/>
-              <a:tabLst/>
-              <a:defRPr/>
             </a:pPr>
             <a:r>
-              <a:rPr kumimoji="0" lang="te-IN" i="0" u="none" strike="noStrike" kern="1200" cap="none" spc="0" normalizeH="0" baseline="0" noProof="0" dirty="0">
+              <a:rPr lang="te-IN" sz="1380" b="0" i="0" dirty="0">
                 <a:solidFill>
                   <a:schemeClr val="tx1"/>
                 </a:solidFill>
                 <a:effectLst/>
-                <a:uLnTx/>
-                <a:uFillTx/>
-                <a:latin typeface="Ramabhadra" panose="02000600000000000000" pitchFamily="2" charset="0"/>
-                <a:cs typeface="Ramabhadra" panose="02000600000000000000" pitchFamily="2" charset="0"/>
-              </a:rPr>
-              <a:t>కరుణా కటాక్షములను నీకు కిరీటముగా </a:t>
-            </a:r>
-          </a:p>
-          <a:p>
-            <a:pPr marL="0" marR="0" lvl="0" indent="0" algn="ctr" defTabSz="439781" rtl="0" eaLnBrk="1" fontAlgn="auto" latinLnBrk="0" hangingPunct="1">
+                <a:latin typeface="Ramabhadra" panose="02000600000000000000" pitchFamily="2" charset="0"/>
+                <a:cs typeface="Ramabhadra" panose="02000600000000000000" pitchFamily="2" charset="0"/>
+              </a:rPr>
+              <a:t>కలతచెందక నిలిపినది నీ దివ్య దర్శనమే</a:t>
+            </a:r>
+          </a:p>
+          <a:p>
+            <a:pPr marL="0" marR="0" indent="0" algn="ctr" rtl="0" eaLnBrk="1" fontAlgn="auto" latinLnBrk="0" hangingPunct="1">
               <a:spcBef>
                 <a:spcPts val="0"/>
               </a:spcBef>
               <a:spcAft>
                 <a:spcPts val="0"/>
               </a:spcAft>
-              <a:buClrTx/>
-              <a:buSzTx/>
-              <a:buFontTx/>
-              <a:buNone/>
-              <a:tabLst/>
-              <a:defRPr/>
             </a:pPr>
             <a:r>
-              <a:rPr kumimoji="0" lang="te-IN" i="0" u="none" strike="noStrike" kern="1200" cap="none" spc="0" normalizeH="0" baseline="0" noProof="0" dirty="0">
+              <a:rPr lang="te-IN" sz="1380" b="0" i="0" dirty="0">
                 <a:solidFill>
                   <a:schemeClr val="tx1"/>
                 </a:solidFill>
                 <a:effectLst/>
-                <a:uLnTx/>
-                <a:uFillTx/>
-                <a:latin typeface="Ramabhadra" panose="02000600000000000000" pitchFamily="2" charset="0"/>
-                <a:cs typeface="Ramabhadra" panose="02000600000000000000" pitchFamily="2" charset="0"/>
-              </a:rPr>
-              <a:t>ధరియింపజేయును ప్రభు యేసుడు (2)</a:t>
-            </a:r>
-          </a:p>
-        </p:txBody>
-      </p:sp>
-      <p:sp>
-        <p:nvSpPr>
-          <p:cNvPr id="13" name="Rectangle 12">
+                <a:latin typeface="Ramabhadra" panose="02000600000000000000" pitchFamily="2" charset="0"/>
+                <a:cs typeface="Ramabhadra" panose="02000600000000000000" pitchFamily="2" charset="0"/>
+              </a:rPr>
+              <a:t>గమ్యము చేరే శక్తితో నను నింపి నూతన కృపనిచ్చెను (2)</a:t>
+            </a:r>
+          </a:p>
+          <a:p>
+            <a:pPr marL="0" marR="0" indent="0" algn="ctr" rtl="0" eaLnBrk="1" fontAlgn="auto" latinLnBrk="0" hangingPunct="1">
+              <a:spcBef>
+                <a:spcPts val="0"/>
+              </a:spcBef>
+              <a:spcAft>
+                <a:spcPts val="0"/>
+              </a:spcAft>
+            </a:pPr>
+            <a:r>
+              <a:rPr lang="te-IN" sz="1380" b="0" i="0" dirty="0">
+                <a:solidFill>
+                  <a:schemeClr val="tx1"/>
+                </a:solidFill>
+                <a:effectLst/>
+                <a:latin typeface="Ramabhadra" panose="02000600000000000000" pitchFamily="2" charset="0"/>
+                <a:cs typeface="Ramabhadra" panose="02000600000000000000" pitchFamily="2" charset="0"/>
+              </a:rPr>
+              <a:t>ఆరాధ్యుడా అభిషిక్తుడా ఆరాధన నీకే</a:t>
+            </a:r>
+          </a:p>
+          <a:p>
+            <a:pPr marL="0" marR="0" indent="0" algn="ctr" rtl="0" eaLnBrk="1" fontAlgn="auto" latinLnBrk="0" hangingPunct="1">
+              <a:spcBef>
+                <a:spcPts val="0"/>
+              </a:spcBef>
+              <a:spcAft>
+                <a:spcPts val="0"/>
+              </a:spcAft>
+            </a:pPr>
+            <a:r>
+              <a:rPr lang="te-IN" sz="1380" b="0" i="0" dirty="0">
+                <a:solidFill>
+                  <a:schemeClr val="tx1"/>
+                </a:solidFill>
+                <a:effectLst/>
+                <a:latin typeface="Ramabhadra" panose="02000600000000000000" pitchFamily="2" charset="0"/>
+                <a:cs typeface="Ramabhadra" panose="02000600000000000000" pitchFamily="2" charset="0"/>
+              </a:rPr>
+              <a:t>నా యేసయ్య స్తుతిపాత్రుడ ఆరాధన నీకే (2)</a:t>
+            </a:r>
+          </a:p>
+          <a:p>
+            <a:pPr marL="0" marR="0" indent="0" algn="ctr" rtl="0" eaLnBrk="1" fontAlgn="auto" latinLnBrk="0" hangingPunct="1">
+              <a:spcBef>
+                <a:spcPts val="0"/>
+              </a:spcBef>
+              <a:spcAft>
+                <a:spcPts val="0"/>
+              </a:spcAft>
+            </a:pPr>
+            <a:r>
+              <a:rPr lang="te-IN" sz="1380" b="0" i="0" dirty="0">
+                <a:solidFill>
+                  <a:schemeClr val="tx1"/>
+                </a:solidFill>
+                <a:effectLst/>
+                <a:latin typeface="Ramabhadra" panose="02000600000000000000" pitchFamily="2" charset="0"/>
+                <a:cs typeface="Ramabhadra" panose="02000600000000000000" pitchFamily="2" charset="0"/>
+              </a:rPr>
+              <a:t>ఆరాధన నీకే</a:t>
+            </a:r>
+          </a:p>
+        </p:txBody>
+      </p:sp>
+      <p:sp>
+        <p:nvSpPr>
+          <p:cNvPr id="3" name="Rectangle 2">
             <a:extLst>
               <a:ext uri="{FF2B5EF4-FFF2-40B4-BE49-F238E27FC236}">
-                <a16:creationId xmlns:a16="http://schemas.microsoft.com/office/drawing/2014/main" id="{6B2765AB-2009-4D78-90CF-9192BE5415CE}"/>
+                <a16:creationId xmlns:a16="http://schemas.microsoft.com/office/drawing/2014/main" id="{1A91DD97-2F45-459B-B58B-E67033410700}"/>
               </a:ext>
             </a:extLst>
           </p:cNvPr>
@@ -4025,8 +4052,8 @@
         </p:nvSpPr>
         <p:spPr>
           <a:xfrm>
-            <a:off x="3458027" y="4876800"/>
-            <a:ext cx="3319813" cy="4752474"/>
+            <a:off x="3429000" y="125663"/>
+            <a:ext cx="3377868" cy="4752474"/>
           </a:xfrm>
           <a:prstGeom prst="rect">
             <a:avLst/>
@@ -4034,7 +4061,7 @@
           <a:solidFill>
             <a:schemeClr val="bg1"/>
           </a:solidFill>
-          <a:ln w="28575">
+          <a:ln>
             <a:solidFill>
               <a:schemeClr val="bg1">
                 <a:lumMod val="85000"/>
@@ -4062,66 +4089,150 @@
           <a:bodyPr rtlCol="0" anchor="ctr"/>
           <a:lstStyle/>
           <a:p>
-            <a:pPr marL="0" lvl="1" algn="ctr"/>
-            <a:r>
-              <a:rPr lang="te-IN" sz="1600" b="0" i="0" dirty="0">
-                <a:solidFill>
-                  <a:schemeClr val="tx1"/>
-                </a:solidFill>
-                <a:effectLst/>
-                <a:latin typeface="Ramabhadra" panose="02000600000000000000" pitchFamily="2" charset="0"/>
-                <a:cs typeface="Ramabhadra" panose="02000600000000000000" pitchFamily="2" charset="0"/>
-              </a:rPr>
-              <a:t>యెహోవా నీ నామము ఎంతో బలమైనది</a:t>
-            </a:r>
-          </a:p>
-          <a:p>
-            <a:pPr marL="0" lvl="1" algn="ctr"/>
-            <a:r>
-              <a:rPr lang="te-IN" sz="1600" b="0" i="0" dirty="0">
-                <a:solidFill>
-                  <a:schemeClr val="tx1"/>
-                </a:solidFill>
-                <a:effectLst/>
-                <a:latin typeface="Ramabhadra" panose="02000600000000000000" pitchFamily="2" charset="0"/>
-                <a:cs typeface="Ramabhadra" panose="02000600000000000000" pitchFamily="2" charset="0"/>
-              </a:rPr>
-              <a:t>ఆ…ఆ…ఆ… ఎంతో బలమైనది</a:t>
-            </a:r>
-          </a:p>
-          <a:p>
-            <a:pPr marL="0" lvl="1" algn="ctr"/>
-            <a:r>
-              <a:rPr lang="te-IN" sz="1600" b="0" i="0" dirty="0">
-                <a:solidFill>
-                  <a:schemeClr val="tx1"/>
-                </a:solidFill>
-                <a:effectLst/>
-                <a:latin typeface="Ramabhadra" panose="02000600000000000000" pitchFamily="2" charset="0"/>
-                <a:cs typeface="Ramabhadra" panose="02000600000000000000" pitchFamily="2" charset="0"/>
-              </a:rPr>
-              <a:t>యేసయ్య నీ నామము ఎంతో ఘనమైనది</a:t>
-            </a:r>
-          </a:p>
-          <a:p>
-            <a:pPr marL="0" lvl="1" algn="ctr"/>
-            <a:r>
-              <a:rPr lang="te-IN" sz="1600" b="0" i="0" dirty="0">
-                <a:solidFill>
-                  <a:schemeClr val="tx1"/>
-                </a:solidFill>
-                <a:effectLst/>
-                <a:latin typeface="Ramabhadra" panose="02000600000000000000" pitchFamily="2" charset="0"/>
-                <a:cs typeface="Ramabhadra" panose="02000600000000000000" pitchFamily="2" charset="0"/>
-              </a:rPr>
-              <a:t>ఆ…ఆ…ఆ…  ఎంతో ఘనమైనది</a:t>
-            </a:r>
-          </a:p>
-          <a:p>
-            <a:pPr marL="0" lvl="1" algn="ctr"/>
-            <a:endParaRPr lang="te-IN" sz="1600" b="0" i="0" dirty="0">
+            <a:pPr algn="ctr"/>
+            <a:r>
+              <a:rPr lang="te-IN" sz="1450" b="0" i="0" dirty="0">
+                <a:solidFill>
+                  <a:srgbClr val="000000"/>
+                </a:solidFill>
+                <a:effectLst/>
+                <a:latin typeface="Ramabhadra" panose="02000600000000000000" pitchFamily="2" charset="0"/>
+                <a:cs typeface="Ramabhadra" panose="02000600000000000000" pitchFamily="2" charset="0"/>
+              </a:rPr>
+              <a:t>పరిశుద్ధుడవై – మహిమ ప్రభావములకు నీవే పాత్రుడవు</a:t>
+            </a:r>
+            <a:br>
+              <a:rPr lang="te-IN" sz="1450" b="0" i="0" dirty="0">
+                <a:solidFill>
+                  <a:srgbClr val="000000"/>
+                </a:solidFill>
+                <a:effectLst/>
+                <a:latin typeface="Ramabhadra" panose="02000600000000000000" pitchFamily="2" charset="0"/>
+                <a:cs typeface="Ramabhadra" panose="02000600000000000000" pitchFamily="2" charset="0"/>
+              </a:rPr>
+            </a:br>
+            <a:r>
+              <a:rPr lang="te-IN" sz="1450" b="0" i="0" dirty="0">
+                <a:solidFill>
+                  <a:srgbClr val="000000"/>
+                </a:solidFill>
+                <a:effectLst/>
+                <a:latin typeface="Ramabhadra" panose="02000600000000000000" pitchFamily="2" charset="0"/>
+                <a:cs typeface="Ramabhadra" panose="02000600000000000000" pitchFamily="2" charset="0"/>
+              </a:rPr>
+              <a:t>బలవంతుడవై – దీనుల పక్షమై</a:t>
+            </a:r>
+          </a:p>
+          <a:p>
+            <a:pPr algn="ctr"/>
+            <a:r>
+              <a:rPr lang="te-IN" sz="1450" b="0" i="0" dirty="0">
+                <a:solidFill>
+                  <a:srgbClr val="000000"/>
+                </a:solidFill>
+                <a:effectLst/>
+                <a:latin typeface="Ramabhadra" panose="02000600000000000000" pitchFamily="2" charset="0"/>
+                <a:cs typeface="Ramabhadra" panose="02000600000000000000" pitchFamily="2" charset="0"/>
+              </a:rPr>
+              <a:t>కృప చూపు వాడవు (2)</a:t>
+            </a:r>
+            <a:br>
+              <a:rPr lang="te-IN" sz="1450" b="0" i="0" dirty="0">
+                <a:solidFill>
+                  <a:srgbClr val="000000"/>
+                </a:solidFill>
+                <a:effectLst/>
+                <a:latin typeface="Ramabhadra" panose="02000600000000000000" pitchFamily="2" charset="0"/>
+                <a:cs typeface="Ramabhadra" panose="02000600000000000000" pitchFamily="2" charset="0"/>
+              </a:rPr>
+            </a:br>
+            <a:r>
+              <a:rPr lang="te-IN" sz="1450" b="0" i="0" dirty="0">
+                <a:solidFill>
+                  <a:srgbClr val="000000"/>
+                </a:solidFill>
+                <a:effectLst/>
+                <a:latin typeface="Ramabhadra" panose="02000600000000000000" pitchFamily="2" charset="0"/>
+                <a:cs typeface="Ramabhadra" panose="02000600000000000000" pitchFamily="2" charset="0"/>
+              </a:rPr>
+              <a:t>దయాళుడవై – ధారాళముగా </a:t>
+            </a:r>
+          </a:p>
+          <a:p>
+            <a:pPr algn="ctr"/>
+            <a:r>
+              <a:rPr lang="te-IN" sz="1450" b="0" i="0" dirty="0">
+                <a:solidFill>
+                  <a:srgbClr val="000000"/>
+                </a:solidFill>
+                <a:effectLst/>
+                <a:latin typeface="Ramabhadra" panose="02000600000000000000" pitchFamily="2" charset="0"/>
+                <a:cs typeface="Ramabhadra" panose="02000600000000000000" pitchFamily="2" charset="0"/>
+              </a:rPr>
+              <a:t>నను దీవించిన శ్రీమంతుడా</a:t>
+            </a:r>
+            <a:br>
+              <a:rPr lang="te-IN" sz="1450" b="0" i="0" dirty="0">
+                <a:solidFill>
+                  <a:srgbClr val="000000"/>
+                </a:solidFill>
+                <a:effectLst/>
+                <a:latin typeface="Ramabhadra" panose="02000600000000000000" pitchFamily="2" charset="0"/>
+                <a:cs typeface="Ramabhadra" panose="02000600000000000000" pitchFamily="2" charset="0"/>
+              </a:rPr>
+            </a:br>
+            <a:r>
+              <a:rPr lang="te-IN" sz="1450" b="0" i="0" dirty="0">
+                <a:solidFill>
+                  <a:srgbClr val="000000"/>
+                </a:solidFill>
+                <a:effectLst/>
+                <a:latin typeface="Ramabhadra" panose="02000600000000000000" pitchFamily="2" charset="0"/>
+                <a:cs typeface="Ramabhadra" panose="02000600000000000000" pitchFamily="2" charset="0"/>
+              </a:rPr>
+              <a:t>ఆరాధన నీకే నా యేసయ్యా</a:t>
+            </a:r>
+            <a:br>
+              <a:rPr lang="te-IN" sz="1450" b="0" i="0" dirty="0">
+                <a:solidFill>
+                  <a:srgbClr val="000000"/>
+                </a:solidFill>
+                <a:effectLst/>
+                <a:latin typeface="Ramabhadra" panose="02000600000000000000" pitchFamily="2" charset="0"/>
+                <a:cs typeface="Ramabhadra" panose="02000600000000000000" pitchFamily="2" charset="0"/>
+              </a:rPr>
+            </a:br>
+            <a:r>
+              <a:rPr lang="te-IN" sz="1450" b="0" i="0" dirty="0">
+                <a:solidFill>
+                  <a:srgbClr val="000000"/>
+                </a:solidFill>
+                <a:effectLst/>
+                <a:latin typeface="Ramabhadra" panose="02000600000000000000" pitchFamily="2" charset="0"/>
+                <a:cs typeface="Ramabhadra" panose="02000600000000000000" pitchFamily="2" charset="0"/>
+              </a:rPr>
+              <a:t>స్తుతి ఆరాధన నీకే నా యేసయ్యా (2)</a:t>
+            </a:r>
+          </a:p>
+          <a:p>
+            <a:pPr algn="ctr"/>
+            <a:r>
+              <a:rPr lang="te-IN" sz="1450" b="0" i="0" dirty="0">
+                <a:solidFill>
+                  <a:srgbClr val="000000"/>
+                </a:solidFill>
+                <a:effectLst/>
+                <a:latin typeface="Ramabhadra" panose="02000600000000000000" pitchFamily="2" charset="0"/>
+                <a:cs typeface="Ramabhadra" panose="02000600000000000000" pitchFamily="2" charset="0"/>
+              </a:rPr>
+              <a:t>సేవించెద నిన్నే  నా పూర్ణ హృదయముతో    </a:t>
+            </a:r>
+          </a:p>
+          <a:p>
+            <a:pPr algn="ctr"/>
+            <a:endParaRPr lang="te-IN" sz="1450" b="0" i="0" dirty="0">
               <a:solidFill>
-                <a:schemeClr val="tx1"/>
+                <a:srgbClr val="000000"/>
               </a:solidFill>
               <a:effectLst/>
               <a:latin typeface="Ramabhadra" panose="02000600000000000000" pitchFamily="2" charset="0"/>
@@ -4129,233 +4240,223 @@
             </a:endParaRPr>
           </a:p>
           <a:p>
-            <a:pPr marL="0" lvl="1" algn="ctr"/>
-            <a:r>
-              <a:rPr lang="te-IN" sz="1600" b="0" i="0" dirty="0">
-                <a:solidFill>
-                  <a:schemeClr val="tx1"/>
-                </a:solidFill>
-                <a:effectLst/>
-                <a:latin typeface="Ramabhadra" panose="02000600000000000000" pitchFamily="2" charset="0"/>
-                <a:cs typeface="Ramabhadra" panose="02000600000000000000" pitchFamily="2" charset="0"/>
-              </a:rPr>
-              <a:t>మోషే ప్రార్ధించగా</a:t>
-            </a:r>
-            <a:endParaRPr lang="en-IN" sz="1600" b="0" i="0" dirty="0">
-              <a:solidFill>
-                <a:schemeClr val="tx1"/>
-              </a:solidFill>
-              <a:effectLst/>
-              <a:latin typeface="Ramabhadra" panose="02000600000000000000" pitchFamily="2" charset="0"/>
-              <a:cs typeface="Ramabhadra" panose="02000600000000000000" pitchFamily="2" charset="0"/>
-            </a:endParaRPr>
-          </a:p>
-          <a:p>
-            <a:pPr marL="0" lvl="1" algn="ctr"/>
-            <a:r>
-              <a:rPr lang="te-IN" sz="1600" b="0" i="0" dirty="0">
-                <a:solidFill>
-                  <a:schemeClr val="tx1"/>
-                </a:solidFill>
-                <a:effectLst/>
-                <a:latin typeface="Ramabhadra" panose="02000600000000000000" pitchFamily="2" charset="0"/>
-                <a:cs typeface="Ramabhadra" panose="02000600000000000000" pitchFamily="2" charset="0"/>
-              </a:rPr>
-              <a:t>మన్నాను కురిపించితివి (2)</a:t>
-            </a:r>
-          </a:p>
-          <a:p>
-            <a:pPr marL="0" lvl="1" algn="ctr"/>
-            <a:r>
-              <a:rPr lang="te-IN" sz="1600" b="0" i="0" dirty="0">
-                <a:solidFill>
-                  <a:schemeClr val="tx1"/>
-                </a:solidFill>
-                <a:effectLst/>
-                <a:latin typeface="Ramabhadra" panose="02000600000000000000" pitchFamily="2" charset="0"/>
-                <a:cs typeface="Ramabhadra" panose="02000600000000000000" pitchFamily="2" charset="0"/>
-              </a:rPr>
-              <a:t>యెహోషువా ప్రార్ధించగా</a:t>
-            </a:r>
-            <a:endParaRPr lang="en-IN" sz="1600" b="0" i="0" dirty="0">
-              <a:solidFill>
-                <a:schemeClr val="tx1"/>
-              </a:solidFill>
-              <a:effectLst/>
-              <a:latin typeface="Ramabhadra" panose="02000600000000000000" pitchFamily="2" charset="0"/>
-              <a:cs typeface="Ramabhadra" panose="02000600000000000000" pitchFamily="2" charset="0"/>
-            </a:endParaRPr>
-          </a:p>
-          <a:p>
-            <a:pPr marL="0" lvl="1" algn="ctr"/>
-            <a:r>
-              <a:rPr lang="te-IN" sz="1600" b="0" i="0" dirty="0">
-                <a:solidFill>
-                  <a:schemeClr val="tx1"/>
-                </a:solidFill>
-                <a:effectLst/>
-                <a:latin typeface="Ramabhadra" panose="02000600000000000000" pitchFamily="2" charset="0"/>
-                <a:cs typeface="Ramabhadra" panose="02000600000000000000" pitchFamily="2" charset="0"/>
-              </a:rPr>
-              <a:t>సూర్యచంద్రుల నాపితివి (2</a:t>
-            </a:r>
-            <a:r>
-              <a:rPr lang="en-IN" sz="1600" b="0" i="0" dirty="0">
-                <a:solidFill>
-                  <a:schemeClr val="tx1"/>
-                </a:solidFill>
-                <a:effectLst/>
-                <a:latin typeface="Ramabhadra" panose="02000600000000000000" pitchFamily="2" charset="0"/>
-                <a:cs typeface="Ramabhadra" panose="02000600000000000000" pitchFamily="2" charset="0"/>
-              </a:rPr>
-              <a:t>)</a:t>
-            </a:r>
-            <a:endParaRPr lang="te-IN" sz="1600" b="0" i="0" dirty="0">
-              <a:solidFill>
-                <a:schemeClr val="tx1"/>
-              </a:solidFill>
-              <a:effectLst/>
-              <a:latin typeface="Ramabhadra" panose="02000600000000000000" pitchFamily="2" charset="0"/>
-              <a:cs typeface="Ramabhadra" panose="02000600000000000000" pitchFamily="2" charset="0"/>
-            </a:endParaRPr>
-          </a:p>
-          <a:p>
-            <a:pPr marL="0" lvl="1" algn="ctr"/>
-            <a:endParaRPr lang="te-IN" sz="1600" b="0" i="0" dirty="0">
-              <a:solidFill>
-                <a:schemeClr val="tx1"/>
-              </a:solidFill>
-              <a:effectLst/>
-              <a:latin typeface="Ramabhadra" panose="02000600000000000000" pitchFamily="2" charset="0"/>
-              <a:cs typeface="Ramabhadra" panose="02000600000000000000" pitchFamily="2" charset="0"/>
-            </a:endParaRPr>
-          </a:p>
-          <a:p>
-            <a:pPr marL="0" lvl="1" algn="ctr"/>
-            <a:r>
-              <a:rPr lang="te-IN" sz="1600" b="0" i="0" dirty="0">
-                <a:solidFill>
-                  <a:schemeClr val="tx1"/>
-                </a:solidFill>
-                <a:effectLst/>
-                <a:latin typeface="Ramabhadra" panose="02000600000000000000" pitchFamily="2" charset="0"/>
-                <a:cs typeface="Ramabhadra" panose="02000600000000000000" pitchFamily="2" charset="0"/>
-              </a:rPr>
-              <a:t>నీ ప్రజల పక్షముగా</a:t>
-            </a:r>
-            <a:endParaRPr lang="en-IN" sz="1600" b="0" i="0" dirty="0">
-              <a:solidFill>
-                <a:schemeClr val="tx1"/>
-              </a:solidFill>
-              <a:effectLst/>
-              <a:latin typeface="Ramabhadra" panose="02000600000000000000" pitchFamily="2" charset="0"/>
-              <a:cs typeface="Ramabhadra" panose="02000600000000000000" pitchFamily="2" charset="0"/>
-            </a:endParaRPr>
-          </a:p>
-          <a:p>
-            <a:pPr marL="0" lvl="1" algn="ctr"/>
-            <a:r>
-              <a:rPr lang="te-IN" sz="1600" b="0" i="0" dirty="0">
-                <a:solidFill>
-                  <a:schemeClr val="tx1"/>
-                </a:solidFill>
-                <a:effectLst/>
-                <a:latin typeface="Ramabhadra" panose="02000600000000000000" pitchFamily="2" charset="0"/>
-                <a:cs typeface="Ramabhadra" panose="02000600000000000000" pitchFamily="2" charset="0"/>
-              </a:rPr>
-              <a:t>యుద్దములు చేసిన దేవా (2)</a:t>
-            </a:r>
-          </a:p>
-          <a:p>
-            <a:pPr marL="0" lvl="1" algn="ctr"/>
-            <a:r>
-              <a:rPr lang="te-IN" sz="1600" b="0" i="0" dirty="0">
-                <a:solidFill>
-                  <a:schemeClr val="tx1"/>
-                </a:solidFill>
-                <a:effectLst/>
-                <a:latin typeface="Ramabhadra" panose="02000600000000000000" pitchFamily="2" charset="0"/>
-                <a:cs typeface="Ramabhadra" panose="02000600000000000000" pitchFamily="2" charset="0"/>
-              </a:rPr>
-              <a:t>అగ్నిలో పడవేసినా</a:t>
-            </a:r>
-            <a:endParaRPr lang="en-IN" sz="1600" b="0" i="0" dirty="0">
-              <a:solidFill>
-                <a:schemeClr val="tx1"/>
-              </a:solidFill>
-              <a:effectLst/>
-              <a:latin typeface="Ramabhadra" panose="02000600000000000000" pitchFamily="2" charset="0"/>
-              <a:cs typeface="Ramabhadra" panose="02000600000000000000" pitchFamily="2" charset="0"/>
-            </a:endParaRPr>
-          </a:p>
-          <a:p>
-            <a:pPr marL="0" lvl="1" algn="ctr"/>
-            <a:r>
-              <a:rPr lang="te-IN" sz="1600" b="0" i="0" dirty="0">
-                <a:solidFill>
-                  <a:schemeClr val="tx1"/>
-                </a:solidFill>
-                <a:effectLst/>
-                <a:latin typeface="Ramabhadra" panose="02000600000000000000" pitchFamily="2" charset="0"/>
-                <a:cs typeface="Ramabhadra" panose="02000600000000000000" pitchFamily="2" charset="0"/>
-              </a:rPr>
-              <a:t>భయమేమి లేకుండిరి (2)</a:t>
-            </a:r>
-            <a:endParaRPr lang="en-US" sz="1600" b="0" i="0" dirty="0">
-              <a:solidFill>
-                <a:schemeClr val="tx1"/>
-              </a:solidFill>
-              <a:effectLst/>
-              <a:latin typeface="Ramabhadra" panose="02000600000000000000" pitchFamily="2" charset="0"/>
-              <a:cs typeface="Ramabhadra" panose="02000600000000000000" pitchFamily="2" charset="0"/>
-            </a:endParaRPr>
-          </a:p>
-          <a:p>
-            <a:pPr marL="0" lvl="1" algn="ctr"/>
-            <a:endParaRPr lang="en-US" sz="1600" dirty="0">
-              <a:solidFill>
-                <a:schemeClr val="tx1"/>
-              </a:solidFill>
-              <a:latin typeface="Ramabhadra" panose="02000600000000000000" pitchFamily="2" charset="0"/>
-              <a:cs typeface="Ramabhadra" panose="02000600000000000000" pitchFamily="2" charset="0"/>
-            </a:endParaRPr>
-          </a:p>
-          <a:p>
-            <a:pPr marL="0" lvl="1" algn="ctr"/>
-            <a:r>
-              <a:rPr lang="te-IN" sz="1600" b="0" i="0" dirty="0">
-                <a:solidFill>
-                  <a:schemeClr val="tx1"/>
-                </a:solidFill>
-                <a:effectLst/>
-                <a:latin typeface="Ramabhadra" panose="02000600000000000000" pitchFamily="2" charset="0"/>
-                <a:cs typeface="Ramabhadra" panose="02000600000000000000" pitchFamily="2" charset="0"/>
-              </a:rPr>
-              <a:t>సింహాల బోనుకైనా సంతోషముగా వెళ్ళిరి (2)</a:t>
-            </a:r>
-          </a:p>
-          <a:p>
-            <a:pPr marL="0" lvl="1" algn="ctr"/>
-            <a:r>
-              <a:rPr lang="te-IN" sz="1600" b="0" i="0" dirty="0">
-                <a:solidFill>
-                  <a:schemeClr val="tx1"/>
-                </a:solidFill>
-                <a:effectLst/>
-                <a:latin typeface="Ramabhadra" panose="02000600000000000000" pitchFamily="2" charset="0"/>
-                <a:cs typeface="Ramabhadra" panose="02000600000000000000" pitchFamily="2" charset="0"/>
-              </a:rPr>
-              <a:t>ప్రార్ధించిన వెంటనే రక్షించె నీ హస్తము (2)</a:t>
-            </a:r>
-          </a:p>
-        </p:txBody>
-      </p:sp>
-      <p:sp>
-        <p:nvSpPr>
-          <p:cNvPr id="14" name="Rectangle 13">
+            <a:pPr algn="ctr"/>
+            <a:r>
+              <a:rPr lang="te-IN" sz="1450" b="0" i="0" dirty="0">
+                <a:solidFill>
+                  <a:srgbClr val="000000"/>
+                </a:solidFill>
+                <a:effectLst/>
+                <a:latin typeface="Ramabhadra" panose="02000600000000000000" pitchFamily="2" charset="0"/>
+                <a:cs typeface="Ramabhadra" panose="02000600000000000000" pitchFamily="2" charset="0"/>
+              </a:rPr>
+              <a:t>నీ స్వాస్థ్యమైన నీ వారితో కలిసి నిను సేవించుటకు</a:t>
+            </a:r>
+            <a:br>
+              <a:rPr lang="te-IN" sz="1450" b="0" i="0" dirty="0">
+                <a:solidFill>
+                  <a:srgbClr val="000000"/>
+                </a:solidFill>
+                <a:effectLst/>
+                <a:latin typeface="Ramabhadra" panose="02000600000000000000" pitchFamily="2" charset="0"/>
+                <a:cs typeface="Ramabhadra" panose="02000600000000000000" pitchFamily="2" charset="0"/>
+              </a:rPr>
+            </a:br>
+            <a:r>
+              <a:rPr lang="te-IN" sz="1450" b="0" i="0" dirty="0">
+                <a:solidFill>
+                  <a:srgbClr val="000000"/>
+                </a:solidFill>
+                <a:effectLst/>
+                <a:latin typeface="Ramabhadra" panose="02000600000000000000" pitchFamily="2" charset="0"/>
+                <a:cs typeface="Ramabhadra" panose="02000600000000000000" pitchFamily="2" charset="0"/>
+              </a:rPr>
+              <a:t>నీ మహిమ ప్రభావమును</a:t>
+            </a:r>
+          </a:p>
+          <a:p>
+            <a:pPr algn="ctr"/>
+            <a:r>
+              <a:rPr lang="te-IN" sz="1450" b="0" i="0" dirty="0">
+                <a:solidFill>
+                  <a:srgbClr val="000000"/>
+                </a:solidFill>
+                <a:effectLst/>
+                <a:latin typeface="Ramabhadra" panose="02000600000000000000" pitchFamily="2" charset="0"/>
+                <a:cs typeface="Ramabhadra" panose="02000600000000000000" pitchFamily="2" charset="0"/>
+              </a:rPr>
+              <a:t>కిరీటముగా ధరింపజేసితివి (2)</a:t>
+            </a:r>
+            <a:br>
+              <a:rPr lang="te-IN" sz="1450" b="0" i="0" dirty="0">
+                <a:solidFill>
+                  <a:srgbClr val="000000"/>
+                </a:solidFill>
+                <a:effectLst/>
+                <a:latin typeface="Ramabhadra" panose="02000600000000000000" pitchFamily="2" charset="0"/>
+                <a:cs typeface="Ramabhadra" panose="02000600000000000000" pitchFamily="2" charset="0"/>
+              </a:rPr>
+            </a:br>
+            <a:r>
+              <a:rPr lang="te-IN" sz="1450" b="0" i="0" dirty="0">
+                <a:solidFill>
+                  <a:srgbClr val="000000"/>
+                </a:solidFill>
+                <a:effectLst/>
+                <a:latin typeface="Ramabhadra" panose="02000600000000000000" pitchFamily="2" charset="0"/>
+                <a:cs typeface="Ramabhadra" panose="02000600000000000000" pitchFamily="2" charset="0"/>
+              </a:rPr>
+              <a:t>శాశ్వత కాలము వరకు నీ సంతతిపై దృష్టి నిలిపి</a:t>
+            </a:r>
+            <a:br>
+              <a:rPr lang="te-IN" sz="1450" b="0" i="0" dirty="0">
+                <a:solidFill>
+                  <a:srgbClr val="000000"/>
+                </a:solidFill>
+                <a:effectLst/>
+                <a:latin typeface="Ramabhadra" panose="02000600000000000000" pitchFamily="2" charset="0"/>
+                <a:cs typeface="Ramabhadra" panose="02000600000000000000" pitchFamily="2" charset="0"/>
+              </a:rPr>
+            </a:br>
+            <a:r>
+              <a:rPr lang="te-IN" sz="1450" b="0" i="0" dirty="0">
+                <a:solidFill>
+                  <a:srgbClr val="000000"/>
+                </a:solidFill>
+                <a:effectLst/>
+                <a:latin typeface="Ramabhadra" panose="02000600000000000000" pitchFamily="2" charset="0"/>
+                <a:cs typeface="Ramabhadra" panose="02000600000000000000" pitchFamily="2" charset="0"/>
+              </a:rPr>
+              <a:t>నీ దాసుల ప్రార్ధనలు సఫలము చేసితివి</a:t>
+            </a:r>
+          </a:p>
+          <a:p>
+            <a:pPr algn="ctr"/>
+            <a:r>
+              <a:rPr lang="te-IN" sz="1450" b="0" i="0" dirty="0">
+                <a:solidFill>
+                  <a:srgbClr val="000000"/>
+                </a:solidFill>
+                <a:effectLst/>
+                <a:latin typeface="Ramabhadra" panose="02000600000000000000" pitchFamily="2" charset="0"/>
+                <a:cs typeface="Ramabhadra" panose="02000600000000000000" pitchFamily="2" charset="0"/>
+              </a:rPr>
+              <a:t> </a:t>
+            </a:r>
+          </a:p>
+          <a:p>
+            <a:pPr algn="ctr"/>
+            <a:r>
+              <a:rPr lang="te-IN" sz="1450" b="0" i="0" dirty="0">
+                <a:solidFill>
+                  <a:srgbClr val="000000"/>
+                </a:solidFill>
+                <a:effectLst/>
+                <a:latin typeface="Ramabhadra" panose="02000600000000000000" pitchFamily="2" charset="0"/>
+                <a:cs typeface="Ramabhadra" panose="02000600000000000000" pitchFamily="2" charset="0"/>
+              </a:rPr>
+              <a:t>నీ నిత్యమైన ఆదరణ చూపి నను స్థిరపరచుటకు</a:t>
+            </a:r>
+            <a:br>
+              <a:rPr lang="te-IN" sz="1450" b="0" i="0" dirty="0">
+                <a:solidFill>
+                  <a:srgbClr val="000000"/>
+                </a:solidFill>
+                <a:effectLst/>
+                <a:latin typeface="Ramabhadra" panose="02000600000000000000" pitchFamily="2" charset="0"/>
+                <a:cs typeface="Ramabhadra" panose="02000600000000000000" pitchFamily="2" charset="0"/>
+              </a:rPr>
+            </a:br>
+            <a:r>
+              <a:rPr lang="te-IN" sz="1450" b="0" i="0" dirty="0">
+                <a:solidFill>
+                  <a:srgbClr val="000000"/>
+                </a:solidFill>
+                <a:effectLst/>
+                <a:latin typeface="Ramabhadra" panose="02000600000000000000" pitchFamily="2" charset="0"/>
+                <a:cs typeface="Ramabhadra" panose="02000600000000000000" pitchFamily="2" charset="0"/>
+              </a:rPr>
+              <a:t>నీ కరుణా కటాక్షమును</a:t>
+            </a:r>
+          </a:p>
+          <a:p>
+            <a:pPr algn="ctr"/>
+            <a:r>
+              <a:rPr lang="te-IN" sz="1450" b="0" i="0" dirty="0">
+                <a:solidFill>
+                  <a:srgbClr val="000000"/>
+                </a:solidFill>
+                <a:effectLst/>
+                <a:latin typeface="Ramabhadra" panose="02000600000000000000" pitchFamily="2" charset="0"/>
+                <a:cs typeface="Ramabhadra" panose="02000600000000000000" pitchFamily="2" charset="0"/>
+              </a:rPr>
+              <a:t>నాపై కురిపించి నను ప్రేమించితివి (2)</a:t>
+            </a:r>
+            <a:br>
+              <a:rPr lang="te-IN" sz="1450" b="0" i="0" dirty="0">
+                <a:solidFill>
+                  <a:srgbClr val="000000"/>
+                </a:solidFill>
+                <a:effectLst/>
+                <a:latin typeface="Ramabhadra" panose="02000600000000000000" pitchFamily="2" charset="0"/>
+                <a:cs typeface="Ramabhadra" panose="02000600000000000000" pitchFamily="2" charset="0"/>
+              </a:rPr>
+            </a:br>
+            <a:r>
+              <a:rPr lang="te-IN" sz="1450" b="0" i="0" dirty="0">
+                <a:solidFill>
+                  <a:srgbClr val="000000"/>
+                </a:solidFill>
+                <a:effectLst/>
+                <a:latin typeface="Ramabhadra" panose="02000600000000000000" pitchFamily="2" charset="0"/>
+                <a:cs typeface="Ramabhadra" panose="02000600000000000000" pitchFamily="2" charset="0"/>
+              </a:rPr>
+              <a:t>నాకు ప్రయోజనము కలుగజేయుటకు</a:t>
+            </a:r>
+          </a:p>
+          <a:p>
+            <a:pPr algn="ctr"/>
+            <a:r>
+              <a:rPr lang="te-IN" sz="1450" b="0" i="0" dirty="0">
+                <a:solidFill>
+                  <a:srgbClr val="000000"/>
+                </a:solidFill>
+                <a:effectLst/>
+                <a:latin typeface="Ramabhadra" panose="02000600000000000000" pitchFamily="2" charset="0"/>
+                <a:cs typeface="Ramabhadra" panose="02000600000000000000" pitchFamily="2" charset="0"/>
+              </a:rPr>
+              <a:t>నీ ఉపదేశమును బోధించి</a:t>
+            </a:r>
+            <a:br>
+              <a:rPr lang="te-IN" sz="1450" b="0" i="0" dirty="0">
+                <a:solidFill>
+                  <a:srgbClr val="000000"/>
+                </a:solidFill>
+                <a:effectLst/>
+                <a:latin typeface="Ramabhadra" panose="02000600000000000000" pitchFamily="2" charset="0"/>
+                <a:cs typeface="Ramabhadra" panose="02000600000000000000" pitchFamily="2" charset="0"/>
+              </a:rPr>
+            </a:br>
+            <a:r>
+              <a:rPr lang="te-IN" sz="1450" b="0" i="0" dirty="0">
+                <a:solidFill>
+                  <a:srgbClr val="000000"/>
+                </a:solidFill>
+                <a:effectLst/>
+                <a:latin typeface="Ramabhadra" panose="02000600000000000000" pitchFamily="2" charset="0"/>
+                <a:cs typeface="Ramabhadra" panose="02000600000000000000" pitchFamily="2" charset="0"/>
+              </a:rPr>
+              <a:t>నీ దాసుని ప్రాణమును సంతోషపరచితివి</a:t>
+            </a:r>
+          </a:p>
+        </p:txBody>
+      </p:sp>
+      <p:sp>
+        <p:nvSpPr>
+          <p:cNvPr id="4" name="Rectangle 3">
             <a:extLst>
               <a:ext uri="{FF2B5EF4-FFF2-40B4-BE49-F238E27FC236}">
-                <a16:creationId xmlns:a16="http://schemas.microsoft.com/office/drawing/2014/main" id="{4D5AA086-62D7-4ABA-9178-F1303C2758F1}"/>
+                <a16:creationId xmlns:a16="http://schemas.microsoft.com/office/drawing/2014/main" id="{33055CCC-C265-417F-BC2F-ED69E16338ED}"/>
               </a:ext>
             </a:extLst>
           </p:cNvPr>
@@ -4364,7 +4465,7 @@
         </p:nvSpPr>
         <p:spPr>
           <a:xfrm>
-            <a:off x="80160" y="124326"/>
+            <a:off x="51132" y="4878137"/>
             <a:ext cx="3377868" cy="4752474"/>
           </a:xfrm>
           <a:prstGeom prst="rect">
@@ -4373,7 +4474,7 @@
           <a:solidFill>
             <a:schemeClr val="bg1"/>
           </a:solidFill>
-          <a:ln w="28575">
+          <a:ln>
             <a:solidFill>
               <a:schemeClr val="bg1">
                 <a:lumMod val="85000"/>
@@ -4403,141 +4504,36 @@
           <a:p>
             <a:pPr algn="ctr"/>
             <a:r>
-              <a:rPr lang="te-IN" sz="1750" b="0" i="0" dirty="0">
-                <a:solidFill>
-                  <a:srgbClr val="000000"/>
-                </a:solidFill>
-                <a:effectLst/>
-                <a:latin typeface="Ramabhadra" panose="02000600000000000000" pitchFamily="2" charset="0"/>
-                <a:cs typeface="Ramabhadra" panose="02000600000000000000" pitchFamily="2" charset="0"/>
-              </a:rPr>
-              <a:t>శాశ్వతమైన ప్రేమ </a:t>
+              <a:rPr lang="te-IN" sz="1850" b="0" i="0" dirty="0">
+                <a:solidFill>
+                  <a:schemeClr val="tx1"/>
+                </a:solidFill>
+                <a:effectLst/>
+                <a:latin typeface="Ramabhadra" panose="02000600000000000000" pitchFamily="2" charset="0"/>
+                <a:cs typeface="Ramabhadra" panose="02000600000000000000" pitchFamily="2" charset="0"/>
+              </a:rPr>
+              <a:t>మంచి దేవుడు భలే మంచి దేవుడు</a:t>
             </a:r>
           </a:p>
           <a:p>
             <a:pPr algn="ctr"/>
             <a:r>
-              <a:rPr lang="te-IN" sz="1750" b="0" i="0" dirty="0">
-                <a:solidFill>
-                  <a:srgbClr val="000000"/>
-                </a:solidFill>
-                <a:effectLst/>
-                <a:latin typeface="Ramabhadra" panose="02000600000000000000" pitchFamily="2" charset="0"/>
-                <a:cs typeface="Ramabhadra" panose="02000600000000000000" pitchFamily="2" charset="0"/>
-              </a:rPr>
-              <a:t>నను ఎడబాయని యేసు ప్రేమ</a:t>
+              <a:rPr lang="te-IN" sz="1850" b="0" i="0" dirty="0">
+                <a:solidFill>
+                  <a:schemeClr val="tx1"/>
+                </a:solidFill>
+                <a:effectLst/>
+                <a:latin typeface="Ramabhadra" panose="02000600000000000000" pitchFamily="2" charset="0"/>
+                <a:cs typeface="Ramabhadra" panose="02000600000000000000" pitchFamily="2" charset="0"/>
+              </a:rPr>
+              <a:t>నిజ దైవం యేసు - అద్వితీయ దేవుడు</a:t>
             </a:r>
           </a:p>
           <a:p>
             <a:pPr algn="ctr"/>
-            <a:r>
-              <a:rPr lang="te-IN" sz="1750" b="0" i="0" dirty="0">
-                <a:solidFill>
-                  <a:srgbClr val="000000"/>
-                </a:solidFill>
-                <a:effectLst/>
-                <a:latin typeface="Ramabhadra" panose="02000600000000000000" pitchFamily="2" charset="0"/>
-                <a:cs typeface="Ramabhadra" panose="02000600000000000000" pitchFamily="2" charset="0"/>
-              </a:rPr>
-              <a:t>విడువక నాయెడ తన కృప చూపు ప్రేమ</a:t>
-            </a:r>
-          </a:p>
-          <a:p>
-            <a:pPr algn="ctr"/>
-            <a:r>
-              <a:rPr lang="te-IN" sz="1750" b="0" i="0" dirty="0">
-                <a:solidFill>
-                  <a:srgbClr val="000000"/>
-                </a:solidFill>
-                <a:effectLst/>
-                <a:latin typeface="Ramabhadra" panose="02000600000000000000" pitchFamily="2" charset="0"/>
-                <a:cs typeface="Ramabhadra" panose="02000600000000000000" pitchFamily="2" charset="0"/>
-              </a:rPr>
-              <a:t>నన్నాదరించు ప్రేమ - నన్నాదుకొన్న ప్రేమ</a:t>
-            </a:r>
-          </a:p>
-          <a:p>
-            <a:pPr algn="ctr"/>
-            <a:endParaRPr lang="en-IN" sz="1750" dirty="0">
+            <a:endParaRPr lang="te-IN" sz="1850" b="0" i="0" dirty="0">
               <a:solidFill>
-                <a:srgbClr val="000000"/>
-              </a:solidFill>
-              <a:latin typeface="Ramabhadra" panose="02000600000000000000" pitchFamily="2" charset="0"/>
-              <a:cs typeface="Ramabhadra" panose="02000600000000000000" pitchFamily="2" charset="0"/>
-            </a:endParaRPr>
-          </a:p>
-          <a:p>
-            <a:pPr algn="ctr"/>
-            <a:r>
-              <a:rPr lang="te-IN" sz="1750" b="0" i="0" dirty="0">
-                <a:solidFill>
-                  <a:srgbClr val="000000"/>
-                </a:solidFill>
-                <a:effectLst/>
-                <a:latin typeface="Ramabhadra" panose="02000600000000000000" pitchFamily="2" charset="0"/>
-                <a:cs typeface="Ramabhadra" panose="02000600000000000000" pitchFamily="2" charset="0"/>
-              </a:rPr>
-              <a:t>యుగములు మారినను </a:t>
-            </a:r>
-          </a:p>
-          <a:p>
-            <a:pPr algn="ctr"/>
-            <a:r>
-              <a:rPr lang="te-IN" sz="1750" b="0" i="0" dirty="0">
-                <a:solidFill>
-                  <a:srgbClr val="000000"/>
-                </a:solidFill>
-                <a:effectLst/>
-                <a:latin typeface="Ramabhadra" panose="02000600000000000000" pitchFamily="2" charset="0"/>
-                <a:cs typeface="Ramabhadra" panose="02000600000000000000" pitchFamily="2" charset="0"/>
-              </a:rPr>
-              <a:t>తరములు తరళినను</a:t>
-            </a:r>
-          </a:p>
-          <a:p>
-            <a:pPr algn="ctr"/>
-            <a:r>
-              <a:rPr lang="te-IN" sz="1750" b="0" i="0" dirty="0">
-                <a:solidFill>
-                  <a:srgbClr val="000000"/>
-                </a:solidFill>
-                <a:effectLst/>
-                <a:latin typeface="Ramabhadra" panose="02000600000000000000" pitchFamily="2" charset="0"/>
-                <a:cs typeface="Ramabhadra" panose="02000600000000000000" pitchFamily="2" charset="0"/>
-              </a:rPr>
-              <a:t>రాజ్యములే కంపించిన  </a:t>
-            </a:r>
-          </a:p>
-          <a:p>
-            <a:pPr algn="ctr"/>
-            <a:r>
-              <a:rPr lang="te-IN" sz="1750" b="0" i="0" dirty="0">
-                <a:solidFill>
-                  <a:srgbClr val="000000"/>
-                </a:solidFill>
-                <a:effectLst/>
-                <a:latin typeface="Ramabhadra" panose="02000600000000000000" pitchFamily="2" charset="0"/>
-                <a:cs typeface="Ramabhadra" panose="02000600000000000000" pitchFamily="2" charset="0"/>
-              </a:rPr>
-              <a:t>భూ రాష్ట్రములె అంతరించిన</a:t>
-            </a:r>
-          </a:p>
-          <a:p>
-            <a:pPr algn="ctr"/>
-            <a:r>
-              <a:rPr lang="te-IN" sz="1750" b="0" i="0" dirty="0">
-                <a:solidFill>
-                  <a:srgbClr val="000000"/>
-                </a:solidFill>
-                <a:effectLst/>
-                <a:latin typeface="Ramabhadra" panose="02000600000000000000" pitchFamily="2" charset="0"/>
-                <a:cs typeface="Ramabhadra" panose="02000600000000000000" pitchFamily="2" charset="0"/>
-              </a:rPr>
-              <a:t>మారని ప్రేమ అత్యంత ప్రేమ</a:t>
-            </a:r>
-            <a:endParaRPr lang="en-IN" sz="1750" b="0" i="0" dirty="0">
-              <a:solidFill>
-                <a:srgbClr val="000000"/>
+                <a:schemeClr val="tx1"/>
               </a:solidFill>
               <a:effectLst/>
               <a:latin typeface="Ramabhadra" panose="02000600000000000000" pitchFamily="2" charset="0"/>
@@ -4547,43 +4543,92 @@
           <a:p>
             <a:pPr algn="ctr"/>
             <a:r>
-              <a:rPr lang="te-IN" sz="1750" b="0" i="0" dirty="0">
-                <a:solidFill>
-                  <a:srgbClr val="000000"/>
-                </a:solidFill>
-                <a:effectLst/>
-                <a:latin typeface="Ramabhadra" panose="02000600000000000000" pitchFamily="2" charset="0"/>
-                <a:cs typeface="Ramabhadra" panose="02000600000000000000" pitchFamily="2" charset="0"/>
-              </a:rPr>
-              <a:t>అవధులే లేని ప్రేమ</a:t>
+              <a:rPr lang="te-IN" sz="1850" b="0" i="0" dirty="0">
+                <a:solidFill>
+                  <a:schemeClr val="tx1"/>
+                </a:solidFill>
+                <a:effectLst/>
+                <a:latin typeface="Ramabhadra" panose="02000600000000000000" pitchFamily="2" charset="0"/>
+                <a:cs typeface="Ramabhadra" panose="02000600000000000000" pitchFamily="2" charset="0"/>
+              </a:rPr>
+              <a:t>మ్రొక్కులను కోరడు - మనసిస్తే చాలును</a:t>
             </a:r>
           </a:p>
           <a:p>
             <a:pPr algn="ctr"/>
-            <a:endParaRPr lang="en-IN" sz="1750" dirty="0">
+            <a:r>
+              <a:rPr lang="te-IN" sz="1850" b="0" i="0" dirty="0">
+                <a:solidFill>
+                  <a:schemeClr val="tx1"/>
+                </a:solidFill>
+                <a:effectLst/>
+                <a:latin typeface="Ramabhadra" panose="02000600000000000000" pitchFamily="2" charset="0"/>
+                <a:cs typeface="Ramabhadra" panose="02000600000000000000" pitchFamily="2" charset="0"/>
+              </a:rPr>
+              <a:t>కొండలెక్కి రమ్మనడు –</a:t>
+            </a:r>
+          </a:p>
+          <a:p>
+            <a:pPr algn="ctr"/>
+            <a:r>
+              <a:rPr lang="te-IN" sz="1850" b="0" i="0" dirty="0">
+                <a:solidFill>
+                  <a:schemeClr val="tx1"/>
+                </a:solidFill>
+                <a:effectLst/>
+                <a:latin typeface="Ramabhadra" panose="02000600000000000000" pitchFamily="2" charset="0"/>
+                <a:cs typeface="Ramabhadra" panose="02000600000000000000" pitchFamily="2" charset="0"/>
+              </a:rPr>
+              <a:t>మనలో కొలువుంటాడు</a:t>
+            </a:r>
+          </a:p>
+          <a:p>
+            <a:pPr algn="ctr"/>
+            <a:r>
+              <a:rPr lang="te-IN" sz="1850" b="0" i="0" dirty="0">
+                <a:solidFill>
+                  <a:schemeClr val="tx1"/>
+                </a:solidFill>
+                <a:effectLst/>
+                <a:latin typeface="Ramabhadra" panose="02000600000000000000" pitchFamily="2" charset="0"/>
+                <a:cs typeface="Ramabhadra" panose="02000600000000000000" pitchFamily="2" charset="0"/>
+              </a:rPr>
+              <a:t>వెదికితే ప్రతి వారికి - దొరికేను యేసు</a:t>
+            </a:r>
+          </a:p>
+          <a:p>
+            <a:pPr algn="ctr"/>
+            <a:r>
+              <a:rPr lang="te-IN" sz="1850" b="0" i="0" dirty="0">
+                <a:solidFill>
+                  <a:schemeClr val="tx1"/>
+                </a:solidFill>
+                <a:effectLst/>
+                <a:latin typeface="Ramabhadra" panose="02000600000000000000" pitchFamily="2" charset="0"/>
+                <a:cs typeface="Ramabhadra" panose="02000600000000000000" pitchFamily="2" charset="0"/>
+              </a:rPr>
+              <a:t>పిలిచే ప్రతి వారికి - పలికేను యేసు</a:t>
+            </a:r>
+          </a:p>
+          <a:p>
+            <a:pPr algn="ctr"/>
+            <a:r>
+              <a:rPr lang="te-IN" sz="1850" b="0" i="0" dirty="0">
+                <a:solidFill>
+                  <a:schemeClr val="tx1"/>
+                </a:solidFill>
+                <a:effectLst/>
+                <a:latin typeface="Ramabhadra" panose="02000600000000000000" pitchFamily="2" charset="0"/>
+                <a:cs typeface="Ramabhadra" panose="02000600000000000000" pitchFamily="2" charset="0"/>
+              </a:rPr>
+              <a:t>బొమ్మ కాదయ్యో - జీవమున్న దేవుడు</a:t>
+            </a:r>
+          </a:p>
+          <a:p>
+            <a:pPr algn="ctr"/>
+            <a:endParaRPr lang="te-IN" sz="1850" b="0" i="0" dirty="0">
               <a:solidFill>
-                <a:srgbClr val="000000"/>
-              </a:solidFill>
-              <a:latin typeface="Ramabhadra" panose="02000600000000000000" pitchFamily="2" charset="0"/>
-              <a:cs typeface="Ramabhadra" panose="02000600000000000000" pitchFamily="2" charset="0"/>
-            </a:endParaRPr>
-          </a:p>
-          <a:p>
-            <a:pPr algn="ctr"/>
-            <a:r>
-              <a:rPr lang="te-IN" sz="1750" b="0" i="0" dirty="0">
-                <a:solidFill>
-                  <a:srgbClr val="000000"/>
-                </a:solidFill>
-                <a:effectLst/>
-                <a:latin typeface="Ramabhadra" panose="02000600000000000000" pitchFamily="2" charset="0"/>
-                <a:cs typeface="Ramabhadra" panose="02000600000000000000" pitchFamily="2" charset="0"/>
-              </a:rPr>
-              <a:t>నా వారు వెలివేసినా</a:t>
-            </a:r>
-            <a:endParaRPr lang="en-IN" sz="1750" b="0" i="0" dirty="0">
-              <a:solidFill>
-                <a:srgbClr val="000000"/>
+                <a:schemeClr val="tx1"/>
               </a:solidFill>
               <a:effectLst/>
               <a:latin typeface="Ramabhadra" panose="02000600000000000000" pitchFamily="2" charset="0"/>
@@ -4593,81 +4638,81 @@
           <a:p>
             <a:pPr algn="ctr"/>
             <a:r>
-              <a:rPr lang="te-IN" sz="1750" b="0" i="0" dirty="0">
-                <a:solidFill>
-                  <a:srgbClr val="000000"/>
-                </a:solidFill>
-                <a:effectLst/>
-                <a:latin typeface="Ramabhadra" panose="02000600000000000000" pitchFamily="2" charset="0"/>
-                <a:cs typeface="Ramabhadra" panose="02000600000000000000" pitchFamily="2" charset="0"/>
-              </a:rPr>
-              <a:t>నాకున్న వారే దూరమైన</a:t>
+              <a:rPr lang="te-IN" sz="1850" b="0" i="0" dirty="0">
+                <a:solidFill>
+                  <a:schemeClr val="tx1"/>
+                </a:solidFill>
+                <a:effectLst/>
+                <a:latin typeface="Ramabhadra" panose="02000600000000000000" pitchFamily="2" charset="0"/>
+                <a:cs typeface="Ramabhadra" panose="02000600000000000000" pitchFamily="2" charset="0"/>
+              </a:rPr>
+              <a:t>కుంటివాడు గంతులేయ–</a:t>
             </a:r>
           </a:p>
           <a:p>
             <a:pPr algn="ctr"/>
             <a:r>
-              <a:rPr lang="te-IN" sz="1750" b="0" i="0" dirty="0">
-                <a:solidFill>
-                  <a:srgbClr val="000000"/>
-                </a:solidFill>
-                <a:effectLst/>
-                <a:latin typeface="Ramabhadra" panose="02000600000000000000" pitchFamily="2" charset="0"/>
-                <a:cs typeface="Ramabhadra" panose="02000600000000000000" pitchFamily="2" charset="0"/>
-              </a:rPr>
-              <a:t>తన బిడ్డను తల్లి మరచిన </a:t>
+              <a:rPr lang="te-IN" sz="1850" b="0" i="0" dirty="0">
+                <a:solidFill>
+                  <a:schemeClr val="tx1"/>
+                </a:solidFill>
+                <a:effectLst/>
+                <a:latin typeface="Ramabhadra" panose="02000600000000000000" pitchFamily="2" charset="0"/>
+                <a:cs typeface="Ramabhadra" panose="02000600000000000000" pitchFamily="2" charset="0"/>
+              </a:rPr>
+              <a:t>కాళ్ళ నొసగినాడు</a:t>
             </a:r>
           </a:p>
           <a:p>
             <a:pPr algn="ctr"/>
             <a:r>
-              <a:rPr lang="te-IN" sz="1750" b="0" i="0" dirty="0">
-                <a:solidFill>
-                  <a:srgbClr val="000000"/>
-                </a:solidFill>
-                <a:effectLst/>
-                <a:latin typeface="Ramabhadra" panose="02000600000000000000" pitchFamily="2" charset="0"/>
-                <a:cs typeface="Ramabhadra" panose="02000600000000000000" pitchFamily="2" charset="0"/>
-              </a:rPr>
-              <a:t>నను ఎన్నటికి మరువననిన</a:t>
+              <a:rPr lang="te-IN" sz="1850" b="0" i="0" dirty="0">
+                <a:solidFill>
+                  <a:schemeClr val="tx1"/>
+                </a:solidFill>
+                <a:effectLst/>
+                <a:latin typeface="Ramabhadra" panose="02000600000000000000" pitchFamily="2" charset="0"/>
+                <a:cs typeface="Ramabhadra" panose="02000600000000000000" pitchFamily="2" charset="0"/>
+              </a:rPr>
+              <a:t>మూగవారు స్తుతిచేయ – నోటినిచ్చినాడు</a:t>
             </a:r>
           </a:p>
           <a:p>
             <a:pPr algn="ctr"/>
             <a:r>
-              <a:rPr lang="te-IN" sz="1750" b="0" i="0" dirty="0">
-                <a:solidFill>
-                  <a:srgbClr val="000000"/>
-                </a:solidFill>
-                <a:effectLst/>
-                <a:latin typeface="Ramabhadra" panose="02000600000000000000" pitchFamily="2" charset="0"/>
-                <a:cs typeface="Ramabhadra" panose="02000600000000000000" pitchFamily="2" charset="0"/>
-              </a:rPr>
-              <a:t>అరచేతిలో నన్ను చెక్కుకొన్న ప్రేమ</a:t>
+              <a:rPr lang="te-IN" sz="1850" b="0" i="0" dirty="0">
+                <a:solidFill>
+                  <a:schemeClr val="tx1"/>
+                </a:solidFill>
+                <a:effectLst/>
+                <a:latin typeface="Ramabhadra" panose="02000600000000000000" pitchFamily="2" charset="0"/>
+                <a:cs typeface="Ramabhadra" panose="02000600000000000000" pitchFamily="2" charset="0"/>
+              </a:rPr>
+              <a:t>బధిరులు తన స్వరము విన- చెవులిచ్చినాడు</a:t>
             </a:r>
           </a:p>
           <a:p>
             <a:pPr algn="ctr"/>
             <a:r>
-              <a:rPr lang="te-IN" sz="1750" b="0" i="0" dirty="0">
-                <a:solidFill>
-                  <a:srgbClr val="000000"/>
-                </a:solidFill>
-                <a:effectLst/>
-                <a:latin typeface="Ramabhadra" panose="02000600000000000000" pitchFamily="2" charset="0"/>
-                <a:cs typeface="Ramabhadra" panose="02000600000000000000" pitchFamily="2" charset="0"/>
-              </a:rPr>
-              <a:t> మరవని విడువని ప్రేమ</a:t>
-            </a:r>
-          </a:p>
-        </p:txBody>
-      </p:sp>
-      <p:sp>
-        <p:nvSpPr>
-          <p:cNvPr id="15" name="Rectangle 14">
+              <a:rPr lang="te-IN" sz="1850" b="0" i="0" dirty="0">
+                <a:solidFill>
+                  <a:schemeClr val="tx1"/>
+                </a:solidFill>
+                <a:effectLst/>
+                <a:latin typeface="Ramabhadra" panose="02000600000000000000" pitchFamily="2" charset="0"/>
+                <a:cs typeface="Ramabhadra" panose="02000600000000000000" pitchFamily="2" charset="0"/>
+              </a:rPr>
+              <a:t>ప్రేమా మయుడు - ఆశ్చర్య దేవుడు</a:t>
+            </a:r>
+          </a:p>
+        </p:txBody>
+      </p:sp>
+      <p:sp>
+        <p:nvSpPr>
+          <p:cNvPr id="5" name="Rectangle 4">
             <a:extLst>
               <a:ext uri="{FF2B5EF4-FFF2-40B4-BE49-F238E27FC236}">
-                <a16:creationId xmlns:a16="http://schemas.microsoft.com/office/drawing/2014/main" id="{1E968DF1-7B8E-4A1C-81AF-6FA2F0D1F092}"/>
+                <a16:creationId xmlns:a16="http://schemas.microsoft.com/office/drawing/2014/main" id="{954B1B4E-F899-4AA1-B554-B078DFCD42B8}"/>
               </a:ext>
             </a:extLst>
           </p:cNvPr>
@@ -4676,8 +4721,8 @@
         </p:nvSpPr>
         <p:spPr>
           <a:xfrm>
-            <a:off x="3458028" y="124326"/>
-            <a:ext cx="3326737" cy="4752474"/>
+            <a:off x="3429000" y="4878137"/>
+            <a:ext cx="3377868" cy="4752474"/>
           </a:xfrm>
           <a:prstGeom prst="rect">
             <a:avLst/>
@@ -4685,7 +4730,7 @@
           <a:solidFill>
             <a:schemeClr val="bg1"/>
           </a:solidFill>
-          <a:ln w="28575">
+          <a:ln>
             <a:solidFill>
               <a:schemeClr val="bg1">
                 <a:lumMod val="85000"/>
@@ -4713,267 +4758,445 @@
           <a:bodyPr rtlCol="0" anchor="ctr"/>
           <a:lstStyle/>
           <a:p>
-            <a:pPr algn="ctr" defTabSz="439781"/>
-            <a:r>
-              <a:rPr lang="te-IN" sz="1400" dirty="0">
+            <a:pPr marL="0" marR="0" lvl="0" indent="0" algn="ctr" defTabSz="439781" rtl="0" eaLnBrk="1" fontAlgn="auto" latinLnBrk="0" hangingPunct="1">
+              <a:spcBef>
+                <a:spcPts val="0"/>
+              </a:spcBef>
+              <a:spcAft>
+                <a:spcPts val="0"/>
+              </a:spcAft>
+              <a:buClrTx/>
+              <a:buSzTx/>
+              <a:buFontTx/>
+              <a:buNone/>
+              <a:tabLst/>
+              <a:defRPr/>
+            </a:pPr>
+            <a:r>
+              <a:rPr kumimoji="0" lang="te-IN" i="0" u="none" strike="noStrike" kern="1200" cap="none" spc="0" normalizeH="0" baseline="0" noProof="0" dirty="0">
+                <a:ln>
+                  <a:noFill/>
+                </a:ln>
                 <a:solidFill>
                   <a:schemeClr val="tx1"/>
                 </a:solidFill>
-                <a:latin typeface="Ramabhadra" panose="02000600000000000000" pitchFamily="2" charset="0"/>
-                <a:cs typeface="Ramabhadra" panose="02000600000000000000" pitchFamily="2" charset="0"/>
-              </a:rPr>
-              <a:t>యేసయ్యా నీ కృప నాకు చాలయ్యా</a:t>
-            </a:r>
-          </a:p>
-          <a:p>
-            <a:pPr algn="ctr" defTabSz="439781"/>
-            <a:r>
-              <a:rPr lang="te-IN" sz="1400" dirty="0">
+                <a:effectLst/>
+                <a:uLnTx/>
+                <a:uFillTx/>
+                <a:latin typeface="Ramabhadra" panose="02000600000000000000" pitchFamily="2" charset="0"/>
+                <a:cs typeface="Ramabhadra" panose="02000600000000000000" pitchFamily="2" charset="0"/>
+              </a:rPr>
+              <a:t>స్తుతి పాత్రుడా – స్తోత్రార్హుడా</a:t>
+            </a:r>
+          </a:p>
+          <a:p>
+            <a:pPr marL="0" marR="0" lvl="0" indent="0" algn="ctr" defTabSz="439781" rtl="0" eaLnBrk="1" fontAlgn="auto" latinLnBrk="0" hangingPunct="1">
+              <a:spcBef>
+                <a:spcPts val="0"/>
+              </a:spcBef>
+              <a:spcAft>
+                <a:spcPts val="0"/>
+              </a:spcAft>
+              <a:buClrTx/>
+              <a:buSzTx/>
+              <a:buFontTx/>
+              <a:buNone/>
+              <a:tabLst/>
+              <a:defRPr/>
+            </a:pPr>
+            <a:r>
+              <a:rPr kumimoji="0" lang="te-IN" i="0" u="none" strike="noStrike" kern="1200" cap="none" spc="0" normalizeH="0" baseline="0" noProof="0" dirty="0">
+                <a:ln>
+                  <a:noFill/>
+                </a:ln>
                 <a:solidFill>
                   <a:schemeClr val="tx1"/>
                 </a:solidFill>
-                <a:latin typeface="Ramabhadra" panose="02000600000000000000" pitchFamily="2" charset="0"/>
-                <a:cs typeface="Ramabhadra" panose="02000600000000000000" pitchFamily="2" charset="0"/>
-              </a:rPr>
-              <a:t>నీ కృప లేనిదే నే బ్రతుకలేనయ్యా</a:t>
-            </a:r>
-          </a:p>
-          <a:p>
-            <a:pPr algn="ctr" defTabSz="439781"/>
-            <a:endParaRPr lang="te-IN" sz="1400" dirty="0">
+                <a:effectLst/>
+                <a:uLnTx/>
+                <a:uFillTx/>
+                <a:latin typeface="Ramabhadra" panose="02000600000000000000" pitchFamily="2" charset="0"/>
+                <a:cs typeface="Ramabhadra" panose="02000600000000000000" pitchFamily="2" charset="0"/>
+              </a:rPr>
+              <a:t>స్తుతులందుకో - పూజార్హుడా</a:t>
+            </a:r>
+          </a:p>
+          <a:p>
+            <a:pPr marL="0" marR="0" lvl="0" indent="0" algn="ctr" defTabSz="439781" rtl="0" eaLnBrk="1" fontAlgn="auto" latinLnBrk="0" hangingPunct="1">
+              <a:spcBef>
+                <a:spcPts val="0"/>
+              </a:spcBef>
+              <a:spcAft>
+                <a:spcPts val="0"/>
+              </a:spcAft>
+              <a:buClrTx/>
+              <a:buSzTx/>
+              <a:buFontTx/>
+              <a:buNone/>
+              <a:tabLst/>
+              <a:defRPr/>
+            </a:pPr>
+            <a:r>
+              <a:rPr kumimoji="0" lang="te-IN" i="0" u="none" strike="noStrike" kern="1200" cap="none" spc="0" normalizeH="0" baseline="0" noProof="0" dirty="0">
+                <a:ln>
+                  <a:noFill/>
+                </a:ln>
+                <a:solidFill>
+                  <a:schemeClr val="tx1"/>
+                </a:solidFill>
+                <a:effectLst/>
+                <a:uLnTx/>
+                <a:uFillTx/>
+                <a:latin typeface="Ramabhadra" panose="02000600000000000000" pitchFamily="2" charset="0"/>
+                <a:cs typeface="Ramabhadra" panose="02000600000000000000" pitchFamily="2" charset="0"/>
+              </a:rPr>
+              <a:t>ఆకాశమందు నీవు తప్ప - నాకెవరున్నారు నా ప్రభు</a:t>
+            </a:r>
+          </a:p>
+          <a:p>
+            <a:pPr marL="0" marR="0" lvl="0" indent="0" algn="ctr" defTabSz="439781" rtl="0" eaLnBrk="1" fontAlgn="auto" latinLnBrk="0" hangingPunct="1">
+              <a:spcBef>
+                <a:spcPts val="0"/>
+              </a:spcBef>
+              <a:spcAft>
+                <a:spcPts val="0"/>
+              </a:spcAft>
+              <a:buClrTx/>
+              <a:buSzTx/>
+              <a:buFontTx/>
+              <a:buNone/>
+              <a:tabLst/>
+              <a:defRPr/>
+            </a:pPr>
+            <a:r>
+              <a:rPr kumimoji="0" lang="te-IN" i="0" u="none" strike="noStrike" kern="1200" cap="none" spc="0" normalizeH="0" baseline="0" noProof="0" dirty="0">
+                <a:ln>
+                  <a:noFill/>
+                </a:ln>
+                <a:solidFill>
+                  <a:schemeClr val="tx1"/>
+                </a:solidFill>
+                <a:effectLst/>
+                <a:uLnTx/>
+                <a:uFillTx/>
+                <a:latin typeface="Ramabhadra" panose="02000600000000000000" pitchFamily="2" charset="0"/>
+                <a:cs typeface="Ramabhadra" panose="02000600000000000000" pitchFamily="2" charset="0"/>
+              </a:rPr>
+              <a:t>స్తుతి పాత్రుడా.... ఆఆఅ</a:t>
+            </a:r>
+          </a:p>
+          <a:p>
+            <a:pPr marL="0" marR="0" lvl="0" indent="0" algn="ctr" defTabSz="439781" rtl="0" eaLnBrk="1" fontAlgn="auto" latinLnBrk="0" hangingPunct="1">
+              <a:spcBef>
+                <a:spcPts val="0"/>
+              </a:spcBef>
+              <a:spcAft>
+                <a:spcPts val="0"/>
+              </a:spcAft>
+              <a:buClrTx/>
+              <a:buSzTx/>
+              <a:buFontTx/>
+              <a:buNone/>
+              <a:tabLst/>
+              <a:defRPr/>
+            </a:pPr>
+            <a:endParaRPr kumimoji="0" lang="te-IN" i="0" u="none" strike="noStrike" kern="1200" cap="none" spc="0" normalizeH="0" baseline="0" noProof="0" dirty="0">
+              <a:ln>
+                <a:noFill/>
+              </a:ln>
               <a:solidFill>
                 <a:schemeClr val="tx1"/>
               </a:solidFill>
+              <a:effectLst/>
+              <a:uLnTx/>
+              <a:uFillTx/>
               <a:latin typeface="Ramabhadra" panose="02000600000000000000" pitchFamily="2" charset="0"/>
               <a:cs typeface="Ramabhadra" panose="02000600000000000000" pitchFamily="2" charset="0"/>
             </a:endParaRPr>
           </a:p>
           <a:p>
-            <a:pPr algn="ctr" defTabSz="439781"/>
-            <a:r>
-              <a:rPr lang="te-IN" sz="1400" dirty="0">
+            <a:pPr marL="0" marR="0" lvl="0" indent="0" algn="ctr" defTabSz="439781" rtl="0" eaLnBrk="1" fontAlgn="auto" latinLnBrk="0" hangingPunct="1">
+              <a:spcBef>
+                <a:spcPts val="0"/>
+              </a:spcBef>
+              <a:spcAft>
+                <a:spcPts val="0"/>
+              </a:spcAft>
+              <a:buClrTx/>
+              <a:buSzTx/>
+              <a:buFontTx/>
+              <a:buNone/>
+              <a:tabLst/>
+              <a:defRPr/>
+            </a:pPr>
+            <a:r>
+              <a:rPr kumimoji="0" lang="te-IN" i="0" u="none" strike="noStrike" kern="1200" cap="none" spc="0" normalizeH="0" baseline="0" noProof="0" dirty="0">
+                <a:ln>
+                  <a:noFill/>
+                </a:ln>
                 <a:solidFill>
                   <a:schemeClr val="tx1"/>
                 </a:solidFill>
-                <a:latin typeface="Ramabhadra" panose="02000600000000000000" pitchFamily="2" charset="0"/>
-                <a:cs typeface="Ramabhadra" panose="02000600000000000000" pitchFamily="2" charset="0"/>
-              </a:rPr>
-              <a:t>నీ కృప లేని క్షణము – నీ దయ లేని క్షణము</a:t>
-            </a:r>
-          </a:p>
-          <a:p>
-            <a:pPr algn="ctr" defTabSz="439781"/>
-            <a:r>
-              <a:rPr lang="te-IN" sz="1400" dirty="0">
+                <a:effectLst/>
+                <a:uLnTx/>
+                <a:uFillTx/>
+                <a:latin typeface="Ramabhadra" panose="02000600000000000000" pitchFamily="2" charset="0"/>
+                <a:cs typeface="Ramabhadra" panose="02000600000000000000" pitchFamily="2" charset="0"/>
+              </a:rPr>
+              <a:t>నా శత్రువులు నను తరుముచుండగా –</a:t>
+            </a:r>
+          </a:p>
+          <a:p>
+            <a:pPr marL="0" marR="0" lvl="0" indent="0" algn="ctr" defTabSz="439781" rtl="0" eaLnBrk="1" fontAlgn="auto" latinLnBrk="0" hangingPunct="1">
+              <a:spcBef>
+                <a:spcPts val="0"/>
+              </a:spcBef>
+              <a:spcAft>
+                <a:spcPts val="0"/>
+              </a:spcAft>
+              <a:buClrTx/>
+              <a:buSzTx/>
+              <a:buFontTx/>
+              <a:buNone/>
+              <a:tabLst/>
+              <a:defRPr/>
+            </a:pPr>
+            <a:r>
+              <a:rPr kumimoji="0" lang="te-IN" i="0" u="none" strike="noStrike" kern="1200" cap="none" spc="0" normalizeH="0" baseline="0" noProof="0" dirty="0">
+                <a:ln>
+                  <a:noFill/>
+                </a:ln>
                 <a:solidFill>
                   <a:schemeClr val="tx1"/>
                 </a:solidFill>
-                <a:latin typeface="Ramabhadra" panose="02000600000000000000" pitchFamily="2" charset="0"/>
-                <a:cs typeface="Ramabhadra" panose="02000600000000000000" pitchFamily="2" charset="0"/>
-              </a:rPr>
-              <a:t>నేనూహించలేను యేసయ్యా (2)</a:t>
-            </a:r>
-          </a:p>
-          <a:p>
-            <a:pPr algn="ctr" defTabSz="439781"/>
-            <a:r>
-              <a:rPr lang="te-IN" sz="1400" dirty="0">
+                <a:effectLst/>
+                <a:uLnTx/>
+                <a:uFillTx/>
+                <a:latin typeface="Ramabhadra" panose="02000600000000000000" pitchFamily="2" charset="0"/>
+                <a:cs typeface="Ramabhadra" panose="02000600000000000000" pitchFamily="2" charset="0"/>
+              </a:rPr>
+              <a:t>నా యాత్మ నాలో కృంగెనే ప్రభూ -2</a:t>
+            </a:r>
+          </a:p>
+          <a:p>
+            <a:pPr marL="0" marR="0" lvl="0" indent="0" algn="ctr" defTabSz="439781" rtl="0" eaLnBrk="1" fontAlgn="auto" latinLnBrk="0" hangingPunct="1">
+              <a:spcBef>
+                <a:spcPts val="0"/>
+              </a:spcBef>
+              <a:spcAft>
+                <a:spcPts val="0"/>
+              </a:spcAft>
+              <a:buClrTx/>
+              <a:buSzTx/>
+              <a:buFontTx/>
+              <a:buNone/>
+              <a:tabLst/>
+              <a:defRPr/>
+            </a:pPr>
+            <a:r>
+              <a:rPr kumimoji="0" lang="te-IN" i="0" u="none" strike="noStrike" kern="1200" cap="none" spc="0" normalizeH="0" baseline="0" noProof="0" dirty="0">
+                <a:ln>
+                  <a:noFill/>
+                </a:ln>
                 <a:solidFill>
                   <a:schemeClr val="tx1"/>
                 </a:solidFill>
-                <a:latin typeface="Ramabhadra" panose="02000600000000000000" pitchFamily="2" charset="0"/>
-                <a:cs typeface="Ramabhadra" panose="02000600000000000000" pitchFamily="2" charset="0"/>
-              </a:rPr>
-              <a:t>యేసయ్యా నీ కృప నాకు చాలయ్యా</a:t>
-            </a:r>
-          </a:p>
-          <a:p>
-            <a:pPr algn="ctr" defTabSz="439781"/>
-            <a:r>
-              <a:rPr lang="te-IN" sz="1400" dirty="0">
+                <a:effectLst/>
+                <a:uLnTx/>
+                <a:uFillTx/>
+                <a:latin typeface="Ramabhadra" panose="02000600000000000000" pitchFamily="2" charset="0"/>
+                <a:cs typeface="Ramabhadra" panose="02000600000000000000" pitchFamily="2" charset="0"/>
+              </a:rPr>
+              <a:t>నా మనస్సు నీ వైపు త్రిప్పిన వెంటనే - శత్రుల చేతినుండి</a:t>
+            </a:r>
+          </a:p>
+          <a:p>
+            <a:pPr marL="0" marR="0" lvl="0" indent="0" algn="ctr" defTabSz="439781" rtl="0" eaLnBrk="1" fontAlgn="auto" latinLnBrk="0" hangingPunct="1">
+              <a:spcBef>
+                <a:spcPts val="0"/>
+              </a:spcBef>
+              <a:spcAft>
+                <a:spcPts val="0"/>
+              </a:spcAft>
+              <a:buClrTx/>
+              <a:buSzTx/>
+              <a:buFontTx/>
+              <a:buNone/>
+              <a:tabLst/>
+              <a:defRPr/>
+            </a:pPr>
+            <a:r>
+              <a:rPr kumimoji="0" lang="te-IN" i="0" u="none" strike="noStrike" kern="1200" cap="none" spc="0" normalizeH="0" baseline="0" noProof="0" dirty="0">
+                <a:ln>
+                  <a:noFill/>
+                </a:ln>
                 <a:solidFill>
                   <a:schemeClr val="tx1"/>
                 </a:solidFill>
-                <a:latin typeface="Ramabhadra" panose="02000600000000000000" pitchFamily="2" charset="0"/>
-                <a:cs typeface="Ramabhadra" panose="02000600000000000000" pitchFamily="2" charset="0"/>
-              </a:rPr>
-              <a:t>నీ కృప లేనిదే నేనుండలేనయ్యా (2) ||నీ కృప||</a:t>
-            </a:r>
-          </a:p>
-          <a:p>
-            <a:pPr algn="ctr" defTabSz="439781"/>
-            <a:endParaRPr lang="te-IN" sz="1400" dirty="0">
+                <a:effectLst/>
+                <a:uLnTx/>
+                <a:uFillTx/>
+                <a:latin typeface="Ramabhadra" panose="02000600000000000000" pitchFamily="2" charset="0"/>
+                <a:cs typeface="Ramabhadra" panose="02000600000000000000" pitchFamily="2" charset="0"/>
+              </a:rPr>
+              <a:t>విడిపించినావు - కాపాడినావు -2</a:t>
+            </a:r>
+          </a:p>
+          <a:p>
+            <a:pPr marL="0" marR="0" lvl="0" indent="0" algn="ctr" defTabSz="439781" rtl="0" eaLnBrk="1" fontAlgn="auto" latinLnBrk="0" hangingPunct="1">
+              <a:spcBef>
+                <a:spcPts val="0"/>
+              </a:spcBef>
+              <a:spcAft>
+                <a:spcPts val="0"/>
+              </a:spcAft>
+              <a:buClrTx/>
+              <a:buSzTx/>
+              <a:buFontTx/>
+              <a:buNone/>
+              <a:tabLst/>
+              <a:defRPr/>
+            </a:pPr>
+            <a:endParaRPr kumimoji="0" lang="te-IN" i="0" u="none" strike="noStrike" kern="1200" cap="none" spc="0" normalizeH="0" baseline="0" noProof="0" dirty="0">
+              <a:ln>
+                <a:noFill/>
+              </a:ln>
               <a:solidFill>
                 <a:schemeClr val="tx1"/>
               </a:solidFill>
+              <a:effectLst/>
+              <a:uLnTx/>
+              <a:uFillTx/>
               <a:latin typeface="Ramabhadra" panose="02000600000000000000" pitchFamily="2" charset="0"/>
               <a:cs typeface="Ramabhadra" panose="02000600000000000000" pitchFamily="2" charset="0"/>
             </a:endParaRPr>
           </a:p>
           <a:p>
-            <a:pPr algn="ctr" defTabSz="439781"/>
-            <a:r>
-              <a:rPr lang="te-IN" sz="1400" dirty="0">
+            <a:pPr marL="0" marR="0" lvl="0" indent="0" algn="ctr" defTabSz="439781" rtl="0" eaLnBrk="1" fontAlgn="auto" latinLnBrk="0" hangingPunct="1">
+              <a:spcBef>
+                <a:spcPts val="0"/>
+              </a:spcBef>
+              <a:spcAft>
+                <a:spcPts val="0"/>
+              </a:spcAft>
+              <a:buClrTx/>
+              <a:buSzTx/>
+              <a:buFontTx/>
+              <a:buNone/>
+              <a:tabLst/>
+              <a:defRPr/>
+            </a:pPr>
+            <a:r>
+              <a:rPr kumimoji="0" lang="te-IN" i="0" u="none" strike="noStrike" kern="1200" cap="none" spc="0" normalizeH="0" baseline="0" noProof="0" dirty="0">
+                <a:ln>
+                  <a:noFill/>
+                </a:ln>
                 <a:solidFill>
                   <a:schemeClr val="tx1"/>
                 </a:solidFill>
-                <a:latin typeface="Ramabhadra" panose="02000600000000000000" pitchFamily="2" charset="0"/>
-                <a:cs typeface="Ramabhadra" panose="02000600000000000000" pitchFamily="2" charset="0"/>
-              </a:rPr>
-              <a:t>మహిమను విడిచి మహిలోకి దిగి వచ్చి</a:t>
-            </a:r>
-          </a:p>
-          <a:p>
-            <a:pPr algn="ctr" defTabSz="439781"/>
-            <a:r>
-              <a:rPr lang="te-IN" sz="1400" dirty="0">
+                <a:effectLst/>
+                <a:uLnTx/>
+                <a:uFillTx/>
+                <a:latin typeface="Ramabhadra" panose="02000600000000000000" pitchFamily="2" charset="0"/>
+                <a:cs typeface="Ramabhadra" panose="02000600000000000000" pitchFamily="2" charset="0"/>
+              </a:rPr>
+              <a:t>నా ప్రాణ స్నేహితులు నన్ను చూచి దూరాన నిలిచేరు నా ప్రభూ -2</a:t>
+            </a:r>
+          </a:p>
+          <a:p>
+            <a:pPr marL="0" marR="0" lvl="0" indent="0" algn="ctr" defTabSz="439781" rtl="0" eaLnBrk="1" fontAlgn="auto" latinLnBrk="0" hangingPunct="1">
+              <a:spcBef>
+                <a:spcPts val="0"/>
+              </a:spcBef>
+              <a:spcAft>
+                <a:spcPts val="0"/>
+              </a:spcAft>
+              <a:buClrTx/>
+              <a:buSzTx/>
+              <a:buFontTx/>
+              <a:buNone/>
+              <a:tabLst/>
+              <a:defRPr/>
+            </a:pPr>
+            <a:r>
+              <a:rPr kumimoji="0" lang="te-IN" i="0" u="none" strike="noStrike" kern="1200" cap="none" spc="0" normalizeH="0" baseline="0" noProof="0" dirty="0">
+                <a:ln>
+                  <a:noFill/>
+                </a:ln>
                 <a:solidFill>
                   <a:schemeClr val="tx1"/>
                 </a:solidFill>
-                <a:latin typeface="Ramabhadra" panose="02000600000000000000" pitchFamily="2" charset="0"/>
-                <a:cs typeface="Ramabhadra" panose="02000600000000000000" pitchFamily="2" charset="0"/>
-              </a:rPr>
-              <a:t>మార్గముగా మారి మనిషిగా మార్చావు</a:t>
-            </a:r>
-          </a:p>
-          <a:p>
-            <a:pPr algn="ctr" defTabSz="439781"/>
-            <a:r>
-              <a:rPr lang="te-IN" sz="1400" dirty="0">
+                <a:effectLst/>
+                <a:uLnTx/>
+                <a:uFillTx/>
+                <a:latin typeface="Ramabhadra" panose="02000600000000000000" pitchFamily="2" charset="0"/>
+                <a:cs typeface="Ramabhadra" panose="02000600000000000000" pitchFamily="2" charset="0"/>
+              </a:rPr>
+              <a:t>నీ వాక్య ధ్యానమే నా త్రోవకు వెలుగై –</a:t>
+            </a:r>
+          </a:p>
+          <a:p>
+            <a:pPr marL="0" marR="0" lvl="0" indent="0" algn="ctr" defTabSz="439781" rtl="0" eaLnBrk="1" fontAlgn="auto" latinLnBrk="0" hangingPunct="1">
+              <a:spcBef>
+                <a:spcPts val="0"/>
+              </a:spcBef>
+              <a:spcAft>
+                <a:spcPts val="0"/>
+              </a:spcAft>
+              <a:buClrTx/>
+              <a:buSzTx/>
+              <a:buFontTx/>
+              <a:buNone/>
+              <a:tabLst/>
+              <a:defRPr/>
+            </a:pPr>
+            <a:r>
+              <a:rPr kumimoji="0" lang="te-IN" i="0" u="none" strike="noStrike" kern="1200" cap="none" spc="0" normalizeH="0" baseline="0" noProof="0" dirty="0">
+                <a:ln>
+                  <a:noFill/>
+                </a:ln>
                 <a:solidFill>
                   <a:schemeClr val="tx1"/>
                 </a:solidFill>
-                <a:latin typeface="Ramabhadra" panose="02000600000000000000" pitchFamily="2" charset="0"/>
-                <a:cs typeface="Ramabhadra" panose="02000600000000000000" pitchFamily="2" charset="0"/>
-              </a:rPr>
-              <a:t>మహిని నీవు మాధుర్యముగా మార్చి</a:t>
-            </a:r>
-          </a:p>
-          <a:p>
-            <a:pPr algn="ctr" defTabSz="439781"/>
-            <a:r>
-              <a:rPr lang="te-IN" sz="1400" dirty="0">
+                <a:effectLst/>
+                <a:uLnTx/>
+                <a:uFillTx/>
+                <a:latin typeface="Ramabhadra" panose="02000600000000000000" pitchFamily="2" charset="0"/>
+                <a:cs typeface="Ramabhadra" panose="02000600000000000000" pitchFamily="2" charset="0"/>
+              </a:rPr>
+              <a:t>నను నిల్పెను</a:t>
+            </a:r>
+          </a:p>
+          <a:p>
+            <a:pPr marL="0" marR="0" lvl="0" indent="0" algn="ctr" defTabSz="439781" rtl="0" eaLnBrk="1" fontAlgn="auto" latinLnBrk="0" hangingPunct="1">
+              <a:spcBef>
+                <a:spcPts val="0"/>
+              </a:spcBef>
+              <a:spcAft>
+                <a:spcPts val="0"/>
+              </a:spcAft>
+              <a:buClrTx/>
+              <a:buSzTx/>
+              <a:buFontTx/>
+              <a:buNone/>
+              <a:tabLst/>
+              <a:defRPr/>
+            </a:pPr>
+            <a:r>
+              <a:rPr kumimoji="0" lang="te-IN" i="0" u="none" strike="noStrike" kern="1200" cap="none" spc="0" normalizeH="0" baseline="0" noProof="0" dirty="0">
+                <a:ln>
+                  <a:noFill/>
+                </a:ln>
                 <a:solidFill>
                   <a:schemeClr val="tx1"/>
                 </a:solidFill>
-                <a:latin typeface="Ramabhadra" panose="02000600000000000000" pitchFamily="2" charset="0"/>
-                <a:cs typeface="Ramabhadra" panose="02000600000000000000" pitchFamily="2" charset="0"/>
-              </a:rPr>
-              <a:t>మాదిరి చూపి మరో రూపమిచ్చావు (2)</a:t>
-            </a:r>
-          </a:p>
-          <a:p>
-            <a:pPr algn="ctr" defTabSz="439781"/>
-            <a:r>
-              <a:rPr lang="te-IN" sz="1400" dirty="0">
-                <a:solidFill>
-                  <a:schemeClr val="tx1"/>
-                </a:solidFill>
-                <a:latin typeface="Ramabhadra" panose="02000600000000000000" pitchFamily="2" charset="0"/>
-                <a:cs typeface="Ramabhadra" panose="02000600000000000000" pitchFamily="2" charset="0"/>
-              </a:rPr>
-              <a:t>మహిమలో నేను మహిమను పొంద</a:t>
-            </a:r>
-          </a:p>
-          <a:p>
-            <a:pPr algn="ctr" defTabSz="439781"/>
-            <a:r>
-              <a:rPr lang="te-IN" sz="1400" dirty="0">
-                <a:solidFill>
-                  <a:schemeClr val="tx1"/>
-                </a:solidFill>
-                <a:latin typeface="Ramabhadra" panose="02000600000000000000" pitchFamily="2" charset="0"/>
-                <a:cs typeface="Ramabhadra" panose="02000600000000000000" pitchFamily="2" charset="0"/>
-              </a:rPr>
-              <a:t>మహిమగా మార్చింది నీ కృప (2) ||యేసయ్యా||</a:t>
-            </a:r>
-          </a:p>
-          <a:p>
-            <a:pPr algn="ctr" defTabSz="439781"/>
-            <a:endParaRPr lang="te-IN" sz="1400" dirty="0">
-              <a:solidFill>
-                <a:schemeClr val="tx1"/>
-              </a:solidFill>
-              <a:latin typeface="Ramabhadra" panose="02000600000000000000" pitchFamily="2" charset="0"/>
-              <a:cs typeface="Ramabhadra" panose="02000600000000000000" pitchFamily="2" charset="0"/>
-            </a:endParaRPr>
-          </a:p>
-          <a:p>
-            <a:pPr algn="ctr" defTabSz="439781"/>
-            <a:r>
-              <a:rPr lang="te-IN" sz="1400" dirty="0">
-                <a:solidFill>
-                  <a:schemeClr val="tx1"/>
-                </a:solidFill>
-                <a:latin typeface="Ramabhadra" panose="02000600000000000000" pitchFamily="2" charset="0"/>
-                <a:cs typeface="Ramabhadra" panose="02000600000000000000" pitchFamily="2" charset="0"/>
-              </a:rPr>
-              <a:t>ఆజ్ఞల మార్గమున ఆశ్రయమును ఇచ్చి</a:t>
-            </a:r>
-          </a:p>
-          <a:p>
-            <a:pPr algn="ctr" defTabSz="439781"/>
-            <a:r>
-              <a:rPr lang="te-IN" sz="1400" dirty="0">
-                <a:solidFill>
-                  <a:schemeClr val="tx1"/>
-                </a:solidFill>
-                <a:latin typeface="Ramabhadra" panose="02000600000000000000" pitchFamily="2" charset="0"/>
-                <a:cs typeface="Ramabhadra" panose="02000600000000000000" pitchFamily="2" charset="0"/>
-              </a:rPr>
-              <a:t>ఆపత్కాలమున ఆదుకొన్నావు</a:t>
-            </a:r>
-          </a:p>
-          <a:p>
-            <a:pPr algn="ctr" defTabSz="439781"/>
-            <a:r>
-              <a:rPr lang="te-IN" sz="1400" dirty="0">
-                <a:solidFill>
-                  <a:schemeClr val="tx1"/>
-                </a:solidFill>
-                <a:latin typeface="Ramabhadra" panose="02000600000000000000" pitchFamily="2" charset="0"/>
-                <a:cs typeface="Ramabhadra" panose="02000600000000000000" pitchFamily="2" charset="0"/>
-              </a:rPr>
-              <a:t>ఆత్మీయులతో ఆనందింప చేసి</a:t>
-            </a:r>
-          </a:p>
-          <a:p>
-            <a:pPr algn="ctr" defTabSz="439781"/>
-            <a:r>
-              <a:rPr lang="te-IN" sz="1400" dirty="0">
-                <a:solidFill>
-                  <a:schemeClr val="tx1"/>
-                </a:solidFill>
-                <a:latin typeface="Ramabhadra" panose="02000600000000000000" pitchFamily="2" charset="0"/>
-                <a:cs typeface="Ramabhadra" panose="02000600000000000000" pitchFamily="2" charset="0"/>
-              </a:rPr>
-              <a:t>ఆనంద తైలముతో అభిషేకించావు (2)</a:t>
-            </a:r>
-          </a:p>
-          <a:p>
-            <a:pPr algn="ctr" defTabSz="439781"/>
-            <a:r>
-              <a:rPr lang="te-IN" sz="1400" dirty="0">
-                <a:solidFill>
-                  <a:schemeClr val="tx1"/>
-                </a:solidFill>
-                <a:latin typeface="Ramabhadra" panose="02000600000000000000" pitchFamily="2" charset="0"/>
-                <a:cs typeface="Ramabhadra" panose="02000600000000000000" pitchFamily="2" charset="0"/>
-              </a:rPr>
-              <a:t>ఆశ తీర ఆరాధన చేసే</a:t>
-            </a:r>
-          </a:p>
-          <a:p>
-            <a:pPr algn="ctr" defTabSz="439781"/>
-            <a:r>
-              <a:rPr lang="te-IN" sz="1400" dirty="0">
-                <a:solidFill>
-                  <a:schemeClr val="tx1"/>
-                </a:solidFill>
-                <a:latin typeface="Ramabhadra" panose="02000600000000000000" pitchFamily="2" charset="0"/>
-                <a:cs typeface="Ramabhadra" panose="02000600000000000000" pitchFamily="2" charset="0"/>
-              </a:rPr>
-              <a:t>అదృష్టమిచ్చింది నీ కృప (2) ||యేసయ్యా||</a:t>
+                <a:effectLst/>
+                <a:uLnTx/>
+                <a:uFillTx/>
+                <a:latin typeface="Ramabhadra" panose="02000600000000000000" pitchFamily="2" charset="0"/>
+                <a:cs typeface="Ramabhadra" panose="02000600000000000000" pitchFamily="2" charset="0"/>
+              </a:rPr>
+              <a:t>నీ సన్నీధిలో - నీ సంఘములో -2</a:t>
             </a:r>
           </a:p>
         </p:txBody>
@@ -4981,7 +5204,7 @@
     </p:spTree>
     <p:extLst>
       <p:ext uri="{BB962C8B-B14F-4D97-AF65-F5344CB8AC3E}">
-        <p14:creationId xmlns:p14="http://schemas.microsoft.com/office/powerpoint/2010/main" val="268521446"/>
+        <p14:creationId xmlns:p14="http://schemas.microsoft.com/office/powerpoint/2010/main" val="1511661631"/>
       </p:ext>
     </p:extLst>
   </p:cSld>

</xml_diff>

<commit_message>
9 sunday songs june
</commit_message>
<xml_diff>
--- a/xerox.pptx
+++ b/xerox.pptx
@@ -224,7 +224,7 @@
           <a:p>
             <a:fld id="{3502DD63-DF8D-4AB8-92A0-0ECCF612C06C}" type="datetimeFigureOut">
               <a:rPr lang="en-IN" smtClean="0"/>
-              <a:t>01-06-2024</a:t>
+              <a:t>08-06-2024</a:t>
             </a:fld>
             <a:endParaRPr lang="en-IN"/>
           </a:p>
@@ -402,7 +402,7 @@
           <a:p>
             <a:fld id="{1AE741EC-1360-4793-999B-941E0396C9FA}" type="datetimeFigureOut">
               <a:rPr lang="en-IN" smtClean="0"/>
-              <a:t>01-06-2024</a:t>
+              <a:t>08-06-2024</a:t>
             </a:fld>
             <a:endParaRPr lang="en-IN"/>
           </a:p>
@@ -802,7 +802,7 @@
           <a:p>
             <a:fld id="{86FBD32F-FCAD-481A-B7D8-4D813FB7DB24}" type="datetimeFigureOut">
               <a:rPr lang="en-IN" smtClean="0"/>
-              <a:t>01-06-2024</a:t>
+              <a:t>08-06-2024</a:t>
             </a:fld>
             <a:endParaRPr lang="en-IN"/>
           </a:p>
@@ -972,7 +972,7 @@
           <a:p>
             <a:fld id="{86FBD32F-FCAD-481A-B7D8-4D813FB7DB24}" type="datetimeFigureOut">
               <a:rPr lang="en-IN" smtClean="0"/>
-              <a:t>01-06-2024</a:t>
+              <a:t>08-06-2024</a:t>
             </a:fld>
             <a:endParaRPr lang="en-IN"/>
           </a:p>
@@ -1152,7 +1152,7 @@
           <a:p>
             <a:fld id="{86FBD32F-FCAD-481A-B7D8-4D813FB7DB24}" type="datetimeFigureOut">
               <a:rPr lang="en-IN" smtClean="0"/>
-              <a:t>01-06-2024</a:t>
+              <a:t>08-06-2024</a:t>
             </a:fld>
             <a:endParaRPr lang="en-IN"/>
           </a:p>
@@ -1322,7 +1322,7 @@
           <a:p>
             <a:fld id="{86FBD32F-FCAD-481A-B7D8-4D813FB7DB24}" type="datetimeFigureOut">
               <a:rPr lang="en-IN" smtClean="0"/>
-              <a:t>01-06-2024</a:t>
+              <a:t>08-06-2024</a:t>
             </a:fld>
             <a:endParaRPr lang="en-IN"/>
           </a:p>
@@ -1566,7 +1566,7 @@
           <a:p>
             <a:fld id="{86FBD32F-FCAD-481A-B7D8-4D813FB7DB24}" type="datetimeFigureOut">
               <a:rPr lang="en-IN" smtClean="0"/>
-              <a:t>01-06-2024</a:t>
+              <a:t>08-06-2024</a:t>
             </a:fld>
             <a:endParaRPr lang="en-IN"/>
           </a:p>
@@ -1798,7 +1798,7 @@
           <a:p>
             <a:fld id="{86FBD32F-FCAD-481A-B7D8-4D813FB7DB24}" type="datetimeFigureOut">
               <a:rPr lang="en-IN" smtClean="0"/>
-              <a:t>01-06-2024</a:t>
+              <a:t>08-06-2024</a:t>
             </a:fld>
             <a:endParaRPr lang="en-IN"/>
           </a:p>
@@ -2165,7 +2165,7 @@
           <a:p>
             <a:fld id="{86FBD32F-FCAD-481A-B7D8-4D813FB7DB24}" type="datetimeFigureOut">
               <a:rPr lang="en-IN" smtClean="0"/>
-              <a:t>01-06-2024</a:t>
+              <a:t>08-06-2024</a:t>
             </a:fld>
             <a:endParaRPr lang="en-IN"/>
           </a:p>
@@ -2283,7 +2283,7 @@
           <a:p>
             <a:fld id="{86FBD32F-FCAD-481A-B7D8-4D813FB7DB24}" type="datetimeFigureOut">
               <a:rPr lang="en-IN" smtClean="0"/>
-              <a:t>01-06-2024</a:t>
+              <a:t>08-06-2024</a:t>
             </a:fld>
             <a:endParaRPr lang="en-IN"/>
           </a:p>
@@ -2378,7 +2378,7 @@
           <a:p>
             <a:fld id="{86FBD32F-FCAD-481A-B7D8-4D813FB7DB24}" type="datetimeFigureOut">
               <a:rPr lang="en-IN" smtClean="0"/>
-              <a:t>01-06-2024</a:t>
+              <a:t>08-06-2024</a:t>
             </a:fld>
             <a:endParaRPr lang="en-IN"/>
           </a:p>
@@ -2655,7 +2655,7 @@
           <a:p>
             <a:fld id="{86FBD32F-FCAD-481A-B7D8-4D813FB7DB24}" type="datetimeFigureOut">
               <a:rPr lang="en-IN" smtClean="0"/>
-              <a:t>01-06-2024</a:t>
+              <a:t>08-06-2024</a:t>
             </a:fld>
             <a:endParaRPr lang="en-IN"/>
           </a:p>
@@ -2912,7 +2912,7 @@
           <a:p>
             <a:fld id="{86FBD32F-FCAD-481A-B7D8-4D813FB7DB24}" type="datetimeFigureOut">
               <a:rPr lang="en-IN" smtClean="0"/>
-              <a:t>01-06-2024</a:t>
+              <a:t>08-06-2024</a:t>
             </a:fld>
             <a:endParaRPr lang="en-IN"/>
           </a:p>
@@ -3125,7 +3125,7 @@
           <a:p>
             <a:fld id="{86FBD32F-FCAD-481A-B7D8-4D813FB7DB24}" type="datetimeFigureOut">
               <a:rPr lang="en-IN" smtClean="0"/>
-              <a:t>01-06-2024</a:t>
+              <a:t>08-06-2024</a:t>
             </a:fld>
             <a:endParaRPr lang="en-IN"/>
           </a:p>
@@ -3590,7 +3590,7 @@
               </a:spcAft>
             </a:pPr>
             <a:r>
-              <a:rPr lang="te-IN" sz="1380" b="0" i="0" dirty="0">
+              <a:rPr lang="te-IN" b="0" i="0" dirty="0">
                 <a:solidFill>
                   <a:schemeClr val="tx1"/>
                 </a:solidFill>
@@ -3598,7 +3598,7 @@
                 <a:latin typeface="Ramabhadra" panose="02000600000000000000" pitchFamily="2" charset="0"/>
                 <a:cs typeface="Ramabhadra" panose="02000600000000000000" pitchFamily="2" charset="0"/>
               </a:rPr>
-              <a:t>కృపా క్షేమము నీ శాశ్వత జీవము</a:t>
+              <a:t>స్తుతియించెదా నీ నామం</a:t>
             </a:r>
           </a:p>
           <a:p>
@@ -3611,7 +3611,7 @@
               </a:spcAft>
             </a:pPr>
             <a:r>
-              <a:rPr lang="te-IN" sz="1380" b="0" i="0" dirty="0">
+              <a:rPr lang="te-IN" b="0" i="0" dirty="0">
                 <a:solidFill>
                   <a:schemeClr val="tx1"/>
                 </a:solidFill>
@@ -3619,7 +3619,7 @@
                 <a:latin typeface="Ramabhadra" panose="02000600000000000000" pitchFamily="2" charset="0"/>
                 <a:cs typeface="Ramabhadra" panose="02000600000000000000" pitchFamily="2" charset="0"/>
               </a:rPr>
-              <a:t>నా జీవిత కాలమంతయు నీవు దయచేయువాడవు (2)</a:t>
+              <a:t>దేవా అనుదినం </a:t>
             </a:r>
           </a:p>
           <a:p>
@@ -3632,7 +3632,7 @@
               </a:spcAft>
             </a:pPr>
             <a:r>
-              <a:rPr lang="te-IN" sz="1380" b="0" i="0" dirty="0">
+              <a:rPr lang="te-IN" b="0" i="0" dirty="0">
                 <a:solidFill>
                   <a:schemeClr val="tx1"/>
                 </a:solidFill>
@@ -3640,7 +3640,7 @@
                 <a:latin typeface="Ramabhadra" panose="02000600000000000000" pitchFamily="2" charset="0"/>
                 <a:cs typeface="Ramabhadra" panose="02000600000000000000" pitchFamily="2" charset="0"/>
               </a:rPr>
-              <a:t>మహోన్నతమైన నీ ఉపకారములు</a:t>
+              <a:t>స్తుతియించెదా నీ నామం</a:t>
             </a:r>
           </a:p>
           <a:p>
@@ -3653,7 +3653,7 @@
               </a:spcAft>
             </a:pPr>
             <a:r>
-              <a:rPr lang="te-IN" sz="1380" b="0" i="0" dirty="0">
+              <a:rPr lang="te-IN" b="0" i="0" dirty="0">
                 <a:solidFill>
                   <a:schemeClr val="tx1"/>
                 </a:solidFill>
@@ -3661,7 +3661,7 @@
                 <a:latin typeface="Ramabhadra" panose="02000600000000000000" pitchFamily="2" charset="0"/>
                 <a:cs typeface="Ramabhadra" panose="02000600000000000000" pitchFamily="2" charset="0"/>
               </a:rPr>
-              <a:t>తలంచుచు అనుక్షణము పరవశించనా</a:t>
+              <a:t>దేవా అనుక్షణం</a:t>
             </a:r>
           </a:p>
           <a:p>
@@ -3673,17 +3673,14 @@
                 <a:spcPts val="0"/>
               </a:spcAft>
             </a:pPr>
-            <a:r>
-              <a:rPr lang="te-IN" sz="1380" b="0" i="0" dirty="0">
-                <a:solidFill>
-                  <a:schemeClr val="tx1"/>
-                </a:solidFill>
-                <a:effectLst/>
-                <a:latin typeface="Ramabhadra" panose="02000600000000000000" pitchFamily="2" charset="0"/>
-                <a:cs typeface="Ramabhadra" panose="02000600000000000000" pitchFamily="2" charset="0"/>
-              </a:rPr>
-              <a:t>నీ కృపలోనే పరవశించనా</a:t>
-            </a:r>
+            <a:endParaRPr lang="te-IN" b="0" i="0" dirty="0">
+              <a:solidFill>
+                <a:schemeClr val="tx1"/>
+              </a:solidFill>
+              <a:effectLst/>
+              <a:latin typeface="Ramabhadra" panose="02000600000000000000" pitchFamily="2" charset="0"/>
+              <a:cs typeface="Ramabhadra" panose="02000600000000000000" pitchFamily="2" charset="0"/>
+            </a:endParaRPr>
           </a:p>
           <a:p>
             <a:pPr marL="0" marR="0" indent="0" algn="ctr" rtl="0" eaLnBrk="1" fontAlgn="auto" latinLnBrk="0" hangingPunct="1">
@@ -3694,14 +3691,17 @@
                 <a:spcPts val="0"/>
               </a:spcAft>
             </a:pPr>
-            <a:endParaRPr lang="te-IN" sz="1380" b="0" i="0" dirty="0">
-              <a:solidFill>
-                <a:schemeClr val="tx1"/>
-              </a:solidFill>
-              <a:effectLst/>
-              <a:latin typeface="Ramabhadra" panose="02000600000000000000" pitchFamily="2" charset="0"/>
-              <a:cs typeface="Ramabhadra" panose="02000600000000000000" pitchFamily="2" charset="0"/>
-            </a:endParaRPr>
+            <a:r>
+              <a:rPr lang="te-IN" b="0" i="0" dirty="0">
+                <a:solidFill>
+                  <a:schemeClr val="tx1"/>
+                </a:solidFill>
+                <a:effectLst/>
+                <a:latin typeface="Ramabhadra" panose="02000600000000000000" pitchFamily="2" charset="0"/>
+                <a:cs typeface="Ramabhadra" panose="02000600000000000000" pitchFamily="2" charset="0"/>
+              </a:rPr>
+              <a:t>దయతో కాపాడినావు</a:t>
+            </a:r>
           </a:p>
           <a:p>
             <a:pPr marL="0" marR="0" indent="0" algn="ctr" rtl="0" eaLnBrk="1" fontAlgn="auto" latinLnBrk="0" hangingPunct="1">
@@ -3713,7 +3713,7 @@
               </a:spcAft>
             </a:pPr>
             <a:r>
-              <a:rPr lang="te-IN" sz="1380" b="0" i="0" dirty="0">
+              <a:rPr lang="te-IN" b="0" i="0" dirty="0">
                 <a:solidFill>
                   <a:schemeClr val="tx1"/>
                 </a:solidFill>
@@ -3721,7 +3721,7 @@
                 <a:latin typeface="Ramabhadra" panose="02000600000000000000" pitchFamily="2" charset="0"/>
                 <a:cs typeface="Ramabhadra" panose="02000600000000000000" pitchFamily="2" charset="0"/>
               </a:rPr>
-              <a:t>నా ప్రతి ప్రార్ధనకు నీవిచ్చిన ఈవులే</a:t>
+              <a:t>కృపనే చూపించినావు (2) </a:t>
             </a:r>
           </a:p>
           <a:p>
@@ -3734,7 +3734,7 @@
               </a:spcAft>
             </a:pPr>
             <a:r>
-              <a:rPr lang="te-IN" sz="1380" b="0" i="0" dirty="0">
+              <a:rPr lang="te-IN" b="0" i="0" dirty="0">
                 <a:solidFill>
                   <a:schemeClr val="tx1"/>
                 </a:solidFill>
@@ -3742,7 +3742,7 @@
                 <a:latin typeface="Ramabhadra" panose="02000600000000000000" pitchFamily="2" charset="0"/>
                 <a:cs typeface="Ramabhadra" panose="02000600000000000000" pitchFamily="2" charset="0"/>
               </a:rPr>
-              <a:t>లెక్కకు మించిన దీవెనలైనాయి (2)</a:t>
+              <a:t>నిను నే మరువనేసు</a:t>
             </a:r>
           </a:p>
           <a:p>
@@ -3755,7 +3755,7 @@
               </a:spcAft>
             </a:pPr>
             <a:r>
-              <a:rPr lang="te-IN" sz="1380" b="0" i="0" dirty="0">
+              <a:rPr lang="te-IN" b="0" i="0" dirty="0">
                 <a:solidFill>
                   <a:schemeClr val="tx1"/>
                 </a:solidFill>
@@ -3763,7 +3763,7 @@
                 <a:latin typeface="Ramabhadra" panose="02000600000000000000" pitchFamily="2" charset="0"/>
                 <a:cs typeface="Ramabhadra" panose="02000600000000000000" pitchFamily="2" charset="0"/>
               </a:rPr>
-              <a:t>అడుగులు తడబడక నడిపినది నీ దివ్య వాక్యమే</a:t>
+              <a:t>నిను నే విడువనేసు</a:t>
             </a:r>
           </a:p>
           <a:p>
@@ -3776,7 +3776,7 @@
               </a:spcAft>
             </a:pPr>
             <a:r>
-              <a:rPr lang="te-IN" sz="1380" b="0" i="0" dirty="0">
+              <a:rPr lang="te-IN" b="0" i="0" dirty="0">
                 <a:solidFill>
                   <a:schemeClr val="tx1"/>
                 </a:solidFill>
@@ -3784,7 +3784,7 @@
                 <a:latin typeface="Ramabhadra" panose="02000600000000000000" pitchFamily="2" charset="0"/>
                 <a:cs typeface="Ramabhadra" panose="02000600000000000000" pitchFamily="2" charset="0"/>
               </a:rPr>
-              <a:t>కడలిని మించిన విశ్వాసమునిచ్చి</a:t>
+              <a:t> </a:t>
             </a:r>
           </a:p>
           <a:p>
@@ -3797,7 +3797,7 @@
               </a:spcAft>
             </a:pPr>
             <a:r>
-              <a:rPr lang="te-IN" sz="1380" b="0" i="0" dirty="0">
+              <a:rPr lang="te-IN" b="0" i="0" dirty="0">
                 <a:solidFill>
                   <a:schemeClr val="tx1"/>
                 </a:solidFill>
@@ -3805,7 +3805,7 @@
                 <a:latin typeface="Ramabhadra" panose="02000600000000000000" pitchFamily="2" charset="0"/>
                 <a:cs typeface="Ramabhadra" panose="02000600000000000000" pitchFamily="2" charset="0"/>
               </a:rPr>
-              <a:t>విజయము చేకూర్చెను (2)</a:t>
+              <a:t>పాపినై యుండగ నేను</a:t>
             </a:r>
           </a:p>
           <a:p>
@@ -3818,7 +3818,7 @@
               </a:spcAft>
             </a:pPr>
             <a:r>
-              <a:rPr lang="te-IN" sz="1380" b="0" i="0" dirty="0">
+              <a:rPr lang="te-IN" b="0" i="0" dirty="0">
                 <a:solidFill>
                   <a:schemeClr val="tx1"/>
                 </a:solidFill>
@@ -3826,7 +3826,7 @@
                 <a:latin typeface="Ramabhadra" panose="02000600000000000000" pitchFamily="2" charset="0"/>
                 <a:cs typeface="Ramabhadra" panose="02000600000000000000" pitchFamily="2" charset="0"/>
               </a:rPr>
-              <a:t>నీ వాక్యమే మకరంధమై బలపరిచెను నన్ను</a:t>
+              <a:t>రక్షించి దరి చేర్చినావు (2)  </a:t>
             </a:r>
           </a:p>
           <a:p>
@@ -3839,7 +3839,7 @@
               </a:spcAft>
             </a:pPr>
             <a:r>
-              <a:rPr lang="te-IN" sz="1380" b="0" i="0" dirty="0">
+              <a:rPr lang="te-IN" b="0" i="0" dirty="0">
                 <a:solidFill>
                   <a:schemeClr val="tx1"/>
                 </a:solidFill>
@@ -3847,7 +3847,7 @@
                 <a:latin typeface="Ramabhadra" panose="02000600000000000000" pitchFamily="2" charset="0"/>
                 <a:cs typeface="Ramabhadra" panose="02000600000000000000" pitchFamily="2" charset="0"/>
               </a:rPr>
-              <a:t>నా యేసయ్య స్తుతిపాత్రుడ ఆరాధన నీకే (2)</a:t>
+              <a:t>నిను నే మరువనేసు – నిను నే విడువనేసు</a:t>
             </a:r>
           </a:p>
           <a:p>
@@ -3859,17 +3859,14 @@
                 <a:spcPts val="0"/>
               </a:spcAft>
             </a:pPr>
-            <a:r>
-              <a:rPr lang="te-IN" sz="1380" b="0" i="0" dirty="0">
-                <a:solidFill>
-                  <a:schemeClr val="tx1"/>
-                </a:solidFill>
-                <a:effectLst/>
-                <a:latin typeface="Ramabhadra" panose="02000600000000000000" pitchFamily="2" charset="0"/>
-                <a:cs typeface="Ramabhadra" panose="02000600000000000000" pitchFamily="2" charset="0"/>
-              </a:rPr>
-              <a:t>ఆరాధన నీకే</a:t>
-            </a:r>
+            <a:endParaRPr lang="te-IN" b="0" i="0" dirty="0">
+              <a:solidFill>
+                <a:schemeClr val="tx1"/>
+              </a:solidFill>
+              <a:effectLst/>
+              <a:latin typeface="Ramabhadra" panose="02000600000000000000" pitchFamily="2" charset="0"/>
+              <a:cs typeface="Ramabhadra" panose="02000600000000000000" pitchFamily="2" charset="0"/>
+            </a:endParaRPr>
           </a:p>
           <a:p>
             <a:pPr marL="0" marR="0" indent="0" algn="ctr" rtl="0" eaLnBrk="1" fontAlgn="auto" latinLnBrk="0" hangingPunct="1">
@@ -3880,14 +3877,17 @@
                 <a:spcPts val="0"/>
               </a:spcAft>
             </a:pPr>
-            <a:endParaRPr lang="te-IN" sz="1380" b="0" i="0" dirty="0">
-              <a:solidFill>
-                <a:schemeClr val="tx1"/>
-              </a:solidFill>
-              <a:effectLst/>
-              <a:latin typeface="Ramabhadra" panose="02000600000000000000" pitchFamily="2" charset="0"/>
-              <a:cs typeface="Ramabhadra" panose="02000600000000000000" pitchFamily="2" charset="0"/>
-            </a:endParaRPr>
+            <a:r>
+              <a:rPr lang="te-IN" b="0" i="0" dirty="0">
+                <a:solidFill>
+                  <a:schemeClr val="tx1"/>
+                </a:solidFill>
+                <a:effectLst/>
+                <a:latin typeface="Ramabhadra" panose="02000600000000000000" pitchFamily="2" charset="0"/>
+                <a:cs typeface="Ramabhadra" panose="02000600000000000000" pitchFamily="2" charset="0"/>
+              </a:rPr>
+              <a:t>సిలువే నాకు శరణం నీవే నాకు మార్గం (2)  </a:t>
+            </a:r>
           </a:p>
           <a:p>
             <a:pPr marL="0" marR="0" indent="0" algn="ctr" rtl="0" eaLnBrk="1" fontAlgn="auto" latinLnBrk="0" hangingPunct="1">
@@ -3899,7 +3899,7 @@
               </a:spcAft>
             </a:pPr>
             <a:r>
-              <a:rPr lang="te-IN" sz="1380" b="0" i="0" dirty="0">
+              <a:rPr lang="te-IN" b="0" i="0" dirty="0">
                 <a:solidFill>
                   <a:schemeClr val="tx1"/>
                 </a:solidFill>
@@ -3907,133 +3907,7 @@
                 <a:latin typeface="Ramabhadra" panose="02000600000000000000" pitchFamily="2" charset="0"/>
                 <a:cs typeface="Ramabhadra" panose="02000600000000000000" pitchFamily="2" charset="0"/>
               </a:rPr>
-              <a:t>నీ సత్య మార్గములో ఫలించిన అనుభవమే</a:t>
-            </a:r>
-          </a:p>
-          <a:p>
-            <a:pPr marL="0" marR="0" indent="0" algn="ctr" rtl="0" eaLnBrk="1" fontAlgn="auto" latinLnBrk="0" hangingPunct="1">
-              <a:spcBef>
-                <a:spcPts val="0"/>
-              </a:spcBef>
-              <a:spcAft>
-                <a:spcPts val="0"/>
-              </a:spcAft>
-            </a:pPr>
-            <a:r>
-              <a:rPr lang="te-IN" sz="1380" b="0" i="0" dirty="0">
-                <a:solidFill>
-                  <a:schemeClr val="tx1"/>
-                </a:solidFill>
-                <a:effectLst/>
-                <a:latin typeface="Ramabhadra" panose="02000600000000000000" pitchFamily="2" charset="0"/>
-                <a:cs typeface="Ramabhadra" panose="02000600000000000000" pitchFamily="2" charset="0"/>
-              </a:rPr>
-              <a:t>పరిమళింపచేసి సాక్షిగ నిలిపాయి (2)</a:t>
-            </a:r>
-          </a:p>
-          <a:p>
-            <a:pPr marL="0" marR="0" indent="0" algn="ctr" rtl="0" eaLnBrk="1" fontAlgn="auto" latinLnBrk="0" hangingPunct="1">
-              <a:spcBef>
-                <a:spcPts val="0"/>
-              </a:spcBef>
-              <a:spcAft>
-                <a:spcPts val="0"/>
-              </a:spcAft>
-            </a:pPr>
-            <a:r>
-              <a:rPr lang="te-IN" sz="1380" b="0" i="0" dirty="0">
-                <a:solidFill>
-                  <a:schemeClr val="tx1"/>
-                </a:solidFill>
-                <a:effectLst/>
-                <a:latin typeface="Ramabhadra" panose="02000600000000000000" pitchFamily="2" charset="0"/>
-                <a:cs typeface="Ramabhadra" panose="02000600000000000000" pitchFamily="2" charset="0"/>
-              </a:rPr>
-              <a:t>కలతచెందక నిలిపినది నీ దివ్య దర్శనమే</a:t>
-            </a:r>
-          </a:p>
-          <a:p>
-            <a:pPr marL="0" marR="0" indent="0" algn="ctr" rtl="0" eaLnBrk="1" fontAlgn="auto" latinLnBrk="0" hangingPunct="1">
-              <a:spcBef>
-                <a:spcPts val="0"/>
-              </a:spcBef>
-              <a:spcAft>
-                <a:spcPts val="0"/>
-              </a:spcAft>
-            </a:pPr>
-            <a:r>
-              <a:rPr lang="te-IN" sz="1380" b="0" i="0" dirty="0">
-                <a:solidFill>
-                  <a:schemeClr val="tx1"/>
-                </a:solidFill>
-                <a:effectLst/>
-                <a:latin typeface="Ramabhadra" panose="02000600000000000000" pitchFamily="2" charset="0"/>
-                <a:cs typeface="Ramabhadra" panose="02000600000000000000" pitchFamily="2" charset="0"/>
-              </a:rPr>
-              <a:t>గమ్యము చేరే శక్తితో నను నింపి నూతన కృపనిచ్చెను (2)</a:t>
-            </a:r>
-          </a:p>
-          <a:p>
-            <a:pPr marL="0" marR="0" indent="0" algn="ctr" rtl="0" eaLnBrk="1" fontAlgn="auto" latinLnBrk="0" hangingPunct="1">
-              <a:spcBef>
-                <a:spcPts val="0"/>
-              </a:spcBef>
-              <a:spcAft>
-                <a:spcPts val="0"/>
-              </a:spcAft>
-            </a:pPr>
-            <a:r>
-              <a:rPr lang="te-IN" sz="1380" b="0" i="0" dirty="0">
-                <a:solidFill>
-                  <a:schemeClr val="tx1"/>
-                </a:solidFill>
-                <a:effectLst/>
-                <a:latin typeface="Ramabhadra" panose="02000600000000000000" pitchFamily="2" charset="0"/>
-                <a:cs typeface="Ramabhadra" panose="02000600000000000000" pitchFamily="2" charset="0"/>
-              </a:rPr>
-              <a:t>ఆరాధ్యుడా అభిషిక్తుడా ఆరాధన నీకే</a:t>
-            </a:r>
-          </a:p>
-          <a:p>
-            <a:pPr marL="0" marR="0" indent="0" algn="ctr" rtl="0" eaLnBrk="1" fontAlgn="auto" latinLnBrk="0" hangingPunct="1">
-              <a:spcBef>
-                <a:spcPts val="0"/>
-              </a:spcBef>
-              <a:spcAft>
-                <a:spcPts val="0"/>
-              </a:spcAft>
-            </a:pPr>
-            <a:r>
-              <a:rPr lang="te-IN" sz="1380" b="0" i="0" dirty="0">
-                <a:solidFill>
-                  <a:schemeClr val="tx1"/>
-                </a:solidFill>
-                <a:effectLst/>
-                <a:latin typeface="Ramabhadra" panose="02000600000000000000" pitchFamily="2" charset="0"/>
-                <a:cs typeface="Ramabhadra" panose="02000600000000000000" pitchFamily="2" charset="0"/>
-              </a:rPr>
-              <a:t>నా యేసయ్య స్తుతిపాత్రుడ ఆరాధన నీకే (2)</a:t>
-            </a:r>
-          </a:p>
-          <a:p>
-            <a:pPr marL="0" marR="0" indent="0" algn="ctr" rtl="0" eaLnBrk="1" fontAlgn="auto" latinLnBrk="0" hangingPunct="1">
-              <a:spcBef>
-                <a:spcPts val="0"/>
-              </a:spcBef>
-              <a:spcAft>
-                <a:spcPts val="0"/>
-              </a:spcAft>
-            </a:pPr>
-            <a:r>
-              <a:rPr lang="te-IN" sz="1380" b="0" i="0" dirty="0">
-                <a:solidFill>
-                  <a:schemeClr val="tx1"/>
-                </a:solidFill>
-                <a:effectLst/>
-                <a:latin typeface="Ramabhadra" panose="02000600000000000000" pitchFamily="2" charset="0"/>
-                <a:cs typeface="Ramabhadra" panose="02000600000000000000" pitchFamily="2" charset="0"/>
-              </a:rPr>
-              <a:t>ఆరాధన నీకే</a:t>
+              <a:t>నిను నే మరువనేసు – నిను నే విడువనేసు </a:t>
             </a:r>
           </a:p>
         </p:txBody>
@@ -4091,7 +3965,7 @@
           <a:p>
             <a:pPr algn="ctr"/>
             <a:r>
-              <a:rPr lang="te-IN" sz="1450" b="0" i="0" dirty="0">
+              <a:rPr lang="te-IN" sz="1600" b="0" i="0" dirty="0">
                 <a:solidFill>
                   <a:srgbClr val="000000"/>
                 </a:solidFill>
@@ -4099,10 +3973,10 @@
                 <a:latin typeface="Ramabhadra" panose="02000600000000000000" pitchFamily="2" charset="0"/>
                 <a:cs typeface="Ramabhadra" panose="02000600000000000000" pitchFamily="2" charset="0"/>
               </a:rPr>
-              <a:t>పరిశుద్ధుడవై – మహిమ ప్రభావములకు నీవే పాత్రుడవు</a:t>
+              <a:t>(యేసు) రాజా నీ భవనములో</a:t>
             </a:r>
             <a:br>
-              <a:rPr lang="te-IN" sz="1450" b="0" i="0" dirty="0">
+              <a:rPr lang="te-IN" sz="1600" b="0" i="0" dirty="0">
                 <a:solidFill>
                   <a:srgbClr val="000000"/>
                 </a:solidFill>
@@ -4112,7 +3986,7 @@
               </a:rPr>
             </a:br>
             <a:r>
-              <a:rPr lang="te-IN" sz="1450" b="0" i="0" dirty="0">
+              <a:rPr lang="te-IN" sz="1600" b="0" i="0" dirty="0">
                 <a:solidFill>
                   <a:srgbClr val="000000"/>
                 </a:solidFill>
@@ -4120,117 +3994,54 @@
                 <a:latin typeface="Ramabhadra" panose="02000600000000000000" pitchFamily="2" charset="0"/>
                 <a:cs typeface="Ramabhadra" panose="02000600000000000000" pitchFamily="2" charset="0"/>
               </a:rPr>
-              <a:t>బలవంతుడవై – దీనుల పక్షమై</a:t>
+              <a:t>రేయి పగలు వేచియుందును (2)</a:t>
+            </a:r>
+            <a:br>
+              <a:rPr lang="te-IN" sz="1600" b="0" i="0" dirty="0">
+                <a:solidFill>
+                  <a:srgbClr val="000000"/>
+                </a:solidFill>
+                <a:effectLst/>
+                <a:latin typeface="Ramabhadra" panose="02000600000000000000" pitchFamily="2" charset="0"/>
+                <a:cs typeface="Ramabhadra" panose="02000600000000000000" pitchFamily="2" charset="0"/>
+              </a:rPr>
+            </a:br>
+            <a:r>
+              <a:rPr lang="te-IN" sz="1600" b="0" i="0" dirty="0">
+                <a:solidFill>
+                  <a:srgbClr val="000000"/>
+                </a:solidFill>
+                <a:effectLst/>
+                <a:latin typeface="Ramabhadra" panose="02000600000000000000" pitchFamily="2" charset="0"/>
+                <a:cs typeface="Ramabhadra" panose="02000600000000000000" pitchFamily="2" charset="0"/>
+              </a:rPr>
+              <a:t>(నిన్ను) స్తుతించి ఆనందింతును</a:t>
+            </a:r>
+            <a:br>
+              <a:rPr lang="te-IN" sz="1600" b="0" i="0" dirty="0">
+                <a:solidFill>
+                  <a:srgbClr val="000000"/>
+                </a:solidFill>
+                <a:effectLst/>
+                <a:latin typeface="Ramabhadra" panose="02000600000000000000" pitchFamily="2" charset="0"/>
+                <a:cs typeface="Ramabhadra" panose="02000600000000000000" pitchFamily="2" charset="0"/>
+              </a:rPr>
+            </a:br>
+            <a:r>
+              <a:rPr lang="te-IN" sz="1600" b="0" i="0" dirty="0">
+                <a:solidFill>
+                  <a:srgbClr val="000000"/>
+                </a:solidFill>
+                <a:effectLst/>
+                <a:latin typeface="Ramabhadra" panose="02000600000000000000" pitchFamily="2" charset="0"/>
+                <a:cs typeface="Ramabhadra" panose="02000600000000000000" pitchFamily="2" charset="0"/>
+              </a:rPr>
+              <a:t>చింతలు మరచెదను (2)</a:t>
             </a:r>
           </a:p>
           <a:p>
             <a:pPr algn="ctr"/>
-            <a:r>
-              <a:rPr lang="te-IN" sz="1450" b="0" i="0" dirty="0">
-                <a:solidFill>
-                  <a:srgbClr val="000000"/>
-                </a:solidFill>
-                <a:effectLst/>
-                <a:latin typeface="Ramabhadra" panose="02000600000000000000" pitchFamily="2" charset="0"/>
-                <a:cs typeface="Ramabhadra" panose="02000600000000000000" pitchFamily="2" charset="0"/>
-              </a:rPr>
-              <a:t>కృప చూపు వాడవు (2)</a:t>
-            </a:r>
-            <a:br>
-              <a:rPr lang="te-IN" sz="1450" b="0" i="0" dirty="0">
-                <a:solidFill>
-                  <a:srgbClr val="000000"/>
-                </a:solidFill>
-                <a:effectLst/>
-                <a:latin typeface="Ramabhadra" panose="02000600000000000000" pitchFamily="2" charset="0"/>
-                <a:cs typeface="Ramabhadra" panose="02000600000000000000" pitchFamily="2" charset="0"/>
-              </a:rPr>
-            </a:br>
-            <a:r>
-              <a:rPr lang="te-IN" sz="1450" b="0" i="0" dirty="0">
-                <a:solidFill>
-                  <a:srgbClr val="000000"/>
-                </a:solidFill>
-                <a:effectLst/>
-                <a:latin typeface="Ramabhadra" panose="02000600000000000000" pitchFamily="2" charset="0"/>
-                <a:cs typeface="Ramabhadra" panose="02000600000000000000" pitchFamily="2" charset="0"/>
-              </a:rPr>
-              <a:t>దయాళుడవై – ధారాళముగా </a:t>
-            </a:r>
-          </a:p>
-          <a:p>
-            <a:pPr algn="ctr"/>
-            <a:r>
-              <a:rPr lang="te-IN" sz="1450" b="0" i="0" dirty="0">
-                <a:solidFill>
-                  <a:srgbClr val="000000"/>
-                </a:solidFill>
-                <a:effectLst/>
-                <a:latin typeface="Ramabhadra" panose="02000600000000000000" pitchFamily="2" charset="0"/>
-                <a:cs typeface="Ramabhadra" panose="02000600000000000000" pitchFamily="2" charset="0"/>
-              </a:rPr>
-              <a:t>నను దీవించిన శ్రీమంతుడా</a:t>
-            </a:r>
-            <a:br>
-              <a:rPr lang="te-IN" sz="1450" b="0" i="0" dirty="0">
-                <a:solidFill>
-                  <a:srgbClr val="000000"/>
-                </a:solidFill>
-                <a:effectLst/>
-                <a:latin typeface="Ramabhadra" panose="02000600000000000000" pitchFamily="2" charset="0"/>
-                <a:cs typeface="Ramabhadra" panose="02000600000000000000" pitchFamily="2" charset="0"/>
-              </a:rPr>
-            </a:br>
-            <a:r>
-              <a:rPr lang="te-IN" sz="1450" b="0" i="0" dirty="0">
-                <a:solidFill>
-                  <a:srgbClr val="000000"/>
-                </a:solidFill>
-                <a:effectLst/>
-                <a:latin typeface="Ramabhadra" panose="02000600000000000000" pitchFamily="2" charset="0"/>
-                <a:cs typeface="Ramabhadra" panose="02000600000000000000" pitchFamily="2" charset="0"/>
-              </a:rPr>
-              <a:t>ఆరాధన నీకే నా యేసయ్యా</a:t>
-            </a:r>
-            <a:br>
-              <a:rPr lang="te-IN" sz="1450" b="0" i="0" dirty="0">
-                <a:solidFill>
-                  <a:srgbClr val="000000"/>
-                </a:solidFill>
-                <a:effectLst/>
-                <a:latin typeface="Ramabhadra" panose="02000600000000000000" pitchFamily="2" charset="0"/>
-                <a:cs typeface="Ramabhadra" panose="02000600000000000000" pitchFamily="2" charset="0"/>
-              </a:rPr>
-            </a:br>
-            <a:r>
-              <a:rPr lang="te-IN" sz="1450" b="0" i="0" dirty="0">
-                <a:solidFill>
-                  <a:srgbClr val="000000"/>
-                </a:solidFill>
-                <a:effectLst/>
-                <a:latin typeface="Ramabhadra" panose="02000600000000000000" pitchFamily="2" charset="0"/>
-                <a:cs typeface="Ramabhadra" panose="02000600000000000000" pitchFamily="2" charset="0"/>
-              </a:rPr>
-              <a:t>స్తుతి ఆరాధన నీకే నా యేసయ్యా (2)</a:t>
-            </a:r>
-          </a:p>
-          <a:p>
-            <a:pPr algn="ctr"/>
-            <a:r>
-              <a:rPr lang="te-IN" sz="1450" b="0" i="0" dirty="0">
-                <a:solidFill>
-                  <a:srgbClr val="000000"/>
-                </a:solidFill>
-                <a:effectLst/>
-                <a:latin typeface="Ramabhadra" panose="02000600000000000000" pitchFamily="2" charset="0"/>
-                <a:cs typeface="Ramabhadra" panose="02000600000000000000" pitchFamily="2" charset="0"/>
-              </a:rPr>
-              <a:t>సేవించెద నిన్నే  నా పూర్ణ హృదయముతో    </a:t>
-            </a:r>
-          </a:p>
-          <a:p>
-            <a:pPr algn="ctr"/>
-            <a:endParaRPr lang="te-IN" sz="1450" b="0" i="0" dirty="0">
+            <a:endParaRPr lang="te-IN" sz="1600" b="0" i="0" dirty="0">
               <a:solidFill>
                 <a:srgbClr val="000000"/>
               </a:solidFill>
@@ -4242,7 +4053,7 @@
           <a:p>
             <a:pPr algn="ctr"/>
             <a:r>
-              <a:rPr lang="te-IN" sz="1450" b="0" i="0" dirty="0">
+              <a:rPr lang="te-IN" sz="1600" b="0" i="0" dirty="0">
                 <a:solidFill>
                   <a:srgbClr val="000000"/>
                 </a:solidFill>
@@ -4250,10 +4061,10 @@
                 <a:latin typeface="Ramabhadra" panose="02000600000000000000" pitchFamily="2" charset="0"/>
                 <a:cs typeface="Ramabhadra" panose="02000600000000000000" pitchFamily="2" charset="0"/>
               </a:rPr>
-              <a:t>నీ స్వాస్థ్యమైన నీ వారితో కలిసి నిను సేవించుటకు</a:t>
+              <a:t>నా బలమా నా కోట</a:t>
             </a:r>
             <a:br>
-              <a:rPr lang="te-IN" sz="1450" b="0" i="0" dirty="0">
+              <a:rPr lang="te-IN" sz="1600" b="0" i="0" dirty="0">
                 <a:solidFill>
                   <a:srgbClr val="000000"/>
                 </a:solidFill>
@@ -4263,7 +4074,7 @@
               </a:rPr>
             </a:br>
             <a:r>
-              <a:rPr lang="te-IN" sz="1450" b="0" i="0" dirty="0">
+              <a:rPr lang="te-IN" sz="1600" b="0" i="0" dirty="0">
                 <a:solidFill>
                   <a:srgbClr val="000000"/>
                 </a:solidFill>
@@ -4271,13 +4082,108 @@
                 <a:latin typeface="Ramabhadra" panose="02000600000000000000" pitchFamily="2" charset="0"/>
                 <a:cs typeface="Ramabhadra" panose="02000600000000000000" pitchFamily="2" charset="0"/>
               </a:rPr>
-              <a:t>నీ మహిమ ప్రభావమును</a:t>
+              <a:t>ఆరాధన నీకే (2)</a:t>
+            </a:r>
+            <a:br>
+              <a:rPr lang="te-IN" sz="1600" b="0" i="0" dirty="0">
+                <a:solidFill>
+                  <a:srgbClr val="000000"/>
+                </a:solidFill>
+                <a:effectLst/>
+                <a:latin typeface="Ramabhadra" panose="02000600000000000000" pitchFamily="2" charset="0"/>
+                <a:cs typeface="Ramabhadra" panose="02000600000000000000" pitchFamily="2" charset="0"/>
+              </a:rPr>
+            </a:br>
+            <a:r>
+              <a:rPr lang="te-IN" sz="1600" b="0" i="0" dirty="0">
+                <a:solidFill>
+                  <a:srgbClr val="000000"/>
+                </a:solidFill>
+                <a:effectLst/>
+                <a:latin typeface="Ramabhadra" panose="02000600000000000000" pitchFamily="2" charset="0"/>
+                <a:cs typeface="Ramabhadra" panose="02000600000000000000" pitchFamily="2" charset="0"/>
+              </a:rPr>
+              <a:t>నా దుర్గమా ఆశ్రయమా</a:t>
+            </a:r>
+            <a:br>
+              <a:rPr lang="te-IN" sz="1600" b="0" i="0" dirty="0">
+                <a:solidFill>
+                  <a:srgbClr val="000000"/>
+                </a:solidFill>
+                <a:effectLst/>
+                <a:latin typeface="Ramabhadra" panose="02000600000000000000" pitchFamily="2" charset="0"/>
+                <a:cs typeface="Ramabhadra" panose="02000600000000000000" pitchFamily="2" charset="0"/>
+              </a:rPr>
+            </a:br>
+            <a:r>
+              <a:rPr lang="te-IN" sz="1600" b="0" i="0" dirty="0">
+                <a:solidFill>
+                  <a:srgbClr val="000000"/>
+                </a:solidFill>
+                <a:effectLst/>
+                <a:latin typeface="Ramabhadra" panose="02000600000000000000" pitchFamily="2" charset="0"/>
+                <a:cs typeface="Ramabhadra" panose="02000600000000000000" pitchFamily="2" charset="0"/>
+              </a:rPr>
+              <a:t>ఆరాధన నీకే (2)</a:t>
+            </a:r>
+            <a:br>
+              <a:rPr lang="te-IN" sz="1600" b="0" i="0" dirty="0">
+                <a:solidFill>
+                  <a:srgbClr val="000000"/>
+                </a:solidFill>
+                <a:effectLst/>
+                <a:latin typeface="Ramabhadra" panose="02000600000000000000" pitchFamily="2" charset="0"/>
+                <a:cs typeface="Ramabhadra" panose="02000600000000000000" pitchFamily="2" charset="0"/>
+              </a:rPr>
+            </a:br>
+            <a:r>
+              <a:rPr lang="te-IN" sz="1600" b="0" i="0" dirty="0">
+                <a:solidFill>
+                  <a:srgbClr val="000000"/>
+                </a:solidFill>
+                <a:effectLst/>
+                <a:latin typeface="Ramabhadra" panose="02000600000000000000" pitchFamily="2" charset="0"/>
+                <a:cs typeface="Ramabhadra" panose="02000600000000000000" pitchFamily="2" charset="0"/>
+              </a:rPr>
+              <a:t>ఆరాధనా ఆరాధనా</a:t>
+            </a:r>
+            <a:br>
+              <a:rPr lang="te-IN" sz="1600" b="0" i="0" dirty="0">
+                <a:solidFill>
+                  <a:srgbClr val="000000"/>
+                </a:solidFill>
+                <a:effectLst/>
+                <a:latin typeface="Ramabhadra" panose="02000600000000000000" pitchFamily="2" charset="0"/>
+                <a:cs typeface="Ramabhadra" panose="02000600000000000000" pitchFamily="2" charset="0"/>
+              </a:rPr>
+            </a:br>
+            <a:r>
+              <a:rPr lang="te-IN" sz="1600" b="0" i="0" dirty="0">
+                <a:solidFill>
+                  <a:srgbClr val="000000"/>
+                </a:solidFill>
+                <a:effectLst/>
+                <a:latin typeface="Ramabhadra" panose="02000600000000000000" pitchFamily="2" charset="0"/>
+                <a:cs typeface="Ramabhadra" panose="02000600000000000000" pitchFamily="2" charset="0"/>
+              </a:rPr>
+              <a:t>అబ్బ తండ్రి నీకేనయ్యా</a:t>
             </a:r>
           </a:p>
           <a:p>
             <a:pPr algn="ctr"/>
-            <a:r>
-              <a:rPr lang="te-IN" sz="1450" b="0" i="0" dirty="0">
+            <a:endParaRPr lang="te-IN" sz="1600" b="0" i="0" dirty="0">
+              <a:solidFill>
+                <a:srgbClr val="000000"/>
+              </a:solidFill>
+              <a:effectLst/>
+              <a:latin typeface="Ramabhadra" panose="02000600000000000000" pitchFamily="2" charset="0"/>
+              <a:cs typeface="Ramabhadra" panose="02000600000000000000" pitchFamily="2" charset="0"/>
+            </a:endParaRPr>
+          </a:p>
+          <a:p>
+            <a:pPr algn="ctr"/>
+            <a:r>
+              <a:rPr lang="te-IN" sz="1600" b="0" i="0" dirty="0">
                 <a:solidFill>
                   <a:srgbClr val="000000"/>
                 </a:solidFill>
@@ -4285,10 +4191,10 @@
                 <a:latin typeface="Ramabhadra" panose="02000600000000000000" pitchFamily="2" charset="0"/>
                 <a:cs typeface="Ramabhadra" panose="02000600000000000000" pitchFamily="2" charset="0"/>
               </a:rPr>
-              <a:t>కిరీటముగా ధరింపజేసితివి (2)</a:t>
+              <a:t>అంతట నివసించు యెహోవా ఎలోహిం</a:t>
             </a:r>
             <a:br>
-              <a:rPr lang="te-IN" sz="1450" b="0" i="0" dirty="0">
+              <a:rPr lang="te-IN" sz="1600" b="0" i="0" dirty="0">
                 <a:solidFill>
                   <a:srgbClr val="000000"/>
                 </a:solidFill>
@@ -4298,7 +4204,7 @@
               </a:rPr>
             </a:br>
             <a:r>
-              <a:rPr lang="te-IN" sz="1450" b="0" i="0" dirty="0">
+              <a:rPr lang="te-IN" sz="1600" b="0" i="0" dirty="0">
                 <a:solidFill>
                   <a:srgbClr val="000000"/>
                 </a:solidFill>
@@ -4306,10 +4212,10 @@
                 <a:latin typeface="Ramabhadra" panose="02000600000000000000" pitchFamily="2" charset="0"/>
                 <a:cs typeface="Ramabhadra" panose="02000600000000000000" pitchFamily="2" charset="0"/>
               </a:rPr>
-              <a:t>శాశ్వత కాలము వరకు నీ సంతతిపై దృష్టి నిలిపి</a:t>
+              <a:t>ఆరాధన నీకే (2)</a:t>
             </a:r>
             <a:br>
-              <a:rPr lang="te-IN" sz="1450" b="0" i="0" dirty="0">
+              <a:rPr lang="te-IN" sz="1600" b="0" i="0" dirty="0">
                 <a:solidFill>
                   <a:srgbClr val="000000"/>
                 </a:solidFill>
@@ -4319,7 +4225,7 @@
               </a:rPr>
             </a:br>
             <a:r>
-              <a:rPr lang="te-IN" sz="1450" b="0" i="0" dirty="0">
+              <a:rPr lang="te-IN" sz="1600" b="0" i="0" dirty="0">
                 <a:solidFill>
                   <a:srgbClr val="000000"/>
                 </a:solidFill>
@@ -4327,13 +4233,10 @@
                 <a:latin typeface="Ramabhadra" panose="02000600000000000000" pitchFamily="2" charset="0"/>
                 <a:cs typeface="Ramabhadra" panose="02000600000000000000" pitchFamily="2" charset="0"/>
               </a:rPr>
-              <a:t>నీ దాసుల ప్రార్ధనలు సఫలము చేసితివి</a:t>
-            </a:r>
-          </a:p>
-          <a:p>
-            <a:pPr algn="ctr"/>
-            <a:r>
-              <a:rPr lang="te-IN" sz="1450" b="0" i="0" dirty="0">
+              <a:t>మా యొక్క నీతి యెహోవా సిద్కేను</a:t>
+            </a:r>
+            <a:br>
+              <a:rPr lang="te-IN" sz="1600" b="0" i="0" dirty="0">
                 <a:solidFill>
                   <a:srgbClr val="000000"/>
                 </a:solidFill>
@@ -4341,13 +4244,9 @@
                 <a:latin typeface="Ramabhadra" panose="02000600000000000000" pitchFamily="2" charset="0"/>
                 <a:cs typeface="Ramabhadra" panose="02000600000000000000" pitchFamily="2" charset="0"/>
               </a:rPr>
-              <a:t> </a:t>
-            </a:r>
-          </a:p>
-          <a:p>
-            <a:pPr algn="ctr"/>
-            <a:r>
-              <a:rPr lang="te-IN" sz="1450" b="0" i="0" dirty="0">
+            </a:br>
+            <a:r>
+              <a:rPr lang="te-IN" sz="1600" b="0" i="0" dirty="0">
                 <a:solidFill>
                   <a:srgbClr val="000000"/>
                 </a:solidFill>
@@ -4355,10 +4254,10 @@
                 <a:latin typeface="Ramabhadra" panose="02000600000000000000" pitchFamily="2" charset="0"/>
                 <a:cs typeface="Ramabhadra" panose="02000600000000000000" pitchFamily="2" charset="0"/>
               </a:rPr>
-              <a:t>నీ నిత్యమైన ఆదరణ చూపి నను స్థిరపరచుటకు</a:t>
+              <a:t>ఆరాధన నీకే (2)</a:t>
             </a:r>
             <a:br>
-              <a:rPr lang="te-IN" sz="1450" b="0" i="0" dirty="0">
+              <a:rPr lang="te-IN" sz="1600" b="0" i="0" dirty="0">
                 <a:solidFill>
                   <a:srgbClr val="000000"/>
                 </a:solidFill>
@@ -4368,7 +4267,7 @@
               </a:rPr>
             </a:br>
             <a:r>
-              <a:rPr lang="te-IN" sz="1450" b="0" i="0" dirty="0">
+              <a:rPr lang="te-IN" sz="1600" b="0" i="0" dirty="0">
                 <a:solidFill>
                   <a:srgbClr val="000000"/>
                 </a:solidFill>
@@ -4376,13 +4275,10 @@
                 <a:latin typeface="Ramabhadra" panose="02000600000000000000" pitchFamily="2" charset="0"/>
                 <a:cs typeface="Ramabhadra" panose="02000600000000000000" pitchFamily="2" charset="0"/>
               </a:rPr>
-              <a:t>నీ కరుణా కటాక్షమును</a:t>
-            </a:r>
-          </a:p>
-          <a:p>
-            <a:pPr algn="ctr"/>
-            <a:r>
-              <a:rPr lang="te-IN" sz="1450" b="0" i="0" dirty="0">
+              <a:t>ఆరాధనా ఆరాధనా</a:t>
+            </a:r>
+            <a:br>
+              <a:rPr lang="te-IN" sz="1600" b="0" i="0" dirty="0">
                 <a:solidFill>
                   <a:srgbClr val="000000"/>
                 </a:solidFill>
@@ -4390,10 +4286,9 @@
                 <a:latin typeface="Ramabhadra" panose="02000600000000000000" pitchFamily="2" charset="0"/>
                 <a:cs typeface="Ramabhadra" panose="02000600000000000000" pitchFamily="2" charset="0"/>
               </a:rPr>
-              <a:t>నాపై కురిపించి నను ప్రేమించితివి (2)</a:t>
-            </a:r>
-            <a:br>
-              <a:rPr lang="te-IN" sz="1450" b="0" i="0" dirty="0">
+            </a:br>
+            <a:r>
+              <a:rPr lang="te-IN" sz="1600" b="0" i="0" dirty="0">
                 <a:solidFill>
                   <a:srgbClr val="000000"/>
                 </a:solidFill>
@@ -4401,52 +4296,7 @@
                 <a:latin typeface="Ramabhadra" panose="02000600000000000000" pitchFamily="2" charset="0"/>
                 <a:cs typeface="Ramabhadra" panose="02000600000000000000" pitchFamily="2" charset="0"/>
               </a:rPr>
-            </a:br>
-            <a:r>
-              <a:rPr lang="te-IN" sz="1450" b="0" i="0" dirty="0">
-                <a:solidFill>
-                  <a:srgbClr val="000000"/>
-                </a:solidFill>
-                <a:effectLst/>
-                <a:latin typeface="Ramabhadra" panose="02000600000000000000" pitchFamily="2" charset="0"/>
-                <a:cs typeface="Ramabhadra" panose="02000600000000000000" pitchFamily="2" charset="0"/>
-              </a:rPr>
-              <a:t>నాకు ప్రయోజనము కలుగజేయుటకు</a:t>
-            </a:r>
-          </a:p>
-          <a:p>
-            <a:pPr algn="ctr"/>
-            <a:r>
-              <a:rPr lang="te-IN" sz="1450" b="0" i="0" dirty="0">
-                <a:solidFill>
-                  <a:srgbClr val="000000"/>
-                </a:solidFill>
-                <a:effectLst/>
-                <a:latin typeface="Ramabhadra" panose="02000600000000000000" pitchFamily="2" charset="0"/>
-                <a:cs typeface="Ramabhadra" panose="02000600000000000000" pitchFamily="2" charset="0"/>
-              </a:rPr>
-              <a:t>నీ ఉపదేశమును బోధించి</a:t>
-            </a:r>
-            <a:br>
-              <a:rPr lang="te-IN" sz="1450" b="0" i="0" dirty="0">
-                <a:solidFill>
-                  <a:srgbClr val="000000"/>
-                </a:solidFill>
-                <a:effectLst/>
-                <a:latin typeface="Ramabhadra" panose="02000600000000000000" pitchFamily="2" charset="0"/>
-                <a:cs typeface="Ramabhadra" panose="02000600000000000000" pitchFamily="2" charset="0"/>
-              </a:rPr>
-            </a:br>
-            <a:r>
-              <a:rPr lang="te-IN" sz="1450" b="0" i="0" dirty="0">
-                <a:solidFill>
-                  <a:srgbClr val="000000"/>
-                </a:solidFill>
-                <a:effectLst/>
-                <a:latin typeface="Ramabhadra" panose="02000600000000000000" pitchFamily="2" charset="0"/>
-                <a:cs typeface="Ramabhadra" panose="02000600000000000000" pitchFamily="2" charset="0"/>
-              </a:rPr>
-              <a:t>నీ దాసుని ప్రాణమును సంతోషపరచితివి</a:t>
+              <a:t>అబ్బ తండ్రి నీకేనయ్యా</a:t>
             </a:r>
           </a:p>
         </p:txBody>
@@ -4504,7 +4354,7 @@
           <a:p>
             <a:pPr algn="ctr"/>
             <a:r>
-              <a:rPr lang="te-IN" sz="1850" b="0" i="0" dirty="0">
+              <a:rPr lang="te-IN" sz="1700" b="0" i="0" dirty="0">
                 <a:solidFill>
                   <a:schemeClr val="tx1"/>
                 </a:solidFill>
@@ -4512,13 +4362,13 @@
                 <a:latin typeface="Ramabhadra" panose="02000600000000000000" pitchFamily="2" charset="0"/>
                 <a:cs typeface="Ramabhadra" panose="02000600000000000000" pitchFamily="2" charset="0"/>
               </a:rPr>
-              <a:t>మంచి దేవుడు భలే మంచి దేవుడు</a:t>
+              <a:t>హల్లెలూయ పాట యేసయ్య పాట</a:t>
             </a:r>
           </a:p>
           <a:p>
             <a:pPr algn="ctr"/>
             <a:r>
-              <a:rPr lang="te-IN" sz="1850" b="0" i="0" dirty="0">
+              <a:rPr lang="te-IN" sz="1700" b="0" i="0" dirty="0">
                 <a:solidFill>
                   <a:schemeClr val="tx1"/>
                 </a:solidFill>
@@ -4526,12 +4376,26 @@
                 <a:latin typeface="Ramabhadra" panose="02000600000000000000" pitchFamily="2" charset="0"/>
                 <a:cs typeface="Ramabhadra" panose="02000600000000000000" pitchFamily="2" charset="0"/>
               </a:rPr>
-              <a:t>నిజ దైవం యేసు - అద్వితీయ దేవుడు</a:t>
+              <a:t>పాడాలి ప్రతి చోట పాడాలి ప్రతి నోట</a:t>
             </a:r>
           </a:p>
           <a:p>
             <a:pPr algn="ctr"/>
-            <a:endParaRPr lang="te-IN" sz="1850" b="0" i="0" dirty="0">
+            <a:r>
+              <a:rPr lang="te-IN" sz="1700" b="0" i="0" dirty="0">
+                <a:solidFill>
+                  <a:schemeClr val="tx1"/>
+                </a:solidFill>
+                <a:effectLst/>
+                <a:latin typeface="Ramabhadra" panose="02000600000000000000" pitchFamily="2" charset="0"/>
+                <a:cs typeface="Ramabhadra" panose="02000600000000000000" pitchFamily="2" charset="0"/>
+              </a:rPr>
+              <a:t>హల్లెలూయా హల్లెలూయా హల్లెలూయా (4)</a:t>
+            </a:r>
+          </a:p>
+          <a:p>
+            <a:pPr algn="ctr"/>
+            <a:endParaRPr lang="te-IN" sz="1700" b="0" i="0" dirty="0">
               <a:solidFill>
                 <a:schemeClr val="tx1"/>
               </a:solidFill>
@@ -4543,7 +4407,7 @@
           <a:p>
             <a:pPr algn="ctr"/>
             <a:r>
-              <a:rPr lang="te-IN" sz="1850" b="0" i="0" dirty="0">
+              <a:rPr lang="te-IN" sz="1700" b="0" i="0" dirty="0">
                 <a:solidFill>
                   <a:schemeClr val="tx1"/>
                 </a:solidFill>
@@ -4551,13 +4415,13 @@
                 <a:latin typeface="Ramabhadra" panose="02000600000000000000" pitchFamily="2" charset="0"/>
                 <a:cs typeface="Ramabhadra" panose="02000600000000000000" pitchFamily="2" charset="0"/>
               </a:rPr>
-              <a:t>మ్రొక్కులను కోరడు - మనసిస్తే చాలును</a:t>
+              <a:t>స్తుతిపాటలే పాడుమా –</a:t>
             </a:r>
           </a:p>
           <a:p>
             <a:pPr algn="ctr"/>
             <a:r>
-              <a:rPr lang="te-IN" sz="1850" b="0" i="0" dirty="0">
+              <a:rPr lang="te-IN" sz="1700" b="0" i="0" dirty="0">
                 <a:solidFill>
                   <a:schemeClr val="tx1"/>
                 </a:solidFill>
@@ -4565,68 +4429,12 @@
                 <a:latin typeface="Ramabhadra" panose="02000600000000000000" pitchFamily="2" charset="0"/>
                 <a:cs typeface="Ramabhadra" panose="02000600000000000000" pitchFamily="2" charset="0"/>
               </a:rPr>
-              <a:t>కొండలెక్కి రమ్మనడు –</a:t>
+              <a:t>ప్రభు యేసునే వేడుమా (2)</a:t>
             </a:r>
           </a:p>
           <a:p>
             <a:pPr algn="ctr"/>
-            <a:r>
-              <a:rPr lang="te-IN" sz="1850" b="0" i="0" dirty="0">
-                <a:solidFill>
-                  <a:schemeClr val="tx1"/>
-                </a:solidFill>
-                <a:effectLst/>
-                <a:latin typeface="Ramabhadra" panose="02000600000000000000" pitchFamily="2" charset="0"/>
-                <a:cs typeface="Ramabhadra" panose="02000600000000000000" pitchFamily="2" charset="0"/>
-              </a:rPr>
-              <a:t>మనలో కొలువుంటాడు</a:t>
-            </a:r>
-          </a:p>
-          <a:p>
-            <a:pPr algn="ctr"/>
-            <a:r>
-              <a:rPr lang="te-IN" sz="1850" b="0" i="0" dirty="0">
-                <a:solidFill>
-                  <a:schemeClr val="tx1"/>
-                </a:solidFill>
-                <a:effectLst/>
-                <a:latin typeface="Ramabhadra" panose="02000600000000000000" pitchFamily="2" charset="0"/>
-                <a:cs typeface="Ramabhadra" panose="02000600000000000000" pitchFamily="2" charset="0"/>
-              </a:rPr>
-              <a:t>వెదికితే ప్రతి వారికి - దొరికేను యేసు</a:t>
-            </a:r>
-          </a:p>
-          <a:p>
-            <a:pPr algn="ctr"/>
-            <a:r>
-              <a:rPr lang="te-IN" sz="1850" b="0" i="0" dirty="0">
-                <a:solidFill>
-                  <a:schemeClr val="tx1"/>
-                </a:solidFill>
-                <a:effectLst/>
-                <a:latin typeface="Ramabhadra" panose="02000600000000000000" pitchFamily="2" charset="0"/>
-                <a:cs typeface="Ramabhadra" panose="02000600000000000000" pitchFamily="2" charset="0"/>
-              </a:rPr>
-              <a:t>పిలిచే ప్రతి వారికి - పలికేను యేసు</a:t>
-            </a:r>
-          </a:p>
-          <a:p>
-            <a:pPr algn="ctr"/>
-            <a:r>
-              <a:rPr lang="te-IN" sz="1850" b="0" i="0" dirty="0">
-                <a:solidFill>
-                  <a:schemeClr val="tx1"/>
-                </a:solidFill>
-                <a:effectLst/>
-                <a:latin typeface="Ramabhadra" panose="02000600000000000000" pitchFamily="2" charset="0"/>
-                <a:cs typeface="Ramabhadra" panose="02000600000000000000" pitchFamily="2" charset="0"/>
-              </a:rPr>
-              <a:t>బొమ్మ కాదయ్యో - జీవమున్న దేవుడు</a:t>
-            </a:r>
-          </a:p>
-          <a:p>
-            <a:pPr algn="ctr"/>
-            <a:endParaRPr lang="te-IN" sz="1850" b="0" i="0" dirty="0">
+            <a:endParaRPr lang="te-IN" sz="1700" b="0" i="0" dirty="0">
               <a:solidFill>
                 <a:schemeClr val="tx1"/>
               </a:solidFill>
@@ -4638,7 +4446,7 @@
           <a:p>
             <a:pPr algn="ctr"/>
             <a:r>
-              <a:rPr lang="te-IN" sz="1850" b="0" i="0" dirty="0">
+              <a:rPr lang="te-IN" sz="1700" b="0" i="0" dirty="0">
                 <a:solidFill>
                   <a:schemeClr val="tx1"/>
                 </a:solidFill>
@@ -4646,13 +4454,13 @@
                 <a:latin typeface="Ramabhadra" panose="02000600000000000000" pitchFamily="2" charset="0"/>
                 <a:cs typeface="Ramabhadra" panose="02000600000000000000" pitchFamily="2" charset="0"/>
               </a:rPr>
-              <a:t>కుంటివాడు గంతులేయ–</a:t>
+              <a:t>కష్టములే కలిగిన –</a:t>
             </a:r>
           </a:p>
           <a:p>
             <a:pPr algn="ctr"/>
             <a:r>
-              <a:rPr lang="te-IN" sz="1850" b="0" i="0" dirty="0">
+              <a:rPr lang="te-IN" sz="1700" b="0" i="0" dirty="0">
                 <a:solidFill>
                   <a:schemeClr val="tx1"/>
                 </a:solidFill>
@@ -4660,13 +4468,24 @@
                 <a:latin typeface="Ramabhadra" panose="02000600000000000000" pitchFamily="2" charset="0"/>
                 <a:cs typeface="Ramabhadra" panose="02000600000000000000" pitchFamily="2" charset="0"/>
               </a:rPr>
-              <a:t>కాళ్ళ నొసగినాడు</a:t>
+              <a:t>కన్నీరులే మిగిలినా “స్తుతి”</a:t>
             </a:r>
           </a:p>
           <a:p>
             <a:pPr algn="ctr"/>
-            <a:r>
-              <a:rPr lang="te-IN" sz="1850" b="0" i="0" dirty="0">
+            <a:endParaRPr lang="te-IN" sz="1700" b="0" i="0" dirty="0">
+              <a:solidFill>
+                <a:schemeClr val="tx1"/>
+              </a:solidFill>
+              <a:effectLst/>
+              <a:latin typeface="Ramabhadra" panose="02000600000000000000" pitchFamily="2" charset="0"/>
+              <a:cs typeface="Ramabhadra" panose="02000600000000000000" pitchFamily="2" charset="0"/>
+            </a:endParaRPr>
+          </a:p>
+          <a:p>
+            <a:pPr algn="ctr"/>
+            <a:r>
+              <a:rPr lang="te-IN" sz="1700" b="0" i="0" dirty="0">
                 <a:solidFill>
                   <a:schemeClr val="tx1"/>
                 </a:solidFill>
@@ -4674,13 +4493,13 @@
                 <a:latin typeface="Ramabhadra" panose="02000600000000000000" pitchFamily="2" charset="0"/>
                 <a:cs typeface="Ramabhadra" panose="02000600000000000000" pitchFamily="2" charset="0"/>
               </a:rPr>
-              <a:t>మూగవారు స్తుతిచేయ – నోటినిచ్చినాడు</a:t>
+              <a:t>బంధాలు బిగియించినా –</a:t>
             </a:r>
           </a:p>
           <a:p>
             <a:pPr algn="ctr"/>
             <a:r>
-              <a:rPr lang="te-IN" sz="1850" b="0" i="0" dirty="0">
+              <a:rPr lang="te-IN" sz="1700" b="0" i="0" dirty="0">
                 <a:solidFill>
                   <a:schemeClr val="tx1"/>
                 </a:solidFill>
@@ -4688,13 +4507,24 @@
                 <a:latin typeface="Ramabhadra" panose="02000600000000000000" pitchFamily="2" charset="0"/>
                 <a:cs typeface="Ramabhadra" panose="02000600000000000000" pitchFamily="2" charset="0"/>
               </a:rPr>
-              <a:t>బధిరులు తన స్వరము విన- చెవులిచ్చినాడు</a:t>
+              <a:t>చేరసాలలో వేసినా “స్తుతి”</a:t>
             </a:r>
           </a:p>
           <a:p>
             <a:pPr algn="ctr"/>
-            <a:r>
-              <a:rPr lang="te-IN" sz="1850" b="0" i="0" dirty="0">
+            <a:endParaRPr lang="te-IN" sz="1700" b="0" i="0" dirty="0">
+              <a:solidFill>
+                <a:schemeClr val="tx1"/>
+              </a:solidFill>
+              <a:effectLst/>
+              <a:latin typeface="Ramabhadra" panose="02000600000000000000" pitchFamily="2" charset="0"/>
+              <a:cs typeface="Ramabhadra" panose="02000600000000000000" pitchFamily="2" charset="0"/>
+            </a:endParaRPr>
+          </a:p>
+          <a:p>
+            <a:pPr algn="ctr"/>
+            <a:r>
+              <a:rPr lang="te-IN" sz="1700" b="0" i="0" dirty="0">
                 <a:solidFill>
                   <a:schemeClr val="tx1"/>
                 </a:solidFill>
@@ -4702,7 +4532,60 @@
                 <a:latin typeface="Ramabhadra" panose="02000600000000000000" pitchFamily="2" charset="0"/>
                 <a:cs typeface="Ramabhadra" panose="02000600000000000000" pitchFamily="2" charset="0"/>
               </a:rPr>
-              <a:t>ప్రేమా మయుడు - ఆశ్చర్య దేవుడు</a:t>
+              <a:t>నీ తల్లి నిను మరిచినా –</a:t>
+            </a:r>
+          </a:p>
+          <a:p>
+            <a:pPr algn="ctr"/>
+            <a:r>
+              <a:rPr lang="te-IN" sz="1700" b="0" i="0" dirty="0">
+                <a:solidFill>
+                  <a:schemeClr val="tx1"/>
+                </a:solidFill>
+                <a:effectLst/>
+                <a:latin typeface="Ramabhadra" panose="02000600000000000000" pitchFamily="2" charset="0"/>
+                <a:cs typeface="Ramabhadra" panose="02000600000000000000" pitchFamily="2" charset="0"/>
+              </a:rPr>
+              <a:t>మరువని నీ దేవుడు “స్తుతి”</a:t>
+            </a:r>
+          </a:p>
+          <a:p>
+            <a:pPr algn="ctr"/>
+            <a:endParaRPr lang="te-IN" sz="1700" b="0" i="0" dirty="0">
+              <a:solidFill>
+                <a:schemeClr val="tx1"/>
+              </a:solidFill>
+              <a:effectLst/>
+              <a:latin typeface="Ramabhadra" panose="02000600000000000000" pitchFamily="2" charset="0"/>
+              <a:cs typeface="Ramabhadra" panose="02000600000000000000" pitchFamily="2" charset="0"/>
+            </a:endParaRPr>
+          </a:p>
+          <a:p>
+            <a:pPr algn="ctr"/>
+            <a:r>
+              <a:rPr lang="te-IN" sz="1700" b="0" i="0" dirty="0">
+                <a:solidFill>
+                  <a:schemeClr val="tx1"/>
+                </a:solidFill>
+                <a:effectLst/>
+                <a:latin typeface="Ramabhadra" panose="02000600000000000000" pitchFamily="2" charset="0"/>
+                <a:cs typeface="Ramabhadra" panose="02000600000000000000" pitchFamily="2" charset="0"/>
+              </a:rPr>
+              <a:t>జనులెంత నిందించినా –</a:t>
+            </a:r>
+          </a:p>
+          <a:p>
+            <a:pPr algn="ctr"/>
+            <a:r>
+              <a:rPr lang="te-IN" sz="1700" b="0" i="0" dirty="0">
+                <a:solidFill>
+                  <a:schemeClr val="tx1"/>
+                </a:solidFill>
+                <a:effectLst/>
+                <a:latin typeface="Ramabhadra" panose="02000600000000000000" pitchFamily="2" charset="0"/>
+                <a:cs typeface="Ramabhadra" panose="02000600000000000000" pitchFamily="2" charset="0"/>
+              </a:rPr>
+              <a:t>చేడుమాటలే పలికినా “స్తుతి”</a:t>
             </a:r>
           </a:p>
         </p:txBody>
@@ -4773,7 +4656,7 @@
               <a:defRPr/>
             </a:pPr>
             <a:r>
-              <a:rPr kumimoji="0" lang="te-IN" i="0" u="none" strike="noStrike" kern="1200" cap="none" spc="0" normalizeH="0" baseline="0" noProof="0" dirty="0">
+              <a:rPr kumimoji="0" lang="te-IN" sz="1900" i="0" u="none" strike="noStrike" kern="1200" cap="none" spc="0" normalizeH="0" baseline="0" noProof="0" dirty="0">
                 <a:ln>
                   <a:noFill/>
                 </a:ln>
@@ -4786,7 +4669,7 @@
                 <a:latin typeface="Ramabhadra" panose="02000600000000000000" pitchFamily="2" charset="0"/>
                 <a:cs typeface="Ramabhadra" panose="02000600000000000000" pitchFamily="2" charset="0"/>
               </a:rPr>
-              <a:t>స్తుతి పాత్రుడా – స్తోత్రార్హుడా</a:t>
+              <a:t>ఆత్మ స్వరూపుడా ప్రియ ఆత్మ స్వరూపుడా </a:t>
             </a:r>
           </a:p>
           <a:p>
@@ -4805,7 +4688,7 @@
               <a:defRPr/>
             </a:pPr>
             <a:r>
-              <a:rPr kumimoji="0" lang="te-IN" i="0" u="none" strike="noStrike" kern="1200" cap="none" spc="0" normalizeH="0" baseline="0" noProof="0" dirty="0">
+              <a:rPr kumimoji="0" lang="te-IN" sz="1900" i="0" u="none" strike="noStrike" kern="1200" cap="none" spc="0" normalizeH="0" baseline="0" noProof="0" dirty="0">
                 <a:ln>
                   <a:noFill/>
                 </a:ln>
@@ -4818,7 +4701,7 @@
                 <a:latin typeface="Ramabhadra" panose="02000600000000000000" pitchFamily="2" charset="0"/>
                 <a:cs typeface="Ramabhadra" panose="02000600000000000000" pitchFamily="2" charset="0"/>
               </a:rPr>
-              <a:t>స్తుతులందుకో - పూజార్హుడా</a:t>
+              <a:t>నేడే రా దేవా నేడే రా దేవా మా మధ్యకు</a:t>
             </a:r>
           </a:p>
           <a:p>
@@ -4836,71 +4719,7 @@
               <a:tabLst/>
               <a:defRPr/>
             </a:pPr>
-            <a:r>
-              <a:rPr kumimoji="0" lang="te-IN" i="0" u="none" strike="noStrike" kern="1200" cap="none" spc="0" normalizeH="0" baseline="0" noProof="0" dirty="0">
-                <a:ln>
-                  <a:noFill/>
-                </a:ln>
-                <a:solidFill>
-                  <a:schemeClr val="tx1"/>
-                </a:solidFill>
-                <a:effectLst/>
-                <a:uLnTx/>
-                <a:uFillTx/>
-                <a:latin typeface="Ramabhadra" panose="02000600000000000000" pitchFamily="2" charset="0"/>
-                <a:cs typeface="Ramabhadra" panose="02000600000000000000" pitchFamily="2" charset="0"/>
-              </a:rPr>
-              <a:t>ఆకాశమందు నీవు తప్ప - నాకెవరున్నారు నా ప్రభు</a:t>
-            </a:r>
-          </a:p>
-          <a:p>
-            <a:pPr marL="0" marR="0" lvl="0" indent="0" algn="ctr" defTabSz="439781" rtl="0" eaLnBrk="1" fontAlgn="auto" latinLnBrk="0" hangingPunct="1">
-              <a:spcBef>
-                <a:spcPts val="0"/>
-              </a:spcBef>
-              <a:spcAft>
-                <a:spcPts val="0"/>
-              </a:spcAft>
-              <a:buClrTx/>
-              <a:buSzTx/>
-              <a:buFontTx/>
-              <a:buNone/>
-              <a:tabLst/>
-              <a:defRPr/>
-            </a:pPr>
-            <a:r>
-              <a:rPr kumimoji="0" lang="te-IN" i="0" u="none" strike="noStrike" kern="1200" cap="none" spc="0" normalizeH="0" baseline="0" noProof="0" dirty="0">
-                <a:ln>
-                  <a:noFill/>
-                </a:ln>
-                <a:solidFill>
-                  <a:schemeClr val="tx1"/>
-                </a:solidFill>
-                <a:effectLst/>
-                <a:uLnTx/>
-                <a:uFillTx/>
-                <a:latin typeface="Ramabhadra" panose="02000600000000000000" pitchFamily="2" charset="0"/>
-                <a:cs typeface="Ramabhadra" panose="02000600000000000000" pitchFamily="2" charset="0"/>
-              </a:rPr>
-              <a:t>స్తుతి పాత్రుడా.... ఆఆఅ</a:t>
-            </a:r>
-          </a:p>
-          <a:p>
-            <a:pPr marL="0" marR="0" lvl="0" indent="0" algn="ctr" defTabSz="439781" rtl="0" eaLnBrk="1" fontAlgn="auto" latinLnBrk="0" hangingPunct="1">
-              <a:spcBef>
-                <a:spcPts val="0"/>
-              </a:spcBef>
-              <a:spcAft>
-                <a:spcPts val="0"/>
-              </a:spcAft>
-              <a:buClrTx/>
-              <a:buSzTx/>
-              <a:buFontTx/>
-              <a:buNone/>
-              <a:tabLst/>
-              <a:defRPr/>
-            </a:pPr>
-            <a:endParaRPr kumimoji="0" lang="te-IN" i="0" u="none" strike="noStrike" kern="1200" cap="none" spc="0" normalizeH="0" baseline="0" noProof="0" dirty="0">
+            <a:endParaRPr kumimoji="0" lang="te-IN" sz="1900" i="0" u="none" strike="noStrike" kern="1200" cap="none" spc="0" normalizeH="0" baseline="0" noProof="0" dirty="0">
               <a:ln>
                 <a:noFill/>
               </a:ln>
@@ -4930,7 +4749,7 @@
               <a:defRPr/>
             </a:pPr>
             <a:r>
-              <a:rPr kumimoji="0" lang="te-IN" i="0" u="none" strike="noStrike" kern="1200" cap="none" spc="0" normalizeH="0" baseline="0" noProof="0" dirty="0">
+              <a:rPr kumimoji="0" lang="te-IN" sz="1900" i="0" u="none" strike="noStrike" kern="1200" cap="none" spc="0" normalizeH="0" baseline="0" noProof="0" dirty="0">
                 <a:ln>
                   <a:noFill/>
                 </a:ln>
@@ -4943,7 +4762,7 @@
                 <a:latin typeface="Ramabhadra" panose="02000600000000000000" pitchFamily="2" charset="0"/>
                 <a:cs typeface="Ramabhadra" panose="02000600000000000000" pitchFamily="2" charset="0"/>
               </a:rPr>
-              <a:t>నా శత్రువులు నను తరుముచుండగా –</a:t>
+              <a:t>పాపపు ఊబి నుండి నను రక్షించితివి </a:t>
             </a:r>
           </a:p>
           <a:p>
@@ -4962,7 +4781,7 @@
               <a:defRPr/>
             </a:pPr>
             <a:r>
-              <a:rPr kumimoji="0" lang="te-IN" i="0" u="none" strike="noStrike" kern="1200" cap="none" spc="0" normalizeH="0" baseline="0" noProof="0" dirty="0">
+              <a:rPr kumimoji="0" lang="te-IN" sz="1900" i="0" u="none" strike="noStrike" kern="1200" cap="none" spc="0" normalizeH="0" baseline="0" noProof="0" dirty="0">
                 <a:ln>
                   <a:noFill/>
                 </a:ln>
@@ -4975,7 +4794,7 @@
                 <a:latin typeface="Ramabhadra" panose="02000600000000000000" pitchFamily="2" charset="0"/>
                 <a:cs typeface="Ramabhadra" panose="02000600000000000000" pitchFamily="2" charset="0"/>
               </a:rPr>
-              <a:t>నా యాత్మ నాలో కృంగెనే ప్రభూ -2</a:t>
+              <a:t>పాపం కడిగి శుద్ధీకరించి</a:t>
             </a:r>
           </a:p>
           <a:p>
@@ -4994,7 +4813,7 @@
               <a:defRPr/>
             </a:pPr>
             <a:r>
-              <a:rPr kumimoji="0" lang="te-IN" i="0" u="none" strike="noStrike" kern="1200" cap="none" spc="0" normalizeH="0" baseline="0" noProof="0" dirty="0">
+              <a:rPr kumimoji="0" lang="te-IN" sz="1900" i="0" u="none" strike="noStrike" kern="1200" cap="none" spc="0" normalizeH="0" baseline="0" noProof="0" dirty="0">
                 <a:ln>
                   <a:noFill/>
                 </a:ln>
@@ -5007,7 +4826,7 @@
                 <a:latin typeface="Ramabhadra" panose="02000600000000000000" pitchFamily="2" charset="0"/>
                 <a:cs typeface="Ramabhadra" panose="02000600000000000000" pitchFamily="2" charset="0"/>
               </a:rPr>
-              <a:t>నా మనస్సు నీ వైపు త్రిప్పిన వెంటనే - శత్రుల చేతినుండి</a:t>
+              <a:t> నీ దివ్య రక్తంతో</a:t>
             </a:r>
           </a:p>
           <a:p>
@@ -5025,39 +4844,7 @@
               <a:tabLst/>
               <a:defRPr/>
             </a:pPr>
-            <a:r>
-              <a:rPr kumimoji="0" lang="te-IN" i="0" u="none" strike="noStrike" kern="1200" cap="none" spc="0" normalizeH="0" baseline="0" noProof="0" dirty="0">
-                <a:ln>
-                  <a:noFill/>
-                </a:ln>
-                <a:solidFill>
-                  <a:schemeClr val="tx1"/>
-                </a:solidFill>
-                <a:effectLst/>
-                <a:uLnTx/>
-                <a:uFillTx/>
-                <a:latin typeface="Ramabhadra" panose="02000600000000000000" pitchFamily="2" charset="0"/>
-                <a:cs typeface="Ramabhadra" panose="02000600000000000000" pitchFamily="2" charset="0"/>
-              </a:rPr>
-              <a:t>విడిపించినావు - కాపాడినావు -2</a:t>
-            </a:r>
-          </a:p>
-          <a:p>
-            <a:pPr marL="0" marR="0" lvl="0" indent="0" algn="ctr" defTabSz="439781" rtl="0" eaLnBrk="1" fontAlgn="auto" latinLnBrk="0" hangingPunct="1">
-              <a:spcBef>
-                <a:spcPts val="0"/>
-              </a:spcBef>
-              <a:spcAft>
-                <a:spcPts val="0"/>
-              </a:spcAft>
-              <a:buClrTx/>
-              <a:buSzTx/>
-              <a:buFontTx/>
-              <a:buNone/>
-              <a:tabLst/>
-              <a:defRPr/>
-            </a:pPr>
-            <a:endParaRPr kumimoji="0" lang="te-IN" i="0" u="none" strike="noStrike" kern="1200" cap="none" spc="0" normalizeH="0" baseline="0" noProof="0" dirty="0">
+            <a:endParaRPr kumimoji="0" lang="te-IN" sz="1900" i="0" u="none" strike="noStrike" kern="1200" cap="none" spc="0" normalizeH="0" baseline="0" noProof="0" dirty="0">
               <a:ln>
                 <a:noFill/>
               </a:ln>
@@ -5087,7 +4874,7 @@
               <a:defRPr/>
             </a:pPr>
             <a:r>
-              <a:rPr kumimoji="0" lang="te-IN" i="0" u="none" strike="noStrike" kern="1200" cap="none" spc="0" normalizeH="0" baseline="0" noProof="0" dirty="0">
+              <a:rPr kumimoji="0" lang="te-IN" sz="1900" i="0" u="none" strike="noStrike" kern="1200" cap="none" spc="0" normalizeH="0" baseline="0" noProof="0" dirty="0">
                 <a:ln>
                   <a:noFill/>
                 </a:ln>
@@ -5100,7 +4887,7 @@
                 <a:latin typeface="Ramabhadra" panose="02000600000000000000" pitchFamily="2" charset="0"/>
                 <a:cs typeface="Ramabhadra" panose="02000600000000000000" pitchFamily="2" charset="0"/>
               </a:rPr>
-              <a:t>నా ప్రాణ స్నేహితులు నన్ను చూచి దూరాన నిలిచేరు నా ప్రభూ -2</a:t>
+              <a:t>సీనాయి కొండపై అరుదెంచిన దేవా </a:t>
             </a:r>
           </a:p>
           <a:p>
@@ -5119,7 +4906,7 @@
               <a:defRPr/>
             </a:pPr>
             <a:r>
-              <a:rPr kumimoji="0" lang="te-IN" i="0" u="none" strike="noStrike" kern="1200" cap="none" spc="0" normalizeH="0" baseline="0" noProof="0" dirty="0">
+              <a:rPr kumimoji="0" lang="te-IN" sz="1900" i="0" u="none" strike="noStrike" kern="1200" cap="none" spc="0" normalizeH="0" baseline="0" noProof="0" dirty="0">
                 <a:ln>
                   <a:noFill/>
                 </a:ln>
@@ -5132,7 +4919,7 @@
                 <a:latin typeface="Ramabhadra" panose="02000600000000000000" pitchFamily="2" charset="0"/>
                 <a:cs typeface="Ramabhadra" panose="02000600000000000000" pitchFamily="2" charset="0"/>
               </a:rPr>
-              <a:t>నీ వాక్య ధ్యానమే నా త్రోవకు వెలుగై –</a:t>
+              <a:t>ఆత్మ దాహం తీర్చుటకై </a:t>
             </a:r>
           </a:p>
           <a:p>
@@ -5151,7 +4938,7 @@
               <a:defRPr/>
             </a:pPr>
             <a:r>
-              <a:rPr kumimoji="0" lang="te-IN" i="0" u="none" strike="noStrike" kern="1200" cap="none" spc="0" normalizeH="0" baseline="0" noProof="0" dirty="0">
+              <a:rPr kumimoji="0" lang="te-IN" sz="1900" i="0" u="none" strike="noStrike" kern="1200" cap="none" spc="0" normalizeH="0" baseline="0" noProof="0" dirty="0">
                 <a:ln>
                   <a:noFill/>
                 </a:ln>
@@ -5164,7 +4951,7 @@
                 <a:latin typeface="Ramabhadra" panose="02000600000000000000" pitchFamily="2" charset="0"/>
                 <a:cs typeface="Ramabhadra" panose="02000600000000000000" pitchFamily="2" charset="0"/>
               </a:rPr>
-              <a:t>నను నిల్పెను</a:t>
+              <a:t> ఆ దివ్య సమయంలో</a:t>
             </a:r>
           </a:p>
           <a:p>
@@ -5182,8 +4969,37 @@
               <a:tabLst/>
               <a:defRPr/>
             </a:pPr>
-            <a:r>
-              <a:rPr kumimoji="0" lang="te-IN" i="0" u="none" strike="noStrike" kern="1200" cap="none" spc="0" normalizeH="0" baseline="0" noProof="0" dirty="0">
+            <a:endParaRPr kumimoji="0" lang="te-IN" sz="1900" i="0" u="none" strike="noStrike" kern="1200" cap="none" spc="0" normalizeH="0" baseline="0" noProof="0" dirty="0">
+              <a:ln>
+                <a:noFill/>
+              </a:ln>
+              <a:solidFill>
+                <a:schemeClr val="tx1"/>
+              </a:solidFill>
+              <a:effectLst/>
+              <a:uLnTx/>
+              <a:uFillTx/>
+              <a:latin typeface="Ramabhadra" panose="02000600000000000000" pitchFamily="2" charset="0"/>
+              <a:cs typeface="Ramabhadra" panose="02000600000000000000" pitchFamily="2" charset="0"/>
+            </a:endParaRPr>
+          </a:p>
+          <a:p>
+            <a:pPr marL="0" marR="0" lvl="0" indent="0" algn="ctr" defTabSz="439781" rtl="0" eaLnBrk="1" fontAlgn="auto" latinLnBrk="0" hangingPunct="1">
+              <a:spcBef>
+                <a:spcPts val="0"/>
+              </a:spcBef>
+              <a:spcAft>
+                <a:spcPts val="0"/>
+              </a:spcAft>
+              <a:buClrTx/>
+              <a:buSzTx/>
+              <a:buFontTx/>
+              <a:buNone/>
+              <a:tabLst/>
+              <a:defRPr/>
+            </a:pPr>
+            <a:r>
+              <a:rPr kumimoji="0" lang="te-IN" sz="1900" i="0" u="none" strike="noStrike" kern="1200" cap="none" spc="0" normalizeH="0" baseline="0" noProof="0" dirty="0">
                 <a:ln>
                   <a:noFill/>
                 </a:ln>
@@ -5196,7 +5012,71 @@
                 <a:latin typeface="Ramabhadra" panose="02000600000000000000" pitchFamily="2" charset="0"/>
                 <a:cs typeface="Ramabhadra" panose="02000600000000000000" pitchFamily="2" charset="0"/>
               </a:rPr>
-              <a:t>నీ సన్నీధిలో - నీ సంఘములో -2</a:t>
+              <a:t>ఆత్మవరములతో నన్ను నింపు దేవా </a:t>
+            </a:r>
+          </a:p>
+          <a:p>
+            <a:pPr marL="0" marR="0" lvl="0" indent="0" algn="ctr" defTabSz="439781" rtl="0" eaLnBrk="1" fontAlgn="auto" latinLnBrk="0" hangingPunct="1">
+              <a:spcBef>
+                <a:spcPts val="0"/>
+              </a:spcBef>
+              <a:spcAft>
+                <a:spcPts val="0"/>
+              </a:spcAft>
+              <a:buClrTx/>
+              <a:buSzTx/>
+              <a:buFontTx/>
+              <a:buNone/>
+              <a:tabLst/>
+              <a:defRPr/>
+            </a:pPr>
+            <a:r>
+              <a:rPr kumimoji="0" lang="te-IN" sz="1900" i="0" u="none" strike="noStrike" kern="1200" cap="none" spc="0" normalizeH="0" baseline="0" noProof="0" dirty="0">
+                <a:ln>
+                  <a:noFill/>
+                </a:ln>
+                <a:solidFill>
+                  <a:schemeClr val="tx1"/>
+                </a:solidFill>
+                <a:effectLst/>
+                <a:uLnTx/>
+                <a:uFillTx/>
+                <a:latin typeface="Ramabhadra" panose="02000600000000000000" pitchFamily="2" charset="0"/>
+                <a:cs typeface="Ramabhadra" panose="02000600000000000000" pitchFamily="2" charset="0"/>
+              </a:rPr>
+              <a:t>క్రీస్తు వలె నను అభిషేకించుము </a:t>
+            </a:r>
+          </a:p>
+          <a:p>
+            <a:pPr marL="0" marR="0" lvl="0" indent="0" algn="ctr" defTabSz="439781" rtl="0" eaLnBrk="1" fontAlgn="auto" latinLnBrk="0" hangingPunct="1">
+              <a:spcBef>
+                <a:spcPts val="0"/>
+              </a:spcBef>
+              <a:spcAft>
+                <a:spcPts val="0"/>
+              </a:spcAft>
+              <a:buClrTx/>
+              <a:buSzTx/>
+              <a:buFontTx/>
+              <a:buNone/>
+              <a:tabLst/>
+              <a:defRPr/>
+            </a:pPr>
+            <a:r>
+              <a:rPr kumimoji="0" lang="te-IN" sz="1900" i="0" u="none" strike="noStrike" kern="1200" cap="none" spc="0" normalizeH="0" baseline="0" noProof="0" dirty="0">
+                <a:ln>
+                  <a:noFill/>
+                </a:ln>
+                <a:solidFill>
+                  <a:schemeClr val="tx1"/>
+                </a:solidFill>
+                <a:effectLst/>
+                <a:uLnTx/>
+                <a:uFillTx/>
+                <a:latin typeface="Ramabhadra" panose="02000600000000000000" pitchFamily="2" charset="0"/>
+                <a:cs typeface="Ramabhadra" panose="02000600000000000000" pitchFamily="2" charset="0"/>
+              </a:rPr>
+              <a:t>నీ దివ్య సన్నిధిలో</a:t>
             </a:r>
           </a:p>
         </p:txBody>

</xml_diff>

<commit_message>
16 june sunday songs
</commit_message>
<xml_diff>
--- a/xerox.pptx
+++ b/xerox.pptx
@@ -224,7 +224,7 @@
           <a:p>
             <a:fld id="{3502DD63-DF8D-4AB8-92A0-0ECCF612C06C}" type="datetimeFigureOut">
               <a:rPr lang="en-IN" smtClean="0"/>
-              <a:t>08-06-2024</a:t>
+              <a:t>13-06-2024</a:t>
             </a:fld>
             <a:endParaRPr lang="en-IN"/>
           </a:p>
@@ -402,7 +402,7 @@
           <a:p>
             <a:fld id="{1AE741EC-1360-4793-999B-941E0396C9FA}" type="datetimeFigureOut">
               <a:rPr lang="en-IN" smtClean="0"/>
-              <a:t>08-06-2024</a:t>
+              <a:t>13-06-2024</a:t>
             </a:fld>
             <a:endParaRPr lang="en-IN"/>
           </a:p>
@@ -802,7 +802,7 @@
           <a:p>
             <a:fld id="{86FBD32F-FCAD-481A-B7D8-4D813FB7DB24}" type="datetimeFigureOut">
               <a:rPr lang="en-IN" smtClean="0"/>
-              <a:t>08-06-2024</a:t>
+              <a:t>13-06-2024</a:t>
             </a:fld>
             <a:endParaRPr lang="en-IN"/>
           </a:p>
@@ -972,7 +972,7 @@
           <a:p>
             <a:fld id="{86FBD32F-FCAD-481A-B7D8-4D813FB7DB24}" type="datetimeFigureOut">
               <a:rPr lang="en-IN" smtClean="0"/>
-              <a:t>08-06-2024</a:t>
+              <a:t>13-06-2024</a:t>
             </a:fld>
             <a:endParaRPr lang="en-IN"/>
           </a:p>
@@ -1152,7 +1152,7 @@
           <a:p>
             <a:fld id="{86FBD32F-FCAD-481A-B7D8-4D813FB7DB24}" type="datetimeFigureOut">
               <a:rPr lang="en-IN" smtClean="0"/>
-              <a:t>08-06-2024</a:t>
+              <a:t>13-06-2024</a:t>
             </a:fld>
             <a:endParaRPr lang="en-IN"/>
           </a:p>
@@ -1322,7 +1322,7 @@
           <a:p>
             <a:fld id="{86FBD32F-FCAD-481A-B7D8-4D813FB7DB24}" type="datetimeFigureOut">
               <a:rPr lang="en-IN" smtClean="0"/>
-              <a:t>08-06-2024</a:t>
+              <a:t>13-06-2024</a:t>
             </a:fld>
             <a:endParaRPr lang="en-IN"/>
           </a:p>
@@ -1566,7 +1566,7 @@
           <a:p>
             <a:fld id="{86FBD32F-FCAD-481A-B7D8-4D813FB7DB24}" type="datetimeFigureOut">
               <a:rPr lang="en-IN" smtClean="0"/>
-              <a:t>08-06-2024</a:t>
+              <a:t>13-06-2024</a:t>
             </a:fld>
             <a:endParaRPr lang="en-IN"/>
           </a:p>
@@ -1798,7 +1798,7 @@
           <a:p>
             <a:fld id="{86FBD32F-FCAD-481A-B7D8-4D813FB7DB24}" type="datetimeFigureOut">
               <a:rPr lang="en-IN" smtClean="0"/>
-              <a:t>08-06-2024</a:t>
+              <a:t>13-06-2024</a:t>
             </a:fld>
             <a:endParaRPr lang="en-IN"/>
           </a:p>
@@ -2165,7 +2165,7 @@
           <a:p>
             <a:fld id="{86FBD32F-FCAD-481A-B7D8-4D813FB7DB24}" type="datetimeFigureOut">
               <a:rPr lang="en-IN" smtClean="0"/>
-              <a:t>08-06-2024</a:t>
+              <a:t>13-06-2024</a:t>
             </a:fld>
             <a:endParaRPr lang="en-IN"/>
           </a:p>
@@ -2283,7 +2283,7 @@
           <a:p>
             <a:fld id="{86FBD32F-FCAD-481A-B7D8-4D813FB7DB24}" type="datetimeFigureOut">
               <a:rPr lang="en-IN" smtClean="0"/>
-              <a:t>08-06-2024</a:t>
+              <a:t>13-06-2024</a:t>
             </a:fld>
             <a:endParaRPr lang="en-IN"/>
           </a:p>
@@ -2378,7 +2378,7 @@
           <a:p>
             <a:fld id="{86FBD32F-FCAD-481A-B7D8-4D813FB7DB24}" type="datetimeFigureOut">
               <a:rPr lang="en-IN" smtClean="0"/>
-              <a:t>08-06-2024</a:t>
+              <a:t>13-06-2024</a:t>
             </a:fld>
             <a:endParaRPr lang="en-IN"/>
           </a:p>
@@ -2655,7 +2655,7 @@
           <a:p>
             <a:fld id="{86FBD32F-FCAD-481A-B7D8-4D813FB7DB24}" type="datetimeFigureOut">
               <a:rPr lang="en-IN" smtClean="0"/>
-              <a:t>08-06-2024</a:t>
+              <a:t>13-06-2024</a:t>
             </a:fld>
             <a:endParaRPr lang="en-IN"/>
           </a:p>
@@ -2912,7 +2912,7 @@
           <a:p>
             <a:fld id="{86FBD32F-FCAD-481A-B7D8-4D813FB7DB24}" type="datetimeFigureOut">
               <a:rPr lang="en-IN" smtClean="0"/>
-              <a:t>08-06-2024</a:t>
+              <a:t>13-06-2024</a:t>
             </a:fld>
             <a:endParaRPr lang="en-IN"/>
           </a:p>
@@ -3125,7 +3125,7 @@
           <a:p>
             <a:fld id="{86FBD32F-FCAD-481A-B7D8-4D813FB7DB24}" type="datetimeFigureOut">
               <a:rPr lang="en-IN" smtClean="0"/>
-              <a:t>08-06-2024</a:t>
+              <a:t>13-06-2024</a:t>
             </a:fld>
             <a:endParaRPr lang="en-IN"/>
           </a:p>
@@ -3590,7 +3590,7 @@
               </a:spcAft>
             </a:pPr>
             <a:r>
-              <a:rPr lang="te-IN" b="0" i="0" dirty="0">
+              <a:rPr lang="te-IN" sz="1750" b="0" i="0" dirty="0">
                 <a:solidFill>
                   <a:schemeClr val="tx1"/>
                 </a:solidFill>
@@ -3598,8 +3598,16 @@
                 <a:latin typeface="Ramabhadra" panose="02000600000000000000" pitchFamily="2" charset="0"/>
                 <a:cs typeface="Ramabhadra" panose="02000600000000000000" pitchFamily="2" charset="0"/>
               </a:rPr>
-              <a:t>స్తుతియించెదా నీ నామం</a:t>
-            </a:r>
+              <a:t>స్తుతి గానములతో నేను –</a:t>
+            </a:r>
+            <a:endParaRPr lang="en-IN" sz="1750" b="0" i="0" dirty="0">
+              <a:solidFill>
+                <a:schemeClr val="tx1"/>
+              </a:solidFill>
+              <a:effectLst/>
+              <a:latin typeface="Ramabhadra" panose="02000600000000000000" pitchFamily="2" charset="0"/>
+              <a:cs typeface="Ramabhadra" panose="02000600000000000000" pitchFamily="2" charset="0"/>
+            </a:endParaRPr>
           </a:p>
           <a:p>
             <a:pPr marL="0" marR="0" indent="0" algn="ctr" rtl="0" eaLnBrk="1" fontAlgn="auto" latinLnBrk="0" hangingPunct="1">
@@ -3611,7 +3619,7 @@
               </a:spcAft>
             </a:pPr>
             <a:r>
-              <a:rPr lang="te-IN" b="0" i="0" dirty="0">
+              <a:rPr lang="te-IN" sz="1750" b="0" i="0" dirty="0">
                 <a:solidFill>
                   <a:schemeClr val="tx1"/>
                 </a:solidFill>
@@ -3619,7 +3627,7 @@
                 <a:latin typeface="Ramabhadra" panose="02000600000000000000" pitchFamily="2" charset="0"/>
                 <a:cs typeface="Ramabhadra" panose="02000600000000000000" pitchFamily="2" charset="0"/>
               </a:rPr>
-              <a:t>దేవా అనుదినం </a:t>
+              <a:t>నా దేవునీ స్తుతించెదనూ</a:t>
             </a:r>
           </a:p>
           <a:p>
@@ -3632,7 +3640,7 @@
               </a:spcAft>
             </a:pPr>
             <a:r>
-              <a:rPr lang="te-IN" b="0" i="0" dirty="0">
+              <a:rPr lang="te-IN" sz="1750" b="0" i="0" dirty="0">
                 <a:solidFill>
                   <a:schemeClr val="tx1"/>
                 </a:solidFill>
@@ -3640,8 +3648,38 @@
                 <a:latin typeface="Ramabhadra" panose="02000600000000000000" pitchFamily="2" charset="0"/>
                 <a:cs typeface="Ramabhadra" panose="02000600000000000000" pitchFamily="2" charset="0"/>
               </a:rPr>
-              <a:t>స్తుతియించెదా నీ నామం</a:t>
-            </a:r>
+              <a:t>నీ జీవితమంతా ప్రభు కొరకై</a:t>
+            </a:r>
+            <a:r>
+              <a:rPr lang="en-IN" sz="1750" b="0" i="0" dirty="0">
+                <a:solidFill>
+                  <a:schemeClr val="tx1"/>
+                </a:solidFill>
+                <a:effectLst/>
+                <a:latin typeface="Ramabhadra" panose="02000600000000000000" pitchFamily="2" charset="0"/>
+                <a:cs typeface="Ramabhadra" panose="02000600000000000000" pitchFamily="2" charset="0"/>
+              </a:rPr>
+              <a:t> </a:t>
+            </a:r>
+            <a:r>
+              <a:rPr lang="te-IN" sz="1750" b="0" i="0" dirty="0">
+                <a:solidFill>
+                  <a:schemeClr val="tx1"/>
+                </a:solidFill>
+                <a:effectLst/>
+                <a:latin typeface="Ramabhadra" panose="02000600000000000000" pitchFamily="2" charset="0"/>
+                <a:cs typeface="Ramabhadra" panose="02000600000000000000" pitchFamily="2" charset="0"/>
+              </a:rPr>
+              <a:t>-</a:t>
+            </a:r>
+            <a:endParaRPr lang="en-IN" sz="1750" b="0" i="0" dirty="0">
+              <a:solidFill>
+                <a:schemeClr val="tx1"/>
+              </a:solidFill>
+              <a:effectLst/>
+              <a:latin typeface="Ramabhadra" panose="02000600000000000000" pitchFamily="2" charset="0"/>
+              <a:cs typeface="Ramabhadra" panose="02000600000000000000" pitchFamily="2" charset="0"/>
+            </a:endParaRPr>
           </a:p>
           <a:p>
             <a:pPr marL="0" marR="0" indent="0" algn="ctr" rtl="0" eaLnBrk="1" fontAlgn="auto" latinLnBrk="0" hangingPunct="1">
@@ -3653,7 +3691,7 @@
               </a:spcAft>
             </a:pPr>
             <a:r>
-              <a:rPr lang="te-IN" b="0" i="0" dirty="0">
+              <a:rPr lang="te-IN" sz="1750" b="0" i="0" dirty="0">
                 <a:solidFill>
                   <a:schemeClr val="tx1"/>
                 </a:solidFill>
@@ -3661,7 +3699,7 @@
                 <a:latin typeface="Ramabhadra" panose="02000600000000000000" pitchFamily="2" charset="0"/>
                 <a:cs typeface="Ramabhadra" panose="02000600000000000000" pitchFamily="2" charset="0"/>
               </a:rPr>
-              <a:t>దేవా అనుక్షణం</a:t>
+              <a:t>నేయిల జీవించెదనూ</a:t>
             </a:r>
           </a:p>
           <a:p>
@@ -3673,14 +3711,17 @@
                 <a:spcPts val="0"/>
               </a:spcAft>
             </a:pPr>
-            <a:endParaRPr lang="te-IN" b="0" i="0" dirty="0">
-              <a:solidFill>
-                <a:schemeClr val="tx1"/>
-              </a:solidFill>
-              <a:effectLst/>
-              <a:latin typeface="Ramabhadra" panose="02000600000000000000" pitchFamily="2" charset="0"/>
-              <a:cs typeface="Ramabhadra" panose="02000600000000000000" pitchFamily="2" charset="0"/>
-            </a:endParaRPr>
+            <a:r>
+              <a:rPr lang="te-IN" sz="1750" b="0" i="0" dirty="0">
+                <a:solidFill>
+                  <a:schemeClr val="tx1"/>
+                </a:solidFill>
+                <a:effectLst/>
+                <a:latin typeface="Ramabhadra" panose="02000600000000000000" pitchFamily="2" charset="0"/>
+                <a:cs typeface="Ramabhadra" panose="02000600000000000000" pitchFamily="2" charset="0"/>
+              </a:rPr>
+              <a:t>ప్రభూ కొరకై నిలచెదనూ</a:t>
+            </a:r>
           </a:p>
           <a:p>
             <a:pPr marL="0" marR="0" indent="0" algn="ctr" rtl="0" eaLnBrk="1" fontAlgn="auto" latinLnBrk="0" hangingPunct="1">
@@ -3691,17 +3732,14 @@
                 <a:spcPts val="0"/>
               </a:spcAft>
             </a:pPr>
-            <a:r>
-              <a:rPr lang="te-IN" b="0" i="0" dirty="0">
-                <a:solidFill>
-                  <a:schemeClr val="tx1"/>
-                </a:solidFill>
-                <a:effectLst/>
-                <a:latin typeface="Ramabhadra" panose="02000600000000000000" pitchFamily="2" charset="0"/>
-                <a:cs typeface="Ramabhadra" panose="02000600000000000000" pitchFamily="2" charset="0"/>
-              </a:rPr>
-              <a:t>దయతో కాపాడినావు</a:t>
-            </a:r>
+            <a:endParaRPr lang="te-IN" sz="1750" b="0" i="0" dirty="0">
+              <a:solidFill>
+                <a:schemeClr val="tx1"/>
+              </a:solidFill>
+              <a:effectLst/>
+              <a:latin typeface="Ramabhadra" panose="02000600000000000000" pitchFamily="2" charset="0"/>
+              <a:cs typeface="Ramabhadra" panose="02000600000000000000" pitchFamily="2" charset="0"/>
+            </a:endParaRPr>
           </a:p>
           <a:p>
             <a:pPr marL="0" marR="0" indent="0" algn="ctr" rtl="0" eaLnBrk="1" fontAlgn="auto" latinLnBrk="0" hangingPunct="1">
@@ -3713,7 +3751,7 @@
               </a:spcAft>
             </a:pPr>
             <a:r>
-              <a:rPr lang="te-IN" b="0" i="0" dirty="0">
+              <a:rPr lang="te-IN" sz="1750" b="0" i="0" dirty="0">
                 <a:solidFill>
                   <a:schemeClr val="tx1"/>
                 </a:solidFill>
@@ -3721,7 +3759,7 @@
                 <a:latin typeface="Ramabhadra" panose="02000600000000000000" pitchFamily="2" charset="0"/>
                 <a:cs typeface="Ramabhadra" panose="02000600000000000000" pitchFamily="2" charset="0"/>
               </a:rPr>
-              <a:t>కృపనే చూపించినావు (2) </a:t>
+              <a:t>అది అంతము నీవే .... ఆధార భూతుడ నీవే</a:t>
             </a:r>
           </a:p>
           <a:p>
@@ -3734,7 +3772,7 @@
               </a:spcAft>
             </a:pPr>
             <a:r>
-              <a:rPr lang="te-IN" b="0" i="0" dirty="0">
+              <a:rPr lang="te-IN" sz="1750" b="0" i="0" dirty="0">
                 <a:solidFill>
                   <a:schemeClr val="tx1"/>
                 </a:solidFill>
@@ -3742,7 +3780,7 @@
                 <a:latin typeface="Ramabhadra" panose="02000600000000000000" pitchFamily="2" charset="0"/>
                 <a:cs typeface="Ramabhadra" panose="02000600000000000000" pitchFamily="2" charset="0"/>
               </a:rPr>
-              <a:t>నిను నే మరువనేసు</a:t>
+              <a:t>ప్రతి జీవిని ప్రేమించి పోషించు ప్రాణదాత నీవే</a:t>
             </a:r>
           </a:p>
           <a:p>
@@ -3755,7 +3793,7 @@
               </a:spcAft>
             </a:pPr>
             <a:r>
-              <a:rPr lang="te-IN" b="0" i="0" dirty="0">
+              <a:rPr lang="te-IN" sz="1750" b="0" i="0" dirty="0">
                 <a:solidFill>
                   <a:schemeClr val="tx1"/>
                 </a:solidFill>
@@ -3763,8 +3801,37 @@
                 <a:latin typeface="Ramabhadra" panose="02000600000000000000" pitchFamily="2" charset="0"/>
                 <a:cs typeface="Ramabhadra" panose="02000600000000000000" pitchFamily="2" charset="0"/>
               </a:rPr>
-              <a:t>నిను నే విడువనేసు</a:t>
-            </a:r>
+              <a:t>నీ ప్రేమలో ... నీ నీడలో</a:t>
+            </a:r>
+            <a:r>
+              <a:rPr lang="en-IN" sz="1750" dirty="0">
+                <a:solidFill>
+                  <a:schemeClr val="tx1"/>
+                </a:solidFill>
+                <a:latin typeface="Ramabhadra" panose="02000600000000000000" pitchFamily="2" charset="0"/>
+                <a:cs typeface="Ramabhadra" panose="02000600000000000000" pitchFamily="2" charset="0"/>
+              </a:rPr>
+              <a:t> </a:t>
+            </a:r>
+            <a:r>
+              <a:rPr lang="te-IN" sz="1750" b="0" i="0" dirty="0">
+                <a:solidFill>
+                  <a:schemeClr val="tx1"/>
+                </a:solidFill>
+                <a:effectLst/>
+                <a:latin typeface="Ramabhadra" panose="02000600000000000000" pitchFamily="2" charset="0"/>
+                <a:cs typeface="Ramabhadra" panose="02000600000000000000" pitchFamily="2" charset="0"/>
+              </a:rPr>
+              <a:t>నిలుపుము</a:t>
+            </a:r>
+            <a:endParaRPr lang="en-IN" sz="1750" b="0" i="0" dirty="0">
+              <a:solidFill>
+                <a:schemeClr val="tx1"/>
+              </a:solidFill>
+              <a:effectLst/>
+              <a:latin typeface="Ramabhadra" panose="02000600000000000000" pitchFamily="2" charset="0"/>
+              <a:cs typeface="Ramabhadra" panose="02000600000000000000" pitchFamily="2" charset="0"/>
+            </a:endParaRPr>
           </a:p>
           <a:p>
             <a:pPr marL="0" marR="0" indent="0" algn="ctr" rtl="0" eaLnBrk="1" fontAlgn="auto" latinLnBrk="0" hangingPunct="1">
@@ -3776,7 +3843,7 @@
               </a:spcAft>
             </a:pPr>
             <a:r>
-              <a:rPr lang="te-IN" b="0" i="0" dirty="0">
+              <a:rPr lang="te-IN" sz="1750" b="0" i="0" dirty="0">
                 <a:solidFill>
                   <a:schemeClr val="tx1"/>
                 </a:solidFill>
@@ -3784,7 +3851,7 @@
                 <a:latin typeface="Ramabhadra" panose="02000600000000000000" pitchFamily="2" charset="0"/>
                 <a:cs typeface="Ramabhadra" panose="02000600000000000000" pitchFamily="2" charset="0"/>
               </a:rPr>
-              <a:t> </a:t>
+              <a:t>నీకే స్తోత్రము</a:t>
             </a:r>
           </a:p>
           <a:p>
@@ -3796,17 +3863,14 @@
                 <a:spcPts val="0"/>
               </a:spcAft>
             </a:pPr>
-            <a:r>
-              <a:rPr lang="te-IN" b="0" i="0" dirty="0">
-                <a:solidFill>
-                  <a:schemeClr val="tx1"/>
-                </a:solidFill>
-                <a:effectLst/>
-                <a:latin typeface="Ramabhadra" panose="02000600000000000000" pitchFamily="2" charset="0"/>
-                <a:cs typeface="Ramabhadra" panose="02000600000000000000" pitchFamily="2" charset="0"/>
-              </a:rPr>
-              <a:t>పాపినై యుండగ నేను</a:t>
-            </a:r>
+            <a:endParaRPr lang="te-IN" sz="1750" b="0" i="0" dirty="0">
+              <a:solidFill>
+                <a:schemeClr val="tx1"/>
+              </a:solidFill>
+              <a:effectLst/>
+              <a:latin typeface="Ramabhadra" panose="02000600000000000000" pitchFamily="2" charset="0"/>
+              <a:cs typeface="Ramabhadra" panose="02000600000000000000" pitchFamily="2" charset="0"/>
+            </a:endParaRPr>
           </a:p>
           <a:p>
             <a:pPr marL="0" marR="0" indent="0" algn="ctr" rtl="0" eaLnBrk="1" fontAlgn="auto" latinLnBrk="0" hangingPunct="1">
@@ -3818,7 +3882,7 @@
               </a:spcAft>
             </a:pPr>
             <a:r>
-              <a:rPr lang="te-IN" b="0" i="0" dirty="0">
+              <a:rPr lang="te-IN" sz="1750" b="0" i="0" dirty="0">
                 <a:solidFill>
                   <a:schemeClr val="tx1"/>
                 </a:solidFill>
@@ -3826,8 +3890,16 @@
                 <a:latin typeface="Ramabhadra" panose="02000600000000000000" pitchFamily="2" charset="0"/>
                 <a:cs typeface="Ramabhadra" panose="02000600000000000000" pitchFamily="2" charset="0"/>
               </a:rPr>
-              <a:t>రక్షించి దరి చేర్చినావు (2)  </a:t>
-            </a:r>
+              <a:t>లోకమంత నీరాకకై</a:t>
+            </a:r>
+            <a:endParaRPr lang="en-IN" sz="1750" b="0" i="0" dirty="0">
+              <a:solidFill>
+                <a:schemeClr val="tx1"/>
+              </a:solidFill>
+              <a:effectLst/>
+              <a:latin typeface="Ramabhadra" panose="02000600000000000000" pitchFamily="2" charset="0"/>
+              <a:cs typeface="Ramabhadra" panose="02000600000000000000" pitchFamily="2" charset="0"/>
+            </a:endParaRPr>
           </a:p>
           <a:p>
             <a:pPr marL="0" marR="0" indent="0" algn="ctr" rtl="0" eaLnBrk="1" fontAlgn="auto" latinLnBrk="0" hangingPunct="1">
@@ -3839,7 +3911,7 @@
               </a:spcAft>
             </a:pPr>
             <a:r>
-              <a:rPr lang="te-IN" b="0" i="0" dirty="0">
+              <a:rPr lang="te-IN" sz="1750" b="0" i="0" dirty="0">
                 <a:solidFill>
                   <a:schemeClr val="tx1"/>
                 </a:solidFill>
@@ -3847,7 +3919,7 @@
                 <a:latin typeface="Ramabhadra" panose="02000600000000000000" pitchFamily="2" charset="0"/>
                 <a:cs typeface="Ramabhadra" panose="02000600000000000000" pitchFamily="2" charset="0"/>
               </a:rPr>
-              <a:t>నిను నే మరువనేసు – నిను నే విడువనేసు</a:t>
+              <a:t>వేచి యుండెను నా ప్రభూ</a:t>
             </a:r>
           </a:p>
           <a:p>
@@ -3859,7 +3931,18 @@
                 <a:spcPts val="0"/>
               </a:spcAft>
             </a:pPr>
-            <a:endParaRPr lang="te-IN" b="0" i="0" dirty="0">
+            <a:r>
+              <a:rPr lang="te-IN" sz="1750" b="0" i="0" dirty="0">
+                <a:solidFill>
+                  <a:schemeClr val="tx1"/>
+                </a:solidFill>
+                <a:effectLst/>
+                <a:latin typeface="Ramabhadra" panose="02000600000000000000" pitchFamily="2" charset="0"/>
+                <a:cs typeface="Ramabhadra" panose="02000600000000000000" pitchFamily="2" charset="0"/>
+              </a:rPr>
+              <a:t>మేఘ వాహనంబు మీద</a:t>
+            </a:r>
+            <a:endParaRPr lang="en-IN" sz="1750" b="0" i="0" dirty="0">
               <a:solidFill>
                 <a:schemeClr val="tx1"/>
               </a:solidFill>
@@ -3878,7 +3961,7 @@
               </a:spcAft>
             </a:pPr>
             <a:r>
-              <a:rPr lang="te-IN" b="0" i="0" dirty="0">
+              <a:rPr lang="te-IN" sz="1750" b="0" i="0" dirty="0">
                 <a:solidFill>
                   <a:schemeClr val="tx1"/>
                 </a:solidFill>
@@ -3886,7 +3969,7 @@
                 <a:latin typeface="Ramabhadra" panose="02000600000000000000" pitchFamily="2" charset="0"/>
                 <a:cs typeface="Ramabhadra" panose="02000600000000000000" pitchFamily="2" charset="0"/>
               </a:rPr>
-              <a:t>సిలువే నాకు శరణం నీవే నాకు మార్గం (2)  </a:t>
+              <a:t>మేటి దూత గణముల తోడా</a:t>
             </a:r>
           </a:p>
           <a:p>
@@ -3899,7 +3982,7 @@
               </a:spcAft>
             </a:pPr>
             <a:r>
-              <a:rPr lang="te-IN" b="0" i="0" dirty="0">
+              <a:rPr lang="te-IN" sz="1750" b="0" i="0" dirty="0">
                 <a:solidFill>
                   <a:schemeClr val="tx1"/>
                 </a:solidFill>
@@ -3907,7 +3990,36 @@
                 <a:latin typeface="Ramabhadra" panose="02000600000000000000" pitchFamily="2" charset="0"/>
                 <a:cs typeface="Ramabhadra" panose="02000600000000000000" pitchFamily="2" charset="0"/>
               </a:rPr>
-              <a:t>నిను నే మరువనేసు – నిను నే విడువనేసు </a:t>
+              <a:t>వేవేగమే రానైయున్న రారాజా-</a:t>
+            </a:r>
+            <a:endParaRPr lang="en-IN" sz="1750" b="0" i="0" dirty="0">
+              <a:solidFill>
+                <a:schemeClr val="tx1"/>
+              </a:solidFill>
+              <a:effectLst/>
+              <a:latin typeface="Ramabhadra" panose="02000600000000000000" pitchFamily="2" charset="0"/>
+              <a:cs typeface="Ramabhadra" panose="02000600000000000000" pitchFamily="2" charset="0"/>
+            </a:endParaRPr>
+          </a:p>
+          <a:p>
+            <a:pPr marL="0" marR="0" indent="0" algn="ctr" rtl="0" eaLnBrk="1" fontAlgn="auto" latinLnBrk="0" hangingPunct="1">
+              <a:spcBef>
+                <a:spcPts val="0"/>
+              </a:spcBef>
+              <a:spcAft>
+                <a:spcPts val="0"/>
+              </a:spcAft>
+            </a:pPr>
+            <a:r>
+              <a:rPr lang="te-IN" sz="1750" b="0" i="0" dirty="0">
+                <a:solidFill>
+                  <a:schemeClr val="tx1"/>
+                </a:solidFill>
+                <a:effectLst/>
+                <a:latin typeface="Ramabhadra" panose="02000600000000000000" pitchFamily="2" charset="0"/>
+                <a:cs typeface="Ramabhadra" panose="02000600000000000000" pitchFamily="2" charset="0"/>
+              </a:rPr>
+              <a:t>నీకై స్తోత్రము</a:t>
             </a:r>
           </a:p>
         </p:txBody>
@@ -3926,7 +4038,7 @@
         </p:nvSpPr>
         <p:spPr>
           <a:xfrm>
-            <a:off x="3429000" y="125663"/>
+            <a:off x="51132" y="4874508"/>
             <a:ext cx="3377868" cy="4752474"/>
           </a:xfrm>
           <a:prstGeom prst="rect">
@@ -3965,7 +4077,7 @@
           <a:p>
             <a:pPr algn="ctr"/>
             <a:r>
-              <a:rPr lang="te-IN" sz="1600" b="0" i="0" dirty="0">
+              <a:rPr lang="te-IN" b="0" i="0" dirty="0">
                 <a:solidFill>
                   <a:srgbClr val="000000"/>
                 </a:solidFill>
@@ -3973,10 +4085,13 @@
                 <a:latin typeface="Ramabhadra" panose="02000600000000000000" pitchFamily="2" charset="0"/>
                 <a:cs typeface="Ramabhadra" panose="02000600000000000000" pitchFamily="2" charset="0"/>
               </a:rPr>
-              <a:t>(యేసు) రాజా నీ భవనములో</a:t>
-            </a:r>
-            <a:br>
-              <a:rPr lang="te-IN" sz="1600" b="0" i="0" dirty="0">
+              <a:t>నేనున్న స్థితిలోనే సంతృప్తిని కలిగించు </a:t>
+            </a:r>
+          </a:p>
+          <a:p>
+            <a:pPr algn="ctr"/>
+            <a:r>
+              <a:rPr lang="te-IN" b="0" i="0" dirty="0">
                 <a:solidFill>
                   <a:srgbClr val="000000"/>
                 </a:solidFill>
@@ -3984,9 +4099,13 @@
                 <a:latin typeface="Ramabhadra" panose="02000600000000000000" pitchFamily="2" charset="0"/>
                 <a:cs typeface="Ramabhadra" panose="02000600000000000000" pitchFamily="2" charset="0"/>
               </a:rPr>
-            </a:br>
-            <a:r>
-              <a:rPr lang="te-IN" sz="1600" b="0" i="0" dirty="0">
+              <a:t>ఏమున్న లేకున్న నీకొరకే బ్రతికించు (2)</a:t>
+            </a:r>
+          </a:p>
+          <a:p>
+            <a:pPr algn="ctr"/>
+            <a:r>
+              <a:rPr lang="te-IN" b="0" i="0" dirty="0">
                 <a:solidFill>
                   <a:srgbClr val="000000"/>
                 </a:solidFill>
@@ -3994,10 +4113,13 @@
                 <a:latin typeface="Ramabhadra" panose="02000600000000000000" pitchFamily="2" charset="0"/>
                 <a:cs typeface="Ramabhadra" panose="02000600000000000000" pitchFamily="2" charset="0"/>
               </a:rPr>
-              <a:t>రేయి పగలు వేచియుందును (2)</a:t>
-            </a:r>
-            <a:br>
-              <a:rPr lang="te-IN" sz="1600" b="0" i="0" dirty="0">
+              <a:t>కష్టాలు ఎదురైనా నా యాత్రను సాగించు </a:t>
+            </a:r>
+          </a:p>
+          <a:p>
+            <a:pPr algn="ctr"/>
+            <a:r>
+              <a:rPr lang="te-IN" b="0" i="0" dirty="0">
                 <a:solidFill>
                   <a:srgbClr val="000000"/>
                 </a:solidFill>
@@ -4005,43 +4127,12 @@
                 <a:latin typeface="Ramabhadra" panose="02000600000000000000" pitchFamily="2" charset="0"/>
                 <a:cs typeface="Ramabhadra" panose="02000600000000000000" pitchFamily="2" charset="0"/>
               </a:rPr>
-            </a:br>
-            <a:r>
-              <a:rPr lang="te-IN" sz="1600" b="0" i="0" dirty="0">
-                <a:solidFill>
-                  <a:srgbClr val="000000"/>
-                </a:solidFill>
-                <a:effectLst/>
-                <a:latin typeface="Ramabhadra" panose="02000600000000000000" pitchFamily="2" charset="0"/>
-                <a:cs typeface="Ramabhadra" panose="02000600000000000000" pitchFamily="2" charset="0"/>
-              </a:rPr>
-              <a:t>(నిన్ను) స్తుతించి ఆనందింతును</a:t>
-            </a:r>
-            <a:br>
-              <a:rPr lang="te-IN" sz="1600" b="0" i="0" dirty="0">
-                <a:solidFill>
-                  <a:srgbClr val="000000"/>
-                </a:solidFill>
-                <a:effectLst/>
-                <a:latin typeface="Ramabhadra" panose="02000600000000000000" pitchFamily="2" charset="0"/>
-                <a:cs typeface="Ramabhadra" panose="02000600000000000000" pitchFamily="2" charset="0"/>
-              </a:rPr>
-            </a:br>
-            <a:r>
-              <a:rPr lang="te-IN" sz="1600" b="0" i="0" dirty="0">
-                <a:solidFill>
-                  <a:srgbClr val="000000"/>
-                </a:solidFill>
-                <a:effectLst/>
-                <a:latin typeface="Ramabhadra" panose="02000600000000000000" pitchFamily="2" charset="0"/>
-                <a:cs typeface="Ramabhadra" panose="02000600000000000000" pitchFamily="2" charset="0"/>
-              </a:rPr>
-              <a:t>చింతలు మరచెదను (2)</a:t>
+              <a:t>నష్టాలలోనైనా స్తుతిచేయుట నేర్పించు (2)</a:t>
             </a:r>
           </a:p>
           <a:p>
             <a:pPr algn="ctr"/>
-            <a:endParaRPr lang="te-IN" sz="1600" b="0" i="0" dirty="0">
+            <a:endParaRPr lang="te-IN" b="0" i="0" dirty="0">
               <a:solidFill>
                 <a:srgbClr val="000000"/>
               </a:solidFill>
@@ -4053,7 +4144,7 @@
           <a:p>
             <a:pPr algn="ctr"/>
             <a:r>
-              <a:rPr lang="te-IN" sz="1600" b="0" i="0" dirty="0">
+              <a:rPr lang="te-IN" b="0" i="0" dirty="0">
                 <a:solidFill>
                   <a:srgbClr val="000000"/>
                 </a:solidFill>
@@ -4061,117 +4152,9 @@
                 <a:latin typeface="Ramabhadra" panose="02000600000000000000" pitchFamily="2" charset="0"/>
                 <a:cs typeface="Ramabhadra" panose="02000600000000000000" pitchFamily="2" charset="0"/>
               </a:rPr>
-              <a:t>నా బలమా నా కోట</a:t>
-            </a:r>
-            <a:br>
-              <a:rPr lang="te-IN" sz="1600" b="0" i="0" dirty="0">
-                <a:solidFill>
-                  <a:srgbClr val="000000"/>
-                </a:solidFill>
-                <a:effectLst/>
-                <a:latin typeface="Ramabhadra" panose="02000600000000000000" pitchFamily="2" charset="0"/>
-                <a:cs typeface="Ramabhadra" panose="02000600000000000000" pitchFamily="2" charset="0"/>
-              </a:rPr>
-            </a:br>
-            <a:r>
-              <a:rPr lang="te-IN" sz="1600" b="0" i="0" dirty="0">
-                <a:solidFill>
-                  <a:srgbClr val="000000"/>
-                </a:solidFill>
-                <a:effectLst/>
-                <a:latin typeface="Ramabhadra" panose="02000600000000000000" pitchFamily="2" charset="0"/>
-                <a:cs typeface="Ramabhadra" panose="02000600000000000000" pitchFamily="2" charset="0"/>
-              </a:rPr>
-              <a:t>ఆరాధన నీకే (2)</a:t>
-            </a:r>
-            <a:br>
-              <a:rPr lang="te-IN" sz="1600" b="0" i="0" dirty="0">
-                <a:solidFill>
-                  <a:srgbClr val="000000"/>
-                </a:solidFill>
-                <a:effectLst/>
-                <a:latin typeface="Ramabhadra" panose="02000600000000000000" pitchFamily="2" charset="0"/>
-                <a:cs typeface="Ramabhadra" panose="02000600000000000000" pitchFamily="2" charset="0"/>
-              </a:rPr>
-            </a:br>
-            <a:r>
-              <a:rPr lang="te-IN" sz="1600" b="0" i="0" dirty="0">
-                <a:solidFill>
-                  <a:srgbClr val="000000"/>
-                </a:solidFill>
-                <a:effectLst/>
-                <a:latin typeface="Ramabhadra" panose="02000600000000000000" pitchFamily="2" charset="0"/>
-                <a:cs typeface="Ramabhadra" panose="02000600000000000000" pitchFamily="2" charset="0"/>
-              </a:rPr>
-              <a:t>నా దుర్గమా ఆశ్రయమా</a:t>
-            </a:r>
-            <a:br>
-              <a:rPr lang="te-IN" sz="1600" b="0" i="0" dirty="0">
-                <a:solidFill>
-                  <a:srgbClr val="000000"/>
-                </a:solidFill>
-                <a:effectLst/>
-                <a:latin typeface="Ramabhadra" panose="02000600000000000000" pitchFamily="2" charset="0"/>
-                <a:cs typeface="Ramabhadra" panose="02000600000000000000" pitchFamily="2" charset="0"/>
-              </a:rPr>
-            </a:br>
-            <a:r>
-              <a:rPr lang="te-IN" sz="1600" b="0" i="0" dirty="0">
-                <a:solidFill>
-                  <a:srgbClr val="000000"/>
-                </a:solidFill>
-                <a:effectLst/>
-                <a:latin typeface="Ramabhadra" panose="02000600000000000000" pitchFamily="2" charset="0"/>
-                <a:cs typeface="Ramabhadra" panose="02000600000000000000" pitchFamily="2" charset="0"/>
-              </a:rPr>
-              <a:t>ఆరాధన నీకే (2)</a:t>
-            </a:r>
-            <a:br>
-              <a:rPr lang="te-IN" sz="1600" b="0" i="0" dirty="0">
-                <a:solidFill>
-                  <a:srgbClr val="000000"/>
-                </a:solidFill>
-                <a:effectLst/>
-                <a:latin typeface="Ramabhadra" panose="02000600000000000000" pitchFamily="2" charset="0"/>
-                <a:cs typeface="Ramabhadra" panose="02000600000000000000" pitchFamily="2" charset="0"/>
-              </a:rPr>
-            </a:br>
-            <a:r>
-              <a:rPr lang="te-IN" sz="1600" b="0" i="0" dirty="0">
-                <a:solidFill>
-                  <a:srgbClr val="000000"/>
-                </a:solidFill>
-                <a:effectLst/>
-                <a:latin typeface="Ramabhadra" panose="02000600000000000000" pitchFamily="2" charset="0"/>
-                <a:cs typeface="Ramabhadra" panose="02000600000000000000" pitchFamily="2" charset="0"/>
-              </a:rPr>
-              <a:t>ఆరాధనా ఆరాధనా</a:t>
-            </a:r>
-            <a:br>
-              <a:rPr lang="te-IN" sz="1600" b="0" i="0" dirty="0">
-                <a:solidFill>
-                  <a:srgbClr val="000000"/>
-                </a:solidFill>
-                <a:effectLst/>
-                <a:latin typeface="Ramabhadra" panose="02000600000000000000" pitchFamily="2" charset="0"/>
-                <a:cs typeface="Ramabhadra" panose="02000600000000000000" pitchFamily="2" charset="0"/>
-              </a:rPr>
-            </a:br>
-            <a:r>
-              <a:rPr lang="te-IN" sz="1600" b="0" i="0" dirty="0">
-                <a:solidFill>
-                  <a:srgbClr val="000000"/>
-                </a:solidFill>
-                <a:effectLst/>
-                <a:latin typeface="Ramabhadra" panose="02000600000000000000" pitchFamily="2" charset="0"/>
-                <a:cs typeface="Ramabhadra" panose="02000600000000000000" pitchFamily="2" charset="0"/>
-              </a:rPr>
-              <a:t>అబ్బ తండ్రి నీకేనయ్యా</a:t>
-            </a:r>
-          </a:p>
-          <a:p>
-            <a:pPr algn="ctr"/>
-            <a:endParaRPr lang="te-IN" sz="1600" b="0" i="0" dirty="0">
+              <a:t>లోకములో నీ కొరకు</a:t>
+            </a:r>
+            <a:endParaRPr lang="en-US" b="0" i="0" dirty="0">
               <a:solidFill>
                 <a:srgbClr val="000000"/>
               </a:solidFill>
@@ -4183,7 +4166,7 @@
           <a:p>
             <a:pPr algn="ctr"/>
             <a:r>
-              <a:rPr lang="te-IN" sz="1600" b="0" i="0" dirty="0">
+              <a:rPr lang="te-IN" b="0" i="0" dirty="0">
                 <a:solidFill>
                   <a:srgbClr val="000000"/>
                 </a:solidFill>
@@ -4191,10 +4174,13 @@
                 <a:latin typeface="Ramabhadra" panose="02000600000000000000" pitchFamily="2" charset="0"/>
                 <a:cs typeface="Ramabhadra" panose="02000600000000000000" pitchFamily="2" charset="0"/>
               </a:rPr>
-              <a:t>అంతట నివసించు యెహోవా ఎలోహిం</a:t>
-            </a:r>
-            <a:br>
-              <a:rPr lang="te-IN" sz="1600" b="0" i="0" dirty="0">
+              <a:t>జ్యోతిగ నను వెలిగించు (2)</a:t>
+            </a:r>
+          </a:p>
+          <a:p>
+            <a:pPr algn="ctr"/>
+            <a:r>
+              <a:rPr lang="te-IN" b="0" i="0" dirty="0">
                 <a:solidFill>
                   <a:srgbClr val="000000"/>
                 </a:solidFill>
@@ -4202,9 +4188,21 @@
                 <a:latin typeface="Ramabhadra" panose="02000600000000000000" pitchFamily="2" charset="0"/>
                 <a:cs typeface="Ramabhadra" panose="02000600000000000000" pitchFamily="2" charset="0"/>
               </a:rPr>
-            </a:br>
-            <a:r>
-              <a:rPr lang="te-IN" sz="1600" b="0" i="0" dirty="0">
+              <a:t>రెండవ రాకడవరకు</a:t>
+            </a:r>
+            <a:endParaRPr lang="en-US" b="0" i="0" dirty="0">
+              <a:solidFill>
+                <a:srgbClr val="000000"/>
+              </a:solidFill>
+              <a:effectLst/>
+              <a:latin typeface="Ramabhadra" panose="02000600000000000000" pitchFamily="2" charset="0"/>
+              <a:cs typeface="Ramabhadra" panose="02000600000000000000" pitchFamily="2" charset="0"/>
+            </a:endParaRPr>
+          </a:p>
+          <a:p>
+            <a:pPr algn="ctr"/>
+            <a:r>
+              <a:rPr lang="te-IN" b="0" i="0" dirty="0">
                 <a:solidFill>
                   <a:srgbClr val="000000"/>
                 </a:solidFill>
@@ -4212,10 +4210,24 @@
                 <a:latin typeface="Ramabhadra" panose="02000600000000000000" pitchFamily="2" charset="0"/>
                 <a:cs typeface="Ramabhadra" panose="02000600000000000000" pitchFamily="2" charset="0"/>
               </a:rPr>
-              <a:t>ఆరాధన నీకే (2)</a:t>
-            </a:r>
-            <a:br>
-              <a:rPr lang="te-IN" sz="1600" b="0" i="0" dirty="0">
+              <a:t>విడువక నను నడిపించు (2)</a:t>
+            </a:r>
+          </a:p>
+          <a:p>
+            <a:pPr algn="ctr"/>
+            <a:endParaRPr lang="te-IN" b="0" i="0" dirty="0">
+              <a:solidFill>
+                <a:srgbClr val="000000"/>
+              </a:solidFill>
+              <a:effectLst/>
+              <a:latin typeface="Ramabhadra" panose="02000600000000000000" pitchFamily="2" charset="0"/>
+              <a:cs typeface="Ramabhadra" panose="02000600000000000000" pitchFamily="2" charset="0"/>
+            </a:endParaRPr>
+          </a:p>
+          <a:p>
+            <a:pPr algn="ctr"/>
+            <a:r>
+              <a:rPr lang="te-IN" b="0" i="0" dirty="0">
                 <a:solidFill>
                   <a:srgbClr val="000000"/>
                 </a:solidFill>
@@ -4223,9 +4235,21 @@
                 <a:latin typeface="Ramabhadra" panose="02000600000000000000" pitchFamily="2" charset="0"/>
                 <a:cs typeface="Ramabhadra" panose="02000600000000000000" pitchFamily="2" charset="0"/>
               </a:rPr>
-            </a:br>
-            <a:r>
-              <a:rPr lang="te-IN" sz="1600" b="0" i="0" dirty="0">
+              <a:t>నా దినముల పరిమాణం</a:t>
+            </a:r>
+            <a:endParaRPr lang="en-US" b="0" i="0" dirty="0">
+              <a:solidFill>
+                <a:srgbClr val="000000"/>
+              </a:solidFill>
+              <a:effectLst/>
+              <a:latin typeface="Ramabhadra" panose="02000600000000000000" pitchFamily="2" charset="0"/>
+              <a:cs typeface="Ramabhadra" panose="02000600000000000000" pitchFamily="2" charset="0"/>
+            </a:endParaRPr>
+          </a:p>
+          <a:p>
+            <a:pPr algn="ctr"/>
+            <a:r>
+              <a:rPr lang="te-IN" b="0" i="0" dirty="0">
                 <a:solidFill>
                   <a:srgbClr val="000000"/>
                 </a:solidFill>
@@ -4233,10 +4257,13 @@
                 <a:latin typeface="Ramabhadra" panose="02000600000000000000" pitchFamily="2" charset="0"/>
                 <a:cs typeface="Ramabhadra" panose="02000600000000000000" pitchFamily="2" charset="0"/>
               </a:rPr>
-              <a:t>మా యొక్క నీతి యెహోవా సిద్కేను</a:t>
-            </a:r>
-            <a:br>
-              <a:rPr lang="te-IN" sz="1600" b="0" i="0" dirty="0">
+              <a:t>లెక్కించుట నేర్పించు (2)</a:t>
+            </a:r>
+          </a:p>
+          <a:p>
+            <a:pPr algn="ctr"/>
+            <a:r>
+              <a:rPr lang="te-IN" b="0" i="0" dirty="0">
                 <a:solidFill>
                   <a:srgbClr val="000000"/>
                 </a:solidFill>
@@ -4244,9 +4271,13 @@
                 <a:latin typeface="Ramabhadra" panose="02000600000000000000" pitchFamily="2" charset="0"/>
                 <a:cs typeface="Ramabhadra" panose="02000600000000000000" pitchFamily="2" charset="0"/>
               </a:rPr>
-            </a:br>
-            <a:r>
-              <a:rPr lang="te-IN" sz="1600" b="0" i="0" dirty="0">
+              <a:t>నా లోపల స్థిర హృదయం</a:t>
+            </a:r>
+          </a:p>
+          <a:p>
+            <a:pPr algn="ctr"/>
+            <a:r>
+              <a:rPr lang="te-IN" b="0" i="0" dirty="0">
                 <a:solidFill>
                   <a:srgbClr val="000000"/>
                 </a:solidFill>
@@ -4254,49 +4285,7 @@
                 <a:latin typeface="Ramabhadra" panose="02000600000000000000" pitchFamily="2" charset="0"/>
                 <a:cs typeface="Ramabhadra" panose="02000600000000000000" pitchFamily="2" charset="0"/>
               </a:rPr>
-              <a:t>ఆరాధన నీకే (2)</a:t>
-            </a:r>
-            <a:br>
-              <a:rPr lang="te-IN" sz="1600" b="0" i="0" dirty="0">
-                <a:solidFill>
-                  <a:srgbClr val="000000"/>
-                </a:solidFill>
-                <a:effectLst/>
-                <a:latin typeface="Ramabhadra" panose="02000600000000000000" pitchFamily="2" charset="0"/>
-                <a:cs typeface="Ramabhadra" panose="02000600000000000000" pitchFamily="2" charset="0"/>
-              </a:rPr>
-            </a:br>
-            <a:r>
-              <a:rPr lang="te-IN" sz="1600" b="0" i="0" dirty="0">
-                <a:solidFill>
-                  <a:srgbClr val="000000"/>
-                </a:solidFill>
-                <a:effectLst/>
-                <a:latin typeface="Ramabhadra" panose="02000600000000000000" pitchFamily="2" charset="0"/>
-                <a:cs typeface="Ramabhadra" panose="02000600000000000000" pitchFamily="2" charset="0"/>
-              </a:rPr>
-              <a:t>ఆరాధనా ఆరాధనా</a:t>
-            </a:r>
-            <a:br>
-              <a:rPr lang="te-IN" sz="1600" b="0" i="0" dirty="0">
-                <a:solidFill>
-                  <a:srgbClr val="000000"/>
-                </a:solidFill>
-                <a:effectLst/>
-                <a:latin typeface="Ramabhadra" panose="02000600000000000000" pitchFamily="2" charset="0"/>
-                <a:cs typeface="Ramabhadra" panose="02000600000000000000" pitchFamily="2" charset="0"/>
-              </a:rPr>
-            </a:br>
-            <a:r>
-              <a:rPr lang="te-IN" sz="1600" b="0" i="0" dirty="0">
-                <a:solidFill>
-                  <a:srgbClr val="000000"/>
-                </a:solidFill>
-                <a:effectLst/>
-                <a:latin typeface="Ramabhadra" panose="02000600000000000000" pitchFamily="2" charset="0"/>
-                <a:cs typeface="Ramabhadra" panose="02000600000000000000" pitchFamily="2" charset="0"/>
-              </a:rPr>
-              <a:t>అబ్బ తండ్రి నీకేనయ్యా</a:t>
+              <a:t>నూతనముగ పుట్టించు (2)</a:t>
             </a:r>
           </a:p>
         </p:txBody>
@@ -4315,7 +4304,7 @@
         </p:nvSpPr>
         <p:spPr>
           <a:xfrm>
-            <a:off x="51132" y="4878137"/>
+            <a:off x="3429000" y="129292"/>
             <a:ext cx="3377868" cy="4752474"/>
           </a:xfrm>
           <a:prstGeom prst="rect">
@@ -4354,7 +4343,7 @@
           <a:p>
             <a:pPr algn="ctr"/>
             <a:r>
-              <a:rPr lang="te-IN" sz="1700" b="0" i="0" dirty="0">
+              <a:rPr lang="te-IN" sz="1750" b="0" i="0" dirty="0">
                 <a:solidFill>
                   <a:schemeClr val="tx1"/>
                 </a:solidFill>
@@ -4362,13 +4351,13 @@
                 <a:latin typeface="Ramabhadra" panose="02000600000000000000" pitchFamily="2" charset="0"/>
                 <a:cs typeface="Ramabhadra" panose="02000600000000000000" pitchFamily="2" charset="0"/>
               </a:rPr>
-              <a:t>హల్లెలూయ పాట యేసయ్య పాట</a:t>
+              <a:t>హల్లెలూయా స్తుతించి పాడి కీర్తింతును</a:t>
             </a:r>
           </a:p>
           <a:p>
             <a:pPr algn="ctr"/>
             <a:r>
-              <a:rPr lang="te-IN" sz="1700" b="0" i="0" dirty="0">
+              <a:rPr lang="te-IN" sz="1750" b="0" i="0" dirty="0">
                 <a:solidFill>
                   <a:schemeClr val="tx1"/>
                 </a:solidFill>
@@ -4376,13 +4365,13 @@
                 <a:latin typeface="Ramabhadra" panose="02000600000000000000" pitchFamily="2" charset="0"/>
                 <a:cs typeface="Ramabhadra" panose="02000600000000000000" pitchFamily="2" charset="0"/>
               </a:rPr>
-              <a:t>పాడాలి ప్రతి చోట పాడాలి ప్రతి నోట</a:t>
+              <a:t>జీవము కంటే ఉత్తమమౌ నీ కృపను</a:t>
             </a:r>
           </a:p>
           <a:p>
             <a:pPr algn="ctr"/>
             <a:r>
-              <a:rPr lang="te-IN" sz="1700" b="0" i="0" dirty="0">
+              <a:rPr lang="te-IN" sz="1750" b="0" i="0" dirty="0">
                 <a:solidFill>
                   <a:schemeClr val="tx1"/>
                 </a:solidFill>
@@ -4390,12 +4379,12 @@
                 <a:latin typeface="Ramabhadra" panose="02000600000000000000" pitchFamily="2" charset="0"/>
                 <a:cs typeface="Ramabhadra" panose="02000600000000000000" pitchFamily="2" charset="0"/>
               </a:rPr>
-              <a:t>హల్లెలూయా హల్లెలూయా హల్లెలూయా (4)</a:t>
+              <a:t>యేసయ్యా........ 4 హల్లెలూయా........ 4</a:t>
             </a:r>
           </a:p>
           <a:p>
             <a:pPr algn="ctr"/>
-            <a:endParaRPr lang="te-IN" sz="1700" b="0" i="0" dirty="0">
+            <a:endParaRPr lang="te-IN" sz="1750" b="0" i="0" dirty="0">
               <a:solidFill>
                 <a:schemeClr val="tx1"/>
               </a:solidFill>
@@ -4407,7 +4396,7 @@
           <a:p>
             <a:pPr algn="ctr"/>
             <a:r>
-              <a:rPr lang="te-IN" sz="1700" b="0" i="0" dirty="0">
+              <a:rPr lang="te-IN" sz="1750" b="0" i="0" dirty="0">
                 <a:solidFill>
                   <a:schemeClr val="tx1"/>
                 </a:solidFill>
@@ -4415,13 +4404,13 @@
                 <a:latin typeface="Ramabhadra" panose="02000600000000000000" pitchFamily="2" charset="0"/>
                 <a:cs typeface="Ramabhadra" panose="02000600000000000000" pitchFamily="2" charset="0"/>
               </a:rPr>
-              <a:t>స్తుతిపాటలే పాడుమా –</a:t>
+              <a:t>బంధువులు స్నేహితులు ఎంతో మందుండగా</a:t>
             </a:r>
           </a:p>
           <a:p>
             <a:pPr algn="ctr"/>
             <a:r>
-              <a:rPr lang="te-IN" sz="1700" b="0" i="0" dirty="0">
+              <a:rPr lang="te-IN" sz="1750" b="0" i="0" dirty="0">
                 <a:solidFill>
                   <a:schemeClr val="tx1"/>
                 </a:solidFill>
@@ -4429,12 +4418,54 @@
                 <a:latin typeface="Ramabhadra" panose="02000600000000000000" pitchFamily="2" charset="0"/>
                 <a:cs typeface="Ramabhadra" panose="02000600000000000000" pitchFamily="2" charset="0"/>
               </a:rPr>
-              <a:t>ప్రభు యేసునే వేడుమా (2)</a:t>
+              <a:t>ఎన్నో మారులు నేను ఒంటరినై యుంటిని -2</a:t>
             </a:r>
           </a:p>
           <a:p>
             <a:pPr algn="ctr"/>
-            <a:endParaRPr lang="te-IN" sz="1700" b="0" i="0" dirty="0">
+            <a:r>
+              <a:rPr lang="te-IN" sz="1750" b="0" i="0" dirty="0">
+                <a:solidFill>
+                  <a:schemeClr val="tx1"/>
+                </a:solidFill>
+                <a:effectLst/>
+                <a:latin typeface="Ramabhadra" panose="02000600000000000000" pitchFamily="2" charset="0"/>
+                <a:cs typeface="Ramabhadra" panose="02000600000000000000" pitchFamily="2" charset="0"/>
+              </a:rPr>
+              <a:t>నా ఒంటరి తనంలో మంచి స్నేహితునిగా </a:t>
+            </a:r>
+          </a:p>
+          <a:p>
+            <a:pPr algn="ctr"/>
+            <a:r>
+              <a:rPr lang="te-IN" sz="1750" b="0" i="0" dirty="0">
+                <a:solidFill>
+                  <a:schemeClr val="tx1"/>
+                </a:solidFill>
+                <a:effectLst/>
+                <a:latin typeface="Ramabhadra" panose="02000600000000000000" pitchFamily="2" charset="0"/>
+                <a:cs typeface="Ramabhadra" panose="02000600000000000000" pitchFamily="2" charset="0"/>
+              </a:rPr>
+              <a:t>చెంత చేరినావే-చెలిమి పంచినావే</a:t>
+            </a:r>
+          </a:p>
+          <a:p>
+            <a:pPr algn="ctr"/>
+            <a:r>
+              <a:rPr lang="te-IN" sz="1750" b="0" i="0" dirty="0">
+                <a:solidFill>
+                  <a:schemeClr val="tx1"/>
+                </a:solidFill>
+                <a:effectLst/>
+                <a:latin typeface="Ramabhadra" panose="02000600000000000000" pitchFamily="2" charset="0"/>
+                <a:cs typeface="Ramabhadra" panose="02000600000000000000" pitchFamily="2" charset="0"/>
+              </a:rPr>
+              <a:t>గుండెల నిండా నీవే - నిన్ను పాడని</a:t>
+            </a:r>
+          </a:p>
+          <a:p>
+            <a:pPr algn="ctr"/>
+            <a:endParaRPr lang="te-IN" sz="1750" b="0" i="0" dirty="0">
               <a:solidFill>
                 <a:schemeClr val="tx1"/>
               </a:solidFill>
@@ -4446,7 +4477,7 @@
           <a:p>
             <a:pPr algn="ctr"/>
             <a:r>
-              <a:rPr lang="te-IN" sz="1700" b="0" i="0" dirty="0">
+              <a:rPr lang="te-IN" sz="1750" b="0" i="0" dirty="0">
                 <a:solidFill>
                   <a:schemeClr val="tx1"/>
                 </a:solidFill>
@@ -4454,13 +4485,13 @@
                 <a:latin typeface="Ramabhadra" panose="02000600000000000000" pitchFamily="2" charset="0"/>
                 <a:cs typeface="Ramabhadra" panose="02000600000000000000" pitchFamily="2" charset="0"/>
               </a:rPr>
-              <a:t>కష్టములే కలిగిన –</a:t>
+              <a:t>నా జీవితంలో ఎండవానలు రాగా</a:t>
             </a:r>
           </a:p>
           <a:p>
             <a:pPr algn="ctr"/>
             <a:r>
-              <a:rPr lang="te-IN" sz="1700" b="0" i="0" dirty="0">
+              <a:rPr lang="te-IN" sz="1750" b="0" i="0" dirty="0">
                 <a:solidFill>
                   <a:schemeClr val="tx1"/>
                 </a:solidFill>
@@ -4468,24 +4499,27 @@
                 <a:latin typeface="Ramabhadra" panose="02000600000000000000" pitchFamily="2" charset="0"/>
                 <a:cs typeface="Ramabhadra" panose="02000600000000000000" pitchFamily="2" charset="0"/>
               </a:rPr>
-              <a:t>కన్నీరులే మిగిలినా “స్తుతి”</a:t>
+              <a:t>పగలు చీకటిని నేను అనుభవింపగా</a:t>
             </a:r>
           </a:p>
           <a:p>
             <a:pPr algn="ctr"/>
-            <a:endParaRPr lang="te-IN" sz="1700" b="0" i="0" dirty="0">
-              <a:solidFill>
-                <a:schemeClr val="tx1"/>
-              </a:solidFill>
-              <a:effectLst/>
-              <a:latin typeface="Ramabhadra" panose="02000600000000000000" pitchFamily="2" charset="0"/>
-              <a:cs typeface="Ramabhadra" panose="02000600000000000000" pitchFamily="2" charset="0"/>
-            </a:endParaRPr>
+            <a:r>
+              <a:rPr lang="te-IN" sz="1750" b="0" i="0" dirty="0">
+                <a:solidFill>
+                  <a:schemeClr val="tx1"/>
+                </a:solidFill>
+                <a:effectLst/>
+                <a:latin typeface="Ramabhadra" panose="02000600000000000000" pitchFamily="2" charset="0"/>
+                <a:cs typeface="Ramabhadra" panose="02000600000000000000" pitchFamily="2" charset="0"/>
+              </a:rPr>
+              <a:t>పగలు మేఘ స్థంబమై- రాత్రి అగ్ని స్థంబమై</a:t>
+            </a:r>
           </a:p>
           <a:p>
             <a:pPr algn="ctr"/>
             <a:r>
-              <a:rPr lang="te-IN" sz="1700" b="0" i="0" dirty="0">
+              <a:rPr lang="te-IN" sz="1750" b="0" i="0" dirty="0">
                 <a:solidFill>
                   <a:schemeClr val="tx1"/>
                 </a:solidFill>
@@ -4493,13 +4527,13 @@
                 <a:latin typeface="Ramabhadra" panose="02000600000000000000" pitchFamily="2" charset="0"/>
                 <a:cs typeface="Ramabhadra" panose="02000600000000000000" pitchFamily="2" charset="0"/>
               </a:rPr>
-              <a:t>బంధాలు బిగియించినా –</a:t>
+              <a:t>ఆవరించి నావే- ఆదరించి నావే</a:t>
             </a:r>
           </a:p>
           <a:p>
             <a:pPr algn="ctr"/>
             <a:r>
-              <a:rPr lang="te-IN" sz="1700" b="0" i="0" dirty="0">
+              <a:rPr lang="te-IN" sz="1750" b="0" i="0" dirty="0">
                 <a:solidFill>
                   <a:schemeClr val="tx1"/>
                 </a:solidFill>
@@ -4507,85 +4541,7 @@
                 <a:latin typeface="Ramabhadra" panose="02000600000000000000" pitchFamily="2" charset="0"/>
                 <a:cs typeface="Ramabhadra" panose="02000600000000000000" pitchFamily="2" charset="0"/>
               </a:rPr>
-              <a:t>చేరసాలలో వేసినా “స్తుతి”</a:t>
-            </a:r>
-          </a:p>
-          <a:p>
-            <a:pPr algn="ctr"/>
-            <a:endParaRPr lang="te-IN" sz="1700" b="0" i="0" dirty="0">
-              <a:solidFill>
-                <a:schemeClr val="tx1"/>
-              </a:solidFill>
-              <a:effectLst/>
-              <a:latin typeface="Ramabhadra" panose="02000600000000000000" pitchFamily="2" charset="0"/>
-              <a:cs typeface="Ramabhadra" panose="02000600000000000000" pitchFamily="2" charset="0"/>
-            </a:endParaRPr>
-          </a:p>
-          <a:p>
-            <a:pPr algn="ctr"/>
-            <a:r>
-              <a:rPr lang="te-IN" sz="1700" b="0" i="0" dirty="0">
-                <a:solidFill>
-                  <a:schemeClr val="tx1"/>
-                </a:solidFill>
-                <a:effectLst/>
-                <a:latin typeface="Ramabhadra" panose="02000600000000000000" pitchFamily="2" charset="0"/>
-                <a:cs typeface="Ramabhadra" panose="02000600000000000000" pitchFamily="2" charset="0"/>
-              </a:rPr>
-              <a:t>నీ తల్లి నిను మరిచినా –</a:t>
-            </a:r>
-          </a:p>
-          <a:p>
-            <a:pPr algn="ctr"/>
-            <a:r>
-              <a:rPr lang="te-IN" sz="1700" b="0" i="0" dirty="0">
-                <a:solidFill>
-                  <a:schemeClr val="tx1"/>
-                </a:solidFill>
-                <a:effectLst/>
-                <a:latin typeface="Ramabhadra" panose="02000600000000000000" pitchFamily="2" charset="0"/>
-                <a:cs typeface="Ramabhadra" panose="02000600000000000000" pitchFamily="2" charset="0"/>
-              </a:rPr>
-              <a:t>మరువని నీ దేవుడు “స్తుతి”</a:t>
-            </a:r>
-          </a:p>
-          <a:p>
-            <a:pPr algn="ctr"/>
-            <a:endParaRPr lang="te-IN" sz="1700" b="0" i="0" dirty="0">
-              <a:solidFill>
-                <a:schemeClr val="tx1"/>
-              </a:solidFill>
-              <a:effectLst/>
-              <a:latin typeface="Ramabhadra" panose="02000600000000000000" pitchFamily="2" charset="0"/>
-              <a:cs typeface="Ramabhadra" panose="02000600000000000000" pitchFamily="2" charset="0"/>
-            </a:endParaRPr>
-          </a:p>
-          <a:p>
-            <a:pPr algn="ctr"/>
-            <a:r>
-              <a:rPr lang="te-IN" sz="1700" b="0" i="0" dirty="0">
-                <a:solidFill>
-                  <a:schemeClr val="tx1"/>
-                </a:solidFill>
-                <a:effectLst/>
-                <a:latin typeface="Ramabhadra" panose="02000600000000000000" pitchFamily="2" charset="0"/>
-                <a:cs typeface="Ramabhadra" panose="02000600000000000000" pitchFamily="2" charset="0"/>
-              </a:rPr>
-              <a:t>జనులెంత నిందించినా –</a:t>
-            </a:r>
-          </a:p>
-          <a:p>
-            <a:pPr algn="ctr"/>
-            <a:r>
-              <a:rPr lang="te-IN" sz="1700" b="0" i="0" dirty="0">
-                <a:solidFill>
-                  <a:schemeClr val="tx1"/>
-                </a:solidFill>
-                <a:effectLst/>
-                <a:latin typeface="Ramabhadra" panose="02000600000000000000" pitchFamily="2" charset="0"/>
-                <a:cs typeface="Ramabhadra" panose="02000600000000000000" pitchFamily="2" charset="0"/>
-              </a:rPr>
-              <a:t>చేడుమాటలే పలికినా “స్తుతి”</a:t>
+              <a:t>కన్నీరు తుడచి నన్ను – ముద్దాడితివే</a:t>
             </a:r>
           </a:p>
         </p:txBody>
@@ -4656,7 +4612,7 @@
               <a:defRPr/>
             </a:pPr>
             <a:r>
-              <a:rPr kumimoji="0" lang="te-IN" sz="1900" i="0" u="none" strike="noStrike" kern="1200" cap="none" spc="0" normalizeH="0" baseline="0" noProof="0" dirty="0">
+              <a:rPr kumimoji="0" lang="te-IN" sz="1600" i="0" u="none" strike="noStrike" kern="1200" cap="none" spc="0" normalizeH="0" baseline="0" noProof="0" dirty="0">
                 <a:ln>
                   <a:noFill/>
                 </a:ln>
@@ -4669,7 +4625,38 @@
                 <a:latin typeface="Ramabhadra" panose="02000600000000000000" pitchFamily="2" charset="0"/>
                 <a:cs typeface="Ramabhadra" panose="02000600000000000000" pitchFamily="2" charset="0"/>
               </a:rPr>
-              <a:t>ఆత్మ స్వరూపుడా ప్రియ ఆత్మ స్వరూపుడా </a:t>
+              <a:t>స్తోత్రబలి స్తోత్రబలి – మంచిదేవా నీకేనయ్యా</a:t>
+            </a:r>
+            <a:br>
+              <a:rPr kumimoji="0" lang="te-IN" sz="1600" i="0" u="none" strike="noStrike" kern="1200" cap="none" spc="0" normalizeH="0" baseline="0" noProof="0" dirty="0">
+                <a:ln>
+                  <a:noFill/>
+                </a:ln>
+                <a:solidFill>
+                  <a:schemeClr val="tx1"/>
+                </a:solidFill>
+                <a:effectLst/>
+                <a:uLnTx/>
+                <a:uFillTx/>
+                <a:latin typeface="Ramabhadra" panose="02000600000000000000" pitchFamily="2" charset="0"/>
+                <a:cs typeface="Ramabhadra" panose="02000600000000000000" pitchFamily="2" charset="0"/>
+              </a:rPr>
+            </a:br>
+            <a:r>
+              <a:rPr kumimoji="0" lang="te-IN" sz="1600" i="0" u="none" strike="noStrike" kern="1200" cap="none" spc="0" normalizeH="0" baseline="0" noProof="0" dirty="0">
+                <a:ln>
+                  <a:noFill/>
+                </a:ln>
+                <a:solidFill>
+                  <a:schemeClr val="tx1"/>
+                </a:solidFill>
+                <a:effectLst/>
+                <a:uLnTx/>
+                <a:uFillTx/>
+                <a:latin typeface="Ramabhadra" panose="02000600000000000000" pitchFamily="2" charset="0"/>
+                <a:cs typeface="Ramabhadra" panose="02000600000000000000" pitchFamily="2" charset="0"/>
+              </a:rPr>
+              <a:t>శుభవేళ ఆనందమే – నా తండ్రి నీ చిరుపాదమే (2)</a:t>
             </a:r>
           </a:p>
           <a:p>
@@ -4687,39 +4674,7 @@
               <a:tabLst/>
               <a:defRPr/>
             </a:pPr>
-            <a:r>
-              <a:rPr kumimoji="0" lang="te-IN" sz="1900" i="0" u="none" strike="noStrike" kern="1200" cap="none" spc="0" normalizeH="0" baseline="0" noProof="0" dirty="0">
-                <a:ln>
-                  <a:noFill/>
-                </a:ln>
-                <a:solidFill>
-                  <a:schemeClr val="tx1"/>
-                </a:solidFill>
-                <a:effectLst/>
-                <a:uLnTx/>
-                <a:uFillTx/>
-                <a:latin typeface="Ramabhadra" panose="02000600000000000000" pitchFamily="2" charset="0"/>
-                <a:cs typeface="Ramabhadra" panose="02000600000000000000" pitchFamily="2" charset="0"/>
-              </a:rPr>
-              <a:t>నేడే రా దేవా నేడే రా దేవా మా మధ్యకు</a:t>
-            </a:r>
-          </a:p>
-          <a:p>
-            <a:pPr marL="0" marR="0" lvl="0" indent="0" algn="ctr" defTabSz="439781" rtl="0" eaLnBrk="1" fontAlgn="auto" latinLnBrk="0" hangingPunct="1">
-              <a:spcBef>
-                <a:spcPts val="0"/>
-              </a:spcBef>
-              <a:spcAft>
-                <a:spcPts val="0"/>
-              </a:spcAft>
-              <a:buClrTx/>
-              <a:buSzTx/>
-              <a:buFontTx/>
-              <a:buNone/>
-              <a:tabLst/>
-              <a:defRPr/>
-            </a:pPr>
-            <a:endParaRPr kumimoji="0" lang="te-IN" sz="1900" i="0" u="none" strike="noStrike" kern="1200" cap="none" spc="0" normalizeH="0" baseline="0" noProof="0" dirty="0">
+            <a:endParaRPr kumimoji="0" lang="te-IN" sz="1600" i="0" u="none" strike="noStrike" kern="1200" cap="none" spc="0" normalizeH="0" baseline="0" noProof="0" dirty="0">
               <a:ln>
                 <a:noFill/>
               </a:ln>
@@ -4749,7 +4704,7 @@
               <a:defRPr/>
             </a:pPr>
             <a:r>
-              <a:rPr kumimoji="0" lang="te-IN" sz="1900" i="0" u="none" strike="noStrike" kern="1200" cap="none" spc="0" normalizeH="0" baseline="0" noProof="0" dirty="0">
+              <a:rPr kumimoji="0" lang="te-IN" sz="1600" i="0" u="none" strike="noStrike" kern="1200" cap="none" spc="0" normalizeH="0" baseline="0" noProof="0" dirty="0">
                 <a:ln>
                   <a:noFill/>
                 </a:ln>
@@ -4762,7 +4717,69 @@
                 <a:latin typeface="Ramabhadra" panose="02000600000000000000" pitchFamily="2" charset="0"/>
                 <a:cs typeface="Ramabhadra" panose="02000600000000000000" pitchFamily="2" charset="0"/>
               </a:rPr>
-              <a:t>పాపపు ఊబి నుండి నను రక్షించితివి </a:t>
+              <a:t>నిన్నటి బాధలంతా నేటికి మాయమయ్యే (2)</a:t>
+            </a:r>
+            <a:br>
+              <a:rPr kumimoji="0" lang="te-IN" sz="1600" i="0" u="none" strike="noStrike" kern="1200" cap="none" spc="0" normalizeH="0" baseline="0" noProof="0" dirty="0">
+                <a:ln>
+                  <a:noFill/>
+                </a:ln>
+                <a:solidFill>
+                  <a:schemeClr val="tx1"/>
+                </a:solidFill>
+                <a:effectLst/>
+                <a:uLnTx/>
+                <a:uFillTx/>
+                <a:latin typeface="Ramabhadra" panose="02000600000000000000" pitchFamily="2" charset="0"/>
+                <a:cs typeface="Ramabhadra" panose="02000600000000000000" pitchFamily="2" charset="0"/>
+              </a:rPr>
+            </a:br>
+            <a:r>
+              <a:rPr kumimoji="0" lang="te-IN" sz="1600" i="0" u="none" strike="noStrike" kern="1200" cap="none" spc="0" normalizeH="0" baseline="0" noProof="0" dirty="0">
+                <a:ln>
+                  <a:noFill/>
+                </a:ln>
+                <a:solidFill>
+                  <a:schemeClr val="tx1"/>
+                </a:solidFill>
+                <a:effectLst/>
+                <a:uLnTx/>
+                <a:uFillTx/>
+                <a:latin typeface="Ramabhadra" panose="02000600000000000000" pitchFamily="2" charset="0"/>
+                <a:cs typeface="Ramabhadra" panose="02000600000000000000" pitchFamily="2" charset="0"/>
+              </a:rPr>
+              <a:t>నెమ్మది ఉదయించె అది శాశ్వతమైనదయ్యా (2)</a:t>
+            </a:r>
+            <a:br>
+              <a:rPr kumimoji="0" lang="te-IN" sz="1600" i="0" u="none" strike="noStrike" kern="1200" cap="none" spc="0" normalizeH="0" baseline="0" noProof="0" dirty="0">
+                <a:ln>
+                  <a:noFill/>
+                </a:ln>
+                <a:solidFill>
+                  <a:schemeClr val="tx1"/>
+                </a:solidFill>
+                <a:effectLst/>
+                <a:uLnTx/>
+                <a:uFillTx/>
+                <a:latin typeface="Ramabhadra" panose="02000600000000000000" pitchFamily="2" charset="0"/>
+                <a:cs typeface="Ramabhadra" panose="02000600000000000000" pitchFamily="2" charset="0"/>
+              </a:rPr>
+            </a:br>
+            <a:r>
+              <a:rPr kumimoji="0" lang="te-IN" sz="1600" i="0" u="none" strike="noStrike" kern="1200" cap="none" spc="0" normalizeH="0" baseline="0" noProof="0" dirty="0">
+                <a:ln>
+                  <a:noFill/>
+                </a:ln>
+                <a:solidFill>
+                  <a:schemeClr val="tx1"/>
+                </a:solidFill>
+                <a:effectLst/>
+                <a:uLnTx/>
+                <a:uFillTx/>
+                <a:latin typeface="Ramabhadra" panose="02000600000000000000" pitchFamily="2" charset="0"/>
+                <a:cs typeface="Ramabhadra" panose="02000600000000000000" pitchFamily="2" charset="0"/>
+              </a:rPr>
+              <a:t>కోటి కోటి స్తోత్రం డాడి (3)       </a:t>
             </a:r>
           </a:p>
           <a:p>
@@ -4781,7 +4798,7 @@
               <a:defRPr/>
             </a:pPr>
             <a:r>
-              <a:rPr kumimoji="0" lang="te-IN" sz="1900" i="0" u="none" strike="noStrike" kern="1200" cap="none" spc="0" normalizeH="0" baseline="0" noProof="0" dirty="0">
+              <a:rPr kumimoji="0" lang="te-IN" sz="1600" i="0" u="none" strike="noStrike" kern="1200" cap="none" spc="0" normalizeH="0" baseline="0" noProof="0" dirty="0">
                 <a:ln>
                   <a:noFill/>
                 </a:ln>
@@ -4794,7 +4811,7 @@
                 <a:latin typeface="Ramabhadra" panose="02000600000000000000" pitchFamily="2" charset="0"/>
                 <a:cs typeface="Ramabhadra" panose="02000600000000000000" pitchFamily="2" charset="0"/>
               </a:rPr>
-              <a:t>పాపం కడిగి శుద్ధీకరించి</a:t>
+              <a:t>   </a:t>
             </a:r>
           </a:p>
           <a:p>
@@ -4813,7 +4830,7 @@
               <a:defRPr/>
             </a:pPr>
             <a:r>
-              <a:rPr kumimoji="0" lang="te-IN" sz="1900" i="0" u="none" strike="noStrike" kern="1200" cap="none" spc="0" normalizeH="0" baseline="0" noProof="0" dirty="0">
+              <a:rPr kumimoji="0" lang="te-IN" sz="1600" i="0" u="none" strike="noStrike" kern="1200" cap="none" spc="0" normalizeH="0" baseline="0" noProof="0" dirty="0">
                 <a:ln>
                   <a:noFill/>
                 </a:ln>
@@ -4826,7 +4843,69 @@
                 <a:latin typeface="Ramabhadra" panose="02000600000000000000" pitchFamily="2" charset="0"/>
                 <a:cs typeface="Ramabhadra" panose="02000600000000000000" pitchFamily="2" charset="0"/>
               </a:rPr>
-              <a:t> నీ దివ్య రక్తంతో</a:t>
+              <a:t>రేయంతా కాచితివి మరు దినమిచ్చితివి (2)</a:t>
+            </a:r>
+            <a:br>
+              <a:rPr kumimoji="0" lang="te-IN" sz="1600" i="0" u="none" strike="noStrike" kern="1200" cap="none" spc="0" normalizeH="0" baseline="0" noProof="0" dirty="0">
+                <a:ln>
+                  <a:noFill/>
+                </a:ln>
+                <a:solidFill>
+                  <a:schemeClr val="tx1"/>
+                </a:solidFill>
+                <a:effectLst/>
+                <a:uLnTx/>
+                <a:uFillTx/>
+                <a:latin typeface="Ramabhadra" panose="02000600000000000000" pitchFamily="2" charset="0"/>
+                <a:cs typeface="Ramabhadra" panose="02000600000000000000" pitchFamily="2" charset="0"/>
+              </a:rPr>
+            </a:br>
+            <a:r>
+              <a:rPr kumimoji="0" lang="te-IN" sz="1600" i="0" u="none" strike="noStrike" kern="1200" cap="none" spc="0" normalizeH="0" baseline="0" noProof="0" dirty="0">
+                <a:ln>
+                  <a:noFill/>
+                </a:ln>
+                <a:solidFill>
+                  <a:schemeClr val="tx1"/>
+                </a:solidFill>
+                <a:effectLst/>
+                <a:uLnTx/>
+                <a:uFillTx/>
+                <a:latin typeface="Ramabhadra" panose="02000600000000000000" pitchFamily="2" charset="0"/>
+                <a:cs typeface="Ramabhadra" panose="02000600000000000000" pitchFamily="2" charset="0"/>
+              </a:rPr>
+              <a:t>మరువని నా స్నేహమా నీతో కలసి సంతోషింతును (2)</a:t>
+            </a:r>
+            <a:br>
+              <a:rPr kumimoji="0" lang="te-IN" sz="1600" i="0" u="none" strike="noStrike" kern="1200" cap="none" spc="0" normalizeH="0" baseline="0" noProof="0" dirty="0">
+                <a:ln>
+                  <a:noFill/>
+                </a:ln>
+                <a:solidFill>
+                  <a:schemeClr val="tx1"/>
+                </a:solidFill>
+                <a:effectLst/>
+                <a:uLnTx/>
+                <a:uFillTx/>
+                <a:latin typeface="Ramabhadra" panose="02000600000000000000" pitchFamily="2" charset="0"/>
+                <a:cs typeface="Ramabhadra" panose="02000600000000000000" pitchFamily="2" charset="0"/>
+              </a:rPr>
+            </a:br>
+            <a:r>
+              <a:rPr kumimoji="0" lang="te-IN" sz="1600" i="0" u="none" strike="noStrike" kern="1200" cap="none" spc="0" normalizeH="0" baseline="0" noProof="0" dirty="0">
+                <a:ln>
+                  <a:noFill/>
+                </a:ln>
+                <a:solidFill>
+                  <a:schemeClr val="tx1"/>
+                </a:solidFill>
+                <a:effectLst/>
+                <a:uLnTx/>
+                <a:uFillTx/>
+                <a:latin typeface="Ramabhadra" panose="02000600000000000000" pitchFamily="2" charset="0"/>
+                <a:cs typeface="Ramabhadra" panose="02000600000000000000" pitchFamily="2" charset="0"/>
+              </a:rPr>
+              <a:t>కోటి కోటి స్తోత్రం డాడి (3)     </a:t>
             </a:r>
           </a:p>
           <a:p>
@@ -4844,19 +4923,22 @@
               <a:tabLst/>
               <a:defRPr/>
             </a:pPr>
-            <a:endParaRPr kumimoji="0" lang="te-IN" sz="1900" i="0" u="none" strike="noStrike" kern="1200" cap="none" spc="0" normalizeH="0" baseline="0" noProof="0" dirty="0">
-              <a:ln>
-                <a:noFill/>
-              </a:ln>
-              <a:solidFill>
-                <a:schemeClr val="tx1"/>
-              </a:solidFill>
-              <a:effectLst/>
-              <a:uLnTx/>
-              <a:uFillTx/>
-              <a:latin typeface="Ramabhadra" panose="02000600000000000000" pitchFamily="2" charset="0"/>
-              <a:cs typeface="Ramabhadra" panose="02000600000000000000" pitchFamily="2" charset="0"/>
-            </a:endParaRPr>
+            <a:r>
+              <a:rPr kumimoji="0" lang="te-IN" sz="1600" i="0" u="none" strike="noStrike" kern="1200" cap="none" spc="0" normalizeH="0" baseline="0" noProof="0" dirty="0">
+                <a:ln>
+                  <a:noFill/>
+                </a:ln>
+                <a:solidFill>
+                  <a:schemeClr val="tx1"/>
+                </a:solidFill>
+                <a:effectLst/>
+                <a:uLnTx/>
+                <a:uFillTx/>
+                <a:latin typeface="Ramabhadra" panose="02000600000000000000" pitchFamily="2" charset="0"/>
+                <a:cs typeface="Ramabhadra" panose="02000600000000000000" pitchFamily="2" charset="0"/>
+              </a:rPr>
+              <a:t>   </a:t>
+            </a:r>
           </a:p>
           <a:p>
             <a:pPr marL="0" marR="0" lvl="0" indent="0" algn="ctr" defTabSz="439781" rtl="0" eaLnBrk="1" fontAlgn="auto" latinLnBrk="0" hangingPunct="1">
@@ -4874,7 +4956,7 @@
               <a:defRPr/>
             </a:pPr>
             <a:r>
-              <a:rPr kumimoji="0" lang="te-IN" sz="1900" i="0" u="none" strike="noStrike" kern="1200" cap="none" spc="0" normalizeH="0" baseline="0" noProof="0" dirty="0">
+              <a:rPr kumimoji="0" lang="te-IN" sz="1600" i="0" u="none" strike="noStrike" kern="1200" cap="none" spc="0" normalizeH="0" baseline="0" noProof="0" dirty="0">
                 <a:ln>
                   <a:noFill/>
                 </a:ln>
@@ -4887,26 +4969,10 @@
                 <a:latin typeface="Ramabhadra" panose="02000600000000000000" pitchFamily="2" charset="0"/>
                 <a:cs typeface="Ramabhadra" panose="02000600000000000000" pitchFamily="2" charset="0"/>
               </a:rPr>
-              <a:t>సీనాయి కొండపై అరుదెంచిన దేవా </a:t>
-            </a:r>
-          </a:p>
-          <a:p>
-            <a:pPr marL="0" marR="0" lvl="0" indent="0" algn="ctr" defTabSz="439781" rtl="0" eaLnBrk="1" fontAlgn="auto" latinLnBrk="0" hangingPunct="1">
-              <a:spcBef>
-                <a:spcPts val="0"/>
-              </a:spcBef>
-              <a:spcAft>
-                <a:spcPts val="0"/>
-              </a:spcAft>
-              <a:buClrTx/>
-              <a:buSzTx/>
-              <a:buFontTx/>
-              <a:buNone/>
-              <a:tabLst/>
-              <a:defRPr/>
-            </a:pPr>
-            <a:r>
-              <a:rPr kumimoji="0" lang="te-IN" sz="1900" i="0" u="none" strike="noStrike" kern="1200" cap="none" spc="0" normalizeH="0" baseline="0" noProof="0" dirty="0">
+              <a:t>నీ సేవ మార్గంలో ఉత్సాహం నొసగితివి (2)</a:t>
+            </a:r>
+            <a:br>
+              <a:rPr kumimoji="0" lang="te-IN" sz="1600" i="0" u="none" strike="noStrike" kern="1200" cap="none" spc="0" normalizeH="0" baseline="0" noProof="0" dirty="0">
                 <a:ln>
                   <a:noFill/>
                 </a:ln>
@@ -4919,26 +4985,9 @@
                 <a:latin typeface="Ramabhadra" panose="02000600000000000000" pitchFamily="2" charset="0"/>
                 <a:cs typeface="Ramabhadra" panose="02000600000000000000" pitchFamily="2" charset="0"/>
               </a:rPr>
-              <a:t>ఆత్మ దాహం తీర్చుటకై </a:t>
-            </a:r>
-          </a:p>
-          <a:p>
-            <a:pPr marL="0" marR="0" lvl="0" indent="0" algn="ctr" defTabSz="439781" rtl="0" eaLnBrk="1" fontAlgn="auto" latinLnBrk="0" hangingPunct="1">
-              <a:spcBef>
-                <a:spcPts val="0"/>
-              </a:spcBef>
-              <a:spcAft>
-                <a:spcPts val="0"/>
-              </a:spcAft>
-              <a:buClrTx/>
-              <a:buSzTx/>
-              <a:buFontTx/>
-              <a:buNone/>
-              <a:tabLst/>
-              <a:defRPr/>
-            </a:pPr>
-            <a:r>
-              <a:rPr kumimoji="0" lang="te-IN" sz="1900" i="0" u="none" strike="noStrike" kern="1200" cap="none" spc="0" normalizeH="0" baseline="0" noProof="0" dirty="0">
+            </a:br>
+            <a:r>
+              <a:rPr kumimoji="0" lang="te-IN" sz="1600" i="0" u="none" strike="noStrike" kern="1200" cap="none" spc="0" normalizeH="0" baseline="0" noProof="0" dirty="0">
                 <a:ln>
                   <a:noFill/>
                 </a:ln>
@@ -4951,55 +5000,10 @@
                 <a:latin typeface="Ramabhadra" panose="02000600000000000000" pitchFamily="2" charset="0"/>
                 <a:cs typeface="Ramabhadra" panose="02000600000000000000" pitchFamily="2" charset="0"/>
               </a:rPr>
-              <a:t> ఆ దివ్య సమయంలో</a:t>
-            </a:r>
-          </a:p>
-          <a:p>
-            <a:pPr marL="0" marR="0" lvl="0" indent="0" algn="ctr" defTabSz="439781" rtl="0" eaLnBrk="1" fontAlgn="auto" latinLnBrk="0" hangingPunct="1">
-              <a:spcBef>
-                <a:spcPts val="0"/>
-              </a:spcBef>
-              <a:spcAft>
-                <a:spcPts val="0"/>
-              </a:spcAft>
-              <a:buClrTx/>
-              <a:buSzTx/>
-              <a:buFontTx/>
-              <a:buNone/>
-              <a:tabLst/>
-              <a:defRPr/>
-            </a:pPr>
-            <a:endParaRPr kumimoji="0" lang="te-IN" sz="1900" i="0" u="none" strike="noStrike" kern="1200" cap="none" spc="0" normalizeH="0" baseline="0" noProof="0" dirty="0">
-              <a:ln>
-                <a:noFill/>
-              </a:ln>
-              <a:solidFill>
-                <a:schemeClr val="tx1"/>
-              </a:solidFill>
-              <a:effectLst/>
-              <a:uLnTx/>
-              <a:uFillTx/>
-              <a:latin typeface="Ramabhadra" panose="02000600000000000000" pitchFamily="2" charset="0"/>
-              <a:cs typeface="Ramabhadra" panose="02000600000000000000" pitchFamily="2" charset="0"/>
-            </a:endParaRPr>
-          </a:p>
-          <a:p>
-            <a:pPr marL="0" marR="0" lvl="0" indent="0" algn="ctr" defTabSz="439781" rtl="0" eaLnBrk="1" fontAlgn="auto" latinLnBrk="0" hangingPunct="1">
-              <a:spcBef>
-                <a:spcPts val="0"/>
-              </a:spcBef>
-              <a:spcAft>
-                <a:spcPts val="0"/>
-              </a:spcAft>
-              <a:buClrTx/>
-              <a:buSzTx/>
-              <a:buFontTx/>
-              <a:buNone/>
-              <a:tabLst/>
-              <a:defRPr/>
-            </a:pPr>
-            <a:r>
-              <a:rPr kumimoji="0" lang="te-IN" sz="1900" i="0" u="none" strike="noStrike" kern="1200" cap="none" spc="0" normalizeH="0" baseline="0" noProof="0" dirty="0">
+              <a:t>ఉరికురికి పనిచేయ నాకు ఆరోగ్యమిచ్చితివి (2)</a:t>
+            </a:r>
+            <a:br>
+              <a:rPr kumimoji="0" lang="te-IN" sz="1600" i="0" u="none" strike="noStrike" kern="1200" cap="none" spc="0" normalizeH="0" baseline="0" noProof="0" dirty="0">
                 <a:ln>
                   <a:noFill/>
                 </a:ln>
@@ -5012,26 +5016,9 @@
                 <a:latin typeface="Ramabhadra" panose="02000600000000000000" pitchFamily="2" charset="0"/>
                 <a:cs typeface="Ramabhadra" panose="02000600000000000000" pitchFamily="2" charset="0"/>
               </a:rPr>
-              <a:t>ఆత్మవరములతో నన్ను నింపు దేవా </a:t>
-            </a:r>
-          </a:p>
-          <a:p>
-            <a:pPr marL="0" marR="0" lvl="0" indent="0" algn="ctr" defTabSz="439781" rtl="0" eaLnBrk="1" fontAlgn="auto" latinLnBrk="0" hangingPunct="1">
-              <a:spcBef>
-                <a:spcPts val="0"/>
-              </a:spcBef>
-              <a:spcAft>
-                <a:spcPts val="0"/>
-              </a:spcAft>
-              <a:buClrTx/>
-              <a:buSzTx/>
-              <a:buFontTx/>
-              <a:buNone/>
-              <a:tabLst/>
-              <a:defRPr/>
-            </a:pPr>
-            <a:r>
-              <a:rPr kumimoji="0" lang="te-IN" sz="1900" i="0" u="none" strike="noStrike" kern="1200" cap="none" spc="0" normalizeH="0" baseline="0" noProof="0" dirty="0">
+            </a:br>
+            <a:r>
+              <a:rPr kumimoji="0" lang="te-IN" sz="1600" i="0" u="none" strike="noStrike" kern="1200" cap="none" spc="0" normalizeH="0" baseline="0" noProof="0" dirty="0">
                 <a:ln>
                   <a:noFill/>
                 </a:ln>
@@ -5044,39 +5031,7 @@
                 <a:latin typeface="Ramabhadra" panose="02000600000000000000" pitchFamily="2" charset="0"/>
                 <a:cs typeface="Ramabhadra" panose="02000600000000000000" pitchFamily="2" charset="0"/>
               </a:rPr>
-              <a:t>క్రీస్తు వలె నను అభిషేకించుము </a:t>
-            </a:r>
-          </a:p>
-          <a:p>
-            <a:pPr marL="0" marR="0" lvl="0" indent="0" algn="ctr" defTabSz="439781" rtl="0" eaLnBrk="1" fontAlgn="auto" latinLnBrk="0" hangingPunct="1">
-              <a:spcBef>
-                <a:spcPts val="0"/>
-              </a:spcBef>
-              <a:spcAft>
-                <a:spcPts val="0"/>
-              </a:spcAft>
-              <a:buClrTx/>
-              <a:buSzTx/>
-              <a:buFontTx/>
-              <a:buNone/>
-              <a:tabLst/>
-              <a:defRPr/>
-            </a:pPr>
-            <a:r>
-              <a:rPr kumimoji="0" lang="te-IN" sz="1900" i="0" u="none" strike="noStrike" kern="1200" cap="none" spc="0" normalizeH="0" baseline="0" noProof="0" dirty="0">
-                <a:ln>
-                  <a:noFill/>
-                </a:ln>
-                <a:solidFill>
-                  <a:schemeClr val="tx1"/>
-                </a:solidFill>
-                <a:effectLst/>
-                <a:uLnTx/>
-                <a:uFillTx/>
-                <a:latin typeface="Ramabhadra" panose="02000600000000000000" pitchFamily="2" charset="0"/>
-                <a:cs typeface="Ramabhadra" panose="02000600000000000000" pitchFamily="2" charset="0"/>
-              </a:rPr>
-              <a:t>నీ దివ్య సన్నిధిలో</a:t>
+              <a:t>కోటి కోటి స్తోత్రం డాడి (3)   </a:t>
             </a:r>
           </a:p>
         </p:txBody>

</xml_diff>

<commit_message>
23 sunday june songs
</commit_message>
<xml_diff>
--- a/xerox.pptx
+++ b/xerox.pptx
@@ -2,18 +2,19 @@
 <file path=ppt/presentation.xml><?xml version="1.0" encoding="utf-8"?>
 <p:presentation xmlns:a="http://schemas.openxmlformats.org/drawingml/2006/main" xmlns:r="http://schemas.openxmlformats.org/officeDocument/2006/relationships" xmlns:p="http://schemas.openxmlformats.org/presentationml/2006/main" saveSubsetFonts="1">
   <p:sldMasterIdLst>
-    <p:sldMasterId id="2147483660" r:id="rId1"/>
+    <p:sldMasterId id="2147483672" r:id="rId1"/>
   </p:sldMasterIdLst>
   <p:notesMasterIdLst>
-    <p:notesMasterId r:id="rId3"/>
+    <p:notesMasterId r:id="rId4"/>
   </p:notesMasterIdLst>
   <p:handoutMasterIdLst>
-    <p:handoutMasterId r:id="rId4"/>
+    <p:handoutMasterId r:id="rId5"/>
   </p:handoutMasterIdLst>
   <p:sldIdLst>
     <p:sldId id="282" r:id="rId2"/>
+    <p:sldId id="283" r:id="rId3"/>
   </p:sldIdLst>
-  <p:sldSz cx="6858000" cy="9906000" type="A4"/>
+  <p:sldSz cx="17610138" cy="9906000"/>
   <p:notesSz cx="6858000" cy="9945688"/>
   <p:defaultTextStyle>
     <a:defPPr>
@@ -116,6 +117,7 @@
         <p14:section name="Untitled Section" id="{A9D60E13-7795-4B21-B9EC-5BF21E65AAC1}">
           <p14:sldIdLst>
             <p14:sldId id="282"/>
+            <p14:sldId id="283"/>
           </p14:sldIdLst>
         </p14:section>
         <p14:section name="Untitled Section" id="{A6F8D81D-7D40-4647-AE92-8344CF040961}">
@@ -224,7 +226,7 @@
           <a:p>
             <a:fld id="{3502DD63-DF8D-4AB8-92A0-0ECCF612C06C}" type="datetimeFigureOut">
               <a:rPr lang="en-IN" smtClean="0"/>
-              <a:t>13-06-2024</a:t>
+              <a:t>17-06-2024</a:t>
             </a:fld>
             <a:endParaRPr lang="en-IN"/>
           </a:p>
@@ -402,7 +404,7 @@
           <a:p>
             <a:fld id="{1AE741EC-1360-4793-999B-941E0396C9FA}" type="datetimeFigureOut">
               <a:rPr lang="en-IN" smtClean="0"/>
-              <a:t>13-06-2024</a:t>
+              <a:t>17-06-2024</a:t>
             </a:fld>
             <a:endParaRPr lang="en-IN"/>
           </a:p>
@@ -420,8 +422,8 @@
         </p:nvSpPr>
         <p:spPr>
           <a:xfrm>
-            <a:off x="2266950" y="1243013"/>
-            <a:ext cx="2324100" cy="3357562"/>
+            <a:off x="446088" y="1243013"/>
+            <a:ext cx="5965825" cy="3357562"/>
           </a:xfrm>
           <a:prstGeom prst="rect">
             <a:avLst/>
@@ -700,15 +702,15 @@
         </p:nvSpPr>
         <p:spPr>
           <a:xfrm>
-            <a:off x="514350" y="1621191"/>
-            <a:ext cx="5829300" cy="3448756"/>
+            <a:off x="2201267" y="1621191"/>
+            <a:ext cx="13207604" cy="3448756"/>
           </a:xfrm>
         </p:spPr>
         <p:txBody>
           <a:bodyPr anchor="b"/>
           <a:lstStyle>
             <a:lvl1pPr algn="ctr">
-              <a:defRPr sz="4500"/>
+              <a:defRPr sz="8666"/>
             </a:lvl1pPr>
           </a:lstStyle>
           <a:p>
@@ -732,8 +734,8 @@
         </p:nvSpPr>
         <p:spPr>
           <a:xfrm>
-            <a:off x="857250" y="5202944"/>
-            <a:ext cx="5143500" cy="2391656"/>
+            <a:off x="2201267" y="5202944"/>
+            <a:ext cx="13207604" cy="2391656"/>
           </a:xfrm>
         </p:spPr>
         <p:txBody>
@@ -741,39 +743,39 @@
           <a:lstStyle>
             <a:lvl1pPr marL="0" indent="0" algn="ctr">
               <a:buNone/>
-              <a:defRPr sz="1800"/>
+              <a:defRPr sz="3467"/>
             </a:lvl1pPr>
-            <a:lvl2pPr marL="342900" indent="0" algn="ctr">
+            <a:lvl2pPr marL="660380" indent="0" algn="ctr">
               <a:buNone/>
-              <a:defRPr sz="1500"/>
+              <a:defRPr sz="2889"/>
             </a:lvl2pPr>
-            <a:lvl3pPr marL="685800" indent="0" algn="ctr">
+            <a:lvl3pPr marL="1320759" indent="0" algn="ctr">
               <a:buNone/>
-              <a:defRPr sz="1350"/>
+              <a:defRPr sz="2600"/>
             </a:lvl3pPr>
-            <a:lvl4pPr marL="1028700" indent="0" algn="ctr">
+            <a:lvl4pPr marL="1981139" indent="0" algn="ctr">
               <a:buNone/>
-              <a:defRPr sz="1200"/>
+              <a:defRPr sz="2311"/>
             </a:lvl4pPr>
-            <a:lvl5pPr marL="1371600" indent="0" algn="ctr">
+            <a:lvl5pPr marL="2641519" indent="0" algn="ctr">
               <a:buNone/>
-              <a:defRPr sz="1200"/>
+              <a:defRPr sz="2311"/>
             </a:lvl5pPr>
-            <a:lvl6pPr marL="1714500" indent="0" algn="ctr">
+            <a:lvl6pPr marL="3301898" indent="0" algn="ctr">
               <a:buNone/>
-              <a:defRPr sz="1200"/>
+              <a:defRPr sz="2311"/>
             </a:lvl6pPr>
-            <a:lvl7pPr marL="2057400" indent="0" algn="ctr">
+            <a:lvl7pPr marL="3962278" indent="0" algn="ctr">
               <a:buNone/>
-              <a:defRPr sz="1200"/>
+              <a:defRPr sz="2311"/>
             </a:lvl7pPr>
-            <a:lvl8pPr marL="2400300" indent="0" algn="ctr">
+            <a:lvl8pPr marL="4622658" indent="0" algn="ctr">
               <a:buNone/>
-              <a:defRPr sz="1200"/>
+              <a:defRPr sz="2311"/>
             </a:lvl8pPr>
-            <a:lvl9pPr marL="2743200" indent="0" algn="ctr">
+            <a:lvl9pPr marL="5283037" indent="0" algn="ctr">
               <a:buNone/>
-              <a:defRPr sz="1200"/>
+              <a:defRPr sz="2311"/>
             </a:lvl9pPr>
           </a:lstStyle>
           <a:p>
@@ -802,7 +804,7 @@
           <a:p>
             <a:fld id="{86FBD32F-FCAD-481A-B7D8-4D813FB7DB24}" type="datetimeFigureOut">
               <a:rPr lang="en-IN" smtClean="0"/>
-              <a:t>13-06-2024</a:t>
+              <a:t>17-06-2024</a:t>
             </a:fld>
             <a:endParaRPr lang="en-IN"/>
           </a:p>
@@ -853,7 +855,7 @@
     </p:spTree>
     <p:extLst>
       <p:ext uri="{BB962C8B-B14F-4D97-AF65-F5344CB8AC3E}">
-        <p14:creationId xmlns:p14="http://schemas.microsoft.com/office/powerpoint/2010/main" val="4212323296"/>
+        <p14:creationId xmlns:p14="http://schemas.microsoft.com/office/powerpoint/2010/main" val="968886354"/>
       </p:ext>
     </p:extLst>
   </p:cSld>
@@ -972,7 +974,7 @@
           <a:p>
             <a:fld id="{86FBD32F-FCAD-481A-B7D8-4D813FB7DB24}" type="datetimeFigureOut">
               <a:rPr lang="en-IN" smtClean="0"/>
-              <a:t>13-06-2024</a:t>
+              <a:t>17-06-2024</a:t>
             </a:fld>
             <a:endParaRPr lang="en-IN"/>
           </a:p>
@@ -1023,7 +1025,7 @@
     </p:spTree>
     <p:extLst>
       <p:ext uri="{BB962C8B-B14F-4D97-AF65-F5344CB8AC3E}">
-        <p14:creationId xmlns:p14="http://schemas.microsoft.com/office/powerpoint/2010/main" val="2894259841"/>
+        <p14:creationId xmlns:p14="http://schemas.microsoft.com/office/powerpoint/2010/main" val="2826100549"/>
       </p:ext>
     </p:extLst>
   </p:cSld>
@@ -1062,8 +1064,8 @@
         </p:nvSpPr>
         <p:spPr>
           <a:xfrm>
-            <a:off x="4907757" y="527403"/>
-            <a:ext cx="1478756" cy="8394877"/>
+            <a:off x="12602255" y="527403"/>
+            <a:ext cx="3797186" cy="8394877"/>
           </a:xfrm>
         </p:spPr>
         <p:txBody>
@@ -1090,8 +1092,8 @@
         </p:nvSpPr>
         <p:spPr>
           <a:xfrm>
-            <a:off x="471488" y="527403"/>
-            <a:ext cx="4350544" cy="8394877"/>
+            <a:off x="1210697" y="527403"/>
+            <a:ext cx="11171431" cy="8394877"/>
           </a:xfrm>
         </p:spPr>
         <p:txBody>
@@ -1152,7 +1154,7 @@
           <a:p>
             <a:fld id="{86FBD32F-FCAD-481A-B7D8-4D813FB7DB24}" type="datetimeFigureOut">
               <a:rPr lang="en-IN" smtClean="0"/>
-              <a:t>13-06-2024</a:t>
+              <a:t>17-06-2024</a:t>
             </a:fld>
             <a:endParaRPr lang="en-IN"/>
           </a:p>
@@ -1203,7 +1205,7 @@
     </p:spTree>
     <p:extLst>
       <p:ext uri="{BB962C8B-B14F-4D97-AF65-F5344CB8AC3E}">
-        <p14:creationId xmlns:p14="http://schemas.microsoft.com/office/powerpoint/2010/main" val="658798204"/>
+        <p14:creationId xmlns:p14="http://schemas.microsoft.com/office/powerpoint/2010/main" val="1872737456"/>
       </p:ext>
     </p:extLst>
   </p:cSld>
@@ -1322,7 +1324,7 @@
           <a:p>
             <a:fld id="{86FBD32F-FCAD-481A-B7D8-4D813FB7DB24}" type="datetimeFigureOut">
               <a:rPr lang="en-IN" smtClean="0"/>
-              <a:t>13-06-2024</a:t>
+              <a:t>17-06-2024</a:t>
             </a:fld>
             <a:endParaRPr lang="en-IN"/>
           </a:p>
@@ -1373,7 +1375,7 @@
     </p:spTree>
     <p:extLst>
       <p:ext uri="{BB962C8B-B14F-4D97-AF65-F5344CB8AC3E}">
-        <p14:creationId xmlns:p14="http://schemas.microsoft.com/office/powerpoint/2010/main" val="302366330"/>
+        <p14:creationId xmlns:p14="http://schemas.microsoft.com/office/powerpoint/2010/main" val="3037406850"/>
       </p:ext>
     </p:extLst>
   </p:cSld>
@@ -1412,15 +1414,15 @@
         </p:nvSpPr>
         <p:spPr>
           <a:xfrm>
-            <a:off x="467916" y="2469624"/>
-            <a:ext cx="5915025" cy="4120620"/>
+            <a:off x="1201525" y="2469622"/>
+            <a:ext cx="15188744" cy="4120620"/>
           </a:xfrm>
         </p:spPr>
         <p:txBody>
           <a:bodyPr anchor="b"/>
           <a:lstStyle>
             <a:lvl1pPr>
-              <a:defRPr sz="4500"/>
+              <a:defRPr sz="8666"/>
             </a:lvl1pPr>
           </a:lstStyle>
           <a:p>
@@ -1444,8 +1446,8 @@
         </p:nvSpPr>
         <p:spPr>
           <a:xfrm>
-            <a:off x="467916" y="6629226"/>
-            <a:ext cx="5915025" cy="2166937"/>
+            <a:off x="1201525" y="6629225"/>
+            <a:ext cx="15188744" cy="2166937"/>
           </a:xfrm>
         </p:spPr>
         <p:txBody>
@@ -1453,91 +1455,93 @@
           <a:lstStyle>
             <a:lvl1pPr marL="0" indent="0">
               <a:buNone/>
-              <a:defRPr sz="1800">
-                <a:solidFill>
-                  <a:schemeClr val="tx1"/>
-                </a:solidFill>
-              </a:defRPr>
-            </a:lvl1pPr>
-            <a:lvl2pPr marL="342900" indent="0">
-              <a:buNone/>
-              <a:defRPr sz="1500">
+              <a:defRPr sz="3467">
                 <a:solidFill>
                   <a:schemeClr val="tx1">
                     <a:tint val="75000"/>
                   </a:schemeClr>
                 </a:solidFill>
               </a:defRPr>
-            </a:lvl2pPr>
-            <a:lvl3pPr marL="685800" indent="0">
+            </a:lvl1pPr>
+            <a:lvl2pPr marL="660380" indent="0">
               <a:buNone/>
-              <a:defRPr sz="1350">
+              <a:defRPr sz="2889">
                 <a:solidFill>
                   <a:schemeClr val="tx1">
                     <a:tint val="75000"/>
                   </a:schemeClr>
                 </a:solidFill>
               </a:defRPr>
-            </a:lvl3pPr>
-            <a:lvl4pPr marL="1028700" indent="0">
+            </a:lvl2pPr>
+            <a:lvl3pPr marL="1320759" indent="0">
               <a:buNone/>
-              <a:defRPr sz="1200">
+              <a:defRPr sz="2600">
                 <a:solidFill>
                   <a:schemeClr val="tx1">
                     <a:tint val="75000"/>
                   </a:schemeClr>
                 </a:solidFill>
               </a:defRPr>
-            </a:lvl4pPr>
-            <a:lvl5pPr marL="1371600" indent="0">
+            </a:lvl3pPr>
+            <a:lvl4pPr marL="1981139" indent="0">
               <a:buNone/>
-              <a:defRPr sz="1200">
+              <a:defRPr sz="2311">
                 <a:solidFill>
                   <a:schemeClr val="tx1">
                     <a:tint val="75000"/>
                   </a:schemeClr>
                 </a:solidFill>
               </a:defRPr>
-            </a:lvl5pPr>
-            <a:lvl6pPr marL="1714500" indent="0">
+            </a:lvl4pPr>
+            <a:lvl5pPr marL="2641519" indent="0">
               <a:buNone/>
-              <a:defRPr sz="1200">
+              <a:defRPr sz="2311">
                 <a:solidFill>
                   <a:schemeClr val="tx1">
                     <a:tint val="75000"/>
                   </a:schemeClr>
                 </a:solidFill>
               </a:defRPr>
-            </a:lvl6pPr>
-            <a:lvl7pPr marL="2057400" indent="0">
+            </a:lvl5pPr>
+            <a:lvl6pPr marL="3301898" indent="0">
               <a:buNone/>
-              <a:defRPr sz="1200">
+              <a:defRPr sz="2311">
                 <a:solidFill>
                   <a:schemeClr val="tx1">
                     <a:tint val="75000"/>
                   </a:schemeClr>
                 </a:solidFill>
               </a:defRPr>
-            </a:lvl7pPr>
-            <a:lvl8pPr marL="2400300" indent="0">
+            </a:lvl6pPr>
+            <a:lvl7pPr marL="3962278" indent="0">
               <a:buNone/>
-              <a:defRPr sz="1200">
+              <a:defRPr sz="2311">
                 <a:solidFill>
                   <a:schemeClr val="tx1">
                     <a:tint val="75000"/>
                   </a:schemeClr>
                 </a:solidFill>
               </a:defRPr>
-            </a:lvl8pPr>
-            <a:lvl9pPr marL="2743200" indent="0">
+            </a:lvl7pPr>
+            <a:lvl8pPr marL="4622658" indent="0">
               <a:buNone/>
-              <a:defRPr sz="1200">
+              <a:defRPr sz="2311">
                 <a:solidFill>
                   <a:schemeClr val="tx1">
                     <a:tint val="75000"/>
                   </a:schemeClr>
                 </a:solidFill>
               </a:defRPr>
+            </a:lvl8pPr>
+            <a:lvl9pPr marL="5283037" indent="0">
+              <a:buNone/>
+              <a:defRPr sz="2311">
+                <a:solidFill>
+                  <a:schemeClr val="tx1">
+                    <a:tint val="75000"/>
+                  </a:schemeClr>
+                </a:solidFill>
+              </a:defRPr>
             </a:lvl9pPr>
           </a:lstStyle>
           <a:p>
@@ -1566,7 +1570,7 @@
           <a:p>
             <a:fld id="{86FBD32F-FCAD-481A-B7D8-4D813FB7DB24}" type="datetimeFigureOut">
               <a:rPr lang="en-IN" smtClean="0"/>
-              <a:t>13-06-2024</a:t>
+              <a:t>17-06-2024</a:t>
             </a:fld>
             <a:endParaRPr lang="en-IN"/>
           </a:p>
@@ -1617,7 +1621,7 @@
     </p:spTree>
     <p:extLst>
       <p:ext uri="{BB962C8B-B14F-4D97-AF65-F5344CB8AC3E}">
-        <p14:creationId xmlns:p14="http://schemas.microsoft.com/office/powerpoint/2010/main" val="3158312098"/>
+        <p14:creationId xmlns:p14="http://schemas.microsoft.com/office/powerpoint/2010/main" val="3524043591"/>
       </p:ext>
     </p:extLst>
   </p:cSld>
@@ -1679,8 +1683,8 @@
         </p:nvSpPr>
         <p:spPr>
           <a:xfrm>
-            <a:off x="471488" y="2637014"/>
-            <a:ext cx="2914650" cy="6285266"/>
+            <a:off x="1210697" y="2637014"/>
+            <a:ext cx="7484309" cy="6285266"/>
           </a:xfrm>
         </p:spPr>
         <p:txBody>
@@ -1736,8 +1740,8 @@
         </p:nvSpPr>
         <p:spPr>
           <a:xfrm>
-            <a:off x="3471863" y="2637014"/>
-            <a:ext cx="2914650" cy="6285266"/>
+            <a:off x="8915132" y="2637014"/>
+            <a:ext cx="7484309" cy="6285266"/>
           </a:xfrm>
         </p:spPr>
         <p:txBody>
@@ -1798,7 +1802,7 @@
           <a:p>
             <a:fld id="{86FBD32F-FCAD-481A-B7D8-4D813FB7DB24}" type="datetimeFigureOut">
               <a:rPr lang="en-IN" smtClean="0"/>
-              <a:t>13-06-2024</a:t>
+              <a:t>17-06-2024</a:t>
             </a:fld>
             <a:endParaRPr lang="en-IN"/>
           </a:p>
@@ -1849,7 +1853,7 @@
     </p:spTree>
     <p:extLst>
       <p:ext uri="{BB962C8B-B14F-4D97-AF65-F5344CB8AC3E}">
-        <p14:creationId xmlns:p14="http://schemas.microsoft.com/office/powerpoint/2010/main" val="2108088497"/>
+        <p14:creationId xmlns:p14="http://schemas.microsoft.com/office/powerpoint/2010/main" val="1400582787"/>
       </p:ext>
     </p:extLst>
   </p:cSld>
@@ -1888,8 +1892,8 @@
         </p:nvSpPr>
         <p:spPr>
           <a:xfrm>
-            <a:off x="472381" y="527405"/>
-            <a:ext cx="5915025" cy="1914702"/>
+            <a:off x="1212991" y="527404"/>
+            <a:ext cx="15188744" cy="1914702"/>
           </a:xfrm>
         </p:spPr>
         <p:txBody>
@@ -1916,8 +1920,8 @@
         </p:nvSpPr>
         <p:spPr>
           <a:xfrm>
-            <a:off x="472381" y="2428347"/>
-            <a:ext cx="2901255" cy="1190095"/>
+            <a:off x="1212991" y="2428347"/>
+            <a:ext cx="7449913" cy="1190095"/>
           </a:xfrm>
         </p:spPr>
         <p:txBody>
@@ -1925,39 +1929,39 @@
           <a:lstStyle>
             <a:lvl1pPr marL="0" indent="0">
               <a:buNone/>
-              <a:defRPr sz="1800" b="1"/>
+              <a:defRPr sz="3467" b="1"/>
             </a:lvl1pPr>
-            <a:lvl2pPr marL="342900" indent="0">
+            <a:lvl2pPr marL="660380" indent="0">
               <a:buNone/>
-              <a:defRPr sz="1500" b="1"/>
+              <a:defRPr sz="2889" b="1"/>
             </a:lvl2pPr>
-            <a:lvl3pPr marL="685800" indent="0">
+            <a:lvl3pPr marL="1320759" indent="0">
               <a:buNone/>
-              <a:defRPr sz="1350" b="1"/>
+              <a:defRPr sz="2600" b="1"/>
             </a:lvl3pPr>
-            <a:lvl4pPr marL="1028700" indent="0">
+            <a:lvl4pPr marL="1981139" indent="0">
               <a:buNone/>
-              <a:defRPr sz="1200" b="1"/>
+              <a:defRPr sz="2311" b="1"/>
             </a:lvl4pPr>
-            <a:lvl5pPr marL="1371600" indent="0">
+            <a:lvl5pPr marL="2641519" indent="0">
               <a:buNone/>
-              <a:defRPr sz="1200" b="1"/>
+              <a:defRPr sz="2311" b="1"/>
             </a:lvl5pPr>
-            <a:lvl6pPr marL="1714500" indent="0">
+            <a:lvl6pPr marL="3301898" indent="0">
               <a:buNone/>
-              <a:defRPr sz="1200" b="1"/>
+              <a:defRPr sz="2311" b="1"/>
             </a:lvl6pPr>
-            <a:lvl7pPr marL="2057400" indent="0">
+            <a:lvl7pPr marL="3962278" indent="0">
               <a:buNone/>
-              <a:defRPr sz="1200" b="1"/>
+              <a:defRPr sz="2311" b="1"/>
             </a:lvl7pPr>
-            <a:lvl8pPr marL="2400300" indent="0">
+            <a:lvl8pPr marL="4622658" indent="0">
               <a:buNone/>
-              <a:defRPr sz="1200" b="1"/>
+              <a:defRPr sz="2311" b="1"/>
             </a:lvl8pPr>
-            <a:lvl9pPr marL="2743200" indent="0">
+            <a:lvl9pPr marL="5283037" indent="0">
               <a:buNone/>
-              <a:defRPr sz="1200" b="1"/>
+              <a:defRPr sz="2311" b="1"/>
             </a:lvl9pPr>
           </a:lstStyle>
           <a:p>
@@ -1981,8 +1985,8 @@
         </p:nvSpPr>
         <p:spPr>
           <a:xfrm>
-            <a:off x="472381" y="3618442"/>
-            <a:ext cx="2901255" cy="5322183"/>
+            <a:off x="1212991" y="3618442"/>
+            <a:ext cx="7449913" cy="5322183"/>
           </a:xfrm>
         </p:spPr>
         <p:txBody>
@@ -2038,8 +2042,8 @@
         </p:nvSpPr>
         <p:spPr>
           <a:xfrm>
-            <a:off x="3471863" y="2428347"/>
-            <a:ext cx="2915543" cy="1190095"/>
+            <a:off x="8915133" y="2428347"/>
+            <a:ext cx="7486602" cy="1190095"/>
           </a:xfrm>
         </p:spPr>
         <p:txBody>
@@ -2047,39 +2051,39 @@
           <a:lstStyle>
             <a:lvl1pPr marL="0" indent="0">
               <a:buNone/>
-              <a:defRPr sz="1800" b="1"/>
+              <a:defRPr sz="3467" b="1"/>
             </a:lvl1pPr>
-            <a:lvl2pPr marL="342900" indent="0">
+            <a:lvl2pPr marL="660380" indent="0">
               <a:buNone/>
-              <a:defRPr sz="1500" b="1"/>
+              <a:defRPr sz="2889" b="1"/>
             </a:lvl2pPr>
-            <a:lvl3pPr marL="685800" indent="0">
+            <a:lvl3pPr marL="1320759" indent="0">
               <a:buNone/>
-              <a:defRPr sz="1350" b="1"/>
+              <a:defRPr sz="2600" b="1"/>
             </a:lvl3pPr>
-            <a:lvl4pPr marL="1028700" indent="0">
+            <a:lvl4pPr marL="1981139" indent="0">
               <a:buNone/>
-              <a:defRPr sz="1200" b="1"/>
+              <a:defRPr sz="2311" b="1"/>
             </a:lvl4pPr>
-            <a:lvl5pPr marL="1371600" indent="0">
+            <a:lvl5pPr marL="2641519" indent="0">
               <a:buNone/>
-              <a:defRPr sz="1200" b="1"/>
+              <a:defRPr sz="2311" b="1"/>
             </a:lvl5pPr>
-            <a:lvl6pPr marL="1714500" indent="0">
+            <a:lvl6pPr marL="3301898" indent="0">
               <a:buNone/>
-              <a:defRPr sz="1200" b="1"/>
+              <a:defRPr sz="2311" b="1"/>
             </a:lvl6pPr>
-            <a:lvl7pPr marL="2057400" indent="0">
+            <a:lvl7pPr marL="3962278" indent="0">
               <a:buNone/>
-              <a:defRPr sz="1200" b="1"/>
+              <a:defRPr sz="2311" b="1"/>
             </a:lvl7pPr>
-            <a:lvl8pPr marL="2400300" indent="0">
+            <a:lvl8pPr marL="4622658" indent="0">
               <a:buNone/>
-              <a:defRPr sz="1200" b="1"/>
+              <a:defRPr sz="2311" b="1"/>
             </a:lvl8pPr>
-            <a:lvl9pPr marL="2743200" indent="0">
+            <a:lvl9pPr marL="5283037" indent="0">
               <a:buNone/>
-              <a:defRPr sz="1200" b="1"/>
+              <a:defRPr sz="2311" b="1"/>
             </a:lvl9pPr>
           </a:lstStyle>
           <a:p>
@@ -2103,8 +2107,8 @@
         </p:nvSpPr>
         <p:spPr>
           <a:xfrm>
-            <a:off x="3471863" y="3618442"/>
-            <a:ext cx="2915543" cy="5322183"/>
+            <a:off x="8915133" y="3618442"/>
+            <a:ext cx="7486602" cy="5322183"/>
           </a:xfrm>
         </p:spPr>
         <p:txBody>
@@ -2165,7 +2169,7 @@
           <a:p>
             <a:fld id="{86FBD32F-FCAD-481A-B7D8-4D813FB7DB24}" type="datetimeFigureOut">
               <a:rPr lang="en-IN" smtClean="0"/>
-              <a:t>13-06-2024</a:t>
+              <a:t>17-06-2024</a:t>
             </a:fld>
             <a:endParaRPr lang="en-IN"/>
           </a:p>
@@ -2216,7 +2220,7 @@
     </p:spTree>
     <p:extLst>
       <p:ext uri="{BB962C8B-B14F-4D97-AF65-F5344CB8AC3E}">
-        <p14:creationId xmlns:p14="http://schemas.microsoft.com/office/powerpoint/2010/main" val="3235989668"/>
+        <p14:creationId xmlns:p14="http://schemas.microsoft.com/office/powerpoint/2010/main" val="4211073618"/>
       </p:ext>
     </p:extLst>
   </p:cSld>
@@ -2283,7 +2287,7 @@
           <a:p>
             <a:fld id="{86FBD32F-FCAD-481A-B7D8-4D813FB7DB24}" type="datetimeFigureOut">
               <a:rPr lang="en-IN" smtClean="0"/>
-              <a:t>13-06-2024</a:t>
+              <a:t>17-06-2024</a:t>
             </a:fld>
             <a:endParaRPr lang="en-IN"/>
           </a:p>
@@ -2334,7 +2338,7 @@
     </p:spTree>
     <p:extLst>
       <p:ext uri="{BB962C8B-B14F-4D97-AF65-F5344CB8AC3E}">
-        <p14:creationId xmlns:p14="http://schemas.microsoft.com/office/powerpoint/2010/main" val="3437716454"/>
+        <p14:creationId xmlns:p14="http://schemas.microsoft.com/office/powerpoint/2010/main" val="4282904816"/>
       </p:ext>
     </p:extLst>
   </p:cSld>
@@ -2378,7 +2382,7 @@
           <a:p>
             <a:fld id="{86FBD32F-FCAD-481A-B7D8-4D813FB7DB24}" type="datetimeFigureOut">
               <a:rPr lang="en-IN" smtClean="0"/>
-              <a:t>13-06-2024</a:t>
+              <a:t>17-06-2024</a:t>
             </a:fld>
             <a:endParaRPr lang="en-IN"/>
           </a:p>
@@ -2429,7 +2433,7 @@
     </p:spTree>
     <p:extLst>
       <p:ext uri="{BB962C8B-B14F-4D97-AF65-F5344CB8AC3E}">
-        <p14:creationId xmlns:p14="http://schemas.microsoft.com/office/powerpoint/2010/main" val="3964830373"/>
+        <p14:creationId xmlns:p14="http://schemas.microsoft.com/office/powerpoint/2010/main" val="694914933"/>
       </p:ext>
     </p:extLst>
   </p:cSld>
@@ -2468,15 +2472,15 @@
         </p:nvSpPr>
         <p:spPr>
           <a:xfrm>
-            <a:off x="472381" y="660400"/>
-            <a:ext cx="2211884" cy="2311400"/>
+            <a:off x="1212992" y="660400"/>
+            <a:ext cx="5679727" cy="2311400"/>
           </a:xfrm>
         </p:spPr>
         <p:txBody>
           <a:bodyPr anchor="b"/>
           <a:lstStyle>
             <a:lvl1pPr>
-              <a:defRPr sz="2400"/>
+              <a:defRPr sz="4622"/>
             </a:lvl1pPr>
           </a:lstStyle>
           <a:p>
@@ -2500,39 +2504,39 @@
         </p:nvSpPr>
         <p:spPr>
           <a:xfrm>
-            <a:off x="2915543" y="1426283"/>
-            <a:ext cx="3471863" cy="7039681"/>
+            <a:off x="7486603" y="1426281"/>
+            <a:ext cx="8915132" cy="7039681"/>
           </a:xfrm>
         </p:spPr>
         <p:txBody>
           <a:bodyPr/>
           <a:lstStyle>
             <a:lvl1pPr>
-              <a:defRPr sz="2400"/>
+              <a:defRPr sz="4622"/>
             </a:lvl1pPr>
             <a:lvl2pPr>
-              <a:defRPr sz="2100"/>
+              <a:defRPr sz="4044"/>
             </a:lvl2pPr>
             <a:lvl3pPr>
-              <a:defRPr sz="1800"/>
+              <a:defRPr sz="3467"/>
             </a:lvl3pPr>
             <a:lvl4pPr>
-              <a:defRPr sz="1500"/>
+              <a:defRPr sz="2889"/>
             </a:lvl4pPr>
             <a:lvl5pPr>
-              <a:defRPr sz="1500"/>
+              <a:defRPr sz="2889"/>
             </a:lvl5pPr>
             <a:lvl6pPr>
-              <a:defRPr sz="1500"/>
+              <a:defRPr sz="2889"/>
             </a:lvl6pPr>
             <a:lvl7pPr>
-              <a:defRPr sz="1500"/>
+              <a:defRPr sz="2889"/>
             </a:lvl7pPr>
             <a:lvl8pPr>
-              <a:defRPr sz="1500"/>
+              <a:defRPr sz="2889"/>
             </a:lvl8pPr>
             <a:lvl9pPr>
-              <a:defRPr sz="1500"/>
+              <a:defRPr sz="2889"/>
             </a:lvl9pPr>
           </a:lstStyle>
           <a:p>
@@ -2585,8 +2589,8 @@
         </p:nvSpPr>
         <p:spPr>
           <a:xfrm>
-            <a:off x="472381" y="2971800"/>
-            <a:ext cx="2211884" cy="5505627"/>
+            <a:off x="1212992" y="2971800"/>
+            <a:ext cx="5679727" cy="5505627"/>
           </a:xfrm>
         </p:spPr>
         <p:txBody>
@@ -2594,39 +2598,39 @@
           <a:lstStyle>
             <a:lvl1pPr marL="0" indent="0">
               <a:buNone/>
-              <a:defRPr sz="1200"/>
+              <a:defRPr sz="2311"/>
             </a:lvl1pPr>
-            <a:lvl2pPr marL="342900" indent="0">
+            <a:lvl2pPr marL="660380" indent="0">
               <a:buNone/>
-              <a:defRPr sz="1050"/>
+              <a:defRPr sz="2022"/>
             </a:lvl2pPr>
-            <a:lvl3pPr marL="685800" indent="0">
+            <a:lvl3pPr marL="1320759" indent="0">
               <a:buNone/>
-              <a:defRPr sz="900"/>
+              <a:defRPr sz="1733"/>
             </a:lvl3pPr>
-            <a:lvl4pPr marL="1028700" indent="0">
+            <a:lvl4pPr marL="1981139" indent="0">
               <a:buNone/>
-              <a:defRPr sz="750"/>
+              <a:defRPr sz="1444"/>
             </a:lvl4pPr>
-            <a:lvl5pPr marL="1371600" indent="0">
+            <a:lvl5pPr marL="2641519" indent="0">
               <a:buNone/>
-              <a:defRPr sz="750"/>
+              <a:defRPr sz="1444"/>
             </a:lvl5pPr>
-            <a:lvl6pPr marL="1714500" indent="0">
+            <a:lvl6pPr marL="3301898" indent="0">
               <a:buNone/>
-              <a:defRPr sz="750"/>
+              <a:defRPr sz="1444"/>
             </a:lvl6pPr>
-            <a:lvl7pPr marL="2057400" indent="0">
+            <a:lvl7pPr marL="3962278" indent="0">
               <a:buNone/>
-              <a:defRPr sz="750"/>
+              <a:defRPr sz="1444"/>
             </a:lvl7pPr>
-            <a:lvl8pPr marL="2400300" indent="0">
+            <a:lvl8pPr marL="4622658" indent="0">
               <a:buNone/>
-              <a:defRPr sz="750"/>
+              <a:defRPr sz="1444"/>
             </a:lvl8pPr>
-            <a:lvl9pPr marL="2743200" indent="0">
+            <a:lvl9pPr marL="5283037" indent="0">
               <a:buNone/>
-              <a:defRPr sz="750"/>
+              <a:defRPr sz="1444"/>
             </a:lvl9pPr>
           </a:lstStyle>
           <a:p>
@@ -2655,7 +2659,7 @@
           <a:p>
             <a:fld id="{86FBD32F-FCAD-481A-B7D8-4D813FB7DB24}" type="datetimeFigureOut">
               <a:rPr lang="en-IN" smtClean="0"/>
-              <a:t>13-06-2024</a:t>
+              <a:t>17-06-2024</a:t>
             </a:fld>
             <a:endParaRPr lang="en-IN"/>
           </a:p>
@@ -2706,7 +2710,7 @@
     </p:spTree>
     <p:extLst>
       <p:ext uri="{BB962C8B-B14F-4D97-AF65-F5344CB8AC3E}">
-        <p14:creationId xmlns:p14="http://schemas.microsoft.com/office/powerpoint/2010/main" val="965244924"/>
+        <p14:creationId xmlns:p14="http://schemas.microsoft.com/office/powerpoint/2010/main" val="3092988902"/>
       </p:ext>
     </p:extLst>
   </p:cSld>
@@ -2745,15 +2749,15 @@
         </p:nvSpPr>
         <p:spPr>
           <a:xfrm>
-            <a:off x="472381" y="660400"/>
-            <a:ext cx="2211884" cy="2311400"/>
+            <a:off x="1212992" y="660400"/>
+            <a:ext cx="5679727" cy="2311400"/>
           </a:xfrm>
         </p:spPr>
         <p:txBody>
           <a:bodyPr anchor="b"/>
           <a:lstStyle>
             <a:lvl1pPr>
-              <a:defRPr sz="2400"/>
+              <a:defRPr sz="4622"/>
             </a:lvl1pPr>
           </a:lstStyle>
           <a:p>
@@ -2777,8 +2781,8 @@
         </p:nvSpPr>
         <p:spPr>
           <a:xfrm>
-            <a:off x="2915543" y="1426283"/>
-            <a:ext cx="3471863" cy="7039681"/>
+            <a:off x="7486603" y="1426281"/>
+            <a:ext cx="8915132" cy="7039681"/>
           </a:xfrm>
         </p:spPr>
         <p:txBody>
@@ -2786,39 +2790,39 @@
           <a:lstStyle>
             <a:lvl1pPr marL="0" indent="0">
               <a:buNone/>
-              <a:defRPr sz="2400"/>
+              <a:defRPr sz="4622"/>
             </a:lvl1pPr>
-            <a:lvl2pPr marL="342900" indent="0">
+            <a:lvl2pPr marL="660380" indent="0">
               <a:buNone/>
-              <a:defRPr sz="2100"/>
+              <a:defRPr sz="4044"/>
             </a:lvl2pPr>
-            <a:lvl3pPr marL="685800" indent="0">
+            <a:lvl3pPr marL="1320759" indent="0">
               <a:buNone/>
-              <a:defRPr sz="1800"/>
+              <a:defRPr sz="3467"/>
             </a:lvl3pPr>
-            <a:lvl4pPr marL="1028700" indent="0">
+            <a:lvl4pPr marL="1981139" indent="0">
               <a:buNone/>
-              <a:defRPr sz="1500"/>
+              <a:defRPr sz="2889"/>
             </a:lvl4pPr>
-            <a:lvl5pPr marL="1371600" indent="0">
+            <a:lvl5pPr marL="2641519" indent="0">
               <a:buNone/>
-              <a:defRPr sz="1500"/>
+              <a:defRPr sz="2889"/>
             </a:lvl5pPr>
-            <a:lvl6pPr marL="1714500" indent="0">
+            <a:lvl6pPr marL="3301898" indent="0">
               <a:buNone/>
-              <a:defRPr sz="1500"/>
+              <a:defRPr sz="2889"/>
             </a:lvl6pPr>
-            <a:lvl7pPr marL="2057400" indent="0">
+            <a:lvl7pPr marL="3962278" indent="0">
               <a:buNone/>
-              <a:defRPr sz="1500"/>
+              <a:defRPr sz="2889"/>
             </a:lvl7pPr>
-            <a:lvl8pPr marL="2400300" indent="0">
+            <a:lvl8pPr marL="4622658" indent="0">
               <a:buNone/>
-              <a:defRPr sz="1500"/>
+              <a:defRPr sz="2889"/>
             </a:lvl8pPr>
-            <a:lvl9pPr marL="2743200" indent="0">
+            <a:lvl9pPr marL="5283037" indent="0">
               <a:buNone/>
-              <a:defRPr sz="1500"/>
+              <a:defRPr sz="2889"/>
             </a:lvl9pPr>
           </a:lstStyle>
           <a:p>
@@ -2842,8 +2846,8 @@
         </p:nvSpPr>
         <p:spPr>
           <a:xfrm>
-            <a:off x="472381" y="2971800"/>
-            <a:ext cx="2211884" cy="5505627"/>
+            <a:off x="1212992" y="2971800"/>
+            <a:ext cx="5679727" cy="5505627"/>
           </a:xfrm>
         </p:spPr>
         <p:txBody>
@@ -2851,39 +2855,39 @@
           <a:lstStyle>
             <a:lvl1pPr marL="0" indent="0">
               <a:buNone/>
-              <a:defRPr sz="1200"/>
+              <a:defRPr sz="2311"/>
             </a:lvl1pPr>
-            <a:lvl2pPr marL="342900" indent="0">
+            <a:lvl2pPr marL="660380" indent="0">
               <a:buNone/>
-              <a:defRPr sz="1050"/>
+              <a:defRPr sz="2022"/>
             </a:lvl2pPr>
-            <a:lvl3pPr marL="685800" indent="0">
+            <a:lvl3pPr marL="1320759" indent="0">
               <a:buNone/>
-              <a:defRPr sz="900"/>
+              <a:defRPr sz="1733"/>
             </a:lvl3pPr>
-            <a:lvl4pPr marL="1028700" indent="0">
+            <a:lvl4pPr marL="1981139" indent="0">
               <a:buNone/>
-              <a:defRPr sz="750"/>
+              <a:defRPr sz="1444"/>
             </a:lvl4pPr>
-            <a:lvl5pPr marL="1371600" indent="0">
+            <a:lvl5pPr marL="2641519" indent="0">
               <a:buNone/>
-              <a:defRPr sz="750"/>
+              <a:defRPr sz="1444"/>
             </a:lvl5pPr>
-            <a:lvl6pPr marL="1714500" indent="0">
+            <a:lvl6pPr marL="3301898" indent="0">
               <a:buNone/>
-              <a:defRPr sz="750"/>
+              <a:defRPr sz="1444"/>
             </a:lvl6pPr>
-            <a:lvl7pPr marL="2057400" indent="0">
+            <a:lvl7pPr marL="3962278" indent="0">
               <a:buNone/>
-              <a:defRPr sz="750"/>
+              <a:defRPr sz="1444"/>
             </a:lvl7pPr>
-            <a:lvl8pPr marL="2400300" indent="0">
+            <a:lvl8pPr marL="4622658" indent="0">
               <a:buNone/>
-              <a:defRPr sz="750"/>
+              <a:defRPr sz="1444"/>
             </a:lvl8pPr>
-            <a:lvl9pPr marL="2743200" indent="0">
+            <a:lvl9pPr marL="5283037" indent="0">
               <a:buNone/>
-              <a:defRPr sz="750"/>
+              <a:defRPr sz="1444"/>
             </a:lvl9pPr>
           </a:lstStyle>
           <a:p>
@@ -2912,7 +2916,7 @@
           <a:p>
             <a:fld id="{86FBD32F-FCAD-481A-B7D8-4D813FB7DB24}" type="datetimeFigureOut">
               <a:rPr lang="en-IN" smtClean="0"/>
-              <a:t>13-06-2024</a:t>
+              <a:t>17-06-2024</a:t>
             </a:fld>
             <a:endParaRPr lang="en-IN"/>
           </a:p>
@@ -2963,7 +2967,7 @@
     </p:spTree>
     <p:extLst>
       <p:ext uri="{BB962C8B-B14F-4D97-AF65-F5344CB8AC3E}">
-        <p14:creationId xmlns:p14="http://schemas.microsoft.com/office/powerpoint/2010/main" val="1000742942"/>
+        <p14:creationId xmlns:p14="http://schemas.microsoft.com/office/powerpoint/2010/main" val="3460959683"/>
       </p:ext>
     </p:extLst>
   </p:cSld>
@@ -3007,8 +3011,8 @@
         </p:nvSpPr>
         <p:spPr>
           <a:xfrm>
-            <a:off x="471488" y="527405"/>
-            <a:ext cx="5915025" cy="1914702"/>
+            <a:off x="1210697" y="527404"/>
+            <a:ext cx="15188744" cy="1914702"/>
           </a:xfrm>
           <a:prstGeom prst="rect">
             <a:avLst/>
@@ -3040,8 +3044,8 @@
         </p:nvSpPr>
         <p:spPr>
           <a:xfrm>
-            <a:off x="471488" y="2637014"/>
-            <a:ext cx="5915025" cy="6285266"/>
+            <a:off x="1210697" y="2637014"/>
+            <a:ext cx="15188744" cy="6285266"/>
           </a:xfrm>
           <a:prstGeom prst="rect">
             <a:avLst/>
@@ -3102,8 +3106,8 @@
         </p:nvSpPr>
         <p:spPr>
           <a:xfrm>
-            <a:off x="471488" y="9181397"/>
-            <a:ext cx="1543050" cy="527403"/>
+            <a:off x="1210697" y="9181395"/>
+            <a:ext cx="3962281" cy="527403"/>
           </a:xfrm>
           <a:prstGeom prst="rect">
             <a:avLst/>
@@ -3113,7 +3117,7 @@
           <a:bodyPr vert="horz" lIns="91440" tIns="45720" rIns="91440" bIns="45720" rtlCol="0" anchor="ctr"/>
           <a:lstStyle>
             <a:lvl1pPr algn="l">
-              <a:defRPr sz="900">
+              <a:defRPr sz="1733">
                 <a:solidFill>
                   <a:schemeClr val="tx1">
                     <a:tint val="75000"/>
@@ -3125,7 +3129,7 @@
           <a:p>
             <a:fld id="{86FBD32F-FCAD-481A-B7D8-4D813FB7DB24}" type="datetimeFigureOut">
               <a:rPr lang="en-IN" smtClean="0"/>
-              <a:t>13-06-2024</a:t>
+              <a:t>17-06-2024</a:t>
             </a:fld>
             <a:endParaRPr lang="en-IN"/>
           </a:p>
@@ -3143,8 +3147,8 @@
         </p:nvSpPr>
         <p:spPr>
           <a:xfrm>
-            <a:off x="2271713" y="9181397"/>
-            <a:ext cx="2314575" cy="527403"/>
+            <a:off x="5833358" y="9181395"/>
+            <a:ext cx="5943422" cy="527403"/>
           </a:xfrm>
           <a:prstGeom prst="rect">
             <a:avLst/>
@@ -3154,7 +3158,7 @@
           <a:bodyPr vert="horz" lIns="91440" tIns="45720" rIns="91440" bIns="45720" rtlCol="0" anchor="ctr"/>
           <a:lstStyle>
             <a:lvl1pPr algn="ctr">
-              <a:defRPr sz="900">
+              <a:defRPr sz="1733">
                 <a:solidFill>
                   <a:schemeClr val="tx1">
                     <a:tint val="75000"/>
@@ -3180,8 +3184,8 @@
         </p:nvSpPr>
         <p:spPr>
           <a:xfrm>
-            <a:off x="4843463" y="9181397"/>
-            <a:ext cx="1543050" cy="527403"/>
+            <a:off x="12437160" y="9181395"/>
+            <a:ext cx="3962281" cy="527403"/>
           </a:xfrm>
           <a:prstGeom prst="rect">
             <a:avLst/>
@@ -3191,7 +3195,7 @@
           <a:bodyPr vert="horz" lIns="91440" tIns="45720" rIns="91440" bIns="45720" rtlCol="0" anchor="ctr"/>
           <a:lstStyle>
             <a:lvl1pPr algn="r">
-              <a:defRPr sz="900">
+              <a:defRPr sz="1733">
                 <a:solidFill>
                   <a:schemeClr val="tx1">
                     <a:tint val="75000"/>
@@ -3212,27 +3216,27 @@
     </p:spTree>
     <p:extLst>
       <p:ext uri="{BB962C8B-B14F-4D97-AF65-F5344CB8AC3E}">
-        <p14:creationId xmlns:p14="http://schemas.microsoft.com/office/powerpoint/2010/main" val="1750111857"/>
+        <p14:creationId xmlns:p14="http://schemas.microsoft.com/office/powerpoint/2010/main" val="1467753994"/>
       </p:ext>
     </p:extLst>
   </p:cSld>
   <p:clrMap bg1="lt1" tx1="dk1" bg2="lt2" tx2="dk2" accent1="accent1" accent2="accent2" accent3="accent3" accent4="accent4" accent5="accent5" accent6="accent6" hlink="hlink" folHlink="folHlink"/>
   <p:sldLayoutIdLst>
-    <p:sldLayoutId id="2147483661" r:id="rId1"/>
-    <p:sldLayoutId id="2147483662" r:id="rId2"/>
-    <p:sldLayoutId id="2147483663" r:id="rId3"/>
-    <p:sldLayoutId id="2147483664" r:id="rId4"/>
-    <p:sldLayoutId id="2147483665" r:id="rId5"/>
-    <p:sldLayoutId id="2147483666" r:id="rId6"/>
-    <p:sldLayoutId id="2147483667" r:id="rId7"/>
-    <p:sldLayoutId id="2147483668" r:id="rId8"/>
-    <p:sldLayoutId id="2147483669" r:id="rId9"/>
-    <p:sldLayoutId id="2147483670" r:id="rId10"/>
-    <p:sldLayoutId id="2147483671" r:id="rId11"/>
+    <p:sldLayoutId id="2147483673" r:id="rId1"/>
+    <p:sldLayoutId id="2147483674" r:id="rId2"/>
+    <p:sldLayoutId id="2147483675" r:id="rId3"/>
+    <p:sldLayoutId id="2147483676" r:id="rId4"/>
+    <p:sldLayoutId id="2147483677" r:id="rId5"/>
+    <p:sldLayoutId id="2147483678" r:id="rId6"/>
+    <p:sldLayoutId id="2147483679" r:id="rId7"/>
+    <p:sldLayoutId id="2147483680" r:id="rId8"/>
+    <p:sldLayoutId id="2147483681" r:id="rId9"/>
+    <p:sldLayoutId id="2147483682" r:id="rId10"/>
+    <p:sldLayoutId id="2147483683" r:id="rId11"/>
   </p:sldLayoutIdLst>
   <p:txStyles>
     <p:titleStyle>
-      <a:lvl1pPr algn="l" defTabSz="685800" rtl="0" eaLnBrk="1" latinLnBrk="0" hangingPunct="1">
+      <a:lvl1pPr algn="l" defTabSz="1320759" rtl="0" eaLnBrk="1" latinLnBrk="0" hangingPunct="1">
         <a:lnSpc>
           <a:spcPct val="90000"/>
         </a:lnSpc>
@@ -3240,7 +3244,7 @@
           <a:spcPct val="0"/>
         </a:spcBef>
         <a:buNone/>
-        <a:defRPr sz="3300" kern="1200">
+        <a:defRPr sz="6355" kern="1200">
           <a:solidFill>
             <a:schemeClr val="tx1"/>
           </a:solidFill>
@@ -3251,16 +3255,16 @@
       </a:lvl1pPr>
     </p:titleStyle>
     <p:bodyStyle>
-      <a:lvl1pPr marL="171450" indent="-171450" algn="l" defTabSz="685800" rtl="0" eaLnBrk="1" latinLnBrk="0" hangingPunct="1">
+      <a:lvl1pPr marL="330190" indent="-330190" algn="l" defTabSz="1320759" rtl="0" eaLnBrk="1" latinLnBrk="0" hangingPunct="1">
         <a:lnSpc>
           <a:spcPct val="90000"/>
         </a:lnSpc>
         <a:spcBef>
-          <a:spcPts val="750"/>
+          <a:spcPts val="1444"/>
         </a:spcBef>
         <a:buFont typeface="Arial" panose="020B0604020202020204" pitchFamily="34" charset="0"/>
         <a:buChar char="•"/>
-        <a:defRPr sz="2100" kern="1200">
+        <a:defRPr sz="4044" kern="1200">
           <a:solidFill>
             <a:schemeClr val="tx1"/>
           </a:solidFill>
@@ -3269,16 +3273,16 @@
           <a:cs typeface="+mn-cs"/>
         </a:defRPr>
       </a:lvl1pPr>
-      <a:lvl2pPr marL="514350" indent="-171450" algn="l" defTabSz="685800" rtl="0" eaLnBrk="1" latinLnBrk="0" hangingPunct="1">
+      <a:lvl2pPr marL="990570" indent="-330190" algn="l" defTabSz="1320759" rtl="0" eaLnBrk="1" latinLnBrk="0" hangingPunct="1">
         <a:lnSpc>
           <a:spcPct val="90000"/>
         </a:lnSpc>
         <a:spcBef>
-          <a:spcPts val="375"/>
+          <a:spcPts val="722"/>
         </a:spcBef>
         <a:buFont typeface="Arial" panose="020B0604020202020204" pitchFamily="34" charset="0"/>
         <a:buChar char="•"/>
-        <a:defRPr sz="1800" kern="1200">
+        <a:defRPr sz="3467" kern="1200">
           <a:solidFill>
             <a:schemeClr val="tx1"/>
           </a:solidFill>
@@ -3287,16 +3291,16 @@
           <a:cs typeface="+mn-cs"/>
         </a:defRPr>
       </a:lvl2pPr>
-      <a:lvl3pPr marL="857250" indent="-171450" algn="l" defTabSz="685800" rtl="0" eaLnBrk="1" latinLnBrk="0" hangingPunct="1">
+      <a:lvl3pPr marL="1650949" indent="-330190" algn="l" defTabSz="1320759" rtl="0" eaLnBrk="1" latinLnBrk="0" hangingPunct="1">
         <a:lnSpc>
           <a:spcPct val="90000"/>
         </a:lnSpc>
         <a:spcBef>
-          <a:spcPts val="375"/>
+          <a:spcPts val="722"/>
         </a:spcBef>
         <a:buFont typeface="Arial" panose="020B0604020202020204" pitchFamily="34" charset="0"/>
         <a:buChar char="•"/>
-        <a:defRPr sz="1500" kern="1200">
+        <a:defRPr sz="2889" kern="1200">
           <a:solidFill>
             <a:schemeClr val="tx1"/>
           </a:solidFill>
@@ -3305,16 +3309,16 @@
           <a:cs typeface="+mn-cs"/>
         </a:defRPr>
       </a:lvl3pPr>
-      <a:lvl4pPr marL="1200150" indent="-171450" algn="l" defTabSz="685800" rtl="0" eaLnBrk="1" latinLnBrk="0" hangingPunct="1">
+      <a:lvl4pPr marL="2311329" indent="-330190" algn="l" defTabSz="1320759" rtl="0" eaLnBrk="1" latinLnBrk="0" hangingPunct="1">
         <a:lnSpc>
           <a:spcPct val="90000"/>
         </a:lnSpc>
         <a:spcBef>
-          <a:spcPts val="375"/>
+          <a:spcPts val="722"/>
         </a:spcBef>
         <a:buFont typeface="Arial" panose="020B0604020202020204" pitchFamily="34" charset="0"/>
         <a:buChar char="•"/>
-        <a:defRPr sz="1350" kern="1200">
+        <a:defRPr sz="2600" kern="1200">
           <a:solidFill>
             <a:schemeClr val="tx1"/>
           </a:solidFill>
@@ -3323,16 +3327,16 @@
           <a:cs typeface="+mn-cs"/>
         </a:defRPr>
       </a:lvl4pPr>
-      <a:lvl5pPr marL="1543050" indent="-171450" algn="l" defTabSz="685800" rtl="0" eaLnBrk="1" latinLnBrk="0" hangingPunct="1">
+      <a:lvl5pPr marL="2971709" indent="-330190" algn="l" defTabSz="1320759" rtl="0" eaLnBrk="1" latinLnBrk="0" hangingPunct="1">
         <a:lnSpc>
           <a:spcPct val="90000"/>
         </a:lnSpc>
         <a:spcBef>
-          <a:spcPts val="375"/>
+          <a:spcPts val="722"/>
         </a:spcBef>
         <a:buFont typeface="Arial" panose="020B0604020202020204" pitchFamily="34" charset="0"/>
         <a:buChar char="•"/>
-        <a:defRPr sz="1350" kern="1200">
+        <a:defRPr sz="2600" kern="1200">
           <a:solidFill>
             <a:schemeClr val="tx1"/>
           </a:solidFill>
@@ -3341,16 +3345,16 @@
           <a:cs typeface="+mn-cs"/>
         </a:defRPr>
       </a:lvl5pPr>
-      <a:lvl6pPr marL="1885950" indent="-171450" algn="l" defTabSz="685800" rtl="0" eaLnBrk="1" latinLnBrk="0" hangingPunct="1">
+      <a:lvl6pPr marL="3632088" indent="-330190" algn="l" defTabSz="1320759" rtl="0" eaLnBrk="1" latinLnBrk="0" hangingPunct="1">
         <a:lnSpc>
           <a:spcPct val="90000"/>
         </a:lnSpc>
         <a:spcBef>
-          <a:spcPts val="375"/>
+          <a:spcPts val="722"/>
         </a:spcBef>
         <a:buFont typeface="Arial" panose="020B0604020202020204" pitchFamily="34" charset="0"/>
         <a:buChar char="•"/>
-        <a:defRPr sz="1350" kern="1200">
+        <a:defRPr sz="2600" kern="1200">
           <a:solidFill>
             <a:schemeClr val="tx1"/>
           </a:solidFill>
@@ -3359,16 +3363,16 @@
           <a:cs typeface="+mn-cs"/>
         </a:defRPr>
       </a:lvl6pPr>
-      <a:lvl7pPr marL="2228850" indent="-171450" algn="l" defTabSz="685800" rtl="0" eaLnBrk="1" latinLnBrk="0" hangingPunct="1">
+      <a:lvl7pPr marL="4292468" indent="-330190" algn="l" defTabSz="1320759" rtl="0" eaLnBrk="1" latinLnBrk="0" hangingPunct="1">
         <a:lnSpc>
           <a:spcPct val="90000"/>
         </a:lnSpc>
         <a:spcBef>
-          <a:spcPts val="375"/>
+          <a:spcPts val="722"/>
         </a:spcBef>
         <a:buFont typeface="Arial" panose="020B0604020202020204" pitchFamily="34" charset="0"/>
         <a:buChar char="•"/>
-        <a:defRPr sz="1350" kern="1200">
+        <a:defRPr sz="2600" kern="1200">
           <a:solidFill>
             <a:schemeClr val="tx1"/>
           </a:solidFill>
@@ -3377,16 +3381,16 @@
           <a:cs typeface="+mn-cs"/>
         </a:defRPr>
       </a:lvl7pPr>
-      <a:lvl8pPr marL="2571750" indent="-171450" algn="l" defTabSz="685800" rtl="0" eaLnBrk="1" latinLnBrk="0" hangingPunct="1">
+      <a:lvl8pPr marL="4952848" indent="-330190" algn="l" defTabSz="1320759" rtl="0" eaLnBrk="1" latinLnBrk="0" hangingPunct="1">
         <a:lnSpc>
           <a:spcPct val="90000"/>
         </a:lnSpc>
         <a:spcBef>
-          <a:spcPts val="375"/>
+          <a:spcPts val="722"/>
         </a:spcBef>
         <a:buFont typeface="Arial" panose="020B0604020202020204" pitchFamily="34" charset="0"/>
         <a:buChar char="•"/>
-        <a:defRPr sz="1350" kern="1200">
+        <a:defRPr sz="2600" kern="1200">
           <a:solidFill>
             <a:schemeClr val="tx1"/>
           </a:solidFill>
@@ -3395,16 +3399,16 @@
           <a:cs typeface="+mn-cs"/>
         </a:defRPr>
       </a:lvl8pPr>
-      <a:lvl9pPr marL="2914650" indent="-171450" algn="l" defTabSz="685800" rtl="0" eaLnBrk="1" latinLnBrk="0" hangingPunct="1">
+      <a:lvl9pPr marL="5613227" indent="-330190" algn="l" defTabSz="1320759" rtl="0" eaLnBrk="1" latinLnBrk="0" hangingPunct="1">
         <a:lnSpc>
           <a:spcPct val="90000"/>
         </a:lnSpc>
         <a:spcBef>
-          <a:spcPts val="375"/>
+          <a:spcPts val="722"/>
         </a:spcBef>
         <a:buFont typeface="Arial" panose="020B0604020202020204" pitchFamily="34" charset="0"/>
         <a:buChar char="•"/>
-        <a:defRPr sz="1350" kern="1200">
+        <a:defRPr sz="2600" kern="1200">
           <a:solidFill>
             <a:schemeClr val="tx1"/>
           </a:solidFill>
@@ -3418,8 +3422,8 @@
       <a:defPPr>
         <a:defRPr lang="en-US"/>
       </a:defPPr>
-      <a:lvl1pPr marL="0" algn="l" defTabSz="685800" rtl="0" eaLnBrk="1" latinLnBrk="0" hangingPunct="1">
-        <a:defRPr sz="1350" kern="1200">
+      <a:lvl1pPr marL="0" algn="l" defTabSz="1320759" rtl="0" eaLnBrk="1" latinLnBrk="0" hangingPunct="1">
+        <a:defRPr sz="2600" kern="1200">
           <a:solidFill>
             <a:schemeClr val="tx1"/>
           </a:solidFill>
@@ -3428,8 +3432,8 @@
           <a:cs typeface="+mn-cs"/>
         </a:defRPr>
       </a:lvl1pPr>
-      <a:lvl2pPr marL="342900" algn="l" defTabSz="685800" rtl="0" eaLnBrk="1" latinLnBrk="0" hangingPunct="1">
-        <a:defRPr sz="1350" kern="1200">
+      <a:lvl2pPr marL="660380" algn="l" defTabSz="1320759" rtl="0" eaLnBrk="1" latinLnBrk="0" hangingPunct="1">
+        <a:defRPr sz="2600" kern="1200">
           <a:solidFill>
             <a:schemeClr val="tx1"/>
           </a:solidFill>
@@ -3438,8 +3442,8 @@
           <a:cs typeface="+mn-cs"/>
         </a:defRPr>
       </a:lvl2pPr>
-      <a:lvl3pPr marL="685800" algn="l" defTabSz="685800" rtl="0" eaLnBrk="1" latinLnBrk="0" hangingPunct="1">
-        <a:defRPr sz="1350" kern="1200">
+      <a:lvl3pPr marL="1320759" algn="l" defTabSz="1320759" rtl="0" eaLnBrk="1" latinLnBrk="0" hangingPunct="1">
+        <a:defRPr sz="2600" kern="1200">
           <a:solidFill>
             <a:schemeClr val="tx1"/>
           </a:solidFill>
@@ -3448,8 +3452,8 @@
           <a:cs typeface="+mn-cs"/>
         </a:defRPr>
       </a:lvl3pPr>
-      <a:lvl4pPr marL="1028700" algn="l" defTabSz="685800" rtl="0" eaLnBrk="1" latinLnBrk="0" hangingPunct="1">
-        <a:defRPr sz="1350" kern="1200">
+      <a:lvl4pPr marL="1981139" algn="l" defTabSz="1320759" rtl="0" eaLnBrk="1" latinLnBrk="0" hangingPunct="1">
+        <a:defRPr sz="2600" kern="1200">
           <a:solidFill>
             <a:schemeClr val="tx1"/>
           </a:solidFill>
@@ -3458,8 +3462,8 @@
           <a:cs typeface="+mn-cs"/>
         </a:defRPr>
       </a:lvl4pPr>
-      <a:lvl5pPr marL="1371600" algn="l" defTabSz="685800" rtl="0" eaLnBrk="1" latinLnBrk="0" hangingPunct="1">
-        <a:defRPr sz="1350" kern="1200">
+      <a:lvl5pPr marL="2641519" algn="l" defTabSz="1320759" rtl="0" eaLnBrk="1" latinLnBrk="0" hangingPunct="1">
+        <a:defRPr sz="2600" kern="1200">
           <a:solidFill>
             <a:schemeClr val="tx1"/>
           </a:solidFill>
@@ -3468,8 +3472,8 @@
           <a:cs typeface="+mn-cs"/>
         </a:defRPr>
       </a:lvl5pPr>
-      <a:lvl6pPr marL="1714500" algn="l" defTabSz="685800" rtl="0" eaLnBrk="1" latinLnBrk="0" hangingPunct="1">
-        <a:defRPr sz="1350" kern="1200">
+      <a:lvl6pPr marL="3301898" algn="l" defTabSz="1320759" rtl="0" eaLnBrk="1" latinLnBrk="0" hangingPunct="1">
+        <a:defRPr sz="2600" kern="1200">
           <a:solidFill>
             <a:schemeClr val="tx1"/>
           </a:solidFill>
@@ -3478,8 +3482,8 @@
           <a:cs typeface="+mn-cs"/>
         </a:defRPr>
       </a:lvl6pPr>
-      <a:lvl7pPr marL="2057400" algn="l" defTabSz="685800" rtl="0" eaLnBrk="1" latinLnBrk="0" hangingPunct="1">
-        <a:defRPr sz="1350" kern="1200">
+      <a:lvl7pPr marL="3962278" algn="l" defTabSz="1320759" rtl="0" eaLnBrk="1" latinLnBrk="0" hangingPunct="1">
+        <a:defRPr sz="2600" kern="1200">
           <a:solidFill>
             <a:schemeClr val="tx1"/>
           </a:solidFill>
@@ -3488,8 +3492,8 @@
           <a:cs typeface="+mn-cs"/>
         </a:defRPr>
       </a:lvl7pPr>
-      <a:lvl8pPr marL="2400300" algn="l" defTabSz="685800" rtl="0" eaLnBrk="1" latinLnBrk="0" hangingPunct="1">
-        <a:defRPr sz="1350" kern="1200">
+      <a:lvl8pPr marL="4622658" algn="l" defTabSz="1320759" rtl="0" eaLnBrk="1" latinLnBrk="0" hangingPunct="1">
+        <a:defRPr sz="2600" kern="1200">
           <a:solidFill>
             <a:schemeClr val="tx1"/>
           </a:solidFill>
@@ -3498,8 +3502,8 @@
           <a:cs typeface="+mn-cs"/>
         </a:defRPr>
       </a:lvl8pPr>
-      <a:lvl9pPr marL="2743200" algn="l" defTabSz="685800" rtl="0" eaLnBrk="1" latinLnBrk="0" hangingPunct="1">
-        <a:defRPr sz="1350" kern="1200">
+      <a:lvl9pPr marL="5283037" algn="l" defTabSz="1320759" rtl="0" eaLnBrk="1" latinLnBrk="0" hangingPunct="1">
+        <a:defRPr sz="2600" kern="1200">
           <a:solidFill>
             <a:schemeClr val="tx1"/>
           </a:solidFill>
@@ -3544,7 +3548,7 @@
         </p:nvSpPr>
         <p:spPr>
           <a:xfrm>
-            <a:off x="51132" y="125663"/>
+            <a:off x="5427201" y="125663"/>
             <a:ext cx="3377868" cy="4752474"/>
           </a:xfrm>
           <a:prstGeom prst="rect">
@@ -3581,49 +3585,32 @@
           <a:bodyPr rtlCol="0" anchor="ctr"/>
           <a:lstStyle/>
           <a:p>
-            <a:pPr marL="0" marR="0" indent="0" algn="ctr" rtl="0" eaLnBrk="1" fontAlgn="auto" latinLnBrk="0" hangingPunct="1">
-              <a:spcBef>
-                <a:spcPts val="0"/>
-              </a:spcBef>
-              <a:spcAft>
-                <a:spcPts val="0"/>
-              </a:spcAft>
-            </a:pPr>
-            <a:r>
-              <a:rPr lang="te-IN" sz="1750" b="0" i="0" dirty="0">
-                <a:solidFill>
-                  <a:schemeClr val="tx1"/>
-                </a:solidFill>
-                <a:effectLst/>
+            <a:pPr algn="ctr"/>
+            <a:r>
+              <a:rPr lang="te-IN" sz="1750" dirty="0">
+                <a:solidFill>
+                  <a:schemeClr val="tx1"/>
+                </a:solidFill>
                 <a:latin typeface="Ramabhadra" panose="02000600000000000000" pitchFamily="2" charset="0"/>
                 <a:cs typeface="Ramabhadra" panose="02000600000000000000" pitchFamily="2" charset="0"/>
               </a:rPr>
               <a:t>స్తుతి గానములతో నేను –</a:t>
             </a:r>
-            <a:endParaRPr lang="en-IN" sz="1750" b="0" i="0" dirty="0">
+            <a:endParaRPr lang="en-IN" sz="1750" dirty="0">
               <a:solidFill>
                 <a:schemeClr val="tx1"/>
               </a:solidFill>
-              <a:effectLst/>
               <a:latin typeface="Ramabhadra" panose="02000600000000000000" pitchFamily="2" charset="0"/>
               <a:cs typeface="Ramabhadra" panose="02000600000000000000" pitchFamily="2" charset="0"/>
             </a:endParaRPr>
           </a:p>
           <a:p>
-            <a:pPr marL="0" marR="0" indent="0" algn="ctr" rtl="0" eaLnBrk="1" fontAlgn="auto" latinLnBrk="0" hangingPunct="1">
-              <a:spcBef>
-                <a:spcPts val="0"/>
-              </a:spcBef>
-              <a:spcAft>
-                <a:spcPts val="0"/>
-              </a:spcAft>
-            </a:pPr>
-            <a:r>
-              <a:rPr lang="te-IN" sz="1750" b="0" i="0" dirty="0">
-                <a:solidFill>
-                  <a:schemeClr val="tx1"/>
-                </a:solidFill>
-                <a:effectLst/>
+            <a:pPr algn="ctr"/>
+            <a:r>
+              <a:rPr lang="te-IN" sz="1750" dirty="0">
+                <a:solidFill>
+                  <a:schemeClr val="tx1"/>
+                </a:solidFill>
                 <a:latin typeface="Ramabhadra" panose="02000600000000000000" pitchFamily="2" charset="0"/>
                 <a:cs typeface="Ramabhadra" panose="02000600000000000000" pitchFamily="2" charset="0"/>
               </a:rPr>
@@ -3631,71 +3618,52 @@
             </a:r>
           </a:p>
           <a:p>
-            <a:pPr marL="0" marR="0" indent="0" algn="ctr" rtl="0" eaLnBrk="1" fontAlgn="auto" latinLnBrk="0" hangingPunct="1">
-              <a:spcBef>
-                <a:spcPts val="0"/>
-              </a:spcBef>
-              <a:spcAft>
-                <a:spcPts val="0"/>
-              </a:spcAft>
-            </a:pPr>
-            <a:r>
-              <a:rPr lang="te-IN" sz="1750" b="0" i="0" dirty="0">
-                <a:solidFill>
-                  <a:schemeClr val="tx1"/>
-                </a:solidFill>
-                <a:effectLst/>
+            <a:pPr algn="ctr"/>
+            <a:r>
+              <a:rPr lang="te-IN" sz="1750" dirty="0">
+                <a:solidFill>
+                  <a:schemeClr val="tx1"/>
+                </a:solidFill>
                 <a:latin typeface="Ramabhadra" panose="02000600000000000000" pitchFamily="2" charset="0"/>
                 <a:cs typeface="Ramabhadra" panose="02000600000000000000" pitchFamily="2" charset="0"/>
               </a:rPr>
               <a:t>నీ జీవితమంతా ప్రభు కొరకై</a:t>
             </a:r>
             <a:r>
-              <a:rPr lang="en-IN" sz="1750" b="0" i="0" dirty="0">
-                <a:solidFill>
-                  <a:schemeClr val="tx1"/>
-                </a:solidFill>
-                <a:effectLst/>
+              <a:rPr lang="en-IN" sz="1750" dirty="0">
+                <a:solidFill>
+                  <a:schemeClr val="tx1"/>
+                </a:solidFill>
                 <a:latin typeface="Ramabhadra" panose="02000600000000000000" pitchFamily="2" charset="0"/>
                 <a:cs typeface="Ramabhadra" panose="02000600000000000000" pitchFamily="2" charset="0"/>
               </a:rPr>
               <a:t> </a:t>
             </a:r>
             <a:r>
-              <a:rPr lang="te-IN" sz="1750" b="0" i="0" dirty="0">
-                <a:solidFill>
-                  <a:schemeClr val="tx1"/>
-                </a:solidFill>
-                <a:effectLst/>
+              <a:rPr lang="te-IN" sz="1750" dirty="0">
+                <a:solidFill>
+                  <a:schemeClr val="tx1"/>
+                </a:solidFill>
                 <a:latin typeface="Ramabhadra" panose="02000600000000000000" pitchFamily="2" charset="0"/>
                 <a:cs typeface="Ramabhadra" panose="02000600000000000000" pitchFamily="2" charset="0"/>
               </a:rPr>
               <a:t>-</a:t>
             </a:r>
-            <a:endParaRPr lang="en-IN" sz="1750" b="0" i="0" dirty="0">
+            <a:endParaRPr lang="en-IN" sz="1750" dirty="0">
               <a:solidFill>
                 <a:schemeClr val="tx1"/>
               </a:solidFill>
-              <a:effectLst/>
               <a:latin typeface="Ramabhadra" panose="02000600000000000000" pitchFamily="2" charset="0"/>
               <a:cs typeface="Ramabhadra" panose="02000600000000000000" pitchFamily="2" charset="0"/>
             </a:endParaRPr>
           </a:p>
           <a:p>
-            <a:pPr marL="0" marR="0" indent="0" algn="ctr" rtl="0" eaLnBrk="1" fontAlgn="auto" latinLnBrk="0" hangingPunct="1">
-              <a:spcBef>
-                <a:spcPts val="0"/>
-              </a:spcBef>
-              <a:spcAft>
-                <a:spcPts val="0"/>
-              </a:spcAft>
-            </a:pPr>
-            <a:r>
-              <a:rPr lang="te-IN" sz="1750" b="0" i="0" dirty="0">
-                <a:solidFill>
-                  <a:schemeClr val="tx1"/>
-                </a:solidFill>
-                <a:effectLst/>
+            <a:pPr algn="ctr"/>
+            <a:r>
+              <a:rPr lang="te-IN" sz="1750" dirty="0">
+                <a:solidFill>
+                  <a:schemeClr val="tx1"/>
+                </a:solidFill>
                 <a:latin typeface="Ramabhadra" panose="02000600000000000000" pitchFamily="2" charset="0"/>
                 <a:cs typeface="Ramabhadra" panose="02000600000000000000" pitchFamily="2" charset="0"/>
               </a:rPr>
@@ -3703,20 +3671,12 @@
             </a:r>
           </a:p>
           <a:p>
-            <a:pPr marL="0" marR="0" indent="0" algn="ctr" rtl="0" eaLnBrk="1" fontAlgn="auto" latinLnBrk="0" hangingPunct="1">
-              <a:spcBef>
-                <a:spcPts val="0"/>
-              </a:spcBef>
-              <a:spcAft>
-                <a:spcPts val="0"/>
-              </a:spcAft>
-            </a:pPr>
-            <a:r>
-              <a:rPr lang="te-IN" sz="1750" b="0" i="0" dirty="0">
-                <a:solidFill>
-                  <a:schemeClr val="tx1"/>
-                </a:solidFill>
-                <a:effectLst/>
+            <a:pPr algn="ctr"/>
+            <a:r>
+              <a:rPr lang="te-IN" sz="1750" dirty="0">
+                <a:solidFill>
+                  <a:schemeClr val="tx1"/>
+                </a:solidFill>
                 <a:latin typeface="Ramabhadra" panose="02000600000000000000" pitchFamily="2" charset="0"/>
                 <a:cs typeface="Ramabhadra" panose="02000600000000000000" pitchFamily="2" charset="0"/>
               </a:rPr>
@@ -3724,38 +3684,22 @@
             </a:r>
           </a:p>
           <a:p>
-            <a:pPr marL="0" marR="0" indent="0" algn="ctr" rtl="0" eaLnBrk="1" fontAlgn="auto" latinLnBrk="0" hangingPunct="1">
-              <a:spcBef>
-                <a:spcPts val="0"/>
-              </a:spcBef>
-              <a:spcAft>
-                <a:spcPts val="0"/>
-              </a:spcAft>
-            </a:pPr>
-            <a:endParaRPr lang="te-IN" sz="1750" b="0" i="0" dirty="0">
+            <a:pPr algn="ctr"/>
+            <a:endParaRPr lang="te-IN" sz="1750" dirty="0">
               <a:solidFill>
                 <a:schemeClr val="tx1"/>
               </a:solidFill>
-              <a:effectLst/>
               <a:latin typeface="Ramabhadra" panose="02000600000000000000" pitchFamily="2" charset="0"/>
               <a:cs typeface="Ramabhadra" panose="02000600000000000000" pitchFamily="2" charset="0"/>
             </a:endParaRPr>
           </a:p>
           <a:p>
-            <a:pPr marL="0" marR="0" indent="0" algn="ctr" rtl="0" eaLnBrk="1" fontAlgn="auto" latinLnBrk="0" hangingPunct="1">
-              <a:spcBef>
-                <a:spcPts val="0"/>
-              </a:spcBef>
-              <a:spcAft>
-                <a:spcPts val="0"/>
-              </a:spcAft>
-            </a:pPr>
-            <a:r>
-              <a:rPr lang="te-IN" sz="1750" b="0" i="0" dirty="0">
-                <a:solidFill>
-                  <a:schemeClr val="tx1"/>
-                </a:solidFill>
-                <a:effectLst/>
+            <a:pPr algn="ctr"/>
+            <a:r>
+              <a:rPr lang="te-IN" sz="1750" dirty="0">
+                <a:solidFill>
+                  <a:schemeClr val="tx1"/>
+                </a:solidFill>
                 <a:latin typeface="Ramabhadra" panose="02000600000000000000" pitchFamily="2" charset="0"/>
                 <a:cs typeface="Ramabhadra" panose="02000600000000000000" pitchFamily="2" charset="0"/>
               </a:rPr>
@@ -3763,20 +3707,12 @@
             </a:r>
           </a:p>
           <a:p>
-            <a:pPr marL="0" marR="0" indent="0" algn="ctr" rtl="0" eaLnBrk="1" fontAlgn="auto" latinLnBrk="0" hangingPunct="1">
-              <a:spcBef>
-                <a:spcPts val="0"/>
-              </a:spcBef>
-              <a:spcAft>
-                <a:spcPts val="0"/>
-              </a:spcAft>
-            </a:pPr>
-            <a:r>
-              <a:rPr lang="te-IN" sz="1750" b="0" i="0" dirty="0">
-                <a:solidFill>
-                  <a:schemeClr val="tx1"/>
-                </a:solidFill>
-                <a:effectLst/>
+            <a:pPr algn="ctr"/>
+            <a:r>
+              <a:rPr lang="te-IN" sz="1750" dirty="0">
+                <a:solidFill>
+                  <a:schemeClr val="tx1"/>
+                </a:solidFill>
                 <a:latin typeface="Ramabhadra" panose="02000600000000000000" pitchFamily="2" charset="0"/>
                 <a:cs typeface="Ramabhadra" panose="02000600000000000000" pitchFamily="2" charset="0"/>
               </a:rPr>
@@ -3784,20 +3720,12 @@
             </a:r>
           </a:p>
           <a:p>
-            <a:pPr marL="0" marR="0" indent="0" algn="ctr" rtl="0" eaLnBrk="1" fontAlgn="auto" latinLnBrk="0" hangingPunct="1">
-              <a:spcBef>
-                <a:spcPts val="0"/>
-              </a:spcBef>
-              <a:spcAft>
-                <a:spcPts val="0"/>
-              </a:spcAft>
-            </a:pPr>
-            <a:r>
-              <a:rPr lang="te-IN" sz="1750" b="0" i="0" dirty="0">
-                <a:solidFill>
-                  <a:schemeClr val="tx1"/>
-                </a:solidFill>
-                <a:effectLst/>
+            <a:pPr algn="ctr"/>
+            <a:r>
+              <a:rPr lang="te-IN" sz="1750" dirty="0">
+                <a:solidFill>
+                  <a:schemeClr val="tx1"/>
+                </a:solidFill>
                 <a:latin typeface="Ramabhadra" panose="02000600000000000000" pitchFamily="2" charset="0"/>
                 <a:cs typeface="Ramabhadra" panose="02000600000000000000" pitchFamily="2" charset="0"/>
               </a:rPr>
@@ -3814,40 +3742,30 @@
               <a:t> </a:t>
             </a:r>
             <a:r>
-              <a:rPr lang="te-IN" sz="1750" b="0" i="0" dirty="0">
-                <a:solidFill>
-                  <a:schemeClr val="tx1"/>
-                </a:solidFill>
-                <a:effectLst/>
+              <a:rPr lang="te-IN" sz="1750" dirty="0">
+                <a:solidFill>
+                  <a:schemeClr val="tx1"/>
+                </a:solidFill>
                 <a:latin typeface="Ramabhadra" panose="02000600000000000000" pitchFamily="2" charset="0"/>
                 <a:cs typeface="Ramabhadra" panose="02000600000000000000" pitchFamily="2" charset="0"/>
               </a:rPr>
               <a:t>నిలుపుము</a:t>
             </a:r>
-            <a:endParaRPr lang="en-IN" sz="1750" b="0" i="0" dirty="0">
+            <a:endParaRPr lang="en-IN" sz="1750" dirty="0">
               <a:solidFill>
                 <a:schemeClr val="tx1"/>
               </a:solidFill>
-              <a:effectLst/>
               <a:latin typeface="Ramabhadra" panose="02000600000000000000" pitchFamily="2" charset="0"/>
               <a:cs typeface="Ramabhadra" panose="02000600000000000000" pitchFamily="2" charset="0"/>
             </a:endParaRPr>
           </a:p>
           <a:p>
-            <a:pPr marL="0" marR="0" indent="0" algn="ctr" rtl="0" eaLnBrk="1" fontAlgn="auto" latinLnBrk="0" hangingPunct="1">
-              <a:spcBef>
-                <a:spcPts val="0"/>
-              </a:spcBef>
-              <a:spcAft>
-                <a:spcPts val="0"/>
-              </a:spcAft>
-            </a:pPr>
-            <a:r>
-              <a:rPr lang="te-IN" sz="1750" b="0" i="0" dirty="0">
-                <a:solidFill>
-                  <a:schemeClr val="tx1"/>
-                </a:solidFill>
-                <a:effectLst/>
+            <a:pPr algn="ctr"/>
+            <a:r>
+              <a:rPr lang="te-IN" sz="1750" dirty="0">
+                <a:solidFill>
+                  <a:schemeClr val="tx1"/>
+                </a:solidFill>
                 <a:latin typeface="Ramabhadra" panose="02000600000000000000" pitchFamily="2" charset="0"/>
                 <a:cs typeface="Ramabhadra" panose="02000600000000000000" pitchFamily="2" charset="0"/>
               </a:rPr>
@@ -3855,67 +3773,42 @@
             </a:r>
           </a:p>
           <a:p>
-            <a:pPr marL="0" marR="0" indent="0" algn="ctr" rtl="0" eaLnBrk="1" fontAlgn="auto" latinLnBrk="0" hangingPunct="1">
-              <a:spcBef>
-                <a:spcPts val="0"/>
-              </a:spcBef>
-              <a:spcAft>
-                <a:spcPts val="0"/>
-              </a:spcAft>
-            </a:pPr>
-            <a:endParaRPr lang="te-IN" sz="1750" b="0" i="0" dirty="0">
+            <a:pPr algn="ctr"/>
+            <a:endParaRPr lang="te-IN" sz="1750" dirty="0">
               <a:solidFill>
                 <a:schemeClr val="tx1"/>
               </a:solidFill>
-              <a:effectLst/>
               <a:latin typeface="Ramabhadra" panose="02000600000000000000" pitchFamily="2" charset="0"/>
               <a:cs typeface="Ramabhadra" panose="02000600000000000000" pitchFamily="2" charset="0"/>
             </a:endParaRPr>
           </a:p>
           <a:p>
-            <a:pPr marL="0" marR="0" indent="0" algn="ctr" rtl="0" eaLnBrk="1" fontAlgn="auto" latinLnBrk="0" hangingPunct="1">
-              <a:spcBef>
-                <a:spcPts val="0"/>
-              </a:spcBef>
-              <a:spcAft>
-                <a:spcPts val="0"/>
-              </a:spcAft>
-            </a:pPr>
-            <a:r>
-              <a:rPr lang="te-IN" sz="1750" b="0" i="0" dirty="0">
-                <a:solidFill>
-                  <a:schemeClr val="tx1"/>
-                </a:solidFill>
-                <a:effectLst/>
+            <a:pPr algn="ctr"/>
+            <a:r>
+              <a:rPr lang="te-IN" sz="1750" dirty="0">
+                <a:solidFill>
+                  <a:schemeClr val="tx1"/>
+                </a:solidFill>
                 <a:latin typeface="Ramabhadra" panose="02000600000000000000" pitchFamily="2" charset="0"/>
                 <a:cs typeface="Ramabhadra" panose="02000600000000000000" pitchFamily="2" charset="0"/>
               </a:rPr>
               <a:t>లోకమంత నీరాకకై</a:t>
             </a:r>
-            <a:endParaRPr lang="en-IN" sz="1750" b="0" i="0" dirty="0">
+            <a:endParaRPr lang="en-IN" sz="1750" dirty="0">
               <a:solidFill>
                 <a:schemeClr val="tx1"/>
               </a:solidFill>
-              <a:effectLst/>
               <a:latin typeface="Ramabhadra" panose="02000600000000000000" pitchFamily="2" charset="0"/>
               <a:cs typeface="Ramabhadra" panose="02000600000000000000" pitchFamily="2" charset="0"/>
             </a:endParaRPr>
           </a:p>
           <a:p>
-            <a:pPr marL="0" marR="0" indent="0" algn="ctr" rtl="0" eaLnBrk="1" fontAlgn="auto" latinLnBrk="0" hangingPunct="1">
-              <a:spcBef>
-                <a:spcPts val="0"/>
-              </a:spcBef>
-              <a:spcAft>
-                <a:spcPts val="0"/>
-              </a:spcAft>
-            </a:pPr>
-            <a:r>
-              <a:rPr lang="te-IN" sz="1750" b="0" i="0" dirty="0">
-                <a:solidFill>
-                  <a:schemeClr val="tx1"/>
-                </a:solidFill>
-                <a:effectLst/>
+            <a:pPr algn="ctr"/>
+            <a:r>
+              <a:rPr lang="te-IN" sz="1750" dirty="0">
+                <a:solidFill>
+                  <a:schemeClr val="tx1"/>
+                </a:solidFill>
                 <a:latin typeface="Ramabhadra" panose="02000600000000000000" pitchFamily="2" charset="0"/>
                 <a:cs typeface="Ramabhadra" panose="02000600000000000000" pitchFamily="2" charset="0"/>
               </a:rPr>
@@ -3923,49 +3816,32 @@
             </a:r>
           </a:p>
           <a:p>
-            <a:pPr marL="0" marR="0" indent="0" algn="ctr" rtl="0" eaLnBrk="1" fontAlgn="auto" latinLnBrk="0" hangingPunct="1">
-              <a:spcBef>
-                <a:spcPts val="0"/>
-              </a:spcBef>
-              <a:spcAft>
-                <a:spcPts val="0"/>
-              </a:spcAft>
-            </a:pPr>
-            <a:r>
-              <a:rPr lang="te-IN" sz="1750" b="0" i="0" dirty="0">
-                <a:solidFill>
-                  <a:schemeClr val="tx1"/>
-                </a:solidFill>
-                <a:effectLst/>
+            <a:pPr algn="ctr"/>
+            <a:r>
+              <a:rPr lang="te-IN" sz="1750" dirty="0">
+                <a:solidFill>
+                  <a:schemeClr val="tx1"/>
+                </a:solidFill>
                 <a:latin typeface="Ramabhadra" panose="02000600000000000000" pitchFamily="2" charset="0"/>
                 <a:cs typeface="Ramabhadra" panose="02000600000000000000" pitchFamily="2" charset="0"/>
               </a:rPr>
               <a:t>మేఘ వాహనంబు మీద</a:t>
             </a:r>
-            <a:endParaRPr lang="en-IN" sz="1750" b="0" i="0" dirty="0">
+            <a:endParaRPr lang="en-IN" sz="1750" dirty="0">
               <a:solidFill>
                 <a:schemeClr val="tx1"/>
               </a:solidFill>
-              <a:effectLst/>
               <a:latin typeface="Ramabhadra" panose="02000600000000000000" pitchFamily="2" charset="0"/>
               <a:cs typeface="Ramabhadra" panose="02000600000000000000" pitchFamily="2" charset="0"/>
             </a:endParaRPr>
           </a:p>
           <a:p>
-            <a:pPr marL="0" marR="0" indent="0" algn="ctr" rtl="0" eaLnBrk="1" fontAlgn="auto" latinLnBrk="0" hangingPunct="1">
-              <a:spcBef>
-                <a:spcPts val="0"/>
-              </a:spcBef>
-              <a:spcAft>
-                <a:spcPts val="0"/>
-              </a:spcAft>
-            </a:pPr>
-            <a:r>
-              <a:rPr lang="te-IN" sz="1750" b="0" i="0" dirty="0">
-                <a:solidFill>
-                  <a:schemeClr val="tx1"/>
-                </a:solidFill>
-                <a:effectLst/>
+            <a:pPr algn="ctr"/>
+            <a:r>
+              <a:rPr lang="te-IN" sz="1750" dirty="0">
+                <a:solidFill>
+                  <a:schemeClr val="tx1"/>
+                </a:solidFill>
                 <a:latin typeface="Ramabhadra" panose="02000600000000000000" pitchFamily="2" charset="0"/>
                 <a:cs typeface="Ramabhadra" panose="02000600000000000000" pitchFamily="2" charset="0"/>
               </a:rPr>
@@ -3973,49 +3849,32 @@
             </a:r>
           </a:p>
           <a:p>
-            <a:pPr marL="0" marR="0" indent="0" algn="ctr" rtl="0" eaLnBrk="1" fontAlgn="auto" latinLnBrk="0" hangingPunct="1">
-              <a:spcBef>
-                <a:spcPts val="0"/>
-              </a:spcBef>
-              <a:spcAft>
-                <a:spcPts val="0"/>
-              </a:spcAft>
-            </a:pPr>
-            <a:r>
-              <a:rPr lang="te-IN" sz="1750" b="0" i="0" dirty="0">
-                <a:solidFill>
-                  <a:schemeClr val="tx1"/>
-                </a:solidFill>
-                <a:effectLst/>
+            <a:pPr algn="ctr"/>
+            <a:r>
+              <a:rPr lang="te-IN" sz="1750" dirty="0">
+                <a:solidFill>
+                  <a:schemeClr val="tx1"/>
+                </a:solidFill>
                 <a:latin typeface="Ramabhadra" panose="02000600000000000000" pitchFamily="2" charset="0"/>
                 <a:cs typeface="Ramabhadra" panose="02000600000000000000" pitchFamily="2" charset="0"/>
               </a:rPr>
               <a:t>వేవేగమే రానైయున్న రారాజా-</a:t>
             </a:r>
-            <a:endParaRPr lang="en-IN" sz="1750" b="0" i="0" dirty="0">
+            <a:endParaRPr lang="en-IN" sz="1750" dirty="0">
               <a:solidFill>
                 <a:schemeClr val="tx1"/>
               </a:solidFill>
-              <a:effectLst/>
               <a:latin typeface="Ramabhadra" panose="02000600000000000000" pitchFamily="2" charset="0"/>
               <a:cs typeface="Ramabhadra" panose="02000600000000000000" pitchFamily="2" charset="0"/>
             </a:endParaRPr>
           </a:p>
           <a:p>
-            <a:pPr marL="0" marR="0" indent="0" algn="ctr" rtl="0" eaLnBrk="1" fontAlgn="auto" latinLnBrk="0" hangingPunct="1">
-              <a:spcBef>
-                <a:spcPts val="0"/>
-              </a:spcBef>
-              <a:spcAft>
-                <a:spcPts val="0"/>
-              </a:spcAft>
-            </a:pPr>
-            <a:r>
-              <a:rPr lang="te-IN" sz="1750" b="0" i="0" dirty="0">
-                <a:solidFill>
-                  <a:schemeClr val="tx1"/>
-                </a:solidFill>
-                <a:effectLst/>
+            <a:pPr algn="ctr"/>
+            <a:r>
+              <a:rPr lang="te-IN" sz="1750" dirty="0">
+                <a:solidFill>
+                  <a:schemeClr val="tx1"/>
+                </a:solidFill>
                 <a:latin typeface="Ramabhadra" panose="02000600000000000000" pitchFamily="2" charset="0"/>
                 <a:cs typeface="Ramabhadra" panose="02000600000000000000" pitchFamily="2" charset="0"/>
               </a:rPr>
@@ -4038,7 +3897,7 @@
         </p:nvSpPr>
         <p:spPr>
           <a:xfrm>
-            <a:off x="51132" y="4874508"/>
+            <a:off x="5427201" y="4874508"/>
             <a:ext cx="3377868" cy="4752474"/>
           </a:xfrm>
           <a:prstGeom prst="rect">
@@ -4077,11 +3936,10 @@
           <a:p>
             <a:pPr algn="ctr"/>
             <a:r>
-              <a:rPr lang="te-IN" b="0" i="0" dirty="0">
+              <a:rPr lang="te-IN" dirty="0">
                 <a:solidFill>
                   <a:srgbClr val="000000"/>
                 </a:solidFill>
-                <a:effectLst/>
                 <a:latin typeface="Ramabhadra" panose="02000600000000000000" pitchFamily="2" charset="0"/>
                 <a:cs typeface="Ramabhadra" panose="02000600000000000000" pitchFamily="2" charset="0"/>
               </a:rPr>
@@ -4091,11 +3949,10 @@
           <a:p>
             <a:pPr algn="ctr"/>
             <a:r>
-              <a:rPr lang="te-IN" b="0" i="0" dirty="0">
+              <a:rPr lang="te-IN" dirty="0">
                 <a:solidFill>
                   <a:srgbClr val="000000"/>
                 </a:solidFill>
-                <a:effectLst/>
                 <a:latin typeface="Ramabhadra" panose="02000600000000000000" pitchFamily="2" charset="0"/>
                 <a:cs typeface="Ramabhadra" panose="02000600000000000000" pitchFamily="2" charset="0"/>
               </a:rPr>
@@ -4105,11 +3962,10 @@
           <a:p>
             <a:pPr algn="ctr"/>
             <a:r>
-              <a:rPr lang="te-IN" b="0" i="0" dirty="0">
+              <a:rPr lang="te-IN" dirty="0">
                 <a:solidFill>
                   <a:srgbClr val="000000"/>
                 </a:solidFill>
-                <a:effectLst/>
                 <a:latin typeface="Ramabhadra" panose="02000600000000000000" pitchFamily="2" charset="0"/>
                 <a:cs typeface="Ramabhadra" panose="02000600000000000000" pitchFamily="2" charset="0"/>
               </a:rPr>
@@ -4119,11 +3975,10 @@
           <a:p>
             <a:pPr algn="ctr"/>
             <a:r>
-              <a:rPr lang="te-IN" b="0" i="0" dirty="0">
+              <a:rPr lang="te-IN" dirty="0">
                 <a:solidFill>
                   <a:srgbClr val="000000"/>
                 </a:solidFill>
-                <a:effectLst/>
                 <a:latin typeface="Ramabhadra" panose="02000600000000000000" pitchFamily="2" charset="0"/>
                 <a:cs typeface="Ramabhadra" panose="02000600000000000000" pitchFamily="2" charset="0"/>
               </a:rPr>
@@ -4132,11 +3987,10 @@
           </a:p>
           <a:p>
             <a:pPr algn="ctr"/>
-            <a:endParaRPr lang="te-IN" b="0" i="0" dirty="0">
+            <a:endParaRPr lang="te-IN" dirty="0">
               <a:solidFill>
                 <a:srgbClr val="000000"/>
               </a:solidFill>
-              <a:effectLst/>
               <a:latin typeface="Ramabhadra" panose="02000600000000000000" pitchFamily="2" charset="0"/>
               <a:cs typeface="Ramabhadra" panose="02000600000000000000" pitchFamily="2" charset="0"/>
             </a:endParaRPr>
@@ -4144,21 +3998,19 @@
           <a:p>
             <a:pPr algn="ctr"/>
             <a:r>
-              <a:rPr lang="te-IN" b="0" i="0" dirty="0">
+              <a:rPr lang="te-IN" dirty="0">
                 <a:solidFill>
                   <a:srgbClr val="000000"/>
                 </a:solidFill>
-                <a:effectLst/>
                 <a:latin typeface="Ramabhadra" panose="02000600000000000000" pitchFamily="2" charset="0"/>
                 <a:cs typeface="Ramabhadra" panose="02000600000000000000" pitchFamily="2" charset="0"/>
               </a:rPr>
               <a:t>లోకములో నీ కొరకు</a:t>
             </a:r>
-            <a:endParaRPr lang="en-US" b="0" i="0" dirty="0">
+            <a:endParaRPr lang="en-US" dirty="0">
               <a:solidFill>
                 <a:srgbClr val="000000"/>
               </a:solidFill>
-              <a:effectLst/>
               <a:latin typeface="Ramabhadra" panose="02000600000000000000" pitchFamily="2" charset="0"/>
               <a:cs typeface="Ramabhadra" panose="02000600000000000000" pitchFamily="2" charset="0"/>
             </a:endParaRPr>
@@ -4166,11 +4018,10 @@
           <a:p>
             <a:pPr algn="ctr"/>
             <a:r>
-              <a:rPr lang="te-IN" b="0" i="0" dirty="0">
+              <a:rPr lang="te-IN" dirty="0">
                 <a:solidFill>
                   <a:srgbClr val="000000"/>
                 </a:solidFill>
-                <a:effectLst/>
                 <a:latin typeface="Ramabhadra" panose="02000600000000000000" pitchFamily="2" charset="0"/>
                 <a:cs typeface="Ramabhadra" panose="02000600000000000000" pitchFamily="2" charset="0"/>
               </a:rPr>
@@ -4180,21 +4031,19 @@
           <a:p>
             <a:pPr algn="ctr"/>
             <a:r>
-              <a:rPr lang="te-IN" b="0" i="0" dirty="0">
+              <a:rPr lang="te-IN" dirty="0">
                 <a:solidFill>
                   <a:srgbClr val="000000"/>
                 </a:solidFill>
-                <a:effectLst/>
                 <a:latin typeface="Ramabhadra" panose="02000600000000000000" pitchFamily="2" charset="0"/>
                 <a:cs typeface="Ramabhadra" panose="02000600000000000000" pitchFamily="2" charset="0"/>
               </a:rPr>
               <a:t>రెండవ రాకడవరకు</a:t>
             </a:r>
-            <a:endParaRPr lang="en-US" b="0" i="0" dirty="0">
+            <a:endParaRPr lang="en-US" dirty="0">
               <a:solidFill>
                 <a:srgbClr val="000000"/>
               </a:solidFill>
-              <a:effectLst/>
               <a:latin typeface="Ramabhadra" panose="02000600000000000000" pitchFamily="2" charset="0"/>
               <a:cs typeface="Ramabhadra" panose="02000600000000000000" pitchFamily="2" charset="0"/>
             </a:endParaRPr>
@@ -4202,11 +4051,10 @@
           <a:p>
             <a:pPr algn="ctr"/>
             <a:r>
-              <a:rPr lang="te-IN" b="0" i="0" dirty="0">
+              <a:rPr lang="te-IN" dirty="0">
                 <a:solidFill>
                   <a:srgbClr val="000000"/>
                 </a:solidFill>
-                <a:effectLst/>
                 <a:latin typeface="Ramabhadra" panose="02000600000000000000" pitchFamily="2" charset="0"/>
                 <a:cs typeface="Ramabhadra" panose="02000600000000000000" pitchFamily="2" charset="0"/>
               </a:rPr>
@@ -4215,11 +4063,10 @@
           </a:p>
           <a:p>
             <a:pPr algn="ctr"/>
-            <a:endParaRPr lang="te-IN" b="0" i="0" dirty="0">
+            <a:endParaRPr lang="te-IN" dirty="0">
               <a:solidFill>
                 <a:srgbClr val="000000"/>
               </a:solidFill>
-              <a:effectLst/>
               <a:latin typeface="Ramabhadra" panose="02000600000000000000" pitchFamily="2" charset="0"/>
               <a:cs typeface="Ramabhadra" panose="02000600000000000000" pitchFamily="2" charset="0"/>
             </a:endParaRPr>
@@ -4227,21 +4074,19 @@
           <a:p>
             <a:pPr algn="ctr"/>
             <a:r>
-              <a:rPr lang="te-IN" b="0" i="0" dirty="0">
+              <a:rPr lang="te-IN" dirty="0">
                 <a:solidFill>
                   <a:srgbClr val="000000"/>
                 </a:solidFill>
-                <a:effectLst/>
                 <a:latin typeface="Ramabhadra" panose="02000600000000000000" pitchFamily="2" charset="0"/>
                 <a:cs typeface="Ramabhadra" panose="02000600000000000000" pitchFamily="2" charset="0"/>
               </a:rPr>
               <a:t>నా దినముల పరిమాణం</a:t>
             </a:r>
-            <a:endParaRPr lang="en-US" b="0" i="0" dirty="0">
+            <a:endParaRPr lang="en-US" dirty="0">
               <a:solidFill>
                 <a:srgbClr val="000000"/>
               </a:solidFill>
-              <a:effectLst/>
               <a:latin typeface="Ramabhadra" panose="02000600000000000000" pitchFamily="2" charset="0"/>
               <a:cs typeface="Ramabhadra" panose="02000600000000000000" pitchFamily="2" charset="0"/>
             </a:endParaRPr>
@@ -4249,11 +4094,10 @@
           <a:p>
             <a:pPr algn="ctr"/>
             <a:r>
-              <a:rPr lang="te-IN" b="0" i="0" dirty="0">
+              <a:rPr lang="te-IN" dirty="0">
                 <a:solidFill>
                   <a:srgbClr val="000000"/>
                 </a:solidFill>
-                <a:effectLst/>
                 <a:latin typeface="Ramabhadra" panose="02000600000000000000" pitchFamily="2" charset="0"/>
                 <a:cs typeface="Ramabhadra" panose="02000600000000000000" pitchFamily="2" charset="0"/>
               </a:rPr>
@@ -4263,11 +4107,10 @@
           <a:p>
             <a:pPr algn="ctr"/>
             <a:r>
-              <a:rPr lang="te-IN" b="0" i="0" dirty="0">
+              <a:rPr lang="te-IN" dirty="0">
                 <a:solidFill>
                   <a:srgbClr val="000000"/>
                 </a:solidFill>
-                <a:effectLst/>
                 <a:latin typeface="Ramabhadra" panose="02000600000000000000" pitchFamily="2" charset="0"/>
                 <a:cs typeface="Ramabhadra" panose="02000600000000000000" pitchFamily="2" charset="0"/>
               </a:rPr>
@@ -4277,11 +4120,10 @@
           <a:p>
             <a:pPr algn="ctr"/>
             <a:r>
-              <a:rPr lang="te-IN" b="0" i="0" dirty="0">
+              <a:rPr lang="te-IN" dirty="0">
                 <a:solidFill>
                   <a:srgbClr val="000000"/>
                 </a:solidFill>
-                <a:effectLst/>
                 <a:latin typeface="Ramabhadra" panose="02000600000000000000" pitchFamily="2" charset="0"/>
                 <a:cs typeface="Ramabhadra" panose="02000600000000000000" pitchFamily="2" charset="0"/>
               </a:rPr>
@@ -4304,7 +4146,7 @@
         </p:nvSpPr>
         <p:spPr>
           <a:xfrm>
-            <a:off x="3429000" y="129292"/>
+            <a:off x="8805069" y="129292"/>
             <a:ext cx="3377868" cy="4752474"/>
           </a:xfrm>
           <a:prstGeom prst="rect">
@@ -4343,11 +4185,10 @@
           <a:p>
             <a:pPr algn="ctr"/>
             <a:r>
-              <a:rPr lang="te-IN" sz="1750" b="0" i="0" dirty="0">
-                <a:solidFill>
-                  <a:schemeClr val="tx1"/>
-                </a:solidFill>
-                <a:effectLst/>
+              <a:rPr lang="te-IN" sz="1750" dirty="0">
+                <a:solidFill>
+                  <a:schemeClr val="tx1"/>
+                </a:solidFill>
                 <a:latin typeface="Ramabhadra" panose="02000600000000000000" pitchFamily="2" charset="0"/>
                 <a:cs typeface="Ramabhadra" panose="02000600000000000000" pitchFamily="2" charset="0"/>
               </a:rPr>
@@ -4357,11 +4198,10 @@
           <a:p>
             <a:pPr algn="ctr"/>
             <a:r>
-              <a:rPr lang="te-IN" sz="1750" b="0" i="0" dirty="0">
-                <a:solidFill>
-                  <a:schemeClr val="tx1"/>
-                </a:solidFill>
-                <a:effectLst/>
+              <a:rPr lang="te-IN" sz="1750" dirty="0">
+                <a:solidFill>
+                  <a:schemeClr val="tx1"/>
+                </a:solidFill>
                 <a:latin typeface="Ramabhadra" panose="02000600000000000000" pitchFamily="2" charset="0"/>
                 <a:cs typeface="Ramabhadra" panose="02000600000000000000" pitchFamily="2" charset="0"/>
               </a:rPr>
@@ -4371,11 +4211,10 @@
           <a:p>
             <a:pPr algn="ctr"/>
             <a:r>
-              <a:rPr lang="te-IN" sz="1750" b="0" i="0" dirty="0">
-                <a:solidFill>
-                  <a:schemeClr val="tx1"/>
-                </a:solidFill>
-                <a:effectLst/>
+              <a:rPr lang="te-IN" sz="1750" dirty="0">
+                <a:solidFill>
+                  <a:schemeClr val="tx1"/>
+                </a:solidFill>
                 <a:latin typeface="Ramabhadra" panose="02000600000000000000" pitchFamily="2" charset="0"/>
                 <a:cs typeface="Ramabhadra" panose="02000600000000000000" pitchFamily="2" charset="0"/>
               </a:rPr>
@@ -4384,11 +4223,10 @@
           </a:p>
           <a:p>
             <a:pPr algn="ctr"/>
-            <a:endParaRPr lang="te-IN" sz="1750" b="0" i="0" dirty="0">
+            <a:endParaRPr lang="te-IN" sz="1750" dirty="0">
               <a:solidFill>
                 <a:schemeClr val="tx1"/>
               </a:solidFill>
-              <a:effectLst/>
               <a:latin typeface="Ramabhadra" panose="02000600000000000000" pitchFamily="2" charset="0"/>
               <a:cs typeface="Ramabhadra" panose="02000600000000000000" pitchFamily="2" charset="0"/>
             </a:endParaRPr>
@@ -4396,11 +4234,10 @@
           <a:p>
             <a:pPr algn="ctr"/>
             <a:r>
-              <a:rPr lang="te-IN" sz="1750" b="0" i="0" dirty="0">
-                <a:solidFill>
-                  <a:schemeClr val="tx1"/>
-                </a:solidFill>
-                <a:effectLst/>
+              <a:rPr lang="te-IN" sz="1750" dirty="0">
+                <a:solidFill>
+                  <a:schemeClr val="tx1"/>
+                </a:solidFill>
                 <a:latin typeface="Ramabhadra" panose="02000600000000000000" pitchFamily="2" charset="0"/>
                 <a:cs typeface="Ramabhadra" panose="02000600000000000000" pitchFamily="2" charset="0"/>
               </a:rPr>
@@ -4410,11 +4247,10 @@
           <a:p>
             <a:pPr algn="ctr"/>
             <a:r>
-              <a:rPr lang="te-IN" sz="1750" b="0" i="0" dirty="0">
-                <a:solidFill>
-                  <a:schemeClr val="tx1"/>
-                </a:solidFill>
-                <a:effectLst/>
+              <a:rPr lang="te-IN" sz="1750" dirty="0">
+                <a:solidFill>
+                  <a:schemeClr val="tx1"/>
+                </a:solidFill>
                 <a:latin typeface="Ramabhadra" panose="02000600000000000000" pitchFamily="2" charset="0"/>
                 <a:cs typeface="Ramabhadra" panose="02000600000000000000" pitchFamily="2" charset="0"/>
               </a:rPr>
@@ -4424,11 +4260,10 @@
           <a:p>
             <a:pPr algn="ctr"/>
             <a:r>
-              <a:rPr lang="te-IN" sz="1750" b="0" i="0" dirty="0">
-                <a:solidFill>
-                  <a:schemeClr val="tx1"/>
-                </a:solidFill>
-                <a:effectLst/>
+              <a:rPr lang="te-IN" sz="1750" dirty="0">
+                <a:solidFill>
+                  <a:schemeClr val="tx1"/>
+                </a:solidFill>
                 <a:latin typeface="Ramabhadra" panose="02000600000000000000" pitchFamily="2" charset="0"/>
                 <a:cs typeface="Ramabhadra" panose="02000600000000000000" pitchFamily="2" charset="0"/>
               </a:rPr>
@@ -4438,11 +4273,10 @@
           <a:p>
             <a:pPr algn="ctr"/>
             <a:r>
-              <a:rPr lang="te-IN" sz="1750" b="0" i="0" dirty="0">
-                <a:solidFill>
-                  <a:schemeClr val="tx1"/>
-                </a:solidFill>
-                <a:effectLst/>
+              <a:rPr lang="te-IN" sz="1750" dirty="0">
+                <a:solidFill>
+                  <a:schemeClr val="tx1"/>
+                </a:solidFill>
                 <a:latin typeface="Ramabhadra" panose="02000600000000000000" pitchFamily="2" charset="0"/>
                 <a:cs typeface="Ramabhadra" panose="02000600000000000000" pitchFamily="2" charset="0"/>
               </a:rPr>
@@ -4452,11 +4286,10 @@
           <a:p>
             <a:pPr algn="ctr"/>
             <a:r>
-              <a:rPr lang="te-IN" sz="1750" b="0" i="0" dirty="0">
-                <a:solidFill>
-                  <a:schemeClr val="tx1"/>
-                </a:solidFill>
-                <a:effectLst/>
+              <a:rPr lang="te-IN" sz="1750" dirty="0">
+                <a:solidFill>
+                  <a:schemeClr val="tx1"/>
+                </a:solidFill>
                 <a:latin typeface="Ramabhadra" panose="02000600000000000000" pitchFamily="2" charset="0"/>
                 <a:cs typeface="Ramabhadra" panose="02000600000000000000" pitchFamily="2" charset="0"/>
               </a:rPr>
@@ -4465,11 +4298,10 @@
           </a:p>
           <a:p>
             <a:pPr algn="ctr"/>
-            <a:endParaRPr lang="te-IN" sz="1750" b="0" i="0" dirty="0">
+            <a:endParaRPr lang="te-IN" sz="1750" dirty="0">
               <a:solidFill>
                 <a:schemeClr val="tx1"/>
               </a:solidFill>
-              <a:effectLst/>
               <a:latin typeface="Ramabhadra" panose="02000600000000000000" pitchFamily="2" charset="0"/>
               <a:cs typeface="Ramabhadra" panose="02000600000000000000" pitchFamily="2" charset="0"/>
             </a:endParaRPr>
@@ -4477,11 +4309,10 @@
           <a:p>
             <a:pPr algn="ctr"/>
             <a:r>
-              <a:rPr lang="te-IN" sz="1750" b="0" i="0" dirty="0">
-                <a:solidFill>
-                  <a:schemeClr val="tx1"/>
-                </a:solidFill>
-                <a:effectLst/>
+              <a:rPr lang="te-IN" sz="1750" dirty="0">
+                <a:solidFill>
+                  <a:schemeClr val="tx1"/>
+                </a:solidFill>
                 <a:latin typeface="Ramabhadra" panose="02000600000000000000" pitchFamily="2" charset="0"/>
                 <a:cs typeface="Ramabhadra" panose="02000600000000000000" pitchFamily="2" charset="0"/>
               </a:rPr>
@@ -4491,11 +4322,10 @@
           <a:p>
             <a:pPr algn="ctr"/>
             <a:r>
-              <a:rPr lang="te-IN" sz="1750" b="0" i="0" dirty="0">
-                <a:solidFill>
-                  <a:schemeClr val="tx1"/>
-                </a:solidFill>
-                <a:effectLst/>
+              <a:rPr lang="te-IN" sz="1750" dirty="0">
+                <a:solidFill>
+                  <a:schemeClr val="tx1"/>
+                </a:solidFill>
                 <a:latin typeface="Ramabhadra" panose="02000600000000000000" pitchFamily="2" charset="0"/>
                 <a:cs typeface="Ramabhadra" panose="02000600000000000000" pitchFamily="2" charset="0"/>
               </a:rPr>
@@ -4505,11 +4335,10 @@
           <a:p>
             <a:pPr algn="ctr"/>
             <a:r>
-              <a:rPr lang="te-IN" sz="1750" b="0" i="0" dirty="0">
-                <a:solidFill>
-                  <a:schemeClr val="tx1"/>
-                </a:solidFill>
-                <a:effectLst/>
+              <a:rPr lang="te-IN" sz="1750" dirty="0">
+                <a:solidFill>
+                  <a:schemeClr val="tx1"/>
+                </a:solidFill>
                 <a:latin typeface="Ramabhadra" panose="02000600000000000000" pitchFamily="2" charset="0"/>
                 <a:cs typeface="Ramabhadra" panose="02000600000000000000" pitchFamily="2" charset="0"/>
               </a:rPr>
@@ -4519,11 +4348,10 @@
           <a:p>
             <a:pPr algn="ctr"/>
             <a:r>
-              <a:rPr lang="te-IN" sz="1750" b="0" i="0" dirty="0">
-                <a:solidFill>
-                  <a:schemeClr val="tx1"/>
-                </a:solidFill>
-                <a:effectLst/>
+              <a:rPr lang="te-IN" sz="1750" dirty="0">
+                <a:solidFill>
+                  <a:schemeClr val="tx1"/>
+                </a:solidFill>
                 <a:latin typeface="Ramabhadra" panose="02000600000000000000" pitchFamily="2" charset="0"/>
                 <a:cs typeface="Ramabhadra" panose="02000600000000000000" pitchFamily="2" charset="0"/>
               </a:rPr>
@@ -4533,11 +4361,10 @@
           <a:p>
             <a:pPr algn="ctr"/>
             <a:r>
-              <a:rPr lang="te-IN" sz="1750" b="0" i="0" dirty="0">
-                <a:solidFill>
-                  <a:schemeClr val="tx1"/>
-                </a:solidFill>
-                <a:effectLst/>
+              <a:rPr lang="te-IN" sz="1750" dirty="0">
+                <a:solidFill>
+                  <a:schemeClr val="tx1"/>
+                </a:solidFill>
                 <a:latin typeface="Ramabhadra" panose="02000600000000000000" pitchFamily="2" charset="0"/>
                 <a:cs typeface="Ramabhadra" panose="02000600000000000000" pitchFamily="2" charset="0"/>
               </a:rPr>
@@ -4560,7 +4387,7 @@
         </p:nvSpPr>
         <p:spPr>
           <a:xfrm>
-            <a:off x="3429000" y="4878137"/>
+            <a:off x="8805069" y="4878137"/>
             <a:ext cx="3377868" cy="4752474"/>
           </a:xfrm>
           <a:prstGeom prst="rect">
@@ -4597,62 +4424,33 @@
           <a:bodyPr rtlCol="0" anchor="ctr"/>
           <a:lstStyle/>
           <a:p>
-            <a:pPr marL="0" marR="0" lvl="0" indent="0" algn="ctr" defTabSz="439781" rtl="0" eaLnBrk="1" fontAlgn="auto" latinLnBrk="0" hangingPunct="1">
-              <a:spcBef>
-                <a:spcPts val="0"/>
-              </a:spcBef>
-              <a:spcAft>
-                <a:spcPts val="0"/>
-              </a:spcAft>
-              <a:buClrTx/>
-              <a:buSzTx/>
-              <a:buFontTx/>
-              <a:buNone/>
-              <a:tabLst/>
+            <a:pPr algn="ctr" defTabSz="439781">
               <a:defRPr/>
             </a:pPr>
             <a:r>
-              <a:rPr kumimoji="0" lang="te-IN" sz="1600" i="0" u="none" strike="noStrike" kern="1200" cap="none" spc="0" normalizeH="0" baseline="0" noProof="0" dirty="0">
-                <a:ln>
-                  <a:noFill/>
-                </a:ln>
-                <a:solidFill>
-                  <a:schemeClr val="tx1"/>
-                </a:solidFill>
-                <a:effectLst/>
-                <a:uLnTx/>
-                <a:uFillTx/>
+              <a:rPr lang="te-IN" sz="1600" dirty="0">
+                <a:solidFill>
+                  <a:schemeClr val="tx1"/>
+                </a:solidFill>
                 <a:latin typeface="Ramabhadra" panose="02000600000000000000" pitchFamily="2" charset="0"/>
                 <a:cs typeface="Ramabhadra" panose="02000600000000000000" pitchFamily="2" charset="0"/>
               </a:rPr>
               <a:t>స్తోత్రబలి స్తోత్రబలి – మంచిదేవా నీకేనయ్యా</a:t>
             </a:r>
             <a:br>
-              <a:rPr kumimoji="0" lang="te-IN" sz="1600" i="0" u="none" strike="noStrike" kern="1200" cap="none" spc="0" normalizeH="0" baseline="0" noProof="0" dirty="0">
-                <a:ln>
-                  <a:noFill/>
-                </a:ln>
-                <a:solidFill>
-                  <a:schemeClr val="tx1"/>
-                </a:solidFill>
-                <a:effectLst/>
-                <a:uLnTx/>
-                <a:uFillTx/>
+              <a:rPr lang="te-IN" sz="1600" dirty="0">
+                <a:solidFill>
+                  <a:schemeClr val="tx1"/>
+                </a:solidFill>
                 <a:latin typeface="Ramabhadra" panose="02000600000000000000" pitchFamily="2" charset="0"/>
                 <a:cs typeface="Ramabhadra" panose="02000600000000000000" pitchFamily="2" charset="0"/>
               </a:rPr>
             </a:br>
             <a:r>
-              <a:rPr kumimoji="0" lang="te-IN" sz="1600" i="0" u="none" strike="noStrike" kern="1200" cap="none" spc="0" normalizeH="0" baseline="0" noProof="0" dirty="0">
-                <a:ln>
-                  <a:noFill/>
-                </a:ln>
-                <a:solidFill>
-                  <a:schemeClr val="tx1"/>
-                </a:solidFill>
-                <a:effectLst/>
-                <a:uLnTx/>
-                <a:uFillTx/>
+              <a:rPr lang="te-IN" sz="1600" dirty="0">
+                <a:solidFill>
+                  <a:schemeClr val="tx1"/>
+                </a:solidFill>
                 <a:latin typeface="Ramabhadra" panose="02000600000000000000" pitchFamily="2" charset="0"/>
                 <a:cs typeface="Ramabhadra" panose="02000600000000000000" pitchFamily="2" charset="0"/>
               </a:rPr>
@@ -4660,122 +4458,64 @@
             </a:r>
           </a:p>
           <a:p>
-            <a:pPr marL="0" marR="0" lvl="0" indent="0" algn="ctr" defTabSz="439781" rtl="0" eaLnBrk="1" fontAlgn="auto" latinLnBrk="0" hangingPunct="1">
-              <a:spcBef>
-                <a:spcPts val="0"/>
-              </a:spcBef>
-              <a:spcAft>
-                <a:spcPts val="0"/>
-              </a:spcAft>
-              <a:buClrTx/>
-              <a:buSzTx/>
-              <a:buFontTx/>
-              <a:buNone/>
-              <a:tabLst/>
+            <a:pPr algn="ctr" defTabSz="439781">
               <a:defRPr/>
             </a:pPr>
-            <a:endParaRPr kumimoji="0" lang="te-IN" sz="1600" i="0" u="none" strike="noStrike" kern="1200" cap="none" spc="0" normalizeH="0" baseline="0" noProof="0" dirty="0">
-              <a:ln>
-                <a:noFill/>
-              </a:ln>
+            <a:endParaRPr lang="te-IN" sz="1600" dirty="0">
               <a:solidFill>
                 <a:schemeClr val="tx1"/>
               </a:solidFill>
-              <a:effectLst/>
-              <a:uLnTx/>
-              <a:uFillTx/>
               <a:latin typeface="Ramabhadra" panose="02000600000000000000" pitchFamily="2" charset="0"/>
               <a:cs typeface="Ramabhadra" panose="02000600000000000000" pitchFamily="2" charset="0"/>
             </a:endParaRPr>
           </a:p>
           <a:p>
-            <a:pPr marL="0" marR="0" lvl="0" indent="0" algn="ctr" defTabSz="439781" rtl="0" eaLnBrk="1" fontAlgn="auto" latinLnBrk="0" hangingPunct="1">
-              <a:spcBef>
-                <a:spcPts val="0"/>
-              </a:spcBef>
-              <a:spcAft>
-                <a:spcPts val="0"/>
-              </a:spcAft>
-              <a:buClrTx/>
-              <a:buSzTx/>
-              <a:buFontTx/>
-              <a:buNone/>
-              <a:tabLst/>
+            <a:pPr algn="ctr" defTabSz="439781">
               <a:defRPr/>
             </a:pPr>
             <a:r>
-              <a:rPr kumimoji="0" lang="te-IN" sz="1600" i="0" u="none" strike="noStrike" kern="1200" cap="none" spc="0" normalizeH="0" baseline="0" noProof="0" dirty="0">
-                <a:ln>
-                  <a:noFill/>
-                </a:ln>
-                <a:solidFill>
-                  <a:schemeClr val="tx1"/>
-                </a:solidFill>
-                <a:effectLst/>
-                <a:uLnTx/>
-                <a:uFillTx/>
+              <a:rPr lang="te-IN" sz="1600" dirty="0">
+                <a:solidFill>
+                  <a:schemeClr val="tx1"/>
+                </a:solidFill>
                 <a:latin typeface="Ramabhadra" panose="02000600000000000000" pitchFamily="2" charset="0"/>
                 <a:cs typeface="Ramabhadra" panose="02000600000000000000" pitchFamily="2" charset="0"/>
               </a:rPr>
               <a:t>నిన్నటి బాధలంతా నేటికి మాయమయ్యే (2)</a:t>
             </a:r>
             <a:br>
-              <a:rPr kumimoji="0" lang="te-IN" sz="1600" i="0" u="none" strike="noStrike" kern="1200" cap="none" spc="0" normalizeH="0" baseline="0" noProof="0" dirty="0">
-                <a:ln>
-                  <a:noFill/>
-                </a:ln>
-                <a:solidFill>
-                  <a:schemeClr val="tx1"/>
-                </a:solidFill>
-                <a:effectLst/>
-                <a:uLnTx/>
-                <a:uFillTx/>
+              <a:rPr lang="te-IN" sz="1600" dirty="0">
+                <a:solidFill>
+                  <a:schemeClr val="tx1"/>
+                </a:solidFill>
                 <a:latin typeface="Ramabhadra" panose="02000600000000000000" pitchFamily="2" charset="0"/>
                 <a:cs typeface="Ramabhadra" panose="02000600000000000000" pitchFamily="2" charset="0"/>
               </a:rPr>
             </a:br>
             <a:r>
-              <a:rPr kumimoji="0" lang="te-IN" sz="1600" i="0" u="none" strike="noStrike" kern="1200" cap="none" spc="0" normalizeH="0" baseline="0" noProof="0" dirty="0">
-                <a:ln>
-                  <a:noFill/>
-                </a:ln>
-                <a:solidFill>
-                  <a:schemeClr val="tx1"/>
-                </a:solidFill>
-                <a:effectLst/>
-                <a:uLnTx/>
-                <a:uFillTx/>
+              <a:rPr lang="te-IN" sz="1600" dirty="0">
+                <a:solidFill>
+                  <a:schemeClr val="tx1"/>
+                </a:solidFill>
                 <a:latin typeface="Ramabhadra" panose="02000600000000000000" pitchFamily="2" charset="0"/>
                 <a:cs typeface="Ramabhadra" panose="02000600000000000000" pitchFamily="2" charset="0"/>
               </a:rPr>
               <a:t>నెమ్మది ఉదయించె అది శాశ్వతమైనదయ్యా (2)</a:t>
             </a:r>
             <a:br>
-              <a:rPr kumimoji="0" lang="te-IN" sz="1600" i="0" u="none" strike="noStrike" kern="1200" cap="none" spc="0" normalizeH="0" baseline="0" noProof="0" dirty="0">
-                <a:ln>
-                  <a:noFill/>
-                </a:ln>
-                <a:solidFill>
-                  <a:schemeClr val="tx1"/>
-                </a:solidFill>
-                <a:effectLst/>
-                <a:uLnTx/>
-                <a:uFillTx/>
+              <a:rPr lang="te-IN" sz="1600" dirty="0">
+                <a:solidFill>
+                  <a:schemeClr val="tx1"/>
+                </a:solidFill>
                 <a:latin typeface="Ramabhadra" panose="02000600000000000000" pitchFamily="2" charset="0"/>
                 <a:cs typeface="Ramabhadra" panose="02000600000000000000" pitchFamily="2" charset="0"/>
               </a:rPr>
             </a:br>
             <a:r>
-              <a:rPr kumimoji="0" lang="te-IN" sz="1600" i="0" u="none" strike="noStrike" kern="1200" cap="none" spc="0" normalizeH="0" baseline="0" noProof="0" dirty="0">
-                <a:ln>
-                  <a:noFill/>
-                </a:ln>
-                <a:solidFill>
-                  <a:schemeClr val="tx1"/>
-                </a:solidFill>
-                <a:effectLst/>
-                <a:uLnTx/>
-                <a:uFillTx/>
+              <a:rPr lang="te-IN" sz="1600" dirty="0">
+                <a:solidFill>
+                  <a:schemeClr val="tx1"/>
+                </a:solidFill>
                 <a:latin typeface="Ramabhadra" panose="02000600000000000000" pitchFamily="2" charset="0"/>
                 <a:cs typeface="Ramabhadra" panose="02000600000000000000" pitchFamily="2" charset="0"/>
               </a:rPr>
@@ -4783,31 +4523,14 @@
             </a:r>
           </a:p>
           <a:p>
-            <a:pPr marL="0" marR="0" lvl="0" indent="0" algn="ctr" defTabSz="439781" rtl="0" eaLnBrk="1" fontAlgn="auto" latinLnBrk="0" hangingPunct="1">
-              <a:spcBef>
-                <a:spcPts val="0"/>
-              </a:spcBef>
-              <a:spcAft>
-                <a:spcPts val="0"/>
-              </a:spcAft>
-              <a:buClrTx/>
-              <a:buSzTx/>
-              <a:buFontTx/>
-              <a:buNone/>
-              <a:tabLst/>
+            <a:pPr algn="ctr" defTabSz="439781">
               <a:defRPr/>
             </a:pPr>
             <a:r>
-              <a:rPr kumimoji="0" lang="te-IN" sz="1600" i="0" u="none" strike="noStrike" kern="1200" cap="none" spc="0" normalizeH="0" baseline="0" noProof="0" dirty="0">
-                <a:ln>
-                  <a:noFill/>
-                </a:ln>
-                <a:solidFill>
-                  <a:schemeClr val="tx1"/>
-                </a:solidFill>
-                <a:effectLst/>
-                <a:uLnTx/>
-                <a:uFillTx/>
+              <a:rPr lang="te-IN" sz="1600" dirty="0">
+                <a:solidFill>
+                  <a:schemeClr val="tx1"/>
+                </a:solidFill>
                 <a:latin typeface="Ramabhadra" panose="02000600000000000000" pitchFamily="2" charset="0"/>
                 <a:cs typeface="Ramabhadra" panose="02000600000000000000" pitchFamily="2" charset="0"/>
               </a:rPr>
@@ -4815,93 +4538,52 @@
             </a:r>
           </a:p>
           <a:p>
-            <a:pPr marL="0" marR="0" lvl="0" indent="0" algn="ctr" defTabSz="439781" rtl="0" eaLnBrk="1" fontAlgn="auto" latinLnBrk="0" hangingPunct="1">
-              <a:spcBef>
-                <a:spcPts val="0"/>
-              </a:spcBef>
-              <a:spcAft>
-                <a:spcPts val="0"/>
-              </a:spcAft>
-              <a:buClrTx/>
-              <a:buSzTx/>
-              <a:buFontTx/>
-              <a:buNone/>
-              <a:tabLst/>
+            <a:pPr algn="ctr" defTabSz="439781">
               <a:defRPr/>
             </a:pPr>
             <a:r>
-              <a:rPr kumimoji="0" lang="te-IN" sz="1600" i="0" u="none" strike="noStrike" kern="1200" cap="none" spc="0" normalizeH="0" baseline="0" noProof="0" dirty="0">
-                <a:ln>
-                  <a:noFill/>
-                </a:ln>
-                <a:solidFill>
-                  <a:schemeClr val="tx1"/>
-                </a:solidFill>
-                <a:effectLst/>
-                <a:uLnTx/>
-                <a:uFillTx/>
+              <a:rPr lang="te-IN" sz="1600" dirty="0">
+                <a:solidFill>
+                  <a:schemeClr val="tx1"/>
+                </a:solidFill>
                 <a:latin typeface="Ramabhadra" panose="02000600000000000000" pitchFamily="2" charset="0"/>
                 <a:cs typeface="Ramabhadra" panose="02000600000000000000" pitchFamily="2" charset="0"/>
               </a:rPr>
               <a:t>రేయంతా కాచితివి మరు దినమిచ్చితివి (2)</a:t>
             </a:r>
             <a:br>
-              <a:rPr kumimoji="0" lang="te-IN" sz="1600" i="0" u="none" strike="noStrike" kern="1200" cap="none" spc="0" normalizeH="0" baseline="0" noProof="0" dirty="0">
-                <a:ln>
-                  <a:noFill/>
-                </a:ln>
-                <a:solidFill>
-                  <a:schemeClr val="tx1"/>
-                </a:solidFill>
-                <a:effectLst/>
-                <a:uLnTx/>
-                <a:uFillTx/>
+              <a:rPr lang="te-IN" sz="1600" dirty="0">
+                <a:solidFill>
+                  <a:schemeClr val="tx1"/>
+                </a:solidFill>
                 <a:latin typeface="Ramabhadra" panose="02000600000000000000" pitchFamily="2" charset="0"/>
                 <a:cs typeface="Ramabhadra" panose="02000600000000000000" pitchFamily="2" charset="0"/>
               </a:rPr>
             </a:br>
             <a:r>
-              <a:rPr kumimoji="0" lang="te-IN" sz="1600" i="0" u="none" strike="noStrike" kern="1200" cap="none" spc="0" normalizeH="0" baseline="0" noProof="0" dirty="0">
-                <a:ln>
-                  <a:noFill/>
-                </a:ln>
-                <a:solidFill>
-                  <a:schemeClr val="tx1"/>
-                </a:solidFill>
-                <a:effectLst/>
-                <a:uLnTx/>
-                <a:uFillTx/>
+              <a:rPr lang="te-IN" sz="1600" dirty="0">
+                <a:solidFill>
+                  <a:schemeClr val="tx1"/>
+                </a:solidFill>
                 <a:latin typeface="Ramabhadra" panose="02000600000000000000" pitchFamily="2" charset="0"/>
                 <a:cs typeface="Ramabhadra" panose="02000600000000000000" pitchFamily="2" charset="0"/>
               </a:rPr>
               <a:t>మరువని నా స్నేహమా నీతో కలసి సంతోషింతును (2)</a:t>
             </a:r>
             <a:br>
-              <a:rPr kumimoji="0" lang="te-IN" sz="1600" i="0" u="none" strike="noStrike" kern="1200" cap="none" spc="0" normalizeH="0" baseline="0" noProof="0" dirty="0">
-                <a:ln>
-                  <a:noFill/>
-                </a:ln>
-                <a:solidFill>
-                  <a:schemeClr val="tx1"/>
-                </a:solidFill>
-                <a:effectLst/>
-                <a:uLnTx/>
-                <a:uFillTx/>
+              <a:rPr lang="te-IN" sz="1600" dirty="0">
+                <a:solidFill>
+                  <a:schemeClr val="tx1"/>
+                </a:solidFill>
                 <a:latin typeface="Ramabhadra" panose="02000600000000000000" pitchFamily="2" charset="0"/>
                 <a:cs typeface="Ramabhadra" panose="02000600000000000000" pitchFamily="2" charset="0"/>
               </a:rPr>
             </a:br>
             <a:r>
-              <a:rPr kumimoji="0" lang="te-IN" sz="1600" i="0" u="none" strike="noStrike" kern="1200" cap="none" spc="0" normalizeH="0" baseline="0" noProof="0" dirty="0">
-                <a:ln>
-                  <a:noFill/>
-                </a:ln>
-                <a:solidFill>
-                  <a:schemeClr val="tx1"/>
-                </a:solidFill>
-                <a:effectLst/>
-                <a:uLnTx/>
-                <a:uFillTx/>
+              <a:rPr lang="te-IN" sz="1600" dirty="0">
+                <a:solidFill>
+                  <a:schemeClr val="tx1"/>
+                </a:solidFill>
                 <a:latin typeface="Ramabhadra" panose="02000600000000000000" pitchFamily="2" charset="0"/>
                 <a:cs typeface="Ramabhadra" panose="02000600000000000000" pitchFamily="2" charset="0"/>
               </a:rPr>
@@ -4909,31 +4591,14 @@
             </a:r>
           </a:p>
           <a:p>
-            <a:pPr marL="0" marR="0" lvl="0" indent="0" algn="ctr" defTabSz="439781" rtl="0" eaLnBrk="1" fontAlgn="auto" latinLnBrk="0" hangingPunct="1">
-              <a:spcBef>
-                <a:spcPts val="0"/>
-              </a:spcBef>
-              <a:spcAft>
-                <a:spcPts val="0"/>
-              </a:spcAft>
-              <a:buClrTx/>
-              <a:buSzTx/>
-              <a:buFontTx/>
-              <a:buNone/>
-              <a:tabLst/>
+            <a:pPr algn="ctr" defTabSz="439781">
               <a:defRPr/>
             </a:pPr>
             <a:r>
-              <a:rPr kumimoji="0" lang="te-IN" sz="1600" i="0" u="none" strike="noStrike" kern="1200" cap="none" spc="0" normalizeH="0" baseline="0" noProof="0" dirty="0">
-                <a:ln>
-                  <a:noFill/>
-                </a:ln>
-                <a:solidFill>
-                  <a:schemeClr val="tx1"/>
-                </a:solidFill>
-                <a:effectLst/>
-                <a:uLnTx/>
-                <a:uFillTx/>
+              <a:rPr lang="te-IN" sz="1600" dirty="0">
+                <a:solidFill>
+                  <a:schemeClr val="tx1"/>
+                </a:solidFill>
                 <a:latin typeface="Ramabhadra" panose="02000600000000000000" pitchFamily="2" charset="0"/>
                 <a:cs typeface="Ramabhadra" panose="02000600000000000000" pitchFamily="2" charset="0"/>
               </a:rPr>
@@ -4941,93 +4606,52 @@
             </a:r>
           </a:p>
           <a:p>
-            <a:pPr marL="0" marR="0" lvl="0" indent="0" algn="ctr" defTabSz="439781" rtl="0" eaLnBrk="1" fontAlgn="auto" latinLnBrk="0" hangingPunct="1">
-              <a:spcBef>
-                <a:spcPts val="0"/>
-              </a:spcBef>
-              <a:spcAft>
-                <a:spcPts val="0"/>
-              </a:spcAft>
-              <a:buClrTx/>
-              <a:buSzTx/>
-              <a:buFontTx/>
-              <a:buNone/>
-              <a:tabLst/>
+            <a:pPr algn="ctr" defTabSz="439781">
               <a:defRPr/>
             </a:pPr>
             <a:r>
-              <a:rPr kumimoji="0" lang="te-IN" sz="1600" i="0" u="none" strike="noStrike" kern="1200" cap="none" spc="0" normalizeH="0" baseline="0" noProof="0" dirty="0">
-                <a:ln>
-                  <a:noFill/>
-                </a:ln>
-                <a:solidFill>
-                  <a:schemeClr val="tx1"/>
-                </a:solidFill>
-                <a:effectLst/>
-                <a:uLnTx/>
-                <a:uFillTx/>
+              <a:rPr lang="te-IN" sz="1600" dirty="0">
+                <a:solidFill>
+                  <a:schemeClr val="tx1"/>
+                </a:solidFill>
                 <a:latin typeface="Ramabhadra" panose="02000600000000000000" pitchFamily="2" charset="0"/>
                 <a:cs typeface="Ramabhadra" panose="02000600000000000000" pitchFamily="2" charset="0"/>
               </a:rPr>
               <a:t>నీ సేవ మార్గంలో ఉత్సాహం నొసగితివి (2)</a:t>
             </a:r>
             <a:br>
-              <a:rPr kumimoji="0" lang="te-IN" sz="1600" i="0" u="none" strike="noStrike" kern="1200" cap="none" spc="0" normalizeH="0" baseline="0" noProof="0" dirty="0">
-                <a:ln>
-                  <a:noFill/>
-                </a:ln>
-                <a:solidFill>
-                  <a:schemeClr val="tx1"/>
-                </a:solidFill>
-                <a:effectLst/>
-                <a:uLnTx/>
-                <a:uFillTx/>
+              <a:rPr lang="te-IN" sz="1600" dirty="0">
+                <a:solidFill>
+                  <a:schemeClr val="tx1"/>
+                </a:solidFill>
                 <a:latin typeface="Ramabhadra" panose="02000600000000000000" pitchFamily="2" charset="0"/>
                 <a:cs typeface="Ramabhadra" panose="02000600000000000000" pitchFamily="2" charset="0"/>
               </a:rPr>
             </a:br>
             <a:r>
-              <a:rPr kumimoji="0" lang="te-IN" sz="1600" i="0" u="none" strike="noStrike" kern="1200" cap="none" spc="0" normalizeH="0" baseline="0" noProof="0" dirty="0">
-                <a:ln>
-                  <a:noFill/>
-                </a:ln>
-                <a:solidFill>
-                  <a:schemeClr val="tx1"/>
-                </a:solidFill>
-                <a:effectLst/>
-                <a:uLnTx/>
-                <a:uFillTx/>
+              <a:rPr lang="te-IN" sz="1600" dirty="0">
+                <a:solidFill>
+                  <a:schemeClr val="tx1"/>
+                </a:solidFill>
                 <a:latin typeface="Ramabhadra" panose="02000600000000000000" pitchFamily="2" charset="0"/>
                 <a:cs typeface="Ramabhadra" panose="02000600000000000000" pitchFamily="2" charset="0"/>
               </a:rPr>
               <a:t>ఉరికురికి పనిచేయ నాకు ఆరోగ్యమిచ్చితివి (2)</a:t>
             </a:r>
             <a:br>
-              <a:rPr kumimoji="0" lang="te-IN" sz="1600" i="0" u="none" strike="noStrike" kern="1200" cap="none" spc="0" normalizeH="0" baseline="0" noProof="0" dirty="0">
-                <a:ln>
-                  <a:noFill/>
-                </a:ln>
-                <a:solidFill>
-                  <a:schemeClr val="tx1"/>
-                </a:solidFill>
-                <a:effectLst/>
-                <a:uLnTx/>
-                <a:uFillTx/>
+              <a:rPr lang="te-IN" sz="1600" dirty="0">
+                <a:solidFill>
+                  <a:schemeClr val="tx1"/>
+                </a:solidFill>
                 <a:latin typeface="Ramabhadra" panose="02000600000000000000" pitchFamily="2" charset="0"/>
                 <a:cs typeface="Ramabhadra" panose="02000600000000000000" pitchFamily="2" charset="0"/>
               </a:rPr>
             </a:br>
             <a:r>
-              <a:rPr kumimoji="0" lang="te-IN" sz="1600" i="0" u="none" strike="noStrike" kern="1200" cap="none" spc="0" normalizeH="0" baseline="0" noProof="0" dirty="0">
-                <a:ln>
-                  <a:noFill/>
-                </a:ln>
-                <a:solidFill>
-                  <a:schemeClr val="tx1"/>
-                </a:solidFill>
-                <a:effectLst/>
-                <a:uLnTx/>
-                <a:uFillTx/>
+              <a:rPr lang="te-IN" sz="1600" dirty="0">
+                <a:solidFill>
+                  <a:schemeClr val="tx1"/>
+                </a:solidFill>
                 <a:latin typeface="Ramabhadra" panose="02000600000000000000" pitchFamily="2" charset="0"/>
                 <a:cs typeface="Ramabhadra" panose="02000600000000000000" pitchFamily="2" charset="0"/>
               </a:rPr>
@@ -5040,6 +4664,1352 @@
     <p:extLst>
       <p:ext uri="{BB962C8B-B14F-4D97-AF65-F5344CB8AC3E}">
         <p14:creationId xmlns:p14="http://schemas.microsoft.com/office/powerpoint/2010/main" val="1511661631"/>
+      </p:ext>
+    </p:extLst>
+  </p:cSld>
+  <p:clrMapOvr>
+    <a:masterClrMapping/>
+  </p:clrMapOvr>
+</p:sld>
+</file>
+
+<file path=ppt/slides/slide2.xml><?xml version="1.0" encoding="utf-8"?>
+<p:sld xmlns:a="http://schemas.openxmlformats.org/drawingml/2006/main" xmlns:r="http://schemas.openxmlformats.org/officeDocument/2006/relationships" xmlns:p="http://schemas.openxmlformats.org/presentationml/2006/main">
+  <p:cSld>
+    <p:spTree>
+      <p:nvGrpSpPr>
+        <p:cNvPr id="1" name=""/>
+        <p:cNvGrpSpPr/>
+        <p:nvPr/>
+      </p:nvGrpSpPr>
+      <p:grpSpPr>
+        <a:xfrm>
+          <a:off x="0" y="0"/>
+          <a:ext cx="0" cy="0"/>
+          <a:chOff x="0" y="0"/>
+          <a:chExt cx="0" cy="0"/>
+        </a:xfrm>
+      </p:grpSpPr>
+      <p:sp>
+        <p:nvSpPr>
+          <p:cNvPr id="2" name="Rectangle 1">
+            <a:extLst>
+              <a:ext uri="{FF2B5EF4-FFF2-40B4-BE49-F238E27FC236}">
+                <a16:creationId xmlns:a16="http://schemas.microsoft.com/office/drawing/2014/main" id="{C2114CF1-1236-46D5-9846-2222D8891EB8}"/>
+              </a:ext>
+            </a:extLst>
+          </p:cNvPr>
+          <p:cNvSpPr/>
+          <p:nvPr/>
+        </p:nvSpPr>
+        <p:spPr>
+          <a:xfrm>
+            <a:off x="160256" y="200526"/>
+            <a:ext cx="4136611" cy="9370194"/>
+          </a:xfrm>
+          <a:prstGeom prst="rect">
+            <a:avLst/>
+          </a:prstGeom>
+          <a:solidFill>
+            <a:schemeClr val="bg1"/>
+          </a:solidFill>
+          <a:ln>
+            <a:solidFill>
+              <a:schemeClr val="bg1">
+                <a:lumMod val="85000"/>
+              </a:schemeClr>
+            </a:solidFill>
+          </a:ln>
+        </p:spPr>
+        <p:style>
+          <a:lnRef idx="2">
+            <a:schemeClr val="accent1">
+              <a:shade val="50000"/>
+            </a:schemeClr>
+          </a:lnRef>
+          <a:fillRef idx="1">
+            <a:schemeClr val="accent1"/>
+          </a:fillRef>
+          <a:effectRef idx="0">
+            <a:schemeClr val="accent1"/>
+          </a:effectRef>
+          <a:fontRef idx="minor">
+            <a:schemeClr val="lt1"/>
+          </a:fontRef>
+        </p:style>
+        <p:txBody>
+          <a:bodyPr rtlCol="0" anchor="ctr"/>
+          <a:lstStyle/>
+          <a:p>
+            <a:pPr algn="ctr"/>
+            <a:r>
+              <a:rPr lang="te-IN" sz="3100" dirty="0">
+                <a:solidFill>
+                  <a:schemeClr val="tx1"/>
+                </a:solidFill>
+                <a:latin typeface="Ramabhadra" panose="02000600000000000000" pitchFamily="2" charset="0"/>
+                <a:cs typeface="Ramabhadra" panose="02000600000000000000" pitchFamily="2" charset="0"/>
+              </a:rPr>
+              <a:t>స్తుతులన్ గైకొనుమా</a:t>
+            </a:r>
+          </a:p>
+          <a:p>
+            <a:pPr algn="ctr"/>
+            <a:r>
+              <a:rPr lang="te-IN" sz="3100" dirty="0">
+                <a:solidFill>
+                  <a:schemeClr val="tx1"/>
+                </a:solidFill>
+                <a:latin typeface="Ramabhadra" panose="02000600000000000000" pitchFamily="2" charset="0"/>
+                <a:cs typeface="Ramabhadra" panose="02000600000000000000" pitchFamily="2" charset="0"/>
+              </a:rPr>
+              <a:t>సుత యేసు క్రీస్తువా</a:t>
+            </a:r>
+          </a:p>
+          <a:p>
+            <a:pPr algn="ctr"/>
+            <a:r>
+              <a:rPr lang="te-IN" sz="3100" dirty="0">
+                <a:solidFill>
+                  <a:schemeClr val="tx1"/>
+                </a:solidFill>
+                <a:latin typeface="Ramabhadra" panose="02000600000000000000" pitchFamily="2" charset="0"/>
+                <a:cs typeface="Ramabhadra" panose="02000600000000000000" pitchFamily="2" charset="0"/>
+              </a:rPr>
+              <a:t>సతతము మమ్ములను </a:t>
+            </a:r>
+          </a:p>
+          <a:p>
+            <a:pPr algn="ctr"/>
+            <a:r>
+              <a:rPr lang="te-IN" sz="3100" dirty="0">
+                <a:solidFill>
+                  <a:schemeClr val="tx1"/>
+                </a:solidFill>
+                <a:latin typeface="Ramabhadra" panose="02000600000000000000" pitchFamily="2" charset="0"/>
+                <a:cs typeface="Ramabhadra" panose="02000600000000000000" pitchFamily="2" charset="0"/>
+              </a:rPr>
+              <a:t>కృపనిడి కావుమా</a:t>
+            </a:r>
+          </a:p>
+          <a:p>
+            <a:pPr algn="ctr"/>
+            <a:endParaRPr lang="te-IN" sz="3100" dirty="0">
+              <a:solidFill>
+                <a:schemeClr val="tx1"/>
+              </a:solidFill>
+              <a:latin typeface="Ramabhadra" panose="02000600000000000000" pitchFamily="2" charset="0"/>
+              <a:cs typeface="Ramabhadra" panose="02000600000000000000" pitchFamily="2" charset="0"/>
+            </a:endParaRPr>
+          </a:p>
+          <a:p>
+            <a:pPr algn="ctr"/>
+            <a:r>
+              <a:rPr lang="te-IN" sz="3100" dirty="0">
+                <a:solidFill>
+                  <a:schemeClr val="tx1"/>
+                </a:solidFill>
+                <a:latin typeface="Ramabhadra" panose="02000600000000000000" pitchFamily="2" charset="0"/>
+                <a:cs typeface="Ramabhadra" panose="02000600000000000000" pitchFamily="2" charset="0"/>
+              </a:rPr>
+              <a:t>మా పెదవులతో ఎప్పుడు నీ</a:t>
+            </a:r>
+          </a:p>
+          <a:p>
+            <a:pPr algn="ctr"/>
+            <a:r>
+              <a:rPr lang="te-IN" sz="3100" dirty="0">
+                <a:solidFill>
+                  <a:schemeClr val="tx1"/>
+                </a:solidFill>
+                <a:latin typeface="Ramabhadra" panose="02000600000000000000" pitchFamily="2" charset="0"/>
+                <a:cs typeface="Ramabhadra" panose="02000600000000000000" pitchFamily="2" charset="0"/>
+              </a:rPr>
+              <a:t>  వాక్యమును పఠింప నిమ్ము</a:t>
+            </a:r>
+          </a:p>
+          <a:p>
+            <a:pPr algn="ctr"/>
+            <a:r>
+              <a:rPr lang="te-IN" sz="3100" dirty="0">
+                <a:solidFill>
+                  <a:schemeClr val="tx1"/>
+                </a:solidFill>
+                <a:latin typeface="Ramabhadra" panose="02000600000000000000" pitchFamily="2" charset="0"/>
+                <a:cs typeface="Ramabhadra" panose="02000600000000000000" pitchFamily="2" charset="0"/>
+              </a:rPr>
+              <a:t>మా కాలు చేతులు ఎప్పుడు నీ </a:t>
+            </a:r>
+          </a:p>
+          <a:p>
+            <a:pPr algn="ctr"/>
+            <a:r>
+              <a:rPr lang="te-IN" sz="3100" dirty="0">
+                <a:solidFill>
+                  <a:schemeClr val="tx1"/>
+                </a:solidFill>
+                <a:latin typeface="Ramabhadra" panose="02000600000000000000" pitchFamily="2" charset="0"/>
+                <a:cs typeface="Ramabhadra" panose="02000600000000000000" pitchFamily="2" charset="0"/>
+              </a:rPr>
+              <a:t>సేవను చేయను వాడనిమ్ము </a:t>
+            </a:r>
+          </a:p>
+          <a:p>
+            <a:pPr algn="ctr"/>
+            <a:endParaRPr lang="te-IN" sz="3100" dirty="0">
+              <a:solidFill>
+                <a:schemeClr val="tx1"/>
+              </a:solidFill>
+              <a:latin typeface="Ramabhadra" panose="02000600000000000000" pitchFamily="2" charset="0"/>
+              <a:cs typeface="Ramabhadra" panose="02000600000000000000" pitchFamily="2" charset="0"/>
+            </a:endParaRPr>
+          </a:p>
+          <a:p>
+            <a:pPr algn="ctr"/>
+            <a:r>
+              <a:rPr lang="te-IN" sz="3100" dirty="0">
+                <a:solidFill>
+                  <a:schemeClr val="tx1"/>
+                </a:solidFill>
+                <a:latin typeface="Ramabhadra" panose="02000600000000000000" pitchFamily="2" charset="0"/>
+                <a:cs typeface="Ramabhadra" panose="02000600000000000000" pitchFamily="2" charset="0"/>
+              </a:rPr>
+              <a:t>మా కలిమియు పదవుల నెల్ల </a:t>
+            </a:r>
+          </a:p>
+          <a:p>
+            <a:pPr algn="ctr"/>
+            <a:r>
+              <a:rPr lang="te-IN" sz="3100" dirty="0">
+                <a:solidFill>
+                  <a:schemeClr val="tx1"/>
+                </a:solidFill>
+                <a:latin typeface="Ramabhadra" panose="02000600000000000000" pitchFamily="2" charset="0"/>
+                <a:cs typeface="Ramabhadra" panose="02000600000000000000" pitchFamily="2" charset="0"/>
+              </a:rPr>
+              <a:t>నీ శుద్ధ కృపచే పొందితిమి </a:t>
+            </a:r>
+          </a:p>
+          <a:p>
+            <a:pPr algn="ctr"/>
+            <a:r>
+              <a:rPr lang="te-IN" sz="3100" dirty="0">
+                <a:solidFill>
+                  <a:schemeClr val="tx1"/>
+                </a:solidFill>
+                <a:latin typeface="Ramabhadra" panose="02000600000000000000" pitchFamily="2" charset="0"/>
+                <a:cs typeface="Ramabhadra" panose="02000600000000000000" pitchFamily="2" charset="0"/>
+              </a:rPr>
+              <a:t>మా కాలమంతయు జీవింప </a:t>
+            </a:r>
+          </a:p>
+          <a:p>
+            <a:pPr algn="ctr"/>
+            <a:r>
+              <a:rPr lang="te-IN" sz="3100" dirty="0">
+                <a:solidFill>
+                  <a:schemeClr val="tx1"/>
+                </a:solidFill>
+                <a:latin typeface="Ramabhadra" panose="02000600000000000000" pitchFamily="2" charset="0"/>
+                <a:cs typeface="Ramabhadra" panose="02000600000000000000" pitchFamily="2" charset="0"/>
+              </a:rPr>
+              <a:t>నిలకడగ నుండ దీవించుము</a:t>
+            </a:r>
+            <a:endParaRPr lang="en-IN" sz="3100" dirty="0">
+              <a:solidFill>
+                <a:schemeClr val="tx1"/>
+              </a:solidFill>
+              <a:latin typeface="Ramabhadra" panose="02000600000000000000" pitchFamily="2" charset="0"/>
+              <a:cs typeface="Ramabhadra" panose="02000600000000000000" pitchFamily="2" charset="0"/>
+            </a:endParaRPr>
+          </a:p>
+          <a:p>
+            <a:pPr algn="ctr"/>
+            <a:endParaRPr lang="en-IN" sz="3100" dirty="0">
+              <a:solidFill>
+                <a:schemeClr val="tx1"/>
+              </a:solidFill>
+              <a:latin typeface="Ramabhadra" panose="02000600000000000000" pitchFamily="2" charset="0"/>
+              <a:cs typeface="Ramabhadra" panose="02000600000000000000" pitchFamily="2" charset="0"/>
+            </a:endParaRPr>
+          </a:p>
+          <a:p>
+            <a:pPr algn="ctr"/>
+            <a:r>
+              <a:rPr lang="te-IN" sz="3100" dirty="0">
+                <a:solidFill>
+                  <a:schemeClr val="tx1"/>
+                </a:solidFill>
+                <a:latin typeface="Ramabhadra" panose="02000600000000000000" pitchFamily="2" charset="0"/>
+                <a:cs typeface="Ramabhadra" panose="02000600000000000000" pitchFamily="2" charset="0"/>
+              </a:rPr>
+              <a:t>నిజ విశ్వాసములో నెదుగ</a:t>
+            </a:r>
+          </a:p>
+          <a:p>
+            <a:pPr algn="ctr"/>
+            <a:r>
+              <a:rPr lang="te-IN" sz="3100" dirty="0">
+                <a:solidFill>
+                  <a:schemeClr val="tx1"/>
+                </a:solidFill>
+                <a:latin typeface="Ramabhadra" panose="02000600000000000000" pitchFamily="2" charset="0"/>
+                <a:cs typeface="Ramabhadra" panose="02000600000000000000" pitchFamily="2" charset="0"/>
+              </a:rPr>
+              <a:t>నిశ్భల బుద్దిని మా కొసగి</a:t>
+            </a:r>
+          </a:p>
+          <a:p>
+            <a:pPr algn="ctr"/>
+            <a:r>
+              <a:rPr lang="te-IN" sz="3100" dirty="0">
+                <a:solidFill>
+                  <a:schemeClr val="tx1"/>
+                </a:solidFill>
+                <a:latin typeface="Ramabhadra" panose="02000600000000000000" pitchFamily="2" charset="0"/>
+                <a:cs typeface="Ramabhadra" panose="02000600000000000000" pitchFamily="2" charset="0"/>
+              </a:rPr>
+              <a:t>నిరతము నీ సేవ చేయుటకు</a:t>
+            </a:r>
+          </a:p>
+          <a:p>
+            <a:pPr algn="ctr"/>
+            <a:r>
+              <a:rPr lang="te-IN" sz="3100" dirty="0">
+                <a:solidFill>
+                  <a:schemeClr val="tx1"/>
+                </a:solidFill>
+                <a:latin typeface="Ramabhadra" panose="02000600000000000000" pitchFamily="2" charset="0"/>
+                <a:cs typeface="Ramabhadra" panose="02000600000000000000" pitchFamily="2" charset="0"/>
+              </a:rPr>
+              <a:t>నీ ఆత్మ శక్తితో నింపుమయా </a:t>
+            </a:r>
+          </a:p>
+        </p:txBody>
+      </p:sp>
+      <p:sp>
+        <p:nvSpPr>
+          <p:cNvPr id="6" name="Rectangle 5">
+            <a:extLst>
+              <a:ext uri="{FF2B5EF4-FFF2-40B4-BE49-F238E27FC236}">
+                <a16:creationId xmlns:a16="http://schemas.microsoft.com/office/drawing/2014/main" id="{5F9170B8-9D02-4546-B7BF-8B868EFFFB33}"/>
+              </a:ext>
+            </a:extLst>
+          </p:cNvPr>
+          <p:cNvSpPr/>
+          <p:nvPr/>
+        </p:nvSpPr>
+        <p:spPr>
+          <a:xfrm>
+            <a:off x="4296867" y="200526"/>
+            <a:ext cx="4274109" cy="9370194"/>
+          </a:xfrm>
+          <a:prstGeom prst="rect">
+            <a:avLst/>
+          </a:prstGeom>
+          <a:solidFill>
+            <a:schemeClr val="bg1"/>
+          </a:solidFill>
+          <a:ln>
+            <a:solidFill>
+              <a:schemeClr val="bg1">
+                <a:lumMod val="85000"/>
+              </a:schemeClr>
+            </a:solidFill>
+          </a:ln>
+        </p:spPr>
+        <p:style>
+          <a:lnRef idx="2">
+            <a:schemeClr val="accent1">
+              <a:shade val="50000"/>
+            </a:schemeClr>
+          </a:lnRef>
+          <a:fillRef idx="1">
+            <a:schemeClr val="accent1"/>
+          </a:fillRef>
+          <a:effectRef idx="0">
+            <a:schemeClr val="accent1"/>
+          </a:effectRef>
+          <a:fontRef idx="minor">
+            <a:schemeClr val="lt1"/>
+          </a:fontRef>
+        </p:style>
+        <p:txBody>
+          <a:bodyPr rtlCol="0" anchor="ctr"/>
+          <a:lstStyle/>
+          <a:p>
+            <a:pPr algn="ctr"/>
+            <a:r>
+              <a:rPr lang="te-IN" sz="3200" dirty="0">
+                <a:solidFill>
+                  <a:schemeClr val="tx1"/>
+                </a:solidFill>
+                <a:latin typeface="Ramabhadra" panose="02000600000000000000" pitchFamily="2" charset="0"/>
+                <a:cs typeface="Ramabhadra" panose="02000600000000000000" pitchFamily="2" charset="0"/>
+              </a:rPr>
+              <a:t>ఆనంద సంద్రమ్మున –</a:t>
+            </a:r>
+            <a:endParaRPr lang="en-IN" sz="3200" dirty="0">
+              <a:solidFill>
+                <a:schemeClr val="tx1"/>
+              </a:solidFill>
+              <a:latin typeface="Ramabhadra" panose="02000600000000000000" pitchFamily="2" charset="0"/>
+              <a:cs typeface="Ramabhadra" panose="02000600000000000000" pitchFamily="2" charset="0"/>
+            </a:endParaRPr>
+          </a:p>
+          <a:p>
+            <a:pPr algn="ctr"/>
+            <a:r>
+              <a:rPr lang="te-IN" sz="3200" dirty="0">
+                <a:solidFill>
+                  <a:schemeClr val="tx1"/>
+                </a:solidFill>
+                <a:latin typeface="Ramabhadra" panose="02000600000000000000" pitchFamily="2" charset="0"/>
+                <a:cs typeface="Ramabhadra" panose="02000600000000000000" pitchFamily="2" charset="0"/>
+              </a:rPr>
+              <a:t>నా జీవిత నావను </a:t>
+            </a:r>
+          </a:p>
+          <a:p>
+            <a:pPr algn="ctr"/>
+            <a:r>
+              <a:rPr lang="te-IN" sz="3200" dirty="0">
+                <a:solidFill>
+                  <a:schemeClr val="tx1"/>
+                </a:solidFill>
+                <a:latin typeface="Ramabhadra" panose="02000600000000000000" pitchFamily="2" charset="0"/>
+                <a:cs typeface="Ramabhadra" panose="02000600000000000000" pitchFamily="2" charset="0"/>
+              </a:rPr>
+              <a:t>నడిపేది ఆ యేసుడే –</a:t>
+            </a:r>
+            <a:endParaRPr lang="en-IN" sz="3200" dirty="0">
+              <a:solidFill>
+                <a:schemeClr val="tx1"/>
+              </a:solidFill>
+              <a:latin typeface="Ramabhadra" panose="02000600000000000000" pitchFamily="2" charset="0"/>
+              <a:cs typeface="Ramabhadra" panose="02000600000000000000" pitchFamily="2" charset="0"/>
+            </a:endParaRPr>
+          </a:p>
+          <a:p>
+            <a:pPr algn="ctr"/>
+            <a:r>
+              <a:rPr lang="te-IN" sz="3200" dirty="0">
+                <a:solidFill>
+                  <a:schemeClr val="tx1"/>
+                </a:solidFill>
+                <a:latin typeface="Ramabhadra" panose="02000600000000000000" pitchFamily="2" charset="0"/>
+                <a:cs typeface="Ramabhadra" panose="02000600000000000000" pitchFamily="2" charset="0"/>
+              </a:rPr>
+              <a:t>దరిచేర్చు ఆ దేవుడే</a:t>
+            </a:r>
+          </a:p>
+          <a:p>
+            <a:pPr algn="ctr"/>
+            <a:endParaRPr lang="te-IN" sz="3200" dirty="0">
+              <a:solidFill>
+                <a:schemeClr val="tx1"/>
+              </a:solidFill>
+              <a:latin typeface="Ramabhadra" panose="02000600000000000000" pitchFamily="2" charset="0"/>
+              <a:cs typeface="Ramabhadra" panose="02000600000000000000" pitchFamily="2" charset="0"/>
+            </a:endParaRPr>
+          </a:p>
+          <a:p>
+            <a:pPr algn="ctr"/>
+            <a:r>
+              <a:rPr lang="te-IN" sz="3200" dirty="0">
+                <a:solidFill>
+                  <a:schemeClr val="tx1"/>
+                </a:solidFill>
+                <a:latin typeface="Ramabhadra" panose="02000600000000000000" pitchFamily="2" charset="0"/>
+                <a:cs typeface="Ramabhadra" panose="02000600000000000000" pitchFamily="2" charset="0"/>
+              </a:rPr>
+              <a:t>పెనుగాలులే వీచినా –</a:t>
+            </a:r>
+            <a:endParaRPr lang="en-IN" sz="3200" dirty="0">
+              <a:solidFill>
+                <a:schemeClr val="tx1"/>
+              </a:solidFill>
+              <a:latin typeface="Ramabhadra" panose="02000600000000000000" pitchFamily="2" charset="0"/>
+              <a:cs typeface="Ramabhadra" panose="02000600000000000000" pitchFamily="2" charset="0"/>
+            </a:endParaRPr>
+          </a:p>
+          <a:p>
+            <a:pPr algn="ctr"/>
+            <a:r>
+              <a:rPr lang="te-IN" sz="3200" dirty="0">
+                <a:solidFill>
+                  <a:schemeClr val="tx1"/>
+                </a:solidFill>
+                <a:latin typeface="Ramabhadra" panose="02000600000000000000" pitchFamily="2" charset="0"/>
+                <a:cs typeface="Ramabhadra" panose="02000600000000000000" pitchFamily="2" charset="0"/>
+              </a:rPr>
+              <a:t>తుఫానులే తరిమినా</a:t>
+            </a:r>
+          </a:p>
+          <a:p>
+            <a:pPr algn="ctr"/>
+            <a:r>
+              <a:rPr lang="te-IN" sz="3200" dirty="0">
+                <a:solidFill>
+                  <a:schemeClr val="tx1"/>
+                </a:solidFill>
+                <a:latin typeface="Ramabhadra" panose="02000600000000000000" pitchFamily="2" charset="0"/>
+                <a:cs typeface="Ramabhadra" panose="02000600000000000000" pitchFamily="2" charset="0"/>
+              </a:rPr>
+              <a:t>గద్దించి కాపాడు –</a:t>
+            </a:r>
+            <a:endParaRPr lang="en-IN" sz="3200" dirty="0">
+              <a:solidFill>
+                <a:schemeClr val="tx1"/>
+              </a:solidFill>
+              <a:latin typeface="Ramabhadra" panose="02000600000000000000" pitchFamily="2" charset="0"/>
+              <a:cs typeface="Ramabhadra" panose="02000600000000000000" pitchFamily="2" charset="0"/>
+            </a:endParaRPr>
+          </a:p>
+          <a:p>
+            <a:pPr algn="ctr"/>
+            <a:r>
+              <a:rPr lang="te-IN" sz="3200" dirty="0">
+                <a:solidFill>
+                  <a:schemeClr val="tx1"/>
+                </a:solidFill>
+                <a:latin typeface="Ramabhadra" panose="02000600000000000000" pitchFamily="2" charset="0"/>
+                <a:cs typeface="Ramabhadra" panose="02000600000000000000" pitchFamily="2" charset="0"/>
+              </a:rPr>
+              <a:t>ప్రభువండ నీకుండ</a:t>
+            </a:r>
+          </a:p>
+          <a:p>
+            <a:pPr algn="ctr"/>
+            <a:r>
+              <a:rPr lang="te-IN" sz="3200" dirty="0">
+                <a:solidFill>
+                  <a:schemeClr val="tx1"/>
+                </a:solidFill>
+                <a:latin typeface="Ramabhadra" panose="02000600000000000000" pitchFamily="2" charset="0"/>
+                <a:cs typeface="Ramabhadra" panose="02000600000000000000" pitchFamily="2" charset="0"/>
+              </a:rPr>
+              <a:t>దిగులేల ఓ సోదరా! –</a:t>
+            </a:r>
+            <a:endParaRPr lang="en-IN" sz="3200" dirty="0">
+              <a:solidFill>
+                <a:schemeClr val="tx1"/>
+              </a:solidFill>
+              <a:latin typeface="Ramabhadra" panose="02000600000000000000" pitchFamily="2" charset="0"/>
+              <a:cs typeface="Ramabhadra" panose="02000600000000000000" pitchFamily="2" charset="0"/>
+            </a:endParaRPr>
+          </a:p>
+          <a:p>
+            <a:pPr algn="ctr"/>
+            <a:r>
+              <a:rPr lang="te-IN" sz="3200" dirty="0">
+                <a:solidFill>
+                  <a:schemeClr val="tx1"/>
+                </a:solidFill>
+                <a:latin typeface="Ramabhadra" panose="02000600000000000000" pitchFamily="2" charset="0"/>
+                <a:cs typeface="Ramabhadra" panose="02000600000000000000" pitchFamily="2" charset="0"/>
+              </a:rPr>
+              <a:t>నిశ్చింతగా సాగుమా</a:t>
+            </a:r>
+          </a:p>
+          <a:p>
+            <a:pPr algn="ctr"/>
+            <a:endParaRPr lang="te-IN" sz="3200" dirty="0">
+              <a:solidFill>
+                <a:schemeClr val="tx1"/>
+              </a:solidFill>
+              <a:latin typeface="Ramabhadra" panose="02000600000000000000" pitchFamily="2" charset="0"/>
+              <a:cs typeface="Ramabhadra" panose="02000600000000000000" pitchFamily="2" charset="0"/>
+            </a:endParaRPr>
+          </a:p>
+          <a:p>
+            <a:pPr algn="ctr"/>
+            <a:r>
+              <a:rPr lang="te-IN" sz="3200" dirty="0">
+                <a:solidFill>
+                  <a:schemeClr val="tx1"/>
+                </a:solidFill>
+                <a:latin typeface="Ramabhadra" panose="02000600000000000000" pitchFamily="2" charset="0"/>
+                <a:cs typeface="Ramabhadra" panose="02000600000000000000" pitchFamily="2" charset="0"/>
+              </a:rPr>
+              <a:t>ఆపత్కాలములందునా –</a:t>
+            </a:r>
+            <a:endParaRPr lang="en-IN" sz="3200" dirty="0">
+              <a:solidFill>
+                <a:schemeClr val="tx1"/>
+              </a:solidFill>
+              <a:latin typeface="Ramabhadra" panose="02000600000000000000" pitchFamily="2" charset="0"/>
+              <a:cs typeface="Ramabhadra" panose="02000600000000000000" pitchFamily="2" charset="0"/>
+            </a:endParaRPr>
+          </a:p>
+          <a:p>
+            <a:pPr algn="ctr"/>
+            <a:r>
+              <a:rPr lang="te-IN" sz="3200" dirty="0">
+                <a:solidFill>
+                  <a:schemeClr val="tx1"/>
+                </a:solidFill>
+                <a:latin typeface="Ramabhadra" panose="02000600000000000000" pitchFamily="2" charset="0"/>
+                <a:cs typeface="Ramabhadra" panose="02000600000000000000" pitchFamily="2" charset="0"/>
+              </a:rPr>
+              <a:t>రోధించి ప్రార్ధించినా</a:t>
+            </a:r>
+          </a:p>
+          <a:p>
+            <a:pPr algn="ctr"/>
+            <a:r>
+              <a:rPr lang="te-IN" sz="3200" dirty="0">
+                <a:solidFill>
+                  <a:schemeClr val="tx1"/>
+                </a:solidFill>
+                <a:latin typeface="Ramabhadra" panose="02000600000000000000" pitchFamily="2" charset="0"/>
+                <a:cs typeface="Ramabhadra" panose="02000600000000000000" pitchFamily="2" charset="0"/>
+              </a:rPr>
+              <a:t>జవాబేమి లేదని –</a:t>
+            </a:r>
+            <a:endParaRPr lang="en-IN" sz="3200" dirty="0">
+              <a:solidFill>
+                <a:schemeClr val="tx1"/>
+              </a:solidFill>
+              <a:latin typeface="Ramabhadra" panose="02000600000000000000" pitchFamily="2" charset="0"/>
+              <a:cs typeface="Ramabhadra" panose="02000600000000000000" pitchFamily="2" charset="0"/>
+            </a:endParaRPr>
+          </a:p>
+          <a:p>
+            <a:pPr algn="ctr"/>
+            <a:r>
+              <a:rPr lang="te-IN" sz="3200" dirty="0">
+                <a:solidFill>
+                  <a:schemeClr val="tx1"/>
+                </a:solidFill>
+                <a:latin typeface="Ramabhadra" panose="02000600000000000000" pitchFamily="2" charset="0"/>
+                <a:cs typeface="Ramabhadra" panose="02000600000000000000" pitchFamily="2" charset="0"/>
+              </a:rPr>
+              <a:t>దూషింప బోకుమా</a:t>
+            </a:r>
+          </a:p>
+          <a:p>
+            <a:pPr algn="ctr"/>
+            <a:r>
+              <a:rPr lang="te-IN" sz="3200" dirty="0">
+                <a:solidFill>
+                  <a:schemeClr val="tx1"/>
+                </a:solidFill>
+                <a:latin typeface="Ramabhadra" panose="02000600000000000000" pitchFamily="2" charset="0"/>
+                <a:cs typeface="Ramabhadra" panose="02000600000000000000" pitchFamily="2" charset="0"/>
+              </a:rPr>
+              <a:t>ప్రభుచిత్తమనె గిన్నెనే – సంతోషముగ త్రాగుమా </a:t>
+            </a:r>
+          </a:p>
+        </p:txBody>
+      </p:sp>
+      <p:sp>
+        <p:nvSpPr>
+          <p:cNvPr id="7" name="Rectangle 6">
+            <a:extLst>
+              <a:ext uri="{FF2B5EF4-FFF2-40B4-BE49-F238E27FC236}">
+                <a16:creationId xmlns:a16="http://schemas.microsoft.com/office/drawing/2014/main" id="{91772679-4823-4B8E-8AB9-464A9B519206}"/>
+              </a:ext>
+            </a:extLst>
+          </p:cNvPr>
+          <p:cNvSpPr/>
+          <p:nvPr/>
+        </p:nvSpPr>
+        <p:spPr>
+          <a:xfrm>
+            <a:off x="8552012" y="200526"/>
+            <a:ext cx="4274109" cy="9370194"/>
+          </a:xfrm>
+          <a:prstGeom prst="rect">
+            <a:avLst/>
+          </a:prstGeom>
+          <a:solidFill>
+            <a:schemeClr val="bg1"/>
+          </a:solidFill>
+          <a:ln>
+            <a:solidFill>
+              <a:schemeClr val="bg1">
+                <a:lumMod val="85000"/>
+              </a:schemeClr>
+            </a:solidFill>
+          </a:ln>
+        </p:spPr>
+        <p:style>
+          <a:lnRef idx="2">
+            <a:schemeClr val="accent1">
+              <a:shade val="50000"/>
+            </a:schemeClr>
+          </a:lnRef>
+          <a:fillRef idx="1">
+            <a:schemeClr val="accent1"/>
+          </a:fillRef>
+          <a:effectRef idx="0">
+            <a:schemeClr val="accent1"/>
+          </a:effectRef>
+          <a:fontRef idx="minor">
+            <a:schemeClr val="lt1"/>
+          </a:fontRef>
+        </p:style>
+        <p:txBody>
+          <a:bodyPr rtlCol="0" anchor="ctr"/>
+          <a:lstStyle/>
+          <a:p>
+            <a:pPr algn="ctr"/>
+            <a:r>
+              <a:rPr lang="te-IN" sz="2700" dirty="0">
+                <a:solidFill>
+                  <a:schemeClr val="tx1"/>
+                </a:solidFill>
+                <a:latin typeface="Ramabhadra" panose="02000600000000000000" pitchFamily="2" charset="0"/>
+                <a:cs typeface="Ramabhadra" panose="02000600000000000000" pitchFamily="2" charset="0"/>
+              </a:rPr>
+              <a:t>ఎడబాయని నీ కృప</a:t>
+            </a:r>
+          </a:p>
+          <a:p>
+            <a:pPr algn="ctr"/>
+            <a:r>
+              <a:rPr lang="te-IN" sz="2700" dirty="0">
+                <a:solidFill>
+                  <a:schemeClr val="tx1"/>
+                </a:solidFill>
+                <a:latin typeface="Ramabhadra" panose="02000600000000000000" pitchFamily="2" charset="0"/>
+                <a:cs typeface="Ramabhadra" panose="02000600000000000000" pitchFamily="2" charset="0"/>
+              </a:rPr>
+              <a:t>నను విడువదు ఎన్నటికీ (2)</a:t>
+            </a:r>
+          </a:p>
+          <a:p>
+            <a:pPr algn="ctr"/>
+            <a:r>
+              <a:rPr lang="te-IN" sz="2700" dirty="0">
+                <a:solidFill>
+                  <a:schemeClr val="tx1"/>
+                </a:solidFill>
+                <a:latin typeface="Ramabhadra" panose="02000600000000000000" pitchFamily="2" charset="0"/>
+                <a:cs typeface="Ramabhadra" panose="02000600000000000000" pitchFamily="2" charset="0"/>
+              </a:rPr>
+              <a:t>యేసయ్యా నీ ప్రేమానురాగం</a:t>
+            </a:r>
+          </a:p>
+          <a:p>
+            <a:pPr algn="ctr"/>
+            <a:r>
+              <a:rPr lang="te-IN" sz="2700" dirty="0">
+                <a:solidFill>
+                  <a:schemeClr val="tx1"/>
+                </a:solidFill>
+                <a:latin typeface="Ramabhadra" panose="02000600000000000000" pitchFamily="2" charset="0"/>
+                <a:cs typeface="Ramabhadra" panose="02000600000000000000" pitchFamily="2" charset="0"/>
+              </a:rPr>
+              <a:t>నను కాయును అనుక్షణం (2)</a:t>
+            </a:r>
+            <a:endParaRPr lang="en-IN" sz="2700" dirty="0">
+              <a:solidFill>
+                <a:schemeClr val="tx1"/>
+              </a:solidFill>
+              <a:latin typeface="Ramabhadra" panose="02000600000000000000" pitchFamily="2" charset="0"/>
+              <a:cs typeface="Ramabhadra" panose="02000600000000000000" pitchFamily="2" charset="0"/>
+            </a:endParaRPr>
+          </a:p>
+          <a:p>
+            <a:pPr algn="ctr"/>
+            <a:endParaRPr lang="te-IN" sz="2700" dirty="0">
+              <a:solidFill>
+                <a:schemeClr val="tx1"/>
+              </a:solidFill>
+              <a:latin typeface="Ramabhadra" panose="02000600000000000000" pitchFamily="2" charset="0"/>
+              <a:cs typeface="Ramabhadra" panose="02000600000000000000" pitchFamily="2" charset="0"/>
+            </a:endParaRPr>
+          </a:p>
+          <a:p>
+            <a:pPr algn="ctr"/>
+            <a:r>
+              <a:rPr lang="te-IN" sz="2700" dirty="0">
+                <a:solidFill>
+                  <a:schemeClr val="tx1"/>
+                </a:solidFill>
+                <a:latin typeface="Ramabhadra" panose="02000600000000000000" pitchFamily="2" charset="0"/>
+                <a:cs typeface="Ramabhadra" panose="02000600000000000000" pitchFamily="2" charset="0"/>
+              </a:rPr>
+              <a:t>శోకపు లోయలలో –</a:t>
+            </a:r>
+            <a:endParaRPr lang="en-IN" sz="2700" dirty="0">
+              <a:solidFill>
+                <a:schemeClr val="tx1"/>
+              </a:solidFill>
+              <a:latin typeface="Ramabhadra" panose="02000600000000000000" pitchFamily="2" charset="0"/>
+              <a:cs typeface="Ramabhadra" panose="02000600000000000000" pitchFamily="2" charset="0"/>
+            </a:endParaRPr>
+          </a:p>
+          <a:p>
+            <a:pPr algn="ctr"/>
+            <a:r>
+              <a:rPr lang="te-IN" sz="2700" dirty="0">
+                <a:solidFill>
+                  <a:schemeClr val="tx1"/>
+                </a:solidFill>
+                <a:latin typeface="Ramabhadra" panose="02000600000000000000" pitchFamily="2" charset="0"/>
+                <a:cs typeface="Ramabhadra" panose="02000600000000000000" pitchFamily="2" charset="0"/>
+              </a:rPr>
+              <a:t>కష్టాల కడగండ్లలో</a:t>
+            </a:r>
+          </a:p>
+          <a:p>
+            <a:pPr algn="ctr"/>
+            <a:r>
+              <a:rPr lang="te-IN" sz="2700" dirty="0">
+                <a:solidFill>
+                  <a:schemeClr val="tx1"/>
+                </a:solidFill>
+                <a:latin typeface="Ramabhadra" panose="02000600000000000000" pitchFamily="2" charset="0"/>
+                <a:cs typeface="Ramabhadra" panose="02000600000000000000" pitchFamily="2" charset="0"/>
+              </a:rPr>
+              <a:t>కడలేని కడలిలో –</a:t>
+            </a:r>
+            <a:endParaRPr lang="en-IN" sz="2700" dirty="0">
+              <a:solidFill>
+                <a:schemeClr val="tx1"/>
+              </a:solidFill>
+              <a:latin typeface="Ramabhadra" panose="02000600000000000000" pitchFamily="2" charset="0"/>
+              <a:cs typeface="Ramabhadra" panose="02000600000000000000" pitchFamily="2" charset="0"/>
+            </a:endParaRPr>
+          </a:p>
+          <a:p>
+            <a:pPr algn="ctr"/>
+            <a:r>
+              <a:rPr lang="te-IN" sz="2700" dirty="0">
+                <a:solidFill>
+                  <a:schemeClr val="tx1"/>
+                </a:solidFill>
+                <a:latin typeface="Ramabhadra" panose="02000600000000000000" pitchFamily="2" charset="0"/>
+                <a:cs typeface="Ramabhadra" panose="02000600000000000000" pitchFamily="2" charset="0"/>
+              </a:rPr>
+              <a:t>నిరాశ నిసృహలో (2)</a:t>
+            </a:r>
+          </a:p>
+          <a:p>
+            <a:pPr algn="ctr"/>
+            <a:r>
+              <a:rPr lang="te-IN" sz="2700" dirty="0">
+                <a:solidFill>
+                  <a:schemeClr val="tx1"/>
+                </a:solidFill>
+                <a:latin typeface="Ramabhadra" panose="02000600000000000000" pitchFamily="2" charset="0"/>
+                <a:cs typeface="Ramabhadra" panose="02000600000000000000" pitchFamily="2" charset="0"/>
+              </a:rPr>
+              <a:t>అర్ధమేకాని ఈ జీవితం</a:t>
+            </a:r>
+          </a:p>
+          <a:p>
+            <a:pPr algn="ctr"/>
+            <a:r>
+              <a:rPr lang="te-IN" sz="2700" dirty="0">
+                <a:solidFill>
+                  <a:schemeClr val="tx1"/>
+                </a:solidFill>
+                <a:latin typeface="Ramabhadra" panose="02000600000000000000" pitchFamily="2" charset="0"/>
+                <a:cs typeface="Ramabhadra" panose="02000600000000000000" pitchFamily="2" charset="0"/>
+              </a:rPr>
+              <a:t>ఇక వ్యర్థమని నేననుకొనగ (2)</a:t>
+            </a:r>
+          </a:p>
+          <a:p>
+            <a:pPr algn="ctr"/>
+            <a:r>
+              <a:rPr lang="te-IN" sz="2700" dirty="0">
+                <a:solidFill>
+                  <a:schemeClr val="tx1"/>
+                </a:solidFill>
+                <a:latin typeface="Ramabhadra" panose="02000600000000000000" pitchFamily="2" charset="0"/>
+                <a:cs typeface="Ramabhadra" panose="02000600000000000000" pitchFamily="2" charset="0"/>
+              </a:rPr>
+              <a:t>కృపా కనికరముగల దేవా</a:t>
+            </a:r>
+          </a:p>
+          <a:p>
+            <a:pPr algn="ctr"/>
+            <a:r>
+              <a:rPr lang="te-IN" sz="2700" dirty="0">
+                <a:solidFill>
+                  <a:schemeClr val="tx1"/>
+                </a:solidFill>
+                <a:latin typeface="Ramabhadra" panose="02000600000000000000" pitchFamily="2" charset="0"/>
+                <a:cs typeface="Ramabhadra" panose="02000600000000000000" pitchFamily="2" charset="0"/>
+              </a:rPr>
+              <a:t>నా కష్టాల కడలిని దాటించితివి (2)</a:t>
+            </a:r>
+            <a:endParaRPr lang="en-IN" sz="2700" dirty="0">
+              <a:solidFill>
+                <a:schemeClr val="tx1"/>
+              </a:solidFill>
+              <a:latin typeface="Ramabhadra" panose="02000600000000000000" pitchFamily="2" charset="0"/>
+              <a:cs typeface="Ramabhadra" panose="02000600000000000000" pitchFamily="2" charset="0"/>
+            </a:endParaRPr>
+          </a:p>
+          <a:p>
+            <a:pPr algn="ctr"/>
+            <a:endParaRPr lang="te-IN" sz="2700" dirty="0">
+              <a:solidFill>
+                <a:schemeClr val="tx1"/>
+              </a:solidFill>
+              <a:latin typeface="Ramabhadra" panose="02000600000000000000" pitchFamily="2" charset="0"/>
+              <a:cs typeface="Ramabhadra" panose="02000600000000000000" pitchFamily="2" charset="0"/>
+            </a:endParaRPr>
+          </a:p>
+          <a:p>
+            <a:pPr algn="ctr"/>
+            <a:r>
+              <a:rPr lang="te-IN" sz="2700" dirty="0">
+                <a:solidFill>
+                  <a:schemeClr val="tx1"/>
+                </a:solidFill>
+                <a:latin typeface="Ramabhadra" panose="02000600000000000000" pitchFamily="2" charset="0"/>
+                <a:cs typeface="Ramabhadra" panose="02000600000000000000" pitchFamily="2" charset="0"/>
+              </a:rPr>
+              <a:t>విశ్వాస పోరాటంలో –</a:t>
+            </a:r>
+            <a:endParaRPr lang="en-IN" sz="2700" dirty="0">
+              <a:solidFill>
+                <a:schemeClr val="tx1"/>
+              </a:solidFill>
+              <a:latin typeface="Ramabhadra" panose="02000600000000000000" pitchFamily="2" charset="0"/>
+              <a:cs typeface="Ramabhadra" panose="02000600000000000000" pitchFamily="2" charset="0"/>
+            </a:endParaRPr>
+          </a:p>
+          <a:p>
+            <a:pPr algn="ctr"/>
+            <a:r>
+              <a:rPr lang="te-IN" sz="2700" dirty="0">
+                <a:solidFill>
+                  <a:schemeClr val="tx1"/>
+                </a:solidFill>
+                <a:latin typeface="Ramabhadra" panose="02000600000000000000" pitchFamily="2" charset="0"/>
+                <a:cs typeface="Ramabhadra" panose="02000600000000000000" pitchFamily="2" charset="0"/>
+              </a:rPr>
+              <a:t>ఎదురాయె శోధనలు</a:t>
+            </a:r>
+          </a:p>
+          <a:p>
+            <a:pPr algn="ctr"/>
+            <a:r>
+              <a:rPr lang="te-IN" sz="2700" dirty="0">
+                <a:solidFill>
+                  <a:schemeClr val="tx1"/>
+                </a:solidFill>
+                <a:latin typeface="Ramabhadra" panose="02000600000000000000" pitchFamily="2" charset="0"/>
+                <a:cs typeface="Ramabhadra" panose="02000600000000000000" pitchFamily="2" charset="0"/>
+              </a:rPr>
+              <a:t>లోకాశల అలజడిలో –</a:t>
+            </a:r>
+            <a:endParaRPr lang="en-IN" sz="2700" dirty="0">
+              <a:solidFill>
+                <a:schemeClr val="tx1"/>
+              </a:solidFill>
+              <a:latin typeface="Ramabhadra" panose="02000600000000000000" pitchFamily="2" charset="0"/>
+              <a:cs typeface="Ramabhadra" panose="02000600000000000000" pitchFamily="2" charset="0"/>
+            </a:endParaRPr>
+          </a:p>
+          <a:p>
+            <a:pPr algn="ctr"/>
+            <a:r>
+              <a:rPr lang="te-IN" sz="2700" dirty="0">
+                <a:solidFill>
+                  <a:schemeClr val="tx1"/>
+                </a:solidFill>
+                <a:latin typeface="Ramabhadra" panose="02000600000000000000" pitchFamily="2" charset="0"/>
+                <a:cs typeface="Ramabhadra" panose="02000600000000000000" pitchFamily="2" charset="0"/>
+              </a:rPr>
+              <a:t>సడలితి విశ్వాసములో (2)</a:t>
+            </a:r>
+          </a:p>
+          <a:p>
+            <a:pPr algn="ctr"/>
+            <a:r>
+              <a:rPr lang="te-IN" sz="2700" dirty="0">
+                <a:solidFill>
+                  <a:schemeClr val="tx1"/>
+                </a:solidFill>
+                <a:latin typeface="Ramabhadra" panose="02000600000000000000" pitchFamily="2" charset="0"/>
+                <a:cs typeface="Ramabhadra" panose="02000600000000000000" pitchFamily="2" charset="0"/>
+              </a:rPr>
+              <a:t>దుష్టుల క్షేమమునే చూచి</a:t>
+            </a:r>
+          </a:p>
+          <a:p>
+            <a:pPr algn="ctr"/>
+            <a:r>
+              <a:rPr lang="te-IN" sz="2700" dirty="0">
+                <a:solidFill>
+                  <a:schemeClr val="tx1"/>
+                </a:solidFill>
+                <a:latin typeface="Ramabhadra" panose="02000600000000000000" pitchFamily="2" charset="0"/>
+                <a:cs typeface="Ramabhadra" panose="02000600000000000000" pitchFamily="2" charset="0"/>
+              </a:rPr>
+              <a:t>ఇక నీతి వ్యర్థమని అనుకొనగ (2)</a:t>
+            </a:r>
+          </a:p>
+          <a:p>
+            <a:pPr algn="ctr"/>
+            <a:r>
+              <a:rPr lang="te-IN" sz="2700" dirty="0">
+                <a:solidFill>
+                  <a:schemeClr val="tx1"/>
+                </a:solidFill>
+                <a:latin typeface="Ramabhadra" panose="02000600000000000000" pitchFamily="2" charset="0"/>
+                <a:cs typeface="Ramabhadra" panose="02000600000000000000" pitchFamily="2" charset="0"/>
+              </a:rPr>
+              <a:t>దీర్ఘశాంతముగల దేవా</a:t>
+            </a:r>
+          </a:p>
+          <a:p>
+            <a:pPr algn="ctr"/>
+            <a:r>
+              <a:rPr lang="te-IN" sz="2700" dirty="0">
+                <a:solidFill>
+                  <a:schemeClr val="tx1"/>
+                </a:solidFill>
+                <a:latin typeface="Ramabhadra" panose="02000600000000000000" pitchFamily="2" charset="0"/>
+                <a:cs typeface="Ramabhadra" panose="02000600000000000000" pitchFamily="2" charset="0"/>
+              </a:rPr>
+              <a:t>నా చేయి విడువక నడిపించితివి (2) </a:t>
+            </a:r>
+          </a:p>
+        </p:txBody>
+      </p:sp>
+      <p:sp>
+        <p:nvSpPr>
+          <p:cNvPr id="8" name="Rectangle 7">
+            <a:extLst>
+              <a:ext uri="{FF2B5EF4-FFF2-40B4-BE49-F238E27FC236}">
+                <a16:creationId xmlns:a16="http://schemas.microsoft.com/office/drawing/2014/main" id="{F361557D-D07C-4965-BA7F-16390F4CD4A9}"/>
+              </a:ext>
+            </a:extLst>
+          </p:cNvPr>
+          <p:cNvSpPr/>
+          <p:nvPr/>
+        </p:nvSpPr>
+        <p:spPr>
+          <a:xfrm>
+            <a:off x="12826121" y="200526"/>
+            <a:ext cx="4523095" cy="9370194"/>
+          </a:xfrm>
+          <a:prstGeom prst="rect">
+            <a:avLst/>
+          </a:prstGeom>
+          <a:solidFill>
+            <a:schemeClr val="bg1"/>
+          </a:solidFill>
+          <a:ln>
+            <a:solidFill>
+              <a:schemeClr val="bg1">
+                <a:lumMod val="85000"/>
+              </a:schemeClr>
+            </a:solidFill>
+          </a:ln>
+        </p:spPr>
+        <p:style>
+          <a:lnRef idx="2">
+            <a:schemeClr val="accent1">
+              <a:shade val="50000"/>
+            </a:schemeClr>
+          </a:lnRef>
+          <a:fillRef idx="1">
+            <a:schemeClr val="accent1"/>
+          </a:fillRef>
+          <a:effectRef idx="0">
+            <a:schemeClr val="accent1"/>
+          </a:effectRef>
+          <a:fontRef idx="minor">
+            <a:schemeClr val="lt1"/>
+          </a:fontRef>
+        </p:style>
+        <p:txBody>
+          <a:bodyPr rtlCol="0" anchor="ctr"/>
+          <a:lstStyle/>
+          <a:p>
+            <a:pPr algn="ctr"/>
+            <a:r>
+              <a:rPr lang="te-IN" sz="3200" dirty="0">
+                <a:solidFill>
+                  <a:schemeClr val="tx1"/>
+                </a:solidFill>
+                <a:latin typeface="Ramabhadra" panose="02000600000000000000" pitchFamily="2" charset="0"/>
+                <a:cs typeface="Ramabhadra" panose="02000600000000000000" pitchFamily="2" charset="0"/>
+              </a:rPr>
+              <a:t>నేనున్న స్థితిలోనే</a:t>
+            </a:r>
+            <a:endParaRPr lang="en-IN" sz="3200" dirty="0">
+              <a:solidFill>
+                <a:schemeClr val="tx1"/>
+              </a:solidFill>
+              <a:latin typeface="Ramabhadra" panose="02000600000000000000" pitchFamily="2" charset="0"/>
+              <a:cs typeface="Ramabhadra" panose="02000600000000000000" pitchFamily="2" charset="0"/>
+            </a:endParaRPr>
+          </a:p>
+          <a:p>
+            <a:pPr algn="ctr"/>
+            <a:r>
+              <a:rPr lang="te-IN" sz="3200" dirty="0">
+                <a:solidFill>
+                  <a:schemeClr val="tx1"/>
+                </a:solidFill>
+                <a:latin typeface="Ramabhadra" panose="02000600000000000000" pitchFamily="2" charset="0"/>
+                <a:cs typeface="Ramabhadra" panose="02000600000000000000" pitchFamily="2" charset="0"/>
+              </a:rPr>
+              <a:t>సంతృప్తిని కలిగించు </a:t>
+            </a:r>
+          </a:p>
+          <a:p>
+            <a:pPr algn="ctr"/>
+            <a:r>
+              <a:rPr lang="te-IN" sz="3200" dirty="0">
+                <a:solidFill>
+                  <a:schemeClr val="tx1"/>
+                </a:solidFill>
+                <a:latin typeface="Ramabhadra" panose="02000600000000000000" pitchFamily="2" charset="0"/>
+                <a:cs typeface="Ramabhadra" panose="02000600000000000000" pitchFamily="2" charset="0"/>
+              </a:rPr>
+              <a:t>ఏమున్న లేకున్న</a:t>
+            </a:r>
+            <a:endParaRPr lang="en-IN" sz="3200" dirty="0">
+              <a:solidFill>
+                <a:schemeClr val="tx1"/>
+              </a:solidFill>
+              <a:latin typeface="Ramabhadra" panose="02000600000000000000" pitchFamily="2" charset="0"/>
+              <a:cs typeface="Ramabhadra" panose="02000600000000000000" pitchFamily="2" charset="0"/>
+            </a:endParaRPr>
+          </a:p>
+          <a:p>
+            <a:pPr algn="ctr"/>
+            <a:r>
+              <a:rPr lang="te-IN" sz="3200" dirty="0">
+                <a:solidFill>
+                  <a:schemeClr val="tx1"/>
+                </a:solidFill>
+                <a:latin typeface="Ramabhadra" panose="02000600000000000000" pitchFamily="2" charset="0"/>
+                <a:cs typeface="Ramabhadra" panose="02000600000000000000" pitchFamily="2" charset="0"/>
+              </a:rPr>
+              <a:t>నీకొరకే బ్రతికించు (2)</a:t>
+            </a:r>
+          </a:p>
+          <a:p>
+            <a:pPr algn="ctr"/>
+            <a:r>
+              <a:rPr lang="te-IN" sz="3200" dirty="0">
+                <a:solidFill>
+                  <a:schemeClr val="tx1"/>
+                </a:solidFill>
+                <a:latin typeface="Ramabhadra" panose="02000600000000000000" pitchFamily="2" charset="0"/>
+                <a:cs typeface="Ramabhadra" panose="02000600000000000000" pitchFamily="2" charset="0"/>
+              </a:rPr>
+              <a:t>కష్టాలు ఎదురైనా</a:t>
+            </a:r>
+            <a:endParaRPr lang="en-IN" sz="3200" dirty="0">
+              <a:solidFill>
+                <a:schemeClr val="tx1"/>
+              </a:solidFill>
+              <a:latin typeface="Ramabhadra" panose="02000600000000000000" pitchFamily="2" charset="0"/>
+              <a:cs typeface="Ramabhadra" panose="02000600000000000000" pitchFamily="2" charset="0"/>
+            </a:endParaRPr>
+          </a:p>
+          <a:p>
+            <a:pPr algn="ctr"/>
+            <a:r>
+              <a:rPr lang="te-IN" sz="3200" dirty="0">
+                <a:solidFill>
+                  <a:schemeClr val="tx1"/>
+                </a:solidFill>
+                <a:latin typeface="Ramabhadra" panose="02000600000000000000" pitchFamily="2" charset="0"/>
+                <a:cs typeface="Ramabhadra" panose="02000600000000000000" pitchFamily="2" charset="0"/>
+              </a:rPr>
+              <a:t>నా యాత్రను సాగించు </a:t>
+            </a:r>
+          </a:p>
+          <a:p>
+            <a:pPr algn="ctr"/>
+            <a:r>
+              <a:rPr lang="te-IN" sz="3200" dirty="0">
+                <a:solidFill>
+                  <a:schemeClr val="tx1"/>
+                </a:solidFill>
+                <a:latin typeface="Ramabhadra" panose="02000600000000000000" pitchFamily="2" charset="0"/>
+                <a:cs typeface="Ramabhadra" panose="02000600000000000000" pitchFamily="2" charset="0"/>
+              </a:rPr>
+              <a:t>నష్టాలలోనైనా</a:t>
+            </a:r>
+            <a:endParaRPr lang="en-IN" sz="3200" dirty="0">
+              <a:solidFill>
+                <a:schemeClr val="tx1"/>
+              </a:solidFill>
+              <a:latin typeface="Ramabhadra" panose="02000600000000000000" pitchFamily="2" charset="0"/>
+              <a:cs typeface="Ramabhadra" panose="02000600000000000000" pitchFamily="2" charset="0"/>
+            </a:endParaRPr>
+          </a:p>
+          <a:p>
+            <a:pPr algn="ctr"/>
+            <a:r>
+              <a:rPr lang="te-IN" sz="3200" dirty="0">
+                <a:solidFill>
+                  <a:schemeClr val="tx1"/>
+                </a:solidFill>
+                <a:latin typeface="Ramabhadra" panose="02000600000000000000" pitchFamily="2" charset="0"/>
+                <a:cs typeface="Ramabhadra" panose="02000600000000000000" pitchFamily="2" charset="0"/>
+              </a:rPr>
+              <a:t>స్తుతిచేయుట నేర్పించు (2)</a:t>
+            </a:r>
+          </a:p>
+          <a:p>
+            <a:pPr algn="ctr"/>
+            <a:endParaRPr lang="te-IN" sz="3200" dirty="0">
+              <a:solidFill>
+                <a:schemeClr val="tx1"/>
+              </a:solidFill>
+              <a:latin typeface="Ramabhadra" panose="02000600000000000000" pitchFamily="2" charset="0"/>
+              <a:cs typeface="Ramabhadra" panose="02000600000000000000" pitchFamily="2" charset="0"/>
+            </a:endParaRPr>
+          </a:p>
+          <a:p>
+            <a:pPr algn="ctr"/>
+            <a:r>
+              <a:rPr lang="te-IN" sz="3200" dirty="0">
+                <a:solidFill>
+                  <a:schemeClr val="tx1"/>
+                </a:solidFill>
+                <a:latin typeface="Ramabhadra" panose="02000600000000000000" pitchFamily="2" charset="0"/>
+                <a:cs typeface="Ramabhadra" panose="02000600000000000000" pitchFamily="2" charset="0"/>
+              </a:rPr>
+              <a:t>లోకములో నీ కొరకు</a:t>
+            </a:r>
+            <a:endParaRPr lang="en-IN" sz="3200" dirty="0">
+              <a:solidFill>
+                <a:schemeClr val="tx1"/>
+              </a:solidFill>
+              <a:latin typeface="Ramabhadra" panose="02000600000000000000" pitchFamily="2" charset="0"/>
+              <a:cs typeface="Ramabhadra" panose="02000600000000000000" pitchFamily="2" charset="0"/>
+            </a:endParaRPr>
+          </a:p>
+          <a:p>
+            <a:pPr algn="ctr"/>
+            <a:r>
+              <a:rPr lang="te-IN" sz="3200" dirty="0">
+                <a:solidFill>
+                  <a:schemeClr val="tx1"/>
+                </a:solidFill>
+                <a:latin typeface="Ramabhadra" panose="02000600000000000000" pitchFamily="2" charset="0"/>
+                <a:cs typeface="Ramabhadra" panose="02000600000000000000" pitchFamily="2" charset="0"/>
+              </a:rPr>
+              <a:t>జ్యోతిగ నను వెలిగించు (2)</a:t>
+            </a:r>
+          </a:p>
+          <a:p>
+            <a:pPr algn="ctr"/>
+            <a:r>
+              <a:rPr lang="te-IN" sz="3200" dirty="0">
+                <a:solidFill>
+                  <a:schemeClr val="tx1"/>
+                </a:solidFill>
+                <a:latin typeface="Ramabhadra" panose="02000600000000000000" pitchFamily="2" charset="0"/>
+                <a:cs typeface="Ramabhadra" panose="02000600000000000000" pitchFamily="2" charset="0"/>
+              </a:rPr>
+              <a:t>రెండవ రాకడవరకు</a:t>
+            </a:r>
+            <a:endParaRPr lang="en-IN" sz="3200" dirty="0">
+              <a:solidFill>
+                <a:schemeClr val="tx1"/>
+              </a:solidFill>
+              <a:latin typeface="Ramabhadra" panose="02000600000000000000" pitchFamily="2" charset="0"/>
+              <a:cs typeface="Ramabhadra" panose="02000600000000000000" pitchFamily="2" charset="0"/>
+            </a:endParaRPr>
+          </a:p>
+          <a:p>
+            <a:pPr algn="ctr"/>
+            <a:r>
+              <a:rPr lang="te-IN" sz="3200" dirty="0">
+                <a:solidFill>
+                  <a:schemeClr val="tx1"/>
+                </a:solidFill>
+                <a:latin typeface="Ramabhadra" panose="02000600000000000000" pitchFamily="2" charset="0"/>
+                <a:cs typeface="Ramabhadra" panose="02000600000000000000" pitchFamily="2" charset="0"/>
+              </a:rPr>
+              <a:t>విడువక నను నడిపించు (2)</a:t>
+            </a:r>
+          </a:p>
+          <a:p>
+            <a:pPr algn="ctr"/>
+            <a:endParaRPr lang="te-IN" sz="3200" dirty="0">
+              <a:solidFill>
+                <a:schemeClr val="tx1"/>
+              </a:solidFill>
+              <a:latin typeface="Ramabhadra" panose="02000600000000000000" pitchFamily="2" charset="0"/>
+              <a:cs typeface="Ramabhadra" panose="02000600000000000000" pitchFamily="2" charset="0"/>
+            </a:endParaRPr>
+          </a:p>
+          <a:p>
+            <a:pPr algn="ctr"/>
+            <a:r>
+              <a:rPr lang="te-IN" sz="3200" dirty="0">
+                <a:solidFill>
+                  <a:schemeClr val="tx1"/>
+                </a:solidFill>
+                <a:latin typeface="Ramabhadra" panose="02000600000000000000" pitchFamily="2" charset="0"/>
+                <a:cs typeface="Ramabhadra" panose="02000600000000000000" pitchFamily="2" charset="0"/>
+              </a:rPr>
+              <a:t>నా దినముల పరిమాణం</a:t>
+            </a:r>
+            <a:endParaRPr lang="en-IN" sz="3200" dirty="0">
+              <a:solidFill>
+                <a:schemeClr val="tx1"/>
+              </a:solidFill>
+              <a:latin typeface="Ramabhadra" panose="02000600000000000000" pitchFamily="2" charset="0"/>
+              <a:cs typeface="Ramabhadra" panose="02000600000000000000" pitchFamily="2" charset="0"/>
+            </a:endParaRPr>
+          </a:p>
+          <a:p>
+            <a:pPr algn="ctr"/>
+            <a:r>
+              <a:rPr lang="te-IN" sz="3200" dirty="0">
+                <a:solidFill>
+                  <a:schemeClr val="tx1"/>
+                </a:solidFill>
+                <a:latin typeface="Ramabhadra" panose="02000600000000000000" pitchFamily="2" charset="0"/>
+                <a:cs typeface="Ramabhadra" panose="02000600000000000000" pitchFamily="2" charset="0"/>
+              </a:rPr>
+              <a:t>లెక్కించుట నేర్పించు (2)</a:t>
+            </a:r>
+          </a:p>
+          <a:p>
+            <a:pPr algn="ctr"/>
+            <a:r>
+              <a:rPr lang="te-IN" sz="3200" dirty="0">
+                <a:solidFill>
+                  <a:schemeClr val="tx1"/>
+                </a:solidFill>
+                <a:latin typeface="Ramabhadra" panose="02000600000000000000" pitchFamily="2" charset="0"/>
+                <a:cs typeface="Ramabhadra" panose="02000600000000000000" pitchFamily="2" charset="0"/>
+              </a:rPr>
+              <a:t>నా లోపల స్థిర హృదయం</a:t>
+            </a:r>
+          </a:p>
+          <a:p>
+            <a:pPr algn="ctr"/>
+            <a:r>
+              <a:rPr lang="te-IN" sz="3200" dirty="0">
+                <a:solidFill>
+                  <a:schemeClr val="tx1"/>
+                </a:solidFill>
+                <a:latin typeface="Ramabhadra" panose="02000600000000000000" pitchFamily="2" charset="0"/>
+                <a:cs typeface="Ramabhadra" panose="02000600000000000000" pitchFamily="2" charset="0"/>
+              </a:rPr>
+              <a:t>నూతనముగ పుట్టించు (2)</a:t>
+            </a:r>
+          </a:p>
+        </p:txBody>
+      </p:sp>
+    </p:spTree>
+    <p:extLst>
+      <p:ext uri="{BB962C8B-B14F-4D97-AF65-F5344CB8AC3E}">
+        <p14:creationId xmlns:p14="http://schemas.microsoft.com/office/powerpoint/2010/main" val="2862409734"/>
       </p:ext>
     </p:extLst>
   </p:cSld>

</xml_diff>

<commit_message>
30 sunday june songs
</commit_message>
<xml_diff>
--- a/xerox.pptx
+++ b/xerox.pptx
@@ -2,7 +2,7 @@
 <file path=ppt/presentation.xml><?xml version="1.0" encoding="utf-8"?>
 <p:presentation xmlns:a="http://schemas.openxmlformats.org/drawingml/2006/main" xmlns:r="http://schemas.openxmlformats.org/officeDocument/2006/relationships" xmlns:p="http://schemas.openxmlformats.org/presentationml/2006/main" saveSubsetFonts="1">
   <p:sldMasterIdLst>
-    <p:sldMasterId id="2147483672" r:id="rId1"/>
+    <p:sldMasterId id="2147483708" r:id="rId1"/>
   </p:sldMasterIdLst>
   <p:notesMasterIdLst>
     <p:notesMasterId r:id="rId4"/>
@@ -14,8 +14,8 @@
     <p:sldId id="282" r:id="rId2"/>
     <p:sldId id="283" r:id="rId3"/>
   </p:sldIdLst>
-  <p:sldSz cx="17610138" cy="9906000"/>
-  <p:notesSz cx="6858000" cy="9945688"/>
+  <p:sldSz cx="9906000" cy="6858000" type="A4"/>
+  <p:notesSz cx="6797675" cy="9872663"/>
   <p:defaultTextStyle>
     <a:defPPr>
       <a:defRPr lang="en-US"/>
@@ -172,15 +172,15 @@
         </p:nvSpPr>
         <p:spPr>
           <a:xfrm>
-            <a:off x="0" y="0"/>
-            <a:ext cx="2971800" cy="498475"/>
+            <a:off x="0" y="1"/>
+            <a:ext cx="2945659" cy="494815"/>
           </a:xfrm>
           <a:prstGeom prst="rect">
             <a:avLst/>
           </a:prstGeom>
         </p:spPr>
         <p:txBody>
-          <a:bodyPr vert="horz" lIns="91440" tIns="45720" rIns="91440" bIns="45720" rtlCol="0"/>
+          <a:bodyPr vert="horz" lIns="90708" tIns="45354" rIns="90708" bIns="45354" rtlCol="0"/>
           <a:lstStyle>
             <a:lvl1pPr algn="l">
               <a:defRPr sz="1200"/>
@@ -209,15 +209,15 @@
         </p:nvSpPr>
         <p:spPr>
           <a:xfrm>
-            <a:off x="3884613" y="0"/>
-            <a:ext cx="2971800" cy="498475"/>
+            <a:off x="3850443" y="1"/>
+            <a:ext cx="2945659" cy="494815"/>
           </a:xfrm>
           <a:prstGeom prst="rect">
             <a:avLst/>
           </a:prstGeom>
         </p:spPr>
         <p:txBody>
-          <a:bodyPr vert="horz" lIns="91440" tIns="45720" rIns="91440" bIns="45720" rtlCol="0"/>
+          <a:bodyPr vert="horz" lIns="90708" tIns="45354" rIns="90708" bIns="45354" rtlCol="0"/>
           <a:lstStyle>
             <a:lvl1pPr algn="r">
               <a:defRPr sz="1200"/>
@@ -226,7 +226,7 @@
           <a:p>
             <a:fld id="{3502DD63-DF8D-4AB8-92A0-0ECCF612C06C}" type="datetimeFigureOut">
               <a:rPr lang="en-IN" smtClean="0"/>
-              <a:t>17-06-2024</a:t>
+              <a:t>23-06-2024</a:t>
             </a:fld>
             <a:endParaRPr lang="en-IN"/>
           </a:p>
@@ -250,15 +250,15 @@
         </p:nvSpPr>
         <p:spPr>
           <a:xfrm>
-            <a:off x="0" y="9447213"/>
-            <a:ext cx="2971800" cy="498475"/>
+            <a:off x="0" y="9377848"/>
+            <a:ext cx="2945659" cy="494815"/>
           </a:xfrm>
           <a:prstGeom prst="rect">
             <a:avLst/>
           </a:prstGeom>
         </p:spPr>
         <p:txBody>
-          <a:bodyPr vert="horz" lIns="91440" tIns="45720" rIns="91440" bIns="45720" rtlCol="0" anchor="b"/>
+          <a:bodyPr vert="horz" lIns="90708" tIns="45354" rIns="90708" bIns="45354" rtlCol="0" anchor="b"/>
           <a:lstStyle>
             <a:lvl1pPr algn="l">
               <a:defRPr sz="1200"/>
@@ -287,15 +287,15 @@
         </p:nvSpPr>
         <p:spPr>
           <a:xfrm>
-            <a:off x="3884613" y="9447213"/>
-            <a:ext cx="2971800" cy="498475"/>
+            <a:off x="3850443" y="9377848"/>
+            <a:ext cx="2945659" cy="494815"/>
           </a:xfrm>
           <a:prstGeom prst="rect">
             <a:avLst/>
           </a:prstGeom>
         </p:spPr>
         <p:txBody>
-          <a:bodyPr vert="horz" lIns="91440" tIns="45720" rIns="91440" bIns="45720" rtlCol="0" anchor="b"/>
+          <a:bodyPr vert="horz" lIns="90708" tIns="45354" rIns="90708" bIns="45354" rtlCol="0" anchor="b"/>
           <a:lstStyle>
             <a:lvl1pPr algn="r">
               <a:defRPr sz="1200"/>
@@ -356,15 +356,15 @@
         </p:nvSpPr>
         <p:spPr>
           <a:xfrm>
-            <a:off x="0" y="0"/>
-            <a:ext cx="2971800" cy="498475"/>
+            <a:off x="0" y="1"/>
+            <a:ext cx="2945659" cy="494815"/>
           </a:xfrm>
           <a:prstGeom prst="rect">
             <a:avLst/>
           </a:prstGeom>
         </p:spPr>
         <p:txBody>
-          <a:bodyPr vert="horz" lIns="91440" tIns="45720" rIns="91440" bIns="45720" rtlCol="0"/>
+          <a:bodyPr vert="horz" lIns="90708" tIns="45354" rIns="90708" bIns="45354" rtlCol="0"/>
           <a:lstStyle>
             <a:lvl1pPr algn="l">
               <a:defRPr sz="1200"/>
@@ -387,15 +387,15 @@
         </p:nvSpPr>
         <p:spPr>
           <a:xfrm>
-            <a:off x="3884613" y="0"/>
-            <a:ext cx="2971800" cy="498475"/>
+            <a:off x="3850443" y="1"/>
+            <a:ext cx="2945659" cy="494815"/>
           </a:xfrm>
           <a:prstGeom prst="rect">
             <a:avLst/>
           </a:prstGeom>
         </p:spPr>
         <p:txBody>
-          <a:bodyPr vert="horz" lIns="91440" tIns="45720" rIns="91440" bIns="45720" rtlCol="0"/>
+          <a:bodyPr vert="horz" lIns="90708" tIns="45354" rIns="90708" bIns="45354" rtlCol="0"/>
           <a:lstStyle>
             <a:lvl1pPr algn="r">
               <a:defRPr sz="1200"/>
@@ -404,7 +404,7 @@
           <a:p>
             <a:fld id="{1AE741EC-1360-4793-999B-941E0396C9FA}" type="datetimeFigureOut">
               <a:rPr lang="en-IN" smtClean="0"/>
-              <a:t>17-06-2024</a:t>
+              <a:t>23-06-2024</a:t>
             </a:fld>
             <a:endParaRPr lang="en-IN"/>
           </a:p>
@@ -422,8 +422,8 @@
         </p:nvSpPr>
         <p:spPr>
           <a:xfrm>
-            <a:off x="446088" y="1243013"/>
-            <a:ext cx="5965825" cy="3357562"/>
+            <a:off x="992188" y="1233488"/>
+            <a:ext cx="4813300" cy="3333750"/>
           </a:xfrm>
           <a:prstGeom prst="rect">
             <a:avLst/>
@@ -436,7 +436,7 @@
           </a:ln>
         </p:spPr>
         <p:txBody>
-          <a:bodyPr vert="horz" lIns="91440" tIns="45720" rIns="91440" bIns="45720" rtlCol="0" anchor="ctr"/>
+          <a:bodyPr vert="horz" lIns="90708" tIns="45354" rIns="90708" bIns="45354" rtlCol="0" anchor="ctr"/>
           <a:lstStyle/>
           <a:p>
             <a:endParaRPr lang="en-IN"/>
@@ -455,15 +455,15 @@
         </p:nvSpPr>
         <p:spPr>
           <a:xfrm>
-            <a:off x="685800" y="4786313"/>
-            <a:ext cx="5486400" cy="3916362"/>
+            <a:off x="679768" y="4751170"/>
+            <a:ext cx="5438140" cy="3887607"/>
           </a:xfrm>
           <a:prstGeom prst="rect">
             <a:avLst/>
           </a:prstGeom>
         </p:spPr>
         <p:txBody>
-          <a:bodyPr vert="horz" lIns="91440" tIns="45720" rIns="91440" bIns="45720" rtlCol="0"/>
+          <a:bodyPr vert="horz" lIns="90708" tIns="45354" rIns="90708" bIns="45354" rtlCol="0"/>
           <a:lstStyle/>
           <a:p>
             <a:pPr lvl="0"/>
@@ -515,15 +515,15 @@
         </p:nvSpPr>
         <p:spPr>
           <a:xfrm>
-            <a:off x="0" y="9447213"/>
-            <a:ext cx="2971800" cy="498475"/>
+            <a:off x="0" y="9377848"/>
+            <a:ext cx="2945659" cy="494815"/>
           </a:xfrm>
           <a:prstGeom prst="rect">
             <a:avLst/>
           </a:prstGeom>
         </p:spPr>
         <p:txBody>
-          <a:bodyPr vert="horz" lIns="91440" tIns="45720" rIns="91440" bIns="45720" rtlCol="0" anchor="b"/>
+          <a:bodyPr vert="horz" lIns="90708" tIns="45354" rIns="90708" bIns="45354" rtlCol="0" anchor="b"/>
           <a:lstStyle>
             <a:lvl1pPr algn="l">
               <a:defRPr sz="1200"/>
@@ -546,15 +546,15 @@
         </p:nvSpPr>
         <p:spPr>
           <a:xfrm>
-            <a:off x="3884613" y="9447213"/>
-            <a:ext cx="2971800" cy="498475"/>
+            <a:off x="3850443" y="9377848"/>
+            <a:ext cx="2945659" cy="494815"/>
           </a:xfrm>
           <a:prstGeom prst="rect">
             <a:avLst/>
           </a:prstGeom>
         </p:spPr>
         <p:txBody>
-          <a:bodyPr vert="horz" lIns="91440" tIns="45720" rIns="91440" bIns="45720" rtlCol="0" anchor="b"/>
+          <a:bodyPr vert="horz" lIns="90708" tIns="45354" rIns="90708" bIns="45354" rtlCol="0" anchor="b"/>
           <a:lstStyle>
             <a:lvl1pPr algn="r">
               <a:defRPr sz="1200"/>
@@ -579,8 +579,8 @@
   <p:clrMap bg1="lt1" tx1="dk1" bg2="lt2" tx2="dk2" accent1="accent1" accent2="accent2" accent3="accent3" accent4="accent4" accent5="accent5" accent6="accent6" hlink="hlink" folHlink="folHlink"/>
   <p:hf sldNum="0" hdr="0" ftr="0" dt="0"/>
   <p:notesStyle>
-    <a:lvl1pPr marL="0" algn="l" defTabSz="914400" rtl="0" eaLnBrk="1" latinLnBrk="0" hangingPunct="1">
-      <a:defRPr sz="1200" kern="1200">
+    <a:lvl1pPr marL="0" algn="l" defTabSz="557052" rtl="0" eaLnBrk="1" latinLnBrk="0" hangingPunct="1">
+      <a:defRPr sz="731" kern="1200">
         <a:solidFill>
           <a:schemeClr val="tx1"/>
         </a:solidFill>
@@ -589,8 +589,8 @@
         <a:cs typeface="+mn-cs"/>
       </a:defRPr>
     </a:lvl1pPr>
-    <a:lvl2pPr marL="457200" algn="l" defTabSz="914400" rtl="0" eaLnBrk="1" latinLnBrk="0" hangingPunct="1">
-      <a:defRPr sz="1200" kern="1200">
+    <a:lvl2pPr marL="278526" algn="l" defTabSz="557052" rtl="0" eaLnBrk="1" latinLnBrk="0" hangingPunct="1">
+      <a:defRPr sz="731" kern="1200">
         <a:solidFill>
           <a:schemeClr val="tx1"/>
         </a:solidFill>
@@ -599,8 +599,8 @@
         <a:cs typeface="+mn-cs"/>
       </a:defRPr>
     </a:lvl2pPr>
-    <a:lvl3pPr marL="914400" algn="l" defTabSz="914400" rtl="0" eaLnBrk="1" latinLnBrk="0" hangingPunct="1">
-      <a:defRPr sz="1200" kern="1200">
+    <a:lvl3pPr marL="557052" algn="l" defTabSz="557052" rtl="0" eaLnBrk="1" latinLnBrk="0" hangingPunct="1">
+      <a:defRPr sz="731" kern="1200">
         <a:solidFill>
           <a:schemeClr val="tx1"/>
         </a:solidFill>
@@ -609,8 +609,8 @@
         <a:cs typeface="+mn-cs"/>
       </a:defRPr>
     </a:lvl3pPr>
-    <a:lvl4pPr marL="1371600" algn="l" defTabSz="914400" rtl="0" eaLnBrk="1" latinLnBrk="0" hangingPunct="1">
-      <a:defRPr sz="1200" kern="1200">
+    <a:lvl4pPr marL="835579" algn="l" defTabSz="557052" rtl="0" eaLnBrk="1" latinLnBrk="0" hangingPunct="1">
+      <a:defRPr sz="731" kern="1200">
         <a:solidFill>
           <a:schemeClr val="tx1"/>
         </a:solidFill>
@@ -619,8 +619,8 @@
         <a:cs typeface="+mn-cs"/>
       </a:defRPr>
     </a:lvl4pPr>
-    <a:lvl5pPr marL="1828800" algn="l" defTabSz="914400" rtl="0" eaLnBrk="1" latinLnBrk="0" hangingPunct="1">
-      <a:defRPr sz="1200" kern="1200">
+    <a:lvl5pPr marL="1114105" algn="l" defTabSz="557052" rtl="0" eaLnBrk="1" latinLnBrk="0" hangingPunct="1">
+      <a:defRPr sz="731" kern="1200">
         <a:solidFill>
           <a:schemeClr val="tx1"/>
         </a:solidFill>
@@ -629,8 +629,8 @@
         <a:cs typeface="+mn-cs"/>
       </a:defRPr>
     </a:lvl5pPr>
-    <a:lvl6pPr marL="2286000" algn="l" defTabSz="914400" rtl="0" eaLnBrk="1" latinLnBrk="0" hangingPunct="1">
-      <a:defRPr sz="1200" kern="1200">
+    <a:lvl6pPr marL="1392631" algn="l" defTabSz="557052" rtl="0" eaLnBrk="1" latinLnBrk="0" hangingPunct="1">
+      <a:defRPr sz="731" kern="1200">
         <a:solidFill>
           <a:schemeClr val="tx1"/>
         </a:solidFill>
@@ -639,8 +639,8 @@
         <a:cs typeface="+mn-cs"/>
       </a:defRPr>
     </a:lvl6pPr>
-    <a:lvl7pPr marL="2743200" algn="l" defTabSz="914400" rtl="0" eaLnBrk="1" latinLnBrk="0" hangingPunct="1">
-      <a:defRPr sz="1200" kern="1200">
+    <a:lvl7pPr marL="1671157" algn="l" defTabSz="557052" rtl="0" eaLnBrk="1" latinLnBrk="0" hangingPunct="1">
+      <a:defRPr sz="731" kern="1200">
         <a:solidFill>
           <a:schemeClr val="tx1"/>
         </a:solidFill>
@@ -649,8 +649,8 @@
         <a:cs typeface="+mn-cs"/>
       </a:defRPr>
     </a:lvl7pPr>
-    <a:lvl8pPr marL="3200400" algn="l" defTabSz="914400" rtl="0" eaLnBrk="1" latinLnBrk="0" hangingPunct="1">
-      <a:defRPr sz="1200" kern="1200">
+    <a:lvl8pPr marL="1949684" algn="l" defTabSz="557052" rtl="0" eaLnBrk="1" latinLnBrk="0" hangingPunct="1">
+      <a:defRPr sz="731" kern="1200">
         <a:solidFill>
           <a:schemeClr val="tx1"/>
         </a:solidFill>
@@ -659,8 +659,8 @@
         <a:cs typeface="+mn-cs"/>
       </a:defRPr>
     </a:lvl8pPr>
-    <a:lvl9pPr marL="3657600" algn="l" defTabSz="914400" rtl="0" eaLnBrk="1" latinLnBrk="0" hangingPunct="1">
-      <a:defRPr sz="1200" kern="1200">
+    <a:lvl9pPr marL="2228210" algn="l" defTabSz="557052" rtl="0" eaLnBrk="1" latinLnBrk="0" hangingPunct="1">
+      <a:defRPr sz="731" kern="1200">
         <a:solidFill>
           <a:schemeClr val="tx1"/>
         </a:solidFill>
@@ -702,15 +702,15 @@
         </p:nvSpPr>
         <p:spPr>
           <a:xfrm>
-            <a:off x="2201267" y="1621191"/>
-            <a:ext cx="13207604" cy="3448756"/>
+            <a:off x="742950" y="1122363"/>
+            <a:ext cx="8420100" cy="2387600"/>
           </a:xfrm>
         </p:spPr>
         <p:txBody>
           <a:bodyPr anchor="b"/>
           <a:lstStyle>
             <a:lvl1pPr algn="ctr">
-              <a:defRPr sz="8666"/>
+              <a:defRPr sz="6000"/>
             </a:lvl1pPr>
           </a:lstStyle>
           <a:p>
@@ -734,8 +734,8 @@
         </p:nvSpPr>
         <p:spPr>
           <a:xfrm>
-            <a:off x="2201267" y="5202944"/>
-            <a:ext cx="13207604" cy="2391656"/>
+            <a:off x="1238250" y="3602038"/>
+            <a:ext cx="7429500" cy="1655762"/>
           </a:xfrm>
         </p:spPr>
         <p:txBody>
@@ -743,39 +743,39 @@
           <a:lstStyle>
             <a:lvl1pPr marL="0" indent="0" algn="ctr">
               <a:buNone/>
-              <a:defRPr sz="3467"/>
+              <a:defRPr sz="2400"/>
             </a:lvl1pPr>
-            <a:lvl2pPr marL="660380" indent="0" algn="ctr">
+            <a:lvl2pPr marL="457200" indent="0" algn="ctr">
               <a:buNone/>
-              <a:defRPr sz="2889"/>
+              <a:defRPr sz="2000"/>
             </a:lvl2pPr>
-            <a:lvl3pPr marL="1320759" indent="0" algn="ctr">
+            <a:lvl3pPr marL="914400" indent="0" algn="ctr">
               <a:buNone/>
-              <a:defRPr sz="2600"/>
+              <a:defRPr sz="1800"/>
             </a:lvl3pPr>
-            <a:lvl4pPr marL="1981139" indent="0" algn="ctr">
+            <a:lvl4pPr marL="1371600" indent="0" algn="ctr">
               <a:buNone/>
-              <a:defRPr sz="2311"/>
+              <a:defRPr sz="1600"/>
             </a:lvl4pPr>
-            <a:lvl5pPr marL="2641519" indent="0" algn="ctr">
+            <a:lvl5pPr marL="1828800" indent="0" algn="ctr">
               <a:buNone/>
-              <a:defRPr sz="2311"/>
+              <a:defRPr sz="1600"/>
             </a:lvl5pPr>
-            <a:lvl6pPr marL="3301898" indent="0" algn="ctr">
+            <a:lvl6pPr marL="2286000" indent="0" algn="ctr">
               <a:buNone/>
-              <a:defRPr sz="2311"/>
+              <a:defRPr sz="1600"/>
             </a:lvl6pPr>
-            <a:lvl7pPr marL="3962278" indent="0" algn="ctr">
+            <a:lvl7pPr marL="2743200" indent="0" algn="ctr">
               <a:buNone/>
-              <a:defRPr sz="2311"/>
+              <a:defRPr sz="1600"/>
             </a:lvl7pPr>
-            <a:lvl8pPr marL="4622658" indent="0" algn="ctr">
+            <a:lvl8pPr marL="3200400" indent="0" algn="ctr">
               <a:buNone/>
-              <a:defRPr sz="2311"/>
+              <a:defRPr sz="1600"/>
             </a:lvl8pPr>
-            <a:lvl9pPr marL="5283037" indent="0" algn="ctr">
+            <a:lvl9pPr marL="3657600" indent="0" algn="ctr">
               <a:buNone/>
-              <a:defRPr sz="2311"/>
+              <a:defRPr sz="1600"/>
             </a:lvl9pPr>
           </a:lstStyle>
           <a:p>
@@ -804,7 +804,7 @@
           <a:p>
             <a:fld id="{86FBD32F-FCAD-481A-B7D8-4D813FB7DB24}" type="datetimeFigureOut">
               <a:rPr lang="en-IN" smtClean="0"/>
-              <a:t>17-06-2024</a:t>
+              <a:t>23-06-2024</a:t>
             </a:fld>
             <a:endParaRPr lang="en-IN"/>
           </a:p>
@@ -855,7 +855,7 @@
     </p:spTree>
     <p:extLst>
       <p:ext uri="{BB962C8B-B14F-4D97-AF65-F5344CB8AC3E}">
-        <p14:creationId xmlns:p14="http://schemas.microsoft.com/office/powerpoint/2010/main" val="968886354"/>
+        <p14:creationId xmlns:p14="http://schemas.microsoft.com/office/powerpoint/2010/main" val="4245577271"/>
       </p:ext>
     </p:extLst>
   </p:cSld>
@@ -974,7 +974,7 @@
           <a:p>
             <a:fld id="{86FBD32F-FCAD-481A-B7D8-4D813FB7DB24}" type="datetimeFigureOut">
               <a:rPr lang="en-IN" smtClean="0"/>
-              <a:t>17-06-2024</a:t>
+              <a:t>23-06-2024</a:t>
             </a:fld>
             <a:endParaRPr lang="en-IN"/>
           </a:p>
@@ -1025,7 +1025,7 @@
     </p:spTree>
     <p:extLst>
       <p:ext uri="{BB962C8B-B14F-4D97-AF65-F5344CB8AC3E}">
-        <p14:creationId xmlns:p14="http://schemas.microsoft.com/office/powerpoint/2010/main" val="2826100549"/>
+        <p14:creationId xmlns:p14="http://schemas.microsoft.com/office/powerpoint/2010/main" val="589313612"/>
       </p:ext>
     </p:extLst>
   </p:cSld>
@@ -1064,8 +1064,8 @@
         </p:nvSpPr>
         <p:spPr>
           <a:xfrm>
-            <a:off x="12602255" y="527403"/>
-            <a:ext cx="3797186" cy="8394877"/>
+            <a:off x="7088982" y="365125"/>
+            <a:ext cx="2135981" cy="5811838"/>
           </a:xfrm>
         </p:spPr>
         <p:txBody>
@@ -1092,8 +1092,8 @@
         </p:nvSpPr>
         <p:spPr>
           <a:xfrm>
-            <a:off x="1210697" y="527403"/>
-            <a:ext cx="11171431" cy="8394877"/>
+            <a:off x="681038" y="365125"/>
+            <a:ext cx="6284119" cy="5811838"/>
           </a:xfrm>
         </p:spPr>
         <p:txBody>
@@ -1154,7 +1154,7 @@
           <a:p>
             <a:fld id="{86FBD32F-FCAD-481A-B7D8-4D813FB7DB24}" type="datetimeFigureOut">
               <a:rPr lang="en-IN" smtClean="0"/>
-              <a:t>17-06-2024</a:t>
+              <a:t>23-06-2024</a:t>
             </a:fld>
             <a:endParaRPr lang="en-IN"/>
           </a:p>
@@ -1205,7 +1205,7 @@
     </p:spTree>
     <p:extLst>
       <p:ext uri="{BB962C8B-B14F-4D97-AF65-F5344CB8AC3E}">
-        <p14:creationId xmlns:p14="http://schemas.microsoft.com/office/powerpoint/2010/main" val="1872737456"/>
+        <p14:creationId xmlns:p14="http://schemas.microsoft.com/office/powerpoint/2010/main" val="699153555"/>
       </p:ext>
     </p:extLst>
   </p:cSld>
@@ -1324,7 +1324,7 @@
           <a:p>
             <a:fld id="{86FBD32F-FCAD-481A-B7D8-4D813FB7DB24}" type="datetimeFigureOut">
               <a:rPr lang="en-IN" smtClean="0"/>
-              <a:t>17-06-2024</a:t>
+              <a:t>23-06-2024</a:t>
             </a:fld>
             <a:endParaRPr lang="en-IN"/>
           </a:p>
@@ -1375,7 +1375,7 @@
     </p:spTree>
     <p:extLst>
       <p:ext uri="{BB962C8B-B14F-4D97-AF65-F5344CB8AC3E}">
-        <p14:creationId xmlns:p14="http://schemas.microsoft.com/office/powerpoint/2010/main" val="3037406850"/>
+        <p14:creationId xmlns:p14="http://schemas.microsoft.com/office/powerpoint/2010/main" val="3196760402"/>
       </p:ext>
     </p:extLst>
   </p:cSld>
@@ -1414,15 +1414,15 @@
         </p:nvSpPr>
         <p:spPr>
           <a:xfrm>
-            <a:off x="1201525" y="2469622"/>
-            <a:ext cx="15188744" cy="4120620"/>
+            <a:off x="675879" y="1709740"/>
+            <a:ext cx="8543925" cy="2852737"/>
           </a:xfrm>
         </p:spPr>
         <p:txBody>
           <a:bodyPr anchor="b"/>
           <a:lstStyle>
             <a:lvl1pPr>
-              <a:defRPr sz="8666"/>
+              <a:defRPr sz="6000"/>
             </a:lvl1pPr>
           </a:lstStyle>
           <a:p>
@@ -1446,8 +1446,8 @@
         </p:nvSpPr>
         <p:spPr>
           <a:xfrm>
-            <a:off x="1201525" y="6629225"/>
-            <a:ext cx="15188744" cy="2166937"/>
+            <a:off x="675879" y="4589465"/>
+            <a:ext cx="8543925" cy="1500187"/>
           </a:xfrm>
         </p:spPr>
         <p:txBody>
@@ -1455,93 +1455,91 @@
           <a:lstStyle>
             <a:lvl1pPr marL="0" indent="0">
               <a:buNone/>
-              <a:defRPr sz="3467">
+              <a:defRPr sz="2400">
+                <a:solidFill>
+                  <a:schemeClr val="tx1"/>
+                </a:solidFill>
+              </a:defRPr>
+            </a:lvl1pPr>
+            <a:lvl2pPr marL="457200" indent="0">
+              <a:buNone/>
+              <a:defRPr sz="2000">
                 <a:solidFill>
                   <a:schemeClr val="tx1">
                     <a:tint val="75000"/>
                   </a:schemeClr>
                 </a:solidFill>
               </a:defRPr>
-            </a:lvl1pPr>
-            <a:lvl2pPr marL="660380" indent="0">
+            </a:lvl2pPr>
+            <a:lvl3pPr marL="914400" indent="0">
               <a:buNone/>
-              <a:defRPr sz="2889">
+              <a:defRPr sz="1800">
                 <a:solidFill>
                   <a:schemeClr val="tx1">
                     <a:tint val="75000"/>
                   </a:schemeClr>
                 </a:solidFill>
               </a:defRPr>
-            </a:lvl2pPr>
-            <a:lvl3pPr marL="1320759" indent="0">
+            </a:lvl3pPr>
+            <a:lvl4pPr marL="1371600" indent="0">
               <a:buNone/>
-              <a:defRPr sz="2600">
+              <a:defRPr sz="1600">
                 <a:solidFill>
                   <a:schemeClr val="tx1">
                     <a:tint val="75000"/>
                   </a:schemeClr>
                 </a:solidFill>
               </a:defRPr>
-            </a:lvl3pPr>
-            <a:lvl4pPr marL="1981139" indent="0">
+            </a:lvl4pPr>
+            <a:lvl5pPr marL="1828800" indent="0">
               <a:buNone/>
-              <a:defRPr sz="2311">
+              <a:defRPr sz="1600">
                 <a:solidFill>
                   <a:schemeClr val="tx1">
                     <a:tint val="75000"/>
                   </a:schemeClr>
                 </a:solidFill>
               </a:defRPr>
-            </a:lvl4pPr>
-            <a:lvl5pPr marL="2641519" indent="0">
+            </a:lvl5pPr>
+            <a:lvl6pPr marL="2286000" indent="0">
               <a:buNone/>
-              <a:defRPr sz="2311">
+              <a:defRPr sz="1600">
                 <a:solidFill>
                   <a:schemeClr val="tx1">
                     <a:tint val="75000"/>
                   </a:schemeClr>
                 </a:solidFill>
               </a:defRPr>
-            </a:lvl5pPr>
-            <a:lvl6pPr marL="3301898" indent="0">
+            </a:lvl6pPr>
+            <a:lvl7pPr marL="2743200" indent="0">
               <a:buNone/>
-              <a:defRPr sz="2311">
+              <a:defRPr sz="1600">
                 <a:solidFill>
                   <a:schemeClr val="tx1">
                     <a:tint val="75000"/>
                   </a:schemeClr>
                 </a:solidFill>
               </a:defRPr>
-            </a:lvl6pPr>
-            <a:lvl7pPr marL="3962278" indent="0">
+            </a:lvl7pPr>
+            <a:lvl8pPr marL="3200400" indent="0">
               <a:buNone/>
-              <a:defRPr sz="2311">
+              <a:defRPr sz="1600">
                 <a:solidFill>
                   <a:schemeClr val="tx1">
                     <a:tint val="75000"/>
                   </a:schemeClr>
                 </a:solidFill>
               </a:defRPr>
-            </a:lvl7pPr>
-            <a:lvl8pPr marL="4622658" indent="0">
+            </a:lvl8pPr>
+            <a:lvl9pPr marL="3657600" indent="0">
               <a:buNone/>
-              <a:defRPr sz="2311">
+              <a:defRPr sz="1600">
                 <a:solidFill>
                   <a:schemeClr val="tx1">
                     <a:tint val="75000"/>
                   </a:schemeClr>
                 </a:solidFill>
               </a:defRPr>
-            </a:lvl8pPr>
-            <a:lvl9pPr marL="5283037" indent="0">
-              <a:buNone/>
-              <a:defRPr sz="2311">
-                <a:solidFill>
-                  <a:schemeClr val="tx1">
-                    <a:tint val="75000"/>
-                  </a:schemeClr>
-                </a:solidFill>
-              </a:defRPr>
             </a:lvl9pPr>
           </a:lstStyle>
           <a:p>
@@ -1570,7 +1568,7 @@
           <a:p>
             <a:fld id="{86FBD32F-FCAD-481A-B7D8-4D813FB7DB24}" type="datetimeFigureOut">
               <a:rPr lang="en-IN" smtClean="0"/>
-              <a:t>17-06-2024</a:t>
+              <a:t>23-06-2024</a:t>
             </a:fld>
             <a:endParaRPr lang="en-IN"/>
           </a:p>
@@ -1621,7 +1619,7 @@
     </p:spTree>
     <p:extLst>
       <p:ext uri="{BB962C8B-B14F-4D97-AF65-F5344CB8AC3E}">
-        <p14:creationId xmlns:p14="http://schemas.microsoft.com/office/powerpoint/2010/main" val="3524043591"/>
+        <p14:creationId xmlns:p14="http://schemas.microsoft.com/office/powerpoint/2010/main" val="2990509459"/>
       </p:ext>
     </p:extLst>
   </p:cSld>
@@ -1683,8 +1681,8 @@
         </p:nvSpPr>
         <p:spPr>
           <a:xfrm>
-            <a:off x="1210697" y="2637014"/>
-            <a:ext cx="7484309" cy="6285266"/>
+            <a:off x="681038" y="1825625"/>
+            <a:ext cx="4210050" cy="4351338"/>
           </a:xfrm>
         </p:spPr>
         <p:txBody>
@@ -1740,8 +1738,8 @@
         </p:nvSpPr>
         <p:spPr>
           <a:xfrm>
-            <a:off x="8915132" y="2637014"/>
-            <a:ext cx="7484309" cy="6285266"/>
+            <a:off x="5014913" y="1825625"/>
+            <a:ext cx="4210050" cy="4351338"/>
           </a:xfrm>
         </p:spPr>
         <p:txBody>
@@ -1802,7 +1800,7 @@
           <a:p>
             <a:fld id="{86FBD32F-FCAD-481A-B7D8-4D813FB7DB24}" type="datetimeFigureOut">
               <a:rPr lang="en-IN" smtClean="0"/>
-              <a:t>17-06-2024</a:t>
+              <a:t>23-06-2024</a:t>
             </a:fld>
             <a:endParaRPr lang="en-IN"/>
           </a:p>
@@ -1853,7 +1851,7 @@
     </p:spTree>
     <p:extLst>
       <p:ext uri="{BB962C8B-B14F-4D97-AF65-F5344CB8AC3E}">
-        <p14:creationId xmlns:p14="http://schemas.microsoft.com/office/powerpoint/2010/main" val="1400582787"/>
+        <p14:creationId xmlns:p14="http://schemas.microsoft.com/office/powerpoint/2010/main" val="2894282323"/>
       </p:ext>
     </p:extLst>
   </p:cSld>
@@ -1892,8 +1890,8 @@
         </p:nvSpPr>
         <p:spPr>
           <a:xfrm>
-            <a:off x="1212991" y="527404"/>
-            <a:ext cx="15188744" cy="1914702"/>
+            <a:off x="682328" y="365127"/>
+            <a:ext cx="8543925" cy="1325563"/>
           </a:xfrm>
         </p:spPr>
         <p:txBody>
@@ -1920,8 +1918,8 @@
         </p:nvSpPr>
         <p:spPr>
           <a:xfrm>
-            <a:off x="1212991" y="2428347"/>
-            <a:ext cx="7449913" cy="1190095"/>
+            <a:off x="682329" y="1681163"/>
+            <a:ext cx="4190702" cy="823912"/>
           </a:xfrm>
         </p:spPr>
         <p:txBody>
@@ -1929,39 +1927,39 @@
           <a:lstStyle>
             <a:lvl1pPr marL="0" indent="0">
               <a:buNone/>
-              <a:defRPr sz="3467" b="1"/>
+              <a:defRPr sz="2400" b="1"/>
             </a:lvl1pPr>
-            <a:lvl2pPr marL="660380" indent="0">
+            <a:lvl2pPr marL="457200" indent="0">
               <a:buNone/>
-              <a:defRPr sz="2889" b="1"/>
+              <a:defRPr sz="2000" b="1"/>
             </a:lvl2pPr>
-            <a:lvl3pPr marL="1320759" indent="0">
+            <a:lvl3pPr marL="914400" indent="0">
               <a:buNone/>
-              <a:defRPr sz="2600" b="1"/>
+              <a:defRPr sz="1800" b="1"/>
             </a:lvl3pPr>
-            <a:lvl4pPr marL="1981139" indent="0">
+            <a:lvl4pPr marL="1371600" indent="0">
               <a:buNone/>
-              <a:defRPr sz="2311" b="1"/>
+              <a:defRPr sz="1600" b="1"/>
             </a:lvl4pPr>
-            <a:lvl5pPr marL="2641519" indent="0">
+            <a:lvl5pPr marL="1828800" indent="0">
               <a:buNone/>
-              <a:defRPr sz="2311" b="1"/>
+              <a:defRPr sz="1600" b="1"/>
             </a:lvl5pPr>
-            <a:lvl6pPr marL="3301898" indent="0">
+            <a:lvl6pPr marL="2286000" indent="0">
               <a:buNone/>
-              <a:defRPr sz="2311" b="1"/>
+              <a:defRPr sz="1600" b="1"/>
             </a:lvl6pPr>
-            <a:lvl7pPr marL="3962278" indent="0">
+            <a:lvl7pPr marL="2743200" indent="0">
               <a:buNone/>
-              <a:defRPr sz="2311" b="1"/>
+              <a:defRPr sz="1600" b="1"/>
             </a:lvl7pPr>
-            <a:lvl8pPr marL="4622658" indent="0">
+            <a:lvl8pPr marL="3200400" indent="0">
               <a:buNone/>
-              <a:defRPr sz="2311" b="1"/>
+              <a:defRPr sz="1600" b="1"/>
             </a:lvl8pPr>
-            <a:lvl9pPr marL="5283037" indent="0">
+            <a:lvl9pPr marL="3657600" indent="0">
               <a:buNone/>
-              <a:defRPr sz="2311" b="1"/>
+              <a:defRPr sz="1600" b="1"/>
             </a:lvl9pPr>
           </a:lstStyle>
           <a:p>
@@ -1985,8 +1983,8 @@
         </p:nvSpPr>
         <p:spPr>
           <a:xfrm>
-            <a:off x="1212991" y="3618442"/>
-            <a:ext cx="7449913" cy="5322183"/>
+            <a:off x="682329" y="2505075"/>
+            <a:ext cx="4190702" cy="3684588"/>
           </a:xfrm>
         </p:spPr>
         <p:txBody>
@@ -2042,8 +2040,8 @@
         </p:nvSpPr>
         <p:spPr>
           <a:xfrm>
-            <a:off x="8915133" y="2428347"/>
-            <a:ext cx="7486602" cy="1190095"/>
+            <a:off x="5014913" y="1681163"/>
+            <a:ext cx="4211340" cy="823912"/>
           </a:xfrm>
         </p:spPr>
         <p:txBody>
@@ -2051,39 +2049,39 @@
           <a:lstStyle>
             <a:lvl1pPr marL="0" indent="0">
               <a:buNone/>
-              <a:defRPr sz="3467" b="1"/>
+              <a:defRPr sz="2400" b="1"/>
             </a:lvl1pPr>
-            <a:lvl2pPr marL="660380" indent="0">
+            <a:lvl2pPr marL="457200" indent="0">
               <a:buNone/>
-              <a:defRPr sz="2889" b="1"/>
+              <a:defRPr sz="2000" b="1"/>
             </a:lvl2pPr>
-            <a:lvl3pPr marL="1320759" indent="0">
+            <a:lvl3pPr marL="914400" indent="0">
               <a:buNone/>
-              <a:defRPr sz="2600" b="1"/>
+              <a:defRPr sz="1800" b="1"/>
             </a:lvl3pPr>
-            <a:lvl4pPr marL="1981139" indent="0">
+            <a:lvl4pPr marL="1371600" indent="0">
               <a:buNone/>
-              <a:defRPr sz="2311" b="1"/>
+              <a:defRPr sz="1600" b="1"/>
             </a:lvl4pPr>
-            <a:lvl5pPr marL="2641519" indent="0">
+            <a:lvl5pPr marL="1828800" indent="0">
               <a:buNone/>
-              <a:defRPr sz="2311" b="1"/>
+              <a:defRPr sz="1600" b="1"/>
             </a:lvl5pPr>
-            <a:lvl6pPr marL="3301898" indent="0">
+            <a:lvl6pPr marL="2286000" indent="0">
               <a:buNone/>
-              <a:defRPr sz="2311" b="1"/>
+              <a:defRPr sz="1600" b="1"/>
             </a:lvl6pPr>
-            <a:lvl7pPr marL="3962278" indent="0">
+            <a:lvl7pPr marL="2743200" indent="0">
               <a:buNone/>
-              <a:defRPr sz="2311" b="1"/>
+              <a:defRPr sz="1600" b="1"/>
             </a:lvl7pPr>
-            <a:lvl8pPr marL="4622658" indent="0">
+            <a:lvl8pPr marL="3200400" indent="0">
               <a:buNone/>
-              <a:defRPr sz="2311" b="1"/>
+              <a:defRPr sz="1600" b="1"/>
             </a:lvl8pPr>
-            <a:lvl9pPr marL="5283037" indent="0">
+            <a:lvl9pPr marL="3657600" indent="0">
               <a:buNone/>
-              <a:defRPr sz="2311" b="1"/>
+              <a:defRPr sz="1600" b="1"/>
             </a:lvl9pPr>
           </a:lstStyle>
           <a:p>
@@ -2107,8 +2105,8 @@
         </p:nvSpPr>
         <p:spPr>
           <a:xfrm>
-            <a:off x="8915133" y="3618442"/>
-            <a:ext cx="7486602" cy="5322183"/>
+            <a:off x="5014913" y="2505075"/>
+            <a:ext cx="4211340" cy="3684588"/>
           </a:xfrm>
         </p:spPr>
         <p:txBody>
@@ -2169,7 +2167,7 @@
           <a:p>
             <a:fld id="{86FBD32F-FCAD-481A-B7D8-4D813FB7DB24}" type="datetimeFigureOut">
               <a:rPr lang="en-IN" smtClean="0"/>
-              <a:t>17-06-2024</a:t>
+              <a:t>23-06-2024</a:t>
             </a:fld>
             <a:endParaRPr lang="en-IN"/>
           </a:p>
@@ -2220,7 +2218,7 @@
     </p:spTree>
     <p:extLst>
       <p:ext uri="{BB962C8B-B14F-4D97-AF65-F5344CB8AC3E}">
-        <p14:creationId xmlns:p14="http://schemas.microsoft.com/office/powerpoint/2010/main" val="4211073618"/>
+        <p14:creationId xmlns:p14="http://schemas.microsoft.com/office/powerpoint/2010/main" val="1377118117"/>
       </p:ext>
     </p:extLst>
   </p:cSld>
@@ -2287,7 +2285,7 @@
           <a:p>
             <a:fld id="{86FBD32F-FCAD-481A-B7D8-4D813FB7DB24}" type="datetimeFigureOut">
               <a:rPr lang="en-IN" smtClean="0"/>
-              <a:t>17-06-2024</a:t>
+              <a:t>23-06-2024</a:t>
             </a:fld>
             <a:endParaRPr lang="en-IN"/>
           </a:p>
@@ -2338,7 +2336,7 @@
     </p:spTree>
     <p:extLst>
       <p:ext uri="{BB962C8B-B14F-4D97-AF65-F5344CB8AC3E}">
-        <p14:creationId xmlns:p14="http://schemas.microsoft.com/office/powerpoint/2010/main" val="4282904816"/>
+        <p14:creationId xmlns:p14="http://schemas.microsoft.com/office/powerpoint/2010/main" val="418015617"/>
       </p:ext>
     </p:extLst>
   </p:cSld>
@@ -2382,7 +2380,7 @@
           <a:p>
             <a:fld id="{86FBD32F-FCAD-481A-B7D8-4D813FB7DB24}" type="datetimeFigureOut">
               <a:rPr lang="en-IN" smtClean="0"/>
-              <a:t>17-06-2024</a:t>
+              <a:t>23-06-2024</a:t>
             </a:fld>
             <a:endParaRPr lang="en-IN"/>
           </a:p>
@@ -2433,7 +2431,7 @@
     </p:spTree>
     <p:extLst>
       <p:ext uri="{BB962C8B-B14F-4D97-AF65-F5344CB8AC3E}">
-        <p14:creationId xmlns:p14="http://schemas.microsoft.com/office/powerpoint/2010/main" val="694914933"/>
+        <p14:creationId xmlns:p14="http://schemas.microsoft.com/office/powerpoint/2010/main" val="843598295"/>
       </p:ext>
     </p:extLst>
   </p:cSld>
@@ -2472,15 +2470,15 @@
         </p:nvSpPr>
         <p:spPr>
           <a:xfrm>
-            <a:off x="1212992" y="660400"/>
-            <a:ext cx="5679727" cy="2311400"/>
+            <a:off x="682328" y="457200"/>
+            <a:ext cx="3194943" cy="1600200"/>
           </a:xfrm>
         </p:spPr>
         <p:txBody>
           <a:bodyPr anchor="b"/>
           <a:lstStyle>
             <a:lvl1pPr>
-              <a:defRPr sz="4622"/>
+              <a:defRPr sz="3200"/>
             </a:lvl1pPr>
           </a:lstStyle>
           <a:p>
@@ -2504,39 +2502,39 @@
         </p:nvSpPr>
         <p:spPr>
           <a:xfrm>
-            <a:off x="7486603" y="1426281"/>
-            <a:ext cx="8915132" cy="7039681"/>
+            <a:off x="4211340" y="987427"/>
+            <a:ext cx="5014913" cy="4873625"/>
           </a:xfrm>
         </p:spPr>
         <p:txBody>
           <a:bodyPr/>
           <a:lstStyle>
             <a:lvl1pPr>
-              <a:defRPr sz="4622"/>
+              <a:defRPr sz="3200"/>
             </a:lvl1pPr>
             <a:lvl2pPr>
-              <a:defRPr sz="4044"/>
+              <a:defRPr sz="2800"/>
             </a:lvl2pPr>
             <a:lvl3pPr>
-              <a:defRPr sz="3467"/>
+              <a:defRPr sz="2400"/>
             </a:lvl3pPr>
             <a:lvl4pPr>
-              <a:defRPr sz="2889"/>
+              <a:defRPr sz="2000"/>
             </a:lvl4pPr>
             <a:lvl5pPr>
-              <a:defRPr sz="2889"/>
+              <a:defRPr sz="2000"/>
             </a:lvl5pPr>
             <a:lvl6pPr>
-              <a:defRPr sz="2889"/>
+              <a:defRPr sz="2000"/>
             </a:lvl6pPr>
             <a:lvl7pPr>
-              <a:defRPr sz="2889"/>
+              <a:defRPr sz="2000"/>
             </a:lvl7pPr>
             <a:lvl8pPr>
-              <a:defRPr sz="2889"/>
+              <a:defRPr sz="2000"/>
             </a:lvl8pPr>
             <a:lvl9pPr>
-              <a:defRPr sz="2889"/>
+              <a:defRPr sz="2000"/>
             </a:lvl9pPr>
           </a:lstStyle>
           <a:p>
@@ -2589,8 +2587,8 @@
         </p:nvSpPr>
         <p:spPr>
           <a:xfrm>
-            <a:off x="1212992" y="2971800"/>
-            <a:ext cx="5679727" cy="5505627"/>
+            <a:off x="682328" y="2057400"/>
+            <a:ext cx="3194943" cy="3811588"/>
           </a:xfrm>
         </p:spPr>
         <p:txBody>
@@ -2598,39 +2596,39 @@
           <a:lstStyle>
             <a:lvl1pPr marL="0" indent="0">
               <a:buNone/>
-              <a:defRPr sz="2311"/>
+              <a:defRPr sz="1600"/>
             </a:lvl1pPr>
-            <a:lvl2pPr marL="660380" indent="0">
+            <a:lvl2pPr marL="457200" indent="0">
               <a:buNone/>
-              <a:defRPr sz="2022"/>
+              <a:defRPr sz="1400"/>
             </a:lvl2pPr>
-            <a:lvl3pPr marL="1320759" indent="0">
+            <a:lvl3pPr marL="914400" indent="0">
               <a:buNone/>
-              <a:defRPr sz="1733"/>
+              <a:defRPr sz="1200"/>
             </a:lvl3pPr>
-            <a:lvl4pPr marL="1981139" indent="0">
+            <a:lvl4pPr marL="1371600" indent="0">
               <a:buNone/>
-              <a:defRPr sz="1444"/>
+              <a:defRPr sz="1000"/>
             </a:lvl4pPr>
-            <a:lvl5pPr marL="2641519" indent="0">
+            <a:lvl5pPr marL="1828800" indent="0">
               <a:buNone/>
-              <a:defRPr sz="1444"/>
+              <a:defRPr sz="1000"/>
             </a:lvl5pPr>
-            <a:lvl6pPr marL="3301898" indent="0">
+            <a:lvl6pPr marL="2286000" indent="0">
               <a:buNone/>
-              <a:defRPr sz="1444"/>
+              <a:defRPr sz="1000"/>
             </a:lvl6pPr>
-            <a:lvl7pPr marL="3962278" indent="0">
+            <a:lvl7pPr marL="2743200" indent="0">
               <a:buNone/>
-              <a:defRPr sz="1444"/>
+              <a:defRPr sz="1000"/>
             </a:lvl7pPr>
-            <a:lvl8pPr marL="4622658" indent="0">
+            <a:lvl8pPr marL="3200400" indent="0">
               <a:buNone/>
-              <a:defRPr sz="1444"/>
+              <a:defRPr sz="1000"/>
             </a:lvl8pPr>
-            <a:lvl9pPr marL="5283037" indent="0">
+            <a:lvl9pPr marL="3657600" indent="0">
               <a:buNone/>
-              <a:defRPr sz="1444"/>
+              <a:defRPr sz="1000"/>
             </a:lvl9pPr>
           </a:lstStyle>
           <a:p>
@@ -2659,7 +2657,7 @@
           <a:p>
             <a:fld id="{86FBD32F-FCAD-481A-B7D8-4D813FB7DB24}" type="datetimeFigureOut">
               <a:rPr lang="en-IN" smtClean="0"/>
-              <a:t>17-06-2024</a:t>
+              <a:t>23-06-2024</a:t>
             </a:fld>
             <a:endParaRPr lang="en-IN"/>
           </a:p>
@@ -2710,7 +2708,7 @@
     </p:spTree>
     <p:extLst>
       <p:ext uri="{BB962C8B-B14F-4D97-AF65-F5344CB8AC3E}">
-        <p14:creationId xmlns:p14="http://schemas.microsoft.com/office/powerpoint/2010/main" val="3092988902"/>
+        <p14:creationId xmlns:p14="http://schemas.microsoft.com/office/powerpoint/2010/main" val="1072283981"/>
       </p:ext>
     </p:extLst>
   </p:cSld>
@@ -2749,15 +2747,15 @@
         </p:nvSpPr>
         <p:spPr>
           <a:xfrm>
-            <a:off x="1212992" y="660400"/>
-            <a:ext cx="5679727" cy="2311400"/>
+            <a:off x="682328" y="457200"/>
+            <a:ext cx="3194943" cy="1600200"/>
           </a:xfrm>
         </p:spPr>
         <p:txBody>
           <a:bodyPr anchor="b"/>
           <a:lstStyle>
             <a:lvl1pPr>
-              <a:defRPr sz="4622"/>
+              <a:defRPr sz="3200"/>
             </a:lvl1pPr>
           </a:lstStyle>
           <a:p>
@@ -2781,8 +2779,8 @@
         </p:nvSpPr>
         <p:spPr>
           <a:xfrm>
-            <a:off x="7486603" y="1426281"/>
-            <a:ext cx="8915132" cy="7039681"/>
+            <a:off x="4211340" y="987427"/>
+            <a:ext cx="5014913" cy="4873625"/>
           </a:xfrm>
         </p:spPr>
         <p:txBody>
@@ -2790,39 +2788,39 @@
           <a:lstStyle>
             <a:lvl1pPr marL="0" indent="0">
               <a:buNone/>
-              <a:defRPr sz="4622"/>
+              <a:defRPr sz="3200"/>
             </a:lvl1pPr>
-            <a:lvl2pPr marL="660380" indent="0">
+            <a:lvl2pPr marL="457200" indent="0">
               <a:buNone/>
-              <a:defRPr sz="4044"/>
+              <a:defRPr sz="2800"/>
             </a:lvl2pPr>
-            <a:lvl3pPr marL="1320759" indent="0">
+            <a:lvl3pPr marL="914400" indent="0">
               <a:buNone/>
-              <a:defRPr sz="3467"/>
+              <a:defRPr sz="2400"/>
             </a:lvl3pPr>
-            <a:lvl4pPr marL="1981139" indent="0">
+            <a:lvl4pPr marL="1371600" indent="0">
               <a:buNone/>
-              <a:defRPr sz="2889"/>
+              <a:defRPr sz="2000"/>
             </a:lvl4pPr>
-            <a:lvl5pPr marL="2641519" indent="0">
+            <a:lvl5pPr marL="1828800" indent="0">
               <a:buNone/>
-              <a:defRPr sz="2889"/>
+              <a:defRPr sz="2000"/>
             </a:lvl5pPr>
-            <a:lvl6pPr marL="3301898" indent="0">
+            <a:lvl6pPr marL="2286000" indent="0">
               <a:buNone/>
-              <a:defRPr sz="2889"/>
+              <a:defRPr sz="2000"/>
             </a:lvl6pPr>
-            <a:lvl7pPr marL="3962278" indent="0">
+            <a:lvl7pPr marL="2743200" indent="0">
               <a:buNone/>
-              <a:defRPr sz="2889"/>
+              <a:defRPr sz="2000"/>
             </a:lvl7pPr>
-            <a:lvl8pPr marL="4622658" indent="0">
+            <a:lvl8pPr marL="3200400" indent="0">
               <a:buNone/>
-              <a:defRPr sz="2889"/>
+              <a:defRPr sz="2000"/>
             </a:lvl8pPr>
-            <a:lvl9pPr marL="5283037" indent="0">
+            <a:lvl9pPr marL="3657600" indent="0">
               <a:buNone/>
-              <a:defRPr sz="2889"/>
+              <a:defRPr sz="2000"/>
             </a:lvl9pPr>
           </a:lstStyle>
           <a:p>
@@ -2846,8 +2844,8 @@
         </p:nvSpPr>
         <p:spPr>
           <a:xfrm>
-            <a:off x="1212992" y="2971800"/>
-            <a:ext cx="5679727" cy="5505627"/>
+            <a:off x="682328" y="2057400"/>
+            <a:ext cx="3194943" cy="3811588"/>
           </a:xfrm>
         </p:spPr>
         <p:txBody>
@@ -2855,39 +2853,39 @@
           <a:lstStyle>
             <a:lvl1pPr marL="0" indent="0">
               <a:buNone/>
-              <a:defRPr sz="2311"/>
+              <a:defRPr sz="1600"/>
             </a:lvl1pPr>
-            <a:lvl2pPr marL="660380" indent="0">
+            <a:lvl2pPr marL="457200" indent="0">
               <a:buNone/>
-              <a:defRPr sz="2022"/>
+              <a:defRPr sz="1400"/>
             </a:lvl2pPr>
-            <a:lvl3pPr marL="1320759" indent="0">
+            <a:lvl3pPr marL="914400" indent="0">
               <a:buNone/>
-              <a:defRPr sz="1733"/>
+              <a:defRPr sz="1200"/>
             </a:lvl3pPr>
-            <a:lvl4pPr marL="1981139" indent="0">
+            <a:lvl4pPr marL="1371600" indent="0">
               <a:buNone/>
-              <a:defRPr sz="1444"/>
+              <a:defRPr sz="1000"/>
             </a:lvl4pPr>
-            <a:lvl5pPr marL="2641519" indent="0">
+            <a:lvl5pPr marL="1828800" indent="0">
               <a:buNone/>
-              <a:defRPr sz="1444"/>
+              <a:defRPr sz="1000"/>
             </a:lvl5pPr>
-            <a:lvl6pPr marL="3301898" indent="0">
+            <a:lvl6pPr marL="2286000" indent="0">
               <a:buNone/>
-              <a:defRPr sz="1444"/>
+              <a:defRPr sz="1000"/>
             </a:lvl6pPr>
-            <a:lvl7pPr marL="3962278" indent="0">
+            <a:lvl7pPr marL="2743200" indent="0">
               <a:buNone/>
-              <a:defRPr sz="1444"/>
+              <a:defRPr sz="1000"/>
             </a:lvl7pPr>
-            <a:lvl8pPr marL="4622658" indent="0">
+            <a:lvl8pPr marL="3200400" indent="0">
               <a:buNone/>
-              <a:defRPr sz="1444"/>
+              <a:defRPr sz="1000"/>
             </a:lvl8pPr>
-            <a:lvl9pPr marL="5283037" indent="0">
+            <a:lvl9pPr marL="3657600" indent="0">
               <a:buNone/>
-              <a:defRPr sz="1444"/>
+              <a:defRPr sz="1000"/>
             </a:lvl9pPr>
           </a:lstStyle>
           <a:p>
@@ -2916,7 +2914,7 @@
           <a:p>
             <a:fld id="{86FBD32F-FCAD-481A-B7D8-4D813FB7DB24}" type="datetimeFigureOut">
               <a:rPr lang="en-IN" smtClean="0"/>
-              <a:t>17-06-2024</a:t>
+              <a:t>23-06-2024</a:t>
             </a:fld>
             <a:endParaRPr lang="en-IN"/>
           </a:p>
@@ -2967,7 +2965,7 @@
     </p:spTree>
     <p:extLst>
       <p:ext uri="{BB962C8B-B14F-4D97-AF65-F5344CB8AC3E}">
-        <p14:creationId xmlns:p14="http://schemas.microsoft.com/office/powerpoint/2010/main" val="3460959683"/>
+        <p14:creationId xmlns:p14="http://schemas.microsoft.com/office/powerpoint/2010/main" val="146369913"/>
       </p:ext>
     </p:extLst>
   </p:cSld>
@@ -3011,8 +3009,8 @@
         </p:nvSpPr>
         <p:spPr>
           <a:xfrm>
-            <a:off x="1210697" y="527404"/>
-            <a:ext cx="15188744" cy="1914702"/>
+            <a:off x="681038" y="365127"/>
+            <a:ext cx="8543925" cy="1325563"/>
           </a:xfrm>
           <a:prstGeom prst="rect">
             <a:avLst/>
@@ -3044,8 +3042,8 @@
         </p:nvSpPr>
         <p:spPr>
           <a:xfrm>
-            <a:off x="1210697" y="2637014"/>
-            <a:ext cx="15188744" cy="6285266"/>
+            <a:off x="681038" y="1825625"/>
+            <a:ext cx="8543925" cy="4351338"/>
           </a:xfrm>
           <a:prstGeom prst="rect">
             <a:avLst/>
@@ -3106,8 +3104,8 @@
         </p:nvSpPr>
         <p:spPr>
           <a:xfrm>
-            <a:off x="1210697" y="9181395"/>
-            <a:ext cx="3962281" cy="527403"/>
+            <a:off x="681038" y="6356352"/>
+            <a:ext cx="2228850" cy="365125"/>
           </a:xfrm>
           <a:prstGeom prst="rect">
             <a:avLst/>
@@ -3117,7 +3115,7 @@
           <a:bodyPr vert="horz" lIns="91440" tIns="45720" rIns="91440" bIns="45720" rtlCol="0" anchor="ctr"/>
           <a:lstStyle>
             <a:lvl1pPr algn="l">
-              <a:defRPr sz="1733">
+              <a:defRPr sz="1200">
                 <a:solidFill>
                   <a:schemeClr val="tx1">
                     <a:tint val="75000"/>
@@ -3129,7 +3127,7 @@
           <a:p>
             <a:fld id="{86FBD32F-FCAD-481A-B7D8-4D813FB7DB24}" type="datetimeFigureOut">
               <a:rPr lang="en-IN" smtClean="0"/>
-              <a:t>17-06-2024</a:t>
+              <a:t>23-06-2024</a:t>
             </a:fld>
             <a:endParaRPr lang="en-IN"/>
           </a:p>
@@ -3147,8 +3145,8 @@
         </p:nvSpPr>
         <p:spPr>
           <a:xfrm>
-            <a:off x="5833358" y="9181395"/>
-            <a:ext cx="5943422" cy="527403"/>
+            <a:off x="3281363" y="6356352"/>
+            <a:ext cx="3343275" cy="365125"/>
           </a:xfrm>
           <a:prstGeom prst="rect">
             <a:avLst/>
@@ -3158,7 +3156,7 @@
           <a:bodyPr vert="horz" lIns="91440" tIns="45720" rIns="91440" bIns="45720" rtlCol="0" anchor="ctr"/>
           <a:lstStyle>
             <a:lvl1pPr algn="ctr">
-              <a:defRPr sz="1733">
+              <a:defRPr sz="1200">
                 <a:solidFill>
                   <a:schemeClr val="tx1">
                     <a:tint val="75000"/>
@@ -3184,8 +3182,8 @@
         </p:nvSpPr>
         <p:spPr>
           <a:xfrm>
-            <a:off x="12437160" y="9181395"/>
-            <a:ext cx="3962281" cy="527403"/>
+            <a:off x="6996113" y="6356352"/>
+            <a:ext cx="2228850" cy="365125"/>
           </a:xfrm>
           <a:prstGeom prst="rect">
             <a:avLst/>
@@ -3195,7 +3193,7 @@
           <a:bodyPr vert="horz" lIns="91440" tIns="45720" rIns="91440" bIns="45720" rtlCol="0" anchor="ctr"/>
           <a:lstStyle>
             <a:lvl1pPr algn="r">
-              <a:defRPr sz="1733">
+              <a:defRPr sz="1200">
                 <a:solidFill>
                   <a:schemeClr val="tx1">
                     <a:tint val="75000"/>
@@ -3216,27 +3214,27 @@
     </p:spTree>
     <p:extLst>
       <p:ext uri="{BB962C8B-B14F-4D97-AF65-F5344CB8AC3E}">
-        <p14:creationId xmlns:p14="http://schemas.microsoft.com/office/powerpoint/2010/main" val="1467753994"/>
+        <p14:creationId xmlns:p14="http://schemas.microsoft.com/office/powerpoint/2010/main" val="3633701076"/>
       </p:ext>
     </p:extLst>
   </p:cSld>
   <p:clrMap bg1="lt1" tx1="dk1" bg2="lt2" tx2="dk2" accent1="accent1" accent2="accent2" accent3="accent3" accent4="accent4" accent5="accent5" accent6="accent6" hlink="hlink" folHlink="folHlink"/>
   <p:sldLayoutIdLst>
-    <p:sldLayoutId id="2147483673" r:id="rId1"/>
-    <p:sldLayoutId id="2147483674" r:id="rId2"/>
-    <p:sldLayoutId id="2147483675" r:id="rId3"/>
-    <p:sldLayoutId id="2147483676" r:id="rId4"/>
-    <p:sldLayoutId id="2147483677" r:id="rId5"/>
-    <p:sldLayoutId id="2147483678" r:id="rId6"/>
-    <p:sldLayoutId id="2147483679" r:id="rId7"/>
-    <p:sldLayoutId id="2147483680" r:id="rId8"/>
-    <p:sldLayoutId id="2147483681" r:id="rId9"/>
-    <p:sldLayoutId id="2147483682" r:id="rId10"/>
-    <p:sldLayoutId id="2147483683" r:id="rId11"/>
+    <p:sldLayoutId id="2147483709" r:id="rId1"/>
+    <p:sldLayoutId id="2147483710" r:id="rId2"/>
+    <p:sldLayoutId id="2147483711" r:id="rId3"/>
+    <p:sldLayoutId id="2147483712" r:id="rId4"/>
+    <p:sldLayoutId id="2147483713" r:id="rId5"/>
+    <p:sldLayoutId id="2147483714" r:id="rId6"/>
+    <p:sldLayoutId id="2147483715" r:id="rId7"/>
+    <p:sldLayoutId id="2147483716" r:id="rId8"/>
+    <p:sldLayoutId id="2147483717" r:id="rId9"/>
+    <p:sldLayoutId id="2147483718" r:id="rId10"/>
+    <p:sldLayoutId id="2147483719" r:id="rId11"/>
   </p:sldLayoutIdLst>
   <p:txStyles>
     <p:titleStyle>
-      <a:lvl1pPr algn="l" defTabSz="1320759" rtl="0" eaLnBrk="1" latinLnBrk="0" hangingPunct="1">
+      <a:lvl1pPr algn="l" defTabSz="914400" rtl="0" eaLnBrk="1" latinLnBrk="0" hangingPunct="1">
         <a:lnSpc>
           <a:spcPct val="90000"/>
         </a:lnSpc>
@@ -3244,7 +3242,7 @@
           <a:spcPct val="0"/>
         </a:spcBef>
         <a:buNone/>
-        <a:defRPr sz="6355" kern="1200">
+        <a:defRPr sz="4400" kern="1200">
           <a:solidFill>
             <a:schemeClr val="tx1"/>
           </a:solidFill>
@@ -3255,16 +3253,16 @@
       </a:lvl1pPr>
     </p:titleStyle>
     <p:bodyStyle>
-      <a:lvl1pPr marL="330190" indent="-330190" algn="l" defTabSz="1320759" rtl="0" eaLnBrk="1" latinLnBrk="0" hangingPunct="1">
+      <a:lvl1pPr marL="228600" indent="-228600" algn="l" defTabSz="914400" rtl="0" eaLnBrk="1" latinLnBrk="0" hangingPunct="1">
         <a:lnSpc>
           <a:spcPct val="90000"/>
         </a:lnSpc>
         <a:spcBef>
-          <a:spcPts val="1444"/>
+          <a:spcPts val="1000"/>
         </a:spcBef>
         <a:buFont typeface="Arial" panose="020B0604020202020204" pitchFamily="34" charset="0"/>
         <a:buChar char="•"/>
-        <a:defRPr sz="4044" kern="1200">
+        <a:defRPr sz="2800" kern="1200">
           <a:solidFill>
             <a:schemeClr val="tx1"/>
           </a:solidFill>
@@ -3273,16 +3271,16 @@
           <a:cs typeface="+mn-cs"/>
         </a:defRPr>
       </a:lvl1pPr>
-      <a:lvl2pPr marL="990570" indent="-330190" algn="l" defTabSz="1320759" rtl="0" eaLnBrk="1" latinLnBrk="0" hangingPunct="1">
+      <a:lvl2pPr marL="685800" indent="-228600" algn="l" defTabSz="914400" rtl="0" eaLnBrk="1" latinLnBrk="0" hangingPunct="1">
         <a:lnSpc>
           <a:spcPct val="90000"/>
         </a:lnSpc>
         <a:spcBef>
-          <a:spcPts val="722"/>
+          <a:spcPts val="500"/>
         </a:spcBef>
         <a:buFont typeface="Arial" panose="020B0604020202020204" pitchFamily="34" charset="0"/>
         <a:buChar char="•"/>
-        <a:defRPr sz="3467" kern="1200">
+        <a:defRPr sz="2400" kern="1200">
           <a:solidFill>
             <a:schemeClr val="tx1"/>
           </a:solidFill>
@@ -3291,16 +3289,16 @@
           <a:cs typeface="+mn-cs"/>
         </a:defRPr>
       </a:lvl2pPr>
-      <a:lvl3pPr marL="1650949" indent="-330190" algn="l" defTabSz="1320759" rtl="0" eaLnBrk="1" latinLnBrk="0" hangingPunct="1">
+      <a:lvl3pPr marL="1143000" indent="-228600" algn="l" defTabSz="914400" rtl="0" eaLnBrk="1" latinLnBrk="0" hangingPunct="1">
         <a:lnSpc>
           <a:spcPct val="90000"/>
         </a:lnSpc>
         <a:spcBef>
-          <a:spcPts val="722"/>
+          <a:spcPts val="500"/>
         </a:spcBef>
         <a:buFont typeface="Arial" panose="020B0604020202020204" pitchFamily="34" charset="0"/>
         <a:buChar char="•"/>
-        <a:defRPr sz="2889" kern="1200">
+        <a:defRPr sz="2000" kern="1200">
           <a:solidFill>
             <a:schemeClr val="tx1"/>
           </a:solidFill>
@@ -3309,16 +3307,16 @@
           <a:cs typeface="+mn-cs"/>
         </a:defRPr>
       </a:lvl3pPr>
-      <a:lvl4pPr marL="2311329" indent="-330190" algn="l" defTabSz="1320759" rtl="0" eaLnBrk="1" latinLnBrk="0" hangingPunct="1">
+      <a:lvl4pPr marL="1600200" indent="-228600" algn="l" defTabSz="914400" rtl="0" eaLnBrk="1" latinLnBrk="0" hangingPunct="1">
         <a:lnSpc>
           <a:spcPct val="90000"/>
         </a:lnSpc>
         <a:spcBef>
-          <a:spcPts val="722"/>
+          <a:spcPts val="500"/>
         </a:spcBef>
         <a:buFont typeface="Arial" panose="020B0604020202020204" pitchFamily="34" charset="0"/>
         <a:buChar char="•"/>
-        <a:defRPr sz="2600" kern="1200">
+        <a:defRPr sz="1800" kern="1200">
           <a:solidFill>
             <a:schemeClr val="tx1"/>
           </a:solidFill>
@@ -3327,16 +3325,16 @@
           <a:cs typeface="+mn-cs"/>
         </a:defRPr>
       </a:lvl4pPr>
-      <a:lvl5pPr marL="2971709" indent="-330190" algn="l" defTabSz="1320759" rtl="0" eaLnBrk="1" latinLnBrk="0" hangingPunct="1">
+      <a:lvl5pPr marL="2057400" indent="-228600" algn="l" defTabSz="914400" rtl="0" eaLnBrk="1" latinLnBrk="0" hangingPunct="1">
         <a:lnSpc>
           <a:spcPct val="90000"/>
         </a:lnSpc>
         <a:spcBef>
-          <a:spcPts val="722"/>
+          <a:spcPts val="500"/>
         </a:spcBef>
         <a:buFont typeface="Arial" panose="020B0604020202020204" pitchFamily="34" charset="0"/>
         <a:buChar char="•"/>
-        <a:defRPr sz="2600" kern="1200">
+        <a:defRPr sz="1800" kern="1200">
           <a:solidFill>
             <a:schemeClr val="tx1"/>
           </a:solidFill>
@@ -3345,16 +3343,16 @@
           <a:cs typeface="+mn-cs"/>
         </a:defRPr>
       </a:lvl5pPr>
-      <a:lvl6pPr marL="3632088" indent="-330190" algn="l" defTabSz="1320759" rtl="0" eaLnBrk="1" latinLnBrk="0" hangingPunct="1">
+      <a:lvl6pPr marL="2514600" indent="-228600" algn="l" defTabSz="914400" rtl="0" eaLnBrk="1" latinLnBrk="0" hangingPunct="1">
         <a:lnSpc>
           <a:spcPct val="90000"/>
         </a:lnSpc>
         <a:spcBef>
-          <a:spcPts val="722"/>
+          <a:spcPts val="500"/>
         </a:spcBef>
         <a:buFont typeface="Arial" panose="020B0604020202020204" pitchFamily="34" charset="0"/>
         <a:buChar char="•"/>
-        <a:defRPr sz="2600" kern="1200">
+        <a:defRPr sz="1800" kern="1200">
           <a:solidFill>
             <a:schemeClr val="tx1"/>
           </a:solidFill>
@@ -3363,16 +3361,16 @@
           <a:cs typeface="+mn-cs"/>
         </a:defRPr>
       </a:lvl6pPr>
-      <a:lvl7pPr marL="4292468" indent="-330190" algn="l" defTabSz="1320759" rtl="0" eaLnBrk="1" latinLnBrk="0" hangingPunct="1">
+      <a:lvl7pPr marL="2971800" indent="-228600" algn="l" defTabSz="914400" rtl="0" eaLnBrk="1" latinLnBrk="0" hangingPunct="1">
         <a:lnSpc>
           <a:spcPct val="90000"/>
         </a:lnSpc>
         <a:spcBef>
-          <a:spcPts val="722"/>
+          <a:spcPts val="500"/>
         </a:spcBef>
         <a:buFont typeface="Arial" panose="020B0604020202020204" pitchFamily="34" charset="0"/>
         <a:buChar char="•"/>
-        <a:defRPr sz="2600" kern="1200">
+        <a:defRPr sz="1800" kern="1200">
           <a:solidFill>
             <a:schemeClr val="tx1"/>
           </a:solidFill>
@@ -3381,16 +3379,16 @@
           <a:cs typeface="+mn-cs"/>
         </a:defRPr>
       </a:lvl7pPr>
-      <a:lvl8pPr marL="4952848" indent="-330190" algn="l" defTabSz="1320759" rtl="0" eaLnBrk="1" latinLnBrk="0" hangingPunct="1">
+      <a:lvl8pPr marL="3429000" indent="-228600" algn="l" defTabSz="914400" rtl="0" eaLnBrk="1" latinLnBrk="0" hangingPunct="1">
         <a:lnSpc>
           <a:spcPct val="90000"/>
         </a:lnSpc>
         <a:spcBef>
-          <a:spcPts val="722"/>
+          <a:spcPts val="500"/>
         </a:spcBef>
         <a:buFont typeface="Arial" panose="020B0604020202020204" pitchFamily="34" charset="0"/>
         <a:buChar char="•"/>
-        <a:defRPr sz="2600" kern="1200">
+        <a:defRPr sz="1800" kern="1200">
           <a:solidFill>
             <a:schemeClr val="tx1"/>
           </a:solidFill>
@@ -3399,16 +3397,16 @@
           <a:cs typeface="+mn-cs"/>
         </a:defRPr>
       </a:lvl8pPr>
-      <a:lvl9pPr marL="5613227" indent="-330190" algn="l" defTabSz="1320759" rtl="0" eaLnBrk="1" latinLnBrk="0" hangingPunct="1">
+      <a:lvl9pPr marL="3886200" indent="-228600" algn="l" defTabSz="914400" rtl="0" eaLnBrk="1" latinLnBrk="0" hangingPunct="1">
         <a:lnSpc>
           <a:spcPct val="90000"/>
         </a:lnSpc>
         <a:spcBef>
-          <a:spcPts val="722"/>
+          <a:spcPts val="500"/>
         </a:spcBef>
         <a:buFont typeface="Arial" panose="020B0604020202020204" pitchFamily="34" charset="0"/>
         <a:buChar char="•"/>
-        <a:defRPr sz="2600" kern="1200">
+        <a:defRPr sz="1800" kern="1200">
           <a:solidFill>
             <a:schemeClr val="tx1"/>
           </a:solidFill>
@@ -3422,8 +3420,8 @@
       <a:defPPr>
         <a:defRPr lang="en-US"/>
       </a:defPPr>
-      <a:lvl1pPr marL="0" algn="l" defTabSz="1320759" rtl="0" eaLnBrk="1" latinLnBrk="0" hangingPunct="1">
-        <a:defRPr sz="2600" kern="1200">
+      <a:lvl1pPr marL="0" algn="l" defTabSz="914400" rtl="0" eaLnBrk="1" latinLnBrk="0" hangingPunct="1">
+        <a:defRPr sz="1800" kern="1200">
           <a:solidFill>
             <a:schemeClr val="tx1"/>
           </a:solidFill>
@@ -3432,8 +3430,8 @@
           <a:cs typeface="+mn-cs"/>
         </a:defRPr>
       </a:lvl1pPr>
-      <a:lvl2pPr marL="660380" algn="l" defTabSz="1320759" rtl="0" eaLnBrk="1" latinLnBrk="0" hangingPunct="1">
-        <a:defRPr sz="2600" kern="1200">
+      <a:lvl2pPr marL="457200" algn="l" defTabSz="914400" rtl="0" eaLnBrk="1" latinLnBrk="0" hangingPunct="1">
+        <a:defRPr sz="1800" kern="1200">
           <a:solidFill>
             <a:schemeClr val="tx1"/>
           </a:solidFill>
@@ -3442,8 +3440,8 @@
           <a:cs typeface="+mn-cs"/>
         </a:defRPr>
       </a:lvl2pPr>
-      <a:lvl3pPr marL="1320759" algn="l" defTabSz="1320759" rtl="0" eaLnBrk="1" latinLnBrk="0" hangingPunct="1">
-        <a:defRPr sz="2600" kern="1200">
+      <a:lvl3pPr marL="914400" algn="l" defTabSz="914400" rtl="0" eaLnBrk="1" latinLnBrk="0" hangingPunct="1">
+        <a:defRPr sz="1800" kern="1200">
           <a:solidFill>
             <a:schemeClr val="tx1"/>
           </a:solidFill>
@@ -3452,8 +3450,8 @@
           <a:cs typeface="+mn-cs"/>
         </a:defRPr>
       </a:lvl3pPr>
-      <a:lvl4pPr marL="1981139" algn="l" defTabSz="1320759" rtl="0" eaLnBrk="1" latinLnBrk="0" hangingPunct="1">
-        <a:defRPr sz="2600" kern="1200">
+      <a:lvl4pPr marL="1371600" algn="l" defTabSz="914400" rtl="0" eaLnBrk="1" latinLnBrk="0" hangingPunct="1">
+        <a:defRPr sz="1800" kern="1200">
           <a:solidFill>
             <a:schemeClr val="tx1"/>
           </a:solidFill>
@@ -3462,8 +3460,8 @@
           <a:cs typeface="+mn-cs"/>
         </a:defRPr>
       </a:lvl4pPr>
-      <a:lvl5pPr marL="2641519" algn="l" defTabSz="1320759" rtl="0" eaLnBrk="1" latinLnBrk="0" hangingPunct="1">
-        <a:defRPr sz="2600" kern="1200">
+      <a:lvl5pPr marL="1828800" algn="l" defTabSz="914400" rtl="0" eaLnBrk="1" latinLnBrk="0" hangingPunct="1">
+        <a:defRPr sz="1800" kern="1200">
           <a:solidFill>
             <a:schemeClr val="tx1"/>
           </a:solidFill>
@@ -3472,8 +3470,8 @@
           <a:cs typeface="+mn-cs"/>
         </a:defRPr>
       </a:lvl5pPr>
-      <a:lvl6pPr marL="3301898" algn="l" defTabSz="1320759" rtl="0" eaLnBrk="1" latinLnBrk="0" hangingPunct="1">
-        <a:defRPr sz="2600" kern="1200">
+      <a:lvl6pPr marL="2286000" algn="l" defTabSz="914400" rtl="0" eaLnBrk="1" latinLnBrk="0" hangingPunct="1">
+        <a:defRPr sz="1800" kern="1200">
           <a:solidFill>
             <a:schemeClr val="tx1"/>
           </a:solidFill>
@@ -3482,8 +3480,8 @@
           <a:cs typeface="+mn-cs"/>
         </a:defRPr>
       </a:lvl6pPr>
-      <a:lvl7pPr marL="3962278" algn="l" defTabSz="1320759" rtl="0" eaLnBrk="1" latinLnBrk="0" hangingPunct="1">
-        <a:defRPr sz="2600" kern="1200">
+      <a:lvl7pPr marL="2743200" algn="l" defTabSz="914400" rtl="0" eaLnBrk="1" latinLnBrk="0" hangingPunct="1">
+        <a:defRPr sz="1800" kern="1200">
           <a:solidFill>
             <a:schemeClr val="tx1"/>
           </a:solidFill>
@@ -3492,8 +3490,8 @@
           <a:cs typeface="+mn-cs"/>
         </a:defRPr>
       </a:lvl7pPr>
-      <a:lvl8pPr marL="4622658" algn="l" defTabSz="1320759" rtl="0" eaLnBrk="1" latinLnBrk="0" hangingPunct="1">
-        <a:defRPr sz="2600" kern="1200">
+      <a:lvl8pPr marL="3200400" algn="l" defTabSz="914400" rtl="0" eaLnBrk="1" latinLnBrk="0" hangingPunct="1">
+        <a:defRPr sz="1800" kern="1200">
           <a:solidFill>
             <a:schemeClr val="tx1"/>
           </a:solidFill>
@@ -3502,8 +3500,8 @@
           <a:cs typeface="+mn-cs"/>
         </a:defRPr>
       </a:lvl8pPr>
-      <a:lvl9pPr marL="5283037" algn="l" defTabSz="1320759" rtl="0" eaLnBrk="1" latinLnBrk="0" hangingPunct="1">
-        <a:defRPr sz="2600" kern="1200">
+      <a:lvl9pPr marL="3657600" algn="l" defTabSz="914400" rtl="0" eaLnBrk="1" latinLnBrk="0" hangingPunct="1">
+        <a:defRPr sz="1800" kern="1200">
           <a:solidFill>
             <a:schemeClr val="tx1"/>
           </a:solidFill>
@@ -3548,8 +3546,8 @@
         </p:nvSpPr>
         <p:spPr>
           <a:xfrm>
-            <a:off x="5427201" y="125663"/>
-            <a:ext cx="3377868" cy="4752474"/>
+            <a:off x="3334022" y="1115306"/>
+            <a:ext cx="1618978" cy="2277813"/>
           </a:xfrm>
           <a:prstGeom prst="rect">
             <a:avLst/>
@@ -3587,7 +3585,7 @@
           <a:p>
             <a:pPr algn="ctr"/>
             <a:r>
-              <a:rPr lang="te-IN" sz="1750" dirty="0">
+              <a:rPr lang="te-IN" sz="839" dirty="0">
                 <a:solidFill>
                   <a:schemeClr val="tx1"/>
                 </a:solidFill>
@@ -3596,7 +3594,7 @@
               </a:rPr>
               <a:t>స్తుతి గానములతో నేను –</a:t>
             </a:r>
-            <a:endParaRPr lang="en-IN" sz="1750" dirty="0">
+            <a:endParaRPr lang="en-IN" sz="839" dirty="0">
               <a:solidFill>
                 <a:schemeClr val="tx1"/>
               </a:solidFill>
@@ -3607,7 +3605,7 @@
           <a:p>
             <a:pPr algn="ctr"/>
             <a:r>
-              <a:rPr lang="te-IN" sz="1750" dirty="0">
+              <a:rPr lang="te-IN" sz="839" dirty="0">
                 <a:solidFill>
                   <a:schemeClr val="tx1"/>
                 </a:solidFill>
@@ -3620,7 +3618,7 @@
           <a:p>
             <a:pPr algn="ctr"/>
             <a:r>
-              <a:rPr lang="te-IN" sz="1750" dirty="0">
+              <a:rPr lang="te-IN" sz="839" dirty="0">
                 <a:solidFill>
                   <a:schemeClr val="tx1"/>
                 </a:solidFill>
@@ -3630,7 +3628,7 @@
               <a:t>నీ జీవితమంతా ప్రభు కొరకై</a:t>
             </a:r>
             <a:r>
-              <a:rPr lang="en-IN" sz="1750" dirty="0">
+              <a:rPr lang="en-IN" sz="839" dirty="0">
                 <a:solidFill>
                   <a:schemeClr val="tx1"/>
                 </a:solidFill>
@@ -3640,7 +3638,7 @@
               <a:t> </a:t>
             </a:r>
             <a:r>
-              <a:rPr lang="te-IN" sz="1750" dirty="0">
+              <a:rPr lang="te-IN" sz="839" dirty="0">
                 <a:solidFill>
                   <a:schemeClr val="tx1"/>
                 </a:solidFill>
@@ -3649,7 +3647,7 @@
               </a:rPr>
               <a:t>-</a:t>
             </a:r>
-            <a:endParaRPr lang="en-IN" sz="1750" dirty="0">
+            <a:endParaRPr lang="en-IN" sz="839" dirty="0">
               <a:solidFill>
                 <a:schemeClr val="tx1"/>
               </a:solidFill>
@@ -3660,7 +3658,7 @@
           <a:p>
             <a:pPr algn="ctr"/>
             <a:r>
-              <a:rPr lang="te-IN" sz="1750" dirty="0">
+              <a:rPr lang="te-IN" sz="839" dirty="0">
                 <a:solidFill>
                   <a:schemeClr val="tx1"/>
                 </a:solidFill>
@@ -3673,7 +3671,7 @@
           <a:p>
             <a:pPr algn="ctr"/>
             <a:r>
-              <a:rPr lang="te-IN" sz="1750" dirty="0">
+              <a:rPr lang="te-IN" sz="839" dirty="0">
                 <a:solidFill>
                   <a:schemeClr val="tx1"/>
                 </a:solidFill>
@@ -3685,7 +3683,7 @@
           </a:p>
           <a:p>
             <a:pPr algn="ctr"/>
-            <a:endParaRPr lang="te-IN" sz="1750" dirty="0">
+            <a:endParaRPr lang="te-IN" sz="839" dirty="0">
               <a:solidFill>
                 <a:schemeClr val="tx1"/>
               </a:solidFill>
@@ -3696,7 +3694,7 @@
           <a:p>
             <a:pPr algn="ctr"/>
             <a:r>
-              <a:rPr lang="te-IN" sz="1750" dirty="0">
+              <a:rPr lang="te-IN" sz="839" dirty="0">
                 <a:solidFill>
                   <a:schemeClr val="tx1"/>
                 </a:solidFill>
@@ -3709,7 +3707,7 @@
           <a:p>
             <a:pPr algn="ctr"/>
             <a:r>
-              <a:rPr lang="te-IN" sz="1750" dirty="0">
+              <a:rPr lang="te-IN" sz="839" dirty="0">
                 <a:solidFill>
                   <a:schemeClr val="tx1"/>
                 </a:solidFill>
@@ -3722,7 +3720,7 @@
           <a:p>
             <a:pPr algn="ctr"/>
             <a:r>
-              <a:rPr lang="te-IN" sz="1750" dirty="0">
+              <a:rPr lang="te-IN" sz="839" dirty="0">
                 <a:solidFill>
                   <a:schemeClr val="tx1"/>
                 </a:solidFill>
@@ -3732,7 +3730,7 @@
               <a:t>నీ ప్రేమలో ... నీ నీడలో</a:t>
             </a:r>
             <a:r>
-              <a:rPr lang="en-IN" sz="1750" dirty="0">
+              <a:rPr lang="en-IN" sz="839" dirty="0">
                 <a:solidFill>
                   <a:schemeClr val="tx1"/>
                 </a:solidFill>
@@ -3742,7 +3740,7 @@
               <a:t> </a:t>
             </a:r>
             <a:r>
-              <a:rPr lang="te-IN" sz="1750" dirty="0">
+              <a:rPr lang="te-IN" sz="839" dirty="0">
                 <a:solidFill>
                   <a:schemeClr val="tx1"/>
                 </a:solidFill>
@@ -3751,7 +3749,7 @@
               </a:rPr>
               <a:t>నిలుపుము</a:t>
             </a:r>
-            <a:endParaRPr lang="en-IN" sz="1750" dirty="0">
+            <a:endParaRPr lang="en-IN" sz="839" dirty="0">
               <a:solidFill>
                 <a:schemeClr val="tx1"/>
               </a:solidFill>
@@ -3762,7 +3760,7 @@
           <a:p>
             <a:pPr algn="ctr"/>
             <a:r>
-              <a:rPr lang="te-IN" sz="1750" dirty="0">
+              <a:rPr lang="te-IN" sz="839" dirty="0">
                 <a:solidFill>
                   <a:schemeClr val="tx1"/>
                 </a:solidFill>
@@ -3774,7 +3772,7 @@
           </a:p>
           <a:p>
             <a:pPr algn="ctr"/>
-            <a:endParaRPr lang="te-IN" sz="1750" dirty="0">
+            <a:endParaRPr lang="te-IN" sz="839" dirty="0">
               <a:solidFill>
                 <a:schemeClr val="tx1"/>
               </a:solidFill>
@@ -3785,7 +3783,7 @@
           <a:p>
             <a:pPr algn="ctr"/>
             <a:r>
-              <a:rPr lang="te-IN" sz="1750" dirty="0">
+              <a:rPr lang="te-IN" sz="839" dirty="0">
                 <a:solidFill>
                   <a:schemeClr val="tx1"/>
                 </a:solidFill>
@@ -3794,7 +3792,7 @@
               </a:rPr>
               <a:t>లోకమంత నీరాకకై</a:t>
             </a:r>
-            <a:endParaRPr lang="en-IN" sz="1750" dirty="0">
+            <a:endParaRPr lang="en-IN" sz="839" dirty="0">
               <a:solidFill>
                 <a:schemeClr val="tx1"/>
               </a:solidFill>
@@ -3805,7 +3803,7 @@
           <a:p>
             <a:pPr algn="ctr"/>
             <a:r>
-              <a:rPr lang="te-IN" sz="1750" dirty="0">
+              <a:rPr lang="te-IN" sz="839" dirty="0">
                 <a:solidFill>
                   <a:schemeClr val="tx1"/>
                 </a:solidFill>
@@ -3818,7 +3816,7 @@
           <a:p>
             <a:pPr algn="ctr"/>
             <a:r>
-              <a:rPr lang="te-IN" sz="1750" dirty="0">
+              <a:rPr lang="te-IN" sz="839" dirty="0">
                 <a:solidFill>
                   <a:schemeClr val="tx1"/>
                 </a:solidFill>
@@ -3827,7 +3825,7 @@
               </a:rPr>
               <a:t>మేఘ వాహనంబు మీద</a:t>
             </a:r>
-            <a:endParaRPr lang="en-IN" sz="1750" dirty="0">
+            <a:endParaRPr lang="en-IN" sz="839" dirty="0">
               <a:solidFill>
                 <a:schemeClr val="tx1"/>
               </a:solidFill>
@@ -3838,7 +3836,7 @@
           <a:p>
             <a:pPr algn="ctr"/>
             <a:r>
-              <a:rPr lang="te-IN" sz="1750" dirty="0">
+              <a:rPr lang="te-IN" sz="839" dirty="0">
                 <a:solidFill>
                   <a:schemeClr val="tx1"/>
                 </a:solidFill>
@@ -3851,7 +3849,7 @@
           <a:p>
             <a:pPr algn="ctr"/>
             <a:r>
-              <a:rPr lang="te-IN" sz="1750" dirty="0">
+              <a:rPr lang="te-IN" sz="839" dirty="0">
                 <a:solidFill>
                   <a:schemeClr val="tx1"/>
                 </a:solidFill>
@@ -3860,7 +3858,7 @@
               </a:rPr>
               <a:t>వేవేగమే రానైయున్న రారాజా-</a:t>
             </a:r>
-            <a:endParaRPr lang="en-IN" sz="1750" dirty="0">
+            <a:endParaRPr lang="en-IN" sz="839" dirty="0">
               <a:solidFill>
                 <a:schemeClr val="tx1"/>
               </a:solidFill>
@@ -3871,7 +3869,7 @@
           <a:p>
             <a:pPr algn="ctr"/>
             <a:r>
-              <a:rPr lang="te-IN" sz="1750" dirty="0">
+              <a:rPr lang="te-IN" sz="839" dirty="0">
                 <a:solidFill>
                   <a:schemeClr val="tx1"/>
                 </a:solidFill>
@@ -3897,8 +3895,8 @@
         </p:nvSpPr>
         <p:spPr>
           <a:xfrm>
-            <a:off x="5427201" y="4874508"/>
-            <a:ext cx="3377868" cy="4752474"/>
+            <a:off x="3334022" y="3391380"/>
+            <a:ext cx="1618978" cy="2277813"/>
           </a:xfrm>
           <a:prstGeom prst="rect">
             <a:avLst/>
@@ -3936,7 +3934,7 @@
           <a:p>
             <a:pPr algn="ctr"/>
             <a:r>
-              <a:rPr lang="te-IN" dirty="0">
+              <a:rPr lang="te-IN" sz="863" dirty="0">
                 <a:solidFill>
                   <a:srgbClr val="000000"/>
                 </a:solidFill>
@@ -3949,7 +3947,7 @@
           <a:p>
             <a:pPr algn="ctr"/>
             <a:r>
-              <a:rPr lang="te-IN" dirty="0">
+              <a:rPr lang="te-IN" sz="863" dirty="0">
                 <a:solidFill>
                   <a:srgbClr val="000000"/>
                 </a:solidFill>
@@ -3962,7 +3960,7 @@
           <a:p>
             <a:pPr algn="ctr"/>
             <a:r>
-              <a:rPr lang="te-IN" dirty="0">
+              <a:rPr lang="te-IN" sz="863" dirty="0">
                 <a:solidFill>
                   <a:srgbClr val="000000"/>
                 </a:solidFill>
@@ -3975,7 +3973,7 @@
           <a:p>
             <a:pPr algn="ctr"/>
             <a:r>
-              <a:rPr lang="te-IN" dirty="0">
+              <a:rPr lang="te-IN" sz="863" dirty="0">
                 <a:solidFill>
                   <a:srgbClr val="000000"/>
                 </a:solidFill>
@@ -3987,7 +3985,7 @@
           </a:p>
           <a:p>
             <a:pPr algn="ctr"/>
-            <a:endParaRPr lang="te-IN" dirty="0">
+            <a:endParaRPr lang="te-IN" sz="863" dirty="0">
               <a:solidFill>
                 <a:srgbClr val="000000"/>
               </a:solidFill>
@@ -3998,7 +3996,7 @@
           <a:p>
             <a:pPr algn="ctr"/>
             <a:r>
-              <a:rPr lang="te-IN" dirty="0">
+              <a:rPr lang="te-IN" sz="863" dirty="0">
                 <a:solidFill>
                   <a:srgbClr val="000000"/>
                 </a:solidFill>
@@ -4007,7 +4005,7 @@
               </a:rPr>
               <a:t>లోకములో నీ కొరకు</a:t>
             </a:r>
-            <a:endParaRPr lang="en-US" dirty="0">
+            <a:endParaRPr lang="en-US" sz="863" dirty="0">
               <a:solidFill>
                 <a:srgbClr val="000000"/>
               </a:solidFill>
@@ -4018,7 +4016,7 @@
           <a:p>
             <a:pPr algn="ctr"/>
             <a:r>
-              <a:rPr lang="te-IN" dirty="0">
+              <a:rPr lang="te-IN" sz="863" dirty="0">
                 <a:solidFill>
                   <a:srgbClr val="000000"/>
                 </a:solidFill>
@@ -4031,7 +4029,7 @@
           <a:p>
             <a:pPr algn="ctr"/>
             <a:r>
-              <a:rPr lang="te-IN" dirty="0">
+              <a:rPr lang="te-IN" sz="863" dirty="0">
                 <a:solidFill>
                   <a:srgbClr val="000000"/>
                 </a:solidFill>
@@ -4040,7 +4038,7 @@
               </a:rPr>
               <a:t>రెండవ రాకడవరకు</a:t>
             </a:r>
-            <a:endParaRPr lang="en-US" dirty="0">
+            <a:endParaRPr lang="en-US" sz="863" dirty="0">
               <a:solidFill>
                 <a:srgbClr val="000000"/>
               </a:solidFill>
@@ -4051,7 +4049,7 @@
           <a:p>
             <a:pPr algn="ctr"/>
             <a:r>
-              <a:rPr lang="te-IN" dirty="0">
+              <a:rPr lang="te-IN" sz="863" dirty="0">
                 <a:solidFill>
                   <a:srgbClr val="000000"/>
                 </a:solidFill>
@@ -4063,7 +4061,7 @@
           </a:p>
           <a:p>
             <a:pPr algn="ctr"/>
-            <a:endParaRPr lang="te-IN" dirty="0">
+            <a:endParaRPr lang="te-IN" sz="863" dirty="0">
               <a:solidFill>
                 <a:srgbClr val="000000"/>
               </a:solidFill>
@@ -4074,7 +4072,7 @@
           <a:p>
             <a:pPr algn="ctr"/>
             <a:r>
-              <a:rPr lang="te-IN" dirty="0">
+              <a:rPr lang="te-IN" sz="863" dirty="0">
                 <a:solidFill>
                   <a:srgbClr val="000000"/>
                 </a:solidFill>
@@ -4083,7 +4081,7 @@
               </a:rPr>
               <a:t>నా దినముల పరిమాణం</a:t>
             </a:r>
-            <a:endParaRPr lang="en-US" dirty="0">
+            <a:endParaRPr lang="en-US" sz="863" dirty="0">
               <a:solidFill>
                 <a:srgbClr val="000000"/>
               </a:solidFill>
@@ -4094,7 +4092,7 @@
           <a:p>
             <a:pPr algn="ctr"/>
             <a:r>
-              <a:rPr lang="te-IN" dirty="0">
+              <a:rPr lang="te-IN" sz="863" dirty="0">
                 <a:solidFill>
                   <a:srgbClr val="000000"/>
                 </a:solidFill>
@@ -4107,7 +4105,7 @@
           <a:p>
             <a:pPr algn="ctr"/>
             <a:r>
-              <a:rPr lang="te-IN" dirty="0">
+              <a:rPr lang="te-IN" sz="863" dirty="0">
                 <a:solidFill>
                   <a:srgbClr val="000000"/>
                 </a:solidFill>
@@ -4120,7 +4118,7 @@
           <a:p>
             <a:pPr algn="ctr"/>
             <a:r>
-              <a:rPr lang="te-IN" dirty="0">
+              <a:rPr lang="te-IN" sz="863" dirty="0">
                 <a:solidFill>
                   <a:srgbClr val="000000"/>
                 </a:solidFill>
@@ -4146,8 +4144,8 @@
         </p:nvSpPr>
         <p:spPr>
           <a:xfrm>
-            <a:off x="8805069" y="129292"/>
-            <a:ext cx="3377868" cy="4752474"/>
+            <a:off x="4953000" y="1117045"/>
+            <a:ext cx="1618978" cy="2277813"/>
           </a:xfrm>
           <a:prstGeom prst="rect">
             <a:avLst/>
@@ -4185,7 +4183,7 @@
           <a:p>
             <a:pPr algn="ctr"/>
             <a:r>
-              <a:rPr lang="te-IN" sz="1750" dirty="0">
+              <a:rPr lang="te-IN" sz="839" dirty="0">
                 <a:solidFill>
                   <a:schemeClr val="tx1"/>
                 </a:solidFill>
@@ -4198,7 +4196,7 @@
           <a:p>
             <a:pPr algn="ctr"/>
             <a:r>
-              <a:rPr lang="te-IN" sz="1750" dirty="0">
+              <a:rPr lang="te-IN" sz="839" dirty="0">
                 <a:solidFill>
                   <a:schemeClr val="tx1"/>
                 </a:solidFill>
@@ -4211,7 +4209,7 @@
           <a:p>
             <a:pPr algn="ctr"/>
             <a:r>
-              <a:rPr lang="te-IN" sz="1750" dirty="0">
+              <a:rPr lang="te-IN" sz="839" dirty="0">
                 <a:solidFill>
                   <a:schemeClr val="tx1"/>
                 </a:solidFill>
@@ -4223,7 +4221,7 @@
           </a:p>
           <a:p>
             <a:pPr algn="ctr"/>
-            <a:endParaRPr lang="te-IN" sz="1750" dirty="0">
+            <a:endParaRPr lang="te-IN" sz="839" dirty="0">
               <a:solidFill>
                 <a:schemeClr val="tx1"/>
               </a:solidFill>
@@ -4234,7 +4232,7 @@
           <a:p>
             <a:pPr algn="ctr"/>
             <a:r>
-              <a:rPr lang="te-IN" sz="1750" dirty="0">
+              <a:rPr lang="te-IN" sz="839" dirty="0">
                 <a:solidFill>
                   <a:schemeClr val="tx1"/>
                 </a:solidFill>
@@ -4247,7 +4245,7 @@
           <a:p>
             <a:pPr algn="ctr"/>
             <a:r>
-              <a:rPr lang="te-IN" sz="1750" dirty="0">
+              <a:rPr lang="te-IN" sz="839" dirty="0">
                 <a:solidFill>
                   <a:schemeClr val="tx1"/>
                 </a:solidFill>
@@ -4260,7 +4258,7 @@
           <a:p>
             <a:pPr algn="ctr"/>
             <a:r>
-              <a:rPr lang="te-IN" sz="1750" dirty="0">
+              <a:rPr lang="te-IN" sz="839" dirty="0">
                 <a:solidFill>
                   <a:schemeClr val="tx1"/>
                 </a:solidFill>
@@ -4273,7 +4271,7 @@
           <a:p>
             <a:pPr algn="ctr"/>
             <a:r>
-              <a:rPr lang="te-IN" sz="1750" dirty="0">
+              <a:rPr lang="te-IN" sz="839" dirty="0">
                 <a:solidFill>
                   <a:schemeClr val="tx1"/>
                 </a:solidFill>
@@ -4286,7 +4284,7 @@
           <a:p>
             <a:pPr algn="ctr"/>
             <a:r>
-              <a:rPr lang="te-IN" sz="1750" dirty="0">
+              <a:rPr lang="te-IN" sz="839" dirty="0">
                 <a:solidFill>
                   <a:schemeClr val="tx1"/>
                 </a:solidFill>
@@ -4298,7 +4296,7 @@
           </a:p>
           <a:p>
             <a:pPr algn="ctr"/>
-            <a:endParaRPr lang="te-IN" sz="1750" dirty="0">
+            <a:endParaRPr lang="te-IN" sz="839" dirty="0">
               <a:solidFill>
                 <a:schemeClr val="tx1"/>
               </a:solidFill>
@@ -4309,7 +4307,7 @@
           <a:p>
             <a:pPr algn="ctr"/>
             <a:r>
-              <a:rPr lang="te-IN" sz="1750" dirty="0">
+              <a:rPr lang="te-IN" sz="839" dirty="0">
                 <a:solidFill>
                   <a:schemeClr val="tx1"/>
                 </a:solidFill>
@@ -4322,7 +4320,7 @@
           <a:p>
             <a:pPr algn="ctr"/>
             <a:r>
-              <a:rPr lang="te-IN" sz="1750" dirty="0">
+              <a:rPr lang="te-IN" sz="839" dirty="0">
                 <a:solidFill>
                   <a:schemeClr val="tx1"/>
                 </a:solidFill>
@@ -4335,7 +4333,7 @@
           <a:p>
             <a:pPr algn="ctr"/>
             <a:r>
-              <a:rPr lang="te-IN" sz="1750" dirty="0">
+              <a:rPr lang="te-IN" sz="839" dirty="0">
                 <a:solidFill>
                   <a:schemeClr val="tx1"/>
                 </a:solidFill>
@@ -4348,7 +4346,7 @@
           <a:p>
             <a:pPr algn="ctr"/>
             <a:r>
-              <a:rPr lang="te-IN" sz="1750" dirty="0">
+              <a:rPr lang="te-IN" sz="839" dirty="0">
                 <a:solidFill>
                   <a:schemeClr val="tx1"/>
                 </a:solidFill>
@@ -4361,7 +4359,7 @@
           <a:p>
             <a:pPr algn="ctr"/>
             <a:r>
-              <a:rPr lang="te-IN" sz="1750" dirty="0">
+              <a:rPr lang="te-IN" sz="839" dirty="0">
                 <a:solidFill>
                   <a:schemeClr val="tx1"/>
                 </a:solidFill>
@@ -4387,8 +4385,8 @@
         </p:nvSpPr>
         <p:spPr>
           <a:xfrm>
-            <a:off x="8805069" y="4878137"/>
-            <a:ext cx="3377868" cy="4752474"/>
+            <a:off x="4953000" y="3393119"/>
+            <a:ext cx="1618978" cy="2277813"/>
           </a:xfrm>
           <a:prstGeom prst="rect">
             <a:avLst/>
@@ -4424,11 +4422,11 @@
           <a:bodyPr rtlCol="0" anchor="ctr"/>
           <a:lstStyle/>
           <a:p>
-            <a:pPr algn="ctr" defTabSz="439781">
+            <a:pPr algn="ctr" defTabSz="210778">
               <a:defRPr/>
             </a:pPr>
             <a:r>
-              <a:rPr lang="te-IN" sz="1600" dirty="0">
+              <a:rPr lang="te-IN" sz="767" dirty="0">
                 <a:solidFill>
                   <a:schemeClr val="tx1"/>
                 </a:solidFill>
@@ -4438,7 +4436,7 @@
               <a:t>స్తోత్రబలి స్తోత్రబలి – మంచిదేవా నీకేనయ్యా</a:t>
             </a:r>
             <a:br>
-              <a:rPr lang="te-IN" sz="1600" dirty="0">
+              <a:rPr lang="te-IN" sz="767" dirty="0">
                 <a:solidFill>
                   <a:schemeClr val="tx1"/>
                 </a:solidFill>
@@ -4447,7 +4445,7 @@
               </a:rPr>
             </a:br>
             <a:r>
-              <a:rPr lang="te-IN" sz="1600" dirty="0">
+              <a:rPr lang="te-IN" sz="767" dirty="0">
                 <a:solidFill>
                   <a:schemeClr val="tx1"/>
                 </a:solidFill>
@@ -4458,10 +4456,10 @@
             </a:r>
           </a:p>
           <a:p>
-            <a:pPr algn="ctr" defTabSz="439781">
+            <a:pPr algn="ctr" defTabSz="210778">
               <a:defRPr/>
             </a:pPr>
-            <a:endParaRPr lang="te-IN" sz="1600" dirty="0">
+            <a:endParaRPr lang="te-IN" sz="767" dirty="0">
               <a:solidFill>
                 <a:schemeClr val="tx1"/>
               </a:solidFill>
@@ -4470,11 +4468,11 @@
             </a:endParaRPr>
           </a:p>
           <a:p>
-            <a:pPr algn="ctr" defTabSz="439781">
+            <a:pPr algn="ctr" defTabSz="210778">
               <a:defRPr/>
             </a:pPr>
             <a:r>
-              <a:rPr lang="te-IN" sz="1600" dirty="0">
+              <a:rPr lang="te-IN" sz="767" dirty="0">
                 <a:solidFill>
                   <a:schemeClr val="tx1"/>
                 </a:solidFill>
@@ -4484,7 +4482,7 @@
               <a:t>నిన్నటి బాధలంతా నేటికి మాయమయ్యే (2)</a:t>
             </a:r>
             <a:br>
-              <a:rPr lang="te-IN" sz="1600" dirty="0">
+              <a:rPr lang="te-IN" sz="767" dirty="0">
                 <a:solidFill>
                   <a:schemeClr val="tx1"/>
                 </a:solidFill>
@@ -4493,7 +4491,7 @@
               </a:rPr>
             </a:br>
             <a:r>
-              <a:rPr lang="te-IN" sz="1600" dirty="0">
+              <a:rPr lang="te-IN" sz="767" dirty="0">
                 <a:solidFill>
                   <a:schemeClr val="tx1"/>
                 </a:solidFill>
@@ -4503,7 +4501,7 @@
               <a:t>నెమ్మది ఉదయించె అది శాశ్వతమైనదయ్యా (2)</a:t>
             </a:r>
             <a:br>
-              <a:rPr lang="te-IN" sz="1600" dirty="0">
+              <a:rPr lang="te-IN" sz="767" dirty="0">
                 <a:solidFill>
                   <a:schemeClr val="tx1"/>
                 </a:solidFill>
@@ -4512,7 +4510,7 @@
               </a:rPr>
             </a:br>
             <a:r>
-              <a:rPr lang="te-IN" sz="1600" dirty="0">
+              <a:rPr lang="te-IN" sz="767" dirty="0">
                 <a:solidFill>
                   <a:schemeClr val="tx1"/>
                 </a:solidFill>
@@ -4523,11 +4521,11 @@
             </a:r>
           </a:p>
           <a:p>
-            <a:pPr algn="ctr" defTabSz="439781">
+            <a:pPr algn="ctr" defTabSz="210778">
               <a:defRPr/>
             </a:pPr>
             <a:r>
-              <a:rPr lang="te-IN" sz="1600" dirty="0">
+              <a:rPr lang="te-IN" sz="767" dirty="0">
                 <a:solidFill>
                   <a:schemeClr val="tx1"/>
                 </a:solidFill>
@@ -4538,11 +4536,11 @@
             </a:r>
           </a:p>
           <a:p>
-            <a:pPr algn="ctr" defTabSz="439781">
+            <a:pPr algn="ctr" defTabSz="210778">
               <a:defRPr/>
             </a:pPr>
             <a:r>
-              <a:rPr lang="te-IN" sz="1600" dirty="0">
+              <a:rPr lang="te-IN" sz="767" dirty="0">
                 <a:solidFill>
                   <a:schemeClr val="tx1"/>
                 </a:solidFill>
@@ -4552,7 +4550,7 @@
               <a:t>రేయంతా కాచితివి మరు దినమిచ్చితివి (2)</a:t>
             </a:r>
             <a:br>
-              <a:rPr lang="te-IN" sz="1600" dirty="0">
+              <a:rPr lang="te-IN" sz="767" dirty="0">
                 <a:solidFill>
                   <a:schemeClr val="tx1"/>
                 </a:solidFill>
@@ -4561,7 +4559,7 @@
               </a:rPr>
             </a:br>
             <a:r>
-              <a:rPr lang="te-IN" sz="1600" dirty="0">
+              <a:rPr lang="te-IN" sz="767" dirty="0">
                 <a:solidFill>
                   <a:schemeClr val="tx1"/>
                 </a:solidFill>
@@ -4571,7 +4569,7 @@
               <a:t>మరువని నా స్నేహమా నీతో కలసి సంతోషింతును (2)</a:t>
             </a:r>
             <a:br>
-              <a:rPr lang="te-IN" sz="1600" dirty="0">
+              <a:rPr lang="te-IN" sz="767" dirty="0">
                 <a:solidFill>
                   <a:schemeClr val="tx1"/>
                 </a:solidFill>
@@ -4580,7 +4578,7 @@
               </a:rPr>
             </a:br>
             <a:r>
-              <a:rPr lang="te-IN" sz="1600" dirty="0">
+              <a:rPr lang="te-IN" sz="767" dirty="0">
                 <a:solidFill>
                   <a:schemeClr val="tx1"/>
                 </a:solidFill>
@@ -4591,11 +4589,11 @@
             </a:r>
           </a:p>
           <a:p>
-            <a:pPr algn="ctr" defTabSz="439781">
+            <a:pPr algn="ctr" defTabSz="210778">
               <a:defRPr/>
             </a:pPr>
             <a:r>
-              <a:rPr lang="te-IN" sz="1600" dirty="0">
+              <a:rPr lang="te-IN" sz="767" dirty="0">
                 <a:solidFill>
                   <a:schemeClr val="tx1"/>
                 </a:solidFill>
@@ -4606,11 +4604,11 @@
             </a:r>
           </a:p>
           <a:p>
-            <a:pPr algn="ctr" defTabSz="439781">
+            <a:pPr algn="ctr" defTabSz="210778">
               <a:defRPr/>
             </a:pPr>
             <a:r>
-              <a:rPr lang="te-IN" sz="1600" dirty="0">
+              <a:rPr lang="te-IN" sz="767" dirty="0">
                 <a:solidFill>
                   <a:schemeClr val="tx1"/>
                 </a:solidFill>
@@ -4620,7 +4618,7 @@
               <a:t>నీ సేవ మార్గంలో ఉత్సాహం నొసగితివి (2)</a:t>
             </a:r>
             <a:br>
-              <a:rPr lang="te-IN" sz="1600" dirty="0">
+              <a:rPr lang="te-IN" sz="767" dirty="0">
                 <a:solidFill>
                   <a:schemeClr val="tx1"/>
                 </a:solidFill>
@@ -4629,7 +4627,7 @@
               </a:rPr>
             </a:br>
             <a:r>
-              <a:rPr lang="te-IN" sz="1600" dirty="0">
+              <a:rPr lang="te-IN" sz="767" dirty="0">
                 <a:solidFill>
                   <a:schemeClr val="tx1"/>
                 </a:solidFill>
@@ -4639,7 +4637,7 @@
               <a:t>ఉరికురికి పనిచేయ నాకు ఆరోగ్యమిచ్చితివి (2)</a:t>
             </a:r>
             <a:br>
-              <a:rPr lang="te-IN" sz="1600" dirty="0">
+              <a:rPr lang="te-IN" sz="767" dirty="0">
                 <a:solidFill>
                   <a:schemeClr val="tx1"/>
                 </a:solidFill>
@@ -4648,7 +4646,7 @@
               </a:rPr>
             </a:br>
             <a:r>
-              <a:rPr lang="te-IN" sz="1600" dirty="0">
+              <a:rPr lang="te-IN" sz="767" dirty="0">
                 <a:solidFill>
                   <a:schemeClr val="tx1"/>
                 </a:solidFill>
@@ -4704,8 +4702,8 @@
         </p:nvSpPr>
         <p:spPr>
           <a:xfrm>
-            <a:off x="160256" y="200526"/>
-            <a:ext cx="4136611" cy="9370194"/>
+            <a:off x="0" y="0"/>
+            <a:ext cx="2476800" cy="6857999"/>
           </a:xfrm>
           <a:prstGeom prst="rect">
             <a:avLst/>
@@ -4743,58 +4741,110 @@
           <a:p>
             <a:pPr algn="ctr"/>
             <a:r>
-              <a:rPr lang="te-IN" sz="3100" dirty="0">
-                <a:solidFill>
-                  <a:schemeClr val="tx1"/>
-                </a:solidFill>
-                <a:latin typeface="Ramabhadra" panose="02000600000000000000" pitchFamily="2" charset="0"/>
-                <a:cs typeface="Ramabhadra" panose="02000600000000000000" pitchFamily="2" charset="0"/>
-              </a:rPr>
-              <a:t>స్తుతులన్ గైకొనుమా</a:t>
-            </a:r>
-          </a:p>
-          <a:p>
-            <a:pPr algn="ctr"/>
-            <a:r>
-              <a:rPr lang="te-IN" sz="3100" dirty="0">
-                <a:solidFill>
-                  <a:schemeClr val="tx1"/>
-                </a:solidFill>
-                <a:latin typeface="Ramabhadra" panose="02000600000000000000" pitchFamily="2" charset="0"/>
-                <a:cs typeface="Ramabhadra" panose="02000600000000000000" pitchFamily="2" charset="0"/>
-              </a:rPr>
-              <a:t>సుత యేసు క్రీస్తువా</a:t>
-            </a:r>
-          </a:p>
-          <a:p>
-            <a:pPr algn="ctr"/>
-            <a:r>
-              <a:rPr lang="te-IN" sz="3100" dirty="0">
-                <a:solidFill>
-                  <a:schemeClr val="tx1"/>
-                </a:solidFill>
-                <a:latin typeface="Ramabhadra" panose="02000600000000000000" pitchFamily="2" charset="0"/>
-                <a:cs typeface="Ramabhadra" panose="02000600000000000000" pitchFamily="2" charset="0"/>
-              </a:rPr>
-              <a:t>సతతము మమ్ములను </a:t>
-            </a:r>
-          </a:p>
-          <a:p>
-            <a:pPr algn="ctr"/>
-            <a:r>
-              <a:rPr lang="te-IN" sz="3100" dirty="0">
-                <a:solidFill>
-                  <a:schemeClr val="tx1"/>
-                </a:solidFill>
-                <a:latin typeface="Ramabhadra" panose="02000600000000000000" pitchFamily="2" charset="0"/>
-                <a:cs typeface="Ramabhadra" panose="02000600000000000000" pitchFamily="2" charset="0"/>
-              </a:rPr>
-              <a:t>కృపనిడి కావుమా</a:t>
-            </a:r>
-          </a:p>
-          <a:p>
-            <a:pPr algn="ctr"/>
-            <a:endParaRPr lang="te-IN" sz="3100" dirty="0">
+              <a:rPr lang="te-IN" dirty="0">
+                <a:solidFill>
+                  <a:schemeClr val="tx1"/>
+                </a:solidFill>
+                <a:latin typeface="Ramabhadra" panose="02000600000000000000" pitchFamily="2" charset="0"/>
+                <a:cs typeface="Ramabhadra" panose="02000600000000000000" pitchFamily="2" charset="0"/>
+              </a:rPr>
+              <a:t>నాలోని ప్రేమ</a:t>
+            </a:r>
+          </a:p>
+          <a:p>
+            <a:pPr algn="ctr"/>
+            <a:r>
+              <a:rPr lang="te-IN" dirty="0">
+                <a:solidFill>
+                  <a:schemeClr val="tx1"/>
+                </a:solidFill>
+                <a:latin typeface="Ramabhadra" panose="02000600000000000000" pitchFamily="2" charset="0"/>
+                <a:cs typeface="Ramabhadra" panose="02000600000000000000" pitchFamily="2" charset="0"/>
+              </a:rPr>
+              <a:t>నీదై ఉన్నది దేవా</a:t>
+            </a:r>
+          </a:p>
+          <a:p>
+            <a:pPr algn="ctr"/>
+            <a:r>
+              <a:rPr lang="te-IN" dirty="0">
+                <a:solidFill>
+                  <a:schemeClr val="tx1"/>
+                </a:solidFill>
+                <a:latin typeface="Ramabhadra" panose="02000600000000000000" pitchFamily="2" charset="0"/>
+                <a:cs typeface="Ramabhadra" panose="02000600000000000000" pitchFamily="2" charset="0"/>
+              </a:rPr>
+              <a:t>ఆ ప్రేమలో నన్ను</a:t>
+            </a:r>
+          </a:p>
+          <a:p>
+            <a:pPr algn="ctr"/>
+            <a:r>
+              <a:rPr lang="te-IN" dirty="0">
+                <a:solidFill>
+                  <a:schemeClr val="tx1"/>
+                </a:solidFill>
+                <a:latin typeface="Ramabhadra" panose="02000600000000000000" pitchFamily="2" charset="0"/>
+                <a:cs typeface="Ramabhadra" panose="02000600000000000000" pitchFamily="2" charset="0"/>
+              </a:rPr>
+              <a:t>బలపరుచు దేవా - 2</a:t>
+            </a:r>
+          </a:p>
+          <a:p>
+            <a:pPr algn="ctr"/>
+            <a:r>
+              <a:rPr lang="te-IN" dirty="0">
+                <a:solidFill>
+                  <a:schemeClr val="tx1"/>
+                </a:solidFill>
+                <a:latin typeface="Ramabhadra" panose="02000600000000000000" pitchFamily="2" charset="0"/>
+                <a:cs typeface="Ramabhadra" panose="02000600000000000000" pitchFamily="2" charset="0"/>
+              </a:rPr>
+              <a:t>నీ ప్రేమ లేనిదే</a:t>
+            </a:r>
+          </a:p>
+          <a:p>
+            <a:pPr algn="ctr"/>
+            <a:r>
+              <a:rPr lang="te-IN" dirty="0">
+                <a:solidFill>
+                  <a:schemeClr val="tx1"/>
+                </a:solidFill>
+                <a:latin typeface="Ramabhadra" panose="02000600000000000000" pitchFamily="2" charset="0"/>
+                <a:cs typeface="Ramabhadra" panose="02000600000000000000" pitchFamily="2" charset="0"/>
+              </a:rPr>
+              <a:t>నే బ్రతుకలేను - 2</a:t>
+            </a:r>
+          </a:p>
+          <a:p>
+            <a:pPr algn="ctr"/>
+            <a:r>
+              <a:rPr lang="te-IN" dirty="0">
+                <a:solidFill>
+                  <a:schemeClr val="tx1"/>
+                </a:solidFill>
+                <a:latin typeface="Ramabhadra" panose="02000600000000000000" pitchFamily="2" charset="0"/>
+                <a:cs typeface="Ramabhadra" panose="02000600000000000000" pitchFamily="2" charset="0"/>
+              </a:rPr>
+              <a:t>యేసయ్య నీ ప్రేమ</a:t>
+            </a:r>
+          </a:p>
+          <a:p>
+            <a:pPr algn="ctr"/>
+            <a:r>
+              <a:rPr lang="te-IN" dirty="0">
+                <a:solidFill>
+                  <a:schemeClr val="tx1"/>
+                </a:solidFill>
+                <a:latin typeface="Ramabhadra" panose="02000600000000000000" pitchFamily="2" charset="0"/>
+                <a:cs typeface="Ramabhadra" panose="02000600000000000000" pitchFamily="2" charset="0"/>
+              </a:rPr>
+              <a:t>వర్ణింప నా తరమా - 2</a:t>
+            </a:r>
+          </a:p>
+          <a:p>
+            <a:pPr algn="ctr"/>
+            <a:endParaRPr lang="te-IN" dirty="0">
               <a:solidFill>
                 <a:schemeClr val="tx1"/>
               </a:solidFill>
@@ -4805,58 +4855,84 @@
           <a:p>
             <a:pPr algn="ctr"/>
             <a:r>
-              <a:rPr lang="te-IN" sz="3100" dirty="0">
-                <a:solidFill>
-                  <a:schemeClr val="tx1"/>
-                </a:solidFill>
-                <a:latin typeface="Ramabhadra" panose="02000600000000000000" pitchFamily="2" charset="0"/>
-                <a:cs typeface="Ramabhadra" panose="02000600000000000000" pitchFamily="2" charset="0"/>
-              </a:rPr>
-              <a:t>మా పెదవులతో ఎప్పుడు నీ</a:t>
-            </a:r>
-          </a:p>
-          <a:p>
-            <a:pPr algn="ctr"/>
-            <a:r>
-              <a:rPr lang="te-IN" sz="3100" dirty="0">
-                <a:solidFill>
-                  <a:schemeClr val="tx1"/>
-                </a:solidFill>
-                <a:latin typeface="Ramabhadra" panose="02000600000000000000" pitchFamily="2" charset="0"/>
-                <a:cs typeface="Ramabhadra" panose="02000600000000000000" pitchFamily="2" charset="0"/>
-              </a:rPr>
-              <a:t>  వాక్యమును పఠింప నిమ్ము</a:t>
-            </a:r>
-          </a:p>
-          <a:p>
-            <a:pPr algn="ctr"/>
-            <a:r>
-              <a:rPr lang="te-IN" sz="3100" dirty="0">
-                <a:solidFill>
-                  <a:schemeClr val="tx1"/>
-                </a:solidFill>
-                <a:latin typeface="Ramabhadra" panose="02000600000000000000" pitchFamily="2" charset="0"/>
-                <a:cs typeface="Ramabhadra" panose="02000600000000000000" pitchFamily="2" charset="0"/>
-              </a:rPr>
-              <a:t>మా కాలు చేతులు ఎప్పుడు నీ </a:t>
-            </a:r>
-          </a:p>
-          <a:p>
-            <a:pPr algn="ctr"/>
-            <a:r>
-              <a:rPr lang="te-IN" sz="3100" dirty="0">
-                <a:solidFill>
-                  <a:schemeClr val="tx1"/>
-                </a:solidFill>
-                <a:latin typeface="Ramabhadra" panose="02000600000000000000" pitchFamily="2" charset="0"/>
-                <a:cs typeface="Ramabhadra" panose="02000600000000000000" pitchFamily="2" charset="0"/>
-              </a:rPr>
-              <a:t>సేవను చేయను వాడనిమ్ము </a:t>
-            </a:r>
-          </a:p>
-          <a:p>
-            <a:pPr algn="ctr"/>
-            <a:endParaRPr lang="te-IN" sz="3100" dirty="0">
+              <a:rPr lang="te-IN" dirty="0">
+                <a:solidFill>
+                  <a:schemeClr val="tx1"/>
+                </a:solidFill>
+                <a:latin typeface="Ramabhadra" panose="02000600000000000000" pitchFamily="2" charset="0"/>
+                <a:cs typeface="Ramabhadra" panose="02000600000000000000" pitchFamily="2" charset="0"/>
+              </a:rPr>
+              <a:t>నేను వెదకక ముందే</a:t>
+            </a:r>
+          </a:p>
+          <a:p>
+            <a:pPr algn="ctr"/>
+            <a:r>
+              <a:rPr lang="te-IN" dirty="0">
+                <a:solidFill>
+                  <a:schemeClr val="tx1"/>
+                </a:solidFill>
+                <a:latin typeface="Ramabhadra" panose="02000600000000000000" pitchFamily="2" charset="0"/>
+                <a:cs typeface="Ramabhadra" panose="02000600000000000000" pitchFamily="2" charset="0"/>
+              </a:rPr>
+              <a:t>నన్ను వెదికిన ప్రేమ ఇది</a:t>
+            </a:r>
+          </a:p>
+          <a:p>
+            <a:pPr algn="ctr"/>
+            <a:r>
+              <a:rPr lang="te-IN" dirty="0">
+                <a:solidFill>
+                  <a:schemeClr val="tx1"/>
+                </a:solidFill>
+                <a:latin typeface="Ramabhadra" panose="02000600000000000000" pitchFamily="2" charset="0"/>
+                <a:cs typeface="Ramabhadra" panose="02000600000000000000" pitchFamily="2" charset="0"/>
+              </a:rPr>
+              <a:t>నేను ప్రేమించక ముందే</a:t>
+            </a:r>
+          </a:p>
+          <a:p>
+            <a:pPr algn="ctr"/>
+            <a:r>
+              <a:rPr lang="te-IN" dirty="0">
+                <a:solidFill>
+                  <a:schemeClr val="tx1"/>
+                </a:solidFill>
+                <a:latin typeface="Ramabhadra" panose="02000600000000000000" pitchFamily="2" charset="0"/>
+                <a:cs typeface="Ramabhadra" panose="02000600000000000000" pitchFamily="2" charset="0"/>
+              </a:rPr>
+              <a:t>నను ప్రేమించినది - 2</a:t>
+            </a:r>
+          </a:p>
+          <a:p>
+            <a:pPr algn="ctr"/>
+            <a:r>
+              <a:rPr lang="te-IN" dirty="0">
+                <a:solidFill>
+                  <a:schemeClr val="tx1"/>
+                </a:solidFill>
+                <a:latin typeface="Ramabhadra" panose="02000600000000000000" pitchFamily="2" charset="0"/>
+                <a:cs typeface="Ramabhadra" panose="02000600000000000000" pitchFamily="2" charset="0"/>
+              </a:rPr>
+              <a:t>సిలువలో నీ దివ్య ప్రేమ</a:t>
+            </a:r>
+          </a:p>
+          <a:p>
+            <a:pPr algn="ctr"/>
+            <a:r>
+              <a:rPr lang="te-IN" dirty="0">
+                <a:solidFill>
+                  <a:schemeClr val="tx1"/>
+                </a:solidFill>
+                <a:latin typeface="Ramabhadra" panose="02000600000000000000" pitchFamily="2" charset="0"/>
+                <a:cs typeface="Ramabhadra" panose="02000600000000000000" pitchFamily="2" charset="0"/>
+              </a:rPr>
+              <a:t>విలువకు అందనిది - 2</a:t>
+            </a:r>
+          </a:p>
+          <a:p>
+            <a:pPr algn="ctr"/>
+            <a:endParaRPr lang="te-IN" dirty="0">
               <a:solidFill>
                 <a:schemeClr val="tx1"/>
               </a:solidFill>
@@ -4867,132 +4943,89 @@
           <a:p>
             <a:pPr algn="ctr"/>
             <a:r>
-              <a:rPr lang="te-IN" sz="3100" dirty="0">
-                <a:solidFill>
-                  <a:schemeClr val="tx1"/>
-                </a:solidFill>
-                <a:latin typeface="Ramabhadra" panose="02000600000000000000" pitchFamily="2" charset="0"/>
-                <a:cs typeface="Ramabhadra" panose="02000600000000000000" pitchFamily="2" charset="0"/>
-              </a:rPr>
-              <a:t>మా కలిమియు పదవుల నెల్ల </a:t>
-            </a:r>
-          </a:p>
-          <a:p>
-            <a:pPr algn="ctr"/>
-            <a:r>
-              <a:rPr lang="te-IN" sz="3100" dirty="0">
-                <a:solidFill>
-                  <a:schemeClr val="tx1"/>
-                </a:solidFill>
-                <a:latin typeface="Ramabhadra" panose="02000600000000000000" pitchFamily="2" charset="0"/>
-                <a:cs typeface="Ramabhadra" panose="02000600000000000000" pitchFamily="2" charset="0"/>
-              </a:rPr>
-              <a:t>నీ శుద్ధ కృపచే పొందితిమి </a:t>
-            </a:r>
-          </a:p>
-          <a:p>
-            <a:pPr algn="ctr"/>
-            <a:r>
-              <a:rPr lang="te-IN" sz="3100" dirty="0">
-                <a:solidFill>
-                  <a:schemeClr val="tx1"/>
-                </a:solidFill>
-                <a:latin typeface="Ramabhadra" panose="02000600000000000000" pitchFamily="2" charset="0"/>
-                <a:cs typeface="Ramabhadra" panose="02000600000000000000" pitchFamily="2" charset="0"/>
-              </a:rPr>
-              <a:t>మా కాలమంతయు జీవింప </a:t>
-            </a:r>
-          </a:p>
-          <a:p>
-            <a:pPr algn="ctr"/>
-            <a:r>
-              <a:rPr lang="te-IN" sz="3100" dirty="0">
-                <a:solidFill>
-                  <a:schemeClr val="tx1"/>
-                </a:solidFill>
-                <a:latin typeface="Ramabhadra" panose="02000600000000000000" pitchFamily="2" charset="0"/>
-                <a:cs typeface="Ramabhadra" panose="02000600000000000000" pitchFamily="2" charset="0"/>
-              </a:rPr>
-              <a:t>నిలకడగ నుండ దీవించుము</a:t>
-            </a:r>
-            <a:endParaRPr lang="en-IN" sz="3100" dirty="0">
-              <a:solidFill>
-                <a:schemeClr val="tx1"/>
-              </a:solidFill>
-              <a:latin typeface="Ramabhadra" panose="02000600000000000000" pitchFamily="2" charset="0"/>
-              <a:cs typeface="Ramabhadra" panose="02000600000000000000" pitchFamily="2" charset="0"/>
-            </a:endParaRPr>
-          </a:p>
-          <a:p>
-            <a:pPr algn="ctr"/>
-            <a:endParaRPr lang="en-IN" sz="3100" dirty="0">
-              <a:solidFill>
-                <a:schemeClr val="tx1"/>
-              </a:solidFill>
-              <a:latin typeface="Ramabhadra" panose="02000600000000000000" pitchFamily="2" charset="0"/>
-              <a:cs typeface="Ramabhadra" panose="02000600000000000000" pitchFamily="2" charset="0"/>
-            </a:endParaRPr>
-          </a:p>
-          <a:p>
-            <a:pPr algn="ctr"/>
-            <a:r>
-              <a:rPr lang="te-IN" sz="3100" dirty="0">
-                <a:solidFill>
-                  <a:schemeClr val="tx1"/>
-                </a:solidFill>
-                <a:latin typeface="Ramabhadra" panose="02000600000000000000" pitchFamily="2" charset="0"/>
-                <a:cs typeface="Ramabhadra" panose="02000600000000000000" pitchFamily="2" charset="0"/>
-              </a:rPr>
-              <a:t>నిజ విశ్వాసములో నెదుగ</a:t>
-            </a:r>
-          </a:p>
-          <a:p>
-            <a:pPr algn="ctr"/>
-            <a:r>
-              <a:rPr lang="te-IN" sz="3100" dirty="0">
-                <a:solidFill>
-                  <a:schemeClr val="tx1"/>
-                </a:solidFill>
-                <a:latin typeface="Ramabhadra" panose="02000600000000000000" pitchFamily="2" charset="0"/>
-                <a:cs typeface="Ramabhadra" panose="02000600000000000000" pitchFamily="2" charset="0"/>
-              </a:rPr>
-              <a:t>నిశ్భల బుద్దిని మా కొసగి</a:t>
-            </a:r>
-          </a:p>
-          <a:p>
-            <a:pPr algn="ctr"/>
-            <a:r>
-              <a:rPr lang="te-IN" sz="3100" dirty="0">
-                <a:solidFill>
-                  <a:schemeClr val="tx1"/>
-                </a:solidFill>
-                <a:latin typeface="Ramabhadra" panose="02000600000000000000" pitchFamily="2" charset="0"/>
-                <a:cs typeface="Ramabhadra" panose="02000600000000000000" pitchFamily="2" charset="0"/>
-              </a:rPr>
-              <a:t>నిరతము నీ సేవ చేయుటకు</a:t>
-            </a:r>
-          </a:p>
-          <a:p>
-            <a:pPr algn="ctr"/>
-            <a:r>
-              <a:rPr lang="te-IN" sz="3100" dirty="0">
-                <a:solidFill>
-                  <a:schemeClr val="tx1"/>
-                </a:solidFill>
-                <a:latin typeface="Ramabhadra" panose="02000600000000000000" pitchFamily="2" charset="0"/>
-                <a:cs typeface="Ramabhadra" panose="02000600000000000000" pitchFamily="2" charset="0"/>
-              </a:rPr>
-              <a:t>నీ ఆత్మ శక్తితో నింపుమయా </a:t>
-            </a:r>
-          </a:p>
-        </p:txBody>
-      </p:sp>
-      <p:sp>
-        <p:nvSpPr>
-          <p:cNvPr id="6" name="Rectangle 5">
+              <a:rPr lang="te-IN" dirty="0">
+                <a:solidFill>
+                  <a:schemeClr val="tx1"/>
+                </a:solidFill>
+                <a:latin typeface="Ramabhadra" panose="02000600000000000000" pitchFamily="2" charset="0"/>
+                <a:cs typeface="Ramabhadra" panose="02000600000000000000" pitchFamily="2" charset="0"/>
+              </a:rPr>
+              <a:t>బాధ్యతయిన ప్రేమ నీది</a:t>
+            </a:r>
+          </a:p>
+          <a:p>
+            <a:pPr algn="ctr"/>
+            <a:r>
+              <a:rPr lang="te-IN" dirty="0">
+                <a:solidFill>
+                  <a:schemeClr val="tx1"/>
+                </a:solidFill>
+                <a:latin typeface="Ramabhadra" panose="02000600000000000000" pitchFamily="2" charset="0"/>
+                <a:cs typeface="Ramabhadra" panose="02000600000000000000" pitchFamily="2" charset="0"/>
+              </a:rPr>
+              <a:t>నన్ను భరియించినది</a:t>
+            </a:r>
+          </a:p>
+          <a:p>
+            <a:pPr algn="ctr"/>
+            <a:r>
+              <a:rPr lang="te-IN" dirty="0">
+                <a:solidFill>
+                  <a:schemeClr val="tx1"/>
+                </a:solidFill>
+                <a:latin typeface="Ramabhadra" panose="02000600000000000000" pitchFamily="2" charset="0"/>
+                <a:cs typeface="Ramabhadra" panose="02000600000000000000" pitchFamily="2" charset="0"/>
+              </a:rPr>
+              <a:t>భద్రత నిచ్చిన ప్రేమ నీది</a:t>
+            </a:r>
+          </a:p>
+          <a:p>
+            <a:pPr algn="ctr"/>
+            <a:r>
+              <a:rPr lang="te-IN" dirty="0">
+                <a:solidFill>
+                  <a:schemeClr val="tx1"/>
+                </a:solidFill>
+                <a:latin typeface="Ramabhadra" panose="02000600000000000000" pitchFamily="2" charset="0"/>
+                <a:cs typeface="Ramabhadra" panose="02000600000000000000" pitchFamily="2" charset="0"/>
+              </a:rPr>
+              <a:t>భారము బాపినది - 2</a:t>
+            </a:r>
+          </a:p>
+          <a:p>
+            <a:pPr algn="ctr"/>
+            <a:r>
+              <a:rPr lang="te-IN" dirty="0">
+                <a:solidFill>
+                  <a:schemeClr val="tx1"/>
+                </a:solidFill>
+                <a:latin typeface="Ramabhadra" panose="02000600000000000000" pitchFamily="2" charset="0"/>
+                <a:cs typeface="Ramabhadra" panose="02000600000000000000" pitchFamily="2" charset="0"/>
+              </a:rPr>
+              <a:t>బాధలో ఓదార్పునిచ్చి</a:t>
+            </a:r>
+          </a:p>
+          <a:p>
+            <a:pPr algn="ctr"/>
+            <a:r>
+              <a:rPr lang="te-IN" dirty="0">
+                <a:solidFill>
+                  <a:schemeClr val="tx1"/>
+                </a:solidFill>
+                <a:latin typeface="Ramabhadra" panose="02000600000000000000" pitchFamily="2" charset="0"/>
+                <a:cs typeface="Ramabhadra" panose="02000600000000000000" pitchFamily="2" charset="0"/>
+              </a:rPr>
+              <a:t>బలము చేకూర్చెను - 2</a:t>
+            </a:r>
+          </a:p>
+        </p:txBody>
+      </p:sp>
+      <p:sp>
+        <p:nvSpPr>
+          <p:cNvPr id="9" name="Rectangle 8">
             <a:extLst>
               <a:ext uri="{FF2B5EF4-FFF2-40B4-BE49-F238E27FC236}">
-                <a16:creationId xmlns:a16="http://schemas.microsoft.com/office/drawing/2014/main" id="{5F9170B8-9D02-4546-B7BF-8B868EFFFB33}"/>
+                <a16:creationId xmlns:a16="http://schemas.microsoft.com/office/drawing/2014/main" id="{CF71F7B4-8FFE-404C-A782-8BC26C9AA2C9}"/>
               </a:ext>
             </a:extLst>
           </p:cNvPr>
@@ -5001,8 +5034,8 @@
         </p:nvSpPr>
         <p:spPr>
           <a:xfrm>
-            <a:off x="4296867" y="200526"/>
-            <a:ext cx="4274109" cy="9370194"/>
+            <a:off x="2476200" y="3175"/>
+            <a:ext cx="2476800" cy="6854824"/>
           </a:xfrm>
           <a:prstGeom prst="rect">
             <a:avLst/>
@@ -5040,16 +5073,123 @@
           <a:p>
             <a:pPr algn="ctr"/>
             <a:r>
-              <a:rPr lang="te-IN" sz="3200" dirty="0">
-                <a:solidFill>
-                  <a:schemeClr val="tx1"/>
-                </a:solidFill>
-                <a:latin typeface="Ramabhadra" panose="02000600000000000000" pitchFamily="2" charset="0"/>
-                <a:cs typeface="Ramabhadra" panose="02000600000000000000" pitchFamily="2" charset="0"/>
-              </a:rPr>
-              <a:t>ఆనంద సంద్రమ్మున –</a:t>
-            </a:r>
-            <a:endParaRPr lang="en-IN" sz="3200" dirty="0">
+              <a:rPr lang="te-IN" sz="1600" dirty="0">
+                <a:solidFill>
+                  <a:schemeClr val="tx1"/>
+                </a:solidFill>
+                <a:latin typeface="Ramabhadra" panose="02000600000000000000" pitchFamily="2" charset="0"/>
+                <a:cs typeface="Ramabhadra" panose="02000600000000000000" pitchFamily="2" charset="0"/>
+              </a:rPr>
+              <a:t>ప్రార్థన వలనే పయనము –</a:t>
+            </a:r>
+          </a:p>
+          <a:p>
+            <a:pPr algn="ctr"/>
+            <a:r>
+              <a:rPr lang="te-IN" sz="1600" dirty="0">
+                <a:solidFill>
+                  <a:schemeClr val="tx1"/>
+                </a:solidFill>
+                <a:latin typeface="Ramabhadra" panose="02000600000000000000" pitchFamily="2" charset="0"/>
+                <a:cs typeface="Ramabhadra" panose="02000600000000000000" pitchFamily="2" charset="0"/>
+              </a:rPr>
+              <a:t>ప్రార్థనే ప్రాకారము</a:t>
+            </a:r>
+          </a:p>
+          <a:p>
+            <a:pPr algn="ctr"/>
+            <a:r>
+              <a:rPr lang="te-IN" sz="1600" dirty="0">
+                <a:solidFill>
+                  <a:schemeClr val="tx1"/>
+                </a:solidFill>
+                <a:latin typeface="Ramabhadra" panose="02000600000000000000" pitchFamily="2" charset="0"/>
+                <a:cs typeface="Ramabhadra" panose="02000600000000000000" pitchFamily="2" charset="0"/>
+              </a:rPr>
+              <a:t>ప్రార్థనే ప్రాధాన్యము –</a:t>
+            </a:r>
+          </a:p>
+          <a:p>
+            <a:pPr algn="ctr"/>
+            <a:r>
+              <a:rPr lang="te-IN" sz="1600" dirty="0">
+                <a:solidFill>
+                  <a:schemeClr val="tx1"/>
+                </a:solidFill>
+                <a:latin typeface="Ramabhadra" panose="02000600000000000000" pitchFamily="2" charset="0"/>
+                <a:cs typeface="Ramabhadra" panose="02000600000000000000" pitchFamily="2" charset="0"/>
+              </a:rPr>
+              <a:t>ప్రార్థన లేనిదే పరాజయం (2)</a:t>
+            </a:r>
+          </a:p>
+          <a:p>
+            <a:pPr algn="ctr"/>
+            <a:r>
+              <a:rPr lang="te-IN" sz="1600" dirty="0">
+                <a:solidFill>
+                  <a:schemeClr val="tx1"/>
+                </a:solidFill>
+                <a:latin typeface="Ramabhadra" panose="02000600000000000000" pitchFamily="2" charset="0"/>
+                <a:cs typeface="Ramabhadra" panose="02000600000000000000" pitchFamily="2" charset="0"/>
+              </a:rPr>
+              <a:t>ప్రభువా ప్రార్థన నేర్పయ్యా</a:t>
+            </a:r>
+          </a:p>
+          <a:p>
+            <a:pPr algn="ctr"/>
+            <a:r>
+              <a:rPr lang="te-IN" sz="1600" dirty="0">
+                <a:solidFill>
+                  <a:schemeClr val="tx1"/>
+                </a:solidFill>
+                <a:latin typeface="Ramabhadra" panose="02000600000000000000" pitchFamily="2" charset="0"/>
+                <a:cs typeface="Ramabhadra" panose="02000600000000000000" pitchFamily="2" charset="0"/>
+              </a:rPr>
+              <a:t>ప్రార్ధించకుండా</a:t>
+            </a:r>
+          </a:p>
+          <a:p>
+            <a:pPr algn="ctr"/>
+            <a:r>
+              <a:rPr lang="te-IN" sz="1600" dirty="0">
+                <a:solidFill>
+                  <a:schemeClr val="tx1"/>
+                </a:solidFill>
+                <a:latin typeface="Ramabhadra" panose="02000600000000000000" pitchFamily="2" charset="0"/>
+                <a:cs typeface="Ramabhadra" panose="02000600000000000000" pitchFamily="2" charset="0"/>
+              </a:rPr>
+              <a:t>నే ఉండలేనయ్యా (2)</a:t>
+            </a:r>
+          </a:p>
+          <a:p>
+            <a:pPr algn="ctr"/>
+            <a:r>
+              <a:rPr lang="te-IN" sz="1600" dirty="0">
+                <a:solidFill>
+                  <a:schemeClr val="tx1"/>
+                </a:solidFill>
+                <a:latin typeface="Ramabhadra" panose="02000600000000000000" pitchFamily="2" charset="0"/>
+                <a:cs typeface="Ramabhadra" panose="02000600000000000000" pitchFamily="2" charset="0"/>
+              </a:rPr>
+              <a:t>నీ పాదాలు తడపకుండా</a:t>
+            </a:r>
+          </a:p>
+          <a:p>
+            <a:pPr algn="ctr"/>
+            <a:r>
+              <a:rPr lang="te-IN" sz="1600" dirty="0">
+                <a:solidFill>
+                  <a:schemeClr val="tx1"/>
+                </a:solidFill>
+                <a:latin typeface="Ramabhadra" panose="02000600000000000000" pitchFamily="2" charset="0"/>
+                <a:cs typeface="Ramabhadra" panose="02000600000000000000" pitchFamily="2" charset="0"/>
+              </a:rPr>
+              <a:t>నా పయనం సాగదయ్యా (2)</a:t>
+            </a:r>
+          </a:p>
+          <a:p>
+            <a:pPr algn="ctr"/>
+            <a:endParaRPr lang="te-IN" sz="1600" dirty="0">
               <a:solidFill>
                 <a:schemeClr val="tx1"/>
               </a:solidFill>
@@ -5060,29 +5200,110 @@
           <a:p>
             <a:pPr algn="ctr"/>
             <a:r>
-              <a:rPr lang="te-IN" sz="3200" dirty="0">
-                <a:solidFill>
-                  <a:schemeClr val="tx1"/>
-                </a:solidFill>
-                <a:latin typeface="Ramabhadra" panose="02000600000000000000" pitchFamily="2" charset="0"/>
-                <a:cs typeface="Ramabhadra" panose="02000600000000000000" pitchFamily="2" charset="0"/>
-              </a:rPr>
-              <a:t>నా జీవిత నావను </a:t>
-            </a:r>
-          </a:p>
-          <a:p>
-            <a:pPr algn="ctr"/>
-            <a:r>
-              <a:rPr lang="te-IN" sz="3200" dirty="0">
-                <a:solidFill>
-                  <a:schemeClr val="tx1"/>
-                </a:solidFill>
-                <a:latin typeface="Ramabhadra" panose="02000600000000000000" pitchFamily="2" charset="0"/>
-                <a:cs typeface="Ramabhadra" panose="02000600000000000000" pitchFamily="2" charset="0"/>
-              </a:rPr>
-              <a:t>నడిపేది ఆ యేసుడే –</a:t>
-            </a:r>
-            <a:endParaRPr lang="en-IN" sz="3200" dirty="0">
+              <a:rPr lang="te-IN" sz="1600" dirty="0">
+                <a:solidFill>
+                  <a:schemeClr val="tx1"/>
+                </a:solidFill>
+                <a:latin typeface="Ramabhadra" panose="02000600000000000000" pitchFamily="2" charset="0"/>
+                <a:cs typeface="Ramabhadra" panose="02000600000000000000" pitchFamily="2" charset="0"/>
+              </a:rPr>
+              <a:t>ప్రార్ధనలో నాటునది –</a:t>
+            </a:r>
+          </a:p>
+          <a:p>
+            <a:pPr algn="ctr"/>
+            <a:r>
+              <a:rPr lang="te-IN" sz="1600" dirty="0">
+                <a:solidFill>
+                  <a:schemeClr val="tx1"/>
+                </a:solidFill>
+                <a:latin typeface="Ramabhadra" panose="02000600000000000000" pitchFamily="2" charset="0"/>
+                <a:cs typeface="Ramabhadra" panose="02000600000000000000" pitchFamily="2" charset="0"/>
+              </a:rPr>
+              <a:t>పెల్లగించుట అసాధ్యము</a:t>
+            </a:r>
+          </a:p>
+          <a:p>
+            <a:pPr algn="ctr"/>
+            <a:r>
+              <a:rPr lang="te-IN" sz="1600" dirty="0">
+                <a:solidFill>
+                  <a:schemeClr val="tx1"/>
+                </a:solidFill>
+                <a:latin typeface="Ramabhadra" panose="02000600000000000000" pitchFamily="2" charset="0"/>
+                <a:cs typeface="Ramabhadra" panose="02000600000000000000" pitchFamily="2" charset="0"/>
+              </a:rPr>
+              <a:t>ప్రార్ధనలో పోరాడునది –</a:t>
+            </a:r>
+          </a:p>
+          <a:p>
+            <a:pPr algn="ctr"/>
+            <a:r>
+              <a:rPr lang="te-IN" sz="1600" dirty="0">
+                <a:solidFill>
+                  <a:schemeClr val="tx1"/>
+                </a:solidFill>
+                <a:latin typeface="Ramabhadra" panose="02000600000000000000" pitchFamily="2" charset="0"/>
+                <a:cs typeface="Ramabhadra" panose="02000600000000000000" pitchFamily="2" charset="0"/>
+              </a:rPr>
+              <a:t>పొందకపోవుట అసాధ్యము (2)</a:t>
+            </a:r>
+          </a:p>
+          <a:p>
+            <a:pPr algn="ctr"/>
+            <a:r>
+              <a:rPr lang="te-IN" sz="1600" dirty="0">
+                <a:solidFill>
+                  <a:schemeClr val="tx1"/>
+                </a:solidFill>
+                <a:latin typeface="Ramabhadra" panose="02000600000000000000" pitchFamily="2" charset="0"/>
+                <a:cs typeface="Ramabhadra" panose="02000600000000000000" pitchFamily="2" charset="0"/>
+              </a:rPr>
+              <a:t>ప్రార్ధనలో ప్రాకులాడినది –</a:t>
+            </a:r>
+          </a:p>
+          <a:p>
+            <a:pPr algn="ctr"/>
+            <a:r>
+              <a:rPr lang="te-IN" sz="1600" dirty="0">
+                <a:solidFill>
+                  <a:schemeClr val="tx1"/>
+                </a:solidFill>
+                <a:latin typeface="Ramabhadra" panose="02000600000000000000" pitchFamily="2" charset="0"/>
+                <a:cs typeface="Ramabhadra" panose="02000600000000000000" pitchFamily="2" charset="0"/>
+              </a:rPr>
+              <a:t>పతనమవ్వుట అసాధ్యము (2)</a:t>
+            </a:r>
+          </a:p>
+          <a:p>
+            <a:pPr algn="ctr"/>
+            <a:r>
+              <a:rPr lang="te-IN" sz="1600" dirty="0">
+                <a:solidFill>
+                  <a:schemeClr val="tx1"/>
+                </a:solidFill>
+                <a:latin typeface="Ramabhadra" panose="02000600000000000000" pitchFamily="2" charset="0"/>
+                <a:cs typeface="Ramabhadra" panose="02000600000000000000" pitchFamily="2" charset="0"/>
+              </a:rPr>
+              <a:t>ప్రార్ధనలో పదునైనది –</a:t>
+            </a:r>
+          </a:p>
+          <a:p>
+            <a:pPr algn="ctr"/>
+            <a:r>
+              <a:rPr lang="te-IN" sz="1600" dirty="0">
+                <a:solidFill>
+                  <a:schemeClr val="tx1"/>
+                </a:solidFill>
+                <a:latin typeface="Ramabhadra" panose="02000600000000000000" pitchFamily="2" charset="0"/>
+                <a:cs typeface="Ramabhadra" panose="02000600000000000000" pitchFamily="2" charset="0"/>
+              </a:rPr>
+              <a:t>పనిచేయకపోవుట అసాధ్యము (2)</a:t>
+            </a:r>
+          </a:p>
+          <a:p>
+            <a:pPr algn="ctr"/>
+            <a:endParaRPr lang="te-IN" sz="1600" dirty="0">
               <a:solidFill>
                 <a:schemeClr val="tx1"/>
               </a:solidFill>
@@ -5093,222 +5314,115 @@
           <a:p>
             <a:pPr algn="ctr"/>
             <a:r>
-              <a:rPr lang="te-IN" sz="3200" dirty="0">
-                <a:solidFill>
-                  <a:schemeClr val="tx1"/>
-                </a:solidFill>
-                <a:latin typeface="Ramabhadra" panose="02000600000000000000" pitchFamily="2" charset="0"/>
-                <a:cs typeface="Ramabhadra" panose="02000600000000000000" pitchFamily="2" charset="0"/>
-              </a:rPr>
-              <a:t>దరిచేర్చు ఆ దేవుడే</a:t>
-            </a:r>
-          </a:p>
-          <a:p>
-            <a:pPr algn="ctr"/>
-            <a:endParaRPr lang="te-IN" sz="3200" dirty="0">
-              <a:solidFill>
-                <a:schemeClr val="tx1"/>
-              </a:solidFill>
-              <a:latin typeface="Ramabhadra" panose="02000600000000000000" pitchFamily="2" charset="0"/>
-              <a:cs typeface="Ramabhadra" panose="02000600000000000000" pitchFamily="2" charset="0"/>
-            </a:endParaRPr>
-          </a:p>
-          <a:p>
-            <a:pPr algn="ctr"/>
-            <a:r>
-              <a:rPr lang="te-IN" sz="3200" dirty="0">
-                <a:solidFill>
-                  <a:schemeClr val="tx1"/>
-                </a:solidFill>
-                <a:latin typeface="Ramabhadra" panose="02000600000000000000" pitchFamily="2" charset="0"/>
-                <a:cs typeface="Ramabhadra" panose="02000600000000000000" pitchFamily="2" charset="0"/>
-              </a:rPr>
-              <a:t>పెనుగాలులే వీచినా –</a:t>
-            </a:r>
-            <a:endParaRPr lang="en-IN" sz="3200" dirty="0">
-              <a:solidFill>
-                <a:schemeClr val="tx1"/>
-              </a:solidFill>
-              <a:latin typeface="Ramabhadra" panose="02000600000000000000" pitchFamily="2" charset="0"/>
-              <a:cs typeface="Ramabhadra" panose="02000600000000000000" pitchFamily="2" charset="0"/>
-            </a:endParaRPr>
-          </a:p>
-          <a:p>
-            <a:pPr algn="ctr"/>
-            <a:r>
-              <a:rPr lang="te-IN" sz="3200" dirty="0">
-                <a:solidFill>
-                  <a:schemeClr val="tx1"/>
-                </a:solidFill>
-                <a:latin typeface="Ramabhadra" panose="02000600000000000000" pitchFamily="2" charset="0"/>
-                <a:cs typeface="Ramabhadra" panose="02000600000000000000" pitchFamily="2" charset="0"/>
-              </a:rPr>
-              <a:t>తుఫానులే తరిమినా</a:t>
-            </a:r>
-          </a:p>
-          <a:p>
-            <a:pPr algn="ctr"/>
-            <a:r>
-              <a:rPr lang="te-IN" sz="3200" dirty="0">
-                <a:solidFill>
-                  <a:schemeClr val="tx1"/>
-                </a:solidFill>
-                <a:latin typeface="Ramabhadra" panose="02000600000000000000" pitchFamily="2" charset="0"/>
-                <a:cs typeface="Ramabhadra" panose="02000600000000000000" pitchFamily="2" charset="0"/>
-              </a:rPr>
-              <a:t>గద్దించి కాపాడు –</a:t>
-            </a:r>
-            <a:endParaRPr lang="en-IN" sz="3200" dirty="0">
-              <a:solidFill>
-                <a:schemeClr val="tx1"/>
-              </a:solidFill>
-              <a:latin typeface="Ramabhadra" panose="02000600000000000000" pitchFamily="2" charset="0"/>
-              <a:cs typeface="Ramabhadra" panose="02000600000000000000" pitchFamily="2" charset="0"/>
-            </a:endParaRPr>
-          </a:p>
-          <a:p>
-            <a:pPr algn="ctr"/>
-            <a:r>
-              <a:rPr lang="te-IN" sz="3200" dirty="0">
-                <a:solidFill>
-                  <a:schemeClr val="tx1"/>
-                </a:solidFill>
-                <a:latin typeface="Ramabhadra" panose="02000600000000000000" pitchFamily="2" charset="0"/>
-                <a:cs typeface="Ramabhadra" panose="02000600000000000000" pitchFamily="2" charset="0"/>
-              </a:rPr>
-              <a:t>ప్రభువండ నీకుండ</a:t>
-            </a:r>
-          </a:p>
-          <a:p>
-            <a:pPr algn="ctr"/>
-            <a:r>
-              <a:rPr lang="te-IN" sz="3200" dirty="0">
-                <a:solidFill>
-                  <a:schemeClr val="tx1"/>
-                </a:solidFill>
-                <a:latin typeface="Ramabhadra" panose="02000600000000000000" pitchFamily="2" charset="0"/>
-                <a:cs typeface="Ramabhadra" panose="02000600000000000000" pitchFamily="2" charset="0"/>
-              </a:rPr>
-              <a:t>దిగులేల ఓ సోదరా! –</a:t>
-            </a:r>
-            <a:endParaRPr lang="en-IN" sz="3200" dirty="0">
-              <a:solidFill>
-                <a:schemeClr val="tx1"/>
-              </a:solidFill>
-              <a:latin typeface="Ramabhadra" panose="02000600000000000000" pitchFamily="2" charset="0"/>
-              <a:cs typeface="Ramabhadra" panose="02000600000000000000" pitchFamily="2" charset="0"/>
-            </a:endParaRPr>
-          </a:p>
-          <a:p>
-            <a:pPr algn="ctr"/>
-            <a:r>
-              <a:rPr lang="te-IN" sz="3200" dirty="0">
-                <a:solidFill>
-                  <a:schemeClr val="tx1"/>
-                </a:solidFill>
-                <a:latin typeface="Ramabhadra" panose="02000600000000000000" pitchFamily="2" charset="0"/>
-                <a:cs typeface="Ramabhadra" panose="02000600000000000000" pitchFamily="2" charset="0"/>
-              </a:rPr>
-              <a:t>నిశ్చింతగా సాగుమా</a:t>
-            </a:r>
-          </a:p>
-          <a:p>
-            <a:pPr algn="ctr"/>
-            <a:endParaRPr lang="te-IN" sz="3200" dirty="0">
-              <a:solidFill>
-                <a:schemeClr val="tx1"/>
-              </a:solidFill>
-              <a:latin typeface="Ramabhadra" panose="02000600000000000000" pitchFamily="2" charset="0"/>
-              <a:cs typeface="Ramabhadra" panose="02000600000000000000" pitchFamily="2" charset="0"/>
-            </a:endParaRPr>
-          </a:p>
-          <a:p>
-            <a:pPr algn="ctr"/>
-            <a:r>
-              <a:rPr lang="te-IN" sz="3200" dirty="0">
-                <a:solidFill>
-                  <a:schemeClr val="tx1"/>
-                </a:solidFill>
-                <a:latin typeface="Ramabhadra" panose="02000600000000000000" pitchFamily="2" charset="0"/>
-                <a:cs typeface="Ramabhadra" panose="02000600000000000000" pitchFamily="2" charset="0"/>
-              </a:rPr>
-              <a:t>ఆపత్కాలములందునా –</a:t>
-            </a:r>
-            <a:endParaRPr lang="en-IN" sz="3200" dirty="0">
-              <a:solidFill>
-                <a:schemeClr val="tx1"/>
-              </a:solidFill>
-              <a:latin typeface="Ramabhadra" panose="02000600000000000000" pitchFamily="2" charset="0"/>
-              <a:cs typeface="Ramabhadra" panose="02000600000000000000" pitchFamily="2" charset="0"/>
-            </a:endParaRPr>
-          </a:p>
-          <a:p>
-            <a:pPr algn="ctr"/>
-            <a:r>
-              <a:rPr lang="te-IN" sz="3200" dirty="0">
-                <a:solidFill>
-                  <a:schemeClr val="tx1"/>
-                </a:solidFill>
-                <a:latin typeface="Ramabhadra" panose="02000600000000000000" pitchFamily="2" charset="0"/>
-                <a:cs typeface="Ramabhadra" panose="02000600000000000000" pitchFamily="2" charset="0"/>
-              </a:rPr>
-              <a:t>రోధించి ప్రార్ధించినా</a:t>
-            </a:r>
-          </a:p>
-          <a:p>
-            <a:pPr algn="ctr"/>
-            <a:r>
-              <a:rPr lang="te-IN" sz="3200" dirty="0">
-                <a:solidFill>
-                  <a:schemeClr val="tx1"/>
-                </a:solidFill>
-                <a:latin typeface="Ramabhadra" panose="02000600000000000000" pitchFamily="2" charset="0"/>
-                <a:cs typeface="Ramabhadra" panose="02000600000000000000" pitchFamily="2" charset="0"/>
-              </a:rPr>
-              <a:t>జవాబేమి లేదని –</a:t>
-            </a:r>
-            <a:endParaRPr lang="en-IN" sz="3200" dirty="0">
-              <a:solidFill>
-                <a:schemeClr val="tx1"/>
-              </a:solidFill>
-              <a:latin typeface="Ramabhadra" panose="02000600000000000000" pitchFamily="2" charset="0"/>
-              <a:cs typeface="Ramabhadra" panose="02000600000000000000" pitchFamily="2" charset="0"/>
-            </a:endParaRPr>
-          </a:p>
-          <a:p>
-            <a:pPr algn="ctr"/>
-            <a:r>
-              <a:rPr lang="te-IN" sz="3200" dirty="0">
-                <a:solidFill>
-                  <a:schemeClr val="tx1"/>
-                </a:solidFill>
-                <a:latin typeface="Ramabhadra" panose="02000600000000000000" pitchFamily="2" charset="0"/>
-                <a:cs typeface="Ramabhadra" panose="02000600000000000000" pitchFamily="2" charset="0"/>
-              </a:rPr>
-              <a:t>దూషింప బోకుమా</a:t>
-            </a:r>
-          </a:p>
-          <a:p>
-            <a:pPr algn="ctr"/>
-            <a:r>
-              <a:rPr lang="te-IN" sz="3200" dirty="0">
-                <a:solidFill>
-                  <a:schemeClr val="tx1"/>
-                </a:solidFill>
-                <a:latin typeface="Ramabhadra" panose="02000600000000000000" pitchFamily="2" charset="0"/>
-                <a:cs typeface="Ramabhadra" panose="02000600000000000000" pitchFamily="2" charset="0"/>
-              </a:rPr>
-              <a:t>ప్రభుచిత్తమనె గిన్నెనే – సంతోషముగ త్రాగుమా </a:t>
-            </a:r>
-          </a:p>
-        </p:txBody>
-      </p:sp>
-      <p:sp>
-        <p:nvSpPr>
-          <p:cNvPr id="7" name="Rectangle 6">
+              <a:rPr lang="te-IN" sz="1600" dirty="0">
+                <a:solidFill>
+                  <a:schemeClr val="tx1"/>
+                </a:solidFill>
+                <a:latin typeface="Ramabhadra" panose="02000600000000000000" pitchFamily="2" charset="0"/>
+                <a:cs typeface="Ramabhadra" panose="02000600000000000000" pitchFamily="2" charset="0"/>
+              </a:rPr>
+              <a:t>ప్రార్ధనలో కనీళ్లు –</a:t>
+            </a:r>
+          </a:p>
+          <a:p>
+            <a:pPr algn="ctr"/>
+            <a:r>
+              <a:rPr lang="te-IN" sz="1600" dirty="0">
+                <a:solidFill>
+                  <a:schemeClr val="tx1"/>
+                </a:solidFill>
+                <a:latin typeface="Ramabhadra" panose="02000600000000000000" pitchFamily="2" charset="0"/>
+                <a:cs typeface="Ramabhadra" panose="02000600000000000000" pitchFamily="2" charset="0"/>
+              </a:rPr>
+              <a:t>కరిగిపోవుట అసాధ్యము</a:t>
+            </a:r>
+          </a:p>
+          <a:p>
+            <a:pPr algn="ctr"/>
+            <a:r>
+              <a:rPr lang="te-IN" sz="1600" dirty="0">
+                <a:solidFill>
+                  <a:schemeClr val="tx1"/>
+                </a:solidFill>
+                <a:latin typeface="Ramabhadra" panose="02000600000000000000" pitchFamily="2" charset="0"/>
+                <a:cs typeface="Ramabhadra" panose="02000600000000000000" pitchFamily="2" charset="0"/>
+              </a:rPr>
+              <a:t>ప్రార్ధనలో మూల్గునది –</a:t>
+            </a:r>
+          </a:p>
+          <a:p>
+            <a:pPr algn="ctr"/>
+            <a:r>
+              <a:rPr lang="te-IN" sz="1600" dirty="0">
+                <a:solidFill>
+                  <a:schemeClr val="tx1"/>
+                </a:solidFill>
+                <a:latin typeface="Ramabhadra" panose="02000600000000000000" pitchFamily="2" charset="0"/>
+                <a:cs typeface="Ramabhadra" panose="02000600000000000000" pitchFamily="2" charset="0"/>
+              </a:rPr>
+              <a:t>మరుగైపోవుట అసాధ్యము (2)</a:t>
+            </a:r>
+          </a:p>
+          <a:p>
+            <a:pPr algn="ctr"/>
+            <a:r>
+              <a:rPr lang="te-IN" sz="1600" dirty="0">
+                <a:solidFill>
+                  <a:schemeClr val="tx1"/>
+                </a:solidFill>
+                <a:latin typeface="Ramabhadra" panose="02000600000000000000" pitchFamily="2" charset="0"/>
+                <a:cs typeface="Ramabhadra" panose="02000600000000000000" pitchFamily="2" charset="0"/>
+              </a:rPr>
+              <a:t>ప్రార్ధనలో నలిగితే –</a:t>
+            </a:r>
+          </a:p>
+          <a:p>
+            <a:pPr algn="ctr"/>
+            <a:r>
+              <a:rPr lang="te-IN" sz="1600" dirty="0">
+                <a:solidFill>
+                  <a:schemeClr val="tx1"/>
+                </a:solidFill>
+                <a:latin typeface="Ramabhadra" panose="02000600000000000000" pitchFamily="2" charset="0"/>
+                <a:cs typeface="Ramabhadra" panose="02000600000000000000" pitchFamily="2" charset="0"/>
+              </a:rPr>
+              <a:t>నష్టపోవుట అసాధ్యము (2)</a:t>
+            </a:r>
+          </a:p>
+          <a:p>
+            <a:pPr algn="ctr"/>
+            <a:r>
+              <a:rPr lang="te-IN" sz="1600" dirty="0">
+                <a:solidFill>
+                  <a:schemeClr val="tx1"/>
+                </a:solidFill>
+                <a:latin typeface="Ramabhadra" panose="02000600000000000000" pitchFamily="2" charset="0"/>
+                <a:cs typeface="Ramabhadra" panose="02000600000000000000" pitchFamily="2" charset="0"/>
+              </a:rPr>
+              <a:t>ప్రార్ధనలో పెనుగులాడితే –</a:t>
+            </a:r>
+          </a:p>
+          <a:p>
+            <a:pPr algn="ctr"/>
+            <a:r>
+              <a:rPr lang="te-IN" sz="1600" dirty="0">
+                <a:solidFill>
+                  <a:schemeClr val="tx1"/>
+                </a:solidFill>
+                <a:latin typeface="Ramabhadra" panose="02000600000000000000" pitchFamily="2" charset="0"/>
+                <a:cs typeface="Ramabhadra" panose="02000600000000000000" pitchFamily="2" charset="0"/>
+              </a:rPr>
+              <a:t>పడిపోవుట అసాధ్యము (2)</a:t>
+            </a:r>
+          </a:p>
+        </p:txBody>
+      </p:sp>
+      <p:sp>
+        <p:nvSpPr>
+          <p:cNvPr id="10" name="Rectangle 9">
             <a:extLst>
               <a:ext uri="{FF2B5EF4-FFF2-40B4-BE49-F238E27FC236}">
-                <a16:creationId xmlns:a16="http://schemas.microsoft.com/office/drawing/2014/main" id="{91772679-4823-4B8E-8AB9-464A9B519206}"/>
+                <a16:creationId xmlns:a16="http://schemas.microsoft.com/office/drawing/2014/main" id="{5B5E28D2-6FF1-4F74-ABB1-904543A30A6F}"/>
               </a:ext>
             </a:extLst>
           </p:cNvPr>
@@ -5317,8 +5431,8 @@
         </p:nvSpPr>
         <p:spPr>
           <a:xfrm>
-            <a:off x="8552012" y="200526"/>
-            <a:ext cx="4274109" cy="9370194"/>
+            <a:off x="4953000" y="3174"/>
+            <a:ext cx="2476800" cy="6854826"/>
           </a:xfrm>
           <a:prstGeom prst="rect">
             <a:avLst/>
@@ -5356,55 +5470,97 @@
           <a:p>
             <a:pPr algn="ctr"/>
             <a:r>
-              <a:rPr lang="te-IN" sz="2700" dirty="0">
-                <a:solidFill>
-                  <a:schemeClr val="tx1"/>
-                </a:solidFill>
-                <a:latin typeface="Ramabhadra" panose="02000600000000000000" pitchFamily="2" charset="0"/>
-                <a:cs typeface="Ramabhadra" panose="02000600000000000000" pitchFamily="2" charset="0"/>
-              </a:rPr>
-              <a:t>ఎడబాయని నీ కృప</a:t>
-            </a:r>
-          </a:p>
-          <a:p>
-            <a:pPr algn="ctr"/>
-            <a:r>
-              <a:rPr lang="te-IN" sz="2700" dirty="0">
-                <a:solidFill>
-                  <a:schemeClr val="tx1"/>
-                </a:solidFill>
-                <a:latin typeface="Ramabhadra" panose="02000600000000000000" pitchFamily="2" charset="0"/>
-                <a:cs typeface="Ramabhadra" panose="02000600000000000000" pitchFamily="2" charset="0"/>
-              </a:rPr>
-              <a:t>నను విడువదు ఎన్నటికీ (2)</a:t>
-            </a:r>
-          </a:p>
-          <a:p>
-            <a:pPr algn="ctr"/>
-            <a:r>
-              <a:rPr lang="te-IN" sz="2700" dirty="0">
-                <a:solidFill>
-                  <a:schemeClr val="tx1"/>
-                </a:solidFill>
-                <a:latin typeface="Ramabhadra" panose="02000600000000000000" pitchFamily="2" charset="0"/>
-                <a:cs typeface="Ramabhadra" panose="02000600000000000000" pitchFamily="2" charset="0"/>
-              </a:rPr>
-              <a:t>యేసయ్యా నీ ప్రేమానురాగం</a:t>
-            </a:r>
-          </a:p>
-          <a:p>
-            <a:pPr algn="ctr"/>
-            <a:r>
-              <a:rPr lang="te-IN" sz="2700" dirty="0">
-                <a:solidFill>
-                  <a:schemeClr val="tx1"/>
-                </a:solidFill>
-                <a:latin typeface="Ramabhadra" panose="02000600000000000000" pitchFamily="2" charset="0"/>
-                <a:cs typeface="Ramabhadra" panose="02000600000000000000" pitchFamily="2" charset="0"/>
-              </a:rPr>
-              <a:t>నను కాయును అనుక్షణం (2)</a:t>
-            </a:r>
-            <a:endParaRPr lang="en-IN" sz="2700" dirty="0">
+              <a:rPr lang="te-IN" dirty="0">
+                <a:solidFill>
+                  <a:schemeClr val="tx1"/>
+                </a:solidFill>
+                <a:latin typeface="Ramabhadra" panose="02000600000000000000" pitchFamily="2" charset="0"/>
+                <a:cs typeface="Ramabhadra" panose="02000600000000000000" pitchFamily="2" charset="0"/>
+              </a:rPr>
+              <a:t>ప్రేమించెదన్ అధికముగా</a:t>
+            </a:r>
+          </a:p>
+          <a:p>
+            <a:pPr algn="ctr"/>
+            <a:r>
+              <a:rPr lang="te-IN" dirty="0">
+                <a:solidFill>
+                  <a:schemeClr val="tx1"/>
+                </a:solidFill>
+                <a:latin typeface="Ramabhadra" panose="02000600000000000000" pitchFamily="2" charset="0"/>
+                <a:cs typeface="Ramabhadra" panose="02000600000000000000" pitchFamily="2" charset="0"/>
+              </a:rPr>
+              <a:t>ఆరాధింతున్ ఆసక్తితో (2)</a:t>
+            </a:r>
+          </a:p>
+          <a:p>
+            <a:pPr algn="ctr"/>
+            <a:r>
+              <a:rPr lang="te-IN" dirty="0">
+                <a:solidFill>
+                  <a:schemeClr val="tx1"/>
+                </a:solidFill>
+                <a:latin typeface="Ramabhadra" panose="02000600000000000000" pitchFamily="2" charset="0"/>
+                <a:cs typeface="Ramabhadra" panose="02000600000000000000" pitchFamily="2" charset="0"/>
+              </a:rPr>
+              <a:t>నిన్ను పూర్ణ మనసుతో</a:t>
+            </a:r>
+          </a:p>
+          <a:p>
+            <a:pPr algn="ctr"/>
+            <a:r>
+              <a:rPr lang="te-IN" dirty="0">
+                <a:solidFill>
+                  <a:schemeClr val="tx1"/>
+                </a:solidFill>
+                <a:latin typeface="Ramabhadra" panose="02000600000000000000" pitchFamily="2" charset="0"/>
+                <a:cs typeface="Ramabhadra" panose="02000600000000000000" pitchFamily="2" charset="0"/>
+              </a:rPr>
+              <a:t>ఆరాధింతున్</a:t>
+            </a:r>
+          </a:p>
+          <a:p>
+            <a:pPr algn="ctr"/>
+            <a:r>
+              <a:rPr lang="te-IN" dirty="0">
+                <a:solidFill>
+                  <a:schemeClr val="tx1"/>
+                </a:solidFill>
+                <a:latin typeface="Ramabhadra" panose="02000600000000000000" pitchFamily="2" charset="0"/>
+                <a:cs typeface="Ramabhadra" panose="02000600000000000000" pitchFamily="2" charset="0"/>
+              </a:rPr>
+              <a:t>పూర్ణ బలముతో ప్రేమించెదన్</a:t>
+            </a:r>
+          </a:p>
+          <a:p>
+            <a:pPr algn="ctr"/>
+            <a:r>
+              <a:rPr lang="te-IN" dirty="0">
+                <a:solidFill>
+                  <a:schemeClr val="tx1"/>
+                </a:solidFill>
+                <a:latin typeface="Ramabhadra" panose="02000600000000000000" pitchFamily="2" charset="0"/>
+                <a:cs typeface="Ramabhadra" panose="02000600000000000000" pitchFamily="2" charset="0"/>
+              </a:rPr>
+              <a:t>ఆరాధన ఆరాధనా ఆ.. ఆ.. </a:t>
+            </a:r>
+          </a:p>
+          <a:p>
+            <a:pPr algn="ctr"/>
+            <a:r>
+              <a:rPr lang="te-IN" dirty="0">
+                <a:solidFill>
+                  <a:schemeClr val="tx1"/>
+                </a:solidFill>
+                <a:latin typeface="Ramabhadra" panose="02000600000000000000" pitchFamily="2" charset="0"/>
+                <a:cs typeface="Ramabhadra" panose="02000600000000000000" pitchFamily="2" charset="0"/>
+              </a:rPr>
+              <a:t>ఆరాధన ఆరాధనా (2)</a:t>
+            </a:r>
+          </a:p>
+          <a:p>
+            <a:pPr algn="ctr"/>
+            <a:endParaRPr lang="te-IN" dirty="0">
               <a:solidFill>
                 <a:schemeClr val="tx1"/>
               </a:solidFill>
@@ -5414,7 +5570,72 @@
           </a:p>
           <a:p>
             <a:pPr algn="ctr"/>
-            <a:endParaRPr lang="te-IN" sz="2700" dirty="0">
+            <a:r>
+              <a:rPr lang="te-IN" dirty="0">
+                <a:solidFill>
+                  <a:schemeClr val="tx1"/>
+                </a:solidFill>
+                <a:latin typeface="Ramabhadra" panose="02000600000000000000" pitchFamily="2" charset="0"/>
+                <a:cs typeface="Ramabhadra" panose="02000600000000000000" pitchFamily="2" charset="0"/>
+              </a:rPr>
+              <a:t>ఎబినేజరే ఎబినేజరే</a:t>
+            </a:r>
+          </a:p>
+          <a:p>
+            <a:pPr algn="ctr"/>
+            <a:r>
+              <a:rPr lang="te-IN" dirty="0">
+                <a:solidFill>
+                  <a:schemeClr val="tx1"/>
+                </a:solidFill>
+                <a:latin typeface="Ramabhadra" panose="02000600000000000000" pitchFamily="2" charset="0"/>
+                <a:cs typeface="Ramabhadra" panose="02000600000000000000" pitchFamily="2" charset="0"/>
+              </a:rPr>
+              <a:t>ఇంత వరకు</a:t>
+            </a:r>
+          </a:p>
+          <a:p>
+            <a:pPr algn="ctr"/>
+            <a:r>
+              <a:rPr lang="te-IN" dirty="0">
+                <a:solidFill>
+                  <a:schemeClr val="tx1"/>
+                </a:solidFill>
+                <a:latin typeface="Ramabhadra" panose="02000600000000000000" pitchFamily="2" charset="0"/>
+                <a:cs typeface="Ramabhadra" panose="02000600000000000000" pitchFamily="2" charset="0"/>
+              </a:rPr>
+              <a:t>ఆదుకొన్నావే (2)</a:t>
+            </a:r>
+          </a:p>
+          <a:p>
+            <a:pPr algn="ctr"/>
+            <a:r>
+              <a:rPr lang="te-IN" dirty="0">
+                <a:solidFill>
+                  <a:schemeClr val="tx1"/>
+                </a:solidFill>
+                <a:latin typeface="Ramabhadra" panose="02000600000000000000" pitchFamily="2" charset="0"/>
+                <a:cs typeface="Ramabhadra" panose="02000600000000000000" pitchFamily="2" charset="0"/>
+              </a:rPr>
+              <a:t>నన్ను ఇంత వరకు</a:t>
+            </a:r>
+          </a:p>
+          <a:p>
+            <a:pPr algn="ctr"/>
+            <a:r>
+              <a:rPr lang="te-IN" dirty="0">
+                <a:solidFill>
+                  <a:schemeClr val="tx1"/>
+                </a:solidFill>
+                <a:latin typeface="Ramabhadra" panose="02000600000000000000" pitchFamily="2" charset="0"/>
+                <a:cs typeface="Ramabhadra" panose="02000600000000000000" pitchFamily="2" charset="0"/>
+              </a:rPr>
+              <a:t>ఆదుకొన్నావే</a:t>
+            </a:r>
+          </a:p>
+          <a:p>
+            <a:pPr algn="ctr"/>
+            <a:endParaRPr lang="te-IN" dirty="0">
               <a:solidFill>
                 <a:schemeClr val="tx1"/>
               </a:solidFill>
@@ -5425,264 +5646,76 @@
           <a:p>
             <a:pPr algn="ctr"/>
             <a:r>
-              <a:rPr lang="te-IN" sz="2700" dirty="0">
-                <a:solidFill>
-                  <a:schemeClr val="tx1"/>
-                </a:solidFill>
-                <a:latin typeface="Ramabhadra" panose="02000600000000000000" pitchFamily="2" charset="0"/>
-                <a:cs typeface="Ramabhadra" panose="02000600000000000000" pitchFamily="2" charset="0"/>
-              </a:rPr>
-              <a:t>శోకపు లోయలలో –</a:t>
-            </a:r>
-            <a:endParaRPr lang="en-IN" sz="2700" dirty="0">
-              <a:solidFill>
-                <a:schemeClr val="tx1"/>
-              </a:solidFill>
-              <a:latin typeface="Ramabhadra" panose="02000600000000000000" pitchFamily="2" charset="0"/>
-              <a:cs typeface="Ramabhadra" panose="02000600000000000000" pitchFamily="2" charset="0"/>
-            </a:endParaRPr>
-          </a:p>
-          <a:p>
-            <a:pPr algn="ctr"/>
-            <a:r>
-              <a:rPr lang="te-IN" sz="2700" dirty="0">
-                <a:solidFill>
-                  <a:schemeClr val="tx1"/>
-                </a:solidFill>
-                <a:latin typeface="Ramabhadra" panose="02000600000000000000" pitchFamily="2" charset="0"/>
-                <a:cs typeface="Ramabhadra" panose="02000600000000000000" pitchFamily="2" charset="0"/>
-              </a:rPr>
-              <a:t>కష్టాల కడగండ్లలో</a:t>
-            </a:r>
-          </a:p>
-          <a:p>
-            <a:pPr algn="ctr"/>
-            <a:r>
-              <a:rPr lang="te-IN" sz="2700" dirty="0">
-                <a:solidFill>
-                  <a:schemeClr val="tx1"/>
-                </a:solidFill>
-                <a:latin typeface="Ramabhadra" panose="02000600000000000000" pitchFamily="2" charset="0"/>
-                <a:cs typeface="Ramabhadra" panose="02000600000000000000" pitchFamily="2" charset="0"/>
-              </a:rPr>
-              <a:t>కడలేని కడలిలో –</a:t>
-            </a:r>
-            <a:endParaRPr lang="en-IN" sz="2700" dirty="0">
-              <a:solidFill>
-                <a:schemeClr val="tx1"/>
-              </a:solidFill>
-              <a:latin typeface="Ramabhadra" panose="02000600000000000000" pitchFamily="2" charset="0"/>
-              <a:cs typeface="Ramabhadra" panose="02000600000000000000" pitchFamily="2" charset="0"/>
-            </a:endParaRPr>
-          </a:p>
-          <a:p>
-            <a:pPr algn="ctr"/>
-            <a:r>
-              <a:rPr lang="te-IN" sz="2700" dirty="0">
-                <a:solidFill>
-                  <a:schemeClr val="tx1"/>
-                </a:solidFill>
-                <a:latin typeface="Ramabhadra" panose="02000600000000000000" pitchFamily="2" charset="0"/>
-                <a:cs typeface="Ramabhadra" panose="02000600000000000000" pitchFamily="2" charset="0"/>
-              </a:rPr>
-              <a:t>నిరాశ నిసృహలో (2)</a:t>
-            </a:r>
-          </a:p>
-          <a:p>
-            <a:pPr algn="ctr"/>
-            <a:r>
-              <a:rPr lang="te-IN" sz="2700" dirty="0">
-                <a:solidFill>
-                  <a:schemeClr val="tx1"/>
-                </a:solidFill>
-                <a:latin typeface="Ramabhadra" panose="02000600000000000000" pitchFamily="2" charset="0"/>
-                <a:cs typeface="Ramabhadra" panose="02000600000000000000" pitchFamily="2" charset="0"/>
-              </a:rPr>
-              <a:t>అర్ధమేకాని ఈ జీవితం</a:t>
-            </a:r>
-          </a:p>
-          <a:p>
-            <a:pPr algn="ctr"/>
-            <a:r>
-              <a:rPr lang="te-IN" sz="2700" dirty="0">
-                <a:solidFill>
-                  <a:schemeClr val="tx1"/>
-                </a:solidFill>
-                <a:latin typeface="Ramabhadra" panose="02000600000000000000" pitchFamily="2" charset="0"/>
-                <a:cs typeface="Ramabhadra" panose="02000600000000000000" pitchFamily="2" charset="0"/>
-              </a:rPr>
-              <a:t>ఇక వ్యర్థమని నేననుకొనగ (2)</a:t>
-            </a:r>
-          </a:p>
-          <a:p>
-            <a:pPr algn="ctr"/>
-            <a:r>
-              <a:rPr lang="te-IN" sz="2700" dirty="0">
-                <a:solidFill>
-                  <a:schemeClr val="tx1"/>
-                </a:solidFill>
-                <a:latin typeface="Ramabhadra" panose="02000600000000000000" pitchFamily="2" charset="0"/>
-                <a:cs typeface="Ramabhadra" panose="02000600000000000000" pitchFamily="2" charset="0"/>
-              </a:rPr>
-              <a:t>కృపా కనికరముగల దేవా</a:t>
-            </a:r>
-          </a:p>
-          <a:p>
-            <a:pPr algn="ctr"/>
-            <a:r>
-              <a:rPr lang="te-IN" sz="2700" dirty="0">
-                <a:solidFill>
-                  <a:schemeClr val="tx1"/>
-                </a:solidFill>
-                <a:latin typeface="Ramabhadra" panose="02000600000000000000" pitchFamily="2" charset="0"/>
-                <a:cs typeface="Ramabhadra" panose="02000600000000000000" pitchFamily="2" charset="0"/>
-              </a:rPr>
-              <a:t>నా కష్టాల కడలిని దాటించితివి (2)</a:t>
-            </a:r>
-            <a:endParaRPr lang="en-IN" sz="2700" dirty="0">
-              <a:solidFill>
-                <a:schemeClr val="tx1"/>
-              </a:solidFill>
-              <a:latin typeface="Ramabhadra" panose="02000600000000000000" pitchFamily="2" charset="0"/>
-              <a:cs typeface="Ramabhadra" panose="02000600000000000000" pitchFamily="2" charset="0"/>
-            </a:endParaRPr>
-          </a:p>
-          <a:p>
-            <a:pPr algn="ctr"/>
-            <a:endParaRPr lang="te-IN" sz="2700" dirty="0">
-              <a:solidFill>
-                <a:schemeClr val="tx1"/>
-              </a:solidFill>
-              <a:latin typeface="Ramabhadra" panose="02000600000000000000" pitchFamily="2" charset="0"/>
-              <a:cs typeface="Ramabhadra" panose="02000600000000000000" pitchFamily="2" charset="0"/>
-            </a:endParaRPr>
-          </a:p>
-          <a:p>
-            <a:pPr algn="ctr"/>
-            <a:r>
-              <a:rPr lang="te-IN" sz="2700" dirty="0">
-                <a:solidFill>
-                  <a:schemeClr val="tx1"/>
-                </a:solidFill>
-                <a:latin typeface="Ramabhadra" panose="02000600000000000000" pitchFamily="2" charset="0"/>
-                <a:cs typeface="Ramabhadra" panose="02000600000000000000" pitchFamily="2" charset="0"/>
-              </a:rPr>
-              <a:t>విశ్వాస పోరాటంలో –</a:t>
-            </a:r>
-            <a:endParaRPr lang="en-IN" sz="2700" dirty="0">
-              <a:solidFill>
-                <a:schemeClr val="tx1"/>
-              </a:solidFill>
-              <a:latin typeface="Ramabhadra" panose="02000600000000000000" pitchFamily="2" charset="0"/>
-              <a:cs typeface="Ramabhadra" panose="02000600000000000000" pitchFamily="2" charset="0"/>
-            </a:endParaRPr>
-          </a:p>
-          <a:p>
-            <a:pPr algn="ctr"/>
-            <a:r>
-              <a:rPr lang="te-IN" sz="2700" dirty="0">
-                <a:solidFill>
-                  <a:schemeClr val="tx1"/>
-                </a:solidFill>
-                <a:latin typeface="Ramabhadra" panose="02000600000000000000" pitchFamily="2" charset="0"/>
-                <a:cs typeface="Ramabhadra" panose="02000600000000000000" pitchFamily="2" charset="0"/>
-              </a:rPr>
-              <a:t>ఎదురాయె శోధనలు</a:t>
-            </a:r>
-          </a:p>
-          <a:p>
-            <a:pPr algn="ctr"/>
-            <a:r>
-              <a:rPr lang="te-IN" sz="2700" dirty="0">
-                <a:solidFill>
-                  <a:schemeClr val="tx1"/>
-                </a:solidFill>
-                <a:latin typeface="Ramabhadra" panose="02000600000000000000" pitchFamily="2" charset="0"/>
-                <a:cs typeface="Ramabhadra" panose="02000600000000000000" pitchFamily="2" charset="0"/>
-              </a:rPr>
-              <a:t>లోకాశల అలజడిలో –</a:t>
-            </a:r>
-            <a:endParaRPr lang="en-IN" sz="2700" dirty="0">
-              <a:solidFill>
-                <a:schemeClr val="tx1"/>
-              </a:solidFill>
-              <a:latin typeface="Ramabhadra" panose="02000600000000000000" pitchFamily="2" charset="0"/>
-              <a:cs typeface="Ramabhadra" panose="02000600000000000000" pitchFamily="2" charset="0"/>
-            </a:endParaRPr>
-          </a:p>
-          <a:p>
-            <a:pPr algn="ctr"/>
-            <a:r>
-              <a:rPr lang="te-IN" sz="2700" dirty="0">
-                <a:solidFill>
-                  <a:schemeClr val="tx1"/>
-                </a:solidFill>
-                <a:latin typeface="Ramabhadra" panose="02000600000000000000" pitchFamily="2" charset="0"/>
-                <a:cs typeface="Ramabhadra" panose="02000600000000000000" pitchFamily="2" charset="0"/>
-              </a:rPr>
-              <a:t>సడలితి విశ్వాసములో (2)</a:t>
-            </a:r>
-          </a:p>
-          <a:p>
-            <a:pPr algn="ctr"/>
-            <a:r>
-              <a:rPr lang="te-IN" sz="2700" dirty="0">
-                <a:solidFill>
-                  <a:schemeClr val="tx1"/>
-                </a:solidFill>
-                <a:latin typeface="Ramabhadra" panose="02000600000000000000" pitchFamily="2" charset="0"/>
-                <a:cs typeface="Ramabhadra" panose="02000600000000000000" pitchFamily="2" charset="0"/>
-              </a:rPr>
-              <a:t>దుష్టుల క్షేమమునే చూచి</a:t>
-            </a:r>
-          </a:p>
-          <a:p>
-            <a:pPr algn="ctr"/>
-            <a:r>
-              <a:rPr lang="te-IN" sz="2700" dirty="0">
-                <a:solidFill>
-                  <a:schemeClr val="tx1"/>
-                </a:solidFill>
-                <a:latin typeface="Ramabhadra" panose="02000600000000000000" pitchFamily="2" charset="0"/>
-                <a:cs typeface="Ramabhadra" panose="02000600000000000000" pitchFamily="2" charset="0"/>
-              </a:rPr>
-              <a:t>ఇక నీతి వ్యర్థమని అనుకొనగ (2)</a:t>
-            </a:r>
-          </a:p>
-          <a:p>
-            <a:pPr algn="ctr"/>
-            <a:r>
-              <a:rPr lang="te-IN" sz="2700" dirty="0">
-                <a:solidFill>
-                  <a:schemeClr val="tx1"/>
-                </a:solidFill>
-                <a:latin typeface="Ramabhadra" panose="02000600000000000000" pitchFamily="2" charset="0"/>
-                <a:cs typeface="Ramabhadra" panose="02000600000000000000" pitchFamily="2" charset="0"/>
-              </a:rPr>
-              <a:t>దీర్ఘశాంతముగల దేవా</a:t>
-            </a:r>
-          </a:p>
-          <a:p>
-            <a:pPr algn="ctr"/>
-            <a:r>
-              <a:rPr lang="te-IN" sz="2700" dirty="0">
-                <a:solidFill>
-                  <a:schemeClr val="tx1"/>
-                </a:solidFill>
-                <a:latin typeface="Ramabhadra" panose="02000600000000000000" pitchFamily="2" charset="0"/>
-                <a:cs typeface="Ramabhadra" panose="02000600000000000000" pitchFamily="2" charset="0"/>
-              </a:rPr>
-              <a:t>నా చేయి విడువక నడిపించితివి (2) </a:t>
-            </a:r>
-          </a:p>
-        </p:txBody>
-      </p:sp>
-      <p:sp>
-        <p:nvSpPr>
-          <p:cNvPr id="8" name="Rectangle 7">
+              <a:rPr lang="te-IN" dirty="0">
+                <a:solidFill>
+                  <a:schemeClr val="tx1"/>
+                </a:solidFill>
+                <a:latin typeface="Ramabhadra" panose="02000600000000000000" pitchFamily="2" charset="0"/>
+                <a:cs typeface="Ramabhadra" panose="02000600000000000000" pitchFamily="2" charset="0"/>
+              </a:rPr>
+              <a:t>ఎల్రోహి ఎల్రోహి</a:t>
+            </a:r>
+          </a:p>
+          <a:p>
+            <a:pPr algn="ctr"/>
+            <a:r>
+              <a:rPr lang="te-IN" dirty="0">
+                <a:solidFill>
+                  <a:schemeClr val="tx1"/>
+                </a:solidFill>
+                <a:latin typeface="Ramabhadra" panose="02000600000000000000" pitchFamily="2" charset="0"/>
+                <a:cs typeface="Ramabhadra" panose="02000600000000000000" pitchFamily="2" charset="0"/>
+              </a:rPr>
+              <a:t>నన్ను చూచావే</a:t>
+            </a:r>
+          </a:p>
+          <a:p>
+            <a:pPr algn="ctr"/>
+            <a:r>
+              <a:rPr lang="te-IN" dirty="0">
+                <a:solidFill>
+                  <a:schemeClr val="tx1"/>
+                </a:solidFill>
+                <a:latin typeface="Ramabhadra" panose="02000600000000000000" pitchFamily="2" charset="0"/>
+                <a:cs typeface="Ramabhadra" panose="02000600000000000000" pitchFamily="2" charset="0"/>
+              </a:rPr>
+              <a:t>వందనమయ్యా (2)</a:t>
+            </a:r>
+          </a:p>
+          <a:p>
+            <a:pPr algn="ctr"/>
+            <a:r>
+              <a:rPr lang="te-IN" dirty="0">
+                <a:solidFill>
+                  <a:schemeClr val="tx1"/>
+                </a:solidFill>
+                <a:latin typeface="Ramabhadra" panose="02000600000000000000" pitchFamily="2" charset="0"/>
+                <a:cs typeface="Ramabhadra" panose="02000600000000000000" pitchFamily="2" charset="0"/>
+              </a:rPr>
+              <a:t>నన్ను చూచావే</a:t>
+            </a:r>
+          </a:p>
+          <a:p>
+            <a:pPr algn="ctr"/>
+            <a:r>
+              <a:rPr lang="te-IN" dirty="0">
+                <a:solidFill>
+                  <a:schemeClr val="tx1"/>
+                </a:solidFill>
+                <a:latin typeface="Ramabhadra" panose="02000600000000000000" pitchFamily="2" charset="0"/>
+                <a:cs typeface="Ramabhadra" panose="02000600000000000000" pitchFamily="2" charset="0"/>
+              </a:rPr>
+              <a:t>వందనమయ్యా</a:t>
+            </a:r>
+          </a:p>
+        </p:txBody>
+      </p:sp>
+      <p:sp>
+        <p:nvSpPr>
+          <p:cNvPr id="11" name="Rectangle 10">
             <a:extLst>
               <a:ext uri="{FF2B5EF4-FFF2-40B4-BE49-F238E27FC236}">
-                <a16:creationId xmlns:a16="http://schemas.microsoft.com/office/drawing/2014/main" id="{F361557D-D07C-4965-BA7F-16390F4CD4A9}"/>
+                <a16:creationId xmlns:a16="http://schemas.microsoft.com/office/drawing/2014/main" id="{ACB01980-9038-477C-BE98-7CF572519C28}"/>
               </a:ext>
             </a:extLst>
           </p:cNvPr>
@@ -5691,8 +5724,8 @@
         </p:nvSpPr>
         <p:spPr>
           <a:xfrm>
-            <a:off x="12826121" y="200526"/>
-            <a:ext cx="4523095" cy="9370194"/>
+            <a:off x="7429200" y="3174"/>
+            <a:ext cx="2476800" cy="6854826"/>
           </a:xfrm>
           <a:prstGeom prst="rect">
             <a:avLst/>
@@ -5730,16 +5763,45 @@
           <a:p>
             <a:pPr algn="ctr"/>
             <a:r>
-              <a:rPr lang="te-IN" sz="3200" dirty="0">
-                <a:solidFill>
-                  <a:schemeClr val="tx1"/>
-                </a:solidFill>
-                <a:latin typeface="Ramabhadra" panose="02000600000000000000" pitchFamily="2" charset="0"/>
-                <a:cs typeface="Ramabhadra" panose="02000600000000000000" pitchFamily="2" charset="0"/>
-              </a:rPr>
-              <a:t>నేనున్న స్థితిలోనే</a:t>
-            </a:r>
-            <a:endParaRPr lang="en-IN" sz="3200" dirty="0">
+              <a:rPr lang="te-IN" sz="1400" dirty="0">
+                <a:solidFill>
+                  <a:schemeClr val="tx1"/>
+                </a:solidFill>
+                <a:latin typeface="Ramabhadra" panose="02000600000000000000" pitchFamily="2" charset="0"/>
+                <a:cs typeface="Ramabhadra" panose="02000600000000000000" pitchFamily="2" charset="0"/>
+              </a:rPr>
+              <a:t>నేనెల్లప్పుడు యెహోవను సన్నుతించెదన్</a:t>
+            </a:r>
+          </a:p>
+          <a:p>
+            <a:pPr algn="ctr"/>
+            <a:r>
+              <a:rPr lang="te-IN" sz="1400" dirty="0">
+                <a:solidFill>
+                  <a:schemeClr val="tx1"/>
+                </a:solidFill>
+                <a:latin typeface="Ramabhadra" panose="02000600000000000000" pitchFamily="2" charset="0"/>
+                <a:cs typeface="Ramabhadra" panose="02000600000000000000" pitchFamily="2" charset="0"/>
+              </a:rPr>
+              <a:t>నిత్యము ఆయన కీర్తి</a:t>
+            </a:r>
+          </a:p>
+          <a:p>
+            <a:pPr algn="ctr"/>
+            <a:r>
+              <a:rPr lang="te-IN" sz="1400" dirty="0">
+                <a:solidFill>
+                  <a:schemeClr val="tx1"/>
+                </a:solidFill>
+                <a:latin typeface="Ramabhadra" panose="02000600000000000000" pitchFamily="2" charset="0"/>
+                <a:cs typeface="Ramabhadra" panose="02000600000000000000" pitchFamily="2" charset="0"/>
+              </a:rPr>
+              <a:t>నా నోట నుండున్ (2)</a:t>
+            </a:r>
+          </a:p>
+          <a:p>
+            <a:pPr algn="ctr"/>
+            <a:endParaRPr lang="te-IN" sz="1400" dirty="0">
               <a:solidFill>
                 <a:schemeClr val="tx1"/>
               </a:solidFill>
@@ -5750,29 +5812,110 @@
           <a:p>
             <a:pPr algn="ctr"/>
             <a:r>
-              <a:rPr lang="te-IN" sz="3200" dirty="0">
-                <a:solidFill>
-                  <a:schemeClr val="tx1"/>
-                </a:solidFill>
-                <a:latin typeface="Ramabhadra" panose="02000600000000000000" pitchFamily="2" charset="0"/>
-                <a:cs typeface="Ramabhadra" panose="02000600000000000000" pitchFamily="2" charset="0"/>
-              </a:rPr>
-              <a:t>సంతృప్తిని కలిగించు </a:t>
-            </a:r>
-          </a:p>
-          <a:p>
-            <a:pPr algn="ctr"/>
-            <a:r>
-              <a:rPr lang="te-IN" sz="3200" dirty="0">
-                <a:solidFill>
-                  <a:schemeClr val="tx1"/>
-                </a:solidFill>
-                <a:latin typeface="Ramabhadra" panose="02000600000000000000" pitchFamily="2" charset="0"/>
-                <a:cs typeface="Ramabhadra" panose="02000600000000000000" pitchFamily="2" charset="0"/>
-              </a:rPr>
-              <a:t>ఏమున్న లేకున్న</a:t>
-            </a:r>
-            <a:endParaRPr lang="en-IN" sz="3200" dirty="0">
+              <a:rPr lang="te-IN" sz="1400" dirty="0">
+                <a:solidFill>
+                  <a:schemeClr val="tx1"/>
+                </a:solidFill>
+                <a:latin typeface="Ramabhadra" panose="02000600000000000000" pitchFamily="2" charset="0"/>
+                <a:cs typeface="Ramabhadra" panose="02000600000000000000" pitchFamily="2" charset="0"/>
+              </a:rPr>
+              <a:t>అంతా నా మేలుకే –</a:t>
+            </a:r>
+          </a:p>
+          <a:p>
+            <a:pPr algn="ctr"/>
+            <a:r>
+              <a:rPr lang="te-IN" sz="1400" dirty="0">
+                <a:solidFill>
+                  <a:schemeClr val="tx1"/>
+                </a:solidFill>
+                <a:latin typeface="Ramabhadra" panose="02000600000000000000" pitchFamily="2" charset="0"/>
+                <a:cs typeface="Ramabhadra" panose="02000600000000000000" pitchFamily="2" charset="0"/>
+              </a:rPr>
+              <a:t>ఆరాధన యేసుకే</a:t>
+            </a:r>
+          </a:p>
+          <a:p>
+            <a:pPr algn="ctr"/>
+            <a:r>
+              <a:rPr lang="te-IN" sz="1400" dirty="0">
+                <a:solidFill>
+                  <a:schemeClr val="tx1"/>
+                </a:solidFill>
+                <a:latin typeface="Ramabhadra" panose="02000600000000000000" pitchFamily="2" charset="0"/>
+                <a:cs typeface="Ramabhadra" panose="02000600000000000000" pitchFamily="2" charset="0"/>
+              </a:rPr>
+              <a:t>అంతా నా మంచికే –</a:t>
+            </a:r>
+          </a:p>
+          <a:p>
+            <a:pPr algn="ctr"/>
+            <a:r>
+              <a:rPr lang="te-IN" sz="1400" dirty="0">
+                <a:solidFill>
+                  <a:schemeClr val="tx1"/>
+                </a:solidFill>
+                <a:latin typeface="Ramabhadra" panose="02000600000000000000" pitchFamily="2" charset="0"/>
+                <a:cs typeface="Ramabhadra" panose="02000600000000000000" pitchFamily="2" charset="0"/>
+              </a:rPr>
+              <a:t>తన చిత్తమునకు తల వంచితే</a:t>
+            </a:r>
+          </a:p>
+          <a:p>
+            <a:pPr algn="ctr"/>
+            <a:r>
+              <a:rPr lang="te-IN" sz="1400" dirty="0">
+                <a:solidFill>
+                  <a:schemeClr val="tx1"/>
+                </a:solidFill>
+                <a:latin typeface="Ramabhadra" panose="02000600000000000000" pitchFamily="2" charset="0"/>
+                <a:cs typeface="Ramabhadra" panose="02000600000000000000" pitchFamily="2" charset="0"/>
+              </a:rPr>
+              <a:t>తన చిత్తమునకు తల వంచితే</a:t>
+            </a:r>
+          </a:p>
+          <a:p>
+            <a:pPr algn="ctr"/>
+            <a:r>
+              <a:rPr lang="te-IN" sz="1400" dirty="0">
+                <a:solidFill>
+                  <a:schemeClr val="tx1"/>
+                </a:solidFill>
+                <a:latin typeface="Ramabhadra" panose="02000600000000000000" pitchFamily="2" charset="0"/>
+                <a:cs typeface="Ramabhadra" panose="02000600000000000000" pitchFamily="2" charset="0"/>
+              </a:rPr>
+              <a:t>ఆరాధన ఆపను –</a:t>
+            </a:r>
+          </a:p>
+          <a:p>
+            <a:pPr algn="ctr"/>
+            <a:r>
+              <a:rPr lang="te-IN" sz="1400" dirty="0">
+                <a:solidFill>
+                  <a:schemeClr val="tx1"/>
+                </a:solidFill>
+                <a:latin typeface="Ramabhadra" panose="02000600000000000000" pitchFamily="2" charset="0"/>
+                <a:cs typeface="Ramabhadra" panose="02000600000000000000" pitchFamily="2" charset="0"/>
+              </a:rPr>
+              <a:t>స్తుతియించుట మానను (2)</a:t>
+            </a:r>
+          </a:p>
+          <a:p>
+            <a:pPr algn="ctr"/>
+            <a:r>
+              <a:rPr lang="te-IN" sz="1400" dirty="0">
+                <a:solidFill>
+                  <a:schemeClr val="tx1"/>
+                </a:solidFill>
+                <a:latin typeface="Ramabhadra" panose="02000600000000000000" pitchFamily="2" charset="0"/>
+                <a:cs typeface="Ramabhadra" panose="02000600000000000000" pitchFamily="2" charset="0"/>
+              </a:rPr>
+              <a:t>స్తుతియించుట మానను</a:t>
+            </a:r>
+          </a:p>
+          <a:p>
+            <a:pPr algn="ctr"/>
+            <a:endParaRPr lang="te-IN" sz="1400" dirty="0">
               <a:solidFill>
                 <a:schemeClr val="tx1"/>
               </a:solidFill>
@@ -5783,29 +5926,110 @@
           <a:p>
             <a:pPr algn="ctr"/>
             <a:r>
-              <a:rPr lang="te-IN" sz="3200" dirty="0">
-                <a:solidFill>
-                  <a:schemeClr val="tx1"/>
-                </a:solidFill>
-                <a:latin typeface="Ramabhadra" panose="02000600000000000000" pitchFamily="2" charset="0"/>
-                <a:cs typeface="Ramabhadra" panose="02000600000000000000" pitchFamily="2" charset="0"/>
-              </a:rPr>
-              <a:t>నీకొరకే బ్రతికించు (2)</a:t>
-            </a:r>
-          </a:p>
-          <a:p>
-            <a:pPr algn="ctr"/>
-            <a:r>
-              <a:rPr lang="te-IN" sz="3200" dirty="0">
-                <a:solidFill>
-                  <a:schemeClr val="tx1"/>
-                </a:solidFill>
-                <a:latin typeface="Ramabhadra" panose="02000600000000000000" pitchFamily="2" charset="0"/>
-                <a:cs typeface="Ramabhadra" panose="02000600000000000000" pitchFamily="2" charset="0"/>
-              </a:rPr>
-              <a:t>కష్టాలు ఎదురైనా</a:t>
-            </a:r>
-            <a:endParaRPr lang="en-IN" sz="3200" dirty="0">
+              <a:rPr lang="te-IN" sz="1400" dirty="0">
+                <a:solidFill>
+                  <a:schemeClr val="tx1"/>
+                </a:solidFill>
+                <a:latin typeface="Ramabhadra" panose="02000600000000000000" pitchFamily="2" charset="0"/>
+                <a:cs typeface="Ramabhadra" panose="02000600000000000000" pitchFamily="2" charset="0"/>
+              </a:rPr>
+              <a:t>కన్నీళ్లే పానములైనా –</a:t>
+            </a:r>
+          </a:p>
+          <a:p>
+            <a:pPr algn="ctr"/>
+            <a:r>
+              <a:rPr lang="te-IN" sz="1400" dirty="0">
+                <a:solidFill>
+                  <a:schemeClr val="tx1"/>
+                </a:solidFill>
+                <a:latin typeface="Ramabhadra" panose="02000600000000000000" pitchFamily="2" charset="0"/>
+                <a:cs typeface="Ramabhadra" panose="02000600000000000000" pitchFamily="2" charset="0"/>
+              </a:rPr>
+              <a:t>కఠిన దుఃఖ బాధలైనా</a:t>
+            </a:r>
+          </a:p>
+          <a:p>
+            <a:pPr algn="ctr"/>
+            <a:r>
+              <a:rPr lang="te-IN" sz="1400" dirty="0">
+                <a:solidFill>
+                  <a:schemeClr val="tx1"/>
+                </a:solidFill>
+                <a:latin typeface="Ramabhadra" panose="02000600000000000000" pitchFamily="2" charset="0"/>
+                <a:cs typeface="Ramabhadra" panose="02000600000000000000" pitchFamily="2" charset="0"/>
+              </a:rPr>
+              <a:t>స్థితి గతులే మారినా –</a:t>
+            </a:r>
+          </a:p>
+          <a:p>
+            <a:pPr algn="ctr"/>
+            <a:r>
+              <a:rPr lang="te-IN" sz="1400" dirty="0">
+                <a:solidFill>
+                  <a:schemeClr val="tx1"/>
+                </a:solidFill>
+                <a:latin typeface="Ramabhadra" panose="02000600000000000000" pitchFamily="2" charset="0"/>
+                <a:cs typeface="Ramabhadra" panose="02000600000000000000" pitchFamily="2" charset="0"/>
+              </a:rPr>
+              <a:t>అవకాశం చేజారినా (2)</a:t>
+            </a:r>
+          </a:p>
+          <a:p>
+            <a:pPr algn="ctr"/>
+            <a:r>
+              <a:rPr lang="te-IN" sz="1400" dirty="0">
+                <a:solidFill>
+                  <a:schemeClr val="tx1"/>
+                </a:solidFill>
+                <a:latin typeface="Ramabhadra" panose="02000600000000000000" pitchFamily="2" charset="0"/>
+                <a:cs typeface="Ramabhadra" panose="02000600000000000000" pitchFamily="2" charset="0"/>
+              </a:rPr>
+              <a:t>మారదు యేసు ప్రేమ – </a:t>
+            </a:r>
+          </a:p>
+          <a:p>
+            <a:pPr algn="ctr"/>
+            <a:r>
+              <a:rPr lang="te-IN" sz="1400" dirty="0">
+                <a:solidFill>
+                  <a:schemeClr val="tx1"/>
+                </a:solidFill>
+                <a:latin typeface="Ramabhadra" panose="02000600000000000000" pitchFamily="2" charset="0"/>
+                <a:cs typeface="Ramabhadra" panose="02000600000000000000" pitchFamily="2" charset="0"/>
+              </a:rPr>
+              <a:t>నిత్యుడైన తండ్రి ప్రేమ (2)</a:t>
+            </a:r>
+          </a:p>
+          <a:p>
+            <a:pPr algn="ctr"/>
+            <a:r>
+              <a:rPr lang="te-IN" sz="1400" dirty="0">
+                <a:solidFill>
+                  <a:schemeClr val="tx1"/>
+                </a:solidFill>
+                <a:latin typeface="Ramabhadra" panose="02000600000000000000" pitchFamily="2" charset="0"/>
+                <a:cs typeface="Ramabhadra" panose="02000600000000000000" pitchFamily="2" charset="0"/>
+              </a:rPr>
+              <a:t>మారదు యేసు ప్రేమ –</a:t>
+            </a:r>
+          </a:p>
+          <a:p>
+            <a:pPr algn="ctr"/>
+            <a:r>
+              <a:rPr lang="te-IN" sz="1400" dirty="0">
+                <a:solidFill>
+                  <a:schemeClr val="tx1"/>
+                </a:solidFill>
+                <a:latin typeface="Ramabhadra" panose="02000600000000000000" pitchFamily="2" charset="0"/>
+                <a:cs typeface="Ramabhadra" panose="02000600000000000000" pitchFamily="2" charset="0"/>
+              </a:rPr>
+              <a:t>నిత్యుడైన తండ్రి ప్రేమ (2)</a:t>
+            </a:r>
+          </a:p>
+          <a:p>
+            <a:pPr algn="ctr"/>
+            <a:endParaRPr lang="te-IN" sz="1400" dirty="0">
               <a:solidFill>
                 <a:schemeClr val="tx1"/>
               </a:solidFill>
@@ -5816,192 +6040,105 @@
           <a:p>
             <a:pPr algn="ctr"/>
             <a:r>
-              <a:rPr lang="te-IN" sz="3200" dirty="0">
-                <a:solidFill>
-                  <a:schemeClr val="tx1"/>
-                </a:solidFill>
-                <a:latin typeface="Ramabhadra" panose="02000600000000000000" pitchFamily="2" charset="0"/>
-                <a:cs typeface="Ramabhadra" panose="02000600000000000000" pitchFamily="2" charset="0"/>
-              </a:rPr>
-              <a:t>నా యాత్రను సాగించు </a:t>
-            </a:r>
-          </a:p>
-          <a:p>
-            <a:pPr algn="ctr"/>
-            <a:r>
-              <a:rPr lang="te-IN" sz="3200" dirty="0">
-                <a:solidFill>
-                  <a:schemeClr val="tx1"/>
-                </a:solidFill>
-                <a:latin typeface="Ramabhadra" panose="02000600000000000000" pitchFamily="2" charset="0"/>
-                <a:cs typeface="Ramabhadra" panose="02000600000000000000" pitchFamily="2" charset="0"/>
-              </a:rPr>
-              <a:t>నష్టాలలోనైనా</a:t>
-            </a:r>
-            <a:endParaRPr lang="en-IN" sz="3200" dirty="0">
-              <a:solidFill>
-                <a:schemeClr val="tx1"/>
-              </a:solidFill>
-              <a:latin typeface="Ramabhadra" panose="02000600000000000000" pitchFamily="2" charset="0"/>
-              <a:cs typeface="Ramabhadra" panose="02000600000000000000" pitchFamily="2" charset="0"/>
-            </a:endParaRPr>
-          </a:p>
-          <a:p>
-            <a:pPr algn="ctr"/>
-            <a:r>
-              <a:rPr lang="te-IN" sz="3200" dirty="0">
-                <a:solidFill>
-                  <a:schemeClr val="tx1"/>
-                </a:solidFill>
-                <a:latin typeface="Ramabhadra" panose="02000600000000000000" pitchFamily="2" charset="0"/>
-                <a:cs typeface="Ramabhadra" panose="02000600000000000000" pitchFamily="2" charset="0"/>
-              </a:rPr>
-              <a:t>స్తుతిచేయుట నేర్పించు (2)</a:t>
-            </a:r>
-          </a:p>
-          <a:p>
-            <a:pPr algn="ctr"/>
-            <a:endParaRPr lang="te-IN" sz="3200" dirty="0">
-              <a:solidFill>
-                <a:schemeClr val="tx1"/>
-              </a:solidFill>
-              <a:latin typeface="Ramabhadra" panose="02000600000000000000" pitchFamily="2" charset="0"/>
-              <a:cs typeface="Ramabhadra" panose="02000600000000000000" pitchFamily="2" charset="0"/>
-            </a:endParaRPr>
-          </a:p>
-          <a:p>
-            <a:pPr algn="ctr"/>
-            <a:r>
-              <a:rPr lang="te-IN" sz="3200" dirty="0">
-                <a:solidFill>
-                  <a:schemeClr val="tx1"/>
-                </a:solidFill>
-                <a:latin typeface="Ramabhadra" panose="02000600000000000000" pitchFamily="2" charset="0"/>
-                <a:cs typeface="Ramabhadra" panose="02000600000000000000" pitchFamily="2" charset="0"/>
-              </a:rPr>
-              <a:t>లోకములో నీ కొరకు</a:t>
-            </a:r>
-            <a:endParaRPr lang="en-IN" sz="3200" dirty="0">
-              <a:solidFill>
-                <a:schemeClr val="tx1"/>
-              </a:solidFill>
-              <a:latin typeface="Ramabhadra" panose="02000600000000000000" pitchFamily="2" charset="0"/>
-              <a:cs typeface="Ramabhadra" panose="02000600000000000000" pitchFamily="2" charset="0"/>
-            </a:endParaRPr>
-          </a:p>
-          <a:p>
-            <a:pPr algn="ctr"/>
-            <a:r>
-              <a:rPr lang="te-IN" sz="3200" dirty="0">
-                <a:solidFill>
-                  <a:schemeClr val="tx1"/>
-                </a:solidFill>
-                <a:latin typeface="Ramabhadra" panose="02000600000000000000" pitchFamily="2" charset="0"/>
-                <a:cs typeface="Ramabhadra" panose="02000600000000000000" pitchFamily="2" charset="0"/>
-              </a:rPr>
-              <a:t>జ్యోతిగ నను వెలిగించు (2)</a:t>
-            </a:r>
-          </a:p>
-          <a:p>
-            <a:pPr algn="ctr"/>
-            <a:r>
-              <a:rPr lang="te-IN" sz="3200" dirty="0">
-                <a:solidFill>
-                  <a:schemeClr val="tx1"/>
-                </a:solidFill>
-                <a:latin typeface="Ramabhadra" panose="02000600000000000000" pitchFamily="2" charset="0"/>
-                <a:cs typeface="Ramabhadra" panose="02000600000000000000" pitchFamily="2" charset="0"/>
-              </a:rPr>
-              <a:t>రెండవ రాకడవరకు</a:t>
-            </a:r>
-            <a:endParaRPr lang="en-IN" sz="3200" dirty="0">
-              <a:solidFill>
-                <a:schemeClr val="tx1"/>
-              </a:solidFill>
-              <a:latin typeface="Ramabhadra" panose="02000600000000000000" pitchFamily="2" charset="0"/>
-              <a:cs typeface="Ramabhadra" panose="02000600000000000000" pitchFamily="2" charset="0"/>
-            </a:endParaRPr>
-          </a:p>
-          <a:p>
-            <a:pPr algn="ctr"/>
-            <a:r>
-              <a:rPr lang="te-IN" sz="3200" dirty="0">
-                <a:solidFill>
-                  <a:schemeClr val="tx1"/>
-                </a:solidFill>
-                <a:latin typeface="Ramabhadra" panose="02000600000000000000" pitchFamily="2" charset="0"/>
-                <a:cs typeface="Ramabhadra" panose="02000600000000000000" pitchFamily="2" charset="0"/>
-              </a:rPr>
-              <a:t>విడువక నను నడిపించు (2)</a:t>
-            </a:r>
-          </a:p>
-          <a:p>
-            <a:pPr algn="ctr"/>
-            <a:endParaRPr lang="te-IN" sz="3200" dirty="0">
-              <a:solidFill>
-                <a:schemeClr val="tx1"/>
-              </a:solidFill>
-              <a:latin typeface="Ramabhadra" panose="02000600000000000000" pitchFamily="2" charset="0"/>
-              <a:cs typeface="Ramabhadra" panose="02000600000000000000" pitchFamily="2" charset="0"/>
-            </a:endParaRPr>
-          </a:p>
-          <a:p>
-            <a:pPr algn="ctr"/>
-            <a:r>
-              <a:rPr lang="te-IN" sz="3200" dirty="0">
-                <a:solidFill>
-                  <a:schemeClr val="tx1"/>
-                </a:solidFill>
-                <a:latin typeface="Ramabhadra" panose="02000600000000000000" pitchFamily="2" charset="0"/>
-                <a:cs typeface="Ramabhadra" panose="02000600000000000000" pitchFamily="2" charset="0"/>
-              </a:rPr>
-              <a:t>నా దినముల పరిమాణం</a:t>
-            </a:r>
-            <a:endParaRPr lang="en-IN" sz="3200" dirty="0">
-              <a:solidFill>
-                <a:schemeClr val="tx1"/>
-              </a:solidFill>
-              <a:latin typeface="Ramabhadra" panose="02000600000000000000" pitchFamily="2" charset="0"/>
-              <a:cs typeface="Ramabhadra" panose="02000600000000000000" pitchFamily="2" charset="0"/>
-            </a:endParaRPr>
-          </a:p>
-          <a:p>
-            <a:pPr algn="ctr"/>
-            <a:r>
-              <a:rPr lang="te-IN" sz="3200" dirty="0">
-                <a:solidFill>
-                  <a:schemeClr val="tx1"/>
-                </a:solidFill>
-                <a:latin typeface="Ramabhadra" panose="02000600000000000000" pitchFamily="2" charset="0"/>
-                <a:cs typeface="Ramabhadra" panose="02000600000000000000" pitchFamily="2" charset="0"/>
-              </a:rPr>
-              <a:t>లెక్కించుట నేర్పించు (2)</a:t>
-            </a:r>
-          </a:p>
-          <a:p>
-            <a:pPr algn="ctr"/>
-            <a:r>
-              <a:rPr lang="te-IN" sz="3200" dirty="0">
-                <a:solidFill>
-                  <a:schemeClr val="tx1"/>
-                </a:solidFill>
-                <a:latin typeface="Ramabhadra" panose="02000600000000000000" pitchFamily="2" charset="0"/>
-                <a:cs typeface="Ramabhadra" panose="02000600000000000000" pitchFamily="2" charset="0"/>
-              </a:rPr>
-              <a:t>నా లోపల స్థిర హృదయం</a:t>
-            </a:r>
-          </a:p>
-          <a:p>
-            <a:pPr algn="ctr"/>
-            <a:r>
-              <a:rPr lang="te-IN" sz="3200" dirty="0">
-                <a:solidFill>
-                  <a:schemeClr val="tx1"/>
-                </a:solidFill>
-                <a:latin typeface="Ramabhadra" panose="02000600000000000000" pitchFamily="2" charset="0"/>
-                <a:cs typeface="Ramabhadra" panose="02000600000000000000" pitchFamily="2" charset="0"/>
-              </a:rPr>
-              <a:t>నూతనముగ పుట్టించు (2)</a:t>
+              <a:rPr lang="te-IN" sz="1400" dirty="0">
+                <a:solidFill>
+                  <a:schemeClr val="tx1"/>
+                </a:solidFill>
+                <a:latin typeface="Ramabhadra" panose="02000600000000000000" pitchFamily="2" charset="0"/>
+                <a:cs typeface="Ramabhadra" panose="02000600000000000000" pitchFamily="2" charset="0"/>
+              </a:rPr>
+              <a:t>ఆస్తులన్ని కోల్పోయినా –</a:t>
+            </a:r>
+          </a:p>
+          <a:p>
+            <a:pPr algn="ctr"/>
+            <a:r>
+              <a:rPr lang="te-IN" sz="1400" dirty="0">
+                <a:solidFill>
+                  <a:schemeClr val="tx1"/>
+                </a:solidFill>
+                <a:latin typeface="Ramabhadra" panose="02000600000000000000" pitchFamily="2" charset="0"/>
+                <a:cs typeface="Ramabhadra" panose="02000600000000000000" pitchFamily="2" charset="0"/>
+              </a:rPr>
+              <a:t>కన్నవారే కనుమరుగైనా</a:t>
+            </a:r>
+          </a:p>
+          <a:p>
+            <a:pPr algn="ctr"/>
+            <a:r>
+              <a:rPr lang="te-IN" sz="1400" dirty="0">
+                <a:solidFill>
+                  <a:schemeClr val="tx1"/>
+                </a:solidFill>
+                <a:latin typeface="Ramabhadra" panose="02000600000000000000" pitchFamily="2" charset="0"/>
+                <a:cs typeface="Ramabhadra" panose="02000600000000000000" pitchFamily="2" charset="0"/>
+              </a:rPr>
+              <a:t>ఊపిరి భరువైనా –</a:t>
+            </a:r>
+          </a:p>
+          <a:p>
+            <a:pPr algn="ctr"/>
+            <a:r>
+              <a:rPr lang="te-IN" sz="1400" dirty="0">
+                <a:solidFill>
+                  <a:schemeClr val="tx1"/>
+                </a:solidFill>
+                <a:latin typeface="Ramabhadra" panose="02000600000000000000" pitchFamily="2" charset="0"/>
+                <a:cs typeface="Ramabhadra" panose="02000600000000000000" pitchFamily="2" charset="0"/>
+              </a:rPr>
+              <a:t>గుండెలే పగిలినా (2)</a:t>
+            </a:r>
+          </a:p>
+          <a:p>
+            <a:pPr algn="ctr"/>
+            <a:r>
+              <a:rPr lang="te-IN" sz="1400" dirty="0">
+                <a:solidFill>
+                  <a:schemeClr val="tx1"/>
+                </a:solidFill>
+                <a:latin typeface="Ramabhadra" panose="02000600000000000000" pitchFamily="2" charset="0"/>
+                <a:cs typeface="Ramabhadra" panose="02000600000000000000" pitchFamily="2" charset="0"/>
+              </a:rPr>
+              <a:t>యెహోవా ఇచ్చెను –</a:t>
+            </a:r>
+          </a:p>
+          <a:p>
+            <a:pPr algn="ctr"/>
+            <a:r>
+              <a:rPr lang="te-IN" sz="1400" dirty="0">
+                <a:solidFill>
+                  <a:schemeClr val="tx1"/>
+                </a:solidFill>
+                <a:latin typeface="Ramabhadra" panose="02000600000000000000" pitchFamily="2" charset="0"/>
+                <a:cs typeface="Ramabhadra" panose="02000600000000000000" pitchFamily="2" charset="0"/>
+              </a:rPr>
+              <a:t>యెహోవా తీసుకొనెను (2)</a:t>
+            </a:r>
+          </a:p>
+          <a:p>
+            <a:pPr algn="ctr"/>
+            <a:r>
+              <a:rPr lang="te-IN" sz="1400" dirty="0">
+                <a:solidFill>
+                  <a:schemeClr val="tx1"/>
+                </a:solidFill>
+                <a:latin typeface="Ramabhadra" panose="02000600000000000000" pitchFamily="2" charset="0"/>
+                <a:cs typeface="Ramabhadra" panose="02000600000000000000" pitchFamily="2" charset="0"/>
+              </a:rPr>
+              <a:t>ఆయన నామమునకే –</a:t>
+            </a:r>
+          </a:p>
+          <a:p>
+            <a:pPr algn="ctr"/>
+            <a:r>
+              <a:rPr lang="te-IN" sz="1400" dirty="0">
+                <a:solidFill>
+                  <a:schemeClr val="tx1"/>
+                </a:solidFill>
+                <a:latin typeface="Ramabhadra" panose="02000600000000000000" pitchFamily="2" charset="0"/>
+                <a:cs typeface="Ramabhadra" panose="02000600000000000000" pitchFamily="2" charset="0"/>
+              </a:rPr>
+              <a:t>స్తుతి కలుగు గాక (2)</a:t>
             </a:r>
           </a:p>
         </p:txBody>

</xml_diff>

<commit_message>
14 sunday july songs
</commit_message>
<xml_diff>
--- a/xerox.pptx
+++ b/xerox.pptx
@@ -226,7 +226,7 @@
           <a:p>
             <a:fld id="{3502DD63-DF8D-4AB8-92A0-0ECCF612C06C}" type="datetimeFigureOut">
               <a:rPr lang="en-IN" smtClean="0"/>
-              <a:t>23-06-2024</a:t>
+              <a:t>12-07-2024</a:t>
             </a:fld>
             <a:endParaRPr lang="en-IN"/>
           </a:p>
@@ -404,7 +404,7 @@
           <a:p>
             <a:fld id="{1AE741EC-1360-4793-999B-941E0396C9FA}" type="datetimeFigureOut">
               <a:rPr lang="en-IN" smtClean="0"/>
-              <a:t>23-06-2024</a:t>
+              <a:t>12-07-2024</a:t>
             </a:fld>
             <a:endParaRPr lang="en-IN"/>
           </a:p>
@@ -804,7 +804,7 @@
           <a:p>
             <a:fld id="{86FBD32F-FCAD-481A-B7D8-4D813FB7DB24}" type="datetimeFigureOut">
               <a:rPr lang="en-IN" smtClean="0"/>
-              <a:t>23-06-2024</a:t>
+              <a:t>12-07-2024</a:t>
             </a:fld>
             <a:endParaRPr lang="en-IN"/>
           </a:p>
@@ -974,7 +974,7 @@
           <a:p>
             <a:fld id="{86FBD32F-FCAD-481A-B7D8-4D813FB7DB24}" type="datetimeFigureOut">
               <a:rPr lang="en-IN" smtClean="0"/>
-              <a:t>23-06-2024</a:t>
+              <a:t>12-07-2024</a:t>
             </a:fld>
             <a:endParaRPr lang="en-IN"/>
           </a:p>
@@ -1154,7 +1154,7 @@
           <a:p>
             <a:fld id="{86FBD32F-FCAD-481A-B7D8-4D813FB7DB24}" type="datetimeFigureOut">
               <a:rPr lang="en-IN" smtClean="0"/>
-              <a:t>23-06-2024</a:t>
+              <a:t>12-07-2024</a:t>
             </a:fld>
             <a:endParaRPr lang="en-IN"/>
           </a:p>
@@ -1324,7 +1324,7 @@
           <a:p>
             <a:fld id="{86FBD32F-FCAD-481A-B7D8-4D813FB7DB24}" type="datetimeFigureOut">
               <a:rPr lang="en-IN" smtClean="0"/>
-              <a:t>23-06-2024</a:t>
+              <a:t>12-07-2024</a:t>
             </a:fld>
             <a:endParaRPr lang="en-IN"/>
           </a:p>
@@ -1568,7 +1568,7 @@
           <a:p>
             <a:fld id="{86FBD32F-FCAD-481A-B7D8-4D813FB7DB24}" type="datetimeFigureOut">
               <a:rPr lang="en-IN" smtClean="0"/>
-              <a:t>23-06-2024</a:t>
+              <a:t>12-07-2024</a:t>
             </a:fld>
             <a:endParaRPr lang="en-IN"/>
           </a:p>
@@ -1800,7 +1800,7 @@
           <a:p>
             <a:fld id="{86FBD32F-FCAD-481A-B7D8-4D813FB7DB24}" type="datetimeFigureOut">
               <a:rPr lang="en-IN" smtClean="0"/>
-              <a:t>23-06-2024</a:t>
+              <a:t>12-07-2024</a:t>
             </a:fld>
             <a:endParaRPr lang="en-IN"/>
           </a:p>
@@ -2167,7 +2167,7 @@
           <a:p>
             <a:fld id="{86FBD32F-FCAD-481A-B7D8-4D813FB7DB24}" type="datetimeFigureOut">
               <a:rPr lang="en-IN" smtClean="0"/>
-              <a:t>23-06-2024</a:t>
+              <a:t>12-07-2024</a:t>
             </a:fld>
             <a:endParaRPr lang="en-IN"/>
           </a:p>
@@ -2285,7 +2285,7 @@
           <a:p>
             <a:fld id="{86FBD32F-FCAD-481A-B7D8-4D813FB7DB24}" type="datetimeFigureOut">
               <a:rPr lang="en-IN" smtClean="0"/>
-              <a:t>23-06-2024</a:t>
+              <a:t>12-07-2024</a:t>
             </a:fld>
             <a:endParaRPr lang="en-IN"/>
           </a:p>
@@ -2380,7 +2380,7 @@
           <a:p>
             <a:fld id="{86FBD32F-FCAD-481A-B7D8-4D813FB7DB24}" type="datetimeFigureOut">
               <a:rPr lang="en-IN" smtClean="0"/>
-              <a:t>23-06-2024</a:t>
+              <a:t>12-07-2024</a:t>
             </a:fld>
             <a:endParaRPr lang="en-IN"/>
           </a:p>
@@ -2657,7 +2657,7 @@
           <a:p>
             <a:fld id="{86FBD32F-FCAD-481A-B7D8-4D813FB7DB24}" type="datetimeFigureOut">
               <a:rPr lang="en-IN" smtClean="0"/>
-              <a:t>23-06-2024</a:t>
+              <a:t>12-07-2024</a:t>
             </a:fld>
             <a:endParaRPr lang="en-IN"/>
           </a:p>
@@ -2914,7 +2914,7 @@
           <a:p>
             <a:fld id="{86FBD32F-FCAD-481A-B7D8-4D813FB7DB24}" type="datetimeFigureOut">
               <a:rPr lang="en-IN" smtClean="0"/>
-              <a:t>23-06-2024</a:t>
+              <a:t>12-07-2024</a:t>
             </a:fld>
             <a:endParaRPr lang="en-IN"/>
           </a:p>
@@ -3127,7 +3127,7 @@
           <a:p>
             <a:fld id="{86FBD32F-FCAD-481A-B7D8-4D813FB7DB24}" type="datetimeFigureOut">
               <a:rPr lang="en-IN" smtClean="0"/>
-              <a:t>23-06-2024</a:t>
+              <a:t>12-07-2024</a:t>
             </a:fld>
             <a:endParaRPr lang="en-IN"/>
           </a:p>
@@ -4748,11 +4748,18 @@
                 <a:latin typeface="Ramabhadra" panose="02000600000000000000" pitchFamily="2" charset="0"/>
                 <a:cs typeface="Ramabhadra" panose="02000600000000000000" pitchFamily="2" charset="0"/>
               </a:rPr>
-              <a:t>నాలోని ప్రేమ</a:t>
-            </a:r>
-          </a:p>
-          <a:p>
-            <a:pPr algn="ctr"/>
+              <a:t>దేవ నడిపించుమా</a:t>
+            </a:r>
+            <a:r>
+              <a:rPr lang="en-IN" dirty="0">
+                <a:solidFill>
+                  <a:schemeClr val="tx1"/>
+                </a:solidFill>
+                <a:latin typeface="Ramabhadra" panose="02000600000000000000" pitchFamily="2" charset="0"/>
+                <a:cs typeface="Ramabhadra" panose="02000600000000000000" pitchFamily="2" charset="0"/>
+              </a:rPr>
+              <a:t>-</a:t>
+            </a:r>
             <a:r>
               <a:rPr lang="te-IN" dirty="0">
                 <a:solidFill>
@@ -4761,7 +4768,7 @@
                 <a:latin typeface="Ramabhadra" panose="02000600000000000000" pitchFamily="2" charset="0"/>
                 <a:cs typeface="Ramabhadra" panose="02000600000000000000" pitchFamily="2" charset="0"/>
               </a:rPr>
-              <a:t>నీదై ఉన్నది దేవా</a:t>
+              <a:t>అనుదినము</a:t>
             </a:r>
           </a:p>
           <a:p>
@@ -4774,7 +4781,7 @@
                 <a:latin typeface="Ramabhadra" panose="02000600000000000000" pitchFamily="2" charset="0"/>
                 <a:cs typeface="Ramabhadra" panose="02000600000000000000" pitchFamily="2" charset="0"/>
               </a:rPr>
-              <a:t>ఆ ప్రేమలో నన్ను</a:t>
+              <a:t>పరిశుద్ధాత్మతో నడిపించుమా</a:t>
             </a:r>
           </a:p>
           <a:p>
@@ -4787,7 +4794,7 @@
                 <a:latin typeface="Ramabhadra" panose="02000600000000000000" pitchFamily="2" charset="0"/>
                 <a:cs typeface="Ramabhadra" panose="02000600000000000000" pitchFamily="2" charset="0"/>
               </a:rPr>
-              <a:t>బలపరుచు దేవా - 2</a:t>
+              <a:t>యేసయ్యా...... యేసయ్యా.......</a:t>
             </a:r>
           </a:p>
           <a:p>
@@ -4800,46 +4807,7 @@
                 <a:latin typeface="Ramabhadra" panose="02000600000000000000" pitchFamily="2" charset="0"/>
                 <a:cs typeface="Ramabhadra" panose="02000600000000000000" pitchFamily="2" charset="0"/>
               </a:rPr>
-              <a:t>నీ ప్రేమ లేనిదే</a:t>
-            </a:r>
-          </a:p>
-          <a:p>
-            <a:pPr algn="ctr"/>
-            <a:r>
-              <a:rPr lang="te-IN" dirty="0">
-                <a:solidFill>
-                  <a:schemeClr val="tx1"/>
-                </a:solidFill>
-                <a:latin typeface="Ramabhadra" panose="02000600000000000000" pitchFamily="2" charset="0"/>
-                <a:cs typeface="Ramabhadra" panose="02000600000000000000" pitchFamily="2" charset="0"/>
-              </a:rPr>
-              <a:t>నే బ్రతుకలేను - 2</a:t>
-            </a:r>
-          </a:p>
-          <a:p>
-            <a:pPr algn="ctr"/>
-            <a:r>
-              <a:rPr lang="te-IN" dirty="0">
-                <a:solidFill>
-                  <a:schemeClr val="tx1"/>
-                </a:solidFill>
-                <a:latin typeface="Ramabhadra" panose="02000600000000000000" pitchFamily="2" charset="0"/>
-                <a:cs typeface="Ramabhadra" panose="02000600000000000000" pitchFamily="2" charset="0"/>
-              </a:rPr>
-              <a:t>యేసయ్య నీ ప్రేమ</a:t>
-            </a:r>
-          </a:p>
-          <a:p>
-            <a:pPr algn="ctr"/>
-            <a:r>
-              <a:rPr lang="te-IN" dirty="0">
-                <a:solidFill>
-                  <a:schemeClr val="tx1"/>
-                </a:solidFill>
-                <a:latin typeface="Ramabhadra" panose="02000600000000000000" pitchFamily="2" charset="0"/>
-                <a:cs typeface="Ramabhadra" panose="02000600000000000000" pitchFamily="2" charset="0"/>
-              </a:rPr>
-              <a:t>వర్ణింప నా తరమా - 2</a:t>
+              <a:t>యేసయ్యా....... హల్లెలూయా</a:t>
             </a:r>
           </a:p>
           <a:p>
@@ -4862,7 +4830,7 @@
                 <a:latin typeface="Ramabhadra" panose="02000600000000000000" pitchFamily="2" charset="0"/>
                 <a:cs typeface="Ramabhadra" panose="02000600000000000000" pitchFamily="2" charset="0"/>
               </a:rPr>
-              <a:t>నేను వెదకక ముందే</a:t>
+              <a:t>పాటలతో నడిపించుమా - ప్రార్థనతో నడిపించుమా</a:t>
             </a:r>
           </a:p>
           <a:p>
@@ -4875,59 +4843,7 @@
                 <a:latin typeface="Ramabhadra" panose="02000600000000000000" pitchFamily="2" charset="0"/>
                 <a:cs typeface="Ramabhadra" panose="02000600000000000000" pitchFamily="2" charset="0"/>
               </a:rPr>
-              <a:t>నన్ను వెదికిన ప్రేమ ఇది</a:t>
-            </a:r>
-          </a:p>
-          <a:p>
-            <a:pPr algn="ctr"/>
-            <a:r>
-              <a:rPr lang="te-IN" dirty="0">
-                <a:solidFill>
-                  <a:schemeClr val="tx1"/>
-                </a:solidFill>
-                <a:latin typeface="Ramabhadra" panose="02000600000000000000" pitchFamily="2" charset="0"/>
-                <a:cs typeface="Ramabhadra" panose="02000600000000000000" pitchFamily="2" charset="0"/>
-              </a:rPr>
-              <a:t>నేను ప్రేమించక ముందే</a:t>
-            </a:r>
-          </a:p>
-          <a:p>
-            <a:pPr algn="ctr"/>
-            <a:r>
-              <a:rPr lang="te-IN" dirty="0">
-                <a:solidFill>
-                  <a:schemeClr val="tx1"/>
-                </a:solidFill>
-                <a:latin typeface="Ramabhadra" panose="02000600000000000000" pitchFamily="2" charset="0"/>
-                <a:cs typeface="Ramabhadra" panose="02000600000000000000" pitchFamily="2" charset="0"/>
-              </a:rPr>
-              <a:t>నను ప్రేమించినది - 2</a:t>
-            </a:r>
-          </a:p>
-          <a:p>
-            <a:pPr algn="ctr"/>
-            <a:r>
-              <a:rPr lang="te-IN" dirty="0">
-                <a:solidFill>
-                  <a:schemeClr val="tx1"/>
-                </a:solidFill>
-                <a:latin typeface="Ramabhadra" panose="02000600000000000000" pitchFamily="2" charset="0"/>
-                <a:cs typeface="Ramabhadra" panose="02000600000000000000" pitchFamily="2" charset="0"/>
-              </a:rPr>
-              <a:t>సిలువలో నీ దివ్య ప్రేమ</a:t>
-            </a:r>
-          </a:p>
-          <a:p>
-            <a:pPr algn="ctr"/>
-            <a:r>
-              <a:rPr lang="te-IN" dirty="0">
-                <a:solidFill>
-                  <a:schemeClr val="tx1"/>
-                </a:solidFill>
-                <a:latin typeface="Ramabhadra" panose="02000600000000000000" pitchFamily="2" charset="0"/>
-                <a:cs typeface="Ramabhadra" panose="02000600000000000000" pitchFamily="2" charset="0"/>
-              </a:rPr>
-              <a:t>విలువకు అందనిది - 2</a:t>
+              <a:t>వాక్యముతో నడిపించుమా-సాక్షముతో నడిపించుమా</a:t>
             </a:r>
           </a:p>
           <a:p>
@@ -4950,8 +4866,15 @@
                 <a:latin typeface="Ramabhadra" panose="02000600000000000000" pitchFamily="2" charset="0"/>
                 <a:cs typeface="Ramabhadra" panose="02000600000000000000" pitchFamily="2" charset="0"/>
               </a:rPr>
-              <a:t>బాధ్యతయిన ప్రేమ నీది</a:t>
-            </a:r>
+              <a:t>కాపరియై నడిపించుమా –</a:t>
+            </a:r>
+            <a:endParaRPr lang="en-IN" dirty="0">
+              <a:solidFill>
+                <a:schemeClr val="tx1"/>
+              </a:solidFill>
+              <a:latin typeface="Ramabhadra" panose="02000600000000000000" pitchFamily="2" charset="0"/>
+              <a:cs typeface="Ramabhadra" panose="02000600000000000000" pitchFamily="2" charset="0"/>
+            </a:endParaRPr>
           </a:p>
           <a:p>
             <a:pPr algn="ctr"/>
@@ -4963,7 +4886,7 @@
                 <a:latin typeface="Ramabhadra" panose="02000600000000000000" pitchFamily="2" charset="0"/>
                 <a:cs typeface="Ramabhadra" panose="02000600000000000000" pitchFamily="2" charset="0"/>
               </a:rPr>
-              <a:t>నన్ను భరియించినది</a:t>
+              <a:t>ఊపిరి నీవై నడిపించుమా</a:t>
             </a:r>
           </a:p>
           <a:p>
@@ -4976,46 +4899,7 @@
                 <a:latin typeface="Ramabhadra" panose="02000600000000000000" pitchFamily="2" charset="0"/>
                 <a:cs typeface="Ramabhadra" panose="02000600000000000000" pitchFamily="2" charset="0"/>
               </a:rPr>
-              <a:t>భద్రత నిచ్చిన ప్రేమ నీది</a:t>
-            </a:r>
-          </a:p>
-          <a:p>
-            <a:pPr algn="ctr"/>
-            <a:r>
-              <a:rPr lang="te-IN" dirty="0">
-                <a:solidFill>
-                  <a:schemeClr val="tx1"/>
-                </a:solidFill>
-                <a:latin typeface="Ramabhadra" panose="02000600000000000000" pitchFamily="2" charset="0"/>
-                <a:cs typeface="Ramabhadra" panose="02000600000000000000" pitchFamily="2" charset="0"/>
-              </a:rPr>
-              <a:t>భారము బాపినది - 2</a:t>
-            </a:r>
-          </a:p>
-          <a:p>
-            <a:pPr algn="ctr"/>
-            <a:r>
-              <a:rPr lang="te-IN" dirty="0">
-                <a:solidFill>
-                  <a:schemeClr val="tx1"/>
-                </a:solidFill>
-                <a:latin typeface="Ramabhadra" panose="02000600000000000000" pitchFamily="2" charset="0"/>
-                <a:cs typeface="Ramabhadra" panose="02000600000000000000" pitchFamily="2" charset="0"/>
-              </a:rPr>
-              <a:t>బాధలో ఓదార్పునిచ్చి</a:t>
-            </a:r>
-          </a:p>
-          <a:p>
-            <a:pPr algn="ctr"/>
-            <a:r>
-              <a:rPr lang="te-IN" dirty="0">
-                <a:solidFill>
-                  <a:schemeClr val="tx1"/>
-                </a:solidFill>
-                <a:latin typeface="Ramabhadra" panose="02000600000000000000" pitchFamily="2" charset="0"/>
-                <a:cs typeface="Ramabhadra" panose="02000600000000000000" pitchFamily="2" charset="0"/>
-              </a:rPr>
-              <a:t>బలము చేకూర్చెను - 2</a:t>
+              <a:t>యాజకుడావై నడిపించుమా – భోదకుడావై భోదించుమా</a:t>
             </a:r>
           </a:p>
         </p:txBody>
@@ -5073,123 +4957,54 @@
           <a:p>
             <a:pPr algn="ctr"/>
             <a:r>
-              <a:rPr lang="te-IN" sz="1600" dirty="0">
-                <a:solidFill>
-                  <a:schemeClr val="tx1"/>
-                </a:solidFill>
-                <a:latin typeface="Ramabhadra" panose="02000600000000000000" pitchFamily="2" charset="0"/>
-                <a:cs typeface="Ramabhadra" panose="02000600000000000000" pitchFamily="2" charset="0"/>
-              </a:rPr>
-              <a:t>ప్రార్థన వలనే పయనము –</a:t>
-            </a:r>
-          </a:p>
-          <a:p>
-            <a:pPr algn="ctr"/>
-            <a:r>
-              <a:rPr lang="te-IN" sz="1600" dirty="0">
-                <a:solidFill>
-                  <a:schemeClr val="tx1"/>
-                </a:solidFill>
-                <a:latin typeface="Ramabhadra" panose="02000600000000000000" pitchFamily="2" charset="0"/>
-                <a:cs typeface="Ramabhadra" panose="02000600000000000000" pitchFamily="2" charset="0"/>
-              </a:rPr>
-              <a:t>ప్రార్థనే ప్రాకారము</a:t>
-            </a:r>
-          </a:p>
-          <a:p>
-            <a:pPr algn="ctr"/>
-            <a:r>
-              <a:rPr lang="te-IN" sz="1600" dirty="0">
-                <a:solidFill>
-                  <a:schemeClr val="tx1"/>
-                </a:solidFill>
-                <a:latin typeface="Ramabhadra" panose="02000600000000000000" pitchFamily="2" charset="0"/>
-                <a:cs typeface="Ramabhadra" panose="02000600000000000000" pitchFamily="2" charset="0"/>
-              </a:rPr>
-              <a:t>ప్రార్థనే ప్రాధాన్యము –</a:t>
-            </a:r>
-          </a:p>
-          <a:p>
-            <a:pPr algn="ctr"/>
-            <a:r>
-              <a:rPr lang="te-IN" sz="1600" dirty="0">
-                <a:solidFill>
-                  <a:schemeClr val="tx1"/>
-                </a:solidFill>
-                <a:latin typeface="Ramabhadra" panose="02000600000000000000" pitchFamily="2" charset="0"/>
-                <a:cs typeface="Ramabhadra" panose="02000600000000000000" pitchFamily="2" charset="0"/>
-              </a:rPr>
-              <a:t>ప్రార్థన లేనిదే పరాజయం (2)</a:t>
-            </a:r>
-          </a:p>
-          <a:p>
-            <a:pPr algn="ctr"/>
-            <a:r>
-              <a:rPr lang="te-IN" sz="1600" dirty="0">
-                <a:solidFill>
-                  <a:schemeClr val="tx1"/>
-                </a:solidFill>
-                <a:latin typeface="Ramabhadra" panose="02000600000000000000" pitchFamily="2" charset="0"/>
-                <a:cs typeface="Ramabhadra" panose="02000600000000000000" pitchFamily="2" charset="0"/>
-              </a:rPr>
-              <a:t>ప్రభువా ప్రార్థన నేర్పయ్యా</a:t>
-            </a:r>
-          </a:p>
-          <a:p>
-            <a:pPr algn="ctr"/>
-            <a:r>
-              <a:rPr lang="te-IN" sz="1600" dirty="0">
-                <a:solidFill>
-                  <a:schemeClr val="tx1"/>
-                </a:solidFill>
-                <a:latin typeface="Ramabhadra" panose="02000600000000000000" pitchFamily="2" charset="0"/>
-                <a:cs typeface="Ramabhadra" panose="02000600000000000000" pitchFamily="2" charset="0"/>
-              </a:rPr>
-              <a:t>ప్రార్ధించకుండా</a:t>
-            </a:r>
-          </a:p>
-          <a:p>
-            <a:pPr algn="ctr"/>
-            <a:r>
-              <a:rPr lang="te-IN" sz="1600" dirty="0">
-                <a:solidFill>
-                  <a:schemeClr val="tx1"/>
-                </a:solidFill>
-                <a:latin typeface="Ramabhadra" panose="02000600000000000000" pitchFamily="2" charset="0"/>
-                <a:cs typeface="Ramabhadra" panose="02000600000000000000" pitchFamily="2" charset="0"/>
-              </a:rPr>
-              <a:t>నే ఉండలేనయ్యా (2)</a:t>
-            </a:r>
-          </a:p>
-          <a:p>
-            <a:pPr algn="ctr"/>
-            <a:r>
-              <a:rPr lang="te-IN" sz="1600" dirty="0">
-                <a:solidFill>
-                  <a:schemeClr val="tx1"/>
-                </a:solidFill>
-                <a:latin typeface="Ramabhadra" panose="02000600000000000000" pitchFamily="2" charset="0"/>
-                <a:cs typeface="Ramabhadra" panose="02000600000000000000" pitchFamily="2" charset="0"/>
-              </a:rPr>
-              <a:t>నీ పాదాలు తడపకుండా</a:t>
-            </a:r>
-          </a:p>
-          <a:p>
-            <a:pPr algn="ctr"/>
-            <a:r>
-              <a:rPr lang="te-IN" sz="1600" dirty="0">
-                <a:solidFill>
-                  <a:schemeClr val="tx1"/>
-                </a:solidFill>
-                <a:latin typeface="Ramabhadra" panose="02000600000000000000" pitchFamily="2" charset="0"/>
-                <a:cs typeface="Ramabhadra" panose="02000600000000000000" pitchFamily="2" charset="0"/>
-              </a:rPr>
-              <a:t>నా పయనం సాగదయ్యా (2)</a:t>
-            </a:r>
-          </a:p>
-          <a:p>
-            <a:pPr algn="ctr"/>
-            <a:endParaRPr lang="te-IN" sz="1600" dirty="0">
+              <a:rPr lang="te-IN" dirty="0">
+                <a:solidFill>
+                  <a:schemeClr val="tx1"/>
+                </a:solidFill>
+                <a:latin typeface="Ramabhadra" panose="02000600000000000000" pitchFamily="2" charset="0"/>
+                <a:cs typeface="Ramabhadra" panose="02000600000000000000" pitchFamily="2" charset="0"/>
+              </a:rPr>
+              <a:t>ఎంత మంచి దేవుడవయ్యా</a:t>
+            </a:r>
+            <a:br>
+              <a:rPr lang="te-IN" dirty="0">
+                <a:solidFill>
+                  <a:schemeClr val="tx1"/>
+                </a:solidFill>
+                <a:latin typeface="Ramabhadra" panose="02000600000000000000" pitchFamily="2" charset="0"/>
+                <a:cs typeface="Ramabhadra" panose="02000600000000000000" pitchFamily="2" charset="0"/>
+              </a:rPr>
+            </a:br>
+            <a:r>
+              <a:rPr lang="te-IN" dirty="0">
+                <a:solidFill>
+                  <a:schemeClr val="tx1"/>
+                </a:solidFill>
+                <a:latin typeface="Ramabhadra" panose="02000600000000000000" pitchFamily="2" charset="0"/>
+                <a:cs typeface="Ramabhadra" panose="02000600000000000000" pitchFamily="2" charset="0"/>
+              </a:rPr>
+              <a:t>ఎంత మంచి దేవుడవేసయ్యా</a:t>
+            </a:r>
+            <a:br>
+              <a:rPr lang="te-IN" dirty="0">
+                <a:solidFill>
+                  <a:schemeClr val="tx1"/>
+                </a:solidFill>
+                <a:latin typeface="Ramabhadra" panose="02000600000000000000" pitchFamily="2" charset="0"/>
+                <a:cs typeface="Ramabhadra" panose="02000600000000000000" pitchFamily="2" charset="0"/>
+              </a:rPr>
+            </a:br>
+            <a:r>
+              <a:rPr lang="te-IN" dirty="0">
+                <a:solidFill>
+                  <a:schemeClr val="tx1"/>
+                </a:solidFill>
+                <a:latin typeface="Ramabhadra" panose="02000600000000000000" pitchFamily="2" charset="0"/>
+                <a:cs typeface="Ramabhadra" panose="02000600000000000000" pitchFamily="2" charset="0"/>
+              </a:rPr>
+              <a:t>  చింతలన్ని తీరేనయ్యా</a:t>
+            </a:r>
+            <a:endParaRPr lang="en-IN" dirty="0">
               <a:solidFill>
                 <a:schemeClr val="tx1"/>
               </a:solidFill>
@@ -5200,110 +5015,16 @@
           <a:p>
             <a:pPr algn="ctr"/>
             <a:r>
-              <a:rPr lang="te-IN" sz="1600" dirty="0">
-                <a:solidFill>
-                  <a:schemeClr val="tx1"/>
-                </a:solidFill>
-                <a:latin typeface="Ramabhadra" panose="02000600000000000000" pitchFamily="2" charset="0"/>
-                <a:cs typeface="Ramabhadra" panose="02000600000000000000" pitchFamily="2" charset="0"/>
-              </a:rPr>
-              <a:t>ప్రార్ధనలో నాటునది –</a:t>
-            </a:r>
-          </a:p>
-          <a:p>
-            <a:pPr algn="ctr"/>
-            <a:r>
-              <a:rPr lang="te-IN" sz="1600" dirty="0">
-                <a:solidFill>
-                  <a:schemeClr val="tx1"/>
-                </a:solidFill>
-                <a:latin typeface="Ramabhadra" panose="02000600000000000000" pitchFamily="2" charset="0"/>
-                <a:cs typeface="Ramabhadra" panose="02000600000000000000" pitchFamily="2" charset="0"/>
-              </a:rPr>
-              <a:t>పెల్లగించుట అసాధ్యము</a:t>
-            </a:r>
-          </a:p>
-          <a:p>
-            <a:pPr algn="ctr"/>
-            <a:r>
-              <a:rPr lang="te-IN" sz="1600" dirty="0">
-                <a:solidFill>
-                  <a:schemeClr val="tx1"/>
-                </a:solidFill>
-                <a:latin typeface="Ramabhadra" panose="02000600000000000000" pitchFamily="2" charset="0"/>
-                <a:cs typeface="Ramabhadra" panose="02000600000000000000" pitchFamily="2" charset="0"/>
-              </a:rPr>
-              <a:t>ప్రార్ధనలో పోరాడునది –</a:t>
-            </a:r>
-          </a:p>
-          <a:p>
-            <a:pPr algn="ctr"/>
-            <a:r>
-              <a:rPr lang="te-IN" sz="1600" dirty="0">
-                <a:solidFill>
-                  <a:schemeClr val="tx1"/>
-                </a:solidFill>
-                <a:latin typeface="Ramabhadra" panose="02000600000000000000" pitchFamily="2" charset="0"/>
-                <a:cs typeface="Ramabhadra" panose="02000600000000000000" pitchFamily="2" charset="0"/>
-              </a:rPr>
-              <a:t>పొందకపోవుట అసాధ్యము (2)</a:t>
-            </a:r>
-          </a:p>
-          <a:p>
-            <a:pPr algn="ctr"/>
-            <a:r>
-              <a:rPr lang="te-IN" sz="1600" dirty="0">
-                <a:solidFill>
-                  <a:schemeClr val="tx1"/>
-                </a:solidFill>
-                <a:latin typeface="Ramabhadra" panose="02000600000000000000" pitchFamily="2" charset="0"/>
-                <a:cs typeface="Ramabhadra" panose="02000600000000000000" pitchFamily="2" charset="0"/>
-              </a:rPr>
-              <a:t>ప్రార్ధనలో ప్రాకులాడినది –</a:t>
-            </a:r>
-          </a:p>
-          <a:p>
-            <a:pPr algn="ctr"/>
-            <a:r>
-              <a:rPr lang="te-IN" sz="1600" dirty="0">
-                <a:solidFill>
-                  <a:schemeClr val="tx1"/>
-                </a:solidFill>
-                <a:latin typeface="Ramabhadra" panose="02000600000000000000" pitchFamily="2" charset="0"/>
-                <a:cs typeface="Ramabhadra" panose="02000600000000000000" pitchFamily="2" charset="0"/>
-              </a:rPr>
-              <a:t>పతనమవ్వుట అసాధ్యము (2)</a:t>
-            </a:r>
-          </a:p>
-          <a:p>
-            <a:pPr algn="ctr"/>
-            <a:r>
-              <a:rPr lang="te-IN" sz="1600" dirty="0">
-                <a:solidFill>
-                  <a:schemeClr val="tx1"/>
-                </a:solidFill>
-                <a:latin typeface="Ramabhadra" panose="02000600000000000000" pitchFamily="2" charset="0"/>
-                <a:cs typeface="Ramabhadra" panose="02000600000000000000" pitchFamily="2" charset="0"/>
-              </a:rPr>
-              <a:t>ప్రార్ధనలో పదునైనది –</a:t>
-            </a:r>
-          </a:p>
-          <a:p>
-            <a:pPr algn="ctr"/>
-            <a:r>
-              <a:rPr lang="te-IN" sz="1600" dirty="0">
-                <a:solidFill>
-                  <a:schemeClr val="tx1"/>
-                </a:solidFill>
-                <a:latin typeface="Ramabhadra" panose="02000600000000000000" pitchFamily="2" charset="0"/>
-                <a:cs typeface="Ramabhadra" panose="02000600000000000000" pitchFamily="2" charset="0"/>
-              </a:rPr>
-              <a:t>పనిచేయకపోవుట అసాధ్యము (2)</a:t>
-            </a:r>
-          </a:p>
-          <a:p>
-            <a:pPr algn="ctr"/>
-            <a:endParaRPr lang="te-IN" sz="1600" dirty="0">
+              <a:rPr lang="te-IN" dirty="0">
+                <a:solidFill>
+                  <a:schemeClr val="tx1"/>
+                </a:solidFill>
+                <a:latin typeface="Ramabhadra" panose="02000600000000000000" pitchFamily="2" charset="0"/>
+                <a:cs typeface="Ramabhadra" panose="02000600000000000000" pitchFamily="2" charset="0"/>
+              </a:rPr>
+              <a:t>నిను చేరగా</a:t>
+            </a:r>
+            <a:endParaRPr lang="en-IN" dirty="0">
               <a:solidFill>
                 <a:schemeClr val="tx1"/>
               </a:solidFill>
@@ -5314,105 +5035,246 @@
           <a:p>
             <a:pPr algn="ctr"/>
             <a:r>
-              <a:rPr lang="te-IN" sz="1600" dirty="0">
-                <a:solidFill>
-                  <a:schemeClr val="tx1"/>
-                </a:solidFill>
-                <a:latin typeface="Ramabhadra" panose="02000600000000000000" pitchFamily="2" charset="0"/>
-                <a:cs typeface="Ramabhadra" panose="02000600000000000000" pitchFamily="2" charset="0"/>
-              </a:rPr>
-              <a:t>ప్రార్ధనలో కనీళ్లు –</a:t>
-            </a:r>
-          </a:p>
-          <a:p>
-            <a:pPr algn="ctr"/>
-            <a:r>
-              <a:rPr lang="te-IN" sz="1600" dirty="0">
-                <a:solidFill>
-                  <a:schemeClr val="tx1"/>
-                </a:solidFill>
-                <a:latin typeface="Ramabhadra" panose="02000600000000000000" pitchFamily="2" charset="0"/>
-                <a:cs typeface="Ramabhadra" panose="02000600000000000000" pitchFamily="2" charset="0"/>
-              </a:rPr>
-              <a:t>కరిగిపోవుట అసాధ్యము</a:t>
-            </a:r>
-          </a:p>
-          <a:p>
-            <a:pPr algn="ctr"/>
-            <a:r>
-              <a:rPr lang="te-IN" sz="1600" dirty="0">
-                <a:solidFill>
-                  <a:schemeClr val="tx1"/>
-                </a:solidFill>
-                <a:latin typeface="Ramabhadra" panose="02000600000000000000" pitchFamily="2" charset="0"/>
-                <a:cs typeface="Ramabhadra" panose="02000600000000000000" pitchFamily="2" charset="0"/>
-              </a:rPr>
-              <a:t>ప్రార్ధనలో మూల్గునది –</a:t>
-            </a:r>
-          </a:p>
-          <a:p>
-            <a:pPr algn="ctr"/>
-            <a:r>
-              <a:rPr lang="te-IN" sz="1600" dirty="0">
-                <a:solidFill>
-                  <a:schemeClr val="tx1"/>
-                </a:solidFill>
-                <a:latin typeface="Ramabhadra" panose="02000600000000000000" pitchFamily="2" charset="0"/>
-                <a:cs typeface="Ramabhadra" panose="02000600000000000000" pitchFamily="2" charset="0"/>
-              </a:rPr>
-              <a:t>మరుగైపోవుట అసాధ్యము (2)</a:t>
-            </a:r>
-          </a:p>
-          <a:p>
-            <a:pPr algn="ctr"/>
-            <a:r>
-              <a:rPr lang="te-IN" sz="1600" dirty="0">
-                <a:solidFill>
-                  <a:schemeClr val="tx1"/>
-                </a:solidFill>
-                <a:latin typeface="Ramabhadra" panose="02000600000000000000" pitchFamily="2" charset="0"/>
-                <a:cs typeface="Ramabhadra" panose="02000600000000000000" pitchFamily="2" charset="0"/>
-              </a:rPr>
-              <a:t>ప్రార్ధనలో నలిగితే –</a:t>
-            </a:r>
-          </a:p>
-          <a:p>
-            <a:pPr algn="ctr"/>
-            <a:r>
-              <a:rPr lang="te-IN" sz="1600" dirty="0">
-                <a:solidFill>
-                  <a:schemeClr val="tx1"/>
-                </a:solidFill>
-                <a:latin typeface="Ramabhadra" panose="02000600000000000000" pitchFamily="2" charset="0"/>
-                <a:cs typeface="Ramabhadra" panose="02000600000000000000" pitchFamily="2" charset="0"/>
-              </a:rPr>
-              <a:t>నష్టపోవుట అసాధ్యము (2)</a:t>
-            </a:r>
-          </a:p>
-          <a:p>
-            <a:pPr algn="ctr"/>
-            <a:r>
-              <a:rPr lang="te-IN" sz="1600" dirty="0">
-                <a:solidFill>
-                  <a:schemeClr val="tx1"/>
-                </a:solidFill>
-                <a:latin typeface="Ramabhadra" panose="02000600000000000000" pitchFamily="2" charset="0"/>
-                <a:cs typeface="Ramabhadra" panose="02000600000000000000" pitchFamily="2" charset="0"/>
-              </a:rPr>
-              <a:t>ప్రార్ధనలో పెనుగులాడితే –</a:t>
-            </a:r>
-          </a:p>
-          <a:p>
-            <a:pPr algn="ctr"/>
-            <a:r>
-              <a:rPr lang="te-IN" sz="1600" dirty="0">
-                <a:solidFill>
-                  <a:schemeClr val="tx1"/>
-                </a:solidFill>
-                <a:latin typeface="Ramabhadra" panose="02000600000000000000" pitchFamily="2" charset="0"/>
-                <a:cs typeface="Ramabhadra" panose="02000600000000000000" pitchFamily="2" charset="0"/>
-              </a:rPr>
-              <a:t>పడిపోవుట అసాధ్యము (2)</a:t>
+              <a:rPr lang="te-IN" dirty="0">
+                <a:solidFill>
+                  <a:schemeClr val="tx1"/>
+                </a:solidFill>
+                <a:latin typeface="Ramabhadra" panose="02000600000000000000" pitchFamily="2" charset="0"/>
+                <a:cs typeface="Ramabhadra" panose="02000600000000000000" pitchFamily="2" charset="0"/>
+              </a:rPr>
+              <a:t>ఎంత మంచి</a:t>
+            </a:r>
+            <a:endParaRPr lang="en-IN" dirty="0">
+              <a:solidFill>
+                <a:schemeClr val="tx1"/>
+              </a:solidFill>
+              <a:latin typeface="Ramabhadra" panose="02000600000000000000" pitchFamily="2" charset="0"/>
+              <a:cs typeface="Ramabhadra" panose="02000600000000000000" pitchFamily="2" charset="0"/>
+            </a:endParaRPr>
+          </a:p>
+          <a:p>
+            <a:pPr algn="ctr"/>
+            <a:r>
+              <a:rPr lang="te-IN" dirty="0">
+                <a:solidFill>
+                  <a:schemeClr val="tx1"/>
+                </a:solidFill>
+                <a:latin typeface="Ramabhadra" panose="02000600000000000000" pitchFamily="2" charset="0"/>
+                <a:cs typeface="Ramabhadra" panose="02000600000000000000" pitchFamily="2" charset="0"/>
+              </a:rPr>
+              <a:t>దేవుడవేసయ్యా (2)</a:t>
+            </a:r>
+          </a:p>
+          <a:p>
+            <a:pPr algn="ctr"/>
+            <a:endParaRPr lang="te-IN" dirty="0">
+              <a:solidFill>
+                <a:schemeClr val="tx1"/>
+              </a:solidFill>
+              <a:latin typeface="Ramabhadra" panose="02000600000000000000" pitchFamily="2" charset="0"/>
+              <a:cs typeface="Ramabhadra" panose="02000600000000000000" pitchFamily="2" charset="0"/>
+            </a:endParaRPr>
+          </a:p>
+          <a:p>
+            <a:pPr algn="ctr"/>
+            <a:r>
+              <a:rPr lang="te-IN" dirty="0">
+                <a:solidFill>
+                  <a:schemeClr val="tx1"/>
+                </a:solidFill>
+                <a:latin typeface="Ramabhadra" panose="02000600000000000000" pitchFamily="2" charset="0"/>
+                <a:cs typeface="Ramabhadra" panose="02000600000000000000" pitchFamily="2" charset="0"/>
+              </a:rPr>
+              <a:t>ఘోరపాపినైన నేనూ </a:t>
+            </a:r>
+          </a:p>
+          <a:p>
+            <a:pPr algn="ctr"/>
+            <a:r>
+              <a:rPr lang="te-IN" dirty="0">
+                <a:solidFill>
+                  <a:schemeClr val="tx1"/>
+                </a:solidFill>
+                <a:latin typeface="Ramabhadra" panose="02000600000000000000" pitchFamily="2" charset="0"/>
+                <a:cs typeface="Ramabhadra" panose="02000600000000000000" pitchFamily="2" charset="0"/>
+              </a:rPr>
+              <a:t>దూరంగా పారిపోగా (2)</a:t>
+            </a:r>
+            <a:br>
+              <a:rPr lang="te-IN" dirty="0">
+                <a:solidFill>
+                  <a:schemeClr val="tx1"/>
+                </a:solidFill>
+                <a:latin typeface="Ramabhadra" panose="02000600000000000000" pitchFamily="2" charset="0"/>
+                <a:cs typeface="Ramabhadra" panose="02000600000000000000" pitchFamily="2" charset="0"/>
+              </a:rPr>
+            </a:br>
+            <a:r>
+              <a:rPr lang="te-IN" dirty="0">
+                <a:solidFill>
+                  <a:schemeClr val="tx1"/>
+                </a:solidFill>
+                <a:latin typeface="Ramabhadra" panose="02000600000000000000" pitchFamily="2" charset="0"/>
+                <a:cs typeface="Ramabhadra" panose="02000600000000000000" pitchFamily="2" charset="0"/>
+              </a:rPr>
+              <a:t>నీ ప్రేమతో నను క్షమియించి</a:t>
+            </a:r>
+            <a:br>
+              <a:rPr lang="te-IN" dirty="0">
+                <a:solidFill>
+                  <a:schemeClr val="tx1"/>
+                </a:solidFill>
+                <a:latin typeface="Ramabhadra" panose="02000600000000000000" pitchFamily="2" charset="0"/>
+                <a:cs typeface="Ramabhadra" panose="02000600000000000000" pitchFamily="2" charset="0"/>
+              </a:rPr>
+            </a:br>
+            <a:r>
+              <a:rPr lang="te-IN" dirty="0">
+                <a:solidFill>
+                  <a:schemeClr val="tx1"/>
+                </a:solidFill>
+                <a:latin typeface="Ramabhadra" panose="02000600000000000000" pitchFamily="2" charset="0"/>
+                <a:cs typeface="Ramabhadra" panose="02000600000000000000" pitchFamily="2" charset="0"/>
+              </a:rPr>
+              <a:t>నను హత్తుకొన్నావయ్యా (2</a:t>
+            </a:r>
+            <a:r>
+              <a:rPr lang="en-IN" dirty="0">
+                <a:solidFill>
+                  <a:schemeClr val="tx1"/>
+                </a:solidFill>
+                <a:latin typeface="Ramabhadra" panose="02000600000000000000" pitchFamily="2" charset="0"/>
+                <a:cs typeface="Ramabhadra" panose="02000600000000000000" pitchFamily="2" charset="0"/>
+              </a:rPr>
+              <a:t>)</a:t>
+            </a:r>
+            <a:endParaRPr lang="te-IN" dirty="0">
+              <a:solidFill>
+                <a:schemeClr val="tx1"/>
+              </a:solidFill>
+              <a:latin typeface="Ramabhadra" panose="02000600000000000000" pitchFamily="2" charset="0"/>
+              <a:cs typeface="Ramabhadra" panose="02000600000000000000" pitchFamily="2" charset="0"/>
+            </a:endParaRPr>
+          </a:p>
+          <a:p>
+            <a:pPr algn="ctr"/>
+            <a:endParaRPr lang="te-IN" dirty="0">
+              <a:solidFill>
+                <a:schemeClr val="tx1"/>
+              </a:solidFill>
+              <a:latin typeface="Ramabhadra" panose="02000600000000000000" pitchFamily="2" charset="0"/>
+              <a:cs typeface="Ramabhadra" panose="02000600000000000000" pitchFamily="2" charset="0"/>
+            </a:endParaRPr>
+          </a:p>
+          <a:p>
+            <a:pPr algn="ctr"/>
+            <a:r>
+              <a:rPr lang="te-IN" dirty="0">
+                <a:solidFill>
+                  <a:schemeClr val="tx1"/>
+                </a:solidFill>
+                <a:latin typeface="Ramabhadra" panose="02000600000000000000" pitchFamily="2" charset="0"/>
+                <a:cs typeface="Ramabhadra" panose="02000600000000000000" pitchFamily="2" charset="0"/>
+              </a:rPr>
+              <a:t>నాకున్న వారందరూ –</a:t>
+            </a:r>
+            <a:endParaRPr lang="en-IN" dirty="0">
+              <a:solidFill>
+                <a:schemeClr val="tx1"/>
+              </a:solidFill>
+              <a:latin typeface="Ramabhadra" panose="02000600000000000000" pitchFamily="2" charset="0"/>
+              <a:cs typeface="Ramabhadra" panose="02000600000000000000" pitchFamily="2" charset="0"/>
+            </a:endParaRPr>
+          </a:p>
+          <a:p>
+            <a:pPr algn="ctr"/>
+            <a:r>
+              <a:rPr lang="te-IN" dirty="0">
+                <a:solidFill>
+                  <a:schemeClr val="tx1"/>
+                </a:solidFill>
+                <a:latin typeface="Ramabhadra" panose="02000600000000000000" pitchFamily="2" charset="0"/>
+                <a:cs typeface="Ramabhadra" panose="02000600000000000000" pitchFamily="2" charset="0"/>
+              </a:rPr>
+              <a:t>నను విడచిపోయిననూ (2)</a:t>
+            </a:r>
+            <a:br>
+              <a:rPr lang="te-IN" dirty="0">
+                <a:solidFill>
+                  <a:schemeClr val="tx1"/>
+                </a:solidFill>
+                <a:latin typeface="Ramabhadra" panose="02000600000000000000" pitchFamily="2" charset="0"/>
+                <a:cs typeface="Ramabhadra" panose="02000600000000000000" pitchFamily="2" charset="0"/>
+              </a:rPr>
+            </a:br>
+            <a:r>
+              <a:rPr lang="te-IN" dirty="0">
+                <a:solidFill>
+                  <a:schemeClr val="tx1"/>
+                </a:solidFill>
+                <a:latin typeface="Ramabhadra" panose="02000600000000000000" pitchFamily="2" charset="0"/>
+                <a:cs typeface="Ramabhadra" panose="02000600000000000000" pitchFamily="2" charset="0"/>
+              </a:rPr>
+              <a:t>ఎన్నెన్నో ఇబ్బందులకు</a:t>
+            </a:r>
+            <a:endParaRPr lang="en-IN" dirty="0">
+              <a:solidFill>
+                <a:schemeClr val="tx1"/>
+              </a:solidFill>
+              <a:latin typeface="Ramabhadra" panose="02000600000000000000" pitchFamily="2" charset="0"/>
+              <a:cs typeface="Ramabhadra" panose="02000600000000000000" pitchFamily="2" charset="0"/>
+            </a:endParaRPr>
+          </a:p>
+          <a:p>
+            <a:pPr algn="ctr"/>
+            <a:r>
+              <a:rPr lang="te-IN" dirty="0">
+                <a:solidFill>
+                  <a:schemeClr val="tx1"/>
+                </a:solidFill>
+                <a:latin typeface="Ramabhadra" panose="02000600000000000000" pitchFamily="2" charset="0"/>
+                <a:cs typeface="Ramabhadra" panose="02000600000000000000" pitchFamily="2" charset="0"/>
+              </a:rPr>
+              <a:t>గురి చేసిననూ</a:t>
+            </a:r>
+            <a:br>
+              <a:rPr lang="te-IN" dirty="0">
+                <a:solidFill>
+                  <a:schemeClr val="tx1"/>
+                </a:solidFill>
+                <a:latin typeface="Ramabhadra" panose="02000600000000000000" pitchFamily="2" charset="0"/>
+                <a:cs typeface="Ramabhadra" panose="02000600000000000000" pitchFamily="2" charset="0"/>
+              </a:rPr>
+            </a:br>
+            <a:r>
+              <a:rPr lang="te-IN" dirty="0">
+                <a:solidFill>
+                  <a:schemeClr val="tx1"/>
+                </a:solidFill>
+                <a:latin typeface="Ramabhadra" panose="02000600000000000000" pitchFamily="2" charset="0"/>
+                <a:cs typeface="Ramabhadra" panose="02000600000000000000" pitchFamily="2" charset="0"/>
+              </a:rPr>
+              <a:t>నను నీవు</a:t>
+            </a:r>
+            <a:r>
+              <a:rPr lang="en-IN" dirty="0">
+                <a:solidFill>
+                  <a:schemeClr val="tx1"/>
+                </a:solidFill>
+                <a:latin typeface="Ramabhadra" panose="02000600000000000000" pitchFamily="2" charset="0"/>
+                <a:cs typeface="Ramabhadra" panose="02000600000000000000" pitchFamily="2" charset="0"/>
+              </a:rPr>
+              <a:t> </a:t>
+            </a:r>
+            <a:r>
+              <a:rPr lang="te-IN" dirty="0">
+                <a:solidFill>
+                  <a:schemeClr val="tx1"/>
+                </a:solidFill>
+                <a:latin typeface="Ramabhadra" panose="02000600000000000000" pitchFamily="2" charset="0"/>
+                <a:cs typeface="Ramabhadra" panose="02000600000000000000" pitchFamily="2" charset="0"/>
+              </a:rPr>
+              <a:t>విడువలేదయ్యా (2)</a:t>
             </a:r>
           </a:p>
         </p:txBody>
@@ -5470,97 +5332,32 @@
           <a:p>
             <a:pPr algn="ctr"/>
             <a:r>
-              <a:rPr lang="te-IN" dirty="0">
-                <a:solidFill>
-                  <a:schemeClr val="tx1"/>
-                </a:solidFill>
-                <a:latin typeface="Ramabhadra" panose="02000600000000000000" pitchFamily="2" charset="0"/>
-                <a:cs typeface="Ramabhadra" panose="02000600000000000000" pitchFamily="2" charset="0"/>
-              </a:rPr>
-              <a:t>ప్రేమించెదన్ అధికముగా</a:t>
-            </a:r>
-          </a:p>
-          <a:p>
-            <a:pPr algn="ctr"/>
-            <a:r>
-              <a:rPr lang="te-IN" dirty="0">
-                <a:solidFill>
-                  <a:schemeClr val="tx1"/>
-                </a:solidFill>
-                <a:latin typeface="Ramabhadra" panose="02000600000000000000" pitchFamily="2" charset="0"/>
-                <a:cs typeface="Ramabhadra" panose="02000600000000000000" pitchFamily="2" charset="0"/>
-              </a:rPr>
-              <a:t>ఆరాధింతున్ ఆసక్తితో (2)</a:t>
-            </a:r>
-          </a:p>
-          <a:p>
-            <a:pPr algn="ctr"/>
-            <a:r>
-              <a:rPr lang="te-IN" dirty="0">
-                <a:solidFill>
-                  <a:schemeClr val="tx1"/>
-                </a:solidFill>
-                <a:latin typeface="Ramabhadra" panose="02000600000000000000" pitchFamily="2" charset="0"/>
-                <a:cs typeface="Ramabhadra" panose="02000600000000000000" pitchFamily="2" charset="0"/>
-              </a:rPr>
-              <a:t>నిన్ను పూర్ణ మనసుతో</a:t>
-            </a:r>
-          </a:p>
-          <a:p>
-            <a:pPr algn="ctr"/>
-            <a:r>
-              <a:rPr lang="te-IN" dirty="0">
-                <a:solidFill>
-                  <a:schemeClr val="tx1"/>
-                </a:solidFill>
-                <a:latin typeface="Ramabhadra" panose="02000600000000000000" pitchFamily="2" charset="0"/>
-                <a:cs typeface="Ramabhadra" panose="02000600000000000000" pitchFamily="2" charset="0"/>
-              </a:rPr>
-              <a:t>ఆరాధింతున్</a:t>
-            </a:r>
-          </a:p>
-          <a:p>
-            <a:pPr algn="ctr"/>
-            <a:r>
-              <a:rPr lang="te-IN" dirty="0">
-                <a:solidFill>
-                  <a:schemeClr val="tx1"/>
-                </a:solidFill>
-                <a:latin typeface="Ramabhadra" panose="02000600000000000000" pitchFamily="2" charset="0"/>
-                <a:cs typeface="Ramabhadra" panose="02000600000000000000" pitchFamily="2" charset="0"/>
-              </a:rPr>
-              <a:t>పూర్ణ బలముతో ప్రేమించెదన్</a:t>
-            </a:r>
-          </a:p>
-          <a:p>
-            <a:pPr algn="ctr"/>
-            <a:r>
-              <a:rPr lang="te-IN" dirty="0">
-                <a:solidFill>
-                  <a:schemeClr val="tx1"/>
-                </a:solidFill>
-                <a:latin typeface="Ramabhadra" panose="02000600000000000000" pitchFamily="2" charset="0"/>
-                <a:cs typeface="Ramabhadra" panose="02000600000000000000" pitchFamily="2" charset="0"/>
-              </a:rPr>
-              <a:t>ఆరాధన ఆరాధనా ఆ.. ఆ.. </a:t>
-            </a:r>
-          </a:p>
-          <a:p>
-            <a:pPr algn="ctr"/>
-            <a:r>
-              <a:rPr lang="te-IN" dirty="0">
-                <a:solidFill>
-                  <a:schemeClr val="tx1"/>
-                </a:solidFill>
-                <a:latin typeface="Ramabhadra" panose="02000600000000000000" pitchFamily="2" charset="0"/>
-                <a:cs typeface="Ramabhadra" panose="02000600000000000000" pitchFamily="2" charset="0"/>
-              </a:rPr>
-              <a:t>ఆరాధన ఆరాధనా (2)</a:t>
-            </a:r>
-          </a:p>
-          <a:p>
-            <a:pPr algn="ctr"/>
-            <a:endParaRPr lang="te-IN" dirty="0">
+              <a:rPr lang="te-IN" sz="1900" dirty="0">
+                <a:solidFill>
+                  <a:schemeClr val="tx1"/>
+                </a:solidFill>
+                <a:latin typeface="Ramabhadra" panose="02000600000000000000" pitchFamily="2" charset="0"/>
+                <a:cs typeface="Ramabhadra" panose="02000600000000000000" pitchFamily="2" charset="0"/>
+              </a:rPr>
+              <a:t>సన్నుతించెదను - దయాళుడవు నీవని</a:t>
+            </a:r>
+          </a:p>
+          <a:p>
+            <a:pPr algn="ctr"/>
+            <a:r>
+              <a:rPr lang="te-IN" sz="1900" dirty="0">
+                <a:solidFill>
+                  <a:schemeClr val="tx1"/>
+                </a:solidFill>
+                <a:latin typeface="Ramabhadra" panose="02000600000000000000" pitchFamily="2" charset="0"/>
+                <a:cs typeface="Ramabhadra" panose="02000600000000000000" pitchFamily="2" charset="0"/>
+              </a:rPr>
+              <a:t>యెహోవా నీవే దయాళుడవని నిను సన్నుతించెదను - 2</a:t>
+            </a:r>
+          </a:p>
+          <a:p>
+            <a:pPr algn="ctr"/>
+            <a:endParaRPr lang="te-IN" sz="1900" dirty="0">
               <a:solidFill>
                 <a:schemeClr val="tx1"/>
               </a:solidFill>
@@ -5571,71 +5368,29 @@
           <a:p>
             <a:pPr algn="ctr"/>
             <a:r>
-              <a:rPr lang="te-IN" dirty="0">
-                <a:solidFill>
-                  <a:schemeClr val="tx1"/>
-                </a:solidFill>
-                <a:latin typeface="Ramabhadra" panose="02000600000000000000" pitchFamily="2" charset="0"/>
-                <a:cs typeface="Ramabhadra" panose="02000600000000000000" pitchFamily="2" charset="0"/>
-              </a:rPr>
-              <a:t>ఎబినేజరే ఎబినేజరే</a:t>
-            </a:r>
-          </a:p>
-          <a:p>
-            <a:pPr algn="ctr"/>
-            <a:r>
-              <a:rPr lang="te-IN" dirty="0">
-                <a:solidFill>
-                  <a:schemeClr val="tx1"/>
-                </a:solidFill>
-                <a:latin typeface="Ramabhadra" panose="02000600000000000000" pitchFamily="2" charset="0"/>
-                <a:cs typeface="Ramabhadra" panose="02000600000000000000" pitchFamily="2" charset="0"/>
-              </a:rPr>
-              <a:t>ఇంత వరకు</a:t>
-            </a:r>
-          </a:p>
-          <a:p>
-            <a:pPr algn="ctr"/>
-            <a:r>
-              <a:rPr lang="te-IN" dirty="0">
-                <a:solidFill>
-                  <a:schemeClr val="tx1"/>
-                </a:solidFill>
-                <a:latin typeface="Ramabhadra" panose="02000600000000000000" pitchFamily="2" charset="0"/>
-                <a:cs typeface="Ramabhadra" panose="02000600000000000000" pitchFamily="2" charset="0"/>
-              </a:rPr>
-              <a:t>ఆదుకొన్నావే (2)</a:t>
-            </a:r>
-          </a:p>
-          <a:p>
-            <a:pPr algn="ctr"/>
-            <a:r>
-              <a:rPr lang="te-IN" dirty="0">
-                <a:solidFill>
-                  <a:schemeClr val="tx1"/>
-                </a:solidFill>
-                <a:latin typeface="Ramabhadra" panose="02000600000000000000" pitchFamily="2" charset="0"/>
-                <a:cs typeface="Ramabhadra" panose="02000600000000000000" pitchFamily="2" charset="0"/>
-              </a:rPr>
-              <a:t>నన్ను ఇంత వరకు</a:t>
-            </a:r>
-          </a:p>
-          <a:p>
-            <a:pPr algn="ctr"/>
-            <a:r>
-              <a:rPr lang="te-IN" dirty="0">
-                <a:solidFill>
-                  <a:schemeClr val="tx1"/>
-                </a:solidFill>
-                <a:latin typeface="Ramabhadra" panose="02000600000000000000" pitchFamily="2" charset="0"/>
-                <a:cs typeface="Ramabhadra" panose="02000600000000000000" pitchFamily="2" charset="0"/>
-              </a:rPr>
-              <a:t>ఆదుకొన్నావే</a:t>
-            </a:r>
-          </a:p>
-          <a:p>
-            <a:pPr algn="ctr"/>
-            <a:endParaRPr lang="te-IN" dirty="0">
+              <a:rPr lang="te-IN" sz="1900" dirty="0">
+                <a:solidFill>
+                  <a:schemeClr val="tx1"/>
+                </a:solidFill>
+                <a:latin typeface="Ramabhadra" panose="02000600000000000000" pitchFamily="2" charset="0"/>
+                <a:cs typeface="Ramabhadra" panose="02000600000000000000" pitchFamily="2" charset="0"/>
+              </a:rPr>
+              <a:t>సర్వ సత్యములో నను నీవు నడిపి ఆదరించిన –</a:t>
+            </a:r>
+          </a:p>
+          <a:p>
+            <a:pPr algn="ctr"/>
+            <a:r>
+              <a:rPr lang="te-IN" sz="1900" dirty="0">
+                <a:solidFill>
+                  <a:schemeClr val="tx1"/>
+                </a:solidFill>
+                <a:latin typeface="Ramabhadra" panose="02000600000000000000" pitchFamily="2" charset="0"/>
+                <a:cs typeface="Ramabhadra" panose="02000600000000000000" pitchFamily="2" charset="0"/>
+              </a:rPr>
+              <a:t>పరిశుద్ధాత్ముడా</a:t>
+            </a:r>
+            <a:endParaRPr lang="en-IN" sz="1900" dirty="0">
               <a:solidFill>
                 <a:schemeClr val="tx1"/>
               </a:solidFill>
@@ -5646,66 +5401,96 @@
           <a:p>
             <a:pPr algn="ctr"/>
             <a:r>
-              <a:rPr lang="te-IN" dirty="0">
-                <a:solidFill>
-                  <a:schemeClr val="tx1"/>
-                </a:solidFill>
-                <a:latin typeface="Ramabhadra" panose="02000600000000000000" pitchFamily="2" charset="0"/>
-                <a:cs typeface="Ramabhadra" panose="02000600000000000000" pitchFamily="2" charset="0"/>
-              </a:rPr>
-              <a:t>ఎల్రోహి ఎల్రోహి</a:t>
-            </a:r>
-          </a:p>
-          <a:p>
-            <a:pPr algn="ctr"/>
-            <a:r>
-              <a:rPr lang="te-IN" dirty="0">
-                <a:solidFill>
-                  <a:schemeClr val="tx1"/>
-                </a:solidFill>
-                <a:latin typeface="Ramabhadra" panose="02000600000000000000" pitchFamily="2" charset="0"/>
-                <a:cs typeface="Ramabhadra" panose="02000600000000000000" pitchFamily="2" charset="0"/>
-              </a:rPr>
-              <a:t>నన్ను చూచావే</a:t>
-            </a:r>
-          </a:p>
-          <a:p>
-            <a:pPr algn="ctr"/>
-            <a:r>
-              <a:rPr lang="te-IN" dirty="0">
-                <a:solidFill>
-                  <a:schemeClr val="tx1"/>
-                </a:solidFill>
-                <a:latin typeface="Ramabhadra" panose="02000600000000000000" pitchFamily="2" charset="0"/>
-                <a:cs typeface="Ramabhadra" panose="02000600000000000000" pitchFamily="2" charset="0"/>
-              </a:rPr>
-              <a:t>వందనమయ్యా (2)</a:t>
-            </a:r>
-          </a:p>
-          <a:p>
-            <a:pPr algn="ctr"/>
-            <a:r>
-              <a:rPr lang="te-IN" dirty="0">
-                <a:solidFill>
-                  <a:schemeClr val="tx1"/>
-                </a:solidFill>
-                <a:latin typeface="Ramabhadra" panose="02000600000000000000" pitchFamily="2" charset="0"/>
-                <a:cs typeface="Ramabhadra" panose="02000600000000000000" pitchFamily="2" charset="0"/>
-              </a:rPr>
-              <a:t>నన్ను చూచావే</a:t>
-            </a:r>
-          </a:p>
-          <a:p>
-            <a:pPr algn="ctr"/>
-            <a:r>
-              <a:rPr lang="te-IN" dirty="0">
-                <a:solidFill>
-                  <a:schemeClr val="tx1"/>
-                </a:solidFill>
-                <a:latin typeface="Ramabhadra" panose="02000600000000000000" pitchFamily="2" charset="0"/>
-                <a:cs typeface="Ramabhadra" panose="02000600000000000000" pitchFamily="2" charset="0"/>
-              </a:rPr>
-              <a:t>వందనమయ్యా</a:t>
+              <a:rPr lang="te-IN" sz="1900" dirty="0">
+                <a:solidFill>
+                  <a:schemeClr val="tx1"/>
+                </a:solidFill>
+                <a:latin typeface="Ramabhadra" panose="02000600000000000000" pitchFamily="2" charset="0"/>
+                <a:cs typeface="Ramabhadra" panose="02000600000000000000" pitchFamily="2" charset="0"/>
+              </a:rPr>
+              <a:t>కృపాధారము నీవెగా -</a:t>
+            </a:r>
+          </a:p>
+          <a:p>
+            <a:pPr algn="ctr"/>
+            <a:r>
+              <a:rPr lang="te-IN" sz="1900" dirty="0">
+                <a:solidFill>
+                  <a:schemeClr val="tx1"/>
+                </a:solidFill>
+                <a:latin typeface="Ramabhadra" panose="02000600000000000000" pitchFamily="2" charset="0"/>
+                <a:cs typeface="Ramabhadra" panose="02000600000000000000" pitchFamily="2" charset="0"/>
+              </a:rPr>
+              <a:t>షాలేమురాజా నిను సన్మానించెదను</a:t>
+            </a:r>
+          </a:p>
+          <a:p>
+            <a:pPr algn="ctr"/>
+            <a:endParaRPr lang="te-IN" sz="1900" dirty="0">
+              <a:solidFill>
+                <a:schemeClr val="tx1"/>
+              </a:solidFill>
+              <a:latin typeface="Ramabhadra" panose="02000600000000000000" pitchFamily="2" charset="0"/>
+              <a:cs typeface="Ramabhadra" panose="02000600000000000000" pitchFamily="2" charset="0"/>
+            </a:endParaRPr>
+          </a:p>
+          <a:p>
+            <a:pPr algn="ctr"/>
+            <a:r>
+              <a:rPr lang="te-IN" sz="1900" dirty="0">
+                <a:solidFill>
+                  <a:schemeClr val="tx1"/>
+                </a:solidFill>
+                <a:latin typeface="Ramabhadra" panose="02000600000000000000" pitchFamily="2" charset="0"/>
+                <a:cs typeface="Ramabhadra" panose="02000600000000000000" pitchFamily="2" charset="0"/>
+              </a:rPr>
+              <a:t>నీ కను చూపుల పరిధిలోనన్ను నిలిపి</a:t>
+            </a:r>
+          </a:p>
+          <a:p>
+            <a:pPr algn="ctr"/>
+            <a:r>
+              <a:rPr lang="te-IN" sz="1900" dirty="0">
+                <a:solidFill>
+                  <a:schemeClr val="tx1"/>
+                </a:solidFill>
+                <a:latin typeface="Ramabhadra" panose="02000600000000000000" pitchFamily="2" charset="0"/>
+                <a:cs typeface="Ramabhadra" panose="02000600000000000000" pitchFamily="2" charset="0"/>
+              </a:rPr>
+              <a:t>చూపితివా నీ వాత్సల్యమును</a:t>
+            </a:r>
+          </a:p>
+          <a:p>
+            <a:pPr algn="ctr"/>
+            <a:r>
+              <a:rPr lang="te-IN" sz="1900" dirty="0">
+                <a:solidFill>
+                  <a:schemeClr val="tx1"/>
+                </a:solidFill>
+                <a:latin typeface="Ramabhadra" panose="02000600000000000000" pitchFamily="2" charset="0"/>
+                <a:cs typeface="Ramabhadra" panose="02000600000000000000" pitchFamily="2" charset="0"/>
+              </a:rPr>
+              <a:t>కృపానిధివి నీవెగా –</a:t>
+            </a:r>
+            <a:endParaRPr lang="en-IN" sz="1900" dirty="0">
+              <a:solidFill>
+                <a:schemeClr val="tx1"/>
+              </a:solidFill>
+              <a:latin typeface="Ramabhadra" panose="02000600000000000000" pitchFamily="2" charset="0"/>
+              <a:cs typeface="Ramabhadra" panose="02000600000000000000" pitchFamily="2" charset="0"/>
+            </a:endParaRPr>
+          </a:p>
+          <a:p>
+            <a:pPr algn="ctr"/>
+            <a:r>
+              <a:rPr lang="te-IN" sz="1900" dirty="0">
+                <a:solidFill>
+                  <a:schemeClr val="tx1"/>
+                </a:solidFill>
+                <a:latin typeface="Ramabhadra" panose="02000600000000000000" pitchFamily="2" charset="0"/>
+                <a:cs typeface="Ramabhadra" panose="02000600000000000000" pitchFamily="2" charset="0"/>
+              </a:rPr>
+              <a:t>నా యేసురాజా నిను సన్మానించెదను</a:t>
             </a:r>
           </a:p>
         </p:txBody>
@@ -5770,8 +5555,15 @@
                 <a:latin typeface="Ramabhadra" panose="02000600000000000000" pitchFamily="2" charset="0"/>
                 <a:cs typeface="Ramabhadra" panose="02000600000000000000" pitchFamily="2" charset="0"/>
               </a:rPr>
-              <a:t>నేనెల్లప్పుడు యెహోవను సన్నుతించెదన్</a:t>
-            </a:r>
+              <a:t>పరిశుద్ధుడవై –</a:t>
+            </a:r>
+            <a:endParaRPr lang="en-IN" sz="1400" dirty="0">
+              <a:solidFill>
+                <a:schemeClr val="tx1"/>
+              </a:solidFill>
+              <a:latin typeface="Ramabhadra" panose="02000600000000000000" pitchFamily="2" charset="0"/>
+              <a:cs typeface="Ramabhadra" panose="02000600000000000000" pitchFamily="2" charset="0"/>
+            </a:endParaRPr>
           </a:p>
           <a:p>
             <a:pPr algn="ctr"/>
@@ -5783,8 +5575,15 @@
                 <a:latin typeface="Ramabhadra" panose="02000600000000000000" pitchFamily="2" charset="0"/>
                 <a:cs typeface="Ramabhadra" panose="02000600000000000000" pitchFamily="2" charset="0"/>
               </a:rPr>
-              <a:t>నిత్యము ఆయన కీర్తి</a:t>
-            </a:r>
+              <a:t>మహిమ ప్రభావములకు</a:t>
+            </a:r>
+            <a:endParaRPr lang="en-IN" sz="1400" dirty="0">
+              <a:solidFill>
+                <a:schemeClr val="tx1"/>
+              </a:solidFill>
+              <a:latin typeface="Ramabhadra" panose="02000600000000000000" pitchFamily="2" charset="0"/>
+              <a:cs typeface="Ramabhadra" panose="02000600000000000000" pitchFamily="2" charset="0"/>
+            </a:endParaRPr>
           </a:p>
           <a:p>
             <a:pPr algn="ctr"/>
@@ -5796,7 +5595,190 @@
                 <a:latin typeface="Ramabhadra" panose="02000600000000000000" pitchFamily="2" charset="0"/>
                 <a:cs typeface="Ramabhadra" panose="02000600000000000000" pitchFamily="2" charset="0"/>
               </a:rPr>
-              <a:t>నా నోట నుండున్ (2)</a:t>
+              <a:t>నీవే పాత్రుడవు</a:t>
+            </a:r>
+            <a:r>
+              <a:rPr lang="en-IN" sz="1400" dirty="0">
+                <a:solidFill>
+                  <a:schemeClr val="tx1"/>
+                </a:solidFill>
+                <a:latin typeface="Ramabhadra" panose="02000600000000000000" pitchFamily="2" charset="0"/>
+                <a:cs typeface="Ramabhadra" panose="02000600000000000000" pitchFamily="2" charset="0"/>
+              </a:rPr>
+              <a:t> </a:t>
+            </a:r>
+            <a:r>
+              <a:rPr lang="te-IN" sz="1400" dirty="0">
+                <a:solidFill>
+                  <a:schemeClr val="tx1"/>
+                </a:solidFill>
+                <a:latin typeface="Ramabhadra" panose="02000600000000000000" pitchFamily="2" charset="0"/>
+                <a:cs typeface="Ramabhadra" panose="02000600000000000000" pitchFamily="2" charset="0"/>
+              </a:rPr>
+              <a:t>బలవంతుడవై –</a:t>
+            </a:r>
+            <a:endParaRPr lang="en-IN" sz="1400" dirty="0">
+              <a:solidFill>
+                <a:schemeClr val="tx1"/>
+              </a:solidFill>
+              <a:latin typeface="Ramabhadra" panose="02000600000000000000" pitchFamily="2" charset="0"/>
+              <a:cs typeface="Ramabhadra" panose="02000600000000000000" pitchFamily="2" charset="0"/>
+            </a:endParaRPr>
+          </a:p>
+          <a:p>
+            <a:pPr algn="ctr"/>
+            <a:r>
+              <a:rPr lang="te-IN" sz="1400" dirty="0">
+                <a:solidFill>
+                  <a:schemeClr val="tx1"/>
+                </a:solidFill>
+                <a:latin typeface="Ramabhadra" panose="02000600000000000000" pitchFamily="2" charset="0"/>
+                <a:cs typeface="Ramabhadra" panose="02000600000000000000" pitchFamily="2" charset="0"/>
+              </a:rPr>
+              <a:t>దీనుల పక్షమై</a:t>
+            </a:r>
+            <a:endParaRPr lang="en-IN" sz="1400" dirty="0">
+              <a:solidFill>
+                <a:schemeClr val="tx1"/>
+              </a:solidFill>
+              <a:latin typeface="Ramabhadra" panose="02000600000000000000" pitchFamily="2" charset="0"/>
+              <a:cs typeface="Ramabhadra" panose="02000600000000000000" pitchFamily="2" charset="0"/>
+            </a:endParaRPr>
+          </a:p>
+          <a:p>
+            <a:pPr algn="ctr"/>
+            <a:r>
+              <a:rPr lang="te-IN" sz="1400" dirty="0">
+                <a:solidFill>
+                  <a:schemeClr val="tx1"/>
+                </a:solidFill>
+                <a:latin typeface="Ramabhadra" panose="02000600000000000000" pitchFamily="2" charset="0"/>
+                <a:cs typeface="Ramabhadra" panose="02000600000000000000" pitchFamily="2" charset="0"/>
+              </a:rPr>
+              <a:t>కృప చూపు వాడవు (2)</a:t>
+            </a:r>
+            <a:br>
+              <a:rPr lang="te-IN" sz="1400" dirty="0">
+                <a:solidFill>
+                  <a:schemeClr val="tx1"/>
+                </a:solidFill>
+                <a:latin typeface="Ramabhadra" panose="02000600000000000000" pitchFamily="2" charset="0"/>
+                <a:cs typeface="Ramabhadra" panose="02000600000000000000" pitchFamily="2" charset="0"/>
+              </a:rPr>
+            </a:br>
+            <a:r>
+              <a:rPr lang="te-IN" sz="1400" dirty="0">
+                <a:solidFill>
+                  <a:schemeClr val="tx1"/>
+                </a:solidFill>
+                <a:latin typeface="Ramabhadra" panose="02000600000000000000" pitchFamily="2" charset="0"/>
+                <a:cs typeface="Ramabhadra" panose="02000600000000000000" pitchFamily="2" charset="0"/>
+              </a:rPr>
+              <a:t>దయాళుడవై – ధారాళముగా </a:t>
+            </a:r>
+          </a:p>
+          <a:p>
+            <a:pPr algn="ctr"/>
+            <a:r>
+              <a:rPr lang="te-IN" sz="1400" dirty="0">
+                <a:solidFill>
+                  <a:schemeClr val="tx1"/>
+                </a:solidFill>
+                <a:latin typeface="Ramabhadra" panose="02000600000000000000" pitchFamily="2" charset="0"/>
+                <a:cs typeface="Ramabhadra" panose="02000600000000000000" pitchFamily="2" charset="0"/>
+              </a:rPr>
+              <a:t>నను దీవించిన శ్రీమంతుడా</a:t>
+            </a:r>
+            <a:br>
+              <a:rPr lang="te-IN" sz="1400" dirty="0">
+                <a:solidFill>
+                  <a:schemeClr val="tx1"/>
+                </a:solidFill>
+                <a:latin typeface="Ramabhadra" panose="02000600000000000000" pitchFamily="2" charset="0"/>
+                <a:cs typeface="Ramabhadra" panose="02000600000000000000" pitchFamily="2" charset="0"/>
+              </a:rPr>
+            </a:br>
+            <a:r>
+              <a:rPr lang="te-IN" sz="1400" dirty="0">
+                <a:solidFill>
+                  <a:schemeClr val="tx1"/>
+                </a:solidFill>
+                <a:latin typeface="Ramabhadra" panose="02000600000000000000" pitchFamily="2" charset="0"/>
+                <a:cs typeface="Ramabhadra" panose="02000600000000000000" pitchFamily="2" charset="0"/>
+              </a:rPr>
+              <a:t>ఆరాధన నీకే నా యేసయ్యా</a:t>
+            </a:r>
+            <a:br>
+              <a:rPr lang="te-IN" sz="1400" dirty="0">
+                <a:solidFill>
+                  <a:schemeClr val="tx1"/>
+                </a:solidFill>
+                <a:latin typeface="Ramabhadra" panose="02000600000000000000" pitchFamily="2" charset="0"/>
+                <a:cs typeface="Ramabhadra" panose="02000600000000000000" pitchFamily="2" charset="0"/>
+              </a:rPr>
+            </a:br>
+            <a:r>
+              <a:rPr lang="te-IN" sz="1400" dirty="0">
+                <a:solidFill>
+                  <a:schemeClr val="tx1"/>
+                </a:solidFill>
+                <a:latin typeface="Ramabhadra" panose="02000600000000000000" pitchFamily="2" charset="0"/>
+                <a:cs typeface="Ramabhadra" panose="02000600000000000000" pitchFamily="2" charset="0"/>
+              </a:rPr>
+              <a:t>స్తుతి ఆరాధన నీకే</a:t>
+            </a:r>
+            <a:endParaRPr lang="en-IN" sz="1400" dirty="0">
+              <a:solidFill>
+                <a:schemeClr val="tx1"/>
+              </a:solidFill>
+              <a:latin typeface="Ramabhadra" panose="02000600000000000000" pitchFamily="2" charset="0"/>
+              <a:cs typeface="Ramabhadra" panose="02000600000000000000" pitchFamily="2" charset="0"/>
+            </a:endParaRPr>
+          </a:p>
+          <a:p>
+            <a:pPr algn="ctr"/>
+            <a:r>
+              <a:rPr lang="te-IN" sz="1400" dirty="0">
+                <a:solidFill>
+                  <a:schemeClr val="tx1"/>
+                </a:solidFill>
+                <a:latin typeface="Ramabhadra" panose="02000600000000000000" pitchFamily="2" charset="0"/>
+                <a:cs typeface="Ramabhadra" panose="02000600000000000000" pitchFamily="2" charset="0"/>
+              </a:rPr>
+              <a:t>నా యేసయ్యా (2)   </a:t>
+            </a:r>
+          </a:p>
+          <a:p>
+            <a:pPr algn="ctr"/>
+            <a:r>
+              <a:rPr lang="te-IN" sz="1400" dirty="0">
+                <a:solidFill>
+                  <a:schemeClr val="tx1"/>
+                </a:solidFill>
+                <a:latin typeface="Ramabhadra" panose="02000600000000000000" pitchFamily="2" charset="0"/>
+                <a:cs typeface="Ramabhadra" panose="02000600000000000000" pitchFamily="2" charset="0"/>
+              </a:rPr>
+              <a:t>సేవించెద నిన్నే</a:t>
+            </a:r>
+            <a:endParaRPr lang="en-IN" sz="1400" dirty="0">
+              <a:solidFill>
+                <a:schemeClr val="tx1"/>
+              </a:solidFill>
+              <a:latin typeface="Ramabhadra" panose="02000600000000000000" pitchFamily="2" charset="0"/>
+              <a:cs typeface="Ramabhadra" panose="02000600000000000000" pitchFamily="2" charset="0"/>
+            </a:endParaRPr>
+          </a:p>
+          <a:p>
+            <a:pPr algn="ctr"/>
+            <a:r>
+              <a:rPr lang="te-IN" sz="1400" dirty="0">
+                <a:solidFill>
+                  <a:schemeClr val="tx1"/>
+                </a:solidFill>
+                <a:latin typeface="Ramabhadra" panose="02000600000000000000" pitchFamily="2" charset="0"/>
+                <a:cs typeface="Ramabhadra" panose="02000600000000000000" pitchFamily="2" charset="0"/>
+              </a:rPr>
+              <a:t>నా పూర్ణ హృదయముతో    </a:t>
             </a:r>
           </a:p>
           <a:p>
@@ -5819,103 +5801,9 @@
                 <a:latin typeface="Ramabhadra" panose="02000600000000000000" pitchFamily="2" charset="0"/>
                 <a:cs typeface="Ramabhadra" panose="02000600000000000000" pitchFamily="2" charset="0"/>
               </a:rPr>
-              <a:t>అంతా నా మేలుకే –</a:t>
-            </a:r>
-          </a:p>
-          <a:p>
-            <a:pPr algn="ctr"/>
-            <a:r>
-              <a:rPr lang="te-IN" sz="1400" dirty="0">
-                <a:solidFill>
-                  <a:schemeClr val="tx1"/>
-                </a:solidFill>
-                <a:latin typeface="Ramabhadra" panose="02000600000000000000" pitchFamily="2" charset="0"/>
-                <a:cs typeface="Ramabhadra" panose="02000600000000000000" pitchFamily="2" charset="0"/>
-              </a:rPr>
-              <a:t>ఆరాధన యేసుకే</a:t>
-            </a:r>
-          </a:p>
-          <a:p>
-            <a:pPr algn="ctr"/>
-            <a:r>
-              <a:rPr lang="te-IN" sz="1400" dirty="0">
-                <a:solidFill>
-                  <a:schemeClr val="tx1"/>
-                </a:solidFill>
-                <a:latin typeface="Ramabhadra" panose="02000600000000000000" pitchFamily="2" charset="0"/>
-                <a:cs typeface="Ramabhadra" panose="02000600000000000000" pitchFamily="2" charset="0"/>
-              </a:rPr>
-              <a:t>అంతా నా మంచికే –</a:t>
-            </a:r>
-          </a:p>
-          <a:p>
-            <a:pPr algn="ctr"/>
-            <a:r>
-              <a:rPr lang="te-IN" sz="1400" dirty="0">
-                <a:solidFill>
-                  <a:schemeClr val="tx1"/>
-                </a:solidFill>
-                <a:latin typeface="Ramabhadra" panose="02000600000000000000" pitchFamily="2" charset="0"/>
-                <a:cs typeface="Ramabhadra" panose="02000600000000000000" pitchFamily="2" charset="0"/>
-              </a:rPr>
-              <a:t>తన చిత్తమునకు తల వంచితే</a:t>
-            </a:r>
-          </a:p>
-          <a:p>
-            <a:pPr algn="ctr"/>
-            <a:r>
-              <a:rPr lang="te-IN" sz="1400" dirty="0">
-                <a:solidFill>
-                  <a:schemeClr val="tx1"/>
-                </a:solidFill>
-                <a:latin typeface="Ramabhadra" panose="02000600000000000000" pitchFamily="2" charset="0"/>
-                <a:cs typeface="Ramabhadra" panose="02000600000000000000" pitchFamily="2" charset="0"/>
-              </a:rPr>
-              <a:t>తన చిత్తమునకు తల వంచితే</a:t>
-            </a:r>
-          </a:p>
-          <a:p>
-            <a:pPr algn="ctr"/>
-            <a:r>
-              <a:rPr lang="te-IN" sz="1400" dirty="0">
-                <a:solidFill>
-                  <a:schemeClr val="tx1"/>
-                </a:solidFill>
-                <a:latin typeface="Ramabhadra" panose="02000600000000000000" pitchFamily="2" charset="0"/>
-                <a:cs typeface="Ramabhadra" panose="02000600000000000000" pitchFamily="2" charset="0"/>
-              </a:rPr>
-              <a:t>ఆరాధన ఆపను –</a:t>
-            </a:r>
-          </a:p>
-          <a:p>
-            <a:pPr algn="ctr"/>
-            <a:r>
-              <a:rPr lang="te-IN" sz="1400" dirty="0">
-                <a:solidFill>
-                  <a:schemeClr val="tx1"/>
-                </a:solidFill>
-                <a:latin typeface="Ramabhadra" panose="02000600000000000000" pitchFamily="2" charset="0"/>
-                <a:cs typeface="Ramabhadra" panose="02000600000000000000" pitchFamily="2" charset="0"/>
-              </a:rPr>
-              <a:t>స్తుతియించుట మానను (2)</a:t>
-            </a:r>
-          </a:p>
-          <a:p>
-            <a:pPr algn="ctr"/>
-            <a:r>
-              <a:rPr lang="te-IN" sz="1400" dirty="0">
-                <a:solidFill>
-                  <a:schemeClr val="tx1"/>
-                </a:solidFill>
-                <a:latin typeface="Ramabhadra" panose="02000600000000000000" pitchFamily="2" charset="0"/>
-                <a:cs typeface="Ramabhadra" panose="02000600000000000000" pitchFamily="2" charset="0"/>
-              </a:rPr>
-              <a:t>స్తుతియించుట మానను</a:t>
-            </a:r>
-          </a:p>
-          <a:p>
-            <a:pPr algn="ctr"/>
-            <a:endParaRPr lang="te-IN" sz="1400" dirty="0">
+              <a:t>నీ స్వాస్థ్యమైన నీ వారితో కలిసి</a:t>
+            </a:r>
+            <a:endParaRPr lang="en-IN" sz="1400" dirty="0">
               <a:solidFill>
                 <a:schemeClr val="tx1"/>
               </a:solidFill>
@@ -5933,12 +5821,9 @@
                 <a:latin typeface="Ramabhadra" panose="02000600000000000000" pitchFamily="2" charset="0"/>
                 <a:cs typeface="Ramabhadra" panose="02000600000000000000" pitchFamily="2" charset="0"/>
               </a:rPr>
-              <a:t>కన్నీళ్లే పానములైనా –</a:t>
-            </a:r>
-          </a:p>
-          <a:p>
-            <a:pPr algn="ctr"/>
-            <a:r>
+              <a:t>నిను సేవించుటకు</a:t>
+            </a:r>
+            <a:br>
               <a:rPr lang="te-IN" sz="1400" dirty="0">
                 <a:solidFill>
                   <a:schemeClr val="tx1"/>
@@ -5946,11 +5831,7 @@
                 <a:latin typeface="Ramabhadra" panose="02000600000000000000" pitchFamily="2" charset="0"/>
                 <a:cs typeface="Ramabhadra" panose="02000600000000000000" pitchFamily="2" charset="0"/>
               </a:rPr>
-              <a:t>కఠిన దుఃఖ బాధలైనా</a:t>
-            </a:r>
-          </a:p>
-          <a:p>
-            <a:pPr algn="ctr"/>
+            </a:br>
             <a:r>
               <a:rPr lang="te-IN" sz="1400" dirty="0">
                 <a:solidFill>
@@ -5959,77 +5840,9 @@
                 <a:latin typeface="Ramabhadra" panose="02000600000000000000" pitchFamily="2" charset="0"/>
                 <a:cs typeface="Ramabhadra" panose="02000600000000000000" pitchFamily="2" charset="0"/>
               </a:rPr>
-              <a:t>స్థితి గతులే మారినా –</a:t>
-            </a:r>
-          </a:p>
-          <a:p>
-            <a:pPr algn="ctr"/>
-            <a:r>
-              <a:rPr lang="te-IN" sz="1400" dirty="0">
-                <a:solidFill>
-                  <a:schemeClr val="tx1"/>
-                </a:solidFill>
-                <a:latin typeface="Ramabhadra" panose="02000600000000000000" pitchFamily="2" charset="0"/>
-                <a:cs typeface="Ramabhadra" panose="02000600000000000000" pitchFamily="2" charset="0"/>
-              </a:rPr>
-              <a:t>అవకాశం చేజారినా (2)</a:t>
-            </a:r>
-          </a:p>
-          <a:p>
-            <a:pPr algn="ctr"/>
-            <a:r>
-              <a:rPr lang="te-IN" sz="1400" dirty="0">
-                <a:solidFill>
-                  <a:schemeClr val="tx1"/>
-                </a:solidFill>
-                <a:latin typeface="Ramabhadra" panose="02000600000000000000" pitchFamily="2" charset="0"/>
-                <a:cs typeface="Ramabhadra" panose="02000600000000000000" pitchFamily="2" charset="0"/>
-              </a:rPr>
-              <a:t>మారదు యేసు ప్రేమ – </a:t>
-            </a:r>
-          </a:p>
-          <a:p>
-            <a:pPr algn="ctr"/>
-            <a:r>
-              <a:rPr lang="te-IN" sz="1400" dirty="0">
-                <a:solidFill>
-                  <a:schemeClr val="tx1"/>
-                </a:solidFill>
-                <a:latin typeface="Ramabhadra" panose="02000600000000000000" pitchFamily="2" charset="0"/>
-                <a:cs typeface="Ramabhadra" panose="02000600000000000000" pitchFamily="2" charset="0"/>
-              </a:rPr>
-              <a:t>నిత్యుడైన తండ్రి ప్రేమ (2)</a:t>
-            </a:r>
-          </a:p>
-          <a:p>
-            <a:pPr algn="ctr"/>
-            <a:r>
-              <a:rPr lang="te-IN" sz="1400" dirty="0">
-                <a:solidFill>
-                  <a:schemeClr val="tx1"/>
-                </a:solidFill>
-                <a:latin typeface="Ramabhadra" panose="02000600000000000000" pitchFamily="2" charset="0"/>
-                <a:cs typeface="Ramabhadra" panose="02000600000000000000" pitchFamily="2" charset="0"/>
-              </a:rPr>
-              <a:t>మారదు యేసు ప్రేమ –</a:t>
-            </a:r>
-          </a:p>
-          <a:p>
-            <a:pPr algn="ctr"/>
-            <a:r>
-              <a:rPr lang="te-IN" sz="1400" dirty="0">
-                <a:solidFill>
-                  <a:schemeClr val="tx1"/>
-                </a:solidFill>
-                <a:latin typeface="Ramabhadra" panose="02000600000000000000" pitchFamily="2" charset="0"/>
-                <a:cs typeface="Ramabhadra" panose="02000600000000000000" pitchFamily="2" charset="0"/>
-              </a:rPr>
-              <a:t>నిత్యుడైన తండ్రి ప్రేమ (2)</a:t>
-            </a:r>
-          </a:p>
-          <a:p>
-            <a:pPr algn="ctr"/>
-            <a:endParaRPr lang="te-IN" sz="1400" dirty="0">
+              <a:t>నీ మహిమ ప్రభావమును</a:t>
+            </a:r>
+            <a:endParaRPr lang="en-IN" sz="1400" dirty="0">
               <a:solidFill>
                 <a:schemeClr val="tx1"/>
               </a:solidFill>
@@ -6047,12 +5860,9 @@
                 <a:latin typeface="Ramabhadra" panose="02000600000000000000" pitchFamily="2" charset="0"/>
                 <a:cs typeface="Ramabhadra" panose="02000600000000000000" pitchFamily="2" charset="0"/>
               </a:rPr>
-              <a:t>ఆస్తులన్ని కోల్పోయినా –</a:t>
-            </a:r>
-          </a:p>
-          <a:p>
-            <a:pPr algn="ctr"/>
-            <a:r>
+              <a:t>కిరీటముగా ధరింపజేసితివి (2)</a:t>
+            </a:r>
+            <a:br>
               <a:rPr lang="te-IN" sz="1400" dirty="0">
                 <a:solidFill>
                   <a:schemeClr val="tx1"/>
@@ -6060,11 +5870,7 @@
                 <a:latin typeface="Ramabhadra" panose="02000600000000000000" pitchFamily="2" charset="0"/>
                 <a:cs typeface="Ramabhadra" panose="02000600000000000000" pitchFamily="2" charset="0"/>
               </a:rPr>
-              <a:t>కన్నవారే కనుమరుగైనా</a:t>
-            </a:r>
-          </a:p>
-          <a:p>
-            <a:pPr algn="ctr"/>
+            </a:br>
             <a:r>
               <a:rPr lang="te-IN" sz="1400" dirty="0">
                 <a:solidFill>
@@ -6073,8 +5879,15 @@
                 <a:latin typeface="Ramabhadra" panose="02000600000000000000" pitchFamily="2" charset="0"/>
                 <a:cs typeface="Ramabhadra" panose="02000600000000000000" pitchFamily="2" charset="0"/>
               </a:rPr>
-              <a:t>ఊపిరి భరువైనా –</a:t>
-            </a:r>
+              <a:t>శాశ్వత కాలము వరకు</a:t>
+            </a:r>
+            <a:endParaRPr lang="en-IN" sz="1400" dirty="0">
+              <a:solidFill>
+                <a:schemeClr val="tx1"/>
+              </a:solidFill>
+              <a:latin typeface="Ramabhadra" panose="02000600000000000000" pitchFamily="2" charset="0"/>
+              <a:cs typeface="Ramabhadra" panose="02000600000000000000" pitchFamily="2" charset="0"/>
+            </a:endParaRPr>
           </a:p>
           <a:p>
             <a:pPr algn="ctr"/>
@@ -6086,12 +5899,9 @@
                 <a:latin typeface="Ramabhadra" panose="02000600000000000000" pitchFamily="2" charset="0"/>
                 <a:cs typeface="Ramabhadra" panose="02000600000000000000" pitchFamily="2" charset="0"/>
               </a:rPr>
-              <a:t>గుండెలే పగిలినా (2)</a:t>
-            </a:r>
-          </a:p>
-          <a:p>
-            <a:pPr algn="ctr"/>
-            <a:r>
+              <a:t>నీ సంతతిపై దృష్టి నిలిపి</a:t>
+            </a:r>
+            <a:br>
               <a:rPr lang="te-IN" sz="1400" dirty="0">
                 <a:solidFill>
                   <a:schemeClr val="tx1"/>
@@ -6099,11 +5909,7 @@
                 <a:latin typeface="Ramabhadra" panose="02000600000000000000" pitchFamily="2" charset="0"/>
                 <a:cs typeface="Ramabhadra" panose="02000600000000000000" pitchFamily="2" charset="0"/>
               </a:rPr>
-              <a:t>యెహోవా ఇచ్చెను –</a:t>
-            </a:r>
-          </a:p>
-          <a:p>
-            <a:pPr algn="ctr"/>
+            </a:br>
             <a:r>
               <a:rPr lang="te-IN" sz="1400" dirty="0">
                 <a:solidFill>
@@ -6112,8 +5918,15 @@
                 <a:latin typeface="Ramabhadra" panose="02000600000000000000" pitchFamily="2" charset="0"/>
                 <a:cs typeface="Ramabhadra" panose="02000600000000000000" pitchFamily="2" charset="0"/>
               </a:rPr>
-              <a:t>యెహోవా తీసుకొనెను (2)</a:t>
-            </a:r>
+              <a:t>నీ దాసుల ప్రార్ధనలు</a:t>
+            </a:r>
+            <a:endParaRPr lang="en-IN" sz="1400" dirty="0">
+              <a:solidFill>
+                <a:schemeClr val="tx1"/>
+              </a:solidFill>
+              <a:latin typeface="Ramabhadra" panose="02000600000000000000" pitchFamily="2" charset="0"/>
+              <a:cs typeface="Ramabhadra" panose="02000600000000000000" pitchFamily="2" charset="0"/>
+            </a:endParaRPr>
           </a:p>
           <a:p>
             <a:pPr algn="ctr"/>
@@ -6125,7 +5938,7 @@
                 <a:latin typeface="Ramabhadra" panose="02000600000000000000" pitchFamily="2" charset="0"/>
                 <a:cs typeface="Ramabhadra" panose="02000600000000000000" pitchFamily="2" charset="0"/>
               </a:rPr>
-              <a:t>ఆయన నామమునకే –</a:t>
+              <a:t>సఫలము చేసితివి</a:t>
             </a:r>
           </a:p>
           <a:p>
@@ -6138,7 +5951,157 @@
                 <a:latin typeface="Ramabhadra" panose="02000600000000000000" pitchFamily="2" charset="0"/>
                 <a:cs typeface="Ramabhadra" panose="02000600000000000000" pitchFamily="2" charset="0"/>
               </a:rPr>
-              <a:t>స్తుతి కలుగు గాక (2)</a:t>
+              <a:t> </a:t>
+            </a:r>
+          </a:p>
+          <a:p>
+            <a:pPr algn="ctr"/>
+            <a:r>
+              <a:rPr lang="te-IN" sz="1400" dirty="0">
+                <a:solidFill>
+                  <a:schemeClr val="tx1"/>
+                </a:solidFill>
+                <a:latin typeface="Ramabhadra" panose="02000600000000000000" pitchFamily="2" charset="0"/>
+                <a:cs typeface="Ramabhadra" panose="02000600000000000000" pitchFamily="2" charset="0"/>
+              </a:rPr>
+              <a:t>నీ నిత్యమైన ఆదరణ చూపి</a:t>
+            </a:r>
+            <a:endParaRPr lang="en-IN" sz="1400" dirty="0">
+              <a:solidFill>
+                <a:schemeClr val="tx1"/>
+              </a:solidFill>
+              <a:latin typeface="Ramabhadra" panose="02000600000000000000" pitchFamily="2" charset="0"/>
+              <a:cs typeface="Ramabhadra" panose="02000600000000000000" pitchFamily="2" charset="0"/>
+            </a:endParaRPr>
+          </a:p>
+          <a:p>
+            <a:pPr algn="ctr"/>
+            <a:r>
+              <a:rPr lang="te-IN" sz="1400" dirty="0">
+                <a:solidFill>
+                  <a:schemeClr val="tx1"/>
+                </a:solidFill>
+                <a:latin typeface="Ramabhadra" panose="02000600000000000000" pitchFamily="2" charset="0"/>
+                <a:cs typeface="Ramabhadra" panose="02000600000000000000" pitchFamily="2" charset="0"/>
+              </a:rPr>
+              <a:t>నను స్థిరపరచుటకు</a:t>
+            </a:r>
+            <a:br>
+              <a:rPr lang="te-IN" sz="1400" dirty="0">
+                <a:solidFill>
+                  <a:schemeClr val="tx1"/>
+                </a:solidFill>
+                <a:latin typeface="Ramabhadra" panose="02000600000000000000" pitchFamily="2" charset="0"/>
+                <a:cs typeface="Ramabhadra" panose="02000600000000000000" pitchFamily="2" charset="0"/>
+              </a:rPr>
+            </a:br>
+            <a:r>
+              <a:rPr lang="te-IN" sz="1400" dirty="0">
+                <a:solidFill>
+                  <a:schemeClr val="tx1"/>
+                </a:solidFill>
+                <a:latin typeface="Ramabhadra" panose="02000600000000000000" pitchFamily="2" charset="0"/>
+                <a:cs typeface="Ramabhadra" panose="02000600000000000000" pitchFamily="2" charset="0"/>
+              </a:rPr>
+              <a:t>నీ కరుణా కటాక్షమును</a:t>
+            </a:r>
+            <a:endParaRPr lang="en-IN" sz="1400" dirty="0">
+              <a:solidFill>
+                <a:schemeClr val="tx1"/>
+              </a:solidFill>
+              <a:latin typeface="Ramabhadra" panose="02000600000000000000" pitchFamily="2" charset="0"/>
+              <a:cs typeface="Ramabhadra" panose="02000600000000000000" pitchFamily="2" charset="0"/>
+            </a:endParaRPr>
+          </a:p>
+          <a:p>
+            <a:pPr algn="ctr"/>
+            <a:r>
+              <a:rPr lang="te-IN" sz="1400" dirty="0">
+                <a:solidFill>
+                  <a:schemeClr val="tx1"/>
+                </a:solidFill>
+                <a:latin typeface="Ramabhadra" panose="02000600000000000000" pitchFamily="2" charset="0"/>
+                <a:cs typeface="Ramabhadra" panose="02000600000000000000" pitchFamily="2" charset="0"/>
+              </a:rPr>
+              <a:t>నాపై కురిపించి నను ప్రేమించితివి (2)</a:t>
+            </a:r>
+            <a:br>
+              <a:rPr lang="te-IN" sz="1400" dirty="0">
+                <a:solidFill>
+                  <a:schemeClr val="tx1"/>
+                </a:solidFill>
+                <a:latin typeface="Ramabhadra" panose="02000600000000000000" pitchFamily="2" charset="0"/>
+                <a:cs typeface="Ramabhadra" panose="02000600000000000000" pitchFamily="2" charset="0"/>
+              </a:rPr>
+            </a:br>
+            <a:r>
+              <a:rPr lang="te-IN" sz="1400" dirty="0">
+                <a:solidFill>
+                  <a:schemeClr val="tx1"/>
+                </a:solidFill>
+                <a:latin typeface="Ramabhadra" panose="02000600000000000000" pitchFamily="2" charset="0"/>
+                <a:cs typeface="Ramabhadra" panose="02000600000000000000" pitchFamily="2" charset="0"/>
+              </a:rPr>
+              <a:t>నాకు ప్రయోజనము కలుగజేయుటకు</a:t>
+            </a:r>
+            <a:endParaRPr lang="en-IN" sz="1400" dirty="0">
+              <a:solidFill>
+                <a:schemeClr val="tx1"/>
+              </a:solidFill>
+              <a:latin typeface="Ramabhadra" panose="02000600000000000000" pitchFamily="2" charset="0"/>
+              <a:cs typeface="Ramabhadra" panose="02000600000000000000" pitchFamily="2" charset="0"/>
+            </a:endParaRPr>
+          </a:p>
+          <a:p>
+            <a:pPr algn="ctr"/>
+            <a:r>
+              <a:rPr lang="te-IN" sz="1400" dirty="0">
+                <a:solidFill>
+                  <a:schemeClr val="tx1"/>
+                </a:solidFill>
+                <a:latin typeface="Ramabhadra" panose="02000600000000000000" pitchFamily="2" charset="0"/>
+                <a:cs typeface="Ramabhadra" panose="02000600000000000000" pitchFamily="2" charset="0"/>
+              </a:rPr>
+              <a:t>నీ ఉపదేశమును బోధించి</a:t>
+            </a:r>
+            <a:br>
+              <a:rPr lang="te-IN" sz="1400" dirty="0">
+                <a:solidFill>
+                  <a:schemeClr val="tx1"/>
+                </a:solidFill>
+                <a:latin typeface="Ramabhadra" panose="02000600000000000000" pitchFamily="2" charset="0"/>
+                <a:cs typeface="Ramabhadra" panose="02000600000000000000" pitchFamily="2" charset="0"/>
+              </a:rPr>
+            </a:br>
+            <a:r>
+              <a:rPr lang="te-IN" sz="1400" dirty="0">
+                <a:solidFill>
+                  <a:schemeClr val="tx1"/>
+                </a:solidFill>
+                <a:latin typeface="Ramabhadra" panose="02000600000000000000" pitchFamily="2" charset="0"/>
+                <a:cs typeface="Ramabhadra" panose="02000600000000000000" pitchFamily="2" charset="0"/>
+              </a:rPr>
+              <a:t>నీ దాసుని ప్రాణమును</a:t>
+            </a:r>
+            <a:endParaRPr lang="en-IN" sz="1400" dirty="0">
+              <a:solidFill>
+                <a:schemeClr val="tx1"/>
+              </a:solidFill>
+              <a:latin typeface="Ramabhadra" panose="02000600000000000000" pitchFamily="2" charset="0"/>
+              <a:cs typeface="Ramabhadra" panose="02000600000000000000" pitchFamily="2" charset="0"/>
+            </a:endParaRPr>
+          </a:p>
+          <a:p>
+            <a:pPr algn="ctr"/>
+            <a:r>
+              <a:rPr lang="te-IN" sz="1400" dirty="0">
+                <a:solidFill>
+                  <a:schemeClr val="tx1"/>
+                </a:solidFill>
+                <a:latin typeface="Ramabhadra" panose="02000600000000000000" pitchFamily="2" charset="0"/>
+                <a:cs typeface="Ramabhadra" panose="02000600000000000000" pitchFamily="2" charset="0"/>
+              </a:rPr>
+              <a:t>సంతోషపరచితివి</a:t>
             </a:r>
           </a:p>
         </p:txBody>

</xml_diff>

<commit_message>
28 sunday july songs
</commit_message>
<xml_diff>
--- a/xerox.pptx
+++ b/xerox.pptx
@@ -226,7 +226,7 @@
           <a:p>
             <a:fld id="{3502DD63-DF8D-4AB8-92A0-0ECCF612C06C}" type="datetimeFigureOut">
               <a:rPr lang="en-IN" smtClean="0"/>
-              <a:t>19-07-2024</a:t>
+              <a:t>27-07-2024</a:t>
             </a:fld>
             <a:endParaRPr lang="en-IN"/>
           </a:p>
@@ -404,7 +404,7 @@
           <a:p>
             <a:fld id="{1AE741EC-1360-4793-999B-941E0396C9FA}" type="datetimeFigureOut">
               <a:rPr lang="en-IN" smtClean="0"/>
-              <a:t>19-07-2024</a:t>
+              <a:t>27-07-2024</a:t>
             </a:fld>
             <a:endParaRPr lang="en-IN"/>
           </a:p>
@@ -804,7 +804,7 @@
           <a:p>
             <a:fld id="{86FBD32F-FCAD-481A-B7D8-4D813FB7DB24}" type="datetimeFigureOut">
               <a:rPr lang="en-IN" smtClean="0"/>
-              <a:t>19-07-2024</a:t>
+              <a:t>27-07-2024</a:t>
             </a:fld>
             <a:endParaRPr lang="en-IN"/>
           </a:p>
@@ -974,7 +974,7 @@
           <a:p>
             <a:fld id="{86FBD32F-FCAD-481A-B7D8-4D813FB7DB24}" type="datetimeFigureOut">
               <a:rPr lang="en-IN" smtClean="0"/>
-              <a:t>19-07-2024</a:t>
+              <a:t>27-07-2024</a:t>
             </a:fld>
             <a:endParaRPr lang="en-IN"/>
           </a:p>
@@ -1154,7 +1154,7 @@
           <a:p>
             <a:fld id="{86FBD32F-FCAD-481A-B7D8-4D813FB7DB24}" type="datetimeFigureOut">
               <a:rPr lang="en-IN" smtClean="0"/>
-              <a:t>19-07-2024</a:t>
+              <a:t>27-07-2024</a:t>
             </a:fld>
             <a:endParaRPr lang="en-IN"/>
           </a:p>
@@ -1324,7 +1324,7 @@
           <a:p>
             <a:fld id="{86FBD32F-FCAD-481A-B7D8-4D813FB7DB24}" type="datetimeFigureOut">
               <a:rPr lang="en-IN" smtClean="0"/>
-              <a:t>19-07-2024</a:t>
+              <a:t>27-07-2024</a:t>
             </a:fld>
             <a:endParaRPr lang="en-IN"/>
           </a:p>
@@ -1568,7 +1568,7 @@
           <a:p>
             <a:fld id="{86FBD32F-FCAD-481A-B7D8-4D813FB7DB24}" type="datetimeFigureOut">
               <a:rPr lang="en-IN" smtClean="0"/>
-              <a:t>19-07-2024</a:t>
+              <a:t>27-07-2024</a:t>
             </a:fld>
             <a:endParaRPr lang="en-IN"/>
           </a:p>
@@ -1800,7 +1800,7 @@
           <a:p>
             <a:fld id="{86FBD32F-FCAD-481A-B7D8-4D813FB7DB24}" type="datetimeFigureOut">
               <a:rPr lang="en-IN" smtClean="0"/>
-              <a:t>19-07-2024</a:t>
+              <a:t>27-07-2024</a:t>
             </a:fld>
             <a:endParaRPr lang="en-IN"/>
           </a:p>
@@ -2167,7 +2167,7 @@
           <a:p>
             <a:fld id="{86FBD32F-FCAD-481A-B7D8-4D813FB7DB24}" type="datetimeFigureOut">
               <a:rPr lang="en-IN" smtClean="0"/>
-              <a:t>19-07-2024</a:t>
+              <a:t>27-07-2024</a:t>
             </a:fld>
             <a:endParaRPr lang="en-IN"/>
           </a:p>
@@ -2285,7 +2285,7 @@
           <a:p>
             <a:fld id="{86FBD32F-FCAD-481A-B7D8-4D813FB7DB24}" type="datetimeFigureOut">
               <a:rPr lang="en-IN" smtClean="0"/>
-              <a:t>19-07-2024</a:t>
+              <a:t>27-07-2024</a:t>
             </a:fld>
             <a:endParaRPr lang="en-IN"/>
           </a:p>
@@ -2380,7 +2380,7 @@
           <a:p>
             <a:fld id="{86FBD32F-FCAD-481A-B7D8-4D813FB7DB24}" type="datetimeFigureOut">
               <a:rPr lang="en-IN" smtClean="0"/>
-              <a:t>19-07-2024</a:t>
+              <a:t>27-07-2024</a:t>
             </a:fld>
             <a:endParaRPr lang="en-IN"/>
           </a:p>
@@ -2657,7 +2657,7 @@
           <a:p>
             <a:fld id="{86FBD32F-FCAD-481A-B7D8-4D813FB7DB24}" type="datetimeFigureOut">
               <a:rPr lang="en-IN" smtClean="0"/>
-              <a:t>19-07-2024</a:t>
+              <a:t>27-07-2024</a:t>
             </a:fld>
             <a:endParaRPr lang="en-IN"/>
           </a:p>
@@ -2914,7 +2914,7 @@
           <a:p>
             <a:fld id="{86FBD32F-FCAD-481A-B7D8-4D813FB7DB24}" type="datetimeFigureOut">
               <a:rPr lang="en-IN" smtClean="0"/>
-              <a:t>19-07-2024</a:t>
+              <a:t>27-07-2024</a:t>
             </a:fld>
             <a:endParaRPr lang="en-IN"/>
           </a:p>
@@ -3127,7 +3127,7 @@
           <a:p>
             <a:fld id="{86FBD32F-FCAD-481A-B7D8-4D813FB7DB24}" type="datetimeFigureOut">
               <a:rPr lang="en-IN" smtClean="0"/>
-              <a:t>19-07-2024</a:t>
+              <a:t>27-07-2024</a:t>
             </a:fld>
             <a:endParaRPr lang="en-IN"/>
           </a:p>
@@ -4702,7 +4702,7 @@
         </p:nvSpPr>
         <p:spPr>
           <a:xfrm>
-            <a:off x="0" y="0"/>
+            <a:off x="4952400" y="1"/>
             <a:ext cx="2476800" cy="6857999"/>
           </a:xfrm>
           <a:prstGeom prst="rect">
@@ -4741,97 +4741,84 @@
           <a:p>
             <a:pPr algn="ctr"/>
             <a:r>
-              <a:rPr lang="te-IN" sz="1600" dirty="0">
-                <a:solidFill>
-                  <a:schemeClr val="tx1"/>
-                </a:solidFill>
-                <a:latin typeface="Ramabhadra" panose="02000600000000000000" pitchFamily="2" charset="0"/>
-                <a:cs typeface="Ramabhadra" panose="02000600000000000000" pitchFamily="2" charset="0"/>
-              </a:rPr>
-              <a:t>సద్గుణ శీలుడా నీవే పూజ్యుడవు</a:t>
-            </a:r>
-          </a:p>
-          <a:p>
-            <a:pPr algn="ctr"/>
-            <a:r>
-              <a:rPr lang="te-IN" sz="1600" dirty="0">
-                <a:solidFill>
-                  <a:schemeClr val="tx1"/>
-                </a:solidFill>
-                <a:latin typeface="Ramabhadra" panose="02000600000000000000" pitchFamily="2" charset="0"/>
-                <a:cs typeface="Ramabhadra" panose="02000600000000000000" pitchFamily="2" charset="0"/>
-              </a:rPr>
-              <a:t>స్తుతి ఆరాధనకు నీవే యోగ్యుడవు</a:t>
-            </a:r>
-          </a:p>
-          <a:p>
-            <a:pPr algn="ctr"/>
-            <a:r>
-              <a:rPr lang="te-IN" sz="1600" dirty="0">
-                <a:solidFill>
-                  <a:schemeClr val="tx1"/>
-                </a:solidFill>
-                <a:latin typeface="Ramabhadra" panose="02000600000000000000" pitchFamily="2" charset="0"/>
-                <a:cs typeface="Ramabhadra" panose="02000600000000000000" pitchFamily="2" charset="0"/>
-              </a:rPr>
-              <a:t>సత్య ప్రమాణముతో</a:t>
-            </a:r>
-          </a:p>
-          <a:p>
-            <a:pPr algn="ctr"/>
-            <a:r>
-              <a:rPr lang="te-IN" sz="1600" dirty="0">
-                <a:solidFill>
-                  <a:schemeClr val="tx1"/>
-                </a:solidFill>
-                <a:latin typeface="Ramabhadra" panose="02000600000000000000" pitchFamily="2" charset="0"/>
-                <a:cs typeface="Ramabhadra" panose="02000600000000000000" pitchFamily="2" charset="0"/>
-              </a:rPr>
-              <a:t>శాశ్వత కృపనిచ్చి</a:t>
-            </a:r>
-          </a:p>
-          <a:p>
-            <a:pPr algn="ctr"/>
-            <a:r>
-              <a:rPr lang="te-IN" sz="1600" dirty="0">
-                <a:solidFill>
-                  <a:schemeClr val="tx1"/>
-                </a:solidFill>
-                <a:latin typeface="Ramabhadra" panose="02000600000000000000" pitchFamily="2" charset="0"/>
-                <a:cs typeface="Ramabhadra" panose="02000600000000000000" pitchFamily="2" charset="0"/>
-              </a:rPr>
-              <a:t>నీ ప్రియుని స్వాస్థ్యము నాకిచ్చితివి</a:t>
-            </a:r>
-          </a:p>
-          <a:p>
-            <a:pPr algn="ctr"/>
-            <a:r>
-              <a:rPr lang="te-IN" sz="1600" dirty="0">
-                <a:solidFill>
-                  <a:schemeClr val="tx1"/>
-                </a:solidFill>
-                <a:latin typeface="Ramabhadra" panose="02000600000000000000" pitchFamily="2" charset="0"/>
-                <a:cs typeface="Ramabhadra" panose="02000600000000000000" pitchFamily="2" charset="0"/>
-              </a:rPr>
-              <a:t>యేసయ్యా నీ సంకల్పమే</a:t>
-            </a:r>
-          </a:p>
-          <a:p>
-            <a:pPr algn="ctr"/>
-            <a:r>
-              <a:rPr lang="te-IN" sz="1600" dirty="0">
-                <a:solidFill>
-                  <a:schemeClr val="tx1"/>
-                </a:solidFill>
-                <a:latin typeface="Ramabhadra" panose="02000600000000000000" pitchFamily="2" charset="0"/>
-                <a:cs typeface="Ramabhadra" panose="02000600000000000000" pitchFamily="2" charset="0"/>
-              </a:rPr>
-              <a:t>ఇది నాపై నీకున్న అనురాగమే</a:t>
-            </a:r>
-          </a:p>
-          <a:p>
-            <a:pPr algn="ctr"/>
-            <a:endParaRPr lang="te-IN" sz="1600" dirty="0">
+              <a:rPr lang="te-IN" sz="1680" dirty="0">
+                <a:solidFill>
+                  <a:schemeClr val="tx1"/>
+                </a:solidFill>
+                <a:latin typeface="Ramabhadra" panose="02000600000000000000" pitchFamily="2" charset="0"/>
+                <a:cs typeface="Ramabhadra" panose="02000600000000000000" pitchFamily="2" charset="0"/>
+              </a:rPr>
+              <a:t>అత్యున్నత సింహాసనముపై ఆసీనుడా</a:t>
+            </a:r>
+          </a:p>
+          <a:p>
+            <a:pPr algn="ctr"/>
+            <a:r>
+              <a:rPr lang="te-IN" sz="1680" dirty="0">
+                <a:solidFill>
+                  <a:schemeClr val="tx1"/>
+                </a:solidFill>
+                <a:latin typeface="Ramabhadra" panose="02000600000000000000" pitchFamily="2" charset="0"/>
+                <a:cs typeface="Ramabhadra" panose="02000600000000000000" pitchFamily="2" charset="0"/>
+              </a:rPr>
+              <a:t>దేవ దూతలు ఆరాధించు పరిశుద్ధుడా</a:t>
+            </a:r>
+          </a:p>
+          <a:p>
+            <a:pPr algn="ctr"/>
+            <a:r>
+              <a:rPr lang="te-IN" sz="1680" dirty="0">
+                <a:solidFill>
+                  <a:schemeClr val="tx1"/>
+                </a:solidFill>
+                <a:latin typeface="Ramabhadra" panose="02000600000000000000" pitchFamily="2" charset="0"/>
+                <a:cs typeface="Ramabhadra" panose="02000600000000000000" pitchFamily="2" charset="0"/>
+              </a:rPr>
+              <a:t>యేసయ్యా నా నిలువెల్ల నిండియున్నావు</a:t>
+            </a:r>
+          </a:p>
+          <a:p>
+            <a:pPr algn="ctr"/>
+            <a:r>
+              <a:rPr lang="te-IN" sz="1680" dirty="0">
+                <a:solidFill>
+                  <a:schemeClr val="tx1"/>
+                </a:solidFill>
+                <a:latin typeface="Ramabhadra" panose="02000600000000000000" pitchFamily="2" charset="0"/>
+                <a:cs typeface="Ramabhadra" panose="02000600000000000000" pitchFamily="2" charset="0"/>
+              </a:rPr>
+              <a:t>నా మనసార నీ సన్నిధిలో</a:t>
+            </a:r>
+          </a:p>
+          <a:p>
+            <a:pPr algn="ctr"/>
+            <a:r>
+              <a:rPr lang="te-IN" sz="1680" dirty="0">
+                <a:solidFill>
+                  <a:schemeClr val="tx1"/>
+                </a:solidFill>
+                <a:latin typeface="Ramabhadra" panose="02000600000000000000" pitchFamily="2" charset="0"/>
+                <a:cs typeface="Ramabhadra" panose="02000600000000000000" pitchFamily="2" charset="0"/>
+              </a:rPr>
+              <a:t>సాగిలపడి నమస్కారము చేసేదా</a:t>
+            </a:r>
+          </a:p>
+          <a:p>
+            <a:pPr algn="ctr"/>
+            <a:r>
+              <a:rPr lang="te-IN" sz="1680" dirty="0">
+                <a:solidFill>
+                  <a:schemeClr val="tx1"/>
+                </a:solidFill>
+                <a:latin typeface="Ramabhadra" panose="02000600000000000000" pitchFamily="2" charset="0"/>
+                <a:cs typeface="Ramabhadra" panose="02000600000000000000" pitchFamily="2" charset="0"/>
+              </a:rPr>
+              <a:t>సాగిలపడి నమస్కారము చేసేదా (2)</a:t>
+            </a:r>
+          </a:p>
+          <a:p>
+            <a:pPr algn="ctr"/>
+            <a:endParaRPr lang="te-IN" sz="1680" dirty="0">
               <a:solidFill>
                 <a:schemeClr val="tx1"/>
               </a:solidFill>
@@ -4842,84 +4829,16 @@
           <a:p>
             <a:pPr algn="ctr"/>
             <a:r>
-              <a:rPr lang="te-IN" sz="1600" dirty="0">
-                <a:solidFill>
-                  <a:schemeClr val="tx1"/>
-                </a:solidFill>
-                <a:latin typeface="Ramabhadra" panose="02000600000000000000" pitchFamily="2" charset="0"/>
-                <a:cs typeface="Ramabhadra" panose="02000600000000000000" pitchFamily="2" charset="0"/>
-              </a:rPr>
-              <a:t>సిలువ సునాదమును</a:t>
-            </a:r>
-          </a:p>
-          <a:p>
-            <a:pPr algn="ctr"/>
-            <a:r>
-              <a:rPr lang="te-IN" sz="1600" dirty="0">
-                <a:solidFill>
-                  <a:schemeClr val="tx1"/>
-                </a:solidFill>
-                <a:latin typeface="Ramabhadra" panose="02000600000000000000" pitchFamily="2" charset="0"/>
-                <a:cs typeface="Ramabhadra" panose="02000600000000000000" pitchFamily="2" charset="0"/>
-              </a:rPr>
-              <a:t>నా శ్రమదినమున</a:t>
-            </a:r>
-          </a:p>
-          <a:p>
-            <a:pPr algn="ctr"/>
-            <a:r>
-              <a:rPr lang="te-IN" sz="1600" dirty="0">
-                <a:solidFill>
-                  <a:schemeClr val="tx1"/>
-                </a:solidFill>
-                <a:latin typeface="Ramabhadra" panose="02000600000000000000" pitchFamily="2" charset="0"/>
-                <a:cs typeface="Ramabhadra" panose="02000600000000000000" pitchFamily="2" charset="0"/>
-              </a:rPr>
-              <a:t>మధుర గీతికగా మదిలో వినిపించి</a:t>
-            </a:r>
-          </a:p>
-          <a:p>
-            <a:pPr algn="ctr"/>
-            <a:r>
-              <a:rPr lang="te-IN" sz="1600" dirty="0">
-                <a:solidFill>
-                  <a:schemeClr val="tx1"/>
-                </a:solidFill>
-                <a:latin typeface="Ramabhadra" panose="02000600000000000000" pitchFamily="2" charset="0"/>
-                <a:cs typeface="Ramabhadra" panose="02000600000000000000" pitchFamily="2" charset="0"/>
-              </a:rPr>
-              <a:t>సిలువలో దాగిన సర్వసంపదలిచ్చి</a:t>
-            </a:r>
-          </a:p>
-          <a:p>
-            <a:pPr algn="ctr"/>
-            <a:r>
-              <a:rPr lang="te-IN" sz="1600" dirty="0">
-                <a:solidFill>
-                  <a:schemeClr val="tx1"/>
-                </a:solidFill>
-                <a:latin typeface="Ramabhadra" panose="02000600000000000000" pitchFamily="2" charset="0"/>
-                <a:cs typeface="Ramabhadra" panose="02000600000000000000" pitchFamily="2" charset="0"/>
-              </a:rPr>
-              <a:t>కాంతిమయముగా కనపరచితివే</a:t>
-            </a:r>
-          </a:p>
-          <a:p>
-            <a:pPr algn="ctr"/>
-            <a:r>
-              <a:rPr lang="te-IN" sz="1600" dirty="0">
-                <a:solidFill>
-                  <a:schemeClr val="tx1"/>
-                </a:solidFill>
-                <a:latin typeface="Ramabhadra" panose="02000600000000000000" pitchFamily="2" charset="0"/>
-                <a:cs typeface="Ramabhadra" panose="02000600000000000000" pitchFamily="2" charset="0"/>
-              </a:rPr>
-              <a:t>నీ ఆత్మ శక్తితో</a:t>
-            </a:r>
-          </a:p>
-          <a:p>
-            <a:pPr algn="ctr"/>
-            <a:endParaRPr lang="te-IN" sz="1600" dirty="0">
+              <a:rPr lang="te-IN" sz="1680" dirty="0">
+                <a:solidFill>
+                  <a:schemeClr val="tx1"/>
+                </a:solidFill>
+                <a:latin typeface="Ramabhadra" panose="02000600000000000000" pitchFamily="2" charset="0"/>
+                <a:cs typeface="Ramabhadra" panose="02000600000000000000" pitchFamily="2" charset="0"/>
+              </a:rPr>
+              <a:t>ప్రతి వసంతము</a:t>
+            </a:r>
+            <a:endParaRPr lang="en-IN" sz="1680" dirty="0">
               <a:solidFill>
                 <a:schemeClr val="tx1"/>
               </a:solidFill>
@@ -4930,53 +4849,175 @@
           <a:p>
             <a:pPr algn="ctr"/>
             <a:r>
-              <a:rPr lang="te-IN" sz="1600" dirty="0">
-                <a:solidFill>
-                  <a:schemeClr val="tx1"/>
-                </a:solidFill>
-                <a:latin typeface="Ramabhadra" panose="02000600000000000000" pitchFamily="2" charset="0"/>
-                <a:cs typeface="Ramabhadra" panose="02000600000000000000" pitchFamily="2" charset="0"/>
-              </a:rPr>
-              <a:t>నాతోడు నీడవై మరపురాని</a:t>
-            </a:r>
-          </a:p>
-          <a:p>
-            <a:pPr algn="ctr"/>
-            <a:r>
-              <a:rPr lang="te-IN" sz="1600" dirty="0">
-                <a:solidFill>
-                  <a:schemeClr val="tx1"/>
-                </a:solidFill>
-                <a:latin typeface="Ramabhadra" panose="02000600000000000000" pitchFamily="2" charset="0"/>
-                <a:cs typeface="Ramabhadra" panose="02000600000000000000" pitchFamily="2" charset="0"/>
-              </a:rPr>
-              <a:t>మహోప కార్యములు నాకై చేసి</a:t>
-            </a:r>
-          </a:p>
-          <a:p>
-            <a:pPr algn="ctr"/>
-            <a:r>
-              <a:rPr lang="te-IN" sz="1600" dirty="0">
-                <a:solidFill>
-                  <a:schemeClr val="tx1"/>
-                </a:solidFill>
-                <a:latin typeface="Ramabhadra" panose="02000600000000000000" pitchFamily="2" charset="0"/>
-                <a:cs typeface="Ramabhadra" panose="02000600000000000000" pitchFamily="2" charset="0"/>
-              </a:rPr>
-              <a:t>చీకటి దాచిన - వేకువగా మార్చి</a:t>
-            </a:r>
-          </a:p>
-          <a:p>
-            <a:pPr algn="ctr"/>
-            <a:r>
-              <a:rPr lang="te-IN" sz="1600" dirty="0">
-                <a:solidFill>
-                  <a:schemeClr val="tx1"/>
-                </a:solidFill>
-                <a:latin typeface="Ramabhadra" panose="02000600000000000000" pitchFamily="2" charset="0"/>
-                <a:cs typeface="Ramabhadra" panose="02000600000000000000" pitchFamily="2" charset="0"/>
-              </a:rPr>
-              <a:t>బలమైన జనముగా నిర్దారించితివి నీ కీర్తి కొరకే</a:t>
+              <a:rPr lang="te-IN" sz="1680" dirty="0">
+                <a:solidFill>
+                  <a:schemeClr val="tx1"/>
+                </a:solidFill>
+                <a:latin typeface="Ramabhadra" panose="02000600000000000000" pitchFamily="2" charset="0"/>
+                <a:cs typeface="Ramabhadra" panose="02000600000000000000" pitchFamily="2" charset="0"/>
+              </a:rPr>
+              <a:t>నీ దయా కిరీటమే</a:t>
+            </a:r>
+          </a:p>
+          <a:p>
+            <a:pPr algn="ctr"/>
+            <a:r>
+              <a:rPr lang="te-IN" sz="1680" dirty="0">
+                <a:solidFill>
+                  <a:schemeClr val="tx1"/>
+                </a:solidFill>
+                <a:latin typeface="Ramabhadra" panose="02000600000000000000" pitchFamily="2" charset="0"/>
+                <a:cs typeface="Ramabhadra" panose="02000600000000000000" pitchFamily="2" charset="0"/>
+              </a:rPr>
+              <a:t>ప్రకృతి కలలన్నియు</a:t>
+            </a:r>
+            <a:endParaRPr lang="en-IN" sz="1680" dirty="0">
+              <a:solidFill>
+                <a:schemeClr val="tx1"/>
+              </a:solidFill>
+              <a:latin typeface="Ramabhadra" panose="02000600000000000000" pitchFamily="2" charset="0"/>
+              <a:cs typeface="Ramabhadra" panose="02000600000000000000" pitchFamily="2" charset="0"/>
+            </a:endParaRPr>
+          </a:p>
+          <a:p>
+            <a:pPr algn="ctr"/>
+            <a:r>
+              <a:rPr lang="te-IN" sz="1680" dirty="0">
+                <a:solidFill>
+                  <a:schemeClr val="tx1"/>
+                </a:solidFill>
+                <a:latin typeface="Ramabhadra" panose="02000600000000000000" pitchFamily="2" charset="0"/>
+                <a:cs typeface="Ramabhadra" panose="02000600000000000000" pitchFamily="2" charset="0"/>
+              </a:rPr>
+              <a:t>నీ మహిమను వివరించునే (2)</a:t>
+            </a:r>
+          </a:p>
+          <a:p>
+            <a:pPr algn="ctr"/>
+            <a:r>
+              <a:rPr lang="te-IN" sz="1680" dirty="0">
+                <a:solidFill>
+                  <a:schemeClr val="tx1"/>
+                </a:solidFill>
+                <a:latin typeface="Ramabhadra" panose="02000600000000000000" pitchFamily="2" charset="0"/>
+                <a:cs typeface="Ramabhadra" panose="02000600000000000000" pitchFamily="2" charset="0"/>
+              </a:rPr>
+              <a:t>ప్రభువా నిన్నే ఆరాధించెద</a:t>
+            </a:r>
+          </a:p>
+          <a:p>
+            <a:pPr algn="ctr"/>
+            <a:r>
+              <a:rPr lang="te-IN" sz="1680" dirty="0">
+                <a:solidFill>
+                  <a:schemeClr val="tx1"/>
+                </a:solidFill>
+                <a:latin typeface="Ramabhadra" panose="02000600000000000000" pitchFamily="2" charset="0"/>
+                <a:cs typeface="Ramabhadra" panose="02000600000000000000" pitchFamily="2" charset="0"/>
+              </a:rPr>
+              <a:t>కృతజ్ఞాతార్పణలతో – కృతజ్ఞాతార్పణలతో (2)</a:t>
+            </a:r>
+          </a:p>
+          <a:p>
+            <a:pPr algn="ctr"/>
+            <a:endParaRPr lang="te-IN" sz="1680" dirty="0">
+              <a:solidFill>
+                <a:schemeClr val="tx1"/>
+              </a:solidFill>
+              <a:latin typeface="Ramabhadra" panose="02000600000000000000" pitchFamily="2" charset="0"/>
+              <a:cs typeface="Ramabhadra" panose="02000600000000000000" pitchFamily="2" charset="0"/>
+            </a:endParaRPr>
+          </a:p>
+          <a:p>
+            <a:pPr algn="ctr"/>
+            <a:r>
+              <a:rPr lang="te-IN" sz="1680" dirty="0">
+                <a:solidFill>
+                  <a:schemeClr val="tx1"/>
+                </a:solidFill>
+                <a:latin typeface="Ramabhadra" panose="02000600000000000000" pitchFamily="2" charset="0"/>
+                <a:cs typeface="Ramabhadra" panose="02000600000000000000" pitchFamily="2" charset="0"/>
+              </a:rPr>
+              <a:t>పరిమలించునే</a:t>
+            </a:r>
+            <a:endParaRPr lang="en-IN" sz="1680" dirty="0">
+              <a:solidFill>
+                <a:schemeClr val="tx1"/>
+              </a:solidFill>
+              <a:latin typeface="Ramabhadra" panose="02000600000000000000" pitchFamily="2" charset="0"/>
+              <a:cs typeface="Ramabhadra" panose="02000600000000000000" pitchFamily="2" charset="0"/>
+            </a:endParaRPr>
+          </a:p>
+          <a:p>
+            <a:pPr algn="ctr"/>
+            <a:r>
+              <a:rPr lang="te-IN" sz="1680" dirty="0">
+                <a:solidFill>
+                  <a:schemeClr val="tx1"/>
+                </a:solidFill>
+                <a:latin typeface="Ramabhadra" panose="02000600000000000000" pitchFamily="2" charset="0"/>
+                <a:cs typeface="Ramabhadra" panose="02000600000000000000" pitchFamily="2" charset="0"/>
+              </a:rPr>
+              <a:t>నా సాక్ష్య జీవితమే</a:t>
+            </a:r>
+          </a:p>
+          <a:p>
+            <a:pPr algn="ctr"/>
+            <a:r>
+              <a:rPr lang="te-IN" sz="1680" dirty="0">
+                <a:solidFill>
+                  <a:schemeClr val="tx1"/>
+                </a:solidFill>
+                <a:latin typeface="Ramabhadra" panose="02000600000000000000" pitchFamily="2" charset="0"/>
+                <a:cs typeface="Ramabhadra" panose="02000600000000000000" pitchFamily="2" charset="0"/>
+              </a:rPr>
+              <a:t>పరిశుద్ధాత్ముడు నన్ను నడిపించుచున్నందునే (2)</a:t>
+            </a:r>
+          </a:p>
+          <a:p>
+            <a:pPr algn="ctr"/>
+            <a:r>
+              <a:rPr lang="te-IN" sz="1680" dirty="0">
+                <a:solidFill>
+                  <a:schemeClr val="tx1"/>
+                </a:solidFill>
+                <a:latin typeface="Ramabhadra" panose="02000600000000000000" pitchFamily="2" charset="0"/>
+                <a:cs typeface="Ramabhadra" panose="02000600000000000000" pitchFamily="2" charset="0"/>
+              </a:rPr>
+              <a:t>పరిశుద్ధాత్మలో ఆనందించెద</a:t>
+            </a:r>
+          </a:p>
+          <a:p>
+            <a:pPr algn="ctr"/>
+            <a:r>
+              <a:rPr lang="te-IN" sz="1680" dirty="0">
+                <a:solidFill>
+                  <a:schemeClr val="tx1"/>
+                </a:solidFill>
+                <a:latin typeface="Ramabhadra" panose="02000600000000000000" pitchFamily="2" charset="0"/>
+                <a:cs typeface="Ramabhadra" panose="02000600000000000000" pitchFamily="2" charset="0"/>
+              </a:rPr>
+              <a:t>హర్ష ధ్వనులతో –</a:t>
+            </a:r>
+            <a:endParaRPr lang="en-IN" sz="1680" dirty="0">
+              <a:solidFill>
+                <a:schemeClr val="tx1"/>
+              </a:solidFill>
+              <a:latin typeface="Ramabhadra" panose="02000600000000000000" pitchFamily="2" charset="0"/>
+              <a:cs typeface="Ramabhadra" panose="02000600000000000000" pitchFamily="2" charset="0"/>
+            </a:endParaRPr>
+          </a:p>
+          <a:p>
+            <a:pPr algn="ctr"/>
+            <a:r>
+              <a:rPr lang="te-IN" sz="1680" dirty="0">
+                <a:solidFill>
+                  <a:schemeClr val="tx1"/>
+                </a:solidFill>
+                <a:latin typeface="Ramabhadra" panose="02000600000000000000" pitchFamily="2" charset="0"/>
+                <a:cs typeface="Ramabhadra" panose="02000600000000000000" pitchFamily="2" charset="0"/>
+              </a:rPr>
+              <a:t>హర్ష ధ్వనులతో (2)</a:t>
             </a:r>
           </a:p>
         </p:txBody>
@@ -5041,7 +5082,7 @@
                 <a:latin typeface="Ramabhadra" panose="02000600000000000000" pitchFamily="2" charset="0"/>
                 <a:cs typeface="Ramabhadra" panose="02000600000000000000" pitchFamily="2" charset="0"/>
               </a:rPr>
-              <a:t>ఆనందం నీలోనే –</a:t>
+              <a:t>నేనెందుకని నీ సొత్తుగా మారితిని</a:t>
             </a:r>
           </a:p>
           <a:p>
@@ -5054,7 +5095,7 @@
                 <a:latin typeface="Ramabhadra" panose="02000600000000000000" pitchFamily="2" charset="0"/>
                 <a:cs typeface="Ramabhadra" panose="02000600000000000000" pitchFamily="2" charset="0"/>
               </a:rPr>
-              <a:t>ఆధారం నీవేగా</a:t>
+              <a:t>యేసయ్యా నీ రక్తముచే… కడుగబడినందున</a:t>
             </a:r>
           </a:p>
           <a:p>
@@ -5067,59 +5108,7 @@
                 <a:latin typeface="Ramabhadra" panose="02000600000000000000" pitchFamily="2" charset="0"/>
                 <a:cs typeface="Ramabhadra" panose="02000600000000000000" pitchFamily="2" charset="0"/>
               </a:rPr>
-              <a:t>ఆశ్రయం నీలోనే –</a:t>
-            </a:r>
-          </a:p>
-          <a:p>
-            <a:pPr algn="ctr"/>
-            <a:r>
-              <a:rPr lang="te-IN" dirty="0">
-                <a:solidFill>
-                  <a:schemeClr val="tx1"/>
-                </a:solidFill>
-                <a:latin typeface="Ramabhadra" panose="02000600000000000000" pitchFamily="2" charset="0"/>
-                <a:cs typeface="Ramabhadra" panose="02000600000000000000" pitchFamily="2" charset="0"/>
-              </a:rPr>
-              <a:t>నా యేసయ్యా – స్తోత్రార్హుడు</a:t>
-            </a:r>
-          </a:p>
-          <a:p>
-            <a:pPr algn="ctr"/>
-            <a:r>
-              <a:rPr lang="te-IN" dirty="0">
-                <a:solidFill>
-                  <a:schemeClr val="tx1"/>
-                </a:solidFill>
-                <a:latin typeface="Ramabhadra" panose="02000600000000000000" pitchFamily="2" charset="0"/>
-                <a:cs typeface="Ramabhadra" panose="02000600000000000000" pitchFamily="2" charset="0"/>
-              </a:rPr>
-              <a:t>అర్హతేలేని నన్ను – ప్రేమించినావు</a:t>
-            </a:r>
-          </a:p>
-          <a:p>
-            <a:pPr algn="ctr"/>
-            <a:r>
-              <a:rPr lang="te-IN" dirty="0">
-                <a:solidFill>
-                  <a:schemeClr val="tx1"/>
-                </a:solidFill>
-                <a:latin typeface="Ramabhadra" panose="02000600000000000000" pitchFamily="2" charset="0"/>
-                <a:cs typeface="Ramabhadra" panose="02000600000000000000" pitchFamily="2" charset="0"/>
-              </a:rPr>
-              <a:t>జీవింతు ఇలలో –</a:t>
-            </a:r>
-          </a:p>
-          <a:p>
-            <a:pPr algn="ctr"/>
-            <a:r>
-              <a:rPr lang="te-IN" dirty="0">
-                <a:solidFill>
-                  <a:schemeClr val="tx1"/>
-                </a:solidFill>
-                <a:latin typeface="Ramabhadra" panose="02000600000000000000" pitchFamily="2" charset="0"/>
-                <a:cs typeface="Ramabhadra" panose="02000600000000000000" pitchFamily="2" charset="0"/>
-              </a:rPr>
-              <a:t>నీ కోసమే – సాక్ష్యార్థమై   </a:t>
+              <a:t>నీ అనాది ప్రణాళికలో… హర్షించెను నా హృదయసీమ</a:t>
             </a:r>
           </a:p>
           <a:p>
@@ -5142,8 +5131,15 @@
                 <a:latin typeface="Ramabhadra" panose="02000600000000000000" pitchFamily="2" charset="0"/>
                 <a:cs typeface="Ramabhadra" panose="02000600000000000000" pitchFamily="2" charset="0"/>
               </a:rPr>
-              <a:t>పదే పదే నిన్నే చేరగా</a:t>
-            </a:r>
+              <a:t>నీ పరిచర్యను తుదముట్టించుటే…</a:t>
+            </a:r>
+            <a:endParaRPr lang="en-IN" dirty="0">
+              <a:solidFill>
+                <a:schemeClr val="tx1"/>
+              </a:solidFill>
+              <a:latin typeface="Ramabhadra" panose="02000600000000000000" pitchFamily="2" charset="0"/>
+              <a:cs typeface="Ramabhadra" panose="02000600000000000000" pitchFamily="2" charset="0"/>
+            </a:endParaRPr>
           </a:p>
           <a:p>
             <a:pPr algn="ctr"/>
@@ -5155,7 +5151,7 @@
                 <a:latin typeface="Ramabhadra" panose="02000600000000000000" pitchFamily="2" charset="0"/>
                 <a:cs typeface="Ramabhadra" panose="02000600000000000000" pitchFamily="2" charset="0"/>
               </a:rPr>
-              <a:t>ప్రతిక్షణం నీవే ధ్యాసగా (2)</a:t>
+              <a:t>నా నియమమాయెనే</a:t>
             </a:r>
           </a:p>
           <a:p>
@@ -5168,7 +5164,7 @@
                 <a:latin typeface="Ramabhadra" panose="02000600000000000000" pitchFamily="2" charset="0"/>
                 <a:cs typeface="Ramabhadra" panose="02000600000000000000" pitchFamily="2" charset="0"/>
               </a:rPr>
-              <a:t>కలవరాల కోటలో –</a:t>
+              <a:t>నీ సన్నిధిలో నీ పోందుకోరి… నీ స్నేహితుడనైతినే</a:t>
             </a:r>
           </a:p>
           <a:p>
@@ -5181,8 +5177,15 @@
                 <a:latin typeface="Ramabhadra" panose="02000600000000000000" pitchFamily="2" charset="0"/>
                 <a:cs typeface="Ramabhadra" panose="02000600000000000000" pitchFamily="2" charset="0"/>
               </a:rPr>
-              <a:t>కన్నీటి బాటలో (2)</a:t>
-            </a:r>
+              <a:t>అహా..! నాధన్యత</a:t>
+            </a:r>
+            <a:endParaRPr lang="en-IN" dirty="0">
+              <a:solidFill>
+                <a:schemeClr val="tx1"/>
+              </a:solidFill>
+              <a:latin typeface="Ramabhadra" panose="02000600000000000000" pitchFamily="2" charset="0"/>
+              <a:cs typeface="Ramabhadra" panose="02000600000000000000" pitchFamily="2" charset="0"/>
+            </a:endParaRPr>
           </a:p>
           <a:p>
             <a:pPr algn="ctr"/>
@@ -5194,8 +5197,15 @@
                 <a:latin typeface="Ramabhadra" panose="02000600000000000000" pitchFamily="2" charset="0"/>
                 <a:cs typeface="Ramabhadra" panose="02000600000000000000" pitchFamily="2" charset="0"/>
               </a:rPr>
-              <a:t>కాపాడే కవచంగా –</a:t>
-            </a:r>
+              <a:t>ఓహో…! నాభాగ్యము…</a:t>
+            </a:r>
+            <a:endParaRPr lang="en-IN" dirty="0">
+              <a:solidFill>
+                <a:schemeClr val="tx1"/>
+              </a:solidFill>
+              <a:latin typeface="Ramabhadra" panose="02000600000000000000" pitchFamily="2" charset="0"/>
+              <a:cs typeface="Ramabhadra" panose="02000600000000000000" pitchFamily="2" charset="0"/>
+            </a:endParaRPr>
           </a:p>
           <a:p>
             <a:pPr algn="ctr"/>
@@ -5207,20 +5217,7 @@
                 <a:latin typeface="Ramabhadra" panose="02000600000000000000" pitchFamily="2" charset="0"/>
                 <a:cs typeface="Ramabhadra" panose="02000600000000000000" pitchFamily="2" charset="0"/>
               </a:rPr>
-              <a:t>నన్ను ఆవరించిన</a:t>
-            </a:r>
-          </a:p>
-          <a:p>
-            <a:pPr algn="ctr"/>
-            <a:r>
-              <a:rPr lang="te-IN" dirty="0">
-                <a:solidFill>
-                  <a:schemeClr val="tx1"/>
-                </a:solidFill>
-                <a:latin typeface="Ramabhadra" panose="02000600000000000000" pitchFamily="2" charset="0"/>
-                <a:cs typeface="Ramabhadra" panose="02000600000000000000" pitchFamily="2" charset="0"/>
-              </a:rPr>
-              <a:t>దివ్యక్షేత్రమా – స్తోత్రగీతమా   </a:t>
+              <a:t>ఏమని వివరింతును</a:t>
             </a:r>
           </a:p>
           <a:p>
@@ -5243,7 +5240,7 @@
                 <a:latin typeface="Ramabhadra" panose="02000600000000000000" pitchFamily="2" charset="0"/>
                 <a:cs typeface="Ramabhadra" panose="02000600000000000000" pitchFamily="2" charset="0"/>
               </a:rPr>
-              <a:t>నిరంతరం నీవే వెలుగని</a:t>
+              <a:t>నీ శ్రమలలో పాలొందుటయే… నా దర్శనమాయెనే</a:t>
             </a:r>
           </a:p>
           <a:p>
@@ -5256,8 +5253,15 @@
                 <a:latin typeface="Ramabhadra" panose="02000600000000000000" pitchFamily="2" charset="0"/>
                 <a:cs typeface="Ramabhadra" panose="02000600000000000000" pitchFamily="2" charset="0"/>
               </a:rPr>
-              <a:t>నిత్యమైన స్వాస్థ్యం నీదని (2)</a:t>
-            </a:r>
+              <a:t>నా తనువందున</a:t>
+            </a:r>
+            <a:endParaRPr lang="en-IN" dirty="0">
+              <a:solidFill>
+                <a:schemeClr val="tx1"/>
+              </a:solidFill>
+              <a:latin typeface="Ramabhadra" panose="02000600000000000000" pitchFamily="2" charset="0"/>
+              <a:cs typeface="Ramabhadra" panose="02000600000000000000" pitchFamily="2" charset="0"/>
+            </a:endParaRPr>
           </a:p>
           <a:p>
             <a:pPr algn="ctr"/>
@@ -5269,8 +5273,15 @@
                 <a:latin typeface="Ramabhadra" panose="02000600000000000000" pitchFamily="2" charset="0"/>
                 <a:cs typeface="Ramabhadra" panose="02000600000000000000" pitchFamily="2" charset="0"/>
               </a:rPr>
-              <a:t>నీ సన్నిధి వీడక –</a:t>
-            </a:r>
+              <a:t>శ్రమలు సహించి…</a:t>
+            </a:r>
+            <a:endParaRPr lang="en-IN" dirty="0">
+              <a:solidFill>
+                <a:schemeClr val="tx1"/>
+              </a:solidFill>
+              <a:latin typeface="Ramabhadra" panose="02000600000000000000" pitchFamily="2" charset="0"/>
+              <a:cs typeface="Ramabhadra" panose="02000600000000000000" pitchFamily="2" charset="0"/>
+            </a:endParaRPr>
           </a:p>
           <a:p>
             <a:pPr algn="ctr"/>
@@ -5282,7 +5293,7 @@
                 <a:latin typeface="Ramabhadra" panose="02000600000000000000" pitchFamily="2" charset="0"/>
                 <a:cs typeface="Ramabhadra" panose="02000600000000000000" pitchFamily="2" charset="0"/>
               </a:rPr>
-              <a:t>సన్నుతించి పాడనా (2)</a:t>
+              <a:t>నీ వారసుడనైతినే</a:t>
             </a:r>
           </a:p>
           <a:p>
@@ -5295,8 +5306,15 @@
                 <a:latin typeface="Ramabhadra" panose="02000600000000000000" pitchFamily="2" charset="0"/>
                 <a:cs typeface="Ramabhadra" panose="02000600000000000000" pitchFamily="2" charset="0"/>
               </a:rPr>
-              <a:t>నీకొరకే ధ్వజమెత్తి</a:t>
-            </a:r>
+              <a:t>అహా..! నాధన్యత</a:t>
+            </a:r>
+            <a:endParaRPr lang="en-IN" dirty="0">
+              <a:solidFill>
+                <a:schemeClr val="tx1"/>
+              </a:solidFill>
+              <a:latin typeface="Ramabhadra" panose="02000600000000000000" pitchFamily="2" charset="0"/>
+              <a:cs typeface="Ramabhadra" panose="02000600000000000000" pitchFamily="2" charset="0"/>
+            </a:endParaRPr>
           </a:p>
           <a:p>
             <a:pPr algn="ctr"/>
@@ -5308,20 +5326,7 @@
                 <a:latin typeface="Ramabhadra" panose="02000600000000000000" pitchFamily="2" charset="0"/>
                 <a:cs typeface="Ramabhadra" panose="02000600000000000000" pitchFamily="2" charset="0"/>
               </a:rPr>
-              <a:t>నిన్న ప్రకటించనా</a:t>
-            </a:r>
-          </a:p>
-          <a:p>
-            <a:pPr algn="ctr"/>
-            <a:r>
-              <a:rPr lang="te-IN" dirty="0">
-                <a:solidFill>
-                  <a:schemeClr val="tx1"/>
-                </a:solidFill>
-                <a:latin typeface="Ramabhadra" panose="02000600000000000000" pitchFamily="2" charset="0"/>
-                <a:cs typeface="Ramabhadra" panose="02000600000000000000" pitchFamily="2" charset="0"/>
-              </a:rPr>
-              <a:t>సత్యవాక్యమే – జీవవాక్యమే </a:t>
+              <a:t>ఓహో…! నాభాగ్యము… ఏమని వివరింతును</a:t>
             </a:r>
           </a:p>
         </p:txBody>
@@ -5340,7 +5345,7 @@
         </p:nvSpPr>
         <p:spPr>
           <a:xfrm>
-            <a:off x="4953000" y="3174"/>
+            <a:off x="-1200" y="3174"/>
             <a:ext cx="2476800" cy="6854826"/>
           </a:xfrm>
           <a:prstGeom prst="rect">
@@ -5379,58 +5384,16 @@
           <a:p>
             <a:pPr algn="ctr"/>
             <a:r>
-              <a:rPr lang="te-IN" sz="1900" dirty="0">
-                <a:solidFill>
-                  <a:schemeClr val="tx1"/>
-                </a:solidFill>
-                <a:latin typeface="Ramabhadra" panose="02000600000000000000" pitchFamily="2" charset="0"/>
-                <a:cs typeface="Ramabhadra" panose="02000600000000000000" pitchFamily="2" charset="0"/>
-              </a:rPr>
-              <a:t>స్తుతి పాత్రుడా - స్తోత్రార్హుడా</a:t>
-            </a:r>
-          </a:p>
-          <a:p>
-            <a:pPr algn="ctr"/>
-            <a:r>
-              <a:rPr lang="te-IN" sz="1900" dirty="0">
-                <a:solidFill>
-                  <a:schemeClr val="tx1"/>
-                </a:solidFill>
-                <a:latin typeface="Ramabhadra" panose="02000600000000000000" pitchFamily="2" charset="0"/>
-                <a:cs typeface="Ramabhadra" panose="02000600000000000000" pitchFamily="2" charset="0"/>
-              </a:rPr>
-              <a:t>స్తుతులందుకో - పూజార్హుడా</a:t>
-            </a:r>
-          </a:p>
-          <a:p>
-            <a:pPr algn="ctr"/>
-            <a:r>
-              <a:rPr lang="te-IN" sz="1900" dirty="0">
-                <a:solidFill>
-                  <a:schemeClr val="tx1"/>
-                </a:solidFill>
-                <a:latin typeface="Ramabhadra" panose="02000600000000000000" pitchFamily="2" charset="0"/>
-                <a:cs typeface="Ramabhadra" panose="02000600000000000000" pitchFamily="2" charset="0"/>
-              </a:rPr>
-              <a:t>ఆకాశమందు నీవు తప్ప - నాకెవరున్నారు నా ప్రభు</a:t>
-            </a:r>
-          </a:p>
-          <a:p>
-            <a:pPr algn="ctr"/>
-            <a:r>
-              <a:rPr lang="te-IN" sz="1900" dirty="0">
-                <a:solidFill>
-                  <a:schemeClr val="tx1"/>
-                </a:solidFill>
-                <a:latin typeface="Ramabhadra" panose="02000600000000000000" pitchFamily="2" charset="0"/>
-                <a:cs typeface="Ramabhadra" panose="02000600000000000000" pitchFamily="2" charset="0"/>
-              </a:rPr>
-              <a:t>స్తుతి పాత్రుడా.... ఆఆఅ</a:t>
-            </a:r>
-          </a:p>
-          <a:p>
-            <a:pPr algn="ctr"/>
-            <a:endParaRPr lang="te-IN" sz="1900" dirty="0">
+              <a:rPr lang="te-IN" dirty="0">
+                <a:solidFill>
+                  <a:schemeClr val="tx1"/>
+                </a:solidFill>
+                <a:latin typeface="Ramabhadra" panose="02000600000000000000" pitchFamily="2" charset="0"/>
+                <a:cs typeface="Ramabhadra" panose="02000600000000000000" pitchFamily="2" charset="0"/>
+              </a:rPr>
+              <a:t>శృతిచేసి నే పాడనా</a:t>
+            </a:r>
+            <a:endParaRPr lang="en-IN" dirty="0">
               <a:solidFill>
                 <a:schemeClr val="tx1"/>
               </a:solidFill>
@@ -5441,110 +5404,54 @@
           <a:p>
             <a:pPr algn="ctr"/>
             <a:r>
-              <a:rPr lang="te-IN" sz="1900" dirty="0">
-                <a:solidFill>
-                  <a:schemeClr val="tx1"/>
-                </a:solidFill>
-                <a:latin typeface="Ramabhadra" panose="02000600000000000000" pitchFamily="2" charset="0"/>
-                <a:cs typeface="Ramabhadra" panose="02000600000000000000" pitchFamily="2" charset="0"/>
-              </a:rPr>
-              <a:t>నా శత్రువులు</a:t>
-            </a:r>
-          </a:p>
-          <a:p>
-            <a:pPr algn="ctr"/>
-            <a:r>
-              <a:rPr lang="te-IN" sz="1900" dirty="0">
-                <a:solidFill>
-                  <a:schemeClr val="tx1"/>
-                </a:solidFill>
-                <a:latin typeface="Ramabhadra" panose="02000600000000000000" pitchFamily="2" charset="0"/>
-                <a:cs typeface="Ramabhadra" panose="02000600000000000000" pitchFamily="2" charset="0"/>
-              </a:rPr>
-              <a:t>నను తరుముచుండగా –</a:t>
-            </a:r>
-          </a:p>
-          <a:p>
-            <a:pPr algn="ctr"/>
-            <a:r>
-              <a:rPr lang="te-IN" sz="1900" dirty="0">
-                <a:solidFill>
-                  <a:schemeClr val="tx1"/>
-                </a:solidFill>
-                <a:latin typeface="Ramabhadra" panose="02000600000000000000" pitchFamily="2" charset="0"/>
-                <a:cs typeface="Ramabhadra" panose="02000600000000000000" pitchFamily="2" charset="0"/>
-              </a:rPr>
-              <a:t>నా యాత్మ నాలో</a:t>
-            </a:r>
-          </a:p>
-          <a:p>
-            <a:pPr algn="ctr"/>
-            <a:r>
-              <a:rPr lang="te-IN" sz="1900" dirty="0">
-                <a:solidFill>
-                  <a:schemeClr val="tx1"/>
-                </a:solidFill>
-                <a:latin typeface="Ramabhadra" panose="02000600000000000000" pitchFamily="2" charset="0"/>
-                <a:cs typeface="Ramabhadra" panose="02000600000000000000" pitchFamily="2" charset="0"/>
-              </a:rPr>
-              <a:t>కృంగెనే ప్రభూ -2</a:t>
-            </a:r>
-          </a:p>
-          <a:p>
-            <a:pPr algn="ctr"/>
-            <a:r>
-              <a:rPr lang="te-IN" sz="1900" dirty="0">
-                <a:solidFill>
-                  <a:schemeClr val="tx1"/>
-                </a:solidFill>
-                <a:latin typeface="Ramabhadra" panose="02000600000000000000" pitchFamily="2" charset="0"/>
-                <a:cs typeface="Ramabhadra" panose="02000600000000000000" pitchFamily="2" charset="0"/>
-              </a:rPr>
-              <a:t>నా మనస్సు నీ వైపు</a:t>
-            </a:r>
-          </a:p>
-          <a:p>
-            <a:pPr algn="ctr"/>
-            <a:r>
-              <a:rPr lang="te-IN" sz="1900" dirty="0">
-                <a:solidFill>
-                  <a:schemeClr val="tx1"/>
-                </a:solidFill>
-                <a:latin typeface="Ramabhadra" panose="02000600000000000000" pitchFamily="2" charset="0"/>
-                <a:cs typeface="Ramabhadra" panose="02000600000000000000" pitchFamily="2" charset="0"/>
-              </a:rPr>
-              <a:t>త్రిప్పిన వెంటనే –</a:t>
-            </a:r>
-          </a:p>
-          <a:p>
-            <a:pPr algn="ctr"/>
-            <a:r>
-              <a:rPr lang="te-IN" sz="1900" dirty="0">
-                <a:solidFill>
-                  <a:schemeClr val="tx1"/>
-                </a:solidFill>
-                <a:latin typeface="Ramabhadra" panose="02000600000000000000" pitchFamily="2" charset="0"/>
-                <a:cs typeface="Ramabhadra" panose="02000600000000000000" pitchFamily="2" charset="0"/>
-              </a:rPr>
-              <a:t>శత్రుల చేతినుండి విడిపించినావు</a:t>
-            </a:r>
-          </a:p>
-          <a:p>
-            <a:pPr algn="ctr"/>
-            <a:r>
-              <a:rPr lang="te-IN" sz="1900" dirty="0">
-                <a:solidFill>
-                  <a:schemeClr val="tx1"/>
-                </a:solidFill>
-                <a:latin typeface="Ramabhadra" panose="02000600000000000000" pitchFamily="2" charset="0"/>
-                <a:cs typeface="Ramabhadra" panose="02000600000000000000" pitchFamily="2" charset="0"/>
-              </a:rPr>
-              <a:t>కాపాడినావు -2</a:t>
-            </a:r>
-          </a:p>
-          <a:p>
-            <a:pPr algn="ctr"/>
-            <a:endParaRPr lang="te-IN" sz="1900" dirty="0">
+              <a:rPr lang="te-IN" dirty="0">
+                <a:solidFill>
+                  <a:schemeClr val="tx1"/>
+                </a:solidFill>
+                <a:latin typeface="Ramabhadra" panose="02000600000000000000" pitchFamily="2" charset="0"/>
+                <a:cs typeface="Ramabhadra" panose="02000600000000000000" pitchFamily="2" charset="0"/>
+              </a:rPr>
+              <a:t>స్తోత్ర గీతం</a:t>
+            </a:r>
+            <a:br>
+              <a:rPr lang="te-IN" dirty="0">
+                <a:solidFill>
+                  <a:schemeClr val="tx1"/>
+                </a:solidFill>
+                <a:latin typeface="Ramabhadra" panose="02000600000000000000" pitchFamily="2" charset="0"/>
+                <a:cs typeface="Ramabhadra" panose="02000600000000000000" pitchFamily="2" charset="0"/>
+              </a:rPr>
+            </a:br>
+            <a:r>
+              <a:rPr lang="te-IN" dirty="0">
+                <a:solidFill>
+                  <a:schemeClr val="tx1"/>
+                </a:solidFill>
+                <a:latin typeface="Ramabhadra" panose="02000600000000000000" pitchFamily="2" charset="0"/>
+                <a:cs typeface="Ramabhadra" panose="02000600000000000000" pitchFamily="2" charset="0"/>
+              </a:rPr>
+              <a:t>భజియించి నే పొగడనా స్వామీ (2)</a:t>
+            </a:r>
+            <a:br>
+              <a:rPr lang="te-IN" dirty="0">
+                <a:solidFill>
+                  <a:schemeClr val="tx1"/>
+                </a:solidFill>
+                <a:latin typeface="Ramabhadra" panose="02000600000000000000" pitchFamily="2" charset="0"/>
+                <a:cs typeface="Ramabhadra" panose="02000600000000000000" pitchFamily="2" charset="0"/>
+              </a:rPr>
+            </a:br>
+            <a:r>
+              <a:rPr lang="te-IN" dirty="0">
+                <a:solidFill>
+                  <a:schemeClr val="tx1"/>
+                </a:solidFill>
+                <a:latin typeface="Ramabhadra" panose="02000600000000000000" pitchFamily="2" charset="0"/>
+                <a:cs typeface="Ramabhadra" panose="02000600000000000000" pitchFamily="2" charset="0"/>
+              </a:rPr>
+              <a:t>శృతిచేసి నే పాడనా</a:t>
+            </a:r>
+            <a:endParaRPr lang="en-IN" dirty="0">
               <a:solidFill>
                 <a:schemeClr val="tx1"/>
               </a:solidFill>
@@ -5555,66 +5462,310 @@
           <a:p>
             <a:pPr algn="ctr"/>
             <a:r>
-              <a:rPr lang="te-IN" sz="1900" dirty="0">
-                <a:solidFill>
-                  <a:schemeClr val="tx1"/>
-                </a:solidFill>
-                <a:latin typeface="Ramabhadra" panose="02000600000000000000" pitchFamily="2" charset="0"/>
-                <a:cs typeface="Ramabhadra" panose="02000600000000000000" pitchFamily="2" charset="0"/>
-              </a:rPr>
-              <a:t>నా ప్రాణ స్నేహితులు</a:t>
-            </a:r>
-          </a:p>
-          <a:p>
-            <a:pPr algn="ctr"/>
-            <a:r>
-              <a:rPr lang="te-IN" sz="1900" dirty="0">
-                <a:solidFill>
-                  <a:schemeClr val="tx1"/>
-                </a:solidFill>
-                <a:latin typeface="Ramabhadra" panose="02000600000000000000" pitchFamily="2" charset="0"/>
-                <a:cs typeface="Ramabhadra" panose="02000600000000000000" pitchFamily="2" charset="0"/>
-              </a:rPr>
-              <a:t>నన్ను చూచి దూరాన నిలిచేరు నా ప్రభూ -2</a:t>
-            </a:r>
-          </a:p>
-          <a:p>
-            <a:pPr algn="ctr"/>
-            <a:r>
-              <a:rPr lang="te-IN" sz="1900" dirty="0">
-                <a:solidFill>
-                  <a:schemeClr val="tx1"/>
-                </a:solidFill>
-                <a:latin typeface="Ramabhadra" panose="02000600000000000000" pitchFamily="2" charset="0"/>
-                <a:cs typeface="Ramabhadra" panose="02000600000000000000" pitchFamily="2" charset="0"/>
-              </a:rPr>
-              <a:t>నీ వాక్య ధ్యానమే నా త్రోవకు వెలుగై -నను నిల్పెను</a:t>
-            </a:r>
-          </a:p>
-          <a:p>
-            <a:pPr algn="ctr"/>
-            <a:r>
-              <a:rPr lang="te-IN" sz="1900" dirty="0">
-                <a:solidFill>
-                  <a:schemeClr val="tx1"/>
-                </a:solidFill>
-                <a:latin typeface="Ramabhadra" panose="02000600000000000000" pitchFamily="2" charset="0"/>
-                <a:cs typeface="Ramabhadra" panose="02000600000000000000" pitchFamily="2" charset="0"/>
-              </a:rPr>
-              <a:t>నీ సన్నీధిలో –</a:t>
-            </a:r>
-          </a:p>
-          <a:p>
-            <a:pPr algn="ctr"/>
-            <a:r>
-              <a:rPr lang="te-IN" sz="1900" dirty="0">
-                <a:solidFill>
-                  <a:schemeClr val="tx1"/>
-                </a:solidFill>
-                <a:latin typeface="Ramabhadra" panose="02000600000000000000" pitchFamily="2" charset="0"/>
-                <a:cs typeface="Ramabhadra" panose="02000600000000000000" pitchFamily="2" charset="0"/>
-              </a:rPr>
-              <a:t>నీ సంఘములో -2</a:t>
+              <a:rPr lang="te-IN" dirty="0">
+                <a:solidFill>
+                  <a:schemeClr val="tx1"/>
+                </a:solidFill>
+                <a:latin typeface="Ramabhadra" panose="02000600000000000000" pitchFamily="2" charset="0"/>
+                <a:cs typeface="Ramabhadra" panose="02000600000000000000" pitchFamily="2" charset="0"/>
+              </a:rPr>
+              <a:t>స్తోత్ర గీతం</a:t>
+            </a:r>
+            <a:br>
+              <a:rPr lang="te-IN" dirty="0">
+                <a:solidFill>
+                  <a:schemeClr val="tx1"/>
+                </a:solidFill>
+                <a:latin typeface="Ramabhadra" panose="02000600000000000000" pitchFamily="2" charset="0"/>
+                <a:cs typeface="Ramabhadra" panose="02000600000000000000" pitchFamily="2" charset="0"/>
+              </a:rPr>
+            </a:br>
+            <a:r>
+              <a:rPr lang="te-IN" dirty="0">
+                <a:solidFill>
+                  <a:schemeClr val="tx1"/>
+                </a:solidFill>
+                <a:latin typeface="Ramabhadra" panose="02000600000000000000" pitchFamily="2" charset="0"/>
+                <a:cs typeface="Ramabhadra" panose="02000600000000000000" pitchFamily="2" charset="0"/>
+              </a:rPr>
+              <a:t>హల్లేలూయా హల్లేలూయా</a:t>
+            </a:r>
+            <a:br>
+              <a:rPr lang="te-IN" dirty="0">
+                <a:solidFill>
+                  <a:schemeClr val="tx1"/>
+                </a:solidFill>
+                <a:latin typeface="Ramabhadra" panose="02000600000000000000" pitchFamily="2" charset="0"/>
+                <a:cs typeface="Ramabhadra" panose="02000600000000000000" pitchFamily="2" charset="0"/>
+              </a:rPr>
+            </a:br>
+            <a:r>
+              <a:rPr lang="te-IN" dirty="0">
+                <a:solidFill>
+                  <a:schemeClr val="tx1"/>
+                </a:solidFill>
+                <a:latin typeface="Ramabhadra" panose="02000600000000000000" pitchFamily="2" charset="0"/>
+                <a:cs typeface="Ramabhadra" panose="02000600000000000000" pitchFamily="2" charset="0"/>
+              </a:rPr>
+              <a:t>హల్లెలూయ హల్లెలూయ హల్లేలుయా (2)     </a:t>
+            </a:r>
+          </a:p>
+          <a:p>
+            <a:pPr algn="ctr"/>
+            <a:r>
+              <a:rPr lang="te-IN" dirty="0">
+                <a:solidFill>
+                  <a:schemeClr val="tx1"/>
+                </a:solidFill>
+                <a:latin typeface="Ramabhadra" panose="02000600000000000000" pitchFamily="2" charset="0"/>
+                <a:cs typeface="Ramabhadra" panose="02000600000000000000" pitchFamily="2" charset="0"/>
+              </a:rPr>
+              <a:t> </a:t>
+            </a:r>
+          </a:p>
+          <a:p>
+            <a:pPr algn="ctr"/>
+            <a:r>
+              <a:rPr lang="te-IN" dirty="0">
+                <a:solidFill>
+                  <a:schemeClr val="tx1"/>
+                </a:solidFill>
+                <a:latin typeface="Ramabhadra" panose="02000600000000000000" pitchFamily="2" charset="0"/>
+                <a:cs typeface="Ramabhadra" panose="02000600000000000000" pitchFamily="2" charset="0"/>
+              </a:rPr>
+              <a:t>దానియేలును</a:t>
+            </a:r>
+            <a:endParaRPr lang="en-IN" dirty="0">
+              <a:solidFill>
+                <a:schemeClr val="tx1"/>
+              </a:solidFill>
+              <a:latin typeface="Ramabhadra" panose="02000600000000000000" pitchFamily="2" charset="0"/>
+              <a:cs typeface="Ramabhadra" panose="02000600000000000000" pitchFamily="2" charset="0"/>
+            </a:endParaRPr>
+          </a:p>
+          <a:p>
+            <a:pPr algn="ctr"/>
+            <a:r>
+              <a:rPr lang="te-IN" dirty="0">
+                <a:solidFill>
+                  <a:schemeClr val="tx1"/>
+                </a:solidFill>
+                <a:latin typeface="Ramabhadra" panose="02000600000000000000" pitchFamily="2" charset="0"/>
+                <a:cs typeface="Ramabhadra" panose="02000600000000000000" pitchFamily="2" charset="0"/>
+              </a:rPr>
+              <a:t>సింహపు బోనులో</a:t>
+            </a:r>
+            <a:br>
+              <a:rPr lang="te-IN" dirty="0">
+                <a:solidFill>
+                  <a:schemeClr val="tx1"/>
+                </a:solidFill>
+                <a:latin typeface="Ramabhadra" panose="02000600000000000000" pitchFamily="2" charset="0"/>
+                <a:cs typeface="Ramabhadra" panose="02000600000000000000" pitchFamily="2" charset="0"/>
+              </a:rPr>
+            </a:br>
+            <a:r>
+              <a:rPr lang="te-IN" dirty="0">
+                <a:solidFill>
+                  <a:schemeClr val="tx1"/>
+                </a:solidFill>
+                <a:latin typeface="Ramabhadra" panose="02000600000000000000" pitchFamily="2" charset="0"/>
+                <a:cs typeface="Ramabhadra" panose="02000600000000000000" pitchFamily="2" charset="0"/>
+              </a:rPr>
+              <a:t>కాపాడినది నీవెకదా (2)</a:t>
+            </a:r>
+            <a:br>
+              <a:rPr lang="te-IN" dirty="0">
+                <a:solidFill>
+                  <a:schemeClr val="tx1"/>
+                </a:solidFill>
+                <a:latin typeface="Ramabhadra" panose="02000600000000000000" pitchFamily="2" charset="0"/>
+                <a:cs typeface="Ramabhadra" panose="02000600000000000000" pitchFamily="2" charset="0"/>
+              </a:rPr>
+            </a:br>
+            <a:r>
+              <a:rPr lang="te-IN" dirty="0">
+                <a:solidFill>
+                  <a:schemeClr val="tx1"/>
+                </a:solidFill>
+                <a:latin typeface="Ramabhadra" panose="02000600000000000000" pitchFamily="2" charset="0"/>
+                <a:cs typeface="Ramabhadra" panose="02000600000000000000" pitchFamily="2" charset="0"/>
+              </a:rPr>
+              <a:t>జలప్రళయములో</a:t>
+            </a:r>
+            <a:endParaRPr lang="en-IN" dirty="0">
+              <a:solidFill>
+                <a:schemeClr val="tx1"/>
+              </a:solidFill>
+              <a:latin typeface="Ramabhadra" panose="02000600000000000000" pitchFamily="2" charset="0"/>
+              <a:cs typeface="Ramabhadra" panose="02000600000000000000" pitchFamily="2" charset="0"/>
+            </a:endParaRPr>
+          </a:p>
+          <a:p>
+            <a:pPr algn="ctr"/>
+            <a:r>
+              <a:rPr lang="te-IN" dirty="0">
+                <a:solidFill>
+                  <a:schemeClr val="tx1"/>
+                </a:solidFill>
+                <a:latin typeface="Ramabhadra" panose="02000600000000000000" pitchFamily="2" charset="0"/>
+                <a:cs typeface="Ramabhadra" panose="02000600000000000000" pitchFamily="2" charset="0"/>
+              </a:rPr>
+              <a:t>నోవాహును గాచిన</a:t>
+            </a:r>
+            <a:br>
+              <a:rPr lang="te-IN" dirty="0">
+                <a:solidFill>
+                  <a:schemeClr val="tx1"/>
+                </a:solidFill>
+                <a:latin typeface="Ramabhadra" panose="02000600000000000000" pitchFamily="2" charset="0"/>
+                <a:cs typeface="Ramabhadra" panose="02000600000000000000" pitchFamily="2" charset="0"/>
+              </a:rPr>
+            </a:br>
+            <a:r>
+              <a:rPr lang="te-IN" dirty="0">
+                <a:solidFill>
+                  <a:schemeClr val="tx1"/>
+                </a:solidFill>
+                <a:latin typeface="Ramabhadra" panose="02000600000000000000" pitchFamily="2" charset="0"/>
+                <a:cs typeface="Ramabhadra" panose="02000600000000000000" pitchFamily="2" charset="0"/>
+              </a:rPr>
+              <a:t>బలవంతుడవు నీవెకదా (2)</a:t>
+            </a:r>
+            <a:br>
+              <a:rPr lang="te-IN" dirty="0">
+                <a:solidFill>
+                  <a:schemeClr val="tx1"/>
+                </a:solidFill>
+                <a:latin typeface="Ramabhadra" panose="02000600000000000000" pitchFamily="2" charset="0"/>
+                <a:cs typeface="Ramabhadra" panose="02000600000000000000" pitchFamily="2" charset="0"/>
+              </a:rPr>
+            </a:br>
+            <a:r>
+              <a:rPr lang="te-IN" dirty="0">
+                <a:solidFill>
+                  <a:schemeClr val="tx1"/>
+                </a:solidFill>
+                <a:latin typeface="Ramabhadra" panose="02000600000000000000" pitchFamily="2" charset="0"/>
+                <a:cs typeface="Ramabhadra" panose="02000600000000000000" pitchFamily="2" charset="0"/>
+              </a:rPr>
+              <a:t>నీవెకదా (3</a:t>
+            </a:r>
+            <a:r>
+              <a:rPr lang="en-IN" dirty="0">
+                <a:solidFill>
+                  <a:schemeClr val="tx1"/>
+                </a:solidFill>
+                <a:latin typeface="Ramabhadra" panose="02000600000000000000" pitchFamily="2" charset="0"/>
+                <a:cs typeface="Ramabhadra" panose="02000600000000000000" pitchFamily="2" charset="0"/>
+              </a:rPr>
+              <a:t>)</a:t>
+            </a:r>
+            <a:endParaRPr lang="te-IN" dirty="0">
+              <a:solidFill>
+                <a:schemeClr val="tx1"/>
+              </a:solidFill>
+              <a:latin typeface="Ramabhadra" panose="02000600000000000000" pitchFamily="2" charset="0"/>
+              <a:cs typeface="Ramabhadra" panose="02000600000000000000" pitchFamily="2" charset="0"/>
+            </a:endParaRPr>
+          </a:p>
+          <a:p>
+            <a:pPr algn="ctr"/>
+            <a:endParaRPr lang="te-IN" dirty="0">
+              <a:solidFill>
+                <a:schemeClr val="tx1"/>
+              </a:solidFill>
+              <a:latin typeface="Ramabhadra" panose="02000600000000000000" pitchFamily="2" charset="0"/>
+              <a:cs typeface="Ramabhadra" panose="02000600000000000000" pitchFamily="2" charset="0"/>
+            </a:endParaRPr>
+          </a:p>
+          <a:p>
+            <a:pPr algn="ctr"/>
+            <a:r>
+              <a:rPr lang="te-IN" dirty="0">
+                <a:solidFill>
+                  <a:schemeClr val="tx1"/>
+                </a:solidFill>
+                <a:latin typeface="Ramabhadra" panose="02000600000000000000" pitchFamily="2" charset="0"/>
+                <a:cs typeface="Ramabhadra" panose="02000600000000000000" pitchFamily="2" charset="0"/>
+              </a:rPr>
+              <a:t>సమరయ స్త్రీని కరుణతో బ్రోచిన</a:t>
+            </a:r>
+            <a:br>
+              <a:rPr lang="te-IN" dirty="0">
+                <a:solidFill>
+                  <a:schemeClr val="tx1"/>
+                </a:solidFill>
+                <a:latin typeface="Ramabhadra" panose="02000600000000000000" pitchFamily="2" charset="0"/>
+                <a:cs typeface="Ramabhadra" panose="02000600000000000000" pitchFamily="2" charset="0"/>
+              </a:rPr>
+            </a:br>
+            <a:r>
+              <a:rPr lang="te-IN" dirty="0">
+                <a:solidFill>
+                  <a:schemeClr val="tx1"/>
+                </a:solidFill>
+                <a:latin typeface="Ramabhadra" panose="02000600000000000000" pitchFamily="2" charset="0"/>
+                <a:cs typeface="Ramabhadra" panose="02000600000000000000" pitchFamily="2" charset="0"/>
+              </a:rPr>
+              <a:t>సత్య హితుడవు నీవెకదా (2)</a:t>
+            </a:r>
+            <a:br>
+              <a:rPr lang="te-IN" dirty="0">
+                <a:solidFill>
+                  <a:schemeClr val="tx1"/>
+                </a:solidFill>
+                <a:latin typeface="Ramabhadra" panose="02000600000000000000" pitchFamily="2" charset="0"/>
+                <a:cs typeface="Ramabhadra" panose="02000600000000000000" pitchFamily="2" charset="0"/>
+              </a:rPr>
+            </a:br>
+            <a:r>
+              <a:rPr lang="te-IN" dirty="0">
+                <a:solidFill>
+                  <a:schemeClr val="tx1"/>
+                </a:solidFill>
+                <a:latin typeface="Ramabhadra" panose="02000600000000000000" pitchFamily="2" charset="0"/>
+                <a:cs typeface="Ramabhadra" panose="02000600000000000000" pitchFamily="2" charset="0"/>
+              </a:rPr>
+              <a:t>పాపులకొరకై ప్రాణమునిచ్చిన</a:t>
+            </a:r>
+            <a:br>
+              <a:rPr lang="te-IN" dirty="0">
+                <a:solidFill>
+                  <a:schemeClr val="tx1"/>
+                </a:solidFill>
+                <a:latin typeface="Ramabhadra" panose="02000600000000000000" pitchFamily="2" charset="0"/>
+                <a:cs typeface="Ramabhadra" panose="02000600000000000000" pitchFamily="2" charset="0"/>
+              </a:rPr>
+            </a:br>
+            <a:r>
+              <a:rPr lang="te-IN" dirty="0">
+                <a:solidFill>
+                  <a:schemeClr val="tx1"/>
+                </a:solidFill>
+                <a:latin typeface="Ramabhadra" panose="02000600000000000000" pitchFamily="2" charset="0"/>
+                <a:cs typeface="Ramabhadra" panose="02000600000000000000" pitchFamily="2" charset="0"/>
+              </a:rPr>
+              <a:t>కరుణామయుడవు నీవెకదా (2)</a:t>
+            </a:r>
+            <a:br>
+              <a:rPr lang="te-IN" dirty="0">
+                <a:solidFill>
+                  <a:schemeClr val="tx1"/>
+                </a:solidFill>
+                <a:latin typeface="Ramabhadra" panose="02000600000000000000" pitchFamily="2" charset="0"/>
+                <a:cs typeface="Ramabhadra" panose="02000600000000000000" pitchFamily="2" charset="0"/>
+              </a:rPr>
+            </a:br>
+            <a:r>
+              <a:rPr lang="te-IN" dirty="0">
+                <a:solidFill>
+                  <a:schemeClr val="tx1"/>
+                </a:solidFill>
+                <a:latin typeface="Ramabhadra" panose="02000600000000000000" pitchFamily="2" charset="0"/>
+                <a:cs typeface="Ramabhadra" panose="02000600000000000000" pitchFamily="2" charset="0"/>
+              </a:rPr>
+              <a:t>నీవెకదా (3)</a:t>
             </a:r>
           </a:p>
         </p:txBody>
@@ -5672,58 +5823,84 @@
           <a:p>
             <a:pPr algn="ctr"/>
             <a:r>
-              <a:rPr lang="te-IN" sz="2000" dirty="0">
-                <a:solidFill>
-                  <a:schemeClr val="tx1"/>
-                </a:solidFill>
-                <a:latin typeface="Ramabhadra" panose="02000600000000000000" pitchFamily="2" charset="0"/>
-                <a:cs typeface="Ramabhadra" panose="02000600000000000000" pitchFamily="2" charset="0"/>
-              </a:rPr>
-              <a:t>ఎవరు నా చేయి విడచిన</a:t>
-            </a:r>
-          </a:p>
-          <a:p>
-            <a:pPr algn="ctr"/>
-            <a:r>
-              <a:rPr lang="te-IN" sz="2000" dirty="0">
-                <a:solidFill>
-                  <a:schemeClr val="tx1"/>
-                </a:solidFill>
-                <a:latin typeface="Ramabhadra" panose="02000600000000000000" pitchFamily="2" charset="0"/>
-                <a:cs typeface="Ramabhadra" panose="02000600000000000000" pitchFamily="2" charset="0"/>
-              </a:rPr>
-              <a:t>యేసు చేయి విడువడు (2)</a:t>
-            </a:r>
-          </a:p>
-          <a:p>
-            <a:pPr algn="ctr"/>
-            <a:r>
-              <a:rPr lang="te-IN" sz="2000" dirty="0">
-                <a:solidFill>
-                  <a:schemeClr val="tx1"/>
-                </a:solidFill>
-                <a:latin typeface="Ramabhadra" panose="02000600000000000000" pitchFamily="2" charset="0"/>
-                <a:cs typeface="Ramabhadra" panose="02000600000000000000" pitchFamily="2" charset="0"/>
-              </a:rPr>
-              <a:t>చేయి విడువడు (3)</a:t>
-            </a:r>
-          </a:p>
-          <a:p>
-            <a:pPr algn="ctr"/>
-            <a:r>
-              <a:rPr lang="te-IN" sz="2000" dirty="0">
-                <a:solidFill>
-                  <a:schemeClr val="tx1"/>
-                </a:solidFill>
-                <a:latin typeface="Ramabhadra" panose="02000600000000000000" pitchFamily="2" charset="0"/>
-                <a:cs typeface="Ramabhadra" panose="02000600000000000000" pitchFamily="2" charset="0"/>
-              </a:rPr>
-              <a:t>యేసు చేయి విడువడు</a:t>
-            </a:r>
-          </a:p>
-          <a:p>
-            <a:pPr algn="ctr"/>
-            <a:endParaRPr lang="te-IN" sz="2000" dirty="0">
+              <a:rPr lang="te-IN" dirty="0">
+                <a:solidFill>
+                  <a:schemeClr val="tx1"/>
+                </a:solidFill>
+                <a:latin typeface="Ramabhadra" panose="02000600000000000000" pitchFamily="2" charset="0"/>
+                <a:cs typeface="Ramabhadra" panose="02000600000000000000" pitchFamily="2" charset="0"/>
+              </a:rPr>
+              <a:t>నీతోనే ఉండుటయే</a:t>
+            </a:r>
+          </a:p>
+          <a:p>
+            <a:pPr algn="ctr"/>
+            <a:r>
+              <a:rPr lang="te-IN" dirty="0">
+                <a:solidFill>
+                  <a:schemeClr val="tx1"/>
+                </a:solidFill>
+                <a:latin typeface="Ramabhadra" panose="02000600000000000000" pitchFamily="2" charset="0"/>
+                <a:cs typeface="Ramabhadra" panose="02000600000000000000" pitchFamily="2" charset="0"/>
+              </a:rPr>
+              <a:t>నా జీవిత వాంచయ్యా</a:t>
+            </a:r>
+          </a:p>
+          <a:p>
+            <a:pPr algn="ctr"/>
+            <a:r>
+              <a:rPr lang="te-IN" dirty="0">
+                <a:solidFill>
+                  <a:schemeClr val="tx1"/>
+                </a:solidFill>
+                <a:latin typeface="Ramabhadra" panose="02000600000000000000" pitchFamily="2" charset="0"/>
+                <a:cs typeface="Ramabhadra" panose="02000600000000000000" pitchFamily="2" charset="0"/>
+              </a:rPr>
+              <a:t>నీ చిత్తం నెరవేర్చుటయే</a:t>
+            </a:r>
+          </a:p>
+          <a:p>
+            <a:pPr algn="ctr"/>
+            <a:r>
+              <a:rPr lang="te-IN" dirty="0">
+                <a:solidFill>
+                  <a:schemeClr val="tx1"/>
+                </a:solidFill>
+                <a:latin typeface="Ramabhadra" panose="02000600000000000000" pitchFamily="2" charset="0"/>
+                <a:cs typeface="Ramabhadra" panose="02000600000000000000" pitchFamily="2" charset="0"/>
+              </a:rPr>
+              <a:t>నా హృదయ తపనయ్యా (2)</a:t>
+            </a:r>
+          </a:p>
+          <a:p>
+            <a:pPr algn="ctr"/>
+            <a:r>
+              <a:rPr lang="te-IN" dirty="0">
+                <a:solidFill>
+                  <a:schemeClr val="tx1"/>
+                </a:solidFill>
+                <a:latin typeface="Ramabhadra" panose="02000600000000000000" pitchFamily="2" charset="0"/>
+                <a:cs typeface="Ramabhadra" panose="02000600000000000000" pitchFamily="2" charset="0"/>
+              </a:rPr>
+              <a:t>యేసయ్యా నిన్నే కదా</a:t>
+            </a:r>
+          </a:p>
+          <a:p>
+            <a:pPr algn="ctr"/>
+            <a:r>
+              <a:rPr lang="te-IN" dirty="0">
+                <a:solidFill>
+                  <a:schemeClr val="tx1"/>
+                </a:solidFill>
+                <a:latin typeface="Ramabhadra" panose="02000600000000000000" pitchFamily="2" charset="0"/>
+                <a:cs typeface="Ramabhadra" panose="02000600000000000000" pitchFamily="2" charset="0"/>
+              </a:rPr>
+              <a:t>నా ముందు నిలిపేను (2)</a:t>
+            </a:r>
+          </a:p>
+          <a:p>
+            <a:pPr algn="ctr"/>
+            <a:endParaRPr lang="te-IN" dirty="0">
               <a:solidFill>
                 <a:schemeClr val="tx1"/>
               </a:solidFill>
@@ -5734,45 +5911,16 @@
           <a:p>
             <a:pPr algn="ctr"/>
             <a:r>
-              <a:rPr lang="te-IN" sz="2000" dirty="0">
-                <a:solidFill>
-                  <a:schemeClr val="tx1"/>
-                </a:solidFill>
-                <a:latin typeface="Ramabhadra" panose="02000600000000000000" pitchFamily="2" charset="0"/>
-                <a:cs typeface="Ramabhadra" panose="02000600000000000000" pitchFamily="2" charset="0"/>
-              </a:rPr>
-              <a:t>తల్లి ఆయనే</a:t>
-            </a:r>
-          </a:p>
-          <a:p>
-            <a:pPr algn="ctr"/>
-            <a:r>
-              <a:rPr lang="te-IN" sz="2000" dirty="0">
-                <a:solidFill>
-                  <a:schemeClr val="tx1"/>
-                </a:solidFill>
-                <a:latin typeface="Ramabhadra" panose="02000600000000000000" pitchFamily="2" charset="0"/>
-                <a:cs typeface="Ramabhadra" panose="02000600000000000000" pitchFamily="2" charset="0"/>
-              </a:rPr>
-              <a:t>తండ్రి ఆయనే (2)</a:t>
-            </a:r>
-          </a:p>
-          <a:p>
-            <a:pPr algn="ctr"/>
-            <a:r>
-              <a:rPr lang="te-IN" sz="2000" dirty="0">
-                <a:solidFill>
-                  <a:schemeClr val="tx1"/>
-                </a:solidFill>
-                <a:latin typeface="Ramabhadra" panose="02000600000000000000" pitchFamily="2" charset="0"/>
-                <a:cs typeface="Ramabhadra" panose="02000600000000000000" pitchFamily="2" charset="0"/>
-              </a:rPr>
-              <a:t>లాలించును నన్ను పాలించును (2)</a:t>
-            </a:r>
-          </a:p>
-          <a:p>
-            <a:pPr algn="ctr"/>
-            <a:endParaRPr lang="te-IN" sz="2000" dirty="0">
+              <a:rPr lang="te-IN" dirty="0">
+                <a:solidFill>
+                  <a:schemeClr val="tx1"/>
+                </a:solidFill>
+                <a:latin typeface="Ramabhadra" panose="02000600000000000000" pitchFamily="2" charset="0"/>
+                <a:cs typeface="Ramabhadra" panose="02000600000000000000" pitchFamily="2" charset="0"/>
+              </a:rPr>
+              <a:t>కరుణయు కృపయు</a:t>
+            </a:r>
+            <a:endParaRPr lang="en-IN" dirty="0">
               <a:solidFill>
                 <a:schemeClr val="tx1"/>
               </a:solidFill>
@@ -5783,58 +5931,42 @@
           <a:p>
             <a:pPr algn="ctr"/>
             <a:r>
-              <a:rPr lang="te-IN" sz="2000" dirty="0">
-                <a:solidFill>
-                  <a:schemeClr val="tx1"/>
-                </a:solidFill>
-                <a:latin typeface="Ramabhadra" panose="02000600000000000000" pitchFamily="2" charset="0"/>
-                <a:cs typeface="Ramabhadra" panose="02000600000000000000" pitchFamily="2" charset="0"/>
-              </a:rPr>
-              <a:t>వేదన శ్రమలూ</a:t>
-            </a:r>
-          </a:p>
-          <a:p>
-            <a:pPr algn="ctr"/>
-            <a:r>
-              <a:rPr lang="te-IN" sz="2000" dirty="0">
-                <a:solidFill>
-                  <a:schemeClr val="tx1"/>
-                </a:solidFill>
-                <a:latin typeface="Ramabhadra" panose="02000600000000000000" pitchFamily="2" charset="0"/>
-                <a:cs typeface="Ramabhadra" panose="02000600000000000000" pitchFamily="2" charset="0"/>
-              </a:rPr>
-              <a:t>ఉన్నప్పుడల్లా (2)</a:t>
-            </a:r>
-          </a:p>
-          <a:p>
-            <a:pPr algn="ctr"/>
-            <a:r>
-              <a:rPr lang="te-IN" sz="2000" dirty="0">
-                <a:solidFill>
-                  <a:schemeClr val="tx1"/>
-                </a:solidFill>
-                <a:latin typeface="Ramabhadra" panose="02000600000000000000" pitchFamily="2" charset="0"/>
-                <a:cs typeface="Ramabhadra" panose="02000600000000000000" pitchFamily="2" charset="0"/>
-              </a:rPr>
-              <a:t>వేడుకొందునే</a:t>
-            </a:r>
-          </a:p>
-          <a:p>
-            <a:pPr algn="ctr"/>
-            <a:r>
-              <a:rPr lang="te-IN" sz="2000" dirty="0">
-                <a:solidFill>
-                  <a:schemeClr val="tx1"/>
-                </a:solidFill>
-                <a:latin typeface="Ramabhadra" panose="02000600000000000000" pitchFamily="2" charset="0"/>
-                <a:cs typeface="Ramabhadra" panose="02000600000000000000" pitchFamily="2" charset="0"/>
-              </a:rPr>
-              <a:t>కాపాడును (2)</a:t>
-            </a:r>
-          </a:p>
-          <a:p>
-            <a:pPr algn="ctr"/>
-            <a:endParaRPr lang="te-IN" sz="2000" dirty="0">
+              <a:rPr lang="te-IN" dirty="0">
+                <a:solidFill>
+                  <a:schemeClr val="tx1"/>
+                </a:solidFill>
+                <a:latin typeface="Ramabhadra" panose="02000600000000000000" pitchFamily="2" charset="0"/>
+                <a:cs typeface="Ramabhadra" panose="02000600000000000000" pitchFamily="2" charset="0"/>
+              </a:rPr>
+              <a:t>నిరంతర శాంతి</a:t>
+            </a:r>
+          </a:p>
+          <a:p>
+            <a:pPr algn="ctr"/>
+            <a:r>
+              <a:rPr lang="te-IN" dirty="0">
+                <a:solidFill>
+                  <a:schemeClr val="tx1"/>
+                </a:solidFill>
+                <a:latin typeface="Ramabhadra" panose="02000600000000000000" pitchFamily="2" charset="0"/>
+                <a:cs typeface="Ramabhadra" panose="02000600000000000000" pitchFamily="2" charset="0"/>
+              </a:rPr>
+              <a:t>వినయము ఉన్నవాడా(2)</a:t>
+            </a:r>
+          </a:p>
+          <a:p>
+            <a:pPr algn="ctr"/>
+            <a:r>
+              <a:rPr lang="te-IN" dirty="0">
+                <a:solidFill>
+                  <a:schemeClr val="tx1"/>
+                </a:solidFill>
+                <a:latin typeface="Ramabhadra" panose="02000600000000000000" pitchFamily="2" charset="0"/>
+                <a:cs typeface="Ramabhadra" panose="02000600000000000000" pitchFamily="2" charset="0"/>
+              </a:rPr>
+              <a:t>నా జీవితం..</a:t>
+            </a:r>
+            <a:endParaRPr lang="en-IN" dirty="0">
               <a:solidFill>
                 <a:schemeClr val="tx1"/>
               </a:solidFill>
@@ -5845,40 +5977,149 @@
           <a:p>
             <a:pPr algn="ctr"/>
             <a:r>
-              <a:rPr lang="te-IN" sz="2000" dirty="0">
-                <a:solidFill>
-                  <a:schemeClr val="tx1"/>
-                </a:solidFill>
-                <a:latin typeface="Ramabhadra" panose="02000600000000000000" pitchFamily="2" charset="0"/>
-                <a:cs typeface="Ramabhadra" panose="02000600000000000000" pitchFamily="2" charset="0"/>
-              </a:rPr>
-              <a:t>రక్తముతో కడిగి వేసాడే (2)</a:t>
-            </a:r>
-          </a:p>
-          <a:p>
-            <a:pPr algn="ctr"/>
-            <a:r>
-              <a:rPr lang="te-IN" sz="2000" dirty="0">
-                <a:solidFill>
-                  <a:schemeClr val="tx1"/>
-                </a:solidFill>
-                <a:latin typeface="Ramabhadra" panose="02000600000000000000" pitchFamily="2" charset="0"/>
-                <a:cs typeface="Ramabhadra" panose="02000600000000000000" pitchFamily="2" charset="0"/>
-              </a:rPr>
-              <a:t>రక్షణ సంతోషం</a:t>
-            </a:r>
-          </a:p>
-          <a:p>
-            <a:pPr algn="ctr"/>
-            <a:r>
-              <a:rPr lang="te-IN" sz="2000" dirty="0">
-                <a:solidFill>
-                  <a:schemeClr val="tx1"/>
-                </a:solidFill>
-                <a:latin typeface="Ramabhadra" panose="02000600000000000000" pitchFamily="2" charset="0"/>
-                <a:cs typeface="Ramabhadra" panose="02000600000000000000" pitchFamily="2" charset="0"/>
-              </a:rPr>
-              <a:t>నాకు ఇచ్చాడే (2)</a:t>
+              <a:rPr lang="te-IN" dirty="0">
+                <a:solidFill>
+                  <a:schemeClr val="tx1"/>
+                </a:solidFill>
+                <a:latin typeface="Ramabhadra" panose="02000600000000000000" pitchFamily="2" charset="0"/>
+                <a:cs typeface="Ramabhadra" panose="02000600000000000000" pitchFamily="2" charset="0"/>
+              </a:rPr>
+              <a:t>నశియింపక.. (2)</a:t>
+            </a:r>
+          </a:p>
+          <a:p>
+            <a:pPr algn="ctr"/>
+            <a:r>
+              <a:rPr lang="te-IN" dirty="0">
+                <a:solidFill>
+                  <a:schemeClr val="tx1"/>
+                </a:solidFill>
+                <a:latin typeface="Ramabhadra" panose="02000600000000000000" pitchFamily="2" charset="0"/>
+                <a:cs typeface="Ramabhadra" panose="02000600000000000000" pitchFamily="2" charset="0"/>
+              </a:rPr>
+              <a:t>కాపాడువాడా...</a:t>
+            </a:r>
+            <a:endParaRPr lang="en-IN" dirty="0">
+              <a:solidFill>
+                <a:schemeClr val="tx1"/>
+              </a:solidFill>
+              <a:latin typeface="Ramabhadra" panose="02000600000000000000" pitchFamily="2" charset="0"/>
+              <a:cs typeface="Ramabhadra" panose="02000600000000000000" pitchFamily="2" charset="0"/>
+            </a:endParaRPr>
+          </a:p>
+          <a:p>
+            <a:pPr algn="ctr"/>
+            <a:r>
+              <a:rPr lang="te-IN" dirty="0">
+                <a:solidFill>
+                  <a:schemeClr val="tx1"/>
+                </a:solidFill>
+                <a:latin typeface="Ramabhadra" panose="02000600000000000000" pitchFamily="2" charset="0"/>
+                <a:cs typeface="Ramabhadra" panose="02000600000000000000" pitchFamily="2" charset="0"/>
+              </a:rPr>
+              <a:t>నా కాపరి... (2)</a:t>
+            </a:r>
+          </a:p>
+          <a:p>
+            <a:pPr algn="ctr"/>
+            <a:endParaRPr lang="te-IN" dirty="0">
+              <a:solidFill>
+                <a:schemeClr val="tx1"/>
+              </a:solidFill>
+              <a:latin typeface="Ramabhadra" panose="02000600000000000000" pitchFamily="2" charset="0"/>
+              <a:cs typeface="Ramabhadra" panose="02000600000000000000" pitchFamily="2" charset="0"/>
+            </a:endParaRPr>
+          </a:p>
+          <a:p>
+            <a:pPr algn="ctr"/>
+            <a:r>
+              <a:rPr lang="te-IN" dirty="0">
+                <a:solidFill>
+                  <a:schemeClr val="tx1"/>
+                </a:solidFill>
+                <a:latin typeface="Ramabhadra" panose="02000600000000000000" pitchFamily="2" charset="0"/>
+                <a:cs typeface="Ramabhadra" panose="02000600000000000000" pitchFamily="2" charset="0"/>
+              </a:rPr>
+              <a:t>నా కొరకు </a:t>
+            </a:r>
+            <a:endParaRPr lang="en-IN" dirty="0">
+              <a:solidFill>
+                <a:schemeClr val="tx1"/>
+              </a:solidFill>
+              <a:latin typeface="Ramabhadra" panose="02000600000000000000" pitchFamily="2" charset="0"/>
+              <a:cs typeface="Ramabhadra" panose="02000600000000000000" pitchFamily="2" charset="0"/>
+            </a:endParaRPr>
+          </a:p>
+          <a:p>
+            <a:pPr algn="ctr"/>
+            <a:r>
+              <a:rPr lang="te-IN" dirty="0">
+                <a:solidFill>
+                  <a:schemeClr val="tx1"/>
+                </a:solidFill>
+                <a:latin typeface="Ramabhadra" panose="02000600000000000000" pitchFamily="2" charset="0"/>
+                <a:cs typeface="Ramabhadra" panose="02000600000000000000" pitchFamily="2" charset="0"/>
+              </a:rPr>
+              <a:t>అన్నియు చేయువాడా</a:t>
+            </a:r>
+          </a:p>
+          <a:p>
+            <a:pPr algn="ctr"/>
+            <a:r>
+              <a:rPr lang="te-IN" dirty="0">
+                <a:solidFill>
+                  <a:schemeClr val="tx1"/>
+                </a:solidFill>
+                <a:latin typeface="Ramabhadra" panose="02000600000000000000" pitchFamily="2" charset="0"/>
+                <a:cs typeface="Ramabhadra" panose="02000600000000000000" pitchFamily="2" charset="0"/>
+              </a:rPr>
+              <a:t>చేసి ముగించువాడా (2)</a:t>
+            </a:r>
+          </a:p>
+          <a:p>
+            <a:pPr algn="ctr"/>
+            <a:r>
+              <a:rPr lang="te-IN" dirty="0">
+                <a:solidFill>
+                  <a:schemeClr val="tx1"/>
+                </a:solidFill>
+                <a:latin typeface="Ramabhadra" panose="02000600000000000000" pitchFamily="2" charset="0"/>
+                <a:cs typeface="Ramabhadra" panose="02000600000000000000" pitchFamily="2" charset="0"/>
+              </a:rPr>
+              <a:t>నా బరువు.. నా బాధ్యత.. (2)</a:t>
+            </a:r>
+          </a:p>
+          <a:p>
+            <a:pPr algn="ctr"/>
+            <a:r>
+              <a:rPr lang="te-IN" dirty="0">
+                <a:solidFill>
+                  <a:schemeClr val="tx1"/>
+                </a:solidFill>
+                <a:latin typeface="Ramabhadra" panose="02000600000000000000" pitchFamily="2" charset="0"/>
+                <a:cs typeface="Ramabhadra" panose="02000600000000000000" pitchFamily="2" charset="0"/>
+              </a:rPr>
+              <a:t>నీ పాద చెంత...</a:t>
+            </a:r>
+            <a:endParaRPr lang="en-IN" dirty="0">
+              <a:solidFill>
+                <a:schemeClr val="tx1"/>
+              </a:solidFill>
+              <a:latin typeface="Ramabhadra" panose="02000600000000000000" pitchFamily="2" charset="0"/>
+              <a:cs typeface="Ramabhadra" panose="02000600000000000000" pitchFamily="2" charset="0"/>
+            </a:endParaRPr>
+          </a:p>
+          <a:p>
+            <a:pPr algn="ctr"/>
+            <a:r>
+              <a:rPr lang="te-IN" dirty="0">
+                <a:solidFill>
+                  <a:schemeClr val="tx1"/>
+                </a:solidFill>
+                <a:latin typeface="Ramabhadra" panose="02000600000000000000" pitchFamily="2" charset="0"/>
+                <a:cs typeface="Ramabhadra" panose="02000600000000000000" pitchFamily="2" charset="0"/>
+              </a:rPr>
+              <a:t>నుంచితివి... (2)</a:t>
             </a:r>
           </a:p>
         </p:txBody>

</xml_diff>

<commit_message>
04 sunday songs re-edited
</commit_message>
<xml_diff>
--- a/xerox.pptx
+++ b/xerox.pptx
@@ -5,14 +5,13 @@
     <p:sldMasterId id="2147483708" r:id="rId1"/>
   </p:sldMasterIdLst>
   <p:notesMasterIdLst>
-    <p:notesMasterId r:id="rId4"/>
+    <p:notesMasterId r:id="rId3"/>
   </p:notesMasterIdLst>
   <p:handoutMasterIdLst>
-    <p:handoutMasterId r:id="rId5"/>
+    <p:handoutMasterId r:id="rId4"/>
   </p:handoutMasterIdLst>
   <p:sldIdLst>
-    <p:sldId id="282" r:id="rId2"/>
-    <p:sldId id="283" r:id="rId3"/>
+    <p:sldId id="283" r:id="rId2"/>
   </p:sldIdLst>
   <p:sldSz cx="9906000" cy="6858000" type="A4"/>
   <p:notesSz cx="6797675" cy="9872663"/>
@@ -116,7 +115,6 @@
       <p14:sectionLst xmlns:p14="http://schemas.microsoft.com/office/powerpoint/2010/main">
         <p14:section name="Untitled Section" id="{A9D60E13-7795-4B21-B9EC-5BF21E65AAC1}">
           <p14:sldIdLst>
-            <p14:sldId id="282"/>
             <p14:sldId id="283"/>
           </p14:sldIdLst>
         </p14:section>
@@ -226,7 +224,7 @@
           <a:p>
             <a:fld id="{3502DD63-DF8D-4AB8-92A0-0ECCF612C06C}" type="datetimeFigureOut">
               <a:rPr lang="en-IN" smtClean="0"/>
-              <a:t>27-07-2024</a:t>
+              <a:t>03-08-2024</a:t>
             </a:fld>
             <a:endParaRPr lang="en-IN"/>
           </a:p>
@@ -404,7 +402,7 @@
           <a:p>
             <a:fld id="{1AE741EC-1360-4793-999B-941E0396C9FA}" type="datetimeFigureOut">
               <a:rPr lang="en-IN" smtClean="0"/>
-              <a:t>27-07-2024</a:t>
+              <a:t>03-08-2024</a:t>
             </a:fld>
             <a:endParaRPr lang="en-IN"/>
           </a:p>
@@ -804,7 +802,7 @@
           <a:p>
             <a:fld id="{86FBD32F-FCAD-481A-B7D8-4D813FB7DB24}" type="datetimeFigureOut">
               <a:rPr lang="en-IN" smtClean="0"/>
-              <a:t>27-07-2024</a:t>
+              <a:t>03-08-2024</a:t>
             </a:fld>
             <a:endParaRPr lang="en-IN"/>
           </a:p>
@@ -974,7 +972,7 @@
           <a:p>
             <a:fld id="{86FBD32F-FCAD-481A-B7D8-4D813FB7DB24}" type="datetimeFigureOut">
               <a:rPr lang="en-IN" smtClean="0"/>
-              <a:t>27-07-2024</a:t>
+              <a:t>03-08-2024</a:t>
             </a:fld>
             <a:endParaRPr lang="en-IN"/>
           </a:p>
@@ -1154,7 +1152,7 @@
           <a:p>
             <a:fld id="{86FBD32F-FCAD-481A-B7D8-4D813FB7DB24}" type="datetimeFigureOut">
               <a:rPr lang="en-IN" smtClean="0"/>
-              <a:t>27-07-2024</a:t>
+              <a:t>03-08-2024</a:t>
             </a:fld>
             <a:endParaRPr lang="en-IN"/>
           </a:p>
@@ -1324,7 +1322,7 @@
           <a:p>
             <a:fld id="{86FBD32F-FCAD-481A-B7D8-4D813FB7DB24}" type="datetimeFigureOut">
               <a:rPr lang="en-IN" smtClean="0"/>
-              <a:t>27-07-2024</a:t>
+              <a:t>03-08-2024</a:t>
             </a:fld>
             <a:endParaRPr lang="en-IN"/>
           </a:p>
@@ -1568,7 +1566,7 @@
           <a:p>
             <a:fld id="{86FBD32F-FCAD-481A-B7D8-4D813FB7DB24}" type="datetimeFigureOut">
               <a:rPr lang="en-IN" smtClean="0"/>
-              <a:t>27-07-2024</a:t>
+              <a:t>03-08-2024</a:t>
             </a:fld>
             <a:endParaRPr lang="en-IN"/>
           </a:p>
@@ -1800,7 +1798,7 @@
           <a:p>
             <a:fld id="{86FBD32F-FCAD-481A-B7D8-4D813FB7DB24}" type="datetimeFigureOut">
               <a:rPr lang="en-IN" smtClean="0"/>
-              <a:t>27-07-2024</a:t>
+              <a:t>03-08-2024</a:t>
             </a:fld>
             <a:endParaRPr lang="en-IN"/>
           </a:p>
@@ -2167,7 +2165,7 @@
           <a:p>
             <a:fld id="{86FBD32F-FCAD-481A-B7D8-4D813FB7DB24}" type="datetimeFigureOut">
               <a:rPr lang="en-IN" smtClean="0"/>
-              <a:t>27-07-2024</a:t>
+              <a:t>03-08-2024</a:t>
             </a:fld>
             <a:endParaRPr lang="en-IN"/>
           </a:p>
@@ -2285,7 +2283,7 @@
           <a:p>
             <a:fld id="{86FBD32F-FCAD-481A-B7D8-4D813FB7DB24}" type="datetimeFigureOut">
               <a:rPr lang="en-IN" smtClean="0"/>
-              <a:t>27-07-2024</a:t>
+              <a:t>03-08-2024</a:t>
             </a:fld>
             <a:endParaRPr lang="en-IN"/>
           </a:p>
@@ -2380,7 +2378,7 @@
           <a:p>
             <a:fld id="{86FBD32F-FCAD-481A-B7D8-4D813FB7DB24}" type="datetimeFigureOut">
               <a:rPr lang="en-IN" smtClean="0"/>
-              <a:t>27-07-2024</a:t>
+              <a:t>03-08-2024</a:t>
             </a:fld>
             <a:endParaRPr lang="en-IN"/>
           </a:p>
@@ -2657,7 +2655,7 @@
           <a:p>
             <a:fld id="{86FBD32F-FCAD-481A-B7D8-4D813FB7DB24}" type="datetimeFigureOut">
               <a:rPr lang="en-IN" smtClean="0"/>
-              <a:t>27-07-2024</a:t>
+              <a:t>03-08-2024</a:t>
             </a:fld>
             <a:endParaRPr lang="en-IN"/>
           </a:p>
@@ -2914,7 +2912,7 @@
           <a:p>
             <a:fld id="{86FBD32F-FCAD-481A-B7D8-4D813FB7DB24}" type="datetimeFigureOut">
               <a:rPr lang="en-IN" smtClean="0"/>
-              <a:t>27-07-2024</a:t>
+              <a:t>03-08-2024</a:t>
             </a:fld>
             <a:endParaRPr lang="en-IN"/>
           </a:p>
@@ -3127,7 +3125,7 @@
           <a:p>
             <a:fld id="{86FBD32F-FCAD-481A-B7D8-4D813FB7DB24}" type="datetimeFigureOut">
               <a:rPr lang="en-IN" smtClean="0"/>
-              <a:t>27-07-2024</a:t>
+              <a:t>03-08-2024</a:t>
             </a:fld>
             <a:endParaRPr lang="en-IN"/>
           </a:p>
@@ -3546,1162 +3544,6 @@
         </p:nvSpPr>
         <p:spPr>
           <a:xfrm>
-            <a:off x="3334022" y="1115306"/>
-            <a:ext cx="1618978" cy="2277813"/>
-          </a:xfrm>
-          <a:prstGeom prst="rect">
-            <a:avLst/>
-          </a:prstGeom>
-          <a:solidFill>
-            <a:schemeClr val="bg1"/>
-          </a:solidFill>
-          <a:ln>
-            <a:solidFill>
-              <a:schemeClr val="bg1">
-                <a:lumMod val="85000"/>
-              </a:schemeClr>
-            </a:solidFill>
-          </a:ln>
-        </p:spPr>
-        <p:style>
-          <a:lnRef idx="2">
-            <a:schemeClr val="accent1">
-              <a:shade val="50000"/>
-            </a:schemeClr>
-          </a:lnRef>
-          <a:fillRef idx="1">
-            <a:schemeClr val="accent1"/>
-          </a:fillRef>
-          <a:effectRef idx="0">
-            <a:schemeClr val="accent1"/>
-          </a:effectRef>
-          <a:fontRef idx="minor">
-            <a:schemeClr val="lt1"/>
-          </a:fontRef>
-        </p:style>
-        <p:txBody>
-          <a:bodyPr rtlCol="0" anchor="ctr"/>
-          <a:lstStyle/>
-          <a:p>
-            <a:pPr algn="ctr"/>
-            <a:r>
-              <a:rPr lang="te-IN" sz="839" dirty="0">
-                <a:solidFill>
-                  <a:schemeClr val="tx1"/>
-                </a:solidFill>
-                <a:latin typeface="Ramabhadra" panose="02000600000000000000" pitchFamily="2" charset="0"/>
-                <a:cs typeface="Ramabhadra" panose="02000600000000000000" pitchFamily="2" charset="0"/>
-              </a:rPr>
-              <a:t>స్తుతి గానములతో నేను –</a:t>
-            </a:r>
-            <a:endParaRPr lang="en-IN" sz="839" dirty="0">
-              <a:solidFill>
-                <a:schemeClr val="tx1"/>
-              </a:solidFill>
-              <a:latin typeface="Ramabhadra" panose="02000600000000000000" pitchFamily="2" charset="0"/>
-              <a:cs typeface="Ramabhadra" panose="02000600000000000000" pitchFamily="2" charset="0"/>
-            </a:endParaRPr>
-          </a:p>
-          <a:p>
-            <a:pPr algn="ctr"/>
-            <a:r>
-              <a:rPr lang="te-IN" sz="839" dirty="0">
-                <a:solidFill>
-                  <a:schemeClr val="tx1"/>
-                </a:solidFill>
-                <a:latin typeface="Ramabhadra" panose="02000600000000000000" pitchFamily="2" charset="0"/>
-                <a:cs typeface="Ramabhadra" panose="02000600000000000000" pitchFamily="2" charset="0"/>
-              </a:rPr>
-              <a:t>నా దేవునీ స్తుతించెదనూ</a:t>
-            </a:r>
-          </a:p>
-          <a:p>
-            <a:pPr algn="ctr"/>
-            <a:r>
-              <a:rPr lang="te-IN" sz="839" dirty="0">
-                <a:solidFill>
-                  <a:schemeClr val="tx1"/>
-                </a:solidFill>
-                <a:latin typeface="Ramabhadra" panose="02000600000000000000" pitchFamily="2" charset="0"/>
-                <a:cs typeface="Ramabhadra" panose="02000600000000000000" pitchFamily="2" charset="0"/>
-              </a:rPr>
-              <a:t>నీ జీవితమంతా ప్రభు కొరకై</a:t>
-            </a:r>
-            <a:r>
-              <a:rPr lang="en-IN" sz="839" dirty="0">
-                <a:solidFill>
-                  <a:schemeClr val="tx1"/>
-                </a:solidFill>
-                <a:latin typeface="Ramabhadra" panose="02000600000000000000" pitchFamily="2" charset="0"/>
-                <a:cs typeface="Ramabhadra" panose="02000600000000000000" pitchFamily="2" charset="0"/>
-              </a:rPr>
-              <a:t> </a:t>
-            </a:r>
-            <a:r>
-              <a:rPr lang="te-IN" sz="839" dirty="0">
-                <a:solidFill>
-                  <a:schemeClr val="tx1"/>
-                </a:solidFill>
-                <a:latin typeface="Ramabhadra" panose="02000600000000000000" pitchFamily="2" charset="0"/>
-                <a:cs typeface="Ramabhadra" panose="02000600000000000000" pitchFamily="2" charset="0"/>
-              </a:rPr>
-              <a:t>-</a:t>
-            </a:r>
-            <a:endParaRPr lang="en-IN" sz="839" dirty="0">
-              <a:solidFill>
-                <a:schemeClr val="tx1"/>
-              </a:solidFill>
-              <a:latin typeface="Ramabhadra" panose="02000600000000000000" pitchFamily="2" charset="0"/>
-              <a:cs typeface="Ramabhadra" panose="02000600000000000000" pitchFamily="2" charset="0"/>
-            </a:endParaRPr>
-          </a:p>
-          <a:p>
-            <a:pPr algn="ctr"/>
-            <a:r>
-              <a:rPr lang="te-IN" sz="839" dirty="0">
-                <a:solidFill>
-                  <a:schemeClr val="tx1"/>
-                </a:solidFill>
-                <a:latin typeface="Ramabhadra" panose="02000600000000000000" pitchFamily="2" charset="0"/>
-                <a:cs typeface="Ramabhadra" panose="02000600000000000000" pitchFamily="2" charset="0"/>
-              </a:rPr>
-              <a:t>నేయిల జీవించెదనూ</a:t>
-            </a:r>
-          </a:p>
-          <a:p>
-            <a:pPr algn="ctr"/>
-            <a:r>
-              <a:rPr lang="te-IN" sz="839" dirty="0">
-                <a:solidFill>
-                  <a:schemeClr val="tx1"/>
-                </a:solidFill>
-                <a:latin typeface="Ramabhadra" panose="02000600000000000000" pitchFamily="2" charset="0"/>
-                <a:cs typeface="Ramabhadra" panose="02000600000000000000" pitchFamily="2" charset="0"/>
-              </a:rPr>
-              <a:t>ప్రభూ కొరకై నిలచెదనూ</a:t>
-            </a:r>
-          </a:p>
-          <a:p>
-            <a:pPr algn="ctr"/>
-            <a:endParaRPr lang="te-IN" sz="839" dirty="0">
-              <a:solidFill>
-                <a:schemeClr val="tx1"/>
-              </a:solidFill>
-              <a:latin typeface="Ramabhadra" panose="02000600000000000000" pitchFamily="2" charset="0"/>
-              <a:cs typeface="Ramabhadra" panose="02000600000000000000" pitchFamily="2" charset="0"/>
-            </a:endParaRPr>
-          </a:p>
-          <a:p>
-            <a:pPr algn="ctr"/>
-            <a:r>
-              <a:rPr lang="te-IN" sz="839" dirty="0">
-                <a:solidFill>
-                  <a:schemeClr val="tx1"/>
-                </a:solidFill>
-                <a:latin typeface="Ramabhadra" panose="02000600000000000000" pitchFamily="2" charset="0"/>
-                <a:cs typeface="Ramabhadra" panose="02000600000000000000" pitchFamily="2" charset="0"/>
-              </a:rPr>
-              <a:t>అది అంతము నీవే .... ఆధార భూతుడ నీవే</a:t>
-            </a:r>
-          </a:p>
-          <a:p>
-            <a:pPr algn="ctr"/>
-            <a:r>
-              <a:rPr lang="te-IN" sz="839" dirty="0">
-                <a:solidFill>
-                  <a:schemeClr val="tx1"/>
-                </a:solidFill>
-                <a:latin typeface="Ramabhadra" panose="02000600000000000000" pitchFamily="2" charset="0"/>
-                <a:cs typeface="Ramabhadra" panose="02000600000000000000" pitchFamily="2" charset="0"/>
-              </a:rPr>
-              <a:t>ప్రతి జీవిని ప్రేమించి పోషించు ప్రాణదాత నీవే</a:t>
-            </a:r>
-          </a:p>
-          <a:p>
-            <a:pPr algn="ctr"/>
-            <a:r>
-              <a:rPr lang="te-IN" sz="839" dirty="0">
-                <a:solidFill>
-                  <a:schemeClr val="tx1"/>
-                </a:solidFill>
-                <a:latin typeface="Ramabhadra" panose="02000600000000000000" pitchFamily="2" charset="0"/>
-                <a:cs typeface="Ramabhadra" panose="02000600000000000000" pitchFamily="2" charset="0"/>
-              </a:rPr>
-              <a:t>నీ ప్రేమలో ... నీ నీడలో</a:t>
-            </a:r>
-            <a:r>
-              <a:rPr lang="en-IN" sz="839" dirty="0">
-                <a:solidFill>
-                  <a:schemeClr val="tx1"/>
-                </a:solidFill>
-                <a:latin typeface="Ramabhadra" panose="02000600000000000000" pitchFamily="2" charset="0"/>
-                <a:cs typeface="Ramabhadra" panose="02000600000000000000" pitchFamily="2" charset="0"/>
-              </a:rPr>
-              <a:t> </a:t>
-            </a:r>
-            <a:r>
-              <a:rPr lang="te-IN" sz="839" dirty="0">
-                <a:solidFill>
-                  <a:schemeClr val="tx1"/>
-                </a:solidFill>
-                <a:latin typeface="Ramabhadra" panose="02000600000000000000" pitchFamily="2" charset="0"/>
-                <a:cs typeface="Ramabhadra" panose="02000600000000000000" pitchFamily="2" charset="0"/>
-              </a:rPr>
-              <a:t>నిలుపుము</a:t>
-            </a:r>
-            <a:endParaRPr lang="en-IN" sz="839" dirty="0">
-              <a:solidFill>
-                <a:schemeClr val="tx1"/>
-              </a:solidFill>
-              <a:latin typeface="Ramabhadra" panose="02000600000000000000" pitchFamily="2" charset="0"/>
-              <a:cs typeface="Ramabhadra" panose="02000600000000000000" pitchFamily="2" charset="0"/>
-            </a:endParaRPr>
-          </a:p>
-          <a:p>
-            <a:pPr algn="ctr"/>
-            <a:r>
-              <a:rPr lang="te-IN" sz="839" dirty="0">
-                <a:solidFill>
-                  <a:schemeClr val="tx1"/>
-                </a:solidFill>
-                <a:latin typeface="Ramabhadra" panose="02000600000000000000" pitchFamily="2" charset="0"/>
-                <a:cs typeface="Ramabhadra" panose="02000600000000000000" pitchFamily="2" charset="0"/>
-              </a:rPr>
-              <a:t>నీకే స్తోత్రము</a:t>
-            </a:r>
-          </a:p>
-          <a:p>
-            <a:pPr algn="ctr"/>
-            <a:endParaRPr lang="te-IN" sz="839" dirty="0">
-              <a:solidFill>
-                <a:schemeClr val="tx1"/>
-              </a:solidFill>
-              <a:latin typeface="Ramabhadra" panose="02000600000000000000" pitchFamily="2" charset="0"/>
-              <a:cs typeface="Ramabhadra" panose="02000600000000000000" pitchFamily="2" charset="0"/>
-            </a:endParaRPr>
-          </a:p>
-          <a:p>
-            <a:pPr algn="ctr"/>
-            <a:r>
-              <a:rPr lang="te-IN" sz="839" dirty="0">
-                <a:solidFill>
-                  <a:schemeClr val="tx1"/>
-                </a:solidFill>
-                <a:latin typeface="Ramabhadra" panose="02000600000000000000" pitchFamily="2" charset="0"/>
-                <a:cs typeface="Ramabhadra" panose="02000600000000000000" pitchFamily="2" charset="0"/>
-              </a:rPr>
-              <a:t>లోకమంత నీరాకకై</a:t>
-            </a:r>
-            <a:endParaRPr lang="en-IN" sz="839" dirty="0">
-              <a:solidFill>
-                <a:schemeClr val="tx1"/>
-              </a:solidFill>
-              <a:latin typeface="Ramabhadra" panose="02000600000000000000" pitchFamily="2" charset="0"/>
-              <a:cs typeface="Ramabhadra" panose="02000600000000000000" pitchFamily="2" charset="0"/>
-            </a:endParaRPr>
-          </a:p>
-          <a:p>
-            <a:pPr algn="ctr"/>
-            <a:r>
-              <a:rPr lang="te-IN" sz="839" dirty="0">
-                <a:solidFill>
-                  <a:schemeClr val="tx1"/>
-                </a:solidFill>
-                <a:latin typeface="Ramabhadra" panose="02000600000000000000" pitchFamily="2" charset="0"/>
-                <a:cs typeface="Ramabhadra" panose="02000600000000000000" pitchFamily="2" charset="0"/>
-              </a:rPr>
-              <a:t>వేచి యుండెను నా ప్రభూ</a:t>
-            </a:r>
-          </a:p>
-          <a:p>
-            <a:pPr algn="ctr"/>
-            <a:r>
-              <a:rPr lang="te-IN" sz="839" dirty="0">
-                <a:solidFill>
-                  <a:schemeClr val="tx1"/>
-                </a:solidFill>
-                <a:latin typeface="Ramabhadra" panose="02000600000000000000" pitchFamily="2" charset="0"/>
-                <a:cs typeface="Ramabhadra" panose="02000600000000000000" pitchFamily="2" charset="0"/>
-              </a:rPr>
-              <a:t>మేఘ వాహనంబు మీద</a:t>
-            </a:r>
-            <a:endParaRPr lang="en-IN" sz="839" dirty="0">
-              <a:solidFill>
-                <a:schemeClr val="tx1"/>
-              </a:solidFill>
-              <a:latin typeface="Ramabhadra" panose="02000600000000000000" pitchFamily="2" charset="0"/>
-              <a:cs typeface="Ramabhadra" panose="02000600000000000000" pitchFamily="2" charset="0"/>
-            </a:endParaRPr>
-          </a:p>
-          <a:p>
-            <a:pPr algn="ctr"/>
-            <a:r>
-              <a:rPr lang="te-IN" sz="839" dirty="0">
-                <a:solidFill>
-                  <a:schemeClr val="tx1"/>
-                </a:solidFill>
-                <a:latin typeface="Ramabhadra" panose="02000600000000000000" pitchFamily="2" charset="0"/>
-                <a:cs typeface="Ramabhadra" panose="02000600000000000000" pitchFamily="2" charset="0"/>
-              </a:rPr>
-              <a:t>మేటి దూత గణముల తోడా</a:t>
-            </a:r>
-          </a:p>
-          <a:p>
-            <a:pPr algn="ctr"/>
-            <a:r>
-              <a:rPr lang="te-IN" sz="839" dirty="0">
-                <a:solidFill>
-                  <a:schemeClr val="tx1"/>
-                </a:solidFill>
-                <a:latin typeface="Ramabhadra" panose="02000600000000000000" pitchFamily="2" charset="0"/>
-                <a:cs typeface="Ramabhadra" panose="02000600000000000000" pitchFamily="2" charset="0"/>
-              </a:rPr>
-              <a:t>వేవేగమే రానైయున్న రారాజా-</a:t>
-            </a:r>
-            <a:endParaRPr lang="en-IN" sz="839" dirty="0">
-              <a:solidFill>
-                <a:schemeClr val="tx1"/>
-              </a:solidFill>
-              <a:latin typeface="Ramabhadra" panose="02000600000000000000" pitchFamily="2" charset="0"/>
-              <a:cs typeface="Ramabhadra" panose="02000600000000000000" pitchFamily="2" charset="0"/>
-            </a:endParaRPr>
-          </a:p>
-          <a:p>
-            <a:pPr algn="ctr"/>
-            <a:r>
-              <a:rPr lang="te-IN" sz="839" dirty="0">
-                <a:solidFill>
-                  <a:schemeClr val="tx1"/>
-                </a:solidFill>
-                <a:latin typeface="Ramabhadra" panose="02000600000000000000" pitchFamily="2" charset="0"/>
-                <a:cs typeface="Ramabhadra" panose="02000600000000000000" pitchFamily="2" charset="0"/>
-              </a:rPr>
-              <a:t>నీకై స్తోత్రము</a:t>
-            </a:r>
-          </a:p>
-        </p:txBody>
-      </p:sp>
-      <p:sp>
-        <p:nvSpPr>
-          <p:cNvPr id="3" name="Rectangle 2">
-            <a:extLst>
-              <a:ext uri="{FF2B5EF4-FFF2-40B4-BE49-F238E27FC236}">
-                <a16:creationId xmlns:a16="http://schemas.microsoft.com/office/drawing/2014/main" id="{1A91DD97-2F45-459B-B58B-E67033410700}"/>
-              </a:ext>
-            </a:extLst>
-          </p:cNvPr>
-          <p:cNvSpPr/>
-          <p:nvPr/>
-        </p:nvSpPr>
-        <p:spPr>
-          <a:xfrm>
-            <a:off x="3334022" y="3391380"/>
-            <a:ext cx="1618978" cy="2277813"/>
-          </a:xfrm>
-          <a:prstGeom prst="rect">
-            <a:avLst/>
-          </a:prstGeom>
-          <a:solidFill>
-            <a:schemeClr val="bg1"/>
-          </a:solidFill>
-          <a:ln>
-            <a:solidFill>
-              <a:schemeClr val="bg1">
-                <a:lumMod val="85000"/>
-              </a:schemeClr>
-            </a:solidFill>
-          </a:ln>
-        </p:spPr>
-        <p:style>
-          <a:lnRef idx="2">
-            <a:schemeClr val="accent1">
-              <a:shade val="50000"/>
-            </a:schemeClr>
-          </a:lnRef>
-          <a:fillRef idx="1">
-            <a:schemeClr val="accent1"/>
-          </a:fillRef>
-          <a:effectRef idx="0">
-            <a:schemeClr val="accent1"/>
-          </a:effectRef>
-          <a:fontRef idx="minor">
-            <a:schemeClr val="lt1"/>
-          </a:fontRef>
-        </p:style>
-        <p:txBody>
-          <a:bodyPr rtlCol="0" anchor="ctr"/>
-          <a:lstStyle/>
-          <a:p>
-            <a:pPr algn="ctr"/>
-            <a:r>
-              <a:rPr lang="te-IN" sz="863" dirty="0">
-                <a:solidFill>
-                  <a:srgbClr val="000000"/>
-                </a:solidFill>
-                <a:latin typeface="Ramabhadra" panose="02000600000000000000" pitchFamily="2" charset="0"/>
-                <a:cs typeface="Ramabhadra" panose="02000600000000000000" pitchFamily="2" charset="0"/>
-              </a:rPr>
-              <a:t>నేనున్న స్థితిలోనే సంతృప్తిని కలిగించు </a:t>
-            </a:r>
-          </a:p>
-          <a:p>
-            <a:pPr algn="ctr"/>
-            <a:r>
-              <a:rPr lang="te-IN" sz="863" dirty="0">
-                <a:solidFill>
-                  <a:srgbClr val="000000"/>
-                </a:solidFill>
-                <a:latin typeface="Ramabhadra" panose="02000600000000000000" pitchFamily="2" charset="0"/>
-                <a:cs typeface="Ramabhadra" panose="02000600000000000000" pitchFamily="2" charset="0"/>
-              </a:rPr>
-              <a:t>ఏమున్న లేకున్న నీకొరకే బ్రతికించు (2)</a:t>
-            </a:r>
-          </a:p>
-          <a:p>
-            <a:pPr algn="ctr"/>
-            <a:r>
-              <a:rPr lang="te-IN" sz="863" dirty="0">
-                <a:solidFill>
-                  <a:srgbClr val="000000"/>
-                </a:solidFill>
-                <a:latin typeface="Ramabhadra" panose="02000600000000000000" pitchFamily="2" charset="0"/>
-                <a:cs typeface="Ramabhadra" panose="02000600000000000000" pitchFamily="2" charset="0"/>
-              </a:rPr>
-              <a:t>కష్టాలు ఎదురైనా నా యాత్రను సాగించు </a:t>
-            </a:r>
-          </a:p>
-          <a:p>
-            <a:pPr algn="ctr"/>
-            <a:r>
-              <a:rPr lang="te-IN" sz="863" dirty="0">
-                <a:solidFill>
-                  <a:srgbClr val="000000"/>
-                </a:solidFill>
-                <a:latin typeface="Ramabhadra" panose="02000600000000000000" pitchFamily="2" charset="0"/>
-                <a:cs typeface="Ramabhadra" panose="02000600000000000000" pitchFamily="2" charset="0"/>
-              </a:rPr>
-              <a:t>నష్టాలలోనైనా స్తుతిచేయుట నేర్పించు (2)</a:t>
-            </a:r>
-          </a:p>
-          <a:p>
-            <a:pPr algn="ctr"/>
-            <a:endParaRPr lang="te-IN" sz="863" dirty="0">
-              <a:solidFill>
-                <a:srgbClr val="000000"/>
-              </a:solidFill>
-              <a:latin typeface="Ramabhadra" panose="02000600000000000000" pitchFamily="2" charset="0"/>
-              <a:cs typeface="Ramabhadra" panose="02000600000000000000" pitchFamily="2" charset="0"/>
-            </a:endParaRPr>
-          </a:p>
-          <a:p>
-            <a:pPr algn="ctr"/>
-            <a:r>
-              <a:rPr lang="te-IN" sz="863" dirty="0">
-                <a:solidFill>
-                  <a:srgbClr val="000000"/>
-                </a:solidFill>
-                <a:latin typeface="Ramabhadra" panose="02000600000000000000" pitchFamily="2" charset="0"/>
-                <a:cs typeface="Ramabhadra" panose="02000600000000000000" pitchFamily="2" charset="0"/>
-              </a:rPr>
-              <a:t>లోకములో నీ కొరకు</a:t>
-            </a:r>
-            <a:endParaRPr lang="en-US" sz="863" dirty="0">
-              <a:solidFill>
-                <a:srgbClr val="000000"/>
-              </a:solidFill>
-              <a:latin typeface="Ramabhadra" panose="02000600000000000000" pitchFamily="2" charset="0"/>
-              <a:cs typeface="Ramabhadra" panose="02000600000000000000" pitchFamily="2" charset="0"/>
-            </a:endParaRPr>
-          </a:p>
-          <a:p>
-            <a:pPr algn="ctr"/>
-            <a:r>
-              <a:rPr lang="te-IN" sz="863" dirty="0">
-                <a:solidFill>
-                  <a:srgbClr val="000000"/>
-                </a:solidFill>
-                <a:latin typeface="Ramabhadra" panose="02000600000000000000" pitchFamily="2" charset="0"/>
-                <a:cs typeface="Ramabhadra" panose="02000600000000000000" pitchFamily="2" charset="0"/>
-              </a:rPr>
-              <a:t>జ్యోతిగ నను వెలిగించు (2)</a:t>
-            </a:r>
-          </a:p>
-          <a:p>
-            <a:pPr algn="ctr"/>
-            <a:r>
-              <a:rPr lang="te-IN" sz="863" dirty="0">
-                <a:solidFill>
-                  <a:srgbClr val="000000"/>
-                </a:solidFill>
-                <a:latin typeface="Ramabhadra" panose="02000600000000000000" pitchFamily="2" charset="0"/>
-                <a:cs typeface="Ramabhadra" panose="02000600000000000000" pitchFamily="2" charset="0"/>
-              </a:rPr>
-              <a:t>రెండవ రాకడవరకు</a:t>
-            </a:r>
-            <a:endParaRPr lang="en-US" sz="863" dirty="0">
-              <a:solidFill>
-                <a:srgbClr val="000000"/>
-              </a:solidFill>
-              <a:latin typeface="Ramabhadra" panose="02000600000000000000" pitchFamily="2" charset="0"/>
-              <a:cs typeface="Ramabhadra" panose="02000600000000000000" pitchFamily="2" charset="0"/>
-            </a:endParaRPr>
-          </a:p>
-          <a:p>
-            <a:pPr algn="ctr"/>
-            <a:r>
-              <a:rPr lang="te-IN" sz="863" dirty="0">
-                <a:solidFill>
-                  <a:srgbClr val="000000"/>
-                </a:solidFill>
-                <a:latin typeface="Ramabhadra" panose="02000600000000000000" pitchFamily="2" charset="0"/>
-                <a:cs typeface="Ramabhadra" panose="02000600000000000000" pitchFamily="2" charset="0"/>
-              </a:rPr>
-              <a:t>విడువక నను నడిపించు (2)</a:t>
-            </a:r>
-          </a:p>
-          <a:p>
-            <a:pPr algn="ctr"/>
-            <a:endParaRPr lang="te-IN" sz="863" dirty="0">
-              <a:solidFill>
-                <a:srgbClr val="000000"/>
-              </a:solidFill>
-              <a:latin typeface="Ramabhadra" panose="02000600000000000000" pitchFamily="2" charset="0"/>
-              <a:cs typeface="Ramabhadra" panose="02000600000000000000" pitchFamily="2" charset="0"/>
-            </a:endParaRPr>
-          </a:p>
-          <a:p>
-            <a:pPr algn="ctr"/>
-            <a:r>
-              <a:rPr lang="te-IN" sz="863" dirty="0">
-                <a:solidFill>
-                  <a:srgbClr val="000000"/>
-                </a:solidFill>
-                <a:latin typeface="Ramabhadra" panose="02000600000000000000" pitchFamily="2" charset="0"/>
-                <a:cs typeface="Ramabhadra" panose="02000600000000000000" pitchFamily="2" charset="0"/>
-              </a:rPr>
-              <a:t>నా దినముల పరిమాణం</a:t>
-            </a:r>
-            <a:endParaRPr lang="en-US" sz="863" dirty="0">
-              <a:solidFill>
-                <a:srgbClr val="000000"/>
-              </a:solidFill>
-              <a:latin typeface="Ramabhadra" panose="02000600000000000000" pitchFamily="2" charset="0"/>
-              <a:cs typeface="Ramabhadra" panose="02000600000000000000" pitchFamily="2" charset="0"/>
-            </a:endParaRPr>
-          </a:p>
-          <a:p>
-            <a:pPr algn="ctr"/>
-            <a:r>
-              <a:rPr lang="te-IN" sz="863" dirty="0">
-                <a:solidFill>
-                  <a:srgbClr val="000000"/>
-                </a:solidFill>
-                <a:latin typeface="Ramabhadra" panose="02000600000000000000" pitchFamily="2" charset="0"/>
-                <a:cs typeface="Ramabhadra" panose="02000600000000000000" pitchFamily="2" charset="0"/>
-              </a:rPr>
-              <a:t>లెక్కించుట నేర్పించు (2)</a:t>
-            </a:r>
-          </a:p>
-          <a:p>
-            <a:pPr algn="ctr"/>
-            <a:r>
-              <a:rPr lang="te-IN" sz="863" dirty="0">
-                <a:solidFill>
-                  <a:srgbClr val="000000"/>
-                </a:solidFill>
-                <a:latin typeface="Ramabhadra" panose="02000600000000000000" pitchFamily="2" charset="0"/>
-                <a:cs typeface="Ramabhadra" panose="02000600000000000000" pitchFamily="2" charset="0"/>
-              </a:rPr>
-              <a:t>నా లోపల స్థిర హృదయం</a:t>
-            </a:r>
-          </a:p>
-          <a:p>
-            <a:pPr algn="ctr"/>
-            <a:r>
-              <a:rPr lang="te-IN" sz="863" dirty="0">
-                <a:solidFill>
-                  <a:srgbClr val="000000"/>
-                </a:solidFill>
-                <a:latin typeface="Ramabhadra" panose="02000600000000000000" pitchFamily="2" charset="0"/>
-                <a:cs typeface="Ramabhadra" panose="02000600000000000000" pitchFamily="2" charset="0"/>
-              </a:rPr>
-              <a:t>నూతనముగ పుట్టించు (2)</a:t>
-            </a:r>
-          </a:p>
-        </p:txBody>
-      </p:sp>
-      <p:sp>
-        <p:nvSpPr>
-          <p:cNvPr id="4" name="Rectangle 3">
-            <a:extLst>
-              <a:ext uri="{FF2B5EF4-FFF2-40B4-BE49-F238E27FC236}">
-                <a16:creationId xmlns:a16="http://schemas.microsoft.com/office/drawing/2014/main" id="{33055CCC-C265-417F-BC2F-ED69E16338ED}"/>
-              </a:ext>
-            </a:extLst>
-          </p:cNvPr>
-          <p:cNvSpPr/>
-          <p:nvPr/>
-        </p:nvSpPr>
-        <p:spPr>
-          <a:xfrm>
-            <a:off x="4953000" y="1117045"/>
-            <a:ext cx="1618978" cy="2277813"/>
-          </a:xfrm>
-          <a:prstGeom prst="rect">
-            <a:avLst/>
-          </a:prstGeom>
-          <a:solidFill>
-            <a:schemeClr val="bg1"/>
-          </a:solidFill>
-          <a:ln>
-            <a:solidFill>
-              <a:schemeClr val="bg1">
-                <a:lumMod val="85000"/>
-              </a:schemeClr>
-            </a:solidFill>
-          </a:ln>
-        </p:spPr>
-        <p:style>
-          <a:lnRef idx="2">
-            <a:schemeClr val="accent1">
-              <a:shade val="50000"/>
-            </a:schemeClr>
-          </a:lnRef>
-          <a:fillRef idx="1">
-            <a:schemeClr val="accent1"/>
-          </a:fillRef>
-          <a:effectRef idx="0">
-            <a:schemeClr val="accent1"/>
-          </a:effectRef>
-          <a:fontRef idx="minor">
-            <a:schemeClr val="lt1"/>
-          </a:fontRef>
-        </p:style>
-        <p:txBody>
-          <a:bodyPr rtlCol="0" anchor="ctr"/>
-          <a:lstStyle/>
-          <a:p>
-            <a:pPr algn="ctr"/>
-            <a:r>
-              <a:rPr lang="te-IN" sz="839" dirty="0">
-                <a:solidFill>
-                  <a:schemeClr val="tx1"/>
-                </a:solidFill>
-                <a:latin typeface="Ramabhadra" panose="02000600000000000000" pitchFamily="2" charset="0"/>
-                <a:cs typeface="Ramabhadra" panose="02000600000000000000" pitchFamily="2" charset="0"/>
-              </a:rPr>
-              <a:t>హల్లెలూయా స్తుతించి పాడి కీర్తింతును</a:t>
-            </a:r>
-          </a:p>
-          <a:p>
-            <a:pPr algn="ctr"/>
-            <a:r>
-              <a:rPr lang="te-IN" sz="839" dirty="0">
-                <a:solidFill>
-                  <a:schemeClr val="tx1"/>
-                </a:solidFill>
-                <a:latin typeface="Ramabhadra" panose="02000600000000000000" pitchFamily="2" charset="0"/>
-                <a:cs typeface="Ramabhadra" panose="02000600000000000000" pitchFamily="2" charset="0"/>
-              </a:rPr>
-              <a:t>జీవము కంటే ఉత్తమమౌ నీ కృపను</a:t>
-            </a:r>
-          </a:p>
-          <a:p>
-            <a:pPr algn="ctr"/>
-            <a:r>
-              <a:rPr lang="te-IN" sz="839" dirty="0">
-                <a:solidFill>
-                  <a:schemeClr val="tx1"/>
-                </a:solidFill>
-                <a:latin typeface="Ramabhadra" panose="02000600000000000000" pitchFamily="2" charset="0"/>
-                <a:cs typeface="Ramabhadra" panose="02000600000000000000" pitchFamily="2" charset="0"/>
-              </a:rPr>
-              <a:t>యేసయ్యా........ 4 హల్లెలూయా........ 4</a:t>
-            </a:r>
-          </a:p>
-          <a:p>
-            <a:pPr algn="ctr"/>
-            <a:endParaRPr lang="te-IN" sz="839" dirty="0">
-              <a:solidFill>
-                <a:schemeClr val="tx1"/>
-              </a:solidFill>
-              <a:latin typeface="Ramabhadra" panose="02000600000000000000" pitchFamily="2" charset="0"/>
-              <a:cs typeface="Ramabhadra" panose="02000600000000000000" pitchFamily="2" charset="0"/>
-            </a:endParaRPr>
-          </a:p>
-          <a:p>
-            <a:pPr algn="ctr"/>
-            <a:r>
-              <a:rPr lang="te-IN" sz="839" dirty="0">
-                <a:solidFill>
-                  <a:schemeClr val="tx1"/>
-                </a:solidFill>
-                <a:latin typeface="Ramabhadra" panose="02000600000000000000" pitchFamily="2" charset="0"/>
-                <a:cs typeface="Ramabhadra" panose="02000600000000000000" pitchFamily="2" charset="0"/>
-              </a:rPr>
-              <a:t>బంధువులు స్నేహితులు ఎంతో మందుండగా</a:t>
-            </a:r>
-          </a:p>
-          <a:p>
-            <a:pPr algn="ctr"/>
-            <a:r>
-              <a:rPr lang="te-IN" sz="839" dirty="0">
-                <a:solidFill>
-                  <a:schemeClr val="tx1"/>
-                </a:solidFill>
-                <a:latin typeface="Ramabhadra" panose="02000600000000000000" pitchFamily="2" charset="0"/>
-                <a:cs typeface="Ramabhadra" panose="02000600000000000000" pitchFamily="2" charset="0"/>
-              </a:rPr>
-              <a:t>ఎన్నో మారులు నేను ఒంటరినై యుంటిని -2</a:t>
-            </a:r>
-          </a:p>
-          <a:p>
-            <a:pPr algn="ctr"/>
-            <a:r>
-              <a:rPr lang="te-IN" sz="839" dirty="0">
-                <a:solidFill>
-                  <a:schemeClr val="tx1"/>
-                </a:solidFill>
-                <a:latin typeface="Ramabhadra" panose="02000600000000000000" pitchFamily="2" charset="0"/>
-                <a:cs typeface="Ramabhadra" panose="02000600000000000000" pitchFamily="2" charset="0"/>
-              </a:rPr>
-              <a:t>నా ఒంటరి తనంలో మంచి స్నేహితునిగా </a:t>
-            </a:r>
-          </a:p>
-          <a:p>
-            <a:pPr algn="ctr"/>
-            <a:r>
-              <a:rPr lang="te-IN" sz="839" dirty="0">
-                <a:solidFill>
-                  <a:schemeClr val="tx1"/>
-                </a:solidFill>
-                <a:latin typeface="Ramabhadra" panose="02000600000000000000" pitchFamily="2" charset="0"/>
-                <a:cs typeface="Ramabhadra" panose="02000600000000000000" pitchFamily="2" charset="0"/>
-              </a:rPr>
-              <a:t>చెంత చేరినావే-చెలిమి పంచినావే</a:t>
-            </a:r>
-          </a:p>
-          <a:p>
-            <a:pPr algn="ctr"/>
-            <a:r>
-              <a:rPr lang="te-IN" sz="839" dirty="0">
-                <a:solidFill>
-                  <a:schemeClr val="tx1"/>
-                </a:solidFill>
-                <a:latin typeface="Ramabhadra" panose="02000600000000000000" pitchFamily="2" charset="0"/>
-                <a:cs typeface="Ramabhadra" panose="02000600000000000000" pitchFamily="2" charset="0"/>
-              </a:rPr>
-              <a:t>గుండెల నిండా నీవే - నిన్ను పాడని</a:t>
-            </a:r>
-          </a:p>
-          <a:p>
-            <a:pPr algn="ctr"/>
-            <a:endParaRPr lang="te-IN" sz="839" dirty="0">
-              <a:solidFill>
-                <a:schemeClr val="tx1"/>
-              </a:solidFill>
-              <a:latin typeface="Ramabhadra" panose="02000600000000000000" pitchFamily="2" charset="0"/>
-              <a:cs typeface="Ramabhadra" panose="02000600000000000000" pitchFamily="2" charset="0"/>
-            </a:endParaRPr>
-          </a:p>
-          <a:p>
-            <a:pPr algn="ctr"/>
-            <a:r>
-              <a:rPr lang="te-IN" sz="839" dirty="0">
-                <a:solidFill>
-                  <a:schemeClr val="tx1"/>
-                </a:solidFill>
-                <a:latin typeface="Ramabhadra" panose="02000600000000000000" pitchFamily="2" charset="0"/>
-                <a:cs typeface="Ramabhadra" panose="02000600000000000000" pitchFamily="2" charset="0"/>
-              </a:rPr>
-              <a:t>నా జీవితంలో ఎండవానలు రాగా</a:t>
-            </a:r>
-          </a:p>
-          <a:p>
-            <a:pPr algn="ctr"/>
-            <a:r>
-              <a:rPr lang="te-IN" sz="839" dirty="0">
-                <a:solidFill>
-                  <a:schemeClr val="tx1"/>
-                </a:solidFill>
-                <a:latin typeface="Ramabhadra" panose="02000600000000000000" pitchFamily="2" charset="0"/>
-                <a:cs typeface="Ramabhadra" panose="02000600000000000000" pitchFamily="2" charset="0"/>
-              </a:rPr>
-              <a:t>పగలు చీకటిని నేను అనుభవింపగా</a:t>
-            </a:r>
-          </a:p>
-          <a:p>
-            <a:pPr algn="ctr"/>
-            <a:r>
-              <a:rPr lang="te-IN" sz="839" dirty="0">
-                <a:solidFill>
-                  <a:schemeClr val="tx1"/>
-                </a:solidFill>
-                <a:latin typeface="Ramabhadra" panose="02000600000000000000" pitchFamily="2" charset="0"/>
-                <a:cs typeface="Ramabhadra" panose="02000600000000000000" pitchFamily="2" charset="0"/>
-              </a:rPr>
-              <a:t>పగలు మేఘ స్థంబమై- రాత్రి అగ్ని స్థంబమై</a:t>
-            </a:r>
-          </a:p>
-          <a:p>
-            <a:pPr algn="ctr"/>
-            <a:r>
-              <a:rPr lang="te-IN" sz="839" dirty="0">
-                <a:solidFill>
-                  <a:schemeClr val="tx1"/>
-                </a:solidFill>
-                <a:latin typeface="Ramabhadra" panose="02000600000000000000" pitchFamily="2" charset="0"/>
-                <a:cs typeface="Ramabhadra" panose="02000600000000000000" pitchFamily="2" charset="0"/>
-              </a:rPr>
-              <a:t>ఆవరించి నావే- ఆదరించి నావే</a:t>
-            </a:r>
-          </a:p>
-          <a:p>
-            <a:pPr algn="ctr"/>
-            <a:r>
-              <a:rPr lang="te-IN" sz="839" dirty="0">
-                <a:solidFill>
-                  <a:schemeClr val="tx1"/>
-                </a:solidFill>
-                <a:latin typeface="Ramabhadra" panose="02000600000000000000" pitchFamily="2" charset="0"/>
-                <a:cs typeface="Ramabhadra" panose="02000600000000000000" pitchFamily="2" charset="0"/>
-              </a:rPr>
-              <a:t>కన్నీరు తుడచి నన్ను – ముద్దాడితివే</a:t>
-            </a:r>
-          </a:p>
-        </p:txBody>
-      </p:sp>
-      <p:sp>
-        <p:nvSpPr>
-          <p:cNvPr id="5" name="Rectangle 4">
-            <a:extLst>
-              <a:ext uri="{FF2B5EF4-FFF2-40B4-BE49-F238E27FC236}">
-                <a16:creationId xmlns:a16="http://schemas.microsoft.com/office/drawing/2014/main" id="{954B1B4E-F899-4AA1-B554-B078DFCD42B8}"/>
-              </a:ext>
-            </a:extLst>
-          </p:cNvPr>
-          <p:cNvSpPr/>
-          <p:nvPr/>
-        </p:nvSpPr>
-        <p:spPr>
-          <a:xfrm>
-            <a:off x="4953000" y="3393119"/>
-            <a:ext cx="1618978" cy="2277813"/>
-          </a:xfrm>
-          <a:prstGeom prst="rect">
-            <a:avLst/>
-          </a:prstGeom>
-          <a:solidFill>
-            <a:schemeClr val="bg1"/>
-          </a:solidFill>
-          <a:ln>
-            <a:solidFill>
-              <a:schemeClr val="bg1">
-                <a:lumMod val="85000"/>
-              </a:schemeClr>
-            </a:solidFill>
-          </a:ln>
-        </p:spPr>
-        <p:style>
-          <a:lnRef idx="2">
-            <a:schemeClr val="accent1">
-              <a:shade val="50000"/>
-            </a:schemeClr>
-          </a:lnRef>
-          <a:fillRef idx="1">
-            <a:schemeClr val="accent1"/>
-          </a:fillRef>
-          <a:effectRef idx="0">
-            <a:schemeClr val="accent1"/>
-          </a:effectRef>
-          <a:fontRef idx="minor">
-            <a:schemeClr val="lt1"/>
-          </a:fontRef>
-        </p:style>
-        <p:txBody>
-          <a:bodyPr rtlCol="0" anchor="ctr"/>
-          <a:lstStyle/>
-          <a:p>
-            <a:pPr algn="ctr" defTabSz="210778">
-              <a:defRPr/>
-            </a:pPr>
-            <a:r>
-              <a:rPr lang="te-IN" sz="767" dirty="0">
-                <a:solidFill>
-                  <a:schemeClr val="tx1"/>
-                </a:solidFill>
-                <a:latin typeface="Ramabhadra" panose="02000600000000000000" pitchFamily="2" charset="0"/>
-                <a:cs typeface="Ramabhadra" panose="02000600000000000000" pitchFamily="2" charset="0"/>
-              </a:rPr>
-              <a:t>స్తోత్రబలి స్తోత్రబలి – మంచిదేవా నీకేనయ్యా</a:t>
-            </a:r>
-            <a:br>
-              <a:rPr lang="te-IN" sz="767" dirty="0">
-                <a:solidFill>
-                  <a:schemeClr val="tx1"/>
-                </a:solidFill>
-                <a:latin typeface="Ramabhadra" panose="02000600000000000000" pitchFamily="2" charset="0"/>
-                <a:cs typeface="Ramabhadra" panose="02000600000000000000" pitchFamily="2" charset="0"/>
-              </a:rPr>
-            </a:br>
-            <a:r>
-              <a:rPr lang="te-IN" sz="767" dirty="0">
-                <a:solidFill>
-                  <a:schemeClr val="tx1"/>
-                </a:solidFill>
-                <a:latin typeface="Ramabhadra" panose="02000600000000000000" pitchFamily="2" charset="0"/>
-                <a:cs typeface="Ramabhadra" panose="02000600000000000000" pitchFamily="2" charset="0"/>
-              </a:rPr>
-              <a:t>శుభవేళ ఆనందమే – నా తండ్రి నీ చిరుపాదమే (2)</a:t>
-            </a:r>
-          </a:p>
-          <a:p>
-            <a:pPr algn="ctr" defTabSz="210778">
-              <a:defRPr/>
-            </a:pPr>
-            <a:endParaRPr lang="te-IN" sz="767" dirty="0">
-              <a:solidFill>
-                <a:schemeClr val="tx1"/>
-              </a:solidFill>
-              <a:latin typeface="Ramabhadra" panose="02000600000000000000" pitchFamily="2" charset="0"/>
-              <a:cs typeface="Ramabhadra" panose="02000600000000000000" pitchFamily="2" charset="0"/>
-            </a:endParaRPr>
-          </a:p>
-          <a:p>
-            <a:pPr algn="ctr" defTabSz="210778">
-              <a:defRPr/>
-            </a:pPr>
-            <a:r>
-              <a:rPr lang="te-IN" sz="767" dirty="0">
-                <a:solidFill>
-                  <a:schemeClr val="tx1"/>
-                </a:solidFill>
-                <a:latin typeface="Ramabhadra" panose="02000600000000000000" pitchFamily="2" charset="0"/>
-                <a:cs typeface="Ramabhadra" panose="02000600000000000000" pitchFamily="2" charset="0"/>
-              </a:rPr>
-              <a:t>నిన్నటి బాధలంతా నేటికి మాయమయ్యే (2)</a:t>
-            </a:r>
-            <a:br>
-              <a:rPr lang="te-IN" sz="767" dirty="0">
-                <a:solidFill>
-                  <a:schemeClr val="tx1"/>
-                </a:solidFill>
-                <a:latin typeface="Ramabhadra" panose="02000600000000000000" pitchFamily="2" charset="0"/>
-                <a:cs typeface="Ramabhadra" panose="02000600000000000000" pitchFamily="2" charset="0"/>
-              </a:rPr>
-            </a:br>
-            <a:r>
-              <a:rPr lang="te-IN" sz="767" dirty="0">
-                <a:solidFill>
-                  <a:schemeClr val="tx1"/>
-                </a:solidFill>
-                <a:latin typeface="Ramabhadra" panose="02000600000000000000" pitchFamily="2" charset="0"/>
-                <a:cs typeface="Ramabhadra" panose="02000600000000000000" pitchFamily="2" charset="0"/>
-              </a:rPr>
-              <a:t>నెమ్మది ఉదయించె అది శాశ్వతమైనదయ్యా (2)</a:t>
-            </a:r>
-            <a:br>
-              <a:rPr lang="te-IN" sz="767" dirty="0">
-                <a:solidFill>
-                  <a:schemeClr val="tx1"/>
-                </a:solidFill>
-                <a:latin typeface="Ramabhadra" panose="02000600000000000000" pitchFamily="2" charset="0"/>
-                <a:cs typeface="Ramabhadra" panose="02000600000000000000" pitchFamily="2" charset="0"/>
-              </a:rPr>
-            </a:br>
-            <a:r>
-              <a:rPr lang="te-IN" sz="767" dirty="0">
-                <a:solidFill>
-                  <a:schemeClr val="tx1"/>
-                </a:solidFill>
-                <a:latin typeface="Ramabhadra" panose="02000600000000000000" pitchFamily="2" charset="0"/>
-                <a:cs typeface="Ramabhadra" panose="02000600000000000000" pitchFamily="2" charset="0"/>
-              </a:rPr>
-              <a:t>కోటి కోటి స్తోత్రం డాడి (3)       </a:t>
-            </a:r>
-          </a:p>
-          <a:p>
-            <a:pPr algn="ctr" defTabSz="210778">
-              <a:defRPr/>
-            </a:pPr>
-            <a:r>
-              <a:rPr lang="te-IN" sz="767" dirty="0">
-                <a:solidFill>
-                  <a:schemeClr val="tx1"/>
-                </a:solidFill>
-                <a:latin typeface="Ramabhadra" panose="02000600000000000000" pitchFamily="2" charset="0"/>
-                <a:cs typeface="Ramabhadra" panose="02000600000000000000" pitchFamily="2" charset="0"/>
-              </a:rPr>
-              <a:t>   </a:t>
-            </a:r>
-          </a:p>
-          <a:p>
-            <a:pPr algn="ctr" defTabSz="210778">
-              <a:defRPr/>
-            </a:pPr>
-            <a:r>
-              <a:rPr lang="te-IN" sz="767" dirty="0">
-                <a:solidFill>
-                  <a:schemeClr val="tx1"/>
-                </a:solidFill>
-                <a:latin typeface="Ramabhadra" panose="02000600000000000000" pitchFamily="2" charset="0"/>
-                <a:cs typeface="Ramabhadra" panose="02000600000000000000" pitchFamily="2" charset="0"/>
-              </a:rPr>
-              <a:t>రేయంతా కాచితివి మరు దినమిచ్చితివి (2)</a:t>
-            </a:r>
-            <a:br>
-              <a:rPr lang="te-IN" sz="767" dirty="0">
-                <a:solidFill>
-                  <a:schemeClr val="tx1"/>
-                </a:solidFill>
-                <a:latin typeface="Ramabhadra" panose="02000600000000000000" pitchFamily="2" charset="0"/>
-                <a:cs typeface="Ramabhadra" panose="02000600000000000000" pitchFamily="2" charset="0"/>
-              </a:rPr>
-            </a:br>
-            <a:r>
-              <a:rPr lang="te-IN" sz="767" dirty="0">
-                <a:solidFill>
-                  <a:schemeClr val="tx1"/>
-                </a:solidFill>
-                <a:latin typeface="Ramabhadra" panose="02000600000000000000" pitchFamily="2" charset="0"/>
-                <a:cs typeface="Ramabhadra" panose="02000600000000000000" pitchFamily="2" charset="0"/>
-              </a:rPr>
-              <a:t>మరువని నా స్నేహమా నీతో కలసి సంతోషింతును (2)</a:t>
-            </a:r>
-            <a:br>
-              <a:rPr lang="te-IN" sz="767" dirty="0">
-                <a:solidFill>
-                  <a:schemeClr val="tx1"/>
-                </a:solidFill>
-                <a:latin typeface="Ramabhadra" panose="02000600000000000000" pitchFamily="2" charset="0"/>
-                <a:cs typeface="Ramabhadra" panose="02000600000000000000" pitchFamily="2" charset="0"/>
-              </a:rPr>
-            </a:br>
-            <a:r>
-              <a:rPr lang="te-IN" sz="767" dirty="0">
-                <a:solidFill>
-                  <a:schemeClr val="tx1"/>
-                </a:solidFill>
-                <a:latin typeface="Ramabhadra" panose="02000600000000000000" pitchFamily="2" charset="0"/>
-                <a:cs typeface="Ramabhadra" panose="02000600000000000000" pitchFamily="2" charset="0"/>
-              </a:rPr>
-              <a:t>కోటి కోటి స్తోత్రం డాడి (3)     </a:t>
-            </a:r>
-          </a:p>
-          <a:p>
-            <a:pPr algn="ctr" defTabSz="210778">
-              <a:defRPr/>
-            </a:pPr>
-            <a:r>
-              <a:rPr lang="te-IN" sz="767" dirty="0">
-                <a:solidFill>
-                  <a:schemeClr val="tx1"/>
-                </a:solidFill>
-                <a:latin typeface="Ramabhadra" panose="02000600000000000000" pitchFamily="2" charset="0"/>
-                <a:cs typeface="Ramabhadra" panose="02000600000000000000" pitchFamily="2" charset="0"/>
-              </a:rPr>
-              <a:t>   </a:t>
-            </a:r>
-          </a:p>
-          <a:p>
-            <a:pPr algn="ctr" defTabSz="210778">
-              <a:defRPr/>
-            </a:pPr>
-            <a:r>
-              <a:rPr lang="te-IN" sz="767" dirty="0">
-                <a:solidFill>
-                  <a:schemeClr val="tx1"/>
-                </a:solidFill>
-                <a:latin typeface="Ramabhadra" panose="02000600000000000000" pitchFamily="2" charset="0"/>
-                <a:cs typeface="Ramabhadra" panose="02000600000000000000" pitchFamily="2" charset="0"/>
-              </a:rPr>
-              <a:t>నీ సేవ మార్గంలో ఉత్సాహం నొసగితివి (2)</a:t>
-            </a:r>
-            <a:br>
-              <a:rPr lang="te-IN" sz="767" dirty="0">
-                <a:solidFill>
-                  <a:schemeClr val="tx1"/>
-                </a:solidFill>
-                <a:latin typeface="Ramabhadra" panose="02000600000000000000" pitchFamily="2" charset="0"/>
-                <a:cs typeface="Ramabhadra" panose="02000600000000000000" pitchFamily="2" charset="0"/>
-              </a:rPr>
-            </a:br>
-            <a:r>
-              <a:rPr lang="te-IN" sz="767" dirty="0">
-                <a:solidFill>
-                  <a:schemeClr val="tx1"/>
-                </a:solidFill>
-                <a:latin typeface="Ramabhadra" panose="02000600000000000000" pitchFamily="2" charset="0"/>
-                <a:cs typeface="Ramabhadra" panose="02000600000000000000" pitchFamily="2" charset="0"/>
-              </a:rPr>
-              <a:t>ఉరికురికి పనిచేయ నాకు ఆరోగ్యమిచ్చితివి (2)</a:t>
-            </a:r>
-            <a:br>
-              <a:rPr lang="te-IN" sz="767" dirty="0">
-                <a:solidFill>
-                  <a:schemeClr val="tx1"/>
-                </a:solidFill>
-                <a:latin typeface="Ramabhadra" panose="02000600000000000000" pitchFamily="2" charset="0"/>
-                <a:cs typeface="Ramabhadra" panose="02000600000000000000" pitchFamily="2" charset="0"/>
-              </a:rPr>
-            </a:br>
-            <a:r>
-              <a:rPr lang="te-IN" sz="767" dirty="0">
-                <a:solidFill>
-                  <a:schemeClr val="tx1"/>
-                </a:solidFill>
-                <a:latin typeface="Ramabhadra" panose="02000600000000000000" pitchFamily="2" charset="0"/>
-                <a:cs typeface="Ramabhadra" panose="02000600000000000000" pitchFamily="2" charset="0"/>
-              </a:rPr>
-              <a:t>కోటి కోటి స్తోత్రం డాడి (3)   </a:t>
-            </a:r>
-          </a:p>
-        </p:txBody>
-      </p:sp>
-    </p:spTree>
-    <p:extLst>
-      <p:ext uri="{BB962C8B-B14F-4D97-AF65-F5344CB8AC3E}">
-        <p14:creationId xmlns:p14="http://schemas.microsoft.com/office/powerpoint/2010/main" val="1511661631"/>
-      </p:ext>
-    </p:extLst>
-  </p:cSld>
-  <p:clrMapOvr>
-    <a:masterClrMapping/>
-  </p:clrMapOvr>
-</p:sld>
-</file>
-
-<file path=ppt/slides/slide2.xml><?xml version="1.0" encoding="utf-8"?>
-<p:sld xmlns:a="http://schemas.openxmlformats.org/drawingml/2006/main" xmlns:r="http://schemas.openxmlformats.org/officeDocument/2006/relationships" xmlns:p="http://schemas.openxmlformats.org/presentationml/2006/main">
-  <p:cSld>
-    <p:spTree>
-      <p:nvGrpSpPr>
-        <p:cNvPr id="1" name=""/>
-        <p:cNvGrpSpPr/>
-        <p:nvPr/>
-      </p:nvGrpSpPr>
-      <p:grpSpPr>
-        <a:xfrm>
-          <a:off x="0" y="0"/>
-          <a:ext cx="0" cy="0"/>
-          <a:chOff x="0" y="0"/>
-          <a:chExt cx="0" cy="0"/>
-        </a:xfrm>
-      </p:grpSpPr>
-      <p:sp>
-        <p:nvSpPr>
-          <p:cNvPr id="2" name="Rectangle 1">
-            <a:extLst>
-              <a:ext uri="{FF2B5EF4-FFF2-40B4-BE49-F238E27FC236}">
-                <a16:creationId xmlns:a16="http://schemas.microsoft.com/office/drawing/2014/main" id="{C2114CF1-1236-46D5-9846-2222D8891EB8}"/>
-              </a:ext>
-            </a:extLst>
-          </p:cNvPr>
-          <p:cNvSpPr/>
-          <p:nvPr/>
-        </p:nvSpPr>
-        <p:spPr>
-          <a:xfrm>
             <a:off x="4952400" y="1"/>
             <a:ext cx="2476800" cy="6857999"/>
           </a:xfrm>
@@ -4741,84 +3583,16 @@
           <a:p>
             <a:pPr algn="ctr"/>
             <a:r>
-              <a:rPr lang="te-IN" sz="1680" dirty="0">
-                <a:solidFill>
-                  <a:schemeClr val="tx1"/>
-                </a:solidFill>
-                <a:latin typeface="Ramabhadra" panose="02000600000000000000" pitchFamily="2" charset="0"/>
-                <a:cs typeface="Ramabhadra" panose="02000600000000000000" pitchFamily="2" charset="0"/>
-              </a:rPr>
-              <a:t>అత్యున్నత సింహాసనముపై ఆసీనుడా</a:t>
-            </a:r>
-          </a:p>
-          <a:p>
-            <a:pPr algn="ctr"/>
-            <a:r>
-              <a:rPr lang="te-IN" sz="1680" dirty="0">
-                <a:solidFill>
-                  <a:schemeClr val="tx1"/>
-                </a:solidFill>
-                <a:latin typeface="Ramabhadra" panose="02000600000000000000" pitchFamily="2" charset="0"/>
-                <a:cs typeface="Ramabhadra" panose="02000600000000000000" pitchFamily="2" charset="0"/>
-              </a:rPr>
-              <a:t>దేవ దూతలు ఆరాధించు పరిశుద్ధుడా</a:t>
-            </a:r>
-          </a:p>
-          <a:p>
-            <a:pPr algn="ctr"/>
-            <a:r>
-              <a:rPr lang="te-IN" sz="1680" dirty="0">
-                <a:solidFill>
-                  <a:schemeClr val="tx1"/>
-                </a:solidFill>
-                <a:latin typeface="Ramabhadra" panose="02000600000000000000" pitchFamily="2" charset="0"/>
-                <a:cs typeface="Ramabhadra" panose="02000600000000000000" pitchFamily="2" charset="0"/>
-              </a:rPr>
-              <a:t>యేసయ్యా నా నిలువెల్ల నిండియున్నావు</a:t>
-            </a:r>
-          </a:p>
-          <a:p>
-            <a:pPr algn="ctr"/>
-            <a:r>
-              <a:rPr lang="te-IN" sz="1680" dirty="0">
-                <a:solidFill>
-                  <a:schemeClr val="tx1"/>
-                </a:solidFill>
-                <a:latin typeface="Ramabhadra" panose="02000600000000000000" pitchFamily="2" charset="0"/>
-                <a:cs typeface="Ramabhadra" panose="02000600000000000000" pitchFamily="2" charset="0"/>
-              </a:rPr>
-              <a:t>నా మనసార నీ సన్నిధిలో</a:t>
-            </a:r>
-          </a:p>
-          <a:p>
-            <a:pPr algn="ctr"/>
-            <a:r>
-              <a:rPr lang="te-IN" sz="1680" dirty="0">
-                <a:solidFill>
-                  <a:schemeClr val="tx1"/>
-                </a:solidFill>
-                <a:latin typeface="Ramabhadra" panose="02000600000000000000" pitchFamily="2" charset="0"/>
-                <a:cs typeface="Ramabhadra" panose="02000600000000000000" pitchFamily="2" charset="0"/>
-              </a:rPr>
-              <a:t>సాగిలపడి నమస్కారము చేసేదా</a:t>
-            </a:r>
-          </a:p>
-          <a:p>
-            <a:pPr algn="ctr"/>
-            <a:r>
-              <a:rPr lang="te-IN" sz="1680" dirty="0">
-                <a:solidFill>
-                  <a:schemeClr val="tx1"/>
-                </a:solidFill>
-                <a:latin typeface="Ramabhadra" panose="02000600000000000000" pitchFamily="2" charset="0"/>
-                <a:cs typeface="Ramabhadra" panose="02000600000000000000" pitchFamily="2" charset="0"/>
-              </a:rPr>
-              <a:t>సాగిలపడి నమస్కారము చేసేదా (2)</a:t>
-            </a:r>
-          </a:p>
-          <a:p>
-            <a:pPr algn="ctr"/>
-            <a:endParaRPr lang="te-IN" sz="1680" dirty="0">
+              <a:rPr lang="te-IN" sz="2000" dirty="0">
+                <a:solidFill>
+                  <a:schemeClr val="tx1"/>
+                </a:solidFill>
+                <a:latin typeface="Ramabhadra" panose="02000600000000000000" pitchFamily="2" charset="0"/>
+                <a:cs typeface="Ramabhadra" panose="02000600000000000000" pitchFamily="2" charset="0"/>
+              </a:rPr>
+              <a:t>పావుర స్వరము</a:t>
+            </a:r>
+            <a:endParaRPr lang="en-IN" sz="2000" dirty="0">
               <a:solidFill>
                 <a:schemeClr val="tx1"/>
               </a:solidFill>
@@ -4829,16 +3603,29 @@
           <a:p>
             <a:pPr algn="ctr"/>
             <a:r>
-              <a:rPr lang="te-IN" sz="1680" dirty="0">
-                <a:solidFill>
-                  <a:schemeClr val="tx1"/>
-                </a:solidFill>
-                <a:latin typeface="Ramabhadra" panose="02000600000000000000" pitchFamily="2" charset="0"/>
-                <a:cs typeface="Ramabhadra" panose="02000600000000000000" pitchFamily="2" charset="0"/>
-              </a:rPr>
-              <a:t>ప్రతి వసంతము</a:t>
-            </a:r>
-            <a:endParaRPr lang="en-IN" sz="1680" dirty="0">
+              <a:rPr lang="te-IN" sz="2000" dirty="0">
+                <a:solidFill>
+                  <a:schemeClr val="tx1"/>
+                </a:solidFill>
+                <a:latin typeface="Ramabhadra" panose="02000600000000000000" pitchFamily="2" charset="0"/>
+                <a:cs typeface="Ramabhadra" panose="02000600000000000000" pitchFamily="2" charset="0"/>
+              </a:rPr>
+              <a:t>వినబడుచున్నది</a:t>
+            </a:r>
+          </a:p>
+          <a:p>
+            <a:pPr algn="ctr"/>
+            <a:r>
+              <a:rPr lang="te-IN" sz="2000" dirty="0">
+                <a:solidFill>
+                  <a:schemeClr val="tx1"/>
+                </a:solidFill>
+                <a:latin typeface="Ramabhadra" panose="02000600000000000000" pitchFamily="2" charset="0"/>
+                <a:cs typeface="Ramabhadra" panose="02000600000000000000" pitchFamily="2" charset="0"/>
+              </a:rPr>
+              <a:t>పాపము విడచి</a:t>
+            </a:r>
+            <a:endParaRPr lang="en-IN" sz="2000" dirty="0">
               <a:solidFill>
                 <a:schemeClr val="tx1"/>
               </a:solidFill>
@@ -4849,29 +3636,19 @@
           <a:p>
             <a:pPr algn="ctr"/>
             <a:r>
-              <a:rPr lang="te-IN" sz="1680" dirty="0">
-                <a:solidFill>
-                  <a:schemeClr val="tx1"/>
-                </a:solidFill>
-                <a:latin typeface="Ramabhadra" panose="02000600000000000000" pitchFamily="2" charset="0"/>
-                <a:cs typeface="Ramabhadra" panose="02000600000000000000" pitchFamily="2" charset="0"/>
-              </a:rPr>
-              <a:t>నీ దయా కిరీటమే</a:t>
-            </a:r>
-          </a:p>
-          <a:p>
-            <a:pPr algn="ctr"/>
-            <a:r>
-              <a:rPr lang="te-IN" sz="1680" dirty="0">
-                <a:solidFill>
-                  <a:schemeClr val="tx1"/>
-                </a:solidFill>
-                <a:latin typeface="Ramabhadra" panose="02000600000000000000" pitchFamily="2" charset="0"/>
-                <a:cs typeface="Ramabhadra" panose="02000600000000000000" pitchFamily="2" charset="0"/>
-              </a:rPr>
-              <a:t>ప్రకృతి కలలన్నియు</a:t>
-            </a:r>
-            <a:endParaRPr lang="en-IN" sz="1680" dirty="0">
+              <a:rPr lang="te-IN" sz="2000" dirty="0">
+                <a:solidFill>
+                  <a:schemeClr val="tx1"/>
+                </a:solidFill>
+                <a:latin typeface="Ramabhadra" panose="02000600000000000000" pitchFamily="2" charset="0"/>
+                <a:cs typeface="Ramabhadra" panose="02000600000000000000" pitchFamily="2" charset="0"/>
+              </a:rPr>
+              <a:t>పరుగిడి రమ్ము</a:t>
+            </a:r>
+          </a:p>
+          <a:p>
+            <a:pPr algn="ctr"/>
+            <a:endParaRPr lang="te-IN" sz="2000" dirty="0">
               <a:solidFill>
                 <a:schemeClr val="tx1"/>
               </a:solidFill>
@@ -4882,45 +3659,16 @@
           <a:p>
             <a:pPr algn="ctr"/>
             <a:r>
-              <a:rPr lang="te-IN" sz="1680" dirty="0">
-                <a:solidFill>
-                  <a:schemeClr val="tx1"/>
-                </a:solidFill>
-                <a:latin typeface="Ramabhadra" panose="02000600000000000000" pitchFamily="2" charset="0"/>
-                <a:cs typeface="Ramabhadra" panose="02000600000000000000" pitchFamily="2" charset="0"/>
-              </a:rPr>
-              <a:t>నీ మహిమను వివరించునే (2)</a:t>
-            </a:r>
-          </a:p>
-          <a:p>
-            <a:pPr algn="ctr"/>
-            <a:r>
-              <a:rPr lang="te-IN" sz="1680" dirty="0">
-                <a:solidFill>
-                  <a:schemeClr val="tx1"/>
-                </a:solidFill>
-                <a:latin typeface="Ramabhadra" panose="02000600000000000000" pitchFamily="2" charset="0"/>
-                <a:cs typeface="Ramabhadra" panose="02000600000000000000" pitchFamily="2" charset="0"/>
-              </a:rPr>
-              <a:t>ప్రభువా నిన్నే ఆరాధించెద</a:t>
-            </a:r>
-          </a:p>
-          <a:p>
-            <a:pPr algn="ctr"/>
-            <a:r>
-              <a:rPr lang="te-IN" sz="1680" dirty="0">
-                <a:solidFill>
-                  <a:schemeClr val="tx1"/>
-                </a:solidFill>
-                <a:latin typeface="Ramabhadra" panose="02000600000000000000" pitchFamily="2" charset="0"/>
-                <a:cs typeface="Ramabhadra" panose="02000600000000000000" pitchFamily="2" charset="0"/>
-              </a:rPr>
-              <a:t>కృతజ్ఞాతార్పణలతో – కృతజ్ఞాతార్పణలతో (2)</a:t>
-            </a:r>
-          </a:p>
-          <a:p>
-            <a:pPr algn="ctr"/>
-            <a:endParaRPr lang="te-IN" sz="1680" dirty="0">
+              <a:rPr lang="te-IN" sz="2000" dirty="0">
+                <a:solidFill>
+                  <a:schemeClr val="tx1"/>
+                </a:solidFill>
+                <a:latin typeface="Ramabhadra" panose="02000600000000000000" pitchFamily="2" charset="0"/>
+                <a:cs typeface="Ramabhadra" panose="02000600000000000000" pitchFamily="2" charset="0"/>
+              </a:rPr>
+              <a:t>పాపాంధకారములో</a:t>
+            </a:r>
+            <a:endParaRPr lang="en-IN" sz="2000" dirty="0">
               <a:solidFill>
                 <a:schemeClr val="tx1"/>
               </a:solidFill>
@@ -4931,16 +3679,71 @@
           <a:p>
             <a:pPr algn="ctr"/>
             <a:r>
-              <a:rPr lang="te-IN" sz="1680" dirty="0">
-                <a:solidFill>
-                  <a:schemeClr val="tx1"/>
-                </a:solidFill>
-                <a:latin typeface="Ramabhadra" panose="02000600000000000000" pitchFamily="2" charset="0"/>
-                <a:cs typeface="Ramabhadra" panose="02000600000000000000" pitchFamily="2" charset="0"/>
-              </a:rPr>
-              <a:t>పరిమలించునే</a:t>
-            </a:r>
-            <a:endParaRPr lang="en-IN" sz="1680" dirty="0">
+              <a:rPr lang="te-IN" sz="2000" dirty="0">
+                <a:solidFill>
+                  <a:schemeClr val="tx1"/>
+                </a:solidFill>
+                <a:latin typeface="Ramabhadra" panose="02000600000000000000" pitchFamily="2" charset="0"/>
+                <a:cs typeface="Ramabhadra" panose="02000600000000000000" pitchFamily="2" charset="0"/>
+              </a:rPr>
+              <a:t>తిరుగాడు నీవు</a:t>
+            </a:r>
+          </a:p>
+          <a:p>
+            <a:pPr algn="ctr"/>
+            <a:r>
+              <a:rPr lang="te-IN" sz="2000" dirty="0">
+                <a:solidFill>
+                  <a:schemeClr val="tx1"/>
+                </a:solidFill>
+                <a:latin typeface="Ramabhadra" panose="02000600000000000000" pitchFamily="2" charset="0"/>
+                <a:cs typeface="Ramabhadra" panose="02000600000000000000" pitchFamily="2" charset="0"/>
+              </a:rPr>
+              <a:t>లోకాశల నాశ్రయించి నీవు</a:t>
+            </a:r>
+          </a:p>
+          <a:p>
+            <a:pPr algn="ctr"/>
+            <a:r>
+              <a:rPr lang="te-IN" sz="2000" dirty="0">
+                <a:solidFill>
+                  <a:schemeClr val="tx1"/>
+                </a:solidFill>
+                <a:latin typeface="Ramabhadra" panose="02000600000000000000" pitchFamily="2" charset="0"/>
+                <a:cs typeface="Ramabhadra" panose="02000600000000000000" pitchFamily="2" charset="0"/>
+              </a:rPr>
+              <a:t>పశ్చాత్తాపముతో ప్రార్థించుము</a:t>
+            </a:r>
+          </a:p>
+          <a:p>
+            <a:pPr algn="ctr"/>
+            <a:r>
+              <a:rPr lang="te-IN" sz="2000" dirty="0">
+                <a:solidFill>
+                  <a:schemeClr val="tx1"/>
+                </a:solidFill>
+                <a:latin typeface="Ramabhadra" panose="02000600000000000000" pitchFamily="2" charset="0"/>
+                <a:cs typeface="Ramabhadra" panose="02000600000000000000" pitchFamily="2" charset="0"/>
+              </a:rPr>
+              <a:t>నీ స్వరము</a:t>
+            </a:r>
+          </a:p>
+          <a:p>
+            <a:pPr algn="ctr"/>
+            <a:r>
+              <a:rPr lang="te-IN" sz="2000" dirty="0">
+                <a:solidFill>
+                  <a:schemeClr val="tx1"/>
+                </a:solidFill>
+                <a:latin typeface="Ramabhadra" panose="02000600000000000000" pitchFamily="2" charset="0"/>
+                <a:cs typeface="Ramabhadra" panose="02000600000000000000" pitchFamily="2" charset="0"/>
+              </a:rPr>
+              <a:t>ప్రియునికి వినబడనిమ్ము</a:t>
+            </a:r>
+          </a:p>
+          <a:p>
+            <a:pPr algn="ctr"/>
+            <a:endParaRPr lang="te-IN" sz="2000" dirty="0">
               <a:solidFill>
                 <a:schemeClr val="tx1"/>
               </a:solidFill>
@@ -4951,55 +3754,29 @@
           <a:p>
             <a:pPr algn="ctr"/>
             <a:r>
-              <a:rPr lang="te-IN" sz="1680" dirty="0">
-                <a:solidFill>
-                  <a:schemeClr val="tx1"/>
-                </a:solidFill>
-                <a:latin typeface="Ramabhadra" panose="02000600000000000000" pitchFamily="2" charset="0"/>
-                <a:cs typeface="Ramabhadra" panose="02000600000000000000" pitchFamily="2" charset="0"/>
-              </a:rPr>
-              <a:t>నా సాక్ష్య జీవితమే</a:t>
-            </a:r>
-          </a:p>
-          <a:p>
-            <a:pPr algn="ctr"/>
-            <a:r>
-              <a:rPr lang="te-IN" sz="1680" dirty="0">
-                <a:solidFill>
-                  <a:schemeClr val="tx1"/>
-                </a:solidFill>
-                <a:latin typeface="Ramabhadra" panose="02000600000000000000" pitchFamily="2" charset="0"/>
-                <a:cs typeface="Ramabhadra" panose="02000600000000000000" pitchFamily="2" charset="0"/>
-              </a:rPr>
-              <a:t>పరిశుద్ధాత్ముడు నన్ను నడిపించుచున్నందునే (2)</a:t>
-            </a:r>
-          </a:p>
-          <a:p>
-            <a:pPr algn="ctr"/>
-            <a:r>
-              <a:rPr lang="te-IN" sz="1680" dirty="0">
-                <a:solidFill>
-                  <a:schemeClr val="tx1"/>
-                </a:solidFill>
-                <a:latin typeface="Ramabhadra" panose="02000600000000000000" pitchFamily="2" charset="0"/>
-                <a:cs typeface="Ramabhadra" panose="02000600000000000000" pitchFamily="2" charset="0"/>
-              </a:rPr>
-              <a:t>పరిశుద్ధాత్మలో ఆనందించెద</a:t>
-            </a:r>
-          </a:p>
-          <a:p>
-            <a:pPr algn="ctr"/>
-            <a:r>
-              <a:rPr lang="te-IN" sz="1680" dirty="0">
-                <a:solidFill>
-                  <a:schemeClr val="tx1"/>
-                </a:solidFill>
-                <a:latin typeface="Ramabhadra" panose="02000600000000000000" pitchFamily="2" charset="0"/>
-                <a:cs typeface="Ramabhadra" panose="02000600000000000000" pitchFamily="2" charset="0"/>
-              </a:rPr>
-              <a:t>హర్ష ధ్వనులతో –</a:t>
-            </a:r>
-            <a:endParaRPr lang="en-IN" sz="1680" dirty="0">
+              <a:rPr lang="te-IN" sz="2000" dirty="0">
+                <a:solidFill>
+                  <a:schemeClr val="tx1"/>
+                </a:solidFill>
+                <a:latin typeface="Ramabhadra" panose="02000600000000000000" pitchFamily="2" charset="0"/>
+                <a:cs typeface="Ramabhadra" panose="02000600000000000000" pitchFamily="2" charset="0"/>
+              </a:rPr>
+              <a:t>దవళవర్ణుడు రత్నవర్ణుడేసు</a:t>
+            </a:r>
+          </a:p>
+          <a:p>
+            <a:pPr algn="ctr"/>
+            <a:r>
+              <a:rPr lang="te-IN" sz="2000" dirty="0">
+                <a:solidFill>
+                  <a:schemeClr val="tx1"/>
+                </a:solidFill>
+                <a:latin typeface="Ramabhadra" panose="02000600000000000000" pitchFamily="2" charset="0"/>
+                <a:cs typeface="Ramabhadra" panose="02000600000000000000" pitchFamily="2" charset="0"/>
+              </a:rPr>
+              <a:t>అతి మనోహరుడు</a:t>
+            </a:r>
+            <a:endParaRPr lang="en-IN" sz="2000" dirty="0">
               <a:solidFill>
                 <a:schemeClr val="tx1"/>
               </a:solidFill>
@@ -5010,14 +3787,80 @@
           <a:p>
             <a:pPr algn="ctr"/>
             <a:r>
-              <a:rPr lang="te-IN" sz="1680" dirty="0">
-                <a:solidFill>
-                  <a:schemeClr val="tx1"/>
-                </a:solidFill>
-                <a:latin typeface="Ramabhadra" panose="02000600000000000000" pitchFamily="2" charset="0"/>
-                <a:cs typeface="Ramabhadra" panose="02000600000000000000" pitchFamily="2" charset="0"/>
-              </a:rPr>
-              <a:t>హర్ష ధ్వనులతో (2)</a:t>
+              <a:rPr lang="te-IN" sz="2000" dirty="0">
+                <a:solidFill>
+                  <a:schemeClr val="tx1"/>
+                </a:solidFill>
+                <a:latin typeface="Ramabhadra" panose="02000600000000000000" pitchFamily="2" charset="0"/>
+                <a:cs typeface="Ramabhadra" panose="02000600000000000000" pitchFamily="2" charset="0"/>
+              </a:rPr>
+              <a:t>అతి సుందరుడు</a:t>
+            </a:r>
+          </a:p>
+          <a:p>
+            <a:pPr algn="ctr"/>
+            <a:r>
+              <a:rPr lang="te-IN" sz="2000" dirty="0">
+                <a:solidFill>
+                  <a:schemeClr val="tx1"/>
+                </a:solidFill>
+                <a:latin typeface="Ramabhadra" panose="02000600000000000000" pitchFamily="2" charset="0"/>
+                <a:cs typeface="Ramabhadra" panose="02000600000000000000" pitchFamily="2" charset="0"/>
+              </a:rPr>
+              <a:t>నా సహోదరి</a:t>
+            </a:r>
+            <a:endParaRPr lang="en-IN" sz="2000" dirty="0">
+              <a:solidFill>
+                <a:schemeClr val="tx1"/>
+              </a:solidFill>
+              <a:latin typeface="Ramabhadra" panose="02000600000000000000" pitchFamily="2" charset="0"/>
+              <a:cs typeface="Ramabhadra" panose="02000600000000000000" pitchFamily="2" charset="0"/>
+            </a:endParaRPr>
+          </a:p>
+          <a:p>
+            <a:pPr algn="ctr"/>
+            <a:r>
+              <a:rPr lang="te-IN" sz="2000" dirty="0">
+                <a:solidFill>
+                  <a:schemeClr val="tx1"/>
+                </a:solidFill>
+                <a:latin typeface="Ramabhadra" panose="02000600000000000000" pitchFamily="2" charset="0"/>
+                <a:cs typeface="Ramabhadra" panose="02000600000000000000" pitchFamily="2" charset="0"/>
+              </a:rPr>
+              <a:t>ప్రాణేశ్వరీ అని</a:t>
+            </a:r>
+          </a:p>
+          <a:p>
+            <a:pPr algn="ctr"/>
+            <a:r>
+              <a:rPr lang="te-IN" sz="2000" dirty="0">
+                <a:solidFill>
+                  <a:schemeClr val="tx1"/>
+                </a:solidFill>
+                <a:latin typeface="Ramabhadra" panose="02000600000000000000" pitchFamily="2" charset="0"/>
+                <a:cs typeface="Ramabhadra" panose="02000600000000000000" pitchFamily="2" charset="0"/>
+              </a:rPr>
+              <a:t>ప్రయమార నిన్ను</a:t>
+            </a:r>
+            <a:endParaRPr lang="en-IN" sz="2000" dirty="0">
+              <a:solidFill>
+                <a:schemeClr val="tx1"/>
+              </a:solidFill>
+              <a:latin typeface="Ramabhadra" panose="02000600000000000000" pitchFamily="2" charset="0"/>
+              <a:cs typeface="Ramabhadra" panose="02000600000000000000" pitchFamily="2" charset="0"/>
+            </a:endParaRPr>
+          </a:p>
+          <a:p>
+            <a:pPr algn="ctr"/>
+            <a:r>
+              <a:rPr lang="te-IN" sz="2000" dirty="0">
+                <a:solidFill>
+                  <a:schemeClr val="tx1"/>
+                </a:solidFill>
+                <a:latin typeface="Ramabhadra" panose="02000600000000000000" pitchFamily="2" charset="0"/>
+                <a:cs typeface="Ramabhadra" panose="02000600000000000000" pitchFamily="2" charset="0"/>
+              </a:rPr>
+              <a:t>పిలిచెను యేసు</a:t>
             </a:r>
           </a:p>
         </p:txBody>
@@ -5082,8 +3925,15 @@
                 <a:latin typeface="Ramabhadra" panose="02000600000000000000" pitchFamily="2" charset="0"/>
                 <a:cs typeface="Ramabhadra" panose="02000600000000000000" pitchFamily="2" charset="0"/>
               </a:rPr>
-              <a:t>నేనెందుకని నీ సొత్తుగా మారితిని</a:t>
-            </a:r>
+              <a:t>దేవా నా దేవా –</a:t>
+            </a:r>
+            <a:endParaRPr lang="en-IN" dirty="0">
+              <a:solidFill>
+                <a:schemeClr val="tx1"/>
+              </a:solidFill>
+              <a:latin typeface="Ramabhadra" panose="02000600000000000000" pitchFamily="2" charset="0"/>
+              <a:cs typeface="Ramabhadra" panose="02000600000000000000" pitchFamily="2" charset="0"/>
+            </a:endParaRPr>
           </a:p>
           <a:p>
             <a:pPr algn="ctr"/>
@@ -5095,12 +3945,9 @@
                 <a:latin typeface="Ramabhadra" panose="02000600000000000000" pitchFamily="2" charset="0"/>
                 <a:cs typeface="Ramabhadra" panose="02000600000000000000" pitchFamily="2" charset="0"/>
               </a:rPr>
-              <a:t>యేసయ్యా నీ రక్తముచే… కడుగబడినందున</a:t>
-            </a:r>
-          </a:p>
-          <a:p>
-            <a:pPr algn="ctr"/>
-            <a:r>
+              <a:t>నీవే నా కాపరి</a:t>
+            </a:r>
+            <a:br>
               <a:rPr lang="te-IN" dirty="0">
                 <a:solidFill>
                   <a:schemeClr val="tx1"/>
@@ -5108,8 +3955,134 @@
                 <a:latin typeface="Ramabhadra" panose="02000600000000000000" pitchFamily="2" charset="0"/>
                 <a:cs typeface="Ramabhadra" panose="02000600000000000000" pitchFamily="2" charset="0"/>
               </a:rPr>
-              <a:t>నీ అనాది ప్రణాళికలో… హర్షించెను నా హృదయసీమ</a:t>
-            </a:r>
+            </a:br>
+            <a:r>
+              <a:rPr lang="te-IN" dirty="0">
+                <a:solidFill>
+                  <a:schemeClr val="tx1"/>
+                </a:solidFill>
+                <a:latin typeface="Ramabhadra" panose="02000600000000000000" pitchFamily="2" charset="0"/>
+                <a:cs typeface="Ramabhadra" panose="02000600000000000000" pitchFamily="2" charset="0"/>
+              </a:rPr>
+              <a:t>నీ ప్రేమ నీ క్షమా –</a:t>
+            </a:r>
+            <a:endParaRPr lang="en-IN" dirty="0">
+              <a:solidFill>
+                <a:schemeClr val="tx1"/>
+              </a:solidFill>
+              <a:latin typeface="Ramabhadra" panose="02000600000000000000" pitchFamily="2" charset="0"/>
+              <a:cs typeface="Ramabhadra" panose="02000600000000000000" pitchFamily="2" charset="0"/>
+            </a:endParaRPr>
+          </a:p>
+          <a:p>
+            <a:pPr algn="ctr"/>
+            <a:r>
+              <a:rPr lang="te-IN" dirty="0">
+                <a:solidFill>
+                  <a:schemeClr val="tx1"/>
+                </a:solidFill>
+                <a:latin typeface="Ramabhadra" panose="02000600000000000000" pitchFamily="2" charset="0"/>
+                <a:cs typeface="Ramabhadra" panose="02000600000000000000" pitchFamily="2" charset="0"/>
+              </a:rPr>
+              <a:t>ఎంతో గొప్పది (2)</a:t>
+            </a:r>
+            <a:br>
+              <a:rPr lang="te-IN" dirty="0">
+                <a:solidFill>
+                  <a:schemeClr val="tx1"/>
+                </a:solidFill>
+                <a:latin typeface="Ramabhadra" panose="02000600000000000000" pitchFamily="2" charset="0"/>
+                <a:cs typeface="Ramabhadra" panose="02000600000000000000" pitchFamily="2" charset="0"/>
+              </a:rPr>
+            </a:br>
+            <a:r>
+              <a:rPr lang="te-IN" dirty="0">
+                <a:solidFill>
+                  <a:schemeClr val="tx1"/>
+                </a:solidFill>
+                <a:latin typeface="Ramabhadra" panose="02000600000000000000" pitchFamily="2" charset="0"/>
+                <a:cs typeface="Ramabhadra" panose="02000600000000000000" pitchFamily="2" charset="0"/>
+              </a:rPr>
+              <a:t>ఆరాధింతును హృదయాంతరంగములో</a:t>
+            </a:r>
+            <a:br>
+              <a:rPr lang="te-IN" dirty="0">
+                <a:solidFill>
+                  <a:schemeClr val="tx1"/>
+                </a:solidFill>
+                <a:latin typeface="Ramabhadra" panose="02000600000000000000" pitchFamily="2" charset="0"/>
+                <a:cs typeface="Ramabhadra" panose="02000600000000000000" pitchFamily="2" charset="0"/>
+              </a:rPr>
+            </a:br>
+            <a:r>
+              <a:rPr lang="te-IN" dirty="0">
+                <a:solidFill>
+                  <a:schemeClr val="tx1"/>
+                </a:solidFill>
+                <a:latin typeface="Ramabhadra" panose="02000600000000000000" pitchFamily="2" charset="0"/>
+                <a:cs typeface="Ramabhadra" panose="02000600000000000000" pitchFamily="2" charset="0"/>
+              </a:rPr>
+              <a:t>స్తుతియింతును</a:t>
+            </a:r>
+            <a:endParaRPr lang="en-IN" dirty="0">
+              <a:solidFill>
+                <a:schemeClr val="tx1"/>
+              </a:solidFill>
+              <a:latin typeface="Ramabhadra" panose="02000600000000000000" pitchFamily="2" charset="0"/>
+              <a:cs typeface="Ramabhadra" panose="02000600000000000000" pitchFamily="2" charset="0"/>
+            </a:endParaRPr>
+          </a:p>
+          <a:p>
+            <a:pPr algn="ctr"/>
+            <a:r>
+              <a:rPr lang="te-IN" dirty="0">
+                <a:solidFill>
+                  <a:schemeClr val="tx1"/>
+                </a:solidFill>
+                <a:latin typeface="Ramabhadra" panose="02000600000000000000" pitchFamily="2" charset="0"/>
+                <a:cs typeface="Ramabhadra" panose="02000600000000000000" pitchFamily="2" charset="0"/>
+              </a:rPr>
+              <a:t>నీ పాద సన్నిధిలో (2)</a:t>
+            </a:r>
+            <a:br>
+              <a:rPr lang="te-IN" dirty="0">
+                <a:solidFill>
+                  <a:schemeClr val="tx1"/>
+                </a:solidFill>
+                <a:latin typeface="Ramabhadra" panose="02000600000000000000" pitchFamily="2" charset="0"/>
+                <a:cs typeface="Ramabhadra" panose="02000600000000000000" pitchFamily="2" charset="0"/>
+              </a:rPr>
+            </a:br>
+            <a:r>
+              <a:rPr lang="te-IN" dirty="0">
+                <a:solidFill>
+                  <a:schemeClr val="tx1"/>
+                </a:solidFill>
+                <a:latin typeface="Ramabhadra" panose="02000600000000000000" pitchFamily="2" charset="0"/>
+                <a:cs typeface="Ramabhadra" panose="02000600000000000000" pitchFamily="2" charset="0"/>
+              </a:rPr>
+              <a:t>నీవే కదా దేవుడవు – (2)</a:t>
+            </a:r>
+          </a:p>
+          <a:p>
+            <a:pPr algn="ctr"/>
+            <a:r>
+              <a:rPr lang="te-IN" dirty="0">
+                <a:solidFill>
+                  <a:schemeClr val="tx1"/>
+                </a:solidFill>
+                <a:latin typeface="Ramabhadra" panose="02000600000000000000" pitchFamily="2" charset="0"/>
+                <a:cs typeface="Ramabhadra" panose="02000600000000000000" pitchFamily="2" charset="0"/>
+              </a:rPr>
+              <a:t>దేవా యేసు దేవా (4)</a:t>
+            </a:r>
+            <a:endParaRPr lang="en-IN" dirty="0">
+              <a:solidFill>
+                <a:schemeClr val="tx1"/>
+              </a:solidFill>
+              <a:latin typeface="Ramabhadra" panose="02000600000000000000" pitchFamily="2" charset="0"/>
+              <a:cs typeface="Ramabhadra" panose="02000600000000000000" pitchFamily="2" charset="0"/>
+            </a:endParaRPr>
           </a:p>
           <a:p>
             <a:pPr algn="ctr"/>
@@ -5131,7 +4104,106 @@
                 <a:latin typeface="Ramabhadra" panose="02000600000000000000" pitchFamily="2" charset="0"/>
                 <a:cs typeface="Ramabhadra" panose="02000600000000000000" pitchFamily="2" charset="0"/>
               </a:rPr>
-              <a:t>నీ పరిచర్యను తుదముట్టించుటే…</a:t>
+              <a:t>పాపము నుండి విడిపించినావు</a:t>
+            </a:r>
+            <a:br>
+              <a:rPr lang="te-IN" dirty="0">
+                <a:solidFill>
+                  <a:schemeClr val="tx1"/>
+                </a:solidFill>
+                <a:latin typeface="Ramabhadra" panose="02000600000000000000" pitchFamily="2" charset="0"/>
+                <a:cs typeface="Ramabhadra" panose="02000600000000000000" pitchFamily="2" charset="0"/>
+              </a:rPr>
+            </a:br>
+            <a:r>
+              <a:rPr lang="te-IN" dirty="0">
+                <a:solidFill>
+                  <a:schemeClr val="tx1"/>
+                </a:solidFill>
+                <a:latin typeface="Ramabhadra" panose="02000600000000000000" pitchFamily="2" charset="0"/>
+                <a:cs typeface="Ramabhadra" panose="02000600000000000000" pitchFamily="2" charset="0"/>
+              </a:rPr>
+              <a:t>పరిశుద్ధుని చేసి ప్రేమించినావు (2)</a:t>
+            </a:r>
+            <a:br>
+              <a:rPr lang="te-IN" dirty="0">
+                <a:solidFill>
+                  <a:schemeClr val="tx1"/>
+                </a:solidFill>
+                <a:latin typeface="Ramabhadra" panose="02000600000000000000" pitchFamily="2" charset="0"/>
+                <a:cs typeface="Ramabhadra" panose="02000600000000000000" pitchFamily="2" charset="0"/>
+              </a:rPr>
+            </a:br>
+            <a:r>
+              <a:rPr lang="te-IN" dirty="0">
+                <a:solidFill>
+                  <a:schemeClr val="tx1"/>
+                </a:solidFill>
+                <a:latin typeface="Ramabhadra" panose="02000600000000000000" pitchFamily="2" charset="0"/>
+                <a:cs typeface="Ramabhadra" panose="02000600000000000000" pitchFamily="2" charset="0"/>
+              </a:rPr>
+              <a:t>నీవే కదా దేవుడవు – (2)</a:t>
+            </a:r>
+            <a:br>
+              <a:rPr lang="te-IN" dirty="0">
+                <a:solidFill>
+                  <a:schemeClr val="tx1"/>
+                </a:solidFill>
+                <a:latin typeface="Ramabhadra" panose="02000600000000000000" pitchFamily="2" charset="0"/>
+                <a:cs typeface="Ramabhadra" panose="02000600000000000000" pitchFamily="2" charset="0"/>
+              </a:rPr>
+            </a:br>
+            <a:r>
+              <a:rPr lang="te-IN" dirty="0">
+                <a:solidFill>
+                  <a:schemeClr val="tx1"/>
+                </a:solidFill>
+                <a:latin typeface="Ramabhadra" panose="02000600000000000000" pitchFamily="2" charset="0"/>
+                <a:cs typeface="Ramabhadra" panose="02000600000000000000" pitchFamily="2" charset="0"/>
+              </a:rPr>
+              <a:t>దేవా యేసు దేవా (4)</a:t>
+            </a:r>
+          </a:p>
+          <a:p>
+            <a:pPr algn="ctr"/>
+            <a:endParaRPr lang="te-IN" dirty="0">
+              <a:solidFill>
+                <a:schemeClr val="tx1"/>
+              </a:solidFill>
+              <a:latin typeface="Ramabhadra" panose="02000600000000000000" pitchFamily="2" charset="0"/>
+              <a:cs typeface="Ramabhadra" panose="02000600000000000000" pitchFamily="2" charset="0"/>
+            </a:endParaRPr>
+          </a:p>
+          <a:p>
+            <a:pPr algn="ctr"/>
+            <a:r>
+              <a:rPr lang="te-IN" dirty="0">
+                <a:solidFill>
+                  <a:schemeClr val="tx1"/>
+                </a:solidFill>
+                <a:latin typeface="Ramabhadra" panose="02000600000000000000" pitchFamily="2" charset="0"/>
+                <a:cs typeface="Ramabhadra" panose="02000600000000000000" pitchFamily="2" charset="0"/>
+              </a:rPr>
+              <a:t>పరిశుద్ధాత్మను నాలో నింపావు</a:t>
+            </a:r>
+            <a:br>
+              <a:rPr lang="te-IN" dirty="0">
+                <a:solidFill>
+                  <a:schemeClr val="tx1"/>
+                </a:solidFill>
+                <a:latin typeface="Ramabhadra" panose="02000600000000000000" pitchFamily="2" charset="0"/>
+                <a:cs typeface="Ramabhadra" panose="02000600000000000000" pitchFamily="2" charset="0"/>
+              </a:rPr>
+            </a:br>
+            <a:r>
+              <a:rPr lang="te-IN" dirty="0">
+                <a:solidFill>
+                  <a:schemeClr val="tx1"/>
+                </a:solidFill>
+                <a:latin typeface="Ramabhadra" panose="02000600000000000000" pitchFamily="2" charset="0"/>
+                <a:cs typeface="Ramabhadra" panose="02000600000000000000" pitchFamily="2" charset="0"/>
+              </a:rPr>
+              <a:t>మట్టి దేహమును</a:t>
             </a:r>
             <a:endParaRPr lang="en-IN" dirty="0">
               <a:solidFill>
@@ -5151,12 +4223,9 @@
                 <a:latin typeface="Ramabhadra" panose="02000600000000000000" pitchFamily="2" charset="0"/>
                 <a:cs typeface="Ramabhadra" panose="02000600000000000000" pitchFamily="2" charset="0"/>
               </a:rPr>
-              <a:t>నా నియమమాయెనే</a:t>
-            </a:r>
-          </a:p>
-          <a:p>
-            <a:pPr algn="ctr"/>
-            <a:r>
+              <a:t>మహిమతో నింపావు (2)</a:t>
+            </a:r>
+            <a:br>
               <a:rPr lang="te-IN" dirty="0">
                 <a:solidFill>
                   <a:schemeClr val="tx1"/>
@@ -5164,11 +4233,7 @@
                 <a:latin typeface="Ramabhadra" panose="02000600000000000000" pitchFamily="2" charset="0"/>
                 <a:cs typeface="Ramabhadra" panose="02000600000000000000" pitchFamily="2" charset="0"/>
               </a:rPr>
-              <a:t>నీ సన్నిధిలో నీ పోందుకోరి… నీ స్నేహితుడనైతినే</a:t>
-            </a:r>
-          </a:p>
-          <a:p>
-            <a:pPr algn="ctr"/>
+            </a:br>
             <a:r>
               <a:rPr lang="te-IN" dirty="0">
                 <a:solidFill>
@@ -5177,19 +4242,9 @@
                 <a:latin typeface="Ramabhadra" panose="02000600000000000000" pitchFamily="2" charset="0"/>
                 <a:cs typeface="Ramabhadra" panose="02000600000000000000" pitchFamily="2" charset="0"/>
               </a:rPr>
-              <a:t>అహా..! నాధన్యత</a:t>
-            </a:r>
-            <a:endParaRPr lang="en-IN" dirty="0">
-              <a:solidFill>
-                <a:schemeClr val="tx1"/>
-              </a:solidFill>
-              <a:latin typeface="Ramabhadra" panose="02000600000000000000" pitchFamily="2" charset="0"/>
-              <a:cs typeface="Ramabhadra" panose="02000600000000000000" pitchFamily="2" charset="0"/>
-            </a:endParaRPr>
-          </a:p>
-          <a:p>
-            <a:pPr algn="ctr"/>
-            <a:r>
+              <a:t>నీవే కదా దేవుడవు – (2)</a:t>
+            </a:r>
+            <a:br>
               <a:rPr lang="te-IN" dirty="0">
                 <a:solidFill>
                   <a:schemeClr val="tx1"/>
@@ -5197,18 +4252,7 @@
                 <a:latin typeface="Ramabhadra" panose="02000600000000000000" pitchFamily="2" charset="0"/>
                 <a:cs typeface="Ramabhadra" panose="02000600000000000000" pitchFamily="2" charset="0"/>
               </a:rPr>
-              <a:t>ఓహో…! నాభాగ్యము…</a:t>
-            </a:r>
-            <a:endParaRPr lang="en-IN" dirty="0">
-              <a:solidFill>
-                <a:schemeClr val="tx1"/>
-              </a:solidFill>
-              <a:latin typeface="Ramabhadra" panose="02000600000000000000" pitchFamily="2" charset="0"/>
-              <a:cs typeface="Ramabhadra" panose="02000600000000000000" pitchFamily="2" charset="0"/>
-            </a:endParaRPr>
-          </a:p>
-          <a:p>
-            <a:pPr algn="ctr"/>
+            </a:br>
             <a:r>
               <a:rPr lang="te-IN" dirty="0">
                 <a:solidFill>
@@ -5217,116 +4261,7 @@
                 <a:latin typeface="Ramabhadra" panose="02000600000000000000" pitchFamily="2" charset="0"/>
                 <a:cs typeface="Ramabhadra" panose="02000600000000000000" pitchFamily="2" charset="0"/>
               </a:rPr>
-              <a:t>ఏమని వివరింతును</a:t>
-            </a:r>
-          </a:p>
-          <a:p>
-            <a:pPr algn="ctr"/>
-            <a:endParaRPr lang="te-IN" dirty="0">
-              <a:solidFill>
-                <a:schemeClr val="tx1"/>
-              </a:solidFill>
-              <a:latin typeface="Ramabhadra" panose="02000600000000000000" pitchFamily="2" charset="0"/>
-              <a:cs typeface="Ramabhadra" panose="02000600000000000000" pitchFamily="2" charset="0"/>
-            </a:endParaRPr>
-          </a:p>
-          <a:p>
-            <a:pPr algn="ctr"/>
-            <a:r>
-              <a:rPr lang="te-IN" dirty="0">
-                <a:solidFill>
-                  <a:schemeClr val="tx1"/>
-                </a:solidFill>
-                <a:latin typeface="Ramabhadra" panose="02000600000000000000" pitchFamily="2" charset="0"/>
-                <a:cs typeface="Ramabhadra" panose="02000600000000000000" pitchFamily="2" charset="0"/>
-              </a:rPr>
-              <a:t>నీ శ్రమలలో పాలొందుటయే… నా దర్శనమాయెనే</a:t>
-            </a:r>
-          </a:p>
-          <a:p>
-            <a:pPr algn="ctr"/>
-            <a:r>
-              <a:rPr lang="te-IN" dirty="0">
-                <a:solidFill>
-                  <a:schemeClr val="tx1"/>
-                </a:solidFill>
-                <a:latin typeface="Ramabhadra" panose="02000600000000000000" pitchFamily="2" charset="0"/>
-                <a:cs typeface="Ramabhadra" panose="02000600000000000000" pitchFamily="2" charset="0"/>
-              </a:rPr>
-              <a:t>నా తనువందున</a:t>
-            </a:r>
-            <a:endParaRPr lang="en-IN" dirty="0">
-              <a:solidFill>
-                <a:schemeClr val="tx1"/>
-              </a:solidFill>
-              <a:latin typeface="Ramabhadra" panose="02000600000000000000" pitchFamily="2" charset="0"/>
-              <a:cs typeface="Ramabhadra" panose="02000600000000000000" pitchFamily="2" charset="0"/>
-            </a:endParaRPr>
-          </a:p>
-          <a:p>
-            <a:pPr algn="ctr"/>
-            <a:r>
-              <a:rPr lang="te-IN" dirty="0">
-                <a:solidFill>
-                  <a:schemeClr val="tx1"/>
-                </a:solidFill>
-                <a:latin typeface="Ramabhadra" panose="02000600000000000000" pitchFamily="2" charset="0"/>
-                <a:cs typeface="Ramabhadra" panose="02000600000000000000" pitchFamily="2" charset="0"/>
-              </a:rPr>
-              <a:t>శ్రమలు సహించి…</a:t>
-            </a:r>
-            <a:endParaRPr lang="en-IN" dirty="0">
-              <a:solidFill>
-                <a:schemeClr val="tx1"/>
-              </a:solidFill>
-              <a:latin typeface="Ramabhadra" panose="02000600000000000000" pitchFamily="2" charset="0"/>
-              <a:cs typeface="Ramabhadra" panose="02000600000000000000" pitchFamily="2" charset="0"/>
-            </a:endParaRPr>
-          </a:p>
-          <a:p>
-            <a:pPr algn="ctr"/>
-            <a:r>
-              <a:rPr lang="te-IN" dirty="0">
-                <a:solidFill>
-                  <a:schemeClr val="tx1"/>
-                </a:solidFill>
-                <a:latin typeface="Ramabhadra" panose="02000600000000000000" pitchFamily="2" charset="0"/>
-                <a:cs typeface="Ramabhadra" panose="02000600000000000000" pitchFamily="2" charset="0"/>
-              </a:rPr>
-              <a:t>నీ వారసుడనైతినే</a:t>
-            </a:r>
-          </a:p>
-          <a:p>
-            <a:pPr algn="ctr"/>
-            <a:r>
-              <a:rPr lang="te-IN" dirty="0">
-                <a:solidFill>
-                  <a:schemeClr val="tx1"/>
-                </a:solidFill>
-                <a:latin typeface="Ramabhadra" panose="02000600000000000000" pitchFamily="2" charset="0"/>
-                <a:cs typeface="Ramabhadra" panose="02000600000000000000" pitchFamily="2" charset="0"/>
-              </a:rPr>
-              <a:t>అహా..! నాధన్యత</a:t>
-            </a:r>
-            <a:endParaRPr lang="en-IN" dirty="0">
-              <a:solidFill>
-                <a:schemeClr val="tx1"/>
-              </a:solidFill>
-              <a:latin typeface="Ramabhadra" panose="02000600000000000000" pitchFamily="2" charset="0"/>
-              <a:cs typeface="Ramabhadra" panose="02000600000000000000" pitchFamily="2" charset="0"/>
-            </a:endParaRPr>
-          </a:p>
-          <a:p>
-            <a:pPr algn="ctr"/>
-            <a:r>
-              <a:rPr lang="te-IN" dirty="0">
-                <a:solidFill>
-                  <a:schemeClr val="tx1"/>
-                </a:solidFill>
-                <a:latin typeface="Ramabhadra" panose="02000600000000000000" pitchFamily="2" charset="0"/>
-                <a:cs typeface="Ramabhadra" panose="02000600000000000000" pitchFamily="2" charset="0"/>
-              </a:rPr>
-              <a:t>ఓహో…! నాభాగ్యము… ఏమని వివరింతును</a:t>
+              <a:t>దేవా యేసు దేవా (4)</a:t>
             </a:r>
           </a:p>
         </p:txBody>
@@ -5391,7 +4326,7 @@
                 <a:latin typeface="Ramabhadra" panose="02000600000000000000" pitchFamily="2" charset="0"/>
                 <a:cs typeface="Ramabhadra" panose="02000600000000000000" pitchFamily="2" charset="0"/>
               </a:rPr>
-              <a:t>శృతిచేసి నే పాడనా</a:t>
+              <a:t>స్తుతించి పాడెదం –</a:t>
             </a:r>
             <a:endParaRPr lang="en-IN" dirty="0">
               <a:solidFill>
@@ -5411,9 +4346,12 @@
                 <a:latin typeface="Ramabhadra" panose="02000600000000000000" pitchFamily="2" charset="0"/>
                 <a:cs typeface="Ramabhadra" panose="02000600000000000000" pitchFamily="2" charset="0"/>
               </a:rPr>
-              <a:t>స్తోత్ర గీతం</a:t>
-            </a:r>
-            <a:br>
+              <a:t>స్తుతుల స్తోత్రార్హుడా</a:t>
+            </a:r>
+          </a:p>
+          <a:p>
+            <a:pPr algn="ctr"/>
+            <a:r>
               <a:rPr lang="te-IN" dirty="0">
                 <a:solidFill>
                   <a:schemeClr val="tx1"/>
@@ -5421,7 +4359,11 @@
                 <a:latin typeface="Ramabhadra" panose="02000600000000000000" pitchFamily="2" charset="0"/>
                 <a:cs typeface="Ramabhadra" panose="02000600000000000000" pitchFamily="2" charset="0"/>
               </a:rPr>
-            </a:br>
+              <a:t>ఉత్సాహించి పాడెదం – ఉదయ సాయంత్రముల్</a:t>
+            </a:r>
+          </a:p>
+          <a:p>
+            <a:pPr algn="ctr"/>
             <a:r>
               <a:rPr lang="te-IN" dirty="0">
                 <a:solidFill>
@@ -5430,9 +4372,12 @@
                 <a:latin typeface="Ramabhadra" panose="02000600000000000000" pitchFamily="2" charset="0"/>
                 <a:cs typeface="Ramabhadra" panose="02000600000000000000" pitchFamily="2" charset="0"/>
               </a:rPr>
-              <a:t>భజియించి నే పొగడనా స్వామీ (2)</a:t>
-            </a:r>
-            <a:br>
+              <a:t>స్తుతుల సింహాసనం</a:t>
+            </a:r>
+          </a:p>
+          <a:p>
+            <a:pPr algn="ctr"/>
+            <a:r>
               <a:rPr lang="te-IN" dirty="0">
                 <a:solidFill>
                   <a:schemeClr val="tx1"/>
@@ -5440,7 +4385,18 @@
                 <a:latin typeface="Ramabhadra" panose="02000600000000000000" pitchFamily="2" charset="0"/>
                 <a:cs typeface="Ramabhadra" panose="02000600000000000000" pitchFamily="2" charset="0"/>
               </a:rPr>
-            </a:br>
+              <a:t>మీద</a:t>
+            </a:r>
+            <a:r>
+              <a:rPr lang="en-IN" dirty="0">
+                <a:solidFill>
+                  <a:schemeClr val="tx1"/>
+                </a:solidFill>
+                <a:latin typeface="Ramabhadra" panose="02000600000000000000" pitchFamily="2" charset="0"/>
+                <a:cs typeface="Ramabhadra" panose="02000600000000000000" pitchFamily="2" charset="0"/>
+              </a:rPr>
+              <a:t> </a:t>
+            </a:r>
             <a:r>
               <a:rPr lang="te-IN" dirty="0">
                 <a:solidFill>
@@ -5449,7 +4405,33 @@
                 <a:latin typeface="Ramabhadra" panose="02000600000000000000" pitchFamily="2" charset="0"/>
                 <a:cs typeface="Ramabhadra" panose="02000600000000000000" pitchFamily="2" charset="0"/>
               </a:rPr>
-              <a:t>శృతిచేసి నే పాడనా</a:t>
+              <a:t>ఆసీనుడా</a:t>
+            </a:r>
+          </a:p>
+          <a:p>
+            <a:pPr algn="ctr"/>
+            <a:r>
+              <a:rPr lang="te-IN" dirty="0">
+                <a:solidFill>
+                  <a:schemeClr val="tx1"/>
+                </a:solidFill>
+                <a:latin typeface="Ramabhadra" panose="02000600000000000000" pitchFamily="2" charset="0"/>
+                <a:cs typeface="Ramabhadra" panose="02000600000000000000" pitchFamily="2" charset="0"/>
+              </a:rPr>
+              <a:t>మా స్తుతి ఆరాధన</a:t>
+            </a:r>
+          </a:p>
+          <a:p>
+            <a:pPr algn="ctr"/>
+            <a:r>
+              <a:rPr lang="te-IN" dirty="0">
+                <a:solidFill>
+                  <a:schemeClr val="tx1"/>
+                </a:solidFill>
+                <a:latin typeface="Ramabhadra" panose="02000600000000000000" pitchFamily="2" charset="0"/>
+                <a:cs typeface="Ramabhadra" panose="02000600000000000000" pitchFamily="2" charset="0"/>
+              </a:rPr>
+              <a:t>నీకే చెల్లింతుము (2)</a:t>
             </a:r>
             <a:endParaRPr lang="en-IN" dirty="0">
               <a:solidFill>
@@ -5461,6 +4443,16 @@
           </a:p>
           <a:p>
             <a:pPr algn="ctr"/>
+            <a:endParaRPr lang="te-IN" dirty="0">
+              <a:solidFill>
+                <a:schemeClr val="tx1"/>
+              </a:solidFill>
+              <a:latin typeface="Ramabhadra" panose="02000600000000000000" pitchFamily="2" charset="0"/>
+              <a:cs typeface="Ramabhadra" panose="02000600000000000000" pitchFamily="2" charset="0"/>
+            </a:endParaRPr>
+          </a:p>
+          <a:p>
+            <a:pPr algn="ctr"/>
             <a:r>
               <a:rPr lang="te-IN" dirty="0">
                 <a:solidFill>
@@ -5469,71 +4461,7 @@
                 <a:latin typeface="Ramabhadra" panose="02000600000000000000" pitchFamily="2" charset="0"/>
                 <a:cs typeface="Ramabhadra" panose="02000600000000000000" pitchFamily="2" charset="0"/>
               </a:rPr>
-              <a:t>స్తోత్ర గీతం</a:t>
-            </a:r>
-            <a:br>
-              <a:rPr lang="te-IN" dirty="0">
-                <a:solidFill>
-                  <a:schemeClr val="tx1"/>
-                </a:solidFill>
-                <a:latin typeface="Ramabhadra" panose="02000600000000000000" pitchFamily="2" charset="0"/>
-                <a:cs typeface="Ramabhadra" panose="02000600000000000000" pitchFamily="2" charset="0"/>
-              </a:rPr>
-            </a:br>
-            <a:r>
-              <a:rPr lang="te-IN" dirty="0">
-                <a:solidFill>
-                  <a:schemeClr val="tx1"/>
-                </a:solidFill>
-                <a:latin typeface="Ramabhadra" panose="02000600000000000000" pitchFamily="2" charset="0"/>
-                <a:cs typeface="Ramabhadra" panose="02000600000000000000" pitchFamily="2" charset="0"/>
-              </a:rPr>
-              <a:t>హల్లేలూయా హల్లేలూయా</a:t>
-            </a:r>
-            <a:br>
-              <a:rPr lang="te-IN" dirty="0">
-                <a:solidFill>
-                  <a:schemeClr val="tx1"/>
-                </a:solidFill>
-                <a:latin typeface="Ramabhadra" panose="02000600000000000000" pitchFamily="2" charset="0"/>
-                <a:cs typeface="Ramabhadra" panose="02000600000000000000" pitchFamily="2" charset="0"/>
-              </a:rPr>
-            </a:br>
-            <a:r>
-              <a:rPr lang="te-IN" dirty="0">
-                <a:solidFill>
-                  <a:schemeClr val="tx1"/>
-                </a:solidFill>
-                <a:latin typeface="Ramabhadra" panose="02000600000000000000" pitchFamily="2" charset="0"/>
-                <a:cs typeface="Ramabhadra" panose="02000600000000000000" pitchFamily="2" charset="0"/>
-              </a:rPr>
-              <a:t>హల్లెలూయ హల్లెలూయ హల్లేలుయా (2)     </a:t>
-            </a:r>
-          </a:p>
-          <a:p>
-            <a:pPr algn="ctr"/>
-            <a:r>
-              <a:rPr lang="te-IN" dirty="0">
-                <a:solidFill>
-                  <a:schemeClr val="tx1"/>
-                </a:solidFill>
-                <a:latin typeface="Ramabhadra" panose="02000600000000000000" pitchFamily="2" charset="0"/>
-                <a:cs typeface="Ramabhadra" panose="02000600000000000000" pitchFamily="2" charset="0"/>
-              </a:rPr>
-              <a:t> </a:t>
-            </a:r>
-          </a:p>
-          <a:p>
-            <a:pPr algn="ctr"/>
-            <a:r>
-              <a:rPr lang="te-IN" dirty="0">
-                <a:solidFill>
-                  <a:schemeClr val="tx1"/>
-                </a:solidFill>
-                <a:latin typeface="Ramabhadra" panose="02000600000000000000" pitchFamily="2" charset="0"/>
-                <a:cs typeface="Ramabhadra" panose="02000600000000000000" pitchFamily="2" charset="0"/>
-              </a:rPr>
-              <a:t>దానియేలును</a:t>
+              <a:t>గతకాలమంతా నీవు –</a:t>
             </a:r>
             <a:endParaRPr lang="en-IN" dirty="0">
               <a:solidFill>
@@ -5553,9 +4481,12 @@
                 <a:latin typeface="Ramabhadra" panose="02000600000000000000" pitchFamily="2" charset="0"/>
                 <a:cs typeface="Ramabhadra" panose="02000600000000000000" pitchFamily="2" charset="0"/>
               </a:rPr>
-              <a:t>సింహపు బోనులో</a:t>
-            </a:r>
-            <a:br>
+              <a:t>మము కాచి కాపాడావు</a:t>
+            </a:r>
+          </a:p>
+          <a:p>
+            <a:pPr algn="ctr"/>
+            <a:r>
               <a:rPr lang="te-IN" dirty="0">
                 <a:solidFill>
                   <a:schemeClr val="tx1"/>
@@ -5563,7 +4494,11 @@
                 <a:latin typeface="Ramabhadra" panose="02000600000000000000" pitchFamily="2" charset="0"/>
                 <a:cs typeface="Ramabhadra" panose="02000600000000000000" pitchFamily="2" charset="0"/>
               </a:rPr>
-            </a:br>
+              <a:t>వ్యధలన్ని తీసావు (2)</a:t>
+            </a:r>
+          </a:p>
+          <a:p>
+            <a:pPr algn="ctr"/>
             <a:r>
               <a:rPr lang="te-IN" dirty="0">
                 <a:solidFill>
@@ -5572,9 +4507,12 @@
                 <a:latin typeface="Ramabhadra" panose="02000600000000000000" pitchFamily="2" charset="0"/>
                 <a:cs typeface="Ramabhadra" panose="02000600000000000000" pitchFamily="2" charset="0"/>
               </a:rPr>
-              <a:t>కాపాడినది నీవెకదా (2)</a:t>
-            </a:r>
-            <a:br>
+              <a:t>గతి లేని మాపై నీవు</a:t>
+            </a:r>
+          </a:p>
+          <a:p>
+            <a:pPr algn="ctr"/>
+            <a:r>
               <a:rPr lang="te-IN" dirty="0">
                 <a:solidFill>
                   <a:schemeClr val="tx1"/>
@@ -5582,7 +4520,11 @@
                 <a:latin typeface="Ramabhadra" panose="02000600000000000000" pitchFamily="2" charset="0"/>
                 <a:cs typeface="Ramabhadra" panose="02000600000000000000" pitchFamily="2" charset="0"/>
               </a:rPr>
-            </a:br>
+              <a:t>మితిలేని ప్రేమ చూపి (2)</a:t>
+            </a:r>
+          </a:p>
+          <a:p>
+            <a:pPr algn="ctr"/>
             <a:r>
               <a:rPr lang="te-IN" dirty="0">
                 <a:solidFill>
@@ -5591,7 +4533,7 @@
                 <a:latin typeface="Ramabhadra" panose="02000600000000000000" pitchFamily="2" charset="0"/>
                 <a:cs typeface="Ramabhadra" panose="02000600000000000000" pitchFamily="2" charset="0"/>
               </a:rPr>
-              <a:t>జలప్రళయములో</a:t>
+              <a:t>శత సంఖ్యగా</a:t>
             </a:r>
             <a:endParaRPr lang="en-IN" dirty="0">
               <a:solidFill>
@@ -5611,9 +4553,19 @@
                 <a:latin typeface="Ramabhadra" panose="02000600000000000000" pitchFamily="2" charset="0"/>
                 <a:cs typeface="Ramabhadra" panose="02000600000000000000" pitchFamily="2" charset="0"/>
               </a:rPr>
-              <a:t>నోవాహును గాచిన</a:t>
-            </a:r>
-            <a:br>
+              <a:t>మమ్ము</a:t>
+            </a:r>
+            <a:r>
+              <a:rPr lang="en-IN" dirty="0">
+                <a:solidFill>
+                  <a:schemeClr val="tx1"/>
+                </a:solidFill>
+                <a:latin typeface="Ramabhadra" panose="02000600000000000000" pitchFamily="2" charset="0"/>
+                <a:cs typeface="Ramabhadra" panose="02000600000000000000" pitchFamily="2" charset="0"/>
+              </a:rPr>
+              <a:t> </a:t>
+            </a:r>
+            <a:r>
               <a:rPr lang="te-IN" dirty="0">
                 <a:solidFill>
                   <a:schemeClr val="tx1"/>
@@ -5621,46 +4573,11 @@
                 <a:latin typeface="Ramabhadra" panose="02000600000000000000" pitchFamily="2" charset="0"/>
                 <a:cs typeface="Ramabhadra" panose="02000600000000000000" pitchFamily="2" charset="0"/>
               </a:rPr>
-            </a:br>
-            <a:r>
-              <a:rPr lang="te-IN" dirty="0">
-                <a:solidFill>
-                  <a:schemeClr val="tx1"/>
-                </a:solidFill>
-                <a:latin typeface="Ramabhadra" panose="02000600000000000000" pitchFamily="2" charset="0"/>
-                <a:cs typeface="Ramabhadra" panose="02000600000000000000" pitchFamily="2" charset="0"/>
-              </a:rPr>
-              <a:t>బలవంతుడవు నీవెకదా (2)</a:t>
-            </a:r>
-            <a:br>
-              <a:rPr lang="te-IN" dirty="0">
-                <a:solidFill>
-                  <a:schemeClr val="tx1"/>
-                </a:solidFill>
-                <a:latin typeface="Ramabhadra" panose="02000600000000000000" pitchFamily="2" charset="0"/>
-                <a:cs typeface="Ramabhadra" panose="02000600000000000000" pitchFamily="2" charset="0"/>
-              </a:rPr>
-            </a:br>
-            <a:r>
-              <a:rPr lang="te-IN" dirty="0">
-                <a:solidFill>
-                  <a:schemeClr val="tx1"/>
-                </a:solidFill>
-                <a:latin typeface="Ramabhadra" panose="02000600000000000000" pitchFamily="2" charset="0"/>
-                <a:cs typeface="Ramabhadra" panose="02000600000000000000" pitchFamily="2" charset="0"/>
-              </a:rPr>
-              <a:t>నీవెకదా (3</a:t>
-            </a:r>
-            <a:r>
-              <a:rPr lang="en-IN" dirty="0">
-                <a:solidFill>
-                  <a:schemeClr val="tx1"/>
-                </a:solidFill>
-                <a:latin typeface="Ramabhadra" panose="02000600000000000000" pitchFamily="2" charset="0"/>
-                <a:cs typeface="Ramabhadra" panose="02000600000000000000" pitchFamily="2" charset="0"/>
-              </a:rPr>
-              <a:t>)</a:t>
-            </a:r>
+              <a:t>దీవించావు</a:t>
+            </a:r>
+          </a:p>
+          <a:p>
+            <a:pPr algn="ctr"/>
             <a:endParaRPr lang="te-IN" dirty="0">
               <a:solidFill>
                 <a:schemeClr val="tx1"/>
@@ -5671,16 +4588,6 @@
           </a:p>
           <a:p>
             <a:pPr algn="ctr"/>
-            <a:endParaRPr lang="te-IN" dirty="0">
-              <a:solidFill>
-                <a:schemeClr val="tx1"/>
-              </a:solidFill>
-              <a:latin typeface="Ramabhadra" panose="02000600000000000000" pitchFamily="2" charset="0"/>
-              <a:cs typeface="Ramabhadra" panose="02000600000000000000" pitchFamily="2" charset="0"/>
-            </a:endParaRPr>
-          </a:p>
-          <a:p>
-            <a:pPr algn="ctr"/>
             <a:r>
               <a:rPr lang="te-IN" dirty="0">
                 <a:solidFill>
@@ -5689,9 +4596,12 @@
                 <a:latin typeface="Ramabhadra" panose="02000600000000000000" pitchFamily="2" charset="0"/>
                 <a:cs typeface="Ramabhadra" panose="02000600000000000000" pitchFamily="2" charset="0"/>
               </a:rPr>
-              <a:t>సమరయ స్త్రీని కరుణతో బ్రోచిన</a:t>
-            </a:r>
-            <a:br>
+              <a:t>కరుణా కటాక్షములను కిరీటములగాను</a:t>
+            </a:r>
+          </a:p>
+          <a:p>
+            <a:pPr algn="ctr"/>
+            <a:r>
               <a:rPr lang="te-IN" dirty="0">
                 <a:solidFill>
                   <a:schemeClr val="tx1"/>
@@ -5699,7 +4609,11 @@
                 <a:latin typeface="Ramabhadra" panose="02000600000000000000" pitchFamily="2" charset="0"/>
                 <a:cs typeface="Ramabhadra" panose="02000600000000000000" pitchFamily="2" charset="0"/>
               </a:rPr>
-            </a:br>
+              <a:t>ఉంచావు మా తలపై (2)</a:t>
+            </a:r>
+          </a:p>
+          <a:p>
+            <a:pPr algn="ctr"/>
             <a:r>
               <a:rPr lang="te-IN" dirty="0">
                 <a:solidFill>
@@ -5708,9 +4622,12 @@
                 <a:latin typeface="Ramabhadra" panose="02000600000000000000" pitchFamily="2" charset="0"/>
                 <a:cs typeface="Ramabhadra" panose="02000600000000000000" pitchFamily="2" charset="0"/>
               </a:rPr>
-              <a:t>సత్య హితుడవు నీవెకదా (2)</a:t>
-            </a:r>
-            <a:br>
+              <a:t>పక్షి రాజు యవ్వనమువలె</a:t>
+            </a:r>
+          </a:p>
+          <a:p>
+            <a:pPr algn="ctr"/>
+            <a:r>
               <a:rPr lang="te-IN" dirty="0">
                 <a:solidFill>
                   <a:schemeClr val="tx1"/>
@@ -5718,7 +4635,11 @@
                 <a:latin typeface="Ramabhadra" panose="02000600000000000000" pitchFamily="2" charset="0"/>
                 <a:cs typeface="Ramabhadra" panose="02000600000000000000" pitchFamily="2" charset="0"/>
               </a:rPr>
-            </a:br>
+              <a:t>మా యవ్వనమునంతా (2)</a:t>
+            </a:r>
+          </a:p>
+          <a:p>
+            <a:pPr algn="ctr"/>
             <a:r>
               <a:rPr lang="te-IN" dirty="0">
                 <a:solidFill>
@@ -5727,45 +4648,7 @@
                 <a:latin typeface="Ramabhadra" panose="02000600000000000000" pitchFamily="2" charset="0"/>
                 <a:cs typeface="Ramabhadra" panose="02000600000000000000" pitchFamily="2" charset="0"/>
               </a:rPr>
-              <a:t>పాపులకొరకై ప్రాణమునిచ్చిన</a:t>
-            </a:r>
-            <a:br>
-              <a:rPr lang="te-IN" dirty="0">
-                <a:solidFill>
-                  <a:schemeClr val="tx1"/>
-                </a:solidFill>
-                <a:latin typeface="Ramabhadra" panose="02000600000000000000" pitchFamily="2" charset="0"/>
-                <a:cs typeface="Ramabhadra" panose="02000600000000000000" pitchFamily="2" charset="0"/>
-              </a:rPr>
-            </a:br>
-            <a:r>
-              <a:rPr lang="te-IN" dirty="0">
-                <a:solidFill>
-                  <a:schemeClr val="tx1"/>
-                </a:solidFill>
-                <a:latin typeface="Ramabhadra" panose="02000600000000000000" pitchFamily="2" charset="0"/>
-                <a:cs typeface="Ramabhadra" panose="02000600000000000000" pitchFamily="2" charset="0"/>
-              </a:rPr>
-              <a:t>కరుణామయుడవు నీవెకదా (2)</a:t>
-            </a:r>
-            <a:br>
-              <a:rPr lang="te-IN" dirty="0">
-                <a:solidFill>
-                  <a:schemeClr val="tx1"/>
-                </a:solidFill>
-                <a:latin typeface="Ramabhadra" panose="02000600000000000000" pitchFamily="2" charset="0"/>
-                <a:cs typeface="Ramabhadra" panose="02000600000000000000" pitchFamily="2" charset="0"/>
-              </a:rPr>
-            </a:br>
-            <a:r>
-              <a:rPr lang="te-IN" dirty="0">
-                <a:solidFill>
-                  <a:schemeClr val="tx1"/>
-                </a:solidFill>
-                <a:latin typeface="Ramabhadra" panose="02000600000000000000" pitchFamily="2" charset="0"/>
-                <a:cs typeface="Ramabhadra" panose="02000600000000000000" pitchFamily="2" charset="0"/>
-              </a:rPr>
-              <a:t>నీవెకదా (3)</a:t>
+              <a:t>ఉత్తేజపరిచి తృప్తిని ఇచ్చావు</a:t>
             </a:r>
           </a:p>
         </p:txBody>
@@ -5823,84 +4706,32 @@
           <a:p>
             <a:pPr algn="ctr"/>
             <a:r>
-              <a:rPr lang="te-IN" dirty="0">
-                <a:solidFill>
-                  <a:schemeClr val="tx1"/>
-                </a:solidFill>
-                <a:latin typeface="Ramabhadra" panose="02000600000000000000" pitchFamily="2" charset="0"/>
-                <a:cs typeface="Ramabhadra" panose="02000600000000000000" pitchFamily="2" charset="0"/>
-              </a:rPr>
-              <a:t>నీతోనే ఉండుటయే</a:t>
-            </a:r>
-          </a:p>
-          <a:p>
-            <a:pPr algn="ctr"/>
-            <a:r>
-              <a:rPr lang="te-IN" dirty="0">
-                <a:solidFill>
-                  <a:schemeClr val="tx1"/>
-                </a:solidFill>
-                <a:latin typeface="Ramabhadra" panose="02000600000000000000" pitchFamily="2" charset="0"/>
-                <a:cs typeface="Ramabhadra" panose="02000600000000000000" pitchFamily="2" charset="0"/>
-              </a:rPr>
-              <a:t>నా జీవిత వాంచయ్యా</a:t>
-            </a:r>
-          </a:p>
-          <a:p>
-            <a:pPr algn="ctr"/>
-            <a:r>
-              <a:rPr lang="te-IN" dirty="0">
-                <a:solidFill>
-                  <a:schemeClr val="tx1"/>
-                </a:solidFill>
-                <a:latin typeface="Ramabhadra" panose="02000600000000000000" pitchFamily="2" charset="0"/>
-                <a:cs typeface="Ramabhadra" panose="02000600000000000000" pitchFamily="2" charset="0"/>
-              </a:rPr>
-              <a:t>నీ చిత్తం నెరవేర్చుటయే</a:t>
-            </a:r>
-          </a:p>
-          <a:p>
-            <a:pPr algn="ctr"/>
-            <a:r>
-              <a:rPr lang="te-IN" dirty="0">
-                <a:solidFill>
-                  <a:schemeClr val="tx1"/>
-                </a:solidFill>
-                <a:latin typeface="Ramabhadra" panose="02000600000000000000" pitchFamily="2" charset="0"/>
-                <a:cs typeface="Ramabhadra" panose="02000600000000000000" pitchFamily="2" charset="0"/>
-              </a:rPr>
-              <a:t>నా హృదయ తపనయ్యా (2)</a:t>
-            </a:r>
-          </a:p>
-          <a:p>
-            <a:pPr algn="ctr"/>
-            <a:r>
-              <a:rPr lang="te-IN" dirty="0">
-                <a:solidFill>
-                  <a:schemeClr val="tx1"/>
-                </a:solidFill>
-                <a:latin typeface="Ramabhadra" panose="02000600000000000000" pitchFamily="2" charset="0"/>
-                <a:cs typeface="Ramabhadra" panose="02000600000000000000" pitchFamily="2" charset="0"/>
-              </a:rPr>
-              <a:t>యేసయ్యా నిన్నే కదా</a:t>
-            </a:r>
-          </a:p>
-          <a:p>
-            <a:pPr algn="ctr"/>
-            <a:r>
-              <a:rPr lang="te-IN" dirty="0">
-                <a:solidFill>
-                  <a:schemeClr val="tx1"/>
-                </a:solidFill>
-                <a:latin typeface="Ramabhadra" panose="02000600000000000000" pitchFamily="2" charset="0"/>
-                <a:cs typeface="Ramabhadra" panose="02000600000000000000" pitchFamily="2" charset="0"/>
-              </a:rPr>
-              <a:t>నా ముందు నిలిపేను (2)</a:t>
-            </a:r>
-          </a:p>
-          <a:p>
-            <a:pPr algn="ctr"/>
-            <a:endParaRPr lang="te-IN" dirty="0">
+              <a:rPr lang="te-IN" sz="1550" dirty="0">
+                <a:solidFill>
+                  <a:schemeClr val="tx1"/>
+                </a:solidFill>
+                <a:latin typeface="Ramabhadra" panose="02000600000000000000" pitchFamily="2" charset="0"/>
+                <a:cs typeface="Ramabhadra" panose="02000600000000000000" pitchFamily="2" charset="0"/>
+              </a:rPr>
+              <a:t>యేసయ్యా నీ కృప నాకు చాలయ్యా</a:t>
+            </a:r>
+          </a:p>
+          <a:p>
+            <a:pPr algn="ctr"/>
+            <a:r>
+              <a:rPr lang="te-IN" sz="1550" dirty="0">
+                <a:solidFill>
+                  <a:schemeClr val="tx1"/>
+                </a:solidFill>
+                <a:latin typeface="Ramabhadra" panose="02000600000000000000" pitchFamily="2" charset="0"/>
+                <a:cs typeface="Ramabhadra" panose="02000600000000000000" pitchFamily="2" charset="0"/>
+              </a:rPr>
+              <a:t>నీ కృప లేనిదే నే బ్రతుకలేనయ్యా</a:t>
+            </a:r>
+          </a:p>
+          <a:p>
+            <a:pPr algn="ctr"/>
+            <a:endParaRPr lang="te-IN" sz="1550" dirty="0">
               <a:solidFill>
                 <a:schemeClr val="tx1"/>
               </a:solidFill>
@@ -5911,16 +4742,16 @@
           <a:p>
             <a:pPr algn="ctr"/>
             <a:r>
-              <a:rPr lang="te-IN" dirty="0">
-                <a:solidFill>
-                  <a:schemeClr val="tx1"/>
-                </a:solidFill>
-                <a:latin typeface="Ramabhadra" panose="02000600000000000000" pitchFamily="2" charset="0"/>
-                <a:cs typeface="Ramabhadra" panose="02000600000000000000" pitchFamily="2" charset="0"/>
-              </a:rPr>
-              <a:t>కరుణయు కృపయు</a:t>
-            </a:r>
-            <a:endParaRPr lang="en-IN" dirty="0">
+              <a:rPr lang="te-IN" sz="1550" dirty="0">
+                <a:solidFill>
+                  <a:schemeClr val="tx1"/>
+                </a:solidFill>
+                <a:latin typeface="Ramabhadra" panose="02000600000000000000" pitchFamily="2" charset="0"/>
+                <a:cs typeface="Ramabhadra" panose="02000600000000000000" pitchFamily="2" charset="0"/>
+              </a:rPr>
+              <a:t>నీ కృప లేని క్షణము –</a:t>
+            </a:r>
+            <a:endParaRPr lang="en-IN" sz="1550" dirty="0">
               <a:solidFill>
                 <a:schemeClr val="tx1"/>
               </a:solidFill>
@@ -5931,42 +4762,55 @@
           <a:p>
             <a:pPr algn="ctr"/>
             <a:r>
-              <a:rPr lang="te-IN" dirty="0">
-                <a:solidFill>
-                  <a:schemeClr val="tx1"/>
-                </a:solidFill>
-                <a:latin typeface="Ramabhadra" panose="02000600000000000000" pitchFamily="2" charset="0"/>
-                <a:cs typeface="Ramabhadra" panose="02000600000000000000" pitchFamily="2" charset="0"/>
-              </a:rPr>
-              <a:t>నిరంతర శాంతి</a:t>
-            </a:r>
-          </a:p>
-          <a:p>
-            <a:pPr algn="ctr"/>
-            <a:r>
-              <a:rPr lang="te-IN" dirty="0">
-                <a:solidFill>
-                  <a:schemeClr val="tx1"/>
-                </a:solidFill>
-                <a:latin typeface="Ramabhadra" panose="02000600000000000000" pitchFamily="2" charset="0"/>
-                <a:cs typeface="Ramabhadra" panose="02000600000000000000" pitchFamily="2" charset="0"/>
-              </a:rPr>
-              <a:t>వినయము ఉన్నవాడా(2)</a:t>
-            </a:r>
-          </a:p>
-          <a:p>
-            <a:pPr algn="ctr"/>
-            <a:r>
-              <a:rPr lang="te-IN" dirty="0">
-                <a:solidFill>
-                  <a:schemeClr val="tx1"/>
-                </a:solidFill>
-                <a:latin typeface="Ramabhadra" panose="02000600000000000000" pitchFamily="2" charset="0"/>
-                <a:cs typeface="Ramabhadra" panose="02000600000000000000" pitchFamily="2" charset="0"/>
-              </a:rPr>
-              <a:t>నా జీవితం..</a:t>
-            </a:r>
-            <a:endParaRPr lang="en-IN" dirty="0">
+              <a:rPr lang="te-IN" sz="1550" dirty="0">
+                <a:solidFill>
+                  <a:schemeClr val="tx1"/>
+                </a:solidFill>
+                <a:latin typeface="Ramabhadra" panose="02000600000000000000" pitchFamily="2" charset="0"/>
+                <a:cs typeface="Ramabhadra" panose="02000600000000000000" pitchFamily="2" charset="0"/>
+              </a:rPr>
+              <a:t>నీ దయ లేని క్షణము</a:t>
+            </a:r>
+          </a:p>
+          <a:p>
+            <a:pPr algn="ctr"/>
+            <a:r>
+              <a:rPr lang="te-IN" sz="1550" dirty="0">
+                <a:solidFill>
+                  <a:schemeClr val="tx1"/>
+                </a:solidFill>
+                <a:latin typeface="Ramabhadra" panose="02000600000000000000" pitchFamily="2" charset="0"/>
+                <a:cs typeface="Ramabhadra" panose="02000600000000000000" pitchFamily="2" charset="0"/>
+              </a:rPr>
+              <a:t>నేనూహించలేను యేసయ్యా (2)</a:t>
+            </a:r>
+          </a:p>
+          <a:p>
+            <a:pPr algn="ctr"/>
+            <a:r>
+              <a:rPr lang="te-IN" sz="1550" dirty="0">
+                <a:solidFill>
+                  <a:schemeClr val="tx1"/>
+                </a:solidFill>
+                <a:latin typeface="Ramabhadra" panose="02000600000000000000" pitchFamily="2" charset="0"/>
+                <a:cs typeface="Ramabhadra" panose="02000600000000000000" pitchFamily="2" charset="0"/>
+              </a:rPr>
+              <a:t>యేసయ్యా నీ కృప నాకు చాలయ్యా</a:t>
+            </a:r>
+          </a:p>
+          <a:p>
+            <a:pPr algn="ctr"/>
+            <a:r>
+              <a:rPr lang="te-IN" sz="1550" dirty="0">
+                <a:solidFill>
+                  <a:schemeClr val="tx1"/>
+                </a:solidFill>
+                <a:latin typeface="Ramabhadra" panose="02000600000000000000" pitchFamily="2" charset="0"/>
+                <a:cs typeface="Ramabhadra" panose="02000600000000000000" pitchFamily="2" charset="0"/>
+              </a:rPr>
+              <a:t>నీ కృప లేనిదే నేనుండలేనయ్యా (2)</a:t>
+            </a:r>
+            <a:endParaRPr lang="en-IN" sz="1550" dirty="0">
               <a:solidFill>
                 <a:schemeClr val="tx1"/>
               </a:solidFill>
@@ -5976,30 +4820,7 @@
           </a:p>
           <a:p>
             <a:pPr algn="ctr"/>
-            <a:r>
-              <a:rPr lang="te-IN" dirty="0">
-                <a:solidFill>
-                  <a:schemeClr val="tx1"/>
-                </a:solidFill>
-                <a:latin typeface="Ramabhadra" panose="02000600000000000000" pitchFamily="2" charset="0"/>
-                <a:cs typeface="Ramabhadra" panose="02000600000000000000" pitchFamily="2" charset="0"/>
-              </a:rPr>
-              <a:t>నశియింపక.. (2)</a:t>
-            </a:r>
-          </a:p>
-          <a:p>
-            <a:pPr algn="ctr"/>
-            <a:r>
-              <a:rPr lang="te-IN" dirty="0">
-                <a:solidFill>
-                  <a:schemeClr val="tx1"/>
-                </a:solidFill>
-                <a:latin typeface="Ramabhadra" panose="02000600000000000000" pitchFamily="2" charset="0"/>
-                <a:cs typeface="Ramabhadra" panose="02000600000000000000" pitchFamily="2" charset="0"/>
-              </a:rPr>
-              <a:t>కాపాడువాడా...</a:t>
-            </a:r>
-            <a:endParaRPr lang="en-IN" dirty="0">
+            <a:endParaRPr lang="te-IN" sz="1550" dirty="0">
               <a:solidFill>
                 <a:schemeClr val="tx1"/>
               </a:solidFill>
@@ -6010,19 +4831,16 @@
           <a:p>
             <a:pPr algn="ctr"/>
             <a:r>
-              <a:rPr lang="te-IN" dirty="0">
-                <a:solidFill>
-                  <a:schemeClr val="tx1"/>
-                </a:solidFill>
-                <a:latin typeface="Ramabhadra" panose="02000600000000000000" pitchFamily="2" charset="0"/>
-                <a:cs typeface="Ramabhadra" panose="02000600000000000000" pitchFamily="2" charset="0"/>
-              </a:rPr>
-              <a:t>నా కాపరి... (2)</a:t>
-            </a:r>
-          </a:p>
-          <a:p>
-            <a:pPr algn="ctr"/>
-            <a:endParaRPr lang="te-IN" dirty="0">
+              <a:rPr lang="te-IN" sz="1550" dirty="0">
+                <a:solidFill>
+                  <a:schemeClr val="tx1"/>
+                </a:solidFill>
+                <a:latin typeface="Ramabhadra" panose="02000600000000000000" pitchFamily="2" charset="0"/>
+                <a:cs typeface="Ramabhadra" panose="02000600000000000000" pitchFamily="2" charset="0"/>
+              </a:rPr>
+              <a:t>మహిమను విడిచి</a:t>
+            </a:r>
+            <a:endParaRPr lang="en-IN" sz="1550" dirty="0">
               <a:solidFill>
                 <a:schemeClr val="tx1"/>
               </a:solidFill>
@@ -6033,16 +4851,65 @@
           <a:p>
             <a:pPr algn="ctr"/>
             <a:r>
-              <a:rPr lang="te-IN" dirty="0">
-                <a:solidFill>
-                  <a:schemeClr val="tx1"/>
-                </a:solidFill>
-                <a:latin typeface="Ramabhadra" panose="02000600000000000000" pitchFamily="2" charset="0"/>
-                <a:cs typeface="Ramabhadra" panose="02000600000000000000" pitchFamily="2" charset="0"/>
-              </a:rPr>
-              <a:t>నా కొరకు </a:t>
-            </a:r>
-            <a:endParaRPr lang="en-IN" dirty="0">
+              <a:rPr lang="te-IN" sz="1550" dirty="0">
+                <a:solidFill>
+                  <a:schemeClr val="tx1"/>
+                </a:solidFill>
+                <a:latin typeface="Ramabhadra" panose="02000600000000000000" pitchFamily="2" charset="0"/>
+                <a:cs typeface="Ramabhadra" panose="02000600000000000000" pitchFamily="2" charset="0"/>
+              </a:rPr>
+              <a:t>మహిలోకి దిగి వచ్చి</a:t>
+            </a:r>
+          </a:p>
+          <a:p>
+            <a:pPr algn="ctr"/>
+            <a:r>
+              <a:rPr lang="te-IN" sz="1550" dirty="0">
+                <a:solidFill>
+                  <a:schemeClr val="tx1"/>
+                </a:solidFill>
+                <a:latin typeface="Ramabhadra" panose="02000600000000000000" pitchFamily="2" charset="0"/>
+                <a:cs typeface="Ramabhadra" panose="02000600000000000000" pitchFamily="2" charset="0"/>
+              </a:rPr>
+              <a:t>మార్గముగా మారి మనిషిగా మార్చావు</a:t>
+            </a:r>
+          </a:p>
+          <a:p>
+            <a:pPr algn="ctr"/>
+            <a:r>
+              <a:rPr lang="te-IN" sz="1550">
+                <a:solidFill>
+                  <a:schemeClr val="tx1"/>
+                </a:solidFill>
+                <a:latin typeface="Ramabhadra" panose="02000600000000000000" pitchFamily="2" charset="0"/>
+                <a:cs typeface="Ramabhadra" panose="02000600000000000000" pitchFamily="2" charset="0"/>
+              </a:rPr>
+              <a:t>మహినె </a:t>
+            </a:r>
+            <a:r>
+              <a:rPr lang="te-IN" sz="1550" dirty="0">
+                <a:solidFill>
+                  <a:schemeClr val="tx1"/>
+                </a:solidFill>
+                <a:latin typeface="Ramabhadra" panose="02000600000000000000" pitchFamily="2" charset="0"/>
+                <a:cs typeface="Ramabhadra" panose="02000600000000000000" pitchFamily="2" charset="0"/>
+              </a:rPr>
+              <a:t>నీవు మాధుర్యముగా మార్చి</a:t>
+            </a:r>
+          </a:p>
+          <a:p>
+            <a:pPr algn="ctr"/>
+            <a:r>
+              <a:rPr lang="te-IN" sz="1550" dirty="0">
+                <a:solidFill>
+                  <a:schemeClr val="tx1"/>
+                </a:solidFill>
+                <a:latin typeface="Ramabhadra" panose="02000600000000000000" pitchFamily="2" charset="0"/>
+                <a:cs typeface="Ramabhadra" panose="02000600000000000000" pitchFamily="2" charset="0"/>
+              </a:rPr>
+              <a:t>మాదిరి చూపి</a:t>
+            </a:r>
+            <a:endParaRPr lang="en-IN" sz="1550" dirty="0">
               <a:solidFill>
                 <a:schemeClr val="tx1"/>
               </a:solidFill>
@@ -6053,55 +4920,42 @@
           <a:p>
             <a:pPr algn="ctr"/>
             <a:r>
-              <a:rPr lang="te-IN" dirty="0">
-                <a:solidFill>
-                  <a:schemeClr val="tx1"/>
-                </a:solidFill>
-                <a:latin typeface="Ramabhadra" panose="02000600000000000000" pitchFamily="2" charset="0"/>
-                <a:cs typeface="Ramabhadra" panose="02000600000000000000" pitchFamily="2" charset="0"/>
-              </a:rPr>
-              <a:t>అన్నియు చేయువాడా</a:t>
-            </a:r>
-          </a:p>
-          <a:p>
-            <a:pPr algn="ctr"/>
-            <a:r>
-              <a:rPr lang="te-IN" dirty="0">
-                <a:solidFill>
-                  <a:schemeClr val="tx1"/>
-                </a:solidFill>
-                <a:latin typeface="Ramabhadra" panose="02000600000000000000" pitchFamily="2" charset="0"/>
-                <a:cs typeface="Ramabhadra" panose="02000600000000000000" pitchFamily="2" charset="0"/>
-              </a:rPr>
-              <a:t>చేసి ముగించువాడా (2)</a:t>
-            </a:r>
-          </a:p>
-          <a:p>
-            <a:pPr algn="ctr"/>
-            <a:r>
-              <a:rPr lang="te-IN" dirty="0">
-                <a:solidFill>
-                  <a:schemeClr val="tx1"/>
-                </a:solidFill>
-                <a:latin typeface="Ramabhadra" panose="02000600000000000000" pitchFamily="2" charset="0"/>
-                <a:cs typeface="Ramabhadra" panose="02000600000000000000" pitchFamily="2" charset="0"/>
-              </a:rPr>
-              <a:t>నా బరువు.. నా బాధ్యత.. (2)</a:t>
-            </a:r>
-          </a:p>
-          <a:p>
-            <a:pPr algn="ctr"/>
-            <a:r>
-              <a:rPr lang="te-IN" dirty="0">
-                <a:solidFill>
-                  <a:schemeClr val="tx1"/>
-                </a:solidFill>
-                <a:latin typeface="Ramabhadra" panose="02000600000000000000" pitchFamily="2" charset="0"/>
-                <a:cs typeface="Ramabhadra" panose="02000600000000000000" pitchFamily="2" charset="0"/>
-              </a:rPr>
-              <a:t>నీ పాద చెంత...</a:t>
-            </a:r>
-            <a:endParaRPr lang="en-IN" dirty="0">
+              <a:rPr lang="te-IN" sz="1550" dirty="0">
+                <a:solidFill>
+                  <a:schemeClr val="tx1"/>
+                </a:solidFill>
+                <a:latin typeface="Ramabhadra" panose="02000600000000000000" pitchFamily="2" charset="0"/>
+                <a:cs typeface="Ramabhadra" panose="02000600000000000000" pitchFamily="2" charset="0"/>
+              </a:rPr>
+              <a:t>మరో రూపమిచ్చావు (2)</a:t>
+            </a:r>
+          </a:p>
+          <a:p>
+            <a:pPr algn="ctr"/>
+            <a:r>
+              <a:rPr lang="te-IN" sz="1550" dirty="0">
+                <a:solidFill>
+                  <a:schemeClr val="tx1"/>
+                </a:solidFill>
+                <a:latin typeface="Ramabhadra" panose="02000600000000000000" pitchFamily="2" charset="0"/>
+                <a:cs typeface="Ramabhadra" panose="02000600000000000000" pitchFamily="2" charset="0"/>
+              </a:rPr>
+              <a:t>మహిమలో నేను మహిమను పొంద</a:t>
+            </a:r>
+          </a:p>
+          <a:p>
+            <a:pPr algn="ctr"/>
+            <a:r>
+              <a:rPr lang="te-IN" sz="1550" dirty="0">
+                <a:solidFill>
+                  <a:schemeClr val="tx1"/>
+                </a:solidFill>
+                <a:latin typeface="Ramabhadra" panose="02000600000000000000" pitchFamily="2" charset="0"/>
+                <a:cs typeface="Ramabhadra" panose="02000600000000000000" pitchFamily="2" charset="0"/>
+              </a:rPr>
+              <a:t>మహిమగా మార్చింది నీ కృప (2)</a:t>
+            </a:r>
+            <a:endParaRPr lang="en-IN" sz="1550" dirty="0">
               <a:solidFill>
                 <a:schemeClr val="tx1"/>
               </a:solidFill>
@@ -6111,16 +4965,118 @@
           </a:p>
           <a:p>
             <a:pPr algn="ctr"/>
-            <a:r>
-              <a:rPr lang="te-IN" dirty="0">
-                <a:solidFill>
-                  <a:schemeClr val="tx1"/>
-                </a:solidFill>
-                <a:latin typeface="Ramabhadra" panose="02000600000000000000" pitchFamily="2" charset="0"/>
-                <a:cs typeface="Ramabhadra" panose="02000600000000000000" pitchFamily="2" charset="0"/>
-              </a:rPr>
-              <a:t>నుంచితివి... (2)</a:t>
-            </a:r>
+            <a:endParaRPr lang="te-IN" sz="1550" dirty="0">
+              <a:solidFill>
+                <a:schemeClr val="tx1"/>
+              </a:solidFill>
+              <a:latin typeface="Ramabhadra" panose="02000600000000000000" pitchFamily="2" charset="0"/>
+              <a:cs typeface="Ramabhadra" panose="02000600000000000000" pitchFamily="2" charset="0"/>
+            </a:endParaRPr>
+          </a:p>
+          <a:p>
+            <a:pPr algn="ctr"/>
+            <a:r>
+              <a:rPr lang="te-IN" sz="1550" dirty="0">
+                <a:solidFill>
+                  <a:schemeClr val="tx1"/>
+                </a:solidFill>
+                <a:latin typeface="Ramabhadra" panose="02000600000000000000" pitchFamily="2" charset="0"/>
+                <a:cs typeface="Ramabhadra" panose="02000600000000000000" pitchFamily="2" charset="0"/>
+              </a:rPr>
+              <a:t>ఆజ్ఞల మార్గమున ఆశ్రయమును ఇచ్చి</a:t>
+            </a:r>
+          </a:p>
+          <a:p>
+            <a:pPr algn="ctr"/>
+            <a:r>
+              <a:rPr lang="te-IN" sz="1550" dirty="0">
+                <a:solidFill>
+                  <a:schemeClr val="tx1"/>
+                </a:solidFill>
+                <a:latin typeface="Ramabhadra" panose="02000600000000000000" pitchFamily="2" charset="0"/>
+                <a:cs typeface="Ramabhadra" panose="02000600000000000000" pitchFamily="2" charset="0"/>
+              </a:rPr>
+              <a:t>ఆపత్కాలమున ఆదుకొన్నావు</a:t>
+            </a:r>
+          </a:p>
+          <a:p>
+            <a:pPr algn="ctr"/>
+            <a:r>
+              <a:rPr lang="te-IN" sz="1550" dirty="0">
+                <a:solidFill>
+                  <a:schemeClr val="tx1"/>
+                </a:solidFill>
+                <a:latin typeface="Ramabhadra" panose="02000600000000000000" pitchFamily="2" charset="0"/>
+                <a:cs typeface="Ramabhadra" panose="02000600000000000000" pitchFamily="2" charset="0"/>
+              </a:rPr>
+              <a:t>ఆత్మీయులతో ఆనందింప చేసి</a:t>
+            </a:r>
+          </a:p>
+          <a:p>
+            <a:pPr algn="ctr"/>
+            <a:r>
+              <a:rPr lang="te-IN" sz="1550" dirty="0">
+                <a:solidFill>
+                  <a:schemeClr val="tx1"/>
+                </a:solidFill>
+                <a:latin typeface="Ramabhadra" panose="02000600000000000000" pitchFamily="2" charset="0"/>
+                <a:cs typeface="Ramabhadra" panose="02000600000000000000" pitchFamily="2" charset="0"/>
+              </a:rPr>
+              <a:t>ఆనంద తైలముతో</a:t>
+            </a:r>
+            <a:endParaRPr lang="en-IN" sz="1550" dirty="0">
+              <a:solidFill>
+                <a:schemeClr val="tx1"/>
+              </a:solidFill>
+              <a:latin typeface="Ramabhadra" panose="02000600000000000000" pitchFamily="2" charset="0"/>
+              <a:cs typeface="Ramabhadra" panose="02000600000000000000" pitchFamily="2" charset="0"/>
+            </a:endParaRPr>
+          </a:p>
+          <a:p>
+            <a:pPr algn="ctr"/>
+            <a:r>
+              <a:rPr lang="te-IN" sz="1550" dirty="0">
+                <a:solidFill>
+                  <a:schemeClr val="tx1"/>
+                </a:solidFill>
+                <a:latin typeface="Ramabhadra" panose="02000600000000000000" pitchFamily="2" charset="0"/>
+                <a:cs typeface="Ramabhadra" panose="02000600000000000000" pitchFamily="2" charset="0"/>
+              </a:rPr>
+              <a:t>అభిషేకించావు (2)</a:t>
+            </a:r>
+          </a:p>
+          <a:p>
+            <a:pPr algn="ctr"/>
+            <a:r>
+              <a:rPr lang="te-IN" sz="1550" dirty="0">
+                <a:solidFill>
+                  <a:schemeClr val="tx1"/>
+                </a:solidFill>
+                <a:latin typeface="Ramabhadra" panose="02000600000000000000" pitchFamily="2" charset="0"/>
+                <a:cs typeface="Ramabhadra" panose="02000600000000000000" pitchFamily="2" charset="0"/>
+              </a:rPr>
+              <a:t>ఆశ తీర ఆరాధన చేసే</a:t>
+            </a:r>
+          </a:p>
+          <a:p>
+            <a:pPr algn="ctr"/>
+            <a:r>
+              <a:rPr lang="te-IN" sz="1550" dirty="0">
+                <a:solidFill>
+                  <a:schemeClr val="tx1"/>
+                </a:solidFill>
+                <a:latin typeface="Ramabhadra" panose="02000600000000000000" pitchFamily="2" charset="0"/>
+                <a:cs typeface="Ramabhadra" panose="02000600000000000000" pitchFamily="2" charset="0"/>
+              </a:rPr>
+              <a:t>అదృష్టమిచ్చింది నీ కృప (2)</a:t>
+            </a:r>
+            <a:endParaRPr lang="en-IN" sz="1550" dirty="0">
+              <a:solidFill>
+                <a:schemeClr val="tx1"/>
+              </a:solidFill>
+              <a:latin typeface="Ramabhadra" panose="02000600000000000000" pitchFamily="2" charset="0"/>
+              <a:cs typeface="Ramabhadra" panose="02000600000000000000" pitchFamily="2" charset="0"/>
+            </a:endParaRPr>
           </a:p>
         </p:txBody>
       </p:sp>

</xml_diff>

<commit_message>
11 august sunday songs
</commit_message>
<xml_diff>
--- a/xerox.pptx
+++ b/xerox.pptx
@@ -224,7 +224,7 @@
           <a:p>
             <a:fld id="{3502DD63-DF8D-4AB8-92A0-0ECCF612C06C}" type="datetimeFigureOut">
               <a:rPr lang="en-IN" smtClean="0"/>
-              <a:t>03-08-2024</a:t>
+              <a:t>10-08-2024</a:t>
             </a:fld>
             <a:endParaRPr lang="en-IN"/>
           </a:p>
@@ -402,7 +402,7 @@
           <a:p>
             <a:fld id="{1AE741EC-1360-4793-999B-941E0396C9FA}" type="datetimeFigureOut">
               <a:rPr lang="en-IN" smtClean="0"/>
-              <a:t>03-08-2024</a:t>
+              <a:t>10-08-2024</a:t>
             </a:fld>
             <a:endParaRPr lang="en-IN"/>
           </a:p>
@@ -802,7 +802,7 @@
           <a:p>
             <a:fld id="{86FBD32F-FCAD-481A-B7D8-4D813FB7DB24}" type="datetimeFigureOut">
               <a:rPr lang="en-IN" smtClean="0"/>
-              <a:t>03-08-2024</a:t>
+              <a:t>10-08-2024</a:t>
             </a:fld>
             <a:endParaRPr lang="en-IN"/>
           </a:p>
@@ -972,7 +972,7 @@
           <a:p>
             <a:fld id="{86FBD32F-FCAD-481A-B7D8-4D813FB7DB24}" type="datetimeFigureOut">
               <a:rPr lang="en-IN" smtClean="0"/>
-              <a:t>03-08-2024</a:t>
+              <a:t>10-08-2024</a:t>
             </a:fld>
             <a:endParaRPr lang="en-IN"/>
           </a:p>
@@ -1152,7 +1152,7 @@
           <a:p>
             <a:fld id="{86FBD32F-FCAD-481A-B7D8-4D813FB7DB24}" type="datetimeFigureOut">
               <a:rPr lang="en-IN" smtClean="0"/>
-              <a:t>03-08-2024</a:t>
+              <a:t>10-08-2024</a:t>
             </a:fld>
             <a:endParaRPr lang="en-IN"/>
           </a:p>
@@ -1322,7 +1322,7 @@
           <a:p>
             <a:fld id="{86FBD32F-FCAD-481A-B7D8-4D813FB7DB24}" type="datetimeFigureOut">
               <a:rPr lang="en-IN" smtClean="0"/>
-              <a:t>03-08-2024</a:t>
+              <a:t>10-08-2024</a:t>
             </a:fld>
             <a:endParaRPr lang="en-IN"/>
           </a:p>
@@ -1566,7 +1566,7 @@
           <a:p>
             <a:fld id="{86FBD32F-FCAD-481A-B7D8-4D813FB7DB24}" type="datetimeFigureOut">
               <a:rPr lang="en-IN" smtClean="0"/>
-              <a:t>03-08-2024</a:t>
+              <a:t>10-08-2024</a:t>
             </a:fld>
             <a:endParaRPr lang="en-IN"/>
           </a:p>
@@ -1798,7 +1798,7 @@
           <a:p>
             <a:fld id="{86FBD32F-FCAD-481A-B7D8-4D813FB7DB24}" type="datetimeFigureOut">
               <a:rPr lang="en-IN" smtClean="0"/>
-              <a:t>03-08-2024</a:t>
+              <a:t>10-08-2024</a:t>
             </a:fld>
             <a:endParaRPr lang="en-IN"/>
           </a:p>
@@ -2165,7 +2165,7 @@
           <a:p>
             <a:fld id="{86FBD32F-FCAD-481A-B7D8-4D813FB7DB24}" type="datetimeFigureOut">
               <a:rPr lang="en-IN" smtClean="0"/>
-              <a:t>03-08-2024</a:t>
+              <a:t>10-08-2024</a:t>
             </a:fld>
             <a:endParaRPr lang="en-IN"/>
           </a:p>
@@ -2283,7 +2283,7 @@
           <a:p>
             <a:fld id="{86FBD32F-FCAD-481A-B7D8-4D813FB7DB24}" type="datetimeFigureOut">
               <a:rPr lang="en-IN" smtClean="0"/>
-              <a:t>03-08-2024</a:t>
+              <a:t>10-08-2024</a:t>
             </a:fld>
             <a:endParaRPr lang="en-IN"/>
           </a:p>
@@ -2378,7 +2378,7 @@
           <a:p>
             <a:fld id="{86FBD32F-FCAD-481A-B7D8-4D813FB7DB24}" type="datetimeFigureOut">
               <a:rPr lang="en-IN" smtClean="0"/>
-              <a:t>03-08-2024</a:t>
+              <a:t>10-08-2024</a:t>
             </a:fld>
             <a:endParaRPr lang="en-IN"/>
           </a:p>
@@ -2655,7 +2655,7 @@
           <a:p>
             <a:fld id="{86FBD32F-FCAD-481A-B7D8-4D813FB7DB24}" type="datetimeFigureOut">
               <a:rPr lang="en-IN" smtClean="0"/>
-              <a:t>03-08-2024</a:t>
+              <a:t>10-08-2024</a:t>
             </a:fld>
             <a:endParaRPr lang="en-IN"/>
           </a:p>
@@ -2912,7 +2912,7 @@
           <a:p>
             <a:fld id="{86FBD32F-FCAD-481A-B7D8-4D813FB7DB24}" type="datetimeFigureOut">
               <a:rPr lang="en-IN" smtClean="0"/>
-              <a:t>03-08-2024</a:t>
+              <a:t>10-08-2024</a:t>
             </a:fld>
             <a:endParaRPr lang="en-IN"/>
           </a:p>
@@ -3125,7 +3125,7 @@
           <a:p>
             <a:fld id="{86FBD32F-FCAD-481A-B7D8-4D813FB7DB24}" type="datetimeFigureOut">
               <a:rPr lang="en-IN" smtClean="0"/>
-              <a:t>03-08-2024</a:t>
+              <a:t>10-08-2024</a:t>
             </a:fld>
             <a:endParaRPr lang="en-IN"/>
           </a:p>
@@ -3590,7 +3590,7 @@
                 <a:latin typeface="Ramabhadra" panose="02000600000000000000" pitchFamily="2" charset="0"/>
                 <a:cs typeface="Ramabhadra" panose="02000600000000000000" pitchFamily="2" charset="0"/>
               </a:rPr>
-              <a:t>పావుర స్వరము</a:t>
+              <a:t>యేసే నా పరిహారి</a:t>
             </a:r>
             <a:endParaRPr lang="en-IN" sz="2000" dirty="0">
               <a:solidFill>
@@ -3610,12 +3610,9 @@
                 <a:latin typeface="Ramabhadra" panose="02000600000000000000" pitchFamily="2" charset="0"/>
                 <a:cs typeface="Ramabhadra" panose="02000600000000000000" pitchFamily="2" charset="0"/>
               </a:rPr>
-              <a:t>వినబడుచున్నది</a:t>
-            </a:r>
-          </a:p>
-          <a:p>
-            <a:pPr algn="ctr"/>
-            <a:r>
+              <a:t>ప్రియ యేసే నా పరిహారి</a:t>
+            </a:r>
+            <a:br>
               <a:rPr lang="te-IN" sz="2000" dirty="0">
                 <a:solidFill>
                   <a:schemeClr val="tx1"/>
@@ -3623,7 +3620,16 @@
                 <a:latin typeface="Ramabhadra" panose="02000600000000000000" pitchFamily="2" charset="0"/>
                 <a:cs typeface="Ramabhadra" panose="02000600000000000000" pitchFamily="2" charset="0"/>
               </a:rPr>
-              <a:t>పాపము విడచి</a:t>
+            </a:br>
+            <a:r>
+              <a:rPr lang="te-IN" sz="2000" dirty="0">
+                <a:solidFill>
+                  <a:schemeClr val="tx1"/>
+                </a:solidFill>
+                <a:latin typeface="Ramabhadra" panose="02000600000000000000" pitchFamily="2" charset="0"/>
+                <a:cs typeface="Ramabhadra" panose="02000600000000000000" pitchFamily="2" charset="0"/>
+              </a:rPr>
+              <a:t>   నా జీవిత కాలమెల్ల</a:t>
             </a:r>
             <a:endParaRPr lang="en-IN" sz="2000" dirty="0">
               <a:solidFill>
@@ -3643,7 +3649,27 @@
                 <a:latin typeface="Ramabhadra" panose="02000600000000000000" pitchFamily="2" charset="0"/>
                 <a:cs typeface="Ramabhadra" panose="02000600000000000000" pitchFamily="2" charset="0"/>
               </a:rPr>
-              <a:t>పరుగిడి రమ్ము</a:t>
+              <a:t>ప్రియ ప్రభువే</a:t>
+            </a:r>
+            <a:r>
+              <a:rPr lang="en-IN" sz="2000" dirty="0">
+                <a:solidFill>
+                  <a:schemeClr val="tx1"/>
+                </a:solidFill>
+                <a:latin typeface="Ramabhadra" panose="02000600000000000000" pitchFamily="2" charset="0"/>
+                <a:cs typeface="Ramabhadra" panose="02000600000000000000" pitchFamily="2" charset="0"/>
+              </a:rPr>
+              <a:t> </a:t>
+            </a:r>
+            <a:r>
+              <a:rPr lang="te-IN" sz="2000" dirty="0">
+                <a:solidFill>
+                  <a:schemeClr val="tx1"/>
+                </a:solidFill>
+                <a:latin typeface="Ramabhadra" panose="02000600000000000000" pitchFamily="2" charset="0"/>
+                <a:cs typeface="Ramabhadra" panose="02000600000000000000" pitchFamily="2" charset="0"/>
+              </a:rPr>
+              <a:t>నా పరిహారి (2)</a:t>
             </a:r>
           </a:p>
           <a:p>
@@ -3666,7 +3692,7 @@
                 <a:latin typeface="Ramabhadra" panose="02000600000000000000" pitchFamily="2" charset="0"/>
                 <a:cs typeface="Ramabhadra" panose="02000600000000000000" pitchFamily="2" charset="0"/>
               </a:rPr>
-              <a:t>పాపాంధకారములో</a:t>
+              <a:t>ఎన్ని కష్టాలు కలిగిననూ</a:t>
             </a:r>
             <a:endParaRPr lang="en-IN" sz="2000" dirty="0">
               <a:solidFill>
@@ -3686,7 +3712,7 @@
                 <a:latin typeface="Ramabhadra" panose="02000600000000000000" pitchFamily="2" charset="0"/>
                 <a:cs typeface="Ramabhadra" panose="02000600000000000000" pitchFamily="2" charset="0"/>
               </a:rPr>
-              <a:t>తిరుగాడు నీవు</a:t>
+              <a:t>నన్ను కృంగించె భాదలెన్నో</a:t>
             </a:r>
           </a:p>
           <a:p>
@@ -3699,7 +3725,7 @@
                 <a:latin typeface="Ramabhadra" panose="02000600000000000000" pitchFamily="2" charset="0"/>
                 <a:cs typeface="Ramabhadra" panose="02000600000000000000" pitchFamily="2" charset="0"/>
               </a:rPr>
-              <a:t>లోకాశల నాశ్రయించి నీవు</a:t>
+              <a:t>ఎన్ని నష్టాలు వాటిల్లినా </a:t>
             </a:r>
           </a:p>
           <a:p>
@@ -3712,33 +3738,7 @@
                 <a:latin typeface="Ramabhadra" panose="02000600000000000000" pitchFamily="2" charset="0"/>
                 <a:cs typeface="Ramabhadra" panose="02000600000000000000" pitchFamily="2" charset="0"/>
               </a:rPr>
-              <a:t>పశ్చాత్తాపముతో ప్రార్థించుము</a:t>
-            </a:r>
-          </a:p>
-          <a:p>
-            <a:pPr algn="ctr"/>
-            <a:r>
-              <a:rPr lang="te-IN" sz="2000" dirty="0">
-                <a:solidFill>
-                  <a:schemeClr val="tx1"/>
-                </a:solidFill>
-                <a:latin typeface="Ramabhadra" panose="02000600000000000000" pitchFamily="2" charset="0"/>
-                <a:cs typeface="Ramabhadra" panose="02000600000000000000" pitchFamily="2" charset="0"/>
-              </a:rPr>
-              <a:t>నీ స్వరము</a:t>
-            </a:r>
-          </a:p>
-          <a:p>
-            <a:pPr algn="ctr"/>
-            <a:r>
-              <a:rPr lang="te-IN" sz="2000" dirty="0">
-                <a:solidFill>
-                  <a:schemeClr val="tx1"/>
-                </a:solidFill>
-                <a:latin typeface="Ramabhadra" panose="02000600000000000000" pitchFamily="2" charset="0"/>
-                <a:cs typeface="Ramabhadra" panose="02000600000000000000" pitchFamily="2" charset="0"/>
-              </a:rPr>
-              <a:t>ప్రియునికి వినబడనిమ్ము</a:t>
+              <a:t>ప్రియ ప్రభువే నా పరిహారి (2)</a:t>
             </a:r>
           </a:p>
           <a:p>
@@ -3761,20 +3761,7 @@
                 <a:latin typeface="Ramabhadra" panose="02000600000000000000" pitchFamily="2" charset="0"/>
                 <a:cs typeface="Ramabhadra" panose="02000600000000000000" pitchFamily="2" charset="0"/>
               </a:rPr>
-              <a:t>దవళవర్ణుడు రత్నవర్ణుడేసు</a:t>
-            </a:r>
-          </a:p>
-          <a:p>
-            <a:pPr algn="ctr"/>
-            <a:r>
-              <a:rPr lang="te-IN" sz="2000" dirty="0">
-                <a:solidFill>
-                  <a:schemeClr val="tx1"/>
-                </a:solidFill>
-                <a:latin typeface="Ramabhadra" panose="02000600000000000000" pitchFamily="2" charset="0"/>
-                <a:cs typeface="Ramabhadra" panose="02000600000000000000" pitchFamily="2" charset="0"/>
-              </a:rPr>
-              <a:t>అతి మనోహరుడు</a:t>
+              <a:t>దేవా నీవే నా ఆధారం</a:t>
             </a:r>
             <a:endParaRPr lang="en-IN" sz="2000" dirty="0">
               <a:solidFill>
@@ -3794,12 +3781,9 @@
                 <a:latin typeface="Ramabhadra" panose="02000600000000000000" pitchFamily="2" charset="0"/>
                 <a:cs typeface="Ramabhadra" panose="02000600000000000000" pitchFamily="2" charset="0"/>
               </a:rPr>
-              <a:t>అతి సుందరుడు</a:t>
-            </a:r>
-          </a:p>
-          <a:p>
-            <a:pPr algn="ctr"/>
-            <a:r>
+              <a:t>నీ ప్రేమకు సాటెవ్వరూ (2)</a:t>
+            </a:r>
+            <a:br>
               <a:rPr lang="te-IN" sz="2000" dirty="0">
                 <a:solidFill>
                   <a:schemeClr val="tx1"/>
@@ -3807,61 +3791,73 @@
                 <a:latin typeface="Ramabhadra" panose="02000600000000000000" pitchFamily="2" charset="0"/>
                 <a:cs typeface="Ramabhadra" panose="02000600000000000000" pitchFamily="2" charset="0"/>
               </a:rPr>
-              <a:t>నా సహోదరి</a:t>
-            </a:r>
-            <a:endParaRPr lang="en-IN" sz="2000" dirty="0">
+            </a:br>
+            <a:r>
+              <a:rPr lang="te-IN" sz="2000" dirty="0">
+                <a:solidFill>
+                  <a:schemeClr val="tx1"/>
+                </a:solidFill>
+                <a:latin typeface="Ramabhadra" panose="02000600000000000000" pitchFamily="2" charset="0"/>
+                <a:cs typeface="Ramabhadra" panose="02000600000000000000" pitchFamily="2" charset="0"/>
+              </a:rPr>
+              <a:t>నా జీవిత కాలమంతా</a:t>
+            </a:r>
+            <a:br>
+              <a:rPr lang="te-IN" sz="2000" dirty="0">
+                <a:solidFill>
+                  <a:schemeClr val="tx1"/>
+                </a:solidFill>
+                <a:latin typeface="Ramabhadra" panose="02000600000000000000" pitchFamily="2" charset="0"/>
+                <a:cs typeface="Ramabhadra" panose="02000600000000000000" pitchFamily="2" charset="0"/>
+              </a:rPr>
+            </a:br>
+            <a:r>
+              <a:rPr lang="te-IN" sz="2000" dirty="0">
+                <a:solidFill>
+                  <a:schemeClr val="tx1"/>
+                </a:solidFill>
+                <a:latin typeface="Ramabhadra" panose="02000600000000000000" pitchFamily="2" charset="0"/>
+                <a:cs typeface="Ramabhadra" panose="02000600000000000000" pitchFamily="2" charset="0"/>
+              </a:rPr>
+              <a:t>నిన్ను పాడి</a:t>
+            </a:r>
+            <a:r>
+              <a:rPr lang="en-IN" sz="2000" dirty="0">
+                <a:solidFill>
+                  <a:schemeClr val="tx1"/>
+                </a:solidFill>
+                <a:latin typeface="Ramabhadra" panose="02000600000000000000" pitchFamily="2" charset="0"/>
+                <a:cs typeface="Ramabhadra" panose="02000600000000000000" pitchFamily="2" charset="0"/>
+              </a:rPr>
+              <a:t> </a:t>
+            </a:r>
+            <a:r>
+              <a:rPr lang="te-IN" sz="2000" dirty="0">
+                <a:solidFill>
+                  <a:schemeClr val="tx1"/>
+                </a:solidFill>
+                <a:latin typeface="Ramabhadra" panose="02000600000000000000" pitchFamily="2" charset="0"/>
+                <a:cs typeface="Ramabhadra" panose="02000600000000000000" pitchFamily="2" charset="0"/>
+              </a:rPr>
+              <a:t>స్తుతించెదను (2</a:t>
+            </a:r>
+            <a:r>
+              <a:rPr lang="en-IN" sz="2000" dirty="0">
+                <a:solidFill>
+                  <a:schemeClr val="tx1"/>
+                </a:solidFill>
+                <a:latin typeface="Ramabhadra" panose="02000600000000000000" pitchFamily="2" charset="0"/>
+                <a:cs typeface="Ramabhadra" panose="02000600000000000000" pitchFamily="2" charset="0"/>
+              </a:rPr>
+              <a:t>)</a:t>
+            </a:r>
+            <a:endParaRPr lang="te-IN" sz="2000" dirty="0">
               <a:solidFill>
                 <a:schemeClr val="tx1"/>
               </a:solidFill>
               <a:latin typeface="Ramabhadra" panose="02000600000000000000" pitchFamily="2" charset="0"/>
               <a:cs typeface="Ramabhadra" panose="02000600000000000000" pitchFamily="2" charset="0"/>
             </a:endParaRPr>
-          </a:p>
-          <a:p>
-            <a:pPr algn="ctr"/>
-            <a:r>
-              <a:rPr lang="te-IN" sz="2000" dirty="0">
-                <a:solidFill>
-                  <a:schemeClr val="tx1"/>
-                </a:solidFill>
-                <a:latin typeface="Ramabhadra" panose="02000600000000000000" pitchFamily="2" charset="0"/>
-                <a:cs typeface="Ramabhadra" panose="02000600000000000000" pitchFamily="2" charset="0"/>
-              </a:rPr>
-              <a:t>ప్రాణేశ్వరీ అని</a:t>
-            </a:r>
-          </a:p>
-          <a:p>
-            <a:pPr algn="ctr"/>
-            <a:r>
-              <a:rPr lang="te-IN" sz="2000" dirty="0">
-                <a:solidFill>
-                  <a:schemeClr val="tx1"/>
-                </a:solidFill>
-                <a:latin typeface="Ramabhadra" panose="02000600000000000000" pitchFamily="2" charset="0"/>
-                <a:cs typeface="Ramabhadra" panose="02000600000000000000" pitchFamily="2" charset="0"/>
-              </a:rPr>
-              <a:t>ప్రయమార నిన్ను</a:t>
-            </a:r>
-            <a:endParaRPr lang="en-IN" sz="2000" dirty="0">
-              <a:solidFill>
-                <a:schemeClr val="tx1"/>
-              </a:solidFill>
-              <a:latin typeface="Ramabhadra" panose="02000600000000000000" pitchFamily="2" charset="0"/>
-              <a:cs typeface="Ramabhadra" panose="02000600000000000000" pitchFamily="2" charset="0"/>
-            </a:endParaRPr>
-          </a:p>
-          <a:p>
-            <a:pPr algn="ctr"/>
-            <a:r>
-              <a:rPr lang="te-IN" sz="2000" dirty="0">
-                <a:solidFill>
-                  <a:schemeClr val="tx1"/>
-                </a:solidFill>
-                <a:latin typeface="Ramabhadra" panose="02000600000000000000" pitchFamily="2" charset="0"/>
-                <a:cs typeface="Ramabhadra" panose="02000600000000000000" pitchFamily="2" charset="0"/>
-              </a:rPr>
-              <a:t>పిలిచెను యేసు</a:t>
-            </a:r>
           </a:p>
         </p:txBody>
       </p:sp>
@@ -3925,7 +3921,46 @@
                 <a:latin typeface="Ramabhadra" panose="02000600000000000000" pitchFamily="2" charset="0"/>
                 <a:cs typeface="Ramabhadra" panose="02000600000000000000" pitchFamily="2" charset="0"/>
               </a:rPr>
-              <a:t>దేవా నా దేవా –</a:t>
+              <a:t>నా ప్రాణమా నా అంతరంగమా </a:t>
+            </a:r>
+          </a:p>
+          <a:p>
+            <a:pPr algn="ctr"/>
+            <a:r>
+              <a:rPr lang="te-IN" dirty="0">
+                <a:solidFill>
+                  <a:schemeClr val="tx1"/>
+                </a:solidFill>
+                <a:latin typeface="Ramabhadra" panose="02000600000000000000" pitchFamily="2" charset="0"/>
+                <a:cs typeface="Ramabhadra" panose="02000600000000000000" pitchFamily="2" charset="0"/>
+              </a:rPr>
+              <a:t>నాలో వున్న నా సమస్తమా (2)</a:t>
+            </a:r>
+          </a:p>
+          <a:p>
+            <a:pPr algn="ctr"/>
+            <a:r>
+              <a:rPr lang="te-IN" dirty="0">
+                <a:solidFill>
+                  <a:schemeClr val="tx1"/>
+                </a:solidFill>
+                <a:latin typeface="Ramabhadra" panose="02000600000000000000" pitchFamily="2" charset="0"/>
+                <a:cs typeface="Ramabhadra" panose="02000600000000000000" pitchFamily="2" charset="0"/>
+              </a:rPr>
+              <a:t>యెహోవ చేసిన ఉపకారములలో</a:t>
+            </a:r>
+          </a:p>
+          <a:p>
+            <a:pPr algn="ctr"/>
+            <a:r>
+              <a:rPr lang="te-IN" dirty="0">
+                <a:solidFill>
+                  <a:schemeClr val="tx1"/>
+                </a:solidFill>
+                <a:latin typeface="Ramabhadra" panose="02000600000000000000" pitchFamily="2" charset="0"/>
+                <a:cs typeface="Ramabhadra" panose="02000600000000000000" pitchFamily="2" charset="0"/>
+              </a:rPr>
+              <a:t>దేనిని మరువక</a:t>
             </a:r>
             <a:endParaRPr lang="en-IN" dirty="0">
               <a:solidFill>
@@ -3945,9 +3980,12 @@
                 <a:latin typeface="Ramabhadra" panose="02000600000000000000" pitchFamily="2" charset="0"/>
                 <a:cs typeface="Ramabhadra" panose="02000600000000000000" pitchFamily="2" charset="0"/>
               </a:rPr>
-              <a:t>నీవే నా కాపరి</a:t>
-            </a:r>
-            <a:br>
+              <a:t>కొనియాడుమా (2)</a:t>
+            </a:r>
+          </a:p>
+          <a:p>
+            <a:pPr algn="ctr"/>
+            <a:r>
               <a:rPr lang="te-IN" dirty="0">
                 <a:solidFill>
                   <a:schemeClr val="tx1"/>
@@ -3955,7 +3993,21 @@
                 <a:latin typeface="Ramabhadra" panose="02000600000000000000" pitchFamily="2" charset="0"/>
                 <a:cs typeface="Ramabhadra" panose="02000600000000000000" pitchFamily="2" charset="0"/>
               </a:rPr>
-            </a:br>
+              <a:t>ఆ.. ఆ… ఆ.. ఆ… ఆ.. ఆ…</a:t>
+            </a:r>
+          </a:p>
+          <a:p>
+            <a:pPr algn="ctr"/>
+            <a:endParaRPr lang="te-IN" dirty="0">
+              <a:solidFill>
+                <a:schemeClr val="tx1"/>
+              </a:solidFill>
+              <a:latin typeface="Ramabhadra" panose="02000600000000000000" pitchFamily="2" charset="0"/>
+              <a:cs typeface="Ramabhadra" panose="02000600000000000000" pitchFamily="2" charset="0"/>
+            </a:endParaRPr>
+          </a:p>
+          <a:p>
+            <a:pPr algn="ctr"/>
             <a:r>
               <a:rPr lang="te-IN" dirty="0">
                 <a:solidFill>
@@ -3964,7 +4016,20 @@
                 <a:latin typeface="Ramabhadra" panose="02000600000000000000" pitchFamily="2" charset="0"/>
                 <a:cs typeface="Ramabhadra" panose="02000600000000000000" pitchFamily="2" charset="0"/>
               </a:rPr>
-              <a:t>నీ ప్రేమ నీ క్షమా –</a:t>
+              <a:t>నీ దోషములన్నిటిని క్షమియించువాడు </a:t>
+            </a:r>
+          </a:p>
+          <a:p>
+            <a:pPr algn="ctr"/>
+            <a:r>
+              <a:rPr lang="te-IN" dirty="0">
+                <a:solidFill>
+                  <a:schemeClr val="tx1"/>
+                </a:solidFill>
+                <a:latin typeface="Ramabhadra" panose="02000600000000000000" pitchFamily="2" charset="0"/>
+                <a:cs typeface="Ramabhadra" panose="02000600000000000000" pitchFamily="2" charset="0"/>
+              </a:rPr>
+              <a:t>నీ పాపములన్ని</a:t>
             </a:r>
             <a:endParaRPr lang="en-IN" dirty="0">
               <a:solidFill>
@@ -3984,9 +4049,12 @@
                 <a:latin typeface="Ramabhadra" panose="02000600000000000000" pitchFamily="2" charset="0"/>
                 <a:cs typeface="Ramabhadra" panose="02000600000000000000" pitchFamily="2" charset="0"/>
               </a:rPr>
-              <a:t>ఎంతో గొప్పది (2)</a:t>
-            </a:r>
-            <a:br>
+              <a:t>పార ద్రోలువాడు (2)</a:t>
+            </a:r>
+          </a:p>
+          <a:p>
+            <a:pPr algn="ctr"/>
+            <a:r>
               <a:rPr lang="te-IN" dirty="0">
                 <a:solidFill>
                   <a:schemeClr val="tx1"/>
@@ -3994,7 +4062,11 @@
                 <a:latin typeface="Ramabhadra" panose="02000600000000000000" pitchFamily="2" charset="0"/>
                 <a:cs typeface="Ramabhadra" panose="02000600000000000000" pitchFamily="2" charset="0"/>
               </a:rPr>
-            </a:br>
+              <a:t>పరమ వైద్యుడు ప్రభు యేసుడు </a:t>
+            </a:r>
+          </a:p>
+          <a:p>
+            <a:pPr algn="ctr"/>
             <a:r>
               <a:rPr lang="te-IN" dirty="0">
                 <a:solidFill>
@@ -4003,27 +4075,11 @@
                 <a:latin typeface="Ramabhadra" panose="02000600000000000000" pitchFamily="2" charset="0"/>
                 <a:cs typeface="Ramabhadra" panose="02000600000000000000" pitchFamily="2" charset="0"/>
               </a:rPr>
-              <a:t>ఆరాధింతును హృదయాంతరంగములో</a:t>
-            </a:r>
-            <a:br>
-              <a:rPr lang="te-IN" dirty="0">
-                <a:solidFill>
-                  <a:schemeClr val="tx1"/>
-                </a:solidFill>
-                <a:latin typeface="Ramabhadra" panose="02000600000000000000" pitchFamily="2" charset="0"/>
-                <a:cs typeface="Ramabhadra" panose="02000600000000000000" pitchFamily="2" charset="0"/>
-              </a:rPr>
-            </a:br>
-            <a:r>
-              <a:rPr lang="te-IN" dirty="0">
-                <a:solidFill>
-                  <a:schemeClr val="tx1"/>
-                </a:solidFill>
-                <a:latin typeface="Ramabhadra" panose="02000600000000000000" pitchFamily="2" charset="0"/>
-                <a:cs typeface="Ramabhadra" panose="02000600000000000000" pitchFamily="2" charset="0"/>
-              </a:rPr>
-              <a:t>స్తుతియింతును</a:t>
-            </a:r>
+              <a:t>పరిశుద్ధ నామమును సన్నుతించుమా (2)</a:t>
+            </a:r>
+          </a:p>
+          <a:p>
+            <a:pPr algn="ctr"/>
             <a:endParaRPr lang="en-IN" dirty="0">
               <a:solidFill>
                 <a:schemeClr val="tx1"/>
@@ -4042,9 +4098,12 @@
                 <a:latin typeface="Ramabhadra" panose="02000600000000000000" pitchFamily="2" charset="0"/>
                 <a:cs typeface="Ramabhadra" panose="02000600000000000000" pitchFamily="2" charset="0"/>
               </a:rPr>
-              <a:t>నీ పాద సన్నిధిలో (2)</a:t>
-            </a:r>
-            <a:br>
+              <a:t>సమాధిలోనుండి నీ ప్రాణమును </a:t>
+            </a:r>
+          </a:p>
+          <a:p>
+            <a:pPr algn="ctr"/>
+            <a:r>
               <a:rPr lang="te-IN" dirty="0">
                 <a:solidFill>
                   <a:schemeClr val="tx1"/>
@@ -4052,7 +4111,11 @@
                 <a:latin typeface="Ramabhadra" panose="02000600000000000000" pitchFamily="2" charset="0"/>
                 <a:cs typeface="Ramabhadra" panose="02000600000000000000" pitchFamily="2" charset="0"/>
               </a:rPr>
-            </a:br>
+              <a:t>విమోచించుచున్నాడు శ్రీయేసుడు (2)</a:t>
+            </a:r>
+          </a:p>
+          <a:p>
+            <a:pPr algn="ctr"/>
             <a:r>
               <a:rPr lang="te-IN" dirty="0">
                 <a:solidFill>
@@ -4061,20 +4124,7 @@
                 <a:latin typeface="Ramabhadra" panose="02000600000000000000" pitchFamily="2" charset="0"/>
                 <a:cs typeface="Ramabhadra" panose="02000600000000000000" pitchFamily="2" charset="0"/>
               </a:rPr>
-              <a:t>నీవే కదా దేవుడవు – (2)</a:t>
-            </a:r>
-          </a:p>
-          <a:p>
-            <a:pPr algn="ctr"/>
-            <a:r>
-              <a:rPr lang="te-IN" dirty="0">
-                <a:solidFill>
-                  <a:schemeClr val="tx1"/>
-                </a:solidFill>
-                <a:latin typeface="Ramabhadra" panose="02000600000000000000" pitchFamily="2" charset="0"/>
-                <a:cs typeface="Ramabhadra" panose="02000600000000000000" pitchFamily="2" charset="0"/>
-              </a:rPr>
-              <a:t>దేవా యేసు దేవా (4)</a:t>
+              <a:t>కరుణా కటాక్షములను</a:t>
             </a:r>
             <a:endParaRPr lang="en-IN" dirty="0">
               <a:solidFill>
@@ -4086,16 +4136,6 @@
           </a:p>
           <a:p>
             <a:pPr algn="ctr"/>
-            <a:endParaRPr lang="te-IN" dirty="0">
-              <a:solidFill>
-                <a:schemeClr val="tx1"/>
-              </a:solidFill>
-              <a:latin typeface="Ramabhadra" panose="02000600000000000000" pitchFamily="2" charset="0"/>
-              <a:cs typeface="Ramabhadra" panose="02000600000000000000" pitchFamily="2" charset="0"/>
-            </a:endParaRPr>
-          </a:p>
-          <a:p>
-            <a:pPr algn="ctr"/>
             <a:r>
               <a:rPr lang="te-IN" dirty="0">
                 <a:solidFill>
@@ -4104,9 +4144,12 @@
                 <a:latin typeface="Ramabhadra" panose="02000600000000000000" pitchFamily="2" charset="0"/>
                 <a:cs typeface="Ramabhadra" panose="02000600000000000000" pitchFamily="2" charset="0"/>
               </a:rPr>
-              <a:t>పాపము నుండి విడిపించినావు</a:t>
-            </a:r>
-            <a:br>
+              <a:t>నీకు కిరీటముగా </a:t>
+            </a:r>
+          </a:p>
+          <a:p>
+            <a:pPr algn="ctr"/>
+            <a:r>
               <a:rPr lang="te-IN" dirty="0">
                 <a:solidFill>
                   <a:schemeClr val="tx1"/>
@@ -4114,96 +4157,7 @@
                 <a:latin typeface="Ramabhadra" panose="02000600000000000000" pitchFamily="2" charset="0"/>
                 <a:cs typeface="Ramabhadra" panose="02000600000000000000" pitchFamily="2" charset="0"/>
               </a:rPr>
-            </a:br>
-            <a:r>
-              <a:rPr lang="te-IN" dirty="0">
-                <a:solidFill>
-                  <a:schemeClr val="tx1"/>
-                </a:solidFill>
-                <a:latin typeface="Ramabhadra" panose="02000600000000000000" pitchFamily="2" charset="0"/>
-                <a:cs typeface="Ramabhadra" panose="02000600000000000000" pitchFamily="2" charset="0"/>
-              </a:rPr>
-              <a:t>పరిశుద్ధుని చేసి ప్రేమించినావు (2)</a:t>
-            </a:r>
-            <a:br>
-              <a:rPr lang="te-IN" dirty="0">
-                <a:solidFill>
-                  <a:schemeClr val="tx1"/>
-                </a:solidFill>
-                <a:latin typeface="Ramabhadra" panose="02000600000000000000" pitchFamily="2" charset="0"/>
-                <a:cs typeface="Ramabhadra" panose="02000600000000000000" pitchFamily="2" charset="0"/>
-              </a:rPr>
-            </a:br>
-            <a:r>
-              <a:rPr lang="te-IN" dirty="0">
-                <a:solidFill>
-                  <a:schemeClr val="tx1"/>
-                </a:solidFill>
-                <a:latin typeface="Ramabhadra" panose="02000600000000000000" pitchFamily="2" charset="0"/>
-                <a:cs typeface="Ramabhadra" panose="02000600000000000000" pitchFamily="2" charset="0"/>
-              </a:rPr>
-              <a:t>నీవే కదా దేవుడవు – (2)</a:t>
-            </a:r>
-            <a:br>
-              <a:rPr lang="te-IN" dirty="0">
-                <a:solidFill>
-                  <a:schemeClr val="tx1"/>
-                </a:solidFill>
-                <a:latin typeface="Ramabhadra" panose="02000600000000000000" pitchFamily="2" charset="0"/>
-                <a:cs typeface="Ramabhadra" panose="02000600000000000000" pitchFamily="2" charset="0"/>
-              </a:rPr>
-            </a:br>
-            <a:r>
-              <a:rPr lang="te-IN" dirty="0">
-                <a:solidFill>
-                  <a:schemeClr val="tx1"/>
-                </a:solidFill>
-                <a:latin typeface="Ramabhadra" panose="02000600000000000000" pitchFamily="2" charset="0"/>
-                <a:cs typeface="Ramabhadra" panose="02000600000000000000" pitchFamily="2" charset="0"/>
-              </a:rPr>
-              <a:t>దేవా యేసు దేవా (4)</a:t>
-            </a:r>
-          </a:p>
-          <a:p>
-            <a:pPr algn="ctr"/>
-            <a:endParaRPr lang="te-IN" dirty="0">
-              <a:solidFill>
-                <a:schemeClr val="tx1"/>
-              </a:solidFill>
-              <a:latin typeface="Ramabhadra" panose="02000600000000000000" pitchFamily="2" charset="0"/>
-              <a:cs typeface="Ramabhadra" panose="02000600000000000000" pitchFamily="2" charset="0"/>
-            </a:endParaRPr>
-          </a:p>
-          <a:p>
-            <a:pPr algn="ctr"/>
-            <a:r>
-              <a:rPr lang="te-IN" dirty="0">
-                <a:solidFill>
-                  <a:schemeClr val="tx1"/>
-                </a:solidFill>
-                <a:latin typeface="Ramabhadra" panose="02000600000000000000" pitchFamily="2" charset="0"/>
-                <a:cs typeface="Ramabhadra" panose="02000600000000000000" pitchFamily="2" charset="0"/>
-              </a:rPr>
-              <a:t>పరిశుద్ధాత్మను నాలో నింపావు</a:t>
-            </a:r>
-            <a:br>
-              <a:rPr lang="te-IN" dirty="0">
-                <a:solidFill>
-                  <a:schemeClr val="tx1"/>
-                </a:solidFill>
-                <a:latin typeface="Ramabhadra" panose="02000600000000000000" pitchFamily="2" charset="0"/>
-                <a:cs typeface="Ramabhadra" panose="02000600000000000000" pitchFamily="2" charset="0"/>
-              </a:rPr>
-            </a:br>
-            <a:r>
-              <a:rPr lang="te-IN" dirty="0">
-                <a:solidFill>
-                  <a:schemeClr val="tx1"/>
-                </a:solidFill>
-                <a:latin typeface="Ramabhadra" panose="02000600000000000000" pitchFamily="2" charset="0"/>
-                <a:cs typeface="Ramabhadra" panose="02000600000000000000" pitchFamily="2" charset="0"/>
-              </a:rPr>
-              <a:t>మట్టి దేహమును</a:t>
+              <a:t>ధరియింపజేయును</a:t>
             </a:r>
             <a:endParaRPr lang="en-IN" dirty="0">
               <a:solidFill>
@@ -4223,45 +4177,7 @@
                 <a:latin typeface="Ramabhadra" panose="02000600000000000000" pitchFamily="2" charset="0"/>
                 <a:cs typeface="Ramabhadra" panose="02000600000000000000" pitchFamily="2" charset="0"/>
               </a:rPr>
-              <a:t>మహిమతో నింపావు (2)</a:t>
-            </a:r>
-            <a:br>
-              <a:rPr lang="te-IN" dirty="0">
-                <a:solidFill>
-                  <a:schemeClr val="tx1"/>
-                </a:solidFill>
-                <a:latin typeface="Ramabhadra" panose="02000600000000000000" pitchFamily="2" charset="0"/>
-                <a:cs typeface="Ramabhadra" panose="02000600000000000000" pitchFamily="2" charset="0"/>
-              </a:rPr>
-            </a:br>
-            <a:r>
-              <a:rPr lang="te-IN" dirty="0">
-                <a:solidFill>
-                  <a:schemeClr val="tx1"/>
-                </a:solidFill>
-                <a:latin typeface="Ramabhadra" panose="02000600000000000000" pitchFamily="2" charset="0"/>
-                <a:cs typeface="Ramabhadra" panose="02000600000000000000" pitchFamily="2" charset="0"/>
-              </a:rPr>
-              <a:t>నీవే కదా దేవుడవు – (2)</a:t>
-            </a:r>
-            <a:br>
-              <a:rPr lang="te-IN" dirty="0">
-                <a:solidFill>
-                  <a:schemeClr val="tx1"/>
-                </a:solidFill>
-                <a:latin typeface="Ramabhadra" panose="02000600000000000000" pitchFamily="2" charset="0"/>
-                <a:cs typeface="Ramabhadra" panose="02000600000000000000" pitchFamily="2" charset="0"/>
-              </a:rPr>
-            </a:br>
-            <a:r>
-              <a:rPr lang="te-IN" dirty="0">
-                <a:solidFill>
-                  <a:schemeClr val="tx1"/>
-                </a:solidFill>
-                <a:latin typeface="Ramabhadra" panose="02000600000000000000" pitchFamily="2" charset="0"/>
-                <a:cs typeface="Ramabhadra" panose="02000600000000000000" pitchFamily="2" charset="0"/>
-              </a:rPr>
-              <a:t>దేవా యేసు దేవా (4)</a:t>
+              <a:t>ప్రభు యేసుడు (2)</a:t>
             </a:r>
           </a:p>
         </p:txBody>
@@ -4319,16 +4235,84 @@
           <a:p>
             <a:pPr algn="ctr"/>
             <a:r>
-              <a:rPr lang="te-IN" dirty="0">
-                <a:solidFill>
-                  <a:schemeClr val="tx1"/>
-                </a:solidFill>
-                <a:latin typeface="Ramabhadra" panose="02000600000000000000" pitchFamily="2" charset="0"/>
-                <a:cs typeface="Ramabhadra" panose="02000600000000000000" pitchFamily="2" charset="0"/>
-              </a:rPr>
-              <a:t>స్తుతించి పాడెదం –</a:t>
-            </a:r>
-            <a:endParaRPr lang="en-IN" dirty="0">
+              <a:rPr lang="te-IN" sz="2000" dirty="0">
+                <a:solidFill>
+                  <a:schemeClr val="tx1"/>
+                </a:solidFill>
+                <a:latin typeface="Ramabhadra" panose="02000600000000000000" pitchFamily="2" charset="0"/>
+                <a:cs typeface="Ramabhadra" panose="02000600000000000000" pitchFamily="2" charset="0"/>
+              </a:rPr>
+              <a:t>ప్రేమించెదన్ అధికముగా</a:t>
+            </a:r>
+          </a:p>
+          <a:p>
+            <a:pPr algn="ctr"/>
+            <a:r>
+              <a:rPr lang="te-IN" sz="2000" dirty="0">
+                <a:solidFill>
+                  <a:schemeClr val="tx1"/>
+                </a:solidFill>
+                <a:latin typeface="Ramabhadra" panose="02000600000000000000" pitchFamily="2" charset="0"/>
+                <a:cs typeface="Ramabhadra" panose="02000600000000000000" pitchFamily="2" charset="0"/>
+              </a:rPr>
+              <a:t>ఆరాధింతున్ ఆసక్తితో (2)</a:t>
+            </a:r>
+          </a:p>
+          <a:p>
+            <a:pPr algn="ctr"/>
+            <a:r>
+              <a:rPr lang="te-IN" sz="2000" dirty="0">
+                <a:solidFill>
+                  <a:schemeClr val="tx1"/>
+                </a:solidFill>
+                <a:latin typeface="Ramabhadra" panose="02000600000000000000" pitchFamily="2" charset="0"/>
+                <a:cs typeface="Ramabhadra" panose="02000600000000000000" pitchFamily="2" charset="0"/>
+              </a:rPr>
+              <a:t>నిన్ను పూర్ణ మనసుతో ఆరాధింతున్</a:t>
+            </a:r>
+          </a:p>
+          <a:p>
+            <a:pPr algn="ctr"/>
+            <a:r>
+              <a:rPr lang="te-IN" sz="2000" dirty="0">
+                <a:solidFill>
+                  <a:schemeClr val="tx1"/>
+                </a:solidFill>
+                <a:latin typeface="Ramabhadra" panose="02000600000000000000" pitchFamily="2" charset="0"/>
+                <a:cs typeface="Ramabhadra" panose="02000600000000000000" pitchFamily="2" charset="0"/>
+              </a:rPr>
+              <a:t>పూర్ణ బలముతో ప్రేమించెదన్</a:t>
+            </a:r>
+          </a:p>
+          <a:p>
+            <a:pPr algn="ctr"/>
+            <a:r>
+              <a:rPr lang="te-IN" sz="2000" dirty="0">
+                <a:solidFill>
+                  <a:schemeClr val="tx1"/>
+                </a:solidFill>
+                <a:latin typeface="Ramabhadra" panose="02000600000000000000" pitchFamily="2" charset="0"/>
+                <a:cs typeface="Ramabhadra" panose="02000600000000000000" pitchFamily="2" charset="0"/>
+              </a:rPr>
+              <a:t>ఆరాధన ఆరాధనా ఆ.. ఆ.. </a:t>
+            </a:r>
+          </a:p>
+          <a:p>
+            <a:pPr algn="ctr"/>
+            <a:r>
+              <a:rPr lang="te-IN" sz="2000" dirty="0">
+                <a:solidFill>
+                  <a:schemeClr val="tx1"/>
+                </a:solidFill>
+                <a:latin typeface="Ramabhadra" panose="02000600000000000000" pitchFamily="2" charset="0"/>
+                <a:cs typeface="Ramabhadra" panose="02000600000000000000" pitchFamily="2" charset="0"/>
+              </a:rPr>
+              <a:t>ఆరాధన ఆరాధనా (2)</a:t>
+            </a:r>
+          </a:p>
+          <a:p>
+            <a:pPr algn="ctr"/>
+            <a:endParaRPr lang="te-IN" sz="2000" dirty="0">
               <a:solidFill>
                 <a:schemeClr val="tx1"/>
               </a:solidFill>
@@ -4339,101 +4323,29 @@
           <a:p>
             <a:pPr algn="ctr"/>
             <a:r>
-              <a:rPr lang="te-IN" dirty="0">
-                <a:solidFill>
-                  <a:schemeClr val="tx1"/>
-                </a:solidFill>
-                <a:latin typeface="Ramabhadra" panose="02000600000000000000" pitchFamily="2" charset="0"/>
-                <a:cs typeface="Ramabhadra" panose="02000600000000000000" pitchFamily="2" charset="0"/>
-              </a:rPr>
-              <a:t>స్తుతుల స్తోత్రార్హుడా</a:t>
-            </a:r>
-          </a:p>
-          <a:p>
-            <a:pPr algn="ctr"/>
-            <a:r>
-              <a:rPr lang="te-IN" dirty="0">
-                <a:solidFill>
-                  <a:schemeClr val="tx1"/>
-                </a:solidFill>
-                <a:latin typeface="Ramabhadra" panose="02000600000000000000" pitchFamily="2" charset="0"/>
-                <a:cs typeface="Ramabhadra" panose="02000600000000000000" pitchFamily="2" charset="0"/>
-              </a:rPr>
-              <a:t>ఉత్సాహించి పాడెదం – ఉదయ సాయంత్రముల్</a:t>
-            </a:r>
-          </a:p>
-          <a:p>
-            <a:pPr algn="ctr"/>
-            <a:r>
-              <a:rPr lang="te-IN" dirty="0">
-                <a:solidFill>
-                  <a:schemeClr val="tx1"/>
-                </a:solidFill>
-                <a:latin typeface="Ramabhadra" panose="02000600000000000000" pitchFamily="2" charset="0"/>
-                <a:cs typeface="Ramabhadra" panose="02000600000000000000" pitchFamily="2" charset="0"/>
-              </a:rPr>
-              <a:t>స్తుతుల సింహాసనం</a:t>
-            </a:r>
-          </a:p>
-          <a:p>
-            <a:pPr algn="ctr"/>
-            <a:r>
-              <a:rPr lang="te-IN" dirty="0">
-                <a:solidFill>
-                  <a:schemeClr val="tx1"/>
-                </a:solidFill>
-                <a:latin typeface="Ramabhadra" panose="02000600000000000000" pitchFamily="2" charset="0"/>
-                <a:cs typeface="Ramabhadra" panose="02000600000000000000" pitchFamily="2" charset="0"/>
-              </a:rPr>
-              <a:t>మీద</a:t>
-            </a:r>
-            <a:r>
-              <a:rPr lang="en-IN" dirty="0">
-                <a:solidFill>
-                  <a:schemeClr val="tx1"/>
-                </a:solidFill>
-                <a:latin typeface="Ramabhadra" panose="02000600000000000000" pitchFamily="2" charset="0"/>
-                <a:cs typeface="Ramabhadra" panose="02000600000000000000" pitchFamily="2" charset="0"/>
-              </a:rPr>
-              <a:t> </a:t>
-            </a:r>
-            <a:r>
-              <a:rPr lang="te-IN" dirty="0">
-                <a:solidFill>
-                  <a:schemeClr val="tx1"/>
-                </a:solidFill>
-                <a:latin typeface="Ramabhadra" panose="02000600000000000000" pitchFamily="2" charset="0"/>
-                <a:cs typeface="Ramabhadra" panose="02000600000000000000" pitchFamily="2" charset="0"/>
-              </a:rPr>
-              <a:t>ఆసీనుడా</a:t>
-            </a:r>
-          </a:p>
-          <a:p>
-            <a:pPr algn="ctr"/>
-            <a:r>
-              <a:rPr lang="te-IN" dirty="0">
-                <a:solidFill>
-                  <a:schemeClr val="tx1"/>
-                </a:solidFill>
-                <a:latin typeface="Ramabhadra" panose="02000600000000000000" pitchFamily="2" charset="0"/>
-                <a:cs typeface="Ramabhadra" panose="02000600000000000000" pitchFamily="2" charset="0"/>
-              </a:rPr>
-              <a:t>మా స్తుతి ఆరాధన</a:t>
-            </a:r>
-          </a:p>
-          <a:p>
-            <a:pPr algn="ctr"/>
-            <a:r>
-              <a:rPr lang="te-IN" dirty="0">
-                <a:solidFill>
-                  <a:schemeClr val="tx1"/>
-                </a:solidFill>
-                <a:latin typeface="Ramabhadra" panose="02000600000000000000" pitchFamily="2" charset="0"/>
-                <a:cs typeface="Ramabhadra" panose="02000600000000000000" pitchFamily="2" charset="0"/>
-              </a:rPr>
-              <a:t>నీకే చెల్లింతుము (2)</a:t>
-            </a:r>
-            <a:endParaRPr lang="en-IN" dirty="0">
+              <a:rPr lang="te-IN" sz="2000" dirty="0">
+                <a:solidFill>
+                  <a:schemeClr val="tx1"/>
+                </a:solidFill>
+                <a:latin typeface="Ramabhadra" panose="02000600000000000000" pitchFamily="2" charset="0"/>
+                <a:cs typeface="Ramabhadra" panose="02000600000000000000" pitchFamily="2" charset="0"/>
+              </a:rPr>
+              <a:t>ఎబినేజరే ఎబినేజరే</a:t>
+            </a:r>
+          </a:p>
+          <a:p>
+            <a:pPr algn="ctr"/>
+            <a:r>
+              <a:rPr lang="te-IN" sz="2000" dirty="0">
+                <a:solidFill>
+                  <a:schemeClr val="tx1"/>
+                </a:solidFill>
+                <a:latin typeface="Ramabhadra" panose="02000600000000000000" pitchFamily="2" charset="0"/>
+                <a:cs typeface="Ramabhadra" panose="02000600000000000000" pitchFamily="2" charset="0"/>
+              </a:rPr>
+              <a:t>ఇంత వరకు</a:t>
+            </a:r>
+            <a:endParaRPr lang="en-IN" sz="2000" dirty="0">
               <a:solidFill>
                 <a:schemeClr val="tx1"/>
               </a:solidFill>
@@ -4443,7 +4355,33 @@
           </a:p>
           <a:p>
             <a:pPr algn="ctr"/>
-            <a:endParaRPr lang="te-IN" dirty="0">
+            <a:r>
+              <a:rPr lang="te-IN" sz="2000" dirty="0">
+                <a:solidFill>
+                  <a:schemeClr val="tx1"/>
+                </a:solidFill>
+                <a:latin typeface="Ramabhadra" panose="02000600000000000000" pitchFamily="2" charset="0"/>
+                <a:cs typeface="Ramabhadra" panose="02000600000000000000" pitchFamily="2" charset="0"/>
+              </a:rPr>
+              <a:t>ఆదుకొన్నావే (2)</a:t>
+            </a:r>
+          </a:p>
+          <a:p>
+            <a:pPr algn="ctr"/>
+            <a:r>
+              <a:rPr lang="te-IN" sz="2000" dirty="0">
+                <a:solidFill>
+                  <a:schemeClr val="tx1"/>
+                </a:solidFill>
+                <a:latin typeface="Ramabhadra" panose="02000600000000000000" pitchFamily="2" charset="0"/>
+                <a:cs typeface="Ramabhadra" panose="02000600000000000000" pitchFamily="2" charset="0"/>
+              </a:rPr>
+              <a:t>నన్ను ఇంత వరకు ఆదుకొన్నావే</a:t>
+            </a:r>
+          </a:p>
+          <a:p>
+            <a:pPr algn="ctr"/>
+            <a:endParaRPr lang="te-IN" sz="2000" dirty="0">
               <a:solidFill>
                 <a:schemeClr val="tx1"/>
               </a:solidFill>
@@ -4454,201 +4392,40 @@
           <a:p>
             <a:pPr algn="ctr"/>
             <a:r>
-              <a:rPr lang="te-IN" dirty="0">
-                <a:solidFill>
-                  <a:schemeClr val="tx1"/>
-                </a:solidFill>
-                <a:latin typeface="Ramabhadra" panose="02000600000000000000" pitchFamily="2" charset="0"/>
-                <a:cs typeface="Ramabhadra" panose="02000600000000000000" pitchFamily="2" charset="0"/>
-              </a:rPr>
-              <a:t>గతకాలమంతా నీవు –</a:t>
-            </a:r>
-            <a:endParaRPr lang="en-IN" dirty="0">
-              <a:solidFill>
-                <a:schemeClr val="tx1"/>
-              </a:solidFill>
-              <a:latin typeface="Ramabhadra" panose="02000600000000000000" pitchFamily="2" charset="0"/>
-              <a:cs typeface="Ramabhadra" panose="02000600000000000000" pitchFamily="2" charset="0"/>
-            </a:endParaRPr>
-          </a:p>
-          <a:p>
-            <a:pPr algn="ctr"/>
-            <a:r>
-              <a:rPr lang="te-IN" dirty="0">
-                <a:solidFill>
-                  <a:schemeClr val="tx1"/>
-                </a:solidFill>
-                <a:latin typeface="Ramabhadra" panose="02000600000000000000" pitchFamily="2" charset="0"/>
-                <a:cs typeface="Ramabhadra" panose="02000600000000000000" pitchFamily="2" charset="0"/>
-              </a:rPr>
-              <a:t>మము కాచి కాపాడావు</a:t>
-            </a:r>
-          </a:p>
-          <a:p>
-            <a:pPr algn="ctr"/>
-            <a:r>
-              <a:rPr lang="te-IN" dirty="0">
-                <a:solidFill>
-                  <a:schemeClr val="tx1"/>
-                </a:solidFill>
-                <a:latin typeface="Ramabhadra" panose="02000600000000000000" pitchFamily="2" charset="0"/>
-                <a:cs typeface="Ramabhadra" panose="02000600000000000000" pitchFamily="2" charset="0"/>
-              </a:rPr>
-              <a:t>వ్యధలన్ని తీసావు (2)</a:t>
-            </a:r>
-          </a:p>
-          <a:p>
-            <a:pPr algn="ctr"/>
-            <a:r>
-              <a:rPr lang="te-IN" dirty="0">
-                <a:solidFill>
-                  <a:schemeClr val="tx1"/>
-                </a:solidFill>
-                <a:latin typeface="Ramabhadra" panose="02000600000000000000" pitchFamily="2" charset="0"/>
-                <a:cs typeface="Ramabhadra" panose="02000600000000000000" pitchFamily="2" charset="0"/>
-              </a:rPr>
-              <a:t>గతి లేని మాపై నీవు</a:t>
-            </a:r>
-          </a:p>
-          <a:p>
-            <a:pPr algn="ctr"/>
-            <a:r>
-              <a:rPr lang="te-IN" dirty="0">
-                <a:solidFill>
-                  <a:schemeClr val="tx1"/>
-                </a:solidFill>
-                <a:latin typeface="Ramabhadra" panose="02000600000000000000" pitchFamily="2" charset="0"/>
-                <a:cs typeface="Ramabhadra" panose="02000600000000000000" pitchFamily="2" charset="0"/>
-              </a:rPr>
-              <a:t>మితిలేని ప్రేమ చూపి (2)</a:t>
-            </a:r>
-          </a:p>
-          <a:p>
-            <a:pPr algn="ctr"/>
-            <a:r>
-              <a:rPr lang="te-IN" dirty="0">
-                <a:solidFill>
-                  <a:schemeClr val="tx1"/>
-                </a:solidFill>
-                <a:latin typeface="Ramabhadra" panose="02000600000000000000" pitchFamily="2" charset="0"/>
-                <a:cs typeface="Ramabhadra" panose="02000600000000000000" pitchFamily="2" charset="0"/>
-              </a:rPr>
-              <a:t>శత సంఖ్యగా</a:t>
-            </a:r>
-            <a:endParaRPr lang="en-IN" dirty="0">
-              <a:solidFill>
-                <a:schemeClr val="tx1"/>
-              </a:solidFill>
-              <a:latin typeface="Ramabhadra" panose="02000600000000000000" pitchFamily="2" charset="0"/>
-              <a:cs typeface="Ramabhadra" panose="02000600000000000000" pitchFamily="2" charset="0"/>
-            </a:endParaRPr>
-          </a:p>
-          <a:p>
-            <a:pPr algn="ctr"/>
-            <a:r>
-              <a:rPr lang="te-IN" dirty="0">
-                <a:solidFill>
-                  <a:schemeClr val="tx1"/>
-                </a:solidFill>
-                <a:latin typeface="Ramabhadra" panose="02000600000000000000" pitchFamily="2" charset="0"/>
-                <a:cs typeface="Ramabhadra" panose="02000600000000000000" pitchFamily="2" charset="0"/>
-              </a:rPr>
-              <a:t>మమ్ము</a:t>
-            </a:r>
-            <a:r>
-              <a:rPr lang="en-IN" dirty="0">
-                <a:solidFill>
-                  <a:schemeClr val="tx1"/>
-                </a:solidFill>
-                <a:latin typeface="Ramabhadra" panose="02000600000000000000" pitchFamily="2" charset="0"/>
-                <a:cs typeface="Ramabhadra" panose="02000600000000000000" pitchFamily="2" charset="0"/>
-              </a:rPr>
-              <a:t> </a:t>
-            </a:r>
-            <a:r>
-              <a:rPr lang="te-IN" dirty="0">
-                <a:solidFill>
-                  <a:schemeClr val="tx1"/>
-                </a:solidFill>
-                <a:latin typeface="Ramabhadra" panose="02000600000000000000" pitchFamily="2" charset="0"/>
-                <a:cs typeface="Ramabhadra" panose="02000600000000000000" pitchFamily="2" charset="0"/>
-              </a:rPr>
-              <a:t>దీవించావు</a:t>
-            </a:r>
-          </a:p>
-          <a:p>
-            <a:pPr algn="ctr"/>
-            <a:endParaRPr lang="te-IN" dirty="0">
-              <a:solidFill>
-                <a:schemeClr val="tx1"/>
-              </a:solidFill>
-              <a:latin typeface="Ramabhadra" panose="02000600000000000000" pitchFamily="2" charset="0"/>
-              <a:cs typeface="Ramabhadra" panose="02000600000000000000" pitchFamily="2" charset="0"/>
-            </a:endParaRPr>
-          </a:p>
-          <a:p>
-            <a:pPr algn="ctr"/>
-            <a:r>
-              <a:rPr lang="te-IN" dirty="0">
-                <a:solidFill>
-                  <a:schemeClr val="tx1"/>
-                </a:solidFill>
-                <a:latin typeface="Ramabhadra" panose="02000600000000000000" pitchFamily="2" charset="0"/>
-                <a:cs typeface="Ramabhadra" panose="02000600000000000000" pitchFamily="2" charset="0"/>
-              </a:rPr>
-              <a:t>కరుణా కటాక్షములను కిరీటములగాను</a:t>
-            </a:r>
-          </a:p>
-          <a:p>
-            <a:pPr algn="ctr"/>
-            <a:r>
-              <a:rPr lang="te-IN" dirty="0">
-                <a:solidFill>
-                  <a:schemeClr val="tx1"/>
-                </a:solidFill>
-                <a:latin typeface="Ramabhadra" panose="02000600000000000000" pitchFamily="2" charset="0"/>
-                <a:cs typeface="Ramabhadra" panose="02000600000000000000" pitchFamily="2" charset="0"/>
-              </a:rPr>
-              <a:t>ఉంచావు మా తలపై (2)</a:t>
-            </a:r>
-          </a:p>
-          <a:p>
-            <a:pPr algn="ctr"/>
-            <a:r>
-              <a:rPr lang="te-IN" dirty="0">
-                <a:solidFill>
-                  <a:schemeClr val="tx1"/>
-                </a:solidFill>
-                <a:latin typeface="Ramabhadra" panose="02000600000000000000" pitchFamily="2" charset="0"/>
-                <a:cs typeface="Ramabhadra" panose="02000600000000000000" pitchFamily="2" charset="0"/>
-              </a:rPr>
-              <a:t>పక్షి రాజు యవ్వనమువలె</a:t>
-            </a:r>
-          </a:p>
-          <a:p>
-            <a:pPr algn="ctr"/>
-            <a:r>
-              <a:rPr lang="te-IN" dirty="0">
-                <a:solidFill>
-                  <a:schemeClr val="tx1"/>
-                </a:solidFill>
-                <a:latin typeface="Ramabhadra" panose="02000600000000000000" pitchFamily="2" charset="0"/>
-                <a:cs typeface="Ramabhadra" panose="02000600000000000000" pitchFamily="2" charset="0"/>
-              </a:rPr>
-              <a:t>మా యవ్వనమునంతా (2)</a:t>
-            </a:r>
-          </a:p>
-          <a:p>
-            <a:pPr algn="ctr"/>
-            <a:r>
-              <a:rPr lang="te-IN" dirty="0">
-                <a:solidFill>
-                  <a:schemeClr val="tx1"/>
-                </a:solidFill>
-                <a:latin typeface="Ramabhadra" panose="02000600000000000000" pitchFamily="2" charset="0"/>
-                <a:cs typeface="Ramabhadra" panose="02000600000000000000" pitchFamily="2" charset="0"/>
-              </a:rPr>
-              <a:t>ఉత్తేజపరిచి తృప్తిని ఇచ్చావు</a:t>
+              <a:rPr lang="te-IN" sz="2000" dirty="0">
+                <a:solidFill>
+                  <a:schemeClr val="tx1"/>
+                </a:solidFill>
+                <a:latin typeface="Ramabhadra" panose="02000600000000000000" pitchFamily="2" charset="0"/>
+                <a:cs typeface="Ramabhadra" panose="02000600000000000000" pitchFamily="2" charset="0"/>
+              </a:rPr>
+              <a:t>ఎల్రోహి ఎల్రోహి</a:t>
+            </a:r>
+          </a:p>
+          <a:p>
+            <a:pPr algn="ctr"/>
+            <a:r>
+              <a:rPr lang="te-IN" sz="2000" dirty="0">
+                <a:solidFill>
+                  <a:schemeClr val="tx1"/>
+                </a:solidFill>
+                <a:latin typeface="Ramabhadra" panose="02000600000000000000" pitchFamily="2" charset="0"/>
+                <a:cs typeface="Ramabhadra" panose="02000600000000000000" pitchFamily="2" charset="0"/>
+              </a:rPr>
+              <a:t>నన్ను చూచావే వందనమయ్యా (2)</a:t>
+            </a:r>
+          </a:p>
+          <a:p>
+            <a:pPr algn="ctr"/>
+            <a:r>
+              <a:rPr lang="te-IN" sz="2000" dirty="0">
+                <a:solidFill>
+                  <a:schemeClr val="tx1"/>
+                </a:solidFill>
+                <a:latin typeface="Ramabhadra" panose="02000600000000000000" pitchFamily="2" charset="0"/>
+                <a:cs typeface="Ramabhadra" panose="02000600000000000000" pitchFamily="2" charset="0"/>
+              </a:rPr>
+              <a:t>నన్ను చూచావే వందనమయ్యా</a:t>
             </a:r>
           </a:p>
         </p:txBody>
@@ -4706,32 +4483,88 @@
           <a:p>
             <a:pPr algn="ctr"/>
             <a:r>
-              <a:rPr lang="te-IN" sz="1550" dirty="0">
-                <a:solidFill>
-                  <a:schemeClr val="tx1"/>
-                </a:solidFill>
-                <a:latin typeface="Ramabhadra" panose="02000600000000000000" pitchFamily="2" charset="0"/>
-                <a:cs typeface="Ramabhadra" panose="02000600000000000000" pitchFamily="2" charset="0"/>
-              </a:rPr>
-              <a:t>యేసయ్యా నీ కృప నాకు చాలయ్యా</a:t>
-            </a:r>
-          </a:p>
-          <a:p>
-            <a:pPr algn="ctr"/>
-            <a:r>
-              <a:rPr lang="te-IN" sz="1550" dirty="0">
-                <a:solidFill>
-                  <a:schemeClr val="tx1"/>
-                </a:solidFill>
-                <a:latin typeface="Ramabhadra" panose="02000600000000000000" pitchFamily="2" charset="0"/>
-                <a:cs typeface="Ramabhadra" panose="02000600000000000000" pitchFamily="2" charset="0"/>
-              </a:rPr>
-              <a:t>నీ కృప లేనిదే నే బ్రతుకలేనయ్యా</a:t>
-            </a:r>
-          </a:p>
-          <a:p>
-            <a:pPr algn="ctr"/>
-            <a:endParaRPr lang="te-IN" sz="1550" dirty="0">
+              <a:rPr lang="te-IN" dirty="0">
+                <a:solidFill>
+                  <a:schemeClr val="tx1"/>
+                </a:solidFill>
+                <a:latin typeface="Ramabhadra" panose="02000600000000000000" pitchFamily="2" charset="0"/>
+                <a:cs typeface="Ramabhadra" panose="02000600000000000000" pitchFamily="2" charset="0"/>
+              </a:rPr>
+              <a:t>నీ వాక్యమే నన్ను బ్రతికించెను</a:t>
+            </a:r>
+          </a:p>
+          <a:p>
+            <a:pPr algn="ctr"/>
+            <a:r>
+              <a:rPr lang="te-IN" dirty="0">
+                <a:solidFill>
+                  <a:schemeClr val="tx1"/>
+                </a:solidFill>
+                <a:latin typeface="Ramabhadra" panose="02000600000000000000" pitchFamily="2" charset="0"/>
+                <a:cs typeface="Ramabhadra" panose="02000600000000000000" pitchFamily="2" charset="0"/>
+              </a:rPr>
+              <a:t>బాధలలో నెమ్మదినిచ్చెను (2)</a:t>
+            </a:r>
+          </a:p>
+          <a:p>
+            <a:pPr algn="ctr"/>
+            <a:r>
+              <a:rPr lang="te-IN" dirty="0">
+                <a:solidFill>
+                  <a:schemeClr val="tx1"/>
+                </a:solidFill>
+                <a:latin typeface="Ramabhadra" panose="02000600000000000000" pitchFamily="2" charset="0"/>
+                <a:cs typeface="Ramabhadra" panose="02000600000000000000" pitchFamily="2" charset="0"/>
+              </a:rPr>
+              <a:t>కృపా శక్తి దయా సత్య సంపూర్ణుడా</a:t>
+            </a:r>
+          </a:p>
+          <a:p>
+            <a:pPr algn="ctr"/>
+            <a:r>
+              <a:rPr lang="te-IN" dirty="0">
+                <a:solidFill>
+                  <a:schemeClr val="tx1"/>
+                </a:solidFill>
+                <a:latin typeface="Ramabhadra" panose="02000600000000000000" pitchFamily="2" charset="0"/>
+                <a:cs typeface="Ramabhadra" panose="02000600000000000000" pitchFamily="2" charset="0"/>
+              </a:rPr>
+              <a:t>వాక్యమై ఉన్న</a:t>
+            </a:r>
+            <a:r>
+              <a:rPr lang="en-IN" dirty="0">
+                <a:solidFill>
+                  <a:schemeClr val="tx1"/>
+                </a:solidFill>
+                <a:latin typeface="Ramabhadra" panose="02000600000000000000" pitchFamily="2" charset="0"/>
+                <a:cs typeface="Ramabhadra" panose="02000600000000000000" pitchFamily="2" charset="0"/>
+              </a:rPr>
+              <a:t> </a:t>
+            </a:r>
+            <a:r>
+              <a:rPr lang="te-IN" dirty="0">
+                <a:solidFill>
+                  <a:schemeClr val="tx1"/>
+                </a:solidFill>
+                <a:latin typeface="Ramabhadra" panose="02000600000000000000" pitchFamily="2" charset="0"/>
+                <a:cs typeface="Ramabhadra" panose="02000600000000000000" pitchFamily="2" charset="0"/>
+              </a:rPr>
+              <a:t>యేసు వందనమయ్యా (2</a:t>
+            </a:r>
+            <a:r>
+              <a:rPr lang="en-IN" dirty="0">
+                <a:solidFill>
+                  <a:schemeClr val="tx1"/>
+                </a:solidFill>
+                <a:latin typeface="Ramabhadra" panose="02000600000000000000" pitchFamily="2" charset="0"/>
+                <a:cs typeface="Ramabhadra" panose="02000600000000000000" pitchFamily="2" charset="0"/>
+              </a:rPr>
+              <a:t>)</a:t>
+            </a:r>
+          </a:p>
+          <a:p>
+            <a:pPr algn="ctr"/>
+            <a:endParaRPr lang="te-IN" dirty="0">
               <a:solidFill>
                 <a:schemeClr val="tx1"/>
               </a:solidFill>
@@ -4742,16 +4575,29 @@
           <a:p>
             <a:pPr algn="ctr"/>
             <a:r>
-              <a:rPr lang="te-IN" sz="1550" dirty="0">
-                <a:solidFill>
-                  <a:schemeClr val="tx1"/>
-                </a:solidFill>
-                <a:latin typeface="Ramabhadra" panose="02000600000000000000" pitchFamily="2" charset="0"/>
-                <a:cs typeface="Ramabhadra" panose="02000600000000000000" pitchFamily="2" charset="0"/>
-              </a:rPr>
-              <a:t>నీ కృప లేని క్షణము –</a:t>
-            </a:r>
-            <a:endParaRPr lang="en-IN" sz="1550" dirty="0">
+              <a:rPr lang="te-IN" dirty="0">
+                <a:solidFill>
+                  <a:schemeClr val="tx1"/>
+                </a:solidFill>
+                <a:latin typeface="Ramabhadra" panose="02000600000000000000" pitchFamily="2" charset="0"/>
+                <a:cs typeface="Ramabhadra" panose="02000600000000000000" pitchFamily="2" charset="0"/>
+              </a:rPr>
+              <a:t>జిగటగల ఊభినుండి లేవనెత్తెను</a:t>
+            </a:r>
+          </a:p>
+          <a:p>
+            <a:pPr algn="ctr"/>
+            <a:r>
+              <a:rPr lang="te-IN" dirty="0">
+                <a:solidFill>
+                  <a:schemeClr val="tx1"/>
+                </a:solidFill>
+                <a:latin typeface="Ramabhadra" panose="02000600000000000000" pitchFamily="2" charset="0"/>
+                <a:cs typeface="Ramabhadra" panose="02000600000000000000" pitchFamily="2" charset="0"/>
+              </a:rPr>
+              <a:t>సమతలమగు భూమిపై</a:t>
+            </a:r>
+            <a:endParaRPr lang="en-IN" dirty="0">
               <a:solidFill>
                 <a:schemeClr val="tx1"/>
               </a:solidFill>
@@ -4762,55 +4608,29 @@
           <a:p>
             <a:pPr algn="ctr"/>
             <a:r>
-              <a:rPr lang="te-IN" sz="1550" dirty="0">
-                <a:solidFill>
-                  <a:schemeClr val="tx1"/>
-                </a:solidFill>
-                <a:latin typeface="Ramabhadra" panose="02000600000000000000" pitchFamily="2" charset="0"/>
-                <a:cs typeface="Ramabhadra" panose="02000600000000000000" pitchFamily="2" charset="0"/>
-              </a:rPr>
-              <a:t>నీ దయ లేని క్షణము</a:t>
-            </a:r>
-          </a:p>
-          <a:p>
-            <a:pPr algn="ctr"/>
-            <a:r>
-              <a:rPr lang="te-IN" sz="1550" dirty="0">
-                <a:solidFill>
-                  <a:schemeClr val="tx1"/>
-                </a:solidFill>
-                <a:latin typeface="Ramabhadra" panose="02000600000000000000" pitchFamily="2" charset="0"/>
-                <a:cs typeface="Ramabhadra" panose="02000600000000000000" pitchFamily="2" charset="0"/>
-              </a:rPr>
-              <a:t>నేనూహించలేను యేసయ్యా (2)</a:t>
-            </a:r>
-          </a:p>
-          <a:p>
-            <a:pPr algn="ctr"/>
-            <a:r>
-              <a:rPr lang="te-IN" sz="1550" dirty="0">
-                <a:solidFill>
-                  <a:schemeClr val="tx1"/>
-                </a:solidFill>
-                <a:latin typeface="Ramabhadra" panose="02000600000000000000" pitchFamily="2" charset="0"/>
-                <a:cs typeface="Ramabhadra" panose="02000600000000000000" pitchFamily="2" charset="0"/>
-              </a:rPr>
-              <a:t>యేసయ్యా నీ కృప నాకు చాలయ్యా</a:t>
-            </a:r>
-          </a:p>
-          <a:p>
-            <a:pPr algn="ctr"/>
-            <a:r>
-              <a:rPr lang="te-IN" sz="1550" dirty="0">
-                <a:solidFill>
-                  <a:schemeClr val="tx1"/>
-                </a:solidFill>
-                <a:latin typeface="Ramabhadra" panose="02000600000000000000" pitchFamily="2" charset="0"/>
-                <a:cs typeface="Ramabhadra" panose="02000600000000000000" pitchFamily="2" charset="0"/>
-              </a:rPr>
-              <a:t>నీ కృప లేనిదే నేనుండలేనయ్యా (2)</a:t>
-            </a:r>
-            <a:endParaRPr lang="en-IN" sz="1550" dirty="0">
+              <a:rPr lang="te-IN" dirty="0">
+                <a:solidFill>
+                  <a:schemeClr val="tx1"/>
+                </a:solidFill>
+                <a:latin typeface="Ramabhadra" panose="02000600000000000000" pitchFamily="2" charset="0"/>
+                <a:cs typeface="Ramabhadra" panose="02000600000000000000" pitchFamily="2" charset="0"/>
+              </a:rPr>
+              <a:t>నన్ను నిలిపెను (2)</a:t>
+            </a:r>
+          </a:p>
+          <a:p>
+            <a:pPr algn="ctr"/>
+            <a:r>
+              <a:rPr lang="te-IN" dirty="0">
+                <a:solidFill>
+                  <a:schemeClr val="tx1"/>
+                </a:solidFill>
+                <a:latin typeface="Ramabhadra" panose="02000600000000000000" pitchFamily="2" charset="0"/>
+                <a:cs typeface="Ramabhadra" panose="02000600000000000000" pitchFamily="2" charset="0"/>
+              </a:rPr>
+              <a:t>నా పాదములకు</a:t>
+            </a:r>
+            <a:endParaRPr lang="en-IN" dirty="0">
               <a:solidFill>
                 <a:schemeClr val="tx1"/>
               </a:solidFill>
@@ -4820,7 +4640,40 @@
           </a:p>
           <a:p>
             <a:pPr algn="ctr"/>
-            <a:endParaRPr lang="te-IN" sz="1550" dirty="0">
+            <a:r>
+              <a:rPr lang="te-IN" dirty="0">
+                <a:solidFill>
+                  <a:schemeClr val="tx1"/>
+                </a:solidFill>
+                <a:latin typeface="Ramabhadra" panose="02000600000000000000" pitchFamily="2" charset="0"/>
+                <a:cs typeface="Ramabhadra" panose="02000600000000000000" pitchFamily="2" charset="0"/>
+              </a:rPr>
+              <a:t>దీపమాయెను (2)</a:t>
+            </a:r>
+          </a:p>
+          <a:p>
+            <a:pPr algn="ctr"/>
+            <a:r>
+              <a:rPr lang="te-IN" dirty="0">
+                <a:solidFill>
+                  <a:schemeClr val="tx1"/>
+                </a:solidFill>
+                <a:latin typeface="Ramabhadra" panose="02000600000000000000" pitchFamily="2" charset="0"/>
+                <a:cs typeface="Ramabhadra" panose="02000600000000000000" pitchFamily="2" charset="0"/>
+              </a:rPr>
+              <a:t>సత్యమైన మార్గములో నడుపుచుండెను (2</a:t>
+            </a:r>
+            <a:r>
+              <a:rPr lang="en-IN" dirty="0">
+                <a:solidFill>
+                  <a:schemeClr val="tx1"/>
+                </a:solidFill>
+                <a:latin typeface="Ramabhadra" panose="02000600000000000000" pitchFamily="2" charset="0"/>
+                <a:cs typeface="Ramabhadra" panose="02000600000000000000" pitchFamily="2" charset="0"/>
+              </a:rPr>
+              <a:t>)</a:t>
+            </a:r>
+            <a:endParaRPr lang="te-IN" dirty="0">
               <a:solidFill>
                 <a:schemeClr val="tx1"/>
               </a:solidFill>
@@ -4830,17 +4683,7 @@
           </a:p>
           <a:p>
             <a:pPr algn="ctr"/>
-            <a:r>
-              <a:rPr lang="te-IN" sz="1550" dirty="0">
-                <a:solidFill>
-                  <a:schemeClr val="tx1"/>
-                </a:solidFill>
-                <a:latin typeface="Ramabhadra" panose="02000600000000000000" pitchFamily="2" charset="0"/>
-                <a:cs typeface="Ramabhadra" panose="02000600000000000000" pitchFamily="2" charset="0"/>
-              </a:rPr>
-              <a:t>మహిమను విడిచి</a:t>
-            </a:r>
-            <a:endParaRPr lang="en-IN" sz="1550" dirty="0">
+            <a:endParaRPr lang="te-IN" dirty="0">
               <a:solidFill>
                 <a:schemeClr val="tx1"/>
               </a:solidFill>
@@ -4851,65 +4694,16 @@
           <a:p>
             <a:pPr algn="ctr"/>
             <a:r>
-              <a:rPr lang="te-IN" sz="1550" dirty="0">
-                <a:solidFill>
-                  <a:schemeClr val="tx1"/>
-                </a:solidFill>
-                <a:latin typeface="Ramabhadra" panose="02000600000000000000" pitchFamily="2" charset="0"/>
-                <a:cs typeface="Ramabhadra" panose="02000600000000000000" pitchFamily="2" charset="0"/>
-              </a:rPr>
-              <a:t>మహిలోకి దిగి వచ్చి</a:t>
-            </a:r>
-          </a:p>
-          <a:p>
-            <a:pPr algn="ctr"/>
-            <a:r>
-              <a:rPr lang="te-IN" sz="1550" dirty="0">
-                <a:solidFill>
-                  <a:schemeClr val="tx1"/>
-                </a:solidFill>
-                <a:latin typeface="Ramabhadra" panose="02000600000000000000" pitchFamily="2" charset="0"/>
-                <a:cs typeface="Ramabhadra" panose="02000600000000000000" pitchFamily="2" charset="0"/>
-              </a:rPr>
-              <a:t>మార్గముగా మారి మనిషిగా మార్చావు</a:t>
-            </a:r>
-          </a:p>
-          <a:p>
-            <a:pPr algn="ctr"/>
-            <a:r>
-              <a:rPr lang="te-IN" sz="1550">
-                <a:solidFill>
-                  <a:schemeClr val="tx1"/>
-                </a:solidFill>
-                <a:latin typeface="Ramabhadra" panose="02000600000000000000" pitchFamily="2" charset="0"/>
-                <a:cs typeface="Ramabhadra" panose="02000600000000000000" pitchFamily="2" charset="0"/>
-              </a:rPr>
-              <a:t>మహినె </a:t>
-            </a:r>
-            <a:r>
-              <a:rPr lang="te-IN" sz="1550" dirty="0">
-                <a:solidFill>
-                  <a:schemeClr val="tx1"/>
-                </a:solidFill>
-                <a:latin typeface="Ramabhadra" panose="02000600000000000000" pitchFamily="2" charset="0"/>
-                <a:cs typeface="Ramabhadra" panose="02000600000000000000" pitchFamily="2" charset="0"/>
-              </a:rPr>
-              <a:t>నీవు మాధుర్యముగా మార్చి</a:t>
-            </a:r>
-          </a:p>
-          <a:p>
-            <a:pPr algn="ctr"/>
-            <a:r>
-              <a:rPr lang="te-IN" sz="1550" dirty="0">
-                <a:solidFill>
-                  <a:schemeClr val="tx1"/>
-                </a:solidFill>
-                <a:latin typeface="Ramabhadra" panose="02000600000000000000" pitchFamily="2" charset="0"/>
-                <a:cs typeface="Ramabhadra" panose="02000600000000000000" pitchFamily="2" charset="0"/>
-              </a:rPr>
-              <a:t>మాదిరి చూపి</a:t>
-            </a:r>
-            <a:endParaRPr lang="en-IN" sz="1550" dirty="0">
+              <a:rPr lang="te-IN" dirty="0">
+                <a:solidFill>
+                  <a:schemeClr val="tx1"/>
+                </a:solidFill>
+                <a:latin typeface="Ramabhadra" panose="02000600000000000000" pitchFamily="2" charset="0"/>
+                <a:cs typeface="Ramabhadra" panose="02000600000000000000" pitchFamily="2" charset="0"/>
+              </a:rPr>
+              <a:t>శత్రువులను ఎదుర్కొనే</a:t>
+            </a:r>
+            <a:endParaRPr lang="en-IN" dirty="0">
               <a:solidFill>
                 <a:schemeClr val="tx1"/>
               </a:solidFill>
@@ -4920,42 +4714,42 @@
           <a:p>
             <a:pPr algn="ctr"/>
             <a:r>
-              <a:rPr lang="te-IN" sz="1550" dirty="0">
-                <a:solidFill>
-                  <a:schemeClr val="tx1"/>
-                </a:solidFill>
-                <a:latin typeface="Ramabhadra" panose="02000600000000000000" pitchFamily="2" charset="0"/>
-                <a:cs typeface="Ramabhadra" panose="02000600000000000000" pitchFamily="2" charset="0"/>
-              </a:rPr>
-              <a:t>మరో రూపమిచ్చావు (2)</a:t>
-            </a:r>
-          </a:p>
-          <a:p>
-            <a:pPr algn="ctr"/>
-            <a:r>
-              <a:rPr lang="te-IN" sz="1550" dirty="0">
-                <a:solidFill>
-                  <a:schemeClr val="tx1"/>
-                </a:solidFill>
-                <a:latin typeface="Ramabhadra" panose="02000600000000000000" pitchFamily="2" charset="0"/>
-                <a:cs typeface="Ramabhadra" panose="02000600000000000000" pitchFamily="2" charset="0"/>
-              </a:rPr>
-              <a:t>మహిమలో నేను మహిమను పొంద</a:t>
-            </a:r>
-          </a:p>
-          <a:p>
-            <a:pPr algn="ctr"/>
-            <a:r>
-              <a:rPr lang="te-IN" sz="1550" dirty="0">
-                <a:solidFill>
-                  <a:schemeClr val="tx1"/>
-                </a:solidFill>
-                <a:latin typeface="Ramabhadra" panose="02000600000000000000" pitchFamily="2" charset="0"/>
-                <a:cs typeface="Ramabhadra" panose="02000600000000000000" pitchFamily="2" charset="0"/>
-              </a:rPr>
-              <a:t>మహిమగా మార్చింది నీ కృప (2)</a:t>
-            </a:r>
-            <a:endParaRPr lang="en-IN" sz="1550" dirty="0">
+              <a:rPr lang="te-IN" dirty="0">
+                <a:solidFill>
+                  <a:schemeClr val="tx1"/>
+                </a:solidFill>
+                <a:latin typeface="Ramabhadra" panose="02000600000000000000" pitchFamily="2" charset="0"/>
+                <a:cs typeface="Ramabhadra" panose="02000600000000000000" pitchFamily="2" charset="0"/>
+              </a:rPr>
+              <a:t>సర్వాంగ కవచమై</a:t>
+            </a:r>
+          </a:p>
+          <a:p>
+            <a:pPr algn="ctr"/>
+            <a:r>
+              <a:rPr lang="te-IN" dirty="0">
+                <a:solidFill>
+                  <a:schemeClr val="tx1"/>
+                </a:solidFill>
+                <a:latin typeface="Ramabhadra" panose="02000600000000000000" pitchFamily="2" charset="0"/>
+                <a:cs typeface="Ramabhadra" panose="02000600000000000000" pitchFamily="2" charset="0"/>
+              </a:rPr>
+              <a:t>యుద్ధమునకు సిద్ధ మనసు ఇచ్చుచున్నది (2)</a:t>
+            </a:r>
+          </a:p>
+          <a:p>
+            <a:pPr algn="ctr"/>
+            <a:r>
+              <a:rPr lang="te-IN" dirty="0">
+                <a:solidFill>
+                  <a:schemeClr val="tx1"/>
+                </a:solidFill>
+                <a:latin typeface="Ramabhadra" panose="02000600000000000000" pitchFamily="2" charset="0"/>
+                <a:cs typeface="Ramabhadra" panose="02000600000000000000" pitchFamily="2" charset="0"/>
+              </a:rPr>
+              <a:t>అపవాది వేయుచున్న</a:t>
+            </a:r>
+            <a:endParaRPr lang="en-IN" dirty="0">
               <a:solidFill>
                 <a:schemeClr val="tx1"/>
               </a:solidFill>
@@ -4965,7 +4759,30 @@
           </a:p>
           <a:p>
             <a:pPr algn="ctr"/>
-            <a:endParaRPr lang="te-IN" sz="1550" dirty="0">
+            <a:r>
+              <a:rPr lang="te-IN" dirty="0">
+                <a:solidFill>
+                  <a:schemeClr val="tx1"/>
+                </a:solidFill>
+                <a:latin typeface="Ramabhadra" panose="02000600000000000000" pitchFamily="2" charset="0"/>
+                <a:cs typeface="Ramabhadra" panose="02000600000000000000" pitchFamily="2" charset="0"/>
+              </a:rPr>
+              <a:t>అగ్ని బాణములను (2)</a:t>
+            </a:r>
+          </a:p>
+          <a:p>
+            <a:pPr algn="ctr"/>
+            <a:r>
+              <a:rPr lang="te-IN" dirty="0">
+                <a:solidFill>
+                  <a:schemeClr val="tx1"/>
+                </a:solidFill>
+                <a:latin typeface="Ramabhadra" panose="02000600000000000000" pitchFamily="2" charset="0"/>
+                <a:cs typeface="Ramabhadra" panose="02000600000000000000" pitchFamily="2" charset="0"/>
+              </a:rPr>
+              <a:t>ఖడ్గము వలె అడ్డుకొని</a:t>
+            </a:r>
+            <a:endParaRPr lang="en-IN" dirty="0">
               <a:solidFill>
                 <a:schemeClr val="tx1"/>
               </a:solidFill>
@@ -4976,101 +4793,16 @@
           <a:p>
             <a:pPr algn="ctr"/>
             <a:r>
-              <a:rPr lang="te-IN" sz="1550" dirty="0">
-                <a:solidFill>
-                  <a:schemeClr val="tx1"/>
-                </a:solidFill>
-                <a:latin typeface="Ramabhadra" panose="02000600000000000000" pitchFamily="2" charset="0"/>
-                <a:cs typeface="Ramabhadra" panose="02000600000000000000" pitchFamily="2" charset="0"/>
-              </a:rPr>
-              <a:t>ఆజ్ఞల మార్గమున ఆశ్రయమును ఇచ్చి</a:t>
-            </a:r>
-          </a:p>
-          <a:p>
-            <a:pPr algn="ctr"/>
-            <a:r>
-              <a:rPr lang="te-IN" sz="1550" dirty="0">
-                <a:solidFill>
-                  <a:schemeClr val="tx1"/>
-                </a:solidFill>
-                <a:latin typeface="Ramabhadra" panose="02000600000000000000" pitchFamily="2" charset="0"/>
-                <a:cs typeface="Ramabhadra" panose="02000600000000000000" pitchFamily="2" charset="0"/>
-              </a:rPr>
-              <a:t>ఆపత్కాలమున ఆదుకొన్నావు</a:t>
-            </a:r>
-          </a:p>
-          <a:p>
-            <a:pPr algn="ctr"/>
-            <a:r>
-              <a:rPr lang="te-IN" sz="1550" dirty="0">
-                <a:solidFill>
-                  <a:schemeClr val="tx1"/>
-                </a:solidFill>
-                <a:latin typeface="Ramabhadra" panose="02000600000000000000" pitchFamily="2" charset="0"/>
-                <a:cs typeface="Ramabhadra" panose="02000600000000000000" pitchFamily="2" charset="0"/>
-              </a:rPr>
-              <a:t>ఆత్మీయులతో ఆనందింప చేసి</a:t>
-            </a:r>
-          </a:p>
-          <a:p>
-            <a:pPr algn="ctr"/>
-            <a:r>
-              <a:rPr lang="te-IN" sz="1550" dirty="0">
-                <a:solidFill>
-                  <a:schemeClr val="tx1"/>
-                </a:solidFill>
-                <a:latin typeface="Ramabhadra" panose="02000600000000000000" pitchFamily="2" charset="0"/>
-                <a:cs typeface="Ramabhadra" panose="02000600000000000000" pitchFamily="2" charset="0"/>
-              </a:rPr>
-              <a:t>ఆనంద తైలముతో</a:t>
-            </a:r>
-            <a:endParaRPr lang="en-IN" sz="1550" dirty="0">
-              <a:solidFill>
-                <a:schemeClr val="tx1"/>
-              </a:solidFill>
-              <a:latin typeface="Ramabhadra" panose="02000600000000000000" pitchFamily="2" charset="0"/>
-              <a:cs typeface="Ramabhadra" panose="02000600000000000000" pitchFamily="2" charset="0"/>
-            </a:endParaRPr>
-          </a:p>
-          <a:p>
-            <a:pPr algn="ctr"/>
-            <a:r>
-              <a:rPr lang="te-IN" sz="1550" dirty="0">
-                <a:solidFill>
-                  <a:schemeClr val="tx1"/>
-                </a:solidFill>
-                <a:latin typeface="Ramabhadra" panose="02000600000000000000" pitchFamily="2" charset="0"/>
-                <a:cs typeface="Ramabhadra" panose="02000600000000000000" pitchFamily="2" charset="0"/>
-              </a:rPr>
-              <a:t>అభిషేకించావు (2)</a:t>
-            </a:r>
-          </a:p>
-          <a:p>
-            <a:pPr algn="ctr"/>
-            <a:r>
-              <a:rPr lang="te-IN" sz="1550" dirty="0">
-                <a:solidFill>
-                  <a:schemeClr val="tx1"/>
-                </a:solidFill>
-                <a:latin typeface="Ramabhadra" panose="02000600000000000000" pitchFamily="2" charset="0"/>
-                <a:cs typeface="Ramabhadra" panose="02000600000000000000" pitchFamily="2" charset="0"/>
-              </a:rPr>
-              <a:t>ఆశ తీర ఆరాధన చేసే</a:t>
-            </a:r>
-          </a:p>
-          <a:p>
-            <a:pPr algn="ctr"/>
-            <a:r>
-              <a:rPr lang="te-IN" sz="1550" dirty="0">
-                <a:solidFill>
-                  <a:schemeClr val="tx1"/>
-                </a:solidFill>
-                <a:latin typeface="Ramabhadra" panose="02000600000000000000" pitchFamily="2" charset="0"/>
-                <a:cs typeface="Ramabhadra" panose="02000600000000000000" pitchFamily="2" charset="0"/>
-              </a:rPr>
-              <a:t>అదృష్టమిచ్చింది నీ కృప (2)</a:t>
-            </a:r>
-            <a:endParaRPr lang="en-IN" sz="1550" dirty="0">
+              <a:rPr lang="te-IN" dirty="0">
+                <a:solidFill>
+                  <a:schemeClr val="tx1"/>
+                </a:solidFill>
+                <a:latin typeface="Ramabhadra" panose="02000600000000000000" pitchFamily="2" charset="0"/>
+                <a:cs typeface="Ramabhadra" panose="02000600000000000000" pitchFamily="2" charset="0"/>
+              </a:rPr>
+              <a:t>ఆర్పి వేయుచున్నది (2) </a:t>
+            </a:r>
+            <a:endParaRPr lang="en-IN" dirty="0">
               <a:solidFill>
                 <a:schemeClr val="tx1"/>
               </a:solidFill>

</xml_diff>

<commit_message>
18 sudnay aug 24
</commit_message>
<xml_diff>
--- a/xerox.pptx
+++ b/xerox.pptx
@@ -224,7 +224,7 @@
           <a:p>
             <a:fld id="{3502DD63-DF8D-4AB8-92A0-0ECCF612C06C}" type="datetimeFigureOut">
               <a:rPr lang="en-IN" smtClean="0"/>
-              <a:t>10-08-2024</a:t>
+              <a:t>11-08-2024</a:t>
             </a:fld>
             <a:endParaRPr lang="en-IN"/>
           </a:p>
@@ -402,7 +402,7 @@
           <a:p>
             <a:fld id="{1AE741EC-1360-4793-999B-941E0396C9FA}" type="datetimeFigureOut">
               <a:rPr lang="en-IN" smtClean="0"/>
-              <a:t>10-08-2024</a:t>
+              <a:t>11-08-2024</a:t>
             </a:fld>
             <a:endParaRPr lang="en-IN"/>
           </a:p>
@@ -802,7 +802,7 @@
           <a:p>
             <a:fld id="{86FBD32F-FCAD-481A-B7D8-4D813FB7DB24}" type="datetimeFigureOut">
               <a:rPr lang="en-IN" smtClean="0"/>
-              <a:t>10-08-2024</a:t>
+              <a:t>11-08-2024</a:t>
             </a:fld>
             <a:endParaRPr lang="en-IN"/>
           </a:p>
@@ -972,7 +972,7 @@
           <a:p>
             <a:fld id="{86FBD32F-FCAD-481A-B7D8-4D813FB7DB24}" type="datetimeFigureOut">
               <a:rPr lang="en-IN" smtClean="0"/>
-              <a:t>10-08-2024</a:t>
+              <a:t>11-08-2024</a:t>
             </a:fld>
             <a:endParaRPr lang="en-IN"/>
           </a:p>
@@ -1152,7 +1152,7 @@
           <a:p>
             <a:fld id="{86FBD32F-FCAD-481A-B7D8-4D813FB7DB24}" type="datetimeFigureOut">
               <a:rPr lang="en-IN" smtClean="0"/>
-              <a:t>10-08-2024</a:t>
+              <a:t>11-08-2024</a:t>
             </a:fld>
             <a:endParaRPr lang="en-IN"/>
           </a:p>
@@ -1322,7 +1322,7 @@
           <a:p>
             <a:fld id="{86FBD32F-FCAD-481A-B7D8-4D813FB7DB24}" type="datetimeFigureOut">
               <a:rPr lang="en-IN" smtClean="0"/>
-              <a:t>10-08-2024</a:t>
+              <a:t>11-08-2024</a:t>
             </a:fld>
             <a:endParaRPr lang="en-IN"/>
           </a:p>
@@ -1566,7 +1566,7 @@
           <a:p>
             <a:fld id="{86FBD32F-FCAD-481A-B7D8-4D813FB7DB24}" type="datetimeFigureOut">
               <a:rPr lang="en-IN" smtClean="0"/>
-              <a:t>10-08-2024</a:t>
+              <a:t>11-08-2024</a:t>
             </a:fld>
             <a:endParaRPr lang="en-IN"/>
           </a:p>
@@ -1798,7 +1798,7 @@
           <a:p>
             <a:fld id="{86FBD32F-FCAD-481A-B7D8-4D813FB7DB24}" type="datetimeFigureOut">
               <a:rPr lang="en-IN" smtClean="0"/>
-              <a:t>10-08-2024</a:t>
+              <a:t>11-08-2024</a:t>
             </a:fld>
             <a:endParaRPr lang="en-IN"/>
           </a:p>
@@ -2165,7 +2165,7 @@
           <a:p>
             <a:fld id="{86FBD32F-FCAD-481A-B7D8-4D813FB7DB24}" type="datetimeFigureOut">
               <a:rPr lang="en-IN" smtClean="0"/>
-              <a:t>10-08-2024</a:t>
+              <a:t>11-08-2024</a:t>
             </a:fld>
             <a:endParaRPr lang="en-IN"/>
           </a:p>
@@ -2283,7 +2283,7 @@
           <a:p>
             <a:fld id="{86FBD32F-FCAD-481A-B7D8-4D813FB7DB24}" type="datetimeFigureOut">
               <a:rPr lang="en-IN" smtClean="0"/>
-              <a:t>10-08-2024</a:t>
+              <a:t>11-08-2024</a:t>
             </a:fld>
             <a:endParaRPr lang="en-IN"/>
           </a:p>
@@ -2378,7 +2378,7 @@
           <a:p>
             <a:fld id="{86FBD32F-FCAD-481A-B7D8-4D813FB7DB24}" type="datetimeFigureOut">
               <a:rPr lang="en-IN" smtClean="0"/>
-              <a:t>10-08-2024</a:t>
+              <a:t>11-08-2024</a:t>
             </a:fld>
             <a:endParaRPr lang="en-IN"/>
           </a:p>
@@ -2655,7 +2655,7 @@
           <a:p>
             <a:fld id="{86FBD32F-FCAD-481A-B7D8-4D813FB7DB24}" type="datetimeFigureOut">
               <a:rPr lang="en-IN" smtClean="0"/>
-              <a:t>10-08-2024</a:t>
+              <a:t>11-08-2024</a:t>
             </a:fld>
             <a:endParaRPr lang="en-IN"/>
           </a:p>
@@ -2912,7 +2912,7 @@
           <a:p>
             <a:fld id="{86FBD32F-FCAD-481A-B7D8-4D813FB7DB24}" type="datetimeFigureOut">
               <a:rPr lang="en-IN" smtClean="0"/>
-              <a:t>10-08-2024</a:t>
+              <a:t>11-08-2024</a:t>
             </a:fld>
             <a:endParaRPr lang="en-IN"/>
           </a:p>
@@ -3125,7 +3125,7 @@
           <a:p>
             <a:fld id="{86FBD32F-FCAD-481A-B7D8-4D813FB7DB24}" type="datetimeFigureOut">
               <a:rPr lang="en-IN" smtClean="0"/>
-              <a:t>10-08-2024</a:t>
+              <a:t>11-08-2024</a:t>
             </a:fld>
             <a:endParaRPr lang="en-IN"/>
           </a:p>
@@ -3581,279 +3581,196 @@
           <a:bodyPr rtlCol="0" anchor="ctr"/>
           <a:lstStyle/>
           <a:p>
-            <a:pPr algn="ctr"/>
+            <a:pPr algn="ctr" defTabSz="439781"/>
             <a:r>
               <a:rPr lang="te-IN" sz="2000" dirty="0">
                 <a:solidFill>
-                  <a:schemeClr val="tx1"/>
-                </a:solidFill>
-                <a:latin typeface="Ramabhadra" panose="02000600000000000000" pitchFamily="2" charset="0"/>
-                <a:cs typeface="Ramabhadra" panose="02000600000000000000" pitchFamily="2" charset="0"/>
-              </a:rPr>
-              <a:t>యేసే నా పరిహారి</a:t>
-            </a:r>
-            <a:endParaRPr lang="en-IN" sz="2000" dirty="0">
+                  <a:prstClr val="black"/>
+                </a:solidFill>
+                <a:latin typeface="Ramabhadra" panose="02000600000000000000" pitchFamily="2" charset="0"/>
+                <a:cs typeface="Ramabhadra" panose="02000600000000000000" pitchFamily="2" charset="0"/>
+              </a:rPr>
+              <a:t>దేవా నీవే - నా జీవం నీవే</a:t>
+            </a:r>
+          </a:p>
+          <a:p>
+            <a:pPr algn="ctr" defTabSz="439781"/>
+            <a:r>
+              <a:rPr lang="te-IN" sz="2000" dirty="0">
+                <a:solidFill>
+                  <a:prstClr val="black"/>
+                </a:solidFill>
+                <a:latin typeface="Ramabhadra" panose="02000600000000000000" pitchFamily="2" charset="0"/>
+                <a:cs typeface="Ramabhadra" panose="02000600000000000000" pitchFamily="2" charset="0"/>
+              </a:rPr>
+              <a:t>రా యేసయ్య త్వరలో</a:t>
+            </a:r>
+          </a:p>
+          <a:p>
+            <a:pPr algn="ctr" defTabSz="439781"/>
+            <a:r>
+              <a:rPr lang="te-IN" sz="2000" dirty="0">
+                <a:solidFill>
+                  <a:prstClr val="black"/>
+                </a:solidFill>
+                <a:latin typeface="Ramabhadra" panose="02000600000000000000" pitchFamily="2" charset="0"/>
+                <a:cs typeface="Ramabhadra" panose="02000600000000000000" pitchFamily="2" charset="0"/>
+              </a:rPr>
+              <a:t>నీ రాక కోరి</a:t>
+            </a:r>
+          </a:p>
+          <a:p>
+            <a:pPr algn="ctr" defTabSz="439781"/>
+            <a:r>
+              <a:rPr lang="te-IN" sz="2000" dirty="0">
+                <a:solidFill>
+                  <a:prstClr val="black"/>
+                </a:solidFill>
+                <a:latin typeface="Ramabhadra" panose="02000600000000000000" pitchFamily="2" charset="0"/>
+                <a:cs typeface="Ramabhadra" panose="02000600000000000000" pitchFamily="2" charset="0"/>
+              </a:rPr>
+              <a:t>నే వేచియున్నా – </a:t>
+            </a:r>
+          </a:p>
+          <a:p>
+            <a:pPr algn="ctr" defTabSz="439781"/>
+            <a:r>
+              <a:rPr lang="te-IN" sz="2000" dirty="0">
+                <a:solidFill>
+                  <a:prstClr val="black"/>
+                </a:solidFill>
+                <a:latin typeface="Ramabhadra" panose="02000600000000000000" pitchFamily="2" charset="0"/>
+                <a:cs typeface="Ramabhadra" panose="02000600000000000000" pitchFamily="2" charset="0"/>
+              </a:rPr>
+              <a:t>రారాజా త్వరలో  </a:t>
+            </a:r>
+          </a:p>
+          <a:p>
+            <a:pPr algn="ctr" defTabSz="439781"/>
+            <a:endParaRPr lang="te-IN" sz="2000" dirty="0">
               <a:solidFill>
-                <a:schemeClr val="tx1"/>
+                <a:prstClr val="black"/>
               </a:solidFill>
               <a:latin typeface="Ramabhadra" panose="02000600000000000000" pitchFamily="2" charset="0"/>
               <a:cs typeface="Ramabhadra" panose="02000600000000000000" pitchFamily="2" charset="0"/>
             </a:endParaRPr>
           </a:p>
           <a:p>
-            <a:pPr algn="ctr"/>
+            <a:pPr algn="ctr" defTabSz="439781"/>
             <a:r>
               <a:rPr lang="te-IN" sz="2000" dirty="0">
                 <a:solidFill>
-                  <a:schemeClr val="tx1"/>
-                </a:solidFill>
-                <a:latin typeface="Ramabhadra" panose="02000600000000000000" pitchFamily="2" charset="0"/>
-                <a:cs typeface="Ramabhadra" panose="02000600000000000000" pitchFamily="2" charset="0"/>
-              </a:rPr>
-              <a:t>ప్రియ యేసే నా పరిహారి</a:t>
-            </a:r>
-            <a:br>
+                  <a:prstClr val="black"/>
+                </a:solidFill>
+                <a:latin typeface="Ramabhadra" panose="02000600000000000000" pitchFamily="2" charset="0"/>
+                <a:cs typeface="Ramabhadra" panose="02000600000000000000" pitchFamily="2" charset="0"/>
+              </a:rPr>
+              <a:t>నీ వాగ్ధనము నమ్మి – </a:t>
+            </a:r>
+          </a:p>
+          <a:p>
+            <a:pPr algn="ctr" defTabSz="439781"/>
+            <a:r>
               <a:rPr lang="te-IN" sz="2000" dirty="0">
                 <a:solidFill>
-                  <a:schemeClr val="tx1"/>
-                </a:solidFill>
-                <a:latin typeface="Ramabhadra" panose="02000600000000000000" pitchFamily="2" charset="0"/>
-                <a:cs typeface="Ramabhadra" panose="02000600000000000000" pitchFamily="2" charset="0"/>
-              </a:rPr>
-            </a:br>
+                  <a:prstClr val="black"/>
+                </a:solidFill>
+                <a:latin typeface="Ramabhadra" panose="02000600000000000000" pitchFamily="2" charset="0"/>
+                <a:cs typeface="Ramabhadra" panose="02000600000000000000" pitchFamily="2" charset="0"/>
+              </a:rPr>
+              <a:t>ఆశతో వేచియున్నాను </a:t>
+            </a:r>
+          </a:p>
+          <a:p>
+            <a:pPr algn="ctr" defTabSz="439781"/>
             <a:r>
               <a:rPr lang="te-IN" sz="2000" dirty="0">
                 <a:solidFill>
-                  <a:schemeClr val="tx1"/>
-                </a:solidFill>
-                <a:latin typeface="Ramabhadra" panose="02000600000000000000" pitchFamily="2" charset="0"/>
-                <a:cs typeface="Ramabhadra" panose="02000600000000000000" pitchFamily="2" charset="0"/>
-              </a:rPr>
-              <a:t>   నా జీవిత కాలమెల్ల</a:t>
-            </a:r>
-            <a:endParaRPr lang="en-IN" sz="2000" dirty="0">
+                  <a:prstClr val="black"/>
+                </a:solidFill>
+                <a:latin typeface="Ramabhadra" panose="02000600000000000000" pitchFamily="2" charset="0"/>
+                <a:cs typeface="Ramabhadra" panose="02000600000000000000" pitchFamily="2" charset="0"/>
+              </a:rPr>
+              <a:t>నీవున్న చోటికి నన్ను – </a:t>
+            </a:r>
+          </a:p>
+          <a:p>
+            <a:pPr algn="ctr" defTabSz="439781"/>
+            <a:r>
+              <a:rPr lang="te-IN" sz="2000" dirty="0">
+                <a:solidFill>
+                  <a:prstClr val="black"/>
+                </a:solidFill>
+                <a:latin typeface="Ramabhadra" panose="02000600000000000000" pitchFamily="2" charset="0"/>
+                <a:cs typeface="Ramabhadra" panose="02000600000000000000" pitchFamily="2" charset="0"/>
+              </a:rPr>
+              <a:t>కొనిపోవ వేగమె రావా </a:t>
+            </a:r>
+          </a:p>
+          <a:p>
+            <a:pPr algn="ctr" defTabSz="439781"/>
+            <a:endParaRPr lang="te-IN" sz="2000" dirty="0">
               <a:solidFill>
-                <a:schemeClr val="tx1"/>
+                <a:prstClr val="black"/>
               </a:solidFill>
               <a:latin typeface="Ramabhadra" panose="02000600000000000000" pitchFamily="2" charset="0"/>
               <a:cs typeface="Ramabhadra" panose="02000600000000000000" pitchFamily="2" charset="0"/>
             </a:endParaRPr>
           </a:p>
           <a:p>
-            <a:pPr algn="ctr"/>
+            <a:pPr algn="ctr" defTabSz="439781"/>
             <a:r>
               <a:rPr lang="te-IN" sz="2000" dirty="0">
                 <a:solidFill>
-                  <a:schemeClr val="tx1"/>
-                </a:solidFill>
-                <a:latin typeface="Ramabhadra" panose="02000600000000000000" pitchFamily="2" charset="0"/>
-                <a:cs typeface="Ramabhadra" panose="02000600000000000000" pitchFamily="2" charset="0"/>
-              </a:rPr>
-              <a:t>ప్రియ ప్రభువే</a:t>
-            </a:r>
-            <a:r>
-              <a:rPr lang="en-IN" sz="2000" dirty="0">
-                <a:solidFill>
-                  <a:schemeClr val="tx1"/>
-                </a:solidFill>
-                <a:latin typeface="Ramabhadra" panose="02000600000000000000" pitchFamily="2" charset="0"/>
-                <a:cs typeface="Ramabhadra" panose="02000600000000000000" pitchFamily="2" charset="0"/>
-              </a:rPr>
-              <a:t> </a:t>
-            </a:r>
+                  <a:prstClr val="black"/>
+                </a:solidFill>
+                <a:latin typeface="Ramabhadra" panose="02000600000000000000" pitchFamily="2" charset="0"/>
+                <a:cs typeface="Ramabhadra" panose="02000600000000000000" pitchFamily="2" charset="0"/>
+              </a:rPr>
+              <a:t>మేఘాలపై నీవురాగా – </a:t>
+            </a:r>
+          </a:p>
+          <a:p>
+            <a:pPr algn="ctr" defTabSz="439781"/>
             <a:r>
               <a:rPr lang="te-IN" sz="2000" dirty="0">
                 <a:solidFill>
-                  <a:schemeClr val="tx1"/>
-                </a:solidFill>
-                <a:latin typeface="Ramabhadra" panose="02000600000000000000" pitchFamily="2" charset="0"/>
-                <a:cs typeface="Ramabhadra" panose="02000600000000000000" pitchFamily="2" charset="0"/>
-              </a:rPr>
-              <a:t>నా పరిహారి (2)</a:t>
-            </a:r>
-          </a:p>
-          <a:p>
-            <a:pPr algn="ctr"/>
-            <a:endParaRPr lang="te-IN" sz="2000" dirty="0">
-              <a:solidFill>
-                <a:schemeClr val="tx1"/>
-              </a:solidFill>
-              <a:latin typeface="Ramabhadra" panose="02000600000000000000" pitchFamily="2" charset="0"/>
-              <a:cs typeface="Ramabhadra" panose="02000600000000000000" pitchFamily="2" charset="0"/>
-            </a:endParaRPr>
-          </a:p>
-          <a:p>
-            <a:pPr algn="ctr"/>
+                  <a:prstClr val="black"/>
+                </a:solidFill>
+                <a:latin typeface="Ramabhadra" panose="02000600000000000000" pitchFamily="2" charset="0"/>
+                <a:cs typeface="Ramabhadra" panose="02000600000000000000" pitchFamily="2" charset="0"/>
+              </a:rPr>
+              <a:t>దూత గణమెల్ల కొనియాడ</a:t>
+            </a:r>
+          </a:p>
+          <a:p>
+            <a:pPr algn="ctr" defTabSz="439781"/>
             <a:r>
               <a:rPr lang="te-IN" sz="2000" dirty="0">
                 <a:solidFill>
-                  <a:schemeClr val="tx1"/>
-                </a:solidFill>
-                <a:latin typeface="Ramabhadra" panose="02000600000000000000" pitchFamily="2" charset="0"/>
-                <a:cs typeface="Ramabhadra" panose="02000600000000000000" pitchFamily="2" charset="0"/>
-              </a:rPr>
-              <a:t>ఎన్ని కష్టాలు కలిగిననూ</a:t>
+                  <a:prstClr val="black"/>
+                </a:solidFill>
+                <a:latin typeface="Ramabhadra" panose="02000600000000000000" pitchFamily="2" charset="0"/>
+                <a:cs typeface="Ramabhadra" panose="02000600000000000000" pitchFamily="2" charset="0"/>
+              </a:rPr>
+              <a:t>ఆ మహాదానంబుతో – </a:t>
+            </a:r>
+          </a:p>
+          <a:p>
+            <a:pPr algn="ctr" defTabSz="439781"/>
+            <a:r>
+              <a:rPr lang="te-IN" sz="2000" dirty="0">
+                <a:solidFill>
+                  <a:prstClr val="black"/>
+                </a:solidFill>
+                <a:latin typeface="Ramabhadra" panose="02000600000000000000" pitchFamily="2" charset="0"/>
+                <a:cs typeface="Ramabhadra" panose="02000600000000000000" pitchFamily="2" charset="0"/>
+              </a:rPr>
+              <a:t>నీతోనే సదా వసియింతు</a:t>
             </a:r>
             <a:endParaRPr lang="en-IN" sz="2000" dirty="0">
               <a:solidFill>
-                <a:schemeClr val="tx1"/>
-              </a:solidFill>
-              <a:latin typeface="Ramabhadra" panose="02000600000000000000" pitchFamily="2" charset="0"/>
-              <a:cs typeface="Ramabhadra" panose="02000600000000000000" pitchFamily="2" charset="0"/>
-            </a:endParaRPr>
-          </a:p>
-          <a:p>
-            <a:pPr algn="ctr"/>
-            <a:r>
-              <a:rPr lang="te-IN" sz="2000" dirty="0">
-                <a:solidFill>
-                  <a:schemeClr val="tx1"/>
-                </a:solidFill>
-                <a:latin typeface="Ramabhadra" panose="02000600000000000000" pitchFamily="2" charset="0"/>
-                <a:cs typeface="Ramabhadra" panose="02000600000000000000" pitchFamily="2" charset="0"/>
-              </a:rPr>
-              <a:t>నన్ను కృంగించె భాదలెన్నో</a:t>
-            </a:r>
-          </a:p>
-          <a:p>
-            <a:pPr algn="ctr"/>
-            <a:r>
-              <a:rPr lang="te-IN" sz="2000" dirty="0">
-                <a:solidFill>
-                  <a:schemeClr val="tx1"/>
-                </a:solidFill>
-                <a:latin typeface="Ramabhadra" panose="02000600000000000000" pitchFamily="2" charset="0"/>
-                <a:cs typeface="Ramabhadra" panose="02000600000000000000" pitchFamily="2" charset="0"/>
-              </a:rPr>
-              <a:t>ఎన్ని నష్టాలు వాటిల్లినా </a:t>
-            </a:r>
-          </a:p>
-          <a:p>
-            <a:pPr algn="ctr"/>
-            <a:r>
-              <a:rPr lang="te-IN" sz="2000" dirty="0">
-                <a:solidFill>
-                  <a:schemeClr val="tx1"/>
-                </a:solidFill>
-                <a:latin typeface="Ramabhadra" panose="02000600000000000000" pitchFamily="2" charset="0"/>
-                <a:cs typeface="Ramabhadra" panose="02000600000000000000" pitchFamily="2" charset="0"/>
-              </a:rPr>
-              <a:t>ప్రియ ప్రభువే నా పరిహారి (2)</a:t>
-            </a:r>
-          </a:p>
-          <a:p>
-            <a:pPr algn="ctr"/>
-            <a:endParaRPr lang="te-IN" sz="2000" dirty="0">
-              <a:solidFill>
-                <a:schemeClr val="tx1"/>
-              </a:solidFill>
-              <a:latin typeface="Ramabhadra" panose="02000600000000000000" pitchFamily="2" charset="0"/>
-              <a:cs typeface="Ramabhadra" panose="02000600000000000000" pitchFamily="2" charset="0"/>
-            </a:endParaRPr>
-          </a:p>
-          <a:p>
-            <a:pPr algn="ctr"/>
-            <a:r>
-              <a:rPr lang="te-IN" sz="2000" dirty="0">
-                <a:solidFill>
-                  <a:schemeClr val="tx1"/>
-                </a:solidFill>
-                <a:latin typeface="Ramabhadra" panose="02000600000000000000" pitchFamily="2" charset="0"/>
-                <a:cs typeface="Ramabhadra" panose="02000600000000000000" pitchFamily="2" charset="0"/>
-              </a:rPr>
-              <a:t>దేవా నీవే నా ఆధారం</a:t>
-            </a:r>
-            <a:endParaRPr lang="en-IN" sz="2000" dirty="0">
-              <a:solidFill>
-                <a:schemeClr val="tx1"/>
-              </a:solidFill>
-              <a:latin typeface="Ramabhadra" panose="02000600000000000000" pitchFamily="2" charset="0"/>
-              <a:cs typeface="Ramabhadra" panose="02000600000000000000" pitchFamily="2" charset="0"/>
-            </a:endParaRPr>
-          </a:p>
-          <a:p>
-            <a:pPr algn="ctr"/>
-            <a:r>
-              <a:rPr lang="te-IN" sz="2000" dirty="0">
-                <a:solidFill>
-                  <a:schemeClr val="tx1"/>
-                </a:solidFill>
-                <a:latin typeface="Ramabhadra" panose="02000600000000000000" pitchFamily="2" charset="0"/>
-                <a:cs typeface="Ramabhadra" panose="02000600000000000000" pitchFamily="2" charset="0"/>
-              </a:rPr>
-              <a:t>నీ ప్రేమకు సాటెవ్వరూ (2)</a:t>
-            </a:r>
-            <a:br>
-              <a:rPr lang="te-IN" sz="2000" dirty="0">
-                <a:solidFill>
-                  <a:schemeClr val="tx1"/>
-                </a:solidFill>
-                <a:latin typeface="Ramabhadra" panose="02000600000000000000" pitchFamily="2" charset="0"/>
-                <a:cs typeface="Ramabhadra" panose="02000600000000000000" pitchFamily="2" charset="0"/>
-              </a:rPr>
-            </a:br>
-            <a:r>
-              <a:rPr lang="te-IN" sz="2000" dirty="0">
-                <a:solidFill>
-                  <a:schemeClr val="tx1"/>
-                </a:solidFill>
-                <a:latin typeface="Ramabhadra" panose="02000600000000000000" pitchFamily="2" charset="0"/>
-                <a:cs typeface="Ramabhadra" panose="02000600000000000000" pitchFamily="2" charset="0"/>
-              </a:rPr>
-              <a:t>నా జీవిత కాలమంతా</a:t>
-            </a:r>
-            <a:br>
-              <a:rPr lang="te-IN" sz="2000" dirty="0">
-                <a:solidFill>
-                  <a:schemeClr val="tx1"/>
-                </a:solidFill>
-                <a:latin typeface="Ramabhadra" panose="02000600000000000000" pitchFamily="2" charset="0"/>
-                <a:cs typeface="Ramabhadra" panose="02000600000000000000" pitchFamily="2" charset="0"/>
-              </a:rPr>
-            </a:br>
-            <a:r>
-              <a:rPr lang="te-IN" sz="2000" dirty="0">
-                <a:solidFill>
-                  <a:schemeClr val="tx1"/>
-                </a:solidFill>
-                <a:latin typeface="Ramabhadra" panose="02000600000000000000" pitchFamily="2" charset="0"/>
-                <a:cs typeface="Ramabhadra" panose="02000600000000000000" pitchFamily="2" charset="0"/>
-              </a:rPr>
-              <a:t>నిన్ను పాడి</a:t>
-            </a:r>
-            <a:r>
-              <a:rPr lang="en-IN" sz="2000" dirty="0">
-                <a:solidFill>
-                  <a:schemeClr val="tx1"/>
-                </a:solidFill>
-                <a:latin typeface="Ramabhadra" panose="02000600000000000000" pitchFamily="2" charset="0"/>
-                <a:cs typeface="Ramabhadra" panose="02000600000000000000" pitchFamily="2" charset="0"/>
-              </a:rPr>
-              <a:t> </a:t>
-            </a:r>
-            <a:r>
-              <a:rPr lang="te-IN" sz="2000" dirty="0">
-                <a:solidFill>
-                  <a:schemeClr val="tx1"/>
-                </a:solidFill>
-                <a:latin typeface="Ramabhadra" panose="02000600000000000000" pitchFamily="2" charset="0"/>
-                <a:cs typeface="Ramabhadra" panose="02000600000000000000" pitchFamily="2" charset="0"/>
-              </a:rPr>
-              <a:t>స్తుతించెదను (2</a:t>
-            </a:r>
-            <a:r>
-              <a:rPr lang="en-IN" sz="2000" dirty="0">
-                <a:solidFill>
-                  <a:schemeClr val="tx1"/>
-                </a:solidFill>
-                <a:latin typeface="Ramabhadra" panose="02000600000000000000" pitchFamily="2" charset="0"/>
-                <a:cs typeface="Ramabhadra" panose="02000600000000000000" pitchFamily="2" charset="0"/>
-              </a:rPr>
-              <a:t>)</a:t>
-            </a:r>
-            <a:endParaRPr lang="te-IN" sz="2000" dirty="0">
-              <a:solidFill>
-                <a:schemeClr val="tx1"/>
+                <a:prstClr val="black"/>
               </a:solidFill>
               <a:latin typeface="Ramabhadra" panose="02000600000000000000" pitchFamily="2" charset="0"/>
               <a:cs typeface="Ramabhadra" panose="02000600000000000000" pitchFamily="2" charset="0"/>
@@ -3914,55 +3831,110 @@
           <a:p>
             <a:pPr algn="ctr"/>
             <a:r>
-              <a:rPr lang="te-IN" dirty="0">
-                <a:solidFill>
-                  <a:schemeClr val="tx1"/>
-                </a:solidFill>
-                <a:latin typeface="Ramabhadra" panose="02000600000000000000" pitchFamily="2" charset="0"/>
-                <a:cs typeface="Ramabhadra" panose="02000600000000000000" pitchFamily="2" charset="0"/>
-              </a:rPr>
-              <a:t>నా ప్రాణమా నా అంతరంగమా </a:t>
-            </a:r>
-          </a:p>
-          <a:p>
-            <a:pPr algn="ctr"/>
-            <a:r>
-              <a:rPr lang="te-IN" dirty="0">
-                <a:solidFill>
-                  <a:schemeClr val="tx1"/>
-                </a:solidFill>
-                <a:latin typeface="Ramabhadra" panose="02000600000000000000" pitchFamily="2" charset="0"/>
-                <a:cs typeface="Ramabhadra" panose="02000600000000000000" pitchFamily="2" charset="0"/>
-              </a:rPr>
-              <a:t>నాలో వున్న నా సమస్తమా (2)</a:t>
-            </a:r>
-          </a:p>
-          <a:p>
-            <a:pPr algn="ctr"/>
-            <a:r>
-              <a:rPr lang="te-IN" dirty="0">
-                <a:solidFill>
-                  <a:schemeClr val="tx1"/>
-                </a:solidFill>
-                <a:latin typeface="Ramabhadra" panose="02000600000000000000" pitchFamily="2" charset="0"/>
-                <a:cs typeface="Ramabhadra" panose="02000600000000000000" pitchFamily="2" charset="0"/>
-              </a:rPr>
-              <a:t>యెహోవ చేసిన ఉపకారములలో</a:t>
-            </a:r>
-          </a:p>
-          <a:p>
-            <a:pPr algn="ctr"/>
-            <a:r>
-              <a:rPr lang="te-IN" dirty="0">
-                <a:solidFill>
-                  <a:schemeClr val="tx1"/>
-                </a:solidFill>
-                <a:latin typeface="Ramabhadra" panose="02000600000000000000" pitchFamily="2" charset="0"/>
-                <a:cs typeface="Ramabhadra" panose="02000600000000000000" pitchFamily="2" charset="0"/>
-              </a:rPr>
-              <a:t>దేనిని మరువక</a:t>
-            </a:r>
-            <a:endParaRPr lang="en-IN" dirty="0">
+              <a:rPr lang="te-IN" sz="1700" dirty="0">
+                <a:solidFill>
+                  <a:schemeClr val="tx1"/>
+                </a:solidFill>
+                <a:latin typeface="Ramabhadra" panose="02000600000000000000" pitchFamily="2" charset="0"/>
+                <a:cs typeface="Ramabhadra" panose="02000600000000000000" pitchFamily="2" charset="0"/>
+              </a:rPr>
+              <a:t>ఈ దినం సదా</a:t>
+            </a:r>
+          </a:p>
+          <a:p>
+            <a:pPr algn="ctr"/>
+            <a:r>
+              <a:rPr lang="te-IN" sz="1700" dirty="0">
+                <a:solidFill>
+                  <a:schemeClr val="tx1"/>
+                </a:solidFill>
+                <a:latin typeface="Ramabhadra" panose="02000600000000000000" pitchFamily="2" charset="0"/>
+                <a:cs typeface="Ramabhadra" panose="02000600000000000000" pitchFamily="2" charset="0"/>
+              </a:rPr>
+              <a:t>నా యేసుకే సొంతం</a:t>
+            </a:r>
+          </a:p>
+          <a:p>
+            <a:pPr algn="ctr"/>
+            <a:r>
+              <a:rPr lang="te-IN" sz="1700" dirty="0">
+                <a:solidFill>
+                  <a:schemeClr val="tx1"/>
+                </a:solidFill>
+                <a:latin typeface="Ramabhadra" panose="02000600000000000000" pitchFamily="2" charset="0"/>
+                <a:cs typeface="Ramabhadra" panose="02000600000000000000" pitchFamily="2" charset="0"/>
+              </a:rPr>
+              <a:t>నా నాధుని ప్రసన్నత</a:t>
+            </a:r>
+          </a:p>
+          <a:p>
+            <a:pPr algn="ctr"/>
+            <a:r>
+              <a:rPr lang="te-IN" sz="1700" dirty="0">
+                <a:solidFill>
+                  <a:schemeClr val="tx1"/>
+                </a:solidFill>
+                <a:latin typeface="Ramabhadra" panose="02000600000000000000" pitchFamily="2" charset="0"/>
+                <a:cs typeface="Ramabhadra" panose="02000600000000000000" pitchFamily="2" charset="0"/>
+              </a:rPr>
+              <a:t>నా తోడ నడచును (2)</a:t>
+            </a:r>
+          </a:p>
+          <a:p>
+            <a:pPr algn="ctr"/>
+            <a:r>
+              <a:rPr lang="te-IN" sz="1700" dirty="0">
+                <a:solidFill>
+                  <a:schemeClr val="tx1"/>
+                </a:solidFill>
+                <a:latin typeface="Ramabhadra" panose="02000600000000000000" pitchFamily="2" charset="0"/>
+                <a:cs typeface="Ramabhadra" panose="02000600000000000000" pitchFamily="2" charset="0"/>
+              </a:rPr>
+              <a:t>రానున్న కాలము –</a:t>
+            </a:r>
+          </a:p>
+          <a:p>
+            <a:pPr algn="ctr"/>
+            <a:r>
+              <a:rPr lang="te-IN" sz="1700" dirty="0">
+                <a:solidFill>
+                  <a:schemeClr val="tx1"/>
+                </a:solidFill>
+                <a:latin typeface="Ramabhadra" panose="02000600000000000000" pitchFamily="2" charset="0"/>
+                <a:cs typeface="Ramabhadra" panose="02000600000000000000" pitchFamily="2" charset="0"/>
+              </a:rPr>
+              <a:t>కలత నివ్వదు (2)</a:t>
+            </a:r>
+          </a:p>
+          <a:p>
+            <a:pPr algn="ctr"/>
+            <a:r>
+              <a:rPr lang="te-IN" sz="1700" dirty="0">
+                <a:solidFill>
+                  <a:schemeClr val="tx1"/>
+                </a:solidFill>
+                <a:latin typeface="Ramabhadra" panose="02000600000000000000" pitchFamily="2" charset="0"/>
+                <a:cs typeface="Ramabhadra" panose="02000600000000000000" pitchFamily="2" charset="0"/>
+              </a:rPr>
+              <a:t>నా మంచి కాపరీ సదా –</a:t>
+            </a:r>
+          </a:p>
+          <a:p>
+            <a:pPr algn="ctr"/>
+            <a:r>
+              <a:rPr lang="te-IN" sz="1700" dirty="0">
+                <a:solidFill>
+                  <a:schemeClr val="tx1"/>
+                </a:solidFill>
+                <a:latin typeface="Ramabhadra" panose="02000600000000000000" pitchFamily="2" charset="0"/>
+                <a:cs typeface="Ramabhadra" panose="02000600000000000000" pitchFamily="2" charset="0"/>
+              </a:rPr>
+              <a:t>నన్ను నడుపును</a:t>
+            </a:r>
+          </a:p>
+          <a:p>
+            <a:pPr algn="ctr"/>
+            <a:endParaRPr lang="te-IN" sz="1700" dirty="0">
               <a:solidFill>
                 <a:schemeClr val="tx1"/>
               </a:solidFill>
@@ -3973,32 +3945,97 @@
           <a:p>
             <a:pPr algn="ctr"/>
             <a:r>
-              <a:rPr lang="te-IN" dirty="0">
-                <a:solidFill>
-                  <a:schemeClr val="tx1"/>
-                </a:solidFill>
-                <a:latin typeface="Ramabhadra" panose="02000600000000000000" pitchFamily="2" charset="0"/>
-                <a:cs typeface="Ramabhadra" panose="02000600000000000000" pitchFamily="2" charset="0"/>
-              </a:rPr>
-              <a:t>కొనియాడుమా (2)</a:t>
-            </a:r>
-          </a:p>
-          <a:p>
-            <a:pPr algn="ctr"/>
-            <a:r>
-              <a:rPr lang="te-IN" dirty="0">
-                <a:solidFill>
-                  <a:schemeClr val="tx1"/>
-                </a:solidFill>
-                <a:latin typeface="Ramabhadra" panose="02000600000000000000" pitchFamily="2" charset="0"/>
-                <a:cs typeface="Ramabhadra" panose="02000600000000000000" pitchFamily="2" charset="0"/>
-              </a:rPr>
-              <a:t>ఆ.. ఆ… ఆ.. ఆ… ఆ.. ఆ…</a:t>
-            </a:r>
-          </a:p>
-          <a:p>
-            <a:pPr algn="ctr"/>
-            <a:endParaRPr lang="te-IN" dirty="0">
+              <a:rPr lang="te-IN" sz="1700" dirty="0">
+                <a:solidFill>
+                  <a:schemeClr val="tx1"/>
+                </a:solidFill>
+                <a:latin typeface="Ramabhadra" panose="02000600000000000000" pitchFamily="2" charset="0"/>
+                <a:cs typeface="Ramabhadra" panose="02000600000000000000" pitchFamily="2" charset="0"/>
+              </a:rPr>
+              <a:t>ఎడారులు లోయలు</a:t>
+            </a:r>
+          </a:p>
+          <a:p>
+            <a:pPr algn="ctr"/>
+            <a:r>
+              <a:rPr lang="te-IN" sz="1700" dirty="0">
+                <a:solidFill>
+                  <a:schemeClr val="tx1"/>
+                </a:solidFill>
+                <a:latin typeface="Ramabhadra" panose="02000600000000000000" pitchFamily="2" charset="0"/>
+                <a:cs typeface="Ramabhadra" panose="02000600000000000000" pitchFamily="2" charset="0"/>
+              </a:rPr>
+              <a:t>ఎదురు నిలచినా</a:t>
+            </a:r>
+          </a:p>
+          <a:p>
+            <a:pPr algn="ctr"/>
+            <a:r>
+              <a:rPr lang="te-IN" sz="1700" dirty="0">
+                <a:solidFill>
+                  <a:schemeClr val="tx1"/>
+                </a:solidFill>
+                <a:latin typeface="Ramabhadra" panose="02000600000000000000" pitchFamily="2" charset="0"/>
+                <a:cs typeface="Ramabhadra" panose="02000600000000000000" pitchFamily="2" charset="0"/>
+              </a:rPr>
+              <a:t>ఎన్నడెవరు నడువని</a:t>
+            </a:r>
+          </a:p>
+          <a:p>
+            <a:pPr algn="ctr"/>
+            <a:r>
+              <a:rPr lang="te-IN" sz="1700" dirty="0">
+                <a:solidFill>
+                  <a:schemeClr val="tx1"/>
+                </a:solidFill>
+                <a:latin typeface="Ramabhadra" panose="02000600000000000000" pitchFamily="2" charset="0"/>
+                <a:cs typeface="Ramabhadra" panose="02000600000000000000" pitchFamily="2" charset="0"/>
+              </a:rPr>
+              <a:t>బాటయైనను (2)</a:t>
+            </a:r>
+          </a:p>
+          <a:p>
+            <a:pPr algn="ctr"/>
+            <a:r>
+              <a:rPr lang="te-IN" sz="1700" dirty="0">
+                <a:solidFill>
+                  <a:schemeClr val="tx1"/>
+                </a:solidFill>
+                <a:latin typeface="Ramabhadra" panose="02000600000000000000" pitchFamily="2" charset="0"/>
+                <a:cs typeface="Ramabhadra" panose="02000600000000000000" pitchFamily="2" charset="0"/>
+              </a:rPr>
+              <a:t>వెరవదెన్నడైనను నాదు హృదయము (2)</a:t>
+            </a:r>
+          </a:p>
+          <a:p>
+            <a:pPr algn="ctr"/>
+            <a:r>
+              <a:rPr lang="te-IN" sz="1700" dirty="0">
+                <a:solidFill>
+                  <a:schemeClr val="tx1"/>
+                </a:solidFill>
+                <a:latin typeface="Ramabhadra" panose="02000600000000000000" pitchFamily="2" charset="0"/>
+                <a:cs typeface="Ramabhadra" panose="02000600000000000000" pitchFamily="2" charset="0"/>
+              </a:rPr>
+              <a:t>గాయపడిన యేసుపాదం</a:t>
+            </a:r>
+          </a:p>
+          <a:p>
+            <a:pPr algn="ctr"/>
+            <a:r>
+              <a:rPr lang="te-IN" sz="1700" dirty="0">
+                <a:solidFill>
+                  <a:schemeClr val="tx1"/>
+                </a:solidFill>
+                <a:latin typeface="Ramabhadra" panose="02000600000000000000" pitchFamily="2" charset="0"/>
+                <a:cs typeface="Ramabhadra" panose="02000600000000000000" pitchFamily="2" charset="0"/>
+              </a:rPr>
+              <a:t>అందు నడచెను (2)</a:t>
+            </a:r>
+          </a:p>
+          <a:p>
+            <a:pPr algn="ctr"/>
+            <a:endParaRPr lang="te-IN" sz="1700" dirty="0">
               <a:solidFill>
                 <a:schemeClr val="tx1"/>
               </a:solidFill>
@@ -4009,175 +4046,105 @@
           <a:p>
             <a:pPr algn="ctr"/>
             <a:r>
-              <a:rPr lang="te-IN" dirty="0">
-                <a:solidFill>
-                  <a:schemeClr val="tx1"/>
-                </a:solidFill>
-                <a:latin typeface="Ramabhadra" panose="02000600000000000000" pitchFamily="2" charset="0"/>
-                <a:cs typeface="Ramabhadra" panose="02000600000000000000" pitchFamily="2" charset="0"/>
-              </a:rPr>
-              <a:t>నీ దోషములన్నిటిని క్షమియించువాడు </a:t>
-            </a:r>
-          </a:p>
-          <a:p>
-            <a:pPr algn="ctr"/>
-            <a:r>
-              <a:rPr lang="te-IN" dirty="0">
-                <a:solidFill>
-                  <a:schemeClr val="tx1"/>
-                </a:solidFill>
-                <a:latin typeface="Ramabhadra" panose="02000600000000000000" pitchFamily="2" charset="0"/>
-                <a:cs typeface="Ramabhadra" panose="02000600000000000000" pitchFamily="2" charset="0"/>
-              </a:rPr>
-              <a:t>నీ పాపములన్ని</a:t>
-            </a:r>
-            <a:endParaRPr lang="en-IN" dirty="0">
-              <a:solidFill>
-                <a:schemeClr val="tx1"/>
-              </a:solidFill>
-              <a:latin typeface="Ramabhadra" panose="02000600000000000000" pitchFamily="2" charset="0"/>
-              <a:cs typeface="Ramabhadra" panose="02000600000000000000" pitchFamily="2" charset="0"/>
-            </a:endParaRPr>
-          </a:p>
-          <a:p>
-            <a:pPr algn="ctr"/>
-            <a:r>
-              <a:rPr lang="te-IN" dirty="0">
-                <a:solidFill>
-                  <a:schemeClr val="tx1"/>
-                </a:solidFill>
-                <a:latin typeface="Ramabhadra" panose="02000600000000000000" pitchFamily="2" charset="0"/>
-                <a:cs typeface="Ramabhadra" panose="02000600000000000000" pitchFamily="2" charset="0"/>
-              </a:rPr>
-              <a:t>పార ద్రోలువాడు (2)</a:t>
-            </a:r>
-          </a:p>
-          <a:p>
-            <a:pPr algn="ctr"/>
-            <a:r>
-              <a:rPr lang="te-IN" dirty="0">
-                <a:solidFill>
-                  <a:schemeClr val="tx1"/>
-                </a:solidFill>
-                <a:latin typeface="Ramabhadra" panose="02000600000000000000" pitchFamily="2" charset="0"/>
-                <a:cs typeface="Ramabhadra" panose="02000600000000000000" pitchFamily="2" charset="0"/>
-              </a:rPr>
-              <a:t>పరమ వైద్యుడు ప్రభు యేసుడు </a:t>
-            </a:r>
-          </a:p>
-          <a:p>
-            <a:pPr algn="ctr"/>
-            <a:r>
-              <a:rPr lang="te-IN" dirty="0">
-                <a:solidFill>
-                  <a:schemeClr val="tx1"/>
-                </a:solidFill>
-                <a:latin typeface="Ramabhadra" panose="02000600000000000000" pitchFamily="2" charset="0"/>
-                <a:cs typeface="Ramabhadra" panose="02000600000000000000" pitchFamily="2" charset="0"/>
-              </a:rPr>
-              <a:t>పరిశుద్ధ నామమును సన్నుతించుమా (2)</a:t>
-            </a:r>
-          </a:p>
-          <a:p>
-            <a:pPr algn="ctr"/>
-            <a:endParaRPr lang="en-IN" dirty="0">
-              <a:solidFill>
-                <a:schemeClr val="tx1"/>
-              </a:solidFill>
-              <a:latin typeface="Ramabhadra" panose="02000600000000000000" pitchFamily="2" charset="0"/>
-              <a:cs typeface="Ramabhadra" panose="02000600000000000000" pitchFamily="2" charset="0"/>
-            </a:endParaRPr>
-          </a:p>
-          <a:p>
-            <a:pPr algn="ctr"/>
-            <a:r>
-              <a:rPr lang="te-IN" dirty="0">
-                <a:solidFill>
-                  <a:schemeClr val="tx1"/>
-                </a:solidFill>
-                <a:latin typeface="Ramabhadra" panose="02000600000000000000" pitchFamily="2" charset="0"/>
-                <a:cs typeface="Ramabhadra" panose="02000600000000000000" pitchFamily="2" charset="0"/>
-              </a:rPr>
-              <a:t>సమాధిలోనుండి నీ ప్రాణమును </a:t>
-            </a:r>
-          </a:p>
-          <a:p>
-            <a:pPr algn="ctr"/>
-            <a:r>
-              <a:rPr lang="te-IN" dirty="0">
-                <a:solidFill>
-                  <a:schemeClr val="tx1"/>
-                </a:solidFill>
-                <a:latin typeface="Ramabhadra" panose="02000600000000000000" pitchFamily="2" charset="0"/>
-                <a:cs typeface="Ramabhadra" panose="02000600000000000000" pitchFamily="2" charset="0"/>
-              </a:rPr>
-              <a:t>విమోచించుచున్నాడు శ్రీయేసుడు (2)</a:t>
-            </a:r>
-          </a:p>
-          <a:p>
-            <a:pPr algn="ctr"/>
-            <a:r>
-              <a:rPr lang="te-IN" dirty="0">
-                <a:solidFill>
-                  <a:schemeClr val="tx1"/>
-                </a:solidFill>
-                <a:latin typeface="Ramabhadra" panose="02000600000000000000" pitchFamily="2" charset="0"/>
-                <a:cs typeface="Ramabhadra" panose="02000600000000000000" pitchFamily="2" charset="0"/>
-              </a:rPr>
-              <a:t>కరుణా కటాక్షములను</a:t>
-            </a:r>
-            <a:endParaRPr lang="en-IN" dirty="0">
-              <a:solidFill>
-                <a:schemeClr val="tx1"/>
-              </a:solidFill>
-              <a:latin typeface="Ramabhadra" panose="02000600000000000000" pitchFamily="2" charset="0"/>
-              <a:cs typeface="Ramabhadra" panose="02000600000000000000" pitchFamily="2" charset="0"/>
-            </a:endParaRPr>
-          </a:p>
-          <a:p>
-            <a:pPr algn="ctr"/>
-            <a:r>
-              <a:rPr lang="te-IN" dirty="0">
-                <a:solidFill>
-                  <a:schemeClr val="tx1"/>
-                </a:solidFill>
-                <a:latin typeface="Ramabhadra" panose="02000600000000000000" pitchFamily="2" charset="0"/>
-                <a:cs typeface="Ramabhadra" panose="02000600000000000000" pitchFamily="2" charset="0"/>
-              </a:rPr>
-              <a:t>నీకు కిరీటముగా </a:t>
-            </a:r>
-          </a:p>
-          <a:p>
-            <a:pPr algn="ctr"/>
-            <a:r>
-              <a:rPr lang="te-IN" dirty="0">
-                <a:solidFill>
-                  <a:schemeClr val="tx1"/>
-                </a:solidFill>
-                <a:latin typeface="Ramabhadra" panose="02000600000000000000" pitchFamily="2" charset="0"/>
-                <a:cs typeface="Ramabhadra" panose="02000600000000000000" pitchFamily="2" charset="0"/>
-              </a:rPr>
-              <a:t>ధరియింపజేయును</a:t>
-            </a:r>
-            <a:endParaRPr lang="en-IN" dirty="0">
-              <a:solidFill>
-                <a:schemeClr val="tx1"/>
-              </a:solidFill>
-              <a:latin typeface="Ramabhadra" panose="02000600000000000000" pitchFamily="2" charset="0"/>
-              <a:cs typeface="Ramabhadra" panose="02000600000000000000" pitchFamily="2" charset="0"/>
-            </a:endParaRPr>
-          </a:p>
-          <a:p>
-            <a:pPr algn="ctr"/>
-            <a:r>
-              <a:rPr lang="te-IN" dirty="0">
-                <a:solidFill>
-                  <a:schemeClr val="tx1"/>
-                </a:solidFill>
-                <a:latin typeface="Ramabhadra" panose="02000600000000000000" pitchFamily="2" charset="0"/>
-                <a:cs typeface="Ramabhadra" panose="02000600000000000000" pitchFamily="2" charset="0"/>
-              </a:rPr>
-              <a:t>ప్రభు యేసుడు (2)</a:t>
+              <a:rPr lang="te-IN" sz="1700" dirty="0">
+                <a:solidFill>
+                  <a:schemeClr val="tx1"/>
+                </a:solidFill>
+                <a:latin typeface="Ramabhadra" panose="02000600000000000000" pitchFamily="2" charset="0"/>
+                <a:cs typeface="Ramabhadra" panose="02000600000000000000" pitchFamily="2" charset="0"/>
+              </a:rPr>
+              <a:t>ప్రవాహం వోలె శోదకుండు</a:t>
+            </a:r>
+          </a:p>
+          <a:p>
+            <a:pPr algn="ctr"/>
+            <a:r>
+              <a:rPr lang="te-IN" sz="1700" dirty="0">
+                <a:solidFill>
+                  <a:schemeClr val="tx1"/>
+                </a:solidFill>
+                <a:latin typeface="Ramabhadra" panose="02000600000000000000" pitchFamily="2" charset="0"/>
+                <a:cs typeface="Ramabhadra" panose="02000600000000000000" pitchFamily="2" charset="0"/>
+              </a:rPr>
+              <a:t>ఎదురు వచ్చినా</a:t>
+            </a:r>
+          </a:p>
+          <a:p>
+            <a:pPr algn="ctr"/>
+            <a:r>
+              <a:rPr lang="te-IN" sz="1700" dirty="0">
+                <a:solidFill>
+                  <a:schemeClr val="tx1"/>
+                </a:solidFill>
+                <a:latin typeface="Ramabhadra" panose="02000600000000000000" pitchFamily="2" charset="0"/>
+                <a:cs typeface="Ramabhadra" panose="02000600000000000000" pitchFamily="2" charset="0"/>
+              </a:rPr>
+              <a:t>యుద్ధకేక నా నోట</a:t>
+            </a:r>
+          </a:p>
+          <a:p>
+            <a:pPr algn="ctr"/>
+            <a:r>
+              <a:rPr lang="te-IN" sz="1700" dirty="0">
+                <a:solidFill>
+                  <a:schemeClr val="tx1"/>
+                </a:solidFill>
+                <a:latin typeface="Ramabhadra" panose="02000600000000000000" pitchFamily="2" charset="0"/>
+                <a:cs typeface="Ramabhadra" panose="02000600000000000000" pitchFamily="2" charset="0"/>
+              </a:rPr>
+              <a:t>యేసు నామమే</a:t>
+            </a:r>
+          </a:p>
+          <a:p>
+            <a:pPr algn="ctr"/>
+            <a:r>
+              <a:rPr lang="te-IN" sz="1700" dirty="0">
+                <a:solidFill>
+                  <a:schemeClr val="tx1"/>
+                </a:solidFill>
+                <a:latin typeface="Ramabhadra" panose="02000600000000000000" pitchFamily="2" charset="0"/>
+                <a:cs typeface="Ramabhadra" panose="02000600000000000000" pitchFamily="2" charset="0"/>
+              </a:rPr>
+              <a:t>విరోదమైన ఆయుధాలు</a:t>
+            </a:r>
+          </a:p>
+          <a:p>
+            <a:pPr algn="ctr"/>
+            <a:r>
+              <a:rPr lang="te-IN" sz="1700" dirty="0">
+                <a:solidFill>
+                  <a:schemeClr val="tx1"/>
+                </a:solidFill>
+                <a:latin typeface="Ramabhadra" panose="02000600000000000000" pitchFamily="2" charset="0"/>
+                <a:cs typeface="Ramabhadra" panose="02000600000000000000" pitchFamily="2" charset="0"/>
+              </a:rPr>
+              <a:t>యేవి ఫలించవు</a:t>
+            </a:r>
+          </a:p>
+          <a:p>
+            <a:pPr algn="ctr"/>
+            <a:r>
+              <a:rPr lang="te-IN" sz="1700" dirty="0">
+                <a:solidFill>
+                  <a:schemeClr val="tx1"/>
+                </a:solidFill>
+                <a:latin typeface="Ramabhadra" panose="02000600000000000000" pitchFamily="2" charset="0"/>
+                <a:cs typeface="Ramabhadra" panose="02000600000000000000" pitchFamily="2" charset="0"/>
+              </a:rPr>
+              <a:t>యెహోవా నిస్సియే</a:t>
+            </a:r>
+          </a:p>
+          <a:p>
+            <a:pPr algn="ctr"/>
+            <a:r>
+              <a:rPr lang="te-IN" sz="1700" dirty="0">
+                <a:solidFill>
+                  <a:schemeClr val="tx1"/>
+                </a:solidFill>
+                <a:latin typeface="Ramabhadra" panose="02000600000000000000" pitchFamily="2" charset="0"/>
+                <a:cs typeface="Ramabhadra" panose="02000600000000000000" pitchFamily="2" charset="0"/>
+              </a:rPr>
+              <a:t>నాదు విజయము</a:t>
             </a:r>
           </a:p>
         </p:txBody>
@@ -4235,84 +4202,71 @@
           <a:p>
             <a:pPr algn="ctr"/>
             <a:r>
-              <a:rPr lang="te-IN" sz="2000" dirty="0">
-                <a:solidFill>
-                  <a:schemeClr val="tx1"/>
-                </a:solidFill>
-                <a:latin typeface="Ramabhadra" panose="02000600000000000000" pitchFamily="2" charset="0"/>
-                <a:cs typeface="Ramabhadra" panose="02000600000000000000" pitchFamily="2" charset="0"/>
-              </a:rPr>
-              <a:t>ప్రేమించెదన్ అధికముగా</a:t>
-            </a:r>
-          </a:p>
-          <a:p>
-            <a:pPr algn="ctr"/>
-            <a:r>
-              <a:rPr lang="te-IN" sz="2000" dirty="0">
-                <a:solidFill>
-                  <a:schemeClr val="tx1"/>
-                </a:solidFill>
-                <a:latin typeface="Ramabhadra" panose="02000600000000000000" pitchFamily="2" charset="0"/>
-                <a:cs typeface="Ramabhadra" panose="02000600000000000000" pitchFamily="2" charset="0"/>
-              </a:rPr>
-              <a:t>ఆరాధింతున్ ఆసక్తితో (2)</a:t>
-            </a:r>
-          </a:p>
-          <a:p>
-            <a:pPr algn="ctr"/>
-            <a:r>
-              <a:rPr lang="te-IN" sz="2000" dirty="0">
-                <a:solidFill>
-                  <a:schemeClr val="tx1"/>
-                </a:solidFill>
-                <a:latin typeface="Ramabhadra" panose="02000600000000000000" pitchFamily="2" charset="0"/>
-                <a:cs typeface="Ramabhadra" panose="02000600000000000000" pitchFamily="2" charset="0"/>
-              </a:rPr>
-              <a:t>నిన్ను పూర్ణ మనసుతో ఆరాధింతున్</a:t>
-            </a:r>
-          </a:p>
-          <a:p>
-            <a:pPr algn="ctr"/>
-            <a:r>
-              <a:rPr lang="te-IN" sz="2000" dirty="0">
-                <a:solidFill>
-                  <a:schemeClr val="tx1"/>
-                </a:solidFill>
-                <a:latin typeface="Ramabhadra" panose="02000600000000000000" pitchFamily="2" charset="0"/>
-                <a:cs typeface="Ramabhadra" panose="02000600000000000000" pitchFamily="2" charset="0"/>
-              </a:rPr>
-              <a:t>పూర్ణ బలముతో ప్రేమించెదన్</a:t>
-            </a:r>
-          </a:p>
-          <a:p>
-            <a:pPr algn="ctr"/>
-            <a:r>
-              <a:rPr lang="te-IN" sz="2000" dirty="0">
-                <a:solidFill>
-                  <a:schemeClr val="tx1"/>
-                </a:solidFill>
-                <a:latin typeface="Ramabhadra" panose="02000600000000000000" pitchFamily="2" charset="0"/>
-                <a:cs typeface="Ramabhadra" panose="02000600000000000000" pitchFamily="2" charset="0"/>
-              </a:rPr>
-              <a:t>ఆరాధన ఆరాధనా ఆ.. ఆ.. </a:t>
-            </a:r>
-          </a:p>
-          <a:p>
-            <a:pPr algn="ctr"/>
-            <a:r>
-              <a:rPr lang="te-IN" sz="2000" dirty="0">
-                <a:solidFill>
-                  <a:schemeClr val="tx1"/>
-                </a:solidFill>
-                <a:latin typeface="Ramabhadra" panose="02000600000000000000" pitchFamily="2" charset="0"/>
-                <a:cs typeface="Ramabhadra" panose="02000600000000000000" pitchFamily="2" charset="0"/>
-              </a:rPr>
-              <a:t>ఆరాధన ఆరాధనా (2)</a:t>
-            </a:r>
-          </a:p>
-          <a:p>
-            <a:pPr algn="ctr"/>
-            <a:endParaRPr lang="te-IN" sz="2000" dirty="0">
+              <a:rPr lang="te-IN" dirty="0">
+                <a:solidFill>
+                  <a:schemeClr val="tx1"/>
+                </a:solidFill>
+                <a:latin typeface="Ramabhadra" panose="02000600000000000000" pitchFamily="2" charset="0"/>
+                <a:cs typeface="Ramabhadra" panose="02000600000000000000" pitchFamily="2" charset="0"/>
+              </a:rPr>
+              <a:t>యూదా స్తుతి గోత్రపు సింహమా</a:t>
+            </a:r>
+          </a:p>
+          <a:p>
+            <a:pPr algn="ctr"/>
+            <a:r>
+              <a:rPr lang="te-IN" dirty="0">
+                <a:solidFill>
+                  <a:schemeClr val="tx1"/>
+                </a:solidFill>
+                <a:latin typeface="Ramabhadra" panose="02000600000000000000" pitchFamily="2" charset="0"/>
+                <a:cs typeface="Ramabhadra" panose="02000600000000000000" pitchFamily="2" charset="0"/>
+              </a:rPr>
+              <a:t>యేసయ్యా నా ఆత్మీయ ప్రగతి నీ స్వాధీనమా (2)</a:t>
+            </a:r>
+          </a:p>
+          <a:p>
+            <a:pPr algn="ctr"/>
+            <a:r>
+              <a:rPr lang="te-IN" dirty="0">
+                <a:solidFill>
+                  <a:schemeClr val="tx1"/>
+                </a:solidFill>
+                <a:latin typeface="Ramabhadra" panose="02000600000000000000" pitchFamily="2" charset="0"/>
+                <a:cs typeface="Ramabhadra" panose="02000600000000000000" pitchFamily="2" charset="0"/>
+              </a:rPr>
+              <a:t>నీవే కదా నా ఆరాధన</a:t>
+            </a:r>
+          </a:p>
+          <a:p>
+            <a:pPr algn="ctr"/>
+            <a:r>
+              <a:rPr lang="te-IN" dirty="0">
+                <a:solidFill>
+                  <a:schemeClr val="tx1"/>
+                </a:solidFill>
+                <a:latin typeface="Ramabhadra" panose="02000600000000000000" pitchFamily="2" charset="0"/>
+                <a:cs typeface="Ramabhadra" panose="02000600000000000000" pitchFamily="2" charset="0"/>
+              </a:rPr>
+              <a:t>ఆరాధన స్తుతి ఆరాధన</a:t>
+            </a:r>
+          </a:p>
+          <a:p>
+            <a:pPr algn="ctr"/>
+            <a:r>
+              <a:rPr lang="te-IN" dirty="0">
+                <a:solidFill>
+                  <a:schemeClr val="tx1"/>
+                </a:solidFill>
+                <a:latin typeface="Ramabhadra" panose="02000600000000000000" pitchFamily="2" charset="0"/>
+                <a:cs typeface="Ramabhadra" panose="02000600000000000000" pitchFamily="2" charset="0"/>
+              </a:rPr>
+              <a:t>ఆరాధన స్తుతి ఆరాధన (2)</a:t>
+            </a:r>
+          </a:p>
+          <a:p>
+            <a:pPr algn="ctr"/>
+            <a:endParaRPr lang="te-IN" dirty="0">
               <a:solidFill>
                 <a:schemeClr val="tx1"/>
               </a:solidFill>
@@ -4323,29 +4277,71 @@
           <a:p>
             <a:pPr algn="ctr"/>
             <a:r>
-              <a:rPr lang="te-IN" sz="2000" dirty="0">
-                <a:solidFill>
-                  <a:schemeClr val="tx1"/>
-                </a:solidFill>
-                <a:latin typeface="Ramabhadra" panose="02000600000000000000" pitchFamily="2" charset="0"/>
-                <a:cs typeface="Ramabhadra" panose="02000600000000000000" pitchFamily="2" charset="0"/>
-              </a:rPr>
-              <a:t>ఎబినేజరే ఎబినేజరే</a:t>
-            </a:r>
-          </a:p>
-          <a:p>
-            <a:pPr algn="ctr"/>
-            <a:r>
-              <a:rPr lang="te-IN" sz="2000" dirty="0">
-                <a:solidFill>
-                  <a:schemeClr val="tx1"/>
-                </a:solidFill>
-                <a:latin typeface="Ramabhadra" panose="02000600000000000000" pitchFamily="2" charset="0"/>
-                <a:cs typeface="Ramabhadra" panose="02000600000000000000" pitchFamily="2" charset="0"/>
-              </a:rPr>
-              <a:t>ఇంత వరకు</a:t>
-            </a:r>
-            <a:endParaRPr lang="en-IN" sz="2000" dirty="0">
+              <a:rPr lang="te-IN" dirty="0">
+                <a:solidFill>
+                  <a:schemeClr val="tx1"/>
+                </a:solidFill>
+                <a:latin typeface="Ramabhadra" panose="02000600000000000000" pitchFamily="2" charset="0"/>
+                <a:cs typeface="Ramabhadra" panose="02000600000000000000" pitchFamily="2" charset="0"/>
+              </a:rPr>
+              <a:t>నీ ప్రజల నెమ్మదికై</a:t>
+            </a:r>
+          </a:p>
+          <a:p>
+            <a:pPr algn="ctr"/>
+            <a:r>
+              <a:rPr lang="te-IN" dirty="0">
+                <a:solidFill>
+                  <a:schemeClr val="tx1"/>
+                </a:solidFill>
+                <a:latin typeface="Ramabhadra" panose="02000600000000000000" pitchFamily="2" charset="0"/>
+                <a:cs typeface="Ramabhadra" panose="02000600000000000000" pitchFamily="2" charset="0"/>
+              </a:rPr>
+              <a:t>రాజాజ్ఞ మార్చింది నీవేనని</a:t>
+            </a:r>
+          </a:p>
+          <a:p>
+            <a:pPr algn="ctr"/>
+            <a:r>
+              <a:rPr lang="te-IN" dirty="0">
+                <a:solidFill>
+                  <a:schemeClr val="tx1"/>
+                </a:solidFill>
+                <a:latin typeface="Ramabhadra" panose="02000600000000000000" pitchFamily="2" charset="0"/>
+                <a:cs typeface="Ramabhadra" panose="02000600000000000000" pitchFamily="2" charset="0"/>
+              </a:rPr>
+              <a:t>అహమును అణచి అధికారులను</a:t>
+            </a:r>
+          </a:p>
+          <a:p>
+            <a:pPr algn="ctr"/>
+            <a:r>
+              <a:rPr lang="te-IN" dirty="0">
+                <a:solidFill>
+                  <a:schemeClr val="tx1"/>
+                </a:solidFill>
+                <a:latin typeface="Ramabhadra" panose="02000600000000000000" pitchFamily="2" charset="0"/>
+                <a:cs typeface="Ramabhadra" panose="02000600000000000000" pitchFamily="2" charset="0"/>
+              </a:rPr>
+              <a:t>అధముల చేసిన నీకు (2)</a:t>
+            </a:r>
+          </a:p>
+          <a:p>
+            <a:pPr algn="ctr"/>
+            <a:r>
+              <a:rPr lang="te-IN" dirty="0">
+                <a:solidFill>
+                  <a:schemeClr val="tx1"/>
+                </a:solidFill>
+                <a:latin typeface="Ramabhadra" panose="02000600000000000000" pitchFamily="2" charset="0"/>
+                <a:cs typeface="Ramabhadra" panose="02000600000000000000" pitchFamily="2" charset="0"/>
+              </a:rPr>
+              <a:t>అసాధ్యమైనది ఏమున్నది (4)</a:t>
+            </a:r>
+          </a:p>
+          <a:p>
+            <a:pPr algn="ctr"/>
+            <a:endParaRPr lang="te-IN" dirty="0">
               <a:solidFill>
                 <a:schemeClr val="tx1"/>
               </a:solidFill>
@@ -4356,76 +4352,66 @@
           <a:p>
             <a:pPr algn="ctr"/>
             <a:r>
-              <a:rPr lang="te-IN" sz="2000" dirty="0">
-                <a:solidFill>
-                  <a:schemeClr val="tx1"/>
-                </a:solidFill>
-                <a:latin typeface="Ramabhadra" panose="02000600000000000000" pitchFamily="2" charset="0"/>
-                <a:cs typeface="Ramabhadra" panose="02000600000000000000" pitchFamily="2" charset="0"/>
-              </a:rPr>
-              <a:t>ఆదుకొన్నావే (2)</a:t>
-            </a:r>
-          </a:p>
-          <a:p>
-            <a:pPr algn="ctr"/>
-            <a:r>
-              <a:rPr lang="te-IN" sz="2000" dirty="0">
-                <a:solidFill>
-                  <a:schemeClr val="tx1"/>
-                </a:solidFill>
-                <a:latin typeface="Ramabhadra" panose="02000600000000000000" pitchFamily="2" charset="0"/>
-                <a:cs typeface="Ramabhadra" panose="02000600000000000000" pitchFamily="2" charset="0"/>
-              </a:rPr>
-              <a:t>నన్ను ఇంత వరకు ఆదుకొన్నావే</a:t>
-            </a:r>
-          </a:p>
-          <a:p>
-            <a:pPr algn="ctr"/>
-            <a:endParaRPr lang="te-IN" sz="2000" dirty="0">
-              <a:solidFill>
-                <a:schemeClr val="tx1"/>
-              </a:solidFill>
-              <a:latin typeface="Ramabhadra" panose="02000600000000000000" pitchFamily="2" charset="0"/>
-              <a:cs typeface="Ramabhadra" panose="02000600000000000000" pitchFamily="2" charset="0"/>
-            </a:endParaRPr>
-          </a:p>
-          <a:p>
-            <a:pPr algn="ctr"/>
-            <a:r>
-              <a:rPr lang="te-IN" sz="2000" dirty="0">
-                <a:solidFill>
-                  <a:schemeClr val="tx1"/>
-                </a:solidFill>
-                <a:latin typeface="Ramabhadra" panose="02000600000000000000" pitchFamily="2" charset="0"/>
-                <a:cs typeface="Ramabhadra" panose="02000600000000000000" pitchFamily="2" charset="0"/>
-              </a:rPr>
-              <a:t>ఎల్రోహి ఎల్రోహి</a:t>
-            </a:r>
-          </a:p>
-          <a:p>
-            <a:pPr algn="ctr"/>
-            <a:r>
-              <a:rPr lang="te-IN" sz="2000" dirty="0">
-                <a:solidFill>
-                  <a:schemeClr val="tx1"/>
-                </a:solidFill>
-                <a:latin typeface="Ramabhadra" panose="02000600000000000000" pitchFamily="2" charset="0"/>
-                <a:cs typeface="Ramabhadra" panose="02000600000000000000" pitchFamily="2" charset="0"/>
-              </a:rPr>
-              <a:t>నన్ను చూచావే వందనమయ్యా (2)</a:t>
-            </a:r>
-          </a:p>
-          <a:p>
-            <a:pPr algn="ctr"/>
-            <a:r>
-              <a:rPr lang="te-IN" sz="2000" dirty="0">
-                <a:solidFill>
-                  <a:schemeClr val="tx1"/>
-                </a:solidFill>
-                <a:latin typeface="Ramabhadra" panose="02000600000000000000" pitchFamily="2" charset="0"/>
-                <a:cs typeface="Ramabhadra" panose="02000600000000000000" pitchFamily="2" charset="0"/>
-              </a:rPr>
-              <a:t>నన్ను చూచావే వందనమయ్యా</a:t>
+              <a:rPr lang="te-IN" dirty="0">
+                <a:solidFill>
+                  <a:schemeClr val="tx1"/>
+                </a:solidFill>
+                <a:latin typeface="Ramabhadra" panose="02000600000000000000" pitchFamily="2" charset="0"/>
+                <a:cs typeface="Ramabhadra" panose="02000600000000000000" pitchFamily="2" charset="0"/>
+              </a:rPr>
+              <a:t>నీ నీతి కిరణాలకై</a:t>
+            </a:r>
+          </a:p>
+          <a:p>
+            <a:pPr algn="ctr"/>
+            <a:r>
+              <a:rPr lang="te-IN" dirty="0">
+                <a:solidFill>
+                  <a:schemeClr val="tx1"/>
+                </a:solidFill>
+                <a:latin typeface="Ramabhadra" panose="02000600000000000000" pitchFamily="2" charset="0"/>
+                <a:cs typeface="Ramabhadra" panose="02000600000000000000" pitchFamily="2" charset="0"/>
+              </a:rPr>
+              <a:t>నా దిక్కు దెసలన్ని నీవేనని</a:t>
+            </a:r>
+          </a:p>
+          <a:p>
+            <a:pPr algn="ctr"/>
+            <a:r>
+              <a:rPr lang="te-IN" dirty="0">
+                <a:solidFill>
+                  <a:schemeClr val="tx1"/>
+                </a:solidFill>
+                <a:latin typeface="Ramabhadra" panose="02000600000000000000" pitchFamily="2" charset="0"/>
+                <a:cs typeface="Ramabhadra" panose="02000600000000000000" pitchFamily="2" charset="0"/>
+              </a:rPr>
+              <a:t>అనతికాలాన ప్రథమ ఫలముగా</a:t>
+            </a:r>
+          </a:p>
+          <a:p>
+            <a:pPr algn="ctr"/>
+            <a:r>
+              <a:rPr lang="te-IN" dirty="0">
+                <a:solidFill>
+                  <a:schemeClr val="tx1"/>
+                </a:solidFill>
+                <a:latin typeface="Ramabhadra" panose="02000600000000000000" pitchFamily="2" charset="0"/>
+                <a:cs typeface="Ramabhadra" panose="02000600000000000000" pitchFamily="2" charset="0"/>
+              </a:rPr>
+              <a:t>పక్వపరచిన నీకు (2)</a:t>
+            </a:r>
+          </a:p>
+          <a:p>
+            <a:pPr algn="ctr"/>
+            <a:r>
+              <a:rPr lang="te-IN" dirty="0">
+                <a:solidFill>
+                  <a:schemeClr val="tx1"/>
+                </a:solidFill>
+                <a:latin typeface="Ramabhadra" panose="02000600000000000000" pitchFamily="2" charset="0"/>
+                <a:cs typeface="Ramabhadra" panose="02000600000000000000" pitchFamily="2" charset="0"/>
+              </a:rPr>
+              <a:t>అసాధ్యమైనది ఏమున్నది (4)</a:t>
             </a:r>
           </a:p>
         </p:txBody>
@@ -4483,88 +4469,71 @@
           <a:p>
             <a:pPr algn="ctr"/>
             <a:r>
-              <a:rPr lang="te-IN" dirty="0">
-                <a:solidFill>
-                  <a:schemeClr val="tx1"/>
-                </a:solidFill>
-                <a:latin typeface="Ramabhadra" panose="02000600000000000000" pitchFamily="2" charset="0"/>
-                <a:cs typeface="Ramabhadra" panose="02000600000000000000" pitchFamily="2" charset="0"/>
-              </a:rPr>
-              <a:t>నీ వాక్యమే నన్ను బ్రతికించెను</a:t>
-            </a:r>
-          </a:p>
-          <a:p>
-            <a:pPr algn="ctr"/>
-            <a:r>
-              <a:rPr lang="te-IN" dirty="0">
-                <a:solidFill>
-                  <a:schemeClr val="tx1"/>
-                </a:solidFill>
-                <a:latin typeface="Ramabhadra" panose="02000600000000000000" pitchFamily="2" charset="0"/>
-                <a:cs typeface="Ramabhadra" panose="02000600000000000000" pitchFamily="2" charset="0"/>
-              </a:rPr>
-              <a:t>బాధలలో నెమ్మదినిచ్చెను (2)</a:t>
-            </a:r>
-          </a:p>
-          <a:p>
-            <a:pPr algn="ctr"/>
-            <a:r>
-              <a:rPr lang="te-IN" dirty="0">
-                <a:solidFill>
-                  <a:schemeClr val="tx1"/>
-                </a:solidFill>
-                <a:latin typeface="Ramabhadra" panose="02000600000000000000" pitchFamily="2" charset="0"/>
-                <a:cs typeface="Ramabhadra" panose="02000600000000000000" pitchFamily="2" charset="0"/>
-              </a:rPr>
-              <a:t>కృపా శక్తి దయా సత్య సంపూర్ణుడా</a:t>
-            </a:r>
-          </a:p>
-          <a:p>
-            <a:pPr algn="ctr"/>
-            <a:r>
-              <a:rPr lang="te-IN" dirty="0">
-                <a:solidFill>
-                  <a:schemeClr val="tx1"/>
-                </a:solidFill>
-                <a:latin typeface="Ramabhadra" panose="02000600000000000000" pitchFamily="2" charset="0"/>
-                <a:cs typeface="Ramabhadra" panose="02000600000000000000" pitchFamily="2" charset="0"/>
-              </a:rPr>
-              <a:t>వాక్యమై ఉన్న</a:t>
-            </a:r>
-            <a:r>
-              <a:rPr lang="en-IN" dirty="0">
-                <a:solidFill>
-                  <a:schemeClr val="tx1"/>
-                </a:solidFill>
-                <a:latin typeface="Ramabhadra" panose="02000600000000000000" pitchFamily="2" charset="0"/>
-                <a:cs typeface="Ramabhadra" panose="02000600000000000000" pitchFamily="2" charset="0"/>
-              </a:rPr>
-              <a:t> </a:t>
-            </a:r>
-            <a:r>
-              <a:rPr lang="te-IN" dirty="0">
-                <a:solidFill>
-                  <a:schemeClr val="tx1"/>
-                </a:solidFill>
-                <a:latin typeface="Ramabhadra" panose="02000600000000000000" pitchFamily="2" charset="0"/>
-                <a:cs typeface="Ramabhadra" panose="02000600000000000000" pitchFamily="2" charset="0"/>
-              </a:rPr>
-              <a:t>యేసు వందనమయ్యా (2</a:t>
-            </a:r>
-            <a:r>
-              <a:rPr lang="en-IN" dirty="0">
-                <a:solidFill>
-                  <a:schemeClr val="tx1"/>
-                </a:solidFill>
-                <a:latin typeface="Ramabhadra" panose="02000600000000000000" pitchFamily="2" charset="0"/>
-                <a:cs typeface="Ramabhadra" panose="02000600000000000000" pitchFamily="2" charset="0"/>
-              </a:rPr>
-              <a:t>)</a:t>
-            </a:r>
-          </a:p>
-          <a:p>
-            <a:pPr algn="ctr"/>
-            <a:endParaRPr lang="te-IN" dirty="0">
+              <a:rPr lang="te-IN" sz="1450" dirty="0">
+                <a:solidFill>
+                  <a:schemeClr val="tx1"/>
+                </a:solidFill>
+                <a:latin typeface="Ramabhadra" panose="02000600000000000000" pitchFamily="2" charset="0"/>
+                <a:cs typeface="Ramabhadra" panose="02000600000000000000" pitchFamily="2" charset="0"/>
+              </a:rPr>
+              <a:t>కృపా క్షేమము నీ శాశ్వత జీవము</a:t>
+            </a:r>
+          </a:p>
+          <a:p>
+            <a:pPr algn="ctr"/>
+            <a:r>
+              <a:rPr lang="te-IN" sz="1450" dirty="0">
+                <a:solidFill>
+                  <a:schemeClr val="tx1"/>
+                </a:solidFill>
+                <a:latin typeface="Ramabhadra" panose="02000600000000000000" pitchFamily="2" charset="0"/>
+                <a:cs typeface="Ramabhadra" panose="02000600000000000000" pitchFamily="2" charset="0"/>
+              </a:rPr>
+              <a:t>నా జీవిత కాలమంతయు నీవు దయచేయువాడవు (2)</a:t>
+            </a:r>
+          </a:p>
+          <a:p>
+            <a:pPr algn="ctr"/>
+            <a:r>
+              <a:rPr lang="te-IN" sz="1450" dirty="0">
+                <a:solidFill>
+                  <a:schemeClr val="tx1"/>
+                </a:solidFill>
+                <a:latin typeface="Ramabhadra" panose="02000600000000000000" pitchFamily="2" charset="0"/>
+                <a:cs typeface="Ramabhadra" panose="02000600000000000000" pitchFamily="2" charset="0"/>
+              </a:rPr>
+              <a:t>మహోన్నతమైన నీ ఉపకారములు</a:t>
+            </a:r>
+          </a:p>
+          <a:p>
+            <a:pPr algn="ctr"/>
+            <a:r>
+              <a:rPr lang="te-IN" sz="1450" dirty="0">
+                <a:solidFill>
+                  <a:schemeClr val="tx1"/>
+                </a:solidFill>
+                <a:latin typeface="Ramabhadra" panose="02000600000000000000" pitchFamily="2" charset="0"/>
+                <a:cs typeface="Ramabhadra" panose="02000600000000000000" pitchFamily="2" charset="0"/>
+              </a:rPr>
+              <a:t>తలంచుచు అనుక్షణము పరవశించనా</a:t>
+            </a:r>
+          </a:p>
+          <a:p>
+            <a:pPr algn="ctr"/>
+            <a:r>
+              <a:rPr lang="te-IN" sz="1450" dirty="0">
+                <a:solidFill>
+                  <a:schemeClr val="tx1"/>
+                </a:solidFill>
+                <a:latin typeface="Ramabhadra" panose="02000600000000000000" pitchFamily="2" charset="0"/>
+                <a:cs typeface="Ramabhadra" panose="02000600000000000000" pitchFamily="2" charset="0"/>
+              </a:rPr>
+              <a:t>నీ కృపలోనే పరవశించనా</a:t>
+            </a:r>
+          </a:p>
+          <a:p>
+            <a:pPr algn="ctr"/>
+            <a:endParaRPr lang="te-IN" sz="1450" dirty="0">
               <a:solidFill>
                 <a:schemeClr val="tx1"/>
               </a:solidFill>
@@ -4575,29 +4544,136 @@
           <a:p>
             <a:pPr algn="ctr"/>
             <a:r>
-              <a:rPr lang="te-IN" dirty="0">
-                <a:solidFill>
-                  <a:schemeClr val="tx1"/>
-                </a:solidFill>
-                <a:latin typeface="Ramabhadra" panose="02000600000000000000" pitchFamily="2" charset="0"/>
-                <a:cs typeface="Ramabhadra" panose="02000600000000000000" pitchFamily="2" charset="0"/>
-              </a:rPr>
-              <a:t>జిగటగల ఊభినుండి లేవనెత్తెను</a:t>
-            </a:r>
-          </a:p>
-          <a:p>
-            <a:pPr algn="ctr"/>
-            <a:r>
-              <a:rPr lang="te-IN" dirty="0">
-                <a:solidFill>
-                  <a:schemeClr val="tx1"/>
-                </a:solidFill>
-                <a:latin typeface="Ramabhadra" panose="02000600000000000000" pitchFamily="2" charset="0"/>
-                <a:cs typeface="Ramabhadra" panose="02000600000000000000" pitchFamily="2" charset="0"/>
-              </a:rPr>
-              <a:t>సమతలమగు భూమిపై</a:t>
-            </a:r>
-            <a:endParaRPr lang="en-IN" dirty="0">
+              <a:rPr lang="te-IN" sz="1450" dirty="0">
+                <a:solidFill>
+                  <a:schemeClr val="tx1"/>
+                </a:solidFill>
+                <a:latin typeface="Ramabhadra" panose="02000600000000000000" pitchFamily="2" charset="0"/>
+                <a:cs typeface="Ramabhadra" panose="02000600000000000000" pitchFamily="2" charset="0"/>
+              </a:rPr>
+              <a:t>నా ప్రతి ప్రార్ధనకు నీవిచ్చిన ఈవులే</a:t>
+            </a:r>
+          </a:p>
+          <a:p>
+            <a:pPr algn="ctr"/>
+            <a:r>
+              <a:rPr lang="te-IN" sz="1450" dirty="0">
+                <a:solidFill>
+                  <a:schemeClr val="tx1"/>
+                </a:solidFill>
+                <a:latin typeface="Ramabhadra" panose="02000600000000000000" pitchFamily="2" charset="0"/>
+                <a:cs typeface="Ramabhadra" panose="02000600000000000000" pitchFamily="2" charset="0"/>
+              </a:rPr>
+              <a:t>లెక్కకు మించిన దీవెనలైనాయి (2)</a:t>
+            </a:r>
+          </a:p>
+          <a:p>
+            <a:pPr algn="ctr"/>
+            <a:r>
+              <a:rPr lang="te-IN" sz="1450" dirty="0">
+                <a:solidFill>
+                  <a:schemeClr val="tx1"/>
+                </a:solidFill>
+                <a:latin typeface="Ramabhadra" panose="02000600000000000000" pitchFamily="2" charset="0"/>
+                <a:cs typeface="Ramabhadra" panose="02000600000000000000" pitchFamily="2" charset="0"/>
+              </a:rPr>
+              <a:t>అడుగులు తడబడక నడిపినది</a:t>
+            </a:r>
+          </a:p>
+          <a:p>
+            <a:pPr algn="ctr"/>
+            <a:r>
+              <a:rPr lang="te-IN" sz="1450" dirty="0">
+                <a:solidFill>
+                  <a:schemeClr val="tx1"/>
+                </a:solidFill>
+                <a:latin typeface="Ramabhadra" panose="02000600000000000000" pitchFamily="2" charset="0"/>
+                <a:cs typeface="Ramabhadra" panose="02000600000000000000" pitchFamily="2" charset="0"/>
+              </a:rPr>
+              <a:t>నీ దివ్య వాక్యమే</a:t>
+            </a:r>
+          </a:p>
+          <a:p>
+            <a:pPr algn="ctr"/>
+            <a:r>
+              <a:rPr lang="te-IN" sz="1450" dirty="0">
+                <a:solidFill>
+                  <a:schemeClr val="tx1"/>
+                </a:solidFill>
+                <a:latin typeface="Ramabhadra" panose="02000600000000000000" pitchFamily="2" charset="0"/>
+                <a:cs typeface="Ramabhadra" panose="02000600000000000000" pitchFamily="2" charset="0"/>
+              </a:rPr>
+              <a:t>కడలిని మించిన విశ్వాసమునిచ్చి విజయము చేకూర్చెను (2)</a:t>
+            </a:r>
+          </a:p>
+          <a:p>
+            <a:pPr algn="ctr"/>
+            <a:r>
+              <a:rPr lang="te-IN" sz="1450" dirty="0">
+                <a:solidFill>
+                  <a:schemeClr val="tx1"/>
+                </a:solidFill>
+                <a:latin typeface="Ramabhadra" panose="02000600000000000000" pitchFamily="2" charset="0"/>
+                <a:cs typeface="Ramabhadra" panose="02000600000000000000" pitchFamily="2" charset="0"/>
+              </a:rPr>
+              <a:t>నీ వాక్యమే మకరంధమై</a:t>
+            </a:r>
+          </a:p>
+          <a:p>
+            <a:pPr algn="ctr"/>
+            <a:r>
+              <a:rPr lang="te-IN" sz="1450" dirty="0">
+                <a:solidFill>
+                  <a:schemeClr val="tx1"/>
+                </a:solidFill>
+                <a:latin typeface="Ramabhadra" panose="02000600000000000000" pitchFamily="2" charset="0"/>
+                <a:cs typeface="Ramabhadra" panose="02000600000000000000" pitchFamily="2" charset="0"/>
+              </a:rPr>
+              <a:t>బలపరిచెను నన్ను</a:t>
+            </a:r>
+          </a:p>
+          <a:p>
+            <a:pPr algn="ctr"/>
+            <a:r>
+              <a:rPr lang="te-IN" sz="1450" dirty="0">
+                <a:solidFill>
+                  <a:schemeClr val="tx1"/>
+                </a:solidFill>
+                <a:latin typeface="Ramabhadra" panose="02000600000000000000" pitchFamily="2" charset="0"/>
+                <a:cs typeface="Ramabhadra" panose="02000600000000000000" pitchFamily="2" charset="0"/>
+              </a:rPr>
+              <a:t>నా యేసయ్య స్తుతిపాత్రుడ</a:t>
+            </a:r>
+          </a:p>
+          <a:p>
+            <a:pPr algn="ctr"/>
+            <a:r>
+              <a:rPr lang="te-IN" sz="1450" dirty="0">
+                <a:solidFill>
+                  <a:schemeClr val="tx1"/>
+                </a:solidFill>
+                <a:latin typeface="Ramabhadra" panose="02000600000000000000" pitchFamily="2" charset="0"/>
+                <a:cs typeface="Ramabhadra" panose="02000600000000000000" pitchFamily="2" charset="0"/>
+              </a:rPr>
+              <a:t>ఆరాధన నీకే (2)</a:t>
+            </a:r>
+          </a:p>
+          <a:p>
+            <a:pPr algn="ctr"/>
+            <a:r>
+              <a:rPr lang="te-IN" sz="1450" dirty="0">
+                <a:solidFill>
+                  <a:schemeClr val="tx1"/>
+                </a:solidFill>
+                <a:latin typeface="Ramabhadra" panose="02000600000000000000" pitchFamily="2" charset="0"/>
+                <a:cs typeface="Ramabhadra" panose="02000600000000000000" pitchFamily="2" charset="0"/>
+              </a:rPr>
+              <a:t>ఆరాధన నీకే</a:t>
+            </a:r>
+          </a:p>
+          <a:p>
+            <a:pPr algn="ctr"/>
+            <a:endParaRPr lang="te-IN" sz="1450" dirty="0">
               <a:solidFill>
                 <a:schemeClr val="tx1"/>
               </a:solidFill>
@@ -4608,207 +4684,145 @@
           <a:p>
             <a:pPr algn="ctr"/>
             <a:r>
-              <a:rPr lang="te-IN" dirty="0">
-                <a:solidFill>
-                  <a:schemeClr val="tx1"/>
-                </a:solidFill>
-                <a:latin typeface="Ramabhadra" panose="02000600000000000000" pitchFamily="2" charset="0"/>
-                <a:cs typeface="Ramabhadra" panose="02000600000000000000" pitchFamily="2" charset="0"/>
-              </a:rPr>
-              <a:t>నన్ను నిలిపెను (2)</a:t>
-            </a:r>
-          </a:p>
-          <a:p>
-            <a:pPr algn="ctr"/>
-            <a:r>
-              <a:rPr lang="te-IN" dirty="0">
-                <a:solidFill>
-                  <a:schemeClr val="tx1"/>
-                </a:solidFill>
-                <a:latin typeface="Ramabhadra" panose="02000600000000000000" pitchFamily="2" charset="0"/>
-                <a:cs typeface="Ramabhadra" panose="02000600000000000000" pitchFamily="2" charset="0"/>
-              </a:rPr>
-              <a:t>నా పాదములకు</a:t>
-            </a:r>
-            <a:endParaRPr lang="en-IN" dirty="0">
-              <a:solidFill>
-                <a:schemeClr val="tx1"/>
-              </a:solidFill>
-              <a:latin typeface="Ramabhadra" panose="02000600000000000000" pitchFamily="2" charset="0"/>
-              <a:cs typeface="Ramabhadra" panose="02000600000000000000" pitchFamily="2" charset="0"/>
-            </a:endParaRPr>
-          </a:p>
-          <a:p>
-            <a:pPr algn="ctr"/>
-            <a:r>
-              <a:rPr lang="te-IN" dirty="0">
-                <a:solidFill>
-                  <a:schemeClr val="tx1"/>
-                </a:solidFill>
-                <a:latin typeface="Ramabhadra" panose="02000600000000000000" pitchFamily="2" charset="0"/>
-                <a:cs typeface="Ramabhadra" panose="02000600000000000000" pitchFamily="2" charset="0"/>
-              </a:rPr>
-              <a:t>దీపమాయెను (2)</a:t>
-            </a:r>
-          </a:p>
-          <a:p>
-            <a:pPr algn="ctr"/>
-            <a:r>
-              <a:rPr lang="te-IN" dirty="0">
-                <a:solidFill>
-                  <a:schemeClr val="tx1"/>
-                </a:solidFill>
-                <a:latin typeface="Ramabhadra" panose="02000600000000000000" pitchFamily="2" charset="0"/>
-                <a:cs typeface="Ramabhadra" panose="02000600000000000000" pitchFamily="2" charset="0"/>
-              </a:rPr>
-              <a:t>సత్యమైన మార్గములో నడుపుచుండెను (2</a:t>
-            </a:r>
-            <a:r>
-              <a:rPr lang="en-IN" dirty="0">
-                <a:solidFill>
-                  <a:schemeClr val="tx1"/>
-                </a:solidFill>
-                <a:latin typeface="Ramabhadra" panose="02000600000000000000" pitchFamily="2" charset="0"/>
-                <a:cs typeface="Ramabhadra" panose="02000600000000000000" pitchFamily="2" charset="0"/>
-              </a:rPr>
-              <a:t>)</a:t>
-            </a:r>
-            <a:endParaRPr lang="te-IN" dirty="0">
-              <a:solidFill>
-                <a:schemeClr val="tx1"/>
-              </a:solidFill>
-              <a:latin typeface="Ramabhadra" panose="02000600000000000000" pitchFamily="2" charset="0"/>
-              <a:cs typeface="Ramabhadra" panose="02000600000000000000" pitchFamily="2" charset="0"/>
-            </a:endParaRPr>
-          </a:p>
-          <a:p>
-            <a:pPr algn="ctr"/>
-            <a:endParaRPr lang="te-IN" dirty="0">
-              <a:solidFill>
-                <a:schemeClr val="tx1"/>
-              </a:solidFill>
-              <a:latin typeface="Ramabhadra" panose="02000600000000000000" pitchFamily="2" charset="0"/>
-              <a:cs typeface="Ramabhadra" panose="02000600000000000000" pitchFamily="2" charset="0"/>
-            </a:endParaRPr>
-          </a:p>
-          <a:p>
-            <a:pPr algn="ctr"/>
-            <a:r>
-              <a:rPr lang="te-IN" dirty="0">
-                <a:solidFill>
-                  <a:schemeClr val="tx1"/>
-                </a:solidFill>
-                <a:latin typeface="Ramabhadra" panose="02000600000000000000" pitchFamily="2" charset="0"/>
-                <a:cs typeface="Ramabhadra" panose="02000600000000000000" pitchFamily="2" charset="0"/>
-              </a:rPr>
-              <a:t>శత్రువులను ఎదుర్కొనే</a:t>
-            </a:r>
-            <a:endParaRPr lang="en-IN" dirty="0">
-              <a:solidFill>
-                <a:schemeClr val="tx1"/>
-              </a:solidFill>
-              <a:latin typeface="Ramabhadra" panose="02000600000000000000" pitchFamily="2" charset="0"/>
-              <a:cs typeface="Ramabhadra" panose="02000600000000000000" pitchFamily="2" charset="0"/>
-            </a:endParaRPr>
-          </a:p>
-          <a:p>
-            <a:pPr algn="ctr"/>
-            <a:r>
-              <a:rPr lang="te-IN" dirty="0">
-                <a:solidFill>
-                  <a:schemeClr val="tx1"/>
-                </a:solidFill>
-                <a:latin typeface="Ramabhadra" panose="02000600000000000000" pitchFamily="2" charset="0"/>
-                <a:cs typeface="Ramabhadra" panose="02000600000000000000" pitchFamily="2" charset="0"/>
-              </a:rPr>
-              <a:t>సర్వాంగ కవచమై</a:t>
-            </a:r>
-          </a:p>
-          <a:p>
-            <a:pPr algn="ctr"/>
-            <a:r>
-              <a:rPr lang="te-IN" dirty="0">
-                <a:solidFill>
-                  <a:schemeClr val="tx1"/>
-                </a:solidFill>
-                <a:latin typeface="Ramabhadra" panose="02000600000000000000" pitchFamily="2" charset="0"/>
-                <a:cs typeface="Ramabhadra" panose="02000600000000000000" pitchFamily="2" charset="0"/>
-              </a:rPr>
-              <a:t>యుద్ధమునకు సిద్ధ మనసు ఇచ్చుచున్నది (2)</a:t>
-            </a:r>
-          </a:p>
-          <a:p>
-            <a:pPr algn="ctr"/>
-            <a:r>
-              <a:rPr lang="te-IN" dirty="0">
-                <a:solidFill>
-                  <a:schemeClr val="tx1"/>
-                </a:solidFill>
-                <a:latin typeface="Ramabhadra" panose="02000600000000000000" pitchFamily="2" charset="0"/>
-                <a:cs typeface="Ramabhadra" panose="02000600000000000000" pitchFamily="2" charset="0"/>
-              </a:rPr>
-              <a:t>అపవాది వేయుచున్న</a:t>
-            </a:r>
-            <a:endParaRPr lang="en-IN" dirty="0">
-              <a:solidFill>
-                <a:schemeClr val="tx1"/>
-              </a:solidFill>
-              <a:latin typeface="Ramabhadra" panose="02000600000000000000" pitchFamily="2" charset="0"/>
-              <a:cs typeface="Ramabhadra" panose="02000600000000000000" pitchFamily="2" charset="0"/>
-            </a:endParaRPr>
-          </a:p>
-          <a:p>
-            <a:pPr algn="ctr"/>
-            <a:r>
-              <a:rPr lang="te-IN" dirty="0">
-                <a:solidFill>
-                  <a:schemeClr val="tx1"/>
-                </a:solidFill>
-                <a:latin typeface="Ramabhadra" panose="02000600000000000000" pitchFamily="2" charset="0"/>
-                <a:cs typeface="Ramabhadra" panose="02000600000000000000" pitchFamily="2" charset="0"/>
-              </a:rPr>
-              <a:t>అగ్ని బాణములను (2)</a:t>
-            </a:r>
-          </a:p>
-          <a:p>
-            <a:pPr algn="ctr"/>
-            <a:r>
-              <a:rPr lang="te-IN" dirty="0">
-                <a:solidFill>
-                  <a:schemeClr val="tx1"/>
-                </a:solidFill>
-                <a:latin typeface="Ramabhadra" panose="02000600000000000000" pitchFamily="2" charset="0"/>
-                <a:cs typeface="Ramabhadra" panose="02000600000000000000" pitchFamily="2" charset="0"/>
-              </a:rPr>
-              <a:t>ఖడ్గము వలె అడ్డుకొని</a:t>
-            </a:r>
-            <a:endParaRPr lang="en-IN" dirty="0">
-              <a:solidFill>
-                <a:schemeClr val="tx1"/>
-              </a:solidFill>
-              <a:latin typeface="Ramabhadra" panose="02000600000000000000" pitchFamily="2" charset="0"/>
-              <a:cs typeface="Ramabhadra" panose="02000600000000000000" pitchFamily="2" charset="0"/>
-            </a:endParaRPr>
-          </a:p>
-          <a:p>
-            <a:pPr algn="ctr"/>
-            <a:r>
-              <a:rPr lang="te-IN" dirty="0">
-                <a:solidFill>
-                  <a:schemeClr val="tx1"/>
-                </a:solidFill>
-                <a:latin typeface="Ramabhadra" panose="02000600000000000000" pitchFamily="2" charset="0"/>
-                <a:cs typeface="Ramabhadra" panose="02000600000000000000" pitchFamily="2" charset="0"/>
-              </a:rPr>
-              <a:t>ఆర్పి వేయుచున్నది (2) </a:t>
-            </a:r>
-            <a:endParaRPr lang="en-IN" dirty="0">
-              <a:solidFill>
-                <a:schemeClr val="tx1"/>
-              </a:solidFill>
-              <a:latin typeface="Ramabhadra" panose="02000600000000000000" pitchFamily="2" charset="0"/>
-              <a:cs typeface="Ramabhadra" panose="02000600000000000000" pitchFamily="2" charset="0"/>
-            </a:endParaRPr>
+              <a:rPr lang="te-IN" sz="1450" dirty="0">
+                <a:solidFill>
+                  <a:schemeClr val="tx1"/>
+                </a:solidFill>
+                <a:latin typeface="Ramabhadra" panose="02000600000000000000" pitchFamily="2" charset="0"/>
+                <a:cs typeface="Ramabhadra" panose="02000600000000000000" pitchFamily="2" charset="0"/>
+              </a:rPr>
+              <a:t>నీ సత్య మార్గములో</a:t>
+            </a:r>
+          </a:p>
+          <a:p>
+            <a:pPr algn="ctr"/>
+            <a:r>
+              <a:rPr lang="te-IN" sz="1450" dirty="0">
+                <a:solidFill>
+                  <a:schemeClr val="tx1"/>
+                </a:solidFill>
+                <a:latin typeface="Ramabhadra" panose="02000600000000000000" pitchFamily="2" charset="0"/>
+                <a:cs typeface="Ramabhadra" panose="02000600000000000000" pitchFamily="2" charset="0"/>
+              </a:rPr>
+              <a:t>ఫలించిన అనుభవమే</a:t>
+            </a:r>
+          </a:p>
+          <a:p>
+            <a:pPr algn="ctr"/>
+            <a:r>
+              <a:rPr lang="te-IN" sz="1450" dirty="0">
+                <a:solidFill>
+                  <a:schemeClr val="tx1"/>
+                </a:solidFill>
+                <a:latin typeface="Ramabhadra" panose="02000600000000000000" pitchFamily="2" charset="0"/>
+                <a:cs typeface="Ramabhadra" panose="02000600000000000000" pitchFamily="2" charset="0"/>
+              </a:rPr>
+              <a:t>పరిమళింపచేసి సాక్షిగ నిలిపాయి (2)</a:t>
+            </a:r>
+          </a:p>
+          <a:p>
+            <a:pPr algn="ctr"/>
+            <a:r>
+              <a:rPr lang="te-IN" sz="1450" dirty="0">
+                <a:solidFill>
+                  <a:schemeClr val="tx1"/>
+                </a:solidFill>
+                <a:latin typeface="Ramabhadra" panose="02000600000000000000" pitchFamily="2" charset="0"/>
+                <a:cs typeface="Ramabhadra" panose="02000600000000000000" pitchFamily="2" charset="0"/>
+              </a:rPr>
+              <a:t>కలతచెందక నిలిపినది</a:t>
+            </a:r>
+          </a:p>
+          <a:p>
+            <a:pPr algn="ctr"/>
+            <a:r>
+              <a:rPr lang="te-IN" sz="1450" dirty="0">
+                <a:solidFill>
+                  <a:schemeClr val="tx1"/>
+                </a:solidFill>
+                <a:latin typeface="Ramabhadra" panose="02000600000000000000" pitchFamily="2" charset="0"/>
+                <a:cs typeface="Ramabhadra" panose="02000600000000000000" pitchFamily="2" charset="0"/>
+              </a:rPr>
+              <a:t>నీ దివ్య దర్శనమే</a:t>
+            </a:r>
+          </a:p>
+          <a:p>
+            <a:pPr algn="ctr"/>
+            <a:r>
+              <a:rPr lang="te-IN" sz="1450" dirty="0">
+                <a:solidFill>
+                  <a:schemeClr val="tx1"/>
+                </a:solidFill>
+                <a:latin typeface="Ramabhadra" panose="02000600000000000000" pitchFamily="2" charset="0"/>
+                <a:cs typeface="Ramabhadra" panose="02000600000000000000" pitchFamily="2" charset="0"/>
+              </a:rPr>
+              <a:t>గమ్యము చేరే శక్తితో నను నింపి</a:t>
+            </a:r>
+          </a:p>
+          <a:p>
+            <a:pPr algn="ctr"/>
+            <a:r>
+              <a:rPr lang="te-IN" sz="1450" dirty="0">
+                <a:solidFill>
+                  <a:schemeClr val="tx1"/>
+                </a:solidFill>
+                <a:latin typeface="Ramabhadra" panose="02000600000000000000" pitchFamily="2" charset="0"/>
+                <a:cs typeface="Ramabhadra" panose="02000600000000000000" pitchFamily="2" charset="0"/>
+              </a:rPr>
+              <a:t>నూతన కృపనిచ్చెను (2)</a:t>
+            </a:r>
+          </a:p>
+          <a:p>
+            <a:pPr algn="ctr"/>
+            <a:r>
+              <a:rPr lang="te-IN" sz="1450" dirty="0">
+                <a:solidFill>
+                  <a:schemeClr val="tx1"/>
+                </a:solidFill>
+                <a:latin typeface="Ramabhadra" panose="02000600000000000000" pitchFamily="2" charset="0"/>
+                <a:cs typeface="Ramabhadra" panose="02000600000000000000" pitchFamily="2" charset="0"/>
+              </a:rPr>
+              <a:t>ఆరాధ్యుడా అభిషిక్తుడా ఆరాధన నీకే</a:t>
+            </a:r>
+          </a:p>
+          <a:p>
+            <a:pPr algn="ctr"/>
+            <a:r>
+              <a:rPr lang="te-IN" sz="1450" dirty="0">
+                <a:solidFill>
+                  <a:schemeClr val="tx1"/>
+                </a:solidFill>
+                <a:latin typeface="Ramabhadra" panose="02000600000000000000" pitchFamily="2" charset="0"/>
+                <a:cs typeface="Ramabhadra" panose="02000600000000000000" pitchFamily="2" charset="0"/>
+              </a:rPr>
+              <a:t>నా యేసయ్య స్తుతిపాత్రుడ</a:t>
+            </a:r>
+          </a:p>
+          <a:p>
+            <a:pPr algn="ctr"/>
+            <a:r>
+              <a:rPr lang="te-IN" sz="1450" dirty="0">
+                <a:solidFill>
+                  <a:schemeClr val="tx1"/>
+                </a:solidFill>
+                <a:latin typeface="Ramabhadra" panose="02000600000000000000" pitchFamily="2" charset="0"/>
+                <a:cs typeface="Ramabhadra" panose="02000600000000000000" pitchFamily="2" charset="0"/>
+              </a:rPr>
+              <a:t>ఆరాధన నీకే (2)</a:t>
+            </a:r>
+          </a:p>
+          <a:p>
+            <a:pPr algn="ctr"/>
+            <a:r>
+              <a:rPr lang="te-IN" sz="1450" dirty="0">
+                <a:solidFill>
+                  <a:schemeClr val="tx1"/>
+                </a:solidFill>
+                <a:latin typeface="Ramabhadra" panose="02000600000000000000" pitchFamily="2" charset="0"/>
+                <a:cs typeface="Ramabhadra" panose="02000600000000000000" pitchFamily="2" charset="0"/>
+              </a:rPr>
+              <a:t>ఆరాధన నీకే</a:t>
+            </a:r>
           </a:p>
         </p:txBody>
       </p:sp>

</xml_diff>

<commit_message>
25 sunday songs aug
</commit_message>
<xml_diff>
--- a/xerox.pptx
+++ b/xerox.pptx
@@ -224,7 +224,7 @@
           <a:p>
             <a:fld id="{3502DD63-DF8D-4AB8-92A0-0ECCF612C06C}" type="datetimeFigureOut">
               <a:rPr lang="en-IN" smtClean="0"/>
-              <a:t>20-08-2024</a:t>
+              <a:t>24-08-2024</a:t>
             </a:fld>
             <a:endParaRPr lang="en-IN"/>
           </a:p>
@@ -402,7 +402,7 @@
           <a:p>
             <a:fld id="{1AE741EC-1360-4793-999B-941E0396C9FA}" type="datetimeFigureOut">
               <a:rPr lang="en-IN" smtClean="0"/>
-              <a:t>20-08-2024</a:t>
+              <a:t>24-08-2024</a:t>
             </a:fld>
             <a:endParaRPr lang="en-IN"/>
           </a:p>
@@ -802,7 +802,7 @@
           <a:p>
             <a:fld id="{86FBD32F-FCAD-481A-B7D8-4D813FB7DB24}" type="datetimeFigureOut">
               <a:rPr lang="en-IN" smtClean="0"/>
-              <a:t>20-08-2024</a:t>
+              <a:t>24-08-2024</a:t>
             </a:fld>
             <a:endParaRPr lang="en-IN"/>
           </a:p>
@@ -972,7 +972,7 @@
           <a:p>
             <a:fld id="{86FBD32F-FCAD-481A-B7D8-4D813FB7DB24}" type="datetimeFigureOut">
               <a:rPr lang="en-IN" smtClean="0"/>
-              <a:t>20-08-2024</a:t>
+              <a:t>24-08-2024</a:t>
             </a:fld>
             <a:endParaRPr lang="en-IN"/>
           </a:p>
@@ -1152,7 +1152,7 @@
           <a:p>
             <a:fld id="{86FBD32F-FCAD-481A-B7D8-4D813FB7DB24}" type="datetimeFigureOut">
               <a:rPr lang="en-IN" smtClean="0"/>
-              <a:t>20-08-2024</a:t>
+              <a:t>24-08-2024</a:t>
             </a:fld>
             <a:endParaRPr lang="en-IN"/>
           </a:p>
@@ -1322,7 +1322,7 @@
           <a:p>
             <a:fld id="{86FBD32F-FCAD-481A-B7D8-4D813FB7DB24}" type="datetimeFigureOut">
               <a:rPr lang="en-IN" smtClean="0"/>
-              <a:t>20-08-2024</a:t>
+              <a:t>24-08-2024</a:t>
             </a:fld>
             <a:endParaRPr lang="en-IN"/>
           </a:p>
@@ -1566,7 +1566,7 @@
           <a:p>
             <a:fld id="{86FBD32F-FCAD-481A-B7D8-4D813FB7DB24}" type="datetimeFigureOut">
               <a:rPr lang="en-IN" smtClean="0"/>
-              <a:t>20-08-2024</a:t>
+              <a:t>24-08-2024</a:t>
             </a:fld>
             <a:endParaRPr lang="en-IN"/>
           </a:p>
@@ -1798,7 +1798,7 @@
           <a:p>
             <a:fld id="{86FBD32F-FCAD-481A-B7D8-4D813FB7DB24}" type="datetimeFigureOut">
               <a:rPr lang="en-IN" smtClean="0"/>
-              <a:t>20-08-2024</a:t>
+              <a:t>24-08-2024</a:t>
             </a:fld>
             <a:endParaRPr lang="en-IN"/>
           </a:p>
@@ -2165,7 +2165,7 @@
           <a:p>
             <a:fld id="{86FBD32F-FCAD-481A-B7D8-4D813FB7DB24}" type="datetimeFigureOut">
               <a:rPr lang="en-IN" smtClean="0"/>
-              <a:t>20-08-2024</a:t>
+              <a:t>24-08-2024</a:t>
             </a:fld>
             <a:endParaRPr lang="en-IN"/>
           </a:p>
@@ -2283,7 +2283,7 @@
           <a:p>
             <a:fld id="{86FBD32F-FCAD-481A-B7D8-4D813FB7DB24}" type="datetimeFigureOut">
               <a:rPr lang="en-IN" smtClean="0"/>
-              <a:t>20-08-2024</a:t>
+              <a:t>24-08-2024</a:t>
             </a:fld>
             <a:endParaRPr lang="en-IN"/>
           </a:p>
@@ -2378,7 +2378,7 @@
           <a:p>
             <a:fld id="{86FBD32F-FCAD-481A-B7D8-4D813FB7DB24}" type="datetimeFigureOut">
               <a:rPr lang="en-IN" smtClean="0"/>
-              <a:t>20-08-2024</a:t>
+              <a:t>24-08-2024</a:t>
             </a:fld>
             <a:endParaRPr lang="en-IN"/>
           </a:p>
@@ -2655,7 +2655,7 @@
           <a:p>
             <a:fld id="{86FBD32F-FCAD-481A-B7D8-4D813FB7DB24}" type="datetimeFigureOut">
               <a:rPr lang="en-IN" smtClean="0"/>
-              <a:t>20-08-2024</a:t>
+              <a:t>24-08-2024</a:t>
             </a:fld>
             <a:endParaRPr lang="en-IN"/>
           </a:p>
@@ -2912,7 +2912,7 @@
           <a:p>
             <a:fld id="{86FBD32F-FCAD-481A-B7D8-4D813FB7DB24}" type="datetimeFigureOut">
               <a:rPr lang="en-IN" smtClean="0"/>
-              <a:t>20-08-2024</a:t>
+              <a:t>24-08-2024</a:t>
             </a:fld>
             <a:endParaRPr lang="en-IN"/>
           </a:p>
@@ -3125,7 +3125,7 @@
           <a:p>
             <a:fld id="{86FBD32F-FCAD-481A-B7D8-4D813FB7DB24}" type="datetimeFigureOut">
               <a:rPr lang="en-IN" smtClean="0"/>
-              <a:t>20-08-2024</a:t>
+              <a:t>24-08-2024</a:t>
             </a:fld>
             <a:endParaRPr lang="en-IN"/>
           </a:p>
@@ -3792,7 +3792,7 @@
                 <a:latin typeface="Ramabhadra" panose="02000600000000000000" pitchFamily="2" charset="0"/>
                 <a:cs typeface="Ramabhadra" panose="02000600000000000000" pitchFamily="2" charset="0"/>
               </a:rPr>
-              <a:t>  ఆదరణ నా హ్రుదిలోనా నింపుమయా </a:t>
+              <a:t>  ఆదరణ నా హృదిలోనా నింపుమయా </a:t>
             </a:r>
           </a:p>
           <a:p>
@@ -4235,7 +4235,7 @@
                 <a:latin typeface="Ramabhadra" panose="02000600000000000000" pitchFamily="2" charset="0"/>
                 <a:cs typeface="Ramabhadra" panose="02000600000000000000" pitchFamily="2" charset="0"/>
               </a:rPr>
-              <a:t>గొల్యాత్ మనకు ఎదురు వచ్చినా క్రీస్తుయేసు</a:t>
+              <a:t>గోలియాతు మనకు ఎదురు వచ్చినా క్రీస్తుయేసు</a:t>
             </a:r>
           </a:p>
           <a:p>

</xml_diff>

<commit_message>
01 sep 2024 sunday songs
</commit_message>
<xml_diff>
--- a/xerox.pptx
+++ b/xerox.pptx
@@ -224,7 +224,7 @@
           <a:p>
             <a:fld id="{3502DD63-DF8D-4AB8-92A0-0ECCF612C06C}" type="datetimeFigureOut">
               <a:rPr lang="en-IN" smtClean="0"/>
-              <a:t>24-08-2024</a:t>
+              <a:t>31-08-2024</a:t>
             </a:fld>
             <a:endParaRPr lang="en-IN"/>
           </a:p>
@@ -402,7 +402,7 @@
           <a:p>
             <a:fld id="{1AE741EC-1360-4793-999B-941E0396C9FA}" type="datetimeFigureOut">
               <a:rPr lang="en-IN" smtClean="0"/>
-              <a:t>24-08-2024</a:t>
+              <a:t>31-08-2024</a:t>
             </a:fld>
             <a:endParaRPr lang="en-IN"/>
           </a:p>
@@ -802,7 +802,7 @@
           <a:p>
             <a:fld id="{86FBD32F-FCAD-481A-B7D8-4D813FB7DB24}" type="datetimeFigureOut">
               <a:rPr lang="en-IN" smtClean="0"/>
-              <a:t>24-08-2024</a:t>
+              <a:t>31-08-2024</a:t>
             </a:fld>
             <a:endParaRPr lang="en-IN"/>
           </a:p>
@@ -972,7 +972,7 @@
           <a:p>
             <a:fld id="{86FBD32F-FCAD-481A-B7D8-4D813FB7DB24}" type="datetimeFigureOut">
               <a:rPr lang="en-IN" smtClean="0"/>
-              <a:t>24-08-2024</a:t>
+              <a:t>31-08-2024</a:t>
             </a:fld>
             <a:endParaRPr lang="en-IN"/>
           </a:p>
@@ -1152,7 +1152,7 @@
           <a:p>
             <a:fld id="{86FBD32F-FCAD-481A-B7D8-4D813FB7DB24}" type="datetimeFigureOut">
               <a:rPr lang="en-IN" smtClean="0"/>
-              <a:t>24-08-2024</a:t>
+              <a:t>31-08-2024</a:t>
             </a:fld>
             <a:endParaRPr lang="en-IN"/>
           </a:p>
@@ -1322,7 +1322,7 @@
           <a:p>
             <a:fld id="{86FBD32F-FCAD-481A-B7D8-4D813FB7DB24}" type="datetimeFigureOut">
               <a:rPr lang="en-IN" smtClean="0"/>
-              <a:t>24-08-2024</a:t>
+              <a:t>31-08-2024</a:t>
             </a:fld>
             <a:endParaRPr lang="en-IN"/>
           </a:p>
@@ -1566,7 +1566,7 @@
           <a:p>
             <a:fld id="{86FBD32F-FCAD-481A-B7D8-4D813FB7DB24}" type="datetimeFigureOut">
               <a:rPr lang="en-IN" smtClean="0"/>
-              <a:t>24-08-2024</a:t>
+              <a:t>31-08-2024</a:t>
             </a:fld>
             <a:endParaRPr lang="en-IN"/>
           </a:p>
@@ -1798,7 +1798,7 @@
           <a:p>
             <a:fld id="{86FBD32F-FCAD-481A-B7D8-4D813FB7DB24}" type="datetimeFigureOut">
               <a:rPr lang="en-IN" smtClean="0"/>
-              <a:t>24-08-2024</a:t>
+              <a:t>31-08-2024</a:t>
             </a:fld>
             <a:endParaRPr lang="en-IN"/>
           </a:p>
@@ -2165,7 +2165,7 @@
           <a:p>
             <a:fld id="{86FBD32F-FCAD-481A-B7D8-4D813FB7DB24}" type="datetimeFigureOut">
               <a:rPr lang="en-IN" smtClean="0"/>
-              <a:t>24-08-2024</a:t>
+              <a:t>31-08-2024</a:t>
             </a:fld>
             <a:endParaRPr lang="en-IN"/>
           </a:p>
@@ -2283,7 +2283,7 @@
           <a:p>
             <a:fld id="{86FBD32F-FCAD-481A-B7D8-4D813FB7DB24}" type="datetimeFigureOut">
               <a:rPr lang="en-IN" smtClean="0"/>
-              <a:t>24-08-2024</a:t>
+              <a:t>31-08-2024</a:t>
             </a:fld>
             <a:endParaRPr lang="en-IN"/>
           </a:p>
@@ -2378,7 +2378,7 @@
           <a:p>
             <a:fld id="{86FBD32F-FCAD-481A-B7D8-4D813FB7DB24}" type="datetimeFigureOut">
               <a:rPr lang="en-IN" smtClean="0"/>
-              <a:t>24-08-2024</a:t>
+              <a:t>31-08-2024</a:t>
             </a:fld>
             <a:endParaRPr lang="en-IN"/>
           </a:p>
@@ -2655,7 +2655,7 @@
           <a:p>
             <a:fld id="{86FBD32F-FCAD-481A-B7D8-4D813FB7DB24}" type="datetimeFigureOut">
               <a:rPr lang="en-IN" smtClean="0"/>
-              <a:t>24-08-2024</a:t>
+              <a:t>31-08-2024</a:t>
             </a:fld>
             <a:endParaRPr lang="en-IN"/>
           </a:p>
@@ -2912,7 +2912,7 @@
           <a:p>
             <a:fld id="{86FBD32F-FCAD-481A-B7D8-4D813FB7DB24}" type="datetimeFigureOut">
               <a:rPr lang="en-IN" smtClean="0"/>
-              <a:t>24-08-2024</a:t>
+              <a:t>31-08-2024</a:t>
             </a:fld>
             <a:endParaRPr lang="en-IN"/>
           </a:p>
@@ -3125,7 +3125,7 @@
           <a:p>
             <a:fld id="{86FBD32F-FCAD-481A-B7D8-4D813FB7DB24}" type="datetimeFigureOut">
               <a:rPr lang="en-IN" smtClean="0"/>
-              <a:t>24-08-2024</a:t>
+              <a:t>31-08-2024</a:t>
             </a:fld>
             <a:endParaRPr lang="en-IN"/>
           </a:p>
@@ -3583,71 +3583,58 @@
           <a:p>
             <a:pPr algn="ctr" defTabSz="439781"/>
             <a:r>
-              <a:rPr lang="te-IN" sz="1700" dirty="0">
+              <a:rPr lang="te-IN" sz="2000" dirty="0">
                 <a:solidFill>
                   <a:prstClr val="black"/>
                 </a:solidFill>
                 <a:latin typeface="Ramabhadra" panose="02000600000000000000" pitchFamily="2" charset="0"/>
                 <a:cs typeface="Ramabhadra" panose="02000600000000000000" pitchFamily="2" charset="0"/>
               </a:rPr>
-              <a:t> నాదు రక్షక నీ మనసే ఉత్తమం </a:t>
+              <a:t>ఎవరు నా చేయి విడచిన</a:t>
             </a:r>
           </a:p>
           <a:p>
             <a:pPr algn="ctr" defTabSz="439781"/>
             <a:r>
-              <a:rPr lang="te-IN" sz="1700" dirty="0">
+              <a:rPr lang="te-IN" sz="2000" dirty="0">
                 <a:solidFill>
                   <a:prstClr val="black"/>
                 </a:solidFill>
                 <a:latin typeface="Ramabhadra" panose="02000600000000000000" pitchFamily="2" charset="0"/>
                 <a:cs typeface="Ramabhadra" panose="02000600000000000000" pitchFamily="2" charset="0"/>
               </a:rPr>
-              <a:t> దినదినము నీతోనే వసియింతును</a:t>
+              <a:t>యేసు చేయి విడువడు (2)</a:t>
             </a:r>
           </a:p>
           <a:p>
             <a:pPr algn="ctr" defTabSz="439781"/>
             <a:r>
-              <a:rPr lang="te-IN" sz="1700" dirty="0">
+              <a:rPr lang="te-IN" sz="2000" dirty="0">
                 <a:solidFill>
                   <a:prstClr val="black"/>
                 </a:solidFill>
                 <a:latin typeface="Ramabhadra" panose="02000600000000000000" pitchFamily="2" charset="0"/>
                 <a:cs typeface="Ramabhadra" panose="02000600000000000000" pitchFamily="2" charset="0"/>
               </a:rPr>
-              <a:t>  నేనేది పలికినను ఏమి చేసినను</a:t>
+              <a:t>చేయి విడువడు (3)</a:t>
             </a:r>
           </a:p>
           <a:p>
             <a:pPr algn="ctr" defTabSz="439781"/>
             <a:r>
-              <a:rPr lang="te-IN" sz="1700" dirty="0">
+              <a:rPr lang="te-IN" sz="2000" dirty="0">
                 <a:solidFill>
                   <a:prstClr val="black"/>
                 </a:solidFill>
                 <a:latin typeface="Ramabhadra" panose="02000600000000000000" pitchFamily="2" charset="0"/>
                 <a:cs typeface="Ramabhadra" panose="02000600000000000000" pitchFamily="2" charset="0"/>
               </a:rPr>
-              <a:t>  నీ ప్రేమనే కనుపరుతును</a:t>
+              <a:t>యేసు చేయి విడువడు</a:t>
             </a:r>
           </a:p>
           <a:p>
             <a:pPr algn="ctr" defTabSz="439781"/>
-            <a:r>
-              <a:rPr lang="te-IN" sz="1700" dirty="0">
-                <a:solidFill>
-                  <a:prstClr val="black"/>
-                </a:solidFill>
-                <a:latin typeface="Ramabhadra" panose="02000600000000000000" pitchFamily="2" charset="0"/>
-                <a:cs typeface="Ramabhadra" panose="02000600000000000000" pitchFamily="2" charset="0"/>
-              </a:rPr>
-              <a:t>  నీ శక్తినే కొనియాడేదను</a:t>
-            </a:r>
-          </a:p>
-          <a:p>
-            <a:pPr algn="ctr" defTabSz="439781"/>
-            <a:endParaRPr lang="te-IN" sz="1700" dirty="0">
+            <a:endParaRPr lang="te-IN" sz="2000" dirty="0">
               <a:solidFill>
                 <a:prstClr val="black"/>
               </a:solidFill>
@@ -3658,97 +3645,16 @@
           <a:p>
             <a:pPr algn="ctr" defTabSz="439781"/>
             <a:r>
-              <a:rPr lang="te-IN" dirty="0">
+              <a:rPr lang="te-IN" sz="2000" dirty="0">
                 <a:solidFill>
                   <a:prstClr val="black"/>
                 </a:solidFill>
                 <a:latin typeface="Ramabhadra" panose="02000600000000000000" pitchFamily="2" charset="0"/>
                 <a:cs typeface="Ramabhadra" panose="02000600000000000000" pitchFamily="2" charset="0"/>
               </a:rPr>
-              <a:t>నా హృదిలో</a:t>
-            </a:r>
-          </a:p>
-          <a:p>
-            <a:pPr algn="ctr" defTabSz="439781"/>
-            <a:r>
-              <a:rPr lang="te-IN" dirty="0">
-                <a:solidFill>
-                  <a:prstClr val="black"/>
-                </a:solidFill>
-                <a:latin typeface="Ramabhadra" panose="02000600000000000000" pitchFamily="2" charset="0"/>
-                <a:cs typeface="Ramabhadra" panose="02000600000000000000" pitchFamily="2" charset="0"/>
-              </a:rPr>
-              <a:t>నీ వాక్యము నివసింపని</a:t>
-            </a:r>
-          </a:p>
-          <a:p>
-            <a:pPr algn="ctr" defTabSz="439781"/>
-            <a:r>
-              <a:rPr lang="te-IN" dirty="0">
-                <a:solidFill>
-                  <a:prstClr val="black"/>
-                </a:solidFill>
-                <a:latin typeface="Ramabhadra" panose="02000600000000000000" pitchFamily="2" charset="0"/>
-                <a:cs typeface="Ramabhadra" panose="02000600000000000000" pitchFamily="2" charset="0"/>
-              </a:rPr>
-              <a:t>ప్రతిక్షణము ప్రతిదినము ధ్యానింతును </a:t>
-            </a:r>
-          </a:p>
-          <a:p>
-            <a:pPr algn="ctr" defTabSz="439781"/>
-            <a:r>
-              <a:rPr lang="te-IN" dirty="0">
-                <a:solidFill>
-                  <a:prstClr val="black"/>
-                </a:solidFill>
-                <a:latin typeface="Ramabhadra" panose="02000600000000000000" pitchFamily="2" charset="0"/>
-                <a:cs typeface="Ramabhadra" panose="02000600000000000000" pitchFamily="2" charset="0"/>
-              </a:rPr>
-              <a:t>లోకము నను విడచిన</a:t>
-            </a:r>
-          </a:p>
-          <a:p>
-            <a:pPr algn="ctr" defTabSz="439781"/>
-            <a:r>
-              <a:rPr lang="te-IN" dirty="0">
-                <a:solidFill>
-                  <a:prstClr val="black"/>
-                </a:solidFill>
-                <a:latin typeface="Ramabhadra" panose="02000600000000000000" pitchFamily="2" charset="0"/>
-                <a:cs typeface="Ramabhadra" panose="02000600000000000000" pitchFamily="2" charset="0"/>
-              </a:rPr>
-              <a:t>నీవు విడువలేదు    </a:t>
-            </a:r>
-          </a:p>
-          <a:p>
-            <a:pPr algn="ctr" defTabSz="439781"/>
-            <a:r>
-              <a:rPr lang="te-IN" dirty="0">
-                <a:solidFill>
-                  <a:prstClr val="black"/>
-                </a:solidFill>
-                <a:latin typeface="Ramabhadra" panose="02000600000000000000" pitchFamily="2" charset="0"/>
-                <a:cs typeface="Ramabhadra" panose="02000600000000000000" pitchFamily="2" charset="0"/>
-              </a:rPr>
-              <a:t>   నాకు జయము జయము</a:t>
-            </a:r>
-          </a:p>
-          <a:p>
-            <a:pPr algn="ctr" defTabSz="439781"/>
-            <a:r>
-              <a:rPr lang="te-IN" dirty="0">
-                <a:solidFill>
-                  <a:prstClr val="black"/>
-                </a:solidFill>
-                <a:latin typeface="Ramabhadra" panose="02000600000000000000" pitchFamily="2" charset="0"/>
-                <a:cs typeface="Ramabhadra" panose="02000600000000000000" pitchFamily="2" charset="0"/>
-              </a:rPr>
-              <a:t>నీ శక్తితోనే</a:t>
-            </a:r>
-          </a:p>
-          <a:p>
-            <a:pPr algn="ctr" defTabSz="439781"/>
-            <a:endParaRPr lang="te-IN" dirty="0">
+              <a:t>తల్లి ఆయనే</a:t>
+            </a:r>
+            <a:endParaRPr lang="en-IN" sz="2000" dirty="0">
               <a:solidFill>
                 <a:prstClr val="black"/>
               </a:solidFill>
@@ -3759,93 +3665,227 @@
           <a:p>
             <a:pPr algn="ctr" defTabSz="439781"/>
             <a:r>
-              <a:rPr lang="te-IN" dirty="0">
+              <a:rPr lang="te-IN" sz="2000" dirty="0">
                 <a:solidFill>
                   <a:prstClr val="black"/>
                 </a:solidFill>
                 <a:latin typeface="Ramabhadra" panose="02000600000000000000" pitchFamily="2" charset="0"/>
                 <a:cs typeface="Ramabhadra" panose="02000600000000000000" pitchFamily="2" charset="0"/>
               </a:rPr>
-              <a:t>నా తండ్రి నా విభుడా</a:t>
+              <a:t>తండ్రి ఆయనే (2)</a:t>
             </a:r>
           </a:p>
           <a:p>
             <a:pPr algn="ctr" defTabSz="439781"/>
             <a:r>
-              <a:rPr lang="te-IN" dirty="0">
+              <a:rPr lang="te-IN" sz="2000" dirty="0">
                 <a:solidFill>
                   <a:prstClr val="black"/>
                 </a:solidFill>
                 <a:latin typeface="Ramabhadra" panose="02000600000000000000" pitchFamily="2" charset="0"/>
                 <a:cs typeface="Ramabhadra" panose="02000600000000000000" pitchFamily="2" charset="0"/>
               </a:rPr>
-              <a:t>పాలించుమా</a:t>
-            </a:r>
+              <a:t>లాలించును</a:t>
+            </a:r>
+            <a:endParaRPr lang="en-IN" sz="2000" dirty="0">
+              <a:solidFill>
+                <a:prstClr val="black"/>
+              </a:solidFill>
+              <a:latin typeface="Ramabhadra" panose="02000600000000000000" pitchFamily="2" charset="0"/>
+              <a:cs typeface="Ramabhadra" panose="02000600000000000000" pitchFamily="2" charset="0"/>
+            </a:endParaRPr>
           </a:p>
           <a:p>
             <a:pPr algn="ctr" defTabSz="439781"/>
             <a:r>
-              <a:rPr lang="te-IN" dirty="0">
+              <a:rPr lang="te-IN" sz="2000" dirty="0">
                 <a:solidFill>
                   <a:prstClr val="black"/>
                 </a:solidFill>
                 <a:latin typeface="Ramabhadra" panose="02000600000000000000" pitchFamily="2" charset="0"/>
                 <a:cs typeface="Ramabhadra" panose="02000600000000000000" pitchFamily="2" charset="0"/>
               </a:rPr>
-              <a:t>  ఆదరణ నా హృదిలోనా నింపుమయా </a:t>
+              <a:t>నన్ను పాలించును (2)</a:t>
             </a:r>
           </a:p>
           <a:p>
             <a:pPr algn="ctr" defTabSz="439781"/>
-            <a:r>
-              <a:rPr lang="te-IN" dirty="0">
+            <a:endParaRPr lang="te-IN" sz="2000" dirty="0">
+              <a:solidFill>
+                <a:prstClr val="black"/>
+              </a:solidFill>
+              <a:latin typeface="Ramabhadra" panose="02000600000000000000" pitchFamily="2" charset="0"/>
+              <a:cs typeface="Ramabhadra" panose="02000600000000000000" pitchFamily="2" charset="0"/>
+            </a:endParaRPr>
+          </a:p>
+          <a:p>
+            <a:pPr algn="ctr" defTabSz="439781"/>
+            <a:r>
+              <a:rPr lang="te-IN" sz="2000" dirty="0">
                 <a:solidFill>
                   <a:prstClr val="black"/>
                 </a:solidFill>
                 <a:latin typeface="Ramabhadra" panose="02000600000000000000" pitchFamily="2" charset="0"/>
                 <a:cs typeface="Ramabhadra" panose="02000600000000000000" pitchFamily="2" charset="0"/>
               </a:rPr>
-              <a:t>మనుజులు నను మరిచిన</a:t>
-            </a:r>
+              <a:t>వేదన శ్రమలూ</a:t>
+            </a:r>
+            <a:endParaRPr lang="en-IN" sz="2000" dirty="0">
+              <a:solidFill>
+                <a:prstClr val="black"/>
+              </a:solidFill>
+              <a:latin typeface="Ramabhadra" panose="02000600000000000000" pitchFamily="2" charset="0"/>
+              <a:cs typeface="Ramabhadra" panose="02000600000000000000" pitchFamily="2" charset="0"/>
+            </a:endParaRPr>
           </a:p>
           <a:p>
             <a:pPr algn="ctr" defTabSz="439781"/>
             <a:r>
-              <a:rPr lang="te-IN" dirty="0">
+              <a:rPr lang="te-IN" sz="2000" dirty="0">
                 <a:solidFill>
                   <a:prstClr val="black"/>
                 </a:solidFill>
                 <a:latin typeface="Ramabhadra" panose="02000600000000000000" pitchFamily="2" charset="0"/>
                 <a:cs typeface="Ramabhadra" panose="02000600000000000000" pitchFamily="2" charset="0"/>
               </a:rPr>
-              <a:t>నీవు మరువలేదు </a:t>
+              <a:t>ఉన్నప్పుడల్లా (2)</a:t>
             </a:r>
           </a:p>
           <a:p>
             <a:pPr algn="ctr" defTabSz="439781"/>
             <a:r>
-              <a:rPr lang="te-IN" dirty="0">
+              <a:rPr lang="te-IN" sz="2000" dirty="0">
                 <a:solidFill>
                   <a:prstClr val="black"/>
                 </a:solidFill>
                 <a:latin typeface="Ramabhadra" panose="02000600000000000000" pitchFamily="2" charset="0"/>
                 <a:cs typeface="Ramabhadra" panose="02000600000000000000" pitchFamily="2" charset="0"/>
               </a:rPr>
-              <a:t>  నాకు జయము జయము</a:t>
-            </a:r>
+              <a:t>వేడుకొందునే </a:t>
+            </a:r>
+            <a:endParaRPr lang="en-IN" sz="2000" dirty="0">
+              <a:solidFill>
+                <a:prstClr val="black"/>
+              </a:solidFill>
+              <a:latin typeface="Ramabhadra" panose="02000600000000000000" pitchFamily="2" charset="0"/>
+              <a:cs typeface="Ramabhadra" panose="02000600000000000000" pitchFamily="2" charset="0"/>
+            </a:endParaRPr>
           </a:p>
           <a:p>
             <a:pPr algn="ctr" defTabSz="439781"/>
             <a:r>
-              <a:rPr lang="te-IN" dirty="0">
+              <a:rPr lang="te-IN" sz="2000" dirty="0">
                 <a:solidFill>
                   <a:prstClr val="black"/>
                 </a:solidFill>
                 <a:latin typeface="Ramabhadra" panose="02000600000000000000" pitchFamily="2" charset="0"/>
                 <a:cs typeface="Ramabhadra" panose="02000600000000000000" pitchFamily="2" charset="0"/>
               </a:rPr>
-              <a:t>నీ ప్రేమతోనే</a:t>
-            </a:r>
+              <a:t>కాపాడును (2)</a:t>
+            </a:r>
+          </a:p>
+          <a:p>
+            <a:pPr algn="ctr" defTabSz="439781"/>
+            <a:endParaRPr lang="te-IN" sz="2000" dirty="0">
+              <a:solidFill>
+                <a:prstClr val="black"/>
+              </a:solidFill>
+              <a:latin typeface="Ramabhadra" panose="02000600000000000000" pitchFamily="2" charset="0"/>
+              <a:cs typeface="Ramabhadra" panose="02000600000000000000" pitchFamily="2" charset="0"/>
+            </a:endParaRPr>
+          </a:p>
+          <a:p>
+            <a:pPr algn="ctr" defTabSz="439781"/>
+            <a:r>
+              <a:rPr lang="te-IN" sz="2000" dirty="0">
+                <a:solidFill>
+                  <a:prstClr val="black"/>
+                </a:solidFill>
+                <a:latin typeface="Ramabhadra" panose="02000600000000000000" pitchFamily="2" charset="0"/>
+                <a:cs typeface="Ramabhadra" panose="02000600000000000000" pitchFamily="2" charset="0"/>
+              </a:rPr>
+              <a:t>రక్తముతో</a:t>
+            </a:r>
+            <a:endParaRPr lang="en-IN" sz="2000" dirty="0">
+              <a:solidFill>
+                <a:prstClr val="black"/>
+              </a:solidFill>
+              <a:latin typeface="Ramabhadra" panose="02000600000000000000" pitchFamily="2" charset="0"/>
+              <a:cs typeface="Ramabhadra" panose="02000600000000000000" pitchFamily="2" charset="0"/>
+            </a:endParaRPr>
+          </a:p>
+          <a:p>
+            <a:pPr algn="ctr" defTabSz="439781"/>
+            <a:r>
+              <a:rPr lang="te-IN" sz="2000" dirty="0">
+                <a:solidFill>
+                  <a:prstClr val="black"/>
+                </a:solidFill>
+                <a:latin typeface="Ramabhadra" panose="02000600000000000000" pitchFamily="2" charset="0"/>
+                <a:cs typeface="Ramabhadra" panose="02000600000000000000" pitchFamily="2" charset="0"/>
+              </a:rPr>
+              <a:t>కడిగి</a:t>
+            </a:r>
+            <a:r>
+              <a:rPr lang="en-IN" sz="2000" dirty="0">
+                <a:solidFill>
+                  <a:prstClr val="black"/>
+                </a:solidFill>
+                <a:latin typeface="Ramabhadra" panose="02000600000000000000" pitchFamily="2" charset="0"/>
+                <a:cs typeface="Ramabhadra" panose="02000600000000000000" pitchFamily="2" charset="0"/>
+              </a:rPr>
+              <a:t> </a:t>
+            </a:r>
+            <a:r>
+              <a:rPr lang="te-IN" sz="2000" dirty="0">
+                <a:solidFill>
+                  <a:prstClr val="black"/>
+                </a:solidFill>
+                <a:latin typeface="Ramabhadra" panose="02000600000000000000" pitchFamily="2" charset="0"/>
+                <a:cs typeface="Ramabhadra" panose="02000600000000000000" pitchFamily="2" charset="0"/>
+              </a:rPr>
+              <a:t>వేసాడే (2)</a:t>
+            </a:r>
+          </a:p>
+          <a:p>
+            <a:pPr algn="ctr" defTabSz="439781"/>
+            <a:r>
+              <a:rPr lang="te-IN" sz="2000" dirty="0">
+                <a:solidFill>
+                  <a:prstClr val="black"/>
+                </a:solidFill>
+                <a:latin typeface="Ramabhadra" panose="02000600000000000000" pitchFamily="2" charset="0"/>
+                <a:cs typeface="Ramabhadra" panose="02000600000000000000" pitchFamily="2" charset="0"/>
+              </a:rPr>
+              <a:t>రక్షణ సంతోషం</a:t>
+            </a:r>
+            <a:endParaRPr lang="en-IN" sz="2000" dirty="0">
+              <a:solidFill>
+                <a:prstClr val="black"/>
+              </a:solidFill>
+              <a:latin typeface="Ramabhadra" panose="02000600000000000000" pitchFamily="2" charset="0"/>
+              <a:cs typeface="Ramabhadra" panose="02000600000000000000" pitchFamily="2" charset="0"/>
+            </a:endParaRPr>
+          </a:p>
+          <a:p>
+            <a:pPr algn="ctr" defTabSz="439781"/>
+            <a:r>
+              <a:rPr lang="te-IN" sz="2000" dirty="0">
+                <a:solidFill>
+                  <a:prstClr val="black"/>
+                </a:solidFill>
+                <a:latin typeface="Ramabhadra" panose="02000600000000000000" pitchFamily="2" charset="0"/>
+                <a:cs typeface="Ramabhadra" panose="02000600000000000000" pitchFamily="2" charset="0"/>
+              </a:rPr>
+              <a:t>నాకు ఇచ్చాడే (2)</a:t>
+            </a:r>
+            <a:endParaRPr lang="en-IN" sz="2000" dirty="0">
+              <a:solidFill>
+                <a:prstClr val="black"/>
+              </a:solidFill>
+              <a:latin typeface="Ramabhadra" panose="02000600000000000000" pitchFamily="2" charset="0"/>
+              <a:cs typeface="Ramabhadra" panose="02000600000000000000" pitchFamily="2" charset="0"/>
+            </a:endParaRPr>
           </a:p>
         </p:txBody>
       </p:sp>
@@ -3902,45 +3942,42 @@
           <a:p>
             <a:pPr algn="ctr"/>
             <a:r>
-              <a:rPr lang="te-IN" sz="2000" dirty="0">
+              <a:rPr lang="te-IN" sz="1600" dirty="0">
                 <a:solidFill>
                   <a:schemeClr val="tx1"/>
                 </a:solidFill>
                 <a:latin typeface="Ramabhadra" panose="02000600000000000000" pitchFamily="2" charset="0"/>
                 <a:cs typeface="Ramabhadra" panose="02000600000000000000" pitchFamily="2" charset="0"/>
               </a:rPr>
-              <a:t>పాడెద నేనొక నూతన గీతం - పాడెద మనసారా</a:t>
-            </a:r>
-          </a:p>
-          <a:p>
-            <a:pPr algn="ctr"/>
-            <a:r>
-              <a:rPr lang="te-IN" sz="2000" dirty="0">
+              <a:t>నీతో గడిపే ప్రతి క్షణము</a:t>
+            </a:r>
+          </a:p>
+          <a:p>
+            <a:pPr algn="ctr"/>
+            <a:r>
+              <a:rPr lang="te-IN" sz="1600" dirty="0">
                 <a:solidFill>
                   <a:schemeClr val="tx1"/>
                 </a:solidFill>
                 <a:latin typeface="Ramabhadra" panose="02000600000000000000" pitchFamily="2" charset="0"/>
                 <a:cs typeface="Ramabhadra" panose="02000600000000000000" pitchFamily="2" charset="0"/>
               </a:rPr>
-              <a:t>యేసయ్యా నీ నామమే గాక వేరొక నామము</a:t>
-            </a:r>
-          </a:p>
-          <a:p>
-            <a:pPr algn="ctr"/>
-            <a:r>
-              <a:rPr lang="te-IN" sz="2000" dirty="0">
+              <a:t>ఆనంద బాష్పాలు ఆగవయ్యా (2)</a:t>
+            </a:r>
+          </a:p>
+          <a:p>
+            <a:pPr algn="ctr"/>
+            <a:r>
+              <a:rPr lang="te-IN" sz="1600" dirty="0">
                 <a:solidFill>
                   <a:schemeClr val="tx1"/>
                 </a:solidFill>
                 <a:latin typeface="Ramabhadra" panose="02000600000000000000" pitchFamily="2" charset="0"/>
                 <a:cs typeface="Ramabhadra" panose="02000600000000000000" pitchFamily="2" charset="0"/>
               </a:rPr>
-              <a:t>లేదాయే (2)</a:t>
-            </a:r>
-          </a:p>
-          <a:p>
-            <a:pPr algn="ctr"/>
-            <a:endParaRPr lang="te-IN" sz="2000" dirty="0">
+              <a:t>కృప తలంచగా</a:t>
+            </a:r>
+            <a:endParaRPr lang="en-IN" sz="1600" dirty="0">
               <a:solidFill>
                 <a:schemeClr val="tx1"/>
               </a:solidFill>
@@ -3951,45 +3988,29 @@
           <a:p>
             <a:pPr algn="ctr"/>
             <a:r>
-              <a:rPr lang="te-IN" sz="2000" dirty="0">
+              <a:rPr lang="te-IN" sz="1600" dirty="0">
                 <a:solidFill>
                   <a:schemeClr val="tx1"/>
                 </a:solidFill>
                 <a:latin typeface="Ramabhadra" panose="02000600000000000000" pitchFamily="2" charset="0"/>
                 <a:cs typeface="Ramabhadra" panose="02000600000000000000" pitchFamily="2" charset="0"/>
               </a:rPr>
-              <a:t>కలుషితమైన నదియై నేను - కడలియైన నీలో (2)</a:t>
-            </a:r>
-          </a:p>
-          <a:p>
-            <a:pPr algn="ctr"/>
-            <a:r>
-              <a:rPr lang="te-IN" sz="2000" dirty="0">
+              <a:t>మేళ్లు యోచించగా (2)</a:t>
+            </a:r>
+          </a:p>
+          <a:p>
+            <a:pPr algn="ctr"/>
+            <a:r>
+              <a:rPr lang="te-IN" sz="1600" dirty="0">
                 <a:solidFill>
                   <a:schemeClr val="tx1"/>
                 </a:solidFill>
                 <a:latin typeface="Ramabhadra" panose="02000600000000000000" pitchFamily="2" charset="0"/>
                 <a:cs typeface="Ramabhadra" panose="02000600000000000000" pitchFamily="2" charset="0"/>
               </a:rPr>
-              <a:t>కలిసిపోతినే కలువరి దారిలో కనబడదే</a:t>
-            </a:r>
-          </a:p>
-          <a:p>
-            <a:pPr algn="ctr"/>
-            <a:r>
-              <a:rPr lang="te-IN" sz="2000" dirty="0">
-                <a:solidFill>
-                  <a:schemeClr val="tx1"/>
-                </a:solidFill>
-                <a:latin typeface="Ramabhadra" panose="02000600000000000000" pitchFamily="2" charset="0"/>
-                <a:cs typeface="Ramabhadra" panose="02000600000000000000" pitchFamily="2" charset="0"/>
-              </a:rPr>
-              <a:t>ఇక పాపాలరాశి (2)</a:t>
-            </a:r>
-          </a:p>
-          <a:p>
-            <a:pPr algn="ctr"/>
-            <a:endParaRPr lang="te-IN" sz="2000" dirty="0">
+              <a:t>నా గలమాగదు స్తుతించక –</a:t>
+            </a:r>
+            <a:endParaRPr lang="en-IN" sz="1600" dirty="0">
               <a:solidFill>
                 <a:schemeClr val="tx1"/>
               </a:solidFill>
@@ -4000,53 +4021,263 @@
           <a:p>
             <a:pPr algn="ctr"/>
             <a:r>
-              <a:rPr lang="te-IN" sz="2000" dirty="0">
+              <a:rPr lang="te-IN" sz="1600" dirty="0">
                 <a:solidFill>
                   <a:schemeClr val="tx1"/>
                 </a:solidFill>
                 <a:latin typeface="Ramabhadra" panose="02000600000000000000" pitchFamily="2" charset="0"/>
                 <a:cs typeface="Ramabhadra" panose="02000600000000000000" pitchFamily="2" charset="0"/>
               </a:rPr>
-              <a:t>పోరు తరగని సిగ సెగలన్నియు – </a:t>
-            </a:r>
-          </a:p>
-          <a:p>
-            <a:pPr algn="ctr"/>
-            <a:r>
-              <a:rPr lang="te-IN" sz="2000" dirty="0">
+              <a:t>నిను కీర్తించక</a:t>
+            </a:r>
+          </a:p>
+          <a:p>
+            <a:pPr algn="ctr"/>
+            <a:r>
+              <a:rPr lang="te-IN" sz="1600" dirty="0">
                 <a:solidFill>
                   <a:schemeClr val="tx1"/>
                 </a:solidFill>
                 <a:latin typeface="Ramabhadra" panose="02000600000000000000" pitchFamily="2" charset="0"/>
                 <a:cs typeface="Ramabhadra" panose="02000600000000000000" pitchFamily="2" charset="0"/>
               </a:rPr>
-              <a:t>అణచె కృపాతిశయము (2)</a:t>
-            </a:r>
-          </a:p>
-          <a:p>
-            <a:pPr algn="ctr"/>
-            <a:r>
-              <a:rPr lang="te-IN" sz="2000" dirty="0">
+              <a:t>యేసయ్యా యేసయ్యా –</a:t>
+            </a:r>
+            <a:endParaRPr lang="en-IN" sz="1600" dirty="0">
+              <a:solidFill>
+                <a:schemeClr val="tx1"/>
+              </a:solidFill>
+              <a:latin typeface="Ramabhadra" panose="02000600000000000000" pitchFamily="2" charset="0"/>
+              <a:cs typeface="Ramabhadra" panose="02000600000000000000" pitchFamily="2" charset="0"/>
+            </a:endParaRPr>
+          </a:p>
+          <a:p>
+            <a:pPr algn="ctr"/>
+            <a:r>
+              <a:rPr lang="te-IN" sz="1600" dirty="0">
                 <a:solidFill>
                   <a:schemeClr val="tx1"/>
                 </a:solidFill>
                 <a:latin typeface="Ramabhadra" panose="02000600000000000000" pitchFamily="2" charset="0"/>
                 <a:cs typeface="Ramabhadra" panose="02000600000000000000" pitchFamily="2" charset="0"/>
               </a:rPr>
-              <a:t>కొదువైన నా హృదయములోన</a:t>
-            </a:r>
-          </a:p>
-          <a:p>
-            <a:pPr algn="ctr"/>
-            <a:r>
-              <a:rPr lang="te-IN" sz="2000" dirty="0">
+              <a:t>నా యేసయ్యా (4)</a:t>
+            </a:r>
+          </a:p>
+          <a:p>
+            <a:pPr algn="ctr"/>
+            <a:endParaRPr lang="te-IN" sz="1600" dirty="0">
+              <a:solidFill>
+                <a:schemeClr val="tx1"/>
+              </a:solidFill>
+              <a:latin typeface="Ramabhadra" panose="02000600000000000000" pitchFamily="2" charset="0"/>
+              <a:cs typeface="Ramabhadra" panose="02000600000000000000" pitchFamily="2" charset="0"/>
+            </a:endParaRPr>
+          </a:p>
+          <a:p>
+            <a:pPr algn="ctr"/>
+            <a:r>
+              <a:rPr lang="te-IN" sz="1600" dirty="0">
                 <a:solidFill>
                   <a:schemeClr val="tx1"/>
                 </a:solidFill>
                 <a:latin typeface="Ramabhadra" panose="02000600000000000000" pitchFamily="2" charset="0"/>
                 <a:cs typeface="Ramabhadra" panose="02000600000000000000" pitchFamily="2" charset="0"/>
               </a:rPr>
-              <a:t>పొంగెనే అభిషేకతైలం (2)</a:t>
+              <a:t>మారా వంటి నా జీవితాన్ని</a:t>
+            </a:r>
+          </a:p>
+          <a:p>
+            <a:pPr algn="ctr"/>
+            <a:r>
+              <a:rPr lang="te-IN" sz="1600" dirty="0">
+                <a:solidFill>
+                  <a:schemeClr val="tx1"/>
+                </a:solidFill>
+                <a:latin typeface="Ramabhadra" panose="02000600000000000000" pitchFamily="2" charset="0"/>
+                <a:cs typeface="Ramabhadra" panose="02000600000000000000" pitchFamily="2" charset="0"/>
+              </a:rPr>
+              <a:t>మధురముగా మార్చి</a:t>
+            </a:r>
+            <a:endParaRPr lang="en-IN" sz="1600" dirty="0">
+              <a:solidFill>
+                <a:schemeClr val="tx1"/>
+              </a:solidFill>
+              <a:latin typeface="Ramabhadra" panose="02000600000000000000" pitchFamily="2" charset="0"/>
+              <a:cs typeface="Ramabhadra" panose="02000600000000000000" pitchFamily="2" charset="0"/>
+            </a:endParaRPr>
+          </a:p>
+          <a:p>
+            <a:pPr algn="ctr"/>
+            <a:r>
+              <a:rPr lang="te-IN" sz="1600" dirty="0">
+                <a:solidFill>
+                  <a:schemeClr val="tx1"/>
+                </a:solidFill>
+                <a:latin typeface="Ramabhadra" panose="02000600000000000000" pitchFamily="2" charset="0"/>
+                <a:cs typeface="Ramabhadra" panose="02000600000000000000" pitchFamily="2" charset="0"/>
+              </a:rPr>
+              <a:t>ఘనపరచినావు (2)</a:t>
+            </a:r>
+          </a:p>
+          <a:p>
+            <a:pPr algn="ctr"/>
+            <a:r>
+              <a:rPr lang="te-IN" sz="1600" dirty="0">
+                <a:solidFill>
+                  <a:schemeClr val="tx1"/>
+                </a:solidFill>
+                <a:latin typeface="Ramabhadra" panose="02000600000000000000" pitchFamily="2" charset="0"/>
+                <a:cs typeface="Ramabhadra" panose="02000600000000000000" pitchFamily="2" charset="0"/>
+              </a:rPr>
+              <a:t>నా ప్రేమ చేత కాదు</a:t>
+            </a:r>
+          </a:p>
+          <a:p>
+            <a:pPr algn="ctr"/>
+            <a:r>
+              <a:rPr lang="te-IN" sz="1600" dirty="0">
+                <a:solidFill>
+                  <a:schemeClr val="tx1"/>
+                </a:solidFill>
+                <a:latin typeface="Ramabhadra" panose="02000600000000000000" pitchFamily="2" charset="0"/>
+                <a:cs typeface="Ramabhadra" panose="02000600000000000000" pitchFamily="2" charset="0"/>
+              </a:rPr>
+              <a:t>నీవే నను ప్రేమించి (2)</a:t>
+            </a:r>
+          </a:p>
+          <a:p>
+            <a:pPr algn="ctr"/>
+            <a:r>
+              <a:rPr lang="te-IN" sz="1600" dirty="0">
+                <a:solidFill>
+                  <a:schemeClr val="tx1"/>
+                </a:solidFill>
+                <a:latin typeface="Ramabhadra" panose="02000600000000000000" pitchFamily="2" charset="0"/>
+                <a:cs typeface="Ramabhadra" panose="02000600000000000000" pitchFamily="2" charset="0"/>
+              </a:rPr>
+              <a:t>రక్తాన్ని చిందించి</a:t>
+            </a:r>
+          </a:p>
+          <a:p>
+            <a:pPr algn="ctr"/>
+            <a:r>
+              <a:rPr lang="te-IN" sz="1600" dirty="0">
+                <a:solidFill>
+                  <a:schemeClr val="tx1"/>
+                </a:solidFill>
+                <a:latin typeface="Ramabhadra" panose="02000600000000000000" pitchFamily="2" charset="0"/>
+                <a:cs typeface="Ramabhadra" panose="02000600000000000000" pitchFamily="2" charset="0"/>
+              </a:rPr>
+              <a:t>నన్ను రక్షించావు (2)</a:t>
+            </a:r>
+          </a:p>
+          <a:p>
+            <a:pPr algn="ctr"/>
+            <a:endParaRPr lang="te-IN" sz="1600" dirty="0">
+              <a:solidFill>
+                <a:schemeClr val="tx1"/>
+              </a:solidFill>
+              <a:latin typeface="Ramabhadra" panose="02000600000000000000" pitchFamily="2" charset="0"/>
+              <a:cs typeface="Ramabhadra" panose="02000600000000000000" pitchFamily="2" charset="0"/>
+            </a:endParaRPr>
+          </a:p>
+          <a:p>
+            <a:pPr algn="ctr"/>
+            <a:r>
+              <a:rPr lang="te-IN" sz="1600" dirty="0">
+                <a:solidFill>
+                  <a:schemeClr val="tx1"/>
+                </a:solidFill>
+                <a:latin typeface="Ramabhadra" panose="02000600000000000000" pitchFamily="2" charset="0"/>
+                <a:cs typeface="Ramabhadra" panose="02000600000000000000" pitchFamily="2" charset="0"/>
+              </a:rPr>
+              <a:t>గమ్యమే లేని ఓ బాటసారిని</a:t>
+            </a:r>
+          </a:p>
+          <a:p>
+            <a:pPr algn="ctr"/>
+            <a:r>
+              <a:rPr lang="te-IN" sz="1600" dirty="0">
+                <a:solidFill>
+                  <a:schemeClr val="tx1"/>
+                </a:solidFill>
+                <a:latin typeface="Ramabhadra" panose="02000600000000000000" pitchFamily="2" charset="0"/>
+                <a:cs typeface="Ramabhadra" panose="02000600000000000000" pitchFamily="2" charset="0"/>
+              </a:rPr>
+              <a:t>నీతో ఉన్నాను</a:t>
+            </a:r>
+            <a:endParaRPr lang="en-IN" sz="1600" dirty="0">
+              <a:solidFill>
+                <a:schemeClr val="tx1"/>
+              </a:solidFill>
+              <a:latin typeface="Ramabhadra" panose="02000600000000000000" pitchFamily="2" charset="0"/>
+              <a:cs typeface="Ramabhadra" panose="02000600000000000000" pitchFamily="2" charset="0"/>
+            </a:endParaRPr>
+          </a:p>
+          <a:p>
+            <a:pPr algn="ctr"/>
+            <a:r>
+              <a:rPr lang="te-IN" sz="1600" dirty="0">
+                <a:solidFill>
+                  <a:schemeClr val="tx1"/>
+                </a:solidFill>
+                <a:latin typeface="Ramabhadra" panose="02000600000000000000" pitchFamily="2" charset="0"/>
+                <a:cs typeface="Ramabhadra" panose="02000600000000000000" pitchFamily="2" charset="0"/>
+              </a:rPr>
+              <a:t>భయము లేదన్నావు (2)</a:t>
+            </a:r>
+          </a:p>
+          <a:p>
+            <a:pPr algn="ctr"/>
+            <a:r>
+              <a:rPr lang="te-IN" sz="1600" dirty="0">
+                <a:solidFill>
+                  <a:schemeClr val="tx1"/>
+                </a:solidFill>
+                <a:latin typeface="Ramabhadra" panose="02000600000000000000" pitchFamily="2" charset="0"/>
+                <a:cs typeface="Ramabhadra" panose="02000600000000000000" pitchFamily="2" charset="0"/>
+              </a:rPr>
+              <a:t>నా శక్తి చేత కాదు</a:t>
+            </a:r>
+          </a:p>
+          <a:p>
+            <a:pPr algn="ctr"/>
+            <a:r>
+              <a:rPr lang="te-IN" sz="1600" dirty="0">
+                <a:solidFill>
+                  <a:schemeClr val="tx1"/>
+                </a:solidFill>
+                <a:latin typeface="Ramabhadra" panose="02000600000000000000" pitchFamily="2" charset="0"/>
+                <a:cs typeface="Ramabhadra" panose="02000600000000000000" pitchFamily="2" charset="0"/>
+              </a:rPr>
+              <a:t>నీ ఆత్మ ద్వారానే (2)</a:t>
+            </a:r>
+          </a:p>
+          <a:p>
+            <a:pPr algn="ctr"/>
+            <a:r>
+              <a:rPr lang="te-IN" sz="1600" dirty="0">
+                <a:solidFill>
+                  <a:schemeClr val="tx1"/>
+                </a:solidFill>
+                <a:latin typeface="Ramabhadra" panose="02000600000000000000" pitchFamily="2" charset="0"/>
+                <a:cs typeface="Ramabhadra" panose="02000600000000000000" pitchFamily="2" charset="0"/>
+              </a:rPr>
+              <a:t>వాగ్ధానము నెరవేర్చి</a:t>
+            </a:r>
+          </a:p>
+          <a:p>
+            <a:pPr algn="ctr"/>
+            <a:r>
+              <a:rPr lang="te-IN" sz="1600" dirty="0">
+                <a:solidFill>
+                  <a:schemeClr val="tx1"/>
+                </a:solidFill>
+                <a:latin typeface="Ramabhadra" panose="02000600000000000000" pitchFamily="2" charset="0"/>
+                <a:cs typeface="Ramabhadra" panose="02000600000000000000" pitchFamily="2" charset="0"/>
+              </a:rPr>
+              <a:t>వారసుని చేసావు (2)</a:t>
             </a:r>
           </a:p>
         </p:txBody>
@@ -4104,71 +4335,84 @@
           <a:p>
             <a:pPr algn="ctr"/>
             <a:r>
-              <a:rPr lang="te-IN" sz="2000" dirty="0">
+              <a:rPr lang="te-IN" dirty="0">
                 <a:solidFill>
                   <a:schemeClr val="tx1"/>
                 </a:solidFill>
                 <a:latin typeface="Ramabhadra" panose="02000600000000000000" pitchFamily="2" charset="0"/>
                 <a:cs typeface="Ramabhadra" panose="02000600000000000000" pitchFamily="2" charset="0"/>
               </a:rPr>
-              <a:t>స్తోత్రము చెల్లించెదము</a:t>
-            </a:r>
-          </a:p>
-          <a:p>
-            <a:pPr algn="ctr"/>
-            <a:r>
-              <a:rPr lang="te-IN" sz="2000" dirty="0">
+              <a:t>చాలిన దేవుడవు యేసు </a:t>
+            </a:r>
+          </a:p>
+          <a:p>
+            <a:pPr algn="ctr"/>
+            <a:r>
+              <a:rPr lang="te-IN" dirty="0">
                 <a:solidFill>
                   <a:schemeClr val="tx1"/>
                 </a:solidFill>
                 <a:latin typeface="Ramabhadra" panose="02000600000000000000" pitchFamily="2" charset="0"/>
                 <a:cs typeface="Ramabhadra" panose="02000600000000000000" pitchFamily="2" charset="0"/>
               </a:rPr>
-              <a:t>మన యేసుకే స్తోత్రము చెల్లించెదము</a:t>
-            </a:r>
-          </a:p>
-          <a:p>
-            <a:pPr algn="ctr"/>
-            <a:r>
-              <a:rPr lang="te-IN" sz="2000" dirty="0">
+              <a:t>చాలిన దేవుడ నీవు</a:t>
+            </a:r>
+          </a:p>
+          <a:p>
+            <a:pPr algn="ctr"/>
+            <a:r>
+              <a:rPr lang="te-IN" dirty="0">
                 <a:solidFill>
                   <a:schemeClr val="tx1"/>
                 </a:solidFill>
                 <a:latin typeface="Ramabhadra" panose="02000600000000000000" pitchFamily="2" charset="0"/>
                 <a:cs typeface="Ramabhadra" panose="02000600000000000000" pitchFamily="2" charset="0"/>
               </a:rPr>
-              <a:t>మంచివాడు గొప్పవాడు</a:t>
-            </a:r>
-          </a:p>
-          <a:p>
-            <a:pPr algn="ctr"/>
-            <a:r>
-              <a:rPr lang="te-IN" sz="2000" dirty="0">
+              <a:t>వ్యాధి బాధ సమయములో</a:t>
+            </a:r>
+          </a:p>
+          <a:p>
+            <a:pPr algn="ctr"/>
+            <a:r>
+              <a:rPr lang="te-IN" dirty="0">
                 <a:solidFill>
                   <a:schemeClr val="tx1"/>
                 </a:solidFill>
                 <a:latin typeface="Ramabhadra" panose="02000600000000000000" pitchFamily="2" charset="0"/>
                 <a:cs typeface="Ramabhadra" panose="02000600000000000000" pitchFamily="2" charset="0"/>
               </a:rPr>
-              <a:t>మన దేవుడు</a:t>
-            </a:r>
-          </a:p>
-          <a:p>
-            <a:pPr algn="ctr"/>
-            <a:r>
-              <a:rPr lang="te-IN" sz="2000" dirty="0">
+              <a:t> కష్టసుడుల తరంగములో</a:t>
+            </a:r>
+          </a:p>
+          <a:p>
+            <a:pPr algn="ctr"/>
+            <a:r>
+              <a:rPr lang="te-IN" dirty="0">
                 <a:solidFill>
                   <a:schemeClr val="tx1"/>
                 </a:solidFill>
                 <a:latin typeface="Ramabhadra" panose="02000600000000000000" pitchFamily="2" charset="0"/>
                 <a:cs typeface="Ramabhadra" panose="02000600000000000000" pitchFamily="2" charset="0"/>
               </a:rPr>
-              <a:t>వాక్యమునిచ్చు దేవుడు (2)</a:t>
-            </a:r>
-          </a:p>
-          <a:p>
-            <a:pPr algn="ctr"/>
-            <a:endParaRPr lang="te-IN" sz="2000" dirty="0">
+              <a:t>ఏమున్నా లేకున్నా ఏ స్ధితికైనా</a:t>
+            </a:r>
+          </a:p>
+          <a:p>
+            <a:pPr algn="ctr"/>
+            <a:r>
+              <a:rPr lang="te-IN" dirty="0">
+                <a:solidFill>
+                  <a:schemeClr val="tx1"/>
+                </a:solidFill>
+                <a:latin typeface="Ramabhadra" panose="02000600000000000000" pitchFamily="2" charset="0"/>
+                <a:cs typeface="Ramabhadra" panose="02000600000000000000" pitchFamily="2" charset="0"/>
+              </a:rPr>
+              <a:t> చాలిన దేవుడ నీవు</a:t>
+            </a:r>
+          </a:p>
+          <a:p>
+            <a:pPr algn="ctr"/>
+            <a:endParaRPr lang="te-IN" dirty="0">
               <a:solidFill>
                 <a:schemeClr val="tx1"/>
               </a:solidFill>
@@ -4179,45 +4423,55 @@
           <a:p>
             <a:pPr algn="ctr"/>
             <a:r>
-              <a:rPr lang="te-IN" sz="2000" dirty="0">
+              <a:rPr lang="te-IN" dirty="0">
                 <a:solidFill>
                   <a:schemeClr val="tx1"/>
                 </a:solidFill>
                 <a:latin typeface="Ramabhadra" panose="02000600000000000000" pitchFamily="2" charset="0"/>
                 <a:cs typeface="Ramabhadra" panose="02000600000000000000" pitchFamily="2" charset="0"/>
               </a:rPr>
-              <a:t>యెరికో మనకు ముందు వచ్చినా క్రీస్తు యేసు</a:t>
-            </a:r>
-          </a:p>
-          <a:p>
-            <a:pPr algn="ctr"/>
-            <a:r>
-              <a:rPr lang="te-IN" sz="2000" dirty="0">
+              <a:t>అంజూర చెట్లు పూయకున్నను</a:t>
+            </a:r>
+          </a:p>
+          <a:p>
+            <a:pPr algn="ctr"/>
+            <a:r>
+              <a:rPr lang="te-IN" dirty="0">
                 <a:solidFill>
                   <a:schemeClr val="tx1"/>
                 </a:solidFill>
                 <a:latin typeface="Ramabhadra" panose="02000600000000000000" pitchFamily="2" charset="0"/>
                 <a:cs typeface="Ramabhadra" panose="02000600000000000000" pitchFamily="2" charset="0"/>
               </a:rPr>
-              <a:t>ముందే నిలుచును</a:t>
-            </a:r>
-          </a:p>
-          <a:p>
-            <a:pPr algn="ctr"/>
-            <a:r>
-              <a:rPr lang="te-IN" sz="2000" dirty="0">
+              <a:t> ద్రాక్ష చెట్లు ఫలింపకున్నను</a:t>
+            </a:r>
+          </a:p>
+          <a:p>
+            <a:pPr algn="ctr"/>
+            <a:r>
+              <a:rPr lang="te-IN" dirty="0">
                 <a:solidFill>
                   <a:schemeClr val="tx1"/>
                 </a:solidFill>
                 <a:latin typeface="Ramabhadra" panose="02000600000000000000" pitchFamily="2" charset="0"/>
                 <a:cs typeface="Ramabhadra" panose="02000600000000000000" pitchFamily="2" charset="0"/>
               </a:rPr>
-              <a:t>భయపడకు దిగులు పడకు, ప్రార్ధించి స్తుతియించుము</a:t>
-            </a:r>
-          </a:p>
-          <a:p>
-            <a:pPr algn="ctr"/>
-            <a:endParaRPr lang="te-IN" sz="2000" dirty="0">
+              <a:t>చేనులోని పైరు పండకపోయినను</a:t>
+            </a:r>
+          </a:p>
+          <a:p>
+            <a:pPr algn="ctr"/>
+            <a:r>
+              <a:rPr lang="te-IN" dirty="0">
+                <a:solidFill>
+                  <a:schemeClr val="tx1"/>
+                </a:solidFill>
+                <a:latin typeface="Ramabhadra" panose="02000600000000000000" pitchFamily="2" charset="0"/>
+                <a:cs typeface="Ramabhadra" panose="02000600000000000000" pitchFamily="2" charset="0"/>
+              </a:rPr>
+              <a:t>శాలలోని పశువులు</a:t>
+            </a:r>
+            <a:endParaRPr lang="en-IN" dirty="0">
               <a:solidFill>
                 <a:schemeClr val="tx1"/>
               </a:solidFill>
@@ -4228,40 +4482,116 @@
           <a:p>
             <a:pPr algn="ctr"/>
             <a:r>
-              <a:rPr lang="te-IN" sz="2000" dirty="0">
+              <a:rPr lang="te-IN" dirty="0">
                 <a:solidFill>
                   <a:schemeClr val="tx1"/>
                 </a:solidFill>
                 <a:latin typeface="Ramabhadra" panose="02000600000000000000" pitchFamily="2" charset="0"/>
                 <a:cs typeface="Ramabhadra" panose="02000600000000000000" pitchFamily="2" charset="0"/>
               </a:rPr>
-              <a:t>గోలియాతు మనకు ఎదురు వచ్చినా క్రీస్తుయేసు</a:t>
-            </a:r>
-          </a:p>
-          <a:p>
-            <a:pPr algn="ctr"/>
-            <a:r>
-              <a:rPr lang="te-IN" sz="2000" dirty="0">
+              <a:t>లేక పోయినను</a:t>
+            </a:r>
+          </a:p>
+          <a:p>
+            <a:pPr algn="ctr"/>
+            <a:endParaRPr lang="te-IN" dirty="0">
+              <a:solidFill>
+                <a:schemeClr val="tx1"/>
+              </a:solidFill>
+              <a:latin typeface="Ramabhadra" panose="02000600000000000000" pitchFamily="2" charset="0"/>
+              <a:cs typeface="Ramabhadra" panose="02000600000000000000" pitchFamily="2" charset="0"/>
+            </a:endParaRPr>
+          </a:p>
+          <a:p>
+            <a:pPr algn="ctr"/>
+            <a:r>
+              <a:rPr lang="te-IN" dirty="0">
                 <a:solidFill>
                   <a:schemeClr val="tx1"/>
                 </a:solidFill>
                 <a:latin typeface="Ramabhadra" panose="02000600000000000000" pitchFamily="2" charset="0"/>
                 <a:cs typeface="Ramabhadra" panose="02000600000000000000" pitchFamily="2" charset="0"/>
               </a:rPr>
-              <a:t>ముందే నిలుచును</a:t>
-            </a:r>
-          </a:p>
-          <a:p>
-            <a:pPr algn="ctr"/>
-            <a:r>
-              <a:rPr lang="te-IN" sz="2000" dirty="0">
+              <a:t>గాఢాంధకారాన పయనించిన </a:t>
+            </a:r>
+          </a:p>
+          <a:p>
+            <a:pPr algn="ctr"/>
+            <a:r>
+              <a:rPr lang="te-IN" dirty="0">
                 <a:solidFill>
                   <a:schemeClr val="tx1"/>
                 </a:solidFill>
                 <a:latin typeface="Ramabhadra" panose="02000600000000000000" pitchFamily="2" charset="0"/>
                 <a:cs typeface="Ramabhadra" panose="02000600000000000000" pitchFamily="2" charset="0"/>
               </a:rPr>
-              <a:t>హల్లేలూయా-హల్లేలూయా జయమని పాడెదమూ</a:t>
+              <a:t>పొంగు సాగరా లెదురైన</a:t>
+            </a:r>
+          </a:p>
+          <a:p>
+            <a:pPr algn="ctr"/>
+            <a:r>
+              <a:rPr lang="te-IN" dirty="0">
+                <a:solidFill>
+                  <a:schemeClr val="tx1"/>
+                </a:solidFill>
+                <a:latin typeface="Ramabhadra" panose="02000600000000000000" pitchFamily="2" charset="0"/>
+                <a:cs typeface="Ramabhadra" panose="02000600000000000000" pitchFamily="2" charset="0"/>
+              </a:rPr>
+              <a:t>లోకమంత ఒకటైన</a:t>
+            </a:r>
+            <a:endParaRPr lang="en-IN" dirty="0">
+              <a:solidFill>
+                <a:schemeClr val="tx1"/>
+              </a:solidFill>
+              <a:latin typeface="Ramabhadra" panose="02000600000000000000" pitchFamily="2" charset="0"/>
+              <a:cs typeface="Ramabhadra" panose="02000600000000000000" pitchFamily="2" charset="0"/>
+            </a:endParaRPr>
+          </a:p>
+          <a:p>
+            <a:pPr algn="ctr"/>
+            <a:r>
+              <a:rPr lang="te-IN" dirty="0">
+                <a:solidFill>
+                  <a:schemeClr val="tx1"/>
+                </a:solidFill>
+                <a:latin typeface="Ramabhadra" panose="02000600000000000000" pitchFamily="2" charset="0"/>
+                <a:cs typeface="Ramabhadra" panose="02000600000000000000" pitchFamily="2" charset="0"/>
+              </a:rPr>
+              <a:t>అన్యాయ తీర్పుకు గురిచేసిన</a:t>
+            </a:r>
+          </a:p>
+          <a:p>
+            <a:pPr algn="ctr"/>
+            <a:r>
+              <a:rPr lang="te-IN" dirty="0">
+                <a:solidFill>
+                  <a:schemeClr val="tx1"/>
+                </a:solidFill>
+                <a:latin typeface="Ramabhadra" panose="02000600000000000000" pitchFamily="2" charset="0"/>
+                <a:cs typeface="Ramabhadra" panose="02000600000000000000" pitchFamily="2" charset="0"/>
+              </a:rPr>
+              <a:t>సత్యము పలుకుటచే</a:t>
+            </a:r>
+            <a:endParaRPr lang="en-IN" dirty="0">
+              <a:solidFill>
+                <a:schemeClr val="tx1"/>
+              </a:solidFill>
+              <a:latin typeface="Ramabhadra" panose="02000600000000000000" pitchFamily="2" charset="0"/>
+              <a:cs typeface="Ramabhadra" panose="02000600000000000000" pitchFamily="2" charset="0"/>
+            </a:endParaRPr>
+          </a:p>
+          <a:p>
+            <a:pPr algn="ctr"/>
+            <a:r>
+              <a:rPr lang="te-IN" dirty="0">
+                <a:solidFill>
+                  <a:schemeClr val="tx1"/>
+                </a:solidFill>
+                <a:latin typeface="Ramabhadra" panose="02000600000000000000" pitchFamily="2" charset="0"/>
+                <a:cs typeface="Ramabhadra" panose="02000600000000000000" pitchFamily="2" charset="0"/>
+              </a:rPr>
+              <a:t>నష్టము కలిగినను</a:t>
             </a:r>
           </a:p>
         </p:txBody>
@@ -4326,7 +4656,7 @@
                 <a:latin typeface="Ramabhadra" panose="02000600000000000000" pitchFamily="2" charset="0"/>
                 <a:cs typeface="Ramabhadra" panose="02000600000000000000" pitchFamily="2" charset="0"/>
               </a:rPr>
-              <a:t>నీవుంటే నాకు</a:t>
+              <a:t>పరమున ఆలయం నిరతం నీవేగా</a:t>
             </a:r>
           </a:p>
           <a:p>
@@ -4339,7 +4669,7 @@
                 <a:latin typeface="Ramabhadra" panose="02000600000000000000" pitchFamily="2" charset="0"/>
                 <a:cs typeface="Ramabhadra" panose="02000600000000000000" pitchFamily="2" charset="0"/>
               </a:rPr>
-              <a:t>చాలు యేసయ్యా</a:t>
+              <a:t>సరి సాటి రారు ప్రభువా</a:t>
             </a:r>
           </a:p>
           <a:p>
@@ -4352,7 +4682,7 @@
                 <a:latin typeface="Ramabhadra" panose="02000600000000000000" pitchFamily="2" charset="0"/>
                 <a:cs typeface="Ramabhadra" panose="02000600000000000000" pitchFamily="2" charset="0"/>
               </a:rPr>
-              <a:t>నీవెంటే నేను</a:t>
+              <a:t>నీ సన్నిధి కాంతికి</a:t>
             </a:r>
           </a:p>
           <a:p>
@@ -4365,59 +4695,7 @@
                 <a:latin typeface="Ramabhadra" panose="02000600000000000000" pitchFamily="2" charset="0"/>
                 <a:cs typeface="Ramabhadra" panose="02000600000000000000" pitchFamily="2" charset="0"/>
               </a:rPr>
-              <a:t>ఉంటానేసయ్యా (2)</a:t>
-            </a:r>
-          </a:p>
-          <a:p>
-            <a:pPr algn="ctr"/>
-            <a:r>
-              <a:rPr lang="te-IN" dirty="0">
-                <a:solidFill>
-                  <a:schemeClr val="tx1"/>
-                </a:solidFill>
-                <a:latin typeface="Ramabhadra" panose="02000600000000000000" pitchFamily="2" charset="0"/>
-                <a:cs typeface="Ramabhadra" panose="02000600000000000000" pitchFamily="2" charset="0"/>
-              </a:rPr>
-              <a:t>నీ మాట చాలయ్యా</a:t>
-            </a:r>
-          </a:p>
-          <a:p>
-            <a:pPr algn="ctr"/>
-            <a:r>
-              <a:rPr lang="te-IN" dirty="0">
-                <a:solidFill>
-                  <a:schemeClr val="tx1"/>
-                </a:solidFill>
-                <a:latin typeface="Ramabhadra" panose="02000600000000000000" pitchFamily="2" charset="0"/>
-                <a:cs typeface="Ramabhadra" panose="02000600000000000000" pitchFamily="2" charset="0"/>
-              </a:rPr>
-              <a:t>నీ చూపు చాలయ్యా</a:t>
-            </a:r>
-          </a:p>
-          <a:p>
-            <a:pPr algn="ctr"/>
-            <a:r>
-              <a:rPr lang="te-IN" dirty="0">
-                <a:solidFill>
-                  <a:schemeClr val="tx1"/>
-                </a:solidFill>
-                <a:latin typeface="Ramabhadra" panose="02000600000000000000" pitchFamily="2" charset="0"/>
-                <a:cs typeface="Ramabhadra" panose="02000600000000000000" pitchFamily="2" charset="0"/>
-              </a:rPr>
-              <a:t>నీ తోడు చాలయ్యా</a:t>
-            </a:r>
-          </a:p>
-          <a:p>
-            <a:pPr algn="ctr"/>
-            <a:r>
-              <a:rPr lang="te-IN" dirty="0">
-                <a:solidFill>
-                  <a:schemeClr val="tx1"/>
-                </a:solidFill>
-                <a:latin typeface="Ramabhadra" panose="02000600000000000000" pitchFamily="2" charset="0"/>
-                <a:cs typeface="Ramabhadra" panose="02000600000000000000" pitchFamily="2" charset="0"/>
-              </a:rPr>
-              <a:t>నీ నీడ చాలయ్యా (2)</a:t>
+              <a:t>గొరెపిల్ల మహిమకు (2) </a:t>
             </a:r>
           </a:p>
           <a:p>
@@ -4440,7 +4718,7 @@
                 <a:latin typeface="Ramabhadra" panose="02000600000000000000" pitchFamily="2" charset="0"/>
                 <a:cs typeface="Ramabhadra" panose="02000600000000000000" pitchFamily="2" charset="0"/>
               </a:rPr>
-              <a:t>ఎన్ని బాధలున్ననూ</a:t>
+              <a:t>ఉండదు దుఃఖమచట</a:t>
             </a:r>
           </a:p>
           <a:p>
@@ -4453,7 +4731,7 @@
                 <a:latin typeface="Ramabhadra" panose="02000600000000000000" pitchFamily="2" charset="0"/>
                 <a:cs typeface="Ramabhadra" panose="02000600000000000000" pitchFamily="2" charset="0"/>
               </a:rPr>
-              <a:t>ఇబ్బందులైననూ</a:t>
+              <a:t>ఉండును దేవుడు </a:t>
             </a:r>
           </a:p>
           <a:p>
@@ -4466,7 +4744,7 @@
                 <a:latin typeface="Ramabhadra" panose="02000600000000000000" pitchFamily="2" charset="0"/>
                 <a:cs typeface="Ramabhadra" panose="02000600000000000000" pitchFamily="2" charset="0"/>
               </a:rPr>
-              <a:t>ఎంత కష్టమొచ్చినా</a:t>
+              <a:t>తుడిచి వేయును కన్నీటి బాధలు (2)</a:t>
             </a:r>
           </a:p>
           <a:p>
@@ -4479,18 +4757,8 @@
                 <a:latin typeface="Ramabhadra" panose="02000600000000000000" pitchFamily="2" charset="0"/>
                 <a:cs typeface="Ramabhadra" panose="02000600000000000000" pitchFamily="2" charset="0"/>
               </a:rPr>
-              <a:t>నిష్టూరమైననూ (2)</a:t>
-            </a:r>
-          </a:p>
-          <a:p>
-            <a:pPr algn="ctr"/>
-            <a:endParaRPr lang="te-IN" dirty="0">
-              <a:solidFill>
-                <a:schemeClr val="tx1"/>
-              </a:solidFill>
-              <a:latin typeface="Ramabhadra" panose="02000600000000000000" pitchFamily="2" charset="0"/>
-              <a:cs typeface="Ramabhadra" panose="02000600000000000000" pitchFamily="2" charset="0"/>
-            </a:endParaRPr>
+              <a:t>అది అంతము ఆయనే</a:t>
+            </a:r>
           </a:p>
           <a:p>
             <a:pPr algn="ctr"/>
@@ -4502,7 +4770,7 @@
                 <a:latin typeface="Ramabhadra" panose="02000600000000000000" pitchFamily="2" charset="0"/>
                 <a:cs typeface="Ramabhadra" panose="02000600000000000000" pitchFamily="2" charset="0"/>
               </a:rPr>
-              <a:t>బ్రతుకు నావ పగిలినా</a:t>
+              <a:t>జీవ జలముల ఊటయు</a:t>
             </a:r>
           </a:p>
           <a:p>
@@ -4515,7 +4783,7 @@
                 <a:latin typeface="Ramabhadra" panose="02000600000000000000" pitchFamily="2" charset="0"/>
                 <a:cs typeface="Ramabhadra" panose="02000600000000000000" pitchFamily="2" charset="0"/>
               </a:rPr>
-              <a:t>కడలి పాలైననూ</a:t>
+              <a:t> </a:t>
             </a:r>
           </a:p>
           <a:p>
@@ -4528,7 +4796,7 @@
                 <a:latin typeface="Ramabhadra" panose="02000600000000000000" pitchFamily="2" charset="0"/>
                 <a:cs typeface="Ramabhadra" panose="02000600000000000000" pitchFamily="2" charset="0"/>
               </a:rPr>
-              <a:t>అలలు ముంచి వేసినా</a:t>
+              <a:t>తండ్రి భూమి మీద</a:t>
             </a:r>
           </a:p>
           <a:p>
@@ -4541,18 +4809,8 @@
                 <a:latin typeface="Ramabhadra" panose="02000600000000000000" pitchFamily="2" charset="0"/>
                 <a:cs typeface="Ramabhadra" panose="02000600000000000000" pitchFamily="2" charset="0"/>
               </a:rPr>
-              <a:t>ఆశలు అనగారినా (2)</a:t>
-            </a:r>
-          </a:p>
-          <a:p>
-            <a:pPr algn="ctr"/>
-            <a:endParaRPr lang="te-IN" dirty="0">
-              <a:solidFill>
-                <a:schemeClr val="tx1"/>
-              </a:solidFill>
-              <a:latin typeface="Ramabhadra" panose="02000600000000000000" pitchFamily="2" charset="0"/>
-              <a:cs typeface="Ramabhadra" panose="02000600000000000000" pitchFamily="2" charset="0"/>
-            </a:endParaRPr>
+              <a:t>తన చిత్తము జరిపెను</a:t>
+            </a:r>
           </a:p>
           <a:p>
             <a:pPr algn="ctr"/>
@@ -4564,7 +4822,7 @@
                 <a:latin typeface="Ramabhadra" panose="02000600000000000000" pitchFamily="2" charset="0"/>
                 <a:cs typeface="Ramabhadra" panose="02000600000000000000" pitchFamily="2" charset="0"/>
               </a:rPr>
-              <a:t>ఆస్తులన్నీ పోయినా</a:t>
+              <a:t>వ్యాధి లేమీయు</a:t>
             </a:r>
           </a:p>
           <a:p>
@@ -4577,7 +4835,7 @@
                 <a:latin typeface="Ramabhadra" panose="02000600000000000000" pitchFamily="2" charset="0"/>
                 <a:cs typeface="Ramabhadra" panose="02000600000000000000" pitchFamily="2" charset="0"/>
               </a:rPr>
-              <a:t>అనాథగా మిగిలినా</a:t>
+              <a:t>మన పదముల్ తాకెను (2)</a:t>
             </a:r>
           </a:p>
           <a:p>
@@ -4590,7 +4848,7 @@
                 <a:latin typeface="Ramabhadra" panose="02000600000000000000" pitchFamily="2" charset="0"/>
                 <a:cs typeface="Ramabhadra" panose="02000600000000000000" pitchFamily="2" charset="0"/>
               </a:rPr>
-              <a:t>ఆప్తులే విడనాడినా</a:t>
+              <a:t>జయించి మరణమున్</a:t>
             </a:r>
           </a:p>
           <a:p>
@@ -4603,7 +4861,7 @@
                 <a:latin typeface="Ramabhadra" panose="02000600000000000000" pitchFamily="2" charset="0"/>
                 <a:cs typeface="Ramabhadra" panose="02000600000000000000" pitchFamily="2" charset="0"/>
               </a:rPr>
-              <a:t>ఆరోగ్యం క్షీణించినా (2) </a:t>
+              <a:t>నిత్య జీవము నిచ్చెను</a:t>
             </a:r>
           </a:p>
         </p:txBody>

</xml_diff>

<commit_message>
15 sep sunday songs
</commit_message>
<xml_diff>
--- a/xerox.pptx
+++ b/xerox.pptx
@@ -224,7 +224,7 @@
           <a:p>
             <a:fld id="{3502DD63-DF8D-4AB8-92A0-0ECCF612C06C}" type="datetimeFigureOut">
               <a:rPr lang="en-IN" smtClean="0"/>
-              <a:t>07-09-2024</a:t>
+              <a:t>14-09-2024</a:t>
             </a:fld>
             <a:endParaRPr lang="en-IN"/>
           </a:p>
@@ -402,7 +402,7 @@
           <a:p>
             <a:fld id="{1AE741EC-1360-4793-999B-941E0396C9FA}" type="datetimeFigureOut">
               <a:rPr lang="en-IN" smtClean="0"/>
-              <a:t>07-09-2024</a:t>
+              <a:t>14-09-2024</a:t>
             </a:fld>
             <a:endParaRPr lang="en-IN"/>
           </a:p>
@@ -802,7 +802,7 @@
           <a:p>
             <a:fld id="{86FBD32F-FCAD-481A-B7D8-4D813FB7DB24}" type="datetimeFigureOut">
               <a:rPr lang="en-IN" smtClean="0"/>
-              <a:t>07-09-2024</a:t>
+              <a:t>14-09-2024</a:t>
             </a:fld>
             <a:endParaRPr lang="en-IN"/>
           </a:p>
@@ -972,7 +972,7 @@
           <a:p>
             <a:fld id="{86FBD32F-FCAD-481A-B7D8-4D813FB7DB24}" type="datetimeFigureOut">
               <a:rPr lang="en-IN" smtClean="0"/>
-              <a:t>07-09-2024</a:t>
+              <a:t>14-09-2024</a:t>
             </a:fld>
             <a:endParaRPr lang="en-IN"/>
           </a:p>
@@ -1152,7 +1152,7 @@
           <a:p>
             <a:fld id="{86FBD32F-FCAD-481A-B7D8-4D813FB7DB24}" type="datetimeFigureOut">
               <a:rPr lang="en-IN" smtClean="0"/>
-              <a:t>07-09-2024</a:t>
+              <a:t>14-09-2024</a:t>
             </a:fld>
             <a:endParaRPr lang="en-IN"/>
           </a:p>
@@ -1322,7 +1322,7 @@
           <a:p>
             <a:fld id="{86FBD32F-FCAD-481A-B7D8-4D813FB7DB24}" type="datetimeFigureOut">
               <a:rPr lang="en-IN" smtClean="0"/>
-              <a:t>07-09-2024</a:t>
+              <a:t>14-09-2024</a:t>
             </a:fld>
             <a:endParaRPr lang="en-IN"/>
           </a:p>
@@ -1566,7 +1566,7 @@
           <a:p>
             <a:fld id="{86FBD32F-FCAD-481A-B7D8-4D813FB7DB24}" type="datetimeFigureOut">
               <a:rPr lang="en-IN" smtClean="0"/>
-              <a:t>07-09-2024</a:t>
+              <a:t>14-09-2024</a:t>
             </a:fld>
             <a:endParaRPr lang="en-IN"/>
           </a:p>
@@ -1798,7 +1798,7 @@
           <a:p>
             <a:fld id="{86FBD32F-FCAD-481A-B7D8-4D813FB7DB24}" type="datetimeFigureOut">
               <a:rPr lang="en-IN" smtClean="0"/>
-              <a:t>07-09-2024</a:t>
+              <a:t>14-09-2024</a:t>
             </a:fld>
             <a:endParaRPr lang="en-IN"/>
           </a:p>
@@ -2165,7 +2165,7 @@
           <a:p>
             <a:fld id="{86FBD32F-FCAD-481A-B7D8-4D813FB7DB24}" type="datetimeFigureOut">
               <a:rPr lang="en-IN" smtClean="0"/>
-              <a:t>07-09-2024</a:t>
+              <a:t>14-09-2024</a:t>
             </a:fld>
             <a:endParaRPr lang="en-IN"/>
           </a:p>
@@ -2283,7 +2283,7 @@
           <a:p>
             <a:fld id="{86FBD32F-FCAD-481A-B7D8-4D813FB7DB24}" type="datetimeFigureOut">
               <a:rPr lang="en-IN" smtClean="0"/>
-              <a:t>07-09-2024</a:t>
+              <a:t>14-09-2024</a:t>
             </a:fld>
             <a:endParaRPr lang="en-IN"/>
           </a:p>
@@ -2378,7 +2378,7 @@
           <a:p>
             <a:fld id="{86FBD32F-FCAD-481A-B7D8-4D813FB7DB24}" type="datetimeFigureOut">
               <a:rPr lang="en-IN" smtClean="0"/>
-              <a:t>07-09-2024</a:t>
+              <a:t>14-09-2024</a:t>
             </a:fld>
             <a:endParaRPr lang="en-IN"/>
           </a:p>
@@ -2655,7 +2655,7 @@
           <a:p>
             <a:fld id="{86FBD32F-FCAD-481A-B7D8-4D813FB7DB24}" type="datetimeFigureOut">
               <a:rPr lang="en-IN" smtClean="0"/>
-              <a:t>07-09-2024</a:t>
+              <a:t>14-09-2024</a:t>
             </a:fld>
             <a:endParaRPr lang="en-IN"/>
           </a:p>
@@ -2912,7 +2912,7 @@
           <a:p>
             <a:fld id="{86FBD32F-FCAD-481A-B7D8-4D813FB7DB24}" type="datetimeFigureOut">
               <a:rPr lang="en-IN" smtClean="0"/>
-              <a:t>07-09-2024</a:t>
+              <a:t>14-09-2024</a:t>
             </a:fld>
             <a:endParaRPr lang="en-IN"/>
           </a:p>
@@ -3125,7 +3125,7 @@
           <a:p>
             <a:fld id="{86FBD32F-FCAD-481A-B7D8-4D813FB7DB24}" type="datetimeFigureOut">
               <a:rPr lang="en-IN" smtClean="0"/>
-              <a:t>07-09-2024</a:t>
+              <a:t>14-09-2024</a:t>
             </a:fld>
             <a:endParaRPr lang="en-IN"/>
           </a:p>
@@ -3583,110 +3583,51 @@
           <a:p>
             <a:pPr algn="ctr" defTabSz="439781"/>
             <a:r>
-              <a:rPr lang="te-IN" sz="1850" dirty="0">
+              <a:rPr lang="te-IN" sz="2000" dirty="0">
                 <a:solidFill>
                   <a:prstClr val="black"/>
                 </a:solidFill>
                 <a:latin typeface="Ramabhadra" panose="02000600000000000000" pitchFamily="2" charset="0"/>
                 <a:cs typeface="Ramabhadra" panose="02000600000000000000" pitchFamily="2" charset="0"/>
               </a:rPr>
-              <a:t>నిను స్తుతించినా చాలు</a:t>
+              <a:t>స్తోత్రం చెల్లింతుము స్తుతి స్తోత్రం చెల్లింతుము</a:t>
+            </a:r>
+            <a:br>
+              <a:rPr lang="te-IN" sz="2000" dirty="0">
+                <a:solidFill>
+                  <a:prstClr val="black"/>
+                </a:solidFill>
+                <a:latin typeface="Ramabhadra" panose="02000600000000000000" pitchFamily="2" charset="0"/>
+                <a:cs typeface="Ramabhadra" panose="02000600000000000000" pitchFamily="2" charset="0"/>
+              </a:rPr>
+            </a:br>
+            <a:r>
+              <a:rPr lang="te-IN" sz="2000" dirty="0">
+                <a:solidFill>
+                  <a:prstClr val="black"/>
+                </a:solidFill>
+                <a:latin typeface="Ramabhadra" panose="02000600000000000000" pitchFamily="2" charset="0"/>
+                <a:cs typeface="Ramabhadra" panose="02000600000000000000" pitchFamily="2" charset="0"/>
+              </a:rPr>
+              <a:t>యేసు నాథుని</a:t>
             </a:r>
           </a:p>
           <a:p>
             <a:pPr algn="ctr" defTabSz="439781"/>
             <a:r>
-              <a:rPr lang="te-IN" sz="1850" dirty="0">
+              <a:rPr lang="te-IN" sz="2000" dirty="0">
                 <a:solidFill>
                   <a:prstClr val="black"/>
                 </a:solidFill>
                 <a:latin typeface="Ramabhadra" panose="02000600000000000000" pitchFamily="2" charset="0"/>
                 <a:cs typeface="Ramabhadra" panose="02000600000000000000" pitchFamily="2" charset="0"/>
               </a:rPr>
-              <a:t>నా బ్రతుకు దినములో</a:t>
+              <a:t>మేలులు తలంచి</a:t>
             </a:r>
           </a:p>
           <a:p>
             <a:pPr algn="ctr" defTabSz="439781"/>
-            <a:r>
-              <a:rPr lang="te-IN" sz="1850" dirty="0">
-                <a:solidFill>
-                  <a:prstClr val="black"/>
-                </a:solidFill>
-                <a:latin typeface="Ramabhadra" panose="02000600000000000000" pitchFamily="2" charset="0"/>
-                <a:cs typeface="Ramabhadra" panose="02000600000000000000" pitchFamily="2" charset="0"/>
-              </a:rPr>
-              <a:t>నిను పొగిడినా చాలు</a:t>
-            </a:r>
-          </a:p>
-          <a:p>
-            <a:pPr algn="ctr" defTabSz="439781"/>
-            <a:r>
-              <a:rPr lang="te-IN" sz="1850" dirty="0">
-                <a:solidFill>
-                  <a:prstClr val="black"/>
-                </a:solidFill>
-                <a:latin typeface="Ramabhadra" panose="02000600000000000000" pitchFamily="2" charset="0"/>
-                <a:cs typeface="Ramabhadra" panose="02000600000000000000" pitchFamily="2" charset="0"/>
-              </a:rPr>
-              <a:t>నా గుండె గుడిలో (2)</a:t>
-            </a:r>
-          </a:p>
-          <a:p>
-            <a:pPr algn="ctr" defTabSz="439781"/>
-            <a:r>
-              <a:rPr lang="te-IN" sz="1850" dirty="0">
-                <a:solidFill>
-                  <a:prstClr val="black"/>
-                </a:solidFill>
-                <a:latin typeface="Ramabhadra" panose="02000600000000000000" pitchFamily="2" charset="0"/>
-                <a:cs typeface="Ramabhadra" panose="02000600000000000000" pitchFamily="2" charset="0"/>
-              </a:rPr>
-              <a:t>ఉన్నా లేకున్నా</a:t>
-            </a:r>
-          </a:p>
-          <a:p>
-            <a:pPr algn="ctr" defTabSz="439781"/>
-            <a:r>
-              <a:rPr lang="te-IN" sz="1850" dirty="0">
-                <a:solidFill>
-                  <a:prstClr val="black"/>
-                </a:solidFill>
-                <a:latin typeface="Ramabhadra" panose="02000600000000000000" pitchFamily="2" charset="0"/>
-                <a:cs typeface="Ramabhadra" panose="02000600000000000000" pitchFamily="2" charset="0"/>
-              </a:rPr>
-              <a:t>నా స్థితి గతులే మారినా</a:t>
-            </a:r>
-          </a:p>
-          <a:p>
-            <a:pPr algn="ctr" defTabSz="439781"/>
-            <a:r>
-              <a:rPr lang="te-IN" sz="1850" dirty="0">
-                <a:solidFill>
-                  <a:prstClr val="black"/>
-                </a:solidFill>
-                <a:latin typeface="Ramabhadra" panose="02000600000000000000" pitchFamily="2" charset="0"/>
-                <a:cs typeface="Ramabhadra" panose="02000600000000000000" pitchFamily="2" charset="0"/>
-              </a:rPr>
-              <a:t>నీ సన్నిధిలో…</a:t>
-            </a:r>
-          </a:p>
-          <a:p>
-            <a:pPr algn="ctr" defTabSz="439781"/>
-            <a:r>
-              <a:rPr lang="te-IN" sz="1850" dirty="0">
-                <a:solidFill>
-                  <a:prstClr val="black"/>
-                </a:solidFill>
-                <a:latin typeface="Ramabhadra" panose="02000600000000000000" pitchFamily="2" charset="0"/>
-                <a:cs typeface="Ramabhadra" panose="02000600000000000000" pitchFamily="2" charset="0"/>
-              </a:rPr>
-              <a:t>నీ సన్నిధిలో ఆనందించే భాగ్యమున్నా చాలు</a:t>
-            </a:r>
-          </a:p>
-          <a:p>
-            <a:pPr algn="ctr" defTabSz="439781"/>
-            <a:endParaRPr lang="te-IN" sz="1850" dirty="0">
+            <a:endParaRPr lang="te-IN" sz="2000" dirty="0">
               <a:solidFill>
                 <a:prstClr val="black"/>
               </a:solidFill>
@@ -3697,58 +3638,51 @@
           <a:p>
             <a:pPr algn="ctr" defTabSz="439781"/>
             <a:r>
-              <a:rPr lang="te-IN" sz="1850" dirty="0">
+              <a:rPr lang="te-IN" sz="2000" dirty="0">
                 <a:solidFill>
                   <a:prstClr val="black"/>
                 </a:solidFill>
                 <a:latin typeface="Ramabhadra" panose="02000600000000000000" pitchFamily="2" charset="0"/>
                 <a:cs typeface="Ramabhadra" panose="02000600000000000000" pitchFamily="2" charset="0"/>
               </a:rPr>
-              <a:t>స్తుతులకు పాత్రుడవు నీవేనయ్యా</a:t>
+              <a:t>దివారాత్రములు</a:t>
             </a:r>
           </a:p>
           <a:p>
             <a:pPr algn="ctr" defTabSz="439781"/>
             <a:r>
-              <a:rPr lang="te-IN" sz="1850" dirty="0">
+              <a:rPr lang="te-IN" sz="2000" dirty="0">
                 <a:solidFill>
                   <a:prstClr val="black"/>
                 </a:solidFill>
                 <a:latin typeface="Ramabhadra" panose="02000600000000000000" pitchFamily="2" charset="0"/>
                 <a:cs typeface="Ramabhadra" panose="02000600000000000000" pitchFamily="2" charset="0"/>
               </a:rPr>
-              <a:t>స్తోత్రార్హుడవు నీవేనయ్యా (2)</a:t>
+              <a:t>కంటిపాపవలె కాచి (2)</a:t>
+            </a:r>
+            <a:br>
+              <a:rPr lang="te-IN" sz="2000" dirty="0">
+                <a:solidFill>
+                  <a:prstClr val="black"/>
+                </a:solidFill>
+                <a:latin typeface="Ramabhadra" panose="02000600000000000000" pitchFamily="2" charset="0"/>
+                <a:cs typeface="Ramabhadra" panose="02000600000000000000" pitchFamily="2" charset="0"/>
+              </a:rPr>
+            </a:br>
+            <a:r>
+              <a:rPr lang="te-IN" sz="2000" dirty="0">
+                <a:solidFill>
+                  <a:prstClr val="black"/>
+                </a:solidFill>
+                <a:latin typeface="Ramabhadra" panose="02000600000000000000" pitchFamily="2" charset="0"/>
+                <a:cs typeface="Ramabhadra" panose="02000600000000000000" pitchFamily="2" charset="0"/>
+              </a:rPr>
+              <a:t>దయగల హస్తముతో బ్రోచి నడిపించితివి (2)</a:t>
             </a:r>
           </a:p>
           <a:p>
             <a:pPr algn="ctr" defTabSz="439781"/>
-            <a:r>
-              <a:rPr lang="te-IN" sz="1850" dirty="0">
-                <a:solidFill>
-                  <a:prstClr val="black"/>
-                </a:solidFill>
-                <a:latin typeface="Ramabhadra" panose="02000600000000000000" pitchFamily="2" charset="0"/>
-                <a:cs typeface="Ramabhadra" panose="02000600000000000000" pitchFamily="2" charset="0"/>
-              </a:rPr>
-              <a:t>నీవేనయ్యా</a:t>
-            </a:r>
-          </a:p>
-          <a:p>
-            <a:pPr algn="ctr" defTabSz="439781"/>
-            <a:r>
-              <a:rPr lang="te-IN" sz="1850" dirty="0">
-                <a:solidFill>
-                  <a:prstClr val="black"/>
-                </a:solidFill>
-                <a:latin typeface="Ramabhadra" panose="02000600000000000000" pitchFamily="2" charset="0"/>
-                <a:cs typeface="Ramabhadra" panose="02000600000000000000" pitchFamily="2" charset="0"/>
-              </a:rPr>
-              <a:t>నాకు నీవేనయ్యా (2)</a:t>
-            </a:r>
-          </a:p>
-          <a:p>
-            <a:pPr algn="ctr" defTabSz="439781"/>
-            <a:endParaRPr lang="te-IN" sz="1850" dirty="0">
+            <a:endParaRPr lang="te-IN" sz="2000" dirty="0">
               <a:solidFill>
                 <a:prstClr val="black"/>
               </a:solidFill>
@@ -3759,55 +3693,116 @@
           <a:p>
             <a:pPr algn="ctr" defTabSz="439781"/>
             <a:r>
-              <a:rPr lang="te-IN" sz="1850" dirty="0">
+              <a:rPr lang="te-IN" sz="2000" dirty="0">
                 <a:solidFill>
                   <a:prstClr val="black"/>
                 </a:solidFill>
                 <a:latin typeface="Ramabhadra" panose="02000600000000000000" pitchFamily="2" charset="0"/>
                 <a:cs typeface="Ramabhadra" panose="02000600000000000000" pitchFamily="2" charset="0"/>
               </a:rPr>
-              <a:t>ప్రేమా స్వరూపుడవు నీవేనయ్యా</a:t>
+              <a:t>గాడాంధకారములో</a:t>
             </a:r>
           </a:p>
           <a:p>
             <a:pPr algn="ctr" defTabSz="439781"/>
             <a:r>
-              <a:rPr lang="te-IN" sz="1850" dirty="0">
+              <a:rPr lang="te-IN" sz="2000" dirty="0">
                 <a:solidFill>
                   <a:prstClr val="black"/>
                 </a:solidFill>
                 <a:latin typeface="Ramabhadra" panose="02000600000000000000" pitchFamily="2" charset="0"/>
                 <a:cs typeface="Ramabhadra" panose="02000600000000000000" pitchFamily="2" charset="0"/>
               </a:rPr>
-              <a:t>స్తోత్రార్హుడవు నీవేనయ్యా (2)</a:t>
+              <a:t>కన్నీటి లోయలలో (2)</a:t>
+            </a:r>
+            <a:br>
+              <a:rPr lang="te-IN" sz="2000" dirty="0">
+                <a:solidFill>
+                  <a:prstClr val="black"/>
+                </a:solidFill>
+                <a:latin typeface="Ramabhadra" panose="02000600000000000000" pitchFamily="2" charset="0"/>
+                <a:cs typeface="Ramabhadra" panose="02000600000000000000" pitchFamily="2" charset="0"/>
+              </a:rPr>
+            </a:br>
+            <a:r>
+              <a:rPr lang="te-IN" sz="2000" dirty="0">
+                <a:solidFill>
+                  <a:prstClr val="black"/>
+                </a:solidFill>
+                <a:latin typeface="Ramabhadra" panose="02000600000000000000" pitchFamily="2" charset="0"/>
+                <a:cs typeface="Ramabhadra" panose="02000600000000000000" pitchFamily="2" charset="0"/>
+              </a:rPr>
+              <a:t>కృశించి పోనీయక</a:t>
             </a:r>
           </a:p>
           <a:p>
             <a:pPr algn="ctr" defTabSz="439781"/>
             <a:r>
-              <a:rPr lang="te-IN" sz="1850" dirty="0">
+              <a:rPr lang="te-IN" sz="2000" dirty="0">
                 <a:solidFill>
                   <a:prstClr val="black"/>
                 </a:solidFill>
                 <a:latin typeface="Ramabhadra" panose="02000600000000000000" pitchFamily="2" charset="0"/>
                 <a:cs typeface="Ramabhadra" panose="02000600000000000000" pitchFamily="2" charset="0"/>
               </a:rPr>
-              <a:t>నీవేనయ్యా</a:t>
+              <a:t>కృపలతో బలపరచితివి (2)</a:t>
             </a:r>
           </a:p>
           <a:p>
             <a:pPr algn="ctr" defTabSz="439781"/>
-            <a:r>
-              <a:rPr lang="te-IN" sz="1850" dirty="0">
+            <a:endParaRPr lang="te-IN" sz="2000" dirty="0">
+              <a:solidFill>
+                <a:prstClr val="black"/>
+              </a:solidFill>
+              <a:latin typeface="Ramabhadra" panose="02000600000000000000" pitchFamily="2" charset="0"/>
+              <a:cs typeface="Ramabhadra" panose="02000600000000000000" pitchFamily="2" charset="0"/>
+            </a:endParaRPr>
+          </a:p>
+          <a:p>
+            <a:pPr algn="ctr" defTabSz="439781"/>
+            <a:r>
+              <a:rPr lang="te-IN" sz="2000" dirty="0">
                 <a:solidFill>
                   <a:prstClr val="black"/>
                 </a:solidFill>
                 <a:latin typeface="Ramabhadra" panose="02000600000000000000" pitchFamily="2" charset="0"/>
                 <a:cs typeface="Ramabhadra" panose="02000600000000000000" pitchFamily="2" charset="0"/>
               </a:rPr>
-              <a:t>నాకు నీవేనయ్యా (2) </a:t>
-            </a:r>
-            <a:endParaRPr lang="en-IN" sz="1850" dirty="0">
+              <a:t>సజీవ యాగముగా మా శరీరము సమర్పించి (2)</a:t>
+            </a:r>
+            <a:br>
+              <a:rPr lang="te-IN" sz="2000" dirty="0">
+                <a:solidFill>
+                  <a:prstClr val="black"/>
+                </a:solidFill>
+                <a:latin typeface="Ramabhadra" panose="02000600000000000000" pitchFamily="2" charset="0"/>
+                <a:cs typeface="Ramabhadra" panose="02000600000000000000" pitchFamily="2" charset="0"/>
+              </a:rPr>
+            </a:br>
+            <a:r>
+              <a:rPr lang="te-IN" sz="2000" dirty="0">
+                <a:solidFill>
+                  <a:prstClr val="black"/>
+                </a:solidFill>
+                <a:latin typeface="Ramabhadra" panose="02000600000000000000" pitchFamily="2" charset="0"/>
+                <a:cs typeface="Ramabhadra" panose="02000600000000000000" pitchFamily="2" charset="0"/>
+              </a:rPr>
+              <a:t>సంపూర్ణ సిద్దినొంద</a:t>
+            </a:r>
+          </a:p>
+          <a:p>
+            <a:pPr algn="ctr" defTabSz="439781"/>
+            <a:r>
+              <a:rPr lang="te-IN" sz="2000" dirty="0">
+                <a:solidFill>
+                  <a:prstClr val="black"/>
+                </a:solidFill>
+                <a:latin typeface="Ramabhadra" panose="02000600000000000000" pitchFamily="2" charset="0"/>
+                <a:cs typeface="Ramabhadra" panose="02000600000000000000" pitchFamily="2" charset="0"/>
+              </a:rPr>
+              <a:t>శుద్ధాత్మను నొసగితివి (2)</a:t>
+            </a:r>
+            <a:endParaRPr lang="en-IN" sz="2000" dirty="0">
               <a:solidFill>
                 <a:prstClr val="black"/>
               </a:solidFill>
@@ -3870,97 +3865,153 @@
           <a:p>
             <a:pPr algn="ctr"/>
             <a:r>
-              <a:rPr lang="te-IN" sz="1700" dirty="0">
-                <a:solidFill>
-                  <a:schemeClr val="tx1"/>
-                </a:solidFill>
-                <a:latin typeface="Ramabhadra" panose="02000600000000000000" pitchFamily="2" charset="0"/>
-                <a:cs typeface="Ramabhadra" panose="02000600000000000000" pitchFamily="2" charset="0"/>
-              </a:rPr>
-              <a:t>సద్గుణ శీలుడా నీవే పూజ్యుడవు</a:t>
+              <a:rPr lang="te-IN" sz="1550" dirty="0">
+                <a:solidFill>
+                  <a:schemeClr val="tx1"/>
+                </a:solidFill>
+                <a:latin typeface="Ramabhadra" panose="02000600000000000000" pitchFamily="2" charset="0"/>
+                <a:cs typeface="Ramabhadra" panose="02000600000000000000" pitchFamily="2" charset="0"/>
+              </a:rPr>
+              <a:t>ఘనమైనవి నీ కార్యములు</a:t>
             </a:r>
           </a:p>
           <a:p>
             <a:pPr algn="ctr"/>
             <a:r>
-              <a:rPr lang="te-IN" sz="1700" dirty="0">
-                <a:solidFill>
-                  <a:schemeClr val="tx1"/>
-                </a:solidFill>
-                <a:latin typeface="Ramabhadra" panose="02000600000000000000" pitchFamily="2" charset="0"/>
-                <a:cs typeface="Ramabhadra" panose="02000600000000000000" pitchFamily="2" charset="0"/>
-              </a:rPr>
-              <a:t>స్తుతి ఆరాధనకు నీవే యోగ్యుడవు</a:t>
+              <a:rPr lang="te-IN" sz="1550" dirty="0">
+                <a:solidFill>
+                  <a:schemeClr val="tx1"/>
+                </a:solidFill>
+                <a:latin typeface="Ramabhadra" panose="02000600000000000000" pitchFamily="2" charset="0"/>
+                <a:cs typeface="Ramabhadra" panose="02000600000000000000" pitchFamily="2" charset="0"/>
+              </a:rPr>
+              <a:t>నా యెడల</a:t>
+            </a:r>
+            <a:br>
+              <a:rPr lang="te-IN" sz="1550" dirty="0">
+                <a:solidFill>
+                  <a:schemeClr val="tx1"/>
+                </a:solidFill>
+                <a:latin typeface="Ramabhadra" panose="02000600000000000000" pitchFamily="2" charset="0"/>
+                <a:cs typeface="Ramabhadra" panose="02000600000000000000" pitchFamily="2" charset="0"/>
+              </a:rPr>
+            </a:br>
+            <a:r>
+              <a:rPr lang="te-IN" sz="1550" dirty="0">
+                <a:solidFill>
+                  <a:schemeClr val="tx1"/>
+                </a:solidFill>
+                <a:latin typeface="Ramabhadra" panose="02000600000000000000" pitchFamily="2" charset="0"/>
+                <a:cs typeface="Ramabhadra" panose="02000600000000000000" pitchFamily="2" charset="0"/>
+              </a:rPr>
+              <a:t>స్థిరమైనవి నీ ఆలోచనలు</a:t>
             </a:r>
           </a:p>
           <a:p>
             <a:pPr algn="ctr"/>
             <a:r>
-              <a:rPr lang="te-IN" sz="1700" dirty="0">
-                <a:solidFill>
-                  <a:schemeClr val="tx1"/>
-                </a:solidFill>
-                <a:latin typeface="Ramabhadra" panose="02000600000000000000" pitchFamily="2" charset="0"/>
-                <a:cs typeface="Ramabhadra" panose="02000600000000000000" pitchFamily="2" charset="0"/>
-              </a:rPr>
-              <a:t>సత్య ప్రమాణముతో </a:t>
+              <a:rPr lang="te-IN" sz="1550" dirty="0">
+                <a:solidFill>
+                  <a:schemeClr val="tx1"/>
+                </a:solidFill>
+                <a:latin typeface="Ramabhadra" panose="02000600000000000000" pitchFamily="2" charset="0"/>
+                <a:cs typeface="Ramabhadra" panose="02000600000000000000" pitchFamily="2" charset="0"/>
+              </a:rPr>
+              <a:t>నా యేసయ్యా (2)</a:t>
+            </a:r>
+            <a:br>
+              <a:rPr lang="te-IN" sz="1550" dirty="0">
+                <a:solidFill>
+                  <a:schemeClr val="tx1"/>
+                </a:solidFill>
+                <a:latin typeface="Ramabhadra" panose="02000600000000000000" pitchFamily="2" charset="0"/>
+                <a:cs typeface="Ramabhadra" panose="02000600000000000000" pitchFamily="2" charset="0"/>
+              </a:rPr>
+            </a:br>
+            <a:r>
+              <a:rPr lang="te-IN" sz="1550" dirty="0">
+                <a:solidFill>
+                  <a:schemeClr val="tx1"/>
+                </a:solidFill>
+                <a:latin typeface="Ramabhadra" panose="02000600000000000000" pitchFamily="2" charset="0"/>
+                <a:cs typeface="Ramabhadra" panose="02000600000000000000" pitchFamily="2" charset="0"/>
+              </a:rPr>
+              <a:t>కృపలను పొందుచు కృతజ్ఞత కలిగి</a:t>
+            </a:r>
+            <a:br>
+              <a:rPr lang="te-IN" sz="1550" dirty="0">
+                <a:solidFill>
+                  <a:schemeClr val="tx1"/>
+                </a:solidFill>
+                <a:latin typeface="Ramabhadra" panose="02000600000000000000" pitchFamily="2" charset="0"/>
+                <a:cs typeface="Ramabhadra" panose="02000600000000000000" pitchFamily="2" charset="0"/>
+              </a:rPr>
+            </a:br>
+            <a:r>
+              <a:rPr lang="te-IN" sz="1550" dirty="0">
+                <a:solidFill>
+                  <a:schemeClr val="tx1"/>
+                </a:solidFill>
+                <a:latin typeface="Ramabhadra" panose="02000600000000000000" pitchFamily="2" charset="0"/>
+                <a:cs typeface="Ramabhadra" panose="02000600000000000000" pitchFamily="2" charset="0"/>
+              </a:rPr>
+              <a:t>స్తుతులర్పించెదను అన్నివేళలా (2)</a:t>
+            </a:r>
+            <a:br>
+              <a:rPr lang="te-IN" sz="1550" dirty="0">
+                <a:solidFill>
+                  <a:schemeClr val="tx1"/>
+                </a:solidFill>
+                <a:latin typeface="Ramabhadra" panose="02000600000000000000" pitchFamily="2" charset="0"/>
+                <a:cs typeface="Ramabhadra" panose="02000600000000000000" pitchFamily="2" charset="0"/>
+              </a:rPr>
+            </a:br>
+            <a:r>
+              <a:rPr lang="te-IN" sz="1550" dirty="0">
+                <a:solidFill>
+                  <a:schemeClr val="tx1"/>
+                </a:solidFill>
+                <a:latin typeface="Ramabhadra" panose="02000600000000000000" pitchFamily="2" charset="0"/>
+                <a:cs typeface="Ramabhadra" panose="02000600000000000000" pitchFamily="2" charset="0"/>
+              </a:rPr>
+              <a:t>అనుదినము నీ అనుగ్రహమే</a:t>
+            </a:r>
+            <a:br>
+              <a:rPr lang="te-IN" sz="1550" dirty="0">
+                <a:solidFill>
+                  <a:schemeClr val="tx1"/>
+                </a:solidFill>
+                <a:latin typeface="Ramabhadra" panose="02000600000000000000" pitchFamily="2" charset="0"/>
+                <a:cs typeface="Ramabhadra" panose="02000600000000000000" pitchFamily="2" charset="0"/>
+              </a:rPr>
+            </a:br>
+            <a:r>
+              <a:rPr lang="te-IN" sz="1550" dirty="0">
+                <a:solidFill>
+                  <a:schemeClr val="tx1"/>
+                </a:solidFill>
+                <a:latin typeface="Ramabhadra" panose="02000600000000000000" pitchFamily="2" charset="0"/>
+                <a:cs typeface="Ramabhadra" panose="02000600000000000000" pitchFamily="2" charset="0"/>
+              </a:rPr>
+              <a:t>ఆయుష్కాలము</a:t>
             </a:r>
           </a:p>
           <a:p>
             <a:pPr algn="ctr"/>
             <a:r>
-              <a:rPr lang="te-IN" sz="1700" dirty="0">
-                <a:solidFill>
-                  <a:schemeClr val="tx1"/>
-                </a:solidFill>
-                <a:latin typeface="Ramabhadra" panose="02000600000000000000" pitchFamily="2" charset="0"/>
-                <a:cs typeface="Ramabhadra" panose="02000600000000000000" pitchFamily="2" charset="0"/>
-              </a:rPr>
-              <a:t>శాశ్వత కృపనిచ్చి</a:t>
+              <a:rPr lang="te-IN" sz="1550" dirty="0">
+                <a:solidFill>
+                  <a:schemeClr val="tx1"/>
+                </a:solidFill>
+                <a:latin typeface="Ramabhadra" panose="02000600000000000000" pitchFamily="2" charset="0"/>
+                <a:cs typeface="Ramabhadra" panose="02000600000000000000" pitchFamily="2" charset="0"/>
+              </a:rPr>
+              <a:t>నీ వరమే (2)</a:t>
             </a:r>
           </a:p>
           <a:p>
             <a:pPr algn="ctr"/>
-            <a:r>
-              <a:rPr lang="te-IN" sz="1700" dirty="0">
-                <a:solidFill>
-                  <a:schemeClr val="tx1"/>
-                </a:solidFill>
-                <a:latin typeface="Ramabhadra" panose="02000600000000000000" pitchFamily="2" charset="0"/>
-                <a:cs typeface="Ramabhadra" panose="02000600000000000000" pitchFamily="2" charset="0"/>
-              </a:rPr>
-              <a:t>నీ ప్రియుని స్వాస్థ్యము నాకిచ్చితివి</a:t>
-            </a:r>
-          </a:p>
-          <a:p>
-            <a:pPr algn="ctr"/>
-            <a:r>
-              <a:rPr lang="te-IN" sz="1700" dirty="0">
-                <a:solidFill>
-                  <a:schemeClr val="tx1"/>
-                </a:solidFill>
-                <a:latin typeface="Ramabhadra" panose="02000600000000000000" pitchFamily="2" charset="0"/>
-                <a:cs typeface="Ramabhadra" panose="02000600000000000000" pitchFamily="2" charset="0"/>
-              </a:rPr>
-              <a:t>యేసయ్యా నీ సంకల్పమే</a:t>
-            </a:r>
-          </a:p>
-          <a:p>
-            <a:pPr algn="ctr"/>
-            <a:r>
-              <a:rPr lang="te-IN" sz="1700" dirty="0">
-                <a:solidFill>
-                  <a:schemeClr val="tx1"/>
-                </a:solidFill>
-                <a:latin typeface="Ramabhadra" panose="02000600000000000000" pitchFamily="2" charset="0"/>
-                <a:cs typeface="Ramabhadra" panose="02000600000000000000" pitchFamily="2" charset="0"/>
-              </a:rPr>
-              <a:t>ఇది నాపై నీకున్న అనురాగమే</a:t>
-            </a:r>
-          </a:p>
-          <a:p>
-            <a:pPr algn="ctr"/>
-            <a:endParaRPr lang="te-IN" sz="1700" dirty="0">
+            <a:endParaRPr lang="te-IN" sz="1550" dirty="0">
               <a:solidFill>
                 <a:schemeClr val="tx1"/>
               </a:solidFill>
@@ -3971,97 +4022,128 @@
           <a:p>
             <a:pPr algn="ctr"/>
             <a:r>
-              <a:rPr lang="te-IN" sz="1700" dirty="0">
-                <a:solidFill>
-                  <a:schemeClr val="tx1"/>
-                </a:solidFill>
-                <a:latin typeface="Ramabhadra" panose="02000600000000000000" pitchFamily="2" charset="0"/>
-                <a:cs typeface="Ramabhadra" panose="02000600000000000000" pitchFamily="2" charset="0"/>
-              </a:rPr>
-              <a:t>సిలువ సునాదమును</a:t>
+              <a:rPr lang="te-IN" sz="1550" dirty="0">
+                <a:solidFill>
+                  <a:schemeClr val="tx1"/>
+                </a:solidFill>
+                <a:latin typeface="Ramabhadra" panose="02000600000000000000" pitchFamily="2" charset="0"/>
+                <a:cs typeface="Ramabhadra" panose="02000600000000000000" pitchFamily="2" charset="0"/>
+              </a:rPr>
+              <a:t>యే తెగులు సమీపించనీయక –</a:t>
             </a:r>
           </a:p>
           <a:p>
             <a:pPr algn="ctr"/>
             <a:r>
-              <a:rPr lang="te-IN" sz="1700" dirty="0">
-                <a:solidFill>
-                  <a:schemeClr val="tx1"/>
-                </a:solidFill>
-                <a:latin typeface="Ramabhadra" panose="02000600000000000000" pitchFamily="2" charset="0"/>
-                <a:cs typeface="Ramabhadra" panose="02000600000000000000" pitchFamily="2" charset="0"/>
-              </a:rPr>
-              <a:t>నా శ్రమదినమున</a:t>
+              <a:rPr lang="te-IN" sz="1550" dirty="0">
+                <a:solidFill>
+                  <a:schemeClr val="tx1"/>
+                </a:solidFill>
+                <a:latin typeface="Ramabhadra" panose="02000600000000000000" pitchFamily="2" charset="0"/>
+                <a:cs typeface="Ramabhadra" panose="02000600000000000000" pitchFamily="2" charset="0"/>
+              </a:rPr>
+              <a:t>యే కీడైన దరిచేరనీయక</a:t>
+            </a:r>
+            <a:br>
+              <a:rPr lang="te-IN" sz="1550" dirty="0">
+                <a:solidFill>
+                  <a:schemeClr val="tx1"/>
+                </a:solidFill>
+                <a:latin typeface="Ramabhadra" panose="02000600000000000000" pitchFamily="2" charset="0"/>
+                <a:cs typeface="Ramabhadra" panose="02000600000000000000" pitchFamily="2" charset="0"/>
+              </a:rPr>
+            </a:br>
+            <a:r>
+              <a:rPr lang="te-IN" sz="1550" dirty="0">
+                <a:solidFill>
+                  <a:schemeClr val="tx1"/>
+                </a:solidFill>
+                <a:latin typeface="Ramabhadra" panose="02000600000000000000" pitchFamily="2" charset="0"/>
+                <a:cs typeface="Ramabhadra" panose="02000600000000000000" pitchFamily="2" charset="0"/>
+              </a:rPr>
+              <a:t>ఆపదలన్ని తొలగే వరకు –</a:t>
             </a:r>
           </a:p>
           <a:p>
             <a:pPr algn="ctr"/>
             <a:r>
-              <a:rPr lang="te-IN" sz="1700" dirty="0">
-                <a:solidFill>
-                  <a:schemeClr val="tx1"/>
-                </a:solidFill>
-                <a:latin typeface="Ramabhadra" panose="02000600000000000000" pitchFamily="2" charset="0"/>
-                <a:cs typeface="Ramabhadra" panose="02000600000000000000" pitchFamily="2" charset="0"/>
-              </a:rPr>
-              <a:t>మధుర గీతికగా</a:t>
+              <a:rPr lang="te-IN" sz="1550" dirty="0">
+                <a:solidFill>
+                  <a:schemeClr val="tx1"/>
+                </a:solidFill>
+                <a:latin typeface="Ramabhadra" panose="02000600000000000000" pitchFamily="2" charset="0"/>
+                <a:cs typeface="Ramabhadra" panose="02000600000000000000" pitchFamily="2" charset="0"/>
+              </a:rPr>
+              <a:t>ఆత్మలో నెమ్మది కలిగే వరకు (2)</a:t>
+            </a:r>
+            <a:br>
+              <a:rPr lang="te-IN" sz="1550" dirty="0">
+                <a:solidFill>
+                  <a:schemeClr val="tx1"/>
+                </a:solidFill>
+                <a:latin typeface="Ramabhadra" panose="02000600000000000000" pitchFamily="2" charset="0"/>
+                <a:cs typeface="Ramabhadra" panose="02000600000000000000" pitchFamily="2" charset="0"/>
+              </a:rPr>
+            </a:br>
+            <a:r>
+              <a:rPr lang="te-IN" sz="1550" dirty="0">
+                <a:solidFill>
+                  <a:schemeClr val="tx1"/>
+                </a:solidFill>
+                <a:latin typeface="Ramabhadra" panose="02000600000000000000" pitchFamily="2" charset="0"/>
+                <a:cs typeface="Ramabhadra" panose="02000600000000000000" pitchFamily="2" charset="0"/>
+              </a:rPr>
+              <a:t>నా భారము మోసి –</a:t>
             </a:r>
           </a:p>
           <a:p>
             <a:pPr algn="ctr"/>
             <a:r>
-              <a:rPr lang="te-IN" sz="1700" dirty="0">
-                <a:solidFill>
-                  <a:schemeClr val="tx1"/>
-                </a:solidFill>
-                <a:latin typeface="Ramabhadra" panose="02000600000000000000" pitchFamily="2" charset="0"/>
-                <a:cs typeface="Ramabhadra" panose="02000600000000000000" pitchFamily="2" charset="0"/>
-              </a:rPr>
-              <a:t>మదిలో వినిపించి</a:t>
+              <a:rPr lang="te-IN" sz="1550" dirty="0">
+                <a:solidFill>
+                  <a:schemeClr val="tx1"/>
+                </a:solidFill>
+                <a:latin typeface="Ramabhadra" panose="02000600000000000000" pitchFamily="2" charset="0"/>
+                <a:cs typeface="Ramabhadra" panose="02000600000000000000" pitchFamily="2" charset="0"/>
+              </a:rPr>
+              <a:t>బాసటగా నిలిచి – ఆదరించితివి</a:t>
+            </a:r>
+            <a:br>
+              <a:rPr lang="te-IN" sz="1550" dirty="0">
+                <a:solidFill>
+                  <a:schemeClr val="tx1"/>
+                </a:solidFill>
+                <a:latin typeface="Ramabhadra" panose="02000600000000000000" pitchFamily="2" charset="0"/>
+                <a:cs typeface="Ramabhadra" panose="02000600000000000000" pitchFamily="2" charset="0"/>
+              </a:rPr>
+            </a:br>
+            <a:r>
+              <a:rPr lang="te-IN" sz="1550" dirty="0">
+                <a:solidFill>
+                  <a:schemeClr val="tx1"/>
+                </a:solidFill>
+                <a:latin typeface="Ramabhadra" panose="02000600000000000000" pitchFamily="2" charset="0"/>
+                <a:cs typeface="Ramabhadra" panose="02000600000000000000" pitchFamily="2" charset="0"/>
+              </a:rPr>
+              <a:t>ఈ స్తుతి మహిమలు నీకే –</a:t>
             </a:r>
           </a:p>
           <a:p>
             <a:pPr algn="ctr"/>
             <a:r>
-              <a:rPr lang="te-IN" sz="1700" dirty="0">
-                <a:solidFill>
-                  <a:schemeClr val="tx1"/>
-                </a:solidFill>
-                <a:latin typeface="Ramabhadra" panose="02000600000000000000" pitchFamily="2" charset="0"/>
-                <a:cs typeface="Ramabhadra" panose="02000600000000000000" pitchFamily="2" charset="0"/>
-              </a:rPr>
-              <a:t>సిలువలో దాగిన సర్వసంపదలిచ్చి</a:t>
+              <a:rPr lang="te-IN" sz="1550" dirty="0">
+                <a:solidFill>
+                  <a:schemeClr val="tx1"/>
+                </a:solidFill>
+                <a:latin typeface="Ramabhadra" panose="02000600000000000000" pitchFamily="2" charset="0"/>
+                <a:cs typeface="Ramabhadra" panose="02000600000000000000" pitchFamily="2" charset="0"/>
+              </a:rPr>
+              <a:t>చెల్లించెదను -  జీవితాంతము</a:t>
             </a:r>
           </a:p>
           <a:p>
             <a:pPr algn="ctr"/>
-            <a:r>
-              <a:rPr lang="te-IN" sz="1700" dirty="0">
-                <a:solidFill>
-                  <a:schemeClr val="tx1"/>
-                </a:solidFill>
-                <a:latin typeface="Ramabhadra" panose="02000600000000000000" pitchFamily="2" charset="0"/>
-                <a:cs typeface="Ramabhadra" panose="02000600000000000000" pitchFamily="2" charset="0"/>
-              </a:rPr>
-              <a:t>కాంతిమయముగా</a:t>
-            </a:r>
-          </a:p>
-          <a:p>
-            <a:pPr algn="ctr"/>
-            <a:r>
-              <a:rPr lang="te-IN" sz="1700" dirty="0">
-                <a:solidFill>
-                  <a:schemeClr val="tx1"/>
-                </a:solidFill>
-                <a:latin typeface="Ramabhadra" panose="02000600000000000000" pitchFamily="2" charset="0"/>
-                <a:cs typeface="Ramabhadra" panose="02000600000000000000" pitchFamily="2" charset="0"/>
-              </a:rPr>
-              <a:t>కనపరచితివే నీ ఆత్మ శక్తితో</a:t>
-            </a:r>
-          </a:p>
-          <a:p>
-            <a:pPr algn="ctr"/>
-            <a:endParaRPr lang="te-IN" sz="1700" dirty="0">
+            <a:endParaRPr lang="te-IN" sz="1550" dirty="0">
               <a:solidFill>
                 <a:schemeClr val="tx1"/>
               </a:solidFill>
@@ -4072,79 +4154,123 @@
           <a:p>
             <a:pPr algn="ctr"/>
             <a:r>
-              <a:rPr lang="te-IN" sz="1700" dirty="0">
-                <a:solidFill>
-                  <a:schemeClr val="tx1"/>
-                </a:solidFill>
-                <a:latin typeface="Ramabhadra" panose="02000600000000000000" pitchFamily="2" charset="0"/>
-                <a:cs typeface="Ramabhadra" panose="02000600000000000000" pitchFamily="2" charset="0"/>
-              </a:rPr>
-              <a:t>నాతోడు నీడవై మరపురాని</a:t>
+              <a:rPr lang="te-IN" sz="1550" dirty="0">
+                <a:solidFill>
+                  <a:schemeClr val="tx1"/>
+                </a:solidFill>
+                <a:latin typeface="Ramabhadra" panose="02000600000000000000" pitchFamily="2" charset="0"/>
+                <a:cs typeface="Ramabhadra" panose="02000600000000000000" pitchFamily="2" charset="0"/>
+              </a:rPr>
+              <a:t>నాకు ఎత్తైన కోటవు నీవే –</a:t>
             </a:r>
           </a:p>
           <a:p>
             <a:pPr algn="ctr"/>
             <a:r>
-              <a:rPr lang="te-IN" sz="1700" dirty="0">
-                <a:solidFill>
-                  <a:schemeClr val="tx1"/>
-                </a:solidFill>
-                <a:latin typeface="Ramabhadra" panose="02000600000000000000" pitchFamily="2" charset="0"/>
-                <a:cs typeface="Ramabhadra" panose="02000600000000000000" pitchFamily="2" charset="0"/>
-              </a:rPr>
-              <a:t>మహోప కార్యములు నాకై చేసి</a:t>
+              <a:rPr lang="te-IN" sz="1550" dirty="0">
+                <a:solidFill>
+                  <a:schemeClr val="tx1"/>
+                </a:solidFill>
+                <a:latin typeface="Ramabhadra" panose="02000600000000000000" pitchFamily="2" charset="0"/>
+                <a:cs typeface="Ramabhadra" panose="02000600000000000000" pitchFamily="2" charset="0"/>
+              </a:rPr>
+              <a:t>నన్ను కాపాడు కేడెము నీవే</a:t>
+            </a:r>
+            <a:br>
+              <a:rPr lang="te-IN" sz="1550" dirty="0">
+                <a:solidFill>
+                  <a:schemeClr val="tx1"/>
+                </a:solidFill>
+                <a:latin typeface="Ramabhadra" panose="02000600000000000000" pitchFamily="2" charset="0"/>
+                <a:cs typeface="Ramabhadra" panose="02000600000000000000" pitchFamily="2" charset="0"/>
+              </a:rPr>
+            </a:br>
+            <a:r>
+              <a:rPr lang="te-IN" sz="1550" dirty="0">
+                <a:solidFill>
+                  <a:schemeClr val="tx1"/>
+                </a:solidFill>
+                <a:latin typeface="Ramabhadra" panose="02000600000000000000" pitchFamily="2" charset="0"/>
+                <a:cs typeface="Ramabhadra" panose="02000600000000000000" pitchFamily="2" charset="0"/>
+              </a:rPr>
+              <a:t>ఆశ్రయమైన బండవు నీవే –</a:t>
             </a:r>
           </a:p>
           <a:p>
             <a:pPr algn="ctr"/>
             <a:r>
-              <a:rPr lang="te-IN" sz="1700" dirty="0">
-                <a:solidFill>
-                  <a:schemeClr val="tx1"/>
-                </a:solidFill>
-                <a:latin typeface="Ramabhadra" panose="02000600000000000000" pitchFamily="2" charset="0"/>
-                <a:cs typeface="Ramabhadra" panose="02000600000000000000" pitchFamily="2" charset="0"/>
-              </a:rPr>
-              <a:t>చీకటి దాచిన</a:t>
+              <a:rPr lang="te-IN" sz="1550" dirty="0">
+                <a:solidFill>
+                  <a:schemeClr val="tx1"/>
+                </a:solidFill>
+                <a:latin typeface="Ramabhadra" panose="02000600000000000000" pitchFamily="2" charset="0"/>
+                <a:cs typeface="Ramabhadra" panose="02000600000000000000" pitchFamily="2" charset="0"/>
+              </a:rPr>
+              <a:t>శాశ్వత కృపకాధారము నీవే (2)</a:t>
+            </a:r>
+            <a:br>
+              <a:rPr lang="te-IN" sz="1550" dirty="0">
+                <a:solidFill>
+                  <a:schemeClr val="tx1"/>
+                </a:solidFill>
+                <a:latin typeface="Ramabhadra" panose="02000600000000000000" pitchFamily="2" charset="0"/>
+                <a:cs typeface="Ramabhadra" panose="02000600000000000000" pitchFamily="2" charset="0"/>
+              </a:rPr>
+            </a:br>
+            <a:r>
+              <a:rPr lang="te-IN" sz="1550" dirty="0">
+                <a:solidFill>
+                  <a:schemeClr val="tx1"/>
+                </a:solidFill>
+                <a:latin typeface="Ramabhadra" panose="02000600000000000000" pitchFamily="2" charset="0"/>
+                <a:cs typeface="Ramabhadra" panose="02000600000000000000" pitchFamily="2" charset="0"/>
+              </a:rPr>
+              <a:t>నా ప్రతిక్షణమును నీవు –</a:t>
             </a:r>
           </a:p>
           <a:p>
             <a:pPr algn="ctr"/>
             <a:r>
-              <a:rPr lang="te-IN" sz="1700" dirty="0">
-                <a:solidFill>
-                  <a:schemeClr val="tx1"/>
-                </a:solidFill>
-                <a:latin typeface="Ramabhadra" panose="02000600000000000000" pitchFamily="2" charset="0"/>
-                <a:cs typeface="Ramabhadra" panose="02000600000000000000" pitchFamily="2" charset="0"/>
-              </a:rPr>
-              <a:t>వేకువగా మార్చి</a:t>
+              <a:rPr lang="te-IN" sz="1550" dirty="0">
+                <a:solidFill>
+                  <a:schemeClr val="tx1"/>
+                </a:solidFill>
+                <a:latin typeface="Ramabhadra" panose="02000600000000000000" pitchFamily="2" charset="0"/>
+                <a:cs typeface="Ramabhadra" panose="02000600000000000000" pitchFamily="2" charset="0"/>
+              </a:rPr>
+              <a:t>దీవెనగా మార్చి – నడిపించుచున్నావు</a:t>
+            </a:r>
+            <a:br>
+              <a:rPr lang="te-IN" sz="1550" dirty="0">
+                <a:solidFill>
+                  <a:schemeClr val="tx1"/>
+                </a:solidFill>
+                <a:latin typeface="Ramabhadra" panose="02000600000000000000" pitchFamily="2" charset="0"/>
+                <a:cs typeface="Ramabhadra" panose="02000600000000000000" pitchFamily="2" charset="0"/>
+              </a:rPr>
+            </a:br>
+            <a:r>
+              <a:rPr lang="te-IN" sz="1550" dirty="0">
+                <a:solidFill>
+                  <a:schemeClr val="tx1"/>
+                </a:solidFill>
+                <a:latin typeface="Ramabhadra" panose="02000600000000000000" pitchFamily="2" charset="0"/>
+                <a:cs typeface="Ramabhadra" panose="02000600000000000000" pitchFamily="2" charset="0"/>
+              </a:rPr>
+              <a:t>ఈ స్తుతి మహిమలు నీకే –</a:t>
             </a:r>
           </a:p>
           <a:p>
             <a:pPr algn="ctr"/>
             <a:r>
-              <a:rPr lang="te-IN" sz="1700" dirty="0">
-                <a:solidFill>
-                  <a:schemeClr val="tx1"/>
-                </a:solidFill>
-                <a:latin typeface="Ramabhadra" panose="02000600000000000000" pitchFamily="2" charset="0"/>
-                <a:cs typeface="Ramabhadra" panose="02000600000000000000" pitchFamily="2" charset="0"/>
-              </a:rPr>
-              <a:t>బలమైన జనముగా</a:t>
-            </a:r>
-          </a:p>
-          <a:p>
-            <a:pPr algn="ctr"/>
-            <a:r>
-              <a:rPr lang="te-IN" sz="1700" dirty="0">
-                <a:solidFill>
-                  <a:schemeClr val="tx1"/>
-                </a:solidFill>
-                <a:latin typeface="Ramabhadra" panose="02000600000000000000" pitchFamily="2" charset="0"/>
-                <a:cs typeface="Ramabhadra" panose="02000600000000000000" pitchFamily="2" charset="0"/>
-              </a:rPr>
-              <a:t>నిర్దారించితివి నీ కీర్తి కొరకే</a:t>
+              <a:rPr lang="te-IN" sz="1550" dirty="0">
+                <a:solidFill>
+                  <a:schemeClr val="tx1"/>
+                </a:solidFill>
+                <a:latin typeface="Ramabhadra" panose="02000600000000000000" pitchFamily="2" charset="0"/>
+                <a:cs typeface="Ramabhadra" panose="02000600000000000000" pitchFamily="2" charset="0"/>
+              </a:rPr>
+              <a:t>చెల్లించెదను – జీవితాంతము</a:t>
             </a:r>
           </a:p>
         </p:txBody>
@@ -4209,7 +4335,7 @@
                 <a:latin typeface="Ramabhadra" panose="02000600000000000000" pitchFamily="2" charset="0"/>
                 <a:cs typeface="Ramabhadra" panose="02000600000000000000" pitchFamily="2" charset="0"/>
               </a:rPr>
-              <a:t>ఆయనే నా సంగీతము</a:t>
+              <a:t>దేవా నా దేవా –</a:t>
             </a:r>
           </a:p>
           <a:p>
@@ -4222,7 +4348,26 @@
                 <a:latin typeface="Ramabhadra" panose="02000600000000000000" pitchFamily="2" charset="0"/>
                 <a:cs typeface="Ramabhadra" panose="02000600000000000000" pitchFamily="2" charset="0"/>
               </a:rPr>
-              <a:t>బలమైన కోటయును</a:t>
+              <a:t>నీవే నా కాపరి</a:t>
+            </a:r>
+            <a:br>
+              <a:rPr lang="te-IN" dirty="0">
+                <a:solidFill>
+                  <a:schemeClr val="tx1"/>
+                </a:solidFill>
+                <a:latin typeface="Ramabhadra" panose="02000600000000000000" pitchFamily="2" charset="0"/>
+                <a:cs typeface="Ramabhadra" panose="02000600000000000000" pitchFamily="2" charset="0"/>
+              </a:rPr>
+            </a:br>
+            <a:r>
+              <a:rPr lang="te-IN" dirty="0">
+                <a:solidFill>
+                  <a:schemeClr val="tx1"/>
+                </a:solidFill>
+                <a:latin typeface="Ramabhadra" panose="02000600000000000000" pitchFamily="2" charset="0"/>
+                <a:cs typeface="Ramabhadra" panose="02000600000000000000" pitchFamily="2" charset="0"/>
+              </a:rPr>
+              <a:t>నీ ప్రేమ నీ క్షమా –</a:t>
             </a:r>
           </a:p>
           <a:p>
@@ -4235,7 +4380,45 @@
                 <a:latin typeface="Ramabhadra" panose="02000600000000000000" pitchFamily="2" charset="0"/>
                 <a:cs typeface="Ramabhadra" panose="02000600000000000000" pitchFamily="2" charset="0"/>
               </a:rPr>
-              <a:t>జీవాధిపతియు ఆయనే</a:t>
+              <a:t>ఎంతో గొప్పది (2)</a:t>
+            </a:r>
+            <a:br>
+              <a:rPr lang="te-IN" dirty="0">
+                <a:solidFill>
+                  <a:schemeClr val="tx1"/>
+                </a:solidFill>
+                <a:latin typeface="Ramabhadra" panose="02000600000000000000" pitchFamily="2" charset="0"/>
+                <a:cs typeface="Ramabhadra" panose="02000600000000000000" pitchFamily="2" charset="0"/>
+              </a:rPr>
+            </a:br>
+            <a:r>
+              <a:rPr lang="te-IN" dirty="0">
+                <a:solidFill>
+                  <a:schemeClr val="tx1"/>
+                </a:solidFill>
+                <a:latin typeface="Ramabhadra" panose="02000600000000000000" pitchFamily="2" charset="0"/>
+                <a:cs typeface="Ramabhadra" panose="02000600000000000000" pitchFamily="2" charset="0"/>
+              </a:rPr>
+              <a:t>ఆరాధింతును హృదయాంతరంగములో</a:t>
+            </a:r>
+            <a:br>
+              <a:rPr lang="te-IN" dirty="0">
+                <a:solidFill>
+                  <a:schemeClr val="tx1"/>
+                </a:solidFill>
+                <a:latin typeface="Ramabhadra" panose="02000600000000000000" pitchFamily="2" charset="0"/>
+                <a:cs typeface="Ramabhadra" panose="02000600000000000000" pitchFamily="2" charset="0"/>
+              </a:rPr>
+            </a:br>
+            <a:r>
+              <a:rPr lang="te-IN" dirty="0">
+                <a:solidFill>
+                  <a:schemeClr val="tx1"/>
+                </a:solidFill>
+                <a:latin typeface="Ramabhadra" panose="02000600000000000000" pitchFamily="2" charset="0"/>
+                <a:cs typeface="Ramabhadra" panose="02000600000000000000" pitchFamily="2" charset="0"/>
+              </a:rPr>
+              <a:t>స్తుతియింతును</a:t>
             </a:r>
           </a:p>
           <a:p>
@@ -4248,7 +4431,39 @@
                 <a:latin typeface="Ramabhadra" panose="02000600000000000000" pitchFamily="2" charset="0"/>
                 <a:cs typeface="Ramabhadra" panose="02000600000000000000" pitchFamily="2" charset="0"/>
               </a:rPr>
-              <a:t>జీవిత కాలమెల్ల స్తుతించెదము</a:t>
+              <a:t>నీ పాద సన్నిధిలో (2)</a:t>
+            </a:r>
+            <a:br>
+              <a:rPr lang="te-IN" dirty="0">
+                <a:solidFill>
+                  <a:schemeClr val="tx1"/>
+                </a:solidFill>
+                <a:latin typeface="Ramabhadra" panose="02000600000000000000" pitchFamily="2" charset="0"/>
+                <a:cs typeface="Ramabhadra" panose="02000600000000000000" pitchFamily="2" charset="0"/>
+              </a:rPr>
+            </a:br>
+            <a:r>
+              <a:rPr lang="te-IN" dirty="0">
+                <a:solidFill>
+                  <a:schemeClr val="tx1"/>
+                </a:solidFill>
+                <a:latin typeface="Ramabhadra" panose="02000600000000000000" pitchFamily="2" charset="0"/>
+                <a:cs typeface="Ramabhadra" panose="02000600000000000000" pitchFamily="2" charset="0"/>
+              </a:rPr>
+              <a:t>నీవే కదా దేవుడవు – (2)</a:t>
+            </a:r>
+          </a:p>
+          <a:p>
+            <a:pPr algn="ctr"/>
+            <a:r>
+              <a:rPr lang="te-IN" dirty="0">
+                <a:solidFill>
+                  <a:schemeClr val="tx1"/>
+                </a:solidFill>
+                <a:latin typeface="Ramabhadra" panose="02000600000000000000" pitchFamily="2" charset="0"/>
+                <a:cs typeface="Ramabhadra" panose="02000600000000000000" pitchFamily="2" charset="0"/>
+              </a:rPr>
+              <a:t>దేవా యేసు దేవా (4)</a:t>
             </a:r>
           </a:p>
           <a:p>
@@ -4271,12 +4486,9 @@
                 <a:latin typeface="Ramabhadra" panose="02000600000000000000" pitchFamily="2" charset="0"/>
                 <a:cs typeface="Ramabhadra" panose="02000600000000000000" pitchFamily="2" charset="0"/>
               </a:rPr>
-              <a:t>స్తుతుల మధ్యలో నివాసం చేసి</a:t>
-            </a:r>
-          </a:p>
-          <a:p>
-            <a:pPr algn="ctr"/>
-            <a:r>
+              <a:t>పాపము నుండి విడిపించినావు</a:t>
+            </a:r>
+            <a:br>
               <a:rPr lang="te-IN" dirty="0">
                 <a:solidFill>
                   <a:schemeClr val="tx1"/>
@@ -4284,11 +4496,7 @@
                 <a:latin typeface="Ramabhadra" panose="02000600000000000000" pitchFamily="2" charset="0"/>
                 <a:cs typeface="Ramabhadra" panose="02000600000000000000" pitchFamily="2" charset="0"/>
               </a:rPr>
-              <a:t>దూతలెల్ల పొగడే</a:t>
-            </a:r>
-          </a:p>
-          <a:p>
-            <a:pPr algn="ctr"/>
+            </a:br>
             <a:r>
               <a:rPr lang="te-IN" dirty="0">
                 <a:solidFill>
@@ -4297,12 +4505,9 @@
                 <a:latin typeface="Ramabhadra" panose="02000600000000000000" pitchFamily="2" charset="0"/>
                 <a:cs typeface="Ramabhadra" panose="02000600000000000000" pitchFamily="2" charset="0"/>
               </a:rPr>
-              <a:t>దేవుడాయనే (2)</a:t>
-            </a:r>
-          </a:p>
-          <a:p>
-            <a:pPr algn="ctr"/>
-            <a:r>
+              <a:t>పరిశుద్ధుని చేసి ప్రేమించినావు (2)</a:t>
+            </a:r>
+            <a:br>
               <a:rPr lang="te-IN" dirty="0">
                 <a:solidFill>
                   <a:schemeClr val="tx1"/>
@@ -4310,11 +4515,7 @@
                 <a:latin typeface="Ramabhadra" panose="02000600000000000000" pitchFamily="2" charset="0"/>
                 <a:cs typeface="Ramabhadra" panose="02000600000000000000" pitchFamily="2" charset="0"/>
               </a:rPr>
-              <a:t>వేడుచుండు భక్తుల</a:t>
-            </a:r>
-          </a:p>
-          <a:p>
-            <a:pPr algn="ctr"/>
+            </a:br>
             <a:r>
               <a:rPr lang="te-IN" dirty="0">
                 <a:solidFill>
@@ -4323,12 +4524,9 @@
                 <a:latin typeface="Ramabhadra" panose="02000600000000000000" pitchFamily="2" charset="0"/>
                 <a:cs typeface="Ramabhadra" panose="02000600000000000000" pitchFamily="2" charset="0"/>
               </a:rPr>
-              <a:t>స్వరము విని</a:t>
-            </a:r>
-          </a:p>
-          <a:p>
-            <a:pPr algn="ctr"/>
-            <a:r>
+              <a:t>నీవే కదా దేవుడవు – (2)</a:t>
+            </a:r>
+            <a:br>
               <a:rPr lang="te-IN" dirty="0">
                 <a:solidFill>
                   <a:schemeClr val="tx1"/>
@@ -4336,7 +4534,16 @@
                 <a:latin typeface="Ramabhadra" panose="02000600000000000000" pitchFamily="2" charset="0"/>
                 <a:cs typeface="Ramabhadra" panose="02000600000000000000" pitchFamily="2" charset="0"/>
               </a:rPr>
-              <a:t>దిక్కు లేని పిల్లలకు దేవుడాయనే (2)</a:t>
+            </a:br>
+            <a:r>
+              <a:rPr lang="te-IN" dirty="0">
+                <a:solidFill>
+                  <a:schemeClr val="tx1"/>
+                </a:solidFill>
+                <a:latin typeface="Ramabhadra" panose="02000600000000000000" pitchFamily="2" charset="0"/>
+                <a:cs typeface="Ramabhadra" panose="02000600000000000000" pitchFamily="2" charset="0"/>
+              </a:rPr>
+              <a:t>దేవా యేసు దేవా (4)</a:t>
             </a:r>
           </a:p>
           <a:p>
@@ -4359,7 +4566,26 @@
                 <a:latin typeface="Ramabhadra" panose="02000600000000000000" pitchFamily="2" charset="0"/>
                 <a:cs typeface="Ramabhadra" panose="02000600000000000000" pitchFamily="2" charset="0"/>
               </a:rPr>
-              <a:t>ఇద్దరు ముగ్గురు నా నామమున</a:t>
+              <a:t>పరిశుద్ధాత్మను నాలో నింపావు</a:t>
+            </a:r>
+            <a:br>
+              <a:rPr lang="te-IN" dirty="0">
+                <a:solidFill>
+                  <a:schemeClr val="tx1"/>
+                </a:solidFill>
+                <a:latin typeface="Ramabhadra" panose="02000600000000000000" pitchFamily="2" charset="0"/>
+                <a:cs typeface="Ramabhadra" panose="02000600000000000000" pitchFamily="2" charset="0"/>
+              </a:rPr>
+            </a:br>
+            <a:r>
+              <a:rPr lang="te-IN" dirty="0">
+                <a:solidFill>
+                  <a:schemeClr val="tx1"/>
+                </a:solidFill>
+                <a:latin typeface="Ramabhadra" panose="02000600000000000000" pitchFamily="2" charset="0"/>
+                <a:cs typeface="Ramabhadra" panose="02000600000000000000" pitchFamily="2" charset="0"/>
+              </a:rPr>
+              <a:t>మట్టి దేహమును</a:t>
             </a:r>
           </a:p>
           <a:p>
@@ -4372,12 +4598,9 @@
                 <a:latin typeface="Ramabhadra" panose="02000600000000000000" pitchFamily="2" charset="0"/>
                 <a:cs typeface="Ramabhadra" panose="02000600000000000000" pitchFamily="2" charset="0"/>
               </a:rPr>
-              <a:t>ఏకీభవించిన వారి</a:t>
-            </a:r>
-          </a:p>
-          <a:p>
-            <a:pPr algn="ctr"/>
-            <a:r>
+              <a:t>మహిమతో నింపావు (2)</a:t>
+            </a:r>
+            <a:br>
               <a:rPr lang="te-IN" dirty="0">
                 <a:solidFill>
                   <a:schemeClr val="tx1"/>
@@ -4385,11 +4608,7 @@
                 <a:latin typeface="Ramabhadra" panose="02000600000000000000" pitchFamily="2" charset="0"/>
                 <a:cs typeface="Ramabhadra" panose="02000600000000000000" pitchFamily="2" charset="0"/>
               </a:rPr>
-              <a:t>మధ్యలోన (2)</a:t>
-            </a:r>
-          </a:p>
-          <a:p>
-            <a:pPr algn="ctr"/>
+            </a:br>
             <a:r>
               <a:rPr lang="te-IN" dirty="0">
                 <a:solidFill>
@@ -4398,12 +4617,9 @@
                 <a:latin typeface="Ramabhadra" panose="02000600000000000000" pitchFamily="2" charset="0"/>
                 <a:cs typeface="Ramabhadra" panose="02000600000000000000" pitchFamily="2" charset="0"/>
               </a:rPr>
-              <a:t>ఉండెదననిన మన దేవుని</a:t>
-            </a:r>
-          </a:p>
-          <a:p>
-            <a:pPr algn="ctr"/>
-            <a:r>
+              <a:t>నీవే కదా దేవుడవు – (2)</a:t>
+            </a:r>
+            <a:br>
               <a:rPr lang="te-IN" dirty="0">
                 <a:solidFill>
                   <a:schemeClr val="tx1"/>
@@ -4411,7 +4627,16 @@
                 <a:latin typeface="Ramabhadra" panose="02000600000000000000" pitchFamily="2" charset="0"/>
                 <a:cs typeface="Ramabhadra" panose="02000600000000000000" pitchFamily="2" charset="0"/>
               </a:rPr>
-              <a:t>కరములు తట్టి నిత్యం స్తుతించెదము (2)</a:t>
+            </a:br>
+            <a:r>
+              <a:rPr lang="te-IN" dirty="0">
+                <a:solidFill>
+                  <a:schemeClr val="tx1"/>
+                </a:solidFill>
+                <a:latin typeface="Ramabhadra" panose="02000600000000000000" pitchFamily="2" charset="0"/>
+                <a:cs typeface="Ramabhadra" panose="02000600000000000000" pitchFamily="2" charset="0"/>
+              </a:rPr>
+              <a:t>దేవా యేసు దేవా (4)</a:t>
             </a:r>
           </a:p>
         </p:txBody>
@@ -4476,7 +4701,7 @@
                 <a:latin typeface="Ramabhadra" panose="02000600000000000000" pitchFamily="2" charset="0"/>
                 <a:cs typeface="Ramabhadra" panose="02000600000000000000" pitchFamily="2" charset="0"/>
               </a:rPr>
-              <a:t>శాశ్వతమైన ప్రేమ </a:t>
+              <a:t>హల్లెలూయ పాట</a:t>
             </a:r>
           </a:p>
           <a:p>
@@ -4489,7 +4714,7 @@
                 <a:latin typeface="Ramabhadra" panose="02000600000000000000" pitchFamily="2" charset="0"/>
                 <a:cs typeface="Ramabhadra" panose="02000600000000000000" pitchFamily="2" charset="0"/>
               </a:rPr>
-              <a:t>నను ఎడబాయని యేసు ప్రేమ</a:t>
+              <a:t>యేసయ్య పాట</a:t>
             </a:r>
           </a:p>
           <a:p>
@@ -4502,7 +4727,7 @@
                 <a:latin typeface="Ramabhadra" panose="02000600000000000000" pitchFamily="2" charset="0"/>
                 <a:cs typeface="Ramabhadra" panose="02000600000000000000" pitchFamily="2" charset="0"/>
               </a:rPr>
-              <a:t>విడువక నాయెడ తన కృప చూపు ప్రేమ</a:t>
+              <a:t>పాడాలి ప్రతి చోట</a:t>
             </a:r>
           </a:p>
           <a:p>
@@ -4515,7 +4740,20 @@
                 <a:latin typeface="Ramabhadra" panose="02000600000000000000" pitchFamily="2" charset="0"/>
                 <a:cs typeface="Ramabhadra" panose="02000600000000000000" pitchFamily="2" charset="0"/>
               </a:rPr>
-              <a:t>నన్నాదరించు ప్రేమ - నన్నాదుకొన్న ప్రేమ</a:t>
+              <a:t>పాడాలి ప్రతి నోట</a:t>
+            </a:r>
+          </a:p>
+          <a:p>
+            <a:pPr algn="ctr"/>
+            <a:r>
+              <a:rPr lang="te-IN" sz="1900" dirty="0">
+                <a:solidFill>
+                  <a:schemeClr val="tx1"/>
+                </a:solidFill>
+                <a:latin typeface="Ramabhadra" panose="02000600000000000000" pitchFamily="2" charset="0"/>
+                <a:cs typeface="Ramabhadra" panose="02000600000000000000" pitchFamily="2" charset="0"/>
+              </a:rPr>
+              <a:t>హల్లెలూయా హల్లెలూయా హల్లెలూయా (4)</a:t>
             </a:r>
           </a:p>
           <a:p>
@@ -4538,7 +4776,7 @@
                 <a:latin typeface="Ramabhadra" panose="02000600000000000000" pitchFamily="2" charset="0"/>
                 <a:cs typeface="Ramabhadra" panose="02000600000000000000" pitchFamily="2" charset="0"/>
               </a:rPr>
-              <a:t>యుగములు మారినను </a:t>
+              <a:t>స్తుతిపాటలే పాడుమా</a:t>
             </a:r>
           </a:p>
           <a:p>
@@ -4551,46 +4789,7 @@
                 <a:latin typeface="Ramabhadra" panose="02000600000000000000" pitchFamily="2" charset="0"/>
                 <a:cs typeface="Ramabhadra" panose="02000600000000000000" pitchFamily="2" charset="0"/>
               </a:rPr>
-              <a:t>తరములు తరళినను</a:t>
-            </a:r>
-          </a:p>
-          <a:p>
-            <a:pPr algn="ctr"/>
-            <a:r>
-              <a:rPr lang="te-IN" sz="1900" dirty="0">
-                <a:solidFill>
-                  <a:schemeClr val="tx1"/>
-                </a:solidFill>
-                <a:latin typeface="Ramabhadra" panose="02000600000000000000" pitchFamily="2" charset="0"/>
-                <a:cs typeface="Ramabhadra" panose="02000600000000000000" pitchFamily="2" charset="0"/>
-              </a:rPr>
-              <a:t>రాజ్యములే కంపించిన  </a:t>
-            </a:r>
-          </a:p>
-          <a:p>
-            <a:pPr algn="ctr"/>
-            <a:r>
-              <a:rPr lang="te-IN" sz="1900" dirty="0">
-                <a:solidFill>
-                  <a:schemeClr val="tx1"/>
-                </a:solidFill>
-                <a:latin typeface="Ramabhadra" panose="02000600000000000000" pitchFamily="2" charset="0"/>
-                <a:cs typeface="Ramabhadra" panose="02000600000000000000" pitchFamily="2" charset="0"/>
-              </a:rPr>
-              <a:t>భూ రాష్ట్రములె అంతరించిన</a:t>
-            </a:r>
-          </a:p>
-          <a:p>
-            <a:pPr algn="ctr"/>
-            <a:r>
-              <a:rPr lang="te-IN" sz="1900" dirty="0">
-                <a:solidFill>
-                  <a:schemeClr val="tx1"/>
-                </a:solidFill>
-                <a:latin typeface="Ramabhadra" panose="02000600000000000000" pitchFamily="2" charset="0"/>
-                <a:cs typeface="Ramabhadra" panose="02000600000000000000" pitchFamily="2" charset="0"/>
-              </a:rPr>
-              <a:t>మారని ప్రేమ అత్యంత ప్రేమ అవధులే లేని ప్రేమ</a:t>
+              <a:t>ప్రభు యేసునే వేడుమా (2)</a:t>
             </a:r>
           </a:p>
           <a:p>
@@ -4613,7 +4812,7 @@
                 <a:latin typeface="Ramabhadra" panose="02000600000000000000" pitchFamily="2" charset="0"/>
                 <a:cs typeface="Ramabhadra" panose="02000600000000000000" pitchFamily="2" charset="0"/>
               </a:rPr>
-              <a:t>నా వారు వెలివేసినా</a:t>
+              <a:t>కష్టములే కలిగిన</a:t>
             </a:r>
           </a:p>
           <a:p>
@@ -4626,11 +4825,21 @@
                 <a:latin typeface="Ramabhadra" panose="02000600000000000000" pitchFamily="2" charset="0"/>
                 <a:cs typeface="Ramabhadra" panose="02000600000000000000" pitchFamily="2" charset="0"/>
               </a:rPr>
-              <a:t>నాకున్న వారే దూరమైన</a:t>
+              <a:t>కన్నీరులే మిగిలినా “స్తుతి”</a:t>
             </a:r>
           </a:p>
           <a:p>
             <a:pPr algn="ctr"/>
+            <a:endParaRPr lang="te-IN" sz="1900" dirty="0">
+              <a:solidFill>
+                <a:schemeClr val="tx1"/>
+              </a:solidFill>
+              <a:latin typeface="Ramabhadra" panose="02000600000000000000" pitchFamily="2" charset="0"/>
+              <a:cs typeface="Ramabhadra" panose="02000600000000000000" pitchFamily="2" charset="0"/>
+            </a:endParaRPr>
+          </a:p>
+          <a:p>
+            <a:pPr algn="ctr"/>
             <a:r>
               <a:rPr lang="te-IN" sz="1900" dirty="0">
                 <a:solidFill>
@@ -4639,59 +4848,7 @@
                 <a:latin typeface="Ramabhadra" panose="02000600000000000000" pitchFamily="2" charset="0"/>
                 <a:cs typeface="Ramabhadra" panose="02000600000000000000" pitchFamily="2" charset="0"/>
               </a:rPr>
-              <a:t>తన బిడ్డను తల్లి మరచిన </a:t>
-            </a:r>
-          </a:p>
-          <a:p>
-            <a:pPr algn="ctr"/>
-            <a:r>
-              <a:rPr lang="te-IN" sz="1900" dirty="0">
-                <a:solidFill>
-                  <a:schemeClr val="tx1"/>
-                </a:solidFill>
-                <a:latin typeface="Ramabhadra" panose="02000600000000000000" pitchFamily="2" charset="0"/>
-                <a:cs typeface="Ramabhadra" panose="02000600000000000000" pitchFamily="2" charset="0"/>
-              </a:rPr>
-              <a:t>నను ఎన్నటికి మరువననిన</a:t>
-            </a:r>
-          </a:p>
-          <a:p>
-            <a:pPr algn="ctr"/>
-            <a:r>
-              <a:rPr lang="te-IN" sz="1900" dirty="0">
-                <a:solidFill>
-                  <a:schemeClr val="tx1"/>
-                </a:solidFill>
-                <a:latin typeface="Ramabhadra" panose="02000600000000000000" pitchFamily="2" charset="0"/>
-                <a:cs typeface="Ramabhadra" panose="02000600000000000000" pitchFamily="2" charset="0"/>
-              </a:rPr>
-              <a:t>అరచేతిలో నన్ను</a:t>
-            </a:r>
-          </a:p>
-          <a:p>
-            <a:pPr algn="ctr"/>
-            <a:r>
-              <a:rPr lang="te-IN" sz="1900" dirty="0">
-                <a:solidFill>
-                  <a:schemeClr val="tx1"/>
-                </a:solidFill>
-                <a:latin typeface="Ramabhadra" panose="02000600000000000000" pitchFamily="2" charset="0"/>
-                <a:cs typeface="Ramabhadra" panose="02000600000000000000" pitchFamily="2" charset="0"/>
-              </a:rPr>
-              <a:t>చెక్కుకొన్న ప్రేమ</a:t>
-            </a:r>
-          </a:p>
-          <a:p>
-            <a:pPr algn="ctr"/>
-            <a:r>
-              <a:rPr lang="te-IN" sz="1900" dirty="0">
-                <a:solidFill>
-                  <a:schemeClr val="tx1"/>
-                </a:solidFill>
-                <a:latin typeface="Ramabhadra" panose="02000600000000000000" pitchFamily="2" charset="0"/>
-                <a:cs typeface="Ramabhadra" panose="02000600000000000000" pitchFamily="2" charset="0"/>
-              </a:rPr>
-              <a:t> మరవని విడువని ప్రేమ</a:t>
+              <a:t>బంధాలు బిగియించినా చేరసాలలో వేసినా “స్తుతి”</a:t>
             </a:r>
           </a:p>
         </p:txBody>

</xml_diff>